<commit_message>
Addition of presentation with the evaluation results of the new questions.
</commit_message>
<xml_diff>
--- a/RAG_Workshop.pptx
+++ b/RAG_Workshop.pptx
@@ -26,8 +26,8 @@
     <p:sldId id="256" r:id="rId17"/>
     <p:sldId id="313" r:id="rId18"/>
     <p:sldId id="320" r:id="rId19"/>
-    <p:sldId id="315" r:id="rId20"/>
-    <p:sldId id="316" r:id="rId21"/>
+    <p:sldId id="271" r:id="rId20"/>
+    <p:sldId id="272" r:id="rId21"/>
     <p:sldId id="274" r:id="rId22"/>
     <p:sldId id="275" r:id="rId23"/>
     <p:sldId id="276" r:id="rId24"/>
@@ -153,8 +153,8 @@
             <p14:sldId id="256"/>
             <p14:sldId id="313"/>
             <p14:sldId id="320"/>
-            <p14:sldId id="315"/>
-            <p14:sldId id="316"/>
+            <p14:sldId id="271"/>
+            <p14:sldId id="272"/>
             <p14:sldId id="274"/>
             <p14:sldId id="275"/>
             <p14:sldId id="276"/>
@@ -2146,7 +2146,7 @@
           <a:lstStyle/>
           <a:p>
             <a:r>
-              <a:t>Im aktuellen Lauf erreichen Vector und Graph jeweils 100 Prozent Article Recall@K. Die MRR-Werte sind praktisch gleich. GraphRAG benötigt durchschnittlich 746 statt 857 Prompt-Kontext-Tokens, also 13 Prozent weniger. Diese Werte stammen aus acht Fragen und sind keine allgemeine Benchmark.</a:t>
+              <a:t>Der vollständige Lauf umfasst sechs Fragen und ein gemeinsames Budget von sechs Chunks. GraphRAG erreicht mit 87,5 Prozent den höchsten Article Recall@K und verwendet durchschnittlich 802 Prompt-Kontext-Tokens. Der Reranker erzielt mit 0,68 die beste MRR. Diese Werte sind eine Workshop-Messung und keine allgemeine Benchmark.</a:t>
             </a:r>
           </a:p>
           <a:p>
@@ -2159,7 +2159,7 @@
           </a:p>
           <a:p>
             <a:r>
-              <a:t>- C:/Users/mehlst/Documents/RAG-Workshop/evaluation/report.md</a:t>
+              <a:t>- C:/Users/mehlst/Documents/RAG-Workshop/evaluation/report-graph.md</a:t>
             </a:r>
           </a:p>
           <a:p>
@@ -2246,7 +2246,7 @@
           <a:lstStyle/>
           <a:p>
             <a:r>
-              <a:t>GraphRAG deckt im aktuellen Lauf mehr erwartete Fakten ab, liegt aber bei Expected-citation Precision, Citation Grounding und Citation Completeness hinter Vector-RAG. Deshalb müssen Retrieval- und Antwortmetriken gemeinsam interpretiert werden. Term Coverage bleibt nur eine Diagnosemetrik.</a:t>
+              <a:t>Im vollständigen Lauf erreicht GraphRAG 55,6 Prozent Faktenabdeckung und 66,7 Prozent Zitationsvollständigkeit. Fixed Vector erzielt trotz schwächerem Retrieval 61,1 Prozent Faktenabdeckung. Die Antwortmetriken schwanken, weil das LLM nicht deterministisch antwortet und trotz Quellenprompt falsche Artikel nennen kann. Retrieval und Generierung müssen deshalb getrennt bewertet werden.</a:t>
             </a:r>
           </a:p>
           <a:p>
@@ -2259,7 +2259,7 @@
           </a:p>
           <a:p>
             <a:r>
-              <a:t>- C:/Users/mehlst/Documents/RAG-Workshop/evaluation/report.md</a:t>
+              <a:t>- C:/Users/mehlst/Documents/RAG-Workshop/evaluation/report-graph.md</a:t>
             </a:r>
           </a:p>
           <a:p>
@@ -17994,102 +17994,6 @@
       </p:grpSpPr>
       <p:sp>
         <p:nvSpPr>
-          <p:cNvPr id="33" name="clean-canvas">
-            <a:extLst>
-              <a:ext uri="{FF2B5EF4-FFF2-40B4-BE49-F238E27FC236}">
-                <a16:creationId xmlns:a16="http://schemas.microsoft.com/office/drawing/2014/main" id="{B2FBC28B-665B-4948-A297-C71BDA3ECCB7}"/>
-              </a:ext>
-            </a:extLst>
-          </p:cNvPr>
-          <p:cNvSpPr>
-            <a:spLocks noGrp="1"/>
-          </p:cNvSpPr>
-          <p:nvPr/>
-        </p:nvSpPr>
-        <p:spPr>
-          <a:xfrm>
-            <a:off x="0" y="0"/>
-            <a:ext cx="12192000" cy="6096000"/>
-          </a:xfrm>
-          <a:prstGeom prst="rect">
-            <a:avLst/>
-          </a:prstGeom>
-          <a:solidFill>
-            <a:srgbClr val="FFFFFF"/>
-          </a:solidFill>
-          <a:ln w="0">
-            <a:solidFill>
-              <a:srgbClr val="FFFFFF"/>
-            </a:solidFill>
-            <a:prstDash val="solid"/>
-          </a:ln>
-        </p:spPr>
-        <p:txBody>
-          <a:bodyPr/>
-          <a:lstStyle/>
-          <a:p>
-            <a:endParaRPr lang="de-CH"/>
-          </a:p>
-        </p:txBody>
-      </p:sp>
-      <p:sp>
-        <p:nvSpPr>
-          <p:cNvPr id="2" name="slide-title">
-            <a:extLst>
-              <a:ext uri="{FF2B5EF4-FFF2-40B4-BE49-F238E27FC236}">
-                <a16:creationId xmlns:a16="http://schemas.microsoft.com/office/drawing/2014/main" id="{540E8F70-9B23-436C-B2AB-251CB6C804B0}"/>
-              </a:ext>
-            </a:extLst>
-          </p:cNvPr>
-          <p:cNvSpPr>
-            <a:spLocks noGrp="1"/>
-          </p:cNvSpPr>
-          <p:nvPr/>
-        </p:nvSpPr>
-        <p:spPr>
-          <a:xfrm>
-            <a:off x="476250" y="333375"/>
-            <a:ext cx="11239500" cy="714375"/>
-          </a:xfrm>
-          <a:prstGeom prst="rect">
-            <a:avLst/>
-          </a:prstGeom>
-          <a:noFill/>
-          <a:ln w="0">
-            <a:noFill/>
-            <a:prstDash val="solid"/>
-          </a:ln>
-        </p:spPr>
-        <p:txBody>
-          <a:bodyPr anchor="ctr"/>
-          <a:lstStyle/>
-          <a:p>
-            <a:pPr algn="l">
-              <a:defRPr sz="2850" b="0">
-                <a:solidFill>
-                  <a:srgbClr val="2D3F4B"/>
-                </a:solidFill>
-                <a:latin typeface="Arial"/>
-                <a:ea typeface="Arial"/>
-                <a:cs typeface="Arial"/>
-              </a:defRPr>
-            </a:pPr>
-            <a:r>
-              <a:rPr sz="2850" b="0">
-                <a:solidFill>
-                  <a:srgbClr val="2D3F4B"/>
-                </a:solidFill>
-                <a:latin typeface="Arial"/>
-                <a:ea typeface="Arial"/>
-                <a:cs typeface="Arial"/>
-              </a:rPr>
-              <a:t>Retrieval: Beide finden die Artikel – Graph nutzt weniger Kontext</a:t>
-            </a:r>
-          </a:p>
-        </p:txBody>
-      </p:sp>
-      <p:sp>
-        <p:nvSpPr>
           <p:cNvPr id="3" name="title-rule">
             <a:extLst>
               <a:ext uri="{FF2B5EF4-FFF2-40B4-BE49-F238E27FC236}">
@@ -18121,7 +18025,7 @@
           <a:bodyPr/>
           <a:lstStyle/>
           <a:p>
-            <a:endParaRPr lang="de-CH"/>
+            <a:endParaRPr/>
           </a:p>
         </p:txBody>
       </p:sp>
@@ -18158,6 +18062,7 @@
           <a:lstStyle/>
           <a:p>
             <a:pPr algn="l">
+              <a:buNone/>
               <a:defRPr sz="1650" b="0">
                 <a:solidFill>
                   <a:srgbClr val="81725E"/>
@@ -18176,7 +18081,7 @@
                 <a:ea typeface="Arial"/>
                 <a:cs typeface="Arial"/>
               </a:rPr>
-              <a:t>Aktueller Lauf · 8 Fragen · gemeinsames Budget von 6 Chunks.</a:t>
+              <a:t>Reranking verbessert die Rangfolge; GraphRAG ergänzt exakte Artikelauflösung.</a:t>
             </a:r>
           </a:p>
         </p:txBody>
@@ -18214,6 +18119,7 @@
           <a:lstStyle/>
           <a:p>
             <a:pPr algn="l">
+              <a:buNone/>
               <a:defRPr sz="825" b="0">
                 <a:solidFill>
                   <a:srgbClr val="2D3F4B"/>
@@ -18270,6 +18176,7 @@
           <a:lstStyle/>
           <a:p>
             <a:pPr algn="l">
+              <a:buNone/>
               <a:defRPr sz="825" b="0">
                 <a:solidFill>
                   <a:srgbClr val="2D3F4B"/>
@@ -18326,6 +18233,7 @@
           <a:lstStyle/>
           <a:p>
             <a:pPr algn="ctr">
+              <a:buNone/>
               <a:defRPr sz="1200" b="1">
                 <a:solidFill>
                   <a:srgbClr val="C60C30"/>
@@ -18387,7 +18295,7 @@
           <a:bodyPr/>
           <a:lstStyle/>
           <a:p>
-            <a:endParaRPr lang="de-CH"/>
+            <a:endParaRPr/>
           </a:p>
         </p:txBody>
       </p:sp>
@@ -18424,9 +18332,10 @@
           <a:lstStyle/>
           <a:p>
             <a:pPr algn="ctr">
-              <a:defRPr sz="1125" b="1">
-                <a:solidFill>
-                  <a:srgbClr val="81725E"/>
+              <a:buNone/>
+              <a:defRPr sz="825" b="1">
+                <a:solidFill>
+                  <a:srgbClr val="304554"/>
                 </a:solidFill>
                 <a:latin typeface="Arial"/>
                 <a:ea typeface="Arial"/>
@@ -18434,15 +18343,39 @@
               </a:defRPr>
             </a:pPr>
             <a:r>
-              <a:rPr sz="1125" b="1">
-                <a:solidFill>
-                  <a:srgbClr val="81725E"/>
+              <a:rPr sz="825" b="1">
+                <a:solidFill>
+                  <a:srgbClr val="304554"/>
                 </a:solidFill>
                 <a:latin typeface="Arial"/>
                 <a:ea typeface="Arial"/>
                 <a:cs typeface="Arial"/>
               </a:rPr>
-              <a:t>VECTOR</a:t>
+              <a:t>FIXED</a:t>
+            </a:r>
+          </a:p>
+          <a:p>
+            <a:pPr algn="ctr">
+              <a:buNone/>
+              <a:defRPr sz="825" b="1">
+                <a:solidFill>
+                  <a:srgbClr val="304554"/>
+                </a:solidFill>
+                <a:latin typeface="Arial"/>
+                <a:ea typeface="Arial"/>
+                <a:cs typeface="Arial"/>
+              </a:defRPr>
+            </a:pPr>
+            <a:r>
+              <a:rPr sz="825" b="1">
+                <a:solidFill>
+                  <a:srgbClr val="304554"/>
+                </a:solidFill>
+                <a:latin typeface="Arial"/>
+                <a:ea typeface="Arial"/>
+                <a:cs typeface="Arial"/>
+              </a:rPr>
+              <a:t>SEMANTIC</a:t>
             </a:r>
           </a:p>
         </p:txBody>
@@ -18480,9 +18413,10 @@
           <a:lstStyle/>
           <a:p>
             <a:pPr algn="ctr">
-              <a:defRPr sz="2550" b="1">
-                <a:solidFill>
-                  <a:srgbClr val="2D3F4B"/>
+              <a:buNone/>
+              <a:defRPr sz="1725" b="1">
+                <a:solidFill>
+                  <a:srgbClr val="304554"/>
                 </a:solidFill>
                 <a:latin typeface="Arial"/>
                 <a:ea typeface="Arial"/>
@@ -18490,15 +18424,39 @@
               </a:defRPr>
             </a:pPr>
             <a:r>
-              <a:rPr sz="2550" b="1">
-                <a:solidFill>
-                  <a:srgbClr val="2D3F4B"/>
+              <a:rPr sz="1725" b="1">
+                <a:solidFill>
+                  <a:srgbClr val="304554"/>
                 </a:solidFill>
                 <a:latin typeface="Arial"/>
                 <a:ea typeface="Arial"/>
                 <a:cs typeface="Arial"/>
               </a:rPr>
-              <a:t>100%</a:t>
+              <a:t>54 %</a:t>
+            </a:r>
+          </a:p>
+          <a:p>
+            <a:pPr algn="ctr">
+              <a:buNone/>
+              <a:defRPr sz="1725" b="1">
+                <a:solidFill>
+                  <a:srgbClr val="304554"/>
+                </a:solidFill>
+                <a:latin typeface="Arial"/>
+                <a:ea typeface="Arial"/>
+                <a:cs typeface="Arial"/>
+              </a:defRPr>
+            </a:pPr>
+            <a:r>
+              <a:rPr sz="1725" b="1">
+                <a:solidFill>
+                  <a:srgbClr val="304554"/>
+                </a:solidFill>
+                <a:latin typeface="Arial"/>
+                <a:ea typeface="Arial"/>
+                <a:cs typeface="Arial"/>
+              </a:rPr>
+              <a:t>33 %</a:t>
             </a:r>
           </a:p>
         </p:txBody>
@@ -18536,9 +18494,10 @@
           <a:lstStyle/>
           <a:p>
             <a:pPr algn="ctr">
-              <a:defRPr sz="1125" b="1">
-                <a:solidFill>
-                  <a:srgbClr val="C60C30"/>
+              <a:buNone/>
+              <a:defRPr sz="825" b="1">
+                <a:solidFill>
+                  <a:srgbClr val="304554"/>
                 </a:solidFill>
                 <a:latin typeface="Arial"/>
                 <a:ea typeface="Arial"/>
@@ -18546,9 +18505,33 @@
               </a:defRPr>
             </a:pPr>
             <a:r>
-              <a:rPr sz="1125" b="1">
-                <a:solidFill>
-                  <a:srgbClr val="C60C30"/>
+              <a:rPr sz="825" b="1">
+                <a:solidFill>
+                  <a:srgbClr val="304554"/>
+                </a:solidFill>
+                <a:latin typeface="Arial"/>
+                <a:ea typeface="Arial"/>
+                <a:cs typeface="Arial"/>
+              </a:rPr>
+              <a:t>RERANK</a:t>
+            </a:r>
+          </a:p>
+          <a:p>
+            <a:pPr algn="ctr">
+              <a:buNone/>
+              <a:defRPr sz="825" b="1">
+                <a:solidFill>
+                  <a:srgbClr val="304554"/>
+                </a:solidFill>
+                <a:latin typeface="Arial"/>
+                <a:ea typeface="Arial"/>
+                <a:cs typeface="Arial"/>
+              </a:defRPr>
+            </a:pPr>
+            <a:r>
+              <a:rPr sz="825" b="1">
+                <a:solidFill>
+                  <a:srgbClr val="304554"/>
                 </a:solidFill>
                 <a:latin typeface="Arial"/>
                 <a:ea typeface="Arial"/>
@@ -18592,9 +18575,10 @@
           <a:lstStyle/>
           <a:p>
             <a:pPr algn="ctr">
-              <a:defRPr sz="2550" b="1">
-                <a:solidFill>
-                  <a:srgbClr val="C60C30"/>
+              <a:buNone/>
+              <a:defRPr sz="1725" b="1">
+                <a:solidFill>
+                  <a:srgbClr val="4B9298"/>
                 </a:solidFill>
                 <a:latin typeface="Arial"/>
                 <a:ea typeface="Arial"/>
@@ -18602,15 +18586,39 @@
               </a:defRPr>
             </a:pPr>
             <a:r>
-              <a:rPr sz="2550" b="1">
-                <a:solidFill>
-                  <a:srgbClr val="C60C30"/>
+              <a:rPr sz="1725" b="1">
+                <a:solidFill>
+                  <a:srgbClr val="4B9298"/>
                 </a:solidFill>
                 <a:latin typeface="Arial"/>
                 <a:ea typeface="Arial"/>
                 <a:cs typeface="Arial"/>
               </a:rPr>
-              <a:t>100%</a:t>
+              <a:t>71 %</a:t>
+            </a:r>
+          </a:p>
+          <a:p>
+            <a:pPr algn="ctr">
+              <a:buNone/>
+              <a:defRPr sz="1725" b="1">
+                <a:solidFill>
+                  <a:srgbClr val="4B9298"/>
+                </a:solidFill>
+                <a:latin typeface="Arial"/>
+                <a:ea typeface="Arial"/>
+                <a:cs typeface="Arial"/>
+              </a:defRPr>
+            </a:pPr>
+            <a:r>
+              <a:rPr sz="1725" b="1">
+                <a:solidFill>
+                  <a:srgbClr val="4B9298"/>
+                </a:solidFill>
+                <a:latin typeface="Arial"/>
+                <a:ea typeface="Arial"/>
+                <a:cs typeface="Arial"/>
+              </a:rPr>
+              <a:t>88 %</a:t>
             </a:r>
           </a:p>
         </p:txBody>
@@ -18648,7 +18656,7 @@
           <a:bodyPr/>
           <a:lstStyle/>
           <a:p>
-            <a:endParaRPr lang="de-CH"/>
+            <a:endParaRPr/>
           </a:p>
         </p:txBody>
       </p:sp>
@@ -18685,9 +18693,10 @@
           <a:lstStyle/>
           <a:p>
             <a:pPr algn="ctr">
-              <a:defRPr sz="1275" b="0">
-                <a:solidFill>
-                  <a:srgbClr val="2D3F4B"/>
+              <a:buNone/>
+              <a:defRPr sz="1050" b="1">
+                <a:solidFill>
+                  <a:srgbClr val="304554"/>
                 </a:solidFill>
                 <a:latin typeface="Arial"/>
                 <a:ea typeface="Arial"/>
@@ -18695,15 +18704,15 @@
               </a:defRPr>
             </a:pPr>
             <a:r>
-              <a:rPr sz="1275" b="0">
-                <a:solidFill>
-                  <a:srgbClr val="2D3F4B"/>
+              <a:rPr sz="1050" b="1">
+                <a:solidFill>
+                  <a:srgbClr val="304554"/>
                 </a:solidFill>
                 <a:latin typeface="Arial"/>
                 <a:ea typeface="Arial"/>
                 <a:cs typeface="Arial"/>
               </a:rPr>
-              <a:t>Alle erwarteten Artikel im Kontext</a:t>
+              <a:t>Graph liefert den höchsten Recall</a:t>
             </a:r>
           </a:p>
         </p:txBody>
@@ -18741,6 +18750,7 @@
           <a:lstStyle/>
           <a:p>
             <a:pPr algn="ctr">
+              <a:buNone/>
               <a:defRPr sz="1200" b="1">
                 <a:solidFill>
                   <a:srgbClr val="43858A"/>
@@ -18802,7 +18812,7 @@
           <a:bodyPr/>
           <a:lstStyle/>
           <a:p>
-            <a:endParaRPr lang="de-CH"/>
+            <a:endParaRPr/>
           </a:p>
         </p:txBody>
       </p:sp>
@@ -18839,9 +18849,10 @@
           <a:lstStyle/>
           <a:p>
             <a:pPr algn="ctr">
-              <a:defRPr sz="1125" b="1">
-                <a:solidFill>
-                  <a:srgbClr val="81725E"/>
+              <a:buNone/>
+              <a:defRPr sz="825" b="1">
+                <a:solidFill>
+                  <a:srgbClr val="304554"/>
                 </a:solidFill>
                 <a:latin typeface="Arial"/>
                 <a:ea typeface="Arial"/>
@@ -18849,15 +18860,39 @@
               </a:defRPr>
             </a:pPr>
             <a:r>
-              <a:rPr sz="1125" b="1">
-                <a:solidFill>
-                  <a:srgbClr val="81725E"/>
+              <a:rPr sz="825" b="1">
+                <a:solidFill>
+                  <a:srgbClr val="304554"/>
                 </a:solidFill>
                 <a:latin typeface="Arial"/>
                 <a:ea typeface="Arial"/>
                 <a:cs typeface="Arial"/>
               </a:rPr>
-              <a:t>VECTOR</a:t>
+              <a:t>FIXED</a:t>
+            </a:r>
+          </a:p>
+          <a:p>
+            <a:pPr algn="ctr">
+              <a:buNone/>
+              <a:defRPr sz="825" b="1">
+                <a:solidFill>
+                  <a:srgbClr val="304554"/>
+                </a:solidFill>
+                <a:latin typeface="Arial"/>
+                <a:ea typeface="Arial"/>
+                <a:cs typeface="Arial"/>
+              </a:defRPr>
+            </a:pPr>
+            <a:r>
+              <a:rPr sz="825" b="1">
+                <a:solidFill>
+                  <a:srgbClr val="304554"/>
+                </a:solidFill>
+                <a:latin typeface="Arial"/>
+                <a:ea typeface="Arial"/>
+                <a:cs typeface="Arial"/>
+              </a:rPr>
+              <a:t>SEMANTIC</a:t>
             </a:r>
           </a:p>
         </p:txBody>
@@ -18895,9 +18930,10 @@
           <a:lstStyle/>
           <a:p>
             <a:pPr algn="ctr">
-              <a:defRPr sz="2550" b="1">
-                <a:solidFill>
-                  <a:srgbClr val="2D3F4B"/>
+              <a:buNone/>
+              <a:defRPr sz="1725" b="1">
+                <a:solidFill>
+                  <a:srgbClr val="304554"/>
                 </a:solidFill>
                 <a:latin typeface="Arial"/>
                 <a:ea typeface="Arial"/>
@@ -18905,15 +18941,39 @@
               </a:defRPr>
             </a:pPr>
             <a:r>
-              <a:rPr sz="2550" b="1">
-                <a:solidFill>
-                  <a:srgbClr val="2D3F4B"/>
+              <a:rPr sz="1725" b="1">
+                <a:solidFill>
+                  <a:srgbClr val="304554"/>
                 </a:solidFill>
                 <a:latin typeface="Arial"/>
                 <a:ea typeface="Arial"/>
                 <a:cs typeface="Arial"/>
               </a:rPr>
-              <a:t>0.83</a:t>
+              <a:t>0.43</a:t>
+            </a:r>
+          </a:p>
+          <a:p>
+            <a:pPr algn="ctr">
+              <a:buNone/>
+              <a:defRPr sz="1725" b="1">
+                <a:solidFill>
+                  <a:srgbClr val="304554"/>
+                </a:solidFill>
+                <a:latin typeface="Arial"/>
+                <a:ea typeface="Arial"/>
+                <a:cs typeface="Arial"/>
+              </a:defRPr>
+            </a:pPr>
+            <a:r>
+              <a:rPr sz="1725" b="1">
+                <a:solidFill>
+                  <a:srgbClr val="304554"/>
+                </a:solidFill>
+                <a:latin typeface="Arial"/>
+                <a:ea typeface="Arial"/>
+                <a:cs typeface="Arial"/>
+              </a:rPr>
+              <a:t>0.25</a:t>
             </a:r>
           </a:p>
         </p:txBody>
@@ -18951,9 +19011,10 @@
           <a:lstStyle/>
           <a:p>
             <a:pPr algn="ctr">
-              <a:defRPr sz="1125" b="1">
-                <a:solidFill>
-                  <a:srgbClr val="43858A"/>
+              <a:buNone/>
+              <a:defRPr sz="825" b="1">
+                <a:solidFill>
+                  <a:srgbClr val="304554"/>
                 </a:solidFill>
                 <a:latin typeface="Arial"/>
                 <a:ea typeface="Arial"/>
@@ -18961,9 +19022,33 @@
               </a:defRPr>
             </a:pPr>
             <a:r>
-              <a:rPr sz="1125" b="1">
-                <a:solidFill>
-                  <a:srgbClr val="43858A"/>
+              <a:rPr sz="825" b="1">
+                <a:solidFill>
+                  <a:srgbClr val="304554"/>
+                </a:solidFill>
+                <a:latin typeface="Arial"/>
+                <a:ea typeface="Arial"/>
+                <a:cs typeface="Arial"/>
+              </a:rPr>
+              <a:t>RERANK</a:t>
+            </a:r>
+          </a:p>
+          <a:p>
+            <a:pPr algn="ctr">
+              <a:buNone/>
+              <a:defRPr sz="825" b="1">
+                <a:solidFill>
+                  <a:srgbClr val="304554"/>
+                </a:solidFill>
+                <a:latin typeface="Arial"/>
+                <a:ea typeface="Arial"/>
+                <a:cs typeface="Arial"/>
+              </a:defRPr>
+            </a:pPr>
+            <a:r>
+              <a:rPr sz="825" b="1">
+                <a:solidFill>
+                  <a:srgbClr val="304554"/>
                 </a:solidFill>
                 <a:latin typeface="Arial"/>
                 <a:ea typeface="Arial"/>
@@ -19007,9 +19092,10 @@
           <a:lstStyle/>
           <a:p>
             <a:pPr algn="ctr">
-              <a:defRPr sz="2550" b="1">
-                <a:solidFill>
-                  <a:srgbClr val="43858A"/>
+              <a:buNone/>
+              <a:defRPr sz="1725" b="1">
+                <a:solidFill>
+                  <a:srgbClr val="4B9298"/>
                 </a:solidFill>
                 <a:latin typeface="Arial"/>
                 <a:ea typeface="Arial"/>
@@ -19017,15 +19103,39 @@
               </a:defRPr>
             </a:pPr>
             <a:r>
-              <a:rPr sz="2550" b="1">
-                <a:solidFill>
-                  <a:srgbClr val="43858A"/>
+              <a:rPr sz="1725" b="1">
+                <a:solidFill>
+                  <a:srgbClr val="4B9298"/>
                 </a:solidFill>
                 <a:latin typeface="Arial"/>
                 <a:ea typeface="Arial"/>
                 <a:cs typeface="Arial"/>
               </a:rPr>
-              <a:t>0.82</a:t>
+              <a:t>0.68</a:t>
+            </a:r>
+          </a:p>
+          <a:p>
+            <a:pPr algn="ctr">
+              <a:buNone/>
+              <a:defRPr sz="1725" b="1">
+                <a:solidFill>
+                  <a:srgbClr val="4B9298"/>
+                </a:solidFill>
+                <a:latin typeface="Arial"/>
+                <a:ea typeface="Arial"/>
+                <a:cs typeface="Arial"/>
+              </a:defRPr>
+            </a:pPr>
+            <a:r>
+              <a:rPr sz="1725" b="1">
+                <a:solidFill>
+                  <a:srgbClr val="4B9298"/>
+                </a:solidFill>
+                <a:latin typeface="Arial"/>
+                <a:ea typeface="Arial"/>
+                <a:cs typeface="Arial"/>
+              </a:rPr>
+              <a:t>0.52</a:t>
             </a:r>
           </a:p>
         </p:txBody>
@@ -19063,7 +19173,7 @@
           <a:bodyPr/>
           <a:lstStyle/>
           <a:p>
-            <a:endParaRPr lang="de-CH"/>
+            <a:endParaRPr/>
           </a:p>
         </p:txBody>
       </p:sp>
@@ -19100,9 +19210,10 @@
           <a:lstStyle/>
           <a:p>
             <a:pPr algn="ctr">
-              <a:defRPr sz="1275" b="0">
-                <a:solidFill>
-                  <a:srgbClr val="2D3F4B"/>
+              <a:buNone/>
+              <a:defRPr sz="1050" b="1">
+                <a:solidFill>
+                  <a:srgbClr val="304554"/>
                 </a:solidFill>
                 <a:latin typeface="Arial"/>
                 <a:ea typeface="Arial"/>
@@ -19110,15 +19221,15 @@
               </a:defRPr>
             </a:pPr>
             <a:r>
-              <a:rPr sz="1275" b="0">
-                <a:solidFill>
-                  <a:srgbClr val="2D3F4B"/>
+              <a:rPr sz="1050" b="1">
+                <a:solidFill>
+                  <a:srgbClr val="304554"/>
                 </a:solidFill>
                 <a:latin typeface="Arial"/>
                 <a:ea typeface="Arial"/>
                 <a:cs typeface="Arial"/>
               </a:rPr>
-              <a:t>Nahezu gleiche Rangqualität</a:t>
+              <a:t>Reranker ordnet Treffer am besten</a:t>
             </a:r>
           </a:p>
         </p:txBody>
@@ -19156,6 +19267,7 @@
           <a:lstStyle/>
           <a:p>
             <a:pPr algn="ctr">
+              <a:buNone/>
               <a:defRPr sz="1200" b="1">
                 <a:solidFill>
                   <a:srgbClr val="C9960F"/>
@@ -19217,7 +19329,7 @@
           <a:bodyPr/>
           <a:lstStyle/>
           <a:p>
-            <a:endParaRPr lang="de-CH"/>
+            <a:endParaRPr/>
           </a:p>
         </p:txBody>
       </p:sp>
@@ -19254,9 +19366,10 @@
           <a:lstStyle/>
           <a:p>
             <a:pPr algn="ctr">
-              <a:defRPr sz="1125" b="1">
-                <a:solidFill>
-                  <a:srgbClr val="81725E"/>
+              <a:buNone/>
+              <a:defRPr sz="825" b="1">
+                <a:solidFill>
+                  <a:srgbClr val="304554"/>
                 </a:solidFill>
                 <a:latin typeface="Arial"/>
                 <a:ea typeface="Arial"/>
@@ -19264,15 +19377,39 @@
               </a:defRPr>
             </a:pPr>
             <a:r>
-              <a:rPr sz="1125" b="1">
-                <a:solidFill>
-                  <a:srgbClr val="81725E"/>
+              <a:rPr sz="825" b="1">
+                <a:solidFill>
+                  <a:srgbClr val="304554"/>
                 </a:solidFill>
                 <a:latin typeface="Arial"/>
                 <a:ea typeface="Arial"/>
                 <a:cs typeface="Arial"/>
               </a:rPr>
-              <a:t>VECTOR</a:t>
+              <a:t>FIXED</a:t>
+            </a:r>
+          </a:p>
+          <a:p>
+            <a:pPr algn="ctr">
+              <a:buNone/>
+              <a:defRPr sz="825" b="1">
+                <a:solidFill>
+                  <a:srgbClr val="304554"/>
+                </a:solidFill>
+                <a:latin typeface="Arial"/>
+                <a:ea typeface="Arial"/>
+                <a:cs typeface="Arial"/>
+              </a:defRPr>
+            </a:pPr>
+            <a:r>
+              <a:rPr sz="825" b="1">
+                <a:solidFill>
+                  <a:srgbClr val="304554"/>
+                </a:solidFill>
+                <a:latin typeface="Arial"/>
+                <a:ea typeface="Arial"/>
+                <a:cs typeface="Arial"/>
+              </a:rPr>
+              <a:t>SEMANTIC</a:t>
             </a:r>
           </a:p>
         </p:txBody>
@@ -19310,9 +19447,10 @@
           <a:lstStyle/>
           <a:p>
             <a:pPr algn="ctr">
-              <a:defRPr sz="2550" b="1">
-                <a:solidFill>
-                  <a:srgbClr val="2D3F4B"/>
+              <a:buNone/>
+              <a:defRPr sz="1725" b="1">
+                <a:solidFill>
+                  <a:srgbClr val="304554"/>
                 </a:solidFill>
                 <a:latin typeface="Arial"/>
                 <a:ea typeface="Arial"/>
@@ -19320,15 +19458,39 @@
               </a:defRPr>
             </a:pPr>
             <a:r>
-              <a:rPr sz="2550" b="1">
-                <a:solidFill>
-                  <a:srgbClr val="2D3F4B"/>
+              <a:rPr sz="1725" b="1" dirty="0">
+                <a:solidFill>
+                  <a:srgbClr val="304554"/>
                 </a:solidFill>
                 <a:latin typeface="Arial"/>
                 <a:ea typeface="Arial"/>
                 <a:cs typeface="Arial"/>
               </a:rPr>
-              <a:t>857</a:t>
+              <a:t>1 289</a:t>
+            </a:r>
+          </a:p>
+          <a:p>
+            <a:pPr algn="ctr">
+              <a:buNone/>
+              <a:defRPr sz="1725" b="1">
+                <a:solidFill>
+                  <a:srgbClr val="304554"/>
+                </a:solidFill>
+                <a:latin typeface="Arial"/>
+                <a:ea typeface="Arial"/>
+                <a:cs typeface="Arial"/>
+              </a:defRPr>
+            </a:pPr>
+            <a:r>
+              <a:rPr sz="1725" b="1" dirty="0">
+                <a:solidFill>
+                  <a:srgbClr val="304554"/>
+                </a:solidFill>
+                <a:latin typeface="Arial"/>
+                <a:ea typeface="Arial"/>
+                <a:cs typeface="Arial"/>
+              </a:rPr>
+              <a:t>892</a:t>
             </a:r>
           </a:p>
         </p:txBody>
@@ -19366,9 +19528,10 @@
           <a:lstStyle/>
           <a:p>
             <a:pPr algn="ctr">
-              <a:defRPr sz="1125" b="1">
-                <a:solidFill>
-                  <a:srgbClr val="C9960F"/>
+              <a:buNone/>
+              <a:defRPr sz="825" b="1">
+                <a:solidFill>
+                  <a:srgbClr val="304554"/>
                 </a:solidFill>
                 <a:latin typeface="Arial"/>
                 <a:ea typeface="Arial"/>
@@ -19376,9 +19539,33 @@
               </a:defRPr>
             </a:pPr>
             <a:r>
-              <a:rPr sz="1125" b="1">
-                <a:solidFill>
-                  <a:srgbClr val="C9960F"/>
+              <a:rPr sz="825" b="1">
+                <a:solidFill>
+                  <a:srgbClr val="304554"/>
+                </a:solidFill>
+                <a:latin typeface="Arial"/>
+                <a:ea typeface="Arial"/>
+                <a:cs typeface="Arial"/>
+              </a:rPr>
+              <a:t>RERANK</a:t>
+            </a:r>
+          </a:p>
+          <a:p>
+            <a:pPr algn="ctr">
+              <a:buNone/>
+              <a:defRPr sz="825" b="1">
+                <a:solidFill>
+                  <a:srgbClr val="304554"/>
+                </a:solidFill>
+                <a:latin typeface="Arial"/>
+                <a:ea typeface="Arial"/>
+                <a:cs typeface="Arial"/>
+              </a:defRPr>
+            </a:pPr>
+            <a:r>
+              <a:rPr sz="825" b="1">
+                <a:solidFill>
+                  <a:srgbClr val="304554"/>
                 </a:solidFill>
                 <a:latin typeface="Arial"/>
                 <a:ea typeface="Arial"/>
@@ -19422,9 +19609,10 @@
           <a:lstStyle/>
           <a:p>
             <a:pPr algn="ctr">
-              <a:defRPr sz="2550" b="1">
-                <a:solidFill>
-                  <a:srgbClr val="C9960F"/>
+              <a:buNone/>
+              <a:defRPr sz="1725" b="1">
+                <a:solidFill>
+                  <a:srgbClr val="4B9298"/>
                 </a:solidFill>
                 <a:latin typeface="Arial"/>
                 <a:ea typeface="Arial"/>
@@ -19432,15 +19620,39 @@
               </a:defRPr>
             </a:pPr>
             <a:r>
-              <a:rPr sz="2550" b="1">
-                <a:solidFill>
-                  <a:srgbClr val="C9960F"/>
+              <a:rPr sz="1725" b="1">
+                <a:solidFill>
+                  <a:srgbClr val="4B9298"/>
                 </a:solidFill>
                 <a:latin typeface="Arial"/>
                 <a:ea typeface="Arial"/>
                 <a:cs typeface="Arial"/>
               </a:rPr>
-              <a:t>746</a:t>
+              <a:t>923</a:t>
+            </a:r>
+          </a:p>
+          <a:p>
+            <a:pPr algn="ctr">
+              <a:buNone/>
+              <a:defRPr sz="1725" b="1">
+                <a:solidFill>
+                  <a:srgbClr val="4B9298"/>
+                </a:solidFill>
+                <a:latin typeface="Arial"/>
+                <a:ea typeface="Arial"/>
+                <a:cs typeface="Arial"/>
+              </a:defRPr>
+            </a:pPr>
+            <a:r>
+              <a:rPr sz="1725" b="1">
+                <a:solidFill>
+                  <a:srgbClr val="4B9298"/>
+                </a:solidFill>
+                <a:latin typeface="Arial"/>
+                <a:ea typeface="Arial"/>
+                <a:cs typeface="Arial"/>
+              </a:rPr>
+              <a:t>802</a:t>
             </a:r>
           </a:p>
         </p:txBody>
@@ -19478,7 +19690,7 @@
           <a:bodyPr/>
           <a:lstStyle/>
           <a:p>
-            <a:endParaRPr lang="de-CH"/>
+            <a:endParaRPr/>
           </a:p>
         </p:txBody>
       </p:sp>
@@ -19515,9 +19727,10 @@
           <a:lstStyle/>
           <a:p>
             <a:pPr algn="ctr">
-              <a:defRPr sz="1275" b="0">
-                <a:solidFill>
-                  <a:srgbClr val="2D3F4B"/>
+              <a:buNone/>
+              <a:defRPr sz="1050" b="1">
+                <a:solidFill>
+                  <a:srgbClr val="304554"/>
                 </a:solidFill>
                 <a:latin typeface="Arial"/>
                 <a:ea typeface="Arial"/>
@@ -19525,15 +19738,15 @@
               </a:defRPr>
             </a:pPr>
             <a:r>
-              <a:rPr sz="1275" b="0">
-                <a:solidFill>
-                  <a:srgbClr val="2D3F4B"/>
+              <a:rPr sz="1050" b="1">
+                <a:solidFill>
+                  <a:srgbClr val="304554"/>
                 </a:solidFill>
                 <a:latin typeface="Arial"/>
                 <a:ea typeface="Arial"/>
                 <a:cs typeface="Arial"/>
               </a:rPr>
-              <a:t>Graph: 13 % weniger Kontext</a:t>
+              <a:t>Graph: 10 % weniger als Semantic</a:t>
             </a:r>
           </a:p>
         </p:txBody>
@@ -19576,7 +19789,7 @@
           <a:bodyPr/>
           <a:lstStyle/>
           <a:p>
-            <a:endParaRPr lang="de-CH"/>
+            <a:endParaRPr/>
           </a:p>
         </p:txBody>
       </p:sp>
@@ -19609,11 +19822,12 @@
           </a:ln>
         </p:spPr>
         <p:txBody>
-          <a:bodyPr anchor="t"/>
+          <a:bodyPr anchor="ctr"/>
           <a:lstStyle/>
           <a:p>
             <a:pPr algn="ctr">
-              <a:defRPr sz="1500" b="1">
+              <a:buNone/>
+              <a:defRPr sz="1200" b="1">
                 <a:solidFill>
                   <a:srgbClr val="FFFFFF"/>
                 </a:solidFill>
@@ -19623,7 +19837,7 @@
               </a:defRPr>
             </a:pPr>
             <a:r>
-              <a:rPr sz="1500" b="1">
+              <a:rPr sz="1200" b="1">
                 <a:solidFill>
                   <a:srgbClr val="FFFFFF"/>
                 </a:solidFill>
@@ -19631,21 +19845,173 @@
                 <a:ea typeface="Arial"/>
                 <a:cs typeface="Arial"/>
               </a:rPr>
-              <a:t>100 % Recall bedeutet: im Kontext vorhanden – nicht automatisch korrekt beantwortet.</a:t>
-            </a:r>
+              <a:t>Retrieval ≠ Antwortqualität: Der richtige Artikel muss im Kontext sein – und korrekt genutzt werden.</a:t>
+            </a:r>
+          </a:p>
+        </p:txBody>
+      </p:sp>
+      <p:sp>
+        <p:nvSpPr>
+          <p:cNvPr id="36" name="Titel 1">
+            <a:extLst>
+              <a:ext uri="{FF2B5EF4-FFF2-40B4-BE49-F238E27FC236}">
+                <a16:creationId xmlns:a16="http://schemas.microsoft.com/office/drawing/2014/main" id="{C2C3951A-6174-5B25-11EA-FD430B5FD51F}"/>
+              </a:ext>
+            </a:extLst>
+          </p:cNvPr>
+          <p:cNvSpPr>
+            <a:spLocks noGrp="1"/>
+          </p:cNvSpPr>
+          <p:nvPr>
+            <p:ph type="title"/>
+          </p:nvPr>
+        </p:nvSpPr>
+        <p:spPr>
+          <a:xfrm>
+            <a:off x="482461" y="346633"/>
+            <a:ext cx="11230114" cy="767605"/>
+          </a:xfrm>
+        </p:spPr>
+        <p:txBody>
+          <a:bodyPr/>
+          <a:lstStyle/>
+          <a:p>
+            <a:r>
+              <a:rPr lang="de-DE" sz="3600" dirty="0" err="1"/>
+              <a:t>GraphRAG</a:t>
+            </a:r>
+            <a:r>
+              <a:rPr lang="de-DE" sz="3600" dirty="0"/>
+              <a:t>: höchster </a:t>
+            </a:r>
+            <a:r>
+              <a:rPr lang="de-DE" sz="3600" dirty="0" err="1"/>
+              <a:t>Article</a:t>
+            </a:r>
+            <a:r>
+              <a:rPr lang="de-DE" sz="3600" dirty="0"/>
+              <a:t>-Recall, kleinster Kontext</a:t>
+            </a:r>
+            <a:endParaRPr lang="de-CH" sz="3600" dirty="0"/>
           </a:p>
         </p:txBody>
       </p:sp>
     </p:spTree>
     <p:extLst>
       <p:ext uri="{BB962C8B-B14F-4D97-AF65-F5344CB8AC3E}">
-        <p14:creationId xmlns:p14="http://schemas.microsoft.com/office/powerpoint/2010/main" val="1299644877"/>
+        <p14:creationId xmlns:p14="http://schemas.microsoft.com/office/powerpoint/2010/main" val="1099844911"/>
       </p:ext>
     </p:extLst>
   </p:cSld>
   <p:clrMapOvr>
     <a:masterClrMapping/>
   </p:clrMapOvr>
+  <p:timing>
+    <p:tnLst>
+      <p:par>
+        <p:cTn id="1" dur="indefinite" restart="never" nodeType="tmRoot">
+          <p:childTnLst>
+            <p:seq concurrent="1" nextAc="seek">
+              <p:cTn id="2" dur="indefinite" nodeType="mainSeq">
+                <p:childTnLst>
+                  <p:par>
+                    <p:cTn id="3" fill="hold">
+                      <p:stCondLst>
+                        <p:cond delay="indefinite"/>
+                      </p:stCondLst>
+                      <p:childTnLst>
+                        <p:par>
+                          <p:cTn id="4" fill="hold">
+                            <p:stCondLst>
+                              <p:cond delay="0"/>
+                            </p:stCondLst>
+                            <p:childTnLst>
+                              <p:par>
+                                <p:cTn id="5" presetID="1" presetClass="entr" presetSubtype="0" fill="hold" grpId="0" nodeType="clickEffect">
+                                  <p:stCondLst>
+                                    <p:cond delay="0"/>
+                                  </p:stCondLst>
+                                  <p:childTnLst>
+                                    <p:set>
+                                      <p:cBhvr>
+                                        <p:cTn id="6" dur="1" fill="hold">
+                                          <p:stCondLst>
+                                            <p:cond delay="0"/>
+                                          </p:stCondLst>
+                                        </p:cTn>
+                                        <p:tgtEl>
+                                          <p:spTgt spid="31"/>
+                                        </p:tgtEl>
+                                        <p:attrNameLst>
+                                          <p:attrName>style.visibility</p:attrName>
+                                        </p:attrNameLst>
+                                      </p:cBhvr>
+                                      <p:to>
+                                        <p:strVal val="visible"/>
+                                      </p:to>
+                                    </p:set>
+                                  </p:childTnLst>
+                                </p:cTn>
+                              </p:par>
+                              <p:par>
+                                <p:cTn id="7" presetID="1" presetClass="entr" presetSubtype="0" fill="hold" grpId="0" nodeType="withEffect">
+                                  <p:stCondLst>
+                                    <p:cond delay="0"/>
+                                  </p:stCondLst>
+                                  <p:childTnLst>
+                                    <p:set>
+                                      <p:cBhvr>
+                                        <p:cTn id="8" dur="1" fill="hold">
+                                          <p:stCondLst>
+                                            <p:cond delay="0"/>
+                                          </p:stCondLst>
+                                        </p:cTn>
+                                        <p:tgtEl>
+                                          <p:spTgt spid="32"/>
+                                        </p:tgtEl>
+                                        <p:attrNameLst>
+                                          <p:attrName>style.visibility</p:attrName>
+                                        </p:attrNameLst>
+                                      </p:cBhvr>
+                                      <p:to>
+                                        <p:strVal val="visible"/>
+                                      </p:to>
+                                    </p:set>
+                                  </p:childTnLst>
+                                </p:cTn>
+                              </p:par>
+                            </p:childTnLst>
+                          </p:cTn>
+                        </p:par>
+                      </p:childTnLst>
+                    </p:cTn>
+                  </p:par>
+                </p:childTnLst>
+              </p:cTn>
+              <p:prevCondLst>
+                <p:cond evt="onPrev" delay="0">
+                  <p:tgtEl>
+                    <p:sldTgt/>
+                  </p:tgtEl>
+                </p:cond>
+              </p:prevCondLst>
+              <p:nextCondLst>
+                <p:cond evt="onNext" delay="0">
+                  <p:tgtEl>
+                    <p:sldTgt/>
+                  </p:tgtEl>
+                </p:cond>
+              </p:nextCondLst>
+            </p:seq>
+          </p:childTnLst>
+        </p:cTn>
+      </p:par>
+    </p:tnLst>
+    <p:bldLst>
+      <p:bldP spid="31" grpId="0" animBg="1"/>
+      <p:bldP spid="32" grpId="0"/>
+    </p:bldLst>
+  </p:timing>
 </p:sld>
 </file>
 
@@ -19668,46 +20034,6 @@
       </p:grpSpPr>
       <p:sp>
         <p:nvSpPr>
-          <p:cNvPr id="35" name="clean-canvas">
-            <a:extLst>
-              <a:ext uri="{FF2B5EF4-FFF2-40B4-BE49-F238E27FC236}">
-                <a16:creationId xmlns:a16="http://schemas.microsoft.com/office/drawing/2014/main" id="{5E51C087-B602-40CA-9202-01BA72A8860A}"/>
-              </a:ext>
-            </a:extLst>
-          </p:cNvPr>
-          <p:cNvSpPr>
-            <a:spLocks noGrp="1"/>
-          </p:cNvSpPr>
-          <p:nvPr/>
-        </p:nvSpPr>
-        <p:spPr>
-          <a:xfrm>
-            <a:off x="0" y="0"/>
-            <a:ext cx="12192000" cy="6096000"/>
-          </a:xfrm>
-          <a:prstGeom prst="rect">
-            <a:avLst/>
-          </a:prstGeom>
-          <a:solidFill>
-            <a:srgbClr val="FFFFFF"/>
-          </a:solidFill>
-          <a:ln w="0">
-            <a:solidFill>
-              <a:srgbClr val="FFFFFF"/>
-            </a:solidFill>
-            <a:prstDash val="solid"/>
-          </a:ln>
-        </p:spPr>
-        <p:txBody>
-          <a:bodyPr/>
-          <a:lstStyle/>
-          <a:p>
-            <a:endParaRPr lang="de-CH"/>
-          </a:p>
-        </p:txBody>
-      </p:sp>
-      <p:sp>
-        <p:nvSpPr>
           <p:cNvPr id="2" name="slide-title">
             <a:extLst>
               <a:ext uri="{FF2B5EF4-FFF2-40B4-BE49-F238E27FC236}">
@@ -19739,6 +20065,7 @@
           <a:lstStyle/>
           <a:p>
             <a:pPr algn="l">
+              <a:buNone/>
               <a:defRPr sz="2850" b="0">
                 <a:solidFill>
                   <a:srgbClr val="2D3F4B"/>
@@ -19749,7 +20076,7 @@
               </a:defRPr>
             </a:pPr>
             <a:r>
-              <a:rPr sz="2850" b="0">
+              <a:rPr sz="2850" b="0" dirty="0" err="1">
                 <a:solidFill>
                   <a:srgbClr val="2D3F4B"/>
                 </a:solidFill>
@@ -19757,8 +20084,148 @@
                 <a:ea typeface="Arial"/>
                 <a:cs typeface="Arial"/>
               </a:rPr>
-              <a:t>Antwortqualität: Mehr Fakten sind nicht automatisch besser belegt</a:t>
-            </a:r>
+              <a:t>Besseres</a:t>
+            </a:r>
+            <a:r>
+              <a:rPr sz="2850" b="0" dirty="0">
+                <a:solidFill>
+                  <a:srgbClr val="2D3F4B"/>
+                </a:solidFill>
+                <a:latin typeface="Arial"/>
+                <a:ea typeface="Arial"/>
+                <a:cs typeface="Arial"/>
+              </a:rPr>
+              <a:t> Retrieval </a:t>
+            </a:r>
+            <a:r>
+              <a:rPr sz="2850" b="0" dirty="0" err="1">
+                <a:solidFill>
+                  <a:srgbClr val="2D3F4B"/>
+                </a:solidFill>
+                <a:latin typeface="Arial"/>
+                <a:ea typeface="Arial"/>
+                <a:cs typeface="Arial"/>
+              </a:rPr>
+              <a:t>verbessert</a:t>
+            </a:r>
+            <a:r>
+              <a:rPr sz="2850" b="0" dirty="0">
+                <a:solidFill>
+                  <a:srgbClr val="2D3F4B"/>
+                </a:solidFill>
+                <a:latin typeface="Arial"/>
+                <a:ea typeface="Arial"/>
+                <a:cs typeface="Arial"/>
+              </a:rPr>
+              <a:t> </a:t>
+            </a:r>
+            <a:r>
+              <a:rPr sz="2850" b="0" dirty="0" err="1">
+                <a:solidFill>
+                  <a:srgbClr val="2D3F4B"/>
+                </a:solidFill>
+                <a:latin typeface="Arial"/>
+                <a:ea typeface="Arial"/>
+                <a:cs typeface="Arial"/>
+              </a:rPr>
+              <a:t>Antworten</a:t>
+            </a:r>
+            <a:r>
+              <a:rPr sz="2850" b="0" dirty="0">
+                <a:solidFill>
+                  <a:srgbClr val="2D3F4B"/>
+                </a:solidFill>
+                <a:latin typeface="Arial"/>
+                <a:ea typeface="Arial"/>
+                <a:cs typeface="Arial"/>
+              </a:rPr>
+              <a:t> – </a:t>
+            </a:r>
+            <a:r>
+              <a:rPr sz="2850" b="0" dirty="0" err="1">
+                <a:solidFill>
+                  <a:srgbClr val="2D3F4B"/>
+                </a:solidFill>
+                <a:latin typeface="Arial"/>
+                <a:ea typeface="Arial"/>
+                <a:cs typeface="Arial"/>
+              </a:rPr>
+              <a:t>garantiert</a:t>
+            </a:r>
+            <a:r>
+              <a:rPr sz="2850" b="0" dirty="0">
+                <a:solidFill>
+                  <a:srgbClr val="2D3F4B"/>
+                </a:solidFill>
+                <a:latin typeface="Arial"/>
+                <a:ea typeface="Arial"/>
+                <a:cs typeface="Arial"/>
+              </a:rPr>
+              <a:t> </a:t>
+            </a:r>
+            <a:r>
+              <a:rPr sz="2850" b="0" dirty="0" err="1">
+                <a:solidFill>
+                  <a:srgbClr val="2D3F4B"/>
+                </a:solidFill>
+                <a:latin typeface="Arial"/>
+                <a:ea typeface="Arial"/>
+                <a:cs typeface="Arial"/>
+              </a:rPr>
+              <a:t>sie</a:t>
+            </a:r>
+            <a:r>
+              <a:rPr sz="2850" b="0" dirty="0">
+                <a:solidFill>
+                  <a:srgbClr val="2D3F4B"/>
+                </a:solidFill>
+                <a:latin typeface="Arial"/>
+                <a:ea typeface="Arial"/>
+                <a:cs typeface="Arial"/>
+              </a:rPr>
+              <a:t> </a:t>
+            </a:r>
+            <a:r>
+              <a:rPr sz="2850" b="0" dirty="0" err="1">
+                <a:solidFill>
+                  <a:srgbClr val="2D3F4B"/>
+                </a:solidFill>
+                <a:latin typeface="Arial"/>
+                <a:ea typeface="Arial"/>
+                <a:cs typeface="Arial"/>
+              </a:rPr>
+              <a:t>aber</a:t>
+            </a:r>
+            <a:r>
+              <a:rPr sz="2850" b="0" dirty="0">
+                <a:solidFill>
+                  <a:srgbClr val="2D3F4B"/>
+                </a:solidFill>
+                <a:latin typeface="Arial"/>
+                <a:ea typeface="Arial"/>
+                <a:cs typeface="Arial"/>
+              </a:rPr>
+              <a:t> </a:t>
+            </a:r>
+            <a:r>
+              <a:rPr sz="2850" b="0" dirty="0" err="1">
+                <a:solidFill>
+                  <a:srgbClr val="2D3F4B"/>
+                </a:solidFill>
+                <a:latin typeface="Arial"/>
+                <a:ea typeface="Arial"/>
+                <a:cs typeface="Arial"/>
+              </a:rPr>
+              <a:t>nicht</a:t>
+            </a:r>
+            <a:endParaRPr sz="2850" b="0" dirty="0">
+              <a:solidFill>
+                <a:srgbClr val="2D3F4B"/>
+              </a:solidFill>
+              <a:latin typeface="Arial"/>
+              <a:ea typeface="Arial"/>
+              <a:cs typeface="Arial"/>
+            </a:endParaRPr>
           </a:p>
         </p:txBody>
       </p:sp>
@@ -19795,7 +20262,7 @@
           <a:bodyPr/>
           <a:lstStyle/>
           <a:p>
-            <a:endParaRPr lang="de-CH"/>
+            <a:endParaRPr/>
           </a:p>
         </p:txBody>
       </p:sp>
@@ -19832,6 +20299,7 @@
           <a:lstStyle/>
           <a:p>
             <a:pPr algn="l">
+              <a:buNone/>
               <a:defRPr sz="1650" b="0">
                 <a:solidFill>
                   <a:srgbClr val="81725E"/>
@@ -19842,7 +20310,18 @@
               </a:defRPr>
             </a:pPr>
             <a:r>
-              <a:rPr sz="1650" b="0">
+              <a:rPr lang="de-DE" sz="1650" b="1" dirty="0">
+                <a:solidFill>
+                  <a:srgbClr val="2D3F4B"/>
+                </a:solidFill>
+                <a:latin typeface="Arial"/>
+                <a:ea typeface="Arial"/>
+                <a:cs typeface="Arial"/>
+              </a:rPr>
+              <a:t>Faktenabdeckung</a:t>
+            </a:r>
+            <a:r>
+              <a:rPr sz="1650" b="0" dirty="0">
                 <a:solidFill>
                   <a:srgbClr val="81725E"/>
                 </a:solidFill>
@@ -19850,7 +20329,139 @@
                 <a:ea typeface="Arial"/>
                 <a:cs typeface="Arial"/>
               </a:rPr>
-              <a:t>Der aktuelle Lauf zeigt einen echten Trade-off zwischen Abdeckung und Zitierqualität.</a:t>
+              <a:t> </a:t>
+            </a:r>
+            <a:r>
+              <a:rPr sz="1650" b="0" dirty="0">
+                <a:solidFill>
+                  <a:schemeClr val="accent3"/>
+                </a:solidFill>
+                <a:latin typeface="Arial"/>
+                <a:ea typeface="Arial"/>
+                <a:cs typeface="Arial"/>
+              </a:rPr>
+              <a:t>und</a:t>
+            </a:r>
+            <a:r>
+              <a:rPr sz="1650" b="0" dirty="0">
+                <a:solidFill>
+                  <a:srgbClr val="81725E"/>
+                </a:solidFill>
+                <a:latin typeface="Arial"/>
+                <a:ea typeface="Arial"/>
+                <a:cs typeface="Arial"/>
+              </a:rPr>
+              <a:t> </a:t>
+            </a:r>
+            <a:r>
+              <a:rPr sz="1650" b="1" dirty="0" err="1">
+                <a:solidFill>
+                  <a:schemeClr val="accent5"/>
+                </a:solidFill>
+                <a:latin typeface="Arial"/>
+                <a:ea typeface="Arial"/>
+                <a:cs typeface="Arial"/>
+              </a:rPr>
+              <a:t>Zitationsvollständigkeit</a:t>
+            </a:r>
+            <a:r>
+              <a:rPr sz="1650" b="0" dirty="0">
+                <a:solidFill>
+                  <a:srgbClr val="81725E"/>
+                </a:solidFill>
+                <a:latin typeface="Arial"/>
+                <a:ea typeface="Arial"/>
+                <a:cs typeface="Arial"/>
+              </a:rPr>
+              <a:t> </a:t>
+            </a:r>
+            <a:r>
+              <a:rPr sz="1650" b="0" dirty="0" err="1">
+                <a:solidFill>
+                  <a:srgbClr val="81725E"/>
+                </a:solidFill>
+                <a:latin typeface="Arial"/>
+                <a:ea typeface="Arial"/>
+                <a:cs typeface="Arial"/>
+              </a:rPr>
+              <a:t>bleiben</a:t>
+            </a:r>
+            <a:r>
+              <a:rPr sz="1650" b="0" dirty="0">
+                <a:solidFill>
+                  <a:srgbClr val="81725E"/>
+                </a:solidFill>
+                <a:latin typeface="Arial"/>
+                <a:ea typeface="Arial"/>
+                <a:cs typeface="Arial"/>
+              </a:rPr>
+              <a:t> </a:t>
+            </a:r>
+            <a:r>
+              <a:rPr sz="1650" b="0" dirty="0" err="1">
+                <a:solidFill>
+                  <a:srgbClr val="81725E"/>
+                </a:solidFill>
+                <a:latin typeface="Arial"/>
+                <a:ea typeface="Arial"/>
+                <a:cs typeface="Arial"/>
+              </a:rPr>
+              <a:t>vom</a:t>
+            </a:r>
+            <a:r>
+              <a:rPr sz="1650" b="0" dirty="0">
+                <a:solidFill>
+                  <a:srgbClr val="81725E"/>
+                </a:solidFill>
+                <a:latin typeface="Arial"/>
+                <a:ea typeface="Arial"/>
+                <a:cs typeface="Arial"/>
+              </a:rPr>
+              <a:t> </a:t>
+            </a:r>
+            <a:r>
+              <a:rPr sz="1650" b="0" dirty="0" err="1">
+                <a:solidFill>
+                  <a:srgbClr val="81725E"/>
+                </a:solidFill>
+                <a:latin typeface="Arial"/>
+                <a:ea typeface="Arial"/>
+                <a:cs typeface="Arial"/>
+              </a:rPr>
+              <a:t>generierenden</a:t>
+            </a:r>
+            <a:r>
+              <a:rPr sz="1650" b="0" dirty="0">
+                <a:solidFill>
+                  <a:srgbClr val="81725E"/>
+                </a:solidFill>
+                <a:latin typeface="Arial"/>
+                <a:ea typeface="Arial"/>
+                <a:cs typeface="Arial"/>
+              </a:rPr>
+              <a:t> Modell </a:t>
+            </a:r>
+            <a:r>
+              <a:rPr sz="1650" b="0" dirty="0" err="1">
+                <a:solidFill>
+                  <a:srgbClr val="81725E"/>
+                </a:solidFill>
+                <a:latin typeface="Arial"/>
+                <a:ea typeface="Arial"/>
+                <a:cs typeface="Arial"/>
+              </a:rPr>
+              <a:t>abhängig</a:t>
+            </a:r>
+            <a:r>
+              <a:rPr sz="1650" b="0" dirty="0">
+                <a:solidFill>
+                  <a:srgbClr val="81725E"/>
+                </a:solidFill>
+                <a:latin typeface="Arial"/>
+                <a:ea typeface="Arial"/>
+                <a:cs typeface="Arial"/>
+              </a:rPr>
+              <a:t>.</a:t>
             </a:r>
           </a:p>
         </p:txBody>
@@ -19888,6 +20499,7 @@
           <a:lstStyle/>
           <a:p>
             <a:pPr algn="l">
+              <a:buNone/>
               <a:defRPr sz="825" b="0">
                 <a:solidFill>
                   <a:srgbClr val="2D3F4B"/>
@@ -19944,6 +20556,7 @@
           <a:lstStyle/>
           <a:p>
             <a:pPr algn="l">
+              <a:buNone/>
               <a:defRPr sz="825" b="0">
                 <a:solidFill>
                   <a:srgbClr val="2D3F4B"/>
@@ -20000,9 +20613,10 @@
           <a:lstStyle/>
           <a:p>
             <a:pPr algn="ctr">
-              <a:defRPr sz="1200" b="1">
-                <a:solidFill>
-                  <a:srgbClr val="2D3F4B"/>
+              <a:buNone/>
+              <a:defRPr sz="900" b="1">
+                <a:solidFill>
+                  <a:srgbClr val="304554"/>
                 </a:solidFill>
                 <a:latin typeface="Arial"/>
                 <a:ea typeface="Arial"/>
@@ -20010,15 +20624,15 @@
               </a:defRPr>
             </a:pPr>
             <a:r>
-              <a:rPr sz="1200" b="1">
-                <a:solidFill>
-                  <a:srgbClr val="2D3F4B"/>
+              <a:rPr sz="900" b="1">
+                <a:solidFill>
+                  <a:srgbClr val="304554"/>
                 </a:solidFill>
                 <a:latin typeface="Arial"/>
                 <a:ea typeface="Arial"/>
                 <a:cs typeface="Arial"/>
               </a:rPr>
-              <a:t>VECTOR</a:t>
+              <a:t>FAKTEN</a:t>
             </a:r>
           </a:p>
         </p:txBody>
@@ -20056,9 +20670,10 @@
           <a:lstStyle/>
           <a:p>
             <a:pPr algn="ctr">
-              <a:defRPr sz="1200" b="1">
-                <a:solidFill>
-                  <a:srgbClr val="43858A"/>
+              <a:buNone/>
+              <a:defRPr sz="900" b="1">
+                <a:solidFill>
+                  <a:srgbClr val="4B9298"/>
                 </a:solidFill>
                 <a:latin typeface="Arial"/>
                 <a:ea typeface="Arial"/>
@@ -20066,15 +20681,15 @@
               </a:defRPr>
             </a:pPr>
             <a:r>
-              <a:rPr sz="1200" b="1">
-                <a:solidFill>
-                  <a:srgbClr val="43858A"/>
+              <a:rPr sz="900" b="1">
+                <a:solidFill>
+                  <a:srgbClr val="4B9298"/>
                 </a:solidFill>
                 <a:latin typeface="Arial"/>
                 <a:ea typeface="Arial"/>
                 <a:cs typeface="Arial"/>
               </a:rPr>
-              <a:t>GRAPH</a:t>
+              <a:t>ZITATE</a:t>
             </a:r>
           </a:p>
         </p:txBody>
@@ -20112,9 +20727,10 @@
           <a:lstStyle/>
           <a:p>
             <a:pPr algn="l">
-              <a:defRPr sz="1425" b="1">
-                <a:solidFill>
-                  <a:srgbClr val="2D3F4B"/>
+              <a:buNone/>
+              <a:defRPr sz="1200" b="1">
+                <a:solidFill>
+                  <a:srgbClr val="304554"/>
                 </a:solidFill>
                 <a:latin typeface="Arial"/>
                 <a:ea typeface="Arial"/>
@@ -20122,15 +20738,15 @@
               </a:defRPr>
             </a:pPr>
             <a:r>
-              <a:rPr sz="1425" b="1">
-                <a:solidFill>
-                  <a:srgbClr val="2D3F4B"/>
+              <a:rPr sz="1200" b="1">
+                <a:solidFill>
+                  <a:srgbClr val="304554"/>
                 </a:solidFill>
                 <a:latin typeface="Arial"/>
                 <a:ea typeface="Arial"/>
                 <a:cs typeface="Arial"/>
               </a:rPr>
-              <a:t>Fact coverage</a:t>
+              <a:t>FIXED VECTOR</a:t>
             </a:r>
           </a:p>
         </p:txBody>
@@ -20173,7 +20789,7 @@
           <a:bodyPr/>
           <a:lstStyle/>
           <a:p>
-            <a:endParaRPr lang="de-CH"/>
+            <a:endParaRPr/>
           </a:p>
         </p:txBody>
       </p:sp>
@@ -20215,7 +20831,7 @@
           <a:bodyPr/>
           <a:lstStyle/>
           <a:p>
-            <a:endParaRPr lang="de-CH"/>
+            <a:endParaRPr/>
           </a:p>
         </p:txBody>
       </p:sp>
@@ -20257,7 +20873,7 @@
           <a:bodyPr/>
           <a:lstStyle/>
           <a:p>
-            <a:endParaRPr lang="de-CH"/>
+            <a:endParaRPr/>
           </a:p>
         </p:txBody>
       </p:sp>
@@ -20277,8 +20893,8 @@
         </p:nvSpPr>
         <p:spPr>
           <a:xfrm>
-            <a:off x="5905500" y="2314575"/>
-            <a:ext cx="1238250" cy="190500"/>
+            <a:off x="5905500" y="2352675"/>
+            <a:ext cx="1238250" cy="304800"/>
           </a:xfrm>
           <a:prstGeom prst="rect">
             <a:avLst/>
@@ -20294,9 +20910,10 @@
           <a:lstStyle/>
           <a:p>
             <a:pPr algn="ctr">
-              <a:defRPr sz="1125" b="1">
-                <a:solidFill>
-                  <a:srgbClr val="2D3F4B"/>
+              <a:buNone/>
+              <a:defRPr sz="1050" b="1">
+                <a:solidFill>
+                  <a:srgbClr val="304554"/>
                 </a:solidFill>
                 <a:latin typeface="Arial"/>
                 <a:ea typeface="Arial"/>
@@ -20304,15 +20921,15 @@
               </a:defRPr>
             </a:pPr>
             <a:r>
-              <a:rPr sz="1125" b="1">
-                <a:solidFill>
-                  <a:srgbClr val="2D3F4B"/>
+              <a:rPr sz="1050" b="1" dirty="0">
+                <a:solidFill>
+                  <a:srgbClr val="304554"/>
                 </a:solidFill>
                 <a:latin typeface="Arial"/>
                 <a:ea typeface="Arial"/>
                 <a:cs typeface="Arial"/>
               </a:rPr>
-              <a:t>87.5%</a:t>
+              <a:t>61 %</a:t>
             </a:r>
           </a:p>
         </p:txBody>
@@ -20333,8 +20950,8 @@
         </p:nvSpPr>
         <p:spPr>
           <a:xfrm>
-            <a:off x="9334500" y="2505075"/>
-            <a:ext cx="1238250" cy="190500"/>
+            <a:off x="9334500" y="2333625"/>
+            <a:ext cx="1238250" cy="361950"/>
           </a:xfrm>
           <a:prstGeom prst="rect">
             <a:avLst/>
@@ -20350,9 +20967,10 @@
           <a:lstStyle/>
           <a:p>
             <a:pPr algn="ctr">
-              <a:defRPr sz="1125" b="1">
-                <a:solidFill>
-                  <a:srgbClr val="43858A"/>
+              <a:buNone/>
+              <a:defRPr sz="1050" b="1">
+                <a:solidFill>
+                  <a:srgbClr val="4B9298"/>
                 </a:solidFill>
                 <a:latin typeface="Arial"/>
                 <a:ea typeface="Arial"/>
@@ -20360,15 +20978,15 @@
               </a:defRPr>
             </a:pPr>
             <a:r>
-              <a:rPr sz="1125" b="1">
-                <a:solidFill>
-                  <a:srgbClr val="43858A"/>
+              <a:rPr sz="1050" b="1" dirty="0">
+                <a:solidFill>
+                  <a:srgbClr val="4B9298"/>
                 </a:solidFill>
                 <a:latin typeface="Arial"/>
                 <a:ea typeface="Arial"/>
                 <a:cs typeface="Arial"/>
               </a:rPr>
-              <a:t>93.8%</a:t>
+              <a:t>50 %</a:t>
             </a:r>
           </a:p>
         </p:txBody>
@@ -20406,9 +21024,10 @@
           <a:lstStyle/>
           <a:p>
             <a:pPr algn="l">
-              <a:defRPr sz="1425" b="1">
-                <a:solidFill>
-                  <a:srgbClr val="2D3F4B"/>
+              <a:buNone/>
+              <a:defRPr sz="1200" b="1">
+                <a:solidFill>
+                  <a:srgbClr val="304554"/>
                 </a:solidFill>
                 <a:latin typeface="Arial"/>
                 <a:ea typeface="Arial"/>
@@ -20416,15 +21035,15 @@
               </a:defRPr>
             </a:pPr>
             <a:r>
-              <a:rPr sz="1425" b="1">
-                <a:solidFill>
-                  <a:srgbClr val="2D3F4B"/>
+              <a:rPr sz="1200" b="1">
+                <a:solidFill>
+                  <a:srgbClr val="304554"/>
                 </a:solidFill>
                 <a:latin typeface="Arial"/>
                 <a:ea typeface="Arial"/>
                 <a:cs typeface="Arial"/>
               </a:rPr>
-              <a:t>Citation precision</a:t>
+              <a:t>SEMANTIC VECTOR</a:t>
             </a:r>
           </a:p>
         </p:txBody>
@@ -20467,7 +21086,7 @@
           <a:bodyPr/>
           <a:lstStyle/>
           <a:p>
-            <a:endParaRPr lang="de-CH"/>
+            <a:endParaRPr/>
           </a:p>
         </p:txBody>
       </p:sp>
@@ -20509,7 +21128,7 @@
           <a:bodyPr/>
           <a:lstStyle/>
           <a:p>
-            <a:endParaRPr lang="de-CH"/>
+            <a:endParaRPr/>
           </a:p>
         </p:txBody>
       </p:sp>
@@ -20551,7 +21170,7 @@
           <a:bodyPr/>
           <a:lstStyle/>
           <a:p>
-            <a:endParaRPr lang="de-CH"/>
+            <a:endParaRPr/>
           </a:p>
         </p:txBody>
       </p:sp>
@@ -20571,8 +21190,8 @@
         </p:nvSpPr>
         <p:spPr>
           <a:xfrm>
-            <a:off x="5905500" y="3038475"/>
-            <a:ext cx="1238250" cy="190500"/>
+            <a:off x="5905500" y="3095625"/>
+            <a:ext cx="1238250" cy="266700"/>
           </a:xfrm>
           <a:prstGeom prst="rect">
             <a:avLst/>
@@ -20588,9 +21207,10 @@
           <a:lstStyle/>
           <a:p>
             <a:pPr algn="ctr">
-              <a:defRPr sz="1125" b="1">
-                <a:solidFill>
-                  <a:srgbClr val="2D3F4B"/>
+              <a:buNone/>
+              <a:defRPr sz="1050" b="1">
+                <a:solidFill>
+                  <a:srgbClr val="304554"/>
                 </a:solidFill>
                 <a:latin typeface="Arial"/>
                 <a:ea typeface="Arial"/>
@@ -20598,15 +21218,15 @@
               </a:defRPr>
             </a:pPr>
             <a:r>
-              <a:rPr sz="1125" b="1">
-                <a:solidFill>
-                  <a:srgbClr val="2D3F4B"/>
+              <a:rPr sz="1050" b="1" dirty="0">
+                <a:solidFill>
+                  <a:srgbClr val="304554"/>
                 </a:solidFill>
                 <a:latin typeface="Arial"/>
                 <a:ea typeface="Arial"/>
                 <a:cs typeface="Arial"/>
               </a:rPr>
-              <a:t>54.2%</a:t>
+              <a:t>31 %</a:t>
             </a:r>
           </a:p>
         </p:txBody>
@@ -20627,8 +21247,8 @@
         </p:nvSpPr>
         <p:spPr>
           <a:xfrm>
-            <a:off x="9334500" y="3228975"/>
-            <a:ext cx="1238250" cy="190500"/>
+            <a:off x="9334500" y="3076575"/>
+            <a:ext cx="1238250" cy="342900"/>
           </a:xfrm>
           <a:prstGeom prst="rect">
             <a:avLst/>
@@ -20644,9 +21264,10 @@
           <a:lstStyle/>
           <a:p>
             <a:pPr algn="ctr">
-              <a:defRPr sz="1125" b="1">
-                <a:solidFill>
-                  <a:srgbClr val="43858A"/>
+              <a:buNone/>
+              <a:defRPr sz="1050" b="1">
+                <a:solidFill>
+                  <a:srgbClr val="4B9298"/>
                 </a:solidFill>
                 <a:latin typeface="Arial"/>
                 <a:ea typeface="Arial"/>
@@ -20654,15 +21275,15 @@
               </a:defRPr>
             </a:pPr>
             <a:r>
-              <a:rPr sz="1125" b="1">
-                <a:solidFill>
-                  <a:srgbClr val="43858A"/>
+              <a:rPr sz="1050" b="1" dirty="0">
+                <a:solidFill>
+                  <a:srgbClr val="4B9298"/>
                 </a:solidFill>
                 <a:latin typeface="Arial"/>
                 <a:ea typeface="Arial"/>
                 <a:cs typeface="Arial"/>
               </a:rPr>
-              <a:t>39.6%</a:t>
+              <a:t>50 %</a:t>
             </a:r>
           </a:p>
         </p:txBody>
@@ -20700,9 +21321,10 @@
           <a:lstStyle/>
           <a:p>
             <a:pPr algn="l">
-              <a:defRPr sz="1425" b="1">
-                <a:solidFill>
-                  <a:srgbClr val="2D3F4B"/>
+              <a:buNone/>
+              <a:defRPr sz="1200" b="1">
+                <a:solidFill>
+                  <a:srgbClr val="304554"/>
                 </a:solidFill>
                 <a:latin typeface="Arial"/>
                 <a:ea typeface="Arial"/>
@@ -20710,15 +21332,15 @@
               </a:defRPr>
             </a:pPr>
             <a:r>
-              <a:rPr sz="1425" b="1">
-                <a:solidFill>
-                  <a:srgbClr val="2D3F4B"/>
+              <a:rPr sz="1200" b="1">
+                <a:solidFill>
+                  <a:srgbClr val="304554"/>
                 </a:solidFill>
                 <a:latin typeface="Arial"/>
                 <a:ea typeface="Arial"/>
                 <a:cs typeface="Arial"/>
               </a:rPr>
-              <a:t>Citation grounding</a:t>
+              <a:t>RERANK</a:t>
             </a:r>
           </a:p>
         </p:txBody>
@@ -20761,7 +21383,7 @@
           <a:bodyPr/>
           <a:lstStyle/>
           <a:p>
-            <a:endParaRPr lang="de-CH"/>
+            <a:endParaRPr/>
           </a:p>
         </p:txBody>
       </p:sp>
@@ -20803,7 +21425,7 @@
           <a:bodyPr/>
           <a:lstStyle/>
           <a:p>
-            <a:endParaRPr lang="de-CH"/>
+            <a:endParaRPr/>
           </a:p>
         </p:txBody>
       </p:sp>
@@ -20845,7 +21467,7 @@
           <a:bodyPr/>
           <a:lstStyle/>
           <a:p>
-            <a:endParaRPr lang="de-CH"/>
+            <a:endParaRPr/>
           </a:p>
         </p:txBody>
       </p:sp>
@@ -20865,8 +21487,8 @@
         </p:nvSpPr>
         <p:spPr>
           <a:xfrm>
-            <a:off x="5905500" y="3762375"/>
-            <a:ext cx="1238250" cy="190500"/>
+            <a:off x="5905500" y="3813499"/>
+            <a:ext cx="1238250" cy="323850"/>
           </a:xfrm>
           <a:prstGeom prst="rect">
             <a:avLst/>
@@ -20882,9 +21504,10 @@
           <a:lstStyle/>
           <a:p>
             <a:pPr algn="ctr">
-              <a:defRPr sz="1125" b="1">
-                <a:solidFill>
-                  <a:srgbClr val="2D3F4B"/>
+              <a:buNone/>
+              <a:defRPr sz="1050" b="1">
+                <a:solidFill>
+                  <a:srgbClr val="304554"/>
                 </a:solidFill>
                 <a:latin typeface="Arial"/>
                 <a:ea typeface="Arial"/>
@@ -20892,15 +21515,15 @@
               </a:defRPr>
             </a:pPr>
             <a:r>
-              <a:rPr sz="1125" b="1">
-                <a:solidFill>
-                  <a:srgbClr val="2D3F4B"/>
+              <a:rPr sz="1050" b="1" dirty="0">
+                <a:solidFill>
+                  <a:srgbClr val="304554"/>
                 </a:solidFill>
                 <a:latin typeface="Arial"/>
                 <a:ea typeface="Arial"/>
                 <a:cs typeface="Arial"/>
               </a:rPr>
-              <a:t>87.5%</a:t>
+              <a:t>46 %</a:t>
             </a:r>
           </a:p>
         </p:txBody>
@@ -20921,8 +21544,8 @@
         </p:nvSpPr>
         <p:spPr>
           <a:xfrm>
-            <a:off x="9334500" y="3952875"/>
-            <a:ext cx="1238250" cy="190500"/>
+            <a:off x="9334500" y="3824751"/>
+            <a:ext cx="1238250" cy="342900"/>
           </a:xfrm>
           <a:prstGeom prst="rect">
             <a:avLst/>
@@ -20938,9 +21561,10 @@
           <a:lstStyle/>
           <a:p>
             <a:pPr algn="ctr">
-              <a:defRPr sz="1125" b="1">
-                <a:solidFill>
-                  <a:srgbClr val="43858A"/>
+              <a:buNone/>
+              <a:defRPr sz="1050" b="1">
+                <a:solidFill>
+                  <a:srgbClr val="4B9298"/>
                 </a:solidFill>
                 <a:latin typeface="Arial"/>
                 <a:ea typeface="Arial"/>
@@ -20948,15 +21572,15 @@
               </a:defRPr>
             </a:pPr>
             <a:r>
-              <a:rPr sz="1125" b="1">
-                <a:solidFill>
-                  <a:srgbClr val="43858A"/>
+              <a:rPr sz="1050" b="1" dirty="0">
+                <a:solidFill>
+                  <a:srgbClr val="4B9298"/>
                 </a:solidFill>
                 <a:latin typeface="Arial"/>
                 <a:ea typeface="Arial"/>
                 <a:cs typeface="Arial"/>
               </a:rPr>
-              <a:t>79.2%</a:t>
+              <a:t>67 %</a:t>
             </a:r>
           </a:p>
         </p:txBody>
@@ -20994,9 +21618,10 @@
           <a:lstStyle/>
           <a:p>
             <a:pPr algn="l">
-              <a:defRPr sz="1425" b="1">
-                <a:solidFill>
-                  <a:srgbClr val="2D3F4B"/>
+              <a:buNone/>
+              <a:defRPr sz="1200" b="1">
+                <a:solidFill>
+                  <a:srgbClr val="304554"/>
                 </a:solidFill>
                 <a:latin typeface="Arial"/>
                 <a:ea typeface="Arial"/>
@@ -21004,15 +21629,15 @@
               </a:defRPr>
             </a:pPr>
             <a:r>
-              <a:rPr sz="1425" b="1">
-                <a:solidFill>
-                  <a:srgbClr val="2D3F4B"/>
+              <a:rPr sz="1200" b="1">
+                <a:solidFill>
+                  <a:srgbClr val="304554"/>
                 </a:solidFill>
                 <a:latin typeface="Arial"/>
                 <a:ea typeface="Arial"/>
                 <a:cs typeface="Arial"/>
               </a:rPr>
-              <a:t>Citation completeness</a:t>
+              <a:t>GRAPH</a:t>
             </a:r>
           </a:p>
         </p:txBody>
@@ -21055,7 +21680,7 @@
           <a:bodyPr/>
           <a:lstStyle/>
           <a:p>
-            <a:endParaRPr lang="de-CH"/>
+            <a:endParaRPr/>
           </a:p>
         </p:txBody>
       </p:sp>
@@ -21097,7 +21722,7 @@
           <a:bodyPr/>
           <a:lstStyle/>
           <a:p>
-            <a:endParaRPr lang="de-CH"/>
+            <a:endParaRPr/>
           </a:p>
         </p:txBody>
       </p:sp>
@@ -21139,7 +21764,7 @@
           <a:bodyPr/>
           <a:lstStyle/>
           <a:p>
-            <a:endParaRPr lang="de-CH"/>
+            <a:endParaRPr/>
           </a:p>
         </p:txBody>
       </p:sp>
@@ -21159,8 +21784,8 @@
         </p:nvSpPr>
         <p:spPr>
           <a:xfrm>
-            <a:off x="5905500" y="4486275"/>
-            <a:ext cx="1238250" cy="190500"/>
+            <a:off x="5905500" y="4543425"/>
+            <a:ext cx="1238250" cy="304800"/>
           </a:xfrm>
           <a:prstGeom prst="rect">
             <a:avLst/>
@@ -21176,9 +21801,10 @@
           <a:lstStyle/>
           <a:p>
             <a:pPr algn="ctr">
-              <a:defRPr sz="1125" b="1">
-                <a:solidFill>
-                  <a:srgbClr val="2D3F4B"/>
+              <a:buNone/>
+              <a:defRPr sz="1050" b="1">
+                <a:solidFill>
+                  <a:srgbClr val="304554"/>
                 </a:solidFill>
                 <a:latin typeface="Arial"/>
                 <a:ea typeface="Arial"/>
@@ -21186,15 +21812,15 @@
               </a:defRPr>
             </a:pPr>
             <a:r>
-              <a:rPr sz="1125" b="1">
-                <a:solidFill>
-                  <a:srgbClr val="2D3F4B"/>
+              <a:rPr sz="1050" b="1" dirty="0">
+                <a:solidFill>
+                  <a:srgbClr val="304554"/>
                 </a:solidFill>
                 <a:latin typeface="Arial"/>
                 <a:ea typeface="Arial"/>
                 <a:cs typeface="Arial"/>
               </a:rPr>
-              <a:t>87.5%</a:t>
+              <a:t>56 %</a:t>
             </a:r>
           </a:p>
         </p:txBody>
@@ -21215,8 +21841,8 @@
         </p:nvSpPr>
         <p:spPr>
           <a:xfrm>
-            <a:off x="9334500" y="4676775"/>
-            <a:ext cx="1238250" cy="190500"/>
+            <a:off x="9334500" y="4543425"/>
+            <a:ext cx="1238250" cy="323850"/>
           </a:xfrm>
           <a:prstGeom prst="rect">
             <a:avLst/>
@@ -21232,9 +21858,10 @@
           <a:lstStyle/>
           <a:p>
             <a:pPr algn="ctr">
-              <a:defRPr sz="1125" b="1">
-                <a:solidFill>
-                  <a:srgbClr val="43858A"/>
+              <a:buNone/>
+              <a:defRPr sz="1050" b="1">
+                <a:solidFill>
+                  <a:srgbClr val="4B9298"/>
                 </a:solidFill>
                 <a:latin typeface="Arial"/>
                 <a:ea typeface="Arial"/>
@@ -21242,15 +21869,15 @@
               </a:defRPr>
             </a:pPr>
             <a:r>
-              <a:rPr sz="1125" b="1">
-                <a:solidFill>
-                  <a:srgbClr val="43858A"/>
+              <a:rPr sz="1050" b="1">
+                <a:solidFill>
+                  <a:srgbClr val="4B9298"/>
                 </a:solidFill>
                 <a:latin typeface="Arial"/>
                 <a:ea typeface="Arial"/>
                 <a:cs typeface="Arial"/>
               </a:rPr>
-              <a:t>75.0%</a:t>
+              <a:t>67 %</a:t>
             </a:r>
           </a:p>
         </p:txBody>
@@ -21293,7 +21920,7 @@
           <a:bodyPr/>
           <a:lstStyle/>
           <a:p>
-            <a:endParaRPr lang="de-CH"/>
+            <a:endParaRPr/>
           </a:p>
         </p:txBody>
       </p:sp>
@@ -21326,11 +21953,12 @@
           </a:ln>
         </p:spPr>
         <p:txBody>
-          <a:bodyPr anchor="t"/>
+          <a:bodyPr anchor="ctr"/>
           <a:lstStyle/>
           <a:p>
             <a:pPr algn="ctr">
-              <a:defRPr sz="1575" b="1">
+              <a:buNone/>
+              <a:defRPr sz="1200" b="1">
                 <a:solidFill>
                   <a:srgbClr val="FFFFFF"/>
                 </a:solidFill>
@@ -21340,7 +21968,7 @@
               </a:defRPr>
             </a:pPr>
             <a:r>
-              <a:rPr sz="1575" b="1">
+              <a:rPr sz="1200" b="1">
                 <a:solidFill>
                   <a:srgbClr val="FFFFFF"/>
                 </a:solidFill>
@@ -21348,7 +21976,7 @@
                 <a:ea typeface="Arial"/>
                 <a:cs typeface="Arial"/>
               </a:rPr>
-              <a:t>Graph: +6.3 Punkte Faktenabdeckung · Vector: stärkere Zitationsmetriken</a:t>
+              <a:t>Graph maximiert den Recall · Antwortqualität bleibt ein eigener Prüfschritt</a:t>
             </a:r>
           </a:p>
         </p:txBody>
@@ -21356,13 +21984,119 @@
     </p:spTree>
     <p:extLst>
       <p:ext uri="{BB962C8B-B14F-4D97-AF65-F5344CB8AC3E}">
-        <p14:creationId xmlns:p14="http://schemas.microsoft.com/office/powerpoint/2010/main" val="852951726"/>
+        <p14:creationId xmlns:p14="http://schemas.microsoft.com/office/powerpoint/2010/main" val="1197368150"/>
       </p:ext>
     </p:extLst>
   </p:cSld>
   <p:clrMapOvr>
     <a:masterClrMapping/>
   </p:clrMapOvr>
+  <p:timing>
+    <p:tnLst>
+      <p:par>
+        <p:cTn id="1" dur="indefinite" restart="never" nodeType="tmRoot">
+          <p:childTnLst>
+            <p:seq concurrent="1" nextAc="seek">
+              <p:cTn id="2" dur="indefinite" nodeType="mainSeq">
+                <p:childTnLst>
+                  <p:par>
+                    <p:cTn id="3" fill="hold">
+                      <p:stCondLst>
+                        <p:cond delay="indefinite"/>
+                      </p:stCondLst>
+                      <p:childTnLst>
+                        <p:par>
+                          <p:cTn id="4" fill="hold">
+                            <p:stCondLst>
+                              <p:cond delay="0"/>
+                            </p:stCondLst>
+                            <p:childTnLst>
+                              <p:par>
+                                <p:cTn id="5" presetID="1" presetClass="entr" presetSubtype="0" fill="hold" grpId="0" nodeType="clickEffect">
+                                  <p:stCondLst>
+                                    <p:cond delay="0"/>
+                                  </p:stCondLst>
+                                  <p:childTnLst>
+                                    <p:set>
+                                      <p:cBhvr>
+                                        <p:cTn id="6" dur="1" fill="hold">
+                                          <p:stCondLst>
+                                            <p:cond delay="0"/>
+                                          </p:stCondLst>
+                                        </p:cTn>
+                                        <p:tgtEl>
+                                          <p:spTgt spid="33"/>
+                                        </p:tgtEl>
+                                        <p:attrNameLst>
+                                          <p:attrName>style.visibility</p:attrName>
+                                        </p:attrNameLst>
+                                      </p:cBhvr>
+                                      <p:to>
+                                        <p:strVal val="visible"/>
+                                      </p:to>
+                                    </p:set>
+                                  </p:childTnLst>
+                                </p:cTn>
+                              </p:par>
+                              <p:par>
+                                <p:cTn id="7" presetID="1" presetClass="entr" presetSubtype="0" fill="hold" grpId="0" nodeType="withEffect">
+                                  <p:stCondLst>
+                                    <p:cond delay="0"/>
+                                  </p:stCondLst>
+                                  <p:childTnLst>
+                                    <p:set>
+                                      <p:cBhvr>
+                                        <p:cTn id="8" dur="1" fill="hold">
+                                          <p:stCondLst>
+                                            <p:cond delay="0"/>
+                                          </p:stCondLst>
+                                        </p:cTn>
+                                        <p:tgtEl>
+                                          <p:spTgt spid="34"/>
+                                        </p:tgtEl>
+                                        <p:attrNameLst>
+                                          <p:attrName>style.visibility</p:attrName>
+                                        </p:attrNameLst>
+                                      </p:cBhvr>
+                                      <p:to>
+                                        <p:strVal val="visible"/>
+                                      </p:to>
+                                    </p:set>
+                                  </p:childTnLst>
+                                </p:cTn>
+                              </p:par>
+                            </p:childTnLst>
+                          </p:cTn>
+                        </p:par>
+                      </p:childTnLst>
+                    </p:cTn>
+                  </p:par>
+                </p:childTnLst>
+              </p:cTn>
+              <p:prevCondLst>
+                <p:cond evt="onPrev" delay="0">
+                  <p:tgtEl>
+                    <p:sldTgt/>
+                  </p:tgtEl>
+                </p:cond>
+              </p:prevCondLst>
+              <p:nextCondLst>
+                <p:cond evt="onNext" delay="0">
+                  <p:tgtEl>
+                    <p:sldTgt/>
+                  </p:tgtEl>
+                </p:cond>
+              </p:nextCondLst>
+            </p:seq>
+          </p:childTnLst>
+        </p:cTn>
+      </p:par>
+    </p:tnLst>
+    <p:bldLst>
+      <p:bldP spid="33" grpId="0" animBg="1"/>
+      <p:bldP spid="34" grpId="0"/>
+    </p:bldLst>
+  </p:timing>
 </p:sld>
 </file>
 
@@ -43701,26 +44435,6 @@
 </file>
 
 <file path=customXml/item1.xml><?xml version="1.0" encoding="utf-8"?>
-<p:properties xmlns:p="http://schemas.microsoft.com/office/2006/metadata/properties" xmlns:xsi="http://www.w3.org/2001/XMLSchema-instance" xmlns:pc="http://schemas.microsoft.com/office/infopath/2007/PartnerControls">
-  <documentManagement>
-    <lcf76f155ced4ddcb4097134ff3c332f xmlns="501edefc-5b9b-422a-9450-cf7f1f30e3fa">
-      <Terms xmlns="http://schemas.microsoft.com/office/infopath/2007/PartnerControls"/>
-    </lcf76f155ced4ddcb4097134ff3c332f>
-    <TaxCatchAll xmlns="3083c7a9-d95a-44c4-8fb8-f93b125494d6" xsi:nil="true"/>
-  </documentManagement>
-</p:properties>
-</file>
-
-<file path=customXml/item2.xml><?xml version="1.0" encoding="utf-8"?>
-<?mso-contentType ?>
-<FormTemplates xmlns="http://schemas.microsoft.com/sharepoint/v3/contenttype/forms">
-  <Display>DocumentLibraryForm</Display>
-  <Edit>DocumentLibraryForm</Edit>
-  <New>DocumentLibraryForm</New>
-</FormTemplates>
-</file>
-
-<file path=customXml/item3.xml><?xml version="1.0" encoding="utf-8"?>
 <ct:contentTypeSchema xmlns:ct="http://schemas.microsoft.com/office/2006/metadata/contentType" xmlns:ma="http://schemas.microsoft.com/office/2006/metadata/properties/metaAttributes" ct:_="" ma:_="" ma:contentTypeName="Dokument" ma:contentTypeID="0x0101007D39DBAC6A50C74E998B9EB660A68B40" ma:contentTypeVersion="12" ma:contentTypeDescription="Ein neues Dokument erstellen." ma:contentTypeScope="" ma:versionID="34dc225a7d6106712b96f9699847575b">
   <xsd:schema xmlns:xsd="http://www.w3.org/2001/XMLSchema" xmlns:xs="http://www.w3.org/2001/XMLSchema" xmlns:p="http://schemas.microsoft.com/office/2006/metadata/properties" xmlns:ns2="501edefc-5b9b-422a-9450-cf7f1f30e3fa" xmlns:ns3="3083c7a9-d95a-44c4-8fb8-f93b125494d6" targetNamespace="http://schemas.microsoft.com/office/2006/metadata/properties" ma:root="true" ma:fieldsID="b7244162b0b071e6bfc5af2eca0d94d3" ns2:_="" ns3:_="">
     <xsd:import namespace="501edefc-5b9b-422a-9450-cf7f1f30e3fa"/>
@@ -43921,30 +44635,27 @@
 </ct:contentTypeSchema>
 </file>
 
-<file path=customXml/itemProps1.xml><?xml version="1.0" encoding="utf-8"?>
-<ds:datastoreItem xmlns:ds="http://schemas.openxmlformats.org/officeDocument/2006/customXml" ds:itemID="{6302A1CC-4AEF-4830-BB1C-A446161EB02D}">
-  <ds:schemaRefs>
-    <ds:schemaRef ds:uri="http://schemas.microsoft.com/office/2006/metadata/properties"/>
-    <ds:schemaRef ds:uri="http://schemas.microsoft.com/office/infopath/2007/PartnerControls"/>
-    <ds:schemaRef ds:uri="7052a6c1-2dbf-49e9-b6e1-6fe4487af028"/>
-    <ds:schemaRef ds:uri="d8f140f0-05e7-48e3-ba8b-dcc0ff83b3dd"/>
-    <ds:schemaRef ds:uri="b22023f0-d141-4df7-85ad-6dd1e1377ec8"/>
-    <ds:schemaRef ds:uri="bf122554-6983-45b2-a605-6e185ba8cf82"/>
-    <ds:schemaRef ds:uri="501edefc-5b9b-422a-9450-cf7f1f30e3fa"/>
-    <ds:schemaRef ds:uri="3083c7a9-d95a-44c4-8fb8-f93b125494d6"/>
-  </ds:schemaRefs>
-</ds:datastoreItem>
+<file path=customXml/item2.xml><?xml version="1.0" encoding="utf-8"?>
+<?mso-contentType ?>
+<FormTemplates xmlns="http://schemas.microsoft.com/sharepoint/v3/contenttype/forms">
+  <Display>DocumentLibraryForm</Display>
+  <Edit>DocumentLibraryForm</Edit>
+  <New>DocumentLibraryForm</New>
+</FormTemplates>
 </file>
 
-<file path=customXml/itemProps2.xml><?xml version="1.0" encoding="utf-8"?>
-<ds:datastoreItem xmlns:ds="http://schemas.openxmlformats.org/officeDocument/2006/customXml" ds:itemID="{334436CE-240F-4EE4-9FC5-4255E6874223}">
-  <ds:schemaRefs>
-    <ds:schemaRef ds:uri="http://schemas.microsoft.com/sharepoint/v3/contenttype/forms"/>
-  </ds:schemaRefs>
-</ds:datastoreItem>
+<file path=customXml/item3.xml><?xml version="1.0" encoding="utf-8"?>
+<p:properties xmlns:p="http://schemas.microsoft.com/office/2006/metadata/properties" xmlns:xsi="http://www.w3.org/2001/XMLSchema-instance" xmlns:pc="http://schemas.microsoft.com/office/infopath/2007/PartnerControls">
+  <documentManagement>
+    <lcf76f155ced4ddcb4097134ff3c332f xmlns="501edefc-5b9b-422a-9450-cf7f1f30e3fa">
+      <Terms xmlns="http://schemas.microsoft.com/office/infopath/2007/PartnerControls"/>
+    </lcf76f155ced4ddcb4097134ff3c332f>
+    <TaxCatchAll xmlns="3083c7a9-d95a-44c4-8fb8-f93b125494d6" xsi:nil="true"/>
+  </documentManagement>
+</p:properties>
 </file>
 
-<file path=customXml/itemProps3.xml><?xml version="1.0" encoding="utf-8"?>
+<file path=customXml/itemProps1.xml><?xml version="1.0" encoding="utf-8"?>
 <ds:datastoreItem xmlns:ds="http://schemas.openxmlformats.org/officeDocument/2006/customXml" ds:itemID="{42C8284C-7C61-4B35-A2FD-8E50AFE93672}">
   <ds:schemaRefs>
     <ds:schemaRef ds:uri="http://schemas.microsoft.com/office/2006/metadata/contentType"/>
@@ -43963,6 +44674,29 @@
 </ds:datastoreItem>
 </file>
 
+<file path=customXml/itemProps2.xml><?xml version="1.0" encoding="utf-8"?>
+<ds:datastoreItem xmlns:ds="http://schemas.openxmlformats.org/officeDocument/2006/customXml" ds:itemID="{334436CE-240F-4EE4-9FC5-4255E6874223}">
+  <ds:schemaRefs>
+    <ds:schemaRef ds:uri="http://schemas.microsoft.com/sharepoint/v3/contenttype/forms"/>
+  </ds:schemaRefs>
+</ds:datastoreItem>
+</file>
+
+<file path=customXml/itemProps3.xml><?xml version="1.0" encoding="utf-8"?>
+<ds:datastoreItem xmlns:ds="http://schemas.openxmlformats.org/officeDocument/2006/customXml" ds:itemID="{6302A1CC-4AEF-4830-BB1C-A446161EB02D}">
+  <ds:schemaRefs>
+    <ds:schemaRef ds:uri="http://schemas.microsoft.com/office/2006/metadata/properties"/>
+    <ds:schemaRef ds:uri="http://schemas.microsoft.com/office/infopath/2007/PartnerControls"/>
+    <ds:schemaRef ds:uri="7052a6c1-2dbf-49e9-b6e1-6fe4487af028"/>
+    <ds:schemaRef ds:uri="d8f140f0-05e7-48e3-ba8b-dcc0ff83b3dd"/>
+    <ds:schemaRef ds:uri="b22023f0-d141-4df7-85ad-6dd1e1377ec8"/>
+    <ds:schemaRef ds:uri="bf122554-6983-45b2-a605-6e185ba8cf82"/>
+    <ds:schemaRef ds:uri="501edefc-5b9b-422a-9450-cf7f1f30e3fa"/>
+    <ds:schemaRef ds:uri="3083c7a9-d95a-44c4-8fb8-f93b125494d6"/>
+  </ds:schemaRefs>
+</ds:datastoreItem>
+</file>
+
 <file path=docMetadata/LabelInfo.xml><?xml version="1.0" encoding="utf-8"?>
 <clbl:labelList xmlns:clbl="http://schemas.microsoft.com/office/2020/mipLabelMetadata">
   <clbl:label id="{42e461c6-591f-4920-9cf0-f1389542f8ad}" enabled="1" method="Standard" siteId="{2cda5d11-f0ac-46b3-967d-af1b2e1bd01a}" contentBits="2" removed="0"/>

</xml_diff>

<commit_message>
Merge speaker notes into RAG_Workshop.pptx
Transfer the Kernbotschaft/Sprechtext speaker notes from
RAG_Workshop_mit_Referentennotizen.pptx onto the current deck, mapping
slides by title (the notes deck splits two topics over two slides each;
their notes are concatenated on the consolidated slide). Replaces the
older draft annotations that some slides carried.

Co-Authored-By: Claude Fable 5 <noreply@anthropic.com>
Claude-Session: https://claude.ai/code/session_01S2kGP2buE2HmxMttD3XczR
</commit_message>
<xml_diff>
--- a/RAG_Workshop.pptx
+++ b/RAG_Workshop.pptx
@@ -788,35 +788,25 @@
           <a:lstStyle/>
           <a:p>
             <a:r>
-              <a:t>Die Folie baut auf den drei Anfragearten der vorherigen Folie auf. Ohne Kontext muss das Modell fehlende Details expandieren. RAG liefert relevante Dokumentstellen und macht daraus eine Kompressionsaufgabe. Translation verändert dagegen primär Darstellung oder Sprache.</a:t>
-            </a:r>
-          </a:p>
-          <a:p>
-            <a:endParaRPr/>
-          </a:p>
-          <a:p>
-            <a:r>
-              <a:t>[Sources]</a:t>
-            </a:r>
-          </a:p>
-          <a:p>
-            <a:r>
-              <a:t>- Workshop - RAG (Retrieval Augmented Generation), Confluence, Seite 321455241</a:t>
-            </a:r>
-          </a:p>
-          <a:p>
-            <a:r>
-              <a:t>- Google Material Design Icons: open_in_full, compress, translate; Apache License 2.0</a:t>
-            </a:r>
-          </a:p>
-          <a:p>
-            <a:r>
-              <a:t>- https://github.com/google/material-design-icons</a:t>
-            </a:r>
-          </a:p>
-          <a:p>
-            <a:r>
-              <a:t>- https://github.com/google/material-design-icons/blob/master/LICENSE</a:t>
+              <a:t>Kernbotschaft: LLM-Anwendungen erweitern, verdichten oder übersetzen Kontext – RAG ist besonders stark beim gezielten Verdichten.</a:t>
+            </a:r>
+          </a:p>
+          <a:p/>
+          <a:p>
+            <a:r>
+              <a:t>Sprechtext: Expansion bedeutet, aus einer kurzen Eingabe umfangreichen Output zu erzeugen. Kompression bedeutet, aus vielen möglichen Informationen nur die relevanten Belege in den Prompt zu nehmen. Translation meint die Umwandlung zwischen Repräsentationen, etwa Text zu Embeddings oder Dokumente zu strukturierten Metadaten. Unsere RAG-Pipeline kombiniert alle drei, aber ihr eigentlicher Nutzen liegt in der kontrollierten Auswahl von Kontext.</a:t>
+            </a:r>
+          </a:p>
+          <a:p/>
+          <a:p>
+            <a:r>
+              <a:t>Publikumsfrage: Welche dieser Operationen ist bei einer Frage wie „Was steht in Art. 1 OR?“ am wichtigsten?</a:t>
+            </a:r>
+          </a:p>
+          <a:p/>
+          <a:p>
+            <a:r>
+              <a:t>Übergang: RAG ist damit ein Teilgebiet von Context Engineering – aber nicht die einzige Variante.</a:t>
             </a:r>
           </a:p>
         </p:txBody>
@@ -898,25 +888,31 @@
           <a:lstStyle/>
           <a:p>
             <a:r>
-              <a:t>Die Gruppen arbeiten parallel an Chunking, Reranking oder Graph plus Evaluation. Jede Gruppe berichtet maximal zwei Minuten und beantwortet drei Fragen: Was wurde ausgeführt oder verändert? Was wurde besser oder schlechter? Welche Grenze bleibt bestehen?</a:t>
-            </a:r>
-          </a:p>
-          <a:p>
-            <a:endParaRPr/>
-          </a:p>
-          <a:p>
-            <a:r>
-              <a:t>[Sources]</a:t>
-            </a:r>
-          </a:p>
-          <a:p>
-            <a:r>
-              <a:t>- C:/Users/mehlst/Documents/RAG-Workshop/Workshop2026-RAG-Workshop-Script.txt</a:t>
-            </a:r>
-          </a:p>
-          <a:p>
-            <a:r>
-              <a:t>- C:/Users/mehlst/Documents/RAG-Workshop/README.md</a:t>
+              <a:t>Kernbotschaft: Die Gruppen betrachten dieselbe Pipeline aus drei Perspektiven und müssen eine begründete Priorität formulieren.</a:t>
+            </a:r>
+          </a:p>
+          <a:p/>
+          <a:p>
+            <a:r>
+              <a:t>Sprechtext: Jede Gruppe bearbeitet ihr Wahlmodul anhand der bereitgestellten Fragen und Ergebnisse. Entscheidend ist nicht, möglichst viele Ideen zu sammeln, sondern eine konkrete Verbesserung mit erwarteter Wirkung, möglichem Nachteil und einer passenden Messgröße zu benennen.</a:t>
+            </a:r>
+          </a:p>
+          <a:p/>
+          <a:p>
+            <a:r>
+              <a:t>Für die Kurzpräsentation helfen drei Fragen: Welches Problem lösen wir? Welche Änderung schlagen wir vor? Woran erkennen wir, dass sie besser ist? Die Ergebnisvorstellung dauert maximal zwei Minuten pro Gruppe; die Arbeitszeit kann je nach Workshop-Zeitplan angepasst werden.</a:t>
+            </a:r>
+          </a:p>
+          <a:p/>
+          <a:p>
+            <a:r>
+              <a:t>Hinweis: Achtet darauf, Retrieval und Generierung nicht zu vermischen. Eine Maßnahme kann Recall verbessern, ohne die Antwortqualität automatisch im gleichen Maß zu erhöhen.</a:t>
+            </a:r>
+          </a:p>
+          <a:p/>
+          <a:p>
+            <a:r>
+              <a:t>Übergang: Neben Algorithmen beeinflusst auch die Frameworkwahl, wie schnell und kontrolliert wir solche Änderungen umsetzen können.</a:t>
             </a:r>
           </a:p>
         </p:txBody>
@@ -998,25 +994,25 @@
           <a:lstStyle/>
           <a:p>
             <a:r>
-              <a:t>Die Matrix ist eine qualitative Orientierung, keine Rangliste. From scratch maximiert Verständnis und Kontrolle. Frameworks reduzieren Implementierungsaufwand. LangGraph adressiert komplexere zustandsbasierte Abläufe. Managed Services reduzieren Eigenbetrieb, erhöhen aber Abhängigkeit und erfordern eine Prüfung von Datenresidenz, Berechtigungen, Kosten und Lock-in.</a:t>
-            </a:r>
-          </a:p>
-          <a:p>
-            <a:endParaRPr/>
-          </a:p>
-          <a:p>
-            <a:r>
-              <a:t>[Sources]</a:t>
-            </a:r>
-          </a:p>
-          <a:p>
-            <a:r>
-              <a:t>- C:/Users/mehlst/Documents/RAG-Workshop/Workshop2026-RAG-Workshop-Script.txt</a:t>
-            </a:r>
-          </a:p>
-          <a:p>
-            <a:r>
-              <a:t>- C:/Users/mehlst/Documents/RAG-Workshop/README.md</a:t>
+              <a:t>Kernbotschaft: Die Frameworkwahl ist keine reine Featurefrage, sondern eine Entscheidung über Kontrolle, Transparenz und Betriebsaufwand.</a:t>
+            </a:r>
+          </a:p>
+          <a:p/>
+          <a:p>
+            <a:r>
+              <a:t>Sprechtext: Unser Workshop-Code ist bewusst weitgehend framework-frei: OpenAI-kompatibler Client, ChromaDB und klar sichtbare Python-Funktionen. Das erhöht den Lernwert und macht jeden Verarbeitungsschritt nachvollziehbar. Frameworks wie LangChain oder LlamaIndex beschleunigen Standardintegrationen, bringen aber zusätzliche Abstraktionen und Versionsabhängigkeiten. Graph-orientierte Orchestrierung lohnt sich vor allem bei verzweigten, zustandsbehafteten Abläufen. Managed Services reduzieren Betriebsaufwand, erhöhen aber Kosten und Anbieterbindung.</a:t>
+            </a:r>
+          </a:p>
+          <a:p/>
+          <a:p>
+            <a:r>
+              <a:t>Leitfrage: Welche Anforderungen dominieren im echten Projekt – schnelle Entwicklung, maximale Transparenz, komplexe Orchestrierung oder geringer Betrieb?</a:t>
+            </a:r>
+          </a:p>
+          <a:p/>
+          <a:p>
+            <a:r>
+              <a:t>Übergang: Unabhängig vom Werkzeug bleiben drei Grundprinzipien bestehen.</a:t>
             </a:r>
           </a:p>
         </p:txBody>
@@ -1098,25 +1094,25 @@
           <a:lstStyle/>
           <a:p>
             <a:r>
-              <a:t>Die drei Leitlinien fassen den Workshop zusammen. Kontext ist ein Engineering-Artefakt. Retrieval und Antwortqualität brauchen getrennte Metriken. Komplexität wie Reranking oder GraphRAG sollte nur ergänzt werden, wenn ein konkretes Problem gemessen wurde.</a:t>
-            </a:r>
-          </a:p>
-          <a:p>
-            <a:endParaRPr/>
-          </a:p>
-          <a:p>
-            <a:r>
-              <a:t>[Sources]</a:t>
-            </a:r>
-          </a:p>
-          <a:p>
-            <a:r>
-              <a:t>- C:/Users/mehlst/Documents/RAG-Workshop/Workshop2026-RAG-Workshop-Script.txt</a:t>
-            </a:r>
-          </a:p>
-          <a:p>
-            <a:r>
-              <a:t>- C:/Users/mehlst/Documents/RAG-Workshop/evaluation/report.md</a:t>
+              <a:t>Kernbotschaft: Gutes RAG entsteht durch gezielten Kontext, getrennte Evaluation und nur so viel Komplexität wie messbar nötig.</a:t>
+            </a:r>
+          </a:p>
+          <a:p/>
+          <a:p>
+            <a:r>
+              <a:t>Sprechtext: Erstens: RAG ist Context Engineering. Entscheidend ist nicht die maximale Menge, sondern die Relevanz des Kontexts. Zweitens: Retrieval und Antwort müssen getrennt gemessen werden – sonst wissen wir nicht, ob ein Fehler in der Suche oder in der Generierung liegt. Drittens: Chunking, Reranking, hybride Suche und Graphen sind Werkzeuge, keine Selbstzwecke. Wir ergänzen sie nur, wenn die Evaluation einen konkreten Nutzen zeigt.</a:t>
+            </a:r>
+          </a:p>
+          <a:p/>
+          <a:p>
+            <a:r>
+              <a:t>Abschlussfrage: Welchen dieser Hebel würdet ihr in eurem eigenen Projekt als Erstes messen?</a:t>
+            </a:r>
+          </a:p>
+          <a:p/>
+          <a:p>
+            <a:r>
+              <a:t>Übergang: Damit sind wir am Ende des Workshops – Zeit für Fragen und den Transfer in eure Anwendungsfälle.</a:t>
             </a:r>
           </a:p>
         </p:txBody>
@@ -1139,6 +1135,646 @@
             <a:endParaRPr/>
           </a:p>
         </p:txBody>
+      </p:sp>
+    </p:spTree>
+  </p:cSld>
+  <p:clrMapOvr>
+    <a:masterClrMapping/>
+  </p:clrMapOvr>
+</p:notes>
+</file>
+
+<file path=ppt/notesSlides/notesSlide13.xml><?xml version="1.0" encoding="utf-8"?>
+<p:notes xmlns:a="http://schemas.openxmlformats.org/drawingml/2006/main" xmlns:p="http://schemas.openxmlformats.org/presentationml/2006/main" xmlns:r="http://schemas.openxmlformats.org/officeDocument/2006/relationships">
+  <p:cSld>
+    <p:spTree>
+      <p:nvGrpSpPr>
+        <p:cNvPr id="1" name=""/>
+        <p:cNvGrpSpPr/>
+        <p:nvPr/>
+      </p:nvGrpSpPr>
+      <p:grpSpPr>
+        <a:xfrm>
+          <a:off x="0" y="0"/>
+          <a:ext cx="0" cy="0"/>
+          <a:chOff x="0" y="0"/>
+          <a:chExt cx="0" cy="0"/>
+        </a:xfrm>
+      </p:grpSpPr>
+      <p:sp>
+        <p:nvSpPr>
+          <p:cNvPr id="2" name="Slide Image Placeholder 1"/>
+          <p:cNvSpPr>
+            <a:spLocks noGrp="1"/>
+          </p:cNvSpPr>
+          <p:nvPr>
+            <p:ph type="sldImg" idx="2"/>
+          </p:nvPr>
+        </p:nvSpPr>
+        <p:spPr/>
+      </p:sp>
+      <p:sp>
+        <p:nvSpPr>
+          <p:cNvPr id="3" name="Notes Placeholder 2"/>
+          <p:cNvSpPr>
+            <a:spLocks noGrp="1"/>
+          </p:cNvSpPr>
+          <p:nvPr>
+            <p:ph type="body" idx="3" sz="quarter"/>
+          </p:nvPr>
+        </p:nvSpPr>
+        <p:spPr/>
+        <p:txBody>
+          <a:bodyPr/>
+          <a:lstStyle/>
+          <a:p>
+            <a:r>
+              <a:t>Kernbotschaft: Heute bauen wir nicht nur einen Chatbot, sondern verstehen die Mechanik eines belastbaren RAG-Systems.</a:t>
+            </a:r>
+          </a:p>
+          <a:p/>
+          <a:p>
+            <a:r>
+              <a:t>Sprechtext: Willkommen zum RAG-Workshop. Als durchgängiges Beispiel verwenden wir Schweizer Gesetzestexte. Dadurch können wir sehr konkret prüfen, ob ein System den richtigen Erlass und den richtigen Artikel findet, ob es Quellen nennt und wie viel Kontext es dafür benötigt. Am Ende sollt ihr die wichtigsten Qualitätshebel – Chunking, Retrieval, Reranking und Evaluation – bewusst auswählen können.</a:t>
+            </a:r>
+          </a:p>
+          <a:p/>
+          <a:p>
+            <a:r>
+              <a:t>Wichtig: Die Demo erklärt technische Konzepte und ist keine Rechtsberatung.</a:t>
+            </a:r>
+          </a:p>
+          <a:p/>
+          <a:p>
+            <a:r>
+              <a:t>Übergang: Schauen wir zuerst auf den Ablauf und das Ziel der kommenden 90 Minuten.</a:t>
+            </a:r>
+          </a:p>
+        </p:txBody>
+      </p:sp>
+      <p:sp>
+        <p:nvSpPr>
+          <p:cNvPr id="4" name="Slide Number Placeholder 3"/>
+          <p:cNvSpPr>
+            <a:spLocks noGrp="1"/>
+          </p:cNvSpPr>
+          <p:nvPr>
+            <p:ph type="sldNum" idx="5" sz="quarter"/>
+          </p:nvPr>
+        </p:nvSpPr>
+        <p:spPr/>
+      </p:sp>
+    </p:spTree>
+  </p:cSld>
+  <p:clrMapOvr>
+    <a:masterClrMapping/>
+  </p:clrMapOvr>
+</p:notes>
+</file>
+
+<file path=ppt/notesSlides/notesSlide14.xml><?xml version="1.0" encoding="utf-8"?>
+<p:notes xmlns:a="http://schemas.openxmlformats.org/drawingml/2006/main" xmlns:p="http://schemas.openxmlformats.org/presentationml/2006/main" xmlns:r="http://schemas.openxmlformats.org/officeDocument/2006/relationships">
+  <p:cSld>
+    <p:spTree>
+      <p:nvGrpSpPr>
+        <p:cNvPr id="1" name=""/>
+        <p:cNvGrpSpPr/>
+        <p:nvPr/>
+      </p:nvGrpSpPr>
+      <p:grpSpPr>
+        <a:xfrm>
+          <a:off x="0" y="0"/>
+          <a:ext cx="0" cy="0"/>
+          <a:chOff x="0" y="0"/>
+          <a:chExt cx="0" cy="0"/>
+        </a:xfrm>
+      </p:grpSpPr>
+      <p:sp>
+        <p:nvSpPr>
+          <p:cNvPr id="2" name="Slide Image Placeholder 1"/>
+          <p:cNvSpPr>
+            <a:spLocks noGrp="1"/>
+          </p:cNvSpPr>
+          <p:nvPr>
+            <p:ph type="sldImg" idx="2"/>
+          </p:nvPr>
+        </p:nvSpPr>
+        <p:spPr/>
+      </p:sp>
+      <p:sp>
+        <p:nvSpPr>
+          <p:cNvPr id="3" name="Notes Placeholder 2"/>
+          <p:cNvSpPr>
+            <a:spLocks noGrp="1"/>
+          </p:cNvSpPr>
+          <p:nvPr>
+            <p:ph type="body" idx="3" sz="quarter"/>
+          </p:nvPr>
+        </p:nvSpPr>
+        <p:spPr/>
+        <p:txBody>
+          <a:bodyPr/>
+          <a:lstStyle/>
+          <a:p>
+            <a:r>
+              <a:t>Kernbotschaft: Wir entwickeln die Lösung schrittweise und messen nach jeder Verbesserung erneut.</a:t>
+            </a:r>
+          </a:p>
+          <a:p/>
+          <a:p>
+            <a:r>
+              <a:t>Sprechtext: Zuerst klären wir, welches Problem RAG löst. Danach bauen wir eine einfache Pipeline, verbessern das Chunking, ergänzen Reranking und schließlich GraphRAG. Die Evaluation läuft nicht nur am Ende: Sie begleitet jede Stufe, damit wir sehen, welche Änderung tatsächlich einen messbaren Effekt hat.</a:t>
+            </a:r>
+          </a:p>
+          <a:p/>
+          <a:p>
+            <a:r>
+              <a:t>Publikumsfrage: Wer hat bereits selbst ein RAG-System gebaut oder eine Vektordatenbank verwendet?</a:t>
+            </a:r>
+          </a:p>
+          <a:p/>
+          <a:p>
+            <a:r>
+              <a:t>Übergang: Bevor wir RAG definieren, schauen wir auf die Grenzen eines reinen LLMs.</a:t>
+            </a:r>
+          </a:p>
+        </p:txBody>
+      </p:sp>
+      <p:sp>
+        <p:nvSpPr>
+          <p:cNvPr id="4" name="Slide Number Placeholder 3"/>
+          <p:cNvSpPr>
+            <a:spLocks noGrp="1"/>
+          </p:cNvSpPr>
+          <p:nvPr>
+            <p:ph type="sldNum" idx="5" sz="quarter"/>
+          </p:nvPr>
+        </p:nvSpPr>
+        <p:spPr/>
+      </p:sp>
+    </p:spTree>
+  </p:cSld>
+  <p:clrMapOvr>
+    <a:masterClrMapping/>
+  </p:clrMapOvr>
+</p:notes>
+</file>
+
+<file path=ppt/notesSlides/notesSlide15.xml><?xml version="1.0" encoding="utf-8"?>
+<p:notes xmlns:a="http://schemas.openxmlformats.org/drawingml/2006/main" xmlns:p="http://schemas.openxmlformats.org/presentationml/2006/main" xmlns:r="http://schemas.openxmlformats.org/officeDocument/2006/relationships">
+  <p:cSld>
+    <p:spTree>
+      <p:nvGrpSpPr>
+        <p:cNvPr id="1" name=""/>
+        <p:cNvGrpSpPr/>
+        <p:nvPr/>
+      </p:nvGrpSpPr>
+      <p:grpSpPr>
+        <a:xfrm>
+          <a:off x="0" y="0"/>
+          <a:ext cx="0" cy="0"/>
+          <a:chOff x="0" y="0"/>
+          <a:chExt cx="0" cy="0"/>
+        </a:xfrm>
+      </p:grpSpPr>
+      <p:sp>
+        <p:nvSpPr>
+          <p:cNvPr id="2" name="Slide Image Placeholder 1"/>
+          <p:cNvSpPr>
+            <a:spLocks noGrp="1"/>
+          </p:cNvSpPr>
+          <p:nvPr>
+            <p:ph type="sldImg" idx="2"/>
+          </p:nvPr>
+        </p:nvSpPr>
+        <p:spPr/>
+      </p:sp>
+      <p:sp>
+        <p:nvSpPr>
+          <p:cNvPr id="3" name="Notes Placeholder 2"/>
+          <p:cNvSpPr>
+            <a:spLocks noGrp="1"/>
+          </p:cNvSpPr>
+          <p:nvPr>
+            <p:ph type="body" idx="3" sz="quarter"/>
+          </p:nvPr>
+        </p:nvSpPr>
+        <p:spPr/>
+        <p:txBody>
+          <a:bodyPr/>
+          <a:lstStyle/>
+          <a:p>
+            <a:r>
+              <a:t>Kernbotschaft: RAG ist eine Methode, dem Modell zur Laufzeit gezielt externes Wissen bereitzustellen.</a:t>
+            </a:r>
+          </a:p>
+          <a:p/>
+          <a:p>
+            <a:r>
+              <a:t>Sprechtext: In diesem Abschnitt geht es zunächst um das Warum. Wir trennen dabei zwei Dinge: Das Sprachmodell formuliert die Antwort; das Retrieval entscheidet, welche Informationen es dafür überhaupt sieht.</a:t>
+            </a:r>
+          </a:p>
+          <a:p/>
+          <a:p>
+            <a:r>
+              <a:t>Publikumsfrage: Was fehlt einem reinen LLM, wenn wir eine aktuelle oder intern belegbare Antwort erwarten?</a:t>
+            </a:r>
+          </a:p>
+          <a:p/>
+          <a:p>
+            <a:r>
+              <a:t>Übergang: Drei typische blinde Flecken machen dieses Problem sichtbar.</a:t>
+            </a:r>
+          </a:p>
+        </p:txBody>
+      </p:sp>
+      <p:sp>
+        <p:nvSpPr>
+          <p:cNvPr id="4" name="Slide Number Placeholder 3"/>
+          <p:cNvSpPr>
+            <a:spLocks noGrp="1"/>
+          </p:cNvSpPr>
+          <p:nvPr>
+            <p:ph type="sldNum" idx="5" sz="quarter"/>
+          </p:nvPr>
+        </p:nvSpPr>
+        <p:spPr/>
+      </p:sp>
+    </p:spTree>
+  </p:cSld>
+  <p:clrMapOvr>
+    <a:masterClrMapping/>
+  </p:clrMapOvr>
+</p:notes>
+</file>
+
+<file path=ppt/notesSlides/notesSlide16.xml><?xml version="1.0" encoding="utf-8"?>
+<p:notes xmlns:a="http://schemas.openxmlformats.org/drawingml/2006/main" xmlns:p="http://schemas.openxmlformats.org/presentationml/2006/main" xmlns:r="http://schemas.openxmlformats.org/officeDocument/2006/relationships">
+  <p:cSld>
+    <p:spTree>
+      <p:nvGrpSpPr>
+        <p:cNvPr id="1" name=""/>
+        <p:cNvGrpSpPr/>
+        <p:nvPr/>
+      </p:nvGrpSpPr>
+      <p:grpSpPr>
+        <a:xfrm>
+          <a:off x="0" y="0"/>
+          <a:ext cx="0" cy="0"/>
+          <a:chOff x="0" y="0"/>
+          <a:chExt cx="0" cy="0"/>
+        </a:xfrm>
+      </p:grpSpPr>
+      <p:sp>
+        <p:nvSpPr>
+          <p:cNvPr id="2" name="Slide Image Placeholder 1"/>
+          <p:cNvSpPr>
+            <a:spLocks noGrp="1"/>
+          </p:cNvSpPr>
+          <p:nvPr>
+            <p:ph type="sldImg" idx="2"/>
+          </p:nvPr>
+        </p:nvSpPr>
+        <p:spPr/>
+      </p:sp>
+      <p:sp>
+        <p:nvSpPr>
+          <p:cNvPr id="3" name="Notes Placeholder 2"/>
+          <p:cNvSpPr>
+            <a:spLocks noGrp="1"/>
+          </p:cNvSpPr>
+          <p:nvPr>
+            <p:ph type="body" idx="3" sz="quarter"/>
+          </p:nvPr>
+        </p:nvSpPr>
+        <p:spPr/>
+        <p:txBody>
+          <a:bodyPr/>
+          <a:lstStyle/>
+          <a:p>
+            <a:r>
+              <a:t>Kernbotschaft: Ein reines LLM kennt nicht automatisch unsere aktuellen Daten, liefert keine verlässlichen Belege und kann nicht beliebig viel Kontext effizient verarbeiten.</a:t>
+            </a:r>
+          </a:p>
+          <a:p/>
+          <a:p>
+            <a:r>
+              <a:t>Sprechtext: Erstens endet das Wissen des Modells an seinen Trainingsdaten und umfasst keine vertraulichen Firmendokumente. Zweitens kann eine plausible Antwort sprachlich überzeugend, aber sachlich falsch oder nicht nachvollziehbar sein. Drittens ist „alles in den Prompt legen“ teuer und erzeugt Rauschen: Mehr Kontext ist nicht automatisch besserer Kontext.</a:t>
+            </a:r>
+          </a:p>
+          <a:p/>
+          <a:p>
+            <a:r>
+              <a:t>RAG macht das Modell nicht intelligenter. RAG steuert, welche Evidenz das Modell für eine konkrete Frage erhält.</a:t>
+            </a:r>
+          </a:p>
+          <a:p/>
+          <a:p>
+            <a:r>
+              <a:t>Übergang: Diese Steuerung kann man als drei grundlegende Kontextoperationen verstehen.</a:t>
+            </a:r>
+          </a:p>
+        </p:txBody>
+      </p:sp>
+      <p:sp>
+        <p:nvSpPr>
+          <p:cNvPr id="4" name="Slide Number Placeholder 3"/>
+          <p:cNvSpPr>
+            <a:spLocks noGrp="1"/>
+          </p:cNvSpPr>
+          <p:nvPr>
+            <p:ph type="sldNum" idx="5" sz="quarter"/>
+          </p:nvPr>
+        </p:nvSpPr>
+        <p:spPr/>
+      </p:sp>
+    </p:spTree>
+  </p:cSld>
+  <p:clrMapOvr>
+    <a:masterClrMapping/>
+  </p:clrMapOvr>
+</p:notes>
+</file>
+
+<file path=ppt/notesSlides/notesSlide17.xml><?xml version="1.0" encoding="utf-8"?>
+<p:notes xmlns:a="http://schemas.openxmlformats.org/drawingml/2006/main" xmlns:p="http://schemas.openxmlformats.org/presentationml/2006/main" xmlns:r="http://schemas.openxmlformats.org/officeDocument/2006/relationships">
+  <p:cSld>
+    <p:spTree>
+      <p:nvGrpSpPr>
+        <p:cNvPr id="1" name=""/>
+        <p:cNvGrpSpPr/>
+        <p:nvPr/>
+      </p:nvGrpSpPr>
+      <p:grpSpPr>
+        <a:xfrm>
+          <a:off x="0" y="0"/>
+          <a:ext cx="0" cy="0"/>
+          <a:chOff x="0" y="0"/>
+          <a:chExt cx="0" cy="0"/>
+        </a:xfrm>
+      </p:grpSpPr>
+      <p:sp>
+        <p:nvSpPr>
+          <p:cNvPr id="2" name="Slide Image Placeholder 1"/>
+          <p:cNvSpPr>
+            <a:spLocks noGrp="1"/>
+          </p:cNvSpPr>
+          <p:nvPr>
+            <p:ph type="sldImg" idx="2"/>
+          </p:nvPr>
+        </p:nvSpPr>
+        <p:spPr/>
+      </p:sp>
+      <p:sp>
+        <p:nvSpPr>
+          <p:cNvPr id="3" name="Notes Placeholder 2"/>
+          <p:cNvSpPr>
+            <a:spLocks noGrp="1"/>
+          </p:cNvSpPr>
+          <p:nvPr>
+            <p:ph type="body" idx="3" sz="quarter"/>
+          </p:nvPr>
+        </p:nvSpPr>
+        <p:spPr/>
+        <p:txBody>
+          <a:bodyPr/>
+          <a:lstStyle/>
+          <a:p>
+            <a:r>
+              <a:t>Kernbotschaft: Ein Vector RAG besteht aus einer vorbereitenden Ingest-Pipeline und einer Laufzeit-Pipeline für Fragen.</a:t>
+            </a:r>
+          </a:p>
+          <a:p/>
+          <a:p>
+            <a:r>
+              <a:t>Sprechtext: Links läuft der Ingest: Rohdateien werden extrahiert, bereinigt, in Chunks geteilt, in Embeddings übersetzt und in ChromaDB gespeichert. Rechts läuft die Anfrage: Auch die Frage wird mit demselben Embedding-Modell in einen Vektor übersetzt. Die Datenbank sucht ähnliche Chunks; diese werden als relevanter Kontext zusammen mit der Frage an das Chat-LLM gegeben.</a:t>
+            </a:r>
+          </a:p>
+          <a:p/>
+          <a:p>
+            <a:r>
+              <a:t>Wichtig: Embedding-LLM und Chat-LLM haben unterschiedliche Aufgaben. Das Embedding-Modell erzeugt vergleichbare Vektoren; das Chat-Modell formuliert die Antwort.</a:t>
+            </a:r>
+          </a:p>
+          <a:p/>
+          <a:p>
+            <a:r>
+              <a:t>Übergang: Auf der nächsten Folie lesen wir denselben Ablauf als klar getrennten Offline- und Online-Prozess.</a:t>
+            </a:r>
+          </a:p>
+          <a:p/>
+          <a:p>
+            <a:r>
+              <a:t>Kernbotschaft: Die aufwendige Dokumentverarbeitung geschieht offline; bei jeder Frage werden nur Query-Embedding, Suche und Generierung ausgeführt.</a:t>
+            </a:r>
+          </a:p>
+          <a:p/>
+          <a:p>
+            <a:r>
+              <a:t>Sprechtext: Der obere beziehungsweise linke Pfad wird beim Aufbau oder Aktualisieren des Index ausgeführt. Der Anfragepfad beginnt bei der Query, erzeugt ein Query-Embedding, sucht in der Vector Database und übergibt nur die ausgewählten Chunks an das LLM. Genau diese „Relevant Data“ sind der abgefragte Dokumentkontext, den wir später in der Evaluation vermessen.</a:t>
+            </a:r>
+          </a:p>
+          <a:p/>
+          <a:p>
+            <a:r>
+              <a:t>Publikumsfrage: An welchen Stellen kann trotz dieser Pipeline noch ein Fehler entstehen?</a:t>
+            </a:r>
+          </a:p>
+          <a:p/>
+          <a:p>
+            <a:r>
+              <a:t>Mögliche Antworten: schlechte PDF-Extraktion, ungünstige Chunk-Grenzen, unpassende Embeddings, falsche Rangfolge oder eine fehlerhafte Nutzung des richtigen Kontexts durch das Chat-LLM.</a:t>
+            </a:r>
+          </a:p>
+          <a:p/>
+          <a:p>
+            <a:r>
+              <a:t>Übergang: Diese Fehlerquellen bearbeiten wir im Repository in aufeinander aufbauenden Stufen.</a:t>
+            </a:r>
+          </a:p>
+        </p:txBody>
+      </p:sp>
+      <p:sp>
+        <p:nvSpPr>
+          <p:cNvPr id="4" name="Slide Number Placeholder 3"/>
+          <p:cNvSpPr>
+            <a:spLocks noGrp="1"/>
+          </p:cNvSpPr>
+          <p:nvPr>
+            <p:ph type="sldNum" idx="5" sz="quarter"/>
+          </p:nvPr>
+        </p:nvSpPr>
+        <p:spPr/>
+      </p:sp>
+    </p:spTree>
+  </p:cSld>
+  <p:clrMapOvr>
+    <a:masterClrMapping/>
+  </p:clrMapOvr>
+</p:notes>
+</file>
+
+<file path=ppt/notesSlides/notesSlide18.xml><?xml version="1.0" encoding="utf-8"?>
+<p:notes xmlns:a="http://schemas.openxmlformats.org/drawingml/2006/main" xmlns:p="http://schemas.openxmlformats.org/presentationml/2006/main" xmlns:r="http://schemas.openxmlformats.org/officeDocument/2006/relationships">
+  <p:cSld>
+    <p:spTree>
+      <p:nvGrpSpPr>
+        <p:cNvPr id="1" name=""/>
+        <p:cNvGrpSpPr/>
+        <p:nvPr/>
+      </p:nvGrpSpPr>
+      <p:grpSpPr>
+        <a:xfrm>
+          <a:off x="0" y="0"/>
+          <a:ext cx="0" cy="0"/>
+          <a:chOff x="0" y="0"/>
+          <a:chExt cx="0" cy="0"/>
+        </a:xfrm>
+      </p:grpSpPr>
+      <p:sp>
+        <p:nvSpPr>
+          <p:cNvPr id="2" name="Slide Image Placeholder 1"/>
+          <p:cNvSpPr>
+            <a:spLocks noGrp="1"/>
+          </p:cNvSpPr>
+          <p:nvPr>
+            <p:ph type="sldImg" idx="2"/>
+          </p:nvPr>
+        </p:nvSpPr>
+        <p:spPr/>
+      </p:sp>
+      <p:sp>
+        <p:nvSpPr>
+          <p:cNvPr id="3" name="Notes Placeholder 2"/>
+          <p:cNvSpPr>
+            <a:spLocks noGrp="1"/>
+          </p:cNvSpPr>
+          <p:nvPr>
+            <p:ph type="body" idx="3" sz="quarter"/>
+          </p:nvPr>
+        </p:nvSpPr>
+        <p:spPr/>
+        <p:txBody>
+          <a:bodyPr/>
+          <a:lstStyle/>
+          <a:p>
+            <a:r>
+              <a:t>Kernbotschaft: Im Hands-on bauen und testen wir die Pipeline selbst.</a:t>
+            </a:r>
+          </a:p>
+          <a:p/>
+          <a:p>
+            <a:r>
+              <a:t>Sprechtext: Bitte öffnet das Repository und prüft, ob die virtuelle Umgebung aktiv ist. VPN und API-Key müssen funktionieren; Zugangsdaten gehören ausschließlich in die lokale .env und nicht ins Git-Repository. Die Gesetzestexte und vorbereiteten Fragen bilden unseren gemeinsamen Testbestand.</a:t>
+            </a:r>
+          </a:p>
+          <a:p/>
+          <a:p>
+            <a:r>
+              <a:t>Publikumsfrage: Gibt es noch technische Blocker, bevor wir starten?</a:t>
+            </a:r>
+          </a:p>
+          <a:p/>
+          <a:p>
+            <a:r>
+              <a:t>Übergang: Wir beginnen mit der einfachsten lauffähigen Variante und erhöhen die Qualität schrittweise.</a:t>
+            </a:r>
+          </a:p>
+        </p:txBody>
+      </p:sp>
+      <p:sp>
+        <p:nvSpPr>
+          <p:cNvPr id="4" name="Slide Number Placeholder 3"/>
+          <p:cNvSpPr>
+            <a:spLocks noGrp="1"/>
+          </p:cNvSpPr>
+          <p:nvPr>
+            <p:ph type="sldNum" idx="5" sz="quarter"/>
+          </p:nvPr>
+        </p:nvSpPr>
+        <p:spPr/>
+      </p:sp>
+    </p:spTree>
+  </p:cSld>
+  <p:clrMapOvr>
+    <a:masterClrMapping/>
+  </p:clrMapOvr>
+</p:notes>
+</file>
+
+<file path=ppt/notesSlides/notesSlide19.xml><?xml version="1.0" encoding="utf-8"?>
+<p:notes xmlns:a="http://schemas.openxmlformats.org/drawingml/2006/main" xmlns:p="http://schemas.openxmlformats.org/presentationml/2006/main" xmlns:r="http://schemas.openxmlformats.org/officeDocument/2006/relationships">
+  <p:cSld>
+    <p:spTree>
+      <p:nvGrpSpPr>
+        <p:cNvPr id="1" name=""/>
+        <p:cNvGrpSpPr/>
+        <p:nvPr/>
+      </p:nvGrpSpPr>
+      <p:grpSpPr>
+        <a:xfrm>
+          <a:off x="0" y="0"/>
+          <a:ext cx="0" cy="0"/>
+          <a:chOff x="0" y="0"/>
+          <a:chExt cx="0" cy="0"/>
+        </a:xfrm>
+      </p:grpSpPr>
+      <p:sp>
+        <p:nvSpPr>
+          <p:cNvPr id="2" name="Slide Image Placeholder 1"/>
+          <p:cNvSpPr>
+            <a:spLocks noGrp="1"/>
+          </p:cNvSpPr>
+          <p:nvPr>
+            <p:ph type="sldImg" idx="2"/>
+          </p:nvPr>
+        </p:nvSpPr>
+        <p:spPr/>
+      </p:sp>
+      <p:sp>
+        <p:nvSpPr>
+          <p:cNvPr id="3" name="Notes Placeholder 2"/>
+          <p:cNvSpPr>
+            <a:spLocks noGrp="1"/>
+          </p:cNvSpPr>
+          <p:nvPr>
+            <p:ph type="body" idx="3" sz="quarter"/>
+          </p:nvPr>
+        </p:nvSpPr>
+        <p:spPr/>
+        <p:txBody>
+          <a:bodyPr/>
+          <a:lstStyle/>
+          <a:p>
+            <a:r>
+              <a:t>Kernbotschaft: Advanced RAG beginnt dort, wo wir Retrieval nicht mehr als einzelne Vektorsuche betrachten.</a:t>
+            </a:r>
+          </a:p>
+          <a:p/>
+          <a:p>
+            <a:r>
+              <a:t>Sprechtext: Nach dem Baseline-RAG untersuchen wir drei Hebel: bessere Chunk-Grenzen, eine bessere Rangfolge vorhandener Kandidaten und zusätzliche lexikalische beziehungsweise graphbasierte Signale. Wichtig ist, jede zusätzliche Komplexität gegen dieselben Fragen und Metriken zu prüfen.</a:t>
+            </a:r>
+          </a:p>
+          <a:p/>
+          <a:p>
+            <a:r>
+              <a:t>Übergang: Der erste und oft unterschätzte Hebel ist das Chunking.</a:t>
+            </a:r>
+          </a:p>
+        </p:txBody>
+      </p:sp>
+      <p:sp>
+        <p:nvSpPr>
+          <p:cNvPr id="4" name="Slide Number Placeholder 3"/>
+          <p:cNvSpPr>
+            <a:spLocks noGrp="1"/>
+          </p:cNvSpPr>
+          <p:nvPr>
+            <p:ph type="sldNum" idx="5" sz="quarter"/>
+          </p:nvPr>
+        </p:nvSpPr>
+        <p:spPr/>
       </p:sp>
     </p:spTree>
   </p:cSld>
@@ -1216,25 +1852,55 @@
           <a:lstStyle/>
           <a:p>
             <a:r>
-              <a:t>Context Engineering ist die bewusste Zusammenstellung dessen, was das Modell für die aktuelle Anfrage sieht. RAG liefert relevante Dokument-Chunks. MCP-Tools stellen aktuelle Daten bereit oder führen Aktionen aus. Skills aktivieren spezialisierte Anweisungen und Workflows. Das Kontextfenster enthält schließlich Frage, Verlauf und die ausgewählten Inhalte.</a:t>
-            </a:r>
-          </a:p>
-          <a:p>
-            <a:endParaRPr/>
-          </a:p>
-          <a:p>
-            <a:r>
-              <a:t>[Sources]</a:t>
-            </a:r>
-          </a:p>
-          <a:p>
-            <a:r>
-              <a:t>- Workshop - RAG (Retrieval Augmented Generation), Confluence, Seite 321455241</a:t>
-            </a:r>
-          </a:p>
-          <a:p>
-            <a:r>
-              <a:t>- RAG-Workshop Repository README.md</a:t>
+              <a:t>Kernbotschaft: RAG, MCP, Skills und große Kontextfenster lösen unterschiedliche Aufgaben im Context Engineering.</a:t>
+            </a:r>
+          </a:p>
+          <a:p/>
+          <a:p>
+            <a:r>
+              <a:t>Sprechtext: RAG ruft relevante Dokument-Chunks bei Bedarf ab. MCP macht Datenquellen oder Aktionen über standardisierte Connectoren verfügbar. Skills bündeln spezialisierte Anweisungen und Arbeitsabläufe, die nur bei Bedarf geladen werden. Ein großes Kontextfenster kann viel Material direkt aufnehmen, ist aber häufig die teuerste und unpräziseste Brute-Force-Variante.</a:t>
+            </a:r>
+          </a:p>
+          <a:p/>
+          <a:p>
+            <a:r>
+              <a:t>Wichtig: Ein Skill ist nicht einfach eine Wissensdatenbank. Er beschreibt vor allem, wie eine Aufgabe ausgeführt werden soll; RAG liefert dagegen die konkreten Dokumentinhalte.</a:t>
+            </a:r>
+          </a:p>
+          <a:p/>
+          <a:p>
+            <a:r>
+              <a:t>Übergang: Auf der nächsten Folie trennen wir noch genauer zwischen Anweisung und bereitgestelltem Kontext.</a:t>
+            </a:r>
+          </a:p>
+          <a:p/>
+          <a:p>
+            <a:r>
+              <a:t>Kernbotschaft: Der Systemprompt greift nicht selbst auf Dokumente zu – er legt Regeln fest, nach denen das Modell den bereitgestellten Kontext verwendet.</a:t>
+            </a:r>
+          </a:p>
+          <a:p/>
+          <a:p>
+            <a:r>
+              <a:t>Sprechtext: Diese Folie eignet sich als Publikumsfrage: „Worauf greift der Systemprompt zu?“ Die präzise Antwort lautet: Er greift nicht aktiv zu. Der Systemprompt ist eine Anweisung, zum Beispiel „Antworte nur anhand des Kontexts und nenne Quellen“. Erst die Anwendung beziehungsweise das Retrieval lädt passende Gesetzes-Chunks und fügt sie als Kontext in den Modellaufruf ein.</a:t>
+            </a:r>
+          </a:p>
+          <a:p/>
+          <a:p>
+            <a:r>
+              <a:t>Publikumsfrage: Was passiert, wenn der Systemprompt korrekt ist, aber Retrieval den falschen Artikel liefert?</a:t>
+            </a:r>
+          </a:p>
+          <a:p/>
+          <a:p>
+            <a:r>
+              <a:t>Erwartete Antwort: Das Modell kann die korrekte Information nicht zuverlässig nutzen; Prompting ersetzt kein gutes Retrieval.</a:t>
+            </a:r>
+          </a:p>
+          <a:p/>
+          <a:p>
+            <a:r>
+              <a:t>Übergang: Jetzt verfolgen wir den Datenfluss eines Vector RAGs von den Rohdaten bis zur Antwort.</a:t>
             </a:r>
           </a:p>
         </p:txBody>
@@ -1270,6 +1936,94 @@
         <p14:creationId xmlns:p14="http://schemas.microsoft.com/office/powerpoint/2010/main" val="2100833005"/>
       </p:ext>
     </p:extLst>
+  </p:cSld>
+  <p:clrMapOvr>
+    <a:masterClrMapping/>
+  </p:clrMapOvr>
+</p:notes>
+</file>
+
+<file path=ppt/notesSlides/notesSlide20.xml><?xml version="1.0" encoding="utf-8"?>
+<p:notes xmlns:a="http://schemas.openxmlformats.org/drawingml/2006/main" xmlns:p="http://schemas.openxmlformats.org/presentationml/2006/main" xmlns:r="http://schemas.openxmlformats.org/officeDocument/2006/relationships">
+  <p:cSld>
+    <p:spTree>
+      <p:nvGrpSpPr>
+        <p:cNvPr id="1" name=""/>
+        <p:cNvGrpSpPr/>
+        <p:nvPr/>
+      </p:nvGrpSpPr>
+      <p:grpSpPr>
+        <a:xfrm>
+          <a:off x="0" y="0"/>
+          <a:ext cx="0" cy="0"/>
+          <a:chOff x="0" y="0"/>
+          <a:chExt cx="0" cy="0"/>
+        </a:xfrm>
+      </p:grpSpPr>
+      <p:sp>
+        <p:nvSpPr>
+          <p:cNvPr id="2" name="Slide Image Placeholder 1"/>
+          <p:cNvSpPr>
+            <a:spLocks noGrp="1"/>
+          </p:cNvSpPr>
+          <p:nvPr>
+            <p:ph type="sldImg" idx="2"/>
+          </p:nvPr>
+        </p:nvSpPr>
+        <p:spPr/>
+      </p:sp>
+      <p:sp>
+        <p:nvSpPr>
+          <p:cNvPr id="3" name="Notes Placeholder 2"/>
+          <p:cNvSpPr>
+            <a:spLocks noGrp="1"/>
+          </p:cNvSpPr>
+          <p:nvPr>
+            <p:ph type="body" idx="3" sz="quarter"/>
+          </p:nvPr>
+        </p:nvSpPr>
+        <p:spPr/>
+        <p:txBody>
+          <a:bodyPr/>
+          <a:lstStyle/>
+          <a:p>
+            <a:r>
+              <a:t>Kernbotschaft: Die Teilnehmenden sollen die Pipeline jetzt nicht nur ausführen, sondern ihre Qualitätsentscheidungen begründen können.</a:t>
+            </a:r>
+          </a:p>
+          <a:p/>
+          <a:p>
+            <a:r>
+              <a:t>Sprechtext: Vielen Dank. Wir haben aus Schweizer Gesetzestexten eine nachvollziehbare RAG-Pipeline aufgebaut, mehrere Retrieval-Varianten verglichen und gesehen, warum gute Treffer noch keine perfekte Antwort garantieren. Die wichtigsten Artefakte sind der Code, die vorbereiteten Fragen und die Evaluationsberichte im Repository.</a:t>
+            </a:r>
+          </a:p>
+          <a:p/>
+          <a:p>
+            <a:r>
+              <a:t>Mögliche Abschlussfragen an das Publikum: Wo würdet ihr RAG in eurem Umfeld einsetzen? Welche Daten- oder Compliance-Anforderungen wären dort kritisch? Welche Metrik fehlt euch für eine produktive Entscheidung?</a:t>
+            </a:r>
+          </a:p>
+          <a:p/>
+          <a:p>
+            <a:r>
+              <a:t>Hinweis: Bei einer Live-Demo am Ende lieber eine bereits evaluierte Frage verwenden und gemeinsam Kontext, Quellen und Antwort vergleichen.</a:t>
+            </a:r>
+          </a:p>
+        </p:txBody>
+      </p:sp>
+      <p:sp>
+        <p:nvSpPr>
+          <p:cNvPr id="4" name="Slide Number Placeholder 3"/>
+          <p:cNvSpPr>
+            <a:spLocks noGrp="1"/>
+          </p:cNvSpPr>
+          <p:nvPr>
+            <p:ph type="sldNum" idx="5" sz="quarter"/>
+          </p:nvPr>
+        </p:nvSpPr>
+        <p:spPr/>
+      </p:sp>
+    </p:spTree>
   </p:cSld>
   <p:clrMapOvr>
     <a:masterClrMapping/>
@@ -1327,12 +2081,28 @@
           <a:lstStyle/>
           <a:p>
             <a:r>
-              <a:t>Das Repository ist bewusst stufenweise aufgebaut. rag-1 zeigt nur den Modellaufruf. rag-2 ergänzt Fixed-Size-Chunking, Chroma und klassisches Vector Retrieval. rag-3 führt strukturorientiertes Legal-Chunking sowie optionales Cross-Encoder-Reranking ein. rag-4 ergänzt hybrides Retrieval und Graph-Nachbarn. evaluate.py vergleicht Retrieval, Antwortqualität und Tokenverbrauch. Die Stufen sind Lernschritte und keine konkurrierenden Produktversionen.</a:t>
-            </a:r>
-          </a:p>
-          <a:p>
-            <a:endParaRPr/>
-          </a:p>
+              <a:t>Kernbotschaft: Jede Projektstufe ergänzt genau einen neuen Qualitätshebel – und die Evaluation macht den Effekt sichtbar.</a:t>
+            </a:r>
+          </a:p>
+          <a:p/>
+          <a:p>
+            <a:r>
+              <a:t>Sprechtext: Stage 1 zeigt den reinen Modellaufruf ohne Retrieval. Stage 2 ergänzt Fixed-Size-Chunking und Vector Search. Stage 3 führt strukturorientiertes Chunking und anschließend Reranking ein. Stage 4 kombiniert semantische und lexikalische Suche mit Artikelauflösung und Graph-Nachbarn. evaluate.py kann die Methoden kumulativ ausführen, sodass nach jeder Verbesserung die bisherigen Varianten als Vergleich erhalten bleiben.</a:t>
+            </a:r>
+          </a:p>
+          <a:p/>
+          <a:p>
+            <a:r>
+              <a:t>Hinweis für die Demo: Die Collections und Embeddings müssen vor dem jeweiligen Chat- oder Evaluationslauf aufgebaut sein. VPN, API-Key und die konfigurierte .env sind erforderlich.</a:t>
+            </a:r>
+          </a:p>
+          <a:p/>
+          <a:p>
+            <a:r>
+              <a:t>Übergang: Nun wechseln wir vom Konzept in den praktischen Teil.</a:t>
+            </a:r>
+          </a:p>
+          <a:p/>
           <a:p>
             <a:r>
               <a:t>[Sources]</a:t>
@@ -1341,31 +2111,6 @@
           <a:p>
             <a:r>
               <a:t>- C:/Users/mehlst/Documents/RAG-Workshop/README.md</a:t>
-            </a:r>
-          </a:p>
-          <a:p>
-            <a:r>
-              <a:t>- C:/Users/mehlst/Documents/RAG-Workshop/Workshop2026-RAG-Workshop-Script.txt</a:t>
-            </a:r>
-          </a:p>
-          <a:p>
-            <a:r>
-              <a:t>- C:/Users/mehlst/Documents/RAG-Workshop/rag-1-chat.py</a:t>
-            </a:r>
-          </a:p>
-          <a:p>
-            <a:r>
-              <a:t>- C:/Users/mehlst/Documents/RAG-Workshop/rag-2a-ingest.py</a:t>
-            </a:r>
-          </a:p>
-          <a:p>
-            <a:r>
-              <a:t>- C:/Users/mehlst/Documents/RAG-Workshop/rag-3a-ingest.py</a:t>
-            </a:r>
-          </a:p>
-          <a:p>
-            <a:r>
-              <a:t>- C:/Users/mehlst/Documents/RAG-Workshop/rag-4b-chat.py</a:t>
             </a:r>
           </a:p>
           <a:p>
@@ -1451,128 +2196,50 @@
           <a:bodyPr/>
           <a:lstStyle/>
           <a:p>
-            <a:pPr marL="0" indent="0">
-              <a:buNone/>
-            </a:pPr>
-            <a:r>
-              <a:rPr lang="de-DE" dirty="0"/>
-              <a:t>Semantische Chunking in unserer Implementierung:</a:t>
-            </a:r>
-          </a:p>
-          <a:p>
-            <a:r>
-              <a:rPr lang="de-DE" dirty="0"/>
-              <a:t>So funktioniert es:</a:t>
-            </a:r>
-          </a:p>
-          <a:p>
-            <a:r>
-              <a:rPr lang="de-DE" dirty="0" err="1"/>
-              <a:t>Markdown</a:t>
-            </a:r>
-            <a:r>
-              <a:rPr lang="de-DE" dirty="0"/>
-              <a:t> wird in Blöcke beziehungsweise Absätze zerlegt.</a:t>
-            </a:r>
-          </a:p>
-          <a:p>
-            <a:r>
-              <a:rPr lang="de-DE" dirty="0"/>
-              <a:t>PDF-Seitenmarker, Inhaltsverzeichnisse und isolierte Quellenfragmente werden entfernt.</a:t>
-            </a:r>
-          </a:p>
-          <a:p>
-            <a:r>
-              <a:rPr lang="de-DE" dirty="0"/>
-              <a:t>Eine Zeile mit </a:t>
-            </a:r>
-            <a:r>
-              <a:rPr lang="de-DE" sz="1800" kern="1200" dirty="0">
-                <a:solidFill>
-                  <a:schemeClr val="tx1"/>
-                </a:solidFill>
-                <a:latin typeface="+mn-lt"/>
-                <a:ea typeface="+mn-ea"/>
-                <a:cs typeface="+mn-cs"/>
-              </a:rPr>
-              <a:t>Art. &lt;Nummer&gt;</a:t>
-            </a:r>
-            <a:r>
-              <a:rPr lang="de-DE" dirty="0"/>
-              <a:t> beginnt einen neuen Artikel-Chunk.</a:t>
-            </a:r>
-          </a:p>
-          <a:p>
-            <a:r>
-              <a:rPr lang="de-DE" dirty="0"/>
-              <a:t>Ein Artikel bleibt möglichst vollständig zusammen.</a:t>
-            </a:r>
-          </a:p>
-          <a:p>
-            <a:r>
-              <a:rPr lang="de-DE" dirty="0"/>
-              <a:t>Ist ein Artikel zu groß, wird bevorzugt getrennt an:</a:t>
-            </a:r>
-          </a:p>
-          <a:p>
-            <a:pPr lvl="1"/>
-            <a:r>
-              <a:rPr lang="de-DE" dirty="0"/>
-              <a:t>Absätzen</a:t>
-            </a:r>
-          </a:p>
-          <a:p>
-            <a:pPr lvl="1"/>
-            <a:r>
-              <a:rPr lang="de-DE" dirty="0"/>
-              <a:t>nummerierten Bestimmungen</a:t>
-            </a:r>
-          </a:p>
-          <a:p>
-            <a:pPr lvl="1"/>
-            <a:r>
-              <a:rPr lang="de-DE" dirty="0"/>
-              <a:t>Satzgrenzen</a:t>
-            </a:r>
-          </a:p>
-          <a:p>
-            <a:pPr lvl="1"/>
-            <a:r>
-              <a:rPr lang="de-DE" dirty="0"/>
-              <a:t>erst im Notfall an Leerzeichen beziehungsweise Zeichen</a:t>
-            </a:r>
-          </a:p>
-          <a:p>
-            <a:r>
-              <a:rPr lang="de-DE" dirty="0"/>
-              <a:t>Fortsetzungen erhalten einen Präfix wie:</a:t>
-            </a:r>
-          </a:p>
-          <a:p>
-            <a:pPr rtl="0"/>
-            <a:r>
-              <a:rPr lang="de-DE" sz="1800" kern="1200" dirty="0">
-                <a:solidFill>
-                  <a:schemeClr val="tx1"/>
-                </a:solidFill>
-                <a:latin typeface="+mn-lt"/>
-                <a:ea typeface="+mn-ea"/>
-                <a:cs typeface="+mn-cs"/>
-              </a:rPr>
-              <a:t>Art. 13 (Fortsetzung)</a:t>
-            </a:r>
-          </a:p>
-          <a:p>
-            <a:r>
-              <a:rPr lang="de-DE" dirty="0"/>
-              <a:t>Kleine Nicht-Artikel-Blöcke werden bis zum Größenbudget zusammengeführt.</a:t>
-            </a:r>
-          </a:p>
-          <a:p>
-            <a:endParaRPr lang="de-DE" dirty="0"/>
-          </a:p>
-          <a:p>
-            <a:endParaRPr dirty="0"/>
+            <a:r>
+              <a:t>Kernbotschaft: Chunking bestimmt, welche Bedeutungseinheiten später überhaupt als Treffer zurückkommen können.</a:t>
+            </a:r>
+          </a:p>
+          <a:p/>
+          <a:p>
+            <a:r>
+              <a:t>Sprechtext: Links sehen wir Fixed-Size-Chunking mit einem starren Budget von 800 Zeichen. Die Grenze kann mitten in einem Satz oder direkt vor dem nächsten Artikel liegen. Dadurch verliert ein Treffer Kontext oder vermischt mehrere Artikel. Rechts orientiert sich unser verbessertes Verfahren primär an Markdown- und Artikelüberschriften. Übergroße Artikel werden zusätzlich an Satzgrenzen geteilt; kleine zusammengehörige Blöcke werden bis zum Budget verbunden.</a:t>
+            </a:r>
+          </a:p>
+          <a:p/>
+          <a:p>
+            <a:r>
+              <a:t>Präzisierung: Unser Budget beträgt 800 Zeichen, nicht 800 Tokens. Das Verfahren ist deshalb besser als „strukturorientiertes Chunking“ beschrieben; es ist kein LLM-basiertes semantisches Chunking.</a:t>
+            </a:r>
+          </a:p>
+          <a:p/>
+          <a:p>
+            <a:r>
+              <a:t>Zusätzlich entfernen wir typisches PDF-Rauschen wie Seitenmarker, Inhaltsverzeichnisse und isolierte Fundstellenblöcke. Quellen, die zum Gesetzesinhalt gehören, werden nicht pauschal gelöscht.</a:t>
+            </a:r>
+          </a:p>
+          <a:p/>
+          <a:p>
+            <a:r>
+              <a:t>Publikumsfrage: Welche Seite würdet ihr für die Suche nach Art. 335b OR bevorzugen – und warum?</a:t>
+            </a:r>
+          </a:p>
+          <a:p/>
+          <a:p>
+            <a:r>
+              <a:t>Übergang: Gute Chunks erzeugen bessere Kandidaten. Als Nächstes verbessern wir deren Reihenfolge.</a:t>
+            </a:r>
+          </a:p>
+          <a:p/>
+          <a:p>
+            <a:r>
+              <a:t>[Sources]</a:t>
+            </a:r>
+          </a:p>
+          <a:p>
+            <a:r>
+              <a:t>- C:/Users/mehlst/Documents/RAG-Workshop/rag-3a-ingest.py</a:t>
+            </a:r>
           </a:p>
         </p:txBody>
       </p:sp>
@@ -1652,200 +2319,49 @@
           <a:bodyPr/>
           <a:lstStyle/>
           <a:p>
-            <a:pPr marL="0" marR="0" lvl="0" indent="0" algn="l" defTabSz="914400" rtl="0" eaLnBrk="1" fontAlgn="auto" latinLnBrk="0" hangingPunct="1">
-              <a:lnSpc>
-                <a:spcPct val="100000"/>
-              </a:lnSpc>
-              <a:spcBef>
-                <a:spcPts val="0"/>
-              </a:spcBef>
-              <a:spcAft>
-                <a:spcPts val="1000"/>
-              </a:spcAft>
-              <a:buClrTx/>
-              <a:buSzTx/>
-              <a:buFont typeface="Arial" panose="020B0604020202020204" pitchFamily="34" charset="0"/>
-              <a:buNone/>
-              <a:tabLst/>
-              <a:defRPr/>
-            </a:pPr>
-            <a:r>
-              <a:rPr lang="de-CH" sz="1800" kern="1200" dirty="0">
-                <a:solidFill>
-                  <a:schemeClr val="tx1"/>
-                </a:solidFill>
-                <a:latin typeface="+mn-lt"/>
-                <a:ea typeface="+mn-ea"/>
-                <a:cs typeface="+mn-cs"/>
-              </a:rPr>
-              <a:t>BAAI/bge-reranker-v2-m3 ist unser Cross-Encoder</a:t>
-            </a:r>
-          </a:p>
-          <a:p>
-            <a:pPr marL="0" marR="0" lvl="0" indent="0" algn="l" defTabSz="914400" rtl="0" eaLnBrk="1" fontAlgn="auto" latinLnBrk="0" hangingPunct="1">
-              <a:lnSpc>
-                <a:spcPct val="100000"/>
-              </a:lnSpc>
-              <a:spcBef>
-                <a:spcPts val="0"/>
-              </a:spcBef>
-              <a:spcAft>
-                <a:spcPts val="1000"/>
-              </a:spcAft>
-              <a:buClrTx/>
-              <a:buSzTx/>
-              <a:buFont typeface="Arial" panose="020B0604020202020204" pitchFamily="34" charset="0"/>
-              <a:buNone/>
-              <a:tabLst/>
-              <a:defRPr/>
-            </a:pPr>
-            <a:endParaRPr lang="de-DE" dirty="0"/>
-          </a:p>
-          <a:p>
-            <a:r>
-              <a:rPr dirty="0"/>
-              <a:t>rag-3c holt </a:t>
-            </a:r>
-            <a:r>
-              <a:rPr dirty="0" err="1"/>
-              <a:t>zunächst</a:t>
-            </a:r>
-            <a:r>
-              <a:rPr dirty="0"/>
-              <a:t> Vector-</a:t>
-            </a:r>
-            <a:r>
-              <a:rPr dirty="0" err="1"/>
-              <a:t>Kandidaten</a:t>
-            </a:r>
-            <a:r>
-              <a:rPr dirty="0"/>
-              <a:t> und </a:t>
-            </a:r>
-            <a:r>
-              <a:rPr dirty="0" err="1"/>
-              <a:t>bewertet</a:t>
-            </a:r>
-            <a:r>
-              <a:rPr dirty="0"/>
-              <a:t> </a:t>
-            </a:r>
-            <a:r>
-              <a:rPr dirty="0" err="1"/>
-              <a:t>anschließend</a:t>
-            </a:r>
-            <a:r>
-              <a:rPr dirty="0"/>
-              <a:t> Frage und Chunk </a:t>
-            </a:r>
-            <a:r>
-              <a:rPr dirty="0" err="1"/>
-              <a:t>gemeinsam</a:t>
-            </a:r>
-            <a:r>
-              <a:rPr dirty="0"/>
-              <a:t> </a:t>
-            </a:r>
-            <a:r>
-              <a:rPr dirty="0" err="1"/>
-              <a:t>mit</a:t>
-            </a:r>
-            <a:r>
-              <a:rPr dirty="0"/>
-              <a:t> </a:t>
-            </a:r>
-            <a:r>
-              <a:rPr dirty="0" err="1"/>
-              <a:t>einem</a:t>
-            </a:r>
-            <a:r>
-              <a:rPr dirty="0"/>
-              <a:t> Cross-Encoder. Nur die </a:t>
-            </a:r>
-            <a:r>
-              <a:rPr dirty="0" err="1"/>
-              <a:t>bestbewerteten</a:t>
-            </a:r>
-            <a:r>
-              <a:rPr dirty="0"/>
-              <a:t> Chunks </a:t>
-            </a:r>
-            <a:r>
-              <a:rPr dirty="0" err="1"/>
-              <a:t>gehen</a:t>
-            </a:r>
-            <a:r>
-              <a:rPr dirty="0"/>
-              <a:t> in den Prompt. Reranking </a:t>
-            </a:r>
-            <a:r>
-              <a:rPr dirty="0" err="1"/>
-              <a:t>verbessert</a:t>
-            </a:r>
-            <a:r>
-              <a:rPr dirty="0"/>
-              <a:t> </a:t>
-            </a:r>
-            <a:r>
-              <a:rPr dirty="0" err="1"/>
-              <a:t>Präzision</a:t>
-            </a:r>
-            <a:r>
-              <a:rPr dirty="0"/>
-              <a:t> und </a:t>
-            </a:r>
-            <a:r>
-              <a:rPr dirty="0" err="1"/>
-              <a:t>Reihenfolge</a:t>
-            </a:r>
-            <a:r>
-              <a:rPr dirty="0"/>
-              <a:t>, </a:t>
-            </a:r>
-            <a:r>
-              <a:rPr dirty="0" err="1"/>
-              <a:t>aber</a:t>
-            </a:r>
-            <a:r>
-              <a:rPr dirty="0"/>
-              <a:t> </a:t>
-            </a:r>
-            <a:r>
-              <a:rPr dirty="0" err="1"/>
-              <a:t>nicht</a:t>
-            </a:r>
-            <a:r>
-              <a:rPr dirty="0"/>
-              <a:t> den </a:t>
-            </a:r>
-            <a:r>
-              <a:rPr dirty="0" err="1"/>
-              <a:t>Kandidaten</a:t>
-            </a:r>
-            <a:r>
-              <a:rPr dirty="0"/>
-              <a:t>-Recall.</a:t>
-            </a:r>
-          </a:p>
-          <a:p>
-            <a:endParaRPr dirty="0"/>
-          </a:p>
-          <a:p>
-            <a:r>
-              <a:rPr dirty="0"/>
+            <a:r>
+              <a:t>Kernbotschaft: Reranking sortiert gefundene Kandidaten neu; es kann keinen fehlenden Artikel herbeizaubern.</a:t>
+            </a:r>
+          </a:p>
+          <a:p/>
+          <a:p>
+            <a:r>
+              <a:t>Sprechtext: Die Vektorsuche holt zunächst eine größere Kandidatenmenge. Unser Cross-Encoder BAAI/bge-reranker-v2-m3 liest Frage und Chunk gemeinsam und bewertet ihre Relevanz genauer als der reine Vektorabstand. Für die Evaluation bleiben nach dem Reranking sechs Chunks im gemeinsamen Kontextbudget; der interaktive Chat verwendet standardmäßig vier.</a:t>
+            </a:r>
+          </a:p>
+          <a:p/>
+          <a:p>
+            <a:r>
+              <a:t>Der wichtigste Unterschied: Ein Bi-Encoder berechnet Dokument- und Query-Vektoren getrennt und ist schnell. Ein Cross-Encoder betrachtet beide Texte gemeinsam und ist präziser, aber langsamer. Deshalb wird er erst auf einer kleinen Kandidatenliste eingesetzt.</a:t>
+            </a:r>
+          </a:p>
+          <a:p/>
+          <a:p>
+            <a:r>
+              <a:t>Publikumsfrage: Was passiert, wenn Art. 1 OR in den ersten Kandidaten überhaupt nicht enthalten ist?</a:t>
+            </a:r>
+          </a:p>
+          <a:p/>
+          <a:p>
+            <a:r>
+              <a:t>Erwartete Antwort: Der Reranker kann ihn nicht auswählen; dafür brauchen wir besseren Recall im vorgelagerten Retrieval.</a:t>
+            </a:r>
+          </a:p>
+          <a:p/>
+          <a:p>
+            <a:r>
+              <a:t>Übergang: Genau dort setzt die hybride und graphbasierte Suche an.</a:t>
+            </a:r>
+          </a:p>
+          <a:p/>
+          <a:p>
+            <a:r>
               <a:t>[Sources]</a:t>
             </a:r>
           </a:p>
           <a:p>
             <a:r>
-              <a:rPr dirty="0"/>
               <a:t>- C:/Users/mehlst/Documents/RAG-Workshop/rag-3c-chat-rerank.py</a:t>
-            </a:r>
-          </a:p>
-          <a:p>
-            <a:r>
-              <a:rPr dirty="0"/>
-              <a:t>- C:/Users/mehlst/Documents/RAG-Workshop/Workshop2026-RAG-Workshop-Script.txt</a:t>
             </a:r>
           </a:p>
         </p:txBody>
@@ -1927,45 +2443,48 @@
           <a:lstStyle/>
           <a:p>
             <a:r>
-              <a:rPr lang="de-CH" dirty="0" err="1"/>
-              <a:t>graph_retrieve</a:t>
-            </a:r>
-            <a:r>
-              <a:rPr lang="de-CH" dirty="0"/>
-              <a:t> kombiniert semantische Treffer mit lexikalischen Artikelkandidaten. </a:t>
-            </a:r>
-            <a:r>
-              <a:rPr lang="de-CH" dirty="0" err="1"/>
-              <a:t>Reciprocal</a:t>
-            </a:r>
-            <a:r>
-              <a:rPr lang="de-CH" dirty="0"/>
-              <a:t> Rank Fusion führt die Rankings zusammen. Erst danach werden Graph-Nachbarn und erkannte Artikelverweise ergänzt. Der Graph ersetzt die Suche nicht, sondern erweitert gute Seeds.</a:t>
-            </a:r>
-          </a:p>
-          <a:p>
-            <a:endParaRPr lang="de-CH" dirty="0"/>
-          </a:p>
-          <a:p>
-            <a:r>
-              <a:rPr lang="de-CH" dirty="0"/>
+              <a:t>Kernbotschaft: GraphRAG kombiniert mehrere Suchsignale, damit explizite Artikelangaben und strukturelle Beziehungen nicht von semantischer Ähnlichkeit verdrängt werden.</a:t>
+            </a:r>
+          </a:p>
+          <a:p/>
+          <a:p>
+            <a:r>
+              <a:t>Sprechtext: Zuerst holen wir semantische Vector-Treffer und lexikalische beziehungsweise BM25-Kandidaten. Reciprocal Rank Fusion führt beide Ranglisten robust zusammen, ohne die Rohscores direkt vergleichbar machen zu müssen. Explizite Referenzen wie „Art. 1 OR“ können zusätzlich auf eine konkrete Artikeldefinition aufgelöst werden. Danach ergänzen wir passende Graph-Nachbarn, etwa angrenzende Artikel oder erkannte Verweise.</a:t>
+            </a:r>
+          </a:p>
+          <a:p/>
+          <a:p>
+            <a:r>
+              <a:t>Der Graph ersetzt die Suche nicht. Er erweitert gute Seed-Treffer um strukturell verwandten Kontext. Das hilft besonders bei Fragen, die mehrere Artikel oder Erlasse verbinden.</a:t>
+            </a:r>
+          </a:p>
+          <a:p/>
+          <a:p>
+            <a:r>
+              <a:t>Publikumsfrage: Warum ist eine lexikalische Suche bei „Art. 1 OR“ oft zuverlässiger als reine semantische Ähnlichkeit?</a:t>
+            </a:r>
+          </a:p>
+          <a:p/>
+          <a:p>
+            <a:r>
+              <a:t>Übergang: Jetzt prüfen wir, ob diese zusätzliche Logik tatsächlich Recall, Rangfolge und Kontextbedarf verbessert.</a:t>
+            </a:r>
+          </a:p>
+          <a:p/>
+          <a:p>
+            <a:r>
               <a:t>[Sources]</a:t>
             </a:r>
           </a:p>
           <a:p>
             <a:r>
-              <a:rPr lang="de-CH" dirty="0"/>
               <a:t>- C:/Users/mehlst/Documents/RAG-Workshop/graph_retrieval.py</a:t>
             </a:r>
           </a:p>
           <a:p>
             <a:r>
-              <a:rPr lang="de-CH" dirty="0"/>
               <a:t>- C:/Users/mehlst/Documents/RAG-Workshop/rag-4b-chat.py</a:t>
             </a:r>
-          </a:p>
-          <a:p>
-            <a:endParaRPr dirty="0"/>
           </a:p>
         </p:txBody>
       </p:sp>
@@ -2121,12 +2640,34 @@
           <a:lstStyle/>
           <a:p>
             <a:r>
-              <a:t>Der vollständige Lauf umfasst sechs Fragen und ein gemeinsames Budget von sechs Chunks. GraphRAG erreicht mit 87,5 Prozent den höchsten Article Recall@K und verwendet durchschnittlich 802 Prompt-Kontext-Tokens. Der Reranker erzielt mit 0,68 die beste MRR. Diese Werte sind eine Workshop-Messung und keine allgemeine Benchmark.</a:t>
-            </a:r>
-          </a:p>
-          <a:p>
-            <a:endParaRPr/>
-          </a:p>
+              <a:t>Kernbotschaft: GraphRAG findet in diesem Workshop-Test die meisten erwarteten Artikel und benötigt gleichzeitig den kleinsten Prompt-Kontext; der Reranker liefert die beste frühe Rangposition.</a:t>
+            </a:r>
+          </a:p>
+          <a:p/>
+          <a:p>
+            <a:r>
+              <a:t>Sprechtext: Alle vier Methoden beantworten dieselben sechs Fragen mit demselben Kontextbudget von sechs Chunks. Article Recall@K misst, welcher Anteil aller erwarteten Artikel unter den K Treffern vorkommt. MRR – Mean Reciprocal Rank – belohnt eine frühe Position des ersten relevanten Artikels. Prompt-Kontext-Tokens zählen den tatsächlich in den Modellprompt eingefügten Dokumentkontext einschließlich Formatierung.</a:t>
+            </a:r>
+          </a:p>
+          <a:p/>
+          <a:p>
+            <a:r>
+              <a:t>Die Werte: Fixed erreicht 54 Prozent Recall, 0,43 MRR und 1.289 Tokens. Semantic erreicht 33 Prozent, 0,25 und 892 Tokens. Reranking erreicht 71 Prozent, 0,68 und 923 Tokens. GraphRAG erreicht 88 Prozent Recall, 0,52 MRR und 802 Tokens.</a:t>
+            </a:r>
+          </a:p>
+          <a:p/>
+          <a:p>
+            <a:r>
+              <a:t>Lesart: GraphRAG maximiert hier die Vollständigkeit bei kleinem Kontext. Reranking positioniert den ersten relevanten Treffer am besten. Diese sechs Fragen sind eine Workshop-Messung, keine allgemeine Benchmark.</a:t>
+            </a:r>
+          </a:p>
+          <a:p/>
+          <a:p>
+            <a:r>
+              <a:t>Übergang: Ein guter Retrieval-Treffer ist notwendig – aber beantwortet noch nicht, ob das LLM daraus eine vollständige und korrekt belegte Antwort erzeugt.</a:t>
+            </a:r>
+          </a:p>
+          <a:p/>
           <a:p>
             <a:r>
               <a:t>[Sources]</a:t>
@@ -2221,12 +2762,34 @@
           <a:lstStyle/>
           <a:p>
             <a:r>
-              <a:t>Im vollständigen Lauf erreicht GraphRAG 55,6 Prozent Faktenabdeckung und 66,7 Prozent Zitationsvollständigkeit. Fixed Vector erzielt trotz schwächerem Retrieval 61,1 Prozent Faktenabdeckung. Die Antwortmetriken schwanken, weil das LLM nicht deterministisch antwortet und trotz Quellenprompt falsche Artikel nennen kann. Retrieval und Generierung müssen deshalb getrennt bewertet werden.</a:t>
-            </a:r>
-          </a:p>
-          <a:p>
-            <a:endParaRPr/>
-          </a:p>
+              <a:t>Kernbotschaft: Retrieval-Qualität und Antwortqualität sind zwei getrennte Ebenen und müssen separat bewertet werden.</a:t>
+            </a:r>
+          </a:p>
+          <a:p/>
+          <a:p>
+            <a:r>
+              <a:t>Sprechtext: Die dunkelblauen Balken zeigen die Faktenabdeckung – auf Englisch Fact Coverage. Sie misst, welcher Anteil der zuvor definierten erforderlichen Fakten in der generierten Antwort enthalten ist. Die hellblauen beziehungsweise türkisen Balken zeigen die Zitationsvollständigkeit – Citation Completeness. Sie misst, welcher Anteil der erwarteten Artikelbezeichnungen in der Antwort zitiert wird.</a:t>
+            </a:r>
+          </a:p>
+          <a:p/>
+          <a:p>
+            <a:r>
+              <a:t>Im vollständigen Lauf erreicht GraphRAG 55,6 Prozent Faktenabdeckung und 66,7 Prozent Zitationsvollständigkeit. Fixed Vector erzielt trotz schwächerem Retrieval 61,1 Prozent Faktenabdeckung. Das ist kein Widerspruch: Das generierende LLM ist nicht vollständig deterministisch und kann vorhandenen Kontext unvollständig nutzen oder einen falschen Artikel nennen.</a:t>
+            </a:r>
+          </a:p>
+          <a:p/>
+          <a:p>
+            <a:r>
+              <a:t>Wichtig: Faktenabdeckung bewertet das Vorhandensein erwarteter Inhalte, nicht automatisch juristische Korrektheit jeder Aussage. Zitationsvollständigkeit sagt, ob erwartete Quellen genannt wurden; sie sagt allein noch nicht, ob die jeweilige Quelle die Aussage tatsächlich belegt.</a:t>
+            </a:r>
+          </a:p>
+          <a:p/>
+          <a:p>
+            <a:r>
+              <a:t>Übergang: Diese Ergebnisse bilden die Grundlage für die Gruppenarbeit: Wo würden wir als Nächstes investieren?</a:t>
+            </a:r>
+          </a:p>
+          <a:p/>
           <a:p>
             <a:r>
               <a:t>[Sources]</a:t>

</xml_diff>

<commit_message>
feat(evaluate): always run all four variants in one evaluation
The per-stage evaluation runs (--stage fixed/semantic/rerank and the
--methods override) are no longer needed for the workshop; the full run
already contains every variant. Drop the stage/method selection from
evaluate.py, tests and README, always evaluate fixed-vector,
semantic-vector, rerank and graph, and write the single report to
evaluation/report-graph.md (regenerated against the current indexes).
Remove the three obsolete per-stage reports.

Co-Authored-By: Claude Fable 5 <noreply@anthropic.com>
Claude-Session: https://claude.ai/code/session_01S2kGP2buE2HmxMttD3XczR
</commit_message>
<xml_diff>
--- a/RAG_Workshop.pptx
+++ b/RAG_Workshop.pptx
@@ -762,7 +762,7 @@
             <a:spLocks noGrp="1" noRot="1" noChangeAspect="1"/>
           </p:cNvSpPr>
           <p:nvPr>
-            <p:ph type="sldImg"/>
+            <p:ph type="sldImg" idx="2"/>
           </p:nvPr>
         </p:nvSpPr>
         <p:spPr>
@@ -779,7 +779,7 @@
             <a:spLocks noGrp="1"/>
           </p:cNvSpPr>
           <p:nvPr>
-            <p:ph type="body" idx="1"/>
+            <p:ph type="body" sz="quarter" idx="3"/>
           </p:nvPr>
         </p:nvSpPr>
         <p:spPr/>
@@ -788,25 +788,31 @@
           <a:lstStyle/>
           <a:p>
             <a:r>
-              <a:t>Kernbotschaft: LLM-Anwendungen erweitern, verdichten oder übersetzen Kontext – RAG ist besonders stark beim gezielten Verdichten.</a:t>
-            </a:r>
-          </a:p>
-          <a:p/>
-          <a:p>
-            <a:r>
-              <a:t>Sprechtext: Expansion bedeutet, aus einer kurzen Eingabe umfangreichen Output zu erzeugen. Kompression bedeutet, aus vielen möglichen Informationen nur die relevanten Belege in den Prompt zu nehmen. Translation meint die Umwandlung zwischen Repräsentationen, etwa Text zu Embeddings oder Dokumente zu strukturierten Metadaten. Unsere RAG-Pipeline kombiniert alle drei, aber ihr eigentlicher Nutzen liegt in der kontrollierten Auswahl von Kontext.</a:t>
-            </a:r>
-          </a:p>
-          <a:p/>
-          <a:p>
-            <a:r>
-              <a:t>Publikumsfrage: Welche dieser Operationen ist bei einer Frage wie „Was steht in Art. 1 OR?“ am wichtigsten?</a:t>
-            </a:r>
-          </a:p>
-          <a:p/>
-          <a:p>
-            <a:r>
-              <a:t>Übergang: RAG ist damit ein Teilgebiet von Context Engineering – aber nicht die einzige Variante.</a:t>
+              <a:t>Kernbotschaft: Heute bauen wir nicht nur einen Chatbot, sondern verstehen die Mechanik eines belastbaren RAG-Systems.</a:t>
+            </a:r>
+          </a:p>
+          <a:p>
+            <a:endParaRPr/>
+          </a:p>
+          <a:p>
+            <a:r>
+              <a:t>Sprechtext: Willkommen zum RAG-Workshop. Als durchgängiges Beispiel verwenden wir Schweizer Gesetzestexte. Dadurch können wir sehr konkret prüfen, ob ein System den richtigen Erlass und den richtigen Artikel findet, ob es Quellen nennt und wie viel Kontext es dafür benötigt. Am Ende sollt ihr die wichtigsten Qualitätshebel – Chunking, Retrieval, Reranking und Evaluation – bewusst auswählen können.</a:t>
+            </a:r>
+          </a:p>
+          <a:p>
+            <a:endParaRPr/>
+          </a:p>
+          <a:p>
+            <a:r>
+              <a:t>Wichtig: Die Demo erklärt technische Konzepte und ist keine Rechtsberatung.</a:t>
+            </a:r>
+          </a:p>
+          <a:p>
+            <a:endParaRPr/>
+          </a:p>
+          <a:p>
+            <a:r>
+              <a:t>Übergang: Schauen wir zuerst auf den Ablauf und das Ziel der kommenden 90 Minuten.</a:t>
             </a:r>
           </a:p>
         </p:txBody>
@@ -818,17 +824,10 @@
             <a:spLocks noGrp="1"/>
           </p:cNvSpPr>
           <p:nvPr>
-            <p:ph type="sldNum" idx="5"/>
+            <p:ph type="sldNum" sz="quarter" idx="5"/>
           </p:nvPr>
         </p:nvSpPr>
         <p:spPr/>
-        <p:txBody>
-          <a:bodyPr/>
-          <a:lstStyle/>
-          <a:p>
-            <a:endParaRPr/>
-          </a:p>
-        </p:txBody>
       </p:sp>
     </p:spTree>
   </p:cSld>
@@ -862,15 +861,10 @@
             <a:spLocks noGrp="1" noRot="1" noChangeAspect="1"/>
           </p:cNvSpPr>
           <p:nvPr>
-            <p:ph type="sldImg"/>
+            <p:ph type="sldImg" idx="2"/>
           </p:nvPr>
         </p:nvSpPr>
-        <p:spPr>
-          <a:xfrm>
-            <a:off x="1081088" y="617538"/>
-            <a:ext cx="4695825" cy="2641600"/>
-          </a:xfrm>
-        </p:spPr>
+        <p:spPr/>
       </p:sp>
       <p:sp>
         <p:nvSpPr>
@@ -879,7 +873,7 @@
             <a:spLocks noGrp="1"/>
           </p:cNvSpPr>
           <p:nvPr>
-            <p:ph type="body" idx="1"/>
+            <p:ph type="body" sz="quarter" idx="3"/>
           </p:nvPr>
         </p:nvSpPr>
         <p:spPr/>
@@ -888,31 +882,23 @@
           <a:lstStyle/>
           <a:p>
             <a:r>
-              <a:t>Kernbotschaft: Die Gruppen betrachten dieselbe Pipeline aus drei Perspektiven und müssen eine begründete Priorität formulieren.</a:t>
-            </a:r>
-          </a:p>
-          <a:p/>
-          <a:p>
-            <a:r>
-              <a:t>Sprechtext: Jede Gruppe bearbeitet ihr Wahlmodul anhand der bereitgestellten Fragen und Ergebnisse. Entscheidend ist nicht, möglichst viele Ideen zu sammeln, sondern eine konkrete Verbesserung mit erwarteter Wirkung, möglichem Nachteil und einer passenden Messgröße zu benennen.</a:t>
-            </a:r>
-          </a:p>
-          <a:p/>
-          <a:p>
-            <a:r>
-              <a:t>Für die Kurzpräsentation helfen drei Fragen: Welches Problem lösen wir? Welche Änderung schlagen wir vor? Woran erkennen wir, dass sie besser ist? Die Ergebnisvorstellung dauert maximal zwei Minuten pro Gruppe; die Arbeitszeit kann je nach Workshop-Zeitplan angepasst werden.</a:t>
-            </a:r>
-          </a:p>
-          <a:p/>
-          <a:p>
-            <a:r>
-              <a:t>Hinweis: Achtet darauf, Retrieval und Generierung nicht zu vermischen. Eine Maßnahme kann Recall verbessern, ohne die Antwortqualität automatisch im gleichen Maß zu erhöhen.</a:t>
-            </a:r>
-          </a:p>
-          <a:p/>
-          <a:p>
-            <a:r>
-              <a:t>Übergang: Neben Algorithmen beeinflusst auch die Frameworkwahl, wie schnell und kontrolliert wir solche Änderungen umsetzen können.</a:t>
+              <a:t>Kernbotschaft: Advanced RAG beginnt dort, wo wir Retrieval nicht mehr als einzelne Vektorsuche betrachten.</a:t>
+            </a:r>
+          </a:p>
+          <a:p>
+            <a:endParaRPr/>
+          </a:p>
+          <a:p>
+            <a:r>
+              <a:t>Sprechtext: Nach dem Baseline-RAG untersuchen wir drei Hebel: bessere Chunk-Grenzen, eine bessere Rangfolge vorhandener Kandidaten und zusätzliche lexikalische beziehungsweise graphbasierte Signale. Wichtig ist, jede zusätzliche Komplexität gegen dieselben Fragen und Metriken zu prüfen.</a:t>
+            </a:r>
+          </a:p>
+          <a:p>
+            <a:endParaRPr/>
+          </a:p>
+          <a:p>
+            <a:r>
+              <a:t>Übergang: Der erste und oft unterschätzte Hebel ist das Chunking.</a:t>
             </a:r>
           </a:p>
         </p:txBody>
@@ -924,17 +910,10 @@
             <a:spLocks noGrp="1"/>
           </p:cNvSpPr>
           <p:nvPr>
-            <p:ph type="sldNum" idx="5"/>
+            <p:ph type="sldNum" sz="quarter" idx="5"/>
           </p:nvPr>
         </p:nvSpPr>
         <p:spPr/>
-        <p:txBody>
-          <a:bodyPr/>
-          <a:lstStyle/>
-          <a:p>
-            <a:endParaRPr/>
-          </a:p>
-        </p:txBody>
       </p:sp>
     </p:spTree>
   </p:cSld>
@@ -994,25 +973,60 @@
           <a:lstStyle/>
           <a:p>
             <a:r>
-              <a:t>Kernbotschaft: Die Frameworkwahl ist keine reine Featurefrage, sondern eine Entscheidung über Kontrolle, Transparenz und Betriebsaufwand.</a:t>
-            </a:r>
-          </a:p>
-          <a:p/>
-          <a:p>
-            <a:r>
-              <a:t>Sprechtext: Unser Workshop-Code ist bewusst weitgehend framework-frei: OpenAI-kompatibler Client, ChromaDB und klar sichtbare Python-Funktionen. Das erhöht den Lernwert und macht jeden Verarbeitungsschritt nachvollziehbar. Frameworks wie LangChain oder LlamaIndex beschleunigen Standardintegrationen, bringen aber zusätzliche Abstraktionen und Versionsabhängigkeiten. Graph-orientierte Orchestrierung lohnt sich vor allem bei verzweigten, zustandsbehafteten Abläufen. Managed Services reduzieren Betriebsaufwand, erhöhen aber Kosten und Anbieterbindung.</a:t>
-            </a:r>
-          </a:p>
-          <a:p/>
-          <a:p>
-            <a:r>
-              <a:t>Leitfrage: Welche Anforderungen dominieren im echten Projekt – schnelle Entwicklung, maximale Transparenz, komplexe Orchestrierung oder geringer Betrieb?</a:t>
-            </a:r>
-          </a:p>
-          <a:p/>
-          <a:p>
-            <a:r>
-              <a:t>Übergang: Unabhängig vom Werkzeug bleiben drei Grundprinzipien bestehen.</a:t>
+              <a:t>Kernbotschaft: Chunking bestimmt, welche Bedeutungseinheiten später überhaupt als Treffer zurückkommen können.</a:t>
+            </a:r>
+          </a:p>
+          <a:p>
+            <a:endParaRPr/>
+          </a:p>
+          <a:p>
+            <a:r>
+              <a:t>Sprechtext: Links sehen wir Fixed-Size-Chunking mit einem starren Budget von 800 Zeichen. Die Grenze kann mitten in einem Satz oder direkt vor dem nächsten Artikel liegen. Dadurch verliert ein Treffer Kontext oder vermischt mehrere Artikel. Rechts orientiert sich unser verbessertes Verfahren primär an Markdown- und Artikelüberschriften. Übergroße Artikel werden zusätzlich an Satzgrenzen geteilt; kleine zusammengehörige Blöcke werden bis zum Budget verbunden.</a:t>
+            </a:r>
+          </a:p>
+          <a:p>
+            <a:endParaRPr/>
+          </a:p>
+          <a:p>
+            <a:r>
+              <a:t>Präzisierung: Unser Budget beträgt 800 Zeichen, nicht 800 Tokens. Das Verfahren ist deshalb besser als „strukturorientiertes Chunking“ beschrieben; es ist kein LLM-basiertes semantisches Chunking.</a:t>
+            </a:r>
+          </a:p>
+          <a:p>
+            <a:endParaRPr/>
+          </a:p>
+          <a:p>
+            <a:r>
+              <a:t>Zusätzlich entfernen wir typisches PDF-Rauschen wie Seitenmarker, Inhaltsverzeichnisse und isolierte Fundstellenblöcke. Quellen, die zum Gesetzesinhalt gehören, werden nicht pauschal gelöscht.</a:t>
+            </a:r>
+          </a:p>
+          <a:p>
+            <a:endParaRPr/>
+          </a:p>
+          <a:p>
+            <a:r>
+              <a:t>Publikumsfrage: Welche Seite würdet ihr für die Suche nach Art. 335b OR bevorzugen – und warum?</a:t>
+            </a:r>
+          </a:p>
+          <a:p>
+            <a:endParaRPr/>
+          </a:p>
+          <a:p>
+            <a:r>
+              <a:t>Übergang: Gute Chunks erzeugen bessere Kandidaten. Als Nächstes verbessern wir deren Reihenfolge.</a:t>
+            </a:r>
+          </a:p>
+          <a:p>
+            <a:endParaRPr/>
+          </a:p>
+          <a:p>
+            <a:r>
+              <a:t>[Sources]</a:t>
+            </a:r>
+          </a:p>
+          <a:p>
+            <a:r>
+              <a:t>- C:/Users/mehlst/Documents/RAG-Workshop/rag-3a-ingest.py</a:t>
             </a:r>
           </a:p>
         </p:txBody>
@@ -1094,25 +1108,60 @@
           <a:lstStyle/>
           <a:p>
             <a:r>
-              <a:t>Kernbotschaft: Gutes RAG entsteht durch gezielten Kontext, getrennte Evaluation und nur so viel Komplexität wie messbar nötig.</a:t>
-            </a:r>
-          </a:p>
-          <a:p/>
-          <a:p>
-            <a:r>
-              <a:t>Sprechtext: Erstens: RAG ist Context Engineering. Entscheidend ist nicht die maximale Menge, sondern die Relevanz des Kontexts. Zweitens: Retrieval und Antwort müssen getrennt gemessen werden – sonst wissen wir nicht, ob ein Fehler in der Suche oder in der Generierung liegt. Drittens: Chunking, Reranking, hybride Suche und Graphen sind Werkzeuge, keine Selbstzwecke. Wir ergänzen sie nur, wenn die Evaluation einen konkreten Nutzen zeigt.</a:t>
-            </a:r>
-          </a:p>
-          <a:p/>
-          <a:p>
-            <a:r>
-              <a:t>Abschlussfrage: Welchen dieser Hebel würdet ihr in eurem eigenen Projekt als Erstes messen?</a:t>
-            </a:r>
-          </a:p>
-          <a:p/>
-          <a:p>
-            <a:r>
-              <a:t>Übergang: Damit sind wir am Ende des Workshops – Zeit für Fragen und den Transfer in eure Anwendungsfälle.</a:t>
+              <a:t>Kernbotschaft: Reranking sortiert gefundene Kandidaten neu; es kann keinen fehlenden Artikel herbeizaubern.</a:t>
+            </a:r>
+          </a:p>
+          <a:p>
+            <a:endParaRPr/>
+          </a:p>
+          <a:p>
+            <a:r>
+              <a:t>Sprechtext: Die Vektorsuche holt zunächst eine größere Kandidatenmenge. Unser Cross-Encoder BAAI/bge-reranker-v2-m3 liest Frage und Chunk gemeinsam und bewertet ihre Relevanz genauer als der reine Vektorabstand. Für die Evaluation bleiben nach dem Reranking sechs Chunks im gemeinsamen Kontextbudget; der interaktive Chat verwendet standardmäßig vier.</a:t>
+            </a:r>
+          </a:p>
+          <a:p>
+            <a:endParaRPr/>
+          </a:p>
+          <a:p>
+            <a:r>
+              <a:t>Der wichtigste Unterschied: Ein Bi-Encoder berechnet Dokument- und Query-Vektoren getrennt und ist schnell. Ein Cross-Encoder betrachtet beide Texte gemeinsam und ist präziser, aber langsamer. Deshalb wird er erst auf einer kleinen Kandidatenliste eingesetzt.</a:t>
+            </a:r>
+          </a:p>
+          <a:p>
+            <a:endParaRPr/>
+          </a:p>
+          <a:p>
+            <a:r>
+              <a:t>Publikumsfrage: Was passiert, wenn Art. 1 OR in den ersten Kandidaten überhaupt nicht enthalten ist?</a:t>
+            </a:r>
+          </a:p>
+          <a:p>
+            <a:endParaRPr/>
+          </a:p>
+          <a:p>
+            <a:r>
+              <a:t>Erwartete Antwort: Der Reranker kann ihn nicht auswählen; dafür brauchen wir besseren Recall im vorgelagerten Retrieval.</a:t>
+            </a:r>
+          </a:p>
+          <a:p>
+            <a:endParaRPr/>
+          </a:p>
+          <a:p>
+            <a:r>
+              <a:t>Übergang: Genau dort setzt die hybride und graphbasierte Suche an.</a:t>
+            </a:r>
+          </a:p>
+          <a:p>
+            <a:endParaRPr/>
+          </a:p>
+          <a:p>
+            <a:r>
+              <a:t>[Sources]</a:t>
+            </a:r>
+          </a:p>
+          <a:p>
+            <a:r>
+              <a:t>- C:/Users/mehlst/Documents/RAG-Workshop/rag-3c-chat-rerank.py</a:t>
             </a:r>
           </a:p>
         </p:txBody>
@@ -1145,7 +1194,7 @@
 </file>
 
 <file path=ppt/notesSlides/notesSlide13.xml><?xml version="1.0" encoding="utf-8"?>
-<p:notes xmlns:a="http://schemas.openxmlformats.org/drawingml/2006/main" xmlns:p="http://schemas.openxmlformats.org/presentationml/2006/main" xmlns:r="http://schemas.openxmlformats.org/officeDocument/2006/relationships">
+<p:notes xmlns:a="http://schemas.openxmlformats.org/drawingml/2006/main" xmlns:r="http://schemas.openxmlformats.org/officeDocument/2006/relationships" xmlns:p="http://schemas.openxmlformats.org/presentationml/2006/main">
   <p:cSld>
     <p:spTree>
       <p:nvGrpSpPr>
@@ -1165,22 +1214,98 @@
         <p:nvSpPr>
           <p:cNvPr id="2" name="Slide Image Placeholder 1"/>
           <p:cNvSpPr>
-            <a:spLocks noGrp="1"/>
+            <a:spLocks noGrp="1" noRot="1" noChangeAspect="1"/>
           </p:cNvSpPr>
           <p:nvPr>
-            <p:ph type="sldImg" idx="2"/>
+            <p:ph type="sldImg"/>
           </p:nvPr>
         </p:nvSpPr>
+        <p:spPr>
+          <a:xfrm>
+            <a:off x="1081088" y="617538"/>
+            <a:ext cx="4695825" cy="2641600"/>
+          </a:xfrm>
+        </p:spPr>
+      </p:sp>
+      <p:sp>
+        <p:nvSpPr>
+          <p:cNvPr id="3" name="Notes Placeholder 2"/>
+          <p:cNvSpPr>
+            <a:spLocks noGrp="1"/>
+          </p:cNvSpPr>
+          <p:nvPr>
+            <p:ph type="body" idx="1"/>
+          </p:nvPr>
+        </p:nvSpPr>
         <p:spPr/>
-      </p:sp>
-      <p:sp>
-        <p:nvSpPr>
-          <p:cNvPr id="3" name="Notes Placeholder 2"/>
+        <p:txBody>
+          <a:bodyPr/>
+          <a:lstStyle/>
+          <a:p>
+            <a:r>
+              <a:t>Kernbotschaft: GraphRAG kombiniert mehrere Suchsignale, damit explizite Artikelangaben und strukturelle Beziehungen nicht von semantischer Ähnlichkeit verdrängt werden.</a:t>
+            </a:r>
+          </a:p>
+          <a:p>
+            <a:endParaRPr/>
+          </a:p>
+          <a:p>
+            <a:r>
+              <a:t>Sprechtext: Zuerst holen wir semantische Vector-Treffer und lexikalische beziehungsweise BM25-Kandidaten. Reciprocal Rank Fusion führt beide Ranglisten robust zusammen, ohne die Rohscores direkt vergleichbar machen zu müssen. Explizite Referenzen wie „Art. 1 OR“ können zusätzlich auf eine konkrete Artikeldefinition aufgelöst werden. Danach ergänzen wir passende Graph-Nachbarn, etwa angrenzende Artikel oder erkannte Verweise.</a:t>
+            </a:r>
+          </a:p>
+          <a:p>
+            <a:endParaRPr/>
+          </a:p>
+          <a:p>
+            <a:r>
+              <a:t>Der Graph ersetzt die Suche nicht. Er erweitert gute Seed-Treffer um strukturell verwandten Kontext. Das hilft besonders bei Fragen, die mehrere Artikel oder Erlasse verbinden.</a:t>
+            </a:r>
+          </a:p>
+          <a:p>
+            <a:endParaRPr/>
+          </a:p>
+          <a:p>
+            <a:r>
+              <a:t>Publikumsfrage: Warum ist eine lexikalische Suche bei „Art. 1 OR“ oft zuverlässiger als reine semantische Ähnlichkeit?</a:t>
+            </a:r>
+          </a:p>
+          <a:p>
+            <a:endParaRPr/>
+          </a:p>
+          <a:p>
+            <a:r>
+              <a:t>Übergang: Jetzt prüfen wir, ob diese zusätzliche Logik tatsächlich Recall, Rangfolge und Kontextbedarf verbessert.</a:t>
+            </a:r>
+          </a:p>
+          <a:p>
+            <a:endParaRPr/>
+          </a:p>
+          <a:p>
+            <a:r>
+              <a:t>[Sources]</a:t>
+            </a:r>
+          </a:p>
+          <a:p>
+            <a:r>
+              <a:t>- C:/Users/mehlst/Documents/RAG-Workshop/graph_retrieval.py</a:t>
+            </a:r>
+          </a:p>
+          <a:p>
+            <a:r>
+              <a:t>- C:/Users/mehlst/Documents/RAG-Workshop/rag-4b-chat.py</a:t>
+            </a:r>
+          </a:p>
+        </p:txBody>
+      </p:sp>
+      <p:sp>
+        <p:nvSpPr>
+          <p:cNvPr id="4" name="Slide Number Placeholder 3"/>
           <p:cNvSpPr>
             <a:spLocks noGrp="1"/>
           </p:cNvSpPr>
           <p:nvPr>
-            <p:ph type="body" idx="3" sz="quarter"/>
+            <p:ph type="sldNum" idx="5"/>
           </p:nvPr>
         </p:nvSpPr>
         <p:spPr/>
@@ -1188,41 +1313,9 @@
           <a:bodyPr/>
           <a:lstStyle/>
           <a:p>
-            <a:r>
-              <a:t>Kernbotschaft: Heute bauen wir nicht nur einen Chatbot, sondern verstehen die Mechanik eines belastbaren RAG-Systems.</a:t>
-            </a:r>
-          </a:p>
-          <a:p/>
-          <a:p>
-            <a:r>
-              <a:t>Sprechtext: Willkommen zum RAG-Workshop. Als durchgängiges Beispiel verwenden wir Schweizer Gesetzestexte. Dadurch können wir sehr konkret prüfen, ob ein System den richtigen Erlass und den richtigen Artikel findet, ob es Quellen nennt und wie viel Kontext es dafür benötigt. Am Ende sollt ihr die wichtigsten Qualitätshebel – Chunking, Retrieval, Reranking und Evaluation – bewusst auswählen können.</a:t>
-            </a:r>
-          </a:p>
-          <a:p/>
-          <a:p>
-            <a:r>
-              <a:t>Wichtig: Die Demo erklärt technische Konzepte und ist keine Rechtsberatung.</a:t>
-            </a:r>
-          </a:p>
-          <a:p/>
-          <a:p>
-            <a:r>
-              <a:t>Übergang: Schauen wir zuerst auf den Ablauf und das Ziel der kommenden 90 Minuten.</a:t>
-            </a:r>
-          </a:p>
-        </p:txBody>
-      </p:sp>
-      <p:sp>
-        <p:nvSpPr>
-          <p:cNvPr id="4" name="Slide Number Placeholder 3"/>
-          <p:cNvSpPr>
-            <a:spLocks noGrp="1"/>
-          </p:cNvSpPr>
-          <p:nvPr>
-            <p:ph type="sldNum" idx="5" sz="quarter"/>
-          </p:nvPr>
-        </p:nvSpPr>
-        <p:spPr/>
+            <a:endParaRPr/>
+          </a:p>
+        </p:txBody>
       </p:sp>
     </p:spTree>
   </p:cSld>
@@ -1233,7 +1326,7 @@
 </file>
 
 <file path=ppt/notesSlides/notesSlide14.xml><?xml version="1.0" encoding="utf-8"?>
-<p:notes xmlns:a="http://schemas.openxmlformats.org/drawingml/2006/main" xmlns:p="http://schemas.openxmlformats.org/presentationml/2006/main" xmlns:r="http://schemas.openxmlformats.org/officeDocument/2006/relationships">
+<p:notes xmlns:a="http://schemas.openxmlformats.org/drawingml/2006/main" xmlns:r="http://schemas.openxmlformats.org/officeDocument/2006/relationships" xmlns:p="http://schemas.openxmlformats.org/presentationml/2006/main">
   <p:cSld>
     <p:spTree>
       <p:nvGrpSpPr>
@@ -1253,10 +1346,10 @@
         <p:nvSpPr>
           <p:cNvPr id="2" name="Slide Image Placeholder 1"/>
           <p:cNvSpPr>
-            <a:spLocks noGrp="1"/>
+            <a:spLocks noGrp="1" noRot="1" noChangeAspect="1"/>
           </p:cNvSpPr>
           <p:nvPr>
-            <p:ph type="sldImg" idx="2"/>
+            <p:ph type="sldImg"/>
           </p:nvPr>
         </p:nvSpPr>
         <p:spPr/>
@@ -1268,7 +1361,7 @@
             <a:spLocks noGrp="1"/>
           </p:cNvSpPr>
           <p:nvPr>
-            <p:ph type="body" idx="3" sz="quarter"/>
+            <p:ph type="body" idx="1"/>
           </p:nvPr>
         </p:nvSpPr>
         <p:spPr/>
@@ -1276,27 +1369,7 @@
           <a:bodyPr/>
           <a:lstStyle/>
           <a:p>
-            <a:r>
-              <a:t>Kernbotschaft: Wir entwickeln die Lösung schrittweise und messen nach jeder Verbesserung erneut.</a:t>
-            </a:r>
-          </a:p>
-          <a:p/>
-          <a:p>
-            <a:r>
-              <a:t>Sprechtext: Zuerst klären wir, welches Problem RAG löst. Danach bauen wir eine einfache Pipeline, verbessern das Chunking, ergänzen Reranking und schließlich GraphRAG. Die Evaluation läuft nicht nur am Ende: Sie begleitet jede Stufe, damit wir sehen, welche Änderung tatsächlich einen messbaren Effekt hat.</a:t>
-            </a:r>
-          </a:p>
-          <a:p/>
-          <a:p>
-            <a:r>
-              <a:t>Publikumsfrage: Wer hat bereits selbst ein RAG-System gebaut oder eine Vektordatenbank verwendet?</a:t>
-            </a:r>
-          </a:p>
-          <a:p/>
-          <a:p>
-            <a:r>
-              <a:t>Übergang: Bevor wir RAG definieren, schauen wir auf die Grenzen eines reinen LLMs.</a:t>
-            </a:r>
+            <a:endParaRPr/>
           </a:p>
         </p:txBody>
       </p:sp>
@@ -1307,10 +1380,17 @@
             <a:spLocks noGrp="1"/>
           </p:cNvSpPr>
           <p:nvPr>
-            <p:ph type="sldNum" idx="5" sz="quarter"/>
+            <p:ph type="sldNum" idx="5"/>
           </p:nvPr>
         </p:nvSpPr>
         <p:spPr/>
+        <p:txBody>
+          <a:bodyPr/>
+          <a:lstStyle/>
+          <a:p>
+            <a:endParaRPr/>
+          </a:p>
+        </p:txBody>
       </p:sp>
     </p:spTree>
   </p:cSld>
@@ -1321,7 +1401,7 @@
 </file>
 
 <file path=ppt/notesSlides/notesSlide15.xml><?xml version="1.0" encoding="utf-8"?>
-<p:notes xmlns:a="http://schemas.openxmlformats.org/drawingml/2006/main" xmlns:p="http://schemas.openxmlformats.org/presentationml/2006/main" xmlns:r="http://schemas.openxmlformats.org/officeDocument/2006/relationships">
+<p:notes xmlns:a="http://schemas.openxmlformats.org/drawingml/2006/main" xmlns:r="http://schemas.openxmlformats.org/officeDocument/2006/relationships" xmlns:p="http://schemas.openxmlformats.org/presentationml/2006/main">
   <p:cSld>
     <p:spTree>
       <p:nvGrpSpPr>
@@ -1341,22 +1421,98 @@
         <p:nvSpPr>
           <p:cNvPr id="2" name="Slide Image Placeholder 1"/>
           <p:cNvSpPr>
-            <a:spLocks noGrp="1"/>
+            <a:spLocks noGrp="1" noRot="1" noChangeAspect="1"/>
           </p:cNvSpPr>
           <p:nvPr>
-            <p:ph type="sldImg" idx="2"/>
+            <p:ph type="sldImg"/>
           </p:nvPr>
         </p:nvSpPr>
+        <p:spPr>
+          <a:xfrm>
+            <a:off x="1081088" y="617538"/>
+            <a:ext cx="4695825" cy="2641600"/>
+          </a:xfrm>
+        </p:spPr>
+      </p:sp>
+      <p:sp>
+        <p:nvSpPr>
+          <p:cNvPr id="3" name="Notes Placeholder 2"/>
+          <p:cNvSpPr>
+            <a:spLocks noGrp="1"/>
+          </p:cNvSpPr>
+          <p:nvPr>
+            <p:ph type="body" idx="1"/>
+          </p:nvPr>
+        </p:nvSpPr>
         <p:spPr/>
-      </p:sp>
-      <p:sp>
-        <p:nvSpPr>
-          <p:cNvPr id="3" name="Notes Placeholder 2"/>
+        <p:txBody>
+          <a:bodyPr/>
+          <a:lstStyle/>
+          <a:p>
+            <a:r>
+              <a:t>Kernbotschaft: GraphRAG findet in diesem Workshop-Test die meisten erwarteten Artikel und benötigt gleichzeitig den kleinsten Prompt-Kontext; der Reranker liefert die beste frühe Rangposition.</a:t>
+            </a:r>
+          </a:p>
+          <a:p>
+            <a:endParaRPr/>
+          </a:p>
+          <a:p>
+            <a:r>
+              <a:t>Sprechtext: Alle vier Methoden beantworten dieselben sechs Fragen mit demselben Kontextbudget von sechs Chunks. Article Recall@K misst, welcher Anteil aller erwarteten Artikel unter den K Treffern vorkommt. MRR – Mean Reciprocal Rank – belohnt eine frühe Position des ersten relevanten Artikels. Prompt-Kontext-Tokens zählen den tatsächlich in den Modellprompt eingefügten Dokumentkontext einschließlich Formatierung.</a:t>
+            </a:r>
+          </a:p>
+          <a:p>
+            <a:endParaRPr/>
+          </a:p>
+          <a:p>
+            <a:r>
+              <a:t>Die Werte: Fixed erreicht 54 Prozent Recall, 0,43 MRR und 1.289 Tokens. Semantic erreicht 33 Prozent, 0,25 und 892 Tokens. Reranking erreicht 71 Prozent, 0,68 und 923 Tokens. GraphRAG erreicht 88 Prozent Recall, 0,52 MRR und 802 Tokens.</a:t>
+            </a:r>
+          </a:p>
+          <a:p>
+            <a:endParaRPr/>
+          </a:p>
+          <a:p>
+            <a:r>
+              <a:t>Lesart: GraphRAG maximiert hier die Vollständigkeit bei kleinem Kontext. Reranking positioniert den ersten relevanten Treffer am besten. Diese sechs Fragen sind eine Workshop-Messung, keine allgemeine Benchmark.</a:t>
+            </a:r>
+          </a:p>
+          <a:p>
+            <a:endParaRPr/>
+          </a:p>
+          <a:p>
+            <a:r>
+              <a:t>Übergang: Ein guter Retrieval-Treffer ist notwendig – aber beantwortet noch nicht, ob das LLM daraus eine vollständige und korrekt belegte Antwort erzeugt.</a:t>
+            </a:r>
+          </a:p>
+          <a:p>
+            <a:endParaRPr/>
+          </a:p>
+          <a:p>
+            <a:r>
+              <a:t>[Sources]</a:t>
+            </a:r>
+          </a:p>
+          <a:p>
+            <a:r>
+              <a:t>- C:/Users/mehlst/Documents/RAG-Workshop/evaluation/report-graph.md</a:t>
+            </a:r>
+          </a:p>
+          <a:p>
+            <a:r>
+              <a:t>- C:/Users/mehlst/Documents/RAG-Workshop/evaluate.py</a:t>
+            </a:r>
+          </a:p>
+        </p:txBody>
+      </p:sp>
+      <p:sp>
+        <p:nvSpPr>
+          <p:cNvPr id="4" name="Slide Number Placeholder 3"/>
           <p:cNvSpPr>
             <a:spLocks noGrp="1"/>
           </p:cNvSpPr>
           <p:nvPr>
-            <p:ph type="body" idx="3" sz="quarter"/>
+            <p:ph type="sldNum" idx="5"/>
           </p:nvPr>
         </p:nvSpPr>
         <p:spPr/>
@@ -1364,41 +1520,9 @@
           <a:bodyPr/>
           <a:lstStyle/>
           <a:p>
-            <a:r>
-              <a:t>Kernbotschaft: RAG ist eine Methode, dem Modell zur Laufzeit gezielt externes Wissen bereitzustellen.</a:t>
-            </a:r>
-          </a:p>
-          <a:p/>
-          <a:p>
-            <a:r>
-              <a:t>Sprechtext: In diesem Abschnitt geht es zunächst um das Warum. Wir trennen dabei zwei Dinge: Das Sprachmodell formuliert die Antwort; das Retrieval entscheidet, welche Informationen es dafür überhaupt sieht.</a:t>
-            </a:r>
-          </a:p>
-          <a:p/>
-          <a:p>
-            <a:r>
-              <a:t>Publikumsfrage: Was fehlt einem reinen LLM, wenn wir eine aktuelle oder intern belegbare Antwort erwarten?</a:t>
-            </a:r>
-          </a:p>
-          <a:p/>
-          <a:p>
-            <a:r>
-              <a:t>Übergang: Drei typische blinde Flecken machen dieses Problem sichtbar.</a:t>
-            </a:r>
-          </a:p>
-        </p:txBody>
-      </p:sp>
-      <p:sp>
-        <p:nvSpPr>
-          <p:cNvPr id="4" name="Slide Number Placeholder 3"/>
-          <p:cNvSpPr>
-            <a:spLocks noGrp="1"/>
-          </p:cNvSpPr>
-          <p:nvPr>
-            <p:ph type="sldNum" idx="5" sz="quarter"/>
-          </p:nvPr>
-        </p:nvSpPr>
-        <p:spPr/>
+            <a:endParaRPr/>
+          </a:p>
+        </p:txBody>
       </p:sp>
     </p:spTree>
   </p:cSld>
@@ -1409,7 +1533,7 @@
 </file>
 
 <file path=ppt/notesSlides/notesSlide16.xml><?xml version="1.0" encoding="utf-8"?>
-<p:notes xmlns:a="http://schemas.openxmlformats.org/drawingml/2006/main" xmlns:p="http://schemas.openxmlformats.org/presentationml/2006/main" xmlns:r="http://schemas.openxmlformats.org/officeDocument/2006/relationships">
+<p:notes xmlns:a="http://schemas.openxmlformats.org/drawingml/2006/main" xmlns:r="http://schemas.openxmlformats.org/officeDocument/2006/relationships" xmlns:p="http://schemas.openxmlformats.org/presentationml/2006/main">
   <p:cSld>
     <p:spTree>
       <p:nvGrpSpPr>
@@ -1429,22 +1553,98 @@
         <p:nvSpPr>
           <p:cNvPr id="2" name="Slide Image Placeholder 1"/>
           <p:cNvSpPr>
-            <a:spLocks noGrp="1"/>
+            <a:spLocks noGrp="1" noRot="1" noChangeAspect="1"/>
           </p:cNvSpPr>
           <p:nvPr>
-            <p:ph type="sldImg" idx="2"/>
+            <p:ph type="sldImg"/>
           </p:nvPr>
         </p:nvSpPr>
+        <p:spPr>
+          <a:xfrm>
+            <a:off x="1081088" y="617538"/>
+            <a:ext cx="4695825" cy="2641600"/>
+          </a:xfrm>
+        </p:spPr>
+      </p:sp>
+      <p:sp>
+        <p:nvSpPr>
+          <p:cNvPr id="3" name="Notes Placeholder 2"/>
+          <p:cNvSpPr>
+            <a:spLocks noGrp="1"/>
+          </p:cNvSpPr>
+          <p:nvPr>
+            <p:ph type="body" idx="1"/>
+          </p:nvPr>
+        </p:nvSpPr>
         <p:spPr/>
-      </p:sp>
-      <p:sp>
-        <p:nvSpPr>
-          <p:cNvPr id="3" name="Notes Placeholder 2"/>
+        <p:txBody>
+          <a:bodyPr/>
+          <a:lstStyle/>
+          <a:p>
+            <a:r>
+              <a:t>Kernbotschaft: Retrieval-Qualität und Antwortqualität sind zwei getrennte Ebenen und müssen separat bewertet werden.</a:t>
+            </a:r>
+          </a:p>
+          <a:p>
+            <a:endParaRPr/>
+          </a:p>
+          <a:p>
+            <a:r>
+              <a:t>Sprechtext: Die dunkelblauen Balken zeigen die Faktenabdeckung – auf Englisch Fact Coverage. Sie misst, welcher Anteil der zuvor definierten erforderlichen Fakten in der generierten Antwort enthalten ist. Die hellblauen beziehungsweise türkisen Balken zeigen die Zitationsvollständigkeit – Citation Completeness. Sie misst, welcher Anteil der erwarteten Artikelbezeichnungen in der Antwort zitiert wird.</a:t>
+            </a:r>
+          </a:p>
+          <a:p>
+            <a:endParaRPr/>
+          </a:p>
+          <a:p>
+            <a:r>
+              <a:t>Im vollständigen Lauf erreicht GraphRAG 55,6 Prozent Faktenabdeckung und 66,7 Prozent Zitationsvollständigkeit. Fixed Vector erzielt trotz schwächerem Retrieval 61,1 Prozent Faktenabdeckung. Das ist kein Widerspruch: Das generierende LLM ist nicht vollständig deterministisch und kann vorhandenen Kontext unvollständig nutzen oder einen falschen Artikel nennen.</a:t>
+            </a:r>
+          </a:p>
+          <a:p>
+            <a:endParaRPr/>
+          </a:p>
+          <a:p>
+            <a:r>
+              <a:t>Wichtig: Faktenabdeckung bewertet das Vorhandensein erwarteter Inhalte, nicht automatisch juristische Korrektheit jeder Aussage. Zitationsvollständigkeit sagt, ob erwartete Quellen genannt wurden; sie sagt allein noch nicht, ob die jeweilige Quelle die Aussage tatsächlich belegt.</a:t>
+            </a:r>
+          </a:p>
+          <a:p>
+            <a:endParaRPr/>
+          </a:p>
+          <a:p>
+            <a:r>
+              <a:t>Übergang: Diese Ergebnisse bilden die Grundlage für die Gruppenarbeit: Wo würden wir als Nächstes investieren?</a:t>
+            </a:r>
+          </a:p>
+          <a:p>
+            <a:endParaRPr/>
+          </a:p>
+          <a:p>
+            <a:r>
+              <a:t>[Sources]</a:t>
+            </a:r>
+          </a:p>
+          <a:p>
+            <a:r>
+              <a:t>- C:/Users/mehlst/Documents/RAG-Workshop/evaluation/report-graph.md</a:t>
+            </a:r>
+          </a:p>
+          <a:p>
+            <a:r>
+              <a:t>- C:/Users/mehlst/Documents/RAG-Workshop/evaluate.py</a:t>
+            </a:r>
+          </a:p>
+        </p:txBody>
+      </p:sp>
+      <p:sp>
+        <p:nvSpPr>
+          <p:cNvPr id="4" name="Slide Number Placeholder 3"/>
           <p:cNvSpPr>
             <a:spLocks noGrp="1"/>
           </p:cNvSpPr>
           <p:nvPr>
-            <p:ph type="body" idx="3" sz="quarter"/>
+            <p:ph type="sldNum" idx="5"/>
           </p:nvPr>
         </p:nvSpPr>
         <p:spPr/>
@@ -1452,41 +1652,9 @@
           <a:bodyPr/>
           <a:lstStyle/>
           <a:p>
-            <a:r>
-              <a:t>Kernbotschaft: Ein reines LLM kennt nicht automatisch unsere aktuellen Daten, liefert keine verlässlichen Belege und kann nicht beliebig viel Kontext effizient verarbeiten.</a:t>
-            </a:r>
-          </a:p>
-          <a:p/>
-          <a:p>
-            <a:r>
-              <a:t>Sprechtext: Erstens endet das Wissen des Modells an seinen Trainingsdaten und umfasst keine vertraulichen Firmendokumente. Zweitens kann eine plausible Antwort sprachlich überzeugend, aber sachlich falsch oder nicht nachvollziehbar sein. Drittens ist „alles in den Prompt legen“ teuer und erzeugt Rauschen: Mehr Kontext ist nicht automatisch besserer Kontext.</a:t>
-            </a:r>
-          </a:p>
-          <a:p/>
-          <a:p>
-            <a:r>
-              <a:t>RAG macht das Modell nicht intelligenter. RAG steuert, welche Evidenz das Modell für eine konkrete Frage erhält.</a:t>
-            </a:r>
-          </a:p>
-          <a:p/>
-          <a:p>
-            <a:r>
-              <a:t>Übergang: Diese Steuerung kann man als drei grundlegende Kontextoperationen verstehen.</a:t>
-            </a:r>
-          </a:p>
-        </p:txBody>
-      </p:sp>
-      <p:sp>
-        <p:nvSpPr>
-          <p:cNvPr id="4" name="Slide Number Placeholder 3"/>
-          <p:cNvSpPr>
-            <a:spLocks noGrp="1"/>
-          </p:cNvSpPr>
-          <p:nvPr>
-            <p:ph type="sldNum" idx="5" sz="quarter"/>
-          </p:nvPr>
-        </p:nvSpPr>
-        <p:spPr/>
+            <a:endParaRPr/>
+          </a:p>
+        </p:txBody>
       </p:sp>
     </p:spTree>
   </p:cSld>
@@ -1497,7 +1665,7 @@
 </file>
 
 <file path=ppt/notesSlides/notesSlide17.xml><?xml version="1.0" encoding="utf-8"?>
-<p:notes xmlns:a="http://schemas.openxmlformats.org/drawingml/2006/main" xmlns:p="http://schemas.openxmlformats.org/presentationml/2006/main" xmlns:r="http://schemas.openxmlformats.org/officeDocument/2006/relationships">
+<p:notes xmlns:a="http://schemas.openxmlformats.org/drawingml/2006/main" xmlns:r="http://schemas.openxmlformats.org/officeDocument/2006/relationships" xmlns:p="http://schemas.openxmlformats.org/presentationml/2006/main">
   <p:cSld>
     <p:spTree>
       <p:nvGrpSpPr>
@@ -1517,22 +1685,80 @@
         <p:nvSpPr>
           <p:cNvPr id="2" name="Slide Image Placeholder 1"/>
           <p:cNvSpPr>
-            <a:spLocks noGrp="1"/>
+            <a:spLocks noGrp="1" noRot="1" noChangeAspect="1"/>
           </p:cNvSpPr>
           <p:nvPr>
-            <p:ph type="sldImg" idx="2"/>
+            <p:ph type="sldImg"/>
           </p:nvPr>
         </p:nvSpPr>
+        <p:spPr>
+          <a:xfrm>
+            <a:off x="1081088" y="617538"/>
+            <a:ext cx="4695825" cy="2641600"/>
+          </a:xfrm>
+        </p:spPr>
+      </p:sp>
+      <p:sp>
+        <p:nvSpPr>
+          <p:cNvPr id="3" name="Notes Placeholder 2"/>
+          <p:cNvSpPr>
+            <a:spLocks noGrp="1"/>
+          </p:cNvSpPr>
+          <p:nvPr>
+            <p:ph type="body" idx="1"/>
+          </p:nvPr>
+        </p:nvSpPr>
         <p:spPr/>
-      </p:sp>
-      <p:sp>
-        <p:nvSpPr>
-          <p:cNvPr id="3" name="Notes Placeholder 2"/>
+        <p:txBody>
+          <a:bodyPr/>
+          <a:lstStyle/>
+          <a:p>
+            <a:r>
+              <a:t>Kernbotschaft: Die Gruppen betrachten dieselbe Pipeline aus drei Perspektiven und müssen eine begründete Priorität formulieren.</a:t>
+            </a:r>
+          </a:p>
+          <a:p>
+            <a:endParaRPr/>
+          </a:p>
+          <a:p>
+            <a:r>
+              <a:t>Sprechtext: Jede Gruppe bearbeitet ihr Wahlmodul anhand der bereitgestellten Fragen und Ergebnisse. Entscheidend ist nicht, möglichst viele Ideen zu sammeln, sondern eine konkrete Verbesserung mit erwarteter Wirkung, möglichem Nachteil und einer passenden Messgröße zu benennen.</a:t>
+            </a:r>
+          </a:p>
+          <a:p>
+            <a:endParaRPr/>
+          </a:p>
+          <a:p>
+            <a:r>
+              <a:t>Für die Kurzpräsentation helfen drei Fragen: Welches Problem lösen wir? Welche Änderung schlagen wir vor? Woran erkennen wir, dass sie besser ist? Die Ergebnisvorstellung dauert maximal zwei Minuten pro Gruppe; die Arbeitszeit kann je nach Workshop-Zeitplan angepasst werden.</a:t>
+            </a:r>
+          </a:p>
+          <a:p>
+            <a:endParaRPr/>
+          </a:p>
+          <a:p>
+            <a:r>
+              <a:t>Hinweis: Achtet darauf, Retrieval und Generierung nicht zu vermischen. Eine Maßnahme kann Recall verbessern, ohne die Antwortqualität automatisch im gleichen Maß zu erhöhen.</a:t>
+            </a:r>
+          </a:p>
+          <a:p>
+            <a:endParaRPr/>
+          </a:p>
+          <a:p>
+            <a:r>
+              <a:t>Übergang: Neben Algorithmen beeinflusst auch die Frameworkwahl, wie schnell und kontrolliert wir solche Änderungen umsetzen können.</a:t>
+            </a:r>
+          </a:p>
+        </p:txBody>
+      </p:sp>
+      <p:sp>
+        <p:nvSpPr>
+          <p:cNvPr id="4" name="Slide Number Placeholder 3"/>
           <p:cNvSpPr>
             <a:spLocks noGrp="1"/>
           </p:cNvSpPr>
           <p:nvPr>
-            <p:ph type="body" idx="3" sz="quarter"/>
+            <p:ph type="sldNum" idx="5"/>
           </p:nvPr>
         </p:nvSpPr>
         <p:spPr/>
@@ -1540,71 +1766,9 @@
           <a:bodyPr/>
           <a:lstStyle/>
           <a:p>
-            <a:r>
-              <a:t>Kernbotschaft: Ein Vector RAG besteht aus einer vorbereitenden Ingest-Pipeline und einer Laufzeit-Pipeline für Fragen.</a:t>
-            </a:r>
-          </a:p>
-          <a:p/>
-          <a:p>
-            <a:r>
-              <a:t>Sprechtext: Links läuft der Ingest: Rohdateien werden extrahiert, bereinigt, in Chunks geteilt, in Embeddings übersetzt und in ChromaDB gespeichert. Rechts läuft die Anfrage: Auch die Frage wird mit demselben Embedding-Modell in einen Vektor übersetzt. Die Datenbank sucht ähnliche Chunks; diese werden als relevanter Kontext zusammen mit der Frage an das Chat-LLM gegeben.</a:t>
-            </a:r>
-          </a:p>
-          <a:p/>
-          <a:p>
-            <a:r>
-              <a:t>Wichtig: Embedding-LLM und Chat-LLM haben unterschiedliche Aufgaben. Das Embedding-Modell erzeugt vergleichbare Vektoren; das Chat-Modell formuliert die Antwort.</a:t>
-            </a:r>
-          </a:p>
-          <a:p/>
-          <a:p>
-            <a:r>
-              <a:t>Übergang: Auf der nächsten Folie lesen wir denselben Ablauf als klar getrennten Offline- und Online-Prozess.</a:t>
-            </a:r>
-          </a:p>
-          <a:p/>
-          <a:p>
-            <a:r>
-              <a:t>Kernbotschaft: Die aufwendige Dokumentverarbeitung geschieht offline; bei jeder Frage werden nur Query-Embedding, Suche und Generierung ausgeführt.</a:t>
-            </a:r>
-          </a:p>
-          <a:p/>
-          <a:p>
-            <a:r>
-              <a:t>Sprechtext: Der obere beziehungsweise linke Pfad wird beim Aufbau oder Aktualisieren des Index ausgeführt. Der Anfragepfad beginnt bei der Query, erzeugt ein Query-Embedding, sucht in der Vector Database und übergibt nur die ausgewählten Chunks an das LLM. Genau diese „Relevant Data“ sind der abgefragte Dokumentkontext, den wir später in der Evaluation vermessen.</a:t>
-            </a:r>
-          </a:p>
-          <a:p/>
-          <a:p>
-            <a:r>
-              <a:t>Publikumsfrage: An welchen Stellen kann trotz dieser Pipeline noch ein Fehler entstehen?</a:t>
-            </a:r>
-          </a:p>
-          <a:p/>
-          <a:p>
-            <a:r>
-              <a:t>Mögliche Antworten: schlechte PDF-Extraktion, ungünstige Chunk-Grenzen, unpassende Embeddings, falsche Rangfolge oder eine fehlerhafte Nutzung des richtigen Kontexts durch das Chat-LLM.</a:t>
-            </a:r>
-          </a:p>
-          <a:p/>
-          <a:p>
-            <a:r>
-              <a:t>Übergang: Diese Fehlerquellen bearbeiten wir im Repository in aufeinander aufbauenden Stufen.</a:t>
-            </a:r>
-          </a:p>
-        </p:txBody>
-      </p:sp>
-      <p:sp>
-        <p:nvSpPr>
-          <p:cNvPr id="4" name="Slide Number Placeholder 3"/>
-          <p:cNvSpPr>
-            <a:spLocks noGrp="1"/>
-          </p:cNvSpPr>
-          <p:nvPr>
-            <p:ph type="sldNum" idx="5" sz="quarter"/>
-          </p:nvPr>
-        </p:nvSpPr>
-        <p:spPr/>
+            <a:endParaRPr/>
+          </a:p>
+        </p:txBody>
       </p:sp>
     </p:spTree>
   </p:cSld>
@@ -1615,7 +1779,7 @@
 </file>
 
 <file path=ppt/notesSlides/notesSlide18.xml><?xml version="1.0" encoding="utf-8"?>
-<p:notes xmlns:a="http://schemas.openxmlformats.org/drawingml/2006/main" xmlns:p="http://schemas.openxmlformats.org/presentationml/2006/main" xmlns:r="http://schemas.openxmlformats.org/officeDocument/2006/relationships">
+<p:notes xmlns:a="http://schemas.openxmlformats.org/drawingml/2006/main" xmlns:r="http://schemas.openxmlformats.org/officeDocument/2006/relationships" xmlns:p="http://schemas.openxmlformats.org/presentationml/2006/main">
   <p:cSld>
     <p:spTree>
       <p:nvGrpSpPr>
@@ -1635,22 +1799,72 @@
         <p:nvSpPr>
           <p:cNvPr id="2" name="Slide Image Placeholder 1"/>
           <p:cNvSpPr>
-            <a:spLocks noGrp="1"/>
+            <a:spLocks noGrp="1" noRot="1" noChangeAspect="1"/>
           </p:cNvSpPr>
           <p:nvPr>
-            <p:ph type="sldImg" idx="2"/>
+            <p:ph type="sldImg"/>
           </p:nvPr>
         </p:nvSpPr>
+        <p:spPr>
+          <a:xfrm>
+            <a:off x="1081088" y="617538"/>
+            <a:ext cx="4695825" cy="2641600"/>
+          </a:xfrm>
+        </p:spPr>
+      </p:sp>
+      <p:sp>
+        <p:nvSpPr>
+          <p:cNvPr id="3" name="Notes Placeholder 2"/>
+          <p:cNvSpPr>
+            <a:spLocks noGrp="1"/>
+          </p:cNvSpPr>
+          <p:nvPr>
+            <p:ph type="body" idx="1"/>
+          </p:nvPr>
+        </p:nvSpPr>
         <p:spPr/>
-      </p:sp>
-      <p:sp>
-        <p:nvSpPr>
-          <p:cNvPr id="3" name="Notes Placeholder 2"/>
+        <p:txBody>
+          <a:bodyPr/>
+          <a:lstStyle/>
+          <a:p>
+            <a:r>
+              <a:t>Kernbotschaft: Die Frameworkwahl ist keine reine Featurefrage, sondern eine Entscheidung über Kontrolle, Transparenz und Betriebsaufwand.</a:t>
+            </a:r>
+          </a:p>
+          <a:p>
+            <a:endParaRPr/>
+          </a:p>
+          <a:p>
+            <a:r>
+              <a:t>Sprechtext: Unser Workshop-Code ist bewusst weitgehend framework-frei: OpenAI-kompatibler Client, ChromaDB und klar sichtbare Python-Funktionen. Das erhöht den Lernwert und macht jeden Verarbeitungsschritt nachvollziehbar. Frameworks wie LangChain oder LlamaIndex beschleunigen Standardintegrationen, bringen aber zusätzliche Abstraktionen und Versionsabhängigkeiten. Graph-orientierte Orchestrierung lohnt sich vor allem bei verzweigten, zustandsbehafteten Abläufen. Managed Services reduzieren Betriebsaufwand, erhöhen aber Kosten und Anbieterbindung.</a:t>
+            </a:r>
+          </a:p>
+          <a:p>
+            <a:endParaRPr/>
+          </a:p>
+          <a:p>
+            <a:r>
+              <a:t>Leitfrage: Welche Anforderungen dominieren im echten Projekt – schnelle Entwicklung, maximale Transparenz, komplexe Orchestrierung oder geringer Betrieb?</a:t>
+            </a:r>
+          </a:p>
+          <a:p>
+            <a:endParaRPr/>
+          </a:p>
+          <a:p>
+            <a:r>
+              <a:t>Übergang: Unabhängig vom Werkzeug bleiben drei Grundprinzipien bestehen.</a:t>
+            </a:r>
+          </a:p>
+        </p:txBody>
+      </p:sp>
+      <p:sp>
+        <p:nvSpPr>
+          <p:cNvPr id="4" name="Slide Number Placeholder 3"/>
           <p:cNvSpPr>
             <a:spLocks noGrp="1"/>
           </p:cNvSpPr>
           <p:nvPr>
-            <p:ph type="body" idx="3" sz="quarter"/>
+            <p:ph type="sldNum" idx="5"/>
           </p:nvPr>
         </p:nvSpPr>
         <p:spPr/>
@@ -1658,41 +1872,9 @@
           <a:bodyPr/>
           <a:lstStyle/>
           <a:p>
-            <a:r>
-              <a:t>Kernbotschaft: Im Hands-on bauen und testen wir die Pipeline selbst.</a:t>
-            </a:r>
-          </a:p>
-          <a:p/>
-          <a:p>
-            <a:r>
-              <a:t>Sprechtext: Bitte öffnet das Repository und prüft, ob die virtuelle Umgebung aktiv ist. VPN und API-Key müssen funktionieren; Zugangsdaten gehören ausschließlich in die lokale .env und nicht ins Git-Repository. Die Gesetzestexte und vorbereiteten Fragen bilden unseren gemeinsamen Testbestand.</a:t>
-            </a:r>
-          </a:p>
-          <a:p/>
-          <a:p>
-            <a:r>
-              <a:t>Publikumsfrage: Gibt es noch technische Blocker, bevor wir starten?</a:t>
-            </a:r>
-          </a:p>
-          <a:p/>
-          <a:p>
-            <a:r>
-              <a:t>Übergang: Wir beginnen mit der einfachsten lauffähigen Variante und erhöhen die Qualität schrittweise.</a:t>
-            </a:r>
-          </a:p>
-        </p:txBody>
-      </p:sp>
-      <p:sp>
-        <p:nvSpPr>
-          <p:cNvPr id="4" name="Slide Number Placeholder 3"/>
-          <p:cNvSpPr>
-            <a:spLocks noGrp="1"/>
-          </p:cNvSpPr>
-          <p:nvPr>
-            <p:ph type="sldNum" idx="5" sz="quarter"/>
-          </p:nvPr>
-        </p:nvSpPr>
-        <p:spPr/>
+            <a:endParaRPr/>
+          </a:p>
+        </p:txBody>
       </p:sp>
     </p:spTree>
   </p:cSld>
@@ -1703,7 +1885,7 @@
 </file>
 
 <file path=ppt/notesSlides/notesSlide19.xml><?xml version="1.0" encoding="utf-8"?>
-<p:notes xmlns:a="http://schemas.openxmlformats.org/drawingml/2006/main" xmlns:p="http://schemas.openxmlformats.org/presentationml/2006/main" xmlns:r="http://schemas.openxmlformats.org/officeDocument/2006/relationships">
+<p:notes xmlns:a="http://schemas.openxmlformats.org/drawingml/2006/main" xmlns:r="http://schemas.openxmlformats.org/officeDocument/2006/relationships" xmlns:p="http://schemas.openxmlformats.org/presentationml/2006/main">
   <p:cSld>
     <p:spTree>
       <p:nvGrpSpPr>
@@ -1723,22 +1905,72 @@
         <p:nvSpPr>
           <p:cNvPr id="2" name="Slide Image Placeholder 1"/>
           <p:cNvSpPr>
-            <a:spLocks noGrp="1"/>
+            <a:spLocks noGrp="1" noRot="1" noChangeAspect="1"/>
           </p:cNvSpPr>
           <p:nvPr>
-            <p:ph type="sldImg" idx="2"/>
+            <p:ph type="sldImg"/>
           </p:nvPr>
         </p:nvSpPr>
+        <p:spPr>
+          <a:xfrm>
+            <a:off x="1081088" y="617538"/>
+            <a:ext cx="4695825" cy="2641600"/>
+          </a:xfrm>
+        </p:spPr>
+      </p:sp>
+      <p:sp>
+        <p:nvSpPr>
+          <p:cNvPr id="3" name="Notes Placeholder 2"/>
+          <p:cNvSpPr>
+            <a:spLocks noGrp="1"/>
+          </p:cNvSpPr>
+          <p:nvPr>
+            <p:ph type="body" idx="1"/>
+          </p:nvPr>
+        </p:nvSpPr>
         <p:spPr/>
-      </p:sp>
-      <p:sp>
-        <p:nvSpPr>
-          <p:cNvPr id="3" name="Notes Placeholder 2"/>
+        <p:txBody>
+          <a:bodyPr/>
+          <a:lstStyle/>
+          <a:p>
+            <a:r>
+              <a:t>Kernbotschaft: Gutes RAG entsteht durch gezielten Kontext, getrennte Evaluation und nur so viel Komplexität wie messbar nötig.</a:t>
+            </a:r>
+          </a:p>
+          <a:p>
+            <a:endParaRPr/>
+          </a:p>
+          <a:p>
+            <a:r>
+              <a:t>Sprechtext: Erstens: RAG ist Context Engineering. Entscheidend ist nicht die maximale Menge, sondern die Relevanz des Kontexts. Zweitens: Retrieval und Antwort müssen getrennt gemessen werden – sonst wissen wir nicht, ob ein Fehler in der Suche oder in der Generierung liegt. Drittens: Chunking, Reranking, hybride Suche und Graphen sind Werkzeuge, keine Selbstzwecke. Wir ergänzen sie nur, wenn die Evaluation einen konkreten Nutzen zeigt.</a:t>
+            </a:r>
+          </a:p>
+          <a:p>
+            <a:endParaRPr/>
+          </a:p>
+          <a:p>
+            <a:r>
+              <a:t>Abschlussfrage: Welchen dieser Hebel würdet ihr in eurem eigenen Projekt als Erstes messen?</a:t>
+            </a:r>
+          </a:p>
+          <a:p>
+            <a:endParaRPr/>
+          </a:p>
+          <a:p>
+            <a:r>
+              <a:t>Übergang: Damit sind wir am Ende des Workshops – Zeit für Fragen und den Transfer in eure Anwendungsfälle.</a:t>
+            </a:r>
+          </a:p>
+        </p:txBody>
+      </p:sp>
+      <p:sp>
+        <p:nvSpPr>
+          <p:cNvPr id="4" name="Slide Number Placeholder 3"/>
           <p:cNvSpPr>
             <a:spLocks noGrp="1"/>
           </p:cNvSpPr>
           <p:nvPr>
-            <p:ph type="body" idx="3" sz="quarter"/>
+            <p:ph type="sldNum" idx="5"/>
           </p:nvPr>
         </p:nvSpPr>
         <p:spPr/>
@@ -1746,35 +1978,9 @@
           <a:bodyPr/>
           <a:lstStyle/>
           <a:p>
-            <a:r>
-              <a:t>Kernbotschaft: Advanced RAG beginnt dort, wo wir Retrieval nicht mehr als einzelne Vektorsuche betrachten.</a:t>
-            </a:r>
-          </a:p>
-          <a:p/>
-          <a:p>
-            <a:r>
-              <a:t>Sprechtext: Nach dem Baseline-RAG untersuchen wir drei Hebel: bessere Chunk-Grenzen, eine bessere Rangfolge vorhandener Kandidaten und zusätzliche lexikalische beziehungsweise graphbasierte Signale. Wichtig ist, jede zusätzliche Komplexität gegen dieselben Fragen und Metriken zu prüfen.</a:t>
-            </a:r>
-          </a:p>
-          <a:p/>
-          <a:p>
-            <a:r>
-              <a:t>Übergang: Der erste und oft unterschätzte Hebel ist das Chunking.</a:t>
-            </a:r>
-          </a:p>
-        </p:txBody>
-      </p:sp>
-      <p:sp>
-        <p:nvSpPr>
-          <p:cNvPr id="4" name="Slide Number Placeholder 3"/>
-          <p:cNvSpPr>
-            <a:spLocks noGrp="1"/>
-          </p:cNvSpPr>
-          <p:nvPr>
-            <p:ph type="sldNum" idx="5" sz="quarter"/>
-          </p:nvPr>
-        </p:nvSpPr>
-        <p:spPr/>
+            <a:endParaRPr/>
+          </a:p>
+        </p:txBody>
       </p:sp>
     </p:spTree>
   </p:cSld>
@@ -1786,165 +1992,6 @@
 
 <file path=ppt/notesSlides/notesSlide2.xml><?xml version="1.0" encoding="utf-8"?>
 <p:notes xmlns:a="http://schemas.openxmlformats.org/drawingml/2006/main" xmlns:r="http://schemas.openxmlformats.org/officeDocument/2006/relationships" xmlns:p="http://schemas.openxmlformats.org/presentationml/2006/main">
-  <p:cSld>
-    <p:spTree>
-      <p:nvGrpSpPr>
-        <p:cNvPr id="1" name="">
-          <a:extLst>
-            <a:ext uri="{FF2B5EF4-FFF2-40B4-BE49-F238E27FC236}">
-              <a16:creationId xmlns:a16="http://schemas.microsoft.com/office/drawing/2014/main" id="{5CD76D84-ECD5-F1BE-9C42-65ABF6B80EA3}"/>
-            </a:ext>
-          </a:extLst>
-        </p:cNvPr>
-        <p:cNvGrpSpPr/>
-        <p:nvPr/>
-      </p:nvGrpSpPr>
-      <p:grpSpPr>
-        <a:xfrm>
-          <a:off x="0" y="0"/>
-          <a:ext cx="0" cy="0"/>
-          <a:chOff x="0" y="0"/>
-          <a:chExt cx="0" cy="0"/>
-        </a:xfrm>
-      </p:grpSpPr>
-      <p:sp>
-        <p:nvSpPr>
-          <p:cNvPr id="2" name="Slide Image Placeholder 1">
-            <a:extLst>
-              <a:ext uri="{FF2B5EF4-FFF2-40B4-BE49-F238E27FC236}">
-                <a16:creationId xmlns:a16="http://schemas.microsoft.com/office/drawing/2014/main" id="{ED067005-E004-5FF5-8CCF-35C3192F10CA}"/>
-              </a:ext>
-            </a:extLst>
-          </p:cNvPr>
-          <p:cNvSpPr>
-            <a:spLocks noGrp="1" noRot="1" noChangeAspect="1"/>
-          </p:cNvSpPr>
-          <p:nvPr>
-            <p:ph type="sldImg"/>
-          </p:nvPr>
-        </p:nvSpPr>
-        <p:spPr>
-          <a:xfrm>
-            <a:off x="1081088" y="617538"/>
-            <a:ext cx="4695825" cy="2641600"/>
-          </a:xfrm>
-        </p:spPr>
-      </p:sp>
-      <p:sp>
-        <p:nvSpPr>
-          <p:cNvPr id="3" name="Notes Placeholder 2">
-            <a:extLst>
-              <a:ext uri="{FF2B5EF4-FFF2-40B4-BE49-F238E27FC236}">
-                <a16:creationId xmlns:a16="http://schemas.microsoft.com/office/drawing/2014/main" id="{8525DEA0-FB50-0FB1-BD8F-3CC6A173B32B}"/>
-              </a:ext>
-            </a:extLst>
-          </p:cNvPr>
-          <p:cNvSpPr>
-            <a:spLocks noGrp="1"/>
-          </p:cNvSpPr>
-          <p:nvPr>
-            <p:ph type="body" idx="1"/>
-          </p:nvPr>
-        </p:nvSpPr>
-        <p:spPr/>
-        <p:txBody>
-          <a:bodyPr/>
-          <a:lstStyle/>
-          <a:p>
-            <a:r>
-              <a:t>Kernbotschaft: RAG, MCP, Skills und große Kontextfenster lösen unterschiedliche Aufgaben im Context Engineering.</a:t>
-            </a:r>
-          </a:p>
-          <a:p/>
-          <a:p>
-            <a:r>
-              <a:t>Sprechtext: RAG ruft relevante Dokument-Chunks bei Bedarf ab. MCP macht Datenquellen oder Aktionen über standardisierte Connectoren verfügbar. Skills bündeln spezialisierte Anweisungen und Arbeitsabläufe, die nur bei Bedarf geladen werden. Ein großes Kontextfenster kann viel Material direkt aufnehmen, ist aber häufig die teuerste und unpräziseste Brute-Force-Variante.</a:t>
-            </a:r>
-          </a:p>
-          <a:p/>
-          <a:p>
-            <a:r>
-              <a:t>Wichtig: Ein Skill ist nicht einfach eine Wissensdatenbank. Er beschreibt vor allem, wie eine Aufgabe ausgeführt werden soll; RAG liefert dagegen die konkreten Dokumentinhalte.</a:t>
-            </a:r>
-          </a:p>
-          <a:p/>
-          <a:p>
-            <a:r>
-              <a:t>Übergang: Auf der nächsten Folie trennen wir noch genauer zwischen Anweisung und bereitgestelltem Kontext.</a:t>
-            </a:r>
-          </a:p>
-          <a:p/>
-          <a:p>
-            <a:r>
-              <a:t>Kernbotschaft: Der Systemprompt greift nicht selbst auf Dokumente zu – er legt Regeln fest, nach denen das Modell den bereitgestellten Kontext verwendet.</a:t>
-            </a:r>
-          </a:p>
-          <a:p/>
-          <a:p>
-            <a:r>
-              <a:t>Sprechtext: Diese Folie eignet sich als Publikumsfrage: „Worauf greift der Systemprompt zu?“ Die präzise Antwort lautet: Er greift nicht aktiv zu. Der Systemprompt ist eine Anweisung, zum Beispiel „Antworte nur anhand des Kontexts und nenne Quellen“. Erst die Anwendung beziehungsweise das Retrieval lädt passende Gesetzes-Chunks und fügt sie als Kontext in den Modellaufruf ein.</a:t>
-            </a:r>
-          </a:p>
-          <a:p/>
-          <a:p>
-            <a:r>
-              <a:t>Publikumsfrage: Was passiert, wenn der Systemprompt korrekt ist, aber Retrieval den falschen Artikel liefert?</a:t>
-            </a:r>
-          </a:p>
-          <a:p/>
-          <a:p>
-            <a:r>
-              <a:t>Erwartete Antwort: Das Modell kann die korrekte Information nicht zuverlässig nutzen; Prompting ersetzt kein gutes Retrieval.</a:t>
-            </a:r>
-          </a:p>
-          <a:p/>
-          <a:p>
-            <a:r>
-              <a:t>Übergang: Jetzt verfolgen wir den Datenfluss eines Vector RAGs von den Rohdaten bis zur Antwort.</a:t>
-            </a:r>
-          </a:p>
-        </p:txBody>
-      </p:sp>
-      <p:sp>
-        <p:nvSpPr>
-          <p:cNvPr id="4" name="Slide Number Placeholder 3">
-            <a:extLst>
-              <a:ext uri="{FF2B5EF4-FFF2-40B4-BE49-F238E27FC236}">
-                <a16:creationId xmlns:a16="http://schemas.microsoft.com/office/drawing/2014/main" id="{9ED937AB-F8F2-FF70-35EB-B9680596B5D1}"/>
-              </a:ext>
-            </a:extLst>
-          </p:cNvPr>
-          <p:cNvSpPr>
-            <a:spLocks noGrp="1"/>
-          </p:cNvSpPr>
-          <p:nvPr>
-            <p:ph type="sldNum" idx="5"/>
-          </p:nvPr>
-        </p:nvSpPr>
-        <p:spPr/>
-        <p:txBody>
-          <a:bodyPr/>
-          <a:lstStyle/>
-          <a:p>
-            <a:endParaRPr/>
-          </a:p>
-        </p:txBody>
-      </p:sp>
-    </p:spTree>
-    <p:extLst>
-      <p:ext uri="{BB962C8B-B14F-4D97-AF65-F5344CB8AC3E}">
-        <p14:creationId xmlns:p14="http://schemas.microsoft.com/office/powerpoint/2010/main" val="2100833005"/>
-      </p:ext>
-    </p:extLst>
-  </p:cSld>
-  <p:clrMapOvr>
-    <a:masterClrMapping/>
-  </p:clrMapOvr>
-</p:notes>
-</file>
-
-<file path=ppt/notesSlides/notesSlide20.xml><?xml version="1.0" encoding="utf-8"?>
-<p:notes xmlns:a="http://schemas.openxmlformats.org/drawingml/2006/main" xmlns:p="http://schemas.openxmlformats.org/presentationml/2006/main" xmlns:r="http://schemas.openxmlformats.org/officeDocument/2006/relationships">
   <p:cSld>
     <p:spTree>
       <p:nvGrpSpPr>
@@ -1964,7 +2011,7 @@
         <p:nvSpPr>
           <p:cNvPr id="2" name="Slide Image Placeholder 1"/>
           <p:cNvSpPr>
-            <a:spLocks noGrp="1"/>
+            <a:spLocks noGrp="1" noRot="1" noChangeAspect="1"/>
           </p:cNvSpPr>
           <p:nvPr>
             <p:ph type="sldImg" idx="2"/>
@@ -1979,7 +2026,7 @@
             <a:spLocks noGrp="1"/>
           </p:cNvSpPr>
           <p:nvPr>
-            <p:ph type="body" idx="3" sz="quarter"/>
+            <p:ph type="body" sz="quarter" idx="3"/>
           </p:nvPr>
         </p:nvSpPr>
         <p:spPr/>
@@ -1988,22 +2035,122 @@
           <a:lstStyle/>
           <a:p>
             <a:r>
+              <a:t>Kernbotschaft: Wir entwickeln die Lösung schrittweise und messen nach jeder Verbesserung erneut.</a:t>
+            </a:r>
+          </a:p>
+          <a:p>
+            <a:endParaRPr/>
+          </a:p>
+          <a:p>
+            <a:r>
+              <a:t>Sprechtext: Zuerst klären wir, welches Problem RAG löst. Danach bauen wir eine einfache Pipeline, verbessern das Chunking, ergänzen Reranking und schließlich GraphRAG. Die Evaluation läuft nicht nur am Ende: Sie begleitet jede Stufe, damit wir sehen, welche Änderung tatsächlich einen messbaren Effekt hat.</a:t>
+            </a:r>
+          </a:p>
+          <a:p>
+            <a:endParaRPr/>
+          </a:p>
+          <a:p>
+            <a:r>
+              <a:t>Publikumsfrage: Wer hat bereits selbst ein RAG-System gebaut oder eine Vektordatenbank verwendet?</a:t>
+            </a:r>
+          </a:p>
+          <a:p>
+            <a:endParaRPr/>
+          </a:p>
+          <a:p>
+            <a:r>
+              <a:t>Übergang: Bevor wir RAG definieren, schauen wir auf die Grenzen eines reinen LLMs.</a:t>
+            </a:r>
+          </a:p>
+        </p:txBody>
+      </p:sp>
+      <p:sp>
+        <p:nvSpPr>
+          <p:cNvPr id="4" name="Slide Number Placeholder 3"/>
+          <p:cNvSpPr>
+            <a:spLocks noGrp="1"/>
+          </p:cNvSpPr>
+          <p:nvPr>
+            <p:ph type="sldNum" sz="quarter" idx="5"/>
+          </p:nvPr>
+        </p:nvSpPr>
+        <p:spPr/>
+      </p:sp>
+    </p:spTree>
+  </p:cSld>
+  <p:clrMapOvr>
+    <a:masterClrMapping/>
+  </p:clrMapOvr>
+</p:notes>
+</file>
+
+<file path=ppt/notesSlides/notesSlide20.xml><?xml version="1.0" encoding="utf-8"?>
+<p:notes xmlns:a="http://schemas.openxmlformats.org/drawingml/2006/main" xmlns:r="http://schemas.openxmlformats.org/officeDocument/2006/relationships" xmlns:p="http://schemas.openxmlformats.org/presentationml/2006/main">
+  <p:cSld>
+    <p:spTree>
+      <p:nvGrpSpPr>
+        <p:cNvPr id="1" name=""/>
+        <p:cNvGrpSpPr/>
+        <p:nvPr/>
+      </p:nvGrpSpPr>
+      <p:grpSpPr>
+        <a:xfrm>
+          <a:off x="0" y="0"/>
+          <a:ext cx="0" cy="0"/>
+          <a:chOff x="0" y="0"/>
+          <a:chExt cx="0" cy="0"/>
+        </a:xfrm>
+      </p:grpSpPr>
+      <p:sp>
+        <p:nvSpPr>
+          <p:cNvPr id="2" name="Slide Image Placeholder 1"/>
+          <p:cNvSpPr>
+            <a:spLocks noGrp="1" noRot="1" noChangeAspect="1"/>
+          </p:cNvSpPr>
+          <p:nvPr>
+            <p:ph type="sldImg" idx="2"/>
+          </p:nvPr>
+        </p:nvSpPr>
+        <p:spPr/>
+      </p:sp>
+      <p:sp>
+        <p:nvSpPr>
+          <p:cNvPr id="3" name="Notes Placeholder 2"/>
+          <p:cNvSpPr>
+            <a:spLocks noGrp="1"/>
+          </p:cNvSpPr>
+          <p:nvPr>
+            <p:ph type="body" sz="quarter" idx="3"/>
+          </p:nvPr>
+        </p:nvSpPr>
+        <p:spPr/>
+        <p:txBody>
+          <a:bodyPr/>
+          <a:lstStyle/>
+          <a:p>
+            <a:r>
               <a:t>Kernbotschaft: Die Teilnehmenden sollen die Pipeline jetzt nicht nur ausführen, sondern ihre Qualitätsentscheidungen begründen können.</a:t>
             </a:r>
           </a:p>
-          <a:p/>
+          <a:p>
+            <a:endParaRPr/>
+          </a:p>
           <a:p>
             <a:r>
               <a:t>Sprechtext: Vielen Dank. Wir haben aus Schweizer Gesetzestexten eine nachvollziehbare RAG-Pipeline aufgebaut, mehrere Retrieval-Varianten verglichen und gesehen, warum gute Treffer noch keine perfekte Antwort garantieren. Die wichtigsten Artefakte sind der Code, die vorbereiteten Fragen und die Evaluationsberichte im Repository.</a:t>
             </a:r>
           </a:p>
-          <a:p/>
+          <a:p>
+            <a:endParaRPr/>
+          </a:p>
           <a:p>
             <a:r>
               <a:t>Mögliche Abschlussfragen an das Publikum: Wo würdet ihr RAG in eurem Umfeld einsetzen? Welche Daten- oder Compliance-Anforderungen wären dort kritisch? Welche Metrik fehlt euch für eine produktive Entscheidung?</a:t>
             </a:r>
           </a:p>
-          <a:p/>
+          <a:p>
+            <a:endParaRPr/>
+          </a:p>
           <a:p>
             <a:r>
               <a:t>Hinweis: Bei einer Live-Demo am Ende lieber eine bereits evaluierte Frage verwenden und gemeinsam Kontext, Quellen und Antwort vergleichen.</a:t>
@@ -2018,7 +2165,7 @@
             <a:spLocks noGrp="1"/>
           </p:cNvSpPr>
           <p:nvPr>
-            <p:ph type="sldNum" idx="5" sz="quarter"/>
+            <p:ph type="sldNum" sz="quarter" idx="5"/>
           </p:nvPr>
         </p:nvSpPr>
         <p:spPr/>
@@ -2055,15 +2202,10 @@
             <a:spLocks noGrp="1" noRot="1" noChangeAspect="1"/>
           </p:cNvSpPr>
           <p:nvPr>
-            <p:ph type="sldImg"/>
+            <p:ph type="sldImg" idx="2"/>
           </p:nvPr>
         </p:nvSpPr>
-        <p:spPr>
-          <a:xfrm>
-            <a:off x="1081088" y="617538"/>
-            <a:ext cx="4695825" cy="2641600"/>
-          </a:xfrm>
-        </p:spPr>
+        <p:spPr/>
       </p:sp>
       <p:sp>
         <p:nvSpPr>
@@ -2072,7 +2214,7 @@
             <a:spLocks noGrp="1"/>
           </p:cNvSpPr>
           <p:nvPr>
-            <p:ph type="body" idx="1"/>
+            <p:ph type="body" sz="quarter" idx="3"/>
           </p:nvPr>
         </p:nvSpPr>
         <p:spPr/>
@@ -2081,41 +2223,31 @@
           <a:lstStyle/>
           <a:p>
             <a:r>
-              <a:t>Kernbotschaft: Jede Projektstufe ergänzt genau einen neuen Qualitätshebel – und die Evaluation macht den Effekt sichtbar.</a:t>
-            </a:r>
-          </a:p>
-          <a:p/>
-          <a:p>
-            <a:r>
-              <a:t>Sprechtext: Stage 1 zeigt den reinen Modellaufruf ohne Retrieval. Stage 2 ergänzt Fixed-Size-Chunking und Vector Search. Stage 3 führt strukturorientiertes Chunking und anschließend Reranking ein. Stage 4 kombiniert semantische und lexikalische Suche mit Artikelauflösung und Graph-Nachbarn. evaluate.py kann die Methoden kumulativ ausführen, sodass nach jeder Verbesserung die bisherigen Varianten als Vergleich erhalten bleiben.</a:t>
-            </a:r>
-          </a:p>
-          <a:p/>
-          <a:p>
-            <a:r>
-              <a:t>Hinweis für die Demo: Die Collections und Embeddings müssen vor dem jeweiligen Chat- oder Evaluationslauf aufgebaut sein. VPN, API-Key und die konfigurierte .env sind erforderlich.</a:t>
-            </a:r>
-          </a:p>
-          <a:p/>
-          <a:p>
-            <a:r>
-              <a:t>Übergang: Nun wechseln wir vom Konzept in den praktischen Teil.</a:t>
-            </a:r>
-          </a:p>
-          <a:p/>
-          <a:p>
-            <a:r>
-              <a:t>[Sources]</a:t>
-            </a:r>
-          </a:p>
-          <a:p>
-            <a:r>
-              <a:t>- C:/Users/mehlst/Documents/RAG-Workshop/README.md</a:t>
-            </a:r>
-          </a:p>
-          <a:p>
-            <a:r>
-              <a:t>- C:/Users/mehlst/Documents/RAG-Workshop/evaluate.py</a:t>
+              <a:t>Kernbotschaft: RAG ist eine Methode, dem Modell zur Laufzeit gezielt externes Wissen bereitzustellen.</a:t>
+            </a:r>
+          </a:p>
+          <a:p>
+            <a:endParaRPr/>
+          </a:p>
+          <a:p>
+            <a:r>
+              <a:t>Sprechtext: In diesem Abschnitt geht es zunächst um das Warum. Wir trennen dabei zwei Dinge: Das Sprachmodell formuliert die Antwort; das Retrieval entscheidet, welche Informationen es dafür überhaupt sieht.</a:t>
+            </a:r>
+          </a:p>
+          <a:p>
+            <a:endParaRPr/>
+          </a:p>
+          <a:p>
+            <a:r>
+              <a:t>Publikumsfrage: Was fehlt einem reinen LLM, wenn wir eine aktuelle oder intern belegbare Antwort erwarten?</a:t>
+            </a:r>
+          </a:p>
+          <a:p>
+            <a:endParaRPr/>
+          </a:p>
+          <a:p>
+            <a:r>
+              <a:t>Übergang: Drei typische blinde Flecken machen dieses Problem sichtbar.</a:t>
             </a:r>
           </a:p>
         </p:txBody>
@@ -2127,17 +2259,10 @@
             <a:spLocks noGrp="1"/>
           </p:cNvSpPr>
           <p:nvPr>
-            <p:ph type="sldNum" idx="5"/>
+            <p:ph type="sldNum" sz="quarter" idx="5"/>
           </p:nvPr>
         </p:nvSpPr>
         <p:spPr/>
-        <p:txBody>
-          <a:bodyPr/>
-          <a:lstStyle/>
-          <a:p>
-            <a:endParaRPr/>
-          </a:p>
-        </p:txBody>
       </p:sp>
     </p:spTree>
   </p:cSld>
@@ -2171,15 +2296,10 @@
             <a:spLocks noGrp="1" noRot="1" noChangeAspect="1"/>
           </p:cNvSpPr>
           <p:nvPr>
-            <p:ph type="sldImg"/>
+            <p:ph type="sldImg" idx="2"/>
           </p:nvPr>
         </p:nvSpPr>
-        <p:spPr>
-          <a:xfrm>
-            <a:off x="1081088" y="617538"/>
-            <a:ext cx="4695825" cy="2641600"/>
-          </a:xfrm>
-        </p:spPr>
+        <p:spPr/>
       </p:sp>
       <p:sp>
         <p:nvSpPr>
@@ -2188,7 +2308,7 @@
             <a:spLocks noGrp="1"/>
           </p:cNvSpPr>
           <p:nvPr>
-            <p:ph type="body" idx="1"/>
+            <p:ph type="body" sz="quarter" idx="3"/>
           </p:nvPr>
         </p:nvSpPr>
         <p:spPr/>
@@ -2197,48 +2317,31 @@
           <a:lstStyle/>
           <a:p>
             <a:r>
-              <a:t>Kernbotschaft: Chunking bestimmt, welche Bedeutungseinheiten später überhaupt als Treffer zurückkommen können.</a:t>
-            </a:r>
-          </a:p>
-          <a:p/>
-          <a:p>
-            <a:r>
-              <a:t>Sprechtext: Links sehen wir Fixed-Size-Chunking mit einem starren Budget von 800 Zeichen. Die Grenze kann mitten in einem Satz oder direkt vor dem nächsten Artikel liegen. Dadurch verliert ein Treffer Kontext oder vermischt mehrere Artikel. Rechts orientiert sich unser verbessertes Verfahren primär an Markdown- und Artikelüberschriften. Übergroße Artikel werden zusätzlich an Satzgrenzen geteilt; kleine zusammengehörige Blöcke werden bis zum Budget verbunden.</a:t>
-            </a:r>
-          </a:p>
-          <a:p/>
-          <a:p>
-            <a:r>
-              <a:t>Präzisierung: Unser Budget beträgt 800 Zeichen, nicht 800 Tokens. Das Verfahren ist deshalb besser als „strukturorientiertes Chunking“ beschrieben; es ist kein LLM-basiertes semantisches Chunking.</a:t>
-            </a:r>
-          </a:p>
-          <a:p/>
-          <a:p>
-            <a:r>
-              <a:t>Zusätzlich entfernen wir typisches PDF-Rauschen wie Seitenmarker, Inhaltsverzeichnisse und isolierte Fundstellenblöcke. Quellen, die zum Gesetzesinhalt gehören, werden nicht pauschal gelöscht.</a:t>
-            </a:r>
-          </a:p>
-          <a:p/>
-          <a:p>
-            <a:r>
-              <a:t>Publikumsfrage: Welche Seite würdet ihr für die Suche nach Art. 335b OR bevorzugen – und warum?</a:t>
-            </a:r>
-          </a:p>
-          <a:p/>
-          <a:p>
-            <a:r>
-              <a:t>Übergang: Gute Chunks erzeugen bessere Kandidaten. Als Nächstes verbessern wir deren Reihenfolge.</a:t>
-            </a:r>
-          </a:p>
-          <a:p/>
-          <a:p>
-            <a:r>
-              <a:t>[Sources]</a:t>
-            </a:r>
-          </a:p>
-          <a:p>
-            <a:r>
-              <a:t>- C:/Users/mehlst/Documents/RAG-Workshop/rag-3a-ingest.py</a:t>
+              <a:t>Kernbotschaft: Ein reines LLM kennt nicht automatisch unsere aktuellen Daten, liefert keine verlässlichen Belege und kann nicht beliebig viel Kontext effizient verarbeiten.</a:t>
+            </a:r>
+          </a:p>
+          <a:p>
+            <a:endParaRPr/>
+          </a:p>
+          <a:p>
+            <a:r>
+              <a:t>Sprechtext: Erstens endet das Wissen des Modells an seinen Trainingsdaten und umfasst keine vertraulichen Firmendokumente. Zweitens kann eine plausible Antwort sprachlich überzeugend, aber sachlich falsch oder nicht nachvollziehbar sein. Drittens ist „alles in den Prompt legen“ teuer und erzeugt Rauschen: Mehr Kontext ist nicht automatisch besserer Kontext.</a:t>
+            </a:r>
+          </a:p>
+          <a:p>
+            <a:endParaRPr/>
+          </a:p>
+          <a:p>
+            <a:r>
+              <a:t>RAG macht das Modell nicht intelligenter. RAG steuert, welche Evidenz das Modell für eine konkrete Frage erhält.</a:t>
+            </a:r>
+          </a:p>
+          <a:p>
+            <a:endParaRPr/>
+          </a:p>
+          <a:p>
+            <a:r>
+              <a:t>Übergang: Diese Steuerung kann man als drei grundlegende Kontextoperationen verstehen.</a:t>
             </a:r>
           </a:p>
         </p:txBody>
@@ -2250,17 +2353,10 @@
             <a:spLocks noGrp="1"/>
           </p:cNvSpPr>
           <p:nvPr>
-            <p:ph type="sldNum" idx="5"/>
+            <p:ph type="sldNum" sz="quarter" idx="5"/>
           </p:nvPr>
         </p:nvSpPr>
         <p:spPr/>
-        <p:txBody>
-          <a:bodyPr/>
-          <a:lstStyle/>
-          <a:p>
-            <a:endParaRPr/>
-          </a:p>
-        </p:txBody>
       </p:sp>
     </p:spTree>
   </p:cSld>
@@ -2320,48 +2416,31 @@
           <a:lstStyle/>
           <a:p>
             <a:r>
-              <a:t>Kernbotschaft: Reranking sortiert gefundene Kandidaten neu; es kann keinen fehlenden Artikel herbeizaubern.</a:t>
-            </a:r>
-          </a:p>
-          <a:p/>
-          <a:p>
-            <a:r>
-              <a:t>Sprechtext: Die Vektorsuche holt zunächst eine größere Kandidatenmenge. Unser Cross-Encoder BAAI/bge-reranker-v2-m3 liest Frage und Chunk gemeinsam und bewertet ihre Relevanz genauer als der reine Vektorabstand. Für die Evaluation bleiben nach dem Reranking sechs Chunks im gemeinsamen Kontextbudget; der interaktive Chat verwendet standardmäßig vier.</a:t>
-            </a:r>
-          </a:p>
-          <a:p/>
-          <a:p>
-            <a:r>
-              <a:t>Der wichtigste Unterschied: Ein Bi-Encoder berechnet Dokument- und Query-Vektoren getrennt und ist schnell. Ein Cross-Encoder betrachtet beide Texte gemeinsam und ist präziser, aber langsamer. Deshalb wird er erst auf einer kleinen Kandidatenliste eingesetzt.</a:t>
-            </a:r>
-          </a:p>
-          <a:p/>
-          <a:p>
-            <a:r>
-              <a:t>Publikumsfrage: Was passiert, wenn Art. 1 OR in den ersten Kandidaten überhaupt nicht enthalten ist?</a:t>
-            </a:r>
-          </a:p>
-          <a:p/>
-          <a:p>
-            <a:r>
-              <a:t>Erwartete Antwort: Der Reranker kann ihn nicht auswählen; dafür brauchen wir besseren Recall im vorgelagerten Retrieval.</a:t>
-            </a:r>
-          </a:p>
-          <a:p/>
-          <a:p>
-            <a:r>
-              <a:t>Übergang: Genau dort setzt die hybride und graphbasierte Suche an.</a:t>
-            </a:r>
-          </a:p>
-          <a:p/>
-          <a:p>
-            <a:r>
-              <a:t>[Sources]</a:t>
-            </a:r>
-          </a:p>
-          <a:p>
-            <a:r>
-              <a:t>- C:/Users/mehlst/Documents/RAG-Workshop/rag-3c-chat-rerank.py</a:t>
+              <a:t>Kernbotschaft: LLM-Anwendungen erweitern, verdichten oder übersetzen Kontext – RAG ist besonders stark beim gezielten Verdichten.</a:t>
+            </a:r>
+          </a:p>
+          <a:p>
+            <a:endParaRPr/>
+          </a:p>
+          <a:p>
+            <a:r>
+              <a:t>Sprechtext: Expansion bedeutet, aus einer kurzen Eingabe umfangreichen Output zu erzeugen. Kompression bedeutet, aus vielen möglichen Informationen nur die relevanten Belege in den Prompt zu nehmen. Translation meint die Umwandlung zwischen Repräsentationen, etwa Text zu Embeddings oder Dokumente zu strukturierten Metadaten. Unsere RAG-Pipeline kombiniert alle drei, aber ihr eigentlicher Nutzen liegt in der kontrollierten Auswahl von Kontext.</a:t>
+            </a:r>
+          </a:p>
+          <a:p>
+            <a:endParaRPr/>
+          </a:p>
+          <a:p>
+            <a:r>
+              <a:t>Publikumsfrage: Welche dieser Operationen ist bei einer Frage wie „Was steht in Art. 1 OR?“ am wichtigsten?</a:t>
+            </a:r>
+          </a:p>
+          <a:p>
+            <a:endParaRPr/>
+          </a:p>
+          <a:p>
+            <a:r>
+              <a:t>Übergang: RAG ist damit ein Teilgebiet von Context Engineering – aber nicht die einzige Variante.</a:t>
             </a:r>
           </a:p>
         </p:txBody>
@@ -2398,7 +2477,13 @@
   <p:cSld>
     <p:spTree>
       <p:nvGrpSpPr>
-        <p:cNvPr id="1" name=""/>
+        <p:cNvPr id="1" name="">
+          <a:extLst>
+            <a:ext uri="{FF2B5EF4-FFF2-40B4-BE49-F238E27FC236}">
+              <a16:creationId xmlns:a16="http://schemas.microsoft.com/office/drawing/2014/main" id="{5CD76D84-ECD5-F1BE-9C42-65ABF6B80EA3}"/>
+            </a:ext>
+          </a:extLst>
+        </p:cNvPr>
         <p:cNvGrpSpPr/>
         <p:nvPr/>
       </p:nvGrpSpPr>
@@ -2412,7 +2497,13 @@
       </p:grpSpPr>
       <p:sp>
         <p:nvSpPr>
-          <p:cNvPr id="2" name="Slide Image Placeholder 1"/>
+          <p:cNvPr id="2" name="Slide Image Placeholder 1">
+            <a:extLst>
+              <a:ext uri="{FF2B5EF4-FFF2-40B4-BE49-F238E27FC236}">
+                <a16:creationId xmlns:a16="http://schemas.microsoft.com/office/drawing/2014/main" id="{ED067005-E004-5FF5-8CCF-35C3192F10CA}"/>
+              </a:ext>
+            </a:extLst>
+          </p:cNvPr>
           <p:cNvSpPr>
             <a:spLocks noGrp="1" noRot="1" noChangeAspect="1"/>
           </p:cNvSpPr>
@@ -2429,7 +2520,13 @@
       </p:sp>
       <p:sp>
         <p:nvSpPr>
-          <p:cNvPr id="3" name="Notes Placeholder 2"/>
+          <p:cNvPr id="3" name="Notes Placeholder 2">
+            <a:extLst>
+              <a:ext uri="{FF2B5EF4-FFF2-40B4-BE49-F238E27FC236}">
+                <a16:creationId xmlns:a16="http://schemas.microsoft.com/office/drawing/2014/main" id="{8525DEA0-FB50-0FB1-BD8F-3CC6A173B32B}"/>
+              </a:ext>
+            </a:extLst>
+          </p:cNvPr>
           <p:cNvSpPr>
             <a:spLocks noGrp="1"/>
           </p:cNvSpPr>
@@ -2443,54 +2540,84 @@
           <a:lstStyle/>
           <a:p>
             <a:r>
-              <a:t>Kernbotschaft: GraphRAG kombiniert mehrere Suchsignale, damit explizite Artikelangaben und strukturelle Beziehungen nicht von semantischer Ähnlichkeit verdrängt werden.</a:t>
-            </a:r>
-          </a:p>
-          <a:p/>
-          <a:p>
-            <a:r>
-              <a:t>Sprechtext: Zuerst holen wir semantische Vector-Treffer und lexikalische beziehungsweise BM25-Kandidaten. Reciprocal Rank Fusion führt beide Ranglisten robust zusammen, ohne die Rohscores direkt vergleichbar machen zu müssen. Explizite Referenzen wie „Art. 1 OR“ können zusätzlich auf eine konkrete Artikeldefinition aufgelöst werden. Danach ergänzen wir passende Graph-Nachbarn, etwa angrenzende Artikel oder erkannte Verweise.</a:t>
-            </a:r>
-          </a:p>
-          <a:p/>
-          <a:p>
-            <a:r>
-              <a:t>Der Graph ersetzt die Suche nicht. Er erweitert gute Seed-Treffer um strukturell verwandten Kontext. Das hilft besonders bei Fragen, die mehrere Artikel oder Erlasse verbinden.</a:t>
-            </a:r>
-          </a:p>
-          <a:p/>
-          <a:p>
-            <a:r>
-              <a:t>Publikumsfrage: Warum ist eine lexikalische Suche bei „Art. 1 OR“ oft zuverlässiger als reine semantische Ähnlichkeit?</a:t>
-            </a:r>
-          </a:p>
-          <a:p/>
-          <a:p>
-            <a:r>
-              <a:t>Übergang: Jetzt prüfen wir, ob diese zusätzliche Logik tatsächlich Recall, Rangfolge und Kontextbedarf verbessert.</a:t>
-            </a:r>
-          </a:p>
-          <a:p/>
-          <a:p>
-            <a:r>
-              <a:t>[Sources]</a:t>
-            </a:r>
-          </a:p>
-          <a:p>
-            <a:r>
-              <a:t>- C:/Users/mehlst/Documents/RAG-Workshop/graph_retrieval.py</a:t>
-            </a:r>
-          </a:p>
-          <a:p>
-            <a:r>
-              <a:t>- C:/Users/mehlst/Documents/RAG-Workshop/rag-4b-chat.py</a:t>
-            </a:r>
-          </a:p>
-        </p:txBody>
-      </p:sp>
-      <p:sp>
-        <p:nvSpPr>
-          <p:cNvPr id="4" name="Slide Number Placeholder 3"/>
+              <a:t>Kernbotschaft: RAG, MCP, Skills und große Kontextfenster lösen unterschiedliche Aufgaben im Context Engineering.</a:t>
+            </a:r>
+          </a:p>
+          <a:p>
+            <a:endParaRPr/>
+          </a:p>
+          <a:p>
+            <a:r>
+              <a:t>Sprechtext: RAG ruft relevante Dokument-Chunks bei Bedarf ab. MCP macht Datenquellen oder Aktionen über standardisierte Connectoren verfügbar. Skills bündeln spezialisierte Anweisungen und Arbeitsabläufe, die nur bei Bedarf geladen werden. Ein großes Kontextfenster kann viel Material direkt aufnehmen, ist aber häufig die teuerste und unpräziseste Brute-Force-Variante.</a:t>
+            </a:r>
+          </a:p>
+          <a:p>
+            <a:endParaRPr/>
+          </a:p>
+          <a:p>
+            <a:r>
+              <a:t>Wichtig: Ein Skill ist nicht einfach eine Wissensdatenbank. Er beschreibt vor allem, wie eine Aufgabe ausgeführt werden soll; RAG liefert dagegen die konkreten Dokumentinhalte.</a:t>
+            </a:r>
+          </a:p>
+          <a:p>
+            <a:endParaRPr/>
+          </a:p>
+          <a:p>
+            <a:r>
+              <a:t>Übergang: Auf der nächsten Folie trennen wir noch genauer zwischen Anweisung und bereitgestelltem Kontext.</a:t>
+            </a:r>
+          </a:p>
+          <a:p>
+            <a:endParaRPr/>
+          </a:p>
+          <a:p>
+            <a:r>
+              <a:t>Kernbotschaft: Der Systemprompt greift nicht selbst auf Dokumente zu – er legt Regeln fest, nach denen das Modell den bereitgestellten Kontext verwendet.</a:t>
+            </a:r>
+          </a:p>
+          <a:p>
+            <a:endParaRPr/>
+          </a:p>
+          <a:p>
+            <a:r>
+              <a:t>Sprechtext: Diese Folie eignet sich als Publikumsfrage: „Worauf greift der Systemprompt zu?“ Die präzise Antwort lautet: Er greift nicht aktiv zu. Der Systemprompt ist eine Anweisung, zum Beispiel „Antworte nur anhand des Kontexts und nenne Quellen“. Erst die Anwendung beziehungsweise das Retrieval lädt passende Gesetzes-Chunks und fügt sie als Kontext in den Modellaufruf ein.</a:t>
+            </a:r>
+          </a:p>
+          <a:p>
+            <a:endParaRPr/>
+          </a:p>
+          <a:p>
+            <a:r>
+              <a:t>Publikumsfrage: Was passiert, wenn der Systemprompt korrekt ist, aber Retrieval den falschen Artikel liefert?</a:t>
+            </a:r>
+          </a:p>
+          <a:p>
+            <a:endParaRPr/>
+          </a:p>
+          <a:p>
+            <a:r>
+              <a:t>Erwartete Antwort: Das Modell kann die korrekte Information nicht zuverlässig nutzen; Prompting ersetzt kein gutes Retrieval.</a:t>
+            </a:r>
+          </a:p>
+          <a:p>
+            <a:endParaRPr/>
+          </a:p>
+          <a:p>
+            <a:r>
+              <a:t>Übergang: Jetzt verfolgen wir den Datenfluss eines Vector RAGs von den Rohdaten bis zur Antwort.</a:t>
+            </a:r>
+          </a:p>
+        </p:txBody>
+      </p:sp>
+      <p:sp>
+        <p:nvSpPr>
+          <p:cNvPr id="4" name="Slide Number Placeholder 3">
+            <a:extLst>
+              <a:ext uri="{FF2B5EF4-FFF2-40B4-BE49-F238E27FC236}">
+                <a16:creationId xmlns:a16="http://schemas.microsoft.com/office/drawing/2014/main" id="{9ED937AB-F8F2-FF70-35EB-B9680596B5D1}"/>
+              </a:ext>
+            </a:extLst>
+          </p:cNvPr>
           <p:cNvSpPr>
             <a:spLocks noGrp="1"/>
           </p:cNvSpPr>
@@ -2508,6 +2635,11 @@
         </p:txBody>
       </p:sp>
     </p:spTree>
+    <p:extLst>
+      <p:ext uri="{BB962C8B-B14F-4D97-AF65-F5344CB8AC3E}">
+        <p14:creationId xmlns:p14="http://schemas.microsoft.com/office/powerpoint/2010/main" val="2100833005"/>
+      </p:ext>
+    </p:extLst>
   </p:cSld>
   <p:clrMapOvr>
     <a:masterClrMapping/>
@@ -2539,7 +2671,7 @@
             <a:spLocks noGrp="1" noRot="1" noChangeAspect="1"/>
           </p:cNvSpPr>
           <p:nvPr>
-            <p:ph type="sldImg"/>
+            <p:ph type="sldImg" idx="2"/>
           </p:nvPr>
         </p:nvSpPr>
         <p:spPr/>
@@ -2551,7 +2683,7 @@
             <a:spLocks noGrp="1"/>
           </p:cNvSpPr>
           <p:nvPr>
-            <p:ph type="body" idx="1"/>
+            <p:ph type="body" sz="quarter" idx="3"/>
           </p:nvPr>
         </p:nvSpPr>
         <p:spPr/>
@@ -2559,8 +2691,74 @@
           <a:bodyPr/>
           <a:lstStyle/>
           <a:p>
+            <a:r>
+              <a:t>Kernbotschaft: Ein Vector RAG besteht aus einer vorbereitenden Ingest-Pipeline und einer Laufzeit-Pipeline für Fragen.</a:t>
+            </a:r>
+          </a:p>
+          <a:p>
             <a:endParaRPr/>
           </a:p>
+          <a:p>
+            <a:r>
+              <a:t>Sprechtext: Links läuft der Ingest: Rohdateien werden extrahiert, bereinigt, in Chunks geteilt, in Embeddings übersetzt und in ChromaDB gespeichert. Rechts läuft die Anfrage: Auch die Frage wird mit demselben Embedding-Modell in einen Vektor übersetzt. Die Datenbank sucht ähnliche Chunks; diese werden als relevanter Kontext zusammen mit der Frage an das Chat-LLM gegeben.</a:t>
+            </a:r>
+          </a:p>
+          <a:p>
+            <a:endParaRPr/>
+          </a:p>
+          <a:p>
+            <a:r>
+              <a:t>Wichtig: Embedding-LLM und Chat-LLM haben unterschiedliche Aufgaben. Das Embedding-Modell erzeugt vergleichbare Vektoren; das Chat-Modell formuliert die Antwort.</a:t>
+            </a:r>
+          </a:p>
+          <a:p>
+            <a:endParaRPr/>
+          </a:p>
+          <a:p>
+            <a:r>
+              <a:t>Übergang: Auf der nächsten Folie lesen wir denselben Ablauf als klar getrennten Offline- und Online-Prozess.</a:t>
+            </a:r>
+          </a:p>
+          <a:p>
+            <a:endParaRPr/>
+          </a:p>
+          <a:p>
+            <a:r>
+              <a:t>Kernbotschaft: Die aufwendige Dokumentverarbeitung geschieht offline; bei jeder Frage werden nur Query-Embedding, Suche und Generierung ausgeführt.</a:t>
+            </a:r>
+          </a:p>
+          <a:p>
+            <a:endParaRPr/>
+          </a:p>
+          <a:p>
+            <a:r>
+              <a:t>Sprechtext: Der obere beziehungsweise linke Pfad wird beim Aufbau oder Aktualisieren des Index ausgeführt. Der Anfragepfad beginnt bei der Query, erzeugt ein Query-Embedding, sucht in der Vector Database und übergibt nur die ausgewählten Chunks an das LLM. Genau diese „Relevant Data“ sind der abgefragte Dokumentkontext, den wir später in der Evaluation vermessen.</a:t>
+            </a:r>
+          </a:p>
+          <a:p>
+            <a:endParaRPr/>
+          </a:p>
+          <a:p>
+            <a:r>
+              <a:t>Publikumsfrage: An welchen Stellen kann trotz dieser Pipeline noch ein Fehler entstehen?</a:t>
+            </a:r>
+          </a:p>
+          <a:p>
+            <a:endParaRPr/>
+          </a:p>
+          <a:p>
+            <a:r>
+              <a:t>Mögliche Antworten: schlechte PDF-Extraktion, ungünstige Chunk-Grenzen, unpassende Embeddings, falsche Rangfolge oder eine fehlerhafte Nutzung des richtigen Kontexts durch das Chat-LLM.</a:t>
+            </a:r>
+          </a:p>
+          <a:p>
+            <a:endParaRPr/>
+          </a:p>
+          <a:p>
+            <a:r>
+              <a:t>Übergang: Diese Fehlerquellen bearbeiten wir im Repository in aufeinander aufbauenden Stufen.</a:t>
+            </a:r>
+          </a:p>
         </p:txBody>
       </p:sp>
       <p:sp>
@@ -2570,17 +2768,10 @@
             <a:spLocks noGrp="1"/>
           </p:cNvSpPr>
           <p:nvPr>
-            <p:ph type="sldNum" idx="5"/>
+            <p:ph type="sldNum" sz="quarter" idx="5"/>
           </p:nvPr>
         </p:nvSpPr>
         <p:spPr/>
-        <p:txBody>
-          <a:bodyPr/>
-          <a:lstStyle/>
-          <a:p>
-            <a:endParaRPr/>
-          </a:p>
-        </p:txBody>
       </p:sp>
     </p:spTree>
   </p:cSld>
@@ -2640,34 +2831,36 @@
           <a:lstStyle/>
           <a:p>
             <a:r>
-              <a:t>Kernbotschaft: GraphRAG findet in diesem Workshop-Test die meisten erwarteten Artikel und benötigt gleichzeitig den kleinsten Prompt-Kontext; der Reranker liefert die beste frühe Rangposition.</a:t>
-            </a:r>
-          </a:p>
-          <a:p/>
-          <a:p>
-            <a:r>
-              <a:t>Sprechtext: Alle vier Methoden beantworten dieselben sechs Fragen mit demselben Kontextbudget von sechs Chunks. Article Recall@K misst, welcher Anteil aller erwarteten Artikel unter den K Treffern vorkommt. MRR – Mean Reciprocal Rank – belohnt eine frühe Position des ersten relevanten Artikels. Prompt-Kontext-Tokens zählen den tatsächlich in den Modellprompt eingefügten Dokumentkontext einschließlich Formatierung.</a:t>
-            </a:r>
-          </a:p>
-          <a:p/>
-          <a:p>
-            <a:r>
-              <a:t>Die Werte: Fixed erreicht 54 Prozent Recall, 0,43 MRR und 1.289 Tokens. Semantic erreicht 33 Prozent, 0,25 und 892 Tokens. Reranking erreicht 71 Prozent, 0,68 und 923 Tokens. GraphRAG erreicht 88 Prozent Recall, 0,52 MRR und 802 Tokens.</a:t>
-            </a:r>
-          </a:p>
-          <a:p/>
-          <a:p>
-            <a:r>
-              <a:t>Lesart: GraphRAG maximiert hier die Vollständigkeit bei kleinem Kontext. Reranking positioniert den ersten relevanten Treffer am besten. Diese sechs Fragen sind eine Workshop-Messung, keine allgemeine Benchmark.</a:t>
-            </a:r>
-          </a:p>
-          <a:p/>
-          <a:p>
-            <a:r>
-              <a:t>Übergang: Ein guter Retrieval-Treffer ist notwendig – aber beantwortet noch nicht, ob das LLM daraus eine vollständige und korrekt belegte Antwort erzeugt.</a:t>
-            </a:r>
-          </a:p>
-          <a:p/>
+              <a:t>Kernbotschaft: Jede Projektstufe ergänzt genau einen neuen Qualitätshebel – und die Evaluation macht den Effekt sichtbar.</a:t>
+            </a:r>
+          </a:p>
+          <a:p>
+            <a:endParaRPr/>
+          </a:p>
+          <a:p>
+            <a:r>
+              <a:t>Sprechtext: Stage 1 zeigt den reinen Modellaufruf ohne Retrieval. Stage 2 ergänzt Fixed-Size-Chunking und Vector Search. Stage 3 führt strukturorientiertes Chunking und anschließend Reranking ein. Stage 4 kombiniert semantische und lexikalische Suche mit Artikelauflösung und Graph-Nachbarn. evaluate.py kann die Methoden kumulativ ausführen, sodass nach jeder Verbesserung die bisherigen Varianten als Vergleich erhalten bleiben.</a:t>
+            </a:r>
+          </a:p>
+          <a:p>
+            <a:endParaRPr/>
+          </a:p>
+          <a:p>
+            <a:r>
+              <a:t>Hinweis für die Demo: Die Collections und Embeddings müssen vor dem jeweiligen Chat- oder Evaluationslauf aufgebaut sein. VPN, API-Key und die konfigurierte .env sind erforderlich.</a:t>
+            </a:r>
+          </a:p>
+          <a:p>
+            <a:endParaRPr/>
+          </a:p>
+          <a:p>
+            <a:r>
+              <a:t>Übergang: Nun wechseln wir vom Konzept in den praktischen Teil.</a:t>
+            </a:r>
+          </a:p>
+          <a:p>
+            <a:endParaRPr/>
+          </a:p>
           <a:p>
             <a:r>
               <a:t>[Sources]</a:t>
@@ -2675,7 +2868,7 @@
           </a:p>
           <a:p>
             <a:r>
-              <a:t>- C:/Users/mehlst/Documents/RAG-Workshop/evaluation/report-graph.md</a:t>
+              <a:t>- C:/Users/mehlst/Documents/RAG-Workshop/README.md</a:t>
             </a:r>
           </a:p>
           <a:p>
@@ -2736,15 +2929,10 @@
             <a:spLocks noGrp="1" noRot="1" noChangeAspect="1"/>
           </p:cNvSpPr>
           <p:nvPr>
-            <p:ph type="sldImg"/>
+            <p:ph type="sldImg" idx="2"/>
           </p:nvPr>
         </p:nvSpPr>
-        <p:spPr>
-          <a:xfrm>
-            <a:off x="1081088" y="617538"/>
-            <a:ext cx="4695825" cy="2641600"/>
-          </a:xfrm>
-        </p:spPr>
+        <p:spPr/>
       </p:sp>
       <p:sp>
         <p:nvSpPr>
@@ -2753,7 +2941,7 @@
             <a:spLocks noGrp="1"/>
           </p:cNvSpPr>
           <p:nvPr>
-            <p:ph type="body" idx="1"/>
+            <p:ph type="body" sz="quarter" idx="3"/>
           </p:nvPr>
         </p:nvSpPr>
         <p:spPr/>
@@ -2762,47 +2950,31 @@
           <a:lstStyle/>
           <a:p>
             <a:r>
-              <a:t>Kernbotschaft: Retrieval-Qualität und Antwortqualität sind zwei getrennte Ebenen und müssen separat bewertet werden.</a:t>
-            </a:r>
-          </a:p>
-          <a:p/>
-          <a:p>
-            <a:r>
-              <a:t>Sprechtext: Die dunkelblauen Balken zeigen die Faktenabdeckung – auf Englisch Fact Coverage. Sie misst, welcher Anteil der zuvor definierten erforderlichen Fakten in der generierten Antwort enthalten ist. Die hellblauen beziehungsweise türkisen Balken zeigen die Zitationsvollständigkeit – Citation Completeness. Sie misst, welcher Anteil der erwarteten Artikelbezeichnungen in der Antwort zitiert wird.</a:t>
-            </a:r>
-          </a:p>
-          <a:p/>
-          <a:p>
-            <a:r>
-              <a:t>Im vollständigen Lauf erreicht GraphRAG 55,6 Prozent Faktenabdeckung und 66,7 Prozent Zitationsvollständigkeit. Fixed Vector erzielt trotz schwächerem Retrieval 61,1 Prozent Faktenabdeckung. Das ist kein Widerspruch: Das generierende LLM ist nicht vollständig deterministisch und kann vorhandenen Kontext unvollständig nutzen oder einen falschen Artikel nennen.</a:t>
-            </a:r>
-          </a:p>
-          <a:p/>
-          <a:p>
-            <a:r>
-              <a:t>Wichtig: Faktenabdeckung bewertet das Vorhandensein erwarteter Inhalte, nicht automatisch juristische Korrektheit jeder Aussage. Zitationsvollständigkeit sagt, ob erwartete Quellen genannt wurden; sie sagt allein noch nicht, ob die jeweilige Quelle die Aussage tatsächlich belegt.</a:t>
-            </a:r>
-          </a:p>
-          <a:p/>
-          <a:p>
-            <a:r>
-              <a:t>Übergang: Diese Ergebnisse bilden die Grundlage für die Gruppenarbeit: Wo würden wir als Nächstes investieren?</a:t>
-            </a:r>
-          </a:p>
-          <a:p/>
-          <a:p>
-            <a:r>
-              <a:t>[Sources]</a:t>
-            </a:r>
-          </a:p>
-          <a:p>
-            <a:r>
-              <a:t>- C:/Users/mehlst/Documents/RAG-Workshop/evaluation/report-graph.md</a:t>
-            </a:r>
-          </a:p>
-          <a:p>
-            <a:r>
-              <a:t>- C:/Users/mehlst/Documents/RAG-Workshop/evaluate.py</a:t>
+              <a:t>Kernbotschaft: Im Hands-on bauen und testen wir die Pipeline selbst.</a:t>
+            </a:r>
+          </a:p>
+          <a:p>
+            <a:endParaRPr/>
+          </a:p>
+          <a:p>
+            <a:r>
+              <a:t>Sprechtext: Bitte öffnet das Repository und prüft, ob die virtuelle Umgebung aktiv ist. VPN und API-Key müssen funktionieren; Zugangsdaten gehören ausschließlich in die lokale .env und nicht ins Git-Repository. Die Gesetzestexte und vorbereiteten Fragen bilden unseren gemeinsamen Testbestand.</a:t>
+            </a:r>
+          </a:p>
+          <a:p>
+            <a:endParaRPr/>
+          </a:p>
+          <a:p>
+            <a:r>
+              <a:t>Publikumsfrage: Gibt es noch technische Blocker, bevor wir starten?</a:t>
+            </a:r>
+          </a:p>
+          <a:p>
+            <a:endParaRPr/>
+          </a:p>
+          <a:p>
+            <a:r>
+              <a:t>Übergang: Wir beginnen mit der einfachsten lauffähigen Variante und erhöhen die Qualität schrittweise.</a:t>
             </a:r>
           </a:p>
         </p:txBody>
@@ -2814,17 +2986,10 @@
             <a:spLocks noGrp="1"/>
           </p:cNvSpPr>
           <p:nvPr>
-            <p:ph type="sldNum" idx="5"/>
+            <p:ph type="sldNum" sz="quarter" idx="5"/>
           </p:nvPr>
         </p:nvSpPr>
         <p:spPr/>
-        <p:txBody>
-          <a:bodyPr/>
-          <a:lstStyle/>
-          <a:p>
-            <a:endParaRPr/>
-          </a:p>
-        </p:txBody>
       </p:sp>
     </p:spTree>
   </p:cSld>
@@ -6356,7 +6521,7 @@
         <p:spPr>
           <a:xfrm>
             <a:off x="498765" y="3660815"/>
-            <a:ext cx="6148215" cy="514351"/>
+            <a:ext cx="6148215" cy="971475"/>
           </a:xfrm>
           <a:prstGeom prst="rect">
             <a:avLst/>
@@ -6588,6 +6753,12 @@
             <a:r>
               <a:rPr lang="de-DE" dirty="0"/>
               <a:t>Bau eines eigenen Knowledge-Workers</a:t>
+            </a:r>
+          </a:p>
+          <a:p>
+            <a:r>
+              <a:rPr lang="de-DE" dirty="0"/>
+              <a:t>Stephanie Mehltretter, Daniel Frey</a:t>
             </a:r>
           </a:p>
         </p:txBody>
@@ -28750,7 +28921,7 @@
             <a:avLst/>
           </a:prstGeom>
           <a:blipFill dpi="0" rotWithShape="1">
-            <a:blip r:embed="rId2">
+            <a:blip r:embed="rId3">
               <a:extLst>
                 <a:ext uri="{28A0092B-C50C-407E-A947-70E740481C1C}">
                   <a14:useLocalDpi xmlns:a14="http://schemas.microsoft.com/office/drawing/2010/main" val="0"/>
@@ -28816,7 +28987,7 @@
             <a:avLst/>
           </a:prstGeom>
           <a:blipFill dpi="0" rotWithShape="1">
-            <a:blip r:embed="rId3">
+            <a:blip r:embed="rId4">
               <a:extLst>
                 <a:ext uri="{28A0092B-C50C-407E-A947-70E740481C1C}">
                   <a14:useLocalDpi xmlns:a14="http://schemas.microsoft.com/office/drawing/2010/main" val="0"/>
@@ -35454,7 +35625,7 @@
           <p:nvPr/>
         </p:nvPicPr>
         <p:blipFill>
-          <a:blip r:embed="rId2"/>
+          <a:blip r:embed="rId3"/>
           <a:stretch>
             <a:fillRect/>
           </a:stretch>
@@ -35542,7 +35713,7 @@
           <p:nvPr/>
         </p:nvPicPr>
         <p:blipFill>
-          <a:blip r:embed="rId3"/>
+          <a:blip r:embed="rId4"/>
           <a:stretch>
             <a:fillRect/>
           </a:stretch>
@@ -35674,7 +35845,7 @@
           <p:nvPr/>
         </p:nvPicPr>
         <p:blipFill>
-          <a:blip r:embed="rId4"/>
+          <a:blip r:embed="rId5"/>
           <a:stretch>
             <a:fillRect/>
           </a:stretch>
@@ -35806,7 +35977,7 @@
           <p:nvPr/>
         </p:nvPicPr>
         <p:blipFill>
-          <a:blip r:embed="rId5"/>
+          <a:blip r:embed="rId6"/>
           <a:stretch>
             <a:fillRect/>
           </a:stretch>
@@ -35984,7 +36155,7 @@
           <p:nvPr/>
         </p:nvPicPr>
         <p:blipFill>
-          <a:blip r:embed="rId6"/>
+          <a:blip r:embed="rId7"/>
           <a:stretch>
             <a:fillRect/>
           </a:stretch>
@@ -36162,7 +36333,7 @@
           <p:nvPr/>
         </p:nvPicPr>
         <p:blipFill>
-          <a:blip r:embed="rId7"/>
+          <a:blip r:embed="rId8"/>
           <a:stretch>
             <a:fillRect/>
           </a:stretch>
@@ -36340,7 +36511,7 @@
           <p:nvPr/>
         </p:nvPicPr>
         <p:blipFill>
-          <a:blip r:embed="rId7"/>
+          <a:blip r:embed="rId8"/>
           <a:stretch>
             <a:fillRect/>
           </a:stretch>
@@ -36518,7 +36689,7 @@
           <p:nvPr/>
         </p:nvPicPr>
         <p:blipFill>
-          <a:blip r:embed="rId8"/>
+          <a:blip r:embed="rId9"/>
           <a:stretch>
             <a:fillRect/>
           </a:stretch>
@@ -36696,7 +36867,7 @@
           <p:nvPr/>
         </p:nvPicPr>
         <p:blipFill>
-          <a:blip r:embed="rId9"/>
+          <a:blip r:embed="rId10"/>
           <a:stretch>
             <a:fillRect/>
           </a:stretch>
@@ -36877,7 +37048,7 @@
           <p:nvPr/>
         </p:nvPicPr>
         <p:blipFill>
-          <a:blip r:embed="rId10"/>
+          <a:blip r:embed="rId11"/>
           <a:stretch>
             <a:fillRect/>
           </a:stretch>
@@ -37058,7 +37229,7 @@
           <p:nvPr/>
         </p:nvPicPr>
         <p:blipFill>
-          <a:blip r:embed="rId10"/>
+          <a:blip r:embed="rId11"/>
           <a:stretch>
             <a:fillRect/>
           </a:stretch>
@@ -37723,7 +37894,7 @@
           <p:nvPr/>
         </p:nvPicPr>
         <p:blipFill>
-          <a:blip r:embed="rId11"/>
+          <a:blip r:embed="rId12"/>
           <a:stretch>
             <a:fillRect/>
           </a:stretch>
@@ -38269,7 +38440,7 @@
           <p:nvPr/>
         </p:nvPicPr>
         <p:blipFill>
-          <a:blip r:embed="rId10"/>
+          <a:blip r:embed="rId11"/>
           <a:stretch>
             <a:fillRect/>
           </a:stretch>
@@ -43273,17 +43444,6 @@
 </file>
 
 <file path=customXml/item2.xml><?xml version="1.0" encoding="utf-8"?>
-<p:properties xmlns:p="http://schemas.microsoft.com/office/2006/metadata/properties" xmlns:xsi="http://www.w3.org/2001/XMLSchema-instance" xmlns:pc="http://schemas.microsoft.com/office/infopath/2007/PartnerControls">
-  <documentManagement>
-    <lcf76f155ced4ddcb4097134ff3c332f xmlns="501edefc-5b9b-422a-9450-cf7f1f30e3fa">
-      <Terms xmlns="http://schemas.microsoft.com/office/infopath/2007/PartnerControls"/>
-    </lcf76f155ced4ddcb4097134ff3c332f>
-    <TaxCatchAll xmlns="3083c7a9-d95a-44c4-8fb8-f93b125494d6" xsi:nil="true"/>
-  </documentManagement>
-</p:properties>
-</file>
-
-<file path=customXml/item3.xml><?xml version="1.0" encoding="utf-8"?>
 <ct:contentTypeSchema xmlns:ct="http://schemas.microsoft.com/office/2006/metadata/contentType" xmlns:ma="http://schemas.microsoft.com/office/2006/metadata/properties/metaAttributes" ct:_="" ma:_="" ma:contentTypeName="Dokument" ma:contentTypeID="0x0101007D39DBAC6A50C74E998B9EB660A68B40" ma:contentTypeVersion="12" ma:contentTypeDescription="Ein neues Dokument erstellen." ma:contentTypeScope="" ma:versionID="34dc225a7d6106712b96f9699847575b">
   <xsd:schema xmlns:xsd="http://www.w3.org/2001/XMLSchema" xmlns:xs="http://www.w3.org/2001/XMLSchema" xmlns:p="http://schemas.microsoft.com/office/2006/metadata/properties" xmlns:ns2="501edefc-5b9b-422a-9450-cf7f1f30e3fa" xmlns:ns3="3083c7a9-d95a-44c4-8fb8-f93b125494d6" targetNamespace="http://schemas.microsoft.com/office/2006/metadata/properties" ma:root="true" ma:fieldsID="b7244162b0b071e6bfc5af2eca0d94d3" ns2:_="" ns3:_="">
     <xsd:import namespace="501edefc-5b9b-422a-9450-cf7f1f30e3fa"/>
@@ -43484,6 +43644,17 @@
 </ct:contentTypeSchema>
 </file>
 
+<file path=customXml/item3.xml><?xml version="1.0" encoding="utf-8"?>
+<p:properties xmlns:p="http://schemas.microsoft.com/office/2006/metadata/properties" xmlns:xsi="http://www.w3.org/2001/XMLSchema-instance" xmlns:pc="http://schemas.microsoft.com/office/infopath/2007/PartnerControls">
+  <documentManagement>
+    <lcf76f155ced4ddcb4097134ff3c332f xmlns="501edefc-5b9b-422a-9450-cf7f1f30e3fa">
+      <Terms xmlns="http://schemas.microsoft.com/office/infopath/2007/PartnerControls"/>
+    </lcf76f155ced4ddcb4097134ff3c332f>
+    <TaxCatchAll xmlns="3083c7a9-d95a-44c4-8fb8-f93b125494d6" xsi:nil="true"/>
+  </documentManagement>
+</p:properties>
+</file>
+
 <file path=customXml/itemProps1.xml><?xml version="1.0" encoding="utf-8"?>
 <ds:datastoreItem xmlns:ds="http://schemas.openxmlformats.org/officeDocument/2006/customXml" ds:itemID="{334436CE-240F-4EE4-9FC5-4255E6874223}">
   <ds:schemaRefs>
@@ -43493,21 +43664,6 @@
 </file>
 
 <file path=customXml/itemProps2.xml><?xml version="1.0" encoding="utf-8"?>
-<ds:datastoreItem xmlns:ds="http://schemas.openxmlformats.org/officeDocument/2006/customXml" ds:itemID="{6302A1CC-4AEF-4830-BB1C-A446161EB02D}">
-  <ds:schemaRefs>
-    <ds:schemaRef ds:uri="http://schemas.microsoft.com/office/2006/metadata/properties"/>
-    <ds:schemaRef ds:uri="http://schemas.microsoft.com/office/infopath/2007/PartnerControls"/>
-    <ds:schemaRef ds:uri="7052a6c1-2dbf-49e9-b6e1-6fe4487af028"/>
-    <ds:schemaRef ds:uri="d8f140f0-05e7-48e3-ba8b-dcc0ff83b3dd"/>
-    <ds:schemaRef ds:uri="b22023f0-d141-4df7-85ad-6dd1e1377ec8"/>
-    <ds:schemaRef ds:uri="bf122554-6983-45b2-a605-6e185ba8cf82"/>
-    <ds:schemaRef ds:uri="501edefc-5b9b-422a-9450-cf7f1f30e3fa"/>
-    <ds:schemaRef ds:uri="3083c7a9-d95a-44c4-8fb8-f93b125494d6"/>
-  </ds:schemaRefs>
-</ds:datastoreItem>
-</file>
-
-<file path=customXml/itemProps3.xml><?xml version="1.0" encoding="utf-8"?>
 <ds:datastoreItem xmlns:ds="http://schemas.openxmlformats.org/officeDocument/2006/customXml" ds:itemID="{42C8284C-7C61-4B35-A2FD-8E50AFE93672}">
   <ds:schemaRefs>
     <ds:schemaRef ds:uri="http://schemas.microsoft.com/office/2006/metadata/contentType"/>
@@ -43526,6 +43682,21 @@
 </ds:datastoreItem>
 </file>
 
+<file path=customXml/itemProps3.xml><?xml version="1.0" encoding="utf-8"?>
+<ds:datastoreItem xmlns:ds="http://schemas.openxmlformats.org/officeDocument/2006/customXml" ds:itemID="{6302A1CC-4AEF-4830-BB1C-A446161EB02D}">
+  <ds:schemaRefs>
+    <ds:schemaRef ds:uri="http://schemas.microsoft.com/office/2006/metadata/properties"/>
+    <ds:schemaRef ds:uri="http://schemas.microsoft.com/office/infopath/2007/PartnerControls"/>
+    <ds:schemaRef ds:uri="7052a6c1-2dbf-49e9-b6e1-6fe4487af028"/>
+    <ds:schemaRef ds:uri="d8f140f0-05e7-48e3-ba8b-dcc0ff83b3dd"/>
+    <ds:schemaRef ds:uri="b22023f0-d141-4df7-85ad-6dd1e1377ec8"/>
+    <ds:schemaRef ds:uri="bf122554-6983-45b2-a605-6e185ba8cf82"/>
+    <ds:schemaRef ds:uri="501edefc-5b9b-422a-9450-cf7f1f30e3fa"/>
+    <ds:schemaRef ds:uri="3083c7a9-d95a-44c4-8fb8-f93b125494d6"/>
+  </ds:schemaRefs>
+</ds:datastoreItem>
+</file>
+
 <file path=docMetadata/LabelInfo.xml><?xml version="1.0" encoding="utf-8"?>
 <clbl:labelList xmlns:clbl="http://schemas.microsoft.com/office/2020/mipLabelMetadata">
   <clbl:label id="{42e461c6-591f-4920-9cf0-f1389542f8ad}" enabled="1" method="Standard" siteId="{2cda5d11-f0ac-46b3-967d-af1b2e1bd01a}" contentBits="2" removed="0"/>

</xml_diff>

<commit_message>
Unlock grouping for the diagram shapes on slide 7
The rounded rectangles, label text boxes and divider connectors of the
Vector-RAG diagram carried placeholder-style noGrp locks, which PowerPoint
does not surface anywhere and which disable the Group command for any
selection containing them. Strip the lock from the 37 non-placeholder
shapes; title and slide-number placeholders keep theirs.

Co-Authored-By: Claude Fable 5 <noreply@anthropic.com>
Claude-Session: https://claude.ai/code/session_01S2kGP2buE2HmxMttD3XczR
</commit_message>
<xml_diff>
--- a/RAG_Workshop.pptx
+++ b/RAG_Workshop.pptx
@@ -2111,7 +2111,12 @@
             <p:ph type="sldImg" idx="2"/>
           </p:nvPr>
         </p:nvSpPr>
-        <p:spPr/>
+        <p:spPr>
+          <a:xfrm>
+            <a:off x="1081088" y="617538"/>
+            <a:ext cx="4695825" cy="2641600"/>
+          </a:xfrm>
+        </p:spPr>
       </p:sp>
       <p:sp>
         <p:nvSpPr>
@@ -2674,7 +2679,12 @@
             <p:ph type="sldImg" idx="2"/>
           </p:nvPr>
         </p:nvSpPr>
-        <p:spPr/>
+        <p:spPr>
+          <a:xfrm>
+            <a:off x="1081088" y="617538"/>
+            <a:ext cx="4695825" cy="2641600"/>
+          </a:xfrm>
+        </p:spPr>
       </p:sp>
       <p:sp>
         <p:nvSpPr>
@@ -8857,14 +8867,7 @@
               </a:defRPr>
             </a:pPr>
             <a:r>
-              <a:rPr lang="de-DE" sz="2850" dirty="0">
-                <a:solidFill>
-                  <a:srgbClr val="2D3F4B"/>
-                </a:solidFill>
-                <a:latin typeface="Arial"/>
-                <a:ea typeface="Arial"/>
-                <a:cs typeface="Arial"/>
-              </a:rPr>
+              <a:rPr lang="de-DE" sz="3600" dirty="0"/>
               <a:t>Chunking entscheidet, was auffindbar bleibt</a:t>
             </a:r>
           </a:p>
@@ -9682,7 +9685,7 @@
               </a:defRPr>
             </a:pPr>
             <a:r>
-              <a:rPr sz="2850" b="0">
+              <a:rPr sz="2850" b="0" dirty="0">
                 <a:solidFill>
                   <a:srgbClr val="2D3F4B"/>
                 </a:solidFill>
@@ -9690,8 +9693,115 @@
                 <a:ea typeface="Arial"/>
                 <a:cs typeface="Arial"/>
               </a:rPr>
-              <a:t>Reranking sortiert Kandidaten – es findet keine neuen</a:t>
-            </a:r>
+              <a:t>Reranking </a:t>
+            </a:r>
+            <a:r>
+              <a:rPr sz="2850" b="0" dirty="0" err="1">
+                <a:solidFill>
+                  <a:srgbClr val="2D3F4B"/>
+                </a:solidFill>
+                <a:latin typeface="Arial"/>
+                <a:ea typeface="Arial"/>
+                <a:cs typeface="Arial"/>
+              </a:rPr>
+              <a:t>sortiert</a:t>
+            </a:r>
+            <a:r>
+              <a:rPr sz="2850" b="0" dirty="0">
+                <a:solidFill>
+                  <a:srgbClr val="2D3F4B"/>
+                </a:solidFill>
+                <a:latin typeface="Arial"/>
+                <a:ea typeface="Arial"/>
+                <a:cs typeface="Arial"/>
+              </a:rPr>
+              <a:t> </a:t>
+            </a:r>
+            <a:r>
+              <a:rPr sz="2850" b="0" dirty="0" err="1">
+                <a:solidFill>
+                  <a:srgbClr val="2D3F4B"/>
+                </a:solidFill>
+                <a:latin typeface="Arial"/>
+                <a:ea typeface="Arial"/>
+                <a:cs typeface="Arial"/>
+              </a:rPr>
+              <a:t>Kandidaten</a:t>
+            </a:r>
+            <a:r>
+              <a:rPr sz="2850" b="0" dirty="0">
+                <a:solidFill>
+                  <a:srgbClr val="2D3F4B"/>
+                </a:solidFill>
+                <a:latin typeface="Arial"/>
+                <a:ea typeface="Arial"/>
+                <a:cs typeface="Arial"/>
+              </a:rPr>
+              <a:t> – es </a:t>
+            </a:r>
+            <a:r>
+              <a:rPr sz="2850" b="0" dirty="0" err="1">
+                <a:solidFill>
+                  <a:srgbClr val="2D3F4B"/>
+                </a:solidFill>
+                <a:latin typeface="Arial"/>
+                <a:ea typeface="Arial"/>
+                <a:cs typeface="Arial"/>
+              </a:rPr>
+              <a:t>findet</a:t>
+            </a:r>
+            <a:r>
+              <a:rPr sz="2850" b="0" dirty="0">
+                <a:solidFill>
+                  <a:srgbClr val="2D3F4B"/>
+                </a:solidFill>
+                <a:latin typeface="Arial"/>
+                <a:ea typeface="Arial"/>
+                <a:cs typeface="Arial"/>
+              </a:rPr>
+              <a:t> </a:t>
+            </a:r>
+            <a:r>
+              <a:rPr sz="2850" b="0" dirty="0" err="1">
+                <a:solidFill>
+                  <a:srgbClr val="2D3F4B"/>
+                </a:solidFill>
+                <a:latin typeface="Arial"/>
+                <a:ea typeface="Arial"/>
+                <a:cs typeface="Arial"/>
+              </a:rPr>
+              <a:t>keine</a:t>
+            </a:r>
+            <a:r>
+              <a:rPr sz="2850" b="0" dirty="0">
+                <a:solidFill>
+                  <a:srgbClr val="2D3F4B"/>
+                </a:solidFill>
+                <a:latin typeface="Arial"/>
+                <a:ea typeface="Arial"/>
+                <a:cs typeface="Arial"/>
+              </a:rPr>
+              <a:t> </a:t>
+            </a:r>
+            <a:r>
+              <a:rPr sz="2850" b="0" dirty="0" err="1">
+                <a:solidFill>
+                  <a:srgbClr val="2D3F4B"/>
+                </a:solidFill>
+                <a:latin typeface="Arial"/>
+                <a:ea typeface="Arial"/>
+                <a:cs typeface="Arial"/>
+              </a:rPr>
+              <a:t>neuen</a:t>
+            </a:r>
+            <a:endParaRPr sz="2850" b="0" dirty="0">
+              <a:solidFill>
+                <a:srgbClr val="2D3F4B"/>
+              </a:solidFill>
+              <a:latin typeface="Arial"/>
+              <a:ea typeface="Arial"/>
+              <a:cs typeface="Arial"/>
+            </a:endParaRPr>
           </a:p>
         </p:txBody>
       </p:sp>
@@ -11084,17 +11194,14 @@
                 <a:cs typeface="Arial"/>
               </a:defRPr>
             </a:pPr>
-            <a:r>
-              <a:rPr sz="2550" b="1">
-                <a:solidFill>
-                  <a:srgbClr val="FFFFFF"/>
-                </a:solidFill>
-                <a:latin typeface="Arial"/>
-                <a:ea typeface="Arial"/>
-                <a:cs typeface="Arial"/>
-              </a:rPr>
-              <a:t>×</a:t>
-            </a:r>
+            <a:endParaRPr sz="2550" b="1" dirty="0">
+              <a:solidFill>
+                <a:srgbClr val="FFFFFF"/>
+              </a:solidFill>
+              <a:latin typeface="Arial"/>
+              <a:ea typeface="Arial"/>
+              <a:cs typeface="Arial"/>
+            </a:endParaRPr>
           </a:p>
         </p:txBody>
       </p:sp>
@@ -12267,6 +12374,36 @@
           </a:p>
         </p:txBody>
       </p:sp>
+      <p:pic>
+        <p:nvPicPr>
+          <p:cNvPr id="2" name="Grafik 39">
+            <a:extLst>
+              <a:ext uri="{FF2B5EF4-FFF2-40B4-BE49-F238E27FC236}">
+                <a16:creationId xmlns:a16="http://schemas.microsoft.com/office/drawing/2014/main" id="{010C40FB-D25D-CD65-BF09-E9CF2713632D}"/>
+              </a:ext>
+            </a:extLst>
+          </p:cNvPr>
+          <p:cNvPicPr>
+            <a:picLocks noChangeAspect="1"/>
+          </p:cNvPicPr>
+          <p:nvPr/>
+        </p:nvPicPr>
+        <p:blipFill>
+          <a:blip r:embed="rId4"/>
+          <a:stretch>
+            <a:fillRect/>
+          </a:stretch>
+        </p:blipFill>
+        <p:spPr>
+          <a:xfrm flipH="1">
+            <a:off x="7337063" y="2714625"/>
+            <a:ext cx="584924" cy="593680"/>
+          </a:xfrm>
+          <a:prstGeom prst="rect">
+            <a:avLst/>
+          </a:prstGeom>
+        </p:spPr>
+      </p:pic>
     </p:spTree>
     <p:extLst>
       <p:ext uri="{BB962C8B-B14F-4D97-AF65-F5344CB8AC3E}">
@@ -13450,6 +13587,33 @@
                                   </p:childTnLst>
                                 </p:cTn>
                               </p:par>
+                              <p:par>
+                                <p:cTn id="91" presetID="1" presetClass="entr" presetSubtype="0" fill="hold" nodeType="withEffect">
+                                  <p:stCondLst>
+                                    <p:cond delay="0"/>
+                                  </p:stCondLst>
+                                  <p:childTnLst>
+                                    <p:set>
+                                      <p:cBhvr>
+                                        <p:cTn id="92" dur="1" fill="hold">
+                                          <p:stCondLst>
+                                            <p:cond delay="0"/>
+                                          </p:stCondLst>
+                                        </p:cTn>
+                                        <p:tgtEl>
+                                          <p:spTgt spid="2"/>
+                                        </p:tgtEl>
+                                        <p:attrNameLst>
+                                          <p:attrName>style.visibility</p:attrName>
+                                        </p:attrNameLst>
+                                      </p:cBhvr>
+                                      <p:to>
+                                        <p:strVal val="visible"/>
+                                      </p:to>
+                                    </p:set>
+                                  </p:childTnLst>
+                                </p:cTn>
+                              </p:par>
                             </p:childTnLst>
                           </p:cTn>
                         </p:par>
@@ -13457,26 +13621,26 @@
                     </p:cTn>
                   </p:par>
                   <p:par>
-                    <p:cTn id="91" fill="hold">
+                    <p:cTn id="93" fill="hold">
                       <p:stCondLst>
                         <p:cond delay="indefinite"/>
                       </p:stCondLst>
                       <p:childTnLst>
                         <p:par>
-                          <p:cTn id="92" fill="hold">
+                          <p:cTn id="94" fill="hold">
                             <p:stCondLst>
                               <p:cond delay="0"/>
                             </p:stCondLst>
                             <p:childTnLst>
                               <p:par>
-                                <p:cTn id="93" presetID="1" presetClass="entr" presetSubtype="0" fill="hold" grpId="0" nodeType="clickEffect">
+                                <p:cTn id="95" presetID="1" presetClass="entr" presetSubtype="0" fill="hold" grpId="0" nodeType="clickEffect">
                                   <p:stCondLst>
                                     <p:cond delay="0"/>
                                   </p:stCondLst>
                                   <p:childTnLst>
                                     <p:set>
                                       <p:cBhvr>
-                                        <p:cTn id="94" dur="1" fill="hold">
+                                        <p:cTn id="96" dur="1" fill="hold">
                                           <p:stCondLst>
                                             <p:cond delay="0"/>
                                           </p:stCondLst>
@@ -13496,14 +13660,14 @@
                                 </p:cTn>
                               </p:par>
                               <p:par>
-                                <p:cTn id="95" presetID="1" presetClass="entr" presetSubtype="0" fill="hold" grpId="0" nodeType="withEffect">
+                                <p:cTn id="97" presetID="1" presetClass="entr" presetSubtype="0" fill="hold" grpId="0" nodeType="withEffect">
                                   <p:stCondLst>
                                     <p:cond delay="0"/>
                                   </p:stCondLst>
                                   <p:childTnLst>
                                     <p:set>
                                       <p:cBhvr>
-                                        <p:cTn id="96" dur="1" fill="hold">
+                                        <p:cTn id="98" dur="1" fill="hold">
                                           <p:stCondLst>
                                             <p:cond delay="0"/>
                                           </p:stCondLst>
@@ -35472,7 +35636,7 @@
             </a:extLst>
           </p:cNvPr>
           <p:cNvSpPr>
-            <a:spLocks noGrp="1"/>
+            <a:spLocks/>
           </p:cNvSpPr>
           <p:nvPr/>
         </p:nvSpPr>
@@ -35530,7 +35694,7 @@
             </a:extLst>
           </p:cNvPr>
           <p:cNvSpPr>
-            <a:spLocks noGrp="1"/>
+            <a:spLocks/>
           </p:cNvSpPr>
           <p:nvPr/>
         </p:nvSpPr>
@@ -35570,7 +35734,7 @@
             </a:extLst>
           </p:cNvPr>
           <p:cNvSpPr>
-            <a:spLocks noGrp="1"/>
+            <a:spLocks/>
           </p:cNvSpPr>
           <p:nvPr/>
         </p:nvSpPr>
@@ -35650,7 +35814,7 @@
             </a:extLst>
           </p:cNvPr>
           <p:cNvSpPr>
-            <a:spLocks noGrp="1"/>
+            <a:spLocks/>
           </p:cNvSpPr>
           <p:nvPr/>
         </p:nvSpPr>
@@ -35719,9 +35883,9 @@
           </a:stretch>
         </p:blipFill>
         <p:spPr>
-          <a:xfrm flipH="1">
-            <a:off x="10611919" y="1867303"/>
-            <a:ext cx="609861" cy="566720"/>
+          <a:xfrm>
+            <a:off x="10611917" y="1867303"/>
+            <a:ext cx="609864" cy="566720"/>
           </a:xfrm>
           <a:prstGeom prst="rect">
             <a:avLst/>
@@ -35738,7 +35902,7 @@
             </a:extLst>
           </p:cNvPr>
           <p:cNvSpPr>
-            <a:spLocks noGrp="1"/>
+            <a:spLocks/>
           </p:cNvSpPr>
           <p:nvPr/>
         </p:nvSpPr>
@@ -35782,13 +35946,13 @@
             </a:extLst>
           </p:cNvPr>
           <p:cNvSpPr>
-            <a:spLocks noGrp="1"/>
-          </p:cNvSpPr>
-          <p:nvPr/>
-        </p:nvSpPr>
-        <p:spPr>
-          <a:xfrm>
-            <a:off x="10287000" y="4619625"/>
+            <a:spLocks/>
+          </p:cNvSpPr>
+          <p:nvPr/>
+        </p:nvSpPr>
+        <p:spPr>
+          <a:xfrm>
+            <a:off x="10287000" y="5162179"/>
             <a:ext cx="1259680" cy="866775"/>
           </a:xfrm>
           <a:prstGeom prst="roundRect">
@@ -35852,7 +36016,7 @@
         </p:blipFill>
         <p:spPr>
           <a:xfrm flipH="1">
-            <a:off x="10596787" y="4903297"/>
+            <a:off x="10596787" y="5445851"/>
             <a:ext cx="614864" cy="571508"/>
           </a:xfrm>
           <a:prstGeom prst="rect">
@@ -35870,13 +36034,13 @@
             </a:extLst>
           </p:cNvPr>
           <p:cNvSpPr>
-            <a:spLocks noGrp="1"/>
-          </p:cNvSpPr>
-          <p:nvPr/>
-        </p:nvSpPr>
-        <p:spPr>
-          <a:xfrm>
-            <a:off x="10274379" y="4638304"/>
+            <a:spLocks/>
+          </p:cNvSpPr>
+          <p:nvPr/>
+        </p:nvSpPr>
+        <p:spPr>
+          <a:xfrm>
+            <a:off x="10274379" y="5180858"/>
             <a:ext cx="1259680" cy="276999"/>
           </a:xfrm>
           <a:prstGeom prst="rect">
@@ -35914,13 +36078,13 @@
             </a:extLst>
           </p:cNvPr>
           <p:cNvSpPr>
-            <a:spLocks noGrp="1"/>
-          </p:cNvSpPr>
-          <p:nvPr/>
-        </p:nvSpPr>
-        <p:spPr>
-          <a:xfrm>
-            <a:off x="523875" y="3952875"/>
+            <a:spLocks/>
+          </p:cNvSpPr>
+          <p:nvPr/>
+        </p:nvSpPr>
+        <p:spPr>
+          <a:xfrm>
+            <a:off x="513827" y="3952875"/>
             <a:ext cx="1658163" cy="866775"/>
           </a:xfrm>
           <a:prstGeom prst="roundRect">
@@ -35984,7 +36148,7 @@
         </p:blipFill>
         <p:spPr>
           <a:xfrm flipH="1">
-            <a:off x="1119276" y="4248553"/>
+            <a:off x="1109228" y="4248553"/>
             <a:ext cx="467360" cy="559581"/>
           </a:xfrm>
           <a:prstGeom prst="rect">
@@ -36002,13 +36166,13 @@
             </a:extLst>
           </p:cNvPr>
           <p:cNvSpPr>
-            <a:spLocks noGrp="1"/>
-          </p:cNvSpPr>
-          <p:nvPr/>
-        </p:nvSpPr>
-        <p:spPr>
-          <a:xfrm>
-            <a:off x="511254" y="3971554"/>
+            <a:spLocks/>
+          </p:cNvSpPr>
+          <p:nvPr/>
+        </p:nvSpPr>
+        <p:spPr>
+          <a:xfrm>
+            <a:off x="501206" y="3971554"/>
             <a:ext cx="1733633" cy="276999"/>
           </a:xfrm>
           <a:prstGeom prst="rect">
@@ -36042,13 +36206,13 @@
             </a:extLst>
           </p:cNvPr>
           <p:cNvSpPr>
-            <a:spLocks noGrp="1"/>
-          </p:cNvSpPr>
-          <p:nvPr/>
-        </p:nvSpPr>
-        <p:spPr>
-          <a:xfrm>
-            <a:off x="523875" y="4248553"/>
+            <a:spLocks/>
+          </p:cNvSpPr>
+          <p:nvPr/>
+        </p:nvSpPr>
+        <p:spPr>
+          <a:xfrm>
+            <a:off x="513827" y="4248553"/>
             <a:ext cx="1658163" cy="0"/>
           </a:xfrm>
           <a:prstGeom prst="line">
@@ -36092,7 +36256,7 @@
             </a:extLst>
           </p:cNvPr>
           <p:cNvSpPr>
-            <a:spLocks noGrp="1"/>
+            <a:spLocks/>
           </p:cNvSpPr>
           <p:nvPr/>
         </p:nvSpPr>
@@ -36140,36 +36304,6 @@
           </a:p>
         </p:txBody>
       </p:sp>
-      <p:pic>
-        <p:nvPicPr>
-          <p:cNvPr id="46" name="Grafik 10">
-            <a:extLst>
-              <a:ext uri="{FF2B5EF4-FFF2-40B4-BE49-F238E27FC236}">
-                <a16:creationId xmlns:a16="http://schemas.microsoft.com/office/drawing/2014/main" id="{BE3EA945-55FA-7EAD-DC73-B9FB8CEDC576}"/>
-              </a:ext>
-            </a:extLst>
-          </p:cNvPr>
-          <p:cNvPicPr>
-            <a:picLocks noChangeAspect="1"/>
-          </p:cNvPicPr>
-          <p:nvPr/>
-        </p:nvPicPr>
-        <p:blipFill>
-          <a:blip r:embed="rId7"/>
-          <a:stretch>
-            <a:fillRect/>
-          </a:stretch>
-        </p:blipFill>
-        <p:spPr>
-          <a:xfrm flipH="1">
-            <a:off x="1116684" y="3076607"/>
-            <a:ext cx="455061" cy="530359"/>
-          </a:xfrm>
-          <a:prstGeom prst="rect">
-            <a:avLst/>
-          </a:prstGeom>
-        </p:spPr>
-      </p:pic>
       <p:sp>
         <p:nvSpPr>
           <p:cNvPr id="48" name="Textfeld 60">
@@ -36180,7 +36314,7 @@
             </a:extLst>
           </p:cNvPr>
           <p:cNvSpPr>
-            <a:spLocks noGrp="1"/>
+            <a:spLocks/>
           </p:cNvSpPr>
           <p:nvPr/>
         </p:nvSpPr>
@@ -36220,7 +36354,7 @@
             </a:extLst>
           </p:cNvPr>
           <p:cNvSpPr>
-            <a:spLocks noGrp="1"/>
+            <a:spLocks/>
           </p:cNvSpPr>
           <p:nvPr/>
         </p:nvSpPr>
@@ -36270,13 +36404,13 @@
             </a:extLst>
           </p:cNvPr>
           <p:cNvSpPr>
-            <a:spLocks noGrp="1"/>
-          </p:cNvSpPr>
-          <p:nvPr/>
-        </p:nvSpPr>
-        <p:spPr>
-          <a:xfrm>
-            <a:off x="5119500" y="1578909"/>
+            <a:spLocks/>
+          </p:cNvSpPr>
+          <p:nvPr/>
+        </p:nvSpPr>
+        <p:spPr>
+          <a:xfrm>
+            <a:off x="5099404" y="1578909"/>
             <a:ext cx="1259680" cy="866775"/>
           </a:xfrm>
           <a:prstGeom prst="roundRect">
@@ -36333,15 +36467,15 @@
           <p:nvPr/>
         </p:nvPicPr>
         <p:blipFill>
-          <a:blip r:embed="rId8"/>
+          <a:blip r:embed="rId7"/>
           <a:stretch>
             <a:fillRect/>
           </a:stretch>
         </p:blipFill>
         <p:spPr>
           <a:xfrm flipH="1">
-            <a:off x="5478577" y="1886883"/>
-            <a:ext cx="541526" cy="571097"/>
+            <a:off x="5487815" y="1917819"/>
+            <a:ext cx="482858" cy="509226"/>
           </a:xfrm>
           <a:prstGeom prst="rect">
             <a:avLst/>
@@ -36358,13 +36492,13 @@
             </a:extLst>
           </p:cNvPr>
           <p:cNvSpPr>
-            <a:spLocks noGrp="1"/>
-          </p:cNvSpPr>
-          <p:nvPr/>
-        </p:nvSpPr>
-        <p:spPr>
-          <a:xfrm>
-            <a:off x="5106879" y="1597588"/>
+            <a:spLocks/>
+          </p:cNvSpPr>
+          <p:nvPr/>
+        </p:nvSpPr>
+        <p:spPr>
+          <a:xfrm>
+            <a:off x="5086783" y="1597588"/>
             <a:ext cx="1259680" cy="276999"/>
           </a:xfrm>
           <a:prstGeom prst="rect">
@@ -36398,13 +36532,13 @@
             </a:extLst>
           </p:cNvPr>
           <p:cNvSpPr>
-            <a:spLocks noGrp="1"/>
+            <a:spLocks/>
           </p:cNvSpPr>
           <p:nvPr/>
         </p:nvSpPr>
         <p:spPr>
           <a:xfrm flipV="1">
-            <a:off x="5119500" y="1874587"/>
+            <a:off x="5099404" y="1874587"/>
             <a:ext cx="1259680" cy="12295"/>
           </a:xfrm>
           <a:prstGeom prst="line">
@@ -36448,13 +36582,13 @@
             </a:extLst>
           </p:cNvPr>
           <p:cNvSpPr>
-            <a:spLocks noGrp="1"/>
-          </p:cNvSpPr>
-          <p:nvPr/>
-        </p:nvSpPr>
-        <p:spPr>
-          <a:xfrm>
-            <a:off x="8096250" y="3048000"/>
+            <a:spLocks/>
+          </p:cNvSpPr>
+          <p:nvPr/>
+        </p:nvSpPr>
+        <p:spPr>
+          <a:xfrm>
+            <a:off x="8096250" y="2776991"/>
             <a:ext cx="1259680" cy="866775"/>
           </a:xfrm>
           <a:prstGeom prst="roundRect">
@@ -36511,14 +36645,14 @@
           <p:nvPr/>
         </p:nvPicPr>
         <p:blipFill>
-          <a:blip r:embed="rId8"/>
+          <a:blip r:embed="rId7"/>
           <a:stretch>
             <a:fillRect/>
           </a:stretch>
         </p:blipFill>
         <p:spPr>
           <a:xfrm flipH="1">
-            <a:off x="8455327" y="3355974"/>
+            <a:off x="8455327" y="3084965"/>
             <a:ext cx="541526" cy="571097"/>
           </a:xfrm>
           <a:prstGeom prst="rect">
@@ -36536,13 +36670,13 @@
             </a:extLst>
           </p:cNvPr>
           <p:cNvSpPr>
-            <a:spLocks noGrp="1"/>
-          </p:cNvSpPr>
-          <p:nvPr/>
-        </p:nvSpPr>
-        <p:spPr>
-          <a:xfrm>
-            <a:off x="8083629" y="3066679"/>
+            <a:spLocks/>
+          </p:cNvSpPr>
+          <p:nvPr/>
+        </p:nvSpPr>
+        <p:spPr>
+          <a:xfrm>
+            <a:off x="8083629" y="2795670"/>
             <a:ext cx="1259680" cy="276999"/>
           </a:xfrm>
           <a:prstGeom prst="rect">
@@ -36576,13 +36710,13 @@
             </a:extLst>
           </p:cNvPr>
           <p:cNvSpPr>
-            <a:spLocks noGrp="1"/>
+            <a:spLocks/>
           </p:cNvSpPr>
           <p:nvPr/>
         </p:nvSpPr>
         <p:spPr>
           <a:xfrm flipV="1">
-            <a:off x="8096250" y="3343678"/>
+            <a:off x="8096250" y="3072669"/>
             <a:ext cx="1259680" cy="12296"/>
           </a:xfrm>
           <a:prstGeom prst="line">
@@ -36626,13 +36760,13 @@
             </a:extLst>
           </p:cNvPr>
           <p:cNvSpPr>
-            <a:spLocks noGrp="1"/>
-          </p:cNvSpPr>
-          <p:nvPr/>
-        </p:nvSpPr>
-        <p:spPr>
-          <a:xfrm>
-            <a:off x="5095875" y="3048000"/>
+            <a:spLocks/>
+          </p:cNvSpPr>
+          <p:nvPr/>
+        </p:nvSpPr>
+        <p:spPr>
+          <a:xfrm>
+            <a:off x="5095875" y="2776991"/>
             <a:ext cx="1259680" cy="866775"/>
           </a:xfrm>
           <a:prstGeom prst="roundRect">
@@ -36689,15 +36823,15 @@
           <p:nvPr/>
         </p:nvPicPr>
         <p:blipFill>
-          <a:blip r:embed="rId9"/>
+          <a:blip r:embed="rId8"/>
           <a:stretch>
             <a:fillRect/>
           </a:stretch>
         </p:blipFill>
         <p:spPr>
           <a:xfrm flipH="1">
-            <a:off x="5405249" y="3397860"/>
-            <a:ext cx="631298" cy="547851"/>
+            <a:off x="5440897" y="3157787"/>
+            <a:ext cx="560002" cy="485980"/>
           </a:xfrm>
           <a:prstGeom prst="rect">
             <a:avLst/>
@@ -36714,13 +36848,13 @@
             </a:extLst>
           </p:cNvPr>
           <p:cNvSpPr>
-            <a:spLocks noGrp="1"/>
-          </p:cNvSpPr>
-          <p:nvPr/>
-        </p:nvSpPr>
-        <p:spPr>
-          <a:xfrm>
-            <a:off x="5083254" y="3066679"/>
+            <a:spLocks/>
+          </p:cNvSpPr>
+          <p:nvPr/>
+        </p:nvSpPr>
+        <p:spPr>
+          <a:xfrm>
+            <a:off x="5083254" y="2795670"/>
             <a:ext cx="1341782" cy="285750"/>
           </a:xfrm>
           <a:prstGeom prst="rect">
@@ -36754,13 +36888,13 @@
             </a:extLst>
           </p:cNvPr>
           <p:cNvSpPr>
-            <a:spLocks noGrp="1"/>
-          </p:cNvSpPr>
-          <p:nvPr/>
-        </p:nvSpPr>
-        <p:spPr>
-          <a:xfrm>
-            <a:off x="5095875" y="3352429"/>
+            <a:spLocks/>
+          </p:cNvSpPr>
+          <p:nvPr/>
+        </p:nvSpPr>
+        <p:spPr>
+          <a:xfrm>
+            <a:off x="5095875" y="3081420"/>
             <a:ext cx="1252223" cy="0"/>
           </a:xfrm>
           <a:prstGeom prst="line">
@@ -36804,13 +36938,13 @@
             </a:extLst>
           </p:cNvPr>
           <p:cNvSpPr>
-            <a:spLocks noGrp="1"/>
-          </p:cNvSpPr>
-          <p:nvPr/>
-        </p:nvSpPr>
-        <p:spPr>
-          <a:xfrm>
-            <a:off x="5095875" y="4619625"/>
+            <a:spLocks/>
+          </p:cNvSpPr>
+          <p:nvPr/>
+        </p:nvSpPr>
+        <p:spPr>
+          <a:xfrm>
+            <a:off x="5095875" y="5162179"/>
             <a:ext cx="1259680" cy="866775"/>
           </a:xfrm>
           <a:prstGeom prst="roundRect">
@@ -36867,14 +37001,14 @@
           <p:nvPr/>
         </p:nvPicPr>
         <p:blipFill>
-          <a:blip r:embed="rId10"/>
+          <a:blip r:embed="rId9"/>
           <a:stretch>
             <a:fillRect/>
           </a:stretch>
         </p:blipFill>
         <p:spPr>
           <a:xfrm flipH="1">
-            <a:off x="5365621" y="4886943"/>
+            <a:off x="5365621" y="5429497"/>
             <a:ext cx="694946" cy="618136"/>
           </a:xfrm>
           <a:prstGeom prst="rect">
@@ -36892,13 +37026,13 @@
             </a:extLst>
           </p:cNvPr>
           <p:cNvSpPr>
-            <a:spLocks noGrp="1"/>
-          </p:cNvSpPr>
-          <p:nvPr/>
-        </p:nvSpPr>
-        <p:spPr>
-          <a:xfrm>
-            <a:off x="5083254" y="4638304"/>
+            <a:spLocks/>
+          </p:cNvSpPr>
+          <p:nvPr/>
+        </p:nvSpPr>
+        <p:spPr>
+          <a:xfrm>
+            <a:off x="5083254" y="5180858"/>
             <a:ext cx="1259680" cy="276999"/>
           </a:xfrm>
           <a:prstGeom prst="rect">
@@ -36932,13 +37066,13 @@
             </a:extLst>
           </p:cNvPr>
           <p:cNvSpPr>
-            <a:spLocks noGrp="1"/>
-          </p:cNvSpPr>
-          <p:nvPr/>
-        </p:nvSpPr>
-        <p:spPr>
-          <a:xfrm>
-            <a:off x="5083254" y="4915303"/>
+            <a:spLocks/>
+          </p:cNvSpPr>
+          <p:nvPr/>
+        </p:nvSpPr>
+        <p:spPr>
+          <a:xfrm>
+            <a:off x="5083254" y="5457857"/>
             <a:ext cx="1259680" cy="0"/>
           </a:xfrm>
           <a:prstGeom prst="line">
@@ -36982,13 +37116,13 @@
             </a:extLst>
           </p:cNvPr>
           <p:cNvSpPr>
-            <a:spLocks noGrp="1"/>
-          </p:cNvSpPr>
-          <p:nvPr/>
-        </p:nvSpPr>
-        <p:spPr>
-          <a:xfrm>
-            <a:off x="8096250" y="1571625"/>
+            <a:spLocks/>
+          </p:cNvSpPr>
+          <p:nvPr/>
+        </p:nvSpPr>
+        <p:spPr>
+          <a:xfrm>
+            <a:off x="8086202" y="1571625"/>
             <a:ext cx="1259680" cy="866775"/>
           </a:xfrm>
           <a:prstGeom prst="roundRect">
@@ -37048,15 +37182,15 @@
           <p:nvPr/>
         </p:nvPicPr>
         <p:blipFill>
-          <a:blip r:embed="rId11"/>
+          <a:blip r:embed="rId10"/>
           <a:stretch>
             <a:fillRect/>
           </a:stretch>
         </p:blipFill>
         <p:spPr>
           <a:xfrm flipH="1">
-            <a:off x="8437495" y="1867303"/>
-            <a:ext cx="584924" cy="593680"/>
+            <a:off x="8453013" y="1893252"/>
+            <a:ext cx="533792" cy="541782"/>
           </a:xfrm>
           <a:prstGeom prst="rect">
             <a:avLst/>
@@ -37073,13 +37207,13 @@
             </a:extLst>
           </p:cNvPr>
           <p:cNvSpPr>
-            <a:spLocks noGrp="1"/>
-          </p:cNvSpPr>
-          <p:nvPr/>
-        </p:nvSpPr>
-        <p:spPr>
-          <a:xfrm>
-            <a:off x="8050449" y="1571625"/>
+            <a:spLocks/>
+          </p:cNvSpPr>
+          <p:nvPr/>
+        </p:nvSpPr>
+        <p:spPr>
+          <a:xfrm>
+            <a:off x="8040401" y="1571625"/>
             <a:ext cx="1414131" cy="276999"/>
           </a:xfrm>
           <a:prstGeom prst="rect">
@@ -37113,13 +37247,13 @@
             </a:extLst>
           </p:cNvPr>
           <p:cNvSpPr>
-            <a:spLocks noGrp="1"/>
-          </p:cNvSpPr>
-          <p:nvPr/>
-        </p:nvSpPr>
-        <p:spPr>
-          <a:xfrm>
-            <a:off x="8096250" y="1855424"/>
+            <a:spLocks/>
+          </p:cNvSpPr>
+          <p:nvPr/>
+        </p:nvSpPr>
+        <p:spPr>
+          <a:xfrm>
+            <a:off x="8086202" y="1855424"/>
             <a:ext cx="1259680" cy="0"/>
           </a:xfrm>
           <a:prstGeom prst="line">
@@ -37163,13 +37297,13 @@
             </a:extLst>
           </p:cNvPr>
           <p:cNvSpPr>
-            <a:spLocks noGrp="1"/>
-          </p:cNvSpPr>
-          <p:nvPr/>
-        </p:nvSpPr>
-        <p:spPr>
-          <a:xfrm>
-            <a:off x="8096250" y="4619625"/>
+            <a:spLocks/>
+          </p:cNvSpPr>
+          <p:nvPr/>
+        </p:nvSpPr>
+        <p:spPr>
+          <a:xfrm>
+            <a:off x="8096250" y="5162179"/>
             <a:ext cx="1259680" cy="866775"/>
           </a:xfrm>
           <a:prstGeom prst="roundRect">
@@ -37229,14 +37363,14 @@
           <p:nvPr/>
         </p:nvPicPr>
         <p:blipFill>
-          <a:blip r:embed="rId11"/>
+          <a:blip r:embed="rId10"/>
           <a:stretch>
             <a:fillRect/>
           </a:stretch>
         </p:blipFill>
         <p:spPr>
           <a:xfrm flipH="1">
-            <a:off x="8437495" y="4915303"/>
+            <a:off x="8437495" y="5457857"/>
             <a:ext cx="584924" cy="593680"/>
           </a:xfrm>
           <a:prstGeom prst="rect">
@@ -37254,13 +37388,13 @@
             </a:extLst>
           </p:cNvPr>
           <p:cNvSpPr>
-            <a:spLocks noGrp="1"/>
-          </p:cNvSpPr>
-          <p:nvPr/>
-        </p:nvSpPr>
-        <p:spPr>
-          <a:xfrm>
-            <a:off x="8155543" y="4665605"/>
+            <a:spLocks/>
+          </p:cNvSpPr>
+          <p:nvPr/>
+        </p:nvSpPr>
+        <p:spPr>
+          <a:xfrm>
+            <a:off x="8155543" y="5208159"/>
             <a:ext cx="1128128" cy="276999"/>
           </a:xfrm>
           <a:prstGeom prst="rect">
@@ -37302,13 +37436,13 @@
             </a:extLst>
           </p:cNvPr>
           <p:cNvSpPr>
-            <a:spLocks noGrp="1"/>
+            <a:spLocks/>
           </p:cNvSpPr>
           <p:nvPr/>
         </p:nvSpPr>
         <p:spPr>
           <a:xfrm flipV="1">
-            <a:off x="8083629" y="4908186"/>
+            <a:off x="8083629" y="5450740"/>
             <a:ext cx="1272301" cy="7117"/>
           </a:xfrm>
           <a:prstGeom prst="line">
@@ -37397,21 +37531,26 @@
             </a:extLst>
           </p:cNvPr>
           <p:cNvCxnSpPr>
+            <a:cxnSpLocks/>
             <a:stCxn id="37" idx="0"/>
             <a:endCxn id="45" idx="2"/>
           </p:cNvCxnSpPr>
           <p:nvPr/>
         </p:nvCxnSpPr>
         <p:spPr>
-          <a:xfrm flipH="1" flipV="1">
-            <a:off x="1344215" y="3629025"/>
-            <a:ext cx="8742" cy="323850"/>
+          <a:xfrm flipV="1">
+            <a:off x="1342909" y="3629025"/>
+            <a:ext cx="1306" cy="323850"/>
           </a:xfrm>
           <a:prstGeom prst="straightConnector1">
             <a:avLst/>
           </a:prstGeom>
-          <a:ln w="0">
-            <a:noFill/>
+          <a:ln w="50800">
+            <a:solidFill>
+              <a:schemeClr val="tx1">
+                <a:alpha val="50000"/>
+              </a:schemeClr>
+            </a:solidFill>
             <a:prstDash val="solid"/>
             <a:tailEnd type="triangle"/>
           </a:ln>
@@ -37441,21 +37580,26 @@
             </a:extLst>
           </p:cNvPr>
           <p:cNvCxnSpPr>
-            <a:stCxn id="48" idx="0"/>
+            <a:cxnSpLocks/>
+            <a:stCxn id="45" idx="0"/>
             <a:endCxn id="121" idx="2"/>
           </p:cNvCxnSpPr>
           <p:nvPr/>
         </p:nvCxnSpPr>
         <p:spPr>
-          <a:xfrm flipV="1">
-            <a:off x="1331594" y="2438400"/>
-            <a:ext cx="12621" cy="342529"/>
+          <a:xfrm flipH="1" flipV="1">
+            <a:off x="1337904" y="2438400"/>
+            <a:ext cx="6311" cy="323850"/>
           </a:xfrm>
           <a:prstGeom prst="straightConnector1">
             <a:avLst/>
           </a:prstGeom>
-          <a:ln w="0">
-            <a:noFill/>
+          <a:ln w="50800">
+            <a:solidFill>
+              <a:schemeClr val="tx1">
+                <a:alpha val="50000"/>
+              </a:schemeClr>
+            </a:solidFill>
             <a:prstDash val="solid"/>
             <a:tailEnd type="triangle"/>
           </a:ln>
@@ -37493,7 +37637,7 @@
         <p:spPr>
           <a:xfrm flipH="1">
             <a:off x="5754145" y="2012297"/>
-            <a:ext cx="625035" cy="1054382"/>
+            <a:ext cx="604939" cy="783373"/>
           </a:xfrm>
           <a:prstGeom prst="straightConnector1">
             <a:avLst/>
@@ -37579,14 +37723,18 @@
         </p:nvCxnSpPr>
         <p:spPr>
           <a:xfrm>
-            <a:off x="6355555" y="5053013"/>
+            <a:off x="6355555" y="5595567"/>
             <a:ext cx="1740695" cy="0"/>
           </a:xfrm>
           <a:prstGeom prst="straightConnector1">
             <a:avLst/>
           </a:prstGeom>
-          <a:ln w="0">
-            <a:noFill/>
+          <a:ln w="50800">
+            <a:solidFill>
+              <a:schemeClr val="tx1">
+                <a:alpha val="50000"/>
+              </a:schemeClr>
+            </a:solidFill>
             <a:prstDash val="solid"/>
             <a:tailEnd type="triangle"/>
           </a:ln>
@@ -37622,7 +37770,7 @@
         </p:nvCxnSpPr>
         <p:spPr>
           <a:xfrm flipV="1">
-            <a:off x="7969527" y="4619625"/>
+            <a:off x="7969527" y="5162179"/>
             <a:ext cx="2947313" cy="882620"/>
           </a:xfrm>
           <a:prstGeom prst="straightConnector1">
@@ -37666,14 +37814,18 @@
         </p:nvCxnSpPr>
         <p:spPr>
           <a:xfrm flipH="1">
-            <a:off x="6355555" y="3481388"/>
+            <a:off x="6355555" y="3210379"/>
             <a:ext cx="1740695" cy="0"/>
           </a:xfrm>
           <a:prstGeom prst="straightConnector1">
             <a:avLst/>
           </a:prstGeom>
-          <a:ln w="0">
-            <a:noFill/>
+          <a:ln w="50800">
+            <a:solidFill>
+              <a:schemeClr val="tx1">
+                <a:alpha val="50000"/>
+              </a:schemeClr>
+            </a:solidFill>
             <a:prstDash val="solid"/>
             <a:tailEnd type="triangle"/>
           </a:ln>
@@ -37709,7 +37861,7 @@
         </p:nvCxnSpPr>
         <p:spPr>
           <a:xfrm flipH="1">
-            <a:off x="4365106" y="1891405"/>
+            <a:off x="4355058" y="1891405"/>
             <a:ext cx="3003894" cy="893383"/>
           </a:xfrm>
           <a:prstGeom prst="straightConnector1">
@@ -37795,7 +37947,7 @@
         <p:spPr>
           <a:xfrm flipH="1">
             <a:off x="9355930" y="2005013"/>
-            <a:ext cx="931070" cy="1476375"/>
+            <a:ext cx="931070" cy="1205366"/>
           </a:xfrm>
           <a:prstGeom prst="straightConnector1">
             <a:avLst/>
@@ -37821,34 +37973,116 @@
           </a:fontRef>
         </p:style>
       </p:cxnSp>
-      <p:sp>
-        <p:nvSpPr>
-          <p:cNvPr id="121" name="Rechteck: abgerundete Ecken 120">
-            <a:extLst>
-              <a:ext uri="{FF2B5EF4-FFF2-40B4-BE49-F238E27FC236}">
-                <a16:creationId xmlns:a16="http://schemas.microsoft.com/office/drawing/2014/main" id="{AD7B8046-A7E5-977B-9789-31E7E99EC995}"/>
-              </a:ext>
-            </a:extLst>
-          </p:cNvPr>
-          <p:cNvSpPr>
-            <a:spLocks noGrp="1"/>
-          </p:cNvSpPr>
-          <p:nvPr/>
-        </p:nvSpPr>
-        <p:spPr>
-          <a:xfrm>
-            <a:off x="714375" y="1571625"/>
+      <p:pic>
+        <p:nvPicPr>
+          <p:cNvPr id="122" name="Grafik 165">
+            <a:extLst>
+              <a:ext uri="{FF2B5EF4-FFF2-40B4-BE49-F238E27FC236}">
+                <a16:creationId xmlns:a16="http://schemas.microsoft.com/office/drawing/2014/main" id="{C58BB8C8-2491-48E5-46A3-5E1BEB7A5BA2}"/>
+              </a:ext>
+            </a:extLst>
+          </p:cNvPr>
+          <p:cNvPicPr>
+            <a:picLocks noChangeAspect="1"/>
+          </p:cNvPicPr>
+          <p:nvPr/>
+        </p:nvPicPr>
+        <p:blipFill>
+          <a:blip r:embed="rId11"/>
+          <a:stretch>
+            <a:fillRect/>
+          </a:stretch>
+        </p:blipFill>
+        <p:spPr>
+          <a:xfrm>
+            <a:off x="1086583" y="3154111"/>
+            <a:ext cx="515265" cy="403725"/>
+          </a:xfrm>
+          <a:prstGeom prst="rect">
+            <a:avLst/>
+          </a:prstGeom>
+        </p:spPr>
+      </p:pic>
+      <p:cxnSp>
+        <p:nvCxnSpPr>
+          <p:cNvPr id="125" name="Gerade Verbindung mit Pfeil 175">
+            <a:extLst>
+              <a:ext uri="{FF2B5EF4-FFF2-40B4-BE49-F238E27FC236}">
+                <a16:creationId xmlns:a16="http://schemas.microsoft.com/office/drawing/2014/main" id="{C72D8DE9-33EF-8199-896F-3B4B34E4C33F}"/>
+              </a:ext>
+            </a:extLst>
+          </p:cNvPr>
+          <p:cNvCxnSpPr>
+            <a:cxnSpLocks/>
+            <a:stCxn id="121" idx="3"/>
+            <a:endCxn id="137" idx="1"/>
+          </p:cNvCxnSpPr>
+          <p:nvPr/>
+        </p:nvCxnSpPr>
+        <p:spPr>
+          <a:xfrm>
+            <a:off x="1967744" y="2005013"/>
+            <a:ext cx="906332" cy="0"/>
+          </a:xfrm>
+          <a:prstGeom prst="straightConnector1">
+            <a:avLst/>
+          </a:prstGeom>
+          <a:ln w="50800">
+            <a:solidFill>
+              <a:schemeClr val="tx1">
+                <a:alpha val="50000"/>
+              </a:schemeClr>
+            </a:solidFill>
+            <a:prstDash val="solid"/>
+            <a:tailEnd type="triangle"/>
+          </a:ln>
+        </p:spPr>
+        <p:style>
+          <a:lnRef idx="1">
+            <a:schemeClr val="accent1"/>
+          </a:lnRef>
+          <a:fillRef idx="0">
+            <a:schemeClr val="accent1"/>
+          </a:fillRef>
+          <a:effectRef idx="0">
+            <a:schemeClr val="accent1"/>
+          </a:effectRef>
+          <a:fontRef idx="minor">
+            <a:schemeClr val="tx1"/>
+          </a:fontRef>
+        </p:style>
+      </p:cxnSp>
+      <p:sp>
+        <p:nvSpPr>
+          <p:cNvPr id="137" name="Rechteck: abgerundete Ecken 136">
+            <a:extLst>
+              <a:ext uri="{FF2B5EF4-FFF2-40B4-BE49-F238E27FC236}">
+                <a16:creationId xmlns:a16="http://schemas.microsoft.com/office/drawing/2014/main" id="{2F0E7FDF-A2C6-F785-F1E7-936F202EF2F8}"/>
+              </a:ext>
+            </a:extLst>
+          </p:cNvPr>
+          <p:cNvSpPr>
+            <a:spLocks/>
+          </p:cNvSpPr>
+          <p:nvPr/>
+        </p:nvSpPr>
+        <p:spPr>
+          <a:xfrm>
+            <a:off x="2874076" y="1571625"/>
             <a:ext cx="1259680" cy="866775"/>
           </a:xfrm>
           <a:prstGeom prst="roundRect">
             <a:avLst/>
           </a:prstGeom>
           <a:solidFill>
-            <a:schemeClr val="accent2"/>
+            <a:schemeClr val="accent6">
+              <a:lumMod val="40000"/>
+              <a:lumOff val="60000"/>
+            </a:schemeClr>
           </a:solidFill>
           <a:ln>
             <a:solidFill>
-              <a:schemeClr val="accent3"/>
+              <a:schemeClr val="tx2"/>
             </a:solidFill>
           </a:ln>
         </p:spPr>
@@ -37881,10 +38115,10 @@
       </p:sp>
       <p:pic>
         <p:nvPicPr>
-          <p:cNvPr id="122" name="Grafik 165">
-            <a:extLst>
-              <a:ext uri="{FF2B5EF4-FFF2-40B4-BE49-F238E27FC236}">
-                <a16:creationId xmlns:a16="http://schemas.microsoft.com/office/drawing/2014/main" id="{C58BB8C8-2491-48E5-46A3-5E1BEB7A5BA2}"/>
+          <p:cNvPr id="138" name="Grafik 39">
+            <a:extLst>
+              <a:ext uri="{FF2B5EF4-FFF2-40B4-BE49-F238E27FC236}">
+                <a16:creationId xmlns:a16="http://schemas.microsoft.com/office/drawing/2014/main" id="{CED68F23-700B-1E3E-A249-76DCDEF47E2F}"/>
               </a:ext>
             </a:extLst>
           </p:cNvPr>
@@ -37894,15 +38128,15 @@
           <p:nvPr/>
         </p:nvPicPr>
         <p:blipFill>
-          <a:blip r:embed="rId12"/>
+          <a:blip r:embed="rId10"/>
           <a:stretch>
             <a:fillRect/>
           </a:stretch>
         </p:blipFill>
         <p:spPr>
-          <a:xfrm>
-            <a:off x="1064972" y="1970328"/>
-            <a:ext cx="515265" cy="403725"/>
+          <a:xfrm flipH="1">
+            <a:off x="3270221" y="1910325"/>
+            <a:ext cx="475124" cy="482236"/>
           </a:xfrm>
           <a:prstGeom prst="rect">
             <a:avLst/>
@@ -37911,22 +38145,22 @@
       </p:pic>
       <p:sp>
         <p:nvSpPr>
-          <p:cNvPr id="123" name="Textfeld 171">
-            <a:extLst>
-              <a:ext uri="{FF2B5EF4-FFF2-40B4-BE49-F238E27FC236}">
-                <a16:creationId xmlns:a16="http://schemas.microsoft.com/office/drawing/2014/main" id="{94B0B414-3457-95E7-777A-E27F72556F9D}"/>
-              </a:ext>
-            </a:extLst>
-          </p:cNvPr>
-          <p:cNvSpPr>
-            <a:spLocks noGrp="1"/>
-          </p:cNvSpPr>
-          <p:nvPr/>
-        </p:nvSpPr>
-        <p:spPr>
-          <a:xfrm>
-            <a:off x="701754" y="1590304"/>
-            <a:ext cx="1259680" cy="276999"/>
+          <p:cNvPr id="139" name="Textfeld 40">
+            <a:extLst>
+              <a:ext uri="{FF2B5EF4-FFF2-40B4-BE49-F238E27FC236}">
+                <a16:creationId xmlns:a16="http://schemas.microsoft.com/office/drawing/2014/main" id="{F5202F32-CF94-B0E2-B061-FC87820AD558}"/>
+              </a:ext>
+            </a:extLst>
+          </p:cNvPr>
+          <p:cNvSpPr>
+            <a:spLocks/>
+          </p:cNvSpPr>
+          <p:nvPr/>
+        </p:nvSpPr>
+        <p:spPr>
+          <a:xfrm>
+            <a:off x="2828275" y="1571625"/>
+            <a:ext cx="1414131" cy="276999"/>
           </a:xfrm>
           <a:prstGeom prst="rect">
             <a:avLst/>
@@ -37943,37 +38177,37 @@
               <a:buNone/>
             </a:pPr>
             <a:r>
-              <a:rPr sz="1200"/>
-              <a:t>Chunks</a:t>
-            </a:r>
-          </a:p>
-        </p:txBody>
-      </p:sp>
-      <p:sp>
-        <p:nvSpPr>
-          <p:cNvPr id="124" name="Gerader Verbinder 123">
-            <a:extLst>
-              <a:ext uri="{FF2B5EF4-FFF2-40B4-BE49-F238E27FC236}">
-                <a16:creationId xmlns:a16="http://schemas.microsoft.com/office/drawing/2014/main" id="{E1830494-1611-ADE7-C919-BF9ADBCD7AEF}"/>
-              </a:ext>
-            </a:extLst>
-          </p:cNvPr>
-          <p:cNvSpPr>
-            <a:spLocks noGrp="1"/>
-          </p:cNvSpPr>
-          <p:nvPr/>
-        </p:nvSpPr>
-        <p:spPr>
-          <a:xfrm flipV="1">
-            <a:off x="714375" y="1867303"/>
-            <a:ext cx="1259680" cy="12295"/>
+              <a:rPr sz="1200" dirty="0"/>
+              <a:t>Embedding LLM</a:t>
+            </a:r>
+          </a:p>
+        </p:txBody>
+      </p:sp>
+      <p:sp>
+        <p:nvSpPr>
+          <p:cNvPr id="140" name="Gerader Verbinder 139">
+            <a:extLst>
+              <a:ext uri="{FF2B5EF4-FFF2-40B4-BE49-F238E27FC236}">
+                <a16:creationId xmlns:a16="http://schemas.microsoft.com/office/drawing/2014/main" id="{FAE015C5-0604-FCE4-AE8F-E2A5506C996F}"/>
+              </a:ext>
+            </a:extLst>
+          </p:cNvPr>
+          <p:cNvSpPr>
+            <a:spLocks/>
+          </p:cNvSpPr>
+          <p:nvPr/>
+        </p:nvSpPr>
+        <p:spPr>
+          <a:xfrm>
+            <a:off x="2874076" y="1855424"/>
+            <a:ext cx="1259680" cy="0"/>
           </a:xfrm>
           <a:prstGeom prst="line">
             <a:avLst/>
           </a:prstGeom>
           <a:ln>
             <a:solidFill>
-              <a:schemeClr val="accent3"/>
+              <a:schemeClr val="tx2"/>
             </a:solidFill>
           </a:ln>
         </p:spPr>
@@ -37999,31 +38233,72 @@
           </a:p>
         </p:txBody>
       </p:sp>
+      <p:sp>
+        <p:nvSpPr>
+          <p:cNvPr id="145" name="Textfeld 144">
+            <a:extLst>
+              <a:ext uri="{FF2B5EF4-FFF2-40B4-BE49-F238E27FC236}">
+                <a16:creationId xmlns:a16="http://schemas.microsoft.com/office/drawing/2014/main" id="{8C156430-C202-53BD-8023-A0D5C9A9CCB0}"/>
+              </a:ext>
+            </a:extLst>
+          </p:cNvPr>
+          <p:cNvSpPr txBox="1"/>
+          <p:nvPr/>
+        </p:nvSpPr>
+        <p:spPr>
+          <a:xfrm>
+            <a:off x="6838721" y="5342499"/>
+            <a:ext cx="922500" cy="276999"/>
+          </a:xfrm>
+          <a:prstGeom prst="rect">
+            <a:avLst/>
+          </a:prstGeom>
+          <a:noFill/>
+        </p:spPr>
+        <p:txBody>
+          <a:bodyPr wrap="square" rtlCol="0">
+            <a:spAutoFit/>
+          </a:bodyPr>
+          <a:lstStyle/>
+          <a:p>
+            <a:r>
+              <a:rPr lang="de-CH" sz="1200" dirty="0" err="1"/>
+              <a:t>Context</a:t>
+            </a:r>
+            <a:endParaRPr lang="de-CH" sz="1200" dirty="0"/>
+          </a:p>
+        </p:txBody>
+      </p:sp>
       <p:cxnSp>
         <p:nvCxnSpPr>
-          <p:cNvPr id="125" name="Gerade Verbindung mit Pfeil 175">
-            <a:extLst>
-              <a:ext uri="{FF2B5EF4-FFF2-40B4-BE49-F238E27FC236}">
-                <a16:creationId xmlns:a16="http://schemas.microsoft.com/office/drawing/2014/main" id="{C72D8DE9-33EF-8199-896F-3B4B34E4C33F}"/>
+          <p:cNvPr id="7" name="Gerade Verbindung mit Pfeil 175">
+            <a:extLst>
+              <a:ext uri="{FF2B5EF4-FFF2-40B4-BE49-F238E27FC236}">
+                <a16:creationId xmlns:a16="http://schemas.microsoft.com/office/drawing/2014/main" id="{0D4E258E-510F-CDC1-7824-B97B0D97B16A}"/>
               </a:ext>
             </a:extLst>
           </p:cNvPr>
           <p:cNvCxnSpPr>
-            <a:stCxn id="121" idx="3"/>
+            <a:cxnSpLocks/>
+            <a:stCxn id="137" idx="3"/>
             <a:endCxn id="54" idx="1"/>
           </p:cNvCxnSpPr>
           <p:nvPr/>
         </p:nvCxnSpPr>
         <p:spPr>
           <a:xfrm>
-            <a:off x="1974055" y="2005013"/>
-            <a:ext cx="3145445" cy="7284"/>
+            <a:off x="4133756" y="2005013"/>
+            <a:ext cx="965648" cy="7284"/>
           </a:xfrm>
           <a:prstGeom prst="straightConnector1">
             <a:avLst/>
           </a:prstGeom>
-          <a:ln w="0">
-            <a:noFill/>
+          <a:ln w="50800">
+            <a:solidFill>
+              <a:schemeClr val="tx1">
+                <a:alpha val="50000"/>
+              </a:schemeClr>
+            </a:solidFill>
             <a:prstDash val="solid"/>
             <a:tailEnd type="triangle"/>
           </a:ln>
@@ -38045,356 +38320,326 @@
       </p:cxnSp>
       <p:cxnSp>
         <p:nvCxnSpPr>
-          <p:cNvPr id="126" name="Gerade Verbindung mit Pfeil 125">
-            <a:extLst>
-              <a:ext uri="{FF2B5EF4-FFF2-40B4-BE49-F238E27FC236}">
-                <a16:creationId xmlns:a16="http://schemas.microsoft.com/office/drawing/2014/main" id="{2F8AE9B7-7DF2-DD44-666C-0F46DF7C984C}"/>
+          <p:cNvPr id="15" name="Gerade Verbindung mit Pfeil 143">
+            <a:extLst>
+              <a:ext uri="{FF2B5EF4-FFF2-40B4-BE49-F238E27FC236}">
+                <a16:creationId xmlns:a16="http://schemas.microsoft.com/office/drawing/2014/main" id="{A1A5E8C3-3F80-9A63-9DF4-CD841A9DCB7A}"/>
               </a:ext>
             </a:extLst>
           </p:cNvPr>
           <p:cNvCxnSpPr>
-            <a:stCxn id="10" idx="0"/>
-            <a:endCxn id="37" idx="2"/>
+            <a:cxnSpLocks/>
+            <a:stCxn id="102" idx="3"/>
+            <a:endCxn id="24" idx="1"/>
           </p:cNvCxnSpPr>
           <p:nvPr/>
         </p:nvCxnSpPr>
         <p:spPr>
-          <a:xfrm flipV="1">
-            <a:off x="1344215" y="4819650"/>
-            <a:ext cx="8742" cy="323850"/>
+          <a:xfrm>
+            <a:off x="9355930" y="5595567"/>
+            <a:ext cx="931070" cy="0"/>
           </a:xfrm>
           <a:prstGeom prst="straightConnector1">
             <a:avLst/>
           </a:prstGeom>
-          <a:ln w="20955">
+          <a:ln w="50800">
             <a:solidFill>
-              <a:srgbClr val="304554"/>
+              <a:schemeClr val="tx1">
+                <a:alpha val="50000"/>
+              </a:schemeClr>
             </a:solidFill>
             <a:prstDash val="solid"/>
-            <a:tailEnd type="triangle" w="sm" len="sm"/>
+            <a:tailEnd type="triangle"/>
           </a:ln>
         </p:spPr>
+        <p:style>
+          <a:lnRef idx="1">
+            <a:schemeClr val="accent1"/>
+          </a:lnRef>
+          <a:fillRef idx="0">
+            <a:schemeClr val="accent1"/>
+          </a:fillRef>
+          <a:effectRef idx="0">
+            <a:schemeClr val="accent1"/>
+          </a:effectRef>
+          <a:fontRef idx="minor">
+            <a:schemeClr val="tx1"/>
+          </a:fontRef>
+        </p:style>
       </p:cxnSp>
       <p:cxnSp>
         <p:nvCxnSpPr>
-          <p:cNvPr id="127" name="Gerade Verbindung mit Pfeil 126">
-            <a:extLst>
-              <a:ext uri="{FF2B5EF4-FFF2-40B4-BE49-F238E27FC236}">
-                <a16:creationId xmlns:a16="http://schemas.microsoft.com/office/drawing/2014/main" id="{3D560821-5CFC-8CEA-9E6D-08367593D66A}"/>
+          <p:cNvPr id="26" name="Gerade Verbindung mit Pfeil 116">
+            <a:extLst>
+              <a:ext uri="{FF2B5EF4-FFF2-40B4-BE49-F238E27FC236}">
+                <a16:creationId xmlns:a16="http://schemas.microsoft.com/office/drawing/2014/main" id="{02CDE7FC-A0D5-07F3-2CE6-481F9220CCFB}"/>
               </a:ext>
             </a:extLst>
           </p:cNvPr>
           <p:cNvCxnSpPr>
-            <a:stCxn id="37" idx="0"/>
-            <a:endCxn id="45" idx="2"/>
+            <a:cxnSpLocks/>
+            <a:stCxn id="10" idx="0"/>
+            <a:endCxn id="42" idx="2"/>
           </p:cNvCxnSpPr>
           <p:nvPr/>
         </p:nvCxnSpPr>
         <p:spPr>
           <a:xfrm flipH="1" flipV="1">
-            <a:off x="1344215" y="3629025"/>
-            <a:ext cx="8742" cy="323850"/>
+            <a:off x="1342908" y="4808134"/>
+            <a:ext cx="1307" cy="335366"/>
           </a:xfrm>
           <a:prstGeom prst="straightConnector1">
             <a:avLst/>
           </a:prstGeom>
-          <a:ln w="20955">
+          <a:ln w="50800">
             <a:solidFill>
-              <a:srgbClr val="304554"/>
+              <a:schemeClr val="tx1">
+                <a:alpha val="50000"/>
+              </a:schemeClr>
             </a:solidFill>
             <a:prstDash val="solid"/>
-            <a:tailEnd type="triangle" w="sm" len="sm"/>
+            <a:tailEnd type="triangle"/>
           </a:ln>
         </p:spPr>
+        <p:style>
+          <a:lnRef idx="1">
+            <a:schemeClr val="accent1"/>
+          </a:lnRef>
+          <a:fillRef idx="0">
+            <a:schemeClr val="accent1"/>
+          </a:fillRef>
+          <a:effectRef idx="0">
+            <a:schemeClr val="accent1"/>
+          </a:effectRef>
+          <a:fontRef idx="minor">
+            <a:schemeClr val="tx1"/>
+          </a:fontRef>
+        </p:style>
       </p:cxnSp>
       <p:cxnSp>
         <p:nvCxnSpPr>
-          <p:cNvPr id="128" name="Gerade Verbindung mit Pfeil 127">
-            <a:extLst>
-              <a:ext uri="{FF2B5EF4-FFF2-40B4-BE49-F238E27FC236}">
-                <a16:creationId xmlns:a16="http://schemas.microsoft.com/office/drawing/2014/main" id="{A1F75876-635A-EB2E-14AF-3E3B0E315CAF}"/>
+          <p:cNvPr id="30" name="Gerade Verbindung mit Pfeil 116">
+            <a:extLst>
+              <a:ext uri="{FF2B5EF4-FFF2-40B4-BE49-F238E27FC236}">
+                <a16:creationId xmlns:a16="http://schemas.microsoft.com/office/drawing/2014/main" id="{F834C3E5-D35F-44C7-AEE0-6AEAEACA36B4}"/>
               </a:ext>
             </a:extLst>
           </p:cNvPr>
           <p:cNvCxnSpPr>
-            <a:stCxn id="45" idx="0"/>
-            <a:endCxn id="121" idx="2"/>
+            <a:cxnSpLocks/>
+            <a:stCxn id="18" idx="1"/>
+            <a:endCxn id="93" idx="3"/>
           </p:cNvCxnSpPr>
           <p:nvPr/>
         </p:nvCxnSpPr>
         <p:spPr>
-          <a:xfrm flipV="1">
-            <a:off x="1344215" y="2438400"/>
-            <a:ext cx="0" cy="323850"/>
+          <a:xfrm flipH="1">
+            <a:off x="9345882" y="2005013"/>
+            <a:ext cx="941118" cy="0"/>
           </a:xfrm>
           <a:prstGeom prst="straightConnector1">
             <a:avLst/>
           </a:prstGeom>
-          <a:ln w="20955">
+          <a:ln w="50800">
             <a:solidFill>
-              <a:srgbClr val="304554"/>
+              <a:schemeClr val="tx1">
+                <a:alpha val="50000"/>
+              </a:schemeClr>
             </a:solidFill>
             <a:prstDash val="solid"/>
-            <a:tailEnd type="triangle" w="sm" len="sm"/>
+            <a:tailEnd type="triangle"/>
           </a:ln>
         </p:spPr>
+        <p:style>
+          <a:lnRef idx="1">
+            <a:schemeClr val="accent1"/>
+          </a:lnRef>
+          <a:fillRef idx="0">
+            <a:schemeClr val="accent1"/>
+          </a:fillRef>
+          <a:effectRef idx="0">
+            <a:schemeClr val="accent1"/>
+          </a:effectRef>
+          <a:fontRef idx="minor">
+            <a:schemeClr val="tx1"/>
+          </a:fontRef>
+        </p:style>
       </p:cxnSp>
       <p:cxnSp>
         <p:nvCxnSpPr>
-          <p:cNvPr id="129" name="Gerade Verbindung mit Pfeil 128">
-            <a:extLst>
-              <a:ext uri="{FF2B5EF4-FFF2-40B4-BE49-F238E27FC236}">
-                <a16:creationId xmlns:a16="http://schemas.microsoft.com/office/drawing/2014/main" id="{11AAC394-26E2-4C16-5C24-E25FD3E7D705}"/>
+          <p:cNvPr id="34" name="Gerade Verbindung mit Pfeil 116">
+            <a:extLst>
+              <a:ext uri="{FF2B5EF4-FFF2-40B4-BE49-F238E27FC236}">
+                <a16:creationId xmlns:a16="http://schemas.microsoft.com/office/drawing/2014/main" id="{AAD4A9FA-5DEA-3E74-98D7-E03DAAF937A5}"/>
               </a:ext>
             </a:extLst>
           </p:cNvPr>
           <p:cNvCxnSpPr>
             <a:cxnSpLocks/>
-            <a:stCxn id="121" idx="3"/>
-            <a:endCxn id="137" idx="1"/>
+            <a:stCxn id="96" idx="2"/>
+            <a:endCxn id="67" idx="0"/>
           </p:cNvCxnSpPr>
           <p:nvPr/>
         </p:nvCxnSpPr>
         <p:spPr>
-          <a:xfrm>
-            <a:off x="1974055" y="2005013"/>
-            <a:ext cx="900021" cy="0"/>
+          <a:xfrm flipH="1">
+            <a:off x="8713469" y="2435034"/>
+            <a:ext cx="6440" cy="360636"/>
           </a:xfrm>
           <a:prstGeom prst="straightConnector1">
             <a:avLst/>
           </a:prstGeom>
-          <a:ln w="20955">
+          <a:ln w="50800">
             <a:solidFill>
-              <a:srgbClr val="304554"/>
+              <a:schemeClr val="tx1">
+                <a:alpha val="50000"/>
+              </a:schemeClr>
             </a:solidFill>
             <a:prstDash val="solid"/>
-            <a:tailEnd type="triangle" w="sm" len="sm"/>
+            <a:tailEnd type="triangle"/>
           </a:ln>
         </p:spPr>
+        <p:style>
+          <a:lnRef idx="1">
+            <a:schemeClr val="accent1"/>
+          </a:lnRef>
+          <a:fillRef idx="0">
+            <a:schemeClr val="accent1"/>
+          </a:fillRef>
+          <a:effectRef idx="0">
+            <a:schemeClr val="accent1"/>
+          </a:effectRef>
+          <a:fontRef idx="minor">
+            <a:schemeClr val="tx1"/>
+          </a:fontRef>
+        </p:style>
       </p:cxnSp>
       <p:cxnSp>
         <p:nvCxnSpPr>
-          <p:cNvPr id="130" name="Gerade Verbindung mit Pfeil 129">
-            <a:extLst>
-              <a:ext uri="{FF2B5EF4-FFF2-40B4-BE49-F238E27FC236}">
-                <a16:creationId xmlns:a16="http://schemas.microsoft.com/office/drawing/2014/main" id="{572FB2CE-8851-3537-32C3-B05BFCE5D204}"/>
+          <p:cNvPr id="38" name="Gerade Verbindung mit Pfeil 116">
+            <a:extLst>
+              <a:ext uri="{FF2B5EF4-FFF2-40B4-BE49-F238E27FC236}">
+                <a16:creationId xmlns:a16="http://schemas.microsoft.com/office/drawing/2014/main" id="{BBC39D6B-1A7E-43A7-AB4C-507B2811AD74}"/>
               </a:ext>
             </a:extLst>
           </p:cNvPr>
           <p:cNvCxnSpPr>
-            <a:stCxn id="18" idx="1"/>
-            <a:endCxn id="93" idx="3"/>
+            <a:cxnSpLocks/>
+            <a:stCxn id="56" idx="2"/>
+            <a:endCxn id="72" idx="0"/>
           </p:cNvCxnSpPr>
           <p:nvPr/>
         </p:nvCxnSpPr>
         <p:spPr>
           <a:xfrm flipH="1">
-            <a:off x="9355930" y="2005013"/>
-            <a:ext cx="931070" cy="0"/>
+            <a:off x="5725715" y="2427045"/>
+            <a:ext cx="3529" cy="349946"/>
           </a:xfrm>
           <a:prstGeom prst="straightConnector1">
             <a:avLst/>
           </a:prstGeom>
-          <a:ln w="20955">
+          <a:ln w="50800">
             <a:solidFill>
-              <a:srgbClr val="8D8271"/>
+              <a:schemeClr val="tx1">
+                <a:alpha val="50000"/>
+              </a:schemeClr>
             </a:solidFill>
             <a:prstDash val="solid"/>
-            <a:tailEnd type="triangle" w="sm" len="sm"/>
+            <a:tailEnd type="triangle"/>
           </a:ln>
         </p:spPr>
+        <p:style>
+          <a:lnRef idx="1">
+            <a:schemeClr val="accent1"/>
+          </a:lnRef>
+          <a:fillRef idx="0">
+            <a:schemeClr val="accent1"/>
+          </a:fillRef>
+          <a:effectRef idx="0">
+            <a:schemeClr val="accent1"/>
+          </a:effectRef>
+          <a:fontRef idx="minor">
+            <a:schemeClr val="tx1"/>
+          </a:fontRef>
+        </p:style>
       </p:cxnSp>
       <p:cxnSp>
         <p:nvCxnSpPr>
-          <p:cNvPr id="131" name="Gerade Verbindung mit Pfeil 130">
-            <a:extLst>
-              <a:ext uri="{FF2B5EF4-FFF2-40B4-BE49-F238E27FC236}">
-                <a16:creationId xmlns:a16="http://schemas.microsoft.com/office/drawing/2014/main" id="{8D4278C3-96BC-BBC5-2E76-E6FCA97DDB47}"/>
+          <p:cNvPr id="49" name="Gerade Verbindung mit Pfeil 116">
+            <a:extLst>
+              <a:ext uri="{FF2B5EF4-FFF2-40B4-BE49-F238E27FC236}">
+                <a16:creationId xmlns:a16="http://schemas.microsoft.com/office/drawing/2014/main" id="{95BD79AE-8E27-C417-44A9-1DA30BB87BB2}"/>
               </a:ext>
             </a:extLst>
           </p:cNvPr>
           <p:cNvCxnSpPr>
-            <a:stCxn id="93" idx="2"/>
-            <a:endCxn id="60" idx="0"/>
+            <a:cxnSpLocks/>
+            <a:stCxn id="74" idx="2"/>
+            <a:endCxn id="87" idx="0"/>
           </p:cNvCxnSpPr>
           <p:nvPr/>
         </p:nvCxnSpPr>
         <p:spPr>
-          <a:xfrm>
-            <a:off x="8726090" y="2438400"/>
-            <a:ext cx="0" cy="609600"/>
+          <a:xfrm flipH="1">
+            <a:off x="5713094" y="3643767"/>
+            <a:ext cx="7804" cy="1537091"/>
           </a:xfrm>
           <a:prstGeom prst="straightConnector1">
             <a:avLst/>
           </a:prstGeom>
-          <a:ln w="20955">
+          <a:ln w="50800">
             <a:solidFill>
-              <a:srgbClr val="8D8271"/>
+              <a:schemeClr val="tx1">
+                <a:alpha val="50000"/>
+              </a:schemeClr>
             </a:solidFill>
             <a:prstDash val="solid"/>
-            <a:tailEnd type="triangle" w="sm" len="sm"/>
+            <a:tailEnd type="triangle"/>
           </a:ln>
         </p:spPr>
+        <p:style>
+          <a:lnRef idx="1">
+            <a:schemeClr val="accent1"/>
+          </a:lnRef>
+          <a:fillRef idx="0">
+            <a:schemeClr val="accent1"/>
+          </a:fillRef>
+          <a:effectRef idx="0">
+            <a:schemeClr val="accent1"/>
+          </a:effectRef>
+          <a:fontRef idx="minor">
+            <a:schemeClr val="tx1"/>
+          </a:fontRef>
+        </p:style>
       </p:cxnSp>
-      <p:cxnSp>
-        <p:nvCxnSpPr>
-          <p:cNvPr id="133" name="Gerade Verbindung mit Pfeil 132">
-            <a:extLst>
-              <a:ext uri="{FF2B5EF4-FFF2-40B4-BE49-F238E27FC236}">
-                <a16:creationId xmlns:a16="http://schemas.microsoft.com/office/drawing/2014/main" id="{2D067BCA-65FF-5D06-9747-239393946F3C}"/>
-              </a:ext>
-            </a:extLst>
-          </p:cNvPr>
-          <p:cNvCxnSpPr>
-            <a:stCxn id="60" idx="1"/>
-            <a:endCxn id="72" idx="3"/>
-          </p:cNvCxnSpPr>
-          <p:nvPr/>
-        </p:nvCxnSpPr>
-        <p:spPr>
-          <a:xfrm flipH="1">
-            <a:off x="6355555" y="3481388"/>
-            <a:ext cx="1740695" cy="0"/>
-          </a:xfrm>
-          <a:prstGeom prst="straightConnector1">
-            <a:avLst/>
-          </a:prstGeom>
-          <a:ln w="20955">
-            <a:solidFill>
-              <a:srgbClr val="8D8271"/>
-            </a:solidFill>
-            <a:prstDash val="solid"/>
-            <a:tailEnd type="triangle" w="sm" len="sm"/>
-          </a:ln>
-        </p:spPr>
-      </p:cxnSp>
-      <p:cxnSp>
-        <p:nvCxnSpPr>
-          <p:cNvPr id="134" name="Gerade Verbindung mit Pfeil 133">
-            <a:extLst>
-              <a:ext uri="{FF2B5EF4-FFF2-40B4-BE49-F238E27FC236}">
-                <a16:creationId xmlns:a16="http://schemas.microsoft.com/office/drawing/2014/main" id="{71E25062-8F3D-DDAB-DCED-4672C3BE29B3}"/>
-              </a:ext>
-            </a:extLst>
-          </p:cNvPr>
-          <p:cNvCxnSpPr>
-            <a:stCxn id="72" idx="2"/>
-            <a:endCxn id="81" idx="0"/>
-          </p:cNvCxnSpPr>
-          <p:nvPr/>
-        </p:nvCxnSpPr>
-        <p:spPr>
-          <a:xfrm>
-            <a:off x="5725715" y="3914775"/>
-            <a:ext cx="0" cy="704850"/>
-          </a:xfrm>
-          <a:prstGeom prst="straightConnector1">
-            <a:avLst/>
-          </a:prstGeom>
-          <a:ln w="20955">
-            <a:solidFill>
-              <a:srgbClr val="8D8271"/>
-            </a:solidFill>
-            <a:prstDash val="solid"/>
-            <a:tailEnd type="triangle" w="sm" len="sm"/>
-          </a:ln>
-        </p:spPr>
-      </p:cxnSp>
-      <p:cxnSp>
-        <p:nvCxnSpPr>
-          <p:cNvPr id="135" name="Gerade Verbindung mit Pfeil 134">
-            <a:extLst>
-              <a:ext uri="{FF2B5EF4-FFF2-40B4-BE49-F238E27FC236}">
-                <a16:creationId xmlns:a16="http://schemas.microsoft.com/office/drawing/2014/main" id="{C9AE14A9-3DBE-E4A2-3659-9E3080C717DF}"/>
-              </a:ext>
-            </a:extLst>
-          </p:cNvPr>
-          <p:cNvCxnSpPr>
-            <a:stCxn id="81" idx="3"/>
-            <a:endCxn id="102" idx="1"/>
-          </p:cNvCxnSpPr>
-          <p:nvPr/>
-        </p:nvCxnSpPr>
-        <p:spPr>
-          <a:xfrm>
-            <a:off x="6355555" y="5053013"/>
-            <a:ext cx="1740695" cy="0"/>
-          </a:xfrm>
-          <a:prstGeom prst="straightConnector1">
-            <a:avLst/>
-          </a:prstGeom>
-          <a:ln w="22860">
-            <a:solidFill>
-              <a:srgbClr val="CF062E"/>
-            </a:solidFill>
-            <a:prstDash val="solid"/>
-            <a:tailEnd type="triangle" w="sm" len="sm"/>
-          </a:ln>
-        </p:spPr>
-      </p:cxnSp>
-      <p:cxnSp>
-        <p:nvCxnSpPr>
-          <p:cNvPr id="136" name="Gerade Verbindung mit Pfeil 135">
-            <a:extLst>
-              <a:ext uri="{FF2B5EF4-FFF2-40B4-BE49-F238E27FC236}">
-                <a16:creationId xmlns:a16="http://schemas.microsoft.com/office/drawing/2014/main" id="{911C4D5D-F807-983E-E278-9B3558601794}"/>
-              </a:ext>
-            </a:extLst>
-          </p:cNvPr>
-          <p:cNvCxnSpPr>
-            <a:stCxn id="102" idx="3"/>
-            <a:endCxn id="24" idx="1"/>
-          </p:cNvCxnSpPr>
-          <p:nvPr/>
-        </p:nvCxnSpPr>
-        <p:spPr>
-          <a:xfrm>
-            <a:off x="9355930" y="5053013"/>
-            <a:ext cx="931070" cy="0"/>
-          </a:xfrm>
-          <a:prstGeom prst="straightConnector1">
-            <a:avLst/>
-          </a:prstGeom>
-          <a:ln w="22860">
-            <a:solidFill>
-              <a:srgbClr val="CF062E"/>
-            </a:solidFill>
-            <a:prstDash val="solid"/>
-            <a:tailEnd type="triangle" w="sm" len="sm"/>
-          </a:ln>
-        </p:spPr>
-      </p:cxnSp>
-      <p:sp>
-        <p:nvSpPr>
-          <p:cNvPr id="137" name="Rechteck: abgerundete Ecken 136">
-            <a:extLst>
-              <a:ext uri="{FF2B5EF4-FFF2-40B4-BE49-F238E27FC236}">
-                <a16:creationId xmlns:a16="http://schemas.microsoft.com/office/drawing/2014/main" id="{2F0E7FDF-A2C6-F785-F1E7-936F202EF2F8}"/>
-              </a:ext>
-            </a:extLst>
-          </p:cNvPr>
-          <p:cNvSpPr>
-            <a:spLocks noGrp="1"/>
-          </p:cNvSpPr>
-          <p:nvPr/>
-        </p:nvSpPr>
-        <p:spPr>
-          <a:xfrm>
-            <a:off x="2874076" y="1571625"/>
+      <p:sp>
+        <p:nvSpPr>
+          <p:cNvPr id="121" name="Rechteck: abgerundete Ecken 120">
+            <a:extLst>
+              <a:ext uri="{FF2B5EF4-FFF2-40B4-BE49-F238E27FC236}">
+                <a16:creationId xmlns:a16="http://schemas.microsoft.com/office/drawing/2014/main" id="{AD7B8046-A7E5-977B-9789-31E7E99EC995}"/>
+              </a:ext>
+            </a:extLst>
+          </p:cNvPr>
+          <p:cNvSpPr>
+            <a:spLocks/>
+          </p:cNvSpPr>
+          <p:nvPr/>
+        </p:nvSpPr>
+        <p:spPr>
+          <a:xfrm>
+            <a:off x="708064" y="1571625"/>
             <a:ext cx="1259680" cy="866775"/>
           </a:xfrm>
           <a:prstGeom prst="roundRect">
             <a:avLst/>
           </a:prstGeom>
           <a:solidFill>
-            <a:schemeClr val="accent6">
-              <a:lumMod val="40000"/>
-              <a:lumOff val="60000"/>
-            </a:schemeClr>
+            <a:schemeClr val="accent2"/>
           </a:solidFill>
           <a:ln>
             <a:solidFill>
-              <a:schemeClr val="tx2"/>
+              <a:schemeClr val="accent3"/>
             </a:solidFill>
           </a:ln>
         </p:spPr>
@@ -38425,12 +38670,52 @@
           </a:p>
         </p:txBody>
       </p:sp>
+      <p:sp>
+        <p:nvSpPr>
+          <p:cNvPr id="123" name="Textfeld 171">
+            <a:extLst>
+              <a:ext uri="{FF2B5EF4-FFF2-40B4-BE49-F238E27FC236}">
+                <a16:creationId xmlns:a16="http://schemas.microsoft.com/office/drawing/2014/main" id="{94B0B414-3457-95E7-777A-E27F72556F9D}"/>
+              </a:ext>
+            </a:extLst>
+          </p:cNvPr>
+          <p:cNvSpPr>
+            <a:spLocks/>
+          </p:cNvSpPr>
+          <p:nvPr/>
+        </p:nvSpPr>
+        <p:spPr>
+          <a:xfrm>
+            <a:off x="708064" y="1590304"/>
+            <a:ext cx="1259680" cy="276999"/>
+          </a:xfrm>
+          <a:prstGeom prst="rect">
+            <a:avLst/>
+          </a:prstGeom>
+          <a:noFill/>
+        </p:spPr>
+        <p:txBody>
+          <a:bodyPr wrap="square">
+            <a:spAutoFit/>
+          </a:bodyPr>
+          <a:lstStyle/>
+          <a:p>
+            <a:pPr algn="ctr">
+              <a:buNone/>
+            </a:pPr>
+            <a:r>
+              <a:rPr sz="1200" dirty="0"/>
+              <a:t>Chunks</a:t>
+            </a:r>
+          </a:p>
+        </p:txBody>
+      </p:sp>
       <p:pic>
         <p:nvPicPr>
-          <p:cNvPr id="138" name="Grafik 39">
-            <a:extLst>
-              <a:ext uri="{FF2B5EF4-FFF2-40B4-BE49-F238E27FC236}">
-                <a16:creationId xmlns:a16="http://schemas.microsoft.com/office/drawing/2014/main" id="{CED68F23-700B-1E3E-A249-76DCDEF47E2F}"/>
+          <p:cNvPr id="46" name="Grafik 10">
+            <a:extLst>
+              <a:ext uri="{FF2B5EF4-FFF2-40B4-BE49-F238E27FC236}">
+                <a16:creationId xmlns:a16="http://schemas.microsoft.com/office/drawing/2014/main" id="{BE3EA945-55FA-7EAD-DC73-B9FB8CEDC576}"/>
               </a:ext>
             </a:extLst>
           </p:cNvPr>
@@ -38440,15 +38725,15 @@
           <p:nvPr/>
         </p:nvPicPr>
         <p:blipFill>
-          <a:blip r:embed="rId11"/>
+          <a:blip r:embed="rId12"/>
           <a:stretch>
             <a:fillRect/>
           </a:stretch>
         </p:blipFill>
         <p:spPr>
           <a:xfrm flipH="1">
-            <a:off x="3215321" y="1867303"/>
-            <a:ext cx="584924" cy="593680"/>
+            <a:off x="1110374" y="1881733"/>
+            <a:ext cx="455061" cy="530359"/>
           </a:xfrm>
           <a:prstGeom prst="rect">
             <a:avLst/>
@@ -38457,69 +38742,29 @@
       </p:pic>
       <p:sp>
         <p:nvSpPr>
-          <p:cNvPr id="139" name="Textfeld 40">
-            <a:extLst>
-              <a:ext uri="{FF2B5EF4-FFF2-40B4-BE49-F238E27FC236}">
-                <a16:creationId xmlns:a16="http://schemas.microsoft.com/office/drawing/2014/main" id="{F5202F32-CF94-B0E2-B061-FC87820AD558}"/>
-              </a:ext>
-            </a:extLst>
-          </p:cNvPr>
-          <p:cNvSpPr>
-            <a:spLocks noGrp="1"/>
-          </p:cNvSpPr>
-          <p:nvPr/>
-        </p:nvSpPr>
-        <p:spPr>
-          <a:xfrm>
-            <a:off x="2828275" y="1571625"/>
-            <a:ext cx="1414131" cy="276999"/>
-          </a:xfrm>
-          <a:prstGeom prst="rect">
-            <a:avLst/>
-          </a:prstGeom>
-          <a:noFill/>
-        </p:spPr>
-        <p:txBody>
-          <a:bodyPr wrap="square">
-            <a:spAutoFit/>
-          </a:bodyPr>
-          <a:lstStyle/>
-          <a:p>
-            <a:pPr algn="ctr">
-              <a:buNone/>
-            </a:pPr>
-            <a:r>
-              <a:rPr sz="1200" dirty="0"/>
-              <a:t>Embedding LLM</a:t>
-            </a:r>
-          </a:p>
-        </p:txBody>
-      </p:sp>
-      <p:sp>
-        <p:nvSpPr>
-          <p:cNvPr id="140" name="Gerader Verbinder 139">
-            <a:extLst>
-              <a:ext uri="{FF2B5EF4-FFF2-40B4-BE49-F238E27FC236}">
-                <a16:creationId xmlns:a16="http://schemas.microsoft.com/office/drawing/2014/main" id="{FAE015C5-0604-FCE4-AE8F-E2A5506C996F}"/>
-              </a:ext>
-            </a:extLst>
-          </p:cNvPr>
-          <p:cNvSpPr>
-            <a:spLocks noGrp="1"/>
-          </p:cNvSpPr>
-          <p:nvPr/>
-        </p:nvSpPr>
-        <p:spPr>
-          <a:xfrm>
-            <a:off x="2874076" y="1855424"/>
-            <a:ext cx="1259680" cy="0"/>
+          <p:cNvPr id="124" name="Gerader Verbinder 123">
+            <a:extLst>
+              <a:ext uri="{FF2B5EF4-FFF2-40B4-BE49-F238E27FC236}">
+                <a16:creationId xmlns:a16="http://schemas.microsoft.com/office/drawing/2014/main" id="{E1830494-1611-ADE7-C919-BF9ADBCD7AEF}"/>
+              </a:ext>
+            </a:extLst>
+          </p:cNvPr>
+          <p:cNvSpPr>
+            <a:spLocks/>
+          </p:cNvSpPr>
+          <p:nvPr/>
+        </p:nvSpPr>
+        <p:spPr>
+          <a:xfrm>
+            <a:off x="708064" y="1864279"/>
+            <a:ext cx="1259680" cy="3023"/>
           </a:xfrm>
           <a:prstGeom prst="line">
             <a:avLst/>
           </a:prstGeom>
           <a:ln>
             <a:solidFill>
-              <a:schemeClr val="tx2"/>
+              <a:schemeClr val="accent3"/>
             </a:solidFill>
           </a:ln>
         </p:spPr>
@@ -38542,106 +38787,6 @@
           <a:lstStyle/>
           <a:p>
             <a:endParaRPr lang="de-CH"/>
-          </a:p>
-        </p:txBody>
-      </p:sp>
-      <p:cxnSp>
-        <p:nvCxnSpPr>
-          <p:cNvPr id="142" name="Gerade Verbindung mit Pfeil 141">
-            <a:extLst>
-              <a:ext uri="{FF2B5EF4-FFF2-40B4-BE49-F238E27FC236}">
-                <a16:creationId xmlns:a16="http://schemas.microsoft.com/office/drawing/2014/main" id="{250A82F1-6D5C-250C-1CB6-877ACFE32D37}"/>
-              </a:ext>
-            </a:extLst>
-          </p:cNvPr>
-          <p:cNvCxnSpPr>
-            <a:cxnSpLocks/>
-            <a:stCxn id="137" idx="3"/>
-            <a:endCxn id="54" idx="1"/>
-          </p:cNvCxnSpPr>
-          <p:nvPr/>
-        </p:nvCxnSpPr>
-        <p:spPr>
-          <a:xfrm>
-            <a:off x="4133756" y="2005013"/>
-            <a:ext cx="985744" cy="7284"/>
-          </a:xfrm>
-          <a:prstGeom prst="straightConnector1">
-            <a:avLst/>
-          </a:prstGeom>
-          <a:ln w="20955">
-            <a:solidFill>
-              <a:srgbClr val="304554"/>
-            </a:solidFill>
-            <a:prstDash val="solid"/>
-            <a:tailEnd type="triangle" w="sm" len="sm"/>
-          </a:ln>
-        </p:spPr>
-      </p:cxnSp>
-      <p:cxnSp>
-        <p:nvCxnSpPr>
-          <p:cNvPr id="143" name="Gerade Verbindung mit Pfeil 142">
-            <a:extLst>
-              <a:ext uri="{FF2B5EF4-FFF2-40B4-BE49-F238E27FC236}">
-                <a16:creationId xmlns:a16="http://schemas.microsoft.com/office/drawing/2014/main" id="{3CECE63A-21C4-476A-975A-5AC5E3A1EB5E}"/>
-              </a:ext>
-            </a:extLst>
-          </p:cNvPr>
-          <p:cNvCxnSpPr>
-            <a:cxnSpLocks/>
-          </p:cNvCxnSpPr>
-          <p:nvPr/>
-        </p:nvCxnSpPr>
-        <p:spPr>
-          <a:xfrm>
-            <a:off x="5749340" y="2448836"/>
-            <a:ext cx="4805" cy="608699"/>
-          </a:xfrm>
-          <a:prstGeom prst="straightConnector1">
-            <a:avLst/>
-          </a:prstGeom>
-          <a:ln w="20955">
-            <a:solidFill>
-              <a:srgbClr val="304554"/>
-            </a:solidFill>
-            <a:prstDash val="solid"/>
-            <a:tailEnd type="triangle" w="sm" len="sm"/>
-          </a:ln>
-        </p:spPr>
-      </p:cxnSp>
-      <p:sp>
-        <p:nvSpPr>
-          <p:cNvPr id="145" name="Textfeld 144">
-            <a:extLst>
-              <a:ext uri="{FF2B5EF4-FFF2-40B4-BE49-F238E27FC236}">
-                <a16:creationId xmlns:a16="http://schemas.microsoft.com/office/drawing/2014/main" id="{8C156430-C202-53BD-8023-A0D5C9A9CCB0}"/>
-              </a:ext>
-            </a:extLst>
-          </p:cNvPr>
-          <p:cNvSpPr txBox="1"/>
-          <p:nvPr/>
-        </p:nvSpPr>
-        <p:spPr>
-          <a:xfrm>
-            <a:off x="6838721" y="4799945"/>
-            <a:ext cx="922500" cy="276999"/>
-          </a:xfrm>
-          <a:prstGeom prst="rect">
-            <a:avLst/>
-          </a:prstGeom>
-          <a:noFill/>
-        </p:spPr>
-        <p:txBody>
-          <a:bodyPr wrap="square" rtlCol="0">
-            <a:spAutoFit/>
-          </a:bodyPr>
-          <a:lstStyle/>
-          <a:p>
-            <a:r>
-              <a:rPr lang="de-CH" sz="1200" dirty="0" err="1"/>
-              <a:t>Context</a:t>
-            </a:r>
-            <a:endParaRPr lang="de-CH" sz="1200" dirty="0"/>
           </a:p>
         </p:txBody>
       </p:sp>
@@ -38909,33 +39054,6 @@
                                   </p:childTnLst>
                                 </p:cTn>
                               </p:par>
-                              <p:par>
-                                <p:cTn id="23" presetID="1" presetClass="entr" presetSubtype="0" fill="hold" nodeType="withEffect">
-                                  <p:stCondLst>
-                                    <p:cond delay="0"/>
-                                  </p:stCondLst>
-                                  <p:childTnLst>
-                                    <p:set>
-                                      <p:cBhvr>
-                                        <p:cTn id="24" dur="1" fill="hold">
-                                          <p:stCondLst>
-                                            <p:cond delay="0"/>
-                                          </p:stCondLst>
-                                        </p:cTn>
-                                        <p:tgtEl>
-                                          <p:spTgt spid="126"/>
-                                        </p:tgtEl>
-                                        <p:attrNameLst>
-                                          <p:attrName>style.visibility</p:attrName>
-                                        </p:attrNameLst>
-                                      </p:cBhvr>
-                                      <p:to>
-                                        <p:strVal val="visible"/>
-                                      </p:to>
-                                    </p:set>
-                                  </p:childTnLst>
-                                </p:cTn>
-                              </p:par>
                             </p:childTnLst>
                           </p:cTn>
                         </p:par>
@@ -38943,26 +39061,26 @@
                     </p:cTn>
                   </p:par>
                   <p:par>
-                    <p:cTn id="25" fill="hold">
+                    <p:cTn id="23" fill="hold">
                       <p:stCondLst>
                         <p:cond delay="indefinite"/>
                       </p:stCondLst>
                       <p:childTnLst>
                         <p:par>
-                          <p:cTn id="26" fill="hold">
+                          <p:cTn id="24" fill="hold">
                             <p:stCondLst>
                               <p:cond delay="0"/>
                             </p:stCondLst>
                             <p:childTnLst>
                               <p:par>
-                                <p:cTn id="27" presetID="1" presetClass="entr" presetSubtype="0" fill="hold" grpId="0" nodeType="clickEffect">
+                                <p:cTn id="25" presetID="1" presetClass="entr" presetSubtype="0" fill="hold" grpId="0" nodeType="clickEffect">
                                   <p:stCondLst>
                                     <p:cond delay="0"/>
                                   </p:stCondLst>
                                   <p:childTnLst>
                                     <p:set>
                                       <p:cBhvr>
-                                        <p:cTn id="28" dur="1" fill="hold">
+                                        <p:cTn id="26" dur="1" fill="hold">
                                           <p:stCondLst>
                                             <p:cond delay="0"/>
                                           </p:stCondLst>
@@ -38982,7 +39100,34 @@
                                 </p:cTn>
                               </p:par>
                               <p:par>
-                                <p:cTn id="29" presetID="1" presetClass="entr" presetSubtype="0" fill="hold" nodeType="withEffect">
+                                <p:cTn id="27" presetID="1" presetClass="entr" presetSubtype="0" fill="hold" nodeType="withEffect">
+                                  <p:stCondLst>
+                                    <p:cond delay="0"/>
+                                  </p:stCondLst>
+                                  <p:childTnLst>
+                                    <p:set>
+                                      <p:cBhvr>
+                                        <p:cTn id="28" dur="1" fill="hold">
+                                          <p:stCondLst>
+                                            <p:cond delay="0"/>
+                                          </p:stCondLst>
+                                        </p:cTn>
+                                        <p:tgtEl>
+                                          <p:spTgt spid="42"/>
+                                        </p:tgtEl>
+                                        <p:attrNameLst>
+                                          <p:attrName>style.visibility</p:attrName>
+                                        </p:attrNameLst>
+                                      </p:cBhvr>
+                                      <p:to>
+                                        <p:strVal val="visible"/>
+                                      </p:to>
+                                    </p:set>
+                                  </p:childTnLst>
+                                </p:cTn>
+                              </p:par>
+                              <p:par>
+                                <p:cTn id="29" presetID="1" presetClass="entr" presetSubtype="0" fill="hold" grpId="0" nodeType="withEffect">
                                   <p:stCondLst>
                                     <p:cond delay="0"/>
                                   </p:stCondLst>
@@ -38995,7 +39140,7 @@
                                           </p:stCondLst>
                                         </p:cTn>
                                         <p:tgtEl>
-                                          <p:spTgt spid="42"/>
+                                          <p:spTgt spid="43"/>
                                         </p:tgtEl>
                                         <p:attrNameLst>
                                           <p:attrName>style.visibility</p:attrName>
@@ -39022,61 +39167,7 @@
                                           </p:stCondLst>
                                         </p:cTn>
                                         <p:tgtEl>
-                                          <p:spTgt spid="43"/>
-                                        </p:tgtEl>
-                                        <p:attrNameLst>
-                                          <p:attrName>style.visibility</p:attrName>
-                                        </p:attrNameLst>
-                                      </p:cBhvr>
-                                      <p:to>
-                                        <p:strVal val="visible"/>
-                                      </p:to>
-                                    </p:set>
-                                  </p:childTnLst>
-                                </p:cTn>
-                              </p:par>
-                              <p:par>
-                                <p:cTn id="33" presetID="1" presetClass="entr" presetSubtype="0" fill="hold" grpId="0" nodeType="withEffect">
-                                  <p:stCondLst>
-                                    <p:cond delay="0"/>
-                                  </p:stCondLst>
-                                  <p:childTnLst>
-                                    <p:set>
-                                      <p:cBhvr>
-                                        <p:cTn id="34" dur="1" fill="hold">
-                                          <p:stCondLst>
-                                            <p:cond delay="0"/>
-                                          </p:stCondLst>
-                                        </p:cTn>
-                                        <p:tgtEl>
                                           <p:spTgt spid="44"/>
-                                        </p:tgtEl>
-                                        <p:attrNameLst>
-                                          <p:attrName>style.visibility</p:attrName>
-                                        </p:attrNameLst>
-                                      </p:cBhvr>
-                                      <p:to>
-                                        <p:strVal val="visible"/>
-                                      </p:to>
-                                    </p:set>
-                                  </p:childTnLst>
-                                </p:cTn>
-                              </p:par>
-                              <p:par>
-                                <p:cTn id="35" presetID="1" presetClass="entr" presetSubtype="0" fill="hold" nodeType="withEffect">
-                                  <p:stCondLst>
-                                    <p:cond delay="0"/>
-                                  </p:stCondLst>
-                                  <p:childTnLst>
-                                    <p:set>
-                                      <p:cBhvr>
-                                        <p:cTn id="36" dur="1" fill="hold">
-                                          <p:stCondLst>
-                                            <p:cond delay="0"/>
-                                          </p:stCondLst>
-                                        </p:cTn>
-                                        <p:tgtEl>
-                                          <p:spTgt spid="127"/>
                                         </p:tgtEl>
                                         <p:attrNameLst>
                                           <p:attrName>style.visibility</p:attrName>
@@ -39096,19 +39187,73 @@
                     </p:cTn>
                   </p:par>
                   <p:par>
-                    <p:cTn id="37" fill="hold">
+                    <p:cTn id="33" fill="hold">
                       <p:stCondLst>
                         <p:cond delay="indefinite"/>
                       </p:stCondLst>
                       <p:childTnLst>
                         <p:par>
-                          <p:cTn id="38" fill="hold">
+                          <p:cTn id="34" fill="hold">
                             <p:stCondLst>
                               <p:cond delay="0"/>
                             </p:stCondLst>
                             <p:childTnLst>
                               <p:par>
-                                <p:cTn id="39" presetID="1" presetClass="entr" presetSubtype="0" fill="hold" grpId="0" nodeType="clickEffect">
+                                <p:cTn id="35" presetID="1" presetClass="entr" presetSubtype="0" fill="hold" grpId="0" nodeType="clickEffect">
+                                  <p:stCondLst>
+                                    <p:cond delay="0"/>
+                                  </p:stCondLst>
+                                  <p:childTnLst>
+                                    <p:set>
+                                      <p:cBhvr>
+                                        <p:cTn id="36" dur="1" fill="hold">
+                                          <p:stCondLst>
+                                            <p:cond delay="0"/>
+                                          </p:stCondLst>
+                                        </p:cTn>
+                                        <p:tgtEl>
+                                          <p:spTgt spid="48"/>
+                                        </p:tgtEl>
+                                        <p:attrNameLst>
+                                          <p:attrName>style.visibility</p:attrName>
+                                        </p:attrNameLst>
+                                      </p:cBhvr>
+                                      <p:to>
+                                        <p:strVal val="visible"/>
+                                      </p:to>
+                                    </p:set>
+                                  </p:childTnLst>
+                                </p:cTn>
+                              </p:par>
+                              <p:par>
+                                <p:cTn id="37" presetID="1" presetClass="entr" presetSubtype="0" fill="hold" grpId="0" nodeType="withEffect">
+                                  <p:stCondLst>
+                                    <p:cond delay="0"/>
+                                  </p:stCondLst>
+                                  <p:childTnLst>
+                                    <p:set>
+                                      <p:cBhvr>
+                                        <p:cTn id="38" dur="1" fill="hold">
+                                          <p:stCondLst>
+                                            <p:cond delay="0"/>
+                                          </p:stCondLst>
+                                        </p:cTn>
+                                        <p:tgtEl>
+                                          <p:spTgt spid="51"/>
+                                        </p:tgtEl>
+                                        <p:attrNameLst>
+                                          <p:attrName>style.visibility</p:attrName>
+                                        </p:attrNameLst>
+                                      </p:cBhvr>
+                                      <p:to>
+                                        <p:strVal val="visible"/>
+                                      </p:to>
+                                    </p:set>
+                                  </p:childTnLst>
+                                </p:cTn>
+                              </p:par>
+                              <p:par>
+                                <p:cTn id="39" presetID="1" presetClass="entr" presetSubtype="0" fill="hold" nodeType="withEffect">
                                   <p:stCondLst>
                                     <p:cond delay="0"/>
                                   </p:stCondLst>
@@ -39121,7 +39266,7 @@
                                           </p:stCondLst>
                                         </p:cTn>
                                         <p:tgtEl>
-                                          <p:spTgt spid="48"/>
+                                          <p:spTgt spid="109"/>
                                         </p:tgtEl>
                                         <p:attrNameLst>
                                           <p:attrName>style.visibility</p:attrName>
@@ -39148,7 +39293,7 @@
                                           </p:stCondLst>
                                         </p:cTn>
                                         <p:tgtEl>
-                                          <p:spTgt spid="51"/>
+                                          <p:spTgt spid="45"/>
                                         </p:tgtEl>
                                         <p:attrNameLst>
                                           <p:attrName>style.visibility</p:attrName>
@@ -39175,87 +39320,6 @@
                                           </p:stCondLst>
                                         </p:cTn>
                                         <p:tgtEl>
-                                          <p:spTgt spid="109"/>
-                                        </p:tgtEl>
-                                        <p:attrNameLst>
-                                          <p:attrName>style.visibility</p:attrName>
-                                        </p:attrNameLst>
-                                      </p:cBhvr>
-                                      <p:to>
-                                        <p:strVal val="visible"/>
-                                      </p:to>
-                                    </p:set>
-                                  </p:childTnLst>
-                                </p:cTn>
-                              </p:par>
-                              <p:par>
-                                <p:cTn id="45" presetID="1" presetClass="entr" presetSubtype="0" fill="hold" nodeType="withEffect">
-                                  <p:stCondLst>
-                                    <p:cond delay="0"/>
-                                  </p:stCondLst>
-                                  <p:childTnLst>
-                                    <p:set>
-                                      <p:cBhvr>
-                                        <p:cTn id="46" dur="1" fill="hold">
-                                          <p:stCondLst>
-                                            <p:cond delay="0"/>
-                                          </p:stCondLst>
-                                        </p:cTn>
-                                        <p:tgtEl>
-                                          <p:spTgt spid="128"/>
-                                        </p:tgtEl>
-                                        <p:attrNameLst>
-                                          <p:attrName>style.visibility</p:attrName>
-                                        </p:attrNameLst>
-                                      </p:cBhvr>
-                                      <p:to>
-                                        <p:strVal val="visible"/>
-                                      </p:to>
-                                    </p:set>
-                                  </p:childTnLst>
-                                </p:cTn>
-                              </p:par>
-                              <p:par>
-                                <p:cTn id="47" presetID="1" presetClass="entr" presetSubtype="0" fill="hold" grpId="0" nodeType="withEffect">
-                                  <p:stCondLst>
-                                    <p:cond delay="0"/>
-                                  </p:stCondLst>
-                                  <p:childTnLst>
-                                    <p:set>
-                                      <p:cBhvr>
-                                        <p:cTn id="48" dur="1" fill="hold">
-                                          <p:stCondLst>
-                                            <p:cond delay="0"/>
-                                          </p:stCondLst>
-                                        </p:cTn>
-                                        <p:tgtEl>
-                                          <p:spTgt spid="45"/>
-                                        </p:tgtEl>
-                                        <p:attrNameLst>
-                                          <p:attrName>style.visibility</p:attrName>
-                                        </p:attrNameLst>
-                                      </p:cBhvr>
-                                      <p:to>
-                                        <p:strVal val="visible"/>
-                                      </p:to>
-                                    </p:set>
-                                  </p:childTnLst>
-                                </p:cTn>
-                              </p:par>
-                              <p:par>
-                                <p:cTn id="49" presetID="1" presetClass="entr" presetSubtype="0" fill="hold" nodeType="withEffect">
-                                  <p:stCondLst>
-                                    <p:cond delay="0"/>
-                                  </p:stCondLst>
-                                  <p:childTnLst>
-                                    <p:set>
-                                      <p:cBhvr>
-                                        <p:cTn id="50" dur="1" fill="hold">
-                                          <p:stCondLst>
-                                            <p:cond delay="0"/>
-                                          </p:stCondLst>
-                                        </p:cTn>
-                                        <p:tgtEl>
                                           <p:spTgt spid="46"/>
                                         </p:tgtEl>
                                         <p:attrNameLst>
@@ -39276,26 +39340,26 @@
                     </p:cTn>
                   </p:par>
                   <p:par>
-                    <p:cTn id="51" fill="hold">
+                    <p:cTn id="45" fill="hold">
                       <p:stCondLst>
                         <p:cond delay="indefinite"/>
                       </p:stCondLst>
                       <p:childTnLst>
                         <p:par>
-                          <p:cTn id="52" fill="hold">
+                          <p:cTn id="46" fill="hold">
                             <p:stCondLst>
                               <p:cond delay="0"/>
                             </p:stCondLst>
                             <p:childTnLst>
                               <p:par>
-                                <p:cTn id="53" presetID="1" presetClass="entr" presetSubtype="0" fill="hold" nodeType="clickEffect">
+                                <p:cTn id="47" presetID="1" presetClass="entr" presetSubtype="0" fill="hold" nodeType="clickEffect">
                                   <p:stCondLst>
                                     <p:cond delay="0"/>
                                   </p:stCondLst>
                                   <p:childTnLst>
                                     <p:set>
                                       <p:cBhvr>
-                                        <p:cTn id="54" dur="1" fill="hold">
+                                        <p:cTn id="48" dur="1" fill="hold">
                                           <p:stCondLst>
                                             <p:cond delay="0"/>
                                           </p:stCondLst>
@@ -39315,14 +39379,14 @@
                                 </p:cTn>
                               </p:par>
                               <p:par>
-                                <p:cTn id="55" presetID="1" presetClass="entr" presetSubtype="0" fill="hold" grpId="0" nodeType="withEffect">
+                                <p:cTn id="49" presetID="1" presetClass="entr" presetSubtype="0" fill="hold" grpId="0" nodeType="withEffect">
                                   <p:stCondLst>
                                     <p:cond delay="0"/>
                                   </p:stCondLst>
                                   <p:childTnLst>
                                     <p:set>
                                       <p:cBhvr>
-                                        <p:cTn id="56" dur="1" fill="hold">
+                                        <p:cTn id="50" dur="1" fill="hold">
                                           <p:stCondLst>
                                             <p:cond delay="0"/>
                                           </p:stCondLst>
@@ -39342,7 +39406,79 @@
                                 </p:cTn>
                               </p:par>
                               <p:par>
-                                <p:cTn id="57" presetID="1" presetClass="entr" presetSubtype="0" fill="hold" grpId="0" nodeType="withEffect">
+                                <p:cTn id="51" presetID="1" presetClass="entr" presetSubtype="0" fill="hold" grpId="0" nodeType="withEffect">
+                                  <p:stCondLst>
+                                    <p:cond delay="0"/>
+                                  </p:stCondLst>
+                                  <p:childTnLst>
+                                    <p:set>
+                                      <p:cBhvr>
+                                        <p:cTn id="52" dur="1" fill="hold">
+                                          <p:stCondLst>
+                                            <p:cond delay="0"/>
+                                          </p:stCondLst>
+                                        </p:cTn>
+                                        <p:tgtEl>
+                                          <p:spTgt spid="124"/>
+                                        </p:tgtEl>
+                                        <p:attrNameLst>
+                                          <p:attrName>style.visibility</p:attrName>
+                                        </p:attrNameLst>
+                                      </p:cBhvr>
+                                      <p:to>
+                                        <p:strVal val="visible"/>
+                                      </p:to>
+                                    </p:set>
+                                  </p:childTnLst>
+                                </p:cTn>
+                              </p:par>
+                              <p:par>
+                                <p:cTn id="53" presetID="1" presetClass="entr" presetSubtype="0" fill="hold" grpId="0" nodeType="withEffect">
+                                  <p:stCondLst>
+                                    <p:cond delay="0"/>
+                                  </p:stCondLst>
+                                  <p:childTnLst>
+                                    <p:set>
+                                      <p:cBhvr>
+                                        <p:cTn id="54" dur="1" fill="hold">
+                                          <p:stCondLst>
+                                            <p:cond delay="0"/>
+                                          </p:stCondLst>
+                                        </p:cTn>
+                                        <p:tgtEl>
+                                          <p:spTgt spid="121"/>
+                                        </p:tgtEl>
+                                        <p:attrNameLst>
+                                          <p:attrName>style.visibility</p:attrName>
+                                        </p:attrNameLst>
+                                      </p:cBhvr>
+                                      <p:to>
+                                        <p:strVal val="visible"/>
+                                      </p:to>
+                                    </p:set>
+                                  </p:childTnLst>
+                                </p:cTn>
+                              </p:par>
+                            </p:childTnLst>
+                          </p:cTn>
+                        </p:par>
+                      </p:childTnLst>
+                    </p:cTn>
+                  </p:par>
+                  <p:par>
+                    <p:cTn id="55" fill="hold">
+                      <p:stCondLst>
+                        <p:cond delay="indefinite"/>
+                      </p:stCondLst>
+                      <p:childTnLst>
+                        <p:par>
+                          <p:cTn id="56" fill="hold">
+                            <p:stCondLst>
+                              <p:cond delay="0"/>
+                            </p:stCondLst>
+                            <p:childTnLst>
+                              <p:par>
+                                <p:cTn id="57" presetID="1" presetClass="entr" presetSubtype="0" fill="hold" grpId="0" nodeType="clickEffect">
                                   <p:stCondLst>
                                     <p:cond delay="0"/>
                                   </p:stCondLst>
@@ -39355,7 +39491,7 @@
                                           </p:stCondLst>
                                         </p:cTn>
                                         <p:tgtEl>
-                                          <p:spTgt spid="124"/>
+                                          <p:spTgt spid="137"/>
                                         </p:tgtEl>
                                         <p:attrNameLst>
                                           <p:attrName>style.visibility</p:attrName>
@@ -39382,7 +39518,7 @@
                                           </p:stCondLst>
                                         </p:cTn>
                                         <p:tgtEl>
-                                          <p:spTgt spid="129"/>
+                                          <p:spTgt spid="138"/>
                                         </p:tgtEl>
                                         <p:attrNameLst>
                                           <p:attrName>style.visibility</p:attrName>
@@ -39409,7 +39545,34 @@
                                           </p:stCondLst>
                                         </p:cTn>
                                         <p:tgtEl>
-                                          <p:spTgt spid="121"/>
+                                          <p:spTgt spid="140"/>
+                                        </p:tgtEl>
+                                        <p:attrNameLst>
+                                          <p:attrName>style.visibility</p:attrName>
+                                        </p:attrNameLst>
+                                      </p:cBhvr>
+                                      <p:to>
+                                        <p:strVal val="visible"/>
+                                      </p:to>
+                                    </p:set>
+                                  </p:childTnLst>
+                                </p:cTn>
+                              </p:par>
+                              <p:par>
+                                <p:cTn id="63" presetID="1" presetClass="entr" presetSubtype="0" fill="hold" grpId="0" nodeType="withEffect">
+                                  <p:stCondLst>
+                                    <p:cond delay="0"/>
+                                  </p:stCondLst>
+                                  <p:childTnLst>
+                                    <p:set>
+                                      <p:cBhvr>
+                                        <p:cTn id="64" dur="1" fill="hold">
+                                          <p:stCondLst>
+                                            <p:cond delay="0"/>
+                                          </p:stCondLst>
+                                        </p:cTn>
+                                        <p:tgtEl>
+                                          <p:spTgt spid="139"/>
                                         </p:tgtEl>
                                         <p:attrNameLst>
                                           <p:attrName>style.visibility</p:attrName>
@@ -39429,32 +39592,32 @@
                     </p:cTn>
                   </p:par>
                   <p:par>
-                    <p:cTn id="63" fill="hold">
+                    <p:cTn id="65" fill="hold">
                       <p:stCondLst>
                         <p:cond delay="indefinite"/>
                       </p:stCondLst>
                       <p:childTnLst>
                         <p:par>
-                          <p:cTn id="64" fill="hold">
+                          <p:cTn id="66" fill="hold">
                             <p:stCondLst>
                               <p:cond delay="0"/>
                             </p:stCondLst>
                             <p:childTnLst>
                               <p:par>
-                                <p:cTn id="65" presetID="1" presetClass="entr" presetSubtype="0" fill="hold" grpId="0" nodeType="clickEffect">
+                                <p:cTn id="67" presetID="1" presetClass="entr" presetSubtype="0" fill="hold" grpId="0" nodeType="clickEffect">
                                   <p:stCondLst>
                                     <p:cond delay="0"/>
                                   </p:stCondLst>
                                   <p:childTnLst>
                                     <p:set>
                                       <p:cBhvr>
-                                        <p:cTn id="66" dur="1" fill="hold">
+                                        <p:cTn id="68" dur="1" fill="hold">
                                           <p:stCondLst>
                                             <p:cond delay="0"/>
                                           </p:stCondLst>
                                         </p:cTn>
                                         <p:tgtEl>
-                                          <p:spTgt spid="137"/>
+                                          <p:spTgt spid="54"/>
                                         </p:tgtEl>
                                         <p:attrNameLst>
                                           <p:attrName>style.visibility</p:attrName>
@@ -39468,20 +39631,20 @@
                                 </p:cTn>
                               </p:par>
                               <p:par>
-                                <p:cTn id="67" presetID="1" presetClass="entr" presetSubtype="0" fill="hold" nodeType="withEffect">
+                                <p:cTn id="69" presetID="1" presetClass="entr" presetSubtype="0" fill="hold" nodeType="withEffect">
                                   <p:stCondLst>
                                     <p:cond delay="0"/>
                                   </p:stCondLst>
                                   <p:childTnLst>
                                     <p:set>
                                       <p:cBhvr>
-                                        <p:cTn id="68" dur="1" fill="hold">
+                                        <p:cTn id="70" dur="1" fill="hold">
                                           <p:stCondLst>
                                             <p:cond delay="0"/>
                                           </p:stCondLst>
                                         </p:cTn>
                                         <p:tgtEl>
-                                          <p:spTgt spid="138"/>
+                                          <p:spTgt spid="56"/>
                                         </p:tgtEl>
                                         <p:attrNameLst>
                                           <p:attrName>style.visibility</p:attrName>
@@ -39495,34 +39658,7 @@
                                 </p:cTn>
                               </p:par>
                               <p:par>
-                                <p:cTn id="69" presetID="1" presetClass="entr" presetSubtype="0" fill="hold" grpId="0" nodeType="withEffect">
-                                  <p:stCondLst>
-                                    <p:cond delay="0"/>
-                                  </p:stCondLst>
-                                  <p:childTnLst>
-                                    <p:set>
-                                      <p:cBhvr>
-                                        <p:cTn id="70" dur="1" fill="hold">
-                                          <p:stCondLst>
-                                            <p:cond delay="0"/>
-                                          </p:stCondLst>
-                                        </p:cTn>
-                                        <p:tgtEl>
-                                          <p:spTgt spid="140"/>
-                                        </p:tgtEl>
-                                        <p:attrNameLst>
-                                          <p:attrName>style.visibility</p:attrName>
-                                        </p:attrNameLst>
-                                      </p:cBhvr>
-                                      <p:to>
-                                        <p:strVal val="visible"/>
-                                      </p:to>
-                                    </p:set>
-                                  </p:childTnLst>
-                                </p:cTn>
-                              </p:par>
-                              <p:par>
-                                <p:cTn id="71" presetID="1" presetClass="entr" presetSubtype="0" fill="hold" nodeType="withEffect">
+                                <p:cTn id="71" presetID="1" presetClass="entr" presetSubtype="0" fill="hold" grpId="0" nodeType="withEffect">
                                   <p:stCondLst>
                                     <p:cond delay="0"/>
                                   </p:stCondLst>
@@ -39535,7 +39671,7 @@
                                           </p:stCondLst>
                                         </p:cTn>
                                         <p:tgtEl>
-                                          <p:spTgt spid="142"/>
+                                          <p:spTgt spid="57"/>
                                         </p:tgtEl>
                                         <p:attrNameLst>
                                           <p:attrName>style.visibility</p:attrName>
@@ -39562,7 +39698,7 @@
                                           </p:stCondLst>
                                         </p:cTn>
                                         <p:tgtEl>
-                                          <p:spTgt spid="139"/>
+                                          <p:spTgt spid="58"/>
                                         </p:tgtEl>
                                         <p:attrNameLst>
                                           <p:attrName>style.visibility</p:attrName>
@@ -39607,7 +39743,7 @@
                                           </p:stCondLst>
                                         </p:cTn>
                                         <p:tgtEl>
-                                          <p:spTgt spid="54"/>
+                                          <p:spTgt spid="93"/>
                                         </p:tgtEl>
                                         <p:attrNameLst>
                                           <p:attrName>style.visibility</p:attrName>
@@ -39634,7 +39770,7 @@
                                           </p:stCondLst>
                                         </p:cTn>
                                         <p:tgtEl>
-                                          <p:spTgt spid="56"/>
+                                          <p:spTgt spid="96"/>
                                         </p:tgtEl>
                                         <p:attrNameLst>
                                           <p:attrName>style.visibility</p:attrName>
@@ -39661,7 +39797,7 @@
                                           </p:stCondLst>
                                         </p:cTn>
                                         <p:tgtEl>
-                                          <p:spTgt spid="57"/>
+                                          <p:spTgt spid="101"/>
                                         </p:tgtEl>
                                         <p:attrNameLst>
                                           <p:attrName>style.visibility</p:attrName>
@@ -39688,34 +39824,7 @@
                                           </p:stCondLst>
                                         </p:cTn>
                                         <p:tgtEl>
-                                          <p:spTgt spid="58"/>
-                                        </p:tgtEl>
-                                        <p:attrNameLst>
-                                          <p:attrName>style.visibility</p:attrName>
-                                        </p:attrNameLst>
-                                      </p:cBhvr>
-                                      <p:to>
-                                        <p:strVal val="visible"/>
-                                      </p:to>
-                                    </p:set>
-                                  </p:childTnLst>
-                                </p:cTn>
-                              </p:par>
-                              <p:par>
-                                <p:cTn id="85" presetID="1" presetClass="entr" presetSubtype="0" fill="hold" nodeType="withEffect">
-                                  <p:stCondLst>
-                                    <p:cond delay="0"/>
-                                  </p:stCondLst>
-                                  <p:childTnLst>
-                                    <p:set>
-                                      <p:cBhvr>
-                                        <p:cTn id="86" dur="1" fill="hold">
-                                          <p:stCondLst>
-                                            <p:cond delay="0"/>
-                                          </p:stCondLst>
-                                        </p:cTn>
-                                        <p:tgtEl>
-                                          <p:spTgt spid="143"/>
+                                          <p:spTgt spid="99"/>
                                         </p:tgtEl>
                                         <p:attrNameLst>
                                           <p:attrName>style.visibility</p:attrName>
@@ -39735,32 +39844,32 @@
                     </p:cTn>
                   </p:par>
                   <p:par>
-                    <p:cTn id="87" fill="hold">
+                    <p:cTn id="85" fill="hold">
                       <p:stCondLst>
                         <p:cond delay="indefinite"/>
                       </p:stCondLst>
                       <p:childTnLst>
                         <p:par>
-                          <p:cTn id="88" fill="hold">
+                          <p:cTn id="86" fill="hold">
                             <p:stCondLst>
                               <p:cond delay="0"/>
                             </p:stCondLst>
                             <p:childTnLst>
                               <p:par>
-                                <p:cTn id="89" presetID="1" presetClass="entr" presetSubtype="0" fill="hold" grpId="0" nodeType="clickEffect">
+                                <p:cTn id="87" presetID="1" presetClass="entr" presetSubtype="0" fill="hold" grpId="0" nodeType="clickEffect">
                                   <p:stCondLst>
                                     <p:cond delay="0"/>
                                   </p:stCondLst>
                                   <p:childTnLst>
                                     <p:set>
                                       <p:cBhvr>
-                                        <p:cTn id="90" dur="1" fill="hold">
+                                        <p:cTn id="88" dur="1" fill="hold">
                                           <p:stCondLst>
                                             <p:cond delay="0"/>
                                           </p:stCondLst>
                                         </p:cTn>
                                         <p:tgtEl>
-                                          <p:spTgt spid="93"/>
+                                          <p:spTgt spid="60"/>
                                         </p:tgtEl>
                                         <p:attrNameLst>
                                           <p:attrName>style.visibility</p:attrName>
@@ -39774,7 +39883,34 @@
                                 </p:cTn>
                               </p:par>
                               <p:par>
-                                <p:cTn id="91" presetID="1" presetClass="entr" presetSubtype="0" fill="hold" nodeType="withEffect">
+                                <p:cTn id="89" presetID="1" presetClass="entr" presetSubtype="0" fill="hold" nodeType="withEffect">
+                                  <p:stCondLst>
+                                    <p:cond delay="0"/>
+                                  </p:stCondLst>
+                                  <p:childTnLst>
+                                    <p:set>
+                                      <p:cBhvr>
+                                        <p:cTn id="90" dur="1" fill="hold">
+                                          <p:stCondLst>
+                                            <p:cond delay="0"/>
+                                          </p:stCondLst>
+                                        </p:cTn>
+                                        <p:tgtEl>
+                                          <p:spTgt spid="63"/>
+                                        </p:tgtEl>
+                                        <p:attrNameLst>
+                                          <p:attrName>style.visibility</p:attrName>
+                                        </p:attrNameLst>
+                                      </p:cBhvr>
+                                      <p:to>
+                                        <p:strVal val="visible"/>
+                                      </p:to>
+                                    </p:set>
+                                  </p:childTnLst>
+                                </p:cTn>
+                              </p:par>
+                              <p:par>
+                                <p:cTn id="91" presetID="1" presetClass="entr" presetSubtype="0" fill="hold" grpId="0" nodeType="withEffect">
                                   <p:stCondLst>
                                     <p:cond delay="0"/>
                                   </p:stCondLst>
@@ -39787,7 +39923,7 @@
                                           </p:stCondLst>
                                         </p:cTn>
                                         <p:tgtEl>
-                                          <p:spTgt spid="96"/>
+                                          <p:spTgt spid="67"/>
                                         </p:tgtEl>
                                         <p:attrNameLst>
                                           <p:attrName>style.visibility</p:attrName>
@@ -39814,61 +39950,7 @@
                                           </p:stCondLst>
                                         </p:cTn>
                                         <p:tgtEl>
-                                          <p:spTgt spid="101"/>
-                                        </p:tgtEl>
-                                        <p:attrNameLst>
-                                          <p:attrName>style.visibility</p:attrName>
-                                        </p:attrNameLst>
-                                      </p:cBhvr>
-                                      <p:to>
-                                        <p:strVal val="visible"/>
-                                      </p:to>
-                                    </p:set>
-                                  </p:childTnLst>
-                                </p:cTn>
-                              </p:par>
-                              <p:par>
-                                <p:cTn id="95" presetID="1" presetClass="entr" presetSubtype="0" fill="hold" nodeType="withEffect">
-                                  <p:stCondLst>
-                                    <p:cond delay="0"/>
-                                  </p:stCondLst>
-                                  <p:childTnLst>
-                                    <p:set>
-                                      <p:cBhvr>
-                                        <p:cTn id="96" dur="1" fill="hold">
-                                          <p:stCondLst>
-                                            <p:cond delay="0"/>
-                                          </p:stCondLst>
-                                        </p:cTn>
-                                        <p:tgtEl>
-                                          <p:spTgt spid="131"/>
-                                        </p:tgtEl>
-                                        <p:attrNameLst>
-                                          <p:attrName>style.visibility</p:attrName>
-                                        </p:attrNameLst>
-                                      </p:cBhvr>
-                                      <p:to>
-                                        <p:strVal val="visible"/>
-                                      </p:to>
-                                    </p:set>
-                                  </p:childTnLst>
-                                </p:cTn>
-                              </p:par>
-                              <p:par>
-                                <p:cTn id="97" presetID="1" presetClass="entr" presetSubtype="0" fill="hold" grpId="0" nodeType="withEffect">
-                                  <p:stCondLst>
-                                    <p:cond delay="0"/>
-                                  </p:stCondLst>
-                                  <p:childTnLst>
-                                    <p:set>
-                                      <p:cBhvr>
-                                        <p:cTn id="98" dur="1" fill="hold">
-                                          <p:stCondLst>
-                                            <p:cond delay="0"/>
-                                          </p:stCondLst>
-                                        </p:cTn>
-                                        <p:tgtEl>
-                                          <p:spTgt spid="99"/>
+                                          <p:spTgt spid="69"/>
                                         </p:tgtEl>
                                         <p:attrNameLst>
                                           <p:attrName>style.visibility</p:attrName>
@@ -39888,32 +39970,32 @@
                     </p:cTn>
                   </p:par>
                   <p:par>
-                    <p:cTn id="99" fill="hold">
+                    <p:cTn id="95" fill="hold">
                       <p:stCondLst>
                         <p:cond delay="indefinite"/>
                       </p:stCondLst>
                       <p:childTnLst>
                         <p:par>
-                          <p:cTn id="100" fill="hold">
+                          <p:cTn id="96" fill="hold">
                             <p:stCondLst>
                               <p:cond delay="0"/>
                             </p:stCondLst>
                             <p:childTnLst>
                               <p:par>
-                                <p:cTn id="101" presetID="1" presetClass="entr" presetSubtype="0" fill="hold" grpId="0" nodeType="clickEffect">
+                                <p:cTn id="97" presetID="1" presetClass="entr" presetSubtype="0" fill="hold" grpId="0" nodeType="clickEffect">
                                   <p:stCondLst>
                                     <p:cond delay="0"/>
                                   </p:stCondLst>
                                   <p:childTnLst>
                                     <p:set>
                                       <p:cBhvr>
-                                        <p:cTn id="102" dur="1" fill="hold">
+                                        <p:cTn id="98" dur="1" fill="hold">
                                           <p:stCondLst>
                                             <p:cond delay="0"/>
                                           </p:stCondLst>
                                         </p:cTn>
                                         <p:tgtEl>
-                                          <p:spTgt spid="60"/>
+                                          <p:spTgt spid="81"/>
                                         </p:tgtEl>
                                         <p:attrNameLst>
                                           <p:attrName>style.visibility</p:attrName>
@@ -39927,20 +40009,20 @@
                                 </p:cTn>
                               </p:par>
                               <p:par>
-                                <p:cTn id="103" presetID="1" presetClass="entr" presetSubtype="0" fill="hold" nodeType="withEffect">
+                                <p:cTn id="99" presetID="1" presetClass="entr" presetSubtype="0" fill="hold" nodeType="withEffect">
                                   <p:stCondLst>
                                     <p:cond delay="0"/>
                                   </p:stCondLst>
                                   <p:childTnLst>
                                     <p:set>
                                       <p:cBhvr>
-                                        <p:cTn id="104" dur="1" fill="hold">
+                                        <p:cTn id="100" dur="1" fill="hold">
                                           <p:stCondLst>
                                             <p:cond delay="0"/>
                                           </p:stCondLst>
                                         </p:cTn>
                                         <p:tgtEl>
-                                          <p:spTgt spid="63"/>
+                                          <p:spTgt spid="84"/>
                                         </p:tgtEl>
                                         <p:attrNameLst>
                                           <p:attrName>style.visibility</p:attrName>
@@ -39954,20 +40036,20 @@
                                 </p:cTn>
                               </p:par>
                               <p:par>
-                                <p:cTn id="105" presetID="1" presetClass="entr" presetSubtype="0" fill="hold" grpId="0" nodeType="withEffect">
+                                <p:cTn id="101" presetID="1" presetClass="entr" presetSubtype="0" fill="hold" grpId="0" nodeType="withEffect">
                                   <p:stCondLst>
                                     <p:cond delay="0"/>
                                   </p:stCondLst>
                                   <p:childTnLst>
                                     <p:set>
                                       <p:cBhvr>
-                                        <p:cTn id="106" dur="1" fill="hold">
+                                        <p:cTn id="102" dur="1" fill="hold">
                                           <p:stCondLst>
                                             <p:cond delay="0"/>
                                           </p:stCondLst>
                                         </p:cTn>
                                         <p:tgtEl>
-                                          <p:spTgt spid="67"/>
+                                          <p:spTgt spid="87"/>
                                         </p:tgtEl>
                                         <p:attrNameLst>
                                           <p:attrName>style.visibility</p:attrName>
@@ -39981,20 +40063,20 @@
                                 </p:cTn>
                               </p:par>
                               <p:par>
-                                <p:cTn id="107" presetID="1" presetClass="entr" presetSubtype="0" fill="hold" grpId="0" nodeType="withEffect">
+                                <p:cTn id="103" presetID="1" presetClass="entr" presetSubtype="0" fill="hold" grpId="0" nodeType="withEffect">
                                   <p:stCondLst>
                                     <p:cond delay="0"/>
                                   </p:stCondLst>
                                   <p:childTnLst>
                                     <p:set>
                                       <p:cBhvr>
-                                        <p:cTn id="108" dur="1" fill="hold">
+                                        <p:cTn id="104" dur="1" fill="hold">
                                           <p:stCondLst>
                                             <p:cond delay="0"/>
                                           </p:stCondLst>
                                         </p:cTn>
                                         <p:tgtEl>
-                                          <p:spTgt spid="69"/>
+                                          <p:spTgt spid="90"/>
                                         </p:tgtEl>
                                         <p:attrNameLst>
                                           <p:attrName>style.visibility</p:attrName>
@@ -40008,20 +40090,20 @@
                                 </p:cTn>
                               </p:par>
                               <p:par>
-                                <p:cTn id="109" presetID="1" presetClass="entr" presetSubtype="0" fill="hold" nodeType="withEffect">
+                                <p:cTn id="105" presetID="1" presetClass="entr" presetSubtype="0" fill="hold" nodeType="withEffect">
                                   <p:stCondLst>
                                     <p:cond delay="0"/>
                                   </p:stCondLst>
                                   <p:childTnLst>
                                     <p:set>
                                       <p:cBhvr>
-                                        <p:cTn id="110" dur="1" fill="hold">
+                                        <p:cTn id="106" dur="1" fill="hold">
                                           <p:stCondLst>
                                             <p:cond delay="0"/>
                                           </p:stCondLst>
                                         </p:cTn>
                                         <p:tgtEl>
-                                          <p:spTgt spid="133"/>
+                                          <p:spTgt spid="111"/>
                                         </p:tgtEl>
                                         <p:attrNameLst>
                                           <p:attrName>style.visibility</p:attrName>
@@ -40041,32 +40123,32 @@
                     </p:cTn>
                   </p:par>
                   <p:par>
-                    <p:cTn id="111" fill="hold">
+                    <p:cTn id="107" fill="hold">
                       <p:stCondLst>
                         <p:cond delay="indefinite"/>
                       </p:stCondLst>
                       <p:childTnLst>
                         <p:par>
-                          <p:cTn id="112" fill="hold">
+                          <p:cTn id="108" fill="hold">
                             <p:stCondLst>
                               <p:cond delay="0"/>
                             </p:stCondLst>
                             <p:childTnLst>
                               <p:par>
-                                <p:cTn id="113" presetID="1" presetClass="entr" presetSubtype="0" fill="hold" grpId="0" nodeType="clickEffect">
+                                <p:cTn id="109" presetID="1" presetClass="entr" presetSubtype="0" fill="hold" grpId="0" nodeType="clickEffect">
                                   <p:stCondLst>
                                     <p:cond delay="0"/>
                                   </p:stCondLst>
                                   <p:childTnLst>
                                     <p:set>
                                       <p:cBhvr>
-                                        <p:cTn id="114" dur="1" fill="hold">
+                                        <p:cTn id="110" dur="1" fill="hold">
                                           <p:stCondLst>
                                             <p:cond delay="0"/>
                                           </p:stCondLst>
                                         </p:cTn>
                                         <p:tgtEl>
-                                          <p:spTgt spid="81"/>
+                                          <p:spTgt spid="102"/>
                                         </p:tgtEl>
                                         <p:attrNameLst>
                                           <p:attrName>style.visibility</p:attrName>
@@ -40080,7 +40162,61 @@
                                 </p:cTn>
                               </p:par>
                               <p:par>
-                                <p:cTn id="115" presetID="1" presetClass="entr" presetSubtype="0" fill="hold" nodeType="withEffect">
+                                <p:cTn id="111" presetID="1" presetClass="entr" presetSubtype="0" fill="hold" nodeType="withEffect">
+                                  <p:stCondLst>
+                                    <p:cond delay="0"/>
+                                  </p:stCondLst>
+                                  <p:childTnLst>
+                                    <p:set>
+                                      <p:cBhvr>
+                                        <p:cTn id="112" dur="1" fill="hold">
+                                          <p:stCondLst>
+                                            <p:cond delay="0"/>
+                                          </p:stCondLst>
+                                        </p:cTn>
+                                        <p:tgtEl>
+                                          <p:spTgt spid="104"/>
+                                        </p:tgtEl>
+                                        <p:attrNameLst>
+                                          <p:attrName>style.visibility</p:attrName>
+                                        </p:attrNameLst>
+                                      </p:cBhvr>
+                                      <p:to>
+                                        <p:strVal val="visible"/>
+                                      </p:to>
+                                    </p:set>
+                                  </p:childTnLst>
+                                </p:cTn>
+                              </p:par>
+                              <p:par>
+                                <p:cTn id="113" presetID="1" presetClass="entr" presetSubtype="0" fill="hold" grpId="0" nodeType="withEffect">
+                                  <p:stCondLst>
+                                    <p:cond delay="0"/>
+                                  </p:stCondLst>
+                                  <p:childTnLst>
+                                    <p:set>
+                                      <p:cBhvr>
+                                        <p:cTn id="114" dur="1" fill="hold">
+                                          <p:stCondLst>
+                                            <p:cond delay="0"/>
+                                          </p:stCondLst>
+                                        </p:cTn>
+                                        <p:tgtEl>
+                                          <p:spTgt spid="105"/>
+                                        </p:tgtEl>
+                                        <p:attrNameLst>
+                                          <p:attrName>style.visibility</p:attrName>
+                                        </p:attrNameLst>
+                                      </p:cBhvr>
+                                      <p:to>
+                                        <p:strVal val="visible"/>
+                                      </p:to>
+                                    </p:set>
+                                  </p:childTnLst>
+                                </p:cTn>
+                              </p:par>
+                              <p:par>
+                                <p:cTn id="115" presetID="1" presetClass="entr" presetSubtype="0" fill="hold" grpId="0" nodeType="withEffect">
                                   <p:stCondLst>
                                     <p:cond delay="0"/>
                                   </p:stCondLst>
@@ -40093,7 +40229,7 @@
                                           </p:stCondLst>
                                         </p:cTn>
                                         <p:tgtEl>
-                                          <p:spTgt spid="84"/>
+                                          <p:spTgt spid="106"/>
                                         </p:tgtEl>
                                         <p:attrNameLst>
                                           <p:attrName>style.visibility</p:attrName>
@@ -40120,7 +40256,7 @@
                                           </p:stCondLst>
                                         </p:cTn>
                                         <p:tgtEl>
-                                          <p:spTgt spid="87"/>
+                                          <p:spTgt spid="145"/>
                                         </p:tgtEl>
                                         <p:attrNameLst>
                                           <p:attrName>style.visibility</p:attrName>
@@ -40147,7 +40283,7 @@
                                           </p:stCondLst>
                                         </p:cTn>
                                         <p:tgtEl>
-                                          <p:spTgt spid="90"/>
+                                          <p:spTgt spid="24"/>
                                         </p:tgtEl>
                                         <p:attrNameLst>
                                           <p:attrName>style.visibility</p:attrName>
@@ -40174,312 +40310,6 @@
                                           </p:stCondLst>
                                         </p:cTn>
                                         <p:tgtEl>
-                                          <p:spTgt spid="111"/>
-                                        </p:tgtEl>
-                                        <p:attrNameLst>
-                                          <p:attrName>style.visibility</p:attrName>
-                                        </p:attrNameLst>
-                                      </p:cBhvr>
-                                      <p:to>
-                                        <p:strVal val="visible"/>
-                                      </p:to>
-                                    </p:set>
-                                  </p:childTnLst>
-                                </p:cTn>
-                              </p:par>
-                              <p:par>
-                                <p:cTn id="123" presetID="1" presetClass="entr" presetSubtype="0" fill="hold" nodeType="withEffect">
-                                  <p:stCondLst>
-                                    <p:cond delay="0"/>
-                                  </p:stCondLst>
-                                  <p:childTnLst>
-                                    <p:set>
-                                      <p:cBhvr>
-                                        <p:cTn id="124" dur="1" fill="hold">
-                                          <p:stCondLst>
-                                            <p:cond delay="0"/>
-                                          </p:stCondLst>
-                                        </p:cTn>
-                                        <p:tgtEl>
-                                          <p:spTgt spid="134"/>
-                                        </p:tgtEl>
-                                        <p:attrNameLst>
-                                          <p:attrName>style.visibility</p:attrName>
-                                        </p:attrNameLst>
-                                      </p:cBhvr>
-                                      <p:to>
-                                        <p:strVal val="visible"/>
-                                      </p:to>
-                                    </p:set>
-                                  </p:childTnLst>
-                                </p:cTn>
-                              </p:par>
-                            </p:childTnLst>
-                          </p:cTn>
-                        </p:par>
-                      </p:childTnLst>
-                    </p:cTn>
-                  </p:par>
-                  <p:par>
-                    <p:cTn id="125" fill="hold">
-                      <p:stCondLst>
-                        <p:cond delay="indefinite"/>
-                      </p:stCondLst>
-                      <p:childTnLst>
-                        <p:par>
-                          <p:cTn id="126" fill="hold">
-                            <p:stCondLst>
-                              <p:cond delay="0"/>
-                            </p:stCondLst>
-                            <p:childTnLst>
-                              <p:par>
-                                <p:cTn id="127" presetID="1" presetClass="entr" presetSubtype="0" fill="hold" grpId="0" nodeType="clickEffect">
-                                  <p:stCondLst>
-                                    <p:cond delay="0"/>
-                                  </p:stCondLst>
-                                  <p:childTnLst>
-                                    <p:set>
-                                      <p:cBhvr>
-                                        <p:cTn id="128" dur="1" fill="hold">
-                                          <p:stCondLst>
-                                            <p:cond delay="0"/>
-                                          </p:stCondLst>
-                                        </p:cTn>
-                                        <p:tgtEl>
-                                          <p:spTgt spid="102"/>
-                                        </p:tgtEl>
-                                        <p:attrNameLst>
-                                          <p:attrName>style.visibility</p:attrName>
-                                        </p:attrNameLst>
-                                      </p:cBhvr>
-                                      <p:to>
-                                        <p:strVal val="visible"/>
-                                      </p:to>
-                                    </p:set>
-                                  </p:childTnLst>
-                                </p:cTn>
-                              </p:par>
-                              <p:par>
-                                <p:cTn id="129" presetID="1" presetClass="entr" presetSubtype="0" fill="hold" nodeType="withEffect">
-                                  <p:stCondLst>
-                                    <p:cond delay="0"/>
-                                  </p:stCondLst>
-                                  <p:childTnLst>
-                                    <p:set>
-                                      <p:cBhvr>
-                                        <p:cTn id="130" dur="1" fill="hold">
-                                          <p:stCondLst>
-                                            <p:cond delay="0"/>
-                                          </p:stCondLst>
-                                        </p:cTn>
-                                        <p:tgtEl>
-                                          <p:spTgt spid="104"/>
-                                        </p:tgtEl>
-                                        <p:attrNameLst>
-                                          <p:attrName>style.visibility</p:attrName>
-                                        </p:attrNameLst>
-                                      </p:cBhvr>
-                                      <p:to>
-                                        <p:strVal val="visible"/>
-                                      </p:to>
-                                    </p:set>
-                                  </p:childTnLst>
-                                </p:cTn>
-                              </p:par>
-                              <p:par>
-                                <p:cTn id="131" presetID="1" presetClass="entr" presetSubtype="0" fill="hold" grpId="0" nodeType="withEffect">
-                                  <p:stCondLst>
-                                    <p:cond delay="0"/>
-                                  </p:stCondLst>
-                                  <p:childTnLst>
-                                    <p:set>
-                                      <p:cBhvr>
-                                        <p:cTn id="132" dur="1" fill="hold">
-                                          <p:stCondLst>
-                                            <p:cond delay="0"/>
-                                          </p:stCondLst>
-                                        </p:cTn>
-                                        <p:tgtEl>
-                                          <p:spTgt spid="105"/>
-                                        </p:tgtEl>
-                                        <p:attrNameLst>
-                                          <p:attrName>style.visibility</p:attrName>
-                                        </p:attrNameLst>
-                                      </p:cBhvr>
-                                      <p:to>
-                                        <p:strVal val="visible"/>
-                                      </p:to>
-                                    </p:set>
-                                  </p:childTnLst>
-                                </p:cTn>
-                              </p:par>
-                              <p:par>
-                                <p:cTn id="133" presetID="1" presetClass="entr" presetSubtype="0" fill="hold" grpId="0" nodeType="withEffect">
-                                  <p:stCondLst>
-                                    <p:cond delay="0"/>
-                                  </p:stCondLst>
-                                  <p:childTnLst>
-                                    <p:set>
-                                      <p:cBhvr>
-                                        <p:cTn id="134" dur="1" fill="hold">
-                                          <p:stCondLst>
-                                            <p:cond delay="0"/>
-                                          </p:stCondLst>
-                                        </p:cTn>
-                                        <p:tgtEl>
-                                          <p:spTgt spid="106"/>
-                                        </p:tgtEl>
-                                        <p:attrNameLst>
-                                          <p:attrName>style.visibility</p:attrName>
-                                        </p:attrNameLst>
-                                      </p:cBhvr>
-                                      <p:to>
-                                        <p:strVal val="visible"/>
-                                      </p:to>
-                                    </p:set>
-                                  </p:childTnLst>
-                                </p:cTn>
-                              </p:par>
-                              <p:par>
-                                <p:cTn id="135" presetID="1" presetClass="entr" presetSubtype="0" fill="hold" grpId="0" nodeType="withEffect">
-                                  <p:stCondLst>
-                                    <p:cond delay="0"/>
-                                  </p:stCondLst>
-                                  <p:childTnLst>
-                                    <p:set>
-                                      <p:cBhvr>
-                                        <p:cTn id="136" dur="1" fill="hold">
-                                          <p:stCondLst>
-                                            <p:cond delay="0"/>
-                                          </p:stCondLst>
-                                        </p:cTn>
-                                        <p:tgtEl>
-                                          <p:spTgt spid="145"/>
-                                        </p:tgtEl>
-                                        <p:attrNameLst>
-                                          <p:attrName>style.visibility</p:attrName>
-                                        </p:attrNameLst>
-                                      </p:cBhvr>
-                                      <p:to>
-                                        <p:strVal val="visible"/>
-                                      </p:to>
-                                    </p:set>
-                                  </p:childTnLst>
-                                </p:cTn>
-                              </p:par>
-                              <p:par>
-                                <p:cTn id="137" presetID="1" presetClass="entr" presetSubtype="0" fill="hold" nodeType="withEffect">
-                                  <p:stCondLst>
-                                    <p:cond delay="0"/>
-                                  </p:stCondLst>
-                                  <p:childTnLst>
-                                    <p:set>
-                                      <p:cBhvr>
-                                        <p:cTn id="138" dur="1" fill="hold">
-                                          <p:stCondLst>
-                                            <p:cond delay="0"/>
-                                          </p:stCondLst>
-                                        </p:cTn>
-                                        <p:tgtEl>
-                                          <p:spTgt spid="135"/>
-                                        </p:tgtEl>
-                                        <p:attrNameLst>
-                                          <p:attrName>style.visibility</p:attrName>
-                                        </p:attrNameLst>
-                                      </p:cBhvr>
-                                      <p:to>
-                                        <p:strVal val="visible"/>
-                                      </p:to>
-                                    </p:set>
-                                  </p:childTnLst>
-                                </p:cTn>
-                              </p:par>
-                            </p:childTnLst>
-                          </p:cTn>
-                        </p:par>
-                      </p:childTnLst>
-                    </p:cTn>
-                  </p:par>
-                  <p:par>
-                    <p:cTn id="139" fill="hold">
-                      <p:stCondLst>
-                        <p:cond delay="indefinite"/>
-                      </p:stCondLst>
-                      <p:childTnLst>
-                        <p:par>
-                          <p:cTn id="140" fill="hold">
-                            <p:stCondLst>
-                              <p:cond delay="0"/>
-                            </p:stCondLst>
-                            <p:childTnLst>
-                              <p:par>
-                                <p:cTn id="141" presetID="1" presetClass="entr" presetSubtype="0" fill="hold" nodeType="clickEffect">
-                                  <p:stCondLst>
-                                    <p:cond delay="0"/>
-                                  </p:stCondLst>
-                                  <p:childTnLst>
-                                    <p:set>
-                                      <p:cBhvr>
-                                        <p:cTn id="142" dur="1" fill="hold">
-                                          <p:stCondLst>
-                                            <p:cond delay="0"/>
-                                          </p:stCondLst>
-                                        </p:cTn>
-                                        <p:tgtEl>
-                                          <p:spTgt spid="136"/>
-                                        </p:tgtEl>
-                                        <p:attrNameLst>
-                                          <p:attrName>style.visibility</p:attrName>
-                                        </p:attrNameLst>
-                                      </p:cBhvr>
-                                      <p:to>
-                                        <p:strVal val="visible"/>
-                                      </p:to>
-                                    </p:set>
-                                  </p:childTnLst>
-                                </p:cTn>
-                              </p:par>
-                              <p:par>
-                                <p:cTn id="143" presetID="1" presetClass="entr" presetSubtype="0" fill="hold" grpId="0" nodeType="withEffect">
-                                  <p:stCondLst>
-                                    <p:cond delay="0"/>
-                                  </p:stCondLst>
-                                  <p:childTnLst>
-                                    <p:set>
-                                      <p:cBhvr>
-                                        <p:cTn id="144" dur="1" fill="hold">
-                                          <p:stCondLst>
-                                            <p:cond delay="0"/>
-                                          </p:stCondLst>
-                                        </p:cTn>
-                                        <p:tgtEl>
-                                          <p:spTgt spid="24"/>
-                                        </p:tgtEl>
-                                        <p:attrNameLst>
-                                          <p:attrName>style.visibility</p:attrName>
-                                        </p:attrNameLst>
-                                      </p:cBhvr>
-                                      <p:to>
-                                        <p:strVal val="visible"/>
-                                      </p:to>
-                                    </p:set>
-                                  </p:childTnLst>
-                                </p:cTn>
-                              </p:par>
-                              <p:par>
-                                <p:cTn id="145" presetID="1" presetClass="entr" presetSubtype="0" fill="hold" nodeType="withEffect">
-                                  <p:stCondLst>
-                                    <p:cond delay="0"/>
-                                  </p:stCondLst>
-                                  <p:childTnLst>
-                                    <p:set>
-                                      <p:cBhvr>
-                                        <p:cTn id="146" dur="1" fill="hold">
-                                          <p:stCondLst>
-                                            <p:cond delay="0"/>
-                                          </p:stCondLst>
-                                        </p:cTn>
-                                        <p:tgtEl>
                                           <p:spTgt spid="28"/>
                                         </p:tgtEl>
                                         <p:attrNameLst>
@@ -40494,14 +40324,14 @@
                                 </p:cTn>
                               </p:par>
                               <p:par>
-                                <p:cTn id="147" presetID="1" presetClass="entr" presetSubtype="0" fill="hold" grpId="0" nodeType="withEffect">
+                                <p:cTn id="123" presetID="1" presetClass="entr" presetSubtype="0" fill="hold" grpId="0" nodeType="withEffect">
                                   <p:stCondLst>
                                     <p:cond delay="0"/>
                                   </p:stCondLst>
                                   <p:childTnLst>
                                     <p:set>
                                       <p:cBhvr>
-                                        <p:cTn id="148" dur="1" fill="hold">
+                                        <p:cTn id="124" dur="1" fill="hold">
                                           <p:stCondLst>
                                             <p:cond delay="0"/>
                                           </p:stCondLst>
@@ -40577,13 +40407,13 @@
       <p:bldP spid="102" grpId="0" animBg="1"/>
       <p:bldP spid="105" grpId="0" animBg="1"/>
       <p:bldP spid="106" grpId="0" animBg="1"/>
-      <p:bldP spid="121" grpId="0" animBg="1"/>
-      <p:bldP spid="123" grpId="0"/>
-      <p:bldP spid="124" grpId="0" animBg="1"/>
       <p:bldP spid="137" grpId="0" animBg="1"/>
       <p:bldP spid="139" grpId="0"/>
       <p:bldP spid="140" grpId="0" animBg="1"/>
       <p:bldP spid="145" grpId="0"/>
+      <p:bldP spid="121" grpId="0" animBg="1"/>
+      <p:bldP spid="123" grpId="0"/>
+      <p:bldP spid="124" grpId="0" animBg="1"/>
     </p:bldLst>
   </p:timing>
 </p:sld>
@@ -40624,111 +40454,44 @@
         </p:nvSpPr>
         <p:spPr>
           <a:xfrm>
-            <a:off x="476250" y="342900"/>
-            <a:ext cx="11239500" cy="742950"/>
+            <a:off x="482461" y="346633"/>
+            <a:ext cx="11230114" cy="767605"/>
           </a:xfrm>
         </p:spPr>
         <p:txBody>
           <a:bodyPr anchor="ctr"/>
           <a:lstStyle/>
           <a:p>
-            <a:pPr algn="l">
-              <a:buNone/>
-              <a:defRPr sz="2850">
-                <a:solidFill>
-                  <a:srgbClr val="2D3F4B"/>
-                </a:solidFill>
-                <a:latin typeface="Arial"/>
-                <a:ea typeface="Arial"/>
-                <a:cs typeface="Arial"/>
-              </a:defRPr>
-            </a:pPr>
-            <a:r>
-              <a:rPr sz="2850" dirty="0" err="1">
-                <a:solidFill>
-                  <a:srgbClr val="2D3F4B"/>
-                </a:solidFill>
-                <a:latin typeface="Arial"/>
-                <a:ea typeface="Arial"/>
-                <a:cs typeface="Arial"/>
-              </a:rPr>
+            <a:r>
+              <a:rPr lang="de-DE" dirty="0" err="1"/>
               <a:t>Vom</a:t>
             </a:r>
             <a:r>
-              <a:rPr sz="2850" dirty="0">
-                <a:solidFill>
-                  <a:srgbClr val="2D3F4B"/>
-                </a:solidFill>
-                <a:latin typeface="Arial"/>
-                <a:ea typeface="Arial"/>
-                <a:cs typeface="Arial"/>
-              </a:rPr>
+              <a:rPr lang="de-DE" dirty="0"/>
               <a:t> </a:t>
             </a:r>
             <a:r>
-              <a:rPr sz="2850" dirty="0" err="1">
-                <a:solidFill>
-                  <a:srgbClr val="2D3F4B"/>
-                </a:solidFill>
-                <a:latin typeface="Arial"/>
-                <a:ea typeface="Arial"/>
-                <a:cs typeface="Arial"/>
-              </a:rPr>
+              <a:rPr lang="de-DE" dirty="0" err="1"/>
               <a:t>Modellaufruf</a:t>
             </a:r>
             <a:r>
-              <a:rPr sz="2850" dirty="0">
-                <a:solidFill>
-                  <a:srgbClr val="2D3F4B"/>
-                </a:solidFill>
-                <a:latin typeface="Arial"/>
-                <a:ea typeface="Arial"/>
-                <a:cs typeface="Arial"/>
-              </a:rPr>
+              <a:rPr lang="de-DE" dirty="0"/>
               <a:t> </a:t>
             </a:r>
             <a:r>
-              <a:rPr sz="2850" dirty="0" err="1">
-                <a:solidFill>
-                  <a:srgbClr val="2D3F4B"/>
-                </a:solidFill>
-                <a:latin typeface="Arial"/>
-                <a:ea typeface="Arial"/>
-                <a:cs typeface="Arial"/>
-              </a:rPr>
+              <a:rPr lang="de-DE" dirty="0" err="1"/>
               <a:t>zum</a:t>
             </a:r>
             <a:r>
-              <a:rPr sz="2850" dirty="0">
-                <a:solidFill>
-                  <a:srgbClr val="2D3F4B"/>
-                </a:solidFill>
-                <a:latin typeface="Arial"/>
-                <a:ea typeface="Arial"/>
-                <a:cs typeface="Arial"/>
-              </a:rPr>
+              <a:rPr lang="de-DE" dirty="0"/>
               <a:t> </a:t>
             </a:r>
             <a:r>
-              <a:rPr sz="2850" dirty="0" err="1">
-                <a:solidFill>
-                  <a:srgbClr val="2D3F4B"/>
-                </a:solidFill>
-                <a:latin typeface="Arial"/>
-                <a:ea typeface="Arial"/>
-                <a:cs typeface="Arial"/>
-              </a:rPr>
+              <a:rPr lang="de-DE" dirty="0" err="1"/>
               <a:t>messbaren</a:t>
             </a:r>
             <a:r>
-              <a:rPr sz="2850" dirty="0">
-                <a:solidFill>
-                  <a:srgbClr val="2D3F4B"/>
-                </a:solidFill>
-                <a:latin typeface="Arial"/>
-                <a:ea typeface="Arial"/>
-                <a:cs typeface="Arial"/>
-              </a:rPr>
+              <a:rPr lang="de-DE" dirty="0"/>
               <a:t> RAG</a:t>
             </a:r>
           </a:p>
@@ -40747,19 +40510,25 @@
             <a:spLocks noGrp="1"/>
           </p:cNvSpPr>
           <p:nvPr>
-            <p:ph type="dt" idx="10"/>
+            <p:ph type="dt" sz="half" idx="10"/>
           </p:nvPr>
         </p:nvSpPr>
-        <p:spPr/>
+        <p:spPr>
+          <a:xfrm>
+            <a:off x="933451" y="6359712"/>
+            <a:ext cx="616744" cy="365125"/>
+          </a:xfrm>
+        </p:spPr>
         <p:txBody>
           <a:bodyPr/>
           <a:lstStyle/>
           <a:p>
             <a:fld id="{1EB7C1D4-D1F3-40CB-8780-B2B6A9133392}" type="datetime1">
               <a:rPr lang="de-DE"/>
+              <a:pPr/>
               <a:t>07.08.2026</a:t>
             </a:fld>
-            <a:endParaRPr dirty="0"/>
+            <a:endParaRPr lang="de-DE" dirty="0"/>
           </a:p>
         </p:txBody>
       </p:sp>
@@ -40776,19 +40545,50 @@
             <a:spLocks noGrp="1"/>
           </p:cNvSpPr>
           <p:nvPr>
-            <p:ph type="sldNum" idx="12"/>
+            <p:ph type="sldNum" sz="quarter" idx="12"/>
           </p:nvPr>
         </p:nvSpPr>
-        <p:spPr/>
+        <p:spPr>
+          <a:xfrm>
+            <a:off x="482461" y="6359712"/>
+            <a:ext cx="415270" cy="365125"/>
+          </a:xfrm>
+        </p:spPr>
         <p:txBody>
           <a:bodyPr/>
           <a:lstStyle/>
           <a:p>
             <a:fld id="{CE7E00E2-F08D-429A-AD9B-1ECBEC02F4DB}" type="slidenum">
-              <a:rPr/>
+              <a:rPr lang="de-CH"/>
+              <a:pPr/>
               <a:t>8</a:t>
             </a:fld>
-            <a:endParaRPr/>
+            <a:endParaRPr lang="de-CH"/>
+          </a:p>
+        </p:txBody>
+      </p:sp>
+      <p:sp>
+        <p:nvSpPr>
+          <p:cNvPr id="32" name="Inhaltsplatzhalter 31">
+            <a:extLst>
+              <a:ext uri="{FF2B5EF4-FFF2-40B4-BE49-F238E27FC236}">
+                <a16:creationId xmlns:a16="http://schemas.microsoft.com/office/drawing/2014/main" id="{639B734F-7133-C9E6-4712-911C81C98AFD}"/>
+              </a:ext>
+            </a:extLst>
+          </p:cNvPr>
+          <p:cNvSpPr>
+            <a:spLocks noGrp="1"/>
+          </p:cNvSpPr>
+          <p:nvPr>
+            <p:ph sz="quarter" idx="13"/>
+          </p:nvPr>
+        </p:nvSpPr>
+        <p:spPr/>
+        <p:txBody>
+          <a:bodyPr/>
+          <a:lstStyle/>
+          <a:p>
+            <a:endParaRPr lang="de-CH"/>
           </a:p>
         </p:txBody>
       </p:sp>

</xml_diff>

<commit_message>
Group and align the diagram boxes on slide 7
Wrap each rounded box of the Vector-RAG diagram into one group with its
label, divider and icon (13 groups, found geometrically). Centre every
icon horizontally in its box and make the title dividers exactly
horizontal at box width. Arrows between boxes and the free Context label
stay ungrouped.

Co-Authored-By: Claude Fable 5 <noreply@anthropic.com>
Claude-Session: https://claude.ai/code/session_01S2kGP2buE2HmxMttD3XczR
</commit_message>
<xml_diff>
--- a/RAG_Workshop.pptx
+++ b/RAG_Workshop.pptx
@@ -35626,1856 +35626,2051 @@
           </a:p>
         </p:txBody>
       </p:sp>
-      <p:sp>
-        <p:nvSpPr>
-          <p:cNvPr id="10" name="Rechteck: abgerundete Ecken 9">
-            <a:extLst>
-              <a:ext uri="{FF2B5EF4-FFF2-40B4-BE49-F238E27FC236}">
-                <a16:creationId xmlns:a16="http://schemas.microsoft.com/office/drawing/2014/main" id="{B38993B1-D63F-B962-E43D-16CB3FBB6F39}"/>
-              </a:ext>
-            </a:extLst>
-          </p:cNvPr>
-          <p:cNvSpPr>
-            <a:spLocks/>
-          </p:cNvSpPr>
+      <p:grpSp>
+        <p:nvGrpSpPr>
+          <p:cNvPr id="146" name="Gruppe Raw Data Files"/>
+          <p:cNvGrpSpPr/>
           <p:nvPr/>
-        </p:nvSpPr>
-        <p:spPr>
-          <a:xfrm>
-            <a:off x="714375" y="5143500"/>
-            <a:ext cx="1259680" cy="866775"/>
-          </a:xfrm>
-          <a:prstGeom prst="roundRect">
-            <a:avLst/>
-          </a:prstGeom>
-          <a:solidFill>
-            <a:schemeClr val="accent2"/>
-          </a:solidFill>
-          <a:ln>
+        </p:nvGrpSpPr>
+        <p:grpSpPr>
+          <a:xfrm>
+            <a:off x="701754" y="5143500"/>
+            <a:ext cx="1272301" cy="866775"/>
+            <a:chOff x="701754" y="5143500"/>
+            <a:chExt cx="1272301" cy="866775"/>
+          </a:xfrm>
+        </p:grpSpPr>
+        <p:sp>
+          <p:nvSpPr>
+            <p:cNvPr id="10" name="Rechteck: abgerundete Ecken 9">
+              <a:extLst>
+                <a:ext uri="{FF2B5EF4-FFF2-40B4-BE49-F238E27FC236}">
+                  <a16:creationId xmlns:a16="http://schemas.microsoft.com/office/drawing/2014/main" id="{B38993B1-D63F-B962-E43D-16CB3FBB6F39}"/>
+                </a:ext>
+              </a:extLst>
+            </p:cNvPr>
+            <p:cNvSpPr>
+              <a:spLocks/>
+            </p:cNvSpPr>
+            <p:nvPr/>
+          </p:nvSpPr>
+          <p:spPr>
+            <a:xfrm>
+              <a:off x="714375" y="5143500"/>
+              <a:ext cx="1259680" cy="866775"/>
+            </a:xfrm>
+            <a:prstGeom prst="roundRect">
+              <a:avLst/>
+            </a:prstGeom>
             <a:solidFill>
-              <a:schemeClr val="accent3"/>
+              <a:schemeClr val="accent2"/>
             </a:solidFill>
-          </a:ln>
-        </p:spPr>
-        <p:style>
-          <a:lnRef idx="2">
-            <a:schemeClr val="accent1">
-              <a:shade val="15000"/>
-            </a:schemeClr>
-          </a:lnRef>
-          <a:fillRef idx="1">
-            <a:schemeClr val="accent1"/>
-          </a:fillRef>
-          <a:effectRef idx="0">
-            <a:schemeClr val="accent1"/>
-          </a:effectRef>
-          <a:fontRef idx="minor">
-            <a:schemeClr val="lt1"/>
-          </a:fontRef>
-        </p:style>
-        <p:txBody>
-          <a:bodyPr anchor="ctr"/>
-          <a:lstStyle/>
-          <a:p>
-            <a:pPr algn="ctr">
-              <a:buNone/>
-            </a:pPr>
-            <a:endParaRPr/>
-          </a:p>
-        </p:txBody>
-      </p:sp>
-      <p:sp>
-        <p:nvSpPr>
-          <p:cNvPr id="12" name="Textfeld 74">
-            <a:extLst>
-              <a:ext uri="{FF2B5EF4-FFF2-40B4-BE49-F238E27FC236}">
-                <a16:creationId xmlns:a16="http://schemas.microsoft.com/office/drawing/2014/main" id="{DECF3306-686E-CFF1-9A40-27FB67140A18}"/>
-              </a:ext>
-            </a:extLst>
-          </p:cNvPr>
-          <p:cNvSpPr>
-            <a:spLocks/>
-          </p:cNvSpPr>
+            <a:ln>
+              <a:solidFill>
+                <a:schemeClr val="accent3"/>
+              </a:solidFill>
+            </a:ln>
+          </p:spPr>
+          <p:style>
+            <a:lnRef idx="2">
+              <a:schemeClr val="accent1">
+                <a:shade val="15000"/>
+              </a:schemeClr>
+            </a:lnRef>
+            <a:fillRef idx="1">
+              <a:schemeClr val="accent1"/>
+            </a:fillRef>
+            <a:effectRef idx="0">
+              <a:schemeClr val="accent1"/>
+            </a:effectRef>
+            <a:fontRef idx="minor">
+              <a:schemeClr val="lt1"/>
+            </a:fontRef>
+          </p:style>
+          <p:txBody>
+            <a:bodyPr anchor="ctr"/>
+            <a:lstStyle/>
+            <a:p>
+              <a:pPr algn="ctr">
+                <a:buNone/>
+              </a:pPr>
+              <a:endParaRPr/>
+            </a:p>
+          </p:txBody>
+        </p:sp>
+        <p:sp>
+          <p:nvSpPr>
+            <p:cNvPr id="12" name="Textfeld 74">
+              <a:extLst>
+                <a:ext uri="{FF2B5EF4-FFF2-40B4-BE49-F238E27FC236}">
+                  <a16:creationId xmlns:a16="http://schemas.microsoft.com/office/drawing/2014/main" id="{DECF3306-686E-CFF1-9A40-27FB67140A18}"/>
+                </a:ext>
+              </a:extLst>
+            </p:cNvPr>
+            <p:cNvSpPr>
+              <a:spLocks/>
+            </p:cNvSpPr>
+            <p:nvPr/>
+          </p:nvSpPr>
+          <p:spPr>
+            <a:xfrm>
+              <a:off x="701754" y="5162179"/>
+              <a:ext cx="1259680" cy="276999"/>
+            </a:xfrm>
+            <a:prstGeom prst="rect">
+              <a:avLst/>
+            </a:prstGeom>
+            <a:noFill/>
+          </p:spPr>
+          <p:txBody>
+            <a:bodyPr wrap="square">
+              <a:spAutoFit/>
+            </a:bodyPr>
+            <a:lstStyle/>
+            <a:p>
+              <a:pPr algn="ctr">
+                <a:buNone/>
+              </a:pPr>
+              <a:r>
+                <a:rPr sz="1200"/>
+                <a:t>Raw Data Files</a:t>
+              </a:r>
+            </a:p>
+          </p:txBody>
+        </p:sp>
+        <p:sp>
+          <p:nvSpPr>
+            <p:cNvPr id="14" name="Gerader Verbinder 13">
+              <a:extLst>
+                <a:ext uri="{FF2B5EF4-FFF2-40B4-BE49-F238E27FC236}">
+                  <a16:creationId xmlns:a16="http://schemas.microsoft.com/office/drawing/2014/main" id="{CD93CF7F-4061-47BC-D2DF-7546F2E82AED}"/>
+                </a:ext>
+              </a:extLst>
+            </p:cNvPr>
+            <p:cNvSpPr>
+              <a:spLocks/>
+            </p:cNvSpPr>
+            <p:nvPr/>
+          </p:nvSpPr>
+          <p:spPr>
+            <a:xfrm>
+              <a:off x="714375" y="5439178"/>
+              <a:ext cx="1259680" cy="0"/>
+            </a:xfrm>
+            <a:prstGeom prst="line">
+              <a:avLst/>
+            </a:prstGeom>
+            <a:ln>
+              <a:solidFill>
+                <a:schemeClr val="accent3"/>
+              </a:solidFill>
+            </a:ln>
+          </p:spPr>
+          <p:style>
+            <a:lnRef idx="1">
+              <a:schemeClr val="accent1"/>
+            </a:lnRef>
+            <a:fillRef idx="0">
+              <a:schemeClr val="accent1"/>
+            </a:fillRef>
+            <a:effectRef idx="0">
+              <a:schemeClr val="accent1"/>
+            </a:effectRef>
+            <a:fontRef idx="minor">
+              <a:schemeClr val="tx1"/>
+            </a:fontRef>
+          </p:style>
+          <p:txBody>
+            <a:bodyPr/>
+            <a:lstStyle/>
+            <a:p>
+              <a:endParaRPr lang="de-CH"/>
+            </a:p>
+          </p:txBody>
+        </p:sp>
+        <p:pic>
+          <p:nvPicPr>
+            <p:cNvPr id="16" name="Inhaltsplatzhalter 6">
+              <a:extLst>
+                <a:ext uri="{FF2B5EF4-FFF2-40B4-BE49-F238E27FC236}">
+                  <a16:creationId xmlns:a16="http://schemas.microsoft.com/office/drawing/2014/main" id="{A13C77ED-349F-9371-0221-46DB832630CD}"/>
+                </a:ext>
+              </a:extLst>
+            </p:cNvPr>
+            <p:cNvPicPr>
+              <a:picLocks noChangeAspect="1"/>
+            </p:cNvPicPr>
+            <p:nvPr/>
+          </p:nvPicPr>
+          <p:blipFill>
+            <a:blip r:embed="rId3"/>
+            <a:stretch>
+              <a:fillRect/>
+            </a:stretch>
+          </p:blipFill>
+          <p:spPr>
+            <a:xfrm flipH="1">
+              <a:off x="1136680" y="5503383"/>
+              <a:ext cx="415070" cy="480063"/>
+            </a:xfrm>
+            <a:prstGeom prst="rect">
+              <a:avLst/>
+            </a:prstGeom>
+          </p:spPr>
+        </p:pic>
+      </p:grpSp>
+      <p:grpSp>
+        <p:nvGrpSpPr>
+          <p:cNvPr id="147" name="Gruppe Query"/>
+          <p:cNvGrpSpPr/>
           <p:nvPr/>
-        </p:nvSpPr>
-        <p:spPr>
-          <a:xfrm>
-            <a:off x="701754" y="5162179"/>
-            <a:ext cx="1259680" cy="276999"/>
-          </a:xfrm>
-          <a:prstGeom prst="rect">
-            <a:avLst/>
-          </a:prstGeom>
-          <a:noFill/>
-        </p:spPr>
-        <p:txBody>
-          <a:bodyPr wrap="square">
-            <a:spAutoFit/>
-          </a:bodyPr>
-          <a:lstStyle/>
-          <a:p>
-            <a:pPr algn="ctr">
-              <a:buNone/>
-            </a:pPr>
-            <a:r>
-              <a:rPr sz="1200"/>
-              <a:t>Raw Data Files</a:t>
-            </a:r>
-          </a:p>
-        </p:txBody>
-      </p:sp>
-      <p:sp>
-        <p:nvSpPr>
-          <p:cNvPr id="14" name="Gerader Verbinder 13">
-            <a:extLst>
-              <a:ext uri="{FF2B5EF4-FFF2-40B4-BE49-F238E27FC236}">
-                <a16:creationId xmlns:a16="http://schemas.microsoft.com/office/drawing/2014/main" id="{CD93CF7F-4061-47BC-D2DF-7546F2E82AED}"/>
-              </a:ext>
-            </a:extLst>
-          </p:cNvPr>
-          <p:cNvSpPr>
-            <a:spLocks/>
-          </p:cNvSpPr>
+        </p:nvGrpSpPr>
+        <p:grpSpPr>
+          <a:xfrm>
+            <a:off x="10274379" y="1571625"/>
+            <a:ext cx="1272301" cy="866775"/>
+            <a:chOff x="10274379" y="1571625"/>
+            <a:chExt cx="1272301" cy="866775"/>
+          </a:xfrm>
+        </p:grpSpPr>
+        <p:sp>
+          <p:nvSpPr>
+            <p:cNvPr id="18" name="Rechteck: abgerundete Ecken 17">
+              <a:extLst>
+                <a:ext uri="{FF2B5EF4-FFF2-40B4-BE49-F238E27FC236}">
+                  <a16:creationId xmlns:a16="http://schemas.microsoft.com/office/drawing/2014/main" id="{D9E7FE46-B6BE-8721-269A-6415AA075AA3}"/>
+                </a:ext>
+              </a:extLst>
+            </p:cNvPr>
+            <p:cNvSpPr>
+              <a:spLocks/>
+            </p:cNvSpPr>
+            <p:nvPr/>
+          </p:nvSpPr>
+          <p:spPr>
+            <a:xfrm>
+              <a:off x="10287000" y="1571625"/>
+              <a:ext cx="1259680" cy="866775"/>
+            </a:xfrm>
+            <a:prstGeom prst="roundRect">
+              <a:avLst/>
+            </a:prstGeom>
+            <a:solidFill>
+              <a:schemeClr val="accent1"/>
+            </a:solidFill>
+            <a:ln>
+              <a:solidFill>
+                <a:schemeClr val="tx1"/>
+              </a:solidFill>
+            </a:ln>
+          </p:spPr>
+          <p:style>
+            <a:lnRef idx="2">
+              <a:schemeClr val="accent1">
+                <a:shade val="15000"/>
+              </a:schemeClr>
+            </a:lnRef>
+            <a:fillRef idx="1">
+              <a:schemeClr val="accent1"/>
+            </a:fillRef>
+            <a:effectRef idx="0">
+              <a:schemeClr val="accent1"/>
+            </a:effectRef>
+            <a:fontRef idx="minor">
+              <a:schemeClr val="lt1"/>
+            </a:fontRef>
+          </p:style>
+          <p:txBody>
+            <a:bodyPr anchor="ctr"/>
+            <a:lstStyle/>
+            <a:p>
+              <a:pPr algn="ctr">
+                <a:buNone/>
+              </a:pPr>
+              <a:endParaRPr/>
+            </a:p>
+          </p:txBody>
+        </p:sp>
+        <p:pic>
+          <p:nvPicPr>
+            <p:cNvPr id="20" name="Grafik 16">
+              <a:extLst>
+                <a:ext uri="{FF2B5EF4-FFF2-40B4-BE49-F238E27FC236}">
+                  <a16:creationId xmlns:a16="http://schemas.microsoft.com/office/drawing/2014/main" id="{3FD27254-6A1A-1764-0C62-B715418317A1}"/>
+                </a:ext>
+              </a:extLst>
+            </p:cNvPr>
+            <p:cNvPicPr>
+              <a:picLocks noChangeAspect="1"/>
+            </p:cNvPicPr>
+            <p:nvPr/>
+          </p:nvPicPr>
+          <p:blipFill>
+            <a:blip r:embed="rId4"/>
+            <a:stretch>
+              <a:fillRect/>
+            </a:stretch>
+          </p:blipFill>
+          <p:spPr>
+            <a:xfrm>
+              <a:off x="10611908" y="1867303"/>
+              <a:ext cx="609864" cy="566720"/>
+            </a:xfrm>
+            <a:prstGeom prst="rect">
+              <a:avLst/>
+            </a:prstGeom>
+          </p:spPr>
+        </p:pic>
+        <p:sp>
+          <p:nvSpPr>
+            <p:cNvPr id="22" name="Textfeld 51">
+              <a:extLst>
+                <a:ext uri="{FF2B5EF4-FFF2-40B4-BE49-F238E27FC236}">
+                  <a16:creationId xmlns:a16="http://schemas.microsoft.com/office/drawing/2014/main" id="{E9B671B8-ADBD-7C77-A761-7D4C7F8DC77F}"/>
+                </a:ext>
+              </a:extLst>
+            </p:cNvPr>
+            <p:cNvSpPr>
+              <a:spLocks/>
+            </p:cNvSpPr>
+            <p:nvPr/>
+          </p:nvSpPr>
+          <p:spPr>
+            <a:xfrm>
+              <a:off x="10274379" y="1590304"/>
+              <a:ext cx="1259680" cy="276999"/>
+            </a:xfrm>
+            <a:prstGeom prst="rect">
+              <a:avLst/>
+            </a:prstGeom>
+            <a:noFill/>
+          </p:spPr>
+          <p:txBody>
+            <a:bodyPr wrap="square">
+              <a:spAutoFit/>
+            </a:bodyPr>
+            <a:lstStyle/>
+            <a:p>
+              <a:pPr algn="ctr">
+                <a:buNone/>
+              </a:pPr>
+              <a:r>
+                <a:rPr sz="1200">
+                  <a:solidFill>
+                    <a:schemeClr val="bg1"/>
+                  </a:solidFill>
+                </a:rPr>
+                <a:t>Query</a:t>
+              </a:r>
+            </a:p>
+          </p:txBody>
+        </p:sp>
+      </p:grpSp>
+      <p:grpSp>
+        <p:nvGrpSpPr>
+          <p:cNvPr id="148" name="Gruppe Response"/>
+          <p:cNvGrpSpPr/>
           <p:nvPr/>
-        </p:nvSpPr>
-        <p:spPr>
-          <a:xfrm>
-            <a:off x="714375" y="5439178"/>
-            <a:ext cx="1259680" cy="0"/>
-          </a:xfrm>
-          <a:prstGeom prst="line">
-            <a:avLst/>
-          </a:prstGeom>
-          <a:ln>
+        </p:nvGrpSpPr>
+        <p:grpSpPr>
+          <a:xfrm>
+            <a:off x="10274379" y="5162179"/>
+            <a:ext cx="1272301" cy="866775"/>
+            <a:chOff x="10274379" y="5162179"/>
+            <a:chExt cx="1272301" cy="866775"/>
+          </a:xfrm>
+        </p:grpSpPr>
+        <p:sp>
+          <p:nvSpPr>
+            <p:cNvPr id="24" name="Rechteck: abgerundete Ecken 23">
+              <a:extLst>
+                <a:ext uri="{FF2B5EF4-FFF2-40B4-BE49-F238E27FC236}">
+                  <a16:creationId xmlns:a16="http://schemas.microsoft.com/office/drawing/2014/main" id="{EF7C69F7-3BA6-3716-FB87-C6056C54CA0B}"/>
+                </a:ext>
+              </a:extLst>
+            </p:cNvPr>
+            <p:cNvSpPr>
+              <a:spLocks/>
+            </p:cNvSpPr>
+            <p:nvPr/>
+          </p:nvSpPr>
+          <p:spPr>
+            <a:xfrm>
+              <a:off x="10287000" y="5162179"/>
+              <a:ext cx="1259680" cy="866775"/>
+            </a:xfrm>
+            <a:prstGeom prst="roundRect">
+              <a:avLst/>
+            </a:prstGeom>
             <a:solidFill>
-              <a:schemeClr val="accent3"/>
+              <a:schemeClr val="accent5"/>
             </a:solidFill>
-          </a:ln>
-        </p:spPr>
-        <p:style>
-          <a:lnRef idx="1">
-            <a:schemeClr val="accent1"/>
-          </a:lnRef>
-          <a:fillRef idx="0">
-            <a:schemeClr val="accent1"/>
-          </a:fillRef>
-          <a:effectRef idx="0">
-            <a:schemeClr val="accent1"/>
-          </a:effectRef>
-          <a:fontRef idx="minor">
-            <a:schemeClr val="tx1"/>
-          </a:fontRef>
-        </p:style>
-        <p:txBody>
-          <a:bodyPr/>
-          <a:lstStyle/>
-          <a:p>
-            <a:endParaRPr lang="de-CH"/>
-          </a:p>
-        </p:txBody>
-      </p:sp>
-      <p:pic>
-        <p:nvPicPr>
-          <p:cNvPr id="16" name="Inhaltsplatzhalter 6">
-            <a:extLst>
-              <a:ext uri="{FF2B5EF4-FFF2-40B4-BE49-F238E27FC236}">
-                <a16:creationId xmlns:a16="http://schemas.microsoft.com/office/drawing/2014/main" id="{A13C77ED-349F-9371-0221-46DB832630CD}"/>
-              </a:ext>
-            </a:extLst>
-          </p:cNvPr>
-          <p:cNvPicPr>
-            <a:picLocks noChangeAspect="1"/>
-          </p:cNvPicPr>
+            <a:ln>
+              <a:solidFill>
+                <a:schemeClr val="tx1"/>
+              </a:solidFill>
+            </a:ln>
+          </p:spPr>
+          <p:style>
+            <a:lnRef idx="2">
+              <a:schemeClr val="accent1">
+                <a:shade val="15000"/>
+              </a:schemeClr>
+            </a:lnRef>
+            <a:fillRef idx="1">
+              <a:schemeClr val="accent1"/>
+            </a:fillRef>
+            <a:effectRef idx="0">
+              <a:schemeClr val="accent1"/>
+            </a:effectRef>
+            <a:fontRef idx="minor">
+              <a:schemeClr val="lt1"/>
+            </a:fontRef>
+          </p:style>
+          <p:txBody>
+            <a:bodyPr anchor="ctr"/>
+            <a:lstStyle/>
+            <a:p>
+              <a:pPr algn="ctr">
+                <a:buNone/>
+              </a:pPr>
+              <a:endParaRPr/>
+            </a:p>
+          </p:txBody>
+        </p:sp>
+        <p:pic>
+          <p:nvPicPr>
+            <p:cNvPr id="28" name="Grafik 22">
+              <a:extLst>
+                <a:ext uri="{FF2B5EF4-FFF2-40B4-BE49-F238E27FC236}">
+                  <a16:creationId xmlns:a16="http://schemas.microsoft.com/office/drawing/2014/main" id="{8C3ACE01-CA21-EEDC-1F98-9D084AF04C23}"/>
+                </a:ext>
+              </a:extLst>
+            </p:cNvPr>
+            <p:cNvPicPr>
+              <a:picLocks noChangeAspect="1"/>
+            </p:cNvPicPr>
+            <p:nvPr/>
+          </p:nvPicPr>
+          <p:blipFill>
+            <a:blip r:embed="rId5"/>
+            <a:stretch>
+              <a:fillRect/>
+            </a:stretch>
+          </p:blipFill>
+          <p:spPr>
+            <a:xfrm flipH="1">
+              <a:off x="10609408" y="5445851"/>
+              <a:ext cx="614864" cy="571508"/>
+            </a:xfrm>
+            <a:prstGeom prst="rect">
+              <a:avLst/>
+            </a:prstGeom>
+          </p:spPr>
+        </p:pic>
+        <p:sp>
+          <p:nvSpPr>
+            <p:cNvPr id="31" name="Textfeld 54">
+              <a:extLst>
+                <a:ext uri="{FF2B5EF4-FFF2-40B4-BE49-F238E27FC236}">
+                  <a16:creationId xmlns:a16="http://schemas.microsoft.com/office/drawing/2014/main" id="{D4C33B49-7891-AAA7-51F9-90B1FAAF4FA6}"/>
+                </a:ext>
+              </a:extLst>
+            </p:cNvPr>
+            <p:cNvSpPr>
+              <a:spLocks/>
+            </p:cNvSpPr>
+            <p:nvPr/>
+          </p:nvSpPr>
+          <p:spPr>
+            <a:xfrm>
+              <a:off x="10274379" y="5180858"/>
+              <a:ext cx="1259680" cy="276999"/>
+            </a:xfrm>
+            <a:prstGeom prst="rect">
+              <a:avLst/>
+            </a:prstGeom>
+            <a:noFill/>
+          </p:spPr>
+          <p:txBody>
+            <a:bodyPr wrap="square">
+              <a:spAutoFit/>
+            </a:bodyPr>
+            <a:lstStyle/>
+            <a:p>
+              <a:pPr algn="ctr">
+                <a:buNone/>
+              </a:pPr>
+              <a:r>
+                <a:rPr sz="1200">
+                  <a:solidFill>
+                    <a:schemeClr val="bg1"/>
+                  </a:solidFill>
+                </a:rPr>
+                <a:t>Response</a:t>
+              </a:r>
+            </a:p>
+          </p:txBody>
+        </p:sp>
+      </p:grpSp>
+      <p:grpSp>
+        <p:nvGrpSpPr>
+          <p:cNvPr id="149" name="Gruppe Information Extraction"/>
+          <p:cNvGrpSpPr/>
           <p:nvPr/>
-        </p:nvPicPr>
-        <p:blipFill>
-          <a:blip r:embed="rId3"/>
-          <a:stretch>
-            <a:fillRect/>
-          </a:stretch>
-        </p:blipFill>
-        <p:spPr>
-          <a:xfrm flipH="1">
-            <a:off x="1133584" y="5503383"/>
-            <a:ext cx="415070" cy="480063"/>
-          </a:xfrm>
-          <a:prstGeom prst="rect">
-            <a:avLst/>
-          </a:prstGeom>
-        </p:spPr>
-      </p:pic>
-      <p:sp>
-        <p:nvSpPr>
-          <p:cNvPr id="18" name="Rechteck: abgerundete Ecken 17">
-            <a:extLst>
-              <a:ext uri="{FF2B5EF4-FFF2-40B4-BE49-F238E27FC236}">
-                <a16:creationId xmlns:a16="http://schemas.microsoft.com/office/drawing/2014/main" id="{D9E7FE46-B6BE-8721-269A-6415AA075AA3}"/>
-              </a:ext>
-            </a:extLst>
-          </p:cNvPr>
-          <p:cNvSpPr>
-            <a:spLocks/>
-          </p:cNvSpPr>
+        </p:nvGrpSpPr>
+        <p:grpSpPr>
+          <a:xfrm>
+            <a:off x="501206" y="3952875"/>
+            <a:ext cx="1733633" cy="866775"/>
+            <a:chOff x="501206" y="3952875"/>
+            <a:chExt cx="1733633" cy="866775"/>
+          </a:xfrm>
+        </p:grpSpPr>
+        <p:sp>
+          <p:nvSpPr>
+            <p:cNvPr id="37" name="Rechteck: abgerundete Ecken 36">
+              <a:extLst>
+                <a:ext uri="{FF2B5EF4-FFF2-40B4-BE49-F238E27FC236}">
+                  <a16:creationId xmlns:a16="http://schemas.microsoft.com/office/drawing/2014/main" id="{955C229C-DF37-3394-7852-D2530C311E3D}"/>
+                </a:ext>
+              </a:extLst>
+            </p:cNvPr>
+            <p:cNvSpPr>
+              <a:spLocks/>
+            </p:cNvSpPr>
+            <p:nvPr/>
+          </p:nvSpPr>
+          <p:spPr>
+            <a:xfrm>
+              <a:off x="513827" y="3952875"/>
+              <a:ext cx="1658163" cy="866775"/>
+            </a:xfrm>
+            <a:prstGeom prst="roundRect">
+              <a:avLst/>
+            </a:prstGeom>
+            <a:solidFill>
+              <a:schemeClr val="accent2"/>
+            </a:solidFill>
+            <a:ln>
+              <a:solidFill>
+                <a:schemeClr val="accent3"/>
+              </a:solidFill>
+            </a:ln>
+          </p:spPr>
+          <p:style>
+            <a:lnRef idx="2">
+              <a:schemeClr val="accent1">
+                <a:shade val="15000"/>
+              </a:schemeClr>
+            </a:lnRef>
+            <a:fillRef idx="1">
+              <a:schemeClr val="accent1"/>
+            </a:fillRef>
+            <a:effectRef idx="0">
+              <a:schemeClr val="accent1"/>
+            </a:effectRef>
+            <a:fontRef idx="minor">
+              <a:schemeClr val="lt1"/>
+            </a:fontRef>
+          </p:style>
+          <p:txBody>
+            <a:bodyPr anchor="ctr"/>
+            <a:lstStyle/>
+            <a:p>
+              <a:pPr algn="ctr">
+                <a:buNone/>
+              </a:pPr>
+              <a:endParaRPr/>
+            </a:p>
+          </p:txBody>
+        </p:sp>
+        <p:pic>
+          <p:nvPicPr>
+            <p:cNvPr id="42" name="Grafik 8">
+              <a:extLst>
+                <a:ext uri="{FF2B5EF4-FFF2-40B4-BE49-F238E27FC236}">
+                  <a16:creationId xmlns:a16="http://schemas.microsoft.com/office/drawing/2014/main" id="{8D120EA8-E27A-D0DD-C5B0-F34B5211FE48}"/>
+                </a:ext>
+              </a:extLst>
+            </p:cNvPr>
+            <p:cNvPicPr>
+              <a:picLocks noChangeAspect="1"/>
+            </p:cNvPicPr>
+            <p:nvPr/>
+          </p:nvPicPr>
+          <p:blipFill>
+            <a:blip r:embed="rId6"/>
+            <a:stretch>
+              <a:fillRect/>
+            </a:stretch>
+          </p:blipFill>
+          <p:spPr>
+            <a:xfrm flipH="1">
+              <a:off x="1109228" y="4248553"/>
+              <a:ext cx="467360" cy="559581"/>
+            </a:xfrm>
+            <a:prstGeom prst="rect">
+              <a:avLst/>
+            </a:prstGeom>
+          </p:spPr>
+        </p:pic>
+        <p:sp>
+          <p:nvSpPr>
+            <p:cNvPr id="43" name="Textfeld 48">
+              <a:extLst>
+                <a:ext uri="{FF2B5EF4-FFF2-40B4-BE49-F238E27FC236}">
+                  <a16:creationId xmlns:a16="http://schemas.microsoft.com/office/drawing/2014/main" id="{2441BB71-C515-3F41-6A7B-CFE04B47BE00}"/>
+                </a:ext>
+              </a:extLst>
+            </p:cNvPr>
+            <p:cNvSpPr>
+              <a:spLocks/>
+            </p:cNvSpPr>
+            <p:nvPr/>
+          </p:nvSpPr>
+          <p:spPr>
+            <a:xfrm>
+              <a:off x="501206" y="3971554"/>
+              <a:ext cx="1733633" cy="276999"/>
+            </a:xfrm>
+            <a:prstGeom prst="rect">
+              <a:avLst/>
+            </a:prstGeom>
+            <a:noFill/>
+          </p:spPr>
+          <p:txBody>
+            <a:bodyPr wrap="square">
+              <a:spAutoFit/>
+            </a:bodyPr>
+            <a:lstStyle/>
+            <a:p>
+              <a:pPr algn="ctr">
+                <a:buNone/>
+              </a:pPr>
+              <a:r>
+                <a:rPr sz="1200"/>
+                <a:t>Information Extraction</a:t>
+              </a:r>
+            </a:p>
+          </p:txBody>
+        </p:sp>
+        <p:sp>
+          <p:nvSpPr>
+            <p:cNvPr id="44" name="Gerader Verbinder 43">
+              <a:extLst>
+                <a:ext uri="{FF2B5EF4-FFF2-40B4-BE49-F238E27FC236}">
+                  <a16:creationId xmlns:a16="http://schemas.microsoft.com/office/drawing/2014/main" id="{6BF87FBA-FFD4-A870-8990-3B36EDECACE0}"/>
+                </a:ext>
+              </a:extLst>
+            </p:cNvPr>
+            <p:cNvSpPr>
+              <a:spLocks/>
+            </p:cNvSpPr>
+            <p:nvPr/>
+          </p:nvSpPr>
+          <p:spPr>
+            <a:xfrm>
+              <a:off x="513827" y="4248553"/>
+              <a:ext cx="1658163" cy="0"/>
+            </a:xfrm>
+            <a:prstGeom prst="line">
+              <a:avLst/>
+            </a:prstGeom>
+            <a:ln>
+              <a:solidFill>
+                <a:schemeClr val="accent3"/>
+              </a:solidFill>
+            </a:ln>
+          </p:spPr>
+          <p:style>
+            <a:lnRef idx="1">
+              <a:schemeClr val="accent1"/>
+            </a:lnRef>
+            <a:fillRef idx="0">
+              <a:schemeClr val="accent1"/>
+            </a:fillRef>
+            <a:effectRef idx="0">
+              <a:schemeClr val="accent1"/>
+            </a:effectRef>
+            <a:fontRef idx="minor">
+              <a:schemeClr val="tx1"/>
+            </a:fontRef>
+          </p:style>
+          <p:txBody>
+            <a:bodyPr/>
+            <a:lstStyle/>
+            <a:p>
+              <a:endParaRPr lang="de-CH"/>
+            </a:p>
+          </p:txBody>
+        </p:sp>
+      </p:grpSp>
+      <p:grpSp>
+        <p:nvGrpSpPr>
+          <p:cNvPr id="150" name="Gruppe Chunking"/>
+          <p:cNvGrpSpPr/>
           <p:nvPr/>
-        </p:nvSpPr>
-        <p:spPr>
-          <a:xfrm>
-            <a:off x="10287000" y="1571625"/>
-            <a:ext cx="1259680" cy="866775"/>
-          </a:xfrm>
-          <a:prstGeom prst="roundRect">
-            <a:avLst/>
-          </a:prstGeom>
-          <a:solidFill>
-            <a:schemeClr val="accent1"/>
-          </a:solidFill>
-          <a:ln>
+        </p:nvGrpSpPr>
+        <p:grpSpPr>
+          <a:xfrm>
+            <a:off x="701754" y="2762250"/>
+            <a:ext cx="1272301" cy="866775"/>
+            <a:chOff x="701754" y="2762250"/>
+            <a:chExt cx="1272301" cy="866775"/>
+          </a:xfrm>
+        </p:grpSpPr>
+        <p:sp>
+          <p:nvSpPr>
+            <p:cNvPr id="45" name="Rechteck: abgerundete Ecken 44">
+              <a:extLst>
+                <a:ext uri="{FF2B5EF4-FFF2-40B4-BE49-F238E27FC236}">
+                  <a16:creationId xmlns:a16="http://schemas.microsoft.com/office/drawing/2014/main" id="{D48A7F4F-BE6B-CD6F-E690-688E3245F2C5}"/>
+                </a:ext>
+              </a:extLst>
+            </p:cNvPr>
+            <p:cNvSpPr>
+              <a:spLocks/>
+            </p:cNvSpPr>
+            <p:nvPr/>
+          </p:nvSpPr>
+          <p:spPr>
+            <a:xfrm>
+              <a:off x="714375" y="2762250"/>
+              <a:ext cx="1259680" cy="866775"/>
+            </a:xfrm>
+            <a:prstGeom prst="roundRect">
+              <a:avLst/>
+            </a:prstGeom>
             <a:solidFill>
+              <a:schemeClr val="accent2"/>
+            </a:solidFill>
+            <a:ln>
+              <a:solidFill>
+                <a:schemeClr val="accent3"/>
+              </a:solidFill>
+            </a:ln>
+          </p:spPr>
+          <p:style>
+            <a:lnRef idx="2">
+              <a:schemeClr val="accent1">
+                <a:shade val="15000"/>
+              </a:schemeClr>
+            </a:lnRef>
+            <a:fillRef idx="1">
+              <a:schemeClr val="accent1"/>
+            </a:fillRef>
+            <a:effectRef idx="0">
+              <a:schemeClr val="accent1"/>
+            </a:effectRef>
+            <a:fontRef idx="minor">
+              <a:schemeClr val="lt1"/>
+            </a:fontRef>
+          </p:style>
+          <p:txBody>
+            <a:bodyPr anchor="ctr"/>
+            <a:lstStyle/>
+            <a:p>
+              <a:pPr algn="ctr">
+                <a:buNone/>
+              </a:pPr>
+              <a:endParaRPr/>
+            </a:p>
+          </p:txBody>
+        </p:sp>
+        <p:sp>
+          <p:nvSpPr>
+            <p:cNvPr id="48" name="Textfeld 60">
+              <a:extLst>
+                <a:ext uri="{FF2B5EF4-FFF2-40B4-BE49-F238E27FC236}">
+                  <a16:creationId xmlns:a16="http://schemas.microsoft.com/office/drawing/2014/main" id="{9300C327-65D2-42BB-19E9-6CBA235D48A3}"/>
+                </a:ext>
+              </a:extLst>
+            </p:cNvPr>
+            <p:cNvSpPr>
+              <a:spLocks/>
+            </p:cNvSpPr>
+            <p:nvPr/>
+          </p:nvSpPr>
+          <p:spPr>
+            <a:xfrm>
+              <a:off x="701754" y="2780929"/>
+              <a:ext cx="1259680" cy="276999"/>
+            </a:xfrm>
+            <a:prstGeom prst="rect">
+              <a:avLst/>
+            </a:prstGeom>
+            <a:noFill/>
+          </p:spPr>
+          <p:txBody>
+            <a:bodyPr wrap="square">
+              <a:spAutoFit/>
+            </a:bodyPr>
+            <a:lstStyle/>
+            <a:p>
+              <a:pPr algn="ctr">
+                <a:buNone/>
+              </a:pPr>
+              <a:r>
+                <a:rPr sz="1200"/>
+                <a:t>Chunking</a:t>
+              </a:r>
+            </a:p>
+          </p:txBody>
+        </p:sp>
+        <p:sp>
+          <p:nvSpPr>
+            <p:cNvPr id="51" name="Gerader Verbinder 50">
+              <a:extLst>
+                <a:ext uri="{FF2B5EF4-FFF2-40B4-BE49-F238E27FC236}">
+                  <a16:creationId xmlns:a16="http://schemas.microsoft.com/office/drawing/2014/main" id="{329E3D98-43F4-135D-5087-525B26A0404F}"/>
+                </a:ext>
+              </a:extLst>
+            </p:cNvPr>
+            <p:cNvSpPr>
+              <a:spLocks/>
+            </p:cNvSpPr>
+            <p:nvPr/>
+          </p:nvSpPr>
+          <p:spPr>
+            <a:xfrm>
+              <a:off x="714375" y="3054904"/>
+              <a:ext cx="1259680" cy="0"/>
+            </a:xfrm>
+            <a:prstGeom prst="line">
+              <a:avLst/>
+            </a:prstGeom>
+            <a:ln>
+              <a:solidFill>
+                <a:schemeClr val="accent3"/>
+              </a:solidFill>
+            </a:ln>
+          </p:spPr>
+          <p:style>
+            <a:lnRef idx="1">
+              <a:schemeClr val="accent1"/>
+            </a:lnRef>
+            <a:fillRef idx="0">
+              <a:schemeClr val="accent1"/>
+            </a:fillRef>
+            <a:effectRef idx="0">
+              <a:schemeClr val="accent1"/>
+            </a:effectRef>
+            <a:fontRef idx="minor">
               <a:schemeClr val="tx1"/>
+            </a:fontRef>
+          </p:style>
+          <p:txBody>
+            <a:bodyPr/>
+            <a:lstStyle/>
+            <a:p>
+              <a:endParaRPr lang="de-CH"/>
+            </a:p>
+          </p:txBody>
+        </p:sp>
+        <p:pic>
+          <p:nvPicPr>
+            <p:cNvPr id="122" name="Grafik 165">
+              <a:extLst>
+                <a:ext uri="{FF2B5EF4-FFF2-40B4-BE49-F238E27FC236}">
+                  <a16:creationId xmlns:a16="http://schemas.microsoft.com/office/drawing/2014/main" id="{C58BB8C8-2491-48E5-46A3-5E1BEB7A5BA2}"/>
+                </a:ext>
+              </a:extLst>
+            </p:cNvPr>
+            <p:cNvPicPr>
+              <a:picLocks noChangeAspect="1"/>
+            </p:cNvPicPr>
+            <p:nvPr/>
+          </p:nvPicPr>
+          <p:blipFill>
+            <a:blip r:embed="rId11"/>
+            <a:stretch>
+              <a:fillRect/>
+            </a:stretch>
+          </p:blipFill>
+          <p:spPr>
+            <a:xfrm>
+              <a:off x="1086582" y="3154111"/>
+              <a:ext cx="515265" cy="403725"/>
+            </a:xfrm>
+            <a:prstGeom prst="rect">
+              <a:avLst/>
+            </a:prstGeom>
+          </p:spPr>
+        </p:pic>
+      </p:grpSp>
+      <p:grpSp>
+        <p:nvGrpSpPr>
+          <p:cNvPr id="151" name="Gruppe Embedding"/>
+          <p:cNvGrpSpPr/>
+          <p:nvPr/>
+        </p:nvGrpSpPr>
+        <p:grpSpPr>
+          <a:xfrm>
+            <a:off x="5086783" y="1578909"/>
+            <a:ext cx="1272301" cy="866775"/>
+            <a:chOff x="5086783" y="1578909"/>
+            <a:chExt cx="1272301" cy="866775"/>
+          </a:xfrm>
+        </p:grpSpPr>
+        <p:sp>
+          <p:nvSpPr>
+            <p:cNvPr id="54" name="Rechteck: abgerundete Ecken 53">
+              <a:extLst>
+                <a:ext uri="{FF2B5EF4-FFF2-40B4-BE49-F238E27FC236}">
+                  <a16:creationId xmlns:a16="http://schemas.microsoft.com/office/drawing/2014/main" id="{F6937E87-FFDC-5644-BE6B-D3AF0FCBAA56}"/>
+                </a:ext>
+              </a:extLst>
+            </p:cNvPr>
+            <p:cNvSpPr>
+              <a:spLocks/>
+            </p:cNvSpPr>
+            <p:nvPr/>
+          </p:nvSpPr>
+          <p:spPr>
+            <a:xfrm>
+              <a:off x="5099404" y="1578909"/>
+              <a:ext cx="1259680" cy="866775"/>
+            </a:xfrm>
+            <a:prstGeom prst="roundRect">
+              <a:avLst/>
+            </a:prstGeom>
+            <a:solidFill>
+              <a:schemeClr val="accent2"/>
             </a:solidFill>
-          </a:ln>
-        </p:spPr>
-        <p:style>
-          <a:lnRef idx="2">
-            <a:schemeClr val="accent1">
-              <a:shade val="15000"/>
-            </a:schemeClr>
-          </a:lnRef>
-          <a:fillRef idx="1">
-            <a:schemeClr val="accent1"/>
-          </a:fillRef>
-          <a:effectRef idx="0">
-            <a:schemeClr val="accent1"/>
-          </a:effectRef>
-          <a:fontRef idx="minor">
-            <a:schemeClr val="lt1"/>
-          </a:fontRef>
-        </p:style>
-        <p:txBody>
-          <a:bodyPr anchor="ctr"/>
-          <a:lstStyle/>
-          <a:p>
-            <a:pPr algn="ctr">
-              <a:buNone/>
-            </a:pPr>
-            <a:endParaRPr/>
-          </a:p>
-        </p:txBody>
-      </p:sp>
-      <p:pic>
-        <p:nvPicPr>
-          <p:cNvPr id="20" name="Grafik 16">
-            <a:extLst>
-              <a:ext uri="{FF2B5EF4-FFF2-40B4-BE49-F238E27FC236}">
-                <a16:creationId xmlns:a16="http://schemas.microsoft.com/office/drawing/2014/main" id="{3FD27254-6A1A-1764-0C62-B715418317A1}"/>
-              </a:ext>
-            </a:extLst>
-          </p:cNvPr>
-          <p:cNvPicPr>
-            <a:picLocks noChangeAspect="1"/>
-          </p:cNvPicPr>
+            <a:ln>
+              <a:solidFill>
+                <a:schemeClr val="accent3"/>
+              </a:solidFill>
+            </a:ln>
+          </p:spPr>
+          <p:style>
+            <a:lnRef idx="2">
+              <a:schemeClr val="accent1">
+                <a:shade val="15000"/>
+              </a:schemeClr>
+            </a:lnRef>
+            <a:fillRef idx="1">
+              <a:schemeClr val="accent1"/>
+            </a:fillRef>
+            <a:effectRef idx="0">
+              <a:schemeClr val="accent1"/>
+            </a:effectRef>
+            <a:fontRef idx="minor">
+              <a:schemeClr val="lt1"/>
+            </a:fontRef>
+          </p:style>
+          <p:txBody>
+            <a:bodyPr anchor="ctr"/>
+            <a:lstStyle/>
+            <a:p>
+              <a:pPr algn="ctr">
+                <a:buNone/>
+              </a:pPr>
+              <a:endParaRPr/>
+            </a:p>
+          </p:txBody>
+        </p:sp>
+        <p:pic>
+          <p:nvPicPr>
+            <p:cNvPr id="56" name="Grafik 33">
+              <a:extLst>
+                <a:ext uri="{FF2B5EF4-FFF2-40B4-BE49-F238E27FC236}">
+                  <a16:creationId xmlns:a16="http://schemas.microsoft.com/office/drawing/2014/main" id="{4180022B-D146-7907-A8C7-659A2713F829}"/>
+                </a:ext>
+              </a:extLst>
+            </p:cNvPr>
+            <p:cNvPicPr>
+              <a:picLocks noChangeAspect="1"/>
+            </p:cNvPicPr>
+            <p:nvPr/>
+          </p:nvPicPr>
+          <p:blipFill>
+            <a:blip r:embed="rId7"/>
+            <a:stretch>
+              <a:fillRect/>
+            </a:stretch>
+          </p:blipFill>
+          <p:spPr>
+            <a:xfrm flipH="1">
+              <a:off x="5487815" y="1917819"/>
+              <a:ext cx="482858" cy="509226"/>
+            </a:xfrm>
+            <a:prstGeom prst="rect">
+              <a:avLst/>
+            </a:prstGeom>
+          </p:spPr>
+        </p:pic>
+        <p:sp>
+          <p:nvSpPr>
+            <p:cNvPr id="57" name="Textfeld 34">
+              <a:extLst>
+                <a:ext uri="{FF2B5EF4-FFF2-40B4-BE49-F238E27FC236}">
+                  <a16:creationId xmlns:a16="http://schemas.microsoft.com/office/drawing/2014/main" id="{957FA4FE-DEF6-E882-2842-2649F9966023}"/>
+                </a:ext>
+              </a:extLst>
+            </p:cNvPr>
+            <p:cNvSpPr>
+              <a:spLocks/>
+            </p:cNvSpPr>
+            <p:nvPr/>
+          </p:nvSpPr>
+          <p:spPr>
+            <a:xfrm>
+              <a:off x="5086783" y="1597588"/>
+              <a:ext cx="1259680" cy="276999"/>
+            </a:xfrm>
+            <a:prstGeom prst="rect">
+              <a:avLst/>
+            </a:prstGeom>
+            <a:noFill/>
+          </p:spPr>
+          <p:txBody>
+            <a:bodyPr wrap="square">
+              <a:spAutoFit/>
+            </a:bodyPr>
+            <a:lstStyle/>
+            <a:p>
+              <a:pPr algn="ctr">
+                <a:buNone/>
+              </a:pPr>
+              <a:r>
+                <a:rPr sz="1200"/>
+                <a:t>Embedding</a:t>
+              </a:r>
+            </a:p>
+          </p:txBody>
+        </p:sp>
+        <p:sp>
+          <p:nvSpPr>
+            <p:cNvPr id="58" name="Gerader Verbinder 57">
+              <a:extLst>
+                <a:ext uri="{FF2B5EF4-FFF2-40B4-BE49-F238E27FC236}">
+                  <a16:creationId xmlns:a16="http://schemas.microsoft.com/office/drawing/2014/main" id="{2358A794-930F-1800-2F3C-5B5ECED2E77E}"/>
+                </a:ext>
+              </a:extLst>
+            </p:cNvPr>
+            <p:cNvSpPr>
+              <a:spLocks/>
+            </p:cNvSpPr>
+            <p:nvPr/>
+          </p:nvSpPr>
+          <p:spPr>
+            <a:xfrm flipV="1">
+              <a:off x="5099404" y="1874587"/>
+              <a:ext cx="1259680" cy="0"/>
+            </a:xfrm>
+            <a:prstGeom prst="line">
+              <a:avLst/>
+            </a:prstGeom>
+            <a:ln>
+              <a:solidFill>
+                <a:schemeClr val="accent3"/>
+              </a:solidFill>
+            </a:ln>
+          </p:spPr>
+          <p:style>
+            <a:lnRef idx="1">
+              <a:schemeClr val="accent1"/>
+            </a:lnRef>
+            <a:fillRef idx="0">
+              <a:schemeClr val="accent1"/>
+            </a:fillRef>
+            <a:effectRef idx="0">
+              <a:schemeClr val="accent1"/>
+            </a:effectRef>
+            <a:fontRef idx="minor">
+              <a:schemeClr val="tx1"/>
+            </a:fontRef>
+          </p:style>
+          <p:txBody>
+            <a:bodyPr/>
+            <a:lstStyle/>
+            <a:p>
+              <a:endParaRPr lang="de-CH"/>
+            </a:p>
+          </p:txBody>
+        </p:sp>
+      </p:grpSp>
+      <p:grpSp>
+        <p:nvGrpSpPr>
+          <p:cNvPr id="152" name="Gruppe Embedding"/>
+          <p:cNvGrpSpPr/>
           <p:nvPr/>
-        </p:nvPicPr>
-        <p:blipFill>
-          <a:blip r:embed="rId4"/>
-          <a:stretch>
-            <a:fillRect/>
-          </a:stretch>
-        </p:blipFill>
-        <p:spPr>
-          <a:xfrm>
-            <a:off x="10611917" y="1867303"/>
-            <a:ext cx="609864" cy="566720"/>
-          </a:xfrm>
-          <a:prstGeom prst="rect">
-            <a:avLst/>
-          </a:prstGeom>
-        </p:spPr>
-      </p:pic>
-      <p:sp>
-        <p:nvSpPr>
-          <p:cNvPr id="22" name="Textfeld 51">
-            <a:extLst>
-              <a:ext uri="{FF2B5EF4-FFF2-40B4-BE49-F238E27FC236}">
-                <a16:creationId xmlns:a16="http://schemas.microsoft.com/office/drawing/2014/main" id="{E9B671B8-ADBD-7C77-A761-7D4C7F8DC77F}"/>
-              </a:ext>
-            </a:extLst>
-          </p:cNvPr>
-          <p:cNvSpPr>
-            <a:spLocks/>
-          </p:cNvSpPr>
+        </p:nvGrpSpPr>
+        <p:grpSpPr>
+          <a:xfrm>
+            <a:off x="8083629" y="2776991"/>
+            <a:ext cx="1272301" cy="879071"/>
+            <a:chOff x="8083629" y="2776991"/>
+            <a:chExt cx="1272301" cy="879071"/>
+          </a:xfrm>
+        </p:grpSpPr>
+        <p:sp>
+          <p:nvSpPr>
+            <p:cNvPr id="60" name="Rechteck: abgerundete Ecken 59">
+              <a:extLst>
+                <a:ext uri="{FF2B5EF4-FFF2-40B4-BE49-F238E27FC236}">
+                  <a16:creationId xmlns:a16="http://schemas.microsoft.com/office/drawing/2014/main" id="{0F97695A-AB9E-12B2-E874-0BCD324FB8A7}"/>
+                </a:ext>
+              </a:extLst>
+            </p:cNvPr>
+            <p:cNvSpPr>
+              <a:spLocks/>
+            </p:cNvSpPr>
+            <p:nvPr/>
+          </p:nvSpPr>
+          <p:spPr>
+            <a:xfrm>
+              <a:off x="8096250" y="2776991"/>
+              <a:ext cx="1259680" cy="866775"/>
+            </a:xfrm>
+            <a:prstGeom prst="roundRect">
+              <a:avLst/>
+            </a:prstGeom>
+            <a:solidFill>
+              <a:schemeClr val="bg2"/>
+            </a:solidFill>
+            <a:ln>
+              <a:solidFill>
+                <a:schemeClr val="tx2"/>
+              </a:solidFill>
+            </a:ln>
+          </p:spPr>
+          <p:style>
+            <a:lnRef idx="2">
+              <a:schemeClr val="accent1">
+                <a:shade val="15000"/>
+              </a:schemeClr>
+            </a:lnRef>
+            <a:fillRef idx="1">
+              <a:schemeClr val="accent1"/>
+            </a:fillRef>
+            <a:effectRef idx="0">
+              <a:schemeClr val="accent1"/>
+            </a:effectRef>
+            <a:fontRef idx="minor">
+              <a:schemeClr val="lt1"/>
+            </a:fontRef>
+          </p:style>
+          <p:txBody>
+            <a:bodyPr anchor="ctr"/>
+            <a:lstStyle/>
+            <a:p>
+              <a:pPr algn="ctr">
+                <a:buNone/>
+              </a:pPr>
+              <a:endParaRPr/>
+            </a:p>
+          </p:txBody>
+        </p:sp>
+        <p:pic>
+          <p:nvPicPr>
+            <p:cNvPr id="63" name="Grafik 12">
+              <a:extLst>
+                <a:ext uri="{FF2B5EF4-FFF2-40B4-BE49-F238E27FC236}">
+                  <a16:creationId xmlns:a16="http://schemas.microsoft.com/office/drawing/2014/main" id="{E86CBA64-1F16-70AF-49B8-BA3DAF1F453E}"/>
+                </a:ext>
+              </a:extLst>
+            </p:cNvPr>
+            <p:cNvPicPr>
+              <a:picLocks noChangeAspect="1"/>
+            </p:cNvPicPr>
+            <p:nvPr/>
+          </p:nvPicPr>
+          <p:blipFill>
+            <a:blip r:embed="rId7"/>
+            <a:stretch>
+              <a:fillRect/>
+            </a:stretch>
+          </p:blipFill>
+          <p:spPr>
+            <a:xfrm flipH="1">
+              <a:off x="8455327" y="3084965"/>
+              <a:ext cx="541526" cy="571097"/>
+            </a:xfrm>
+            <a:prstGeom prst="rect">
+              <a:avLst/>
+            </a:prstGeom>
+          </p:spPr>
+        </p:pic>
+        <p:sp>
+          <p:nvSpPr>
+            <p:cNvPr id="67" name="Textfeld 31">
+              <a:extLst>
+                <a:ext uri="{FF2B5EF4-FFF2-40B4-BE49-F238E27FC236}">
+                  <a16:creationId xmlns:a16="http://schemas.microsoft.com/office/drawing/2014/main" id="{93602E7B-DC37-F2CD-0924-065EFB64C7BA}"/>
+                </a:ext>
+              </a:extLst>
+            </p:cNvPr>
+            <p:cNvSpPr>
+              <a:spLocks/>
+            </p:cNvSpPr>
+            <p:nvPr/>
+          </p:nvSpPr>
+          <p:spPr>
+            <a:xfrm>
+              <a:off x="8083629" y="2795670"/>
+              <a:ext cx="1259680" cy="276999"/>
+            </a:xfrm>
+            <a:prstGeom prst="rect">
+              <a:avLst/>
+            </a:prstGeom>
+            <a:noFill/>
+          </p:spPr>
+          <p:txBody>
+            <a:bodyPr wrap="square">
+              <a:spAutoFit/>
+            </a:bodyPr>
+            <a:lstStyle/>
+            <a:p>
+              <a:pPr algn="ctr">
+                <a:buNone/>
+              </a:pPr>
+              <a:r>
+                <a:rPr sz="1200"/>
+                <a:t>Embedding</a:t>
+              </a:r>
+            </a:p>
+          </p:txBody>
+        </p:sp>
+        <p:sp>
+          <p:nvSpPr>
+            <p:cNvPr id="69" name="Gerader Verbinder 68">
+              <a:extLst>
+                <a:ext uri="{FF2B5EF4-FFF2-40B4-BE49-F238E27FC236}">
+                  <a16:creationId xmlns:a16="http://schemas.microsoft.com/office/drawing/2014/main" id="{919036DE-C489-76A0-3FDD-88C13187B396}"/>
+                </a:ext>
+              </a:extLst>
+            </p:cNvPr>
+            <p:cNvSpPr>
+              <a:spLocks/>
+            </p:cNvSpPr>
+            <p:nvPr/>
+          </p:nvSpPr>
+          <p:spPr>
+            <a:xfrm flipV="1">
+              <a:off x="8096250" y="3072669"/>
+              <a:ext cx="1259680" cy="0"/>
+            </a:xfrm>
+            <a:prstGeom prst="line">
+              <a:avLst/>
+            </a:prstGeom>
+            <a:ln>
+              <a:solidFill>
+                <a:schemeClr val="tx2"/>
+              </a:solidFill>
+            </a:ln>
+          </p:spPr>
+          <p:style>
+            <a:lnRef idx="1">
+              <a:schemeClr val="accent1"/>
+            </a:lnRef>
+            <a:fillRef idx="0">
+              <a:schemeClr val="accent1"/>
+            </a:fillRef>
+            <a:effectRef idx="0">
+              <a:schemeClr val="accent1"/>
+            </a:effectRef>
+            <a:fontRef idx="minor">
+              <a:schemeClr val="tx1"/>
+            </a:fontRef>
+          </p:style>
+          <p:txBody>
+            <a:bodyPr/>
+            <a:lstStyle/>
+            <a:p>
+              <a:endParaRPr lang="de-CH"/>
+            </a:p>
+          </p:txBody>
+        </p:sp>
+      </p:grpSp>
+      <p:grpSp>
+        <p:nvGrpSpPr>
+          <p:cNvPr id="153" name="Gruppe Vector Database"/>
+          <p:cNvGrpSpPr/>
           <p:nvPr/>
-        </p:nvSpPr>
-        <p:spPr>
-          <a:xfrm>
-            <a:off x="10274379" y="1590304"/>
-            <a:ext cx="1259680" cy="276999"/>
-          </a:xfrm>
-          <a:prstGeom prst="rect">
-            <a:avLst/>
-          </a:prstGeom>
-          <a:noFill/>
-        </p:spPr>
-        <p:txBody>
-          <a:bodyPr wrap="square">
-            <a:spAutoFit/>
-          </a:bodyPr>
-          <a:lstStyle/>
-          <a:p>
-            <a:pPr algn="ctr">
-              <a:buNone/>
-            </a:pPr>
-            <a:r>
-              <a:rPr sz="1200">
-                <a:solidFill>
-                  <a:schemeClr val="bg1"/>
-                </a:solidFill>
-              </a:rPr>
-              <a:t>Query</a:t>
-            </a:r>
-          </a:p>
-        </p:txBody>
-      </p:sp>
-      <p:sp>
-        <p:nvSpPr>
-          <p:cNvPr id="24" name="Rechteck: abgerundete Ecken 23">
-            <a:extLst>
-              <a:ext uri="{FF2B5EF4-FFF2-40B4-BE49-F238E27FC236}">
-                <a16:creationId xmlns:a16="http://schemas.microsoft.com/office/drawing/2014/main" id="{EF7C69F7-3BA6-3716-FB87-C6056C54CA0B}"/>
-              </a:ext>
-            </a:extLst>
-          </p:cNvPr>
-          <p:cNvSpPr>
-            <a:spLocks/>
-          </p:cNvSpPr>
+        </p:nvGrpSpPr>
+        <p:grpSpPr>
+          <a:xfrm>
+            <a:off x="5083254" y="2776991"/>
+            <a:ext cx="1341782" cy="866776"/>
+            <a:chOff x="5083254" y="2776991"/>
+            <a:chExt cx="1341782" cy="866776"/>
+          </a:xfrm>
+        </p:grpSpPr>
+        <p:sp>
+          <p:nvSpPr>
+            <p:cNvPr id="72" name="Rechteck: abgerundete Ecken 71">
+              <a:extLst>
+                <a:ext uri="{FF2B5EF4-FFF2-40B4-BE49-F238E27FC236}">
+                  <a16:creationId xmlns:a16="http://schemas.microsoft.com/office/drawing/2014/main" id="{E9A14601-129B-5663-F0ED-B2E1BD20F945}"/>
+                </a:ext>
+              </a:extLst>
+            </p:cNvPr>
+            <p:cNvSpPr>
+              <a:spLocks/>
+            </p:cNvSpPr>
+            <p:nvPr/>
+          </p:nvSpPr>
+          <p:spPr>
+            <a:xfrm>
+              <a:off x="5095875" y="2776991"/>
+              <a:ext cx="1259680" cy="866775"/>
+            </a:xfrm>
+            <a:prstGeom prst="roundRect">
+              <a:avLst/>
+            </a:prstGeom>
+            <a:solidFill>
+              <a:schemeClr val="bg2"/>
+            </a:solidFill>
+            <a:ln>
+              <a:solidFill>
+                <a:schemeClr val="tx2"/>
+              </a:solidFill>
+            </a:ln>
+          </p:spPr>
+          <p:style>
+            <a:lnRef idx="2">
+              <a:schemeClr val="accent1">
+                <a:shade val="15000"/>
+              </a:schemeClr>
+            </a:lnRef>
+            <a:fillRef idx="1">
+              <a:schemeClr val="accent1"/>
+            </a:fillRef>
+            <a:effectRef idx="0">
+              <a:schemeClr val="accent1"/>
+            </a:effectRef>
+            <a:fontRef idx="minor">
+              <a:schemeClr val="lt1"/>
+            </a:fontRef>
+          </p:style>
+          <p:txBody>
+            <a:bodyPr anchor="ctr"/>
+            <a:lstStyle/>
+            <a:p>
+              <a:pPr algn="ctr">
+                <a:buNone/>
+              </a:pPr>
+              <a:endParaRPr/>
+            </a:p>
+          </p:txBody>
+        </p:sp>
+        <p:pic>
+          <p:nvPicPr>
+            <p:cNvPr id="74" name="Grafik 14">
+              <a:extLst>
+                <a:ext uri="{FF2B5EF4-FFF2-40B4-BE49-F238E27FC236}">
+                  <a16:creationId xmlns:a16="http://schemas.microsoft.com/office/drawing/2014/main" id="{C9AA9F1F-BE1C-5F83-5671-91EF5A5DC37F}"/>
+                </a:ext>
+              </a:extLst>
+            </p:cNvPr>
+            <p:cNvPicPr>
+              <a:picLocks noChangeAspect="1"/>
+            </p:cNvPicPr>
+            <p:nvPr/>
+          </p:nvPicPr>
+          <p:blipFill>
+            <a:blip r:embed="rId8"/>
+            <a:stretch>
+              <a:fillRect/>
+            </a:stretch>
+          </p:blipFill>
+          <p:spPr>
+            <a:xfrm flipH="1">
+              <a:off x="5445714" y="3157787"/>
+              <a:ext cx="560002" cy="485980"/>
+            </a:xfrm>
+            <a:prstGeom prst="rect">
+              <a:avLst/>
+            </a:prstGeom>
+          </p:spPr>
+        </p:pic>
+        <p:sp>
+          <p:nvSpPr>
+            <p:cNvPr id="77" name="Textfeld 25">
+              <a:extLst>
+                <a:ext uri="{FF2B5EF4-FFF2-40B4-BE49-F238E27FC236}">
+                  <a16:creationId xmlns:a16="http://schemas.microsoft.com/office/drawing/2014/main" id="{1C80D23E-AF36-ADDD-DF87-F60A5AC8096B}"/>
+                </a:ext>
+              </a:extLst>
+            </p:cNvPr>
+            <p:cNvSpPr>
+              <a:spLocks/>
+            </p:cNvSpPr>
+            <p:nvPr/>
+          </p:nvSpPr>
+          <p:spPr>
+            <a:xfrm>
+              <a:off x="5083254" y="2795670"/>
+              <a:ext cx="1341782" cy="285750"/>
+            </a:xfrm>
+            <a:prstGeom prst="rect">
+              <a:avLst/>
+            </a:prstGeom>
+            <a:noFill/>
+          </p:spPr>
+          <p:txBody>
+            <a:bodyPr wrap="square">
+              <a:spAutoFit/>
+            </a:bodyPr>
+            <a:lstStyle/>
+            <a:p>
+              <a:pPr algn="ctr">
+                <a:buNone/>
+              </a:pPr>
+              <a:r>
+                <a:rPr sz="1200" dirty="0"/>
+                <a:t>Vector Database</a:t>
+              </a:r>
+            </a:p>
+          </p:txBody>
+        </p:sp>
+        <p:sp>
+          <p:nvSpPr>
+            <p:cNvPr id="79" name="Gerader Verbinder 78">
+              <a:extLst>
+                <a:ext uri="{FF2B5EF4-FFF2-40B4-BE49-F238E27FC236}">
+                  <a16:creationId xmlns:a16="http://schemas.microsoft.com/office/drawing/2014/main" id="{89A0E0B7-A2BB-83F8-DDEA-7BF8AF689E44}"/>
+                </a:ext>
+              </a:extLst>
+            </p:cNvPr>
+            <p:cNvSpPr>
+              <a:spLocks/>
+            </p:cNvSpPr>
+            <p:nvPr/>
+          </p:nvSpPr>
+          <p:spPr>
+            <a:xfrm>
+              <a:off x="5095875" y="3081420"/>
+              <a:ext cx="1259680" cy="0"/>
+            </a:xfrm>
+            <a:prstGeom prst="line">
+              <a:avLst/>
+            </a:prstGeom>
+            <a:ln>
+              <a:solidFill>
+                <a:schemeClr val="tx2"/>
+              </a:solidFill>
+            </a:ln>
+          </p:spPr>
+          <p:style>
+            <a:lnRef idx="1">
+              <a:schemeClr val="accent1"/>
+            </a:lnRef>
+            <a:fillRef idx="0">
+              <a:schemeClr val="accent1"/>
+            </a:fillRef>
+            <a:effectRef idx="0">
+              <a:schemeClr val="accent1"/>
+            </a:effectRef>
+            <a:fontRef idx="minor">
+              <a:schemeClr val="tx1"/>
+            </a:fontRef>
+          </p:style>
+          <p:txBody>
+            <a:bodyPr/>
+            <a:lstStyle/>
+            <a:p>
+              <a:endParaRPr lang="de-CH"/>
+            </a:p>
+          </p:txBody>
+        </p:sp>
+      </p:grpSp>
+      <p:grpSp>
+        <p:nvGrpSpPr>
+          <p:cNvPr id="154" name="Gruppe Relevant Data"/>
+          <p:cNvGrpSpPr/>
           <p:nvPr/>
-        </p:nvSpPr>
-        <p:spPr>
-          <a:xfrm>
-            <a:off x="10287000" y="5162179"/>
-            <a:ext cx="1259680" cy="866775"/>
-          </a:xfrm>
-          <a:prstGeom prst="roundRect">
-            <a:avLst/>
-          </a:prstGeom>
-          <a:solidFill>
-            <a:schemeClr val="accent5"/>
-          </a:solidFill>
-          <a:ln>
+        </p:nvGrpSpPr>
+        <p:grpSpPr>
+          <a:xfrm>
+            <a:off x="5083254" y="5162179"/>
+            <a:ext cx="1272301" cy="885454"/>
+            <a:chOff x="5083254" y="5162179"/>
+            <a:chExt cx="1272301" cy="885454"/>
+          </a:xfrm>
+        </p:grpSpPr>
+        <p:sp>
+          <p:nvSpPr>
+            <p:cNvPr id="81" name="Rechteck: abgerundete Ecken 80">
+              <a:extLst>
+                <a:ext uri="{FF2B5EF4-FFF2-40B4-BE49-F238E27FC236}">
+                  <a16:creationId xmlns:a16="http://schemas.microsoft.com/office/drawing/2014/main" id="{299209A1-E60D-B54F-BCE0-B59442B6BA9E}"/>
+                </a:ext>
+              </a:extLst>
+            </p:cNvPr>
+            <p:cNvSpPr>
+              <a:spLocks/>
+            </p:cNvSpPr>
+            <p:nvPr/>
+          </p:nvSpPr>
+          <p:spPr>
+            <a:xfrm>
+              <a:off x="5095875" y="5162179"/>
+              <a:ext cx="1259680" cy="866775"/>
+            </a:xfrm>
+            <a:prstGeom prst="roundRect">
+              <a:avLst/>
+            </a:prstGeom>
             <a:solidFill>
+              <a:schemeClr val="bg2"/>
+            </a:solidFill>
+            <a:ln>
+              <a:solidFill>
+                <a:schemeClr val="tx2"/>
+              </a:solidFill>
+            </a:ln>
+          </p:spPr>
+          <p:style>
+            <a:lnRef idx="2">
+              <a:schemeClr val="accent1">
+                <a:shade val="15000"/>
+              </a:schemeClr>
+            </a:lnRef>
+            <a:fillRef idx="1">
+              <a:schemeClr val="accent1"/>
+            </a:fillRef>
+            <a:effectRef idx="0">
+              <a:schemeClr val="accent1"/>
+            </a:effectRef>
+            <a:fontRef idx="minor">
+              <a:schemeClr val="lt1"/>
+            </a:fontRef>
+          </p:style>
+          <p:txBody>
+            <a:bodyPr anchor="ctr"/>
+            <a:lstStyle/>
+            <a:p>
+              <a:pPr algn="ctr">
+                <a:buNone/>
+              </a:pPr>
+              <a:endParaRPr/>
+            </a:p>
+          </p:txBody>
+        </p:sp>
+        <p:pic>
+          <p:nvPicPr>
+            <p:cNvPr id="84" name="Grafik 18">
+              <a:extLst>
+                <a:ext uri="{FF2B5EF4-FFF2-40B4-BE49-F238E27FC236}">
+                  <a16:creationId xmlns:a16="http://schemas.microsoft.com/office/drawing/2014/main" id="{75982C35-E39A-47E4-7B79-4694BEFA0FBF}"/>
+                </a:ext>
+              </a:extLst>
+            </p:cNvPr>
+            <p:cNvPicPr>
+              <a:picLocks noChangeAspect="1"/>
+            </p:cNvPicPr>
+            <p:nvPr/>
+          </p:nvPicPr>
+          <p:blipFill>
+            <a:blip r:embed="rId9"/>
+            <a:stretch>
+              <a:fillRect/>
+            </a:stretch>
+          </p:blipFill>
+          <p:spPr>
+            <a:xfrm flipH="1">
+              <a:off x="5378242" y="5429497"/>
+              <a:ext cx="694946" cy="618136"/>
+            </a:xfrm>
+            <a:prstGeom prst="rect">
+              <a:avLst/>
+            </a:prstGeom>
+          </p:spPr>
+        </p:pic>
+        <p:sp>
+          <p:nvSpPr>
+            <p:cNvPr id="87" name="Textfeld 28">
+              <a:extLst>
+                <a:ext uri="{FF2B5EF4-FFF2-40B4-BE49-F238E27FC236}">
+                  <a16:creationId xmlns:a16="http://schemas.microsoft.com/office/drawing/2014/main" id="{97FD2241-5B61-D9A8-9B5C-DE6B07A2BCBE}"/>
+                </a:ext>
+              </a:extLst>
+            </p:cNvPr>
+            <p:cNvSpPr>
+              <a:spLocks/>
+            </p:cNvSpPr>
+            <p:nvPr/>
+          </p:nvSpPr>
+          <p:spPr>
+            <a:xfrm>
+              <a:off x="5083254" y="5180858"/>
+              <a:ext cx="1259680" cy="276999"/>
+            </a:xfrm>
+            <a:prstGeom prst="rect">
+              <a:avLst/>
+            </a:prstGeom>
+            <a:noFill/>
+          </p:spPr>
+          <p:txBody>
+            <a:bodyPr wrap="square">
+              <a:spAutoFit/>
+            </a:bodyPr>
+            <a:lstStyle/>
+            <a:p>
+              <a:pPr algn="ctr">
+                <a:buNone/>
+              </a:pPr>
+              <a:r>
+                <a:rPr sz="1200"/>
+                <a:t>Relevant Data</a:t>
+              </a:r>
+            </a:p>
+          </p:txBody>
+        </p:sp>
+        <p:sp>
+          <p:nvSpPr>
+            <p:cNvPr id="90" name="Gerader Verbinder 89">
+              <a:extLst>
+                <a:ext uri="{FF2B5EF4-FFF2-40B4-BE49-F238E27FC236}">
+                  <a16:creationId xmlns:a16="http://schemas.microsoft.com/office/drawing/2014/main" id="{28E3CEA1-5C20-114C-95BF-87C047395FE4}"/>
+                </a:ext>
+              </a:extLst>
+            </p:cNvPr>
+            <p:cNvSpPr>
+              <a:spLocks/>
+            </p:cNvSpPr>
+            <p:nvPr/>
+          </p:nvSpPr>
+          <p:spPr>
+            <a:xfrm>
+              <a:off x="5095875" y="5457857"/>
+              <a:ext cx="1259680" cy="0"/>
+            </a:xfrm>
+            <a:prstGeom prst="line">
+              <a:avLst/>
+            </a:prstGeom>
+            <a:ln>
+              <a:solidFill>
+                <a:schemeClr val="tx2"/>
+              </a:solidFill>
+            </a:ln>
+          </p:spPr>
+          <p:style>
+            <a:lnRef idx="1">
+              <a:schemeClr val="accent1"/>
+            </a:lnRef>
+            <a:fillRef idx="0">
+              <a:schemeClr val="accent1"/>
+            </a:fillRef>
+            <a:effectRef idx="0">
+              <a:schemeClr val="accent1"/>
+            </a:effectRef>
+            <a:fontRef idx="minor">
               <a:schemeClr val="tx1"/>
+            </a:fontRef>
+          </p:style>
+          <p:txBody>
+            <a:bodyPr/>
+            <a:lstStyle/>
+            <a:p>
+              <a:endParaRPr lang="de-CH"/>
+            </a:p>
+          </p:txBody>
+        </p:sp>
+      </p:grpSp>
+      <p:grpSp>
+        <p:nvGrpSpPr>
+          <p:cNvPr id="155" name="Gruppe Embedding LLM"/>
+          <p:cNvGrpSpPr/>
+          <p:nvPr/>
+        </p:nvGrpSpPr>
+        <p:grpSpPr>
+          <a:xfrm>
+            <a:off x="8040401" y="1571625"/>
+            <a:ext cx="1414131" cy="866775"/>
+            <a:chOff x="8040401" y="1571625"/>
+            <a:chExt cx="1414131" cy="866775"/>
+          </a:xfrm>
+        </p:grpSpPr>
+        <p:sp>
+          <p:nvSpPr>
+            <p:cNvPr id="93" name="Rechteck: abgerundete Ecken 92">
+              <a:extLst>
+                <a:ext uri="{FF2B5EF4-FFF2-40B4-BE49-F238E27FC236}">
+                  <a16:creationId xmlns:a16="http://schemas.microsoft.com/office/drawing/2014/main" id="{AD79A1D2-E83B-1112-88E6-A41F8B4E30C4}"/>
+                </a:ext>
+              </a:extLst>
+            </p:cNvPr>
+            <p:cNvSpPr>
+              <a:spLocks/>
+            </p:cNvSpPr>
+            <p:nvPr/>
+          </p:nvSpPr>
+          <p:spPr>
+            <a:xfrm>
+              <a:off x="8086202" y="1571625"/>
+              <a:ext cx="1259680" cy="866775"/>
+            </a:xfrm>
+            <a:prstGeom prst="roundRect">
+              <a:avLst/>
+            </a:prstGeom>
+            <a:solidFill>
+              <a:schemeClr val="accent6">
+                <a:lumMod val="40000"/>
+                <a:lumOff val="60000"/>
+              </a:schemeClr>
             </a:solidFill>
-          </a:ln>
-        </p:spPr>
-        <p:style>
-          <a:lnRef idx="2">
-            <a:schemeClr val="accent1">
-              <a:shade val="15000"/>
-            </a:schemeClr>
-          </a:lnRef>
-          <a:fillRef idx="1">
-            <a:schemeClr val="accent1"/>
-          </a:fillRef>
-          <a:effectRef idx="0">
-            <a:schemeClr val="accent1"/>
-          </a:effectRef>
-          <a:fontRef idx="minor">
-            <a:schemeClr val="lt1"/>
-          </a:fontRef>
-        </p:style>
-        <p:txBody>
-          <a:bodyPr anchor="ctr"/>
-          <a:lstStyle/>
-          <a:p>
-            <a:pPr algn="ctr">
-              <a:buNone/>
-            </a:pPr>
-            <a:endParaRPr/>
-          </a:p>
-        </p:txBody>
-      </p:sp>
-      <p:pic>
-        <p:nvPicPr>
-          <p:cNvPr id="28" name="Grafik 22">
-            <a:extLst>
-              <a:ext uri="{FF2B5EF4-FFF2-40B4-BE49-F238E27FC236}">
-                <a16:creationId xmlns:a16="http://schemas.microsoft.com/office/drawing/2014/main" id="{8C3ACE01-CA21-EEDC-1F98-9D084AF04C23}"/>
-              </a:ext>
-            </a:extLst>
-          </p:cNvPr>
-          <p:cNvPicPr>
-            <a:picLocks noChangeAspect="1"/>
-          </p:cNvPicPr>
+            <a:ln>
+              <a:solidFill>
+                <a:schemeClr val="tx2"/>
+              </a:solidFill>
+            </a:ln>
+          </p:spPr>
+          <p:style>
+            <a:lnRef idx="2">
+              <a:schemeClr val="accent1">
+                <a:shade val="15000"/>
+              </a:schemeClr>
+            </a:lnRef>
+            <a:fillRef idx="1">
+              <a:schemeClr val="accent1"/>
+            </a:fillRef>
+            <a:effectRef idx="0">
+              <a:schemeClr val="accent1"/>
+            </a:effectRef>
+            <a:fontRef idx="minor">
+              <a:schemeClr val="lt1"/>
+            </a:fontRef>
+          </p:style>
+          <p:txBody>
+            <a:bodyPr anchor="ctr"/>
+            <a:lstStyle/>
+            <a:p>
+              <a:pPr algn="ctr">
+                <a:buNone/>
+              </a:pPr>
+              <a:endParaRPr/>
+            </a:p>
+          </p:txBody>
+        </p:sp>
+        <p:pic>
+          <p:nvPicPr>
+            <p:cNvPr id="96" name="Grafik 39">
+              <a:extLst>
+                <a:ext uri="{FF2B5EF4-FFF2-40B4-BE49-F238E27FC236}">
+                  <a16:creationId xmlns:a16="http://schemas.microsoft.com/office/drawing/2014/main" id="{61249CC0-2AE7-1CF4-AF70-7499619794AF}"/>
+                </a:ext>
+              </a:extLst>
+            </p:cNvPr>
+            <p:cNvPicPr>
+              <a:picLocks noChangeAspect="1"/>
+            </p:cNvPicPr>
+            <p:nvPr/>
+          </p:nvPicPr>
+          <p:blipFill>
+            <a:blip r:embed="rId10"/>
+            <a:stretch>
+              <a:fillRect/>
+            </a:stretch>
+          </p:blipFill>
+          <p:spPr>
+            <a:xfrm flipH="1">
+              <a:off x="8449146" y="1893252"/>
+              <a:ext cx="533792" cy="541782"/>
+            </a:xfrm>
+            <a:prstGeom prst="rect">
+              <a:avLst/>
+            </a:prstGeom>
+          </p:spPr>
+        </p:pic>
+        <p:sp>
+          <p:nvSpPr>
+            <p:cNvPr id="99" name="Textfeld 40">
+              <a:extLst>
+                <a:ext uri="{FF2B5EF4-FFF2-40B4-BE49-F238E27FC236}">
+                  <a16:creationId xmlns:a16="http://schemas.microsoft.com/office/drawing/2014/main" id="{39ADD9CF-0CDD-69E9-2A07-C125FCAA3B7D}"/>
+                </a:ext>
+              </a:extLst>
+            </p:cNvPr>
+            <p:cNvSpPr>
+              <a:spLocks/>
+            </p:cNvSpPr>
+            <p:nvPr/>
+          </p:nvSpPr>
+          <p:spPr>
+            <a:xfrm>
+              <a:off x="8040401" y="1571625"/>
+              <a:ext cx="1414131" cy="276999"/>
+            </a:xfrm>
+            <a:prstGeom prst="rect">
+              <a:avLst/>
+            </a:prstGeom>
+            <a:noFill/>
+          </p:spPr>
+          <p:txBody>
+            <a:bodyPr wrap="square">
+              <a:spAutoFit/>
+            </a:bodyPr>
+            <a:lstStyle/>
+            <a:p>
+              <a:pPr algn="ctr">
+                <a:buNone/>
+              </a:pPr>
+              <a:r>
+                <a:rPr sz="1200" dirty="0"/>
+                <a:t>Embedding LLM</a:t>
+              </a:r>
+            </a:p>
+          </p:txBody>
+        </p:sp>
+        <p:sp>
+          <p:nvSpPr>
+            <p:cNvPr id="101" name="Gerader Verbinder 100">
+              <a:extLst>
+                <a:ext uri="{FF2B5EF4-FFF2-40B4-BE49-F238E27FC236}">
+                  <a16:creationId xmlns:a16="http://schemas.microsoft.com/office/drawing/2014/main" id="{E72F8E13-9942-DFD0-1B23-F1C4A1D4EC76}"/>
+                </a:ext>
+              </a:extLst>
+            </p:cNvPr>
+            <p:cNvSpPr>
+              <a:spLocks/>
+            </p:cNvSpPr>
+            <p:nvPr/>
+          </p:nvSpPr>
+          <p:spPr>
+            <a:xfrm>
+              <a:off x="8086202" y="1855424"/>
+              <a:ext cx="1259680" cy="0"/>
+            </a:xfrm>
+            <a:prstGeom prst="line">
+              <a:avLst/>
+            </a:prstGeom>
+            <a:ln>
+              <a:solidFill>
+                <a:schemeClr val="tx2"/>
+              </a:solidFill>
+            </a:ln>
+          </p:spPr>
+          <p:style>
+            <a:lnRef idx="1">
+              <a:schemeClr val="accent1"/>
+            </a:lnRef>
+            <a:fillRef idx="0">
+              <a:schemeClr val="accent1"/>
+            </a:fillRef>
+            <a:effectRef idx="0">
+              <a:schemeClr val="accent1"/>
+            </a:effectRef>
+            <a:fontRef idx="minor">
+              <a:schemeClr val="tx1"/>
+            </a:fontRef>
+          </p:style>
+          <p:txBody>
+            <a:bodyPr/>
+            <a:lstStyle/>
+            <a:p>
+              <a:endParaRPr lang="de-CH"/>
+            </a:p>
+          </p:txBody>
+        </p:sp>
+      </p:grpSp>
+      <p:grpSp>
+        <p:nvGrpSpPr>
+          <p:cNvPr id="156" name="Gruppe LLM"/>
+          <p:cNvGrpSpPr/>
           <p:nvPr/>
-        </p:nvPicPr>
-        <p:blipFill>
-          <a:blip r:embed="rId5"/>
-          <a:stretch>
-            <a:fillRect/>
-          </a:stretch>
-        </p:blipFill>
-        <p:spPr>
-          <a:xfrm flipH="1">
-            <a:off x="10596787" y="5445851"/>
-            <a:ext cx="614864" cy="571508"/>
-          </a:xfrm>
-          <a:prstGeom prst="rect">
-            <a:avLst/>
-          </a:prstGeom>
-        </p:spPr>
-      </p:pic>
-      <p:sp>
-        <p:nvSpPr>
-          <p:cNvPr id="31" name="Textfeld 54">
-            <a:extLst>
-              <a:ext uri="{FF2B5EF4-FFF2-40B4-BE49-F238E27FC236}">
-                <a16:creationId xmlns:a16="http://schemas.microsoft.com/office/drawing/2014/main" id="{D4C33B49-7891-AAA7-51F9-90B1FAAF4FA6}"/>
-              </a:ext>
-            </a:extLst>
-          </p:cNvPr>
-          <p:cNvSpPr>
-            <a:spLocks/>
-          </p:cNvSpPr>
-          <p:nvPr/>
-        </p:nvSpPr>
-        <p:spPr>
-          <a:xfrm>
-            <a:off x="10274379" y="5180858"/>
-            <a:ext cx="1259680" cy="276999"/>
-          </a:xfrm>
-          <a:prstGeom prst="rect">
-            <a:avLst/>
-          </a:prstGeom>
-          <a:noFill/>
-        </p:spPr>
-        <p:txBody>
-          <a:bodyPr wrap="square">
-            <a:spAutoFit/>
-          </a:bodyPr>
-          <a:lstStyle/>
-          <a:p>
-            <a:pPr algn="ctr">
-              <a:buNone/>
-            </a:pPr>
-            <a:r>
-              <a:rPr sz="1200">
-                <a:solidFill>
-                  <a:schemeClr val="bg1"/>
-                </a:solidFill>
-              </a:rPr>
-              <a:t>Response</a:t>
-            </a:r>
-          </a:p>
-        </p:txBody>
-      </p:sp>
-      <p:sp>
-        <p:nvSpPr>
-          <p:cNvPr id="37" name="Rechteck: abgerundete Ecken 36">
-            <a:extLst>
-              <a:ext uri="{FF2B5EF4-FFF2-40B4-BE49-F238E27FC236}">
-                <a16:creationId xmlns:a16="http://schemas.microsoft.com/office/drawing/2014/main" id="{955C229C-DF37-3394-7852-D2530C311E3D}"/>
-              </a:ext>
-            </a:extLst>
-          </p:cNvPr>
-          <p:cNvSpPr>
-            <a:spLocks/>
-          </p:cNvSpPr>
-          <p:nvPr/>
-        </p:nvSpPr>
-        <p:spPr>
-          <a:xfrm>
-            <a:off x="513827" y="3952875"/>
-            <a:ext cx="1658163" cy="866775"/>
-          </a:xfrm>
-          <a:prstGeom prst="roundRect">
-            <a:avLst/>
-          </a:prstGeom>
-          <a:solidFill>
-            <a:schemeClr val="accent2"/>
-          </a:solidFill>
-          <a:ln>
+        </p:nvGrpSpPr>
+        <p:grpSpPr>
+          <a:xfrm>
+            <a:off x="8096250" y="5162179"/>
+            <a:ext cx="1259680" cy="889358"/>
+            <a:chOff x="8096250" y="5162179"/>
+            <a:chExt cx="1259680" cy="889358"/>
+          </a:xfrm>
+        </p:grpSpPr>
+        <p:sp>
+          <p:nvSpPr>
+            <p:cNvPr id="102" name="Rechteck: abgerundete Ecken 101">
+              <a:extLst>
+                <a:ext uri="{FF2B5EF4-FFF2-40B4-BE49-F238E27FC236}">
+                  <a16:creationId xmlns:a16="http://schemas.microsoft.com/office/drawing/2014/main" id="{CCD2EF0F-009E-7BB9-2850-8D80476CA421}"/>
+                </a:ext>
+              </a:extLst>
+            </p:cNvPr>
+            <p:cNvSpPr>
+              <a:spLocks/>
+            </p:cNvSpPr>
+            <p:nvPr/>
+          </p:nvSpPr>
+          <p:spPr>
+            <a:xfrm>
+              <a:off x="8096250" y="5162179"/>
+              <a:ext cx="1259680" cy="866775"/>
+            </a:xfrm>
+            <a:prstGeom prst="roundRect">
+              <a:avLst/>
+            </a:prstGeom>
             <a:solidFill>
-              <a:schemeClr val="accent3"/>
+              <a:schemeClr val="accent6">
+                <a:lumMod val="40000"/>
+                <a:lumOff val="60000"/>
+              </a:schemeClr>
             </a:solidFill>
-          </a:ln>
-        </p:spPr>
-        <p:style>
-          <a:lnRef idx="2">
-            <a:schemeClr val="accent1">
-              <a:shade val="15000"/>
-            </a:schemeClr>
-          </a:lnRef>
-          <a:fillRef idx="1">
-            <a:schemeClr val="accent1"/>
-          </a:fillRef>
-          <a:effectRef idx="0">
-            <a:schemeClr val="accent1"/>
-          </a:effectRef>
-          <a:fontRef idx="minor">
-            <a:schemeClr val="lt1"/>
-          </a:fontRef>
-        </p:style>
-        <p:txBody>
-          <a:bodyPr anchor="ctr"/>
-          <a:lstStyle/>
-          <a:p>
-            <a:pPr algn="ctr">
-              <a:buNone/>
-            </a:pPr>
-            <a:endParaRPr/>
-          </a:p>
-        </p:txBody>
-      </p:sp>
-      <p:pic>
-        <p:nvPicPr>
-          <p:cNvPr id="42" name="Grafik 8">
-            <a:extLst>
-              <a:ext uri="{FF2B5EF4-FFF2-40B4-BE49-F238E27FC236}">
-                <a16:creationId xmlns:a16="http://schemas.microsoft.com/office/drawing/2014/main" id="{8D120EA8-E27A-D0DD-C5B0-F34B5211FE48}"/>
-              </a:ext>
-            </a:extLst>
-          </p:cNvPr>
-          <p:cNvPicPr>
-            <a:picLocks noChangeAspect="1"/>
-          </p:cNvPicPr>
-          <p:nvPr/>
-        </p:nvPicPr>
-        <p:blipFill>
-          <a:blip r:embed="rId6"/>
-          <a:stretch>
-            <a:fillRect/>
-          </a:stretch>
-        </p:blipFill>
-        <p:spPr>
-          <a:xfrm flipH="1">
-            <a:off x="1109228" y="4248553"/>
-            <a:ext cx="467360" cy="559581"/>
-          </a:xfrm>
-          <a:prstGeom prst="rect">
-            <a:avLst/>
-          </a:prstGeom>
-        </p:spPr>
-      </p:pic>
-      <p:sp>
-        <p:nvSpPr>
-          <p:cNvPr id="43" name="Textfeld 48">
-            <a:extLst>
-              <a:ext uri="{FF2B5EF4-FFF2-40B4-BE49-F238E27FC236}">
-                <a16:creationId xmlns:a16="http://schemas.microsoft.com/office/drawing/2014/main" id="{2441BB71-C515-3F41-6A7B-CFE04B47BE00}"/>
-              </a:ext>
-            </a:extLst>
-          </p:cNvPr>
-          <p:cNvSpPr>
-            <a:spLocks/>
-          </p:cNvSpPr>
-          <p:nvPr/>
-        </p:nvSpPr>
-        <p:spPr>
-          <a:xfrm>
-            <a:off x="501206" y="3971554"/>
-            <a:ext cx="1733633" cy="276999"/>
-          </a:xfrm>
-          <a:prstGeom prst="rect">
-            <a:avLst/>
-          </a:prstGeom>
-          <a:noFill/>
-        </p:spPr>
-        <p:txBody>
-          <a:bodyPr wrap="square">
-            <a:spAutoFit/>
-          </a:bodyPr>
-          <a:lstStyle/>
-          <a:p>
-            <a:pPr algn="ctr">
-              <a:buNone/>
-            </a:pPr>
-            <a:r>
-              <a:rPr sz="1200"/>
-              <a:t>Information Extraction</a:t>
-            </a:r>
-          </a:p>
-        </p:txBody>
-      </p:sp>
-      <p:sp>
-        <p:nvSpPr>
-          <p:cNvPr id="44" name="Gerader Verbinder 43">
-            <a:extLst>
-              <a:ext uri="{FF2B5EF4-FFF2-40B4-BE49-F238E27FC236}">
-                <a16:creationId xmlns:a16="http://schemas.microsoft.com/office/drawing/2014/main" id="{6BF87FBA-FFD4-A870-8990-3B36EDECACE0}"/>
-              </a:ext>
-            </a:extLst>
-          </p:cNvPr>
-          <p:cNvSpPr>
-            <a:spLocks/>
-          </p:cNvSpPr>
-          <p:nvPr/>
-        </p:nvSpPr>
-        <p:spPr>
-          <a:xfrm>
-            <a:off x="513827" y="4248553"/>
-            <a:ext cx="1658163" cy="0"/>
-          </a:xfrm>
-          <a:prstGeom prst="line">
-            <a:avLst/>
-          </a:prstGeom>
-          <a:ln>
+            <a:ln>
+              <a:solidFill>
+                <a:schemeClr val="tx2"/>
+              </a:solidFill>
+            </a:ln>
+          </p:spPr>
+          <p:style>
+            <a:lnRef idx="2">
+              <a:schemeClr val="accent1">
+                <a:shade val="15000"/>
+              </a:schemeClr>
+            </a:lnRef>
+            <a:fillRef idx="1">
+              <a:schemeClr val="accent1"/>
+            </a:fillRef>
+            <a:effectRef idx="0">
+              <a:schemeClr val="accent1"/>
+            </a:effectRef>
+            <a:fontRef idx="minor">
+              <a:schemeClr val="lt1"/>
+            </a:fontRef>
+          </p:style>
+          <p:txBody>
+            <a:bodyPr anchor="ctr"/>
+            <a:lstStyle/>
+            <a:p>
+              <a:pPr algn="ctr">
+                <a:buNone/>
+              </a:pPr>
+              <a:endParaRPr/>
+            </a:p>
+          </p:txBody>
+        </p:sp>
+        <p:pic>
+          <p:nvPicPr>
+            <p:cNvPr id="104" name="Grafik 20">
+              <a:extLst>
+                <a:ext uri="{FF2B5EF4-FFF2-40B4-BE49-F238E27FC236}">
+                  <a16:creationId xmlns:a16="http://schemas.microsoft.com/office/drawing/2014/main" id="{45D89FC9-D1BB-FFF3-F2CC-C8155D4477FE}"/>
+                </a:ext>
+              </a:extLst>
+            </p:cNvPr>
+            <p:cNvPicPr>
+              <a:picLocks noChangeAspect="1"/>
+            </p:cNvPicPr>
+            <p:nvPr/>
+          </p:nvPicPr>
+          <p:blipFill>
+            <a:blip r:embed="rId10"/>
+            <a:stretch>
+              <a:fillRect/>
+            </a:stretch>
+          </p:blipFill>
+          <p:spPr>
+            <a:xfrm flipH="1">
+              <a:off x="8433628" y="5457857"/>
+              <a:ext cx="584924" cy="593680"/>
+            </a:xfrm>
+            <a:prstGeom prst="rect">
+              <a:avLst/>
+            </a:prstGeom>
+          </p:spPr>
+        </p:pic>
+        <p:sp>
+          <p:nvSpPr>
+            <p:cNvPr id="105" name="Textfeld 37">
+              <a:extLst>
+                <a:ext uri="{FF2B5EF4-FFF2-40B4-BE49-F238E27FC236}">
+                  <a16:creationId xmlns:a16="http://schemas.microsoft.com/office/drawing/2014/main" id="{50BD9ACB-9327-9657-F19C-720F9C5F935E}"/>
+                </a:ext>
+              </a:extLst>
+            </p:cNvPr>
+            <p:cNvSpPr>
+              <a:spLocks/>
+            </p:cNvSpPr>
+            <p:nvPr/>
+          </p:nvSpPr>
+          <p:spPr>
+            <a:xfrm>
+              <a:off x="8155543" y="5208159"/>
+              <a:ext cx="1128128" cy="276999"/>
+            </a:xfrm>
+            <a:prstGeom prst="rect">
+              <a:avLst/>
+            </a:prstGeom>
             <a:solidFill>
-              <a:schemeClr val="accent3"/>
+              <a:schemeClr val="accent6">
+                <a:lumMod val="40000"/>
+                <a:lumOff val="60000"/>
+              </a:schemeClr>
             </a:solidFill>
-          </a:ln>
-        </p:spPr>
-        <p:style>
-          <a:lnRef idx="1">
-            <a:schemeClr val="accent1"/>
-          </a:lnRef>
-          <a:fillRef idx="0">
-            <a:schemeClr val="accent1"/>
-          </a:fillRef>
-          <a:effectRef idx="0">
-            <a:schemeClr val="accent1"/>
-          </a:effectRef>
-          <a:fontRef idx="minor">
-            <a:schemeClr val="tx1"/>
-          </a:fontRef>
-        </p:style>
-        <p:txBody>
-          <a:bodyPr/>
-          <a:lstStyle/>
-          <a:p>
-            <a:endParaRPr lang="de-CH"/>
-          </a:p>
-        </p:txBody>
-      </p:sp>
-      <p:sp>
-        <p:nvSpPr>
-          <p:cNvPr id="45" name="Rechteck: abgerundete Ecken 44">
-            <a:extLst>
-              <a:ext uri="{FF2B5EF4-FFF2-40B4-BE49-F238E27FC236}">
-                <a16:creationId xmlns:a16="http://schemas.microsoft.com/office/drawing/2014/main" id="{D48A7F4F-BE6B-CD6F-E690-688E3245F2C5}"/>
-              </a:ext>
-            </a:extLst>
-          </p:cNvPr>
-          <p:cNvSpPr>
-            <a:spLocks/>
-          </p:cNvSpPr>
-          <p:nvPr/>
-        </p:nvSpPr>
-        <p:spPr>
-          <a:xfrm>
-            <a:off x="714375" y="2762250"/>
-            <a:ext cx="1259680" cy="866775"/>
-          </a:xfrm>
-          <a:prstGeom prst="roundRect">
-            <a:avLst/>
-          </a:prstGeom>
-          <a:solidFill>
-            <a:schemeClr val="accent2"/>
-          </a:solidFill>
-          <a:ln>
-            <a:solidFill>
-              <a:schemeClr val="accent3"/>
-            </a:solidFill>
-          </a:ln>
-        </p:spPr>
-        <p:style>
-          <a:lnRef idx="2">
-            <a:schemeClr val="accent1">
-              <a:shade val="15000"/>
-            </a:schemeClr>
-          </a:lnRef>
-          <a:fillRef idx="1">
-            <a:schemeClr val="accent1"/>
-          </a:fillRef>
-          <a:effectRef idx="0">
-            <a:schemeClr val="accent1"/>
-          </a:effectRef>
-          <a:fontRef idx="minor">
-            <a:schemeClr val="lt1"/>
-          </a:fontRef>
-        </p:style>
-        <p:txBody>
-          <a:bodyPr anchor="ctr"/>
-          <a:lstStyle/>
-          <a:p>
-            <a:pPr algn="ctr">
-              <a:buNone/>
-            </a:pPr>
-            <a:endParaRPr/>
-          </a:p>
-        </p:txBody>
-      </p:sp>
-      <p:sp>
-        <p:nvSpPr>
-          <p:cNvPr id="48" name="Textfeld 60">
-            <a:extLst>
-              <a:ext uri="{FF2B5EF4-FFF2-40B4-BE49-F238E27FC236}">
-                <a16:creationId xmlns:a16="http://schemas.microsoft.com/office/drawing/2014/main" id="{9300C327-65D2-42BB-19E9-6CBA235D48A3}"/>
-              </a:ext>
-            </a:extLst>
-          </p:cNvPr>
-          <p:cNvSpPr>
-            <a:spLocks/>
-          </p:cNvSpPr>
-          <p:nvPr/>
-        </p:nvSpPr>
-        <p:spPr>
-          <a:xfrm>
-            <a:off x="701754" y="2780929"/>
-            <a:ext cx="1259680" cy="276999"/>
-          </a:xfrm>
-          <a:prstGeom prst="rect">
-            <a:avLst/>
-          </a:prstGeom>
-          <a:noFill/>
-        </p:spPr>
-        <p:txBody>
-          <a:bodyPr wrap="square">
-            <a:spAutoFit/>
-          </a:bodyPr>
-          <a:lstStyle/>
-          <a:p>
-            <a:pPr algn="ctr">
-              <a:buNone/>
-            </a:pPr>
-            <a:r>
-              <a:rPr sz="1200"/>
-              <a:t>Chunking</a:t>
-            </a:r>
-          </a:p>
-        </p:txBody>
-      </p:sp>
-      <p:sp>
-        <p:nvSpPr>
-          <p:cNvPr id="51" name="Gerader Verbinder 50">
-            <a:extLst>
-              <a:ext uri="{FF2B5EF4-FFF2-40B4-BE49-F238E27FC236}">
-                <a16:creationId xmlns:a16="http://schemas.microsoft.com/office/drawing/2014/main" id="{329E3D98-43F4-135D-5087-525B26A0404F}"/>
-              </a:ext>
-            </a:extLst>
-          </p:cNvPr>
-          <p:cNvSpPr>
-            <a:spLocks/>
-          </p:cNvSpPr>
-          <p:nvPr/>
-        </p:nvSpPr>
-        <p:spPr>
-          <a:xfrm>
-            <a:off x="701754" y="3054904"/>
-            <a:ext cx="1272301" cy="0"/>
-          </a:xfrm>
-          <a:prstGeom prst="line">
-            <a:avLst/>
-          </a:prstGeom>
-          <a:ln>
-            <a:solidFill>
-              <a:schemeClr val="accent3"/>
-            </a:solidFill>
-          </a:ln>
-        </p:spPr>
-        <p:style>
-          <a:lnRef idx="1">
-            <a:schemeClr val="accent1"/>
-          </a:lnRef>
-          <a:fillRef idx="0">
-            <a:schemeClr val="accent1"/>
-          </a:fillRef>
-          <a:effectRef idx="0">
-            <a:schemeClr val="accent1"/>
-          </a:effectRef>
-          <a:fontRef idx="minor">
-            <a:schemeClr val="tx1"/>
-          </a:fontRef>
-        </p:style>
-        <p:txBody>
-          <a:bodyPr/>
-          <a:lstStyle/>
-          <a:p>
-            <a:endParaRPr lang="de-CH"/>
-          </a:p>
-        </p:txBody>
-      </p:sp>
-      <p:sp>
-        <p:nvSpPr>
-          <p:cNvPr id="54" name="Rechteck: abgerundete Ecken 53">
-            <a:extLst>
-              <a:ext uri="{FF2B5EF4-FFF2-40B4-BE49-F238E27FC236}">
-                <a16:creationId xmlns:a16="http://schemas.microsoft.com/office/drawing/2014/main" id="{F6937E87-FFDC-5644-BE6B-D3AF0FCBAA56}"/>
-              </a:ext>
-            </a:extLst>
-          </p:cNvPr>
-          <p:cNvSpPr>
-            <a:spLocks/>
-          </p:cNvSpPr>
-          <p:nvPr/>
-        </p:nvSpPr>
-        <p:spPr>
-          <a:xfrm>
-            <a:off x="5099404" y="1578909"/>
-            <a:ext cx="1259680" cy="866775"/>
-          </a:xfrm>
-          <a:prstGeom prst="roundRect">
-            <a:avLst/>
-          </a:prstGeom>
-          <a:solidFill>
-            <a:schemeClr val="accent2"/>
-          </a:solidFill>
-          <a:ln>
-            <a:solidFill>
-              <a:schemeClr val="accent3"/>
-            </a:solidFill>
-          </a:ln>
-        </p:spPr>
-        <p:style>
-          <a:lnRef idx="2">
-            <a:schemeClr val="accent1">
-              <a:shade val="15000"/>
-            </a:schemeClr>
-          </a:lnRef>
-          <a:fillRef idx="1">
-            <a:schemeClr val="accent1"/>
-          </a:fillRef>
-          <a:effectRef idx="0">
-            <a:schemeClr val="accent1"/>
-          </a:effectRef>
-          <a:fontRef idx="minor">
-            <a:schemeClr val="lt1"/>
-          </a:fontRef>
-        </p:style>
-        <p:txBody>
-          <a:bodyPr anchor="ctr"/>
-          <a:lstStyle/>
-          <a:p>
-            <a:pPr algn="ctr">
-              <a:buNone/>
-            </a:pPr>
-            <a:endParaRPr/>
-          </a:p>
-        </p:txBody>
-      </p:sp>
-      <p:pic>
-        <p:nvPicPr>
-          <p:cNvPr id="56" name="Grafik 33">
-            <a:extLst>
-              <a:ext uri="{FF2B5EF4-FFF2-40B4-BE49-F238E27FC236}">
-                <a16:creationId xmlns:a16="http://schemas.microsoft.com/office/drawing/2014/main" id="{4180022B-D146-7907-A8C7-659A2713F829}"/>
-              </a:ext>
-            </a:extLst>
-          </p:cNvPr>
-          <p:cNvPicPr>
-            <a:picLocks noChangeAspect="1"/>
-          </p:cNvPicPr>
-          <p:nvPr/>
-        </p:nvPicPr>
-        <p:blipFill>
-          <a:blip r:embed="rId7"/>
-          <a:stretch>
-            <a:fillRect/>
-          </a:stretch>
-        </p:blipFill>
-        <p:spPr>
-          <a:xfrm flipH="1">
-            <a:off x="5487815" y="1917819"/>
-            <a:ext cx="482858" cy="509226"/>
-          </a:xfrm>
-          <a:prstGeom prst="rect">
-            <a:avLst/>
-          </a:prstGeom>
-        </p:spPr>
-      </p:pic>
-      <p:sp>
-        <p:nvSpPr>
-          <p:cNvPr id="57" name="Textfeld 34">
-            <a:extLst>
-              <a:ext uri="{FF2B5EF4-FFF2-40B4-BE49-F238E27FC236}">
-                <a16:creationId xmlns:a16="http://schemas.microsoft.com/office/drawing/2014/main" id="{957FA4FE-DEF6-E882-2842-2649F9966023}"/>
-              </a:ext>
-            </a:extLst>
-          </p:cNvPr>
-          <p:cNvSpPr>
-            <a:spLocks/>
-          </p:cNvSpPr>
-          <p:nvPr/>
-        </p:nvSpPr>
-        <p:spPr>
-          <a:xfrm>
-            <a:off x="5086783" y="1597588"/>
-            <a:ext cx="1259680" cy="276999"/>
-          </a:xfrm>
-          <a:prstGeom prst="rect">
-            <a:avLst/>
-          </a:prstGeom>
-          <a:noFill/>
-        </p:spPr>
-        <p:txBody>
-          <a:bodyPr wrap="square">
-            <a:spAutoFit/>
-          </a:bodyPr>
-          <a:lstStyle/>
-          <a:p>
-            <a:pPr algn="ctr">
-              <a:buNone/>
-            </a:pPr>
-            <a:r>
-              <a:rPr sz="1200"/>
-              <a:t>Embedding</a:t>
-            </a:r>
-          </a:p>
-        </p:txBody>
-      </p:sp>
-      <p:sp>
-        <p:nvSpPr>
-          <p:cNvPr id="58" name="Gerader Verbinder 57">
-            <a:extLst>
-              <a:ext uri="{FF2B5EF4-FFF2-40B4-BE49-F238E27FC236}">
-                <a16:creationId xmlns:a16="http://schemas.microsoft.com/office/drawing/2014/main" id="{2358A794-930F-1800-2F3C-5B5ECED2E77E}"/>
-              </a:ext>
-            </a:extLst>
-          </p:cNvPr>
-          <p:cNvSpPr>
-            <a:spLocks/>
-          </p:cNvSpPr>
-          <p:nvPr/>
-        </p:nvSpPr>
-        <p:spPr>
-          <a:xfrm flipV="1">
-            <a:off x="5099404" y="1874587"/>
-            <a:ext cx="1259680" cy="12295"/>
-          </a:xfrm>
-          <a:prstGeom prst="line">
-            <a:avLst/>
-          </a:prstGeom>
-          <a:ln>
-            <a:solidFill>
-              <a:schemeClr val="accent3"/>
-            </a:solidFill>
-          </a:ln>
-        </p:spPr>
-        <p:style>
-          <a:lnRef idx="1">
-            <a:schemeClr val="accent1"/>
-          </a:lnRef>
-          <a:fillRef idx="0">
-            <a:schemeClr val="accent1"/>
-          </a:fillRef>
-          <a:effectRef idx="0">
-            <a:schemeClr val="accent1"/>
-          </a:effectRef>
-          <a:fontRef idx="minor">
-            <a:schemeClr val="tx1"/>
-          </a:fontRef>
-        </p:style>
-        <p:txBody>
-          <a:bodyPr/>
-          <a:lstStyle/>
-          <a:p>
-            <a:endParaRPr lang="de-CH"/>
-          </a:p>
-        </p:txBody>
-      </p:sp>
-      <p:sp>
-        <p:nvSpPr>
-          <p:cNvPr id="60" name="Rechteck: abgerundete Ecken 59">
-            <a:extLst>
-              <a:ext uri="{FF2B5EF4-FFF2-40B4-BE49-F238E27FC236}">
-                <a16:creationId xmlns:a16="http://schemas.microsoft.com/office/drawing/2014/main" id="{0F97695A-AB9E-12B2-E874-0BCD324FB8A7}"/>
-              </a:ext>
-            </a:extLst>
-          </p:cNvPr>
-          <p:cNvSpPr>
-            <a:spLocks/>
-          </p:cNvSpPr>
-          <p:nvPr/>
-        </p:nvSpPr>
-        <p:spPr>
-          <a:xfrm>
-            <a:off x="8096250" y="2776991"/>
-            <a:ext cx="1259680" cy="866775"/>
-          </a:xfrm>
-          <a:prstGeom prst="roundRect">
-            <a:avLst/>
-          </a:prstGeom>
-          <a:solidFill>
-            <a:schemeClr val="bg2"/>
-          </a:solidFill>
-          <a:ln>
-            <a:solidFill>
-              <a:schemeClr val="tx2"/>
-            </a:solidFill>
-          </a:ln>
-        </p:spPr>
-        <p:style>
-          <a:lnRef idx="2">
-            <a:schemeClr val="accent1">
-              <a:shade val="15000"/>
-            </a:schemeClr>
-          </a:lnRef>
-          <a:fillRef idx="1">
-            <a:schemeClr val="accent1"/>
-          </a:fillRef>
-          <a:effectRef idx="0">
-            <a:schemeClr val="accent1"/>
-          </a:effectRef>
-          <a:fontRef idx="minor">
-            <a:schemeClr val="lt1"/>
-          </a:fontRef>
-        </p:style>
-        <p:txBody>
-          <a:bodyPr anchor="ctr"/>
-          <a:lstStyle/>
-          <a:p>
-            <a:pPr algn="ctr">
-              <a:buNone/>
-            </a:pPr>
-            <a:endParaRPr/>
-          </a:p>
-        </p:txBody>
-      </p:sp>
-      <p:pic>
-        <p:nvPicPr>
-          <p:cNvPr id="63" name="Grafik 12">
-            <a:extLst>
-              <a:ext uri="{FF2B5EF4-FFF2-40B4-BE49-F238E27FC236}">
-                <a16:creationId xmlns:a16="http://schemas.microsoft.com/office/drawing/2014/main" id="{E86CBA64-1F16-70AF-49B8-BA3DAF1F453E}"/>
-              </a:ext>
-            </a:extLst>
-          </p:cNvPr>
-          <p:cNvPicPr>
-            <a:picLocks noChangeAspect="1"/>
-          </p:cNvPicPr>
-          <p:nvPr/>
-        </p:nvPicPr>
-        <p:blipFill>
-          <a:blip r:embed="rId7"/>
-          <a:stretch>
-            <a:fillRect/>
-          </a:stretch>
-        </p:blipFill>
-        <p:spPr>
-          <a:xfrm flipH="1">
-            <a:off x="8455327" y="3084965"/>
-            <a:ext cx="541526" cy="571097"/>
-          </a:xfrm>
-          <a:prstGeom prst="rect">
-            <a:avLst/>
-          </a:prstGeom>
-        </p:spPr>
-      </p:pic>
-      <p:sp>
-        <p:nvSpPr>
-          <p:cNvPr id="67" name="Textfeld 31">
-            <a:extLst>
-              <a:ext uri="{FF2B5EF4-FFF2-40B4-BE49-F238E27FC236}">
-                <a16:creationId xmlns:a16="http://schemas.microsoft.com/office/drawing/2014/main" id="{93602E7B-DC37-F2CD-0924-065EFB64C7BA}"/>
-              </a:ext>
-            </a:extLst>
-          </p:cNvPr>
-          <p:cNvSpPr>
-            <a:spLocks/>
-          </p:cNvSpPr>
-          <p:nvPr/>
-        </p:nvSpPr>
-        <p:spPr>
-          <a:xfrm>
-            <a:off x="8083629" y="2795670"/>
-            <a:ext cx="1259680" cy="276999"/>
-          </a:xfrm>
-          <a:prstGeom prst="rect">
-            <a:avLst/>
-          </a:prstGeom>
-          <a:noFill/>
-        </p:spPr>
-        <p:txBody>
-          <a:bodyPr wrap="square">
-            <a:spAutoFit/>
-          </a:bodyPr>
-          <a:lstStyle/>
-          <a:p>
-            <a:pPr algn="ctr">
-              <a:buNone/>
-            </a:pPr>
-            <a:r>
-              <a:rPr sz="1200"/>
-              <a:t>Embedding</a:t>
-            </a:r>
-          </a:p>
-        </p:txBody>
-      </p:sp>
-      <p:sp>
-        <p:nvSpPr>
-          <p:cNvPr id="69" name="Gerader Verbinder 68">
-            <a:extLst>
-              <a:ext uri="{FF2B5EF4-FFF2-40B4-BE49-F238E27FC236}">
-                <a16:creationId xmlns:a16="http://schemas.microsoft.com/office/drawing/2014/main" id="{919036DE-C489-76A0-3FDD-88C13187B396}"/>
-              </a:ext>
-            </a:extLst>
-          </p:cNvPr>
-          <p:cNvSpPr>
-            <a:spLocks/>
-          </p:cNvSpPr>
-          <p:nvPr/>
-        </p:nvSpPr>
-        <p:spPr>
-          <a:xfrm flipV="1">
-            <a:off x="8096250" y="3072669"/>
-            <a:ext cx="1259680" cy="12296"/>
-          </a:xfrm>
-          <a:prstGeom prst="line">
-            <a:avLst/>
-          </a:prstGeom>
-          <a:ln>
-            <a:solidFill>
-              <a:schemeClr val="tx2"/>
-            </a:solidFill>
-          </a:ln>
-        </p:spPr>
-        <p:style>
-          <a:lnRef idx="1">
-            <a:schemeClr val="accent1"/>
-          </a:lnRef>
-          <a:fillRef idx="0">
-            <a:schemeClr val="accent1"/>
-          </a:fillRef>
-          <a:effectRef idx="0">
-            <a:schemeClr val="accent1"/>
-          </a:effectRef>
-          <a:fontRef idx="minor">
-            <a:schemeClr val="tx1"/>
-          </a:fontRef>
-        </p:style>
-        <p:txBody>
-          <a:bodyPr/>
-          <a:lstStyle/>
-          <a:p>
-            <a:endParaRPr lang="de-CH"/>
-          </a:p>
-        </p:txBody>
-      </p:sp>
-      <p:sp>
-        <p:nvSpPr>
-          <p:cNvPr id="72" name="Rechteck: abgerundete Ecken 71">
-            <a:extLst>
-              <a:ext uri="{FF2B5EF4-FFF2-40B4-BE49-F238E27FC236}">
-                <a16:creationId xmlns:a16="http://schemas.microsoft.com/office/drawing/2014/main" id="{E9A14601-129B-5663-F0ED-B2E1BD20F945}"/>
-              </a:ext>
-            </a:extLst>
-          </p:cNvPr>
-          <p:cNvSpPr>
-            <a:spLocks/>
-          </p:cNvSpPr>
-          <p:nvPr/>
-        </p:nvSpPr>
-        <p:spPr>
-          <a:xfrm>
-            <a:off x="5095875" y="2776991"/>
-            <a:ext cx="1259680" cy="866775"/>
-          </a:xfrm>
-          <a:prstGeom prst="roundRect">
-            <a:avLst/>
-          </a:prstGeom>
-          <a:solidFill>
-            <a:schemeClr val="bg2"/>
-          </a:solidFill>
-          <a:ln>
-            <a:solidFill>
-              <a:schemeClr val="tx2"/>
-            </a:solidFill>
-          </a:ln>
-        </p:spPr>
-        <p:style>
-          <a:lnRef idx="2">
-            <a:schemeClr val="accent1">
-              <a:shade val="15000"/>
-            </a:schemeClr>
-          </a:lnRef>
-          <a:fillRef idx="1">
-            <a:schemeClr val="accent1"/>
-          </a:fillRef>
-          <a:effectRef idx="0">
-            <a:schemeClr val="accent1"/>
-          </a:effectRef>
-          <a:fontRef idx="minor">
-            <a:schemeClr val="lt1"/>
-          </a:fontRef>
-        </p:style>
-        <p:txBody>
-          <a:bodyPr anchor="ctr"/>
-          <a:lstStyle/>
-          <a:p>
-            <a:pPr algn="ctr">
-              <a:buNone/>
-            </a:pPr>
-            <a:endParaRPr/>
-          </a:p>
-        </p:txBody>
-      </p:sp>
-      <p:pic>
-        <p:nvPicPr>
-          <p:cNvPr id="74" name="Grafik 14">
-            <a:extLst>
-              <a:ext uri="{FF2B5EF4-FFF2-40B4-BE49-F238E27FC236}">
-                <a16:creationId xmlns:a16="http://schemas.microsoft.com/office/drawing/2014/main" id="{C9AA9F1F-BE1C-5F83-5671-91EF5A5DC37F}"/>
-              </a:ext>
-            </a:extLst>
-          </p:cNvPr>
-          <p:cNvPicPr>
-            <a:picLocks noChangeAspect="1"/>
-          </p:cNvPicPr>
-          <p:nvPr/>
-        </p:nvPicPr>
-        <p:blipFill>
-          <a:blip r:embed="rId8"/>
-          <a:stretch>
-            <a:fillRect/>
-          </a:stretch>
-        </p:blipFill>
-        <p:spPr>
-          <a:xfrm flipH="1">
-            <a:off x="5440897" y="3157787"/>
-            <a:ext cx="560002" cy="485980"/>
-          </a:xfrm>
-          <a:prstGeom prst="rect">
-            <a:avLst/>
-          </a:prstGeom>
-        </p:spPr>
-      </p:pic>
-      <p:sp>
-        <p:nvSpPr>
-          <p:cNvPr id="77" name="Textfeld 25">
-            <a:extLst>
-              <a:ext uri="{FF2B5EF4-FFF2-40B4-BE49-F238E27FC236}">
-                <a16:creationId xmlns:a16="http://schemas.microsoft.com/office/drawing/2014/main" id="{1C80D23E-AF36-ADDD-DF87-F60A5AC8096B}"/>
-              </a:ext>
-            </a:extLst>
-          </p:cNvPr>
-          <p:cNvSpPr>
-            <a:spLocks/>
-          </p:cNvSpPr>
-          <p:nvPr/>
-        </p:nvSpPr>
-        <p:spPr>
-          <a:xfrm>
-            <a:off x="5083254" y="2795670"/>
-            <a:ext cx="1341782" cy="285750"/>
-          </a:xfrm>
-          <a:prstGeom prst="rect">
-            <a:avLst/>
-          </a:prstGeom>
-          <a:noFill/>
-        </p:spPr>
-        <p:txBody>
-          <a:bodyPr wrap="square">
-            <a:spAutoFit/>
-          </a:bodyPr>
-          <a:lstStyle/>
-          <a:p>
-            <a:pPr algn="ctr">
-              <a:buNone/>
-            </a:pPr>
-            <a:r>
-              <a:rPr sz="1200" dirty="0"/>
-              <a:t>Vector Database</a:t>
-            </a:r>
-          </a:p>
-        </p:txBody>
-      </p:sp>
-      <p:sp>
-        <p:nvSpPr>
-          <p:cNvPr id="79" name="Gerader Verbinder 78">
-            <a:extLst>
-              <a:ext uri="{FF2B5EF4-FFF2-40B4-BE49-F238E27FC236}">
-                <a16:creationId xmlns:a16="http://schemas.microsoft.com/office/drawing/2014/main" id="{89A0E0B7-A2BB-83F8-DDEA-7BF8AF689E44}"/>
-              </a:ext>
-            </a:extLst>
-          </p:cNvPr>
-          <p:cNvSpPr>
-            <a:spLocks/>
-          </p:cNvSpPr>
-          <p:nvPr/>
-        </p:nvSpPr>
-        <p:spPr>
-          <a:xfrm>
-            <a:off x="5095875" y="3081420"/>
-            <a:ext cx="1252223" cy="0"/>
-          </a:xfrm>
-          <a:prstGeom prst="line">
-            <a:avLst/>
-          </a:prstGeom>
-          <a:ln>
-            <a:solidFill>
-              <a:schemeClr val="tx2"/>
-            </a:solidFill>
-          </a:ln>
-        </p:spPr>
-        <p:style>
-          <a:lnRef idx="1">
-            <a:schemeClr val="accent1"/>
-          </a:lnRef>
-          <a:fillRef idx="0">
-            <a:schemeClr val="accent1"/>
-          </a:fillRef>
-          <a:effectRef idx="0">
-            <a:schemeClr val="accent1"/>
-          </a:effectRef>
-          <a:fontRef idx="minor">
-            <a:schemeClr val="tx1"/>
-          </a:fontRef>
-        </p:style>
-        <p:txBody>
-          <a:bodyPr/>
-          <a:lstStyle/>
-          <a:p>
-            <a:endParaRPr lang="de-CH"/>
-          </a:p>
-        </p:txBody>
-      </p:sp>
-      <p:sp>
-        <p:nvSpPr>
-          <p:cNvPr id="81" name="Rechteck: abgerundete Ecken 80">
-            <a:extLst>
-              <a:ext uri="{FF2B5EF4-FFF2-40B4-BE49-F238E27FC236}">
-                <a16:creationId xmlns:a16="http://schemas.microsoft.com/office/drawing/2014/main" id="{299209A1-E60D-B54F-BCE0-B59442B6BA9E}"/>
-              </a:ext>
-            </a:extLst>
-          </p:cNvPr>
-          <p:cNvSpPr>
-            <a:spLocks/>
-          </p:cNvSpPr>
-          <p:nvPr/>
-        </p:nvSpPr>
-        <p:spPr>
-          <a:xfrm>
-            <a:off x="5095875" y="5162179"/>
-            <a:ext cx="1259680" cy="866775"/>
-          </a:xfrm>
-          <a:prstGeom prst="roundRect">
-            <a:avLst/>
-          </a:prstGeom>
-          <a:solidFill>
-            <a:schemeClr val="bg2"/>
-          </a:solidFill>
-          <a:ln>
-            <a:solidFill>
-              <a:schemeClr val="tx2"/>
-            </a:solidFill>
-          </a:ln>
-        </p:spPr>
-        <p:style>
-          <a:lnRef idx="2">
-            <a:schemeClr val="accent1">
-              <a:shade val="15000"/>
-            </a:schemeClr>
-          </a:lnRef>
-          <a:fillRef idx="1">
-            <a:schemeClr val="accent1"/>
-          </a:fillRef>
-          <a:effectRef idx="0">
-            <a:schemeClr val="accent1"/>
-          </a:effectRef>
-          <a:fontRef idx="minor">
-            <a:schemeClr val="lt1"/>
-          </a:fontRef>
-        </p:style>
-        <p:txBody>
-          <a:bodyPr anchor="ctr"/>
-          <a:lstStyle/>
-          <a:p>
-            <a:pPr algn="ctr">
-              <a:buNone/>
-            </a:pPr>
-            <a:endParaRPr/>
-          </a:p>
-        </p:txBody>
-      </p:sp>
-      <p:pic>
-        <p:nvPicPr>
-          <p:cNvPr id="84" name="Grafik 18">
-            <a:extLst>
-              <a:ext uri="{FF2B5EF4-FFF2-40B4-BE49-F238E27FC236}">
-                <a16:creationId xmlns:a16="http://schemas.microsoft.com/office/drawing/2014/main" id="{75982C35-E39A-47E4-7B79-4694BEFA0FBF}"/>
-              </a:ext>
-            </a:extLst>
-          </p:cNvPr>
-          <p:cNvPicPr>
-            <a:picLocks noChangeAspect="1"/>
-          </p:cNvPicPr>
-          <p:nvPr/>
-        </p:nvPicPr>
-        <p:blipFill>
-          <a:blip r:embed="rId9"/>
-          <a:stretch>
-            <a:fillRect/>
-          </a:stretch>
-        </p:blipFill>
-        <p:spPr>
-          <a:xfrm flipH="1">
-            <a:off x="5365621" y="5429497"/>
-            <a:ext cx="694946" cy="618136"/>
-          </a:xfrm>
-          <a:prstGeom prst="rect">
-            <a:avLst/>
-          </a:prstGeom>
-        </p:spPr>
-      </p:pic>
-      <p:sp>
-        <p:nvSpPr>
-          <p:cNvPr id="87" name="Textfeld 28">
-            <a:extLst>
-              <a:ext uri="{FF2B5EF4-FFF2-40B4-BE49-F238E27FC236}">
-                <a16:creationId xmlns:a16="http://schemas.microsoft.com/office/drawing/2014/main" id="{97FD2241-5B61-D9A8-9B5C-DE6B07A2BCBE}"/>
-              </a:ext>
-            </a:extLst>
-          </p:cNvPr>
-          <p:cNvSpPr>
-            <a:spLocks/>
-          </p:cNvSpPr>
-          <p:nvPr/>
-        </p:nvSpPr>
-        <p:spPr>
-          <a:xfrm>
-            <a:off x="5083254" y="5180858"/>
-            <a:ext cx="1259680" cy="276999"/>
-          </a:xfrm>
-          <a:prstGeom prst="rect">
-            <a:avLst/>
-          </a:prstGeom>
-          <a:noFill/>
-        </p:spPr>
-        <p:txBody>
-          <a:bodyPr wrap="square">
-            <a:spAutoFit/>
-          </a:bodyPr>
-          <a:lstStyle/>
-          <a:p>
-            <a:pPr algn="ctr">
-              <a:buNone/>
-            </a:pPr>
-            <a:r>
-              <a:rPr sz="1200"/>
-              <a:t>Relevant Data</a:t>
-            </a:r>
-          </a:p>
-        </p:txBody>
-      </p:sp>
-      <p:sp>
-        <p:nvSpPr>
-          <p:cNvPr id="90" name="Gerader Verbinder 89">
-            <a:extLst>
-              <a:ext uri="{FF2B5EF4-FFF2-40B4-BE49-F238E27FC236}">
-                <a16:creationId xmlns:a16="http://schemas.microsoft.com/office/drawing/2014/main" id="{28E3CEA1-5C20-114C-95BF-87C047395FE4}"/>
-              </a:ext>
-            </a:extLst>
-          </p:cNvPr>
-          <p:cNvSpPr>
-            <a:spLocks/>
-          </p:cNvSpPr>
-          <p:nvPr/>
-        </p:nvSpPr>
-        <p:spPr>
-          <a:xfrm>
-            <a:off x="5083254" y="5457857"/>
-            <a:ext cx="1259680" cy="0"/>
-          </a:xfrm>
-          <a:prstGeom prst="line">
-            <a:avLst/>
-          </a:prstGeom>
-          <a:ln>
-            <a:solidFill>
-              <a:schemeClr val="tx2"/>
-            </a:solidFill>
-          </a:ln>
-        </p:spPr>
-        <p:style>
-          <a:lnRef idx="1">
-            <a:schemeClr val="accent1"/>
-          </a:lnRef>
-          <a:fillRef idx="0">
-            <a:schemeClr val="accent1"/>
-          </a:fillRef>
-          <a:effectRef idx="0">
-            <a:schemeClr val="accent1"/>
-          </a:effectRef>
-          <a:fontRef idx="minor">
-            <a:schemeClr val="tx1"/>
-          </a:fontRef>
-        </p:style>
-        <p:txBody>
-          <a:bodyPr/>
-          <a:lstStyle/>
-          <a:p>
-            <a:endParaRPr lang="de-CH"/>
-          </a:p>
-        </p:txBody>
-      </p:sp>
-      <p:sp>
-        <p:nvSpPr>
-          <p:cNvPr id="93" name="Rechteck: abgerundete Ecken 92">
-            <a:extLst>
-              <a:ext uri="{FF2B5EF4-FFF2-40B4-BE49-F238E27FC236}">
-                <a16:creationId xmlns:a16="http://schemas.microsoft.com/office/drawing/2014/main" id="{AD79A1D2-E83B-1112-88E6-A41F8B4E30C4}"/>
-              </a:ext>
-            </a:extLst>
-          </p:cNvPr>
-          <p:cNvSpPr>
-            <a:spLocks/>
-          </p:cNvSpPr>
-          <p:nvPr/>
-        </p:nvSpPr>
-        <p:spPr>
-          <a:xfrm>
-            <a:off x="8086202" y="1571625"/>
-            <a:ext cx="1259680" cy="866775"/>
-          </a:xfrm>
-          <a:prstGeom prst="roundRect">
-            <a:avLst/>
-          </a:prstGeom>
-          <a:solidFill>
-            <a:schemeClr val="accent6">
-              <a:lumMod val="40000"/>
-              <a:lumOff val="60000"/>
-            </a:schemeClr>
-          </a:solidFill>
-          <a:ln>
-            <a:solidFill>
-              <a:schemeClr val="tx2"/>
-            </a:solidFill>
-          </a:ln>
-        </p:spPr>
-        <p:style>
-          <a:lnRef idx="2">
-            <a:schemeClr val="accent1">
-              <a:shade val="15000"/>
-            </a:schemeClr>
-          </a:lnRef>
-          <a:fillRef idx="1">
-            <a:schemeClr val="accent1"/>
-          </a:fillRef>
-          <a:effectRef idx="0">
-            <a:schemeClr val="accent1"/>
-          </a:effectRef>
-          <a:fontRef idx="minor">
-            <a:schemeClr val="lt1"/>
-          </a:fontRef>
-        </p:style>
-        <p:txBody>
-          <a:bodyPr anchor="ctr"/>
-          <a:lstStyle/>
-          <a:p>
-            <a:pPr algn="ctr">
-              <a:buNone/>
-            </a:pPr>
-            <a:endParaRPr/>
-          </a:p>
-        </p:txBody>
-      </p:sp>
-      <p:pic>
-        <p:nvPicPr>
-          <p:cNvPr id="96" name="Grafik 39">
-            <a:extLst>
-              <a:ext uri="{FF2B5EF4-FFF2-40B4-BE49-F238E27FC236}">
-                <a16:creationId xmlns:a16="http://schemas.microsoft.com/office/drawing/2014/main" id="{61249CC0-2AE7-1CF4-AF70-7499619794AF}"/>
-              </a:ext>
-            </a:extLst>
-          </p:cNvPr>
-          <p:cNvPicPr>
-            <a:picLocks noChangeAspect="1"/>
-          </p:cNvPicPr>
-          <p:nvPr/>
-        </p:nvPicPr>
-        <p:blipFill>
-          <a:blip r:embed="rId10"/>
-          <a:stretch>
-            <a:fillRect/>
-          </a:stretch>
-        </p:blipFill>
-        <p:spPr>
-          <a:xfrm flipH="1">
-            <a:off x="8453013" y="1893252"/>
-            <a:ext cx="533792" cy="541782"/>
-          </a:xfrm>
-          <a:prstGeom prst="rect">
-            <a:avLst/>
-          </a:prstGeom>
-        </p:spPr>
-      </p:pic>
-      <p:sp>
-        <p:nvSpPr>
-          <p:cNvPr id="99" name="Textfeld 40">
-            <a:extLst>
-              <a:ext uri="{FF2B5EF4-FFF2-40B4-BE49-F238E27FC236}">
-                <a16:creationId xmlns:a16="http://schemas.microsoft.com/office/drawing/2014/main" id="{39ADD9CF-0CDD-69E9-2A07-C125FCAA3B7D}"/>
-              </a:ext>
-            </a:extLst>
-          </p:cNvPr>
-          <p:cNvSpPr>
-            <a:spLocks/>
-          </p:cNvSpPr>
-          <p:nvPr/>
-        </p:nvSpPr>
-        <p:spPr>
-          <a:xfrm>
-            <a:off x="8040401" y="1571625"/>
-            <a:ext cx="1414131" cy="276999"/>
-          </a:xfrm>
-          <a:prstGeom prst="rect">
-            <a:avLst/>
-          </a:prstGeom>
-          <a:noFill/>
-        </p:spPr>
-        <p:txBody>
-          <a:bodyPr wrap="square">
-            <a:spAutoFit/>
-          </a:bodyPr>
-          <a:lstStyle/>
-          <a:p>
-            <a:pPr algn="ctr">
-              <a:buNone/>
-            </a:pPr>
-            <a:r>
-              <a:rPr sz="1200" dirty="0"/>
-              <a:t>Embedding LLM</a:t>
-            </a:r>
-          </a:p>
-        </p:txBody>
-      </p:sp>
-      <p:sp>
-        <p:nvSpPr>
-          <p:cNvPr id="101" name="Gerader Verbinder 100">
-            <a:extLst>
-              <a:ext uri="{FF2B5EF4-FFF2-40B4-BE49-F238E27FC236}">
-                <a16:creationId xmlns:a16="http://schemas.microsoft.com/office/drawing/2014/main" id="{E72F8E13-9942-DFD0-1B23-F1C4A1D4EC76}"/>
-              </a:ext>
-            </a:extLst>
-          </p:cNvPr>
-          <p:cNvSpPr>
-            <a:spLocks/>
-          </p:cNvSpPr>
-          <p:nvPr/>
-        </p:nvSpPr>
-        <p:spPr>
-          <a:xfrm>
-            <a:off x="8086202" y="1855424"/>
-            <a:ext cx="1259680" cy="0"/>
-          </a:xfrm>
-          <a:prstGeom prst="line">
-            <a:avLst/>
-          </a:prstGeom>
-          <a:ln>
-            <a:solidFill>
-              <a:schemeClr val="tx2"/>
-            </a:solidFill>
-          </a:ln>
-        </p:spPr>
-        <p:style>
-          <a:lnRef idx="1">
-            <a:schemeClr val="accent1"/>
-          </a:lnRef>
-          <a:fillRef idx="0">
-            <a:schemeClr val="accent1"/>
-          </a:fillRef>
-          <a:effectRef idx="0">
-            <a:schemeClr val="accent1"/>
-          </a:effectRef>
-          <a:fontRef idx="minor">
-            <a:schemeClr val="tx1"/>
-          </a:fontRef>
-        </p:style>
-        <p:txBody>
-          <a:bodyPr/>
-          <a:lstStyle/>
-          <a:p>
-            <a:endParaRPr lang="de-CH"/>
-          </a:p>
-        </p:txBody>
-      </p:sp>
-      <p:sp>
-        <p:nvSpPr>
-          <p:cNvPr id="102" name="Rechteck: abgerundete Ecken 101">
-            <a:extLst>
-              <a:ext uri="{FF2B5EF4-FFF2-40B4-BE49-F238E27FC236}">
-                <a16:creationId xmlns:a16="http://schemas.microsoft.com/office/drawing/2014/main" id="{CCD2EF0F-009E-7BB9-2850-8D80476CA421}"/>
-              </a:ext>
-            </a:extLst>
-          </p:cNvPr>
-          <p:cNvSpPr>
-            <a:spLocks/>
-          </p:cNvSpPr>
-          <p:nvPr/>
-        </p:nvSpPr>
-        <p:spPr>
-          <a:xfrm>
-            <a:off x="8096250" y="5162179"/>
-            <a:ext cx="1259680" cy="866775"/>
-          </a:xfrm>
-          <a:prstGeom prst="roundRect">
-            <a:avLst/>
-          </a:prstGeom>
-          <a:solidFill>
-            <a:schemeClr val="accent6">
-              <a:lumMod val="40000"/>
-              <a:lumOff val="60000"/>
-            </a:schemeClr>
-          </a:solidFill>
-          <a:ln>
-            <a:solidFill>
-              <a:schemeClr val="tx2"/>
-            </a:solidFill>
-          </a:ln>
-        </p:spPr>
-        <p:style>
-          <a:lnRef idx="2">
-            <a:schemeClr val="accent1">
-              <a:shade val="15000"/>
-            </a:schemeClr>
-          </a:lnRef>
-          <a:fillRef idx="1">
-            <a:schemeClr val="accent1"/>
-          </a:fillRef>
-          <a:effectRef idx="0">
-            <a:schemeClr val="accent1"/>
-          </a:effectRef>
-          <a:fontRef idx="minor">
-            <a:schemeClr val="lt1"/>
-          </a:fontRef>
-        </p:style>
-        <p:txBody>
-          <a:bodyPr anchor="ctr"/>
-          <a:lstStyle/>
-          <a:p>
-            <a:pPr algn="ctr">
-              <a:buNone/>
-            </a:pPr>
-            <a:endParaRPr/>
-          </a:p>
-        </p:txBody>
-      </p:sp>
-      <p:pic>
-        <p:nvPicPr>
-          <p:cNvPr id="104" name="Grafik 20">
-            <a:extLst>
-              <a:ext uri="{FF2B5EF4-FFF2-40B4-BE49-F238E27FC236}">
-                <a16:creationId xmlns:a16="http://schemas.microsoft.com/office/drawing/2014/main" id="{45D89FC9-D1BB-FFF3-F2CC-C8155D4477FE}"/>
-              </a:ext>
-            </a:extLst>
-          </p:cNvPr>
-          <p:cNvPicPr>
-            <a:picLocks noChangeAspect="1"/>
-          </p:cNvPicPr>
-          <p:nvPr/>
-        </p:nvPicPr>
-        <p:blipFill>
-          <a:blip r:embed="rId10"/>
-          <a:stretch>
-            <a:fillRect/>
-          </a:stretch>
-        </p:blipFill>
-        <p:spPr>
-          <a:xfrm flipH="1">
-            <a:off x="8437495" y="5457857"/>
-            <a:ext cx="584924" cy="593680"/>
-          </a:xfrm>
-          <a:prstGeom prst="rect">
-            <a:avLst/>
-          </a:prstGeom>
-        </p:spPr>
-      </p:pic>
-      <p:sp>
-        <p:nvSpPr>
-          <p:cNvPr id="105" name="Textfeld 37">
-            <a:extLst>
-              <a:ext uri="{FF2B5EF4-FFF2-40B4-BE49-F238E27FC236}">
-                <a16:creationId xmlns:a16="http://schemas.microsoft.com/office/drawing/2014/main" id="{50BD9ACB-9327-9657-F19C-720F9C5F935E}"/>
-              </a:ext>
-            </a:extLst>
-          </p:cNvPr>
-          <p:cNvSpPr>
-            <a:spLocks/>
-          </p:cNvSpPr>
-          <p:nvPr/>
-        </p:nvSpPr>
-        <p:spPr>
-          <a:xfrm>
-            <a:off x="8155543" y="5208159"/>
-            <a:ext cx="1128128" cy="276999"/>
-          </a:xfrm>
-          <a:prstGeom prst="rect">
-            <a:avLst/>
-          </a:prstGeom>
-          <a:solidFill>
-            <a:schemeClr val="accent6">
-              <a:lumMod val="40000"/>
-              <a:lumOff val="60000"/>
-            </a:schemeClr>
-          </a:solidFill>
-          <a:ln>
-            <a:noFill/>
-          </a:ln>
-        </p:spPr>
-        <p:txBody>
-          <a:bodyPr wrap="square">
-            <a:spAutoFit/>
-          </a:bodyPr>
-          <a:lstStyle/>
-          <a:p>
-            <a:pPr algn="ctr">
-              <a:buNone/>
-            </a:pPr>
-            <a:r>
-              <a:rPr sz="1200"/>
-              <a:t>LLM</a:t>
-            </a:r>
-          </a:p>
-        </p:txBody>
-      </p:sp>
-      <p:sp>
-        <p:nvSpPr>
-          <p:cNvPr id="106" name="Gerader Verbinder 105">
-            <a:extLst>
-              <a:ext uri="{FF2B5EF4-FFF2-40B4-BE49-F238E27FC236}">
-                <a16:creationId xmlns:a16="http://schemas.microsoft.com/office/drawing/2014/main" id="{C25ABEB4-F7C7-3DF5-DEEF-6DD6C45FCF01}"/>
-              </a:ext>
-            </a:extLst>
-          </p:cNvPr>
-          <p:cNvSpPr>
-            <a:spLocks/>
-          </p:cNvSpPr>
-          <p:nvPr/>
-        </p:nvSpPr>
-        <p:spPr>
-          <a:xfrm flipV="1">
-            <a:off x="8083629" y="5450740"/>
-            <a:ext cx="1272301" cy="7117"/>
-          </a:xfrm>
-          <a:prstGeom prst="line">
-            <a:avLst/>
-          </a:prstGeom>
-          <a:ln>
-            <a:solidFill>
-              <a:schemeClr val="tx2"/>
-            </a:solidFill>
-          </a:ln>
-        </p:spPr>
-        <p:style>
-          <a:lnRef idx="1">
-            <a:schemeClr val="accent1"/>
-          </a:lnRef>
-          <a:fillRef idx="0">
-            <a:schemeClr val="accent1"/>
-          </a:fillRef>
-          <a:effectRef idx="0">
-            <a:schemeClr val="accent1"/>
-          </a:effectRef>
-          <a:fontRef idx="minor">
-            <a:schemeClr val="tx1"/>
-          </a:fontRef>
-        </p:style>
-        <p:txBody>
-          <a:bodyPr/>
-          <a:lstStyle/>
-          <a:p>
-            <a:endParaRPr lang="de-CH"/>
-          </a:p>
-        </p:txBody>
-      </p:sp>
+            <a:ln>
+              <a:noFill/>
+            </a:ln>
+          </p:spPr>
+          <p:txBody>
+            <a:bodyPr wrap="square">
+              <a:spAutoFit/>
+            </a:bodyPr>
+            <a:lstStyle/>
+            <a:p>
+              <a:pPr algn="ctr">
+                <a:buNone/>
+              </a:pPr>
+              <a:r>
+                <a:rPr sz="1200"/>
+                <a:t>LLM</a:t>
+              </a:r>
+            </a:p>
+          </p:txBody>
+        </p:sp>
+        <p:sp>
+          <p:nvSpPr>
+            <p:cNvPr id="106" name="Gerader Verbinder 105">
+              <a:extLst>
+                <a:ext uri="{FF2B5EF4-FFF2-40B4-BE49-F238E27FC236}">
+                  <a16:creationId xmlns:a16="http://schemas.microsoft.com/office/drawing/2014/main" id="{C25ABEB4-F7C7-3DF5-DEEF-6DD6C45FCF01}"/>
+                </a:ext>
+              </a:extLst>
+            </p:cNvPr>
+            <p:cNvSpPr>
+              <a:spLocks/>
+            </p:cNvSpPr>
+            <p:nvPr/>
+          </p:nvSpPr>
+          <p:spPr>
+            <a:xfrm flipV="1">
+              <a:off x="8096250" y="5450740"/>
+              <a:ext cx="1259680" cy="0"/>
+            </a:xfrm>
+            <a:prstGeom prst="line">
+              <a:avLst/>
+            </a:prstGeom>
+            <a:ln>
+              <a:solidFill>
+                <a:schemeClr val="tx2"/>
+              </a:solidFill>
+            </a:ln>
+          </p:spPr>
+          <p:style>
+            <a:lnRef idx="1">
+              <a:schemeClr val="accent1"/>
+            </a:lnRef>
+            <a:fillRef idx="0">
+              <a:schemeClr val="accent1"/>
+            </a:fillRef>
+            <a:effectRef idx="0">
+              <a:schemeClr val="accent1"/>
+            </a:effectRef>
+            <a:fontRef idx="minor">
+              <a:schemeClr val="tx1"/>
+            </a:fontRef>
+          </p:style>
+          <p:txBody>
+            <a:bodyPr/>
+            <a:lstStyle/>
+            <a:p>
+              <a:endParaRPr lang="de-CH"/>
+            </a:p>
+          </p:txBody>
+        </p:sp>
+      </p:grpSp>
       <p:cxnSp>
         <p:nvCxnSpPr>
           <p:cNvPr id="107" name="Gerade Verbindung mit Pfeil 114">
@@ -37973,36 +38168,6 @@
           </a:fontRef>
         </p:style>
       </p:cxnSp>
-      <p:pic>
-        <p:nvPicPr>
-          <p:cNvPr id="122" name="Grafik 165">
-            <a:extLst>
-              <a:ext uri="{FF2B5EF4-FFF2-40B4-BE49-F238E27FC236}">
-                <a16:creationId xmlns:a16="http://schemas.microsoft.com/office/drawing/2014/main" id="{C58BB8C8-2491-48E5-46A3-5E1BEB7A5BA2}"/>
-              </a:ext>
-            </a:extLst>
-          </p:cNvPr>
-          <p:cNvPicPr>
-            <a:picLocks noChangeAspect="1"/>
-          </p:cNvPicPr>
-          <p:nvPr/>
-        </p:nvPicPr>
-        <p:blipFill>
-          <a:blip r:embed="rId11"/>
-          <a:stretch>
-            <a:fillRect/>
-          </a:stretch>
-        </p:blipFill>
-        <p:spPr>
-          <a:xfrm>
-            <a:off x="1086583" y="3154111"/>
-            <a:ext cx="515265" cy="403725"/>
-          </a:xfrm>
-          <a:prstGeom prst="rect">
-            <a:avLst/>
-          </a:prstGeom>
-        </p:spPr>
-      </p:pic>
       <p:cxnSp>
         <p:nvCxnSpPr>
           <p:cNvPr id="125" name="Gerade Verbindung mit Pfeil 175">
@@ -38052,187 +38217,202 @@
           </a:fontRef>
         </p:style>
       </p:cxnSp>
-      <p:sp>
-        <p:nvSpPr>
-          <p:cNvPr id="137" name="Rechteck: abgerundete Ecken 136">
-            <a:extLst>
-              <a:ext uri="{FF2B5EF4-FFF2-40B4-BE49-F238E27FC236}">
-                <a16:creationId xmlns:a16="http://schemas.microsoft.com/office/drawing/2014/main" id="{2F0E7FDF-A2C6-F785-F1E7-936F202EF2F8}"/>
-              </a:ext>
-            </a:extLst>
-          </p:cNvPr>
-          <p:cNvSpPr>
-            <a:spLocks/>
-          </p:cNvSpPr>
+      <p:grpSp>
+        <p:nvGrpSpPr>
+          <p:cNvPr id="157" name="Gruppe Embedding LLM"/>
+          <p:cNvGrpSpPr/>
           <p:nvPr/>
-        </p:nvSpPr>
-        <p:spPr>
-          <a:xfrm>
-            <a:off x="2874076" y="1571625"/>
-            <a:ext cx="1259680" cy="866775"/>
-          </a:xfrm>
-          <a:prstGeom prst="roundRect">
-            <a:avLst/>
-          </a:prstGeom>
-          <a:solidFill>
-            <a:schemeClr val="accent6">
-              <a:lumMod val="40000"/>
-              <a:lumOff val="60000"/>
-            </a:schemeClr>
-          </a:solidFill>
-          <a:ln>
+        </p:nvGrpSpPr>
+        <p:grpSpPr>
+          <a:xfrm>
+            <a:off x="2828275" y="1571625"/>
+            <a:ext cx="1414131" cy="866775"/>
+            <a:chOff x="2828275" y="1571625"/>
+            <a:chExt cx="1414131" cy="866775"/>
+          </a:xfrm>
+        </p:grpSpPr>
+        <p:sp>
+          <p:nvSpPr>
+            <p:cNvPr id="137" name="Rechteck: abgerundete Ecken 136">
+              <a:extLst>
+                <a:ext uri="{FF2B5EF4-FFF2-40B4-BE49-F238E27FC236}">
+                  <a16:creationId xmlns:a16="http://schemas.microsoft.com/office/drawing/2014/main" id="{2F0E7FDF-A2C6-F785-F1E7-936F202EF2F8}"/>
+                </a:ext>
+              </a:extLst>
+            </p:cNvPr>
+            <p:cNvSpPr>
+              <a:spLocks/>
+            </p:cNvSpPr>
+            <p:nvPr/>
+          </p:nvSpPr>
+          <p:spPr>
+            <a:xfrm>
+              <a:off x="2874076" y="1571625"/>
+              <a:ext cx="1259680" cy="866775"/>
+            </a:xfrm>
+            <a:prstGeom prst="roundRect">
+              <a:avLst/>
+            </a:prstGeom>
             <a:solidFill>
-              <a:schemeClr val="tx2"/>
+              <a:schemeClr val="accent6">
+                <a:lumMod val="40000"/>
+                <a:lumOff val="60000"/>
+              </a:schemeClr>
             </a:solidFill>
-          </a:ln>
-        </p:spPr>
-        <p:style>
-          <a:lnRef idx="2">
-            <a:schemeClr val="accent1">
-              <a:shade val="15000"/>
-            </a:schemeClr>
-          </a:lnRef>
-          <a:fillRef idx="1">
-            <a:schemeClr val="accent1"/>
-          </a:fillRef>
-          <a:effectRef idx="0">
-            <a:schemeClr val="accent1"/>
-          </a:effectRef>
-          <a:fontRef idx="minor">
-            <a:schemeClr val="lt1"/>
-          </a:fontRef>
-        </p:style>
-        <p:txBody>
-          <a:bodyPr anchor="ctr"/>
-          <a:lstStyle/>
-          <a:p>
-            <a:pPr algn="ctr">
-              <a:buNone/>
-            </a:pPr>
-            <a:endParaRPr/>
-          </a:p>
-        </p:txBody>
-      </p:sp>
-      <p:pic>
-        <p:nvPicPr>
-          <p:cNvPr id="138" name="Grafik 39">
-            <a:extLst>
-              <a:ext uri="{FF2B5EF4-FFF2-40B4-BE49-F238E27FC236}">
-                <a16:creationId xmlns:a16="http://schemas.microsoft.com/office/drawing/2014/main" id="{CED68F23-700B-1E3E-A249-76DCDEF47E2F}"/>
-              </a:ext>
-            </a:extLst>
-          </p:cNvPr>
-          <p:cNvPicPr>
-            <a:picLocks noChangeAspect="1"/>
-          </p:cNvPicPr>
-          <p:nvPr/>
-        </p:nvPicPr>
-        <p:blipFill>
-          <a:blip r:embed="rId10"/>
-          <a:stretch>
-            <a:fillRect/>
-          </a:stretch>
-        </p:blipFill>
-        <p:spPr>
-          <a:xfrm flipH="1">
-            <a:off x="3270221" y="1910325"/>
-            <a:ext cx="475124" cy="482236"/>
-          </a:xfrm>
-          <a:prstGeom prst="rect">
-            <a:avLst/>
-          </a:prstGeom>
-        </p:spPr>
-      </p:pic>
-      <p:sp>
-        <p:nvSpPr>
-          <p:cNvPr id="139" name="Textfeld 40">
-            <a:extLst>
-              <a:ext uri="{FF2B5EF4-FFF2-40B4-BE49-F238E27FC236}">
-                <a16:creationId xmlns:a16="http://schemas.microsoft.com/office/drawing/2014/main" id="{F5202F32-CF94-B0E2-B061-FC87820AD558}"/>
-              </a:ext>
-            </a:extLst>
-          </p:cNvPr>
-          <p:cNvSpPr>
-            <a:spLocks/>
-          </p:cNvSpPr>
-          <p:nvPr/>
-        </p:nvSpPr>
-        <p:spPr>
-          <a:xfrm>
-            <a:off x="2828275" y="1571625"/>
-            <a:ext cx="1414131" cy="276999"/>
-          </a:xfrm>
-          <a:prstGeom prst="rect">
-            <a:avLst/>
-          </a:prstGeom>
-          <a:noFill/>
-        </p:spPr>
-        <p:txBody>
-          <a:bodyPr wrap="square">
-            <a:spAutoFit/>
-          </a:bodyPr>
-          <a:lstStyle/>
-          <a:p>
-            <a:pPr algn="ctr">
-              <a:buNone/>
-            </a:pPr>
-            <a:r>
-              <a:rPr sz="1200" dirty="0"/>
-              <a:t>Embedding LLM</a:t>
-            </a:r>
-          </a:p>
-        </p:txBody>
-      </p:sp>
-      <p:sp>
-        <p:nvSpPr>
-          <p:cNvPr id="140" name="Gerader Verbinder 139">
-            <a:extLst>
-              <a:ext uri="{FF2B5EF4-FFF2-40B4-BE49-F238E27FC236}">
-                <a16:creationId xmlns:a16="http://schemas.microsoft.com/office/drawing/2014/main" id="{FAE015C5-0604-FCE4-AE8F-E2A5506C996F}"/>
-              </a:ext>
-            </a:extLst>
-          </p:cNvPr>
-          <p:cNvSpPr>
-            <a:spLocks/>
-          </p:cNvSpPr>
-          <p:nvPr/>
-        </p:nvSpPr>
-        <p:spPr>
-          <a:xfrm>
-            <a:off x="2874076" y="1855424"/>
-            <a:ext cx="1259680" cy="0"/>
-          </a:xfrm>
-          <a:prstGeom prst="line">
-            <a:avLst/>
-          </a:prstGeom>
-          <a:ln>
-            <a:solidFill>
-              <a:schemeClr val="tx2"/>
-            </a:solidFill>
-          </a:ln>
-        </p:spPr>
-        <p:style>
-          <a:lnRef idx="1">
-            <a:schemeClr val="accent1"/>
-          </a:lnRef>
-          <a:fillRef idx="0">
-            <a:schemeClr val="accent1"/>
-          </a:fillRef>
-          <a:effectRef idx="0">
-            <a:schemeClr val="accent1"/>
-          </a:effectRef>
-          <a:fontRef idx="minor">
-            <a:schemeClr val="tx1"/>
-          </a:fontRef>
-        </p:style>
-        <p:txBody>
-          <a:bodyPr/>
-          <a:lstStyle/>
-          <a:p>
-            <a:endParaRPr lang="de-CH"/>
-          </a:p>
-        </p:txBody>
-      </p:sp>
+            <a:ln>
+              <a:solidFill>
+                <a:schemeClr val="tx2"/>
+              </a:solidFill>
+            </a:ln>
+          </p:spPr>
+          <p:style>
+            <a:lnRef idx="2">
+              <a:schemeClr val="accent1">
+                <a:shade val="15000"/>
+              </a:schemeClr>
+            </a:lnRef>
+            <a:fillRef idx="1">
+              <a:schemeClr val="accent1"/>
+            </a:fillRef>
+            <a:effectRef idx="0">
+              <a:schemeClr val="accent1"/>
+            </a:effectRef>
+            <a:fontRef idx="minor">
+              <a:schemeClr val="lt1"/>
+            </a:fontRef>
+          </p:style>
+          <p:txBody>
+            <a:bodyPr anchor="ctr"/>
+            <a:lstStyle/>
+            <a:p>
+              <a:pPr algn="ctr">
+                <a:buNone/>
+              </a:pPr>
+              <a:endParaRPr/>
+            </a:p>
+          </p:txBody>
+        </p:sp>
+        <p:pic>
+          <p:nvPicPr>
+            <p:cNvPr id="138" name="Grafik 39">
+              <a:extLst>
+                <a:ext uri="{FF2B5EF4-FFF2-40B4-BE49-F238E27FC236}">
+                  <a16:creationId xmlns:a16="http://schemas.microsoft.com/office/drawing/2014/main" id="{CED68F23-700B-1E3E-A249-76DCDEF47E2F}"/>
+                </a:ext>
+              </a:extLst>
+            </p:cNvPr>
+            <p:cNvPicPr>
+              <a:picLocks noChangeAspect="1"/>
+            </p:cNvPicPr>
+            <p:nvPr/>
+          </p:nvPicPr>
+          <p:blipFill>
+            <a:blip r:embed="rId10"/>
+            <a:stretch>
+              <a:fillRect/>
+            </a:stretch>
+          </p:blipFill>
+          <p:spPr>
+            <a:xfrm flipH="1">
+              <a:off x="3266354" y="1910325"/>
+              <a:ext cx="475124" cy="482236"/>
+            </a:xfrm>
+            <a:prstGeom prst="rect">
+              <a:avLst/>
+            </a:prstGeom>
+          </p:spPr>
+        </p:pic>
+        <p:sp>
+          <p:nvSpPr>
+            <p:cNvPr id="139" name="Textfeld 40">
+              <a:extLst>
+                <a:ext uri="{FF2B5EF4-FFF2-40B4-BE49-F238E27FC236}">
+                  <a16:creationId xmlns:a16="http://schemas.microsoft.com/office/drawing/2014/main" id="{F5202F32-CF94-B0E2-B061-FC87820AD558}"/>
+                </a:ext>
+              </a:extLst>
+            </p:cNvPr>
+            <p:cNvSpPr>
+              <a:spLocks/>
+            </p:cNvSpPr>
+            <p:nvPr/>
+          </p:nvSpPr>
+          <p:spPr>
+            <a:xfrm>
+              <a:off x="2828275" y="1571625"/>
+              <a:ext cx="1414131" cy="276999"/>
+            </a:xfrm>
+            <a:prstGeom prst="rect">
+              <a:avLst/>
+            </a:prstGeom>
+            <a:noFill/>
+          </p:spPr>
+          <p:txBody>
+            <a:bodyPr wrap="square">
+              <a:spAutoFit/>
+            </a:bodyPr>
+            <a:lstStyle/>
+            <a:p>
+              <a:pPr algn="ctr">
+                <a:buNone/>
+              </a:pPr>
+              <a:r>
+                <a:rPr sz="1200" dirty="0"/>
+                <a:t>Embedding LLM</a:t>
+              </a:r>
+            </a:p>
+          </p:txBody>
+        </p:sp>
+        <p:sp>
+          <p:nvSpPr>
+            <p:cNvPr id="140" name="Gerader Verbinder 139">
+              <a:extLst>
+                <a:ext uri="{FF2B5EF4-FFF2-40B4-BE49-F238E27FC236}">
+                  <a16:creationId xmlns:a16="http://schemas.microsoft.com/office/drawing/2014/main" id="{FAE015C5-0604-FCE4-AE8F-E2A5506C996F}"/>
+                </a:ext>
+              </a:extLst>
+            </p:cNvPr>
+            <p:cNvSpPr>
+              <a:spLocks/>
+            </p:cNvSpPr>
+            <p:nvPr/>
+          </p:nvSpPr>
+          <p:spPr>
+            <a:xfrm>
+              <a:off x="2874076" y="1855424"/>
+              <a:ext cx="1259680" cy="0"/>
+            </a:xfrm>
+            <a:prstGeom prst="line">
+              <a:avLst/>
+            </a:prstGeom>
+            <a:ln>
+              <a:solidFill>
+                <a:schemeClr val="tx2"/>
+              </a:solidFill>
+            </a:ln>
+          </p:spPr>
+          <p:style>
+            <a:lnRef idx="1">
+              <a:schemeClr val="accent1"/>
+            </a:lnRef>
+            <a:fillRef idx="0">
+              <a:schemeClr val="accent1"/>
+            </a:fillRef>
+            <a:effectRef idx="0">
+              <a:schemeClr val="accent1"/>
+            </a:effectRef>
+            <a:fontRef idx="minor">
+              <a:schemeClr val="tx1"/>
+            </a:fontRef>
+          </p:style>
+          <p:txBody>
+            <a:bodyPr/>
+            <a:lstStyle/>
+            <a:p>
+              <a:endParaRPr lang="de-CH"/>
+            </a:p>
+          </p:txBody>
+        </p:sp>
+      </p:grpSp>
       <p:sp>
         <p:nvSpPr>
           <p:cNvPr id="145" name="Textfeld 144">
@@ -38612,184 +38792,199 @@
           </a:fontRef>
         </p:style>
       </p:cxnSp>
-      <p:sp>
-        <p:nvSpPr>
-          <p:cNvPr id="121" name="Rechteck: abgerundete Ecken 120">
-            <a:extLst>
-              <a:ext uri="{FF2B5EF4-FFF2-40B4-BE49-F238E27FC236}">
-                <a16:creationId xmlns:a16="http://schemas.microsoft.com/office/drawing/2014/main" id="{AD7B8046-A7E5-977B-9789-31E7E99EC995}"/>
-              </a:ext>
-            </a:extLst>
-          </p:cNvPr>
-          <p:cNvSpPr>
-            <a:spLocks/>
-          </p:cNvSpPr>
+      <p:grpSp>
+        <p:nvGrpSpPr>
+          <p:cNvPr id="158" name="Gruppe Chunks"/>
+          <p:cNvGrpSpPr/>
           <p:nvPr/>
-        </p:nvSpPr>
-        <p:spPr>
+        </p:nvGrpSpPr>
+        <p:grpSpPr>
           <a:xfrm>
             <a:off x="708064" y="1571625"/>
             <a:ext cx="1259680" cy="866775"/>
-          </a:xfrm>
-          <a:prstGeom prst="roundRect">
-            <a:avLst/>
-          </a:prstGeom>
-          <a:solidFill>
-            <a:schemeClr val="accent2"/>
-          </a:solidFill>
-          <a:ln>
+            <a:chOff x="708064" y="1571625"/>
+            <a:chExt cx="1259680" cy="866775"/>
+          </a:xfrm>
+        </p:grpSpPr>
+        <p:sp>
+          <p:nvSpPr>
+            <p:cNvPr id="121" name="Rechteck: abgerundete Ecken 120">
+              <a:extLst>
+                <a:ext uri="{FF2B5EF4-FFF2-40B4-BE49-F238E27FC236}">
+                  <a16:creationId xmlns:a16="http://schemas.microsoft.com/office/drawing/2014/main" id="{AD7B8046-A7E5-977B-9789-31E7E99EC995}"/>
+                </a:ext>
+              </a:extLst>
+            </p:cNvPr>
+            <p:cNvSpPr>
+              <a:spLocks/>
+            </p:cNvSpPr>
+            <p:nvPr/>
+          </p:nvSpPr>
+          <p:spPr>
+            <a:xfrm>
+              <a:off x="708064" y="1571625"/>
+              <a:ext cx="1259680" cy="866775"/>
+            </a:xfrm>
+            <a:prstGeom prst="roundRect">
+              <a:avLst/>
+            </a:prstGeom>
             <a:solidFill>
-              <a:schemeClr val="accent3"/>
+              <a:schemeClr val="accent2"/>
             </a:solidFill>
-          </a:ln>
-        </p:spPr>
-        <p:style>
-          <a:lnRef idx="2">
-            <a:schemeClr val="accent1">
-              <a:shade val="15000"/>
-            </a:schemeClr>
-          </a:lnRef>
-          <a:fillRef idx="1">
-            <a:schemeClr val="accent1"/>
-          </a:fillRef>
-          <a:effectRef idx="0">
-            <a:schemeClr val="accent1"/>
-          </a:effectRef>
-          <a:fontRef idx="minor">
-            <a:schemeClr val="lt1"/>
-          </a:fontRef>
-        </p:style>
-        <p:txBody>
-          <a:bodyPr anchor="ctr"/>
-          <a:lstStyle/>
-          <a:p>
-            <a:pPr algn="ctr">
-              <a:buNone/>
-            </a:pPr>
-            <a:endParaRPr/>
-          </a:p>
-        </p:txBody>
-      </p:sp>
-      <p:sp>
-        <p:nvSpPr>
-          <p:cNvPr id="123" name="Textfeld 171">
-            <a:extLst>
-              <a:ext uri="{FF2B5EF4-FFF2-40B4-BE49-F238E27FC236}">
-                <a16:creationId xmlns:a16="http://schemas.microsoft.com/office/drawing/2014/main" id="{94B0B414-3457-95E7-777A-E27F72556F9D}"/>
-              </a:ext>
-            </a:extLst>
-          </p:cNvPr>
-          <p:cNvSpPr>
-            <a:spLocks/>
-          </p:cNvSpPr>
-          <p:nvPr/>
-        </p:nvSpPr>
-        <p:spPr>
-          <a:xfrm>
-            <a:off x="708064" y="1590304"/>
-            <a:ext cx="1259680" cy="276999"/>
-          </a:xfrm>
-          <a:prstGeom prst="rect">
-            <a:avLst/>
-          </a:prstGeom>
-          <a:noFill/>
-        </p:spPr>
-        <p:txBody>
-          <a:bodyPr wrap="square">
-            <a:spAutoFit/>
-          </a:bodyPr>
-          <a:lstStyle/>
-          <a:p>
-            <a:pPr algn="ctr">
-              <a:buNone/>
-            </a:pPr>
-            <a:r>
-              <a:rPr sz="1200" dirty="0"/>
-              <a:t>Chunks</a:t>
-            </a:r>
-          </a:p>
-        </p:txBody>
-      </p:sp>
-      <p:pic>
-        <p:nvPicPr>
-          <p:cNvPr id="46" name="Grafik 10">
-            <a:extLst>
-              <a:ext uri="{FF2B5EF4-FFF2-40B4-BE49-F238E27FC236}">
-                <a16:creationId xmlns:a16="http://schemas.microsoft.com/office/drawing/2014/main" id="{BE3EA945-55FA-7EAD-DC73-B9FB8CEDC576}"/>
-              </a:ext>
-            </a:extLst>
-          </p:cNvPr>
-          <p:cNvPicPr>
-            <a:picLocks noChangeAspect="1"/>
-          </p:cNvPicPr>
-          <p:nvPr/>
-        </p:nvPicPr>
-        <p:blipFill>
-          <a:blip r:embed="rId12"/>
-          <a:stretch>
-            <a:fillRect/>
-          </a:stretch>
-        </p:blipFill>
-        <p:spPr>
-          <a:xfrm flipH="1">
-            <a:off x="1110374" y="1881733"/>
-            <a:ext cx="455061" cy="530359"/>
-          </a:xfrm>
-          <a:prstGeom prst="rect">
-            <a:avLst/>
-          </a:prstGeom>
-        </p:spPr>
-      </p:pic>
-      <p:sp>
-        <p:nvSpPr>
-          <p:cNvPr id="124" name="Gerader Verbinder 123">
-            <a:extLst>
-              <a:ext uri="{FF2B5EF4-FFF2-40B4-BE49-F238E27FC236}">
-                <a16:creationId xmlns:a16="http://schemas.microsoft.com/office/drawing/2014/main" id="{E1830494-1611-ADE7-C919-BF9ADBCD7AEF}"/>
-              </a:ext>
-            </a:extLst>
-          </p:cNvPr>
-          <p:cNvSpPr>
-            <a:spLocks/>
-          </p:cNvSpPr>
-          <p:nvPr/>
-        </p:nvSpPr>
-        <p:spPr>
-          <a:xfrm>
-            <a:off x="708064" y="1864279"/>
-            <a:ext cx="1259680" cy="3023"/>
-          </a:xfrm>
-          <a:prstGeom prst="line">
-            <a:avLst/>
-          </a:prstGeom>
-          <a:ln>
-            <a:solidFill>
-              <a:schemeClr val="accent3"/>
-            </a:solidFill>
-          </a:ln>
-        </p:spPr>
-        <p:style>
-          <a:lnRef idx="1">
-            <a:schemeClr val="accent1"/>
-          </a:lnRef>
-          <a:fillRef idx="0">
-            <a:schemeClr val="accent1"/>
-          </a:fillRef>
-          <a:effectRef idx="0">
-            <a:schemeClr val="accent1"/>
-          </a:effectRef>
-          <a:fontRef idx="minor">
-            <a:schemeClr val="tx1"/>
-          </a:fontRef>
-        </p:style>
-        <p:txBody>
-          <a:bodyPr/>
-          <a:lstStyle/>
-          <a:p>
-            <a:endParaRPr lang="de-CH"/>
-          </a:p>
-        </p:txBody>
-      </p:sp>
+            <a:ln>
+              <a:solidFill>
+                <a:schemeClr val="accent3"/>
+              </a:solidFill>
+            </a:ln>
+          </p:spPr>
+          <p:style>
+            <a:lnRef idx="2">
+              <a:schemeClr val="accent1">
+                <a:shade val="15000"/>
+              </a:schemeClr>
+            </a:lnRef>
+            <a:fillRef idx="1">
+              <a:schemeClr val="accent1"/>
+            </a:fillRef>
+            <a:effectRef idx="0">
+              <a:schemeClr val="accent1"/>
+            </a:effectRef>
+            <a:fontRef idx="minor">
+              <a:schemeClr val="lt1"/>
+            </a:fontRef>
+          </p:style>
+          <p:txBody>
+            <a:bodyPr anchor="ctr"/>
+            <a:lstStyle/>
+            <a:p>
+              <a:pPr algn="ctr">
+                <a:buNone/>
+              </a:pPr>
+              <a:endParaRPr/>
+            </a:p>
+          </p:txBody>
+        </p:sp>
+        <p:sp>
+          <p:nvSpPr>
+            <p:cNvPr id="123" name="Textfeld 171">
+              <a:extLst>
+                <a:ext uri="{FF2B5EF4-FFF2-40B4-BE49-F238E27FC236}">
+                  <a16:creationId xmlns:a16="http://schemas.microsoft.com/office/drawing/2014/main" id="{94B0B414-3457-95E7-777A-E27F72556F9D}"/>
+                </a:ext>
+              </a:extLst>
+            </p:cNvPr>
+            <p:cNvSpPr>
+              <a:spLocks/>
+            </p:cNvSpPr>
+            <p:nvPr/>
+          </p:nvSpPr>
+          <p:spPr>
+            <a:xfrm>
+              <a:off x="708064" y="1590304"/>
+              <a:ext cx="1259680" cy="276999"/>
+            </a:xfrm>
+            <a:prstGeom prst="rect">
+              <a:avLst/>
+            </a:prstGeom>
+            <a:noFill/>
+          </p:spPr>
+          <p:txBody>
+            <a:bodyPr wrap="square">
+              <a:spAutoFit/>
+            </a:bodyPr>
+            <a:lstStyle/>
+            <a:p>
+              <a:pPr algn="ctr">
+                <a:buNone/>
+              </a:pPr>
+              <a:r>
+                <a:rPr sz="1200" dirty="0"/>
+                <a:t>Chunks</a:t>
+              </a:r>
+            </a:p>
+          </p:txBody>
+        </p:sp>
+        <p:pic>
+          <p:nvPicPr>
+            <p:cNvPr id="46" name="Grafik 10">
+              <a:extLst>
+                <a:ext uri="{FF2B5EF4-FFF2-40B4-BE49-F238E27FC236}">
+                  <a16:creationId xmlns:a16="http://schemas.microsoft.com/office/drawing/2014/main" id="{BE3EA945-55FA-7EAD-DC73-B9FB8CEDC576}"/>
+                </a:ext>
+              </a:extLst>
+            </p:cNvPr>
+            <p:cNvPicPr>
+              <a:picLocks noChangeAspect="1"/>
+            </p:cNvPicPr>
+            <p:nvPr/>
+          </p:nvPicPr>
+          <p:blipFill>
+            <a:blip r:embed="rId12"/>
+            <a:stretch>
+              <a:fillRect/>
+            </a:stretch>
+          </p:blipFill>
+          <p:spPr>
+            <a:xfrm flipH="1">
+              <a:off x="1110373" y="1881733"/>
+              <a:ext cx="455061" cy="530359"/>
+            </a:xfrm>
+            <a:prstGeom prst="rect">
+              <a:avLst/>
+            </a:prstGeom>
+          </p:spPr>
+        </p:pic>
+        <p:sp>
+          <p:nvSpPr>
+            <p:cNvPr id="124" name="Gerader Verbinder 123">
+              <a:extLst>
+                <a:ext uri="{FF2B5EF4-FFF2-40B4-BE49-F238E27FC236}">
+                  <a16:creationId xmlns:a16="http://schemas.microsoft.com/office/drawing/2014/main" id="{E1830494-1611-ADE7-C919-BF9ADBCD7AEF}"/>
+                </a:ext>
+              </a:extLst>
+            </p:cNvPr>
+            <p:cNvSpPr>
+              <a:spLocks/>
+            </p:cNvSpPr>
+            <p:nvPr/>
+          </p:nvSpPr>
+          <p:spPr>
+            <a:xfrm>
+              <a:off x="708064" y="1864279"/>
+              <a:ext cx="1259680" cy="0"/>
+            </a:xfrm>
+            <a:prstGeom prst="line">
+              <a:avLst/>
+            </a:prstGeom>
+            <a:ln>
+              <a:solidFill>
+                <a:schemeClr val="accent3"/>
+              </a:solidFill>
+            </a:ln>
+          </p:spPr>
+          <p:style>
+            <a:lnRef idx="1">
+              <a:schemeClr val="accent1"/>
+            </a:lnRef>
+            <a:fillRef idx="0">
+              <a:schemeClr val="accent1"/>
+            </a:fillRef>
+            <a:effectRef idx="0">
+              <a:schemeClr val="accent1"/>
+            </a:effectRef>
+            <a:fontRef idx="minor">
+              <a:schemeClr val="tx1"/>
+            </a:fontRef>
+          </p:style>
+          <p:txBody>
+            <a:bodyPr/>
+            <a:lstStyle/>
+            <a:p>
+              <a:endParaRPr lang="de-CH"/>
+            </a:p>
+          </p:txBody>
+        </p:sp>
+      </p:grpSp>
     </p:spTree>
     <p:extLst>
       <p:ext uri="{BB962C8B-B14F-4D97-AF65-F5344CB8AC3E}">

</xml_diff>

<commit_message>
Resize all slide-7 diagram boxes to 4.82 x 2.41 cm
Grow every rounded box around its centre, keep labels and dividers at
box width, re-centre the icons and recompute the group frames.

Co-Authored-By: Claude Fable 5 <noreply@anthropic.com>
Claude-Session: https://claude.ai/code/session_01S2kGP2buE2HmxMttD3XczR
</commit_message>
<xml_diff>
--- a/RAG_Workshop.pptx
+++ b/RAG_Workshop.pptx
@@ -35634,10 +35634,10 @@
         </p:nvGrpSpPr>
         <p:grpSpPr>
           <a:xfrm>
-            <a:off x="701754" y="5143500"/>
-            <a:ext cx="1272301" cy="866775"/>
-            <a:chOff x="701754" y="5143500"/>
-            <a:chExt cx="1272301" cy="866775"/>
+            <a:off x="476615" y="5142674"/>
+            <a:ext cx="1735200" cy="867600"/>
+            <a:chOff x="476615" y="5142674"/>
+            <a:chExt cx="1735200" cy="867600"/>
           </a:xfrm>
         </p:grpSpPr>
         <p:sp>
@@ -35656,8 +35656,8 @@
           </p:nvSpPr>
           <p:spPr>
             <a:xfrm>
-              <a:off x="714375" y="5143500"/>
-              <a:ext cx="1259680" cy="866775"/>
+              <a:off x="476615" y="5142674"/>
+              <a:ext cx="1735200" cy="867600"/>
             </a:xfrm>
             <a:prstGeom prst="roundRect">
               <a:avLst/>
@@ -35714,8 +35714,8 @@
           </p:nvSpPr>
           <p:spPr>
             <a:xfrm>
-              <a:off x="701754" y="5162179"/>
-              <a:ext cx="1259680" cy="276999"/>
+              <a:off x="476615" y="5161353"/>
+              <a:ext cx="1735200" cy="276999"/>
             </a:xfrm>
             <a:prstGeom prst="rect">
               <a:avLst/>
@@ -35754,8 +35754,8 @@
           </p:nvSpPr>
           <p:spPr>
             <a:xfrm>
-              <a:off x="714375" y="5439178"/>
-              <a:ext cx="1259680" cy="0"/>
+              <a:off x="476615" y="5438352"/>
+              <a:ext cx="1735200" cy="0"/>
             </a:xfrm>
             <a:prstGeom prst="line">
               <a:avLst/>
@@ -35810,7 +35810,7 @@
           </p:blipFill>
           <p:spPr>
             <a:xfrm flipH="1">
-              <a:off x="1136680" y="5503383"/>
+              <a:off x="1136680" y="5502557"/>
               <a:ext cx="415070" cy="480063"/>
             </a:xfrm>
             <a:prstGeom prst="rect">
@@ -35827,10 +35827,10 @@
         </p:nvGrpSpPr>
         <p:grpSpPr>
           <a:xfrm>
-            <a:off x="10274379" y="1571625"/>
-            <a:ext cx="1272301" cy="866775"/>
-            <a:chOff x="10274379" y="1571625"/>
-            <a:chExt cx="1272301" cy="866775"/>
+            <a:off x="10049240" y="1570799"/>
+            <a:ext cx="1735200" cy="867600"/>
+            <a:chOff x="10049240" y="1570799"/>
+            <a:chExt cx="1735200" cy="867600"/>
           </a:xfrm>
         </p:grpSpPr>
         <p:sp>
@@ -35849,8 +35849,8 @@
           </p:nvSpPr>
           <p:spPr>
             <a:xfrm>
-              <a:off x="10287000" y="1571625"/>
-              <a:ext cx="1259680" cy="866775"/>
+              <a:off x="10049240" y="1570799"/>
+              <a:ext cx="1735200" cy="867600"/>
             </a:xfrm>
             <a:prstGeom prst="roundRect">
               <a:avLst/>
@@ -35913,7 +35913,7 @@
           </p:blipFill>
           <p:spPr>
             <a:xfrm>
-              <a:off x="10611908" y="1867303"/>
+              <a:off x="10611908" y="1866477"/>
               <a:ext cx="609864" cy="566720"/>
             </a:xfrm>
             <a:prstGeom prst="rect">
@@ -35937,8 +35937,8 @@
           </p:nvSpPr>
           <p:spPr>
             <a:xfrm>
-              <a:off x="10274379" y="1590304"/>
-              <a:ext cx="1259680" cy="276999"/>
+              <a:off x="10049240" y="1589478"/>
+              <a:ext cx="1735200" cy="276999"/>
             </a:xfrm>
             <a:prstGeom prst="rect">
               <a:avLst/>
@@ -35974,10 +35974,10 @@
         </p:nvGrpSpPr>
         <p:grpSpPr>
           <a:xfrm>
-            <a:off x="10274379" y="5162179"/>
-            <a:ext cx="1272301" cy="866775"/>
-            <a:chOff x="10274379" y="5162179"/>
-            <a:chExt cx="1272301" cy="866775"/>
+            <a:off x="10049240" y="5161353"/>
+            <a:ext cx="1735200" cy="867600"/>
+            <a:chOff x="10049240" y="5161353"/>
+            <a:chExt cx="1735200" cy="867600"/>
           </a:xfrm>
         </p:grpSpPr>
         <p:sp>
@@ -35996,8 +35996,8 @@
           </p:nvSpPr>
           <p:spPr>
             <a:xfrm>
-              <a:off x="10287000" y="5162179"/>
-              <a:ext cx="1259680" cy="866775"/>
+              <a:off x="10049240" y="5161353"/>
+              <a:ext cx="1735200" cy="867600"/>
             </a:xfrm>
             <a:prstGeom prst="roundRect">
               <a:avLst/>
@@ -36060,7 +36060,7 @@
           </p:blipFill>
           <p:spPr>
             <a:xfrm flipH="1">
-              <a:off x="10609408" y="5445851"/>
+              <a:off x="10609408" y="5445025"/>
               <a:ext cx="614864" cy="571508"/>
             </a:xfrm>
             <a:prstGeom prst="rect">
@@ -36084,8 +36084,8 @@
           </p:nvSpPr>
           <p:spPr>
             <a:xfrm>
-              <a:off x="10274379" y="5180858"/>
-              <a:ext cx="1259680" cy="276999"/>
+              <a:off x="10049240" y="5180032"/>
+              <a:ext cx="1735200" cy="276999"/>
             </a:xfrm>
             <a:prstGeom prst="rect">
               <a:avLst/>
@@ -36121,10 +36121,10 @@
         </p:nvGrpSpPr>
         <p:grpSpPr>
           <a:xfrm>
-            <a:off x="501206" y="3952875"/>
-            <a:ext cx="1733633" cy="866775"/>
-            <a:chOff x="501206" y="3952875"/>
-            <a:chExt cx="1733633" cy="866775"/>
+            <a:off x="475308" y="3952049"/>
+            <a:ext cx="1735200" cy="867600"/>
+            <a:chOff x="475308" y="3952049"/>
+            <a:chExt cx="1735200" cy="867600"/>
           </a:xfrm>
         </p:grpSpPr>
         <p:sp>
@@ -36143,8 +36143,8 @@
           </p:nvSpPr>
           <p:spPr>
             <a:xfrm>
-              <a:off x="513827" y="3952875"/>
-              <a:ext cx="1658163" cy="866775"/>
+              <a:off x="475308" y="3952049"/>
+              <a:ext cx="1735200" cy="867600"/>
             </a:xfrm>
             <a:prstGeom prst="roundRect">
               <a:avLst/>
@@ -36207,7 +36207,7 @@
           </p:blipFill>
           <p:spPr>
             <a:xfrm flipH="1">
-              <a:off x="1109228" y="4248553"/>
+              <a:off x="1109228" y="4247727"/>
               <a:ext cx="467360" cy="559581"/>
             </a:xfrm>
             <a:prstGeom prst="rect">
@@ -36231,8 +36231,8 @@
           </p:nvSpPr>
           <p:spPr>
             <a:xfrm>
-              <a:off x="501206" y="3971554"/>
-              <a:ext cx="1733633" cy="276999"/>
+              <a:off x="475308" y="3970728"/>
+              <a:ext cx="1735200" cy="276999"/>
             </a:xfrm>
             <a:prstGeom prst="rect">
               <a:avLst/>
@@ -36271,8 +36271,8 @@
           </p:nvSpPr>
           <p:spPr>
             <a:xfrm>
-              <a:off x="513827" y="4248553"/>
-              <a:ext cx="1658163" cy="0"/>
+              <a:off x="475308" y="4247727"/>
+              <a:ext cx="1735200" cy="0"/>
             </a:xfrm>
             <a:prstGeom prst="line">
               <a:avLst/>
@@ -36314,10 +36314,10 @@
         </p:nvGrpSpPr>
         <p:grpSpPr>
           <a:xfrm>
-            <a:off x="701754" y="2762250"/>
-            <a:ext cx="1272301" cy="866775"/>
-            <a:chOff x="701754" y="2762250"/>
-            <a:chExt cx="1272301" cy="866775"/>
+            <a:off x="476615" y="2761424"/>
+            <a:ext cx="1735200" cy="867600"/>
+            <a:chOff x="476615" y="2761424"/>
+            <a:chExt cx="1735200" cy="867600"/>
           </a:xfrm>
         </p:grpSpPr>
         <p:sp>
@@ -36336,8 +36336,8 @@
           </p:nvSpPr>
           <p:spPr>
             <a:xfrm>
-              <a:off x="714375" y="2762250"/>
-              <a:ext cx="1259680" cy="866775"/>
+              <a:off x="476615" y="2761424"/>
+              <a:ext cx="1735200" cy="867600"/>
             </a:xfrm>
             <a:prstGeom prst="roundRect">
               <a:avLst/>
@@ -36394,8 +36394,8 @@
           </p:nvSpPr>
           <p:spPr>
             <a:xfrm>
-              <a:off x="701754" y="2780929"/>
-              <a:ext cx="1259680" cy="276999"/>
+              <a:off x="476615" y="2780103"/>
+              <a:ext cx="1735200" cy="276999"/>
             </a:xfrm>
             <a:prstGeom prst="rect">
               <a:avLst/>
@@ -36434,8 +36434,8 @@
           </p:nvSpPr>
           <p:spPr>
             <a:xfrm>
-              <a:off x="714375" y="3054904"/>
-              <a:ext cx="1259680" cy="0"/>
+              <a:off x="476615" y="3054078"/>
+              <a:ext cx="1735200" cy="0"/>
             </a:xfrm>
             <a:prstGeom prst="line">
               <a:avLst/>
@@ -36483,14 +36483,14 @@
             <p:nvPr/>
           </p:nvPicPr>
           <p:blipFill>
-            <a:blip r:embed="rId11"/>
+            <a:blip r:embed="rId7"/>
             <a:stretch>
               <a:fillRect/>
             </a:stretch>
           </p:blipFill>
           <p:spPr>
             <a:xfrm>
-              <a:off x="1086582" y="3154111"/>
+              <a:off x="1086582" y="3153285"/>
               <a:ext cx="515265" cy="403725"/>
             </a:xfrm>
             <a:prstGeom prst="rect">
@@ -36507,10 +36507,10 @@
         </p:nvGrpSpPr>
         <p:grpSpPr>
           <a:xfrm>
-            <a:off x="5086783" y="1578909"/>
-            <a:ext cx="1272301" cy="866775"/>
-            <a:chOff x="5086783" y="1578909"/>
-            <a:chExt cx="1272301" cy="866775"/>
+            <a:off x="4861644" y="1578083"/>
+            <a:ext cx="1735200" cy="867600"/>
+            <a:chOff x="4861644" y="1578083"/>
+            <a:chExt cx="1735200" cy="867600"/>
           </a:xfrm>
         </p:grpSpPr>
         <p:sp>
@@ -36529,8 +36529,8 @@
           </p:nvSpPr>
           <p:spPr>
             <a:xfrm>
-              <a:off x="5099404" y="1578909"/>
-              <a:ext cx="1259680" cy="866775"/>
+              <a:off x="4861644" y="1578083"/>
+              <a:ext cx="1735200" cy="867600"/>
             </a:xfrm>
             <a:prstGeom prst="roundRect">
               <a:avLst/>
@@ -36586,14 +36586,14 @@
             <p:nvPr/>
           </p:nvPicPr>
           <p:blipFill>
-            <a:blip r:embed="rId7"/>
+            <a:blip r:embed="rId8"/>
             <a:stretch>
               <a:fillRect/>
             </a:stretch>
           </p:blipFill>
           <p:spPr>
             <a:xfrm flipH="1">
-              <a:off x="5487815" y="1917819"/>
+              <a:off x="5487815" y="1916993"/>
               <a:ext cx="482858" cy="509226"/>
             </a:xfrm>
             <a:prstGeom prst="rect">
@@ -36617,8 +36617,8 @@
           </p:nvSpPr>
           <p:spPr>
             <a:xfrm>
-              <a:off x="5086783" y="1597588"/>
-              <a:ext cx="1259680" cy="276999"/>
+              <a:off x="4861644" y="1596762"/>
+              <a:ext cx="1735200" cy="276999"/>
             </a:xfrm>
             <a:prstGeom prst="rect">
               <a:avLst/>
@@ -36657,8 +36657,8 @@
           </p:nvSpPr>
           <p:spPr>
             <a:xfrm flipV="1">
-              <a:off x="5099404" y="1874587"/>
-              <a:ext cx="1259680" cy="0"/>
+              <a:off x="4861644" y="1873761"/>
+              <a:ext cx="1735200" cy="0"/>
             </a:xfrm>
             <a:prstGeom prst="line">
               <a:avLst/>
@@ -36700,10 +36700,10 @@
         </p:nvGrpSpPr>
         <p:grpSpPr>
           <a:xfrm>
-            <a:off x="8083629" y="2776991"/>
-            <a:ext cx="1272301" cy="879071"/>
-            <a:chOff x="8083629" y="2776991"/>
-            <a:chExt cx="1272301" cy="879071"/>
+            <a:off x="7858490" y="2776165"/>
+            <a:ext cx="1735200" cy="879071"/>
+            <a:chOff x="7858490" y="2776165"/>
+            <a:chExt cx="1735200" cy="879071"/>
           </a:xfrm>
         </p:grpSpPr>
         <p:sp>
@@ -36722,8 +36722,8 @@
           </p:nvSpPr>
           <p:spPr>
             <a:xfrm>
-              <a:off x="8096250" y="2776991"/>
-              <a:ext cx="1259680" cy="866775"/>
+              <a:off x="7858490" y="2776165"/>
+              <a:ext cx="1735200" cy="867600"/>
             </a:xfrm>
             <a:prstGeom prst="roundRect">
               <a:avLst/>
@@ -36779,14 +36779,14 @@
             <p:nvPr/>
           </p:nvPicPr>
           <p:blipFill>
-            <a:blip r:embed="rId7"/>
+            <a:blip r:embed="rId8"/>
             <a:stretch>
               <a:fillRect/>
             </a:stretch>
           </p:blipFill>
           <p:spPr>
             <a:xfrm flipH="1">
-              <a:off x="8455327" y="3084965"/>
+              <a:off x="8455327" y="3084139"/>
               <a:ext cx="541526" cy="571097"/>
             </a:xfrm>
             <a:prstGeom prst="rect">
@@ -36810,8 +36810,8 @@
           </p:nvSpPr>
           <p:spPr>
             <a:xfrm>
-              <a:off x="8083629" y="2795670"/>
-              <a:ext cx="1259680" cy="276999"/>
+              <a:off x="7858490" y="2794844"/>
+              <a:ext cx="1735200" cy="276999"/>
             </a:xfrm>
             <a:prstGeom prst="rect">
               <a:avLst/>
@@ -36850,8 +36850,8 @@
           </p:nvSpPr>
           <p:spPr>
             <a:xfrm flipV="1">
-              <a:off x="8096250" y="3072669"/>
-              <a:ext cx="1259680" cy="0"/>
+              <a:off x="7858490" y="3071843"/>
+              <a:ext cx="1735200" cy="0"/>
             </a:xfrm>
             <a:prstGeom prst="line">
               <a:avLst/>
@@ -36893,10 +36893,10 @@
         </p:nvGrpSpPr>
         <p:grpSpPr>
           <a:xfrm>
-            <a:off x="5083254" y="2776991"/>
-            <a:ext cx="1341782" cy="866776"/>
-            <a:chOff x="5083254" y="2776991"/>
-            <a:chExt cx="1341782" cy="866776"/>
+            <a:off x="4858115" y="2776165"/>
+            <a:ext cx="1735200" cy="867600"/>
+            <a:chOff x="4858115" y="2776165"/>
+            <a:chExt cx="1735200" cy="867600"/>
           </a:xfrm>
         </p:grpSpPr>
         <p:sp>
@@ -36915,8 +36915,8 @@
           </p:nvSpPr>
           <p:spPr>
             <a:xfrm>
-              <a:off x="5095875" y="2776991"/>
-              <a:ext cx="1259680" cy="866775"/>
+              <a:off x="4858115" y="2776165"/>
+              <a:ext cx="1735200" cy="867600"/>
             </a:xfrm>
             <a:prstGeom prst="roundRect">
               <a:avLst/>
@@ -36972,14 +36972,14 @@
             <p:nvPr/>
           </p:nvPicPr>
           <p:blipFill>
-            <a:blip r:embed="rId8"/>
+            <a:blip r:embed="rId9"/>
             <a:stretch>
               <a:fillRect/>
             </a:stretch>
           </p:blipFill>
           <p:spPr>
             <a:xfrm flipH="1">
-              <a:off x="5445714" y="3157787"/>
+              <a:off x="5445714" y="3156961"/>
               <a:ext cx="560002" cy="485980"/>
             </a:xfrm>
             <a:prstGeom prst="rect">
@@ -37003,8 +37003,8 @@
           </p:nvSpPr>
           <p:spPr>
             <a:xfrm>
-              <a:off x="5083254" y="2795670"/>
-              <a:ext cx="1341782" cy="285750"/>
+              <a:off x="4858115" y="2794844"/>
+              <a:ext cx="1735200" cy="285750"/>
             </a:xfrm>
             <a:prstGeom prst="rect">
               <a:avLst/>
@@ -37043,8 +37043,8 @@
           </p:nvSpPr>
           <p:spPr>
             <a:xfrm>
-              <a:off x="5095875" y="3081420"/>
-              <a:ext cx="1259680" cy="0"/>
+              <a:off x="4858115" y="3080594"/>
+              <a:ext cx="1735200" cy="0"/>
             </a:xfrm>
             <a:prstGeom prst="line">
               <a:avLst/>
@@ -37086,10 +37086,10 @@
         </p:nvGrpSpPr>
         <p:grpSpPr>
           <a:xfrm>
-            <a:off x="5083254" y="5162179"/>
-            <a:ext cx="1272301" cy="885454"/>
-            <a:chOff x="5083254" y="5162179"/>
-            <a:chExt cx="1272301" cy="885454"/>
+            <a:off x="4858115" y="5161353"/>
+            <a:ext cx="1735200" cy="885454"/>
+            <a:chOff x="4858115" y="5161353"/>
+            <a:chExt cx="1735200" cy="885454"/>
           </a:xfrm>
         </p:grpSpPr>
         <p:sp>
@@ -37108,8 +37108,8 @@
           </p:nvSpPr>
           <p:spPr>
             <a:xfrm>
-              <a:off x="5095875" y="5162179"/>
-              <a:ext cx="1259680" cy="866775"/>
+              <a:off x="4858115" y="5161353"/>
+              <a:ext cx="1735200" cy="867600"/>
             </a:xfrm>
             <a:prstGeom prst="roundRect">
               <a:avLst/>
@@ -37165,14 +37165,14 @@
             <p:nvPr/>
           </p:nvPicPr>
           <p:blipFill>
-            <a:blip r:embed="rId9"/>
+            <a:blip r:embed="rId10"/>
             <a:stretch>
               <a:fillRect/>
             </a:stretch>
           </p:blipFill>
           <p:spPr>
             <a:xfrm flipH="1">
-              <a:off x="5378242" y="5429497"/>
+              <a:off x="5378242" y="5428671"/>
               <a:ext cx="694946" cy="618136"/>
             </a:xfrm>
             <a:prstGeom prst="rect">
@@ -37196,8 +37196,8 @@
           </p:nvSpPr>
           <p:spPr>
             <a:xfrm>
-              <a:off x="5083254" y="5180858"/>
-              <a:ext cx="1259680" cy="276999"/>
+              <a:off x="4858115" y="5180032"/>
+              <a:ext cx="1735200" cy="276999"/>
             </a:xfrm>
             <a:prstGeom prst="rect">
               <a:avLst/>
@@ -37236,8 +37236,8 @@
           </p:nvSpPr>
           <p:spPr>
             <a:xfrm>
-              <a:off x="5095875" y="5457857"/>
-              <a:ext cx="1259680" cy="0"/>
+              <a:off x="4858115" y="5457031"/>
+              <a:ext cx="1735200" cy="0"/>
             </a:xfrm>
             <a:prstGeom prst="line">
               <a:avLst/>
@@ -37279,10 +37279,10 @@
         </p:nvGrpSpPr>
         <p:grpSpPr>
           <a:xfrm>
-            <a:off x="8040401" y="1571625"/>
-            <a:ext cx="1414131" cy="866775"/>
-            <a:chOff x="8040401" y="1571625"/>
-            <a:chExt cx="1414131" cy="866775"/>
+            <a:off x="7848442" y="1570799"/>
+            <a:ext cx="1735200" cy="867600"/>
+            <a:chOff x="7848442" y="1570799"/>
+            <a:chExt cx="1735200" cy="867600"/>
           </a:xfrm>
         </p:grpSpPr>
         <p:sp>
@@ -37301,8 +37301,8 @@
           </p:nvSpPr>
           <p:spPr>
             <a:xfrm>
-              <a:off x="8086202" y="1571625"/>
-              <a:ext cx="1259680" cy="866775"/>
+              <a:off x="7848442" y="1570799"/>
+              <a:ext cx="1735200" cy="867600"/>
             </a:xfrm>
             <a:prstGeom prst="roundRect">
               <a:avLst/>
@@ -37361,14 +37361,14 @@
             <p:nvPr/>
           </p:nvPicPr>
           <p:blipFill>
-            <a:blip r:embed="rId10"/>
+            <a:blip r:embed="rId11"/>
             <a:stretch>
               <a:fillRect/>
             </a:stretch>
           </p:blipFill>
           <p:spPr>
             <a:xfrm flipH="1">
-              <a:off x="8449146" y="1893252"/>
+              <a:off x="8449146" y="1892426"/>
               <a:ext cx="533792" cy="541782"/>
             </a:xfrm>
             <a:prstGeom prst="rect">
@@ -37392,8 +37392,8 @@
           </p:nvSpPr>
           <p:spPr>
             <a:xfrm>
-              <a:off x="8040401" y="1571625"/>
-              <a:ext cx="1414131" cy="276999"/>
+              <a:off x="7848442" y="1570799"/>
+              <a:ext cx="1735200" cy="276999"/>
             </a:xfrm>
             <a:prstGeom prst="rect">
               <a:avLst/>
@@ -37432,8 +37432,8 @@
           </p:nvSpPr>
           <p:spPr>
             <a:xfrm>
-              <a:off x="8086202" y="1855424"/>
-              <a:ext cx="1259680" cy="0"/>
+              <a:off x="7848442" y="1854598"/>
+              <a:ext cx="1735200" cy="0"/>
             </a:xfrm>
             <a:prstGeom prst="line">
               <a:avLst/>
@@ -37475,10 +37475,10 @@
         </p:nvGrpSpPr>
         <p:grpSpPr>
           <a:xfrm>
-            <a:off x="8096250" y="5162179"/>
-            <a:ext cx="1259680" cy="889358"/>
-            <a:chOff x="8096250" y="5162179"/>
-            <a:chExt cx="1259680" cy="889358"/>
+            <a:off x="7858490" y="5161353"/>
+            <a:ext cx="1735200" cy="889358"/>
+            <a:chOff x="7858490" y="5161353"/>
+            <a:chExt cx="1735200" cy="889358"/>
           </a:xfrm>
         </p:grpSpPr>
         <p:sp>
@@ -37497,8 +37497,8 @@
           </p:nvSpPr>
           <p:spPr>
             <a:xfrm>
-              <a:off x="8096250" y="5162179"/>
-              <a:ext cx="1259680" cy="866775"/>
+              <a:off x="7858490" y="5161353"/>
+              <a:ext cx="1735200" cy="867600"/>
             </a:xfrm>
             <a:prstGeom prst="roundRect">
               <a:avLst/>
@@ -37557,14 +37557,14 @@
             <p:nvPr/>
           </p:nvPicPr>
           <p:blipFill>
-            <a:blip r:embed="rId10"/>
+            <a:blip r:embed="rId11"/>
             <a:stretch>
               <a:fillRect/>
             </a:stretch>
           </p:blipFill>
           <p:spPr>
             <a:xfrm flipH="1">
-              <a:off x="8433628" y="5457857"/>
+              <a:off x="8433628" y="5457031"/>
               <a:ext cx="584924" cy="593680"/>
             </a:xfrm>
             <a:prstGeom prst="rect">
@@ -37588,8 +37588,8 @@
           </p:nvSpPr>
           <p:spPr>
             <a:xfrm>
-              <a:off x="8155543" y="5208159"/>
-              <a:ext cx="1128128" cy="276999"/>
+              <a:off x="7858490" y="5207333"/>
+              <a:ext cx="1735200" cy="276999"/>
             </a:xfrm>
             <a:prstGeom prst="rect">
               <a:avLst/>
@@ -37636,8 +37636,8 @@
           </p:nvSpPr>
           <p:spPr>
             <a:xfrm flipV="1">
-              <a:off x="8096250" y="5450740"/>
-              <a:ext cx="1259680" cy="0"/>
+              <a:off x="7858490" y="5449914"/>
+              <a:ext cx="1735200" cy="0"/>
             </a:xfrm>
             <a:prstGeom prst="line">
               <a:avLst/>
@@ -37690,7 +37690,7 @@
         <p:spPr>
           <a:xfrm flipV="1">
             <a:off x="1344215" y="2438400"/>
-            <a:ext cx="2159701" cy="2705100"/>
+            <a:ext cx="2350688" cy="2705100"/>
           </a:xfrm>
           <a:prstGeom prst="straightConnector1">
             <a:avLst/>
@@ -37831,8 +37831,8 @@
         </p:nvCxnSpPr>
         <p:spPr>
           <a:xfrm flipH="1">
-            <a:off x="5754145" y="2012297"/>
-            <a:ext cx="604939" cy="783373"/>
+            <a:off x="6114751" y="2012297"/>
+            <a:ext cx="642461" cy="783373"/>
           </a:xfrm>
           <a:prstGeom prst="straightConnector1">
             <a:avLst/>
@@ -38009,8 +38009,8 @@
         </p:nvCxnSpPr>
         <p:spPr>
           <a:xfrm flipH="1">
-            <a:off x="6355555" y="3210379"/>
-            <a:ext cx="1740695" cy="0"/>
+            <a:off x="6716161" y="3210379"/>
+            <a:ext cx="1380089" cy="0"/>
           </a:xfrm>
           <a:prstGeom prst="straightConnector1">
             <a:avLst/>
@@ -38050,14 +38050,15 @@
             </a:extLst>
           </p:cNvPr>
           <p:cNvCxnSpPr>
+            <a:cxnSpLocks/>
             <a:stCxn id="93" idx="1"/>
           </p:cNvCxnSpPr>
           <p:nvPr/>
         </p:nvCxnSpPr>
         <p:spPr>
           <a:xfrm flipH="1">
-            <a:off x="4355058" y="1891405"/>
-            <a:ext cx="3003894" cy="893383"/>
+            <a:off x="4355058" y="2005013"/>
+            <a:ext cx="3499473" cy="779775"/>
           </a:xfrm>
           <a:prstGeom prst="straightConnector1">
             <a:avLst/>
@@ -38187,7 +38188,7 @@
         <p:spPr>
           <a:xfrm>
             <a:off x="1967744" y="2005013"/>
-            <a:ext cx="906332" cy="0"/>
+            <a:ext cx="1097319" cy="0"/>
           </a:xfrm>
           <a:prstGeom prst="straightConnector1">
             <a:avLst/>
@@ -38225,10 +38226,10 @@
         </p:nvGrpSpPr>
         <p:grpSpPr>
           <a:xfrm>
-            <a:off x="2828275" y="1571625"/>
-            <a:ext cx="1414131" cy="866775"/>
-            <a:chOff x="2828275" y="1571625"/>
-            <a:chExt cx="1414131" cy="866775"/>
+            <a:off x="2636316" y="1570799"/>
+            <a:ext cx="1735200" cy="867600"/>
+            <a:chOff x="2636316" y="1570799"/>
+            <a:chExt cx="1735200" cy="867600"/>
           </a:xfrm>
         </p:grpSpPr>
         <p:sp>
@@ -38247,8 +38248,8 @@
           </p:nvSpPr>
           <p:spPr>
             <a:xfrm>
-              <a:off x="2874076" y="1571625"/>
-              <a:ext cx="1259680" cy="866775"/>
+              <a:off x="2636316" y="1570799"/>
+              <a:ext cx="1735200" cy="867600"/>
             </a:xfrm>
             <a:prstGeom prst="roundRect">
               <a:avLst/>
@@ -38307,14 +38308,14 @@
             <p:nvPr/>
           </p:nvPicPr>
           <p:blipFill>
-            <a:blip r:embed="rId10"/>
+            <a:blip r:embed="rId11"/>
             <a:stretch>
               <a:fillRect/>
             </a:stretch>
           </p:blipFill>
           <p:spPr>
             <a:xfrm flipH="1">
-              <a:off x="3266354" y="1910325"/>
+              <a:off x="3266354" y="1909499"/>
               <a:ext cx="475124" cy="482236"/>
             </a:xfrm>
             <a:prstGeom prst="rect">
@@ -38338,8 +38339,8 @@
           </p:nvSpPr>
           <p:spPr>
             <a:xfrm>
-              <a:off x="2828275" y="1571625"/>
-              <a:ext cx="1414131" cy="276999"/>
+              <a:off x="2636316" y="1570799"/>
+              <a:ext cx="1735200" cy="276999"/>
             </a:xfrm>
             <a:prstGeom prst="rect">
               <a:avLst/>
@@ -38378,8 +38379,8 @@
           </p:nvSpPr>
           <p:spPr>
             <a:xfrm>
-              <a:off x="2874076" y="1855424"/>
-              <a:ext cx="1259680" cy="0"/>
+              <a:off x="2636316" y="1854598"/>
+              <a:ext cx="1735200" cy="0"/>
             </a:xfrm>
             <a:prstGeom prst="line">
               <a:avLst/>
@@ -38467,8 +38468,8 @@
         </p:nvCxnSpPr>
         <p:spPr>
           <a:xfrm>
-            <a:off x="4133756" y="2005013"/>
-            <a:ext cx="965648" cy="7284"/>
+            <a:off x="4324743" y="2005013"/>
+            <a:ext cx="1172789" cy="7284"/>
           </a:xfrm>
           <a:prstGeom prst="straightConnector1">
             <a:avLst/>
@@ -38614,8 +38615,8 @@
         </p:nvCxnSpPr>
         <p:spPr>
           <a:xfrm flipH="1">
-            <a:off x="9345882" y="2005013"/>
-            <a:ext cx="941118" cy="0"/>
+            <a:off x="9114211" y="2005013"/>
+            <a:ext cx="1172789" cy="0"/>
           </a:xfrm>
           <a:prstGeom prst="straightConnector1">
             <a:avLst/>
@@ -38662,9 +38663,9 @@
           <p:nvPr/>
         </p:nvCxnSpPr>
         <p:spPr>
-          <a:xfrm flipH="1">
-            <a:off x="8713469" y="2435034"/>
-            <a:ext cx="6440" cy="360636"/>
+          <a:xfrm>
+            <a:off x="8484371" y="2435034"/>
+            <a:ext cx="229098" cy="360636"/>
           </a:xfrm>
           <a:prstGeom prst="straightConnector1">
             <a:avLst/>
@@ -38712,8 +38713,8 @@
         </p:nvCxnSpPr>
         <p:spPr>
           <a:xfrm flipH="1">
-            <a:off x="5725715" y="2427045"/>
-            <a:ext cx="3529" cy="349946"/>
+            <a:off x="6086321" y="2427045"/>
+            <a:ext cx="41051" cy="349946"/>
           </a:xfrm>
           <a:prstGeom prst="straightConnector1">
             <a:avLst/>
@@ -38762,7 +38763,7 @@
         <p:spPr>
           <a:xfrm flipH="1">
             <a:off x="5713094" y="3643767"/>
-            <a:ext cx="7804" cy="1537091"/>
+            <a:ext cx="373227" cy="1537091"/>
           </a:xfrm>
           <a:prstGeom prst="straightConnector1">
             <a:avLst/>
@@ -38800,10 +38801,10 @@
         </p:nvGrpSpPr>
         <p:grpSpPr>
           <a:xfrm>
-            <a:off x="708064" y="1571625"/>
-            <a:ext cx="1259680" cy="866775"/>
-            <a:chOff x="708064" y="1571625"/>
-            <a:chExt cx="1259680" cy="866775"/>
+            <a:off x="470304" y="1570799"/>
+            <a:ext cx="1735200" cy="867600"/>
+            <a:chOff x="470304" y="1570799"/>
+            <a:chExt cx="1735200" cy="867600"/>
           </a:xfrm>
         </p:grpSpPr>
         <p:sp>
@@ -38822,8 +38823,8 @@
           </p:nvSpPr>
           <p:spPr>
             <a:xfrm>
-              <a:off x="708064" y="1571625"/>
-              <a:ext cx="1259680" cy="866775"/>
+              <a:off x="470304" y="1570799"/>
+              <a:ext cx="1735200" cy="867600"/>
             </a:xfrm>
             <a:prstGeom prst="roundRect">
               <a:avLst/>
@@ -38880,8 +38881,8 @@
           </p:nvSpPr>
           <p:spPr>
             <a:xfrm>
-              <a:off x="708064" y="1590304"/>
-              <a:ext cx="1259680" cy="276999"/>
+              <a:off x="470304" y="1589478"/>
+              <a:ext cx="1735200" cy="276999"/>
             </a:xfrm>
             <a:prstGeom prst="rect">
               <a:avLst/>
@@ -38926,7 +38927,7 @@
           </p:blipFill>
           <p:spPr>
             <a:xfrm flipH="1">
-              <a:off x="1110373" y="1881733"/>
+              <a:off x="1110373" y="1880907"/>
               <a:ext cx="455061" cy="530359"/>
             </a:xfrm>
             <a:prstGeom prst="rect">
@@ -38950,8 +38951,8 @@
           </p:nvSpPr>
           <p:spPr>
             <a:xfrm>
-              <a:off x="708064" y="1864279"/>
-              <a:ext cx="1259680" cy="0"/>
+              <a:off x="470304" y="1863453"/>
+              <a:ext cx="1735200" cy="0"/>
             </a:xfrm>
             <a:prstGeom prst="line">
               <a:avLst/>
@@ -39016,7 +39017,7 @@
                             </p:stCondLst>
                             <p:childTnLst>
                               <p:par>
-                                <p:cTn id="5" presetID="1" presetClass="entr" presetSubtype="0" fill="hold" grpId="0" nodeType="clickEffect">
+                                <p:cTn id="5" presetID="1" presetClass="entr" presetSubtype="0" fill="hold" nodeType="clickEffect">
                                   <p:stCondLst>
                                     <p:cond delay="0"/>
                                   </p:stCondLst>
@@ -39070,7 +39071,7 @@
                                 </p:cTn>
                               </p:par>
                               <p:par>
-                                <p:cTn id="9" presetID="1" presetClass="entr" presetSubtype="0" fill="hold" grpId="0" nodeType="withEffect">
+                                <p:cTn id="9" presetID="1" presetClass="entr" presetSubtype="0" fill="hold" nodeType="withEffect">
                                   <p:stCondLst>
                                     <p:cond delay="0"/>
                                   </p:stCondLst>
@@ -39097,7 +39098,7 @@
                                 </p:cTn>
                               </p:par>
                               <p:par>
-                                <p:cTn id="11" presetID="1" presetClass="entr" presetSubtype="0" fill="hold" grpId="0" nodeType="withEffect">
+                                <p:cTn id="11" presetID="1" presetClass="entr" presetSubtype="0" fill="hold" nodeType="withEffect">
                                   <p:stCondLst>
                                     <p:cond delay="0"/>
                                   </p:stCondLst>
@@ -39142,7 +39143,7 @@
                             </p:stCondLst>
                             <p:childTnLst>
                               <p:par>
-                                <p:cTn id="15" presetID="1" presetClass="entr" presetSubtype="0" fill="hold" grpId="0" nodeType="clickEffect">
+                                <p:cTn id="15" presetID="1" presetClass="entr" presetSubtype="0" fill="hold" nodeType="clickEffect">
                                   <p:stCondLst>
                                     <p:cond delay="0"/>
                                   </p:stCondLst>
@@ -39169,7 +39170,7 @@
                                 </p:cTn>
                               </p:par>
                               <p:par>
-                                <p:cTn id="17" presetID="1" presetClass="entr" presetSubtype="0" fill="hold" grpId="0" nodeType="withEffect">
+                                <p:cTn id="17" presetID="1" presetClass="entr" presetSubtype="0" fill="hold" nodeType="withEffect">
                                   <p:stCondLst>
                                     <p:cond delay="0"/>
                                   </p:stCondLst>
@@ -39196,7 +39197,7 @@
                                 </p:cTn>
                               </p:par>
                               <p:par>
-                                <p:cTn id="19" presetID="1" presetClass="entr" presetSubtype="0" fill="hold" grpId="0" nodeType="withEffect">
+                                <p:cTn id="19" presetID="1" presetClass="entr" presetSubtype="0" fill="hold" nodeType="withEffect">
                                   <p:stCondLst>
                                     <p:cond delay="0"/>
                                   </p:stCondLst>
@@ -39268,7 +39269,7 @@
                             </p:stCondLst>
                             <p:childTnLst>
                               <p:par>
-                                <p:cTn id="25" presetID="1" presetClass="entr" presetSubtype="0" fill="hold" grpId="0" nodeType="clickEffect">
+                                <p:cTn id="25" presetID="1" presetClass="entr" presetSubtype="0" fill="hold" nodeType="clickEffect">
                                   <p:stCondLst>
                                     <p:cond delay="0"/>
                                   </p:stCondLst>
@@ -39322,7 +39323,7 @@
                                 </p:cTn>
                               </p:par>
                               <p:par>
-                                <p:cTn id="29" presetID="1" presetClass="entr" presetSubtype="0" fill="hold" grpId="0" nodeType="withEffect">
+                                <p:cTn id="29" presetID="1" presetClass="entr" presetSubtype="0" fill="hold" nodeType="withEffect">
                                   <p:stCondLst>
                                     <p:cond delay="0"/>
                                   </p:stCondLst>
@@ -39349,7 +39350,7 @@
                                 </p:cTn>
                               </p:par>
                               <p:par>
-                                <p:cTn id="31" presetID="1" presetClass="entr" presetSubtype="0" fill="hold" grpId="0" nodeType="withEffect">
+                                <p:cTn id="31" presetID="1" presetClass="entr" presetSubtype="0" fill="hold" nodeType="withEffect">
                                   <p:stCondLst>
                                     <p:cond delay="0"/>
                                   </p:stCondLst>
@@ -39394,7 +39395,7 @@
                             </p:stCondLst>
                             <p:childTnLst>
                               <p:par>
-                                <p:cTn id="35" presetID="1" presetClass="entr" presetSubtype="0" fill="hold" grpId="0" nodeType="clickEffect">
+                                <p:cTn id="35" presetID="1" presetClass="entr" presetSubtype="0" fill="hold" nodeType="clickEffect">
                                   <p:stCondLst>
                                     <p:cond delay="0"/>
                                   </p:stCondLst>
@@ -39421,7 +39422,7 @@
                                 </p:cTn>
                               </p:par>
                               <p:par>
-                                <p:cTn id="37" presetID="1" presetClass="entr" presetSubtype="0" fill="hold" grpId="0" nodeType="withEffect">
+                                <p:cTn id="37" presetID="1" presetClass="entr" presetSubtype="0" fill="hold" nodeType="withEffect">
                                   <p:stCondLst>
                                     <p:cond delay="0"/>
                                   </p:stCondLst>
@@ -39475,7 +39476,7 @@
                                 </p:cTn>
                               </p:par>
                               <p:par>
-                                <p:cTn id="41" presetID="1" presetClass="entr" presetSubtype="0" fill="hold" grpId="0" nodeType="withEffect">
+                                <p:cTn id="41" presetID="1" presetClass="entr" presetSubtype="0" fill="hold" nodeType="withEffect">
                                   <p:stCondLst>
                                     <p:cond delay="0"/>
                                   </p:stCondLst>
@@ -39574,7 +39575,7 @@
                                 </p:cTn>
                               </p:par>
                               <p:par>
-                                <p:cTn id="49" presetID="1" presetClass="entr" presetSubtype="0" fill="hold" grpId="0" nodeType="withEffect">
+                                <p:cTn id="49" presetID="1" presetClass="entr" presetSubtype="0" fill="hold" nodeType="withEffect">
                                   <p:stCondLst>
                                     <p:cond delay="0"/>
                                   </p:stCondLst>
@@ -39601,7 +39602,7 @@
                                 </p:cTn>
                               </p:par>
                               <p:par>
-                                <p:cTn id="51" presetID="1" presetClass="entr" presetSubtype="0" fill="hold" grpId="0" nodeType="withEffect">
+                                <p:cTn id="51" presetID="1" presetClass="entr" presetSubtype="0" fill="hold" nodeType="withEffect">
                                   <p:stCondLst>
                                     <p:cond delay="0"/>
                                   </p:stCondLst>
@@ -39628,7 +39629,7 @@
                                 </p:cTn>
                               </p:par>
                               <p:par>
-                                <p:cTn id="53" presetID="1" presetClass="entr" presetSubtype="0" fill="hold" grpId="0" nodeType="withEffect">
+                                <p:cTn id="53" presetID="1" presetClass="entr" presetSubtype="0" fill="hold" nodeType="withEffect">
                                   <p:stCondLst>
                                     <p:cond delay="0"/>
                                   </p:stCondLst>
@@ -39673,7 +39674,7 @@
                             </p:stCondLst>
                             <p:childTnLst>
                               <p:par>
-                                <p:cTn id="57" presetID="1" presetClass="entr" presetSubtype="0" fill="hold" grpId="0" nodeType="clickEffect">
+                                <p:cTn id="57" presetID="1" presetClass="entr" presetSubtype="0" fill="hold" nodeType="clickEffect">
                                   <p:stCondLst>
                                     <p:cond delay="0"/>
                                   </p:stCondLst>
@@ -39727,7 +39728,7 @@
                                 </p:cTn>
                               </p:par>
                               <p:par>
-                                <p:cTn id="61" presetID="1" presetClass="entr" presetSubtype="0" fill="hold" grpId="0" nodeType="withEffect">
+                                <p:cTn id="61" presetID="1" presetClass="entr" presetSubtype="0" fill="hold" nodeType="withEffect">
                                   <p:stCondLst>
                                     <p:cond delay="0"/>
                                   </p:stCondLst>
@@ -39754,7 +39755,7 @@
                                 </p:cTn>
                               </p:par>
                               <p:par>
-                                <p:cTn id="63" presetID="1" presetClass="entr" presetSubtype="0" fill="hold" grpId="0" nodeType="withEffect">
+                                <p:cTn id="63" presetID="1" presetClass="entr" presetSubtype="0" fill="hold" nodeType="withEffect">
                                   <p:stCondLst>
                                     <p:cond delay="0"/>
                                   </p:stCondLst>
@@ -39799,7 +39800,7 @@
                             </p:stCondLst>
                             <p:childTnLst>
                               <p:par>
-                                <p:cTn id="67" presetID="1" presetClass="entr" presetSubtype="0" fill="hold" grpId="0" nodeType="clickEffect">
+                                <p:cTn id="67" presetID="1" presetClass="entr" presetSubtype="0" fill="hold" nodeType="clickEffect">
                                   <p:stCondLst>
                                     <p:cond delay="0"/>
                                   </p:stCondLst>
@@ -39853,7 +39854,7 @@
                                 </p:cTn>
                               </p:par>
                               <p:par>
-                                <p:cTn id="71" presetID="1" presetClass="entr" presetSubtype="0" fill="hold" grpId="0" nodeType="withEffect">
+                                <p:cTn id="71" presetID="1" presetClass="entr" presetSubtype="0" fill="hold" nodeType="withEffect">
                                   <p:stCondLst>
                                     <p:cond delay="0"/>
                                   </p:stCondLst>
@@ -39880,7 +39881,7 @@
                                 </p:cTn>
                               </p:par>
                               <p:par>
-                                <p:cTn id="73" presetID="1" presetClass="entr" presetSubtype="0" fill="hold" grpId="0" nodeType="withEffect">
+                                <p:cTn id="73" presetID="1" presetClass="entr" presetSubtype="0" fill="hold" nodeType="withEffect">
                                   <p:stCondLst>
                                     <p:cond delay="0"/>
                                   </p:stCondLst>
@@ -39925,7 +39926,7 @@
                             </p:stCondLst>
                             <p:childTnLst>
                               <p:par>
-                                <p:cTn id="77" presetID="1" presetClass="entr" presetSubtype="0" fill="hold" grpId="0" nodeType="clickEffect">
+                                <p:cTn id="77" presetID="1" presetClass="entr" presetSubtype="0" fill="hold" nodeType="clickEffect">
                                   <p:stCondLst>
                                     <p:cond delay="0"/>
                                   </p:stCondLst>
@@ -39979,7 +39980,7 @@
                                 </p:cTn>
                               </p:par>
                               <p:par>
-                                <p:cTn id="81" presetID="1" presetClass="entr" presetSubtype="0" fill="hold" grpId="0" nodeType="withEffect">
+                                <p:cTn id="81" presetID="1" presetClass="entr" presetSubtype="0" fill="hold" nodeType="withEffect">
                                   <p:stCondLst>
                                     <p:cond delay="0"/>
                                   </p:stCondLst>
@@ -40006,7 +40007,7 @@
                                 </p:cTn>
                               </p:par>
                               <p:par>
-                                <p:cTn id="83" presetID="1" presetClass="entr" presetSubtype="0" fill="hold" grpId="0" nodeType="withEffect">
+                                <p:cTn id="83" presetID="1" presetClass="entr" presetSubtype="0" fill="hold" nodeType="withEffect">
                                   <p:stCondLst>
                                     <p:cond delay="0"/>
                                   </p:stCondLst>
@@ -40051,7 +40052,7 @@
                             </p:stCondLst>
                             <p:childTnLst>
                               <p:par>
-                                <p:cTn id="87" presetID="1" presetClass="entr" presetSubtype="0" fill="hold" grpId="0" nodeType="clickEffect">
+                                <p:cTn id="87" presetID="1" presetClass="entr" presetSubtype="0" fill="hold" nodeType="clickEffect">
                                   <p:stCondLst>
                                     <p:cond delay="0"/>
                                   </p:stCondLst>
@@ -40105,7 +40106,7 @@
                                 </p:cTn>
                               </p:par>
                               <p:par>
-                                <p:cTn id="91" presetID="1" presetClass="entr" presetSubtype="0" fill="hold" grpId="0" nodeType="withEffect">
+                                <p:cTn id="91" presetID="1" presetClass="entr" presetSubtype="0" fill="hold" nodeType="withEffect">
                                   <p:stCondLst>
                                     <p:cond delay="0"/>
                                   </p:stCondLst>
@@ -40132,7 +40133,7 @@
                                 </p:cTn>
                               </p:par>
                               <p:par>
-                                <p:cTn id="93" presetID="1" presetClass="entr" presetSubtype="0" fill="hold" grpId="0" nodeType="withEffect">
+                                <p:cTn id="93" presetID="1" presetClass="entr" presetSubtype="0" fill="hold" nodeType="withEffect">
                                   <p:stCondLst>
                                     <p:cond delay="0"/>
                                   </p:stCondLst>
@@ -40177,7 +40178,7 @@
                             </p:stCondLst>
                             <p:childTnLst>
                               <p:par>
-                                <p:cTn id="97" presetID="1" presetClass="entr" presetSubtype="0" fill="hold" grpId="0" nodeType="clickEffect">
+                                <p:cTn id="97" presetID="1" presetClass="entr" presetSubtype="0" fill="hold" nodeType="clickEffect">
                                   <p:stCondLst>
                                     <p:cond delay="0"/>
                                   </p:stCondLst>
@@ -40231,7 +40232,7 @@
                                 </p:cTn>
                               </p:par>
                               <p:par>
-                                <p:cTn id="101" presetID="1" presetClass="entr" presetSubtype="0" fill="hold" grpId="0" nodeType="withEffect">
+                                <p:cTn id="101" presetID="1" presetClass="entr" presetSubtype="0" fill="hold" nodeType="withEffect">
                                   <p:stCondLst>
                                     <p:cond delay="0"/>
                                   </p:stCondLst>
@@ -40258,7 +40259,7 @@
                                 </p:cTn>
                               </p:par>
                               <p:par>
-                                <p:cTn id="103" presetID="1" presetClass="entr" presetSubtype="0" fill="hold" grpId="0" nodeType="withEffect">
+                                <p:cTn id="103" presetID="1" presetClass="entr" presetSubtype="0" fill="hold" nodeType="withEffect">
                                   <p:stCondLst>
                                     <p:cond delay="0"/>
                                   </p:stCondLst>
@@ -40330,7 +40331,7 @@
                             </p:stCondLst>
                             <p:childTnLst>
                               <p:par>
-                                <p:cTn id="109" presetID="1" presetClass="entr" presetSubtype="0" fill="hold" grpId="0" nodeType="clickEffect">
+                                <p:cTn id="109" presetID="1" presetClass="entr" presetSubtype="0" fill="hold" nodeType="clickEffect">
                                   <p:stCondLst>
                                     <p:cond delay="0"/>
                                   </p:stCondLst>
@@ -40384,7 +40385,7 @@
                                 </p:cTn>
                               </p:par>
                               <p:par>
-                                <p:cTn id="113" presetID="1" presetClass="entr" presetSubtype="0" fill="hold" grpId="0" nodeType="withEffect">
+                                <p:cTn id="113" presetID="1" presetClass="entr" presetSubtype="0" fill="hold" nodeType="withEffect">
                                   <p:stCondLst>
                                     <p:cond delay="0"/>
                                   </p:stCondLst>
@@ -40411,7 +40412,7 @@
                                 </p:cTn>
                               </p:par>
                               <p:par>
-                                <p:cTn id="115" presetID="1" presetClass="entr" presetSubtype="0" fill="hold" grpId="0" nodeType="withEffect">
+                                <p:cTn id="115" presetID="1" presetClass="entr" presetSubtype="0" fill="hold" nodeType="withEffect">
                                   <p:stCondLst>
                                     <p:cond delay="0"/>
                                   </p:stCondLst>
@@ -40465,7 +40466,7 @@
                                 </p:cTn>
                               </p:par>
                               <p:par>
-                                <p:cTn id="119" presetID="1" presetClass="entr" presetSubtype="0" fill="hold" grpId="0" nodeType="withEffect">
+                                <p:cTn id="119" presetID="1" presetClass="entr" presetSubtype="0" fill="hold" nodeType="withEffect">
                                   <p:stCondLst>
                                     <p:cond delay="0"/>
                                   </p:stCondLst>
@@ -40519,7 +40520,7 @@
                                 </p:cTn>
                               </p:par>
                               <p:par>
-                                <p:cTn id="123" presetID="1" presetClass="entr" presetSubtype="0" fill="hold" grpId="0" nodeType="withEffect">
+                                <p:cTn id="123" presetID="1" presetClass="entr" presetSubtype="0" fill="hold" nodeType="withEffect">
                                   <p:stCondLst>
                                     <p:cond delay="0"/>
                                   </p:stCondLst>
@@ -43430,15 +43431,6 @@
 </file>
 
 <file path=customXml/item1.xml><?xml version="1.0" encoding="utf-8"?>
-<?mso-contentType ?>
-<FormTemplates xmlns="http://schemas.microsoft.com/sharepoint/v3/contenttype/forms">
-  <Display>DocumentLibraryForm</Display>
-  <Edit>DocumentLibraryForm</Edit>
-  <New>DocumentLibraryForm</New>
-</FormTemplates>
-</file>
-
-<file path=customXml/item2.xml><?xml version="1.0" encoding="utf-8"?>
 <ct:contentTypeSchema xmlns:ct="http://schemas.microsoft.com/office/2006/metadata/contentType" xmlns:ma="http://schemas.microsoft.com/office/2006/metadata/properties/metaAttributes" ct:_="" ma:_="" ma:contentTypeName="Dokument" ma:contentTypeID="0x0101007D39DBAC6A50C74E998B9EB660A68B40" ma:contentTypeVersion="12" ma:contentTypeDescription="Ein neues Dokument erstellen." ma:contentTypeScope="" ma:versionID="34dc225a7d6106712b96f9699847575b">
   <xsd:schema xmlns:xsd="http://www.w3.org/2001/XMLSchema" xmlns:xs="http://www.w3.org/2001/XMLSchema" xmlns:p="http://schemas.microsoft.com/office/2006/metadata/properties" xmlns:ns2="501edefc-5b9b-422a-9450-cf7f1f30e3fa" xmlns:ns3="3083c7a9-d95a-44c4-8fb8-f93b125494d6" targetNamespace="http://schemas.microsoft.com/office/2006/metadata/properties" ma:root="true" ma:fieldsID="b7244162b0b071e6bfc5af2eca0d94d3" ns2:_="" ns3:_="">
     <xsd:import namespace="501edefc-5b9b-422a-9450-cf7f1f30e3fa"/>
@@ -43639,6 +43631,15 @@
 </ct:contentTypeSchema>
 </file>
 
+<file path=customXml/item2.xml><?xml version="1.0" encoding="utf-8"?>
+<?mso-contentType ?>
+<FormTemplates xmlns="http://schemas.microsoft.com/sharepoint/v3/contenttype/forms">
+  <Display>DocumentLibraryForm</Display>
+  <Edit>DocumentLibraryForm</Edit>
+  <New>DocumentLibraryForm</New>
+</FormTemplates>
+</file>
+
 <file path=customXml/item3.xml><?xml version="1.0" encoding="utf-8"?>
 <p:properties xmlns:p="http://schemas.microsoft.com/office/2006/metadata/properties" xmlns:xsi="http://www.w3.org/2001/XMLSchema-instance" xmlns:pc="http://schemas.microsoft.com/office/infopath/2007/PartnerControls">
   <documentManagement>
@@ -43651,14 +43652,6 @@
 </file>
 
 <file path=customXml/itemProps1.xml><?xml version="1.0" encoding="utf-8"?>
-<ds:datastoreItem xmlns:ds="http://schemas.openxmlformats.org/officeDocument/2006/customXml" ds:itemID="{334436CE-240F-4EE4-9FC5-4255E6874223}">
-  <ds:schemaRefs>
-    <ds:schemaRef ds:uri="http://schemas.microsoft.com/sharepoint/v3/contenttype/forms"/>
-  </ds:schemaRefs>
-</ds:datastoreItem>
-</file>
-
-<file path=customXml/itemProps2.xml><?xml version="1.0" encoding="utf-8"?>
 <ds:datastoreItem xmlns:ds="http://schemas.openxmlformats.org/officeDocument/2006/customXml" ds:itemID="{42C8284C-7C61-4B35-A2FD-8E50AFE93672}">
   <ds:schemaRefs>
     <ds:schemaRef ds:uri="http://schemas.microsoft.com/office/2006/metadata/contentType"/>
@@ -43673,6 +43666,14 @@
     <ds:schemaRef ds:uri="http://purl.org/dc/elements/1.1/"/>
     <ds:schemaRef ds:uri="http://purl.org/dc/terms/"/>
     <ds:schemaRef ds:uri="http://schemas.microsoft.com/internal/obd"/>
+  </ds:schemaRefs>
+</ds:datastoreItem>
+</file>
+
+<file path=customXml/itemProps2.xml><?xml version="1.0" encoding="utf-8"?>
+<ds:datastoreItem xmlns:ds="http://schemas.openxmlformats.org/officeDocument/2006/customXml" ds:itemID="{334436CE-240F-4EE4-9FC5-4255E6874223}">
+  <ds:schemaRefs>
+    <ds:schemaRef ds:uri="http://schemas.microsoft.com/sharepoint/v3/contenttype/forms"/>
   </ds:schemaRefs>
 </ds:datastoreItem>
 </file>

</xml_diff>

<commit_message>
Set slide-7 diagram boxes to 3.8 cm width
Narrow all 16 grouped boxes (including the three groups duplicated
manually since the last commit) around their centres; labels and
dividers follow the new width, icons are re-centred and the group
frames recomputed. Height stays at 2.41 cm.

Co-Authored-By: Claude Fable 5 <noreply@anthropic.com>
Claude-Session: https://claude.ai/code/session_01S2kGP2buE2HmxMttD3XczR
</commit_message>
<xml_diff>
--- a/RAG_Workshop.pptx
+++ b/RAG_Workshop.pptx
@@ -35634,10 +35634,10 @@
         </p:nvGrpSpPr>
         <p:grpSpPr>
           <a:xfrm>
-            <a:off x="476615" y="5142674"/>
-            <a:ext cx="1735200" cy="867600"/>
-            <a:chOff x="476615" y="5142674"/>
-            <a:chExt cx="1735200" cy="867600"/>
+            <a:off x="660215" y="5142674"/>
+            <a:ext cx="1368000" cy="867600"/>
+            <a:chOff x="660215" y="5142674"/>
+            <a:chExt cx="1368000" cy="867600"/>
           </a:xfrm>
         </p:grpSpPr>
         <p:sp>
@@ -35656,8 +35656,8 @@
           </p:nvSpPr>
           <p:spPr>
             <a:xfrm>
-              <a:off x="476615" y="5142674"/>
-              <a:ext cx="1735200" cy="867600"/>
+              <a:off x="660215" y="5142674"/>
+              <a:ext cx="1368000" cy="867600"/>
             </a:xfrm>
             <a:prstGeom prst="roundRect">
               <a:avLst/>
@@ -35714,8 +35714,8 @@
           </p:nvSpPr>
           <p:spPr>
             <a:xfrm>
-              <a:off x="476615" y="5161353"/>
-              <a:ext cx="1735200" cy="276999"/>
+              <a:off x="660215" y="5161353"/>
+              <a:ext cx="1368000" cy="276999"/>
             </a:xfrm>
             <a:prstGeom prst="rect">
               <a:avLst/>
@@ -35754,8 +35754,8 @@
           </p:nvSpPr>
           <p:spPr>
             <a:xfrm>
-              <a:off x="476615" y="5438352"/>
-              <a:ext cx="1735200" cy="0"/>
+              <a:off x="660215" y="5438352"/>
+              <a:ext cx="1368000" cy="0"/>
             </a:xfrm>
             <a:prstGeom prst="line">
               <a:avLst/>
@@ -35827,10 +35827,10 @@
         </p:nvGrpSpPr>
         <p:grpSpPr>
           <a:xfrm>
-            <a:off x="10049240" y="1570799"/>
-            <a:ext cx="1735200" cy="867600"/>
-            <a:chOff x="10049240" y="1570799"/>
-            <a:chExt cx="1735200" cy="867600"/>
+            <a:off x="10232840" y="1570799"/>
+            <a:ext cx="1368000" cy="867600"/>
+            <a:chOff x="10232840" y="1570799"/>
+            <a:chExt cx="1368000" cy="867600"/>
           </a:xfrm>
         </p:grpSpPr>
         <p:sp>
@@ -35849,8 +35849,8 @@
           </p:nvSpPr>
           <p:spPr>
             <a:xfrm>
-              <a:off x="10049240" y="1570799"/>
-              <a:ext cx="1735200" cy="867600"/>
+              <a:off x="10232840" y="1570799"/>
+              <a:ext cx="1368000" cy="867600"/>
             </a:xfrm>
             <a:prstGeom prst="roundRect">
               <a:avLst/>
@@ -35937,8 +35937,8 @@
           </p:nvSpPr>
           <p:spPr>
             <a:xfrm>
-              <a:off x="10049240" y="1589478"/>
-              <a:ext cx="1735200" cy="276999"/>
+              <a:off x="10232840" y="1589478"/>
+              <a:ext cx="1368000" cy="276999"/>
             </a:xfrm>
             <a:prstGeom prst="rect">
               <a:avLst/>
@@ -35974,10 +35974,10 @@
         </p:nvGrpSpPr>
         <p:grpSpPr>
           <a:xfrm>
-            <a:off x="10049240" y="5161353"/>
-            <a:ext cx="1735200" cy="867600"/>
-            <a:chOff x="10049240" y="5161353"/>
-            <a:chExt cx="1735200" cy="867600"/>
+            <a:off x="10232840" y="5161353"/>
+            <a:ext cx="1368000" cy="867600"/>
+            <a:chOff x="10232840" y="5161353"/>
+            <a:chExt cx="1368000" cy="867600"/>
           </a:xfrm>
         </p:grpSpPr>
         <p:sp>
@@ -35996,8 +35996,8 @@
           </p:nvSpPr>
           <p:spPr>
             <a:xfrm>
-              <a:off x="10049240" y="5161353"/>
-              <a:ext cx="1735200" cy="867600"/>
+              <a:off x="10232840" y="5161353"/>
+              <a:ext cx="1368000" cy="867600"/>
             </a:xfrm>
             <a:prstGeom prst="roundRect">
               <a:avLst/>
@@ -36084,8 +36084,8 @@
           </p:nvSpPr>
           <p:spPr>
             <a:xfrm>
-              <a:off x="10049240" y="5180032"/>
-              <a:ext cx="1735200" cy="276999"/>
+              <a:off x="10232840" y="5180032"/>
+              <a:ext cx="1368000" cy="276999"/>
             </a:xfrm>
             <a:prstGeom prst="rect">
               <a:avLst/>
@@ -36121,10 +36121,10 @@
         </p:nvGrpSpPr>
         <p:grpSpPr>
           <a:xfrm>
-            <a:off x="475308" y="3952049"/>
-            <a:ext cx="1735200" cy="867600"/>
-            <a:chOff x="475308" y="3952049"/>
-            <a:chExt cx="1735200" cy="867600"/>
+            <a:off x="658908" y="3952049"/>
+            <a:ext cx="1368000" cy="867600"/>
+            <a:chOff x="658908" y="3952049"/>
+            <a:chExt cx="1368000" cy="867600"/>
           </a:xfrm>
         </p:grpSpPr>
         <p:sp>
@@ -36143,8 +36143,8 @@
           </p:nvSpPr>
           <p:spPr>
             <a:xfrm>
-              <a:off x="475308" y="3952049"/>
-              <a:ext cx="1735200" cy="867600"/>
+              <a:off x="658908" y="3952049"/>
+              <a:ext cx="1368000" cy="867600"/>
             </a:xfrm>
             <a:prstGeom prst="roundRect">
               <a:avLst/>
@@ -36231,8 +36231,8 @@
           </p:nvSpPr>
           <p:spPr>
             <a:xfrm>
-              <a:off x="475308" y="3970728"/>
-              <a:ext cx="1735200" cy="276999"/>
+              <a:off x="658908" y="3970728"/>
+              <a:ext cx="1368000" cy="276999"/>
             </a:xfrm>
             <a:prstGeom prst="rect">
               <a:avLst/>
@@ -36249,9 +36249,10 @@
                 <a:buNone/>
               </a:pPr>
               <a:r>
-                <a:rPr sz="1200"/>
-                <a:t>Information Extraction</a:t>
+                <a:rPr lang="de-CH" sz="1200" dirty="0"/>
+                <a:t>Relevant Data</a:t>
               </a:r>
+              <a:endParaRPr sz="1200" dirty="0"/>
             </a:p>
           </p:txBody>
         </p:sp>
@@ -36271,8 +36272,8 @@
           </p:nvSpPr>
           <p:spPr>
             <a:xfrm>
-              <a:off x="475308" y="4247727"/>
-              <a:ext cx="1735200" cy="0"/>
+              <a:off x="658908" y="4247727"/>
+              <a:ext cx="1368000" cy="0"/>
             </a:xfrm>
             <a:prstGeom prst="line">
               <a:avLst/>
@@ -36314,10 +36315,10 @@
         </p:nvGrpSpPr>
         <p:grpSpPr>
           <a:xfrm>
-            <a:off x="476615" y="2761424"/>
-            <a:ext cx="1735200" cy="867600"/>
-            <a:chOff x="476615" y="2761424"/>
-            <a:chExt cx="1735200" cy="867600"/>
+            <a:off x="660215" y="2761424"/>
+            <a:ext cx="1368000" cy="867600"/>
+            <a:chOff x="660215" y="2761424"/>
+            <a:chExt cx="1368000" cy="867600"/>
           </a:xfrm>
         </p:grpSpPr>
         <p:sp>
@@ -36336,8 +36337,8 @@
           </p:nvSpPr>
           <p:spPr>
             <a:xfrm>
-              <a:off x="476615" y="2761424"/>
-              <a:ext cx="1735200" cy="867600"/>
+              <a:off x="660215" y="2761424"/>
+              <a:ext cx="1368000" cy="867600"/>
             </a:xfrm>
             <a:prstGeom prst="roundRect">
               <a:avLst/>
@@ -36394,8 +36395,8 @@
           </p:nvSpPr>
           <p:spPr>
             <a:xfrm>
-              <a:off x="476615" y="2780103"/>
-              <a:ext cx="1735200" cy="276999"/>
+              <a:off x="660215" y="2780103"/>
+              <a:ext cx="1368000" cy="276999"/>
             </a:xfrm>
             <a:prstGeom prst="rect">
               <a:avLst/>
@@ -36434,8 +36435,8 @@
           </p:nvSpPr>
           <p:spPr>
             <a:xfrm>
-              <a:off x="476615" y="3054078"/>
-              <a:ext cx="1735200" cy="0"/>
+              <a:off x="660215" y="3054078"/>
+              <a:ext cx="1368000" cy="0"/>
             </a:xfrm>
             <a:prstGeom prst="line">
               <a:avLst/>
@@ -36507,10 +36508,10 @@
         </p:nvGrpSpPr>
         <p:grpSpPr>
           <a:xfrm>
-            <a:off x="4861644" y="1578083"/>
-            <a:ext cx="1735200" cy="867600"/>
-            <a:chOff x="4861644" y="1578083"/>
-            <a:chExt cx="1735200" cy="867600"/>
+            <a:off x="5045244" y="1578083"/>
+            <a:ext cx="1368000" cy="867600"/>
+            <a:chOff x="5045244" y="1578083"/>
+            <a:chExt cx="1368000" cy="867600"/>
           </a:xfrm>
         </p:grpSpPr>
         <p:sp>
@@ -36529,8 +36530,8 @@
           </p:nvSpPr>
           <p:spPr>
             <a:xfrm>
-              <a:off x="4861644" y="1578083"/>
-              <a:ext cx="1735200" cy="867600"/>
+              <a:off x="5045244" y="1578083"/>
+              <a:ext cx="1368000" cy="867600"/>
             </a:xfrm>
             <a:prstGeom prst="roundRect">
               <a:avLst/>
@@ -36617,8 +36618,8 @@
           </p:nvSpPr>
           <p:spPr>
             <a:xfrm>
-              <a:off x="4861644" y="1596762"/>
-              <a:ext cx="1735200" cy="276999"/>
+              <a:off x="5045244" y="1596762"/>
+              <a:ext cx="1368000" cy="276999"/>
             </a:xfrm>
             <a:prstGeom prst="rect">
               <a:avLst/>
@@ -36657,8 +36658,8 @@
           </p:nvSpPr>
           <p:spPr>
             <a:xfrm flipV="1">
-              <a:off x="4861644" y="1873761"/>
-              <a:ext cx="1735200" cy="0"/>
+              <a:off x="5045244" y="1873761"/>
+              <a:ext cx="1368000" cy="0"/>
             </a:xfrm>
             <a:prstGeom prst="line">
               <a:avLst/>
@@ -36700,10 +36701,10 @@
         </p:nvGrpSpPr>
         <p:grpSpPr>
           <a:xfrm>
-            <a:off x="7858490" y="2776165"/>
-            <a:ext cx="1735200" cy="879071"/>
-            <a:chOff x="7858490" y="2776165"/>
-            <a:chExt cx="1735200" cy="879071"/>
+            <a:off x="8042090" y="2776165"/>
+            <a:ext cx="1368000" cy="879071"/>
+            <a:chOff x="8042090" y="2776165"/>
+            <a:chExt cx="1368000" cy="879071"/>
           </a:xfrm>
         </p:grpSpPr>
         <p:sp>
@@ -36722,8 +36723,8 @@
           </p:nvSpPr>
           <p:spPr>
             <a:xfrm>
-              <a:off x="7858490" y="2776165"/>
-              <a:ext cx="1735200" cy="867600"/>
+              <a:off x="8042090" y="2776165"/>
+              <a:ext cx="1368000" cy="867600"/>
             </a:xfrm>
             <a:prstGeom prst="roundRect">
               <a:avLst/>
@@ -36810,8 +36811,8 @@
           </p:nvSpPr>
           <p:spPr>
             <a:xfrm>
-              <a:off x="7858490" y="2794844"/>
-              <a:ext cx="1735200" cy="276999"/>
+              <a:off x="8042090" y="2794844"/>
+              <a:ext cx="1368000" cy="276999"/>
             </a:xfrm>
             <a:prstGeom prst="rect">
               <a:avLst/>
@@ -36850,8 +36851,8 @@
           </p:nvSpPr>
           <p:spPr>
             <a:xfrm flipV="1">
-              <a:off x="7858490" y="3071843"/>
-              <a:ext cx="1735200" cy="0"/>
+              <a:off x="8042090" y="3071843"/>
+              <a:ext cx="1368000" cy="0"/>
             </a:xfrm>
             <a:prstGeom prst="line">
               <a:avLst/>
@@ -36893,10 +36894,10 @@
         </p:nvGrpSpPr>
         <p:grpSpPr>
           <a:xfrm>
-            <a:off x="4858115" y="2776165"/>
-            <a:ext cx="1735200" cy="867600"/>
-            <a:chOff x="4858115" y="2776165"/>
-            <a:chExt cx="1735200" cy="867600"/>
+            <a:off x="5041715" y="2776165"/>
+            <a:ext cx="1368000" cy="867600"/>
+            <a:chOff x="5041715" y="2776165"/>
+            <a:chExt cx="1368000" cy="867600"/>
           </a:xfrm>
         </p:grpSpPr>
         <p:sp>
@@ -36915,8 +36916,8 @@
           </p:nvSpPr>
           <p:spPr>
             <a:xfrm>
-              <a:off x="4858115" y="2776165"/>
-              <a:ext cx="1735200" cy="867600"/>
+              <a:off x="5041715" y="2776165"/>
+              <a:ext cx="1368000" cy="867600"/>
             </a:xfrm>
             <a:prstGeom prst="roundRect">
               <a:avLst/>
@@ -37003,8 +37004,8 @@
           </p:nvSpPr>
           <p:spPr>
             <a:xfrm>
-              <a:off x="4858115" y="2794844"/>
-              <a:ext cx="1735200" cy="285750"/>
+              <a:off x="5041715" y="2794844"/>
+              <a:ext cx="1368000" cy="285750"/>
             </a:xfrm>
             <a:prstGeom prst="rect">
               <a:avLst/>
@@ -37022,8 +37023,13 @@
               </a:pPr>
               <a:r>
                 <a:rPr sz="1200" dirty="0"/>
-                <a:t>Vector Database</a:t>
+                <a:t>Vector </a:t>
               </a:r>
+              <a:r>
+                <a:rPr lang="de-CH" sz="1200" dirty="0"/>
+                <a:t>DB</a:t>
+              </a:r>
+              <a:endParaRPr sz="1200" dirty="0"/>
             </a:p>
           </p:txBody>
         </p:sp>
@@ -37043,8 +37049,8 @@
           </p:nvSpPr>
           <p:spPr>
             <a:xfrm>
-              <a:off x="4858115" y="3080594"/>
-              <a:ext cx="1735200" cy="0"/>
+              <a:off x="5041715" y="3080594"/>
+              <a:ext cx="1368000" cy="0"/>
             </a:xfrm>
             <a:prstGeom prst="line">
               <a:avLst/>
@@ -37086,10 +37092,10 @@
         </p:nvGrpSpPr>
         <p:grpSpPr>
           <a:xfrm>
-            <a:off x="4858115" y="5161353"/>
-            <a:ext cx="1735200" cy="885454"/>
-            <a:chOff x="4858115" y="5161353"/>
-            <a:chExt cx="1735200" cy="885454"/>
+            <a:off x="5041715" y="5161353"/>
+            <a:ext cx="1368000" cy="885454"/>
+            <a:chOff x="5041715" y="5161353"/>
+            <a:chExt cx="1368000" cy="885454"/>
           </a:xfrm>
         </p:grpSpPr>
         <p:sp>
@@ -37108,8 +37114,8 @@
           </p:nvSpPr>
           <p:spPr>
             <a:xfrm>
-              <a:off x="4858115" y="5161353"/>
-              <a:ext cx="1735200" cy="867600"/>
+              <a:off x="5041715" y="5161353"/>
+              <a:ext cx="1368000" cy="867600"/>
             </a:xfrm>
             <a:prstGeom prst="roundRect">
               <a:avLst/>
@@ -37196,8 +37202,8 @@
           </p:nvSpPr>
           <p:spPr>
             <a:xfrm>
-              <a:off x="4858115" y="5180032"/>
-              <a:ext cx="1735200" cy="276999"/>
+              <a:off x="5041715" y="5180032"/>
+              <a:ext cx="1368000" cy="276999"/>
             </a:xfrm>
             <a:prstGeom prst="rect">
               <a:avLst/>
@@ -37236,8 +37242,8 @@
           </p:nvSpPr>
           <p:spPr>
             <a:xfrm>
-              <a:off x="4858115" y="5457031"/>
-              <a:ext cx="1735200" cy="0"/>
+              <a:off x="5041715" y="5457031"/>
+              <a:ext cx="1368000" cy="0"/>
             </a:xfrm>
             <a:prstGeom prst="line">
               <a:avLst/>
@@ -37279,10 +37285,10 @@
         </p:nvGrpSpPr>
         <p:grpSpPr>
           <a:xfrm>
-            <a:off x="7848442" y="1570799"/>
-            <a:ext cx="1735200" cy="867600"/>
-            <a:chOff x="7848442" y="1570799"/>
-            <a:chExt cx="1735200" cy="867600"/>
+            <a:off x="8032042" y="1570799"/>
+            <a:ext cx="1368000" cy="867600"/>
+            <a:chOff x="8032042" y="1570799"/>
+            <a:chExt cx="1368000" cy="867600"/>
           </a:xfrm>
         </p:grpSpPr>
         <p:sp>
@@ -37301,8 +37307,8 @@
           </p:nvSpPr>
           <p:spPr>
             <a:xfrm>
-              <a:off x="7848442" y="1570799"/>
-              <a:ext cx="1735200" cy="867600"/>
+              <a:off x="8032042" y="1570799"/>
+              <a:ext cx="1368000" cy="867600"/>
             </a:xfrm>
             <a:prstGeom prst="roundRect">
               <a:avLst/>
@@ -37392,8 +37398,8 @@
           </p:nvSpPr>
           <p:spPr>
             <a:xfrm>
-              <a:off x="7848442" y="1570799"/>
-              <a:ext cx="1735200" cy="276999"/>
+              <a:off x="8032042" y="1570799"/>
+              <a:ext cx="1368000" cy="276999"/>
             </a:xfrm>
             <a:prstGeom prst="rect">
               <a:avLst/>
@@ -37432,8 +37438,8 @@
           </p:nvSpPr>
           <p:spPr>
             <a:xfrm>
-              <a:off x="7848442" y="1854598"/>
-              <a:ext cx="1735200" cy="0"/>
+              <a:off x="8032042" y="1854598"/>
+              <a:ext cx="1368000" cy="0"/>
             </a:xfrm>
             <a:prstGeom prst="line">
               <a:avLst/>
@@ -37475,10 +37481,10 @@
         </p:nvGrpSpPr>
         <p:grpSpPr>
           <a:xfrm>
-            <a:off x="7858490" y="5161353"/>
-            <a:ext cx="1735200" cy="889358"/>
-            <a:chOff x="7858490" y="5161353"/>
-            <a:chExt cx="1735200" cy="889358"/>
+            <a:off x="8042090" y="5161353"/>
+            <a:ext cx="1368000" cy="889358"/>
+            <a:chOff x="8042090" y="5161353"/>
+            <a:chExt cx="1368000" cy="889358"/>
           </a:xfrm>
         </p:grpSpPr>
         <p:sp>
@@ -37497,8 +37503,8 @@
           </p:nvSpPr>
           <p:spPr>
             <a:xfrm>
-              <a:off x="7858490" y="5161353"/>
-              <a:ext cx="1735200" cy="867600"/>
+              <a:off x="8042090" y="5161353"/>
+              <a:ext cx="1368000" cy="867600"/>
             </a:xfrm>
             <a:prstGeom prst="roundRect">
               <a:avLst/>
@@ -37588,8 +37594,8 @@
           </p:nvSpPr>
           <p:spPr>
             <a:xfrm>
-              <a:off x="7858490" y="5207333"/>
-              <a:ext cx="1735200" cy="276999"/>
+              <a:off x="8042090" y="5207333"/>
+              <a:ext cx="1368000" cy="276999"/>
             </a:xfrm>
             <a:prstGeom prst="rect">
               <a:avLst/>
@@ -37636,8 +37642,8 @@
           </p:nvSpPr>
           <p:spPr>
             <a:xfrm flipV="1">
-              <a:off x="7858490" y="5449914"/>
-              <a:ext cx="1735200" cy="0"/>
+              <a:off x="8042090" y="5449914"/>
+              <a:ext cx="1368000" cy="0"/>
             </a:xfrm>
             <a:prstGeom prst="line">
               <a:avLst/>
@@ -37776,15 +37782,15 @@
           </p:cNvPr>
           <p:cNvCxnSpPr>
             <a:cxnSpLocks/>
-            <a:stCxn id="45" idx="0"/>
+            <a:stCxn id="48" idx="0"/>
             <a:endCxn id="121" idx="2"/>
           </p:cNvCxnSpPr>
           <p:nvPr/>
         </p:nvCxnSpPr>
         <p:spPr>
           <a:xfrm flipH="1" flipV="1">
-            <a:off x="1337904" y="2438400"/>
-            <a:ext cx="6311" cy="323850"/>
+            <a:off x="1337904" y="2438399"/>
+            <a:ext cx="6311" cy="341704"/>
           </a:xfrm>
           <a:prstGeom prst="straightConnector1">
             <a:avLst/>
@@ -37911,6 +37917,7 @@
             </a:extLst>
           </p:cNvPr>
           <p:cNvCxnSpPr>
+            <a:cxnSpLocks/>
             <a:stCxn id="81" idx="3"/>
             <a:endCxn id="102" idx="1"/>
           </p:cNvCxnSpPr>
@@ -37918,8 +37925,8 @@
         </p:nvCxnSpPr>
         <p:spPr>
           <a:xfrm>
-            <a:off x="6355555" y="5595567"/>
-            <a:ext cx="1740695" cy="0"/>
+            <a:off x="6593315" y="5595153"/>
+            <a:ext cx="1265175" cy="0"/>
           </a:xfrm>
           <a:prstGeom prst="straightConnector1">
             <a:avLst/>
@@ -38002,6 +38009,7 @@
             </a:extLst>
           </p:cNvPr>
           <p:cNvCxnSpPr>
+            <a:cxnSpLocks/>
             <a:stCxn id="60" idx="1"/>
             <a:endCxn id="72" idx="3"/>
           </p:cNvCxnSpPr>
@@ -38009,8 +38017,8 @@
         </p:nvCxnSpPr>
         <p:spPr>
           <a:xfrm flipH="1">
-            <a:off x="6716161" y="3210379"/>
-            <a:ext cx="1380089" cy="0"/>
+            <a:off x="6593315" y="3209965"/>
+            <a:ext cx="1265175" cy="0"/>
           </a:xfrm>
           <a:prstGeom prst="straightConnector1">
             <a:avLst/>
@@ -38187,8 +38195,8 @@
         </p:nvCxnSpPr>
         <p:spPr>
           <a:xfrm>
-            <a:off x="1967744" y="2005013"/>
-            <a:ext cx="1097319" cy="0"/>
+            <a:off x="2205504" y="2004599"/>
+            <a:ext cx="430812" cy="0"/>
           </a:xfrm>
           <a:prstGeom prst="straightConnector1">
             <a:avLst/>
@@ -38226,10 +38234,10 @@
         </p:nvGrpSpPr>
         <p:grpSpPr>
           <a:xfrm>
-            <a:off x="2636316" y="1570799"/>
-            <a:ext cx="1735200" cy="867600"/>
-            <a:chOff x="2636316" y="1570799"/>
-            <a:chExt cx="1735200" cy="867600"/>
+            <a:off x="2819916" y="1570799"/>
+            <a:ext cx="1368000" cy="867600"/>
+            <a:chOff x="2819916" y="1570799"/>
+            <a:chExt cx="1368000" cy="867600"/>
           </a:xfrm>
         </p:grpSpPr>
         <p:sp>
@@ -38248,8 +38256,8 @@
           </p:nvSpPr>
           <p:spPr>
             <a:xfrm>
-              <a:off x="2636316" y="1570799"/>
-              <a:ext cx="1735200" cy="867600"/>
+              <a:off x="2819916" y="1570799"/>
+              <a:ext cx="1368000" cy="867600"/>
             </a:xfrm>
             <a:prstGeom prst="roundRect">
               <a:avLst/>
@@ -38339,8 +38347,8 @@
           </p:nvSpPr>
           <p:spPr>
             <a:xfrm>
-              <a:off x="2636316" y="1570799"/>
-              <a:ext cx="1735200" cy="276999"/>
+              <a:off x="2819916" y="1570799"/>
+              <a:ext cx="1368000" cy="276999"/>
             </a:xfrm>
             <a:prstGeom prst="rect">
               <a:avLst/>
@@ -38379,8 +38387,8 @@
           </p:nvSpPr>
           <p:spPr>
             <a:xfrm>
-              <a:off x="2636316" y="1854598"/>
-              <a:ext cx="1735200" cy="0"/>
+              <a:off x="2819916" y="1854598"/>
+              <a:ext cx="1368000" cy="0"/>
             </a:xfrm>
             <a:prstGeom prst="line">
               <a:avLst/>
@@ -38414,42 +38422,6 @@
           </p:txBody>
         </p:sp>
       </p:grpSp>
-      <p:sp>
-        <p:nvSpPr>
-          <p:cNvPr id="145" name="Textfeld 144">
-            <a:extLst>
-              <a:ext uri="{FF2B5EF4-FFF2-40B4-BE49-F238E27FC236}">
-                <a16:creationId xmlns:a16="http://schemas.microsoft.com/office/drawing/2014/main" id="{8C156430-C202-53BD-8023-A0D5C9A9CCB0}"/>
-              </a:ext>
-            </a:extLst>
-          </p:cNvPr>
-          <p:cNvSpPr txBox="1"/>
-          <p:nvPr/>
-        </p:nvSpPr>
-        <p:spPr>
-          <a:xfrm>
-            <a:off x="6838721" y="5342499"/>
-            <a:ext cx="922500" cy="276999"/>
-          </a:xfrm>
-          <a:prstGeom prst="rect">
-            <a:avLst/>
-          </a:prstGeom>
-          <a:noFill/>
-        </p:spPr>
-        <p:txBody>
-          <a:bodyPr wrap="square" rtlCol="0">
-            <a:spAutoFit/>
-          </a:bodyPr>
-          <a:lstStyle/>
-          <a:p>
-            <a:r>
-              <a:rPr lang="de-CH" sz="1200" dirty="0" err="1"/>
-              <a:t>Context</a:t>
-            </a:r>
-            <a:endParaRPr lang="de-CH" sz="1200" dirty="0"/>
-          </a:p>
-        </p:txBody>
-      </p:sp>
       <p:cxnSp>
         <p:nvCxnSpPr>
           <p:cNvPr id="7" name="Gerade Verbindung mit Pfeil 175">
@@ -38468,8 +38440,8 @@
         </p:nvCxnSpPr>
         <p:spPr>
           <a:xfrm>
-            <a:off x="4324743" y="2005013"/>
-            <a:ext cx="1172789" cy="7284"/>
+            <a:off x="4371516" y="2004599"/>
+            <a:ext cx="490128" cy="7284"/>
           </a:xfrm>
           <a:prstGeom prst="straightConnector1">
             <a:avLst/>
@@ -38517,8 +38489,8 @@
         </p:nvCxnSpPr>
         <p:spPr>
           <a:xfrm>
-            <a:off x="9355930" y="5595567"/>
-            <a:ext cx="931070" cy="0"/>
+            <a:off x="9593690" y="5595153"/>
+            <a:ext cx="455550" cy="0"/>
           </a:xfrm>
           <a:prstGeom prst="straightConnector1">
             <a:avLst/>
@@ -38615,8 +38587,8 @@
         </p:nvCxnSpPr>
         <p:spPr>
           <a:xfrm flipH="1">
-            <a:off x="9114211" y="2005013"/>
-            <a:ext cx="1172789" cy="0"/>
+            <a:off x="9583642" y="2004599"/>
+            <a:ext cx="465598" cy="0"/>
           </a:xfrm>
           <a:prstGeom prst="straightConnector1">
             <a:avLst/>
@@ -38664,8 +38636,8 @@
         </p:nvCxnSpPr>
         <p:spPr>
           <a:xfrm>
-            <a:off x="8484371" y="2435034"/>
-            <a:ext cx="229098" cy="360636"/>
+            <a:off x="8716042" y="2434208"/>
+            <a:ext cx="10048" cy="360636"/>
           </a:xfrm>
           <a:prstGeom prst="straightConnector1">
             <a:avLst/>
@@ -38706,15 +38678,15 @@
           </p:cNvPr>
           <p:cNvCxnSpPr>
             <a:cxnSpLocks/>
-            <a:stCxn id="56" idx="2"/>
+            <a:stCxn id="54" idx="2"/>
             <a:endCxn id="72" idx="0"/>
           </p:cNvCxnSpPr>
           <p:nvPr/>
         </p:nvCxnSpPr>
         <p:spPr>
           <a:xfrm flipH="1">
-            <a:off x="6086321" y="2427045"/>
-            <a:ext cx="41051" cy="349946"/>
+            <a:off x="5725715" y="2445683"/>
+            <a:ext cx="3529" cy="330482"/>
           </a:xfrm>
           <a:prstGeom prst="straightConnector1">
             <a:avLst/>
@@ -38761,9 +38733,9 @@
           <p:nvPr/>
         </p:nvCxnSpPr>
         <p:spPr>
-          <a:xfrm flipH="1">
-            <a:off x="5713094" y="3643767"/>
-            <a:ext cx="373227" cy="1537091"/>
+          <a:xfrm>
+            <a:off x="5725715" y="3642941"/>
+            <a:ext cx="0" cy="1537091"/>
           </a:xfrm>
           <a:prstGeom prst="straightConnector1">
             <a:avLst/>
@@ -38801,10 +38773,10 @@
         </p:nvGrpSpPr>
         <p:grpSpPr>
           <a:xfrm>
-            <a:off x="470304" y="1570799"/>
-            <a:ext cx="1735200" cy="867600"/>
-            <a:chOff x="470304" y="1570799"/>
-            <a:chExt cx="1735200" cy="867600"/>
+            <a:off x="653904" y="1570799"/>
+            <a:ext cx="1368000" cy="867600"/>
+            <a:chOff x="653904" y="1570799"/>
+            <a:chExt cx="1368000" cy="867600"/>
           </a:xfrm>
         </p:grpSpPr>
         <p:sp>
@@ -38823,8 +38795,8 @@
           </p:nvSpPr>
           <p:spPr>
             <a:xfrm>
-              <a:off x="470304" y="1570799"/>
-              <a:ext cx="1735200" cy="867600"/>
+              <a:off x="653904" y="1570799"/>
+              <a:ext cx="1368000" cy="867600"/>
             </a:xfrm>
             <a:prstGeom prst="roundRect">
               <a:avLst/>
@@ -38881,8 +38853,8 @@
           </p:nvSpPr>
           <p:spPr>
             <a:xfrm>
-              <a:off x="470304" y="1589478"/>
-              <a:ext cx="1735200" cy="276999"/>
+              <a:off x="653904" y="1589478"/>
+              <a:ext cx="1368000" cy="276999"/>
             </a:xfrm>
             <a:prstGeom prst="rect">
               <a:avLst/>
@@ -38951,8 +38923,8 @@
           </p:nvSpPr>
           <p:spPr>
             <a:xfrm>
-              <a:off x="470304" y="1863453"/>
-              <a:ext cx="1735200" cy="0"/>
+              <a:off x="653904" y="1863453"/>
+              <a:ext cx="1368000" cy="0"/>
             </a:xfrm>
             <a:prstGeom prst="line">
               <a:avLst/>
@@ -38986,6 +38958,782 @@
           </p:txBody>
         </p:sp>
       </p:grpSp>
+      <p:grpSp>
+        <p:nvGrpSpPr>
+          <p:cNvPr id="29" name="Gruppe Embedding LLM">
+            <a:extLst>
+              <a:ext uri="{FF2B5EF4-FFF2-40B4-BE49-F238E27FC236}">
+                <a16:creationId xmlns:a16="http://schemas.microsoft.com/office/drawing/2014/main" id="{97DA10AF-5D12-3A3B-5C8A-46A79720B1A4}"/>
+              </a:ext>
+            </a:extLst>
+          </p:cNvPr>
+          <p:cNvGrpSpPr/>
+          <p:nvPr/>
+        </p:nvGrpSpPr>
+        <p:grpSpPr>
+          <a:xfrm>
+            <a:off x="2819916" y="1570799"/>
+            <a:ext cx="1368000" cy="867600"/>
+            <a:chOff x="2819916" y="1570799"/>
+            <a:chExt cx="1368000" cy="867600"/>
+          </a:xfrm>
+        </p:grpSpPr>
+        <p:sp>
+          <p:nvSpPr>
+            <p:cNvPr id="32" name="Rechteck: abgerundete Ecken 31">
+              <a:extLst>
+                <a:ext uri="{FF2B5EF4-FFF2-40B4-BE49-F238E27FC236}">
+                  <a16:creationId xmlns:a16="http://schemas.microsoft.com/office/drawing/2014/main" id="{B73EED8C-74B7-0DE4-4653-D7C4D2CA248D}"/>
+                </a:ext>
+              </a:extLst>
+            </p:cNvPr>
+            <p:cNvSpPr>
+              <a:spLocks/>
+            </p:cNvSpPr>
+            <p:nvPr/>
+          </p:nvSpPr>
+          <p:spPr>
+            <a:xfrm>
+              <a:off x="2819916" y="1570799"/>
+              <a:ext cx="1368000" cy="867600"/>
+            </a:xfrm>
+            <a:prstGeom prst="roundRect">
+              <a:avLst/>
+            </a:prstGeom>
+            <a:solidFill>
+              <a:schemeClr val="accent6">
+                <a:lumMod val="40000"/>
+                <a:lumOff val="60000"/>
+              </a:schemeClr>
+            </a:solidFill>
+            <a:ln>
+              <a:solidFill>
+                <a:schemeClr val="tx2"/>
+              </a:solidFill>
+            </a:ln>
+          </p:spPr>
+          <p:style>
+            <a:lnRef idx="2">
+              <a:schemeClr val="accent1">
+                <a:shade val="15000"/>
+              </a:schemeClr>
+            </a:lnRef>
+            <a:fillRef idx="1">
+              <a:schemeClr val="accent1"/>
+            </a:fillRef>
+            <a:effectRef idx="0">
+              <a:schemeClr val="accent1"/>
+            </a:effectRef>
+            <a:fontRef idx="minor">
+              <a:schemeClr val="lt1"/>
+            </a:fontRef>
+          </p:style>
+          <p:txBody>
+            <a:bodyPr anchor="ctr"/>
+            <a:lstStyle/>
+            <a:p>
+              <a:pPr algn="ctr">
+                <a:buNone/>
+              </a:pPr>
+              <a:endParaRPr/>
+            </a:p>
+          </p:txBody>
+        </p:sp>
+        <p:sp>
+          <p:nvSpPr>
+            <p:cNvPr id="35" name="Textfeld 40">
+              <a:extLst>
+                <a:ext uri="{FF2B5EF4-FFF2-40B4-BE49-F238E27FC236}">
+                  <a16:creationId xmlns:a16="http://schemas.microsoft.com/office/drawing/2014/main" id="{48FF7E7C-9CC8-E0A2-D673-5A5B2FB7A6A1}"/>
+                </a:ext>
+              </a:extLst>
+            </p:cNvPr>
+            <p:cNvSpPr>
+              <a:spLocks/>
+            </p:cNvSpPr>
+            <p:nvPr/>
+          </p:nvSpPr>
+          <p:spPr>
+            <a:xfrm>
+              <a:off x="2819916" y="1570799"/>
+              <a:ext cx="1368000" cy="276999"/>
+            </a:xfrm>
+            <a:prstGeom prst="rect">
+              <a:avLst/>
+            </a:prstGeom>
+            <a:noFill/>
+          </p:spPr>
+          <p:txBody>
+            <a:bodyPr wrap="square">
+              <a:spAutoFit/>
+            </a:bodyPr>
+            <a:lstStyle/>
+            <a:p>
+              <a:pPr algn="ctr">
+                <a:buNone/>
+              </a:pPr>
+              <a:r>
+                <a:rPr lang="de-CH" sz="1200" dirty="0"/>
+                <a:t>Graph Engine</a:t>
+              </a:r>
+              <a:endParaRPr sz="1200" dirty="0"/>
+            </a:p>
+          </p:txBody>
+        </p:sp>
+        <p:sp>
+          <p:nvSpPr>
+            <p:cNvPr id="36" name="Gerader Verbinder 35">
+              <a:extLst>
+                <a:ext uri="{FF2B5EF4-FFF2-40B4-BE49-F238E27FC236}">
+                  <a16:creationId xmlns:a16="http://schemas.microsoft.com/office/drawing/2014/main" id="{E58DDFDC-2C03-2A44-F9F9-B7FC0D217F20}"/>
+                </a:ext>
+              </a:extLst>
+            </p:cNvPr>
+            <p:cNvSpPr>
+              <a:spLocks/>
+            </p:cNvSpPr>
+            <p:nvPr/>
+          </p:nvSpPr>
+          <p:spPr>
+            <a:xfrm>
+              <a:off x="2819916" y="1854598"/>
+              <a:ext cx="1368000" cy="0"/>
+            </a:xfrm>
+            <a:prstGeom prst="line">
+              <a:avLst/>
+            </a:prstGeom>
+            <a:ln>
+              <a:solidFill>
+                <a:schemeClr val="tx2"/>
+              </a:solidFill>
+            </a:ln>
+          </p:spPr>
+          <p:style>
+            <a:lnRef idx="1">
+              <a:schemeClr val="accent1"/>
+            </a:lnRef>
+            <a:fillRef idx="0">
+              <a:schemeClr val="accent1"/>
+            </a:fillRef>
+            <a:effectRef idx="0">
+              <a:schemeClr val="accent1"/>
+            </a:effectRef>
+            <a:fontRef idx="minor">
+              <a:schemeClr val="tx1"/>
+            </a:fontRef>
+          </p:style>
+          <p:txBody>
+            <a:bodyPr/>
+            <a:lstStyle/>
+            <a:p>
+              <a:endParaRPr lang="de-CH"/>
+            </a:p>
+          </p:txBody>
+        </p:sp>
+      </p:grpSp>
+      <p:cxnSp>
+        <p:nvCxnSpPr>
+          <p:cNvPr id="55" name="Gerade Verbindung mit Pfeil 116">
+            <a:extLst>
+              <a:ext uri="{FF2B5EF4-FFF2-40B4-BE49-F238E27FC236}">
+                <a16:creationId xmlns:a16="http://schemas.microsoft.com/office/drawing/2014/main" id="{61F9B370-A340-9EEC-FC69-097193881A3C}"/>
+              </a:ext>
+            </a:extLst>
+          </p:cNvPr>
+          <p:cNvCxnSpPr>
+            <a:cxnSpLocks/>
+            <a:stCxn id="20" idx="2"/>
+            <a:endCxn id="102" idx="0"/>
+          </p:cNvCxnSpPr>
+          <p:nvPr/>
+        </p:nvCxnSpPr>
+        <p:spPr>
+          <a:xfrm flipH="1">
+            <a:off x="8726090" y="2433197"/>
+            <a:ext cx="2190750" cy="2728156"/>
+          </a:xfrm>
+          <a:prstGeom prst="straightConnector1">
+            <a:avLst/>
+          </a:prstGeom>
+          <a:ln w="50800">
+            <a:solidFill>
+              <a:schemeClr val="tx1">
+                <a:alpha val="50000"/>
+              </a:schemeClr>
+            </a:solidFill>
+            <a:prstDash val="solid"/>
+            <a:tailEnd type="triangle"/>
+          </a:ln>
+        </p:spPr>
+        <p:style>
+          <a:lnRef idx="1">
+            <a:schemeClr val="accent1"/>
+          </a:lnRef>
+          <a:fillRef idx="0">
+            <a:schemeClr val="accent1"/>
+          </a:fillRef>
+          <a:effectRef idx="0">
+            <a:schemeClr val="accent1"/>
+          </a:effectRef>
+          <a:fontRef idx="minor">
+            <a:schemeClr val="tx1"/>
+          </a:fontRef>
+        </p:style>
+      </p:cxnSp>
+      <p:grpSp>
+        <p:nvGrpSpPr>
+          <p:cNvPr id="64" name="Gruppe Embedding LLM">
+            <a:extLst>
+              <a:ext uri="{FF2B5EF4-FFF2-40B4-BE49-F238E27FC236}">
+                <a16:creationId xmlns:a16="http://schemas.microsoft.com/office/drawing/2014/main" id="{7D3C3C34-10C0-8929-8845-4EFB21D0B163}"/>
+              </a:ext>
+            </a:extLst>
+          </p:cNvPr>
+          <p:cNvGrpSpPr/>
+          <p:nvPr/>
+        </p:nvGrpSpPr>
+        <p:grpSpPr>
+          <a:xfrm>
+            <a:off x="2819916" y="1570799"/>
+            <a:ext cx="1368000" cy="867600"/>
+            <a:chOff x="2819916" y="1570799"/>
+            <a:chExt cx="1368000" cy="867600"/>
+          </a:xfrm>
+        </p:grpSpPr>
+        <p:sp>
+          <p:nvSpPr>
+            <p:cNvPr id="65" name="Rechteck: abgerundete Ecken 64">
+              <a:extLst>
+                <a:ext uri="{FF2B5EF4-FFF2-40B4-BE49-F238E27FC236}">
+                  <a16:creationId xmlns:a16="http://schemas.microsoft.com/office/drawing/2014/main" id="{76CE6652-449C-657E-7587-9F547A9D6ECD}"/>
+                </a:ext>
+              </a:extLst>
+            </p:cNvPr>
+            <p:cNvSpPr>
+              <a:spLocks/>
+            </p:cNvSpPr>
+            <p:nvPr/>
+          </p:nvSpPr>
+          <p:spPr>
+            <a:xfrm>
+              <a:off x="2819916" y="1570799"/>
+              <a:ext cx="1368000" cy="867600"/>
+            </a:xfrm>
+            <a:prstGeom prst="roundRect">
+              <a:avLst/>
+            </a:prstGeom>
+            <a:solidFill>
+              <a:schemeClr val="accent6">
+                <a:lumMod val="40000"/>
+                <a:lumOff val="60000"/>
+              </a:schemeClr>
+            </a:solidFill>
+            <a:ln>
+              <a:solidFill>
+                <a:schemeClr val="tx2"/>
+              </a:solidFill>
+            </a:ln>
+          </p:spPr>
+          <p:style>
+            <a:lnRef idx="2">
+              <a:schemeClr val="accent1">
+                <a:shade val="15000"/>
+              </a:schemeClr>
+            </a:lnRef>
+            <a:fillRef idx="1">
+              <a:schemeClr val="accent1"/>
+            </a:fillRef>
+            <a:effectRef idx="0">
+              <a:schemeClr val="accent1"/>
+            </a:effectRef>
+            <a:fontRef idx="minor">
+              <a:schemeClr val="lt1"/>
+            </a:fontRef>
+          </p:style>
+          <p:txBody>
+            <a:bodyPr anchor="ctr"/>
+            <a:lstStyle/>
+            <a:p>
+              <a:pPr algn="ctr">
+                <a:buNone/>
+              </a:pPr>
+              <a:endParaRPr dirty="0"/>
+            </a:p>
+          </p:txBody>
+        </p:sp>
+        <p:pic>
+          <p:nvPicPr>
+            <p:cNvPr id="66" name="Grafik 39">
+              <a:extLst>
+                <a:ext uri="{FF2B5EF4-FFF2-40B4-BE49-F238E27FC236}">
+                  <a16:creationId xmlns:a16="http://schemas.microsoft.com/office/drawing/2014/main" id="{2D0438B3-277A-DEEA-3A5E-97C93124AC32}"/>
+                </a:ext>
+              </a:extLst>
+            </p:cNvPr>
+            <p:cNvPicPr>
+              <a:picLocks noChangeAspect="1"/>
+            </p:cNvPicPr>
+            <p:nvPr/>
+          </p:nvPicPr>
+          <p:blipFill>
+            <a:blip r:embed="rId11"/>
+            <a:stretch>
+              <a:fillRect/>
+            </a:stretch>
+          </p:blipFill>
+          <p:spPr>
+            <a:xfrm flipH="1">
+              <a:off x="3266354" y="1909499"/>
+              <a:ext cx="475124" cy="482236"/>
+            </a:xfrm>
+            <a:prstGeom prst="rect">
+              <a:avLst/>
+            </a:prstGeom>
+          </p:spPr>
+        </p:pic>
+        <p:sp>
+          <p:nvSpPr>
+            <p:cNvPr id="68" name="Textfeld 40">
+              <a:extLst>
+                <a:ext uri="{FF2B5EF4-FFF2-40B4-BE49-F238E27FC236}">
+                  <a16:creationId xmlns:a16="http://schemas.microsoft.com/office/drawing/2014/main" id="{49288EC7-398C-49E2-3B9A-979BFB1B3F7D}"/>
+                </a:ext>
+              </a:extLst>
+            </p:cNvPr>
+            <p:cNvSpPr>
+              <a:spLocks/>
+            </p:cNvSpPr>
+            <p:nvPr/>
+          </p:nvSpPr>
+          <p:spPr>
+            <a:xfrm>
+              <a:off x="2819916" y="1570799"/>
+              <a:ext cx="1368000" cy="276999"/>
+            </a:xfrm>
+            <a:prstGeom prst="rect">
+              <a:avLst/>
+            </a:prstGeom>
+            <a:noFill/>
+          </p:spPr>
+          <p:txBody>
+            <a:bodyPr wrap="square">
+              <a:spAutoFit/>
+            </a:bodyPr>
+            <a:lstStyle/>
+            <a:p>
+              <a:pPr algn="ctr">
+                <a:buNone/>
+              </a:pPr>
+              <a:r>
+                <a:rPr lang="de-CH" sz="1200" dirty="0" err="1"/>
+                <a:t>Reranking</a:t>
+              </a:r>
+              <a:r>
+                <a:rPr lang="de-CH" sz="1200" dirty="0"/>
+                <a:t> Model</a:t>
+              </a:r>
+              <a:endParaRPr sz="1200" dirty="0"/>
+            </a:p>
+          </p:txBody>
+        </p:sp>
+        <p:sp>
+          <p:nvSpPr>
+            <p:cNvPr id="70" name="Gerader Verbinder 69">
+              <a:extLst>
+                <a:ext uri="{FF2B5EF4-FFF2-40B4-BE49-F238E27FC236}">
+                  <a16:creationId xmlns:a16="http://schemas.microsoft.com/office/drawing/2014/main" id="{10779A5F-A567-5DF9-7B5F-9A5A5EE7DD74}"/>
+                </a:ext>
+              </a:extLst>
+            </p:cNvPr>
+            <p:cNvSpPr>
+              <a:spLocks/>
+            </p:cNvSpPr>
+            <p:nvPr/>
+          </p:nvSpPr>
+          <p:spPr>
+            <a:xfrm>
+              <a:off x="2819916" y="1854598"/>
+              <a:ext cx="1368000" cy="0"/>
+            </a:xfrm>
+            <a:prstGeom prst="line">
+              <a:avLst/>
+            </a:prstGeom>
+            <a:ln>
+              <a:solidFill>
+                <a:schemeClr val="tx2"/>
+              </a:solidFill>
+            </a:ln>
+          </p:spPr>
+          <p:style>
+            <a:lnRef idx="1">
+              <a:schemeClr val="accent1"/>
+            </a:lnRef>
+            <a:fillRef idx="0">
+              <a:schemeClr val="accent1"/>
+            </a:fillRef>
+            <a:effectRef idx="0">
+              <a:schemeClr val="accent1"/>
+            </a:effectRef>
+            <a:fontRef idx="minor">
+              <a:schemeClr val="tx1"/>
+            </a:fontRef>
+          </p:style>
+          <p:txBody>
+            <a:bodyPr/>
+            <a:lstStyle/>
+            <a:p>
+              <a:endParaRPr lang="de-CH"/>
+            </a:p>
+          </p:txBody>
+        </p:sp>
+      </p:grpSp>
+      <p:grpSp>
+        <p:nvGrpSpPr>
+          <p:cNvPr id="71" name="Gruppe Vector Database">
+            <a:extLst>
+              <a:ext uri="{FF2B5EF4-FFF2-40B4-BE49-F238E27FC236}">
+                <a16:creationId xmlns:a16="http://schemas.microsoft.com/office/drawing/2014/main" id="{B98C4647-36F1-433C-634F-DF32A373D759}"/>
+              </a:ext>
+            </a:extLst>
+          </p:cNvPr>
+          <p:cNvGrpSpPr/>
+          <p:nvPr/>
+        </p:nvGrpSpPr>
+        <p:grpSpPr>
+          <a:xfrm>
+            <a:off x="5041715" y="2776165"/>
+            <a:ext cx="1368000" cy="867600"/>
+            <a:chOff x="5041715" y="2776165"/>
+            <a:chExt cx="1368000" cy="867600"/>
+          </a:xfrm>
+        </p:grpSpPr>
+        <p:sp>
+          <p:nvSpPr>
+            <p:cNvPr id="73" name="Rechteck: abgerundete Ecken 72">
+              <a:extLst>
+                <a:ext uri="{FF2B5EF4-FFF2-40B4-BE49-F238E27FC236}">
+                  <a16:creationId xmlns:a16="http://schemas.microsoft.com/office/drawing/2014/main" id="{3E9D7813-18D0-AF4A-8AE8-061A242CC2EA}"/>
+                </a:ext>
+              </a:extLst>
+            </p:cNvPr>
+            <p:cNvSpPr>
+              <a:spLocks/>
+            </p:cNvSpPr>
+            <p:nvPr/>
+          </p:nvSpPr>
+          <p:spPr>
+            <a:xfrm>
+              <a:off x="5041715" y="2776165"/>
+              <a:ext cx="1368000" cy="867600"/>
+            </a:xfrm>
+            <a:prstGeom prst="roundRect">
+              <a:avLst/>
+            </a:prstGeom>
+            <a:solidFill>
+              <a:schemeClr val="bg2"/>
+            </a:solidFill>
+            <a:ln>
+              <a:solidFill>
+                <a:schemeClr val="tx2"/>
+              </a:solidFill>
+            </a:ln>
+          </p:spPr>
+          <p:style>
+            <a:lnRef idx="2">
+              <a:schemeClr val="accent1">
+                <a:shade val="15000"/>
+              </a:schemeClr>
+            </a:lnRef>
+            <a:fillRef idx="1">
+              <a:schemeClr val="accent1"/>
+            </a:fillRef>
+            <a:effectRef idx="0">
+              <a:schemeClr val="accent1"/>
+            </a:effectRef>
+            <a:fontRef idx="minor">
+              <a:schemeClr val="lt1"/>
+            </a:fontRef>
+          </p:style>
+          <p:txBody>
+            <a:bodyPr anchor="ctr"/>
+            <a:lstStyle/>
+            <a:p>
+              <a:pPr algn="ctr">
+                <a:buNone/>
+              </a:pPr>
+              <a:endParaRPr/>
+            </a:p>
+          </p:txBody>
+        </p:sp>
+        <p:pic>
+          <p:nvPicPr>
+            <p:cNvPr id="75" name="Grafik 14">
+              <a:extLst>
+                <a:ext uri="{FF2B5EF4-FFF2-40B4-BE49-F238E27FC236}">
+                  <a16:creationId xmlns:a16="http://schemas.microsoft.com/office/drawing/2014/main" id="{EABA32D5-430E-BA1F-7CFD-BF324A4D963B}"/>
+                </a:ext>
+              </a:extLst>
+            </p:cNvPr>
+            <p:cNvPicPr>
+              <a:picLocks noChangeAspect="1"/>
+            </p:cNvPicPr>
+            <p:nvPr/>
+          </p:nvPicPr>
+          <p:blipFill>
+            <a:blip r:embed="rId9"/>
+            <a:stretch>
+              <a:fillRect/>
+            </a:stretch>
+          </p:blipFill>
+          <p:spPr>
+            <a:xfrm flipH="1">
+              <a:off x="5445714" y="3112571"/>
+              <a:ext cx="560002" cy="485980"/>
+            </a:xfrm>
+            <a:prstGeom prst="rect">
+              <a:avLst/>
+            </a:prstGeom>
+          </p:spPr>
+        </p:pic>
+        <p:sp>
+          <p:nvSpPr>
+            <p:cNvPr id="76" name="Textfeld 25">
+              <a:extLst>
+                <a:ext uri="{FF2B5EF4-FFF2-40B4-BE49-F238E27FC236}">
+                  <a16:creationId xmlns:a16="http://schemas.microsoft.com/office/drawing/2014/main" id="{CE061EE7-7B86-3DDE-1040-660336EDF0E6}"/>
+                </a:ext>
+              </a:extLst>
+            </p:cNvPr>
+            <p:cNvSpPr>
+              <a:spLocks/>
+            </p:cNvSpPr>
+            <p:nvPr/>
+          </p:nvSpPr>
+          <p:spPr>
+            <a:xfrm>
+              <a:off x="5041715" y="2794844"/>
+              <a:ext cx="1368000" cy="285750"/>
+            </a:xfrm>
+            <a:prstGeom prst="rect">
+              <a:avLst/>
+            </a:prstGeom>
+            <a:noFill/>
+          </p:spPr>
+          <p:txBody>
+            <a:bodyPr wrap="square">
+              <a:spAutoFit/>
+            </a:bodyPr>
+            <a:lstStyle/>
+            <a:p>
+              <a:pPr algn="ctr">
+                <a:buNone/>
+              </a:pPr>
+              <a:r>
+                <a:rPr lang="de-CH" sz="1200" dirty="0"/>
+                <a:t>Graph DB</a:t>
+              </a:r>
+              <a:endParaRPr sz="1200" dirty="0"/>
+            </a:p>
+          </p:txBody>
+        </p:sp>
+        <p:sp>
+          <p:nvSpPr>
+            <p:cNvPr id="78" name="Gerader Verbinder 77">
+              <a:extLst>
+                <a:ext uri="{FF2B5EF4-FFF2-40B4-BE49-F238E27FC236}">
+                  <a16:creationId xmlns:a16="http://schemas.microsoft.com/office/drawing/2014/main" id="{4E074795-CC90-4A5D-B6F0-1CD75A4E2F56}"/>
+                </a:ext>
+              </a:extLst>
+            </p:cNvPr>
+            <p:cNvSpPr>
+              <a:spLocks/>
+            </p:cNvSpPr>
+            <p:nvPr/>
+          </p:nvSpPr>
+          <p:spPr>
+            <a:xfrm>
+              <a:off x="5041715" y="3080594"/>
+              <a:ext cx="1368000" cy="0"/>
+            </a:xfrm>
+            <a:prstGeom prst="line">
+              <a:avLst/>
+            </a:prstGeom>
+            <a:ln>
+              <a:solidFill>
+                <a:schemeClr val="tx2"/>
+              </a:solidFill>
+            </a:ln>
+          </p:spPr>
+          <p:style>
+            <a:lnRef idx="1">
+              <a:schemeClr val="accent1"/>
+            </a:lnRef>
+            <a:fillRef idx="0">
+              <a:schemeClr val="accent1"/>
+            </a:fillRef>
+            <a:effectRef idx="0">
+              <a:schemeClr val="accent1"/>
+            </a:effectRef>
+            <a:fontRef idx="minor">
+              <a:schemeClr val="tx1"/>
+            </a:fontRef>
+          </p:style>
+          <p:txBody>
+            <a:bodyPr/>
+            <a:lstStyle/>
+            <a:p>
+              <a:endParaRPr lang="de-CH"/>
+            </a:p>
+          </p:txBody>
+        </p:sp>
+      </p:grpSp>
+      <p:cxnSp>
+        <p:nvCxnSpPr>
+          <p:cNvPr id="80" name="Gerade Verbindung mit Pfeil 116">
+            <a:extLst>
+              <a:ext uri="{FF2B5EF4-FFF2-40B4-BE49-F238E27FC236}">
+                <a16:creationId xmlns:a16="http://schemas.microsoft.com/office/drawing/2014/main" id="{E376D28E-420A-43B9-883A-3952BE9F2B5B}"/>
+              </a:ext>
+            </a:extLst>
+          </p:cNvPr>
+          <p:cNvCxnSpPr>
+            <a:cxnSpLocks/>
+            <a:stCxn id="37" idx="3"/>
+            <a:endCxn id="32" idx="1"/>
+          </p:cNvCxnSpPr>
+          <p:nvPr/>
+        </p:nvCxnSpPr>
+        <p:spPr>
+          <a:xfrm flipV="1">
+            <a:off x="2210508" y="3840734"/>
+            <a:ext cx="425808" cy="545115"/>
+          </a:xfrm>
+          <a:prstGeom prst="straightConnector1">
+            <a:avLst/>
+          </a:prstGeom>
+          <a:ln w="50800">
+            <a:solidFill>
+              <a:schemeClr val="tx1">
+                <a:alpha val="50000"/>
+              </a:schemeClr>
+            </a:solidFill>
+            <a:prstDash val="solid"/>
+            <a:tailEnd type="triangle"/>
+          </a:ln>
+        </p:spPr>
+        <p:style>
+          <a:lnRef idx="1">
+            <a:schemeClr val="accent1"/>
+          </a:lnRef>
+          <a:fillRef idx="0">
+            <a:schemeClr val="accent1"/>
+          </a:fillRef>
+          <a:effectRef idx="0">
+            <a:schemeClr val="accent1"/>
+          </a:effectRef>
+          <a:fontRef idx="minor">
+            <a:schemeClr val="tx1"/>
+          </a:fontRef>
+        </p:style>
+      </p:cxnSp>
+      <p:cxnSp>
+        <p:nvCxnSpPr>
+          <p:cNvPr id="85" name="Gerade Verbindung mit Pfeil 116">
+            <a:extLst>
+              <a:ext uri="{FF2B5EF4-FFF2-40B4-BE49-F238E27FC236}">
+                <a16:creationId xmlns:a16="http://schemas.microsoft.com/office/drawing/2014/main" id="{C59435DB-3B08-9D13-84B3-B8E6C33DF518}"/>
+              </a:ext>
+            </a:extLst>
+          </p:cNvPr>
+          <p:cNvCxnSpPr>
+            <a:cxnSpLocks/>
+            <a:stCxn id="32" idx="2"/>
+            <a:endCxn id="76" idx="0"/>
+          </p:cNvCxnSpPr>
+          <p:nvPr/>
+        </p:nvCxnSpPr>
+        <p:spPr>
+          <a:xfrm>
+            <a:off x="3503916" y="4274534"/>
+            <a:ext cx="0" cy="357082"/>
+          </a:xfrm>
+          <a:prstGeom prst="straightConnector1">
+            <a:avLst/>
+          </a:prstGeom>
+          <a:ln w="50800">
+            <a:solidFill>
+              <a:schemeClr val="tx1">
+                <a:alpha val="50000"/>
+              </a:schemeClr>
+            </a:solidFill>
+            <a:prstDash val="solid"/>
+            <a:tailEnd type="triangle"/>
+          </a:ln>
+        </p:spPr>
+        <p:style>
+          <a:lnRef idx="1">
+            <a:schemeClr val="accent1"/>
+          </a:lnRef>
+          <a:fillRef idx="0">
+            <a:schemeClr val="accent1"/>
+          </a:fillRef>
+          <a:effectRef idx="0">
+            <a:schemeClr val="accent1"/>
+          </a:effectRef>
+          <a:fontRef idx="minor">
+            <a:schemeClr val="tx1"/>
+          </a:fontRef>
+        </p:style>
+      </p:cxnSp>
+      <p:cxnSp>
+        <p:nvCxnSpPr>
+          <p:cNvPr id="91" name="Gerade Verbindung mit Pfeil 116">
+            <a:extLst>
+              <a:ext uri="{FF2B5EF4-FFF2-40B4-BE49-F238E27FC236}">
+                <a16:creationId xmlns:a16="http://schemas.microsoft.com/office/drawing/2014/main" id="{0936BFDE-4003-BDDE-5765-B85CD9CFFDEB}"/>
+              </a:ext>
+            </a:extLst>
+          </p:cNvPr>
+          <p:cNvCxnSpPr>
+            <a:cxnSpLocks/>
+            <a:stCxn id="73" idx="3"/>
+            <a:endCxn id="65" idx="1"/>
+          </p:cNvCxnSpPr>
+          <p:nvPr/>
+        </p:nvCxnSpPr>
+        <p:spPr>
+          <a:xfrm flipV="1">
+            <a:off x="4371516" y="4390973"/>
+            <a:ext cx="486599" cy="655764"/>
+          </a:xfrm>
+          <a:prstGeom prst="straightConnector1">
+            <a:avLst/>
+          </a:prstGeom>
+          <a:ln w="50800">
+            <a:solidFill>
+              <a:schemeClr val="tx1">
+                <a:alpha val="50000"/>
+              </a:schemeClr>
+            </a:solidFill>
+            <a:prstDash val="solid"/>
+            <a:tailEnd type="triangle"/>
+          </a:ln>
+        </p:spPr>
+        <p:style>
+          <a:lnRef idx="1">
+            <a:schemeClr val="accent1"/>
+          </a:lnRef>
+          <a:fillRef idx="0">
+            <a:schemeClr val="accent1"/>
+          </a:fillRef>
+          <a:effectRef idx="0">
+            <a:schemeClr val="accent1"/>
+          </a:effectRef>
+          <a:fontRef idx="minor">
+            <a:schemeClr val="tx1"/>
+          </a:fontRef>
+        </p:style>
+      </p:cxnSp>
     </p:spTree>
     <p:extLst>
       <p:ext uri="{BB962C8B-B14F-4D97-AF65-F5344CB8AC3E}">
@@ -40439,7 +41187,7 @@
                                 </p:cTn>
                               </p:par>
                               <p:par>
-                                <p:cTn id="117" presetID="1" presetClass="entr" presetSubtype="0" fill="hold" grpId="0" nodeType="withEffect">
+                                <p:cTn id="117" presetID="1" presetClass="entr" presetSubtype="0" fill="hold" nodeType="withEffect">
                                   <p:stCondLst>
                                     <p:cond delay="0"/>
                                   </p:stCondLst>
@@ -40452,7 +41200,7 @@
                                           </p:stCondLst>
                                         </p:cTn>
                                         <p:tgtEl>
-                                          <p:spTgt spid="145"/>
+                                          <p:spTgt spid="24"/>
                                         </p:tgtEl>
                                         <p:attrNameLst>
                                           <p:attrName>style.visibility</p:attrName>
@@ -40479,7 +41227,7 @@
                                           </p:stCondLst>
                                         </p:cTn>
                                         <p:tgtEl>
-                                          <p:spTgt spid="24"/>
+                                          <p:spTgt spid="28"/>
                                         </p:tgtEl>
                                         <p:attrNameLst>
                                           <p:attrName>style.visibility</p:attrName>
@@ -40506,7 +41254,52 @@
                                           </p:stCondLst>
                                         </p:cTn>
                                         <p:tgtEl>
-                                          <p:spTgt spid="28"/>
+                                          <p:spTgt spid="31"/>
+                                        </p:tgtEl>
+                                        <p:attrNameLst>
+                                          <p:attrName>style.visibility</p:attrName>
+                                        </p:attrNameLst>
+                                      </p:cBhvr>
+                                      <p:to>
+                                        <p:strVal val="visible"/>
+                                      </p:to>
+                                    </p:set>
+                                  </p:childTnLst>
+                                </p:cTn>
+                              </p:par>
+                            </p:childTnLst>
+                          </p:cTn>
+                        </p:par>
+                      </p:childTnLst>
+                    </p:cTn>
+                  </p:par>
+                  <p:par>
+                    <p:cTn id="123" fill="hold">
+                      <p:stCondLst>
+                        <p:cond delay="indefinite"/>
+                      </p:stCondLst>
+                      <p:childTnLst>
+                        <p:par>
+                          <p:cTn id="124" fill="hold">
+                            <p:stCondLst>
+                              <p:cond delay="0"/>
+                            </p:stCondLst>
+                            <p:childTnLst>
+                              <p:par>
+                                <p:cTn id="125" presetID="1" presetClass="entr" presetSubtype="0" fill="hold" nodeType="clickEffect">
+                                  <p:stCondLst>
+                                    <p:cond delay="0"/>
+                                  </p:stCondLst>
+                                  <p:childTnLst>
+                                    <p:set>
+                                      <p:cBhvr>
+                                        <p:cTn id="126" dur="1" fill="hold">
+                                          <p:stCondLst>
+                                            <p:cond delay="0"/>
+                                          </p:stCondLst>
+                                        </p:cTn>
+                                        <p:tgtEl>
+                                          <p:spTgt spid="32"/>
                                         </p:tgtEl>
                                         <p:attrNameLst>
                                           <p:attrName>style.visibility</p:attrName>
@@ -40520,20 +41313,299 @@
                                 </p:cTn>
                               </p:par>
                               <p:par>
-                                <p:cTn id="123" presetID="1" presetClass="entr" presetSubtype="0" fill="hold" nodeType="withEffect">
+                                <p:cTn id="127" presetID="1" presetClass="entr" presetSubtype="0" fill="hold" nodeType="withEffect">
                                   <p:stCondLst>
                                     <p:cond delay="0"/>
                                   </p:stCondLst>
                                   <p:childTnLst>
                                     <p:set>
                                       <p:cBhvr>
-                                        <p:cTn id="124" dur="1" fill="hold">
+                                        <p:cTn id="128" dur="1" fill="hold">
                                           <p:stCondLst>
                                             <p:cond delay="0"/>
                                           </p:stCondLst>
                                         </p:cTn>
                                         <p:tgtEl>
-                                          <p:spTgt spid="31"/>
+                                          <p:spTgt spid="36"/>
+                                        </p:tgtEl>
+                                        <p:attrNameLst>
+                                          <p:attrName>style.visibility</p:attrName>
+                                        </p:attrNameLst>
+                                      </p:cBhvr>
+                                      <p:to>
+                                        <p:strVal val="visible"/>
+                                      </p:to>
+                                    </p:set>
+                                  </p:childTnLst>
+                                </p:cTn>
+                              </p:par>
+                              <p:par>
+                                <p:cTn id="129" presetID="1" presetClass="entr" presetSubtype="0" fill="hold" nodeType="withEffect">
+                                  <p:stCondLst>
+                                    <p:cond delay="0"/>
+                                  </p:stCondLst>
+                                  <p:childTnLst>
+                                    <p:set>
+                                      <p:cBhvr>
+                                        <p:cTn id="130" dur="1" fill="hold">
+                                          <p:stCondLst>
+                                            <p:cond delay="0"/>
+                                          </p:stCondLst>
+                                        </p:cTn>
+                                        <p:tgtEl>
+                                          <p:spTgt spid="35"/>
+                                        </p:tgtEl>
+                                        <p:attrNameLst>
+                                          <p:attrName>style.visibility</p:attrName>
+                                        </p:attrNameLst>
+                                      </p:cBhvr>
+                                      <p:to>
+                                        <p:strVal val="visible"/>
+                                      </p:to>
+                                    </p:set>
+                                  </p:childTnLst>
+                                </p:cTn>
+                              </p:par>
+                            </p:childTnLst>
+                          </p:cTn>
+                        </p:par>
+                      </p:childTnLst>
+                    </p:cTn>
+                  </p:par>
+                  <p:par>
+                    <p:cTn id="131" fill="hold">
+                      <p:stCondLst>
+                        <p:cond delay="indefinite"/>
+                      </p:stCondLst>
+                      <p:childTnLst>
+                        <p:par>
+                          <p:cTn id="132" fill="hold">
+                            <p:stCondLst>
+                              <p:cond delay="0"/>
+                            </p:stCondLst>
+                            <p:childTnLst>
+                              <p:par>
+                                <p:cTn id="133" presetID="1" presetClass="entr" presetSubtype="0" fill="hold" nodeType="clickEffect">
+                                  <p:stCondLst>
+                                    <p:cond delay="0"/>
+                                  </p:stCondLst>
+                                  <p:childTnLst>
+                                    <p:set>
+                                      <p:cBhvr>
+                                        <p:cTn id="134" dur="1" fill="hold">
+                                          <p:stCondLst>
+                                            <p:cond delay="0"/>
+                                          </p:stCondLst>
+                                        </p:cTn>
+                                        <p:tgtEl>
+                                          <p:spTgt spid="65"/>
+                                        </p:tgtEl>
+                                        <p:attrNameLst>
+                                          <p:attrName>style.visibility</p:attrName>
+                                        </p:attrNameLst>
+                                      </p:cBhvr>
+                                      <p:to>
+                                        <p:strVal val="visible"/>
+                                      </p:to>
+                                    </p:set>
+                                  </p:childTnLst>
+                                </p:cTn>
+                              </p:par>
+                              <p:par>
+                                <p:cTn id="135" presetID="1" presetClass="entr" presetSubtype="0" fill="hold" nodeType="withEffect">
+                                  <p:stCondLst>
+                                    <p:cond delay="0"/>
+                                  </p:stCondLst>
+                                  <p:childTnLst>
+                                    <p:set>
+                                      <p:cBhvr>
+                                        <p:cTn id="136" dur="1" fill="hold">
+                                          <p:stCondLst>
+                                            <p:cond delay="0"/>
+                                          </p:stCondLst>
+                                        </p:cTn>
+                                        <p:tgtEl>
+                                          <p:spTgt spid="66"/>
+                                        </p:tgtEl>
+                                        <p:attrNameLst>
+                                          <p:attrName>style.visibility</p:attrName>
+                                        </p:attrNameLst>
+                                      </p:cBhvr>
+                                      <p:to>
+                                        <p:strVal val="visible"/>
+                                      </p:to>
+                                    </p:set>
+                                  </p:childTnLst>
+                                </p:cTn>
+                              </p:par>
+                              <p:par>
+                                <p:cTn id="137" presetID="1" presetClass="entr" presetSubtype="0" fill="hold" nodeType="withEffect">
+                                  <p:stCondLst>
+                                    <p:cond delay="0"/>
+                                  </p:stCondLst>
+                                  <p:childTnLst>
+                                    <p:set>
+                                      <p:cBhvr>
+                                        <p:cTn id="138" dur="1" fill="hold">
+                                          <p:stCondLst>
+                                            <p:cond delay="0"/>
+                                          </p:stCondLst>
+                                        </p:cTn>
+                                        <p:tgtEl>
+                                          <p:spTgt spid="70"/>
+                                        </p:tgtEl>
+                                        <p:attrNameLst>
+                                          <p:attrName>style.visibility</p:attrName>
+                                        </p:attrNameLst>
+                                      </p:cBhvr>
+                                      <p:to>
+                                        <p:strVal val="visible"/>
+                                      </p:to>
+                                    </p:set>
+                                  </p:childTnLst>
+                                </p:cTn>
+                              </p:par>
+                              <p:par>
+                                <p:cTn id="139" presetID="1" presetClass="entr" presetSubtype="0" fill="hold" nodeType="withEffect">
+                                  <p:stCondLst>
+                                    <p:cond delay="0"/>
+                                  </p:stCondLst>
+                                  <p:childTnLst>
+                                    <p:set>
+                                      <p:cBhvr>
+                                        <p:cTn id="140" dur="1" fill="hold">
+                                          <p:stCondLst>
+                                            <p:cond delay="0"/>
+                                          </p:stCondLst>
+                                        </p:cTn>
+                                        <p:tgtEl>
+                                          <p:spTgt spid="68"/>
+                                        </p:tgtEl>
+                                        <p:attrNameLst>
+                                          <p:attrName>style.visibility</p:attrName>
+                                        </p:attrNameLst>
+                                      </p:cBhvr>
+                                      <p:to>
+                                        <p:strVal val="visible"/>
+                                      </p:to>
+                                    </p:set>
+                                  </p:childTnLst>
+                                </p:cTn>
+                              </p:par>
+                            </p:childTnLst>
+                          </p:cTn>
+                        </p:par>
+                      </p:childTnLst>
+                    </p:cTn>
+                  </p:par>
+                  <p:par>
+                    <p:cTn id="141" fill="hold">
+                      <p:stCondLst>
+                        <p:cond delay="indefinite"/>
+                      </p:stCondLst>
+                      <p:childTnLst>
+                        <p:par>
+                          <p:cTn id="142" fill="hold">
+                            <p:stCondLst>
+                              <p:cond delay="0"/>
+                            </p:stCondLst>
+                            <p:childTnLst>
+                              <p:par>
+                                <p:cTn id="143" presetID="1" presetClass="entr" presetSubtype="0" fill="hold" nodeType="clickEffect">
+                                  <p:stCondLst>
+                                    <p:cond delay="0"/>
+                                  </p:stCondLst>
+                                  <p:childTnLst>
+                                    <p:set>
+                                      <p:cBhvr>
+                                        <p:cTn id="144" dur="1" fill="hold">
+                                          <p:stCondLst>
+                                            <p:cond delay="0"/>
+                                          </p:stCondLst>
+                                        </p:cTn>
+                                        <p:tgtEl>
+                                          <p:spTgt spid="73"/>
+                                        </p:tgtEl>
+                                        <p:attrNameLst>
+                                          <p:attrName>style.visibility</p:attrName>
+                                        </p:attrNameLst>
+                                      </p:cBhvr>
+                                      <p:to>
+                                        <p:strVal val="visible"/>
+                                      </p:to>
+                                    </p:set>
+                                  </p:childTnLst>
+                                </p:cTn>
+                              </p:par>
+                              <p:par>
+                                <p:cTn id="145" presetID="1" presetClass="entr" presetSubtype="0" fill="hold" nodeType="withEffect">
+                                  <p:stCondLst>
+                                    <p:cond delay="0"/>
+                                  </p:stCondLst>
+                                  <p:childTnLst>
+                                    <p:set>
+                                      <p:cBhvr>
+                                        <p:cTn id="146" dur="1" fill="hold">
+                                          <p:stCondLst>
+                                            <p:cond delay="0"/>
+                                          </p:stCondLst>
+                                        </p:cTn>
+                                        <p:tgtEl>
+                                          <p:spTgt spid="75"/>
+                                        </p:tgtEl>
+                                        <p:attrNameLst>
+                                          <p:attrName>style.visibility</p:attrName>
+                                        </p:attrNameLst>
+                                      </p:cBhvr>
+                                      <p:to>
+                                        <p:strVal val="visible"/>
+                                      </p:to>
+                                    </p:set>
+                                  </p:childTnLst>
+                                </p:cTn>
+                              </p:par>
+                              <p:par>
+                                <p:cTn id="147" presetID="1" presetClass="entr" presetSubtype="0" fill="hold" nodeType="withEffect">
+                                  <p:stCondLst>
+                                    <p:cond delay="0"/>
+                                  </p:stCondLst>
+                                  <p:childTnLst>
+                                    <p:set>
+                                      <p:cBhvr>
+                                        <p:cTn id="148" dur="1" fill="hold">
+                                          <p:stCondLst>
+                                            <p:cond delay="0"/>
+                                          </p:stCondLst>
+                                        </p:cTn>
+                                        <p:tgtEl>
+                                          <p:spTgt spid="76"/>
+                                        </p:tgtEl>
+                                        <p:attrNameLst>
+                                          <p:attrName>style.visibility</p:attrName>
+                                        </p:attrNameLst>
+                                      </p:cBhvr>
+                                      <p:to>
+                                        <p:strVal val="visible"/>
+                                      </p:to>
+                                    </p:set>
+                                  </p:childTnLst>
+                                </p:cTn>
+                              </p:par>
+                              <p:par>
+                                <p:cTn id="149" presetID="1" presetClass="entr" presetSubtype="0" fill="hold" nodeType="withEffect">
+                                  <p:stCondLst>
+                                    <p:cond delay="0"/>
+                                  </p:stCondLst>
+                                  <p:childTnLst>
+                                    <p:set>
+                                      <p:cBhvr>
+                                        <p:cTn id="150" dur="1" fill="hold">
+                                          <p:stCondLst>
+                                            <p:cond delay="0"/>
+                                          </p:stCondLst>
+                                        </p:cTn>
+                                        <p:tgtEl>
+                                          <p:spTgt spid="78"/>
                                         </p:tgtEl>
                                         <p:attrNameLst>
                                           <p:attrName>style.visibility</p:attrName>
@@ -40606,10 +41678,18 @@
       <p:bldP spid="137" grpId="0" animBg="1"/>
       <p:bldP spid="139" grpId="0"/>
       <p:bldP spid="140" grpId="0" animBg="1"/>
-      <p:bldP spid="145" grpId="0"/>
       <p:bldP spid="121" grpId="0" animBg="1"/>
       <p:bldP spid="123" grpId="0"/>
       <p:bldP spid="124" grpId="0" animBg="1"/>
+      <p:bldP spid="32" grpId="0" animBg="1"/>
+      <p:bldP spid="35" grpId="0"/>
+      <p:bldP spid="36" grpId="0" animBg="1"/>
+      <p:bldP spid="65" grpId="0" animBg="1"/>
+      <p:bldP spid="68" grpId="0"/>
+      <p:bldP spid="70" grpId="0" animBg="1"/>
+      <p:bldP spid="73" grpId="0" animBg="1"/>
+      <p:bldP spid="76" grpId="0"/>
+      <p:bldP spid="78" grpId="0" animBg="1"/>
     </p:bldLst>
   </p:timing>
 </p:sld>
@@ -43431,6 +44511,26 @@
 </file>
 
 <file path=customXml/item1.xml><?xml version="1.0" encoding="utf-8"?>
+<?mso-contentType ?>
+<FormTemplates xmlns="http://schemas.microsoft.com/sharepoint/v3/contenttype/forms">
+  <Display>DocumentLibraryForm</Display>
+  <Edit>DocumentLibraryForm</Edit>
+  <New>DocumentLibraryForm</New>
+</FormTemplates>
+</file>
+
+<file path=customXml/item2.xml><?xml version="1.0" encoding="utf-8"?>
+<p:properties xmlns:p="http://schemas.microsoft.com/office/2006/metadata/properties" xmlns:xsi="http://www.w3.org/2001/XMLSchema-instance" xmlns:pc="http://schemas.microsoft.com/office/infopath/2007/PartnerControls">
+  <documentManagement>
+    <lcf76f155ced4ddcb4097134ff3c332f xmlns="501edefc-5b9b-422a-9450-cf7f1f30e3fa">
+      <Terms xmlns="http://schemas.microsoft.com/office/infopath/2007/PartnerControls"/>
+    </lcf76f155ced4ddcb4097134ff3c332f>
+    <TaxCatchAll xmlns="3083c7a9-d95a-44c4-8fb8-f93b125494d6" xsi:nil="true"/>
+  </documentManagement>
+</p:properties>
+</file>
+
+<file path=customXml/item3.xml><?xml version="1.0" encoding="utf-8"?>
 <ct:contentTypeSchema xmlns:ct="http://schemas.microsoft.com/office/2006/metadata/contentType" xmlns:ma="http://schemas.microsoft.com/office/2006/metadata/properties/metaAttributes" ct:_="" ma:_="" ma:contentTypeName="Dokument" ma:contentTypeID="0x0101007D39DBAC6A50C74E998B9EB660A68B40" ma:contentTypeVersion="12" ma:contentTypeDescription="Ein neues Dokument erstellen." ma:contentTypeScope="" ma:versionID="34dc225a7d6106712b96f9699847575b">
   <xsd:schema xmlns:xsd="http://www.w3.org/2001/XMLSchema" xmlns:xs="http://www.w3.org/2001/XMLSchema" xmlns:p="http://schemas.microsoft.com/office/2006/metadata/properties" xmlns:ns2="501edefc-5b9b-422a-9450-cf7f1f30e3fa" xmlns:ns3="3083c7a9-d95a-44c4-8fb8-f93b125494d6" targetNamespace="http://schemas.microsoft.com/office/2006/metadata/properties" ma:root="true" ma:fieldsID="b7244162b0b071e6bfc5af2eca0d94d3" ns2:_="" ns3:_="">
     <xsd:import namespace="501edefc-5b9b-422a-9450-cf7f1f30e3fa"/>
@@ -43631,27 +44731,30 @@
 </ct:contentTypeSchema>
 </file>
 
-<file path=customXml/item2.xml><?xml version="1.0" encoding="utf-8"?>
-<?mso-contentType ?>
-<FormTemplates xmlns="http://schemas.microsoft.com/sharepoint/v3/contenttype/forms">
-  <Display>DocumentLibraryForm</Display>
-  <Edit>DocumentLibraryForm</Edit>
-  <New>DocumentLibraryForm</New>
-</FormTemplates>
+<file path=customXml/itemProps1.xml><?xml version="1.0" encoding="utf-8"?>
+<ds:datastoreItem xmlns:ds="http://schemas.openxmlformats.org/officeDocument/2006/customXml" ds:itemID="{334436CE-240F-4EE4-9FC5-4255E6874223}">
+  <ds:schemaRefs>
+    <ds:schemaRef ds:uri="http://schemas.microsoft.com/sharepoint/v3/contenttype/forms"/>
+  </ds:schemaRefs>
+</ds:datastoreItem>
 </file>
 
-<file path=customXml/item3.xml><?xml version="1.0" encoding="utf-8"?>
-<p:properties xmlns:p="http://schemas.microsoft.com/office/2006/metadata/properties" xmlns:xsi="http://www.w3.org/2001/XMLSchema-instance" xmlns:pc="http://schemas.microsoft.com/office/infopath/2007/PartnerControls">
-  <documentManagement>
-    <lcf76f155ced4ddcb4097134ff3c332f xmlns="501edefc-5b9b-422a-9450-cf7f1f30e3fa">
-      <Terms xmlns="http://schemas.microsoft.com/office/infopath/2007/PartnerControls"/>
-    </lcf76f155ced4ddcb4097134ff3c332f>
-    <TaxCatchAll xmlns="3083c7a9-d95a-44c4-8fb8-f93b125494d6" xsi:nil="true"/>
-  </documentManagement>
-</p:properties>
+<file path=customXml/itemProps2.xml><?xml version="1.0" encoding="utf-8"?>
+<ds:datastoreItem xmlns:ds="http://schemas.openxmlformats.org/officeDocument/2006/customXml" ds:itemID="{6302A1CC-4AEF-4830-BB1C-A446161EB02D}">
+  <ds:schemaRefs>
+    <ds:schemaRef ds:uri="http://schemas.microsoft.com/office/2006/metadata/properties"/>
+    <ds:schemaRef ds:uri="http://schemas.microsoft.com/office/infopath/2007/PartnerControls"/>
+    <ds:schemaRef ds:uri="7052a6c1-2dbf-49e9-b6e1-6fe4487af028"/>
+    <ds:schemaRef ds:uri="d8f140f0-05e7-48e3-ba8b-dcc0ff83b3dd"/>
+    <ds:schemaRef ds:uri="b22023f0-d141-4df7-85ad-6dd1e1377ec8"/>
+    <ds:schemaRef ds:uri="bf122554-6983-45b2-a605-6e185ba8cf82"/>
+    <ds:schemaRef ds:uri="501edefc-5b9b-422a-9450-cf7f1f30e3fa"/>
+    <ds:schemaRef ds:uri="3083c7a9-d95a-44c4-8fb8-f93b125494d6"/>
+  </ds:schemaRefs>
+</ds:datastoreItem>
 </file>
 
-<file path=customXml/itemProps1.xml><?xml version="1.0" encoding="utf-8"?>
+<file path=customXml/itemProps3.xml><?xml version="1.0" encoding="utf-8"?>
 <ds:datastoreItem xmlns:ds="http://schemas.openxmlformats.org/officeDocument/2006/customXml" ds:itemID="{42C8284C-7C61-4B35-A2FD-8E50AFE93672}">
   <ds:schemaRefs>
     <ds:schemaRef ds:uri="http://schemas.microsoft.com/office/2006/metadata/contentType"/>
@@ -43670,29 +44773,6 @@
 </ds:datastoreItem>
 </file>
 
-<file path=customXml/itemProps2.xml><?xml version="1.0" encoding="utf-8"?>
-<ds:datastoreItem xmlns:ds="http://schemas.openxmlformats.org/officeDocument/2006/customXml" ds:itemID="{334436CE-240F-4EE4-9FC5-4255E6874223}">
-  <ds:schemaRefs>
-    <ds:schemaRef ds:uri="http://schemas.microsoft.com/sharepoint/v3/contenttype/forms"/>
-  </ds:schemaRefs>
-</ds:datastoreItem>
-</file>
-
-<file path=customXml/itemProps3.xml><?xml version="1.0" encoding="utf-8"?>
-<ds:datastoreItem xmlns:ds="http://schemas.openxmlformats.org/officeDocument/2006/customXml" ds:itemID="{6302A1CC-4AEF-4830-BB1C-A446161EB02D}">
-  <ds:schemaRefs>
-    <ds:schemaRef ds:uri="http://schemas.microsoft.com/office/2006/metadata/properties"/>
-    <ds:schemaRef ds:uri="http://schemas.microsoft.com/office/infopath/2007/PartnerControls"/>
-    <ds:schemaRef ds:uri="7052a6c1-2dbf-49e9-b6e1-6fe4487af028"/>
-    <ds:schemaRef ds:uri="d8f140f0-05e7-48e3-ba8b-dcc0ff83b3dd"/>
-    <ds:schemaRef ds:uri="b22023f0-d141-4df7-85ad-6dd1e1377ec8"/>
-    <ds:schemaRef ds:uri="bf122554-6983-45b2-a605-6e185ba8cf82"/>
-    <ds:schemaRef ds:uri="501edefc-5b9b-422a-9450-cf7f1f30e3fa"/>
-    <ds:schemaRef ds:uri="3083c7a9-d95a-44c4-8fb8-f93b125494d6"/>
-  </ds:schemaRefs>
-</ds:datastoreItem>
-</file>
-
 <file path=docMetadata/LabelInfo.xml><?xml version="1.0" encoding="utf-8"?>
 <clbl:labelList xmlns:clbl="http://schemas.microsoft.com/office/2020/mipLabelMetadata">
   <clbl:label id="{42e461c6-591f-4920-9cf0-f1389542f8ad}" enabled="1" method="Standard" siteId="{2cda5d11-f0ac-46b3-967d-af1b2e1bd01a}" contentBits="2" removed="0"/>

</xml_diff>

<commit_message>
Revert "Set slide-7 diagram boxes to 3.8 cm width"
The slide needs manual rework first; restore the 4.82 cm state from
1fd79f2 as the working base.

Co-Authored-By: Claude Fable 5 <noreply@anthropic.com>
Claude-Session: https://claude.ai/code/session_01S2kGP2buE2HmxMttD3XczR
</commit_message>
<xml_diff>
--- a/RAG_Workshop.pptx
+++ b/RAG_Workshop.pptx
@@ -35634,10 +35634,10 @@
         </p:nvGrpSpPr>
         <p:grpSpPr>
           <a:xfrm>
-            <a:off x="660215" y="5142674"/>
-            <a:ext cx="1368000" cy="867600"/>
-            <a:chOff x="660215" y="5142674"/>
-            <a:chExt cx="1368000" cy="867600"/>
+            <a:off x="476615" y="5142674"/>
+            <a:ext cx="1735200" cy="867600"/>
+            <a:chOff x="476615" y="5142674"/>
+            <a:chExt cx="1735200" cy="867600"/>
           </a:xfrm>
         </p:grpSpPr>
         <p:sp>
@@ -35656,8 +35656,8 @@
           </p:nvSpPr>
           <p:spPr>
             <a:xfrm>
-              <a:off x="660215" y="5142674"/>
-              <a:ext cx="1368000" cy="867600"/>
+              <a:off x="476615" y="5142674"/>
+              <a:ext cx="1735200" cy="867600"/>
             </a:xfrm>
             <a:prstGeom prst="roundRect">
               <a:avLst/>
@@ -35714,8 +35714,8 @@
           </p:nvSpPr>
           <p:spPr>
             <a:xfrm>
-              <a:off x="660215" y="5161353"/>
-              <a:ext cx="1368000" cy="276999"/>
+              <a:off x="476615" y="5161353"/>
+              <a:ext cx="1735200" cy="276999"/>
             </a:xfrm>
             <a:prstGeom prst="rect">
               <a:avLst/>
@@ -35754,8 +35754,8 @@
           </p:nvSpPr>
           <p:spPr>
             <a:xfrm>
-              <a:off x="660215" y="5438352"/>
-              <a:ext cx="1368000" cy="0"/>
+              <a:off x="476615" y="5438352"/>
+              <a:ext cx="1735200" cy="0"/>
             </a:xfrm>
             <a:prstGeom prst="line">
               <a:avLst/>
@@ -35827,10 +35827,10 @@
         </p:nvGrpSpPr>
         <p:grpSpPr>
           <a:xfrm>
-            <a:off x="10232840" y="1570799"/>
-            <a:ext cx="1368000" cy="867600"/>
-            <a:chOff x="10232840" y="1570799"/>
-            <a:chExt cx="1368000" cy="867600"/>
+            <a:off x="10049240" y="1570799"/>
+            <a:ext cx="1735200" cy="867600"/>
+            <a:chOff x="10049240" y="1570799"/>
+            <a:chExt cx="1735200" cy="867600"/>
           </a:xfrm>
         </p:grpSpPr>
         <p:sp>
@@ -35849,8 +35849,8 @@
           </p:nvSpPr>
           <p:spPr>
             <a:xfrm>
-              <a:off x="10232840" y="1570799"/>
-              <a:ext cx="1368000" cy="867600"/>
+              <a:off x="10049240" y="1570799"/>
+              <a:ext cx="1735200" cy="867600"/>
             </a:xfrm>
             <a:prstGeom prst="roundRect">
               <a:avLst/>
@@ -35937,8 +35937,8 @@
           </p:nvSpPr>
           <p:spPr>
             <a:xfrm>
-              <a:off x="10232840" y="1589478"/>
-              <a:ext cx="1368000" cy="276999"/>
+              <a:off x="10049240" y="1589478"/>
+              <a:ext cx="1735200" cy="276999"/>
             </a:xfrm>
             <a:prstGeom prst="rect">
               <a:avLst/>
@@ -35974,10 +35974,10 @@
         </p:nvGrpSpPr>
         <p:grpSpPr>
           <a:xfrm>
-            <a:off x="10232840" y="5161353"/>
-            <a:ext cx="1368000" cy="867600"/>
-            <a:chOff x="10232840" y="5161353"/>
-            <a:chExt cx="1368000" cy="867600"/>
+            <a:off x="10049240" y="5161353"/>
+            <a:ext cx="1735200" cy="867600"/>
+            <a:chOff x="10049240" y="5161353"/>
+            <a:chExt cx="1735200" cy="867600"/>
           </a:xfrm>
         </p:grpSpPr>
         <p:sp>
@@ -35996,8 +35996,8 @@
           </p:nvSpPr>
           <p:spPr>
             <a:xfrm>
-              <a:off x="10232840" y="5161353"/>
-              <a:ext cx="1368000" cy="867600"/>
+              <a:off x="10049240" y="5161353"/>
+              <a:ext cx="1735200" cy="867600"/>
             </a:xfrm>
             <a:prstGeom prst="roundRect">
               <a:avLst/>
@@ -36084,8 +36084,8 @@
           </p:nvSpPr>
           <p:spPr>
             <a:xfrm>
-              <a:off x="10232840" y="5180032"/>
-              <a:ext cx="1368000" cy="276999"/>
+              <a:off x="10049240" y="5180032"/>
+              <a:ext cx="1735200" cy="276999"/>
             </a:xfrm>
             <a:prstGeom prst="rect">
               <a:avLst/>
@@ -36121,10 +36121,10 @@
         </p:nvGrpSpPr>
         <p:grpSpPr>
           <a:xfrm>
-            <a:off x="658908" y="3952049"/>
-            <a:ext cx="1368000" cy="867600"/>
-            <a:chOff x="658908" y="3952049"/>
-            <a:chExt cx="1368000" cy="867600"/>
+            <a:off x="475308" y="3952049"/>
+            <a:ext cx="1735200" cy="867600"/>
+            <a:chOff x="475308" y="3952049"/>
+            <a:chExt cx="1735200" cy="867600"/>
           </a:xfrm>
         </p:grpSpPr>
         <p:sp>
@@ -36143,8 +36143,8 @@
           </p:nvSpPr>
           <p:spPr>
             <a:xfrm>
-              <a:off x="658908" y="3952049"/>
-              <a:ext cx="1368000" cy="867600"/>
+              <a:off x="475308" y="3952049"/>
+              <a:ext cx="1735200" cy="867600"/>
             </a:xfrm>
             <a:prstGeom prst="roundRect">
               <a:avLst/>
@@ -36231,8 +36231,8 @@
           </p:nvSpPr>
           <p:spPr>
             <a:xfrm>
-              <a:off x="658908" y="3970728"/>
-              <a:ext cx="1368000" cy="276999"/>
+              <a:off x="475308" y="3970728"/>
+              <a:ext cx="1735200" cy="276999"/>
             </a:xfrm>
             <a:prstGeom prst="rect">
               <a:avLst/>
@@ -36249,10 +36249,9 @@
                 <a:buNone/>
               </a:pPr>
               <a:r>
-                <a:rPr lang="de-CH" sz="1200" dirty="0"/>
-                <a:t>Relevant Data</a:t>
+                <a:rPr sz="1200"/>
+                <a:t>Information Extraction</a:t>
               </a:r>
-              <a:endParaRPr sz="1200" dirty="0"/>
             </a:p>
           </p:txBody>
         </p:sp>
@@ -36272,8 +36271,8 @@
           </p:nvSpPr>
           <p:spPr>
             <a:xfrm>
-              <a:off x="658908" y="4247727"/>
-              <a:ext cx="1368000" cy="0"/>
+              <a:off x="475308" y="4247727"/>
+              <a:ext cx="1735200" cy="0"/>
             </a:xfrm>
             <a:prstGeom prst="line">
               <a:avLst/>
@@ -36315,10 +36314,10 @@
         </p:nvGrpSpPr>
         <p:grpSpPr>
           <a:xfrm>
-            <a:off x="660215" y="2761424"/>
-            <a:ext cx="1368000" cy="867600"/>
-            <a:chOff x="660215" y="2761424"/>
-            <a:chExt cx="1368000" cy="867600"/>
+            <a:off x="476615" y="2761424"/>
+            <a:ext cx="1735200" cy="867600"/>
+            <a:chOff x="476615" y="2761424"/>
+            <a:chExt cx="1735200" cy="867600"/>
           </a:xfrm>
         </p:grpSpPr>
         <p:sp>
@@ -36337,8 +36336,8 @@
           </p:nvSpPr>
           <p:spPr>
             <a:xfrm>
-              <a:off x="660215" y="2761424"/>
-              <a:ext cx="1368000" cy="867600"/>
+              <a:off x="476615" y="2761424"/>
+              <a:ext cx="1735200" cy="867600"/>
             </a:xfrm>
             <a:prstGeom prst="roundRect">
               <a:avLst/>
@@ -36395,8 +36394,8 @@
           </p:nvSpPr>
           <p:spPr>
             <a:xfrm>
-              <a:off x="660215" y="2780103"/>
-              <a:ext cx="1368000" cy="276999"/>
+              <a:off x="476615" y="2780103"/>
+              <a:ext cx="1735200" cy="276999"/>
             </a:xfrm>
             <a:prstGeom prst="rect">
               <a:avLst/>
@@ -36435,8 +36434,8 @@
           </p:nvSpPr>
           <p:spPr>
             <a:xfrm>
-              <a:off x="660215" y="3054078"/>
-              <a:ext cx="1368000" cy="0"/>
+              <a:off x="476615" y="3054078"/>
+              <a:ext cx="1735200" cy="0"/>
             </a:xfrm>
             <a:prstGeom prst="line">
               <a:avLst/>
@@ -36508,10 +36507,10 @@
         </p:nvGrpSpPr>
         <p:grpSpPr>
           <a:xfrm>
-            <a:off x="5045244" y="1578083"/>
-            <a:ext cx="1368000" cy="867600"/>
-            <a:chOff x="5045244" y="1578083"/>
-            <a:chExt cx="1368000" cy="867600"/>
+            <a:off x="4861644" y="1578083"/>
+            <a:ext cx="1735200" cy="867600"/>
+            <a:chOff x="4861644" y="1578083"/>
+            <a:chExt cx="1735200" cy="867600"/>
           </a:xfrm>
         </p:grpSpPr>
         <p:sp>
@@ -36530,8 +36529,8 @@
           </p:nvSpPr>
           <p:spPr>
             <a:xfrm>
-              <a:off x="5045244" y="1578083"/>
-              <a:ext cx="1368000" cy="867600"/>
+              <a:off x="4861644" y="1578083"/>
+              <a:ext cx="1735200" cy="867600"/>
             </a:xfrm>
             <a:prstGeom prst="roundRect">
               <a:avLst/>
@@ -36618,8 +36617,8 @@
           </p:nvSpPr>
           <p:spPr>
             <a:xfrm>
-              <a:off x="5045244" y="1596762"/>
-              <a:ext cx="1368000" cy="276999"/>
+              <a:off x="4861644" y="1596762"/>
+              <a:ext cx="1735200" cy="276999"/>
             </a:xfrm>
             <a:prstGeom prst="rect">
               <a:avLst/>
@@ -36658,8 +36657,8 @@
           </p:nvSpPr>
           <p:spPr>
             <a:xfrm flipV="1">
-              <a:off x="5045244" y="1873761"/>
-              <a:ext cx="1368000" cy="0"/>
+              <a:off x="4861644" y="1873761"/>
+              <a:ext cx="1735200" cy="0"/>
             </a:xfrm>
             <a:prstGeom prst="line">
               <a:avLst/>
@@ -36701,10 +36700,10 @@
         </p:nvGrpSpPr>
         <p:grpSpPr>
           <a:xfrm>
-            <a:off x="8042090" y="2776165"/>
-            <a:ext cx="1368000" cy="879071"/>
-            <a:chOff x="8042090" y="2776165"/>
-            <a:chExt cx="1368000" cy="879071"/>
+            <a:off x="7858490" y="2776165"/>
+            <a:ext cx="1735200" cy="879071"/>
+            <a:chOff x="7858490" y="2776165"/>
+            <a:chExt cx="1735200" cy="879071"/>
           </a:xfrm>
         </p:grpSpPr>
         <p:sp>
@@ -36723,8 +36722,8 @@
           </p:nvSpPr>
           <p:spPr>
             <a:xfrm>
-              <a:off x="8042090" y="2776165"/>
-              <a:ext cx="1368000" cy="867600"/>
+              <a:off x="7858490" y="2776165"/>
+              <a:ext cx="1735200" cy="867600"/>
             </a:xfrm>
             <a:prstGeom prst="roundRect">
               <a:avLst/>
@@ -36811,8 +36810,8 @@
           </p:nvSpPr>
           <p:spPr>
             <a:xfrm>
-              <a:off x="8042090" y="2794844"/>
-              <a:ext cx="1368000" cy="276999"/>
+              <a:off x="7858490" y="2794844"/>
+              <a:ext cx="1735200" cy="276999"/>
             </a:xfrm>
             <a:prstGeom prst="rect">
               <a:avLst/>
@@ -36851,8 +36850,8 @@
           </p:nvSpPr>
           <p:spPr>
             <a:xfrm flipV="1">
-              <a:off x="8042090" y="3071843"/>
-              <a:ext cx="1368000" cy="0"/>
+              <a:off x="7858490" y="3071843"/>
+              <a:ext cx="1735200" cy="0"/>
             </a:xfrm>
             <a:prstGeom prst="line">
               <a:avLst/>
@@ -36894,10 +36893,10 @@
         </p:nvGrpSpPr>
         <p:grpSpPr>
           <a:xfrm>
-            <a:off x="5041715" y="2776165"/>
-            <a:ext cx="1368000" cy="867600"/>
-            <a:chOff x="5041715" y="2776165"/>
-            <a:chExt cx="1368000" cy="867600"/>
+            <a:off x="4858115" y="2776165"/>
+            <a:ext cx="1735200" cy="867600"/>
+            <a:chOff x="4858115" y="2776165"/>
+            <a:chExt cx="1735200" cy="867600"/>
           </a:xfrm>
         </p:grpSpPr>
         <p:sp>
@@ -36916,8 +36915,8 @@
           </p:nvSpPr>
           <p:spPr>
             <a:xfrm>
-              <a:off x="5041715" y="2776165"/>
-              <a:ext cx="1368000" cy="867600"/>
+              <a:off x="4858115" y="2776165"/>
+              <a:ext cx="1735200" cy="867600"/>
             </a:xfrm>
             <a:prstGeom prst="roundRect">
               <a:avLst/>
@@ -37004,8 +37003,8 @@
           </p:nvSpPr>
           <p:spPr>
             <a:xfrm>
-              <a:off x="5041715" y="2794844"/>
-              <a:ext cx="1368000" cy="285750"/>
+              <a:off x="4858115" y="2794844"/>
+              <a:ext cx="1735200" cy="285750"/>
             </a:xfrm>
             <a:prstGeom prst="rect">
               <a:avLst/>
@@ -37023,13 +37022,8 @@
               </a:pPr>
               <a:r>
                 <a:rPr sz="1200" dirty="0"/>
-                <a:t>Vector </a:t>
+                <a:t>Vector Database</a:t>
               </a:r>
-              <a:r>
-                <a:rPr lang="de-CH" sz="1200" dirty="0"/>
-                <a:t>DB</a:t>
-              </a:r>
-              <a:endParaRPr sz="1200" dirty="0"/>
             </a:p>
           </p:txBody>
         </p:sp>
@@ -37049,8 +37043,8 @@
           </p:nvSpPr>
           <p:spPr>
             <a:xfrm>
-              <a:off x="5041715" y="3080594"/>
-              <a:ext cx="1368000" cy="0"/>
+              <a:off x="4858115" y="3080594"/>
+              <a:ext cx="1735200" cy="0"/>
             </a:xfrm>
             <a:prstGeom prst="line">
               <a:avLst/>
@@ -37092,10 +37086,10 @@
         </p:nvGrpSpPr>
         <p:grpSpPr>
           <a:xfrm>
-            <a:off x="5041715" y="5161353"/>
-            <a:ext cx="1368000" cy="885454"/>
-            <a:chOff x="5041715" y="5161353"/>
-            <a:chExt cx="1368000" cy="885454"/>
+            <a:off x="4858115" y="5161353"/>
+            <a:ext cx="1735200" cy="885454"/>
+            <a:chOff x="4858115" y="5161353"/>
+            <a:chExt cx="1735200" cy="885454"/>
           </a:xfrm>
         </p:grpSpPr>
         <p:sp>
@@ -37114,8 +37108,8 @@
           </p:nvSpPr>
           <p:spPr>
             <a:xfrm>
-              <a:off x="5041715" y="5161353"/>
-              <a:ext cx="1368000" cy="867600"/>
+              <a:off x="4858115" y="5161353"/>
+              <a:ext cx="1735200" cy="867600"/>
             </a:xfrm>
             <a:prstGeom prst="roundRect">
               <a:avLst/>
@@ -37202,8 +37196,8 @@
           </p:nvSpPr>
           <p:spPr>
             <a:xfrm>
-              <a:off x="5041715" y="5180032"/>
-              <a:ext cx="1368000" cy="276999"/>
+              <a:off x="4858115" y="5180032"/>
+              <a:ext cx="1735200" cy="276999"/>
             </a:xfrm>
             <a:prstGeom prst="rect">
               <a:avLst/>
@@ -37242,8 +37236,8 @@
           </p:nvSpPr>
           <p:spPr>
             <a:xfrm>
-              <a:off x="5041715" y="5457031"/>
-              <a:ext cx="1368000" cy="0"/>
+              <a:off x="4858115" y="5457031"/>
+              <a:ext cx="1735200" cy="0"/>
             </a:xfrm>
             <a:prstGeom prst="line">
               <a:avLst/>
@@ -37285,10 +37279,10 @@
         </p:nvGrpSpPr>
         <p:grpSpPr>
           <a:xfrm>
-            <a:off x="8032042" y="1570799"/>
-            <a:ext cx="1368000" cy="867600"/>
-            <a:chOff x="8032042" y="1570799"/>
-            <a:chExt cx="1368000" cy="867600"/>
+            <a:off x="7848442" y="1570799"/>
+            <a:ext cx="1735200" cy="867600"/>
+            <a:chOff x="7848442" y="1570799"/>
+            <a:chExt cx="1735200" cy="867600"/>
           </a:xfrm>
         </p:grpSpPr>
         <p:sp>
@@ -37307,8 +37301,8 @@
           </p:nvSpPr>
           <p:spPr>
             <a:xfrm>
-              <a:off x="8032042" y="1570799"/>
-              <a:ext cx="1368000" cy="867600"/>
+              <a:off x="7848442" y="1570799"/>
+              <a:ext cx="1735200" cy="867600"/>
             </a:xfrm>
             <a:prstGeom prst="roundRect">
               <a:avLst/>
@@ -37398,8 +37392,8 @@
           </p:nvSpPr>
           <p:spPr>
             <a:xfrm>
-              <a:off x="8032042" y="1570799"/>
-              <a:ext cx="1368000" cy="276999"/>
+              <a:off x="7848442" y="1570799"/>
+              <a:ext cx="1735200" cy="276999"/>
             </a:xfrm>
             <a:prstGeom prst="rect">
               <a:avLst/>
@@ -37438,8 +37432,8 @@
           </p:nvSpPr>
           <p:spPr>
             <a:xfrm>
-              <a:off x="8032042" y="1854598"/>
-              <a:ext cx="1368000" cy="0"/>
+              <a:off x="7848442" y="1854598"/>
+              <a:ext cx="1735200" cy="0"/>
             </a:xfrm>
             <a:prstGeom prst="line">
               <a:avLst/>
@@ -37481,10 +37475,10 @@
         </p:nvGrpSpPr>
         <p:grpSpPr>
           <a:xfrm>
-            <a:off x="8042090" y="5161353"/>
-            <a:ext cx="1368000" cy="889358"/>
-            <a:chOff x="8042090" y="5161353"/>
-            <a:chExt cx="1368000" cy="889358"/>
+            <a:off x="7858490" y="5161353"/>
+            <a:ext cx="1735200" cy="889358"/>
+            <a:chOff x="7858490" y="5161353"/>
+            <a:chExt cx="1735200" cy="889358"/>
           </a:xfrm>
         </p:grpSpPr>
         <p:sp>
@@ -37503,8 +37497,8 @@
           </p:nvSpPr>
           <p:spPr>
             <a:xfrm>
-              <a:off x="8042090" y="5161353"/>
-              <a:ext cx="1368000" cy="867600"/>
+              <a:off x="7858490" y="5161353"/>
+              <a:ext cx="1735200" cy="867600"/>
             </a:xfrm>
             <a:prstGeom prst="roundRect">
               <a:avLst/>
@@ -37594,8 +37588,8 @@
           </p:nvSpPr>
           <p:spPr>
             <a:xfrm>
-              <a:off x="8042090" y="5207333"/>
-              <a:ext cx="1368000" cy="276999"/>
+              <a:off x="7858490" y="5207333"/>
+              <a:ext cx="1735200" cy="276999"/>
             </a:xfrm>
             <a:prstGeom prst="rect">
               <a:avLst/>
@@ -37642,8 +37636,8 @@
           </p:nvSpPr>
           <p:spPr>
             <a:xfrm flipV="1">
-              <a:off x="8042090" y="5449914"/>
-              <a:ext cx="1368000" cy="0"/>
+              <a:off x="7858490" y="5449914"/>
+              <a:ext cx="1735200" cy="0"/>
             </a:xfrm>
             <a:prstGeom prst="line">
               <a:avLst/>
@@ -37782,15 +37776,15 @@
           </p:cNvPr>
           <p:cNvCxnSpPr>
             <a:cxnSpLocks/>
-            <a:stCxn id="48" idx="0"/>
+            <a:stCxn id="45" idx="0"/>
             <a:endCxn id="121" idx="2"/>
           </p:cNvCxnSpPr>
           <p:nvPr/>
         </p:nvCxnSpPr>
         <p:spPr>
           <a:xfrm flipH="1" flipV="1">
-            <a:off x="1337904" y="2438399"/>
-            <a:ext cx="6311" cy="341704"/>
+            <a:off x="1337904" y="2438400"/>
+            <a:ext cx="6311" cy="323850"/>
           </a:xfrm>
           <a:prstGeom prst="straightConnector1">
             <a:avLst/>
@@ -37917,7 +37911,6 @@
             </a:extLst>
           </p:cNvPr>
           <p:cNvCxnSpPr>
-            <a:cxnSpLocks/>
             <a:stCxn id="81" idx="3"/>
             <a:endCxn id="102" idx="1"/>
           </p:cNvCxnSpPr>
@@ -37925,8 +37918,8 @@
         </p:nvCxnSpPr>
         <p:spPr>
           <a:xfrm>
-            <a:off x="6593315" y="5595153"/>
-            <a:ext cx="1265175" cy="0"/>
+            <a:off x="6355555" y="5595567"/>
+            <a:ext cx="1740695" cy="0"/>
           </a:xfrm>
           <a:prstGeom prst="straightConnector1">
             <a:avLst/>
@@ -38009,7 +38002,6 @@
             </a:extLst>
           </p:cNvPr>
           <p:cNvCxnSpPr>
-            <a:cxnSpLocks/>
             <a:stCxn id="60" idx="1"/>
             <a:endCxn id="72" idx="3"/>
           </p:cNvCxnSpPr>
@@ -38017,8 +38009,8 @@
         </p:nvCxnSpPr>
         <p:spPr>
           <a:xfrm flipH="1">
-            <a:off x="6593315" y="3209965"/>
-            <a:ext cx="1265175" cy="0"/>
+            <a:off x="6716161" y="3210379"/>
+            <a:ext cx="1380089" cy="0"/>
           </a:xfrm>
           <a:prstGeom prst="straightConnector1">
             <a:avLst/>
@@ -38195,8 +38187,8 @@
         </p:nvCxnSpPr>
         <p:spPr>
           <a:xfrm>
-            <a:off x="2205504" y="2004599"/>
-            <a:ext cx="430812" cy="0"/>
+            <a:off x="1967744" y="2005013"/>
+            <a:ext cx="1097319" cy="0"/>
           </a:xfrm>
           <a:prstGeom prst="straightConnector1">
             <a:avLst/>
@@ -38234,10 +38226,10 @@
         </p:nvGrpSpPr>
         <p:grpSpPr>
           <a:xfrm>
-            <a:off x="2819916" y="1570799"/>
-            <a:ext cx="1368000" cy="867600"/>
-            <a:chOff x="2819916" y="1570799"/>
-            <a:chExt cx="1368000" cy="867600"/>
+            <a:off x="2636316" y="1570799"/>
+            <a:ext cx="1735200" cy="867600"/>
+            <a:chOff x="2636316" y="1570799"/>
+            <a:chExt cx="1735200" cy="867600"/>
           </a:xfrm>
         </p:grpSpPr>
         <p:sp>
@@ -38256,8 +38248,8 @@
           </p:nvSpPr>
           <p:spPr>
             <a:xfrm>
-              <a:off x="2819916" y="1570799"/>
-              <a:ext cx="1368000" cy="867600"/>
+              <a:off x="2636316" y="1570799"/>
+              <a:ext cx="1735200" cy="867600"/>
             </a:xfrm>
             <a:prstGeom prst="roundRect">
               <a:avLst/>
@@ -38347,8 +38339,8 @@
           </p:nvSpPr>
           <p:spPr>
             <a:xfrm>
-              <a:off x="2819916" y="1570799"/>
-              <a:ext cx="1368000" cy="276999"/>
+              <a:off x="2636316" y="1570799"/>
+              <a:ext cx="1735200" cy="276999"/>
             </a:xfrm>
             <a:prstGeom prst="rect">
               <a:avLst/>
@@ -38387,8 +38379,8 @@
           </p:nvSpPr>
           <p:spPr>
             <a:xfrm>
-              <a:off x="2819916" y="1854598"/>
-              <a:ext cx="1368000" cy="0"/>
+              <a:off x="2636316" y="1854598"/>
+              <a:ext cx="1735200" cy="0"/>
             </a:xfrm>
             <a:prstGeom prst="line">
               <a:avLst/>
@@ -38422,6 +38414,42 @@
           </p:txBody>
         </p:sp>
       </p:grpSp>
+      <p:sp>
+        <p:nvSpPr>
+          <p:cNvPr id="145" name="Textfeld 144">
+            <a:extLst>
+              <a:ext uri="{FF2B5EF4-FFF2-40B4-BE49-F238E27FC236}">
+                <a16:creationId xmlns:a16="http://schemas.microsoft.com/office/drawing/2014/main" id="{8C156430-C202-53BD-8023-A0D5C9A9CCB0}"/>
+              </a:ext>
+            </a:extLst>
+          </p:cNvPr>
+          <p:cNvSpPr txBox="1"/>
+          <p:nvPr/>
+        </p:nvSpPr>
+        <p:spPr>
+          <a:xfrm>
+            <a:off x="6838721" y="5342499"/>
+            <a:ext cx="922500" cy="276999"/>
+          </a:xfrm>
+          <a:prstGeom prst="rect">
+            <a:avLst/>
+          </a:prstGeom>
+          <a:noFill/>
+        </p:spPr>
+        <p:txBody>
+          <a:bodyPr wrap="square" rtlCol="0">
+            <a:spAutoFit/>
+          </a:bodyPr>
+          <a:lstStyle/>
+          <a:p>
+            <a:r>
+              <a:rPr lang="de-CH" sz="1200" dirty="0" err="1"/>
+              <a:t>Context</a:t>
+            </a:r>
+            <a:endParaRPr lang="de-CH" sz="1200" dirty="0"/>
+          </a:p>
+        </p:txBody>
+      </p:sp>
       <p:cxnSp>
         <p:nvCxnSpPr>
           <p:cNvPr id="7" name="Gerade Verbindung mit Pfeil 175">
@@ -38440,8 +38468,8 @@
         </p:nvCxnSpPr>
         <p:spPr>
           <a:xfrm>
-            <a:off x="4371516" y="2004599"/>
-            <a:ext cx="490128" cy="7284"/>
+            <a:off x="4324743" y="2005013"/>
+            <a:ext cx="1172789" cy="7284"/>
           </a:xfrm>
           <a:prstGeom prst="straightConnector1">
             <a:avLst/>
@@ -38489,8 +38517,8 @@
         </p:nvCxnSpPr>
         <p:spPr>
           <a:xfrm>
-            <a:off x="9593690" y="5595153"/>
-            <a:ext cx="455550" cy="0"/>
+            <a:off x="9355930" y="5595567"/>
+            <a:ext cx="931070" cy="0"/>
           </a:xfrm>
           <a:prstGeom prst="straightConnector1">
             <a:avLst/>
@@ -38587,8 +38615,8 @@
         </p:nvCxnSpPr>
         <p:spPr>
           <a:xfrm flipH="1">
-            <a:off x="9583642" y="2004599"/>
-            <a:ext cx="465598" cy="0"/>
+            <a:off x="9114211" y="2005013"/>
+            <a:ext cx="1172789" cy="0"/>
           </a:xfrm>
           <a:prstGeom prst="straightConnector1">
             <a:avLst/>
@@ -38636,8 +38664,8 @@
         </p:nvCxnSpPr>
         <p:spPr>
           <a:xfrm>
-            <a:off x="8716042" y="2434208"/>
-            <a:ext cx="10048" cy="360636"/>
+            <a:off x="8484371" y="2435034"/>
+            <a:ext cx="229098" cy="360636"/>
           </a:xfrm>
           <a:prstGeom prst="straightConnector1">
             <a:avLst/>
@@ -38678,15 +38706,15 @@
           </p:cNvPr>
           <p:cNvCxnSpPr>
             <a:cxnSpLocks/>
-            <a:stCxn id="54" idx="2"/>
+            <a:stCxn id="56" idx="2"/>
             <a:endCxn id="72" idx="0"/>
           </p:cNvCxnSpPr>
           <p:nvPr/>
         </p:nvCxnSpPr>
         <p:spPr>
           <a:xfrm flipH="1">
-            <a:off x="5725715" y="2445683"/>
-            <a:ext cx="3529" cy="330482"/>
+            <a:off x="6086321" y="2427045"/>
+            <a:ext cx="41051" cy="349946"/>
           </a:xfrm>
           <a:prstGeom prst="straightConnector1">
             <a:avLst/>
@@ -38733,9 +38761,9 @@
           <p:nvPr/>
         </p:nvCxnSpPr>
         <p:spPr>
-          <a:xfrm>
-            <a:off x="5725715" y="3642941"/>
-            <a:ext cx="0" cy="1537091"/>
+          <a:xfrm flipH="1">
+            <a:off x="5713094" y="3643767"/>
+            <a:ext cx="373227" cy="1537091"/>
           </a:xfrm>
           <a:prstGeom prst="straightConnector1">
             <a:avLst/>
@@ -38773,10 +38801,10 @@
         </p:nvGrpSpPr>
         <p:grpSpPr>
           <a:xfrm>
-            <a:off x="653904" y="1570799"/>
-            <a:ext cx="1368000" cy="867600"/>
-            <a:chOff x="653904" y="1570799"/>
-            <a:chExt cx="1368000" cy="867600"/>
+            <a:off x="470304" y="1570799"/>
+            <a:ext cx="1735200" cy="867600"/>
+            <a:chOff x="470304" y="1570799"/>
+            <a:chExt cx="1735200" cy="867600"/>
           </a:xfrm>
         </p:grpSpPr>
         <p:sp>
@@ -38795,8 +38823,8 @@
           </p:nvSpPr>
           <p:spPr>
             <a:xfrm>
-              <a:off x="653904" y="1570799"/>
-              <a:ext cx="1368000" cy="867600"/>
+              <a:off x="470304" y="1570799"/>
+              <a:ext cx="1735200" cy="867600"/>
             </a:xfrm>
             <a:prstGeom prst="roundRect">
               <a:avLst/>
@@ -38853,8 +38881,8 @@
           </p:nvSpPr>
           <p:spPr>
             <a:xfrm>
-              <a:off x="653904" y="1589478"/>
-              <a:ext cx="1368000" cy="276999"/>
+              <a:off x="470304" y="1589478"/>
+              <a:ext cx="1735200" cy="276999"/>
             </a:xfrm>
             <a:prstGeom prst="rect">
               <a:avLst/>
@@ -38923,8 +38951,8 @@
           </p:nvSpPr>
           <p:spPr>
             <a:xfrm>
-              <a:off x="653904" y="1863453"/>
-              <a:ext cx="1368000" cy="0"/>
+              <a:off x="470304" y="1863453"/>
+              <a:ext cx="1735200" cy="0"/>
             </a:xfrm>
             <a:prstGeom prst="line">
               <a:avLst/>
@@ -38958,782 +38986,6 @@
           </p:txBody>
         </p:sp>
       </p:grpSp>
-      <p:grpSp>
-        <p:nvGrpSpPr>
-          <p:cNvPr id="29" name="Gruppe Embedding LLM">
-            <a:extLst>
-              <a:ext uri="{FF2B5EF4-FFF2-40B4-BE49-F238E27FC236}">
-                <a16:creationId xmlns:a16="http://schemas.microsoft.com/office/drawing/2014/main" id="{97DA10AF-5D12-3A3B-5C8A-46A79720B1A4}"/>
-              </a:ext>
-            </a:extLst>
-          </p:cNvPr>
-          <p:cNvGrpSpPr/>
-          <p:nvPr/>
-        </p:nvGrpSpPr>
-        <p:grpSpPr>
-          <a:xfrm>
-            <a:off x="2819916" y="1570799"/>
-            <a:ext cx="1368000" cy="867600"/>
-            <a:chOff x="2819916" y="1570799"/>
-            <a:chExt cx="1368000" cy="867600"/>
-          </a:xfrm>
-        </p:grpSpPr>
-        <p:sp>
-          <p:nvSpPr>
-            <p:cNvPr id="32" name="Rechteck: abgerundete Ecken 31">
-              <a:extLst>
-                <a:ext uri="{FF2B5EF4-FFF2-40B4-BE49-F238E27FC236}">
-                  <a16:creationId xmlns:a16="http://schemas.microsoft.com/office/drawing/2014/main" id="{B73EED8C-74B7-0DE4-4653-D7C4D2CA248D}"/>
-                </a:ext>
-              </a:extLst>
-            </p:cNvPr>
-            <p:cNvSpPr>
-              <a:spLocks/>
-            </p:cNvSpPr>
-            <p:nvPr/>
-          </p:nvSpPr>
-          <p:spPr>
-            <a:xfrm>
-              <a:off x="2819916" y="1570799"/>
-              <a:ext cx="1368000" cy="867600"/>
-            </a:xfrm>
-            <a:prstGeom prst="roundRect">
-              <a:avLst/>
-            </a:prstGeom>
-            <a:solidFill>
-              <a:schemeClr val="accent6">
-                <a:lumMod val="40000"/>
-                <a:lumOff val="60000"/>
-              </a:schemeClr>
-            </a:solidFill>
-            <a:ln>
-              <a:solidFill>
-                <a:schemeClr val="tx2"/>
-              </a:solidFill>
-            </a:ln>
-          </p:spPr>
-          <p:style>
-            <a:lnRef idx="2">
-              <a:schemeClr val="accent1">
-                <a:shade val="15000"/>
-              </a:schemeClr>
-            </a:lnRef>
-            <a:fillRef idx="1">
-              <a:schemeClr val="accent1"/>
-            </a:fillRef>
-            <a:effectRef idx="0">
-              <a:schemeClr val="accent1"/>
-            </a:effectRef>
-            <a:fontRef idx="minor">
-              <a:schemeClr val="lt1"/>
-            </a:fontRef>
-          </p:style>
-          <p:txBody>
-            <a:bodyPr anchor="ctr"/>
-            <a:lstStyle/>
-            <a:p>
-              <a:pPr algn="ctr">
-                <a:buNone/>
-              </a:pPr>
-              <a:endParaRPr/>
-            </a:p>
-          </p:txBody>
-        </p:sp>
-        <p:sp>
-          <p:nvSpPr>
-            <p:cNvPr id="35" name="Textfeld 40">
-              <a:extLst>
-                <a:ext uri="{FF2B5EF4-FFF2-40B4-BE49-F238E27FC236}">
-                  <a16:creationId xmlns:a16="http://schemas.microsoft.com/office/drawing/2014/main" id="{48FF7E7C-9CC8-E0A2-D673-5A5B2FB7A6A1}"/>
-                </a:ext>
-              </a:extLst>
-            </p:cNvPr>
-            <p:cNvSpPr>
-              <a:spLocks/>
-            </p:cNvSpPr>
-            <p:nvPr/>
-          </p:nvSpPr>
-          <p:spPr>
-            <a:xfrm>
-              <a:off x="2819916" y="1570799"/>
-              <a:ext cx="1368000" cy="276999"/>
-            </a:xfrm>
-            <a:prstGeom prst="rect">
-              <a:avLst/>
-            </a:prstGeom>
-            <a:noFill/>
-          </p:spPr>
-          <p:txBody>
-            <a:bodyPr wrap="square">
-              <a:spAutoFit/>
-            </a:bodyPr>
-            <a:lstStyle/>
-            <a:p>
-              <a:pPr algn="ctr">
-                <a:buNone/>
-              </a:pPr>
-              <a:r>
-                <a:rPr lang="de-CH" sz="1200" dirty="0"/>
-                <a:t>Graph Engine</a:t>
-              </a:r>
-              <a:endParaRPr sz="1200" dirty="0"/>
-            </a:p>
-          </p:txBody>
-        </p:sp>
-        <p:sp>
-          <p:nvSpPr>
-            <p:cNvPr id="36" name="Gerader Verbinder 35">
-              <a:extLst>
-                <a:ext uri="{FF2B5EF4-FFF2-40B4-BE49-F238E27FC236}">
-                  <a16:creationId xmlns:a16="http://schemas.microsoft.com/office/drawing/2014/main" id="{E58DDFDC-2C03-2A44-F9F9-B7FC0D217F20}"/>
-                </a:ext>
-              </a:extLst>
-            </p:cNvPr>
-            <p:cNvSpPr>
-              <a:spLocks/>
-            </p:cNvSpPr>
-            <p:nvPr/>
-          </p:nvSpPr>
-          <p:spPr>
-            <a:xfrm>
-              <a:off x="2819916" y="1854598"/>
-              <a:ext cx="1368000" cy="0"/>
-            </a:xfrm>
-            <a:prstGeom prst="line">
-              <a:avLst/>
-            </a:prstGeom>
-            <a:ln>
-              <a:solidFill>
-                <a:schemeClr val="tx2"/>
-              </a:solidFill>
-            </a:ln>
-          </p:spPr>
-          <p:style>
-            <a:lnRef idx="1">
-              <a:schemeClr val="accent1"/>
-            </a:lnRef>
-            <a:fillRef idx="0">
-              <a:schemeClr val="accent1"/>
-            </a:fillRef>
-            <a:effectRef idx="0">
-              <a:schemeClr val="accent1"/>
-            </a:effectRef>
-            <a:fontRef idx="minor">
-              <a:schemeClr val="tx1"/>
-            </a:fontRef>
-          </p:style>
-          <p:txBody>
-            <a:bodyPr/>
-            <a:lstStyle/>
-            <a:p>
-              <a:endParaRPr lang="de-CH"/>
-            </a:p>
-          </p:txBody>
-        </p:sp>
-      </p:grpSp>
-      <p:cxnSp>
-        <p:nvCxnSpPr>
-          <p:cNvPr id="55" name="Gerade Verbindung mit Pfeil 116">
-            <a:extLst>
-              <a:ext uri="{FF2B5EF4-FFF2-40B4-BE49-F238E27FC236}">
-                <a16:creationId xmlns:a16="http://schemas.microsoft.com/office/drawing/2014/main" id="{61F9B370-A340-9EEC-FC69-097193881A3C}"/>
-              </a:ext>
-            </a:extLst>
-          </p:cNvPr>
-          <p:cNvCxnSpPr>
-            <a:cxnSpLocks/>
-            <a:stCxn id="20" idx="2"/>
-            <a:endCxn id="102" idx="0"/>
-          </p:cNvCxnSpPr>
-          <p:nvPr/>
-        </p:nvCxnSpPr>
-        <p:spPr>
-          <a:xfrm flipH="1">
-            <a:off x="8726090" y="2433197"/>
-            <a:ext cx="2190750" cy="2728156"/>
-          </a:xfrm>
-          <a:prstGeom prst="straightConnector1">
-            <a:avLst/>
-          </a:prstGeom>
-          <a:ln w="50800">
-            <a:solidFill>
-              <a:schemeClr val="tx1">
-                <a:alpha val="50000"/>
-              </a:schemeClr>
-            </a:solidFill>
-            <a:prstDash val="solid"/>
-            <a:tailEnd type="triangle"/>
-          </a:ln>
-        </p:spPr>
-        <p:style>
-          <a:lnRef idx="1">
-            <a:schemeClr val="accent1"/>
-          </a:lnRef>
-          <a:fillRef idx="0">
-            <a:schemeClr val="accent1"/>
-          </a:fillRef>
-          <a:effectRef idx="0">
-            <a:schemeClr val="accent1"/>
-          </a:effectRef>
-          <a:fontRef idx="minor">
-            <a:schemeClr val="tx1"/>
-          </a:fontRef>
-        </p:style>
-      </p:cxnSp>
-      <p:grpSp>
-        <p:nvGrpSpPr>
-          <p:cNvPr id="64" name="Gruppe Embedding LLM">
-            <a:extLst>
-              <a:ext uri="{FF2B5EF4-FFF2-40B4-BE49-F238E27FC236}">
-                <a16:creationId xmlns:a16="http://schemas.microsoft.com/office/drawing/2014/main" id="{7D3C3C34-10C0-8929-8845-4EFB21D0B163}"/>
-              </a:ext>
-            </a:extLst>
-          </p:cNvPr>
-          <p:cNvGrpSpPr/>
-          <p:nvPr/>
-        </p:nvGrpSpPr>
-        <p:grpSpPr>
-          <a:xfrm>
-            <a:off x="2819916" y="1570799"/>
-            <a:ext cx="1368000" cy="867600"/>
-            <a:chOff x="2819916" y="1570799"/>
-            <a:chExt cx="1368000" cy="867600"/>
-          </a:xfrm>
-        </p:grpSpPr>
-        <p:sp>
-          <p:nvSpPr>
-            <p:cNvPr id="65" name="Rechteck: abgerundete Ecken 64">
-              <a:extLst>
-                <a:ext uri="{FF2B5EF4-FFF2-40B4-BE49-F238E27FC236}">
-                  <a16:creationId xmlns:a16="http://schemas.microsoft.com/office/drawing/2014/main" id="{76CE6652-449C-657E-7587-9F547A9D6ECD}"/>
-                </a:ext>
-              </a:extLst>
-            </p:cNvPr>
-            <p:cNvSpPr>
-              <a:spLocks/>
-            </p:cNvSpPr>
-            <p:nvPr/>
-          </p:nvSpPr>
-          <p:spPr>
-            <a:xfrm>
-              <a:off x="2819916" y="1570799"/>
-              <a:ext cx="1368000" cy="867600"/>
-            </a:xfrm>
-            <a:prstGeom prst="roundRect">
-              <a:avLst/>
-            </a:prstGeom>
-            <a:solidFill>
-              <a:schemeClr val="accent6">
-                <a:lumMod val="40000"/>
-                <a:lumOff val="60000"/>
-              </a:schemeClr>
-            </a:solidFill>
-            <a:ln>
-              <a:solidFill>
-                <a:schemeClr val="tx2"/>
-              </a:solidFill>
-            </a:ln>
-          </p:spPr>
-          <p:style>
-            <a:lnRef idx="2">
-              <a:schemeClr val="accent1">
-                <a:shade val="15000"/>
-              </a:schemeClr>
-            </a:lnRef>
-            <a:fillRef idx="1">
-              <a:schemeClr val="accent1"/>
-            </a:fillRef>
-            <a:effectRef idx="0">
-              <a:schemeClr val="accent1"/>
-            </a:effectRef>
-            <a:fontRef idx="minor">
-              <a:schemeClr val="lt1"/>
-            </a:fontRef>
-          </p:style>
-          <p:txBody>
-            <a:bodyPr anchor="ctr"/>
-            <a:lstStyle/>
-            <a:p>
-              <a:pPr algn="ctr">
-                <a:buNone/>
-              </a:pPr>
-              <a:endParaRPr dirty="0"/>
-            </a:p>
-          </p:txBody>
-        </p:sp>
-        <p:pic>
-          <p:nvPicPr>
-            <p:cNvPr id="66" name="Grafik 39">
-              <a:extLst>
-                <a:ext uri="{FF2B5EF4-FFF2-40B4-BE49-F238E27FC236}">
-                  <a16:creationId xmlns:a16="http://schemas.microsoft.com/office/drawing/2014/main" id="{2D0438B3-277A-DEEA-3A5E-97C93124AC32}"/>
-                </a:ext>
-              </a:extLst>
-            </p:cNvPr>
-            <p:cNvPicPr>
-              <a:picLocks noChangeAspect="1"/>
-            </p:cNvPicPr>
-            <p:nvPr/>
-          </p:nvPicPr>
-          <p:blipFill>
-            <a:blip r:embed="rId11"/>
-            <a:stretch>
-              <a:fillRect/>
-            </a:stretch>
-          </p:blipFill>
-          <p:spPr>
-            <a:xfrm flipH="1">
-              <a:off x="3266354" y="1909499"/>
-              <a:ext cx="475124" cy="482236"/>
-            </a:xfrm>
-            <a:prstGeom prst="rect">
-              <a:avLst/>
-            </a:prstGeom>
-          </p:spPr>
-        </p:pic>
-        <p:sp>
-          <p:nvSpPr>
-            <p:cNvPr id="68" name="Textfeld 40">
-              <a:extLst>
-                <a:ext uri="{FF2B5EF4-FFF2-40B4-BE49-F238E27FC236}">
-                  <a16:creationId xmlns:a16="http://schemas.microsoft.com/office/drawing/2014/main" id="{49288EC7-398C-49E2-3B9A-979BFB1B3F7D}"/>
-                </a:ext>
-              </a:extLst>
-            </p:cNvPr>
-            <p:cNvSpPr>
-              <a:spLocks/>
-            </p:cNvSpPr>
-            <p:nvPr/>
-          </p:nvSpPr>
-          <p:spPr>
-            <a:xfrm>
-              <a:off x="2819916" y="1570799"/>
-              <a:ext cx="1368000" cy="276999"/>
-            </a:xfrm>
-            <a:prstGeom prst="rect">
-              <a:avLst/>
-            </a:prstGeom>
-            <a:noFill/>
-          </p:spPr>
-          <p:txBody>
-            <a:bodyPr wrap="square">
-              <a:spAutoFit/>
-            </a:bodyPr>
-            <a:lstStyle/>
-            <a:p>
-              <a:pPr algn="ctr">
-                <a:buNone/>
-              </a:pPr>
-              <a:r>
-                <a:rPr lang="de-CH" sz="1200" dirty="0" err="1"/>
-                <a:t>Reranking</a:t>
-              </a:r>
-              <a:r>
-                <a:rPr lang="de-CH" sz="1200" dirty="0"/>
-                <a:t> Model</a:t>
-              </a:r>
-              <a:endParaRPr sz="1200" dirty="0"/>
-            </a:p>
-          </p:txBody>
-        </p:sp>
-        <p:sp>
-          <p:nvSpPr>
-            <p:cNvPr id="70" name="Gerader Verbinder 69">
-              <a:extLst>
-                <a:ext uri="{FF2B5EF4-FFF2-40B4-BE49-F238E27FC236}">
-                  <a16:creationId xmlns:a16="http://schemas.microsoft.com/office/drawing/2014/main" id="{10779A5F-A567-5DF9-7B5F-9A5A5EE7DD74}"/>
-                </a:ext>
-              </a:extLst>
-            </p:cNvPr>
-            <p:cNvSpPr>
-              <a:spLocks/>
-            </p:cNvSpPr>
-            <p:nvPr/>
-          </p:nvSpPr>
-          <p:spPr>
-            <a:xfrm>
-              <a:off x="2819916" y="1854598"/>
-              <a:ext cx="1368000" cy="0"/>
-            </a:xfrm>
-            <a:prstGeom prst="line">
-              <a:avLst/>
-            </a:prstGeom>
-            <a:ln>
-              <a:solidFill>
-                <a:schemeClr val="tx2"/>
-              </a:solidFill>
-            </a:ln>
-          </p:spPr>
-          <p:style>
-            <a:lnRef idx="1">
-              <a:schemeClr val="accent1"/>
-            </a:lnRef>
-            <a:fillRef idx="0">
-              <a:schemeClr val="accent1"/>
-            </a:fillRef>
-            <a:effectRef idx="0">
-              <a:schemeClr val="accent1"/>
-            </a:effectRef>
-            <a:fontRef idx="minor">
-              <a:schemeClr val="tx1"/>
-            </a:fontRef>
-          </p:style>
-          <p:txBody>
-            <a:bodyPr/>
-            <a:lstStyle/>
-            <a:p>
-              <a:endParaRPr lang="de-CH"/>
-            </a:p>
-          </p:txBody>
-        </p:sp>
-      </p:grpSp>
-      <p:grpSp>
-        <p:nvGrpSpPr>
-          <p:cNvPr id="71" name="Gruppe Vector Database">
-            <a:extLst>
-              <a:ext uri="{FF2B5EF4-FFF2-40B4-BE49-F238E27FC236}">
-                <a16:creationId xmlns:a16="http://schemas.microsoft.com/office/drawing/2014/main" id="{B98C4647-36F1-433C-634F-DF32A373D759}"/>
-              </a:ext>
-            </a:extLst>
-          </p:cNvPr>
-          <p:cNvGrpSpPr/>
-          <p:nvPr/>
-        </p:nvGrpSpPr>
-        <p:grpSpPr>
-          <a:xfrm>
-            <a:off x="5041715" y="2776165"/>
-            <a:ext cx="1368000" cy="867600"/>
-            <a:chOff x="5041715" y="2776165"/>
-            <a:chExt cx="1368000" cy="867600"/>
-          </a:xfrm>
-        </p:grpSpPr>
-        <p:sp>
-          <p:nvSpPr>
-            <p:cNvPr id="73" name="Rechteck: abgerundete Ecken 72">
-              <a:extLst>
-                <a:ext uri="{FF2B5EF4-FFF2-40B4-BE49-F238E27FC236}">
-                  <a16:creationId xmlns:a16="http://schemas.microsoft.com/office/drawing/2014/main" id="{3E9D7813-18D0-AF4A-8AE8-061A242CC2EA}"/>
-                </a:ext>
-              </a:extLst>
-            </p:cNvPr>
-            <p:cNvSpPr>
-              <a:spLocks/>
-            </p:cNvSpPr>
-            <p:nvPr/>
-          </p:nvSpPr>
-          <p:spPr>
-            <a:xfrm>
-              <a:off x="5041715" y="2776165"/>
-              <a:ext cx="1368000" cy="867600"/>
-            </a:xfrm>
-            <a:prstGeom prst="roundRect">
-              <a:avLst/>
-            </a:prstGeom>
-            <a:solidFill>
-              <a:schemeClr val="bg2"/>
-            </a:solidFill>
-            <a:ln>
-              <a:solidFill>
-                <a:schemeClr val="tx2"/>
-              </a:solidFill>
-            </a:ln>
-          </p:spPr>
-          <p:style>
-            <a:lnRef idx="2">
-              <a:schemeClr val="accent1">
-                <a:shade val="15000"/>
-              </a:schemeClr>
-            </a:lnRef>
-            <a:fillRef idx="1">
-              <a:schemeClr val="accent1"/>
-            </a:fillRef>
-            <a:effectRef idx="0">
-              <a:schemeClr val="accent1"/>
-            </a:effectRef>
-            <a:fontRef idx="minor">
-              <a:schemeClr val="lt1"/>
-            </a:fontRef>
-          </p:style>
-          <p:txBody>
-            <a:bodyPr anchor="ctr"/>
-            <a:lstStyle/>
-            <a:p>
-              <a:pPr algn="ctr">
-                <a:buNone/>
-              </a:pPr>
-              <a:endParaRPr/>
-            </a:p>
-          </p:txBody>
-        </p:sp>
-        <p:pic>
-          <p:nvPicPr>
-            <p:cNvPr id="75" name="Grafik 14">
-              <a:extLst>
-                <a:ext uri="{FF2B5EF4-FFF2-40B4-BE49-F238E27FC236}">
-                  <a16:creationId xmlns:a16="http://schemas.microsoft.com/office/drawing/2014/main" id="{EABA32D5-430E-BA1F-7CFD-BF324A4D963B}"/>
-                </a:ext>
-              </a:extLst>
-            </p:cNvPr>
-            <p:cNvPicPr>
-              <a:picLocks noChangeAspect="1"/>
-            </p:cNvPicPr>
-            <p:nvPr/>
-          </p:nvPicPr>
-          <p:blipFill>
-            <a:blip r:embed="rId9"/>
-            <a:stretch>
-              <a:fillRect/>
-            </a:stretch>
-          </p:blipFill>
-          <p:spPr>
-            <a:xfrm flipH="1">
-              <a:off x="5445714" y="3112571"/>
-              <a:ext cx="560002" cy="485980"/>
-            </a:xfrm>
-            <a:prstGeom prst="rect">
-              <a:avLst/>
-            </a:prstGeom>
-          </p:spPr>
-        </p:pic>
-        <p:sp>
-          <p:nvSpPr>
-            <p:cNvPr id="76" name="Textfeld 25">
-              <a:extLst>
-                <a:ext uri="{FF2B5EF4-FFF2-40B4-BE49-F238E27FC236}">
-                  <a16:creationId xmlns:a16="http://schemas.microsoft.com/office/drawing/2014/main" id="{CE061EE7-7B86-3DDE-1040-660336EDF0E6}"/>
-                </a:ext>
-              </a:extLst>
-            </p:cNvPr>
-            <p:cNvSpPr>
-              <a:spLocks/>
-            </p:cNvSpPr>
-            <p:nvPr/>
-          </p:nvSpPr>
-          <p:spPr>
-            <a:xfrm>
-              <a:off x="5041715" y="2794844"/>
-              <a:ext cx="1368000" cy="285750"/>
-            </a:xfrm>
-            <a:prstGeom prst="rect">
-              <a:avLst/>
-            </a:prstGeom>
-            <a:noFill/>
-          </p:spPr>
-          <p:txBody>
-            <a:bodyPr wrap="square">
-              <a:spAutoFit/>
-            </a:bodyPr>
-            <a:lstStyle/>
-            <a:p>
-              <a:pPr algn="ctr">
-                <a:buNone/>
-              </a:pPr>
-              <a:r>
-                <a:rPr lang="de-CH" sz="1200" dirty="0"/>
-                <a:t>Graph DB</a:t>
-              </a:r>
-              <a:endParaRPr sz="1200" dirty="0"/>
-            </a:p>
-          </p:txBody>
-        </p:sp>
-        <p:sp>
-          <p:nvSpPr>
-            <p:cNvPr id="78" name="Gerader Verbinder 77">
-              <a:extLst>
-                <a:ext uri="{FF2B5EF4-FFF2-40B4-BE49-F238E27FC236}">
-                  <a16:creationId xmlns:a16="http://schemas.microsoft.com/office/drawing/2014/main" id="{4E074795-CC90-4A5D-B6F0-1CD75A4E2F56}"/>
-                </a:ext>
-              </a:extLst>
-            </p:cNvPr>
-            <p:cNvSpPr>
-              <a:spLocks/>
-            </p:cNvSpPr>
-            <p:nvPr/>
-          </p:nvSpPr>
-          <p:spPr>
-            <a:xfrm>
-              <a:off x="5041715" y="3080594"/>
-              <a:ext cx="1368000" cy="0"/>
-            </a:xfrm>
-            <a:prstGeom prst="line">
-              <a:avLst/>
-            </a:prstGeom>
-            <a:ln>
-              <a:solidFill>
-                <a:schemeClr val="tx2"/>
-              </a:solidFill>
-            </a:ln>
-          </p:spPr>
-          <p:style>
-            <a:lnRef idx="1">
-              <a:schemeClr val="accent1"/>
-            </a:lnRef>
-            <a:fillRef idx="0">
-              <a:schemeClr val="accent1"/>
-            </a:fillRef>
-            <a:effectRef idx="0">
-              <a:schemeClr val="accent1"/>
-            </a:effectRef>
-            <a:fontRef idx="minor">
-              <a:schemeClr val="tx1"/>
-            </a:fontRef>
-          </p:style>
-          <p:txBody>
-            <a:bodyPr/>
-            <a:lstStyle/>
-            <a:p>
-              <a:endParaRPr lang="de-CH"/>
-            </a:p>
-          </p:txBody>
-        </p:sp>
-      </p:grpSp>
-      <p:cxnSp>
-        <p:nvCxnSpPr>
-          <p:cNvPr id="80" name="Gerade Verbindung mit Pfeil 116">
-            <a:extLst>
-              <a:ext uri="{FF2B5EF4-FFF2-40B4-BE49-F238E27FC236}">
-                <a16:creationId xmlns:a16="http://schemas.microsoft.com/office/drawing/2014/main" id="{E376D28E-420A-43B9-883A-3952BE9F2B5B}"/>
-              </a:ext>
-            </a:extLst>
-          </p:cNvPr>
-          <p:cNvCxnSpPr>
-            <a:cxnSpLocks/>
-            <a:stCxn id="37" idx="3"/>
-            <a:endCxn id="32" idx="1"/>
-          </p:cNvCxnSpPr>
-          <p:nvPr/>
-        </p:nvCxnSpPr>
-        <p:spPr>
-          <a:xfrm flipV="1">
-            <a:off x="2210508" y="3840734"/>
-            <a:ext cx="425808" cy="545115"/>
-          </a:xfrm>
-          <a:prstGeom prst="straightConnector1">
-            <a:avLst/>
-          </a:prstGeom>
-          <a:ln w="50800">
-            <a:solidFill>
-              <a:schemeClr val="tx1">
-                <a:alpha val="50000"/>
-              </a:schemeClr>
-            </a:solidFill>
-            <a:prstDash val="solid"/>
-            <a:tailEnd type="triangle"/>
-          </a:ln>
-        </p:spPr>
-        <p:style>
-          <a:lnRef idx="1">
-            <a:schemeClr val="accent1"/>
-          </a:lnRef>
-          <a:fillRef idx="0">
-            <a:schemeClr val="accent1"/>
-          </a:fillRef>
-          <a:effectRef idx="0">
-            <a:schemeClr val="accent1"/>
-          </a:effectRef>
-          <a:fontRef idx="minor">
-            <a:schemeClr val="tx1"/>
-          </a:fontRef>
-        </p:style>
-      </p:cxnSp>
-      <p:cxnSp>
-        <p:nvCxnSpPr>
-          <p:cNvPr id="85" name="Gerade Verbindung mit Pfeil 116">
-            <a:extLst>
-              <a:ext uri="{FF2B5EF4-FFF2-40B4-BE49-F238E27FC236}">
-                <a16:creationId xmlns:a16="http://schemas.microsoft.com/office/drawing/2014/main" id="{C59435DB-3B08-9D13-84B3-B8E6C33DF518}"/>
-              </a:ext>
-            </a:extLst>
-          </p:cNvPr>
-          <p:cNvCxnSpPr>
-            <a:cxnSpLocks/>
-            <a:stCxn id="32" idx="2"/>
-            <a:endCxn id="76" idx="0"/>
-          </p:cNvCxnSpPr>
-          <p:nvPr/>
-        </p:nvCxnSpPr>
-        <p:spPr>
-          <a:xfrm>
-            <a:off x="3503916" y="4274534"/>
-            <a:ext cx="0" cy="357082"/>
-          </a:xfrm>
-          <a:prstGeom prst="straightConnector1">
-            <a:avLst/>
-          </a:prstGeom>
-          <a:ln w="50800">
-            <a:solidFill>
-              <a:schemeClr val="tx1">
-                <a:alpha val="50000"/>
-              </a:schemeClr>
-            </a:solidFill>
-            <a:prstDash val="solid"/>
-            <a:tailEnd type="triangle"/>
-          </a:ln>
-        </p:spPr>
-        <p:style>
-          <a:lnRef idx="1">
-            <a:schemeClr val="accent1"/>
-          </a:lnRef>
-          <a:fillRef idx="0">
-            <a:schemeClr val="accent1"/>
-          </a:fillRef>
-          <a:effectRef idx="0">
-            <a:schemeClr val="accent1"/>
-          </a:effectRef>
-          <a:fontRef idx="minor">
-            <a:schemeClr val="tx1"/>
-          </a:fontRef>
-        </p:style>
-      </p:cxnSp>
-      <p:cxnSp>
-        <p:nvCxnSpPr>
-          <p:cNvPr id="91" name="Gerade Verbindung mit Pfeil 116">
-            <a:extLst>
-              <a:ext uri="{FF2B5EF4-FFF2-40B4-BE49-F238E27FC236}">
-                <a16:creationId xmlns:a16="http://schemas.microsoft.com/office/drawing/2014/main" id="{0936BFDE-4003-BDDE-5765-B85CD9CFFDEB}"/>
-              </a:ext>
-            </a:extLst>
-          </p:cNvPr>
-          <p:cNvCxnSpPr>
-            <a:cxnSpLocks/>
-            <a:stCxn id="73" idx="3"/>
-            <a:endCxn id="65" idx="1"/>
-          </p:cNvCxnSpPr>
-          <p:nvPr/>
-        </p:nvCxnSpPr>
-        <p:spPr>
-          <a:xfrm flipV="1">
-            <a:off x="4371516" y="4390973"/>
-            <a:ext cx="486599" cy="655764"/>
-          </a:xfrm>
-          <a:prstGeom prst="straightConnector1">
-            <a:avLst/>
-          </a:prstGeom>
-          <a:ln w="50800">
-            <a:solidFill>
-              <a:schemeClr val="tx1">
-                <a:alpha val="50000"/>
-              </a:schemeClr>
-            </a:solidFill>
-            <a:prstDash val="solid"/>
-            <a:tailEnd type="triangle"/>
-          </a:ln>
-        </p:spPr>
-        <p:style>
-          <a:lnRef idx="1">
-            <a:schemeClr val="accent1"/>
-          </a:lnRef>
-          <a:fillRef idx="0">
-            <a:schemeClr val="accent1"/>
-          </a:fillRef>
-          <a:effectRef idx="0">
-            <a:schemeClr val="accent1"/>
-          </a:effectRef>
-          <a:fontRef idx="minor">
-            <a:schemeClr val="tx1"/>
-          </a:fontRef>
-        </p:style>
-      </p:cxnSp>
     </p:spTree>
     <p:extLst>
       <p:ext uri="{BB962C8B-B14F-4D97-AF65-F5344CB8AC3E}">
@@ -41187,7 +40439,7 @@
                                 </p:cTn>
                               </p:par>
                               <p:par>
-                                <p:cTn id="117" presetID="1" presetClass="entr" presetSubtype="0" fill="hold" nodeType="withEffect">
+                                <p:cTn id="117" presetID="1" presetClass="entr" presetSubtype="0" fill="hold" grpId="0" nodeType="withEffect">
                                   <p:stCondLst>
                                     <p:cond delay="0"/>
                                   </p:stCondLst>
@@ -41200,7 +40452,7 @@
                                           </p:stCondLst>
                                         </p:cTn>
                                         <p:tgtEl>
-                                          <p:spTgt spid="24"/>
+                                          <p:spTgt spid="145"/>
                                         </p:tgtEl>
                                         <p:attrNameLst>
                                           <p:attrName>style.visibility</p:attrName>
@@ -41227,7 +40479,7 @@
                                           </p:stCondLst>
                                         </p:cTn>
                                         <p:tgtEl>
-                                          <p:spTgt spid="28"/>
+                                          <p:spTgt spid="24"/>
                                         </p:tgtEl>
                                         <p:attrNameLst>
                                           <p:attrName>style.visibility</p:attrName>
@@ -41254,52 +40506,7 @@
                                           </p:stCondLst>
                                         </p:cTn>
                                         <p:tgtEl>
-                                          <p:spTgt spid="31"/>
-                                        </p:tgtEl>
-                                        <p:attrNameLst>
-                                          <p:attrName>style.visibility</p:attrName>
-                                        </p:attrNameLst>
-                                      </p:cBhvr>
-                                      <p:to>
-                                        <p:strVal val="visible"/>
-                                      </p:to>
-                                    </p:set>
-                                  </p:childTnLst>
-                                </p:cTn>
-                              </p:par>
-                            </p:childTnLst>
-                          </p:cTn>
-                        </p:par>
-                      </p:childTnLst>
-                    </p:cTn>
-                  </p:par>
-                  <p:par>
-                    <p:cTn id="123" fill="hold">
-                      <p:stCondLst>
-                        <p:cond delay="indefinite"/>
-                      </p:stCondLst>
-                      <p:childTnLst>
-                        <p:par>
-                          <p:cTn id="124" fill="hold">
-                            <p:stCondLst>
-                              <p:cond delay="0"/>
-                            </p:stCondLst>
-                            <p:childTnLst>
-                              <p:par>
-                                <p:cTn id="125" presetID="1" presetClass="entr" presetSubtype="0" fill="hold" nodeType="clickEffect">
-                                  <p:stCondLst>
-                                    <p:cond delay="0"/>
-                                  </p:stCondLst>
-                                  <p:childTnLst>
-                                    <p:set>
-                                      <p:cBhvr>
-                                        <p:cTn id="126" dur="1" fill="hold">
-                                          <p:stCondLst>
-                                            <p:cond delay="0"/>
-                                          </p:stCondLst>
-                                        </p:cTn>
-                                        <p:tgtEl>
-                                          <p:spTgt spid="32"/>
+                                          <p:spTgt spid="28"/>
                                         </p:tgtEl>
                                         <p:attrNameLst>
                                           <p:attrName>style.visibility</p:attrName>
@@ -41313,299 +40520,20 @@
                                 </p:cTn>
                               </p:par>
                               <p:par>
-                                <p:cTn id="127" presetID="1" presetClass="entr" presetSubtype="0" fill="hold" nodeType="withEffect">
+                                <p:cTn id="123" presetID="1" presetClass="entr" presetSubtype="0" fill="hold" nodeType="withEffect">
                                   <p:stCondLst>
                                     <p:cond delay="0"/>
                                   </p:stCondLst>
                                   <p:childTnLst>
                                     <p:set>
                                       <p:cBhvr>
-                                        <p:cTn id="128" dur="1" fill="hold">
+                                        <p:cTn id="124" dur="1" fill="hold">
                                           <p:stCondLst>
                                             <p:cond delay="0"/>
                                           </p:stCondLst>
                                         </p:cTn>
                                         <p:tgtEl>
-                                          <p:spTgt spid="36"/>
-                                        </p:tgtEl>
-                                        <p:attrNameLst>
-                                          <p:attrName>style.visibility</p:attrName>
-                                        </p:attrNameLst>
-                                      </p:cBhvr>
-                                      <p:to>
-                                        <p:strVal val="visible"/>
-                                      </p:to>
-                                    </p:set>
-                                  </p:childTnLst>
-                                </p:cTn>
-                              </p:par>
-                              <p:par>
-                                <p:cTn id="129" presetID="1" presetClass="entr" presetSubtype="0" fill="hold" nodeType="withEffect">
-                                  <p:stCondLst>
-                                    <p:cond delay="0"/>
-                                  </p:stCondLst>
-                                  <p:childTnLst>
-                                    <p:set>
-                                      <p:cBhvr>
-                                        <p:cTn id="130" dur="1" fill="hold">
-                                          <p:stCondLst>
-                                            <p:cond delay="0"/>
-                                          </p:stCondLst>
-                                        </p:cTn>
-                                        <p:tgtEl>
-                                          <p:spTgt spid="35"/>
-                                        </p:tgtEl>
-                                        <p:attrNameLst>
-                                          <p:attrName>style.visibility</p:attrName>
-                                        </p:attrNameLst>
-                                      </p:cBhvr>
-                                      <p:to>
-                                        <p:strVal val="visible"/>
-                                      </p:to>
-                                    </p:set>
-                                  </p:childTnLst>
-                                </p:cTn>
-                              </p:par>
-                            </p:childTnLst>
-                          </p:cTn>
-                        </p:par>
-                      </p:childTnLst>
-                    </p:cTn>
-                  </p:par>
-                  <p:par>
-                    <p:cTn id="131" fill="hold">
-                      <p:stCondLst>
-                        <p:cond delay="indefinite"/>
-                      </p:stCondLst>
-                      <p:childTnLst>
-                        <p:par>
-                          <p:cTn id="132" fill="hold">
-                            <p:stCondLst>
-                              <p:cond delay="0"/>
-                            </p:stCondLst>
-                            <p:childTnLst>
-                              <p:par>
-                                <p:cTn id="133" presetID="1" presetClass="entr" presetSubtype="0" fill="hold" nodeType="clickEffect">
-                                  <p:stCondLst>
-                                    <p:cond delay="0"/>
-                                  </p:stCondLst>
-                                  <p:childTnLst>
-                                    <p:set>
-                                      <p:cBhvr>
-                                        <p:cTn id="134" dur="1" fill="hold">
-                                          <p:stCondLst>
-                                            <p:cond delay="0"/>
-                                          </p:stCondLst>
-                                        </p:cTn>
-                                        <p:tgtEl>
-                                          <p:spTgt spid="65"/>
-                                        </p:tgtEl>
-                                        <p:attrNameLst>
-                                          <p:attrName>style.visibility</p:attrName>
-                                        </p:attrNameLst>
-                                      </p:cBhvr>
-                                      <p:to>
-                                        <p:strVal val="visible"/>
-                                      </p:to>
-                                    </p:set>
-                                  </p:childTnLst>
-                                </p:cTn>
-                              </p:par>
-                              <p:par>
-                                <p:cTn id="135" presetID="1" presetClass="entr" presetSubtype="0" fill="hold" nodeType="withEffect">
-                                  <p:stCondLst>
-                                    <p:cond delay="0"/>
-                                  </p:stCondLst>
-                                  <p:childTnLst>
-                                    <p:set>
-                                      <p:cBhvr>
-                                        <p:cTn id="136" dur="1" fill="hold">
-                                          <p:stCondLst>
-                                            <p:cond delay="0"/>
-                                          </p:stCondLst>
-                                        </p:cTn>
-                                        <p:tgtEl>
-                                          <p:spTgt spid="66"/>
-                                        </p:tgtEl>
-                                        <p:attrNameLst>
-                                          <p:attrName>style.visibility</p:attrName>
-                                        </p:attrNameLst>
-                                      </p:cBhvr>
-                                      <p:to>
-                                        <p:strVal val="visible"/>
-                                      </p:to>
-                                    </p:set>
-                                  </p:childTnLst>
-                                </p:cTn>
-                              </p:par>
-                              <p:par>
-                                <p:cTn id="137" presetID="1" presetClass="entr" presetSubtype="0" fill="hold" nodeType="withEffect">
-                                  <p:stCondLst>
-                                    <p:cond delay="0"/>
-                                  </p:stCondLst>
-                                  <p:childTnLst>
-                                    <p:set>
-                                      <p:cBhvr>
-                                        <p:cTn id="138" dur="1" fill="hold">
-                                          <p:stCondLst>
-                                            <p:cond delay="0"/>
-                                          </p:stCondLst>
-                                        </p:cTn>
-                                        <p:tgtEl>
-                                          <p:spTgt spid="70"/>
-                                        </p:tgtEl>
-                                        <p:attrNameLst>
-                                          <p:attrName>style.visibility</p:attrName>
-                                        </p:attrNameLst>
-                                      </p:cBhvr>
-                                      <p:to>
-                                        <p:strVal val="visible"/>
-                                      </p:to>
-                                    </p:set>
-                                  </p:childTnLst>
-                                </p:cTn>
-                              </p:par>
-                              <p:par>
-                                <p:cTn id="139" presetID="1" presetClass="entr" presetSubtype="0" fill="hold" nodeType="withEffect">
-                                  <p:stCondLst>
-                                    <p:cond delay="0"/>
-                                  </p:stCondLst>
-                                  <p:childTnLst>
-                                    <p:set>
-                                      <p:cBhvr>
-                                        <p:cTn id="140" dur="1" fill="hold">
-                                          <p:stCondLst>
-                                            <p:cond delay="0"/>
-                                          </p:stCondLst>
-                                        </p:cTn>
-                                        <p:tgtEl>
-                                          <p:spTgt spid="68"/>
-                                        </p:tgtEl>
-                                        <p:attrNameLst>
-                                          <p:attrName>style.visibility</p:attrName>
-                                        </p:attrNameLst>
-                                      </p:cBhvr>
-                                      <p:to>
-                                        <p:strVal val="visible"/>
-                                      </p:to>
-                                    </p:set>
-                                  </p:childTnLst>
-                                </p:cTn>
-                              </p:par>
-                            </p:childTnLst>
-                          </p:cTn>
-                        </p:par>
-                      </p:childTnLst>
-                    </p:cTn>
-                  </p:par>
-                  <p:par>
-                    <p:cTn id="141" fill="hold">
-                      <p:stCondLst>
-                        <p:cond delay="indefinite"/>
-                      </p:stCondLst>
-                      <p:childTnLst>
-                        <p:par>
-                          <p:cTn id="142" fill="hold">
-                            <p:stCondLst>
-                              <p:cond delay="0"/>
-                            </p:stCondLst>
-                            <p:childTnLst>
-                              <p:par>
-                                <p:cTn id="143" presetID="1" presetClass="entr" presetSubtype="0" fill="hold" nodeType="clickEffect">
-                                  <p:stCondLst>
-                                    <p:cond delay="0"/>
-                                  </p:stCondLst>
-                                  <p:childTnLst>
-                                    <p:set>
-                                      <p:cBhvr>
-                                        <p:cTn id="144" dur="1" fill="hold">
-                                          <p:stCondLst>
-                                            <p:cond delay="0"/>
-                                          </p:stCondLst>
-                                        </p:cTn>
-                                        <p:tgtEl>
-                                          <p:spTgt spid="73"/>
-                                        </p:tgtEl>
-                                        <p:attrNameLst>
-                                          <p:attrName>style.visibility</p:attrName>
-                                        </p:attrNameLst>
-                                      </p:cBhvr>
-                                      <p:to>
-                                        <p:strVal val="visible"/>
-                                      </p:to>
-                                    </p:set>
-                                  </p:childTnLst>
-                                </p:cTn>
-                              </p:par>
-                              <p:par>
-                                <p:cTn id="145" presetID="1" presetClass="entr" presetSubtype="0" fill="hold" nodeType="withEffect">
-                                  <p:stCondLst>
-                                    <p:cond delay="0"/>
-                                  </p:stCondLst>
-                                  <p:childTnLst>
-                                    <p:set>
-                                      <p:cBhvr>
-                                        <p:cTn id="146" dur="1" fill="hold">
-                                          <p:stCondLst>
-                                            <p:cond delay="0"/>
-                                          </p:stCondLst>
-                                        </p:cTn>
-                                        <p:tgtEl>
-                                          <p:spTgt spid="75"/>
-                                        </p:tgtEl>
-                                        <p:attrNameLst>
-                                          <p:attrName>style.visibility</p:attrName>
-                                        </p:attrNameLst>
-                                      </p:cBhvr>
-                                      <p:to>
-                                        <p:strVal val="visible"/>
-                                      </p:to>
-                                    </p:set>
-                                  </p:childTnLst>
-                                </p:cTn>
-                              </p:par>
-                              <p:par>
-                                <p:cTn id="147" presetID="1" presetClass="entr" presetSubtype="0" fill="hold" nodeType="withEffect">
-                                  <p:stCondLst>
-                                    <p:cond delay="0"/>
-                                  </p:stCondLst>
-                                  <p:childTnLst>
-                                    <p:set>
-                                      <p:cBhvr>
-                                        <p:cTn id="148" dur="1" fill="hold">
-                                          <p:stCondLst>
-                                            <p:cond delay="0"/>
-                                          </p:stCondLst>
-                                        </p:cTn>
-                                        <p:tgtEl>
-                                          <p:spTgt spid="76"/>
-                                        </p:tgtEl>
-                                        <p:attrNameLst>
-                                          <p:attrName>style.visibility</p:attrName>
-                                        </p:attrNameLst>
-                                      </p:cBhvr>
-                                      <p:to>
-                                        <p:strVal val="visible"/>
-                                      </p:to>
-                                    </p:set>
-                                  </p:childTnLst>
-                                </p:cTn>
-                              </p:par>
-                              <p:par>
-                                <p:cTn id="149" presetID="1" presetClass="entr" presetSubtype="0" fill="hold" nodeType="withEffect">
-                                  <p:stCondLst>
-                                    <p:cond delay="0"/>
-                                  </p:stCondLst>
-                                  <p:childTnLst>
-                                    <p:set>
-                                      <p:cBhvr>
-                                        <p:cTn id="150" dur="1" fill="hold">
-                                          <p:stCondLst>
-                                            <p:cond delay="0"/>
-                                          </p:stCondLst>
-                                        </p:cTn>
-                                        <p:tgtEl>
-                                          <p:spTgt spid="78"/>
+                                          <p:spTgt spid="31"/>
                                         </p:tgtEl>
                                         <p:attrNameLst>
                                           <p:attrName>style.visibility</p:attrName>
@@ -41678,18 +40606,10 @@
       <p:bldP spid="137" grpId="0" animBg="1"/>
       <p:bldP spid="139" grpId="0"/>
       <p:bldP spid="140" grpId="0" animBg="1"/>
+      <p:bldP spid="145" grpId="0"/>
       <p:bldP spid="121" grpId="0" animBg="1"/>
       <p:bldP spid="123" grpId="0"/>
       <p:bldP spid="124" grpId="0" animBg="1"/>
-      <p:bldP spid="32" grpId="0" animBg="1"/>
-      <p:bldP spid="35" grpId="0"/>
-      <p:bldP spid="36" grpId="0" animBg="1"/>
-      <p:bldP spid="65" grpId="0" animBg="1"/>
-      <p:bldP spid="68" grpId="0"/>
-      <p:bldP spid="70" grpId="0" animBg="1"/>
-      <p:bldP spid="73" grpId="0" animBg="1"/>
-      <p:bldP spid="76" grpId="0"/>
-      <p:bldP spid="78" grpId="0" animBg="1"/>
     </p:bldLst>
   </p:timing>
 </p:sld>
@@ -44511,26 +43431,6 @@
 </file>
 
 <file path=customXml/item1.xml><?xml version="1.0" encoding="utf-8"?>
-<?mso-contentType ?>
-<FormTemplates xmlns="http://schemas.microsoft.com/sharepoint/v3/contenttype/forms">
-  <Display>DocumentLibraryForm</Display>
-  <Edit>DocumentLibraryForm</Edit>
-  <New>DocumentLibraryForm</New>
-</FormTemplates>
-</file>
-
-<file path=customXml/item2.xml><?xml version="1.0" encoding="utf-8"?>
-<p:properties xmlns:p="http://schemas.microsoft.com/office/2006/metadata/properties" xmlns:xsi="http://www.w3.org/2001/XMLSchema-instance" xmlns:pc="http://schemas.microsoft.com/office/infopath/2007/PartnerControls">
-  <documentManagement>
-    <lcf76f155ced4ddcb4097134ff3c332f xmlns="501edefc-5b9b-422a-9450-cf7f1f30e3fa">
-      <Terms xmlns="http://schemas.microsoft.com/office/infopath/2007/PartnerControls"/>
-    </lcf76f155ced4ddcb4097134ff3c332f>
-    <TaxCatchAll xmlns="3083c7a9-d95a-44c4-8fb8-f93b125494d6" xsi:nil="true"/>
-  </documentManagement>
-</p:properties>
-</file>
-
-<file path=customXml/item3.xml><?xml version="1.0" encoding="utf-8"?>
 <ct:contentTypeSchema xmlns:ct="http://schemas.microsoft.com/office/2006/metadata/contentType" xmlns:ma="http://schemas.microsoft.com/office/2006/metadata/properties/metaAttributes" ct:_="" ma:_="" ma:contentTypeName="Dokument" ma:contentTypeID="0x0101007D39DBAC6A50C74E998B9EB660A68B40" ma:contentTypeVersion="12" ma:contentTypeDescription="Ein neues Dokument erstellen." ma:contentTypeScope="" ma:versionID="34dc225a7d6106712b96f9699847575b">
   <xsd:schema xmlns:xsd="http://www.w3.org/2001/XMLSchema" xmlns:xs="http://www.w3.org/2001/XMLSchema" xmlns:p="http://schemas.microsoft.com/office/2006/metadata/properties" xmlns:ns2="501edefc-5b9b-422a-9450-cf7f1f30e3fa" xmlns:ns3="3083c7a9-d95a-44c4-8fb8-f93b125494d6" targetNamespace="http://schemas.microsoft.com/office/2006/metadata/properties" ma:root="true" ma:fieldsID="b7244162b0b071e6bfc5af2eca0d94d3" ns2:_="" ns3:_="">
     <xsd:import namespace="501edefc-5b9b-422a-9450-cf7f1f30e3fa"/>
@@ -44731,30 +43631,27 @@
 </ct:contentTypeSchema>
 </file>
 
-<file path=customXml/itemProps1.xml><?xml version="1.0" encoding="utf-8"?>
-<ds:datastoreItem xmlns:ds="http://schemas.openxmlformats.org/officeDocument/2006/customXml" ds:itemID="{334436CE-240F-4EE4-9FC5-4255E6874223}">
-  <ds:schemaRefs>
-    <ds:schemaRef ds:uri="http://schemas.microsoft.com/sharepoint/v3/contenttype/forms"/>
-  </ds:schemaRefs>
-</ds:datastoreItem>
+<file path=customXml/item2.xml><?xml version="1.0" encoding="utf-8"?>
+<?mso-contentType ?>
+<FormTemplates xmlns="http://schemas.microsoft.com/sharepoint/v3/contenttype/forms">
+  <Display>DocumentLibraryForm</Display>
+  <Edit>DocumentLibraryForm</Edit>
+  <New>DocumentLibraryForm</New>
+</FormTemplates>
 </file>
 
-<file path=customXml/itemProps2.xml><?xml version="1.0" encoding="utf-8"?>
-<ds:datastoreItem xmlns:ds="http://schemas.openxmlformats.org/officeDocument/2006/customXml" ds:itemID="{6302A1CC-4AEF-4830-BB1C-A446161EB02D}">
-  <ds:schemaRefs>
-    <ds:schemaRef ds:uri="http://schemas.microsoft.com/office/2006/metadata/properties"/>
-    <ds:schemaRef ds:uri="http://schemas.microsoft.com/office/infopath/2007/PartnerControls"/>
-    <ds:schemaRef ds:uri="7052a6c1-2dbf-49e9-b6e1-6fe4487af028"/>
-    <ds:schemaRef ds:uri="d8f140f0-05e7-48e3-ba8b-dcc0ff83b3dd"/>
-    <ds:schemaRef ds:uri="b22023f0-d141-4df7-85ad-6dd1e1377ec8"/>
-    <ds:schemaRef ds:uri="bf122554-6983-45b2-a605-6e185ba8cf82"/>
-    <ds:schemaRef ds:uri="501edefc-5b9b-422a-9450-cf7f1f30e3fa"/>
-    <ds:schemaRef ds:uri="3083c7a9-d95a-44c4-8fb8-f93b125494d6"/>
-  </ds:schemaRefs>
-</ds:datastoreItem>
+<file path=customXml/item3.xml><?xml version="1.0" encoding="utf-8"?>
+<p:properties xmlns:p="http://schemas.microsoft.com/office/2006/metadata/properties" xmlns:xsi="http://www.w3.org/2001/XMLSchema-instance" xmlns:pc="http://schemas.microsoft.com/office/infopath/2007/PartnerControls">
+  <documentManagement>
+    <lcf76f155ced4ddcb4097134ff3c332f xmlns="501edefc-5b9b-422a-9450-cf7f1f30e3fa">
+      <Terms xmlns="http://schemas.microsoft.com/office/infopath/2007/PartnerControls"/>
+    </lcf76f155ced4ddcb4097134ff3c332f>
+    <TaxCatchAll xmlns="3083c7a9-d95a-44c4-8fb8-f93b125494d6" xsi:nil="true"/>
+  </documentManagement>
+</p:properties>
 </file>
 
-<file path=customXml/itemProps3.xml><?xml version="1.0" encoding="utf-8"?>
+<file path=customXml/itemProps1.xml><?xml version="1.0" encoding="utf-8"?>
 <ds:datastoreItem xmlns:ds="http://schemas.openxmlformats.org/officeDocument/2006/customXml" ds:itemID="{42C8284C-7C61-4B35-A2FD-8E50AFE93672}">
   <ds:schemaRefs>
     <ds:schemaRef ds:uri="http://schemas.microsoft.com/office/2006/metadata/contentType"/>
@@ -44773,6 +43670,29 @@
 </ds:datastoreItem>
 </file>
 
+<file path=customXml/itemProps2.xml><?xml version="1.0" encoding="utf-8"?>
+<ds:datastoreItem xmlns:ds="http://schemas.openxmlformats.org/officeDocument/2006/customXml" ds:itemID="{334436CE-240F-4EE4-9FC5-4255E6874223}">
+  <ds:schemaRefs>
+    <ds:schemaRef ds:uri="http://schemas.microsoft.com/sharepoint/v3/contenttype/forms"/>
+  </ds:schemaRefs>
+</ds:datastoreItem>
+</file>
+
+<file path=customXml/itemProps3.xml><?xml version="1.0" encoding="utf-8"?>
+<ds:datastoreItem xmlns:ds="http://schemas.openxmlformats.org/officeDocument/2006/customXml" ds:itemID="{6302A1CC-4AEF-4830-BB1C-A446161EB02D}">
+  <ds:schemaRefs>
+    <ds:schemaRef ds:uri="http://schemas.microsoft.com/office/2006/metadata/properties"/>
+    <ds:schemaRef ds:uri="http://schemas.microsoft.com/office/infopath/2007/PartnerControls"/>
+    <ds:schemaRef ds:uri="7052a6c1-2dbf-49e9-b6e1-6fe4487af028"/>
+    <ds:schemaRef ds:uri="d8f140f0-05e7-48e3-ba8b-dcc0ff83b3dd"/>
+    <ds:schemaRef ds:uri="b22023f0-d141-4df7-85ad-6dd1e1377ec8"/>
+    <ds:schemaRef ds:uri="bf122554-6983-45b2-a605-6e185ba8cf82"/>
+    <ds:schemaRef ds:uri="501edefc-5b9b-422a-9450-cf7f1f30e3fa"/>
+    <ds:schemaRef ds:uri="3083c7a9-d95a-44c4-8fb8-f93b125494d6"/>
+  </ds:schemaRefs>
+</ds:datastoreItem>
+</file>
+
 <file path=docMetadata/LabelInfo.xml><?xml version="1.0" encoding="utf-8"?>
 <clbl:labelList xmlns:clbl="http://schemas.microsoft.com/office/2020/mipLabelMetadata">
   <clbl:label id="{42e461c6-591f-4920-9cf0-f1389542f8ad}" enabled="1" method="Standard" siteId="{2cda5d11-f0ac-46b3-967d-af1b2e1bd01a}" contentBits="2" removed="0"/>

</xml_diff>

<commit_message>
Rework slide-7 diagram boxes in PowerPoint
Co-Authored-By: Claude Fable 5 <noreply@anthropic.com>
Claude-Session: https://claude.ai/code/session_01S2kGP2buE2HmxMttD3XczR
</commit_message>
<xml_diff>
--- a/RAG_Workshop.pptx
+++ b/RAG_Workshop.pptx
@@ -36635,7 +36635,7 @@
                 <a:buNone/>
               </a:pPr>
               <a:r>
-                <a:rPr sz="1200"/>
+                <a:rPr sz="1200" dirty="0"/>
                 <a:t>Embedding</a:t>
               </a:r>
             </a:p>
@@ -36666,199 +36666,6 @@
             <a:ln>
               <a:solidFill>
                 <a:schemeClr val="accent3"/>
-              </a:solidFill>
-            </a:ln>
-          </p:spPr>
-          <p:style>
-            <a:lnRef idx="1">
-              <a:schemeClr val="accent1"/>
-            </a:lnRef>
-            <a:fillRef idx="0">
-              <a:schemeClr val="accent1"/>
-            </a:fillRef>
-            <a:effectRef idx="0">
-              <a:schemeClr val="accent1"/>
-            </a:effectRef>
-            <a:fontRef idx="minor">
-              <a:schemeClr val="tx1"/>
-            </a:fontRef>
-          </p:style>
-          <p:txBody>
-            <a:bodyPr/>
-            <a:lstStyle/>
-            <a:p>
-              <a:endParaRPr lang="de-CH"/>
-            </a:p>
-          </p:txBody>
-        </p:sp>
-      </p:grpSp>
-      <p:grpSp>
-        <p:nvGrpSpPr>
-          <p:cNvPr id="152" name="Gruppe Embedding"/>
-          <p:cNvGrpSpPr/>
-          <p:nvPr/>
-        </p:nvGrpSpPr>
-        <p:grpSpPr>
-          <a:xfrm>
-            <a:off x="7858490" y="2776165"/>
-            <a:ext cx="1735200" cy="879071"/>
-            <a:chOff x="7858490" y="2776165"/>
-            <a:chExt cx="1735200" cy="879071"/>
-          </a:xfrm>
-        </p:grpSpPr>
-        <p:sp>
-          <p:nvSpPr>
-            <p:cNvPr id="60" name="Rechteck: abgerundete Ecken 59">
-              <a:extLst>
-                <a:ext uri="{FF2B5EF4-FFF2-40B4-BE49-F238E27FC236}">
-                  <a16:creationId xmlns:a16="http://schemas.microsoft.com/office/drawing/2014/main" id="{0F97695A-AB9E-12B2-E874-0BCD324FB8A7}"/>
-                </a:ext>
-              </a:extLst>
-            </p:cNvPr>
-            <p:cNvSpPr>
-              <a:spLocks/>
-            </p:cNvSpPr>
-            <p:nvPr/>
-          </p:nvSpPr>
-          <p:spPr>
-            <a:xfrm>
-              <a:off x="7858490" y="2776165"/>
-              <a:ext cx="1735200" cy="867600"/>
-            </a:xfrm>
-            <a:prstGeom prst="roundRect">
-              <a:avLst/>
-            </a:prstGeom>
-            <a:solidFill>
-              <a:schemeClr val="bg2"/>
-            </a:solidFill>
-            <a:ln>
-              <a:solidFill>
-                <a:schemeClr val="tx2"/>
-              </a:solidFill>
-            </a:ln>
-          </p:spPr>
-          <p:style>
-            <a:lnRef idx="2">
-              <a:schemeClr val="accent1">
-                <a:shade val="15000"/>
-              </a:schemeClr>
-            </a:lnRef>
-            <a:fillRef idx="1">
-              <a:schemeClr val="accent1"/>
-            </a:fillRef>
-            <a:effectRef idx="0">
-              <a:schemeClr val="accent1"/>
-            </a:effectRef>
-            <a:fontRef idx="minor">
-              <a:schemeClr val="lt1"/>
-            </a:fontRef>
-          </p:style>
-          <p:txBody>
-            <a:bodyPr anchor="ctr"/>
-            <a:lstStyle/>
-            <a:p>
-              <a:pPr algn="ctr">
-                <a:buNone/>
-              </a:pPr>
-              <a:endParaRPr/>
-            </a:p>
-          </p:txBody>
-        </p:sp>
-        <p:pic>
-          <p:nvPicPr>
-            <p:cNvPr id="63" name="Grafik 12">
-              <a:extLst>
-                <a:ext uri="{FF2B5EF4-FFF2-40B4-BE49-F238E27FC236}">
-                  <a16:creationId xmlns:a16="http://schemas.microsoft.com/office/drawing/2014/main" id="{E86CBA64-1F16-70AF-49B8-BA3DAF1F453E}"/>
-                </a:ext>
-              </a:extLst>
-            </p:cNvPr>
-            <p:cNvPicPr>
-              <a:picLocks noChangeAspect="1"/>
-            </p:cNvPicPr>
-            <p:nvPr/>
-          </p:nvPicPr>
-          <p:blipFill>
-            <a:blip r:embed="rId8"/>
-            <a:stretch>
-              <a:fillRect/>
-            </a:stretch>
-          </p:blipFill>
-          <p:spPr>
-            <a:xfrm flipH="1">
-              <a:off x="8455327" y="3084139"/>
-              <a:ext cx="541526" cy="571097"/>
-            </a:xfrm>
-            <a:prstGeom prst="rect">
-              <a:avLst/>
-            </a:prstGeom>
-          </p:spPr>
-        </p:pic>
-        <p:sp>
-          <p:nvSpPr>
-            <p:cNvPr id="67" name="Textfeld 31">
-              <a:extLst>
-                <a:ext uri="{FF2B5EF4-FFF2-40B4-BE49-F238E27FC236}">
-                  <a16:creationId xmlns:a16="http://schemas.microsoft.com/office/drawing/2014/main" id="{93602E7B-DC37-F2CD-0924-065EFB64C7BA}"/>
-                </a:ext>
-              </a:extLst>
-            </p:cNvPr>
-            <p:cNvSpPr>
-              <a:spLocks/>
-            </p:cNvSpPr>
-            <p:nvPr/>
-          </p:nvSpPr>
-          <p:spPr>
-            <a:xfrm>
-              <a:off x="7858490" y="2794844"/>
-              <a:ext cx="1735200" cy="276999"/>
-            </a:xfrm>
-            <a:prstGeom prst="rect">
-              <a:avLst/>
-            </a:prstGeom>
-            <a:noFill/>
-          </p:spPr>
-          <p:txBody>
-            <a:bodyPr wrap="square">
-              <a:spAutoFit/>
-            </a:bodyPr>
-            <a:lstStyle/>
-            <a:p>
-              <a:pPr algn="ctr">
-                <a:buNone/>
-              </a:pPr>
-              <a:r>
-                <a:rPr sz="1200"/>
-                <a:t>Embedding</a:t>
-              </a:r>
-            </a:p>
-          </p:txBody>
-        </p:sp>
-        <p:sp>
-          <p:nvSpPr>
-            <p:cNvPr id="69" name="Gerader Verbinder 68">
-              <a:extLst>
-                <a:ext uri="{FF2B5EF4-FFF2-40B4-BE49-F238E27FC236}">
-                  <a16:creationId xmlns:a16="http://schemas.microsoft.com/office/drawing/2014/main" id="{919036DE-C489-76A0-3FDD-88C13187B396}"/>
-                </a:ext>
-              </a:extLst>
-            </p:cNvPr>
-            <p:cNvSpPr>
-              <a:spLocks/>
-            </p:cNvSpPr>
-            <p:nvPr/>
-          </p:nvSpPr>
-          <p:spPr>
-            <a:xfrm flipV="1">
-              <a:off x="7858490" y="3071843"/>
-              <a:ext cx="1735200" cy="0"/>
-            </a:xfrm>
-            <a:prstGeom prst="line">
-              <a:avLst/>
-            </a:prstGeom>
-            <a:ln>
-              <a:solidFill>
-                <a:schemeClr val="tx2"/>
               </a:solidFill>
             </a:ln>
           </p:spPr>
@@ -37469,16 +37276,22 @@
       </p:grpSp>
       <p:grpSp>
         <p:nvGrpSpPr>
-          <p:cNvPr id="156" name="Gruppe LLM"/>
+          <p:cNvPr id="27" name="Gruppieren 26">
+            <a:extLst>
+              <a:ext uri="{FF2B5EF4-FFF2-40B4-BE49-F238E27FC236}">
+                <a16:creationId xmlns:a16="http://schemas.microsoft.com/office/drawing/2014/main" id="{CC8957DA-7EEF-07E6-4817-4A1CAB29C56A}"/>
+              </a:ext>
+            </a:extLst>
+          </p:cNvPr>
           <p:cNvGrpSpPr/>
           <p:nvPr/>
         </p:nvGrpSpPr>
         <p:grpSpPr>
           <a:xfrm>
             <a:off x="7858490" y="5161353"/>
-            <a:ext cx="1735200" cy="889358"/>
+            <a:ext cx="1735200" cy="867600"/>
             <a:chOff x="7858490" y="5161353"/>
-            <a:chExt cx="1735200" cy="889358"/>
+            <a:chExt cx="1735200" cy="867600"/>
           </a:xfrm>
         </p:grpSpPr>
         <p:sp>
@@ -37507,11 +37320,12 @@
               <a:schemeClr val="accent6">
                 <a:lumMod val="40000"/>
                 <a:lumOff val="60000"/>
+                <a:alpha val="50000"/>
               </a:schemeClr>
             </a:solidFill>
             <a:ln>
               <a:solidFill>
-                <a:schemeClr val="tx2"/>
+                <a:srgbClr val="FFC000"/>
               </a:solidFill>
             </a:ln>
           </p:spPr>
@@ -37532,13 +37346,29 @@
             </a:fontRef>
           </p:style>
           <p:txBody>
-            <a:bodyPr anchor="ctr"/>
+            <a:bodyPr tIns="28800" anchor="t"/>
             <a:lstStyle/>
             <a:p>
               <a:pPr algn="ctr">
                 <a:buNone/>
               </a:pPr>
-              <a:endParaRPr/>
+              <a:r>
+                <a:rPr lang="de-CH" sz="1200" dirty="0">
+                  <a:solidFill>
+                    <a:schemeClr val="bg2">
+                      <a:lumMod val="10000"/>
+                    </a:schemeClr>
+                  </a:solidFill>
+                </a:rPr>
+                <a:t>LLM</a:t>
+              </a:r>
+              <a:endParaRPr sz="1200" dirty="0">
+                <a:solidFill>
+                  <a:schemeClr val="bg2">
+                    <a:lumMod val="10000"/>
+                  </a:schemeClr>
+                </a:solidFill>
+              </a:endParaRPr>
             </a:p>
           </p:txBody>
         </p:sp>
@@ -37564,62 +37394,14 @@
           </p:blipFill>
           <p:spPr>
             <a:xfrm flipH="1">
-              <a:off x="8433628" y="5457031"/>
-              <a:ext cx="584924" cy="593680"/>
+              <a:off x="8498425" y="5496779"/>
+              <a:ext cx="461098" cy="468000"/>
             </a:xfrm>
             <a:prstGeom prst="rect">
               <a:avLst/>
             </a:prstGeom>
           </p:spPr>
         </p:pic>
-        <p:sp>
-          <p:nvSpPr>
-            <p:cNvPr id="105" name="Textfeld 37">
-              <a:extLst>
-                <a:ext uri="{FF2B5EF4-FFF2-40B4-BE49-F238E27FC236}">
-                  <a16:creationId xmlns:a16="http://schemas.microsoft.com/office/drawing/2014/main" id="{50BD9ACB-9327-9657-F19C-720F9C5F935E}"/>
-                </a:ext>
-              </a:extLst>
-            </p:cNvPr>
-            <p:cNvSpPr>
-              <a:spLocks/>
-            </p:cNvSpPr>
-            <p:nvPr/>
-          </p:nvSpPr>
-          <p:spPr>
-            <a:xfrm>
-              <a:off x="7858490" y="5207333"/>
-              <a:ext cx="1735200" cy="276999"/>
-            </a:xfrm>
-            <a:prstGeom prst="rect">
-              <a:avLst/>
-            </a:prstGeom>
-            <a:solidFill>
-              <a:schemeClr val="accent6">
-                <a:lumMod val="40000"/>
-                <a:lumOff val="60000"/>
-              </a:schemeClr>
-            </a:solidFill>
-            <a:ln>
-              <a:noFill/>
-            </a:ln>
-          </p:spPr>
-          <p:txBody>
-            <a:bodyPr wrap="square">
-              <a:spAutoFit/>
-            </a:bodyPr>
-            <a:lstStyle/>
-            <a:p>
-              <a:pPr algn="ctr">
-                <a:buNone/>
-              </a:pPr>
-              <a:r>
-                <a:rPr sz="1200"/>
-                <a:t>LLM</a:t>
-              </a:r>
-            </a:p>
-          </p:txBody>
-        </p:sp>
         <p:sp>
           <p:nvSpPr>
             <p:cNvPr id="106" name="Gerader Verbinder 105">
@@ -37644,7 +37426,7 @@
             </a:prstGeom>
             <a:ln>
               <a:solidFill>
-                <a:schemeClr val="tx2"/>
+                <a:srgbClr val="FA9400"/>
               </a:solidFill>
             </a:ln>
           </p:spPr>
@@ -37911,6 +37693,7 @@
             </a:extLst>
           </p:cNvPr>
           <p:cNvCxnSpPr>
+            <a:cxnSpLocks/>
             <a:stCxn id="81" idx="3"/>
             <a:endCxn id="102" idx="1"/>
           </p:cNvCxnSpPr>
@@ -37918,8 +37701,8 @@
         </p:nvCxnSpPr>
         <p:spPr>
           <a:xfrm>
-            <a:off x="6355555" y="5595567"/>
-            <a:ext cx="1740695" cy="0"/>
+            <a:off x="6593315" y="5595153"/>
+            <a:ext cx="1265175" cy="0"/>
           </a:xfrm>
           <a:prstGeom prst="straightConnector1">
             <a:avLst/>
@@ -37959,13 +37742,13 @@
             </a:extLst>
           </p:cNvPr>
           <p:cNvCxnSpPr>
-            <a:endCxn id="24" idx="0"/>
+            <a:cxnSpLocks/>
           </p:cNvCxnSpPr>
           <p:nvPr/>
         </p:nvCxnSpPr>
         <p:spPr>
           <a:xfrm flipV="1">
-            <a:off x="7969527" y="5162179"/>
+            <a:off x="7969527" y="5098014"/>
             <a:ext cx="2947313" cy="882620"/>
           </a:xfrm>
           <a:prstGeom prst="straightConnector1">
@@ -38002,15 +37785,16 @@
             </a:extLst>
           </p:cNvPr>
           <p:cNvCxnSpPr>
-            <a:stCxn id="60" idx="1"/>
+            <a:cxnSpLocks/>
+            <a:stCxn id="32" idx="1"/>
             <a:endCxn id="72" idx="3"/>
           </p:cNvCxnSpPr>
           <p:nvPr/>
         </p:nvCxnSpPr>
         <p:spPr>
-          <a:xfrm flipH="1">
-            <a:off x="6716161" y="3210379"/>
-            <a:ext cx="1380089" cy="0"/>
+          <a:xfrm flipH="1" flipV="1">
+            <a:off x="6593315" y="3209965"/>
+            <a:ext cx="1265175" cy="18364"/>
           </a:xfrm>
           <a:prstGeom prst="straightConnector1">
             <a:avLst/>
@@ -38135,8 +37919,8 @@
             </a:extLst>
           </p:cNvPr>
           <p:cNvCxnSpPr>
+            <a:cxnSpLocks/>
             <a:stCxn id="18" idx="1"/>
-            <a:endCxn id="60" idx="3"/>
           </p:cNvCxnSpPr>
           <p:nvPr/>
         </p:nvCxnSpPr>
@@ -38187,8 +37971,8 @@
         </p:nvCxnSpPr>
         <p:spPr>
           <a:xfrm>
-            <a:off x="1967744" y="2005013"/>
-            <a:ext cx="1097319" cy="0"/>
+            <a:off x="2205504" y="2004599"/>
+            <a:ext cx="430812" cy="0"/>
           </a:xfrm>
           <a:prstGeom prst="straightConnector1">
             <a:avLst/>
@@ -38414,42 +38198,6 @@
           </p:txBody>
         </p:sp>
       </p:grpSp>
-      <p:sp>
-        <p:nvSpPr>
-          <p:cNvPr id="145" name="Textfeld 144">
-            <a:extLst>
-              <a:ext uri="{FF2B5EF4-FFF2-40B4-BE49-F238E27FC236}">
-                <a16:creationId xmlns:a16="http://schemas.microsoft.com/office/drawing/2014/main" id="{8C156430-C202-53BD-8023-A0D5C9A9CCB0}"/>
-              </a:ext>
-            </a:extLst>
-          </p:cNvPr>
-          <p:cNvSpPr txBox="1"/>
-          <p:nvPr/>
-        </p:nvSpPr>
-        <p:spPr>
-          <a:xfrm>
-            <a:off x="6838721" y="5342499"/>
-            <a:ext cx="922500" cy="276999"/>
-          </a:xfrm>
-          <a:prstGeom prst="rect">
-            <a:avLst/>
-          </a:prstGeom>
-          <a:noFill/>
-        </p:spPr>
-        <p:txBody>
-          <a:bodyPr wrap="square" rtlCol="0">
-            <a:spAutoFit/>
-          </a:bodyPr>
-          <a:lstStyle/>
-          <a:p>
-            <a:r>
-              <a:rPr lang="de-CH" sz="1200" dirty="0" err="1"/>
-              <a:t>Context</a:t>
-            </a:r>
-            <a:endParaRPr lang="de-CH" sz="1200" dirty="0"/>
-          </a:p>
-        </p:txBody>
-      </p:sp>
       <p:cxnSp>
         <p:nvCxnSpPr>
           <p:cNvPr id="7" name="Gerade Verbindung mit Pfeil 175">
@@ -38468,8 +38216,8 @@
         </p:nvCxnSpPr>
         <p:spPr>
           <a:xfrm>
-            <a:off x="4324743" y="2005013"/>
-            <a:ext cx="1172789" cy="7284"/>
+            <a:off x="4371516" y="2004599"/>
+            <a:ext cx="490128" cy="7284"/>
           </a:xfrm>
           <a:prstGeom prst="straightConnector1">
             <a:avLst/>
@@ -38517,8 +38265,8 @@
         </p:nvCxnSpPr>
         <p:spPr>
           <a:xfrm>
-            <a:off x="9355930" y="5595567"/>
-            <a:ext cx="931070" cy="0"/>
+            <a:off x="9593690" y="5595153"/>
+            <a:ext cx="455550" cy="0"/>
           </a:xfrm>
           <a:prstGeom prst="straightConnector1">
             <a:avLst/>
@@ -38615,8 +38363,8 @@
         </p:nvCxnSpPr>
         <p:spPr>
           <a:xfrm flipH="1">
-            <a:off x="9114211" y="2005013"/>
-            <a:ext cx="1172789" cy="0"/>
+            <a:off x="9583642" y="2004599"/>
+            <a:ext cx="465598" cy="0"/>
           </a:xfrm>
           <a:prstGeom prst="straightConnector1">
             <a:avLst/>
@@ -38658,14 +38406,14 @@
           <p:cNvCxnSpPr>
             <a:cxnSpLocks/>
             <a:stCxn id="96" idx="2"/>
-            <a:endCxn id="67" idx="0"/>
+            <a:endCxn id="32" idx="0"/>
           </p:cNvCxnSpPr>
           <p:nvPr/>
         </p:nvCxnSpPr>
         <p:spPr>
           <a:xfrm>
-            <a:off x="8484371" y="2435034"/>
-            <a:ext cx="229098" cy="360636"/>
+            <a:off x="8716042" y="2434208"/>
+            <a:ext cx="10048" cy="360321"/>
           </a:xfrm>
           <a:prstGeom prst="straightConnector1">
             <a:avLst/>
@@ -38706,15 +38454,14 @@
           </p:cNvPr>
           <p:cNvCxnSpPr>
             <a:cxnSpLocks/>
-            <a:stCxn id="56" idx="2"/>
             <a:endCxn id="72" idx="0"/>
           </p:cNvCxnSpPr>
           <p:nvPr/>
         </p:nvCxnSpPr>
         <p:spPr>
-          <a:xfrm flipH="1">
-            <a:off x="6086321" y="2427045"/>
-            <a:ext cx="41051" cy="349946"/>
+          <a:xfrm>
+            <a:off x="5713094" y="2445683"/>
+            <a:ext cx="12621" cy="330482"/>
           </a:xfrm>
           <a:prstGeom prst="straightConnector1">
             <a:avLst/>
@@ -38761,9 +38508,9 @@
           <p:nvPr/>
         </p:nvCxnSpPr>
         <p:spPr>
-          <a:xfrm flipH="1">
-            <a:off x="5713094" y="3643767"/>
-            <a:ext cx="373227" cy="1537091"/>
+          <a:xfrm>
+            <a:off x="5725715" y="3642941"/>
+            <a:ext cx="0" cy="1537091"/>
           </a:xfrm>
           <a:prstGeom prst="straightConnector1">
             <a:avLst/>
@@ -38960,6 +38707,192 @@
             <a:ln>
               <a:solidFill>
                 <a:schemeClr val="accent3"/>
+              </a:solidFill>
+            </a:ln>
+          </p:spPr>
+          <p:style>
+            <a:lnRef idx="1">
+              <a:schemeClr val="accent1"/>
+            </a:lnRef>
+            <a:fillRef idx="0">
+              <a:schemeClr val="accent1"/>
+            </a:fillRef>
+            <a:effectRef idx="0">
+              <a:schemeClr val="accent1"/>
+            </a:effectRef>
+            <a:fontRef idx="minor">
+              <a:schemeClr val="tx1"/>
+            </a:fontRef>
+          </p:style>
+          <p:txBody>
+            <a:bodyPr/>
+            <a:lstStyle/>
+            <a:p>
+              <a:endParaRPr lang="de-CH"/>
+            </a:p>
+          </p:txBody>
+        </p:sp>
+      </p:grpSp>
+      <p:grpSp>
+        <p:nvGrpSpPr>
+          <p:cNvPr id="29" name="Gruppieren 28">
+            <a:extLst>
+              <a:ext uri="{FF2B5EF4-FFF2-40B4-BE49-F238E27FC236}">
+                <a16:creationId xmlns:a16="http://schemas.microsoft.com/office/drawing/2014/main" id="{7E49CBB9-D26E-EAFB-D6EA-C3D737912938}"/>
+              </a:ext>
+            </a:extLst>
+          </p:cNvPr>
+          <p:cNvGrpSpPr/>
+          <p:nvPr/>
+        </p:nvGrpSpPr>
+        <p:grpSpPr>
+          <a:xfrm>
+            <a:off x="7858490" y="2794529"/>
+            <a:ext cx="1735200" cy="867600"/>
+            <a:chOff x="7858490" y="5161353"/>
+            <a:chExt cx="1735200" cy="867600"/>
+          </a:xfrm>
+        </p:grpSpPr>
+        <p:sp>
+          <p:nvSpPr>
+            <p:cNvPr id="32" name="Rechteck: abgerundete Ecken 31">
+              <a:extLst>
+                <a:ext uri="{FF2B5EF4-FFF2-40B4-BE49-F238E27FC236}">
+                  <a16:creationId xmlns:a16="http://schemas.microsoft.com/office/drawing/2014/main" id="{2A723AF4-EAB5-14C5-1FA0-86467149575A}"/>
+                </a:ext>
+              </a:extLst>
+            </p:cNvPr>
+            <p:cNvSpPr>
+              <a:spLocks/>
+            </p:cNvSpPr>
+            <p:nvPr/>
+          </p:nvSpPr>
+          <p:spPr>
+            <a:xfrm>
+              <a:off x="7858490" y="5161353"/>
+              <a:ext cx="1735200" cy="867600"/>
+            </a:xfrm>
+            <a:prstGeom prst="roundRect">
+              <a:avLst/>
+            </a:prstGeom>
+            <a:solidFill>
+              <a:schemeClr val="bg2">
+                <a:alpha val="50000"/>
+              </a:schemeClr>
+            </a:solidFill>
+            <a:ln>
+              <a:solidFill>
+                <a:schemeClr val="bg2">
+                  <a:lumMod val="50000"/>
+                </a:schemeClr>
+              </a:solidFill>
+            </a:ln>
+          </p:spPr>
+          <p:style>
+            <a:lnRef idx="2">
+              <a:schemeClr val="accent1">
+                <a:shade val="15000"/>
+              </a:schemeClr>
+            </a:lnRef>
+            <a:fillRef idx="1">
+              <a:schemeClr val="accent1"/>
+            </a:fillRef>
+            <a:effectRef idx="0">
+              <a:schemeClr val="accent1"/>
+            </a:effectRef>
+            <a:fontRef idx="minor">
+              <a:schemeClr val="lt1"/>
+            </a:fontRef>
+          </p:style>
+          <p:txBody>
+            <a:bodyPr tIns="28800" anchor="t"/>
+            <a:lstStyle/>
+            <a:p>
+              <a:pPr algn="ctr">
+                <a:buNone/>
+              </a:pPr>
+              <a:r>
+                <a:rPr lang="de-CH" sz="1200" dirty="0">
+                  <a:solidFill>
+                    <a:schemeClr val="bg2">
+                      <a:lumMod val="10000"/>
+                    </a:schemeClr>
+                  </a:solidFill>
+                </a:rPr>
+                <a:t>Embedding</a:t>
+              </a:r>
+              <a:endParaRPr sz="1200" dirty="0">
+                <a:solidFill>
+                  <a:schemeClr val="bg2">
+                    <a:lumMod val="10000"/>
+                  </a:schemeClr>
+                </a:solidFill>
+              </a:endParaRPr>
+            </a:p>
+          </p:txBody>
+        </p:sp>
+        <p:pic>
+          <p:nvPicPr>
+            <p:cNvPr id="33" name="Grafik 20">
+              <a:extLst>
+                <a:ext uri="{FF2B5EF4-FFF2-40B4-BE49-F238E27FC236}">
+                  <a16:creationId xmlns:a16="http://schemas.microsoft.com/office/drawing/2014/main" id="{91CCA1BF-A0BC-0AD7-2334-443BD9585B08}"/>
+                </a:ext>
+              </a:extLst>
+            </p:cNvPr>
+            <p:cNvPicPr>
+              <a:picLocks noChangeAspect="1"/>
+            </p:cNvPicPr>
+            <p:nvPr/>
+          </p:nvPicPr>
+          <p:blipFill>
+            <a:blip r:embed="rId13">
+              <a:extLst>
+                <a:ext uri="{28A0092B-C50C-407E-A947-70E740481C1C}">
+                  <a14:useLocalDpi xmlns:a14="http://schemas.microsoft.com/office/drawing/2010/main" val="0"/>
+                </a:ext>
+              </a:extLst>
+            </a:blip>
+            <a:srcRect/>
+            <a:stretch/>
+          </p:blipFill>
+          <p:spPr>
+            <a:xfrm flipH="1">
+              <a:off x="8507421" y="5496779"/>
+              <a:ext cx="468000" cy="494293"/>
+            </a:xfrm>
+            <a:prstGeom prst="rect">
+              <a:avLst/>
+            </a:prstGeom>
+          </p:spPr>
+        </p:pic>
+        <p:sp>
+          <p:nvSpPr>
+            <p:cNvPr id="35" name="Gerader Verbinder 34">
+              <a:extLst>
+                <a:ext uri="{FF2B5EF4-FFF2-40B4-BE49-F238E27FC236}">
+                  <a16:creationId xmlns:a16="http://schemas.microsoft.com/office/drawing/2014/main" id="{D8883587-3324-32F7-891A-2B743485D887}"/>
+                </a:ext>
+              </a:extLst>
+            </p:cNvPr>
+            <p:cNvSpPr>
+              <a:spLocks/>
+            </p:cNvSpPr>
+            <p:nvPr/>
+          </p:nvSpPr>
+          <p:spPr>
+            <a:xfrm flipV="1">
+              <a:off x="7858490" y="5449914"/>
+              <a:ext cx="1735200" cy="0"/>
+            </a:xfrm>
+            <a:prstGeom prst="line">
+              <a:avLst/>
+            </a:prstGeom>
+            <a:ln>
+              <a:solidFill>
+                <a:schemeClr val="bg2">
+                  <a:lumMod val="50000"/>
+                </a:schemeClr>
               </a:solidFill>
             </a:ln>
           </p:spPr>
@@ -40065,7 +39998,7 @@
                                           </p:stCondLst>
                                         </p:cTn>
                                         <p:tgtEl>
-                                          <p:spTgt spid="60"/>
+                                          <p:spTgt spid="81"/>
                                         </p:tgtEl>
                                         <p:attrNameLst>
                                           <p:attrName>style.visibility</p:attrName>
@@ -40092,7 +40025,7 @@
                                           </p:stCondLst>
                                         </p:cTn>
                                         <p:tgtEl>
-                                          <p:spTgt spid="63"/>
+                                          <p:spTgt spid="84"/>
                                         </p:tgtEl>
                                         <p:attrNameLst>
                                           <p:attrName>style.visibility</p:attrName>
@@ -40119,7 +40052,7 @@
                                           </p:stCondLst>
                                         </p:cTn>
                                         <p:tgtEl>
-                                          <p:spTgt spid="67"/>
+                                          <p:spTgt spid="87"/>
                                         </p:tgtEl>
                                         <p:attrNameLst>
                                           <p:attrName>style.visibility</p:attrName>
@@ -40146,7 +40079,7 @@
                                           </p:stCondLst>
                                         </p:cTn>
                                         <p:tgtEl>
-                                          <p:spTgt spid="69"/>
+                                          <p:spTgt spid="90"/>
                                         </p:tgtEl>
                                         <p:attrNameLst>
                                           <p:attrName>style.visibility</p:attrName>
@@ -40159,26 +40092,35 @@
                                   </p:childTnLst>
                                 </p:cTn>
                               </p:par>
-                            </p:childTnLst>
-                          </p:cTn>
-                        </p:par>
-                      </p:childTnLst>
-                    </p:cTn>
-                  </p:par>
-                  <p:par>
-                    <p:cTn id="95" fill="hold">
-                      <p:stCondLst>
-                        <p:cond delay="indefinite"/>
-                      </p:stCondLst>
-                      <p:childTnLst>
-                        <p:par>
-                          <p:cTn id="96" fill="hold">
-                            <p:stCondLst>
-                              <p:cond delay="0"/>
-                            </p:stCondLst>
-                            <p:childTnLst>
                               <p:par>
-                                <p:cTn id="97" presetID="1" presetClass="entr" presetSubtype="0" fill="hold" nodeType="clickEffect">
+                                <p:cTn id="95" presetID="1" presetClass="entr" presetSubtype="0" fill="hold" nodeType="withEffect">
+                                  <p:stCondLst>
+                                    <p:cond delay="0"/>
+                                  </p:stCondLst>
+                                  <p:childTnLst>
+                                    <p:set>
+                                      <p:cBhvr>
+                                        <p:cTn id="96" dur="1" fill="hold">
+                                          <p:stCondLst>
+                                            <p:cond delay="0"/>
+                                          </p:stCondLst>
+                                        </p:cTn>
+                                        <p:tgtEl>
+                                          <p:spTgt spid="111"/>
+                                        </p:tgtEl>
+                                        <p:attrNameLst>
+                                          <p:attrName>style.visibility</p:attrName>
+                                        </p:attrNameLst>
+                                      </p:cBhvr>
+                                      <p:to>
+                                        <p:strVal val="visible"/>
+                                      </p:to>
+                                    </p:set>
+                                  </p:childTnLst>
+                                </p:cTn>
+                              </p:par>
+                              <p:par>
+                                <p:cTn id="97" presetID="1" presetClass="entr" presetSubtype="0" fill="hold" nodeType="withEffect">
                                   <p:stCondLst>
                                     <p:cond delay="0"/>
                                   </p:stCondLst>
@@ -40191,7 +40133,7 @@
                                           </p:stCondLst>
                                         </p:cTn>
                                         <p:tgtEl>
-                                          <p:spTgt spid="81"/>
+                                          <p:spTgt spid="24"/>
                                         </p:tgtEl>
                                         <p:attrNameLst>
                                           <p:attrName>style.visibility</p:attrName>
@@ -40218,7 +40160,7 @@
                                           </p:stCondLst>
                                         </p:cTn>
                                         <p:tgtEl>
-                                          <p:spTgt spid="84"/>
+                                          <p:spTgt spid="28"/>
                                         </p:tgtEl>
                                         <p:attrNameLst>
                                           <p:attrName>style.visibility</p:attrName>
@@ -40240,294 +40182,6 @@
                                     <p:set>
                                       <p:cBhvr>
                                         <p:cTn id="102" dur="1" fill="hold">
-                                          <p:stCondLst>
-                                            <p:cond delay="0"/>
-                                          </p:stCondLst>
-                                        </p:cTn>
-                                        <p:tgtEl>
-                                          <p:spTgt spid="87"/>
-                                        </p:tgtEl>
-                                        <p:attrNameLst>
-                                          <p:attrName>style.visibility</p:attrName>
-                                        </p:attrNameLst>
-                                      </p:cBhvr>
-                                      <p:to>
-                                        <p:strVal val="visible"/>
-                                      </p:to>
-                                    </p:set>
-                                  </p:childTnLst>
-                                </p:cTn>
-                              </p:par>
-                              <p:par>
-                                <p:cTn id="103" presetID="1" presetClass="entr" presetSubtype="0" fill="hold" nodeType="withEffect">
-                                  <p:stCondLst>
-                                    <p:cond delay="0"/>
-                                  </p:stCondLst>
-                                  <p:childTnLst>
-                                    <p:set>
-                                      <p:cBhvr>
-                                        <p:cTn id="104" dur="1" fill="hold">
-                                          <p:stCondLst>
-                                            <p:cond delay="0"/>
-                                          </p:stCondLst>
-                                        </p:cTn>
-                                        <p:tgtEl>
-                                          <p:spTgt spid="90"/>
-                                        </p:tgtEl>
-                                        <p:attrNameLst>
-                                          <p:attrName>style.visibility</p:attrName>
-                                        </p:attrNameLst>
-                                      </p:cBhvr>
-                                      <p:to>
-                                        <p:strVal val="visible"/>
-                                      </p:to>
-                                    </p:set>
-                                  </p:childTnLst>
-                                </p:cTn>
-                              </p:par>
-                              <p:par>
-                                <p:cTn id="105" presetID="1" presetClass="entr" presetSubtype="0" fill="hold" nodeType="withEffect">
-                                  <p:stCondLst>
-                                    <p:cond delay="0"/>
-                                  </p:stCondLst>
-                                  <p:childTnLst>
-                                    <p:set>
-                                      <p:cBhvr>
-                                        <p:cTn id="106" dur="1" fill="hold">
-                                          <p:stCondLst>
-                                            <p:cond delay="0"/>
-                                          </p:stCondLst>
-                                        </p:cTn>
-                                        <p:tgtEl>
-                                          <p:spTgt spid="111"/>
-                                        </p:tgtEl>
-                                        <p:attrNameLst>
-                                          <p:attrName>style.visibility</p:attrName>
-                                        </p:attrNameLst>
-                                      </p:cBhvr>
-                                      <p:to>
-                                        <p:strVal val="visible"/>
-                                      </p:to>
-                                    </p:set>
-                                  </p:childTnLst>
-                                </p:cTn>
-                              </p:par>
-                            </p:childTnLst>
-                          </p:cTn>
-                        </p:par>
-                      </p:childTnLst>
-                    </p:cTn>
-                  </p:par>
-                  <p:par>
-                    <p:cTn id="107" fill="hold">
-                      <p:stCondLst>
-                        <p:cond delay="indefinite"/>
-                      </p:stCondLst>
-                      <p:childTnLst>
-                        <p:par>
-                          <p:cTn id="108" fill="hold">
-                            <p:stCondLst>
-                              <p:cond delay="0"/>
-                            </p:stCondLst>
-                            <p:childTnLst>
-                              <p:par>
-                                <p:cTn id="109" presetID="1" presetClass="entr" presetSubtype="0" fill="hold" nodeType="clickEffect">
-                                  <p:stCondLst>
-                                    <p:cond delay="0"/>
-                                  </p:stCondLst>
-                                  <p:childTnLst>
-                                    <p:set>
-                                      <p:cBhvr>
-                                        <p:cTn id="110" dur="1" fill="hold">
-                                          <p:stCondLst>
-                                            <p:cond delay="0"/>
-                                          </p:stCondLst>
-                                        </p:cTn>
-                                        <p:tgtEl>
-                                          <p:spTgt spid="102"/>
-                                        </p:tgtEl>
-                                        <p:attrNameLst>
-                                          <p:attrName>style.visibility</p:attrName>
-                                        </p:attrNameLst>
-                                      </p:cBhvr>
-                                      <p:to>
-                                        <p:strVal val="visible"/>
-                                      </p:to>
-                                    </p:set>
-                                  </p:childTnLst>
-                                </p:cTn>
-                              </p:par>
-                              <p:par>
-                                <p:cTn id="111" presetID="1" presetClass="entr" presetSubtype="0" fill="hold" nodeType="withEffect">
-                                  <p:stCondLst>
-                                    <p:cond delay="0"/>
-                                  </p:stCondLst>
-                                  <p:childTnLst>
-                                    <p:set>
-                                      <p:cBhvr>
-                                        <p:cTn id="112" dur="1" fill="hold">
-                                          <p:stCondLst>
-                                            <p:cond delay="0"/>
-                                          </p:stCondLst>
-                                        </p:cTn>
-                                        <p:tgtEl>
-                                          <p:spTgt spid="104"/>
-                                        </p:tgtEl>
-                                        <p:attrNameLst>
-                                          <p:attrName>style.visibility</p:attrName>
-                                        </p:attrNameLst>
-                                      </p:cBhvr>
-                                      <p:to>
-                                        <p:strVal val="visible"/>
-                                      </p:to>
-                                    </p:set>
-                                  </p:childTnLst>
-                                </p:cTn>
-                              </p:par>
-                              <p:par>
-                                <p:cTn id="113" presetID="1" presetClass="entr" presetSubtype="0" fill="hold" nodeType="withEffect">
-                                  <p:stCondLst>
-                                    <p:cond delay="0"/>
-                                  </p:stCondLst>
-                                  <p:childTnLst>
-                                    <p:set>
-                                      <p:cBhvr>
-                                        <p:cTn id="114" dur="1" fill="hold">
-                                          <p:stCondLst>
-                                            <p:cond delay="0"/>
-                                          </p:stCondLst>
-                                        </p:cTn>
-                                        <p:tgtEl>
-                                          <p:spTgt spid="105"/>
-                                        </p:tgtEl>
-                                        <p:attrNameLst>
-                                          <p:attrName>style.visibility</p:attrName>
-                                        </p:attrNameLst>
-                                      </p:cBhvr>
-                                      <p:to>
-                                        <p:strVal val="visible"/>
-                                      </p:to>
-                                    </p:set>
-                                  </p:childTnLst>
-                                </p:cTn>
-                              </p:par>
-                              <p:par>
-                                <p:cTn id="115" presetID="1" presetClass="entr" presetSubtype="0" fill="hold" nodeType="withEffect">
-                                  <p:stCondLst>
-                                    <p:cond delay="0"/>
-                                  </p:stCondLst>
-                                  <p:childTnLst>
-                                    <p:set>
-                                      <p:cBhvr>
-                                        <p:cTn id="116" dur="1" fill="hold">
-                                          <p:stCondLst>
-                                            <p:cond delay="0"/>
-                                          </p:stCondLst>
-                                        </p:cTn>
-                                        <p:tgtEl>
-                                          <p:spTgt spid="106"/>
-                                        </p:tgtEl>
-                                        <p:attrNameLst>
-                                          <p:attrName>style.visibility</p:attrName>
-                                        </p:attrNameLst>
-                                      </p:cBhvr>
-                                      <p:to>
-                                        <p:strVal val="visible"/>
-                                      </p:to>
-                                    </p:set>
-                                  </p:childTnLst>
-                                </p:cTn>
-                              </p:par>
-                              <p:par>
-                                <p:cTn id="117" presetID="1" presetClass="entr" presetSubtype="0" fill="hold" grpId="0" nodeType="withEffect">
-                                  <p:stCondLst>
-                                    <p:cond delay="0"/>
-                                  </p:stCondLst>
-                                  <p:childTnLst>
-                                    <p:set>
-                                      <p:cBhvr>
-                                        <p:cTn id="118" dur="1" fill="hold">
-                                          <p:stCondLst>
-                                            <p:cond delay="0"/>
-                                          </p:stCondLst>
-                                        </p:cTn>
-                                        <p:tgtEl>
-                                          <p:spTgt spid="145"/>
-                                        </p:tgtEl>
-                                        <p:attrNameLst>
-                                          <p:attrName>style.visibility</p:attrName>
-                                        </p:attrNameLst>
-                                      </p:cBhvr>
-                                      <p:to>
-                                        <p:strVal val="visible"/>
-                                      </p:to>
-                                    </p:set>
-                                  </p:childTnLst>
-                                </p:cTn>
-                              </p:par>
-                              <p:par>
-                                <p:cTn id="119" presetID="1" presetClass="entr" presetSubtype="0" fill="hold" nodeType="withEffect">
-                                  <p:stCondLst>
-                                    <p:cond delay="0"/>
-                                  </p:stCondLst>
-                                  <p:childTnLst>
-                                    <p:set>
-                                      <p:cBhvr>
-                                        <p:cTn id="120" dur="1" fill="hold">
-                                          <p:stCondLst>
-                                            <p:cond delay="0"/>
-                                          </p:stCondLst>
-                                        </p:cTn>
-                                        <p:tgtEl>
-                                          <p:spTgt spid="24"/>
-                                        </p:tgtEl>
-                                        <p:attrNameLst>
-                                          <p:attrName>style.visibility</p:attrName>
-                                        </p:attrNameLst>
-                                      </p:cBhvr>
-                                      <p:to>
-                                        <p:strVal val="visible"/>
-                                      </p:to>
-                                    </p:set>
-                                  </p:childTnLst>
-                                </p:cTn>
-                              </p:par>
-                              <p:par>
-                                <p:cTn id="121" presetID="1" presetClass="entr" presetSubtype="0" fill="hold" nodeType="withEffect">
-                                  <p:stCondLst>
-                                    <p:cond delay="0"/>
-                                  </p:stCondLst>
-                                  <p:childTnLst>
-                                    <p:set>
-                                      <p:cBhvr>
-                                        <p:cTn id="122" dur="1" fill="hold">
-                                          <p:stCondLst>
-                                            <p:cond delay="0"/>
-                                          </p:stCondLst>
-                                        </p:cTn>
-                                        <p:tgtEl>
-                                          <p:spTgt spid="28"/>
-                                        </p:tgtEl>
-                                        <p:attrNameLst>
-                                          <p:attrName>style.visibility</p:attrName>
-                                        </p:attrNameLst>
-                                      </p:cBhvr>
-                                      <p:to>
-                                        <p:strVal val="visible"/>
-                                      </p:to>
-                                    </p:set>
-                                  </p:childTnLst>
-                                </p:cTn>
-                              </p:par>
-                              <p:par>
-                                <p:cTn id="123" presetID="1" presetClass="entr" presetSubtype="0" fill="hold" nodeType="withEffect">
-                                  <p:stCondLst>
-                                    <p:cond delay="0"/>
-                                  </p:stCondLst>
-                                  <p:childTnLst>
-                                    <p:set>
-                                      <p:cBhvr>
-                                        <p:cTn id="124" dur="1" fill="hold">
                                           <p:stCondLst>
                                             <p:cond delay="0"/>
                                           </p:stCondLst>
@@ -40588,9 +40242,6 @@
       <p:bldP spid="54" grpId="0" animBg="1"/>
       <p:bldP spid="57" grpId="0"/>
       <p:bldP spid="58" grpId="0" animBg="1"/>
-      <p:bldP spid="60" grpId="0" animBg="1"/>
-      <p:bldP spid="67" grpId="0"/>
-      <p:bldP spid="69" grpId="0" animBg="1"/>
       <p:bldP spid="72" grpId="0" animBg="1"/>
       <p:bldP spid="77" grpId="0"/>
       <p:bldP spid="79" grpId="0" animBg="1"/>
@@ -40601,15 +40252,15 @@
       <p:bldP spid="99" grpId="0"/>
       <p:bldP spid="101" grpId="0" animBg="1"/>
       <p:bldP spid="102" grpId="0" animBg="1"/>
-      <p:bldP spid="105" grpId="0" animBg="1"/>
       <p:bldP spid="106" grpId="0" animBg="1"/>
       <p:bldP spid="137" grpId="0" animBg="1"/>
       <p:bldP spid="139" grpId="0"/>
       <p:bldP spid="140" grpId="0" animBg="1"/>
-      <p:bldP spid="145" grpId="0"/>
       <p:bldP spid="121" grpId="0" animBg="1"/>
       <p:bldP spid="123" grpId="0"/>
       <p:bldP spid="124" grpId="0" animBg="1"/>
+      <p:bldP spid="32" grpId="0" animBg="1"/>
+      <p:bldP spid="35" grpId="0" animBg="1"/>
     </p:bldLst>
   </p:timing>
 </p:sld>
@@ -43632,15 +43283,6 @@
 </file>
 
 <file path=customXml/item2.xml><?xml version="1.0" encoding="utf-8"?>
-<?mso-contentType ?>
-<FormTemplates xmlns="http://schemas.microsoft.com/sharepoint/v3/contenttype/forms">
-  <Display>DocumentLibraryForm</Display>
-  <Edit>DocumentLibraryForm</Edit>
-  <New>DocumentLibraryForm</New>
-</FormTemplates>
-</file>
-
-<file path=customXml/item3.xml><?xml version="1.0" encoding="utf-8"?>
 <p:properties xmlns:p="http://schemas.microsoft.com/office/2006/metadata/properties" xmlns:xsi="http://www.w3.org/2001/XMLSchema-instance" xmlns:pc="http://schemas.microsoft.com/office/infopath/2007/PartnerControls">
   <documentManagement>
     <lcf76f155ced4ddcb4097134ff3c332f xmlns="501edefc-5b9b-422a-9450-cf7f1f30e3fa">
@@ -43649,6 +43291,15 @@
     <TaxCatchAll xmlns="3083c7a9-d95a-44c4-8fb8-f93b125494d6" xsi:nil="true"/>
   </documentManagement>
 </p:properties>
+</file>
+
+<file path=customXml/item3.xml><?xml version="1.0" encoding="utf-8"?>
+<?mso-contentType ?>
+<FormTemplates xmlns="http://schemas.microsoft.com/sharepoint/v3/contenttype/forms">
+  <Display>DocumentLibraryForm</Display>
+  <Edit>DocumentLibraryForm</Edit>
+  <New>DocumentLibraryForm</New>
+</FormTemplates>
 </file>
 
 <file path=customXml/itemProps1.xml><?xml version="1.0" encoding="utf-8"?>
@@ -43671,14 +43322,6 @@
 </file>
 
 <file path=customXml/itemProps2.xml><?xml version="1.0" encoding="utf-8"?>
-<ds:datastoreItem xmlns:ds="http://schemas.openxmlformats.org/officeDocument/2006/customXml" ds:itemID="{334436CE-240F-4EE4-9FC5-4255E6874223}">
-  <ds:schemaRefs>
-    <ds:schemaRef ds:uri="http://schemas.microsoft.com/sharepoint/v3/contenttype/forms"/>
-  </ds:schemaRefs>
-</ds:datastoreItem>
-</file>
-
-<file path=customXml/itemProps3.xml><?xml version="1.0" encoding="utf-8"?>
 <ds:datastoreItem xmlns:ds="http://schemas.openxmlformats.org/officeDocument/2006/customXml" ds:itemID="{6302A1CC-4AEF-4830-BB1C-A446161EB02D}">
   <ds:schemaRefs>
     <ds:schemaRef ds:uri="http://schemas.microsoft.com/office/2006/metadata/properties"/>
@@ -43693,6 +43336,14 @@
 </ds:datastoreItem>
 </file>
 
+<file path=customXml/itemProps3.xml><?xml version="1.0" encoding="utf-8"?>
+<ds:datastoreItem xmlns:ds="http://schemas.openxmlformats.org/officeDocument/2006/customXml" ds:itemID="{334436CE-240F-4EE4-9FC5-4255E6874223}">
+  <ds:schemaRefs>
+    <ds:schemaRef ds:uri="http://schemas.microsoft.com/sharepoint/v3/contenttype/forms"/>
+  </ds:schemaRefs>
+</ds:datastoreItem>
+</file>
+
 <file path=docMetadata/LabelInfo.xml><?xml version="1.0" encoding="utf-8"?>
 <clbl:labelList xmlns:clbl="http://schemas.microsoft.com/office/2020/mipLabelMetadata">
   <clbl:label id="{42e461c6-591f-4920-9cf0-f1389542f8ad}" enabled="1" method="Standard" siteId="{2cda5d11-f0ac-46b3-967d-af1b2e1bd01a}" contentBits="2" removed="0"/>

</xml_diff>

<commit_message>
Restyle slide-7 boxes to new template and swap icons to SVG
All rounded boxes now follow the style of the two manually reworked
template groups: 50% transparent fill, hue-matched border and divider,
title moved into the box (12 pt, centred), separate text boxes removed.
Query and Response gained the divider they were missing. PNG icons are
replaced by the new SVG icons (with rendered PNG fallbacks) at
1.3 x 1.3 cm, horizontally centred. Animation timing nodes of the
removed text boxes are purged to keep the file valid for PowerPoint.

Co-Authored-By: Claude Fable 5 <noreply@anthropic.com>
Claude-Session: https://claude.ai/code/session_01S2kGP2buE2HmxMttD3XczR
</commit_message>
<xml_diff>
--- a/RAG_Workshop.pptx
+++ b/RAG_Workshop.pptx
@@ -35663,11 +35663,15 @@
               <a:avLst/>
             </a:prstGeom>
             <a:solidFill>
-              <a:schemeClr val="accent2"/>
+              <a:schemeClr val="accent2">
+                <a:alpha val="50000"/>
+              </a:schemeClr>
             </a:solidFill>
             <a:ln>
               <a:solidFill>
-                <a:schemeClr val="accent3"/>
+                <a:schemeClr val="accent2">
+                  <a:lumMod val="50000"/>
+                </a:schemeClr>
               </a:solidFill>
             </a:ln>
           </p:spPr>
@@ -35688,53 +35692,29 @@
             </a:fontRef>
           </p:style>
           <p:txBody>
-            <a:bodyPr anchor="ctr"/>
-            <a:lstStyle/>
-            <a:p>
-              <a:pPr algn="ctr">
-                <a:buNone/>
-              </a:pPr>
-              <a:endParaRPr/>
-            </a:p>
-          </p:txBody>
-        </p:sp>
-        <p:sp>
-          <p:nvSpPr>
-            <p:cNvPr id="12" name="Textfeld 74">
-              <a:extLst>
-                <a:ext uri="{FF2B5EF4-FFF2-40B4-BE49-F238E27FC236}">
-                  <a16:creationId xmlns:a16="http://schemas.microsoft.com/office/drawing/2014/main" id="{DECF3306-686E-CFF1-9A40-27FB67140A18}"/>
-                </a:ext>
-              </a:extLst>
-            </p:cNvPr>
-            <p:cNvSpPr>
-              <a:spLocks/>
-            </p:cNvSpPr>
-            <p:nvPr/>
-          </p:nvSpPr>
-          <p:spPr>
-            <a:xfrm>
-              <a:off x="476615" y="5161353"/>
-              <a:ext cx="1735200" cy="276999"/>
-            </a:xfrm>
-            <a:prstGeom prst="rect">
-              <a:avLst/>
-            </a:prstGeom>
-            <a:noFill/>
-          </p:spPr>
-          <p:txBody>
-            <a:bodyPr wrap="square">
-              <a:spAutoFit/>
-            </a:bodyPr>
+            <a:bodyPr tIns="28800" anchor="t"/>
             <a:lstStyle/>
             <a:p>
               <a:pPr algn="ctr">
                 <a:buNone/>
               </a:pPr>
               <a:r>
-                <a:rPr sz="1200"/>
+                <a:rPr lang="de-CH" sz="1200" dirty="0">
+                  <a:solidFill>
+                    <a:schemeClr val="bg2">
+                      <a:lumMod val="10000"/>
+                    </a:schemeClr>
+                  </a:solidFill>
+                </a:rPr>
                 <a:t>Raw Data Files</a:t>
               </a:r>
+              <a:endParaRPr sz="1200" dirty="0">
+                <a:solidFill>
+                  <a:schemeClr val="bg2">
+                    <a:lumMod val="10000"/>
+                  </a:schemeClr>
+                </a:solidFill>
+              </a:endParaRPr>
             </a:p>
           </p:txBody>
         </p:sp>
@@ -35754,7 +35734,7 @@
           </p:nvSpPr>
           <p:spPr>
             <a:xfrm>
-              <a:off x="476615" y="5438352"/>
+              <a:off x="476615" y="5431235"/>
               <a:ext cx="1735200" cy="0"/>
             </a:xfrm>
             <a:prstGeom prst="line">
@@ -35762,7 +35742,9 @@
             </a:prstGeom>
             <a:ln>
               <a:solidFill>
-                <a:schemeClr val="accent3"/>
+                <a:schemeClr val="accent2">
+                  <a:lumMod val="50000"/>
+                </a:schemeClr>
               </a:solidFill>
             </a:ln>
           </p:spPr>
@@ -35810,8 +35792,8 @@
           </p:blipFill>
           <p:spPr>
             <a:xfrm flipH="1">
-              <a:off x="1136680" y="5502557"/>
-              <a:ext cx="415070" cy="480063"/>
+              <a:off x="1141895" y="5478100"/>
+              <a:ext cx="404640" cy="468000"/>
             </a:xfrm>
             <a:prstGeom prst="rect">
               <a:avLst/>
@@ -35856,11 +35838,13 @@
               <a:avLst/>
             </a:prstGeom>
             <a:solidFill>
-              <a:schemeClr val="accent1"/>
+              <a:schemeClr val="accent1">
+                <a:alpha val="50000"/>
+              </a:schemeClr>
             </a:solidFill>
             <a:ln>
               <a:solidFill>
-                <a:schemeClr val="tx1"/>
+                <a:schemeClr val="accent1"/>
               </a:solidFill>
             </a:ln>
           </p:spPr>
@@ -35881,13 +35865,29 @@
             </a:fontRef>
           </p:style>
           <p:txBody>
-            <a:bodyPr anchor="ctr"/>
+            <a:bodyPr tIns="28800" anchor="t"/>
             <a:lstStyle/>
             <a:p>
               <a:pPr algn="ctr">
                 <a:buNone/>
               </a:pPr>
-              <a:endParaRPr/>
+              <a:r>
+                <a:rPr lang="de-CH" sz="1200" dirty="0">
+                  <a:solidFill>
+                    <a:schemeClr val="bg2">
+                      <a:lumMod val="10000"/>
+                    </a:schemeClr>
+                  </a:solidFill>
+                </a:rPr>
+                <a:t>Query</a:t>
+              </a:r>
+              <a:endParaRPr sz="1200" dirty="0">
+                <a:solidFill>
+                  <a:schemeClr val="bg2">
+                    <a:lumMod val="10000"/>
+                  </a:schemeClr>
+                </a:solidFill>
+              </a:endParaRPr>
             </a:p>
           </p:txBody>
         </p:sp>
@@ -35906,15 +35906,21 @@
             <p:nvPr/>
           </p:nvPicPr>
           <p:blipFill>
-            <a:blip r:embed="rId4"/>
+            <a:blip r:embed="rId14">
+              <a:extLst>
+                <a:ext uri="{96DAC541-7B7A-43D3-8B79-37D633B846F1}">
+                  <ns0:svgBlip xmlns:ns0="http://schemas.microsoft.com/office/drawing/2016/SVG/main" r:embed="rId15"/>
+                </a:ext>
+              </a:extLst>
+            </a:blip>
             <a:stretch>
               <a:fillRect/>
             </a:stretch>
           </p:blipFill>
           <p:spPr>
             <a:xfrm>
-              <a:off x="10611908" y="1866477"/>
-              <a:ext cx="609864" cy="566720"/>
+              <a:off x="10682840" y="1906225"/>
+              <a:ext cx="468000" cy="468000"/>
             </a:xfrm>
             <a:prstGeom prst="rect">
               <a:avLst/>
@@ -35923,45 +35929,45 @@
         </p:pic>
         <p:sp>
           <p:nvSpPr>
-            <p:cNvPr id="22" name="Textfeld 51">
-              <a:extLst>
-                <a:ext uri="{FF2B5EF4-FFF2-40B4-BE49-F238E27FC236}">
-                  <a16:creationId xmlns:a16="http://schemas.microsoft.com/office/drawing/2014/main" id="{E9B671B8-ADBD-7C77-A761-7D4C7F8DC77F}"/>
-                </a:ext>
-              </a:extLst>
-            </p:cNvPr>
+            <p:cNvPr id="159" name="Gerader Verbinder 159"/>
             <p:cNvSpPr>
               <a:spLocks/>
             </p:cNvSpPr>
             <p:nvPr/>
           </p:nvSpPr>
           <p:spPr>
-            <a:xfrm>
-              <a:off x="10049240" y="1589478"/>
-              <a:ext cx="1735200" cy="276999"/>
+            <a:xfrm flipV="1">
+              <a:off x="10049240" y="1859360"/>
+              <a:ext cx="1735200" cy="0"/>
             </a:xfrm>
-            <a:prstGeom prst="rect">
+            <a:prstGeom prst="line">
               <a:avLst/>
             </a:prstGeom>
-            <a:noFill/>
+            <a:ln>
+              <a:solidFill>
+                <a:schemeClr val="accent1"/>
+              </a:solidFill>
+            </a:ln>
           </p:spPr>
+          <p:style>
+            <a:lnRef idx="1">
+              <a:schemeClr val="accent1"/>
+            </a:lnRef>
+            <a:fillRef idx="0">
+              <a:schemeClr val="accent1"/>
+            </a:fillRef>
+            <a:effectRef idx="0">
+              <a:schemeClr val="accent1"/>
+            </a:effectRef>
+            <a:fontRef idx="minor">
+              <a:schemeClr val="tx1"/>
+            </a:fontRef>
+          </p:style>
           <p:txBody>
-            <a:bodyPr wrap="square">
-              <a:spAutoFit/>
-            </a:bodyPr>
+            <a:bodyPr/>
             <a:lstStyle/>
             <a:p>
-              <a:pPr algn="ctr">
-                <a:buNone/>
-              </a:pPr>
-              <a:r>
-                <a:rPr sz="1200">
-                  <a:solidFill>
-                    <a:schemeClr val="bg1"/>
-                  </a:solidFill>
-                </a:rPr>
-                <a:t>Query</a:t>
-              </a:r>
+              <a:endParaRPr lang="de-CH"/>
             </a:p>
           </p:txBody>
         </p:sp>
@@ -36003,11 +36009,13 @@
               <a:avLst/>
             </a:prstGeom>
             <a:solidFill>
-              <a:schemeClr val="accent5"/>
+              <a:schemeClr val="accent5">
+                <a:alpha val="50000"/>
+              </a:schemeClr>
             </a:solidFill>
             <a:ln>
               <a:solidFill>
-                <a:schemeClr val="tx1"/>
+                <a:schemeClr val="accent5"/>
               </a:solidFill>
             </a:ln>
           </p:spPr>
@@ -36028,13 +36036,29 @@
             </a:fontRef>
           </p:style>
           <p:txBody>
-            <a:bodyPr anchor="ctr"/>
+            <a:bodyPr tIns="28800" anchor="t"/>
             <a:lstStyle/>
             <a:p>
               <a:pPr algn="ctr">
                 <a:buNone/>
               </a:pPr>
-              <a:endParaRPr/>
+              <a:r>
+                <a:rPr lang="de-CH" sz="1200" dirty="0">
+                  <a:solidFill>
+                    <a:schemeClr val="bg2">
+                      <a:lumMod val="10000"/>
+                    </a:schemeClr>
+                  </a:solidFill>
+                </a:rPr>
+                <a:t>Response</a:t>
+              </a:r>
+              <a:endParaRPr sz="1200" dirty="0">
+                <a:solidFill>
+                  <a:schemeClr val="bg2">
+                    <a:lumMod val="10000"/>
+                  </a:schemeClr>
+                </a:solidFill>
+              </a:endParaRPr>
             </a:p>
           </p:txBody>
         </p:sp>
@@ -36053,15 +36077,21 @@
             <p:nvPr/>
           </p:nvPicPr>
           <p:blipFill>
-            <a:blip r:embed="rId5"/>
+            <a:blip r:embed="rId16">
+              <a:extLst>
+                <a:ext uri="{96DAC541-7B7A-43D3-8B79-37D633B846F1}">
+                  <ns1:svgBlip xmlns:ns1="http://schemas.microsoft.com/office/drawing/2016/SVG/main" r:embed="rId17"/>
+                </a:ext>
+              </a:extLst>
+            </a:blip>
             <a:stretch>
               <a:fillRect/>
             </a:stretch>
           </p:blipFill>
           <p:spPr>
-            <a:xfrm flipH="1">
-              <a:off x="10609408" y="5445025"/>
-              <a:ext cx="614864" cy="571508"/>
+            <a:xfrm>
+              <a:off x="10682840" y="5496779"/>
+              <a:ext cx="468000" cy="468000"/>
             </a:xfrm>
             <a:prstGeom prst="rect">
               <a:avLst/>
@@ -36070,45 +36100,45 @@
         </p:pic>
         <p:sp>
           <p:nvSpPr>
-            <p:cNvPr id="31" name="Textfeld 54">
-              <a:extLst>
-                <a:ext uri="{FF2B5EF4-FFF2-40B4-BE49-F238E27FC236}">
-                  <a16:creationId xmlns:a16="http://schemas.microsoft.com/office/drawing/2014/main" id="{D4C33B49-7891-AAA7-51F9-90B1FAAF4FA6}"/>
-                </a:ext>
-              </a:extLst>
-            </p:cNvPr>
+            <p:cNvPr id="160" name="Gerader Verbinder 160"/>
             <p:cNvSpPr>
               <a:spLocks/>
             </p:cNvSpPr>
             <p:nvPr/>
           </p:nvSpPr>
           <p:spPr>
-            <a:xfrm>
-              <a:off x="10049240" y="5180032"/>
-              <a:ext cx="1735200" cy="276999"/>
+            <a:xfrm flipV="1">
+              <a:off x="10049240" y="5449914"/>
+              <a:ext cx="1735200" cy="0"/>
             </a:xfrm>
-            <a:prstGeom prst="rect">
+            <a:prstGeom prst="line">
               <a:avLst/>
             </a:prstGeom>
-            <a:noFill/>
+            <a:ln>
+              <a:solidFill>
+                <a:schemeClr val="accent5"/>
+              </a:solidFill>
+            </a:ln>
           </p:spPr>
+          <p:style>
+            <a:lnRef idx="1">
+              <a:schemeClr val="accent1"/>
+            </a:lnRef>
+            <a:fillRef idx="0">
+              <a:schemeClr val="accent1"/>
+            </a:fillRef>
+            <a:effectRef idx="0">
+              <a:schemeClr val="accent1"/>
+            </a:effectRef>
+            <a:fontRef idx="minor">
+              <a:schemeClr val="tx1"/>
+            </a:fontRef>
+          </p:style>
           <p:txBody>
-            <a:bodyPr wrap="square">
-              <a:spAutoFit/>
-            </a:bodyPr>
+            <a:bodyPr/>
             <a:lstStyle/>
             <a:p>
-              <a:pPr algn="ctr">
-                <a:buNone/>
-              </a:pPr>
-              <a:r>
-                <a:rPr sz="1200">
-                  <a:solidFill>
-                    <a:schemeClr val="bg1"/>
-                  </a:solidFill>
-                </a:rPr>
-                <a:t>Response</a:t>
-              </a:r>
+              <a:endParaRPr lang="de-CH"/>
             </a:p>
           </p:txBody>
         </p:sp>
@@ -36150,11 +36180,15 @@
               <a:avLst/>
             </a:prstGeom>
             <a:solidFill>
-              <a:schemeClr val="accent2"/>
+              <a:schemeClr val="accent2">
+                <a:alpha val="50000"/>
+              </a:schemeClr>
             </a:solidFill>
             <a:ln>
               <a:solidFill>
-                <a:schemeClr val="accent3"/>
+                <a:schemeClr val="accent2">
+                  <a:lumMod val="50000"/>
+                </a:schemeClr>
               </a:solidFill>
             </a:ln>
           </p:spPr>
@@ -36175,13 +36209,29 @@
             </a:fontRef>
           </p:style>
           <p:txBody>
-            <a:bodyPr anchor="ctr"/>
+            <a:bodyPr tIns="28800" anchor="t"/>
             <a:lstStyle/>
             <a:p>
               <a:pPr algn="ctr">
                 <a:buNone/>
               </a:pPr>
-              <a:endParaRPr/>
+              <a:r>
+                <a:rPr lang="de-CH" sz="1200" dirty="0">
+                  <a:solidFill>
+                    <a:schemeClr val="bg2">
+                      <a:lumMod val="10000"/>
+                    </a:schemeClr>
+                  </a:solidFill>
+                </a:rPr>
+                <a:t>Information Extraction</a:t>
+              </a:r>
+              <a:endParaRPr sz="1200" dirty="0">
+                <a:solidFill>
+                  <a:schemeClr val="bg2">
+                    <a:lumMod val="10000"/>
+                  </a:schemeClr>
+                </a:solidFill>
+              </a:endParaRPr>
             </a:p>
           </p:txBody>
         </p:sp>
@@ -36200,61 +36250,27 @@
             <p:nvPr/>
           </p:nvPicPr>
           <p:blipFill>
-            <a:blip r:embed="rId6"/>
+            <a:blip r:embed="rId18">
+              <a:extLst>
+                <a:ext uri="{96DAC541-7B7A-43D3-8B79-37D633B846F1}">
+                  <ns2:svgBlip xmlns:ns2="http://schemas.microsoft.com/office/drawing/2016/SVG/main" r:embed="rId19"/>
+                </a:ext>
+              </a:extLst>
+            </a:blip>
             <a:stretch>
               <a:fillRect/>
             </a:stretch>
           </p:blipFill>
           <p:spPr>
-            <a:xfrm flipH="1">
-              <a:off x="1109228" y="4247727"/>
-              <a:ext cx="467360" cy="559581"/>
+            <a:xfrm>
+              <a:off x="1108908" y="4287475"/>
+              <a:ext cx="468000" cy="468000"/>
             </a:xfrm>
             <a:prstGeom prst="rect">
               <a:avLst/>
             </a:prstGeom>
           </p:spPr>
         </p:pic>
-        <p:sp>
-          <p:nvSpPr>
-            <p:cNvPr id="43" name="Textfeld 48">
-              <a:extLst>
-                <a:ext uri="{FF2B5EF4-FFF2-40B4-BE49-F238E27FC236}">
-                  <a16:creationId xmlns:a16="http://schemas.microsoft.com/office/drawing/2014/main" id="{2441BB71-C515-3F41-6A7B-CFE04B47BE00}"/>
-                </a:ext>
-              </a:extLst>
-            </p:cNvPr>
-            <p:cNvSpPr>
-              <a:spLocks/>
-            </p:cNvSpPr>
-            <p:nvPr/>
-          </p:nvSpPr>
-          <p:spPr>
-            <a:xfrm>
-              <a:off x="475308" y="3970728"/>
-              <a:ext cx="1735200" cy="276999"/>
-            </a:xfrm>
-            <a:prstGeom prst="rect">
-              <a:avLst/>
-            </a:prstGeom>
-            <a:noFill/>
-          </p:spPr>
-          <p:txBody>
-            <a:bodyPr wrap="square">
-              <a:spAutoFit/>
-            </a:bodyPr>
-            <a:lstStyle/>
-            <a:p>
-              <a:pPr algn="ctr">
-                <a:buNone/>
-              </a:pPr>
-              <a:r>
-                <a:rPr sz="1200"/>
-                <a:t>Information Extraction</a:t>
-              </a:r>
-            </a:p>
-          </p:txBody>
-        </p:sp>
         <p:sp>
           <p:nvSpPr>
             <p:cNvPr id="44" name="Gerader Verbinder 43">
@@ -36271,7 +36287,7 @@
           </p:nvSpPr>
           <p:spPr>
             <a:xfrm>
-              <a:off x="475308" y="4247727"/>
+              <a:off x="475308" y="4240610"/>
               <a:ext cx="1735200" cy="0"/>
             </a:xfrm>
             <a:prstGeom prst="line">
@@ -36279,7 +36295,9 @@
             </a:prstGeom>
             <a:ln>
               <a:solidFill>
-                <a:schemeClr val="accent3"/>
+                <a:schemeClr val="accent2">
+                  <a:lumMod val="50000"/>
+                </a:schemeClr>
               </a:solidFill>
             </a:ln>
           </p:spPr>
@@ -36343,11 +36361,15 @@
               <a:avLst/>
             </a:prstGeom>
             <a:solidFill>
-              <a:schemeClr val="accent2"/>
+              <a:schemeClr val="accent2">
+                <a:alpha val="50000"/>
+              </a:schemeClr>
             </a:solidFill>
             <a:ln>
               <a:solidFill>
-                <a:schemeClr val="accent3"/>
+                <a:schemeClr val="accent2">
+                  <a:lumMod val="50000"/>
+                </a:schemeClr>
               </a:solidFill>
             </a:ln>
           </p:spPr>
@@ -36368,53 +36390,29 @@
             </a:fontRef>
           </p:style>
           <p:txBody>
-            <a:bodyPr anchor="ctr"/>
-            <a:lstStyle/>
-            <a:p>
-              <a:pPr algn="ctr">
-                <a:buNone/>
-              </a:pPr>
-              <a:endParaRPr/>
-            </a:p>
-          </p:txBody>
-        </p:sp>
-        <p:sp>
-          <p:nvSpPr>
-            <p:cNvPr id="48" name="Textfeld 60">
-              <a:extLst>
-                <a:ext uri="{FF2B5EF4-FFF2-40B4-BE49-F238E27FC236}">
-                  <a16:creationId xmlns:a16="http://schemas.microsoft.com/office/drawing/2014/main" id="{9300C327-65D2-42BB-19E9-6CBA235D48A3}"/>
-                </a:ext>
-              </a:extLst>
-            </p:cNvPr>
-            <p:cNvSpPr>
-              <a:spLocks/>
-            </p:cNvSpPr>
-            <p:nvPr/>
-          </p:nvSpPr>
-          <p:spPr>
-            <a:xfrm>
-              <a:off x="476615" y="2780103"/>
-              <a:ext cx="1735200" cy="276999"/>
-            </a:xfrm>
-            <a:prstGeom prst="rect">
-              <a:avLst/>
-            </a:prstGeom>
-            <a:noFill/>
-          </p:spPr>
-          <p:txBody>
-            <a:bodyPr wrap="square">
-              <a:spAutoFit/>
-            </a:bodyPr>
+            <a:bodyPr tIns="28800" anchor="t"/>
             <a:lstStyle/>
             <a:p>
               <a:pPr algn="ctr">
                 <a:buNone/>
               </a:pPr>
               <a:r>
-                <a:rPr sz="1200"/>
+                <a:rPr lang="de-CH" sz="1200" dirty="0">
+                  <a:solidFill>
+                    <a:schemeClr val="bg2">
+                      <a:lumMod val="10000"/>
+                    </a:schemeClr>
+                  </a:solidFill>
+                </a:rPr>
                 <a:t>Chunking</a:t>
               </a:r>
+              <a:endParaRPr sz="1200" dirty="0">
+                <a:solidFill>
+                  <a:schemeClr val="bg2">
+                    <a:lumMod val="10000"/>
+                  </a:schemeClr>
+                </a:solidFill>
+              </a:endParaRPr>
             </a:p>
           </p:txBody>
         </p:sp>
@@ -36434,7 +36432,7 @@
           </p:nvSpPr>
           <p:spPr>
             <a:xfrm>
-              <a:off x="476615" y="3054078"/>
+              <a:off x="476615" y="3049985"/>
               <a:ext cx="1735200" cy="0"/>
             </a:xfrm>
             <a:prstGeom prst="line">
@@ -36442,7 +36440,9 @@
             </a:prstGeom>
             <a:ln>
               <a:solidFill>
-                <a:schemeClr val="accent3"/>
+                <a:schemeClr val="accent2">
+                  <a:lumMod val="50000"/>
+                </a:schemeClr>
               </a:solidFill>
             </a:ln>
           </p:spPr>
@@ -36483,15 +36483,21 @@
             <p:nvPr/>
           </p:nvPicPr>
           <p:blipFill>
-            <a:blip r:embed="rId7"/>
+            <a:blip r:embed="rId20">
+              <a:extLst>
+                <a:ext uri="{96DAC541-7B7A-43D3-8B79-37D633B846F1}">
+                  <ns3:svgBlip xmlns:ns3="http://schemas.microsoft.com/office/drawing/2016/SVG/main" r:embed="rId21"/>
+                </a:ext>
+              </a:extLst>
+            </a:blip>
             <a:stretch>
               <a:fillRect/>
             </a:stretch>
           </p:blipFill>
           <p:spPr>
             <a:xfrm>
-              <a:off x="1086582" y="3153285"/>
-              <a:ext cx="515265" cy="403725"/>
+              <a:off x="1110215" y="3096850"/>
+              <a:ext cx="468000" cy="468000"/>
             </a:xfrm>
             <a:prstGeom prst="rect">
               <a:avLst/>
@@ -36536,11 +36542,15 @@
               <a:avLst/>
             </a:prstGeom>
             <a:solidFill>
-              <a:schemeClr val="accent2"/>
+              <a:schemeClr val="accent2">
+                <a:alpha val="50000"/>
+              </a:schemeClr>
             </a:solidFill>
             <a:ln>
               <a:solidFill>
-                <a:schemeClr val="accent3"/>
+                <a:schemeClr val="accent2">
+                  <a:lumMod val="50000"/>
+                </a:schemeClr>
               </a:solidFill>
             </a:ln>
           </p:spPr>
@@ -36561,13 +36571,29 @@
             </a:fontRef>
           </p:style>
           <p:txBody>
-            <a:bodyPr anchor="ctr"/>
+            <a:bodyPr tIns="28800" anchor="t"/>
             <a:lstStyle/>
             <a:p>
               <a:pPr algn="ctr">
                 <a:buNone/>
               </a:pPr>
-              <a:endParaRPr/>
+              <a:r>
+                <a:rPr lang="de-CH" sz="1200" dirty="0">
+                  <a:solidFill>
+                    <a:schemeClr val="bg2">
+                      <a:lumMod val="10000"/>
+                    </a:schemeClr>
+                  </a:solidFill>
+                </a:rPr>
+                <a:t>Embedding</a:t>
+              </a:r>
+              <a:endParaRPr sz="1200" dirty="0">
+                <a:solidFill>
+                  <a:schemeClr val="bg2">
+                    <a:lumMod val="10000"/>
+                  </a:schemeClr>
+                </a:solidFill>
+              </a:endParaRPr>
             </a:p>
           </p:txBody>
         </p:sp>
@@ -36586,61 +36612,27 @@
             <p:nvPr/>
           </p:nvPicPr>
           <p:blipFill>
-            <a:blip r:embed="rId8"/>
+            <a:blip r:embed="rId22">
+              <a:extLst>
+                <a:ext uri="{96DAC541-7B7A-43D3-8B79-37D633B846F1}">
+                  <ns4:svgBlip xmlns:ns4="http://schemas.microsoft.com/office/drawing/2016/SVG/main" r:embed="rId23"/>
+                </a:ext>
+              </a:extLst>
+            </a:blip>
             <a:stretch>
               <a:fillRect/>
             </a:stretch>
           </p:blipFill>
           <p:spPr>
-            <a:xfrm flipH="1">
-              <a:off x="5487815" y="1916993"/>
-              <a:ext cx="482858" cy="509226"/>
+            <a:xfrm>
+              <a:off x="5495244" y="1913509"/>
+              <a:ext cx="468000" cy="468000"/>
             </a:xfrm>
             <a:prstGeom prst="rect">
               <a:avLst/>
             </a:prstGeom>
           </p:spPr>
         </p:pic>
-        <p:sp>
-          <p:nvSpPr>
-            <p:cNvPr id="57" name="Textfeld 34">
-              <a:extLst>
-                <a:ext uri="{FF2B5EF4-FFF2-40B4-BE49-F238E27FC236}">
-                  <a16:creationId xmlns:a16="http://schemas.microsoft.com/office/drawing/2014/main" id="{957FA4FE-DEF6-E882-2842-2649F9966023}"/>
-                </a:ext>
-              </a:extLst>
-            </p:cNvPr>
-            <p:cNvSpPr>
-              <a:spLocks/>
-            </p:cNvSpPr>
-            <p:nvPr/>
-          </p:nvSpPr>
-          <p:spPr>
-            <a:xfrm>
-              <a:off x="4861644" y="1596762"/>
-              <a:ext cx="1735200" cy="276999"/>
-            </a:xfrm>
-            <a:prstGeom prst="rect">
-              <a:avLst/>
-            </a:prstGeom>
-            <a:noFill/>
-          </p:spPr>
-          <p:txBody>
-            <a:bodyPr wrap="square">
-              <a:spAutoFit/>
-            </a:bodyPr>
-            <a:lstStyle/>
-            <a:p>
-              <a:pPr algn="ctr">
-                <a:buNone/>
-              </a:pPr>
-              <a:r>
-                <a:rPr sz="1200" dirty="0"/>
-                <a:t>Embedding</a:t>
-              </a:r>
-            </a:p>
-          </p:txBody>
-        </p:sp>
         <p:sp>
           <p:nvSpPr>
             <p:cNvPr id="58" name="Gerader Verbinder 57">
@@ -36657,7 +36649,7 @@
           </p:nvSpPr>
           <p:spPr>
             <a:xfrm flipV="1">
-              <a:off x="4861644" y="1873761"/>
+              <a:off x="4861644" y="1866644"/>
               <a:ext cx="1735200" cy="0"/>
             </a:xfrm>
             <a:prstGeom prst="line">
@@ -36665,7 +36657,9 @@
             </a:prstGeom>
             <a:ln>
               <a:solidFill>
-                <a:schemeClr val="accent3"/>
+                <a:schemeClr val="accent2">
+                  <a:lumMod val="50000"/>
+                </a:schemeClr>
               </a:solidFill>
             </a:ln>
           </p:spPr>
@@ -36729,11 +36723,15 @@
               <a:avLst/>
             </a:prstGeom>
             <a:solidFill>
-              <a:schemeClr val="bg2"/>
+              <a:schemeClr val="bg2">
+                <a:alpha val="50000"/>
+              </a:schemeClr>
             </a:solidFill>
             <a:ln>
               <a:solidFill>
-                <a:schemeClr val="tx2"/>
+                <a:schemeClr val="bg2">
+                  <a:lumMod val="50000"/>
+                </a:schemeClr>
               </a:solidFill>
             </a:ln>
           </p:spPr>
@@ -36754,13 +36752,29 @@
             </a:fontRef>
           </p:style>
           <p:txBody>
-            <a:bodyPr anchor="ctr"/>
+            <a:bodyPr tIns="28800" anchor="t"/>
             <a:lstStyle/>
             <a:p>
               <a:pPr algn="ctr">
                 <a:buNone/>
               </a:pPr>
-              <a:endParaRPr/>
+              <a:r>
+                <a:rPr lang="de-CH" sz="1200" dirty="0">
+                  <a:solidFill>
+                    <a:schemeClr val="bg2">
+                      <a:lumMod val="10000"/>
+                    </a:schemeClr>
+                  </a:solidFill>
+                </a:rPr>
+                <a:t>Vector Database</a:t>
+              </a:r>
+              <a:endParaRPr sz="1200" dirty="0">
+                <a:solidFill>
+                  <a:schemeClr val="bg2">
+                    <a:lumMod val="10000"/>
+                  </a:schemeClr>
+                </a:solidFill>
+              </a:endParaRPr>
             </a:p>
           </p:txBody>
         </p:sp>
@@ -36779,61 +36793,27 @@
             <p:nvPr/>
           </p:nvPicPr>
           <p:blipFill>
-            <a:blip r:embed="rId9"/>
+            <a:blip r:embed="rId24">
+              <a:extLst>
+                <a:ext uri="{96DAC541-7B7A-43D3-8B79-37D633B846F1}">
+                  <ns5:svgBlip xmlns:ns5="http://schemas.microsoft.com/office/drawing/2016/SVG/main" r:embed="rId25"/>
+                </a:ext>
+              </a:extLst>
+            </a:blip>
             <a:stretch>
               <a:fillRect/>
             </a:stretch>
           </p:blipFill>
           <p:spPr>
-            <a:xfrm flipH="1">
-              <a:off x="5445714" y="3156961"/>
-              <a:ext cx="560002" cy="485980"/>
+            <a:xfrm>
+              <a:off x="5491715" y="3111591"/>
+              <a:ext cx="468000" cy="468000"/>
             </a:xfrm>
             <a:prstGeom prst="rect">
               <a:avLst/>
             </a:prstGeom>
           </p:spPr>
         </p:pic>
-        <p:sp>
-          <p:nvSpPr>
-            <p:cNvPr id="77" name="Textfeld 25">
-              <a:extLst>
-                <a:ext uri="{FF2B5EF4-FFF2-40B4-BE49-F238E27FC236}">
-                  <a16:creationId xmlns:a16="http://schemas.microsoft.com/office/drawing/2014/main" id="{1C80D23E-AF36-ADDD-DF87-F60A5AC8096B}"/>
-                </a:ext>
-              </a:extLst>
-            </p:cNvPr>
-            <p:cNvSpPr>
-              <a:spLocks/>
-            </p:cNvSpPr>
-            <p:nvPr/>
-          </p:nvSpPr>
-          <p:spPr>
-            <a:xfrm>
-              <a:off x="4858115" y="2794844"/>
-              <a:ext cx="1735200" cy="285750"/>
-            </a:xfrm>
-            <a:prstGeom prst="rect">
-              <a:avLst/>
-            </a:prstGeom>
-            <a:noFill/>
-          </p:spPr>
-          <p:txBody>
-            <a:bodyPr wrap="square">
-              <a:spAutoFit/>
-            </a:bodyPr>
-            <a:lstStyle/>
-            <a:p>
-              <a:pPr algn="ctr">
-                <a:buNone/>
-              </a:pPr>
-              <a:r>
-                <a:rPr sz="1200" dirty="0"/>
-                <a:t>Vector Database</a:t>
-              </a:r>
-            </a:p>
-          </p:txBody>
-        </p:sp>
         <p:sp>
           <p:nvSpPr>
             <p:cNvPr id="79" name="Gerader Verbinder 78">
@@ -36850,7 +36830,7 @@
           </p:nvSpPr>
           <p:spPr>
             <a:xfrm>
-              <a:off x="4858115" y="3080594"/>
+              <a:off x="4858115" y="3064726"/>
               <a:ext cx="1735200" cy="0"/>
             </a:xfrm>
             <a:prstGeom prst="line">
@@ -36858,7 +36838,9 @@
             </a:prstGeom>
             <a:ln>
               <a:solidFill>
-                <a:schemeClr val="tx2"/>
+                <a:schemeClr val="bg2">
+                  <a:lumMod val="50000"/>
+                </a:schemeClr>
               </a:solidFill>
             </a:ln>
           </p:spPr>
@@ -36894,9 +36876,9 @@
         <p:grpSpPr>
           <a:xfrm>
             <a:off x="4858115" y="5161353"/>
-            <a:ext cx="1735200" cy="885454"/>
+            <a:ext cx="1735200" cy="867600"/>
             <a:chOff x="4858115" y="5161353"/>
-            <a:chExt cx="1735200" cy="885454"/>
+            <a:chExt cx="1735200" cy="867600"/>
           </a:xfrm>
         </p:grpSpPr>
         <p:sp>
@@ -36922,11 +36904,15 @@
               <a:avLst/>
             </a:prstGeom>
             <a:solidFill>
-              <a:schemeClr val="bg2"/>
+              <a:schemeClr val="bg2">
+                <a:alpha val="50000"/>
+              </a:schemeClr>
             </a:solidFill>
             <a:ln>
               <a:solidFill>
-                <a:schemeClr val="tx2"/>
+                <a:schemeClr val="bg2">
+                  <a:lumMod val="50000"/>
+                </a:schemeClr>
               </a:solidFill>
             </a:ln>
           </p:spPr>
@@ -36947,13 +36933,29 @@
             </a:fontRef>
           </p:style>
           <p:txBody>
-            <a:bodyPr anchor="ctr"/>
+            <a:bodyPr tIns="28800" anchor="t"/>
             <a:lstStyle/>
             <a:p>
               <a:pPr algn="ctr">
                 <a:buNone/>
               </a:pPr>
-              <a:endParaRPr/>
+              <a:r>
+                <a:rPr lang="de-CH" sz="1200" dirty="0">
+                  <a:solidFill>
+                    <a:schemeClr val="bg2">
+                      <a:lumMod val="10000"/>
+                    </a:schemeClr>
+                  </a:solidFill>
+                </a:rPr>
+                <a:t>Relevant Data</a:t>
+              </a:r>
+              <a:endParaRPr sz="1200" dirty="0">
+                <a:solidFill>
+                  <a:schemeClr val="bg2">
+                    <a:lumMod val="10000"/>
+                  </a:schemeClr>
+                </a:solidFill>
+              </a:endParaRPr>
             </a:p>
           </p:txBody>
         </p:sp>
@@ -36972,61 +36974,27 @@
             <p:nvPr/>
           </p:nvPicPr>
           <p:blipFill>
-            <a:blip r:embed="rId10"/>
+            <a:blip r:embed="rId26">
+              <a:extLst>
+                <a:ext uri="{96DAC541-7B7A-43D3-8B79-37D633B846F1}">
+                  <ns6:svgBlip xmlns:ns6="http://schemas.microsoft.com/office/drawing/2016/SVG/main" r:embed="rId27"/>
+                </a:ext>
+              </a:extLst>
+            </a:blip>
             <a:stretch>
               <a:fillRect/>
             </a:stretch>
           </p:blipFill>
           <p:spPr>
-            <a:xfrm flipH="1">
-              <a:off x="5378242" y="5428671"/>
-              <a:ext cx="694946" cy="618136"/>
+            <a:xfrm>
+              <a:off x="5491715" y="5496779"/>
+              <a:ext cx="468000" cy="468000"/>
             </a:xfrm>
             <a:prstGeom prst="rect">
               <a:avLst/>
             </a:prstGeom>
           </p:spPr>
         </p:pic>
-        <p:sp>
-          <p:nvSpPr>
-            <p:cNvPr id="87" name="Textfeld 28">
-              <a:extLst>
-                <a:ext uri="{FF2B5EF4-FFF2-40B4-BE49-F238E27FC236}">
-                  <a16:creationId xmlns:a16="http://schemas.microsoft.com/office/drawing/2014/main" id="{97FD2241-5B61-D9A8-9B5C-DE6B07A2BCBE}"/>
-                </a:ext>
-              </a:extLst>
-            </p:cNvPr>
-            <p:cNvSpPr>
-              <a:spLocks/>
-            </p:cNvSpPr>
-            <p:nvPr/>
-          </p:nvSpPr>
-          <p:spPr>
-            <a:xfrm>
-              <a:off x="4858115" y="5180032"/>
-              <a:ext cx="1735200" cy="276999"/>
-            </a:xfrm>
-            <a:prstGeom prst="rect">
-              <a:avLst/>
-            </a:prstGeom>
-            <a:noFill/>
-          </p:spPr>
-          <p:txBody>
-            <a:bodyPr wrap="square">
-              <a:spAutoFit/>
-            </a:bodyPr>
-            <a:lstStyle/>
-            <a:p>
-              <a:pPr algn="ctr">
-                <a:buNone/>
-              </a:pPr>
-              <a:r>
-                <a:rPr sz="1200"/>
-                <a:t>Relevant Data</a:t>
-              </a:r>
-            </a:p>
-          </p:txBody>
-        </p:sp>
         <p:sp>
           <p:nvSpPr>
             <p:cNvPr id="90" name="Gerader Verbinder 89">
@@ -37043,7 +37011,7 @@
           </p:nvSpPr>
           <p:spPr>
             <a:xfrm>
-              <a:off x="4858115" y="5457031"/>
+              <a:off x="4858115" y="5449914"/>
               <a:ext cx="1735200" cy="0"/>
             </a:xfrm>
             <a:prstGeom prst="line">
@@ -37051,7 +37019,9 @@
             </a:prstGeom>
             <a:ln>
               <a:solidFill>
-                <a:schemeClr val="tx2"/>
+                <a:schemeClr val="bg2">
+                  <a:lumMod val="50000"/>
+                </a:schemeClr>
               </a:solidFill>
             </a:ln>
           </p:spPr>
@@ -37118,11 +37088,12 @@
               <a:schemeClr val="accent6">
                 <a:lumMod val="40000"/>
                 <a:lumOff val="60000"/>
+                <a:alpha val="50000"/>
               </a:schemeClr>
             </a:solidFill>
             <a:ln>
               <a:solidFill>
-                <a:schemeClr val="tx2"/>
+                <a:srgbClr val="FFC000"/>
               </a:solidFill>
             </a:ln>
           </p:spPr>
@@ -37143,13 +37114,29 @@
             </a:fontRef>
           </p:style>
           <p:txBody>
-            <a:bodyPr anchor="ctr"/>
+            <a:bodyPr tIns="28800" anchor="t"/>
             <a:lstStyle/>
             <a:p>
               <a:pPr algn="ctr">
                 <a:buNone/>
               </a:pPr>
-              <a:endParaRPr/>
+              <a:r>
+                <a:rPr lang="de-CH" sz="1200" dirty="0">
+                  <a:solidFill>
+                    <a:schemeClr val="bg2">
+                      <a:lumMod val="10000"/>
+                    </a:schemeClr>
+                  </a:solidFill>
+                </a:rPr>
+                <a:t>Embedding LLM</a:t>
+              </a:r>
+              <a:endParaRPr sz="1200" dirty="0">
+                <a:solidFill>
+                  <a:schemeClr val="bg2">
+                    <a:lumMod val="10000"/>
+                  </a:schemeClr>
+                </a:solidFill>
+              </a:endParaRPr>
             </a:p>
           </p:txBody>
         </p:sp>
@@ -37168,61 +37155,27 @@
             <p:nvPr/>
           </p:nvPicPr>
           <p:blipFill>
-            <a:blip r:embed="rId11"/>
+            <a:blip r:embed="rId28">
+              <a:extLst>
+                <a:ext uri="{96DAC541-7B7A-43D3-8B79-37D633B846F1}">
+                  <ns7:svgBlip xmlns:ns7="http://schemas.microsoft.com/office/drawing/2016/SVG/main" r:embed="rId29"/>
+                </a:ext>
+              </a:extLst>
+            </a:blip>
             <a:stretch>
               <a:fillRect/>
             </a:stretch>
           </p:blipFill>
           <p:spPr>
-            <a:xfrm flipH="1">
-              <a:off x="8449146" y="1892426"/>
-              <a:ext cx="533792" cy="541782"/>
+            <a:xfrm>
+              <a:off x="8482042" y="1906225"/>
+              <a:ext cx="468000" cy="468000"/>
             </a:xfrm>
             <a:prstGeom prst="rect">
               <a:avLst/>
             </a:prstGeom>
           </p:spPr>
         </p:pic>
-        <p:sp>
-          <p:nvSpPr>
-            <p:cNvPr id="99" name="Textfeld 40">
-              <a:extLst>
-                <a:ext uri="{FF2B5EF4-FFF2-40B4-BE49-F238E27FC236}">
-                  <a16:creationId xmlns:a16="http://schemas.microsoft.com/office/drawing/2014/main" id="{39ADD9CF-0CDD-69E9-2A07-C125FCAA3B7D}"/>
-                </a:ext>
-              </a:extLst>
-            </p:cNvPr>
-            <p:cNvSpPr>
-              <a:spLocks/>
-            </p:cNvSpPr>
-            <p:nvPr/>
-          </p:nvSpPr>
-          <p:spPr>
-            <a:xfrm>
-              <a:off x="7848442" y="1570799"/>
-              <a:ext cx="1735200" cy="276999"/>
-            </a:xfrm>
-            <a:prstGeom prst="rect">
-              <a:avLst/>
-            </a:prstGeom>
-            <a:noFill/>
-          </p:spPr>
-          <p:txBody>
-            <a:bodyPr wrap="square">
-              <a:spAutoFit/>
-            </a:bodyPr>
-            <a:lstStyle/>
-            <a:p>
-              <a:pPr algn="ctr">
-                <a:buNone/>
-              </a:pPr>
-              <a:r>
-                <a:rPr sz="1200" dirty="0"/>
-                <a:t>Embedding LLM</a:t>
-              </a:r>
-            </a:p>
-          </p:txBody>
-        </p:sp>
         <p:sp>
           <p:nvSpPr>
             <p:cNvPr id="101" name="Gerader Verbinder 100">
@@ -37239,7 +37192,7 @@
           </p:nvSpPr>
           <p:spPr>
             <a:xfrm>
-              <a:off x="7848442" y="1854598"/>
+              <a:off x="7848442" y="1859360"/>
               <a:ext cx="1735200" cy="0"/>
             </a:xfrm>
             <a:prstGeom prst="line">
@@ -37247,7 +37200,7 @@
             </a:prstGeom>
             <a:ln>
               <a:solidFill>
-                <a:schemeClr val="tx2"/>
+                <a:srgbClr val="FA9400"/>
               </a:solidFill>
             </a:ln>
           </p:spPr>
@@ -37387,15 +37340,21 @@
             <p:nvPr/>
           </p:nvPicPr>
           <p:blipFill>
-            <a:blip r:embed="rId11"/>
+            <a:blip r:embed="rId30">
+              <a:extLst>
+                <a:ext uri="{96DAC541-7B7A-43D3-8B79-37D633B846F1}">
+                  <ns8:svgBlip xmlns:ns8="http://schemas.microsoft.com/office/drawing/2016/SVG/main" r:embed="rId31"/>
+                </a:ext>
+              </a:extLst>
+            </a:blip>
             <a:stretch>
               <a:fillRect/>
             </a:stretch>
           </p:blipFill>
           <p:spPr>
-            <a:xfrm flipH="1">
-              <a:off x="8498425" y="5496779"/>
-              <a:ext cx="461098" cy="468000"/>
+            <a:xfrm>
+              <a:off x="8492090" y="5496779"/>
+              <a:ext cx="468000" cy="468000"/>
             </a:xfrm>
             <a:prstGeom prst="rect">
               <a:avLst/>
@@ -38042,11 +38001,12 @@
               <a:schemeClr val="accent6">
                 <a:lumMod val="40000"/>
                 <a:lumOff val="60000"/>
+                <a:alpha val="50000"/>
               </a:schemeClr>
             </a:solidFill>
             <a:ln>
               <a:solidFill>
-                <a:schemeClr val="tx2"/>
+                <a:srgbClr val="FFC000"/>
               </a:solidFill>
             </a:ln>
           </p:spPr>
@@ -38067,13 +38027,29 @@
             </a:fontRef>
           </p:style>
           <p:txBody>
-            <a:bodyPr anchor="ctr"/>
+            <a:bodyPr tIns="28800" anchor="t"/>
             <a:lstStyle/>
             <a:p>
               <a:pPr algn="ctr">
                 <a:buNone/>
               </a:pPr>
-              <a:endParaRPr/>
+              <a:r>
+                <a:rPr lang="de-CH" sz="1200" dirty="0">
+                  <a:solidFill>
+                    <a:schemeClr val="bg2">
+                      <a:lumMod val="10000"/>
+                    </a:schemeClr>
+                  </a:solidFill>
+                </a:rPr>
+                <a:t>Embedding LLM</a:t>
+              </a:r>
+              <a:endParaRPr sz="1200" dirty="0">
+                <a:solidFill>
+                  <a:schemeClr val="bg2">
+                    <a:lumMod val="10000"/>
+                  </a:schemeClr>
+                </a:solidFill>
+              </a:endParaRPr>
             </a:p>
           </p:txBody>
         </p:sp>
@@ -38092,61 +38068,27 @@
             <p:nvPr/>
           </p:nvPicPr>
           <p:blipFill>
-            <a:blip r:embed="rId11"/>
+            <a:blip r:embed="rId28">
+              <a:extLst>
+                <a:ext uri="{96DAC541-7B7A-43D3-8B79-37D633B846F1}">
+                  <ns9:svgBlip xmlns:ns9="http://schemas.microsoft.com/office/drawing/2016/SVG/main" r:embed="rId29"/>
+                </a:ext>
+              </a:extLst>
+            </a:blip>
             <a:stretch>
               <a:fillRect/>
             </a:stretch>
           </p:blipFill>
           <p:spPr>
-            <a:xfrm flipH="1">
-              <a:off x="3266354" y="1909499"/>
-              <a:ext cx="475124" cy="482236"/>
+            <a:xfrm>
+              <a:off x="3269916" y="1906225"/>
+              <a:ext cx="468000" cy="468000"/>
             </a:xfrm>
             <a:prstGeom prst="rect">
               <a:avLst/>
             </a:prstGeom>
           </p:spPr>
         </p:pic>
-        <p:sp>
-          <p:nvSpPr>
-            <p:cNvPr id="139" name="Textfeld 40">
-              <a:extLst>
-                <a:ext uri="{FF2B5EF4-FFF2-40B4-BE49-F238E27FC236}">
-                  <a16:creationId xmlns:a16="http://schemas.microsoft.com/office/drawing/2014/main" id="{F5202F32-CF94-B0E2-B061-FC87820AD558}"/>
-                </a:ext>
-              </a:extLst>
-            </p:cNvPr>
-            <p:cNvSpPr>
-              <a:spLocks/>
-            </p:cNvSpPr>
-            <p:nvPr/>
-          </p:nvSpPr>
-          <p:spPr>
-            <a:xfrm>
-              <a:off x="2636316" y="1570799"/>
-              <a:ext cx="1735200" cy="276999"/>
-            </a:xfrm>
-            <a:prstGeom prst="rect">
-              <a:avLst/>
-            </a:prstGeom>
-            <a:noFill/>
-          </p:spPr>
-          <p:txBody>
-            <a:bodyPr wrap="square">
-              <a:spAutoFit/>
-            </a:bodyPr>
-            <a:lstStyle/>
-            <a:p>
-              <a:pPr algn="ctr">
-                <a:buNone/>
-              </a:pPr>
-              <a:r>
-                <a:rPr sz="1200" dirty="0"/>
-                <a:t>Embedding LLM</a:t>
-              </a:r>
-            </a:p>
-          </p:txBody>
-        </p:sp>
         <p:sp>
           <p:nvSpPr>
             <p:cNvPr id="140" name="Gerader Verbinder 139">
@@ -38163,7 +38105,7 @@
           </p:nvSpPr>
           <p:spPr>
             <a:xfrm>
-              <a:off x="2636316" y="1854598"/>
+              <a:off x="2636316" y="1859360"/>
               <a:ext cx="1735200" cy="0"/>
             </a:xfrm>
             <a:prstGeom prst="line">
@@ -38171,7 +38113,7 @@
             </a:prstGeom>
             <a:ln>
               <a:solidFill>
-                <a:schemeClr val="tx2"/>
+                <a:srgbClr val="FA9400"/>
               </a:solidFill>
             </a:ln>
           </p:spPr>
@@ -38577,11 +38519,15 @@
               <a:avLst/>
             </a:prstGeom>
             <a:solidFill>
-              <a:schemeClr val="accent2"/>
+              <a:schemeClr val="accent2">
+                <a:alpha val="50000"/>
+              </a:schemeClr>
             </a:solidFill>
             <a:ln>
               <a:solidFill>
-                <a:schemeClr val="accent3"/>
+                <a:schemeClr val="accent2">
+                  <a:lumMod val="50000"/>
+                </a:schemeClr>
               </a:solidFill>
             </a:ln>
           </p:spPr>
@@ -38602,53 +38548,29 @@
             </a:fontRef>
           </p:style>
           <p:txBody>
-            <a:bodyPr anchor="ctr"/>
-            <a:lstStyle/>
-            <a:p>
-              <a:pPr algn="ctr">
-                <a:buNone/>
-              </a:pPr>
-              <a:endParaRPr/>
-            </a:p>
-          </p:txBody>
-        </p:sp>
-        <p:sp>
-          <p:nvSpPr>
-            <p:cNvPr id="123" name="Textfeld 171">
-              <a:extLst>
-                <a:ext uri="{FF2B5EF4-FFF2-40B4-BE49-F238E27FC236}">
-                  <a16:creationId xmlns:a16="http://schemas.microsoft.com/office/drawing/2014/main" id="{94B0B414-3457-95E7-777A-E27F72556F9D}"/>
-                </a:ext>
-              </a:extLst>
-            </p:cNvPr>
-            <p:cNvSpPr>
-              <a:spLocks/>
-            </p:cNvSpPr>
-            <p:nvPr/>
-          </p:nvSpPr>
-          <p:spPr>
-            <a:xfrm>
-              <a:off x="470304" y="1589478"/>
-              <a:ext cx="1735200" cy="276999"/>
-            </a:xfrm>
-            <a:prstGeom prst="rect">
-              <a:avLst/>
-            </a:prstGeom>
-            <a:noFill/>
-          </p:spPr>
-          <p:txBody>
-            <a:bodyPr wrap="square">
-              <a:spAutoFit/>
-            </a:bodyPr>
+            <a:bodyPr tIns="28800" anchor="t"/>
             <a:lstStyle/>
             <a:p>
               <a:pPr algn="ctr">
                 <a:buNone/>
               </a:pPr>
               <a:r>
-                <a:rPr sz="1200" dirty="0"/>
+                <a:rPr lang="de-CH" sz="1200" dirty="0">
+                  <a:solidFill>
+                    <a:schemeClr val="bg2">
+                      <a:lumMod val="10000"/>
+                    </a:schemeClr>
+                  </a:solidFill>
+                </a:rPr>
                 <a:t>Chunks</a:t>
               </a:r>
+              <a:endParaRPr sz="1200" dirty="0">
+                <a:solidFill>
+                  <a:schemeClr val="bg2">
+                    <a:lumMod val="10000"/>
+                  </a:schemeClr>
+                </a:solidFill>
+              </a:endParaRPr>
             </a:p>
           </p:txBody>
         </p:sp>
@@ -38674,8 +38596,8 @@
           </p:blipFill>
           <p:spPr>
             <a:xfrm flipH="1">
-              <a:off x="1110373" y="1880907"/>
-              <a:ext cx="455061" cy="530359"/>
+              <a:off x="1137126" y="1906225"/>
+              <a:ext cx="401555" cy="468000"/>
             </a:xfrm>
             <a:prstGeom prst="rect">
               <a:avLst/>
@@ -38698,7 +38620,7 @@
           </p:nvSpPr>
           <p:spPr>
             <a:xfrm>
-              <a:off x="470304" y="1863453"/>
+              <a:off x="470304" y="1859360"/>
               <a:ext cx="1735200" cy="0"/>
             </a:xfrm>
             <a:prstGeom prst="line">
@@ -38706,7 +38628,9 @@
             </a:prstGeom>
             <a:ln>
               <a:solidFill>
-                <a:schemeClr val="accent3"/>
+                <a:schemeClr val="accent2">
+                  <a:lumMod val="50000"/>
+                </a:schemeClr>
               </a:solidFill>
             </a:ln>
           </p:spPr>
@@ -38846,20 +38770,21 @@
             <p:nvPr/>
           </p:nvPicPr>
           <p:blipFill>
-            <a:blip r:embed="rId13">
+            <a:blip r:embed="rId22">
               <a:extLst>
-                <a:ext uri="{28A0092B-C50C-407E-A947-70E740481C1C}">
-                  <a14:useLocalDpi xmlns:a14="http://schemas.microsoft.com/office/drawing/2010/main" val="0"/>
+                <a:ext uri="{96DAC541-7B7A-43D3-8B79-37D633B846F1}">
+                  <ns10:svgBlip xmlns:ns10="http://schemas.microsoft.com/office/drawing/2016/SVG/main" r:embed="rId23"/>
                 </a:ext>
               </a:extLst>
             </a:blip>
-            <a:srcRect/>
-            <a:stretch/>
+            <a:stretch>
+              <a:fillRect/>
+            </a:stretch>
           </p:blipFill>
           <p:spPr>
-            <a:xfrm flipH="1">
-              <a:off x="8507421" y="5496779"/>
-              <a:ext cx="468000" cy="494293"/>
+            <a:xfrm>
+              <a:off x="8492090" y="5496779"/>
+              <a:ext cx="468000" cy="468000"/>
             </a:xfrm>
             <a:prstGeom prst="rect">
               <a:avLst/>
@@ -39004,33 +38929,6 @@
                                 </p:cTn>
                               </p:par>
                               <p:par>
-                                <p:cTn id="9" presetID="1" presetClass="entr" presetSubtype="0" fill="hold" nodeType="withEffect">
-                                  <p:stCondLst>
-                                    <p:cond delay="0"/>
-                                  </p:stCondLst>
-                                  <p:childTnLst>
-                                    <p:set>
-                                      <p:cBhvr>
-                                        <p:cTn id="10" dur="1" fill="hold">
-                                          <p:stCondLst>
-                                            <p:cond delay="0"/>
-                                          </p:stCondLst>
-                                        </p:cTn>
-                                        <p:tgtEl>
-                                          <p:spTgt spid="77"/>
-                                        </p:tgtEl>
-                                        <p:attrNameLst>
-                                          <p:attrName>style.visibility</p:attrName>
-                                        </p:attrNameLst>
-                                      </p:cBhvr>
-                                      <p:to>
-                                        <p:strVal val="visible"/>
-                                      </p:to>
-                                    </p:set>
-                                  </p:childTnLst>
-                                </p:cTn>
-                              </p:par>
-                              <p:par>
                                 <p:cTn id="11" presetID="1" presetClass="entr" presetSubtype="0" fill="hold" nodeType="withEffect">
                                   <p:stCondLst>
                                     <p:cond delay="0"/>
@@ -39090,33 +38988,6 @@
                                         </p:cTn>
                                         <p:tgtEl>
                                           <p:spTgt spid="10"/>
-                                        </p:tgtEl>
-                                        <p:attrNameLst>
-                                          <p:attrName>style.visibility</p:attrName>
-                                        </p:attrNameLst>
-                                      </p:cBhvr>
-                                      <p:to>
-                                        <p:strVal val="visible"/>
-                                      </p:to>
-                                    </p:set>
-                                  </p:childTnLst>
-                                </p:cTn>
-                              </p:par>
-                              <p:par>
-                                <p:cTn id="17" presetID="1" presetClass="entr" presetSubtype="0" fill="hold" nodeType="withEffect">
-                                  <p:stCondLst>
-                                    <p:cond delay="0"/>
-                                  </p:stCondLst>
-                                  <p:childTnLst>
-                                    <p:set>
-                                      <p:cBhvr>
-                                        <p:cTn id="18" dur="1" fill="hold">
-                                          <p:stCondLst>
-                                            <p:cond delay="0"/>
-                                          </p:stCondLst>
-                                        </p:cTn>
-                                        <p:tgtEl>
-                                          <p:spTgt spid="12"/>
                                         </p:tgtEl>
                                         <p:attrNameLst>
                                           <p:attrName>style.visibility</p:attrName>
@@ -39256,33 +39127,6 @@
                                 </p:cTn>
                               </p:par>
                               <p:par>
-                                <p:cTn id="29" presetID="1" presetClass="entr" presetSubtype="0" fill="hold" nodeType="withEffect">
-                                  <p:stCondLst>
-                                    <p:cond delay="0"/>
-                                  </p:stCondLst>
-                                  <p:childTnLst>
-                                    <p:set>
-                                      <p:cBhvr>
-                                        <p:cTn id="30" dur="1" fill="hold">
-                                          <p:stCondLst>
-                                            <p:cond delay="0"/>
-                                          </p:stCondLst>
-                                        </p:cTn>
-                                        <p:tgtEl>
-                                          <p:spTgt spid="43"/>
-                                        </p:tgtEl>
-                                        <p:attrNameLst>
-                                          <p:attrName>style.visibility</p:attrName>
-                                        </p:attrNameLst>
-                                      </p:cBhvr>
-                                      <p:to>
-                                        <p:strVal val="visible"/>
-                                      </p:to>
-                                    </p:set>
-                                  </p:childTnLst>
-                                </p:cTn>
-                              </p:par>
-                              <p:par>
                                 <p:cTn id="31" presetID="1" presetClass="entr" presetSubtype="0" fill="hold" nodeType="withEffect">
                                   <p:stCondLst>
                                     <p:cond delay="0"/>
@@ -39327,33 +39171,6 @@
                               <p:cond delay="0"/>
                             </p:stCondLst>
                             <p:childTnLst>
-                              <p:par>
-                                <p:cTn id="35" presetID="1" presetClass="entr" presetSubtype="0" fill="hold" nodeType="clickEffect">
-                                  <p:stCondLst>
-                                    <p:cond delay="0"/>
-                                  </p:stCondLst>
-                                  <p:childTnLst>
-                                    <p:set>
-                                      <p:cBhvr>
-                                        <p:cTn id="36" dur="1" fill="hold">
-                                          <p:stCondLst>
-                                            <p:cond delay="0"/>
-                                          </p:stCondLst>
-                                        </p:cTn>
-                                        <p:tgtEl>
-                                          <p:spTgt spid="48"/>
-                                        </p:tgtEl>
-                                        <p:attrNameLst>
-                                          <p:attrName>style.visibility</p:attrName>
-                                        </p:attrNameLst>
-                                      </p:cBhvr>
-                                      <p:to>
-                                        <p:strVal val="visible"/>
-                                      </p:to>
-                                    </p:set>
-                                  </p:childTnLst>
-                                </p:cTn>
-                              </p:par>
                               <p:par>
                                 <p:cTn id="37" presetID="1" presetClass="entr" presetSubtype="0" fill="hold" nodeType="withEffect">
                                   <p:stCondLst>
@@ -39495,33 +39312,6 @@
                                         </p:cTn>
                                         <p:tgtEl>
                                           <p:spTgt spid="122"/>
-                                        </p:tgtEl>
-                                        <p:attrNameLst>
-                                          <p:attrName>style.visibility</p:attrName>
-                                        </p:attrNameLst>
-                                      </p:cBhvr>
-                                      <p:to>
-                                        <p:strVal val="visible"/>
-                                      </p:to>
-                                    </p:set>
-                                  </p:childTnLst>
-                                </p:cTn>
-                              </p:par>
-                              <p:par>
-                                <p:cTn id="49" presetID="1" presetClass="entr" presetSubtype="0" fill="hold" nodeType="withEffect">
-                                  <p:stCondLst>
-                                    <p:cond delay="0"/>
-                                  </p:stCondLst>
-                                  <p:childTnLst>
-                                    <p:set>
-                                      <p:cBhvr>
-                                        <p:cTn id="50" dur="1" fill="hold">
-                                          <p:stCondLst>
-                                            <p:cond delay="0"/>
-                                          </p:stCondLst>
-                                        </p:cTn>
-                                        <p:tgtEl>
-                                          <p:spTgt spid="123"/>
                                         </p:tgtEl>
                                         <p:attrNameLst>
                                           <p:attrName>style.visibility</p:attrName>
@@ -39687,33 +39477,6 @@
                                   </p:childTnLst>
                                 </p:cTn>
                               </p:par>
-                              <p:par>
-                                <p:cTn id="63" presetID="1" presetClass="entr" presetSubtype="0" fill="hold" nodeType="withEffect">
-                                  <p:stCondLst>
-                                    <p:cond delay="0"/>
-                                  </p:stCondLst>
-                                  <p:childTnLst>
-                                    <p:set>
-                                      <p:cBhvr>
-                                        <p:cTn id="64" dur="1" fill="hold">
-                                          <p:stCondLst>
-                                            <p:cond delay="0"/>
-                                          </p:stCondLst>
-                                        </p:cTn>
-                                        <p:tgtEl>
-                                          <p:spTgt spid="139"/>
-                                        </p:tgtEl>
-                                        <p:attrNameLst>
-                                          <p:attrName>style.visibility</p:attrName>
-                                        </p:attrNameLst>
-                                      </p:cBhvr>
-                                      <p:to>
-                                        <p:strVal val="visible"/>
-                                      </p:to>
-                                    </p:set>
-                                  </p:childTnLst>
-                                </p:cTn>
-                              </p:par>
                             </p:childTnLst>
                           </p:cTn>
                         </p:par>
@@ -39774,33 +39537,6 @@
                                         </p:cTn>
                                         <p:tgtEl>
                                           <p:spTgt spid="56"/>
-                                        </p:tgtEl>
-                                        <p:attrNameLst>
-                                          <p:attrName>style.visibility</p:attrName>
-                                        </p:attrNameLst>
-                                      </p:cBhvr>
-                                      <p:to>
-                                        <p:strVal val="visible"/>
-                                      </p:to>
-                                    </p:set>
-                                  </p:childTnLst>
-                                </p:cTn>
-                              </p:par>
-                              <p:par>
-                                <p:cTn id="71" presetID="1" presetClass="entr" presetSubtype="0" fill="hold" nodeType="withEffect">
-                                  <p:stCondLst>
-                                    <p:cond delay="0"/>
-                                  </p:stCondLst>
-                                  <p:childTnLst>
-                                    <p:set>
-                                      <p:cBhvr>
-                                        <p:cTn id="72" dur="1" fill="hold">
-                                          <p:stCondLst>
-                                            <p:cond delay="0"/>
-                                          </p:stCondLst>
-                                        </p:cTn>
-                                        <p:tgtEl>
-                                          <p:spTgt spid="57"/>
                                         </p:tgtEl>
                                         <p:attrNameLst>
                                           <p:attrName>style.visibility</p:attrName>
@@ -39939,33 +39675,6 @@
                                   </p:childTnLst>
                                 </p:cTn>
                               </p:par>
-                              <p:par>
-                                <p:cTn id="83" presetID="1" presetClass="entr" presetSubtype="0" fill="hold" nodeType="withEffect">
-                                  <p:stCondLst>
-                                    <p:cond delay="0"/>
-                                  </p:stCondLst>
-                                  <p:childTnLst>
-                                    <p:set>
-                                      <p:cBhvr>
-                                        <p:cTn id="84" dur="1" fill="hold">
-                                          <p:stCondLst>
-                                            <p:cond delay="0"/>
-                                          </p:stCondLst>
-                                        </p:cTn>
-                                        <p:tgtEl>
-                                          <p:spTgt spid="99"/>
-                                        </p:tgtEl>
-                                        <p:attrNameLst>
-                                          <p:attrName>style.visibility</p:attrName>
-                                        </p:attrNameLst>
-                                      </p:cBhvr>
-                                      <p:to>
-                                        <p:strVal val="visible"/>
-                                      </p:to>
-                                    </p:set>
-                                  </p:childTnLst>
-                                </p:cTn>
-                              </p:par>
                             </p:childTnLst>
                           </p:cTn>
                         </p:par>
@@ -40026,33 +39735,6 @@
                                         </p:cTn>
                                         <p:tgtEl>
                                           <p:spTgt spid="84"/>
-                                        </p:tgtEl>
-                                        <p:attrNameLst>
-                                          <p:attrName>style.visibility</p:attrName>
-                                        </p:attrNameLst>
-                                      </p:cBhvr>
-                                      <p:to>
-                                        <p:strVal val="visible"/>
-                                      </p:to>
-                                    </p:set>
-                                  </p:childTnLst>
-                                </p:cTn>
-                              </p:par>
-                              <p:par>
-                                <p:cTn id="91" presetID="1" presetClass="entr" presetSubtype="0" fill="hold" nodeType="withEffect">
-                                  <p:stCondLst>
-                                    <p:cond delay="0"/>
-                                  </p:stCondLst>
-                                  <p:childTnLst>
-                                    <p:set>
-                                      <p:cBhvr>
-                                        <p:cTn id="92" dur="1" fill="hold">
-                                          <p:stCondLst>
-                                            <p:cond delay="0"/>
-                                          </p:stCondLst>
-                                        </p:cTn>
-                                        <p:tgtEl>
-                                          <p:spTgt spid="87"/>
                                         </p:tgtEl>
                                         <p:attrNameLst>
                                           <p:attrName>style.visibility</p:attrName>
@@ -40173,33 +39855,6 @@
                                   </p:childTnLst>
                                 </p:cTn>
                               </p:par>
-                              <p:par>
-                                <p:cTn id="101" presetID="1" presetClass="entr" presetSubtype="0" fill="hold" nodeType="withEffect">
-                                  <p:stCondLst>
-                                    <p:cond delay="0"/>
-                                  </p:stCondLst>
-                                  <p:childTnLst>
-                                    <p:set>
-                                      <p:cBhvr>
-                                        <p:cTn id="102" dur="1" fill="hold">
-                                          <p:stCondLst>
-                                            <p:cond delay="0"/>
-                                          </p:stCondLst>
-                                        </p:cTn>
-                                        <p:tgtEl>
-                                          <p:spTgt spid="31"/>
-                                        </p:tgtEl>
-                                        <p:attrNameLst>
-                                          <p:attrName>style.visibility</p:attrName>
-                                        </p:attrNameLst>
-                                      </p:cBhvr>
-                                      <p:to>
-                                        <p:strVal val="visible"/>
-                                      </p:to>
-                                    </p:set>
-                                  </p:childTnLst>
-                                </p:cTn>
-                              </p:par>
                             </p:childTnLst>
                           </p:cTn>
                         </p:par>
@@ -40229,35 +39884,25 @@
     </p:tnLst>
     <p:bldLst>
       <p:bldP spid="10" grpId="0" animBg="1"/>
-      <p:bldP spid="12" grpId="0"/>
       <p:bldP spid="14" grpId="0" animBg="1"/>
       <p:bldP spid="24" grpId="0" animBg="1"/>
-      <p:bldP spid="31" grpId="0"/>
       <p:bldP spid="37" grpId="0" animBg="1"/>
-      <p:bldP spid="43" grpId="0"/>
       <p:bldP spid="44" grpId="0" animBg="1"/>
       <p:bldP spid="45" grpId="0" animBg="1"/>
-      <p:bldP spid="48" grpId="0"/>
       <p:bldP spid="51" grpId="0" animBg="1"/>
       <p:bldP spid="54" grpId="0" animBg="1"/>
-      <p:bldP spid="57" grpId="0"/>
       <p:bldP spid="58" grpId="0" animBg="1"/>
       <p:bldP spid="72" grpId="0" animBg="1"/>
-      <p:bldP spid="77" grpId="0"/>
       <p:bldP spid="79" grpId="0" animBg="1"/>
       <p:bldP spid="81" grpId="0" animBg="1"/>
-      <p:bldP spid="87" grpId="0"/>
       <p:bldP spid="90" grpId="0" animBg="1"/>
       <p:bldP spid="93" grpId="0" animBg="1"/>
-      <p:bldP spid="99" grpId="0"/>
       <p:bldP spid="101" grpId="0" animBg="1"/>
       <p:bldP spid="102" grpId="0" animBg="1"/>
       <p:bldP spid="106" grpId="0" animBg="1"/>
       <p:bldP spid="137" grpId="0" animBg="1"/>
-      <p:bldP spid="139" grpId="0"/>
       <p:bldP spid="140" grpId="0" animBg="1"/>
       <p:bldP spid="121" grpId="0" animBg="1"/>
-      <p:bldP spid="123" grpId="0"/>
       <p:bldP spid="124" grpId="0" animBg="1"/>
       <p:bldP spid="32" grpId="0" animBg="1"/>
       <p:bldP spid="35" grpId="0" animBg="1"/>

</xml_diff>

<commit_message>
Rework slide 7 and update SVG icon set
Icon artwork reassigned across the numbered files and a new
01-raw-data-sources icon added.

Co-Authored-By: Claude Fable 5 <noreply@anthropic.com>
Claude-Session: https://claude.ai/code/session_01S2kGP2buE2HmxMttD3XczR
</commit_message>
<xml_diff>
--- a/RAG_Workshop.pptx
+++ b/RAG_Workshop.pptx
@@ -35699,7 +35699,7 @@
                 <a:buNone/>
               </a:pPr>
               <a:r>
-                <a:rPr lang="de-CH" sz="1200" dirty="0">
+                <a:rPr lang="de-CH" sz="1000" dirty="0">
                   <a:solidFill>
                     <a:schemeClr val="bg2">
                       <a:lumMod val="10000"/>
@@ -35708,7 +35708,7 @@
                 </a:rPr>
                 <a:t>Raw Data Files</a:t>
               </a:r>
-              <a:endParaRPr sz="1200" dirty="0">
+              <a:endParaRPr sz="1000" dirty="0">
                 <a:solidFill>
                   <a:schemeClr val="bg2">
                     <a:lumMod val="10000"/>
@@ -35766,7 +35766,7 @@
             <a:bodyPr/>
             <a:lstStyle/>
             <a:p>
-              <a:endParaRPr lang="de-CH"/>
+              <a:endParaRPr lang="de-CH" sz="1000"/>
             </a:p>
           </p:txBody>
         </p:sp>
@@ -35872,7 +35872,7 @@
                 <a:buNone/>
               </a:pPr>
               <a:r>
-                <a:rPr lang="de-CH" sz="1200" dirty="0">
+                <a:rPr lang="de-CH" sz="1000" dirty="0">
                   <a:solidFill>
                     <a:schemeClr val="bg2">
                       <a:lumMod val="10000"/>
@@ -35881,7 +35881,7 @@
                 </a:rPr>
                 <a:t>Query</a:t>
               </a:r>
-              <a:endParaRPr sz="1200" dirty="0">
+              <a:endParaRPr sz="1000" dirty="0">
                 <a:solidFill>
                   <a:schemeClr val="bg2">
                     <a:lumMod val="10000"/>
@@ -35906,16 +35906,15 @@
             <p:nvPr/>
           </p:nvPicPr>
           <p:blipFill>
-            <a:blip r:embed="rId14">
+            <a:blip>
               <a:extLst>
                 <a:ext uri="{96DAC541-7B7A-43D3-8B79-37D633B846F1}">
-                  <ns0:svgBlip xmlns:ns0="http://schemas.microsoft.com/office/drawing/2016/SVG/main" r:embed="rId15"/>
+                  <asvg:svgBlip xmlns:asvg="http://schemas.microsoft.com/office/drawing/2016/SVG/main" r:embed="rId4"/>
                 </a:ext>
               </a:extLst>
             </a:blip>
-            <a:stretch>
-              <a:fillRect/>
-            </a:stretch>
+            <a:srcRect/>
+            <a:stretch/>
           </p:blipFill>
           <p:spPr>
             <a:xfrm>
@@ -35967,7 +35966,7 @@
             <a:bodyPr/>
             <a:lstStyle/>
             <a:p>
-              <a:endParaRPr lang="de-CH"/>
+              <a:endParaRPr lang="de-CH" sz="1000"/>
             </a:p>
           </p:txBody>
         </p:sp>
@@ -36043,7 +36042,7 @@
                 <a:buNone/>
               </a:pPr>
               <a:r>
-                <a:rPr lang="de-CH" sz="1200" dirty="0">
+                <a:rPr lang="de-CH" sz="1000" dirty="0">
                   <a:solidFill>
                     <a:schemeClr val="bg2">
                       <a:lumMod val="10000"/>
@@ -36052,7 +36051,7 @@
                 </a:rPr>
                 <a:t>Response</a:t>
               </a:r>
-              <a:endParaRPr sz="1200" dirty="0">
+              <a:endParaRPr sz="1000" dirty="0">
                 <a:solidFill>
                   <a:schemeClr val="bg2">
                     <a:lumMod val="10000"/>
@@ -36077,16 +36076,15 @@
             <p:nvPr/>
           </p:nvPicPr>
           <p:blipFill>
-            <a:blip r:embed="rId16">
+            <a:blip>
               <a:extLst>
                 <a:ext uri="{96DAC541-7B7A-43D3-8B79-37D633B846F1}">
-                  <ns1:svgBlip xmlns:ns1="http://schemas.microsoft.com/office/drawing/2016/SVG/main" r:embed="rId17"/>
+                  <asvg:svgBlip xmlns:asvg="http://schemas.microsoft.com/office/drawing/2016/SVG/main" r:embed="rId5"/>
                 </a:ext>
               </a:extLst>
             </a:blip>
-            <a:stretch>
-              <a:fillRect/>
-            </a:stretch>
+            <a:srcRect/>
+            <a:stretch/>
           </p:blipFill>
           <p:spPr>
             <a:xfrm>
@@ -36138,7 +36136,7 @@
             <a:bodyPr/>
             <a:lstStyle/>
             <a:p>
-              <a:endParaRPr lang="de-CH"/>
+              <a:endParaRPr lang="de-CH" sz="1000"/>
             </a:p>
           </p:txBody>
         </p:sp>
@@ -36152,7 +36150,7 @@
         <p:grpSpPr>
           <a:xfrm>
             <a:off x="475308" y="3952049"/>
-            <a:ext cx="1735200" cy="867600"/>
+            <a:ext cx="1434807" cy="867600"/>
             <a:chOff x="475308" y="3952049"/>
             <a:chExt cx="1735200" cy="867600"/>
           </a:xfrm>
@@ -36209,14 +36207,14 @@
             </a:fontRef>
           </p:style>
           <p:txBody>
-            <a:bodyPr tIns="28800" anchor="t"/>
+            <a:bodyPr lIns="54000" tIns="28800" rIns="54000" anchor="t"/>
             <a:lstStyle/>
             <a:p>
               <a:pPr algn="ctr">
                 <a:buNone/>
               </a:pPr>
               <a:r>
-                <a:rPr lang="de-CH" sz="1200" dirty="0">
+                <a:rPr lang="de-CH" sz="1000" dirty="0">
                   <a:solidFill>
                     <a:schemeClr val="bg2">
                       <a:lumMod val="10000"/>
@@ -36225,7 +36223,7 @@
                 </a:rPr>
                 <a:t>Information Extraction</a:t>
               </a:r>
-              <a:endParaRPr sz="1200" dirty="0">
+              <a:endParaRPr sz="1000" dirty="0">
                 <a:solidFill>
                   <a:schemeClr val="bg2">
                     <a:lumMod val="10000"/>
@@ -36250,16 +36248,15 @@
             <p:nvPr/>
           </p:nvPicPr>
           <p:blipFill>
-            <a:blip r:embed="rId18">
+            <a:blip>
               <a:extLst>
                 <a:ext uri="{96DAC541-7B7A-43D3-8B79-37D633B846F1}">
-                  <ns2:svgBlip xmlns:ns2="http://schemas.microsoft.com/office/drawing/2016/SVG/main" r:embed="rId19"/>
+                  <asvg:svgBlip xmlns:asvg="http://schemas.microsoft.com/office/drawing/2016/SVG/main" r:embed="rId6"/>
                 </a:ext>
               </a:extLst>
             </a:blip>
-            <a:stretch>
-              <a:fillRect/>
-            </a:stretch>
+            <a:srcRect/>
+            <a:stretch/>
           </p:blipFill>
           <p:spPr>
             <a:xfrm>
@@ -36316,17 +36313,23 @@
             </a:fontRef>
           </p:style>
           <p:txBody>
-            <a:bodyPr/>
+            <a:bodyPr lIns="54000" tIns="28800" rIns="54000"/>
             <a:lstStyle/>
             <a:p>
-              <a:endParaRPr lang="de-CH"/>
+              <a:endParaRPr lang="de-CH" sz="1000"/>
             </a:p>
           </p:txBody>
         </p:sp>
       </p:grpSp>
       <p:grpSp>
         <p:nvGrpSpPr>
-          <p:cNvPr id="150" name="Gruppe Chunking"/>
+          <p:cNvPr id="50" name="Gruppieren 49">
+            <a:extLst>
+              <a:ext uri="{FF2B5EF4-FFF2-40B4-BE49-F238E27FC236}">
+                <a16:creationId xmlns:a16="http://schemas.microsoft.com/office/drawing/2014/main" id="{8508E21A-AF16-CF37-8FB0-BF8A7BDA03CE}"/>
+              </a:ext>
+            </a:extLst>
+          </p:cNvPr>
           <p:cNvGrpSpPr/>
           <p:nvPr/>
         </p:nvGrpSpPr>
@@ -36361,15 +36364,15 @@
               <a:avLst/>
             </a:prstGeom>
             <a:solidFill>
-              <a:schemeClr val="accent2">
+              <a:schemeClr val="accent6">
+                <a:lumMod val="40000"/>
+                <a:lumOff val="60000"/>
                 <a:alpha val="50000"/>
               </a:schemeClr>
             </a:solidFill>
             <a:ln>
               <a:solidFill>
-                <a:schemeClr val="accent2">
-                  <a:lumMod val="50000"/>
-                </a:schemeClr>
+                <a:srgbClr val="FFC000"/>
               </a:solidFill>
             </a:ln>
           </p:spPr>
@@ -36393,11 +36396,9 @@
             <a:bodyPr tIns="28800" anchor="t"/>
             <a:lstStyle/>
             <a:p>
-              <a:pPr algn="ctr">
-                <a:buNone/>
-              </a:pPr>
+              <a:pPr algn="ctr"/>
               <a:r>
-                <a:rPr lang="de-CH" sz="1200" dirty="0">
+                <a:rPr lang="de-CH" sz="1000" dirty="0">
                   <a:solidFill>
                     <a:schemeClr val="bg2">
                       <a:lumMod val="10000"/>
@@ -36406,7 +36407,7 @@
                 </a:rPr>
                 <a:t>Chunking</a:t>
               </a:r>
-              <a:endParaRPr sz="1200" dirty="0">
+              <a:endParaRPr sz="1000" dirty="0">
                 <a:solidFill>
                   <a:schemeClr val="bg2">
                     <a:lumMod val="10000"/>
@@ -36464,7 +36465,7 @@
             <a:bodyPr/>
             <a:lstStyle/>
             <a:p>
-              <a:endParaRPr lang="de-CH"/>
+              <a:endParaRPr lang="de-CH" sz="1000"/>
             </a:p>
           </p:txBody>
         </p:sp>
@@ -36483,10 +36484,10 @@
             <p:nvPr/>
           </p:nvPicPr>
           <p:blipFill>
-            <a:blip r:embed="rId20">
+            <a:blip>
               <a:extLst>
                 <a:ext uri="{96DAC541-7B7A-43D3-8B79-37D633B846F1}">
-                  <ns3:svgBlip xmlns:ns3="http://schemas.microsoft.com/office/drawing/2016/SVG/main" r:embed="rId21"/>
+                  <asvg:svgBlip xmlns:asvg="http://schemas.microsoft.com/office/drawing/2016/SVG/main" r:embed="rId6"/>
                 </a:ext>
               </a:extLst>
             </a:blip>
@@ -36578,16 +36579,16 @@
                 <a:buNone/>
               </a:pPr>
               <a:r>
-                <a:rPr lang="de-CH" sz="1200" dirty="0">
+                <a:rPr lang="de-CH" sz="1000" dirty="0" err="1">
                   <a:solidFill>
                     <a:schemeClr val="bg2">
                       <a:lumMod val="10000"/>
                     </a:schemeClr>
                   </a:solidFill>
                 </a:rPr>
-                <a:t>Embedding</a:t>
+                <a:t>Embeddings</a:t>
               </a:r>
-              <a:endParaRPr sz="1200" dirty="0">
+              <a:endParaRPr sz="1000" dirty="0">
                 <a:solidFill>
                   <a:schemeClr val="bg2">
                     <a:lumMod val="10000"/>
@@ -36612,16 +36613,15 @@
             <p:nvPr/>
           </p:nvPicPr>
           <p:blipFill>
-            <a:blip r:embed="rId22">
+            <a:blip>
               <a:extLst>
                 <a:ext uri="{96DAC541-7B7A-43D3-8B79-37D633B846F1}">
-                  <ns4:svgBlip xmlns:ns4="http://schemas.microsoft.com/office/drawing/2016/SVG/main" r:embed="rId23"/>
+                  <asvg:svgBlip xmlns:asvg="http://schemas.microsoft.com/office/drawing/2016/SVG/main" r:embed="rId7"/>
                 </a:ext>
               </a:extLst>
             </a:blip>
-            <a:stretch>
-              <a:fillRect/>
-            </a:stretch>
+            <a:srcRect/>
+            <a:stretch/>
           </p:blipFill>
           <p:spPr>
             <a:xfrm>
@@ -36681,7 +36681,7 @@
             <a:bodyPr/>
             <a:lstStyle/>
             <a:p>
-              <a:endParaRPr lang="de-CH"/>
+              <a:endParaRPr lang="de-CH" sz="1000"/>
             </a:p>
           </p:txBody>
         </p:sp>
@@ -36694,7 +36694,7 @@
         </p:nvGrpSpPr>
         <p:grpSpPr>
           <a:xfrm>
-            <a:off x="4858115" y="2776165"/>
+            <a:off x="4858115" y="2761424"/>
             <a:ext cx="1735200" cy="867600"/>
             <a:chOff x="4858115" y="2776165"/>
             <a:chExt cx="1735200" cy="867600"/>
@@ -36759,7 +36759,7 @@
                 <a:buNone/>
               </a:pPr>
               <a:r>
-                <a:rPr lang="de-CH" sz="1200" dirty="0">
+                <a:rPr lang="de-CH" sz="1000" dirty="0">
                   <a:solidFill>
                     <a:schemeClr val="bg2">
                       <a:lumMod val="10000"/>
@@ -36768,7 +36768,7 @@
                 </a:rPr>
                 <a:t>Vector Database</a:t>
               </a:r>
-              <a:endParaRPr sz="1200" dirty="0">
+              <a:endParaRPr sz="1000" dirty="0">
                 <a:solidFill>
                   <a:schemeClr val="bg2">
                     <a:lumMod val="10000"/>
@@ -36793,16 +36793,15 @@
             <p:nvPr/>
           </p:nvPicPr>
           <p:blipFill>
-            <a:blip r:embed="rId24">
+            <a:blip>
               <a:extLst>
                 <a:ext uri="{96DAC541-7B7A-43D3-8B79-37D633B846F1}">
-                  <ns5:svgBlip xmlns:ns5="http://schemas.microsoft.com/office/drawing/2016/SVG/main" r:embed="rId25"/>
+                  <asvg:svgBlip xmlns:asvg="http://schemas.microsoft.com/office/drawing/2016/SVG/main" r:embed="rId8"/>
                 </a:ext>
               </a:extLst>
             </a:blip>
-            <a:stretch>
-              <a:fillRect/>
-            </a:stretch>
+            <a:srcRect/>
+            <a:stretch/>
           </p:blipFill>
           <p:spPr>
             <a:xfrm>
@@ -36862,7 +36861,7 @@
             <a:bodyPr/>
             <a:lstStyle/>
             <a:p>
-              <a:endParaRPr lang="de-CH"/>
+              <a:endParaRPr lang="de-CH" sz="1000"/>
             </a:p>
           </p:txBody>
         </p:sp>
@@ -36940,7 +36939,7 @@
                 <a:buNone/>
               </a:pPr>
               <a:r>
-                <a:rPr lang="de-CH" sz="1200" dirty="0">
+                <a:rPr lang="de-CH" sz="1000" dirty="0">
                   <a:solidFill>
                     <a:schemeClr val="bg2">
                       <a:lumMod val="10000"/>
@@ -36949,7 +36948,7 @@
                 </a:rPr>
                 <a:t>Relevant Data</a:t>
               </a:r>
-              <a:endParaRPr sz="1200" dirty="0">
+              <a:endParaRPr sz="1000" dirty="0">
                 <a:solidFill>
                   <a:schemeClr val="bg2">
                     <a:lumMod val="10000"/>
@@ -36974,16 +36973,15 @@
             <p:nvPr/>
           </p:nvPicPr>
           <p:blipFill>
-            <a:blip r:embed="rId26">
+            <a:blip>
               <a:extLst>
                 <a:ext uri="{96DAC541-7B7A-43D3-8B79-37D633B846F1}">
-                  <ns6:svgBlip xmlns:ns6="http://schemas.microsoft.com/office/drawing/2016/SVG/main" r:embed="rId27"/>
+                  <asvg:svgBlip xmlns:asvg="http://schemas.microsoft.com/office/drawing/2016/SVG/main" r:embed="rId9"/>
                 </a:ext>
               </a:extLst>
             </a:blip>
-            <a:stretch>
-              <a:fillRect/>
-            </a:stretch>
+            <a:srcRect/>
+            <a:stretch/>
           </p:blipFill>
           <p:spPr>
             <a:xfrm>
@@ -37043,7 +37041,7 @@
             <a:bodyPr/>
             <a:lstStyle/>
             <a:p>
-              <a:endParaRPr lang="de-CH"/>
+              <a:endParaRPr lang="de-CH" sz="1000"/>
             </a:p>
           </p:txBody>
         </p:sp>
@@ -37121,7 +37119,7 @@
                 <a:buNone/>
               </a:pPr>
               <a:r>
-                <a:rPr lang="de-CH" sz="1200" dirty="0">
+                <a:rPr lang="de-CH" sz="1000" dirty="0">
                   <a:solidFill>
                     <a:schemeClr val="bg2">
                       <a:lumMod val="10000"/>
@@ -37130,7 +37128,7 @@
                 </a:rPr>
                 <a:t>Embedding LLM</a:t>
               </a:r>
-              <a:endParaRPr sz="1200" dirty="0">
+              <a:endParaRPr sz="1000" dirty="0">
                 <a:solidFill>
                   <a:schemeClr val="bg2">
                     <a:lumMod val="10000"/>
@@ -37155,16 +37153,15 @@
             <p:nvPr/>
           </p:nvPicPr>
           <p:blipFill>
-            <a:blip r:embed="rId28">
+            <a:blip>
               <a:extLst>
                 <a:ext uri="{96DAC541-7B7A-43D3-8B79-37D633B846F1}">
-                  <ns7:svgBlip xmlns:ns7="http://schemas.microsoft.com/office/drawing/2016/SVG/main" r:embed="rId29"/>
+                  <asvg:svgBlip xmlns:asvg="http://schemas.microsoft.com/office/drawing/2016/SVG/main" r:embed="rId10"/>
                 </a:ext>
               </a:extLst>
             </a:blip>
-            <a:stretch>
-              <a:fillRect/>
-            </a:stretch>
+            <a:srcRect/>
+            <a:stretch/>
           </p:blipFill>
           <p:spPr>
             <a:xfrm>
@@ -37222,7 +37219,7 @@
             <a:bodyPr/>
             <a:lstStyle/>
             <a:p>
-              <a:endParaRPr lang="de-CH"/>
+              <a:endParaRPr lang="de-CH" sz="1000"/>
             </a:p>
           </p:txBody>
         </p:sp>
@@ -37306,7 +37303,7 @@
                 <a:buNone/>
               </a:pPr>
               <a:r>
-                <a:rPr lang="de-CH" sz="1200" dirty="0">
+                <a:rPr lang="de-CH" sz="1000" dirty="0">
                   <a:solidFill>
                     <a:schemeClr val="bg2">
                       <a:lumMod val="10000"/>
@@ -37315,7 +37312,7 @@
                 </a:rPr>
                 <a:t>LLM</a:t>
               </a:r>
-              <a:endParaRPr sz="1200" dirty="0">
+              <a:endParaRPr sz="1000" dirty="0">
                 <a:solidFill>
                   <a:schemeClr val="bg2">
                     <a:lumMod val="10000"/>
@@ -37340,16 +37337,15 @@
             <p:nvPr/>
           </p:nvPicPr>
           <p:blipFill>
-            <a:blip r:embed="rId30">
+            <a:blip>
               <a:extLst>
                 <a:ext uri="{96DAC541-7B7A-43D3-8B79-37D633B846F1}">
-                  <ns8:svgBlip xmlns:ns8="http://schemas.microsoft.com/office/drawing/2016/SVG/main" r:embed="rId31"/>
+                  <asvg:svgBlip xmlns:asvg="http://schemas.microsoft.com/office/drawing/2016/SVG/main" r:embed="rId10"/>
                 </a:ext>
               </a:extLst>
             </a:blip>
-            <a:stretch>
-              <a:fillRect/>
-            </a:stretch>
+            <a:srcRect/>
+            <a:stretch/>
           </p:blipFill>
           <p:spPr>
             <a:xfrm>
@@ -37407,7 +37403,7 @@
             <a:bodyPr/>
             <a:lstStyle/>
             <a:p>
-              <a:endParaRPr lang="de-CH"/>
+              <a:endParaRPr lang="de-CH" sz="1000"/>
             </a:p>
           </p:txBody>
         </p:sp>
@@ -37430,8 +37426,8 @@
         </p:nvCxnSpPr>
         <p:spPr>
           <a:xfrm flipV="1">
-            <a:off x="1344215" y="2438400"/>
-            <a:ext cx="2350688" cy="2705100"/>
+            <a:off x="1344215" y="2438399"/>
+            <a:ext cx="2082204" cy="2704275"/>
           </a:xfrm>
           <a:prstGeom prst="straightConnector1">
             <a:avLst/>
@@ -37475,8 +37471,8 @@
         </p:nvCxnSpPr>
         <p:spPr>
           <a:xfrm flipV="1">
-            <a:off x="1342909" y="3629025"/>
-            <a:ext cx="1306" cy="323850"/>
+            <a:off x="1192712" y="3629024"/>
+            <a:ext cx="151503" cy="323025"/>
           </a:xfrm>
           <a:prstGeom prst="straightConnector1">
             <a:avLst/>
@@ -37524,8 +37520,8 @@
         </p:nvCxnSpPr>
         <p:spPr>
           <a:xfrm flipH="1" flipV="1">
-            <a:off x="1337904" y="2438400"/>
-            <a:ext cx="6311" cy="323850"/>
+            <a:off x="1337904" y="2438399"/>
+            <a:ext cx="6311" cy="323025"/>
           </a:xfrm>
           <a:prstGeom prst="straightConnector1">
             <a:avLst/>
@@ -37693,49 +37689,6 @@
       </p:cxnSp>
       <p:cxnSp>
         <p:nvCxnSpPr>
-          <p:cNvPr id="113" name="Gerade Verbindung mit Pfeil 146">
-            <a:extLst>
-              <a:ext uri="{FF2B5EF4-FFF2-40B4-BE49-F238E27FC236}">
-                <a16:creationId xmlns:a16="http://schemas.microsoft.com/office/drawing/2014/main" id="{931477AF-1141-F35E-70BA-9FF1B2A8B638}"/>
-              </a:ext>
-            </a:extLst>
-          </p:cNvPr>
-          <p:cNvCxnSpPr>
-            <a:cxnSpLocks/>
-          </p:cNvCxnSpPr>
-          <p:nvPr/>
-        </p:nvCxnSpPr>
-        <p:spPr>
-          <a:xfrm flipV="1">
-            <a:off x="7969527" y="5098014"/>
-            <a:ext cx="2947313" cy="882620"/>
-          </a:xfrm>
-          <a:prstGeom prst="straightConnector1">
-            <a:avLst/>
-          </a:prstGeom>
-          <a:ln w="0">
-            <a:noFill/>
-            <a:prstDash val="solid"/>
-            <a:tailEnd type="triangle"/>
-          </a:ln>
-        </p:spPr>
-        <p:style>
-          <a:lnRef idx="1">
-            <a:schemeClr val="accent1"/>
-          </a:lnRef>
-          <a:fillRef idx="0">
-            <a:schemeClr val="accent1"/>
-          </a:fillRef>
-          <a:effectRef idx="0">
-            <a:schemeClr val="accent1"/>
-          </a:effectRef>
-          <a:fontRef idx="minor">
-            <a:schemeClr val="tx1"/>
-          </a:fontRef>
-        </p:style>
-      </p:cxnSp>
-      <p:cxnSp>
-        <p:nvCxnSpPr>
           <p:cNvPr id="114" name="Gerade Verbindung mit Pfeil 148">
             <a:extLst>
               <a:ext uri="{FF2B5EF4-FFF2-40B4-BE49-F238E27FC236}">
@@ -37751,9 +37704,9 @@
           <p:nvPr/>
         </p:nvCxnSpPr>
         <p:spPr>
-          <a:xfrm flipH="1" flipV="1">
-            <a:off x="6593315" y="3209965"/>
-            <a:ext cx="1265175" cy="18364"/>
+          <a:xfrm flipH="1">
+            <a:off x="6593315" y="3195224"/>
+            <a:ext cx="1265175" cy="0"/>
           </a:xfrm>
           <a:prstGeom prst="straightConnector1">
             <a:avLst/>
@@ -37931,7 +37884,7 @@
         <p:spPr>
           <a:xfrm>
             <a:off x="2205504" y="2004599"/>
-            <a:ext cx="430812" cy="0"/>
+            <a:ext cx="353315" cy="0"/>
           </a:xfrm>
           <a:prstGeom prst="straightConnector1">
             <a:avLst/>
@@ -37969,7 +37922,7 @@
         </p:nvGrpSpPr>
         <p:grpSpPr>
           <a:xfrm>
-            <a:off x="2636316" y="1570799"/>
+            <a:off x="2558819" y="1570799"/>
             <a:ext cx="1735200" cy="867600"/>
             <a:chOff x="2636316" y="1570799"/>
             <a:chExt cx="1735200" cy="867600"/>
@@ -38034,7 +37987,7 @@
                 <a:buNone/>
               </a:pPr>
               <a:r>
-                <a:rPr lang="de-CH" sz="1200" dirty="0">
+                <a:rPr lang="de-CH" sz="1000" dirty="0">
                   <a:solidFill>
                     <a:schemeClr val="bg2">
                       <a:lumMod val="10000"/>
@@ -38043,7 +37996,7 @@
                 </a:rPr>
                 <a:t>Embedding LLM</a:t>
               </a:r>
-              <a:endParaRPr sz="1200" dirty="0">
+              <a:endParaRPr sz="1000" dirty="0">
                 <a:solidFill>
                   <a:schemeClr val="bg2">
                     <a:lumMod val="10000"/>
@@ -38068,16 +38021,15 @@
             <p:nvPr/>
           </p:nvPicPr>
           <p:blipFill>
-            <a:blip r:embed="rId28">
+            <a:blip>
               <a:extLst>
                 <a:ext uri="{96DAC541-7B7A-43D3-8B79-37D633B846F1}">
-                  <ns9:svgBlip xmlns:ns9="http://schemas.microsoft.com/office/drawing/2016/SVG/main" r:embed="rId29"/>
+                  <asvg:svgBlip xmlns:asvg="http://schemas.microsoft.com/office/drawing/2016/SVG/main" r:embed="rId10"/>
                 </a:ext>
               </a:extLst>
             </a:blip>
-            <a:stretch>
-              <a:fillRect/>
-            </a:stretch>
+            <a:srcRect/>
+            <a:stretch/>
           </p:blipFill>
           <p:spPr>
             <a:xfrm>
@@ -38135,7 +38087,7 @@
             <a:bodyPr/>
             <a:lstStyle/>
             <a:p>
-              <a:endParaRPr lang="de-CH"/>
+              <a:endParaRPr lang="de-CH" sz="1000"/>
             </a:p>
           </p:txBody>
         </p:sp>
@@ -38158,8 +38110,8 @@
         </p:nvCxnSpPr>
         <p:spPr>
           <a:xfrm>
-            <a:off x="4371516" y="2004599"/>
-            <a:ext cx="490128" cy="7284"/>
+            <a:off x="4294019" y="2004599"/>
+            <a:ext cx="567625" cy="7284"/>
           </a:xfrm>
           <a:prstGeom prst="straightConnector1">
             <a:avLst/>
@@ -38256,8 +38208,8 @@
         </p:nvCxnSpPr>
         <p:spPr>
           <a:xfrm flipH="1" flipV="1">
-            <a:off x="1342908" y="4808134"/>
-            <a:ext cx="1307" cy="335366"/>
+            <a:off x="1192712" y="4755475"/>
+            <a:ext cx="151503" cy="387199"/>
           </a:xfrm>
           <a:prstGeom prst="straightConnector1">
             <a:avLst/>
@@ -38354,8 +38306,8 @@
         </p:nvCxnSpPr>
         <p:spPr>
           <a:xfrm>
-            <a:off x="8716042" y="2434208"/>
-            <a:ext cx="10048" cy="360321"/>
+            <a:off x="8716042" y="2374225"/>
+            <a:ext cx="10048" cy="387199"/>
           </a:xfrm>
           <a:prstGeom prst="straightConnector1">
             <a:avLst/>
@@ -38403,7 +38355,7 @@
         <p:spPr>
           <a:xfrm>
             <a:off x="5713094" y="2445683"/>
-            <a:ext cx="12621" cy="330482"/>
+            <a:ext cx="12621" cy="315741"/>
           </a:xfrm>
           <a:prstGeom prst="straightConnector1">
             <a:avLst/>
@@ -38444,15 +38396,15 @@
           </p:cNvPr>
           <p:cNvCxnSpPr>
             <a:cxnSpLocks/>
-            <a:stCxn id="74" idx="2"/>
-            <a:endCxn id="87" idx="0"/>
+            <a:stCxn id="72" idx="2"/>
+            <a:endCxn id="81" idx="0"/>
           </p:cNvCxnSpPr>
           <p:nvPr/>
         </p:nvCxnSpPr>
         <p:spPr>
           <a:xfrm>
-            <a:off x="5725715" y="3642941"/>
-            <a:ext cx="0" cy="1537091"/>
+            <a:off x="5725715" y="3629024"/>
+            <a:ext cx="0" cy="1532329"/>
           </a:xfrm>
           <a:prstGeom prst="straightConnector1">
             <a:avLst/>
@@ -38555,7 +38507,7 @@
                 <a:buNone/>
               </a:pPr>
               <a:r>
-                <a:rPr lang="de-CH" sz="1200" dirty="0">
+                <a:rPr lang="de-CH" sz="1000" dirty="0">
                   <a:solidFill>
                     <a:schemeClr val="bg2">
                       <a:lumMod val="10000"/>
@@ -38564,7 +38516,7 @@
                 </a:rPr>
                 <a:t>Chunks</a:t>
               </a:r>
-              <a:endParaRPr sz="1200" dirty="0">
+              <a:endParaRPr sz="1000" dirty="0">
                 <a:solidFill>
                   <a:schemeClr val="bg2">
                     <a:lumMod val="10000"/>
@@ -38589,7 +38541,7 @@
             <p:nvPr/>
           </p:nvPicPr>
           <p:blipFill>
-            <a:blip r:embed="rId12"/>
+            <a:blip r:embed="rId11"/>
             <a:stretch>
               <a:fillRect/>
             </a:stretch>
@@ -38652,17 +38604,17 @@
             <a:bodyPr/>
             <a:lstStyle/>
             <a:p>
-              <a:endParaRPr lang="de-CH"/>
+              <a:endParaRPr lang="de-CH" sz="1000"/>
             </a:p>
           </p:txBody>
         </p:sp>
       </p:grpSp>
       <p:grpSp>
         <p:nvGrpSpPr>
-          <p:cNvPr id="29" name="Gruppieren 28">
-            <a:extLst>
-              <a:ext uri="{FF2B5EF4-FFF2-40B4-BE49-F238E27FC236}">
-                <a16:creationId xmlns:a16="http://schemas.microsoft.com/office/drawing/2014/main" id="{7E49CBB9-D26E-EAFB-D6EA-C3D737912938}"/>
+          <p:cNvPr id="39" name="Gruppieren 38">
+            <a:extLst>
+              <a:ext uri="{FF2B5EF4-FFF2-40B4-BE49-F238E27FC236}">
+                <a16:creationId xmlns:a16="http://schemas.microsoft.com/office/drawing/2014/main" id="{1CE371FF-AA8D-9463-C284-4D4EC69E806E}"/>
               </a:ext>
             </a:extLst>
           </p:cNvPr>
@@ -38671,9 +38623,9 @@
         </p:nvGrpSpPr>
         <p:grpSpPr>
           <a:xfrm>
-            <a:off x="7858490" y="2794529"/>
+            <a:off x="7858490" y="2761424"/>
             <a:ext cx="1735200" cy="867600"/>
-            <a:chOff x="7858490" y="5161353"/>
+            <a:chOff x="7858490" y="2794529"/>
             <a:chExt cx="1735200" cy="867600"/>
           </a:xfrm>
         </p:grpSpPr>
@@ -38693,20 +38645,20 @@
           </p:nvSpPr>
           <p:spPr>
             <a:xfrm>
-              <a:off x="7858490" y="5161353"/>
+              <a:off x="7858490" y="2794529"/>
               <a:ext cx="1735200" cy="867600"/>
             </a:xfrm>
             <a:prstGeom prst="roundRect">
               <a:avLst/>
             </a:prstGeom>
             <a:solidFill>
-              <a:schemeClr val="bg2">
+              <a:schemeClr val="accent2">
                 <a:alpha val="50000"/>
               </a:schemeClr>
             </a:solidFill>
             <a:ln>
               <a:solidFill>
-                <a:schemeClr val="bg2">
+                <a:schemeClr val="accent2">
                   <a:lumMod val="50000"/>
                 </a:schemeClr>
               </a:solidFill>
@@ -38732,20 +38684,18 @@
             <a:bodyPr tIns="28800" anchor="t"/>
             <a:lstStyle/>
             <a:p>
-              <a:pPr algn="ctr">
-                <a:buNone/>
-              </a:pPr>
+              <a:pPr algn="ctr"/>
               <a:r>
-                <a:rPr lang="de-CH" sz="1200" dirty="0">
+                <a:rPr lang="de-CH" sz="1000" dirty="0" err="1">
                   <a:solidFill>
                     <a:schemeClr val="bg2">
                       <a:lumMod val="10000"/>
                     </a:schemeClr>
                   </a:solidFill>
                 </a:rPr>
-                <a:t>Embedding</a:t>
+                <a:t>Embeddings</a:t>
               </a:r>
-              <a:endParaRPr sz="1200" dirty="0">
+              <a:endParaRPr sz="1000" dirty="0">
                 <a:solidFill>
                   <a:schemeClr val="bg2">
                     <a:lumMod val="10000"/>
@@ -38770,20 +38720,19 @@
             <p:nvPr/>
           </p:nvPicPr>
           <p:blipFill>
-            <a:blip r:embed="rId22">
+            <a:blip>
               <a:extLst>
                 <a:ext uri="{96DAC541-7B7A-43D3-8B79-37D633B846F1}">
-                  <ns10:svgBlip xmlns:ns10="http://schemas.microsoft.com/office/drawing/2016/SVG/main" r:embed="rId23"/>
+                  <asvg:svgBlip xmlns:asvg="http://schemas.microsoft.com/office/drawing/2016/SVG/main" r:embed="rId7"/>
                 </a:ext>
               </a:extLst>
             </a:blip>
-            <a:stretch>
-              <a:fillRect/>
-            </a:stretch>
+            <a:srcRect/>
+            <a:stretch/>
           </p:blipFill>
           <p:spPr>
             <a:xfrm>
-              <a:off x="8492090" y="5496779"/>
+              <a:off x="8492090" y="3129955"/>
               <a:ext cx="468000" cy="468000"/>
             </a:xfrm>
             <a:prstGeom prst="rect">
@@ -38807,7 +38756,7 @@
           </p:nvSpPr>
           <p:spPr>
             <a:xfrm flipV="1">
-              <a:off x="7858490" y="5449914"/>
+              <a:off x="7858490" y="3083090"/>
               <a:ext cx="1735200" cy="0"/>
             </a:xfrm>
             <a:prstGeom prst="line">
@@ -38839,11 +38788,244 @@
             <a:bodyPr/>
             <a:lstStyle/>
             <a:p>
-              <a:endParaRPr lang="de-CH"/>
+              <a:endParaRPr lang="de-CH" sz="1000"/>
             </a:p>
           </p:txBody>
         </p:sp>
       </p:grpSp>
+      <p:grpSp>
+        <p:nvGrpSpPr>
+          <p:cNvPr id="23" name="Gruppe Embedding LLM">
+            <a:extLst>
+              <a:ext uri="{FF2B5EF4-FFF2-40B4-BE49-F238E27FC236}">
+                <a16:creationId xmlns:a16="http://schemas.microsoft.com/office/drawing/2014/main" id="{D25D0927-7500-9C4D-B2AC-C86A40E321DD}"/>
+              </a:ext>
+            </a:extLst>
+          </p:cNvPr>
+          <p:cNvGrpSpPr/>
+          <p:nvPr/>
+        </p:nvGrpSpPr>
+        <p:grpSpPr>
+          <a:xfrm>
+            <a:off x="2543715" y="3952049"/>
+            <a:ext cx="1735200" cy="867600"/>
+            <a:chOff x="2636316" y="1570799"/>
+            <a:chExt cx="1735200" cy="867600"/>
+          </a:xfrm>
+        </p:grpSpPr>
+        <p:sp>
+          <p:nvSpPr>
+            <p:cNvPr id="25" name="Rechteck: abgerundete Ecken 24">
+              <a:extLst>
+                <a:ext uri="{FF2B5EF4-FFF2-40B4-BE49-F238E27FC236}">
+                  <a16:creationId xmlns:a16="http://schemas.microsoft.com/office/drawing/2014/main" id="{6FECBFFE-AEE2-FC47-F568-0299509D082E}"/>
+                </a:ext>
+              </a:extLst>
+            </p:cNvPr>
+            <p:cNvSpPr>
+              <a:spLocks/>
+            </p:cNvSpPr>
+            <p:nvPr/>
+          </p:nvSpPr>
+          <p:spPr>
+            <a:xfrm>
+              <a:off x="2636316" y="1570799"/>
+              <a:ext cx="1735200" cy="867600"/>
+            </a:xfrm>
+            <a:prstGeom prst="roundRect">
+              <a:avLst/>
+            </a:prstGeom>
+            <a:solidFill>
+              <a:schemeClr val="accent6">
+                <a:lumMod val="40000"/>
+                <a:lumOff val="60000"/>
+                <a:alpha val="50000"/>
+              </a:schemeClr>
+            </a:solidFill>
+            <a:ln>
+              <a:solidFill>
+                <a:srgbClr val="FFC000"/>
+              </a:solidFill>
+            </a:ln>
+          </p:spPr>
+          <p:style>
+            <a:lnRef idx="2">
+              <a:schemeClr val="accent1">
+                <a:shade val="15000"/>
+              </a:schemeClr>
+            </a:lnRef>
+            <a:fillRef idx="1">
+              <a:schemeClr val="accent1"/>
+            </a:fillRef>
+            <a:effectRef idx="0">
+              <a:schemeClr val="accent1"/>
+            </a:effectRef>
+            <a:fontRef idx="minor">
+              <a:schemeClr val="lt1"/>
+            </a:fontRef>
+          </p:style>
+          <p:txBody>
+            <a:bodyPr tIns="28800" anchor="t"/>
+            <a:lstStyle/>
+            <a:p>
+              <a:pPr algn="ctr">
+                <a:buNone/>
+              </a:pPr>
+              <a:r>
+                <a:rPr lang="de-CH" sz="1000" dirty="0">
+                  <a:solidFill>
+                    <a:schemeClr val="bg2">
+                      <a:lumMod val="10000"/>
+                    </a:schemeClr>
+                  </a:solidFill>
+                </a:rPr>
+                <a:t>Graph Engine</a:t>
+              </a:r>
+              <a:endParaRPr sz="1000" dirty="0">
+                <a:solidFill>
+                  <a:schemeClr val="bg2">
+                    <a:lumMod val="10000"/>
+                  </a:schemeClr>
+                </a:solidFill>
+              </a:endParaRPr>
+            </a:p>
+          </p:txBody>
+        </p:sp>
+        <p:pic>
+          <p:nvPicPr>
+            <p:cNvPr id="31" name="Grafik 39">
+              <a:extLst>
+                <a:ext uri="{FF2B5EF4-FFF2-40B4-BE49-F238E27FC236}">
+                  <a16:creationId xmlns:a16="http://schemas.microsoft.com/office/drawing/2014/main" id="{0EFCE21A-B763-94D4-1211-67A4EFC1BF9B}"/>
+                </a:ext>
+              </a:extLst>
+            </p:cNvPr>
+            <p:cNvPicPr>
+              <a:picLocks noChangeAspect="1"/>
+            </p:cNvPicPr>
+            <p:nvPr/>
+          </p:nvPicPr>
+          <p:blipFill>
+            <a:blip>
+              <a:extLst>
+                <a:ext uri="{96DAC541-7B7A-43D3-8B79-37D633B846F1}">
+                  <asvg:svgBlip xmlns:asvg="http://schemas.microsoft.com/office/drawing/2016/SVG/main" r:embed="rId12"/>
+                </a:ext>
+              </a:extLst>
+            </a:blip>
+            <a:srcRect/>
+            <a:stretch/>
+          </p:blipFill>
+          <p:spPr>
+            <a:xfrm>
+              <a:off x="3269916" y="1906225"/>
+              <a:ext cx="468000" cy="468000"/>
+            </a:xfrm>
+            <a:prstGeom prst="rect">
+              <a:avLst/>
+            </a:prstGeom>
+          </p:spPr>
+        </p:pic>
+        <p:sp>
+          <p:nvSpPr>
+            <p:cNvPr id="36" name="Gerader Verbinder 35">
+              <a:extLst>
+                <a:ext uri="{FF2B5EF4-FFF2-40B4-BE49-F238E27FC236}">
+                  <a16:creationId xmlns:a16="http://schemas.microsoft.com/office/drawing/2014/main" id="{7AF572F4-9F0D-9BB4-7971-013A069E5F43}"/>
+                </a:ext>
+              </a:extLst>
+            </p:cNvPr>
+            <p:cNvSpPr>
+              <a:spLocks/>
+            </p:cNvSpPr>
+            <p:nvPr/>
+          </p:nvSpPr>
+          <p:spPr>
+            <a:xfrm>
+              <a:off x="2636316" y="1859360"/>
+              <a:ext cx="1735200" cy="0"/>
+            </a:xfrm>
+            <a:prstGeom prst="line">
+              <a:avLst/>
+            </a:prstGeom>
+            <a:ln>
+              <a:solidFill>
+                <a:srgbClr val="FA9400"/>
+              </a:solidFill>
+            </a:ln>
+          </p:spPr>
+          <p:style>
+            <a:lnRef idx="1">
+              <a:schemeClr val="accent1"/>
+            </a:lnRef>
+            <a:fillRef idx="0">
+              <a:schemeClr val="accent1"/>
+            </a:fillRef>
+            <a:effectRef idx="0">
+              <a:schemeClr val="accent1"/>
+            </a:effectRef>
+            <a:fontRef idx="minor">
+              <a:schemeClr val="tx1"/>
+            </a:fontRef>
+          </p:style>
+          <p:txBody>
+            <a:bodyPr/>
+            <a:lstStyle/>
+            <a:p>
+              <a:endParaRPr lang="de-CH" sz="1000"/>
+            </a:p>
+          </p:txBody>
+        </p:sp>
+      </p:grpSp>
+      <p:cxnSp>
+        <p:nvCxnSpPr>
+          <p:cNvPr id="43" name="Gerade Verbindung mit Pfeil 116">
+            <a:extLst>
+              <a:ext uri="{FF2B5EF4-FFF2-40B4-BE49-F238E27FC236}">
+                <a16:creationId xmlns:a16="http://schemas.microsoft.com/office/drawing/2014/main" id="{3BE2586C-9C1C-363F-5145-8C1A7F21DECA}"/>
+              </a:ext>
+            </a:extLst>
+          </p:cNvPr>
+          <p:cNvCxnSpPr>
+            <a:cxnSpLocks/>
+            <a:stCxn id="37" idx="3"/>
+            <a:endCxn id="25" idx="1"/>
+          </p:cNvCxnSpPr>
+          <p:nvPr/>
+        </p:nvCxnSpPr>
+        <p:spPr>
+          <a:xfrm>
+            <a:off x="1910115" y="4385849"/>
+            <a:ext cx="633600" cy="0"/>
+          </a:xfrm>
+          <a:prstGeom prst="straightConnector1">
+            <a:avLst/>
+          </a:prstGeom>
+          <a:ln w="50800">
+            <a:solidFill>
+              <a:schemeClr val="tx1">
+                <a:alpha val="50000"/>
+              </a:schemeClr>
+            </a:solidFill>
+            <a:prstDash val="solid"/>
+            <a:tailEnd type="triangle"/>
+          </a:ln>
+        </p:spPr>
+        <p:style>
+          <a:lnRef idx="1">
+            <a:schemeClr val="accent1"/>
+          </a:lnRef>
+          <a:fillRef idx="0">
+            <a:schemeClr val="accent1"/>
+          </a:fillRef>
+          <a:effectRef idx="0">
+            <a:schemeClr val="accent1"/>
+          </a:effectRef>
+          <a:fontRef idx="minor">
+            <a:schemeClr val="tx1"/>
+          </a:fontRef>
+        </p:style>
+      </p:cxnSp>
     </p:spTree>
     <p:extLst>
       <p:ext uri="{BB962C8B-B14F-4D97-AF65-F5344CB8AC3E}">
@@ -38929,14 +39111,14 @@
                                 </p:cTn>
                               </p:par>
                               <p:par>
-                                <p:cTn id="11" presetID="1" presetClass="entr" presetSubtype="0" fill="hold" nodeType="withEffect">
+                                <p:cTn id="9" presetID="1" presetClass="entr" presetSubtype="0" fill="hold" nodeType="withEffect">
                                   <p:stCondLst>
                                     <p:cond delay="0"/>
                                   </p:stCondLst>
                                   <p:childTnLst>
                                     <p:set>
                                       <p:cBhvr>
-                                        <p:cTn id="12" dur="1" fill="hold">
+                                        <p:cTn id="10" dur="1" fill="hold">
                                           <p:stCondLst>
                                             <p:cond delay="0"/>
                                           </p:stCondLst>
@@ -38962,26 +39144,26 @@
                     </p:cTn>
                   </p:par>
                   <p:par>
-                    <p:cTn id="13" fill="hold">
+                    <p:cTn id="11" fill="hold">
                       <p:stCondLst>
                         <p:cond delay="indefinite"/>
                       </p:stCondLst>
                       <p:childTnLst>
                         <p:par>
-                          <p:cTn id="14" fill="hold">
+                          <p:cTn id="12" fill="hold">
                             <p:stCondLst>
                               <p:cond delay="0"/>
                             </p:stCondLst>
                             <p:childTnLst>
                               <p:par>
-                                <p:cTn id="15" presetID="1" presetClass="entr" presetSubtype="0" fill="hold" nodeType="clickEffect">
+                                <p:cTn id="13" presetID="1" presetClass="entr" presetSubtype="0" fill="hold" nodeType="clickEffect">
                                   <p:stCondLst>
                                     <p:cond delay="0"/>
                                   </p:stCondLst>
                                   <p:childTnLst>
                                     <p:set>
                                       <p:cBhvr>
-                                        <p:cTn id="16" dur="1" fill="hold">
+                                        <p:cTn id="14" dur="1" fill="hold">
                                           <p:stCondLst>
                                             <p:cond delay="0"/>
                                           </p:stCondLst>
@@ -39001,14 +39183,14 @@
                                 </p:cTn>
                               </p:par>
                               <p:par>
-                                <p:cTn id="19" presetID="1" presetClass="entr" presetSubtype="0" fill="hold" nodeType="withEffect">
+                                <p:cTn id="15" presetID="1" presetClass="entr" presetSubtype="0" fill="hold" nodeType="withEffect">
                                   <p:stCondLst>
                                     <p:cond delay="0"/>
                                   </p:stCondLst>
                                   <p:childTnLst>
                                     <p:set>
                                       <p:cBhvr>
-                                        <p:cTn id="20" dur="1" fill="hold">
+                                        <p:cTn id="16" dur="1" fill="hold">
                                           <p:stCondLst>
                                             <p:cond delay="0"/>
                                           </p:stCondLst>
@@ -39028,14 +39210,14 @@
                                 </p:cTn>
                               </p:par>
                               <p:par>
-                                <p:cTn id="21" presetID="1" presetClass="entr" presetSubtype="0" fill="hold" nodeType="withEffect">
+                                <p:cTn id="17" presetID="1" presetClass="entr" presetSubtype="0" fill="hold" nodeType="withEffect">
                                   <p:stCondLst>
                                     <p:cond delay="0"/>
                                   </p:stCondLst>
                                   <p:childTnLst>
                                     <p:set>
                                       <p:cBhvr>
-                                        <p:cTn id="22" dur="1" fill="hold">
+                                        <p:cTn id="18" dur="1" fill="hold">
                                           <p:stCondLst>
                                             <p:cond delay="0"/>
                                           </p:stCondLst>
@@ -39061,19 +39243,73 @@
                     </p:cTn>
                   </p:par>
                   <p:par>
-                    <p:cTn id="23" fill="hold">
+                    <p:cTn id="19" fill="hold">
                       <p:stCondLst>
                         <p:cond delay="indefinite"/>
                       </p:stCondLst>
                       <p:childTnLst>
                         <p:par>
-                          <p:cTn id="24" fill="hold">
+                          <p:cTn id="20" fill="hold">
                             <p:stCondLst>
                               <p:cond delay="0"/>
                             </p:stCondLst>
                             <p:childTnLst>
                               <p:par>
-                                <p:cTn id="25" presetID="1" presetClass="entr" presetSubtype="0" fill="hold" nodeType="clickEffect">
+                                <p:cTn id="21" presetID="1" presetClass="entr" presetSubtype="0" fill="hold" nodeType="clickEffect">
+                                  <p:stCondLst>
+                                    <p:cond delay="0"/>
+                                  </p:stCondLst>
+                                  <p:childTnLst>
+                                    <p:set>
+                                      <p:cBhvr>
+                                        <p:cTn id="22" dur="1" fill="hold">
+                                          <p:stCondLst>
+                                            <p:cond delay="0"/>
+                                          </p:stCondLst>
+                                        </p:cTn>
+                                        <p:tgtEl>
+                                          <p:spTgt spid="37"/>
+                                        </p:tgtEl>
+                                        <p:attrNameLst>
+                                          <p:attrName>style.visibility</p:attrName>
+                                        </p:attrNameLst>
+                                      </p:cBhvr>
+                                      <p:to>
+                                        <p:strVal val="visible"/>
+                                      </p:to>
+                                    </p:set>
+                                  </p:childTnLst>
+                                </p:cTn>
+                              </p:par>
+                              <p:par>
+                                <p:cTn id="23" presetID="1" presetClass="entr" presetSubtype="0" fill="hold" nodeType="withEffect">
+                                  <p:stCondLst>
+                                    <p:cond delay="0"/>
+                                  </p:stCondLst>
+                                  <p:childTnLst>
+                                    <p:set>
+                                      <p:cBhvr>
+                                        <p:cTn id="24" dur="1" fill="hold">
+                                          <p:stCondLst>
+                                            <p:cond delay="0"/>
+                                          </p:stCondLst>
+                                        </p:cTn>
+                                        <p:tgtEl>
+                                          <p:spTgt spid="42"/>
+                                        </p:tgtEl>
+                                        <p:attrNameLst>
+                                          <p:attrName>style.visibility</p:attrName>
+                                        </p:attrNameLst>
+                                      </p:cBhvr>
+                                      <p:to>
+                                        <p:strVal val="visible"/>
+                                      </p:to>
+                                    </p:set>
+                                  </p:childTnLst>
+                                </p:cTn>
+                              </p:par>
+                              <p:par>
+                                <p:cTn id="25" presetID="1" presetClass="entr" presetSubtype="0" fill="hold" nodeType="withEffect">
                                   <p:stCondLst>
                                     <p:cond delay="0"/>
                                   </p:stCondLst>
@@ -39086,7 +39322,7 @@
                                           </p:stCondLst>
                                         </p:cTn>
                                         <p:tgtEl>
-                                          <p:spTgt spid="37"/>
+                                          <p:spTgt spid="44"/>
                                         </p:tgtEl>
                                         <p:attrNameLst>
                                           <p:attrName>style.visibility</p:attrName>
@@ -39113,7 +39349,34 @@
                                           </p:stCondLst>
                                         </p:cTn>
                                         <p:tgtEl>
-                                          <p:spTgt spid="42"/>
+                                          <p:spTgt spid="109"/>
+                                        </p:tgtEl>
+                                        <p:attrNameLst>
+                                          <p:attrName>style.visibility</p:attrName>
+                                        </p:attrNameLst>
+                                      </p:cBhvr>
+                                      <p:to>
+                                        <p:strVal val="visible"/>
+                                      </p:to>
+                                    </p:set>
+                                  </p:childTnLst>
+                                </p:cTn>
+                              </p:par>
+                              <p:par>
+                                <p:cTn id="29" presetID="1" presetClass="entr" presetSubtype="0" fill="hold" nodeType="withEffect">
+                                  <p:stCondLst>
+                                    <p:cond delay="0"/>
+                                  </p:stCondLst>
+                                  <p:childTnLst>
+                                    <p:set>
+                                      <p:cBhvr>
+                                        <p:cTn id="30" dur="1" fill="hold">
+                                          <p:stCondLst>
+                                            <p:cond delay="0"/>
+                                          </p:stCondLst>
+                                        </p:cTn>
+                                        <p:tgtEl>
+                                          <p:spTgt spid="46"/>
                                         </p:tgtEl>
                                         <p:attrNameLst>
                                           <p:attrName>style.visibility</p:attrName>
@@ -39140,7 +39403,34 @@
                                           </p:stCondLst>
                                         </p:cTn>
                                         <p:tgtEl>
-                                          <p:spTgt spid="44"/>
+                                          <p:spTgt spid="124"/>
+                                        </p:tgtEl>
+                                        <p:attrNameLst>
+                                          <p:attrName>style.visibility</p:attrName>
+                                        </p:attrNameLst>
+                                      </p:cBhvr>
+                                      <p:to>
+                                        <p:strVal val="visible"/>
+                                      </p:to>
+                                    </p:set>
+                                  </p:childTnLst>
+                                </p:cTn>
+                              </p:par>
+                              <p:par>
+                                <p:cTn id="33" presetID="1" presetClass="entr" presetSubtype="0" fill="hold" nodeType="withEffect">
+                                  <p:stCondLst>
+                                    <p:cond delay="0"/>
+                                  </p:stCondLst>
+                                  <p:childTnLst>
+                                    <p:set>
+                                      <p:cBhvr>
+                                        <p:cTn id="34" dur="1" fill="hold">
+                                          <p:stCondLst>
+                                            <p:cond delay="0"/>
+                                          </p:stCondLst>
+                                        </p:cTn>
+                                        <p:tgtEl>
+                                          <p:spTgt spid="121"/>
                                         </p:tgtEl>
                                         <p:attrNameLst>
                                           <p:attrName>style.visibility</p:attrName>
@@ -39160,19 +39450,19 @@
                     </p:cTn>
                   </p:par>
                   <p:par>
-                    <p:cTn id="33" fill="hold">
+                    <p:cTn id="35" fill="hold">
                       <p:stCondLst>
                         <p:cond delay="indefinite"/>
                       </p:stCondLst>
                       <p:childTnLst>
                         <p:par>
-                          <p:cTn id="34" fill="hold">
+                          <p:cTn id="36" fill="hold">
                             <p:stCondLst>
                               <p:cond delay="0"/>
                             </p:stCondLst>
                             <p:childTnLst>
                               <p:par>
-                                <p:cTn id="37" presetID="1" presetClass="entr" presetSubtype="0" fill="hold" nodeType="withEffect">
+                                <p:cTn id="37" presetID="1" presetClass="entr" presetSubtype="0" fill="hold" nodeType="clickEffect">
                                   <p:stCondLst>
                                     <p:cond delay="0"/>
                                   </p:stCondLst>
@@ -39185,7 +39475,7 @@
                                           </p:stCondLst>
                                         </p:cTn>
                                         <p:tgtEl>
-                                          <p:spTgt spid="51"/>
+                                          <p:spTgt spid="137"/>
                                         </p:tgtEl>
                                         <p:attrNameLst>
                                           <p:attrName>style.visibility</p:attrName>
@@ -39212,7 +39502,7 @@
                                           </p:stCondLst>
                                         </p:cTn>
                                         <p:tgtEl>
-                                          <p:spTgt spid="109"/>
+                                          <p:spTgt spid="138"/>
                                         </p:tgtEl>
                                         <p:attrNameLst>
                                           <p:attrName>style.visibility</p:attrName>
@@ -39239,231 +39529,6 @@
                                           </p:stCondLst>
                                         </p:cTn>
                                         <p:tgtEl>
-                                          <p:spTgt spid="45"/>
-                                        </p:tgtEl>
-                                        <p:attrNameLst>
-                                          <p:attrName>style.visibility</p:attrName>
-                                        </p:attrNameLst>
-                                      </p:cBhvr>
-                                      <p:to>
-                                        <p:strVal val="visible"/>
-                                      </p:to>
-                                    </p:set>
-                                  </p:childTnLst>
-                                </p:cTn>
-                              </p:par>
-                              <p:par>
-                                <p:cTn id="43" presetID="1" presetClass="entr" presetSubtype="0" fill="hold" nodeType="withEffect">
-                                  <p:stCondLst>
-                                    <p:cond delay="0"/>
-                                  </p:stCondLst>
-                                  <p:childTnLst>
-                                    <p:set>
-                                      <p:cBhvr>
-                                        <p:cTn id="44" dur="1" fill="hold">
-                                          <p:stCondLst>
-                                            <p:cond delay="0"/>
-                                          </p:stCondLst>
-                                        </p:cTn>
-                                        <p:tgtEl>
-                                          <p:spTgt spid="46"/>
-                                        </p:tgtEl>
-                                        <p:attrNameLst>
-                                          <p:attrName>style.visibility</p:attrName>
-                                        </p:attrNameLst>
-                                      </p:cBhvr>
-                                      <p:to>
-                                        <p:strVal val="visible"/>
-                                      </p:to>
-                                    </p:set>
-                                  </p:childTnLst>
-                                </p:cTn>
-                              </p:par>
-                            </p:childTnLst>
-                          </p:cTn>
-                        </p:par>
-                      </p:childTnLst>
-                    </p:cTn>
-                  </p:par>
-                  <p:par>
-                    <p:cTn id="45" fill="hold">
-                      <p:stCondLst>
-                        <p:cond delay="indefinite"/>
-                      </p:stCondLst>
-                      <p:childTnLst>
-                        <p:par>
-                          <p:cTn id="46" fill="hold">
-                            <p:stCondLst>
-                              <p:cond delay="0"/>
-                            </p:stCondLst>
-                            <p:childTnLst>
-                              <p:par>
-                                <p:cTn id="47" presetID="1" presetClass="entr" presetSubtype="0" fill="hold" nodeType="clickEffect">
-                                  <p:stCondLst>
-                                    <p:cond delay="0"/>
-                                  </p:stCondLst>
-                                  <p:childTnLst>
-                                    <p:set>
-                                      <p:cBhvr>
-                                        <p:cTn id="48" dur="1" fill="hold">
-                                          <p:stCondLst>
-                                            <p:cond delay="0"/>
-                                          </p:stCondLst>
-                                        </p:cTn>
-                                        <p:tgtEl>
-                                          <p:spTgt spid="122"/>
-                                        </p:tgtEl>
-                                        <p:attrNameLst>
-                                          <p:attrName>style.visibility</p:attrName>
-                                        </p:attrNameLst>
-                                      </p:cBhvr>
-                                      <p:to>
-                                        <p:strVal val="visible"/>
-                                      </p:to>
-                                    </p:set>
-                                  </p:childTnLst>
-                                </p:cTn>
-                              </p:par>
-                              <p:par>
-                                <p:cTn id="51" presetID="1" presetClass="entr" presetSubtype="0" fill="hold" nodeType="withEffect">
-                                  <p:stCondLst>
-                                    <p:cond delay="0"/>
-                                  </p:stCondLst>
-                                  <p:childTnLst>
-                                    <p:set>
-                                      <p:cBhvr>
-                                        <p:cTn id="52" dur="1" fill="hold">
-                                          <p:stCondLst>
-                                            <p:cond delay="0"/>
-                                          </p:stCondLst>
-                                        </p:cTn>
-                                        <p:tgtEl>
-                                          <p:spTgt spid="124"/>
-                                        </p:tgtEl>
-                                        <p:attrNameLst>
-                                          <p:attrName>style.visibility</p:attrName>
-                                        </p:attrNameLst>
-                                      </p:cBhvr>
-                                      <p:to>
-                                        <p:strVal val="visible"/>
-                                      </p:to>
-                                    </p:set>
-                                  </p:childTnLst>
-                                </p:cTn>
-                              </p:par>
-                              <p:par>
-                                <p:cTn id="53" presetID="1" presetClass="entr" presetSubtype="0" fill="hold" nodeType="withEffect">
-                                  <p:stCondLst>
-                                    <p:cond delay="0"/>
-                                  </p:stCondLst>
-                                  <p:childTnLst>
-                                    <p:set>
-                                      <p:cBhvr>
-                                        <p:cTn id="54" dur="1" fill="hold">
-                                          <p:stCondLst>
-                                            <p:cond delay="0"/>
-                                          </p:stCondLst>
-                                        </p:cTn>
-                                        <p:tgtEl>
-                                          <p:spTgt spid="121"/>
-                                        </p:tgtEl>
-                                        <p:attrNameLst>
-                                          <p:attrName>style.visibility</p:attrName>
-                                        </p:attrNameLst>
-                                      </p:cBhvr>
-                                      <p:to>
-                                        <p:strVal val="visible"/>
-                                      </p:to>
-                                    </p:set>
-                                  </p:childTnLst>
-                                </p:cTn>
-                              </p:par>
-                            </p:childTnLst>
-                          </p:cTn>
-                        </p:par>
-                      </p:childTnLst>
-                    </p:cTn>
-                  </p:par>
-                  <p:par>
-                    <p:cTn id="55" fill="hold">
-                      <p:stCondLst>
-                        <p:cond delay="indefinite"/>
-                      </p:stCondLst>
-                      <p:childTnLst>
-                        <p:par>
-                          <p:cTn id="56" fill="hold">
-                            <p:stCondLst>
-                              <p:cond delay="0"/>
-                            </p:stCondLst>
-                            <p:childTnLst>
-                              <p:par>
-                                <p:cTn id="57" presetID="1" presetClass="entr" presetSubtype="0" fill="hold" nodeType="clickEffect">
-                                  <p:stCondLst>
-                                    <p:cond delay="0"/>
-                                  </p:stCondLst>
-                                  <p:childTnLst>
-                                    <p:set>
-                                      <p:cBhvr>
-                                        <p:cTn id="58" dur="1" fill="hold">
-                                          <p:stCondLst>
-                                            <p:cond delay="0"/>
-                                          </p:stCondLst>
-                                        </p:cTn>
-                                        <p:tgtEl>
-                                          <p:spTgt spid="137"/>
-                                        </p:tgtEl>
-                                        <p:attrNameLst>
-                                          <p:attrName>style.visibility</p:attrName>
-                                        </p:attrNameLst>
-                                      </p:cBhvr>
-                                      <p:to>
-                                        <p:strVal val="visible"/>
-                                      </p:to>
-                                    </p:set>
-                                  </p:childTnLst>
-                                </p:cTn>
-                              </p:par>
-                              <p:par>
-                                <p:cTn id="59" presetID="1" presetClass="entr" presetSubtype="0" fill="hold" nodeType="withEffect">
-                                  <p:stCondLst>
-                                    <p:cond delay="0"/>
-                                  </p:stCondLst>
-                                  <p:childTnLst>
-                                    <p:set>
-                                      <p:cBhvr>
-                                        <p:cTn id="60" dur="1" fill="hold">
-                                          <p:stCondLst>
-                                            <p:cond delay="0"/>
-                                          </p:stCondLst>
-                                        </p:cTn>
-                                        <p:tgtEl>
-                                          <p:spTgt spid="138"/>
-                                        </p:tgtEl>
-                                        <p:attrNameLst>
-                                          <p:attrName>style.visibility</p:attrName>
-                                        </p:attrNameLst>
-                                      </p:cBhvr>
-                                      <p:to>
-                                        <p:strVal val="visible"/>
-                                      </p:to>
-                                    </p:set>
-                                  </p:childTnLst>
-                                </p:cTn>
-                              </p:par>
-                              <p:par>
-                                <p:cTn id="61" presetID="1" presetClass="entr" presetSubtype="0" fill="hold" nodeType="withEffect">
-                                  <p:stCondLst>
-                                    <p:cond delay="0"/>
-                                  </p:stCondLst>
-                                  <p:childTnLst>
-                                    <p:set>
-                                      <p:cBhvr>
-                                        <p:cTn id="62" dur="1" fill="hold">
-                                          <p:stCondLst>
-                                            <p:cond delay="0"/>
-                                          </p:stCondLst>
-                                        </p:cTn>
-                                        <p:tgtEl>
                                           <p:spTgt spid="140"/>
                                         </p:tgtEl>
                                         <p:attrNameLst>
@@ -39484,19 +39549,298 @@
                     </p:cTn>
                   </p:par>
                   <p:par>
-                    <p:cTn id="65" fill="hold">
+                    <p:cTn id="43" fill="hold">
                       <p:stCondLst>
                         <p:cond delay="indefinite"/>
                       </p:stCondLst>
                       <p:childTnLst>
                         <p:par>
-                          <p:cTn id="66" fill="hold">
+                          <p:cTn id="44" fill="hold">
                             <p:stCondLst>
                               <p:cond delay="0"/>
                             </p:stCondLst>
                             <p:childTnLst>
                               <p:par>
-                                <p:cTn id="67" presetID="1" presetClass="entr" presetSubtype="0" fill="hold" nodeType="clickEffect">
+                                <p:cTn id="45" presetID="1" presetClass="entr" presetSubtype="0" fill="hold" nodeType="clickEffect">
+                                  <p:stCondLst>
+                                    <p:cond delay="0"/>
+                                  </p:stCondLst>
+                                  <p:childTnLst>
+                                    <p:set>
+                                      <p:cBhvr>
+                                        <p:cTn id="46" dur="1" fill="hold">
+                                          <p:stCondLst>
+                                            <p:cond delay="0"/>
+                                          </p:stCondLst>
+                                        </p:cTn>
+                                        <p:tgtEl>
+                                          <p:spTgt spid="54"/>
+                                        </p:tgtEl>
+                                        <p:attrNameLst>
+                                          <p:attrName>style.visibility</p:attrName>
+                                        </p:attrNameLst>
+                                      </p:cBhvr>
+                                      <p:to>
+                                        <p:strVal val="visible"/>
+                                      </p:to>
+                                    </p:set>
+                                  </p:childTnLst>
+                                </p:cTn>
+                              </p:par>
+                              <p:par>
+                                <p:cTn id="47" presetID="1" presetClass="entr" presetSubtype="0" fill="hold" nodeType="withEffect">
+                                  <p:stCondLst>
+                                    <p:cond delay="0"/>
+                                  </p:stCondLst>
+                                  <p:childTnLst>
+                                    <p:set>
+                                      <p:cBhvr>
+                                        <p:cTn id="48" dur="1" fill="hold">
+                                          <p:stCondLst>
+                                            <p:cond delay="0"/>
+                                          </p:stCondLst>
+                                        </p:cTn>
+                                        <p:tgtEl>
+                                          <p:spTgt spid="56"/>
+                                        </p:tgtEl>
+                                        <p:attrNameLst>
+                                          <p:attrName>style.visibility</p:attrName>
+                                        </p:attrNameLst>
+                                      </p:cBhvr>
+                                      <p:to>
+                                        <p:strVal val="visible"/>
+                                      </p:to>
+                                    </p:set>
+                                  </p:childTnLst>
+                                </p:cTn>
+                              </p:par>
+                              <p:par>
+                                <p:cTn id="49" presetID="1" presetClass="entr" presetSubtype="0" fill="hold" nodeType="withEffect">
+                                  <p:stCondLst>
+                                    <p:cond delay="0"/>
+                                  </p:stCondLst>
+                                  <p:childTnLst>
+                                    <p:set>
+                                      <p:cBhvr>
+                                        <p:cTn id="50" dur="1" fill="hold">
+                                          <p:stCondLst>
+                                            <p:cond delay="0"/>
+                                          </p:stCondLst>
+                                        </p:cTn>
+                                        <p:tgtEl>
+                                          <p:spTgt spid="58"/>
+                                        </p:tgtEl>
+                                        <p:attrNameLst>
+                                          <p:attrName>style.visibility</p:attrName>
+                                        </p:attrNameLst>
+                                      </p:cBhvr>
+                                      <p:to>
+                                        <p:strVal val="visible"/>
+                                      </p:to>
+                                    </p:set>
+                                  </p:childTnLst>
+                                </p:cTn>
+                              </p:par>
+                            </p:childTnLst>
+                          </p:cTn>
+                        </p:par>
+                      </p:childTnLst>
+                    </p:cTn>
+                  </p:par>
+                  <p:par>
+                    <p:cTn id="51" fill="hold">
+                      <p:stCondLst>
+                        <p:cond delay="indefinite"/>
+                      </p:stCondLst>
+                      <p:childTnLst>
+                        <p:par>
+                          <p:cTn id="52" fill="hold">
+                            <p:stCondLst>
+                              <p:cond delay="0"/>
+                            </p:stCondLst>
+                            <p:childTnLst>
+                              <p:par>
+                                <p:cTn id="53" presetID="1" presetClass="entr" presetSubtype="0" fill="hold" nodeType="clickEffect">
+                                  <p:stCondLst>
+                                    <p:cond delay="0"/>
+                                  </p:stCondLst>
+                                  <p:childTnLst>
+                                    <p:set>
+                                      <p:cBhvr>
+                                        <p:cTn id="54" dur="1" fill="hold">
+                                          <p:stCondLst>
+                                            <p:cond delay="0"/>
+                                          </p:stCondLst>
+                                        </p:cTn>
+                                        <p:tgtEl>
+                                          <p:spTgt spid="93"/>
+                                        </p:tgtEl>
+                                        <p:attrNameLst>
+                                          <p:attrName>style.visibility</p:attrName>
+                                        </p:attrNameLst>
+                                      </p:cBhvr>
+                                      <p:to>
+                                        <p:strVal val="visible"/>
+                                      </p:to>
+                                    </p:set>
+                                  </p:childTnLst>
+                                </p:cTn>
+                              </p:par>
+                              <p:par>
+                                <p:cTn id="55" presetID="1" presetClass="entr" presetSubtype="0" fill="hold" nodeType="withEffect">
+                                  <p:stCondLst>
+                                    <p:cond delay="0"/>
+                                  </p:stCondLst>
+                                  <p:childTnLst>
+                                    <p:set>
+                                      <p:cBhvr>
+                                        <p:cTn id="56" dur="1" fill="hold">
+                                          <p:stCondLst>
+                                            <p:cond delay="0"/>
+                                          </p:stCondLst>
+                                        </p:cTn>
+                                        <p:tgtEl>
+                                          <p:spTgt spid="96"/>
+                                        </p:tgtEl>
+                                        <p:attrNameLst>
+                                          <p:attrName>style.visibility</p:attrName>
+                                        </p:attrNameLst>
+                                      </p:cBhvr>
+                                      <p:to>
+                                        <p:strVal val="visible"/>
+                                      </p:to>
+                                    </p:set>
+                                  </p:childTnLst>
+                                </p:cTn>
+                              </p:par>
+                              <p:par>
+                                <p:cTn id="57" presetID="1" presetClass="entr" presetSubtype="0" fill="hold" nodeType="withEffect">
+                                  <p:stCondLst>
+                                    <p:cond delay="0"/>
+                                  </p:stCondLst>
+                                  <p:childTnLst>
+                                    <p:set>
+                                      <p:cBhvr>
+                                        <p:cTn id="58" dur="1" fill="hold">
+                                          <p:stCondLst>
+                                            <p:cond delay="0"/>
+                                          </p:stCondLst>
+                                        </p:cTn>
+                                        <p:tgtEl>
+                                          <p:spTgt spid="101"/>
+                                        </p:tgtEl>
+                                        <p:attrNameLst>
+                                          <p:attrName>style.visibility</p:attrName>
+                                        </p:attrNameLst>
+                                      </p:cBhvr>
+                                      <p:to>
+                                        <p:strVal val="visible"/>
+                                      </p:to>
+                                    </p:set>
+                                  </p:childTnLst>
+                                </p:cTn>
+                              </p:par>
+                            </p:childTnLst>
+                          </p:cTn>
+                        </p:par>
+                      </p:childTnLst>
+                    </p:cTn>
+                  </p:par>
+                  <p:par>
+                    <p:cTn id="59" fill="hold">
+                      <p:stCondLst>
+                        <p:cond delay="indefinite"/>
+                      </p:stCondLst>
+                      <p:childTnLst>
+                        <p:par>
+                          <p:cTn id="60" fill="hold">
+                            <p:stCondLst>
+                              <p:cond delay="0"/>
+                            </p:stCondLst>
+                            <p:childTnLst>
+                              <p:par>
+                                <p:cTn id="61" presetID="1" presetClass="entr" presetSubtype="0" fill="hold" nodeType="clickEffect">
+                                  <p:stCondLst>
+                                    <p:cond delay="0"/>
+                                  </p:stCondLst>
+                                  <p:childTnLst>
+                                    <p:set>
+                                      <p:cBhvr>
+                                        <p:cTn id="62" dur="1" fill="hold">
+                                          <p:stCondLst>
+                                            <p:cond delay="0"/>
+                                          </p:stCondLst>
+                                        </p:cTn>
+                                        <p:tgtEl>
+                                          <p:spTgt spid="81"/>
+                                        </p:tgtEl>
+                                        <p:attrNameLst>
+                                          <p:attrName>style.visibility</p:attrName>
+                                        </p:attrNameLst>
+                                      </p:cBhvr>
+                                      <p:to>
+                                        <p:strVal val="visible"/>
+                                      </p:to>
+                                    </p:set>
+                                  </p:childTnLst>
+                                </p:cTn>
+                              </p:par>
+                              <p:par>
+                                <p:cTn id="63" presetID="1" presetClass="entr" presetSubtype="0" fill="hold" nodeType="withEffect">
+                                  <p:stCondLst>
+                                    <p:cond delay="0"/>
+                                  </p:stCondLst>
+                                  <p:childTnLst>
+                                    <p:set>
+                                      <p:cBhvr>
+                                        <p:cTn id="64" dur="1" fill="hold">
+                                          <p:stCondLst>
+                                            <p:cond delay="0"/>
+                                          </p:stCondLst>
+                                        </p:cTn>
+                                        <p:tgtEl>
+                                          <p:spTgt spid="84"/>
+                                        </p:tgtEl>
+                                        <p:attrNameLst>
+                                          <p:attrName>style.visibility</p:attrName>
+                                        </p:attrNameLst>
+                                      </p:cBhvr>
+                                      <p:to>
+                                        <p:strVal val="visible"/>
+                                      </p:to>
+                                    </p:set>
+                                  </p:childTnLst>
+                                </p:cTn>
+                              </p:par>
+                              <p:par>
+                                <p:cTn id="65" presetID="1" presetClass="entr" presetSubtype="0" fill="hold" nodeType="withEffect">
+                                  <p:stCondLst>
+                                    <p:cond delay="0"/>
+                                  </p:stCondLst>
+                                  <p:childTnLst>
+                                    <p:set>
+                                      <p:cBhvr>
+                                        <p:cTn id="66" dur="1" fill="hold">
+                                          <p:stCondLst>
+                                            <p:cond delay="0"/>
+                                          </p:stCondLst>
+                                        </p:cTn>
+                                        <p:tgtEl>
+                                          <p:spTgt spid="90"/>
+                                        </p:tgtEl>
+                                        <p:attrNameLst>
+                                          <p:attrName>style.visibility</p:attrName>
+                                        </p:attrNameLst>
+                                      </p:cBhvr>
+                                      <p:to>
+                                        <p:strVal val="visible"/>
+                                      </p:to>
+                                    </p:set>
+                                  </p:childTnLst>
+                                </p:cTn>
+                              </p:par>
+                              <p:par>
+                                <p:cTn id="67" presetID="1" presetClass="entr" presetSubtype="0" fill="hold" nodeType="withEffect">
                                   <p:stCondLst>
                                     <p:cond delay="0"/>
                                   </p:stCondLst>
@@ -39509,7 +39853,7 @@
                                           </p:stCondLst>
                                         </p:cTn>
                                         <p:tgtEl>
-                                          <p:spTgt spid="54"/>
+                                          <p:spTgt spid="111"/>
                                         </p:tgtEl>
                                         <p:attrNameLst>
                                           <p:attrName>style.visibility</p:attrName>
@@ -39536,7 +39880,7 @@
                                           </p:stCondLst>
                                         </p:cTn>
                                         <p:tgtEl>
-                                          <p:spTgt spid="56"/>
+                                          <p:spTgt spid="24"/>
                                         </p:tgtEl>
                                         <p:attrNameLst>
                                           <p:attrName>style.visibility</p:attrName>
@@ -39550,20 +39894,20 @@
                                 </p:cTn>
                               </p:par>
                               <p:par>
-                                <p:cTn id="73" presetID="1" presetClass="entr" presetSubtype="0" fill="hold" nodeType="withEffect">
+                                <p:cTn id="71" presetID="1" presetClass="entr" presetSubtype="0" fill="hold" nodeType="withEffect">
                                   <p:stCondLst>
                                     <p:cond delay="0"/>
                                   </p:stCondLst>
                                   <p:childTnLst>
                                     <p:set>
                                       <p:cBhvr>
-                                        <p:cTn id="74" dur="1" fill="hold">
+                                        <p:cTn id="72" dur="1" fill="hold">
                                           <p:stCondLst>
                                             <p:cond delay="0"/>
                                           </p:stCondLst>
                                         </p:cTn>
                                         <p:tgtEl>
-                                          <p:spTgt spid="58"/>
+                                          <p:spTgt spid="28"/>
                                         </p:tgtEl>
                                         <p:attrNameLst>
                                           <p:attrName>style.visibility</p:attrName>
@@ -39583,19 +39927,46 @@
                     </p:cTn>
                   </p:par>
                   <p:par>
-                    <p:cTn id="75" fill="hold">
+                    <p:cTn id="73" fill="hold">
                       <p:stCondLst>
                         <p:cond delay="indefinite"/>
                       </p:stCondLst>
                       <p:childTnLst>
                         <p:par>
-                          <p:cTn id="76" fill="hold">
+                          <p:cTn id="74" fill="hold">
                             <p:stCondLst>
                               <p:cond delay="0"/>
                             </p:stCondLst>
                             <p:childTnLst>
                               <p:par>
-                                <p:cTn id="77" presetID="1" presetClass="entr" presetSubtype="0" fill="hold" nodeType="clickEffect">
+                                <p:cTn id="75" presetID="1" presetClass="entr" presetSubtype="0" fill="hold" nodeType="clickEffect">
+                                  <p:stCondLst>
+                                    <p:cond delay="0"/>
+                                  </p:stCondLst>
+                                  <p:childTnLst>
+                                    <p:set>
+                                      <p:cBhvr>
+                                        <p:cTn id="76" dur="1" fill="hold">
+                                          <p:stCondLst>
+                                            <p:cond delay="0"/>
+                                          </p:stCondLst>
+                                        </p:cTn>
+                                        <p:tgtEl>
+                                          <p:spTgt spid="25"/>
+                                        </p:tgtEl>
+                                        <p:attrNameLst>
+                                          <p:attrName>style.visibility</p:attrName>
+                                        </p:attrNameLst>
+                                      </p:cBhvr>
+                                      <p:to>
+                                        <p:strVal val="visible"/>
+                                      </p:to>
+                                    </p:set>
+                                  </p:childTnLst>
+                                </p:cTn>
+                              </p:par>
+                              <p:par>
+                                <p:cTn id="77" presetID="1" presetClass="entr" presetSubtype="0" fill="hold" nodeType="withEffect">
                                   <p:stCondLst>
                                     <p:cond delay="0"/>
                                   </p:stCondLst>
@@ -39608,7 +39979,7 @@
                                           </p:stCondLst>
                                         </p:cTn>
                                         <p:tgtEl>
-                                          <p:spTgt spid="93"/>
+                                          <p:spTgt spid="31"/>
                                         </p:tgtEl>
                                         <p:attrNameLst>
                                           <p:attrName>style.visibility</p:attrName>
@@ -39635,214 +40006,7 @@
                                           </p:stCondLst>
                                         </p:cTn>
                                         <p:tgtEl>
-                                          <p:spTgt spid="96"/>
-                                        </p:tgtEl>
-                                        <p:attrNameLst>
-                                          <p:attrName>style.visibility</p:attrName>
-                                        </p:attrNameLst>
-                                      </p:cBhvr>
-                                      <p:to>
-                                        <p:strVal val="visible"/>
-                                      </p:to>
-                                    </p:set>
-                                  </p:childTnLst>
-                                </p:cTn>
-                              </p:par>
-                              <p:par>
-                                <p:cTn id="81" presetID="1" presetClass="entr" presetSubtype="0" fill="hold" nodeType="withEffect">
-                                  <p:stCondLst>
-                                    <p:cond delay="0"/>
-                                  </p:stCondLst>
-                                  <p:childTnLst>
-                                    <p:set>
-                                      <p:cBhvr>
-                                        <p:cTn id="82" dur="1" fill="hold">
-                                          <p:stCondLst>
-                                            <p:cond delay="0"/>
-                                          </p:stCondLst>
-                                        </p:cTn>
-                                        <p:tgtEl>
-                                          <p:spTgt spid="101"/>
-                                        </p:tgtEl>
-                                        <p:attrNameLst>
-                                          <p:attrName>style.visibility</p:attrName>
-                                        </p:attrNameLst>
-                                      </p:cBhvr>
-                                      <p:to>
-                                        <p:strVal val="visible"/>
-                                      </p:to>
-                                    </p:set>
-                                  </p:childTnLst>
-                                </p:cTn>
-                              </p:par>
-                            </p:childTnLst>
-                          </p:cTn>
-                        </p:par>
-                      </p:childTnLst>
-                    </p:cTn>
-                  </p:par>
-                  <p:par>
-                    <p:cTn id="85" fill="hold">
-                      <p:stCondLst>
-                        <p:cond delay="indefinite"/>
-                      </p:stCondLst>
-                      <p:childTnLst>
-                        <p:par>
-                          <p:cTn id="86" fill="hold">
-                            <p:stCondLst>
-                              <p:cond delay="0"/>
-                            </p:stCondLst>
-                            <p:childTnLst>
-                              <p:par>
-                                <p:cTn id="87" presetID="1" presetClass="entr" presetSubtype="0" fill="hold" nodeType="clickEffect">
-                                  <p:stCondLst>
-                                    <p:cond delay="0"/>
-                                  </p:stCondLst>
-                                  <p:childTnLst>
-                                    <p:set>
-                                      <p:cBhvr>
-                                        <p:cTn id="88" dur="1" fill="hold">
-                                          <p:stCondLst>
-                                            <p:cond delay="0"/>
-                                          </p:stCondLst>
-                                        </p:cTn>
-                                        <p:tgtEl>
-                                          <p:spTgt spid="81"/>
-                                        </p:tgtEl>
-                                        <p:attrNameLst>
-                                          <p:attrName>style.visibility</p:attrName>
-                                        </p:attrNameLst>
-                                      </p:cBhvr>
-                                      <p:to>
-                                        <p:strVal val="visible"/>
-                                      </p:to>
-                                    </p:set>
-                                  </p:childTnLst>
-                                </p:cTn>
-                              </p:par>
-                              <p:par>
-                                <p:cTn id="89" presetID="1" presetClass="entr" presetSubtype="0" fill="hold" nodeType="withEffect">
-                                  <p:stCondLst>
-                                    <p:cond delay="0"/>
-                                  </p:stCondLst>
-                                  <p:childTnLst>
-                                    <p:set>
-                                      <p:cBhvr>
-                                        <p:cTn id="90" dur="1" fill="hold">
-                                          <p:stCondLst>
-                                            <p:cond delay="0"/>
-                                          </p:stCondLst>
-                                        </p:cTn>
-                                        <p:tgtEl>
-                                          <p:spTgt spid="84"/>
-                                        </p:tgtEl>
-                                        <p:attrNameLst>
-                                          <p:attrName>style.visibility</p:attrName>
-                                        </p:attrNameLst>
-                                      </p:cBhvr>
-                                      <p:to>
-                                        <p:strVal val="visible"/>
-                                      </p:to>
-                                    </p:set>
-                                  </p:childTnLst>
-                                </p:cTn>
-                              </p:par>
-                              <p:par>
-                                <p:cTn id="93" presetID="1" presetClass="entr" presetSubtype="0" fill="hold" nodeType="withEffect">
-                                  <p:stCondLst>
-                                    <p:cond delay="0"/>
-                                  </p:stCondLst>
-                                  <p:childTnLst>
-                                    <p:set>
-                                      <p:cBhvr>
-                                        <p:cTn id="94" dur="1" fill="hold">
-                                          <p:stCondLst>
-                                            <p:cond delay="0"/>
-                                          </p:stCondLst>
-                                        </p:cTn>
-                                        <p:tgtEl>
-                                          <p:spTgt spid="90"/>
-                                        </p:tgtEl>
-                                        <p:attrNameLst>
-                                          <p:attrName>style.visibility</p:attrName>
-                                        </p:attrNameLst>
-                                      </p:cBhvr>
-                                      <p:to>
-                                        <p:strVal val="visible"/>
-                                      </p:to>
-                                    </p:set>
-                                  </p:childTnLst>
-                                </p:cTn>
-                              </p:par>
-                              <p:par>
-                                <p:cTn id="95" presetID="1" presetClass="entr" presetSubtype="0" fill="hold" nodeType="withEffect">
-                                  <p:stCondLst>
-                                    <p:cond delay="0"/>
-                                  </p:stCondLst>
-                                  <p:childTnLst>
-                                    <p:set>
-                                      <p:cBhvr>
-                                        <p:cTn id="96" dur="1" fill="hold">
-                                          <p:stCondLst>
-                                            <p:cond delay="0"/>
-                                          </p:stCondLst>
-                                        </p:cTn>
-                                        <p:tgtEl>
-                                          <p:spTgt spid="111"/>
-                                        </p:tgtEl>
-                                        <p:attrNameLst>
-                                          <p:attrName>style.visibility</p:attrName>
-                                        </p:attrNameLst>
-                                      </p:cBhvr>
-                                      <p:to>
-                                        <p:strVal val="visible"/>
-                                      </p:to>
-                                    </p:set>
-                                  </p:childTnLst>
-                                </p:cTn>
-                              </p:par>
-                              <p:par>
-                                <p:cTn id="97" presetID="1" presetClass="entr" presetSubtype="0" fill="hold" nodeType="withEffect">
-                                  <p:stCondLst>
-                                    <p:cond delay="0"/>
-                                  </p:stCondLst>
-                                  <p:childTnLst>
-                                    <p:set>
-                                      <p:cBhvr>
-                                        <p:cTn id="98" dur="1" fill="hold">
-                                          <p:stCondLst>
-                                            <p:cond delay="0"/>
-                                          </p:stCondLst>
-                                        </p:cTn>
-                                        <p:tgtEl>
-                                          <p:spTgt spid="24"/>
-                                        </p:tgtEl>
-                                        <p:attrNameLst>
-                                          <p:attrName>style.visibility</p:attrName>
-                                        </p:attrNameLst>
-                                      </p:cBhvr>
-                                      <p:to>
-                                        <p:strVal val="visible"/>
-                                      </p:to>
-                                    </p:set>
-                                  </p:childTnLst>
-                                </p:cTn>
-                              </p:par>
-                              <p:par>
-                                <p:cTn id="99" presetID="1" presetClass="entr" presetSubtype="0" fill="hold" nodeType="withEffect">
-                                  <p:stCondLst>
-                                    <p:cond delay="0"/>
-                                  </p:stCondLst>
-                                  <p:childTnLst>
-                                    <p:set>
-                                      <p:cBhvr>
-                                        <p:cTn id="100" dur="1" fill="hold">
-                                          <p:stCondLst>
-                                            <p:cond delay="0"/>
-                                          </p:stCondLst>
-                                        </p:cTn>
-                                        <p:tgtEl>
-                                          <p:spTgt spid="28"/>
+                                          <p:spTgt spid="36"/>
                                         </p:tgtEl>
                                         <p:attrNameLst>
                                           <p:attrName>style.visibility</p:attrName>
@@ -39906,6 +40070,8 @@
       <p:bldP spid="124" grpId="0" animBg="1"/>
       <p:bldP spid="32" grpId="0" animBg="1"/>
       <p:bldP spid="35" grpId="0" animBg="1"/>
+      <p:bldP spid="25" grpId="0" animBg="1"/>
+      <p:bldP spid="36" grpId="0" animBg="1"/>
     </p:bldLst>
   </p:timing>
 </p:sld>
@@ -42928,6 +43094,15 @@
 </file>
 
 <file path=customXml/item2.xml><?xml version="1.0" encoding="utf-8"?>
+<?mso-contentType ?>
+<FormTemplates xmlns="http://schemas.microsoft.com/sharepoint/v3/contenttype/forms">
+  <Display>DocumentLibraryForm</Display>
+  <Edit>DocumentLibraryForm</Edit>
+  <New>DocumentLibraryForm</New>
+</FormTemplates>
+</file>
+
+<file path=customXml/item3.xml><?xml version="1.0" encoding="utf-8"?>
 <p:properties xmlns:p="http://schemas.microsoft.com/office/2006/metadata/properties" xmlns:xsi="http://www.w3.org/2001/XMLSchema-instance" xmlns:pc="http://schemas.microsoft.com/office/infopath/2007/PartnerControls">
   <documentManagement>
     <lcf76f155ced4ddcb4097134ff3c332f xmlns="501edefc-5b9b-422a-9450-cf7f1f30e3fa">
@@ -42936,15 +43111,6 @@
     <TaxCatchAll xmlns="3083c7a9-d95a-44c4-8fb8-f93b125494d6" xsi:nil="true"/>
   </documentManagement>
 </p:properties>
-</file>
-
-<file path=customXml/item3.xml><?xml version="1.0" encoding="utf-8"?>
-<?mso-contentType ?>
-<FormTemplates xmlns="http://schemas.microsoft.com/sharepoint/v3/contenttype/forms">
-  <Display>DocumentLibraryForm</Display>
-  <Edit>DocumentLibraryForm</Edit>
-  <New>DocumentLibraryForm</New>
-</FormTemplates>
 </file>
 
 <file path=customXml/itemProps1.xml><?xml version="1.0" encoding="utf-8"?>
@@ -42967,6 +43133,14 @@
 </file>
 
 <file path=customXml/itemProps2.xml><?xml version="1.0" encoding="utf-8"?>
+<ds:datastoreItem xmlns:ds="http://schemas.openxmlformats.org/officeDocument/2006/customXml" ds:itemID="{334436CE-240F-4EE4-9FC5-4255E6874223}">
+  <ds:schemaRefs>
+    <ds:schemaRef ds:uri="http://schemas.microsoft.com/sharepoint/v3/contenttype/forms"/>
+  </ds:schemaRefs>
+</ds:datastoreItem>
+</file>
+
+<file path=customXml/itemProps3.xml><?xml version="1.0" encoding="utf-8"?>
 <ds:datastoreItem xmlns:ds="http://schemas.openxmlformats.org/officeDocument/2006/customXml" ds:itemID="{6302A1CC-4AEF-4830-BB1C-A446161EB02D}">
   <ds:schemaRefs>
     <ds:schemaRef ds:uri="http://schemas.microsoft.com/office/2006/metadata/properties"/>
@@ -42981,14 +43155,6 @@
 </ds:datastoreItem>
 </file>
 
-<file path=customXml/itemProps3.xml><?xml version="1.0" encoding="utf-8"?>
-<ds:datastoreItem xmlns:ds="http://schemas.openxmlformats.org/officeDocument/2006/customXml" ds:itemID="{334436CE-240F-4EE4-9FC5-4255E6874223}">
-  <ds:schemaRefs>
-    <ds:schemaRef ds:uri="http://schemas.microsoft.com/sharepoint/v3/contenttype/forms"/>
-  </ds:schemaRefs>
-</ds:datastoreItem>
-</file>
-
 <file path=docMetadata/LabelInfo.xml><?xml version="1.0" encoding="utf-8"?>
 <clbl:labelList xmlns:clbl="http://schemas.microsoft.com/office/2020/mipLabelMetadata">
   <clbl:label id="{42e461c6-591f-4920-9cf0-f1389542f8ad}" enabled="1" method="Standard" siteId="{2cda5d11-f0ac-46b3-967d-af1b2e1bd01a}" contentBits="2" removed="0"/>

</xml_diff>

<commit_message>
Set slide-7 boxes to 4 cm width with tightened text insets
All rounded boxes resized to 4.00 x 2.41 cm (centre-preserving), text
insets set to 0.15 cm left/right, 0.08 cm top, 0.25 cm bottom. Group
scaling normalised back to 1:1. Icons re-embedded from the updated
svg-icons files mapped by box title, including the new
01-raw-data-sources icon; unused image relationships dropped.

Co-Authored-By: Claude Fable 5 <noreply@anthropic.com>
Claude-Session: https://claude.ai/code/session_01S2kGP2buE2HmxMttD3XczR
</commit_message>
<xml_diff>
--- a/RAG_Workshop.pptx
+++ b/RAG_Workshop.pptx
@@ -35634,10 +35634,10 @@
         </p:nvGrpSpPr>
         <p:grpSpPr>
           <a:xfrm>
-            <a:off x="476615" y="5142674"/>
-            <a:ext cx="1735200" cy="867600"/>
-            <a:chOff x="476615" y="5142674"/>
-            <a:chExt cx="1735200" cy="867600"/>
+            <a:off x="624215" y="5142674"/>
+            <a:ext cx="1440000" cy="867600"/>
+            <a:chOff x="624215" y="5142674"/>
+            <a:chExt cx="1440000" cy="867600"/>
           </a:xfrm>
         </p:grpSpPr>
         <p:sp>
@@ -35656,8 +35656,8 @@
           </p:nvSpPr>
           <p:spPr>
             <a:xfrm>
-              <a:off x="476615" y="5142674"/>
-              <a:ext cx="1735200" cy="867600"/>
+              <a:off x="624215" y="5142674"/>
+              <a:ext cx="1440000" cy="867600"/>
             </a:xfrm>
             <a:prstGeom prst="roundRect">
               <a:avLst/>
@@ -35692,7 +35692,7 @@
             </a:fontRef>
           </p:style>
           <p:txBody>
-            <a:bodyPr tIns="28800" anchor="t"/>
+            <a:bodyPr tIns="28800" anchor="t" lIns="54000" rIns="54000" bIns="90000"/>
             <a:lstStyle/>
             <a:p>
               <a:pPr algn="ctr">
@@ -35734,8 +35734,8 @@
           </p:nvSpPr>
           <p:spPr>
             <a:xfrm>
-              <a:off x="476615" y="5431235"/>
-              <a:ext cx="1735200" cy="0"/>
+              <a:off x="624215" y="5431235"/>
+              <a:ext cx="1440000" cy="0"/>
             </a:xfrm>
             <a:prstGeom prst="line">
               <a:avLst/>
@@ -35785,15 +35785,21 @@
             <p:nvPr/>
           </p:nvPicPr>
           <p:blipFill>
-            <a:blip r:embed="rId3"/>
+            <a:blip r:embed="rId13">
+              <a:extLst>
+                <a:ext uri="{96DAC541-7B7A-43D3-8B79-37D633B846F1}">
+                  <ns0:svgBlip xmlns:ns0="http://schemas.microsoft.com/office/drawing/2016/SVG/main" r:embed="rId14"/>
+                </a:ext>
+              </a:extLst>
+            </a:blip>
             <a:stretch>
               <a:fillRect/>
             </a:stretch>
           </p:blipFill>
           <p:spPr>
-            <a:xfrm flipH="1">
-              <a:off x="1141895" y="5478100"/>
-              <a:ext cx="404640" cy="468000"/>
+            <a:xfrm>
+              <a:off x="1110215" y="5478100"/>
+              <a:ext cx="468000" cy="468000"/>
             </a:xfrm>
             <a:prstGeom prst="rect">
               <a:avLst/>
@@ -35809,10 +35815,10 @@
         </p:nvGrpSpPr>
         <p:grpSpPr>
           <a:xfrm>
-            <a:off x="10049240" y="1570799"/>
-            <a:ext cx="1735200" cy="867600"/>
-            <a:chOff x="10049240" y="1570799"/>
-            <a:chExt cx="1735200" cy="867600"/>
+            <a:off x="10196840" y="1570799"/>
+            <a:ext cx="1440000" cy="867600"/>
+            <a:chOff x="10196840" y="1570799"/>
+            <a:chExt cx="1440000" cy="867600"/>
           </a:xfrm>
         </p:grpSpPr>
         <p:sp>
@@ -35831,8 +35837,8 @@
           </p:nvSpPr>
           <p:spPr>
             <a:xfrm>
-              <a:off x="10049240" y="1570799"/>
-              <a:ext cx="1735200" cy="867600"/>
+              <a:off x="10196840" y="1570799"/>
+              <a:ext cx="1440000" cy="867600"/>
             </a:xfrm>
             <a:prstGeom prst="roundRect">
               <a:avLst/>
@@ -35865,7 +35871,7 @@
             </a:fontRef>
           </p:style>
           <p:txBody>
-            <a:bodyPr tIns="28800" anchor="t"/>
+            <a:bodyPr tIns="28800" anchor="t" lIns="54000" rIns="54000" bIns="90000"/>
             <a:lstStyle/>
             <a:p>
               <a:pPr algn="ctr">
@@ -35906,15 +35912,16 @@
             <p:nvPr/>
           </p:nvPicPr>
           <p:blipFill>
-            <a:blip>
+            <a:blip r:embed="rId15">
               <a:extLst>
                 <a:ext uri="{96DAC541-7B7A-43D3-8B79-37D633B846F1}">
-                  <asvg:svgBlip xmlns:asvg="http://schemas.microsoft.com/office/drawing/2016/SVG/main" r:embed="rId4"/>
+                  <ns1:svgBlip xmlns:ns1="http://schemas.microsoft.com/office/drawing/2016/SVG/main" r:embed="rId16"/>
                 </a:ext>
               </a:extLst>
             </a:blip>
-            <a:srcRect/>
-            <a:stretch/>
+            <a:stretch>
+              <a:fillRect/>
+            </a:stretch>
           </p:blipFill>
           <p:spPr>
             <a:xfrm>
@@ -35936,8 +35943,8 @@
           </p:nvSpPr>
           <p:spPr>
             <a:xfrm flipV="1">
-              <a:off x="10049240" y="1859360"/>
-              <a:ext cx="1735200" cy="0"/>
+              <a:off x="10196840" y="1859360"/>
+              <a:ext cx="1440000" cy="0"/>
             </a:xfrm>
             <a:prstGeom prst="line">
               <a:avLst/>
@@ -35979,10 +35986,10 @@
         </p:nvGrpSpPr>
         <p:grpSpPr>
           <a:xfrm>
-            <a:off x="10049240" y="5161353"/>
-            <a:ext cx="1735200" cy="867600"/>
-            <a:chOff x="10049240" y="5161353"/>
-            <a:chExt cx="1735200" cy="867600"/>
+            <a:off x="10196840" y="5161353"/>
+            <a:ext cx="1440000" cy="867600"/>
+            <a:chOff x="10196840" y="5161353"/>
+            <a:chExt cx="1440000" cy="867600"/>
           </a:xfrm>
         </p:grpSpPr>
         <p:sp>
@@ -36001,8 +36008,8 @@
           </p:nvSpPr>
           <p:spPr>
             <a:xfrm>
-              <a:off x="10049240" y="5161353"/>
-              <a:ext cx="1735200" cy="867600"/>
+              <a:off x="10196840" y="5161353"/>
+              <a:ext cx="1440000" cy="867600"/>
             </a:xfrm>
             <a:prstGeom prst="roundRect">
               <a:avLst/>
@@ -36035,7 +36042,7 @@
             </a:fontRef>
           </p:style>
           <p:txBody>
-            <a:bodyPr tIns="28800" anchor="t"/>
+            <a:bodyPr tIns="28800" anchor="t" lIns="54000" rIns="54000" bIns="90000"/>
             <a:lstStyle/>
             <a:p>
               <a:pPr algn="ctr">
@@ -36076,15 +36083,16 @@
             <p:nvPr/>
           </p:nvPicPr>
           <p:blipFill>
-            <a:blip>
+            <a:blip r:embed="rId17">
               <a:extLst>
                 <a:ext uri="{96DAC541-7B7A-43D3-8B79-37D633B846F1}">
-                  <asvg:svgBlip xmlns:asvg="http://schemas.microsoft.com/office/drawing/2016/SVG/main" r:embed="rId5"/>
+                  <ns2:svgBlip xmlns:ns2="http://schemas.microsoft.com/office/drawing/2016/SVG/main" r:embed="rId18"/>
                 </a:ext>
               </a:extLst>
             </a:blip>
-            <a:srcRect/>
-            <a:stretch/>
+            <a:stretch>
+              <a:fillRect/>
+            </a:stretch>
           </p:blipFill>
           <p:spPr>
             <a:xfrm>
@@ -36106,8 +36114,8 @@
           </p:nvSpPr>
           <p:spPr>
             <a:xfrm flipV="1">
-              <a:off x="10049240" y="5449914"/>
-              <a:ext cx="1735200" cy="0"/>
+              <a:off x="10196840" y="5449914"/>
+              <a:ext cx="1440000" cy="0"/>
             </a:xfrm>
             <a:prstGeom prst="line">
               <a:avLst/>
@@ -36149,10 +36157,10 @@
         </p:nvGrpSpPr>
         <p:grpSpPr>
           <a:xfrm>
-            <a:off x="475308" y="3952049"/>
-            <a:ext cx="1434807" cy="867600"/>
-            <a:chOff x="475308" y="3952049"/>
-            <a:chExt cx="1735200" cy="867600"/>
+            <a:off x="472711" y="3952049"/>
+            <a:ext cx="1440000" cy="867600"/>
+            <a:chOff x="622908" y="3952049"/>
+            <a:chExt cx="1440000" cy="867600"/>
           </a:xfrm>
         </p:grpSpPr>
         <p:sp>
@@ -36171,8 +36179,8 @@
           </p:nvSpPr>
           <p:spPr>
             <a:xfrm>
-              <a:off x="475308" y="3952049"/>
-              <a:ext cx="1735200" cy="867600"/>
+              <a:off x="622908" y="3952049"/>
+              <a:ext cx="1440000" cy="867600"/>
             </a:xfrm>
             <a:prstGeom prst="roundRect">
               <a:avLst/>
@@ -36207,7 +36215,7 @@
             </a:fontRef>
           </p:style>
           <p:txBody>
-            <a:bodyPr lIns="54000" tIns="28800" rIns="54000" anchor="t"/>
+            <a:bodyPr lIns="54000" tIns="28800" rIns="54000" anchor="t" bIns="90000"/>
             <a:lstStyle/>
             <a:p>
               <a:pPr algn="ctr">
@@ -36248,15 +36256,16 @@
             <p:nvPr/>
           </p:nvPicPr>
           <p:blipFill>
-            <a:blip>
+            <a:blip r:embed="rId19">
               <a:extLst>
                 <a:ext uri="{96DAC541-7B7A-43D3-8B79-37D633B846F1}">
-                  <asvg:svgBlip xmlns:asvg="http://schemas.microsoft.com/office/drawing/2016/SVG/main" r:embed="rId6"/>
+                  <ns3:svgBlip xmlns:ns3="http://schemas.microsoft.com/office/drawing/2016/SVG/main" r:embed="rId20"/>
                 </a:ext>
               </a:extLst>
             </a:blip>
-            <a:srcRect/>
-            <a:stretch/>
+            <a:stretch>
+              <a:fillRect/>
+            </a:stretch>
           </p:blipFill>
           <p:spPr>
             <a:xfrm>
@@ -36284,8 +36293,8 @@
           </p:nvSpPr>
           <p:spPr>
             <a:xfrm>
-              <a:off x="475308" y="4240610"/>
-              <a:ext cx="1735200" cy="0"/>
+              <a:off x="622908" y="4240610"/>
+              <a:ext cx="1440000" cy="0"/>
             </a:xfrm>
             <a:prstGeom prst="line">
               <a:avLst/>
@@ -36335,10 +36344,10 @@
         </p:nvGrpSpPr>
         <p:grpSpPr>
           <a:xfrm>
-            <a:off x="476615" y="2761424"/>
-            <a:ext cx="1735200" cy="867600"/>
-            <a:chOff x="476615" y="2761424"/>
-            <a:chExt cx="1735200" cy="867600"/>
+            <a:off x="624215" y="2761424"/>
+            <a:ext cx="1440000" cy="867600"/>
+            <a:chOff x="624215" y="2761424"/>
+            <a:chExt cx="1440000" cy="867600"/>
           </a:xfrm>
         </p:grpSpPr>
         <p:sp>
@@ -36357,8 +36366,8 @@
           </p:nvSpPr>
           <p:spPr>
             <a:xfrm>
-              <a:off x="476615" y="2761424"/>
-              <a:ext cx="1735200" cy="867600"/>
+              <a:off x="624215" y="2761424"/>
+              <a:ext cx="1440000" cy="867600"/>
             </a:xfrm>
             <a:prstGeom prst="roundRect">
               <a:avLst/>
@@ -36393,7 +36402,7 @@
             </a:fontRef>
           </p:style>
           <p:txBody>
-            <a:bodyPr tIns="28800" anchor="t"/>
+            <a:bodyPr tIns="28800" anchor="t" lIns="54000" rIns="54000" bIns="90000"/>
             <a:lstStyle/>
             <a:p>
               <a:pPr algn="ctr"/>
@@ -36433,8 +36442,8 @@
           </p:nvSpPr>
           <p:spPr>
             <a:xfrm>
-              <a:off x="476615" y="3049985"/>
-              <a:ext cx="1735200" cy="0"/>
+              <a:off x="624215" y="3049985"/>
+              <a:ext cx="1440000" cy="0"/>
             </a:xfrm>
             <a:prstGeom prst="line">
               <a:avLst/>
@@ -36484,10 +36493,10 @@
             <p:nvPr/>
           </p:nvPicPr>
           <p:blipFill>
-            <a:blip>
+            <a:blip r:embed="rId21">
               <a:extLst>
                 <a:ext uri="{96DAC541-7B7A-43D3-8B79-37D633B846F1}">
-                  <asvg:svgBlip xmlns:asvg="http://schemas.microsoft.com/office/drawing/2016/SVG/main" r:embed="rId6"/>
+                  <ns4:svgBlip xmlns:ns4="http://schemas.microsoft.com/office/drawing/2016/SVG/main" r:embed="rId22"/>
                 </a:ext>
               </a:extLst>
             </a:blip>
@@ -36514,10 +36523,10 @@
         </p:nvGrpSpPr>
         <p:grpSpPr>
           <a:xfrm>
-            <a:off x="4861644" y="1578083"/>
-            <a:ext cx="1735200" cy="867600"/>
-            <a:chOff x="4861644" y="1578083"/>
-            <a:chExt cx="1735200" cy="867600"/>
+            <a:off x="5009244" y="1578083"/>
+            <a:ext cx="1440000" cy="867600"/>
+            <a:chOff x="5009244" y="1578083"/>
+            <a:chExt cx="1440000" cy="867600"/>
           </a:xfrm>
         </p:grpSpPr>
         <p:sp>
@@ -36536,8 +36545,8 @@
           </p:nvSpPr>
           <p:spPr>
             <a:xfrm>
-              <a:off x="4861644" y="1578083"/>
-              <a:ext cx="1735200" cy="867600"/>
+              <a:off x="5009244" y="1578083"/>
+              <a:ext cx="1440000" cy="867600"/>
             </a:xfrm>
             <a:prstGeom prst="roundRect">
               <a:avLst/>
@@ -36572,7 +36581,7 @@
             </a:fontRef>
           </p:style>
           <p:txBody>
-            <a:bodyPr tIns="28800" anchor="t"/>
+            <a:bodyPr tIns="28800" anchor="t" lIns="54000" rIns="54000" bIns="90000"/>
             <a:lstStyle/>
             <a:p>
               <a:pPr algn="ctr">
@@ -36613,15 +36622,16 @@
             <p:nvPr/>
           </p:nvPicPr>
           <p:blipFill>
-            <a:blip>
+            <a:blip r:embed="rId23">
               <a:extLst>
                 <a:ext uri="{96DAC541-7B7A-43D3-8B79-37D633B846F1}">
-                  <asvg:svgBlip xmlns:asvg="http://schemas.microsoft.com/office/drawing/2016/SVG/main" r:embed="rId7"/>
+                  <ns5:svgBlip xmlns:ns5="http://schemas.microsoft.com/office/drawing/2016/SVG/main" r:embed="rId24"/>
                 </a:ext>
               </a:extLst>
             </a:blip>
-            <a:srcRect/>
-            <a:stretch/>
+            <a:stretch>
+              <a:fillRect/>
+            </a:stretch>
           </p:blipFill>
           <p:spPr>
             <a:xfrm>
@@ -36649,8 +36659,8 @@
           </p:nvSpPr>
           <p:spPr>
             <a:xfrm flipV="1">
-              <a:off x="4861644" y="1866644"/>
-              <a:ext cx="1735200" cy="0"/>
+              <a:off x="5009244" y="1866644"/>
+              <a:ext cx="1440000" cy="0"/>
             </a:xfrm>
             <a:prstGeom prst="line">
               <a:avLst/>
@@ -36694,10 +36704,10 @@
         </p:nvGrpSpPr>
         <p:grpSpPr>
           <a:xfrm>
-            <a:off x="4858115" y="2761424"/>
-            <a:ext cx="1735200" cy="867600"/>
-            <a:chOff x="4858115" y="2776165"/>
-            <a:chExt cx="1735200" cy="867600"/>
+            <a:off x="5005715" y="2761424"/>
+            <a:ext cx="1440000" cy="867600"/>
+            <a:chOff x="5005715" y="2776165"/>
+            <a:chExt cx="1440000" cy="867600"/>
           </a:xfrm>
         </p:grpSpPr>
         <p:sp>
@@ -36716,8 +36726,8 @@
           </p:nvSpPr>
           <p:spPr>
             <a:xfrm>
-              <a:off x="4858115" y="2776165"/>
-              <a:ext cx="1735200" cy="867600"/>
+              <a:off x="5005715" y="2776165"/>
+              <a:ext cx="1440000" cy="867600"/>
             </a:xfrm>
             <a:prstGeom prst="roundRect">
               <a:avLst/>
@@ -36752,7 +36762,7 @@
             </a:fontRef>
           </p:style>
           <p:txBody>
-            <a:bodyPr tIns="28800" anchor="t"/>
+            <a:bodyPr tIns="28800" anchor="t" lIns="54000" rIns="54000" bIns="90000"/>
             <a:lstStyle/>
             <a:p>
               <a:pPr algn="ctr">
@@ -36793,15 +36803,16 @@
             <p:nvPr/>
           </p:nvPicPr>
           <p:blipFill>
-            <a:blip>
+            <a:blip r:embed="rId25">
               <a:extLst>
                 <a:ext uri="{96DAC541-7B7A-43D3-8B79-37D633B846F1}">
-                  <asvg:svgBlip xmlns:asvg="http://schemas.microsoft.com/office/drawing/2016/SVG/main" r:embed="rId8"/>
+                  <ns6:svgBlip xmlns:ns6="http://schemas.microsoft.com/office/drawing/2016/SVG/main" r:embed="rId26"/>
                 </a:ext>
               </a:extLst>
             </a:blip>
-            <a:srcRect/>
-            <a:stretch/>
+            <a:stretch>
+              <a:fillRect/>
+            </a:stretch>
           </p:blipFill>
           <p:spPr>
             <a:xfrm>
@@ -36829,8 +36840,8 @@
           </p:nvSpPr>
           <p:spPr>
             <a:xfrm>
-              <a:off x="4858115" y="3064726"/>
-              <a:ext cx="1735200" cy="0"/>
+              <a:off x="5005715" y="3064726"/>
+              <a:ext cx="1440000" cy="0"/>
             </a:xfrm>
             <a:prstGeom prst="line">
               <a:avLst/>
@@ -36874,10 +36885,10 @@
         </p:nvGrpSpPr>
         <p:grpSpPr>
           <a:xfrm>
-            <a:off x="4858115" y="5161353"/>
-            <a:ext cx="1735200" cy="867600"/>
-            <a:chOff x="4858115" y="5161353"/>
-            <a:chExt cx="1735200" cy="867600"/>
+            <a:off x="5005715" y="5161353"/>
+            <a:ext cx="1440000" cy="867600"/>
+            <a:chOff x="5005715" y="5161353"/>
+            <a:chExt cx="1440000" cy="867600"/>
           </a:xfrm>
         </p:grpSpPr>
         <p:sp>
@@ -36896,8 +36907,8 @@
           </p:nvSpPr>
           <p:spPr>
             <a:xfrm>
-              <a:off x="4858115" y="5161353"/>
-              <a:ext cx="1735200" cy="867600"/>
+              <a:off x="5005715" y="5161353"/>
+              <a:ext cx="1440000" cy="867600"/>
             </a:xfrm>
             <a:prstGeom prst="roundRect">
               <a:avLst/>
@@ -36932,7 +36943,7 @@
             </a:fontRef>
           </p:style>
           <p:txBody>
-            <a:bodyPr tIns="28800" anchor="t"/>
+            <a:bodyPr tIns="28800" anchor="t" lIns="54000" rIns="54000" bIns="90000"/>
             <a:lstStyle/>
             <a:p>
               <a:pPr algn="ctr">
@@ -36973,15 +36984,16 @@
             <p:nvPr/>
           </p:nvPicPr>
           <p:blipFill>
-            <a:blip>
+            <a:blip r:embed="rId27">
               <a:extLst>
                 <a:ext uri="{96DAC541-7B7A-43D3-8B79-37D633B846F1}">
-                  <asvg:svgBlip xmlns:asvg="http://schemas.microsoft.com/office/drawing/2016/SVG/main" r:embed="rId9"/>
+                  <ns7:svgBlip xmlns:ns7="http://schemas.microsoft.com/office/drawing/2016/SVG/main" r:embed="rId28"/>
                 </a:ext>
               </a:extLst>
             </a:blip>
-            <a:srcRect/>
-            <a:stretch/>
+            <a:stretch>
+              <a:fillRect/>
+            </a:stretch>
           </p:blipFill>
           <p:spPr>
             <a:xfrm>
@@ -37009,8 +37021,8 @@
           </p:nvSpPr>
           <p:spPr>
             <a:xfrm>
-              <a:off x="4858115" y="5449914"/>
-              <a:ext cx="1735200" cy="0"/>
+              <a:off x="5005715" y="5449914"/>
+              <a:ext cx="1440000" cy="0"/>
             </a:xfrm>
             <a:prstGeom prst="line">
               <a:avLst/>
@@ -37054,10 +37066,10 @@
         </p:nvGrpSpPr>
         <p:grpSpPr>
           <a:xfrm>
-            <a:off x="7848442" y="1570799"/>
-            <a:ext cx="1735200" cy="867600"/>
-            <a:chOff x="7848442" y="1570799"/>
-            <a:chExt cx="1735200" cy="867600"/>
+            <a:off x="7996042" y="1570799"/>
+            <a:ext cx="1440000" cy="867600"/>
+            <a:chOff x="7996042" y="1570799"/>
+            <a:chExt cx="1440000" cy="867600"/>
           </a:xfrm>
         </p:grpSpPr>
         <p:sp>
@@ -37076,8 +37088,8 @@
           </p:nvSpPr>
           <p:spPr>
             <a:xfrm>
-              <a:off x="7848442" y="1570799"/>
-              <a:ext cx="1735200" cy="867600"/>
+              <a:off x="7996042" y="1570799"/>
+              <a:ext cx="1440000" cy="867600"/>
             </a:xfrm>
             <a:prstGeom prst="roundRect">
               <a:avLst/>
@@ -37112,7 +37124,7 @@
             </a:fontRef>
           </p:style>
           <p:txBody>
-            <a:bodyPr tIns="28800" anchor="t"/>
+            <a:bodyPr tIns="28800" anchor="t" lIns="54000" rIns="54000" bIns="90000"/>
             <a:lstStyle/>
             <a:p>
               <a:pPr algn="ctr">
@@ -37153,15 +37165,16 @@
             <p:nvPr/>
           </p:nvPicPr>
           <p:blipFill>
-            <a:blip>
+            <a:blip r:embed="rId29">
               <a:extLst>
                 <a:ext uri="{96DAC541-7B7A-43D3-8B79-37D633B846F1}">
-                  <asvg:svgBlip xmlns:asvg="http://schemas.microsoft.com/office/drawing/2016/SVG/main" r:embed="rId10"/>
+                  <ns8:svgBlip xmlns:ns8="http://schemas.microsoft.com/office/drawing/2016/SVG/main" r:embed="rId30"/>
                 </a:ext>
               </a:extLst>
             </a:blip>
-            <a:srcRect/>
-            <a:stretch/>
+            <a:stretch>
+              <a:fillRect/>
+            </a:stretch>
           </p:blipFill>
           <p:spPr>
             <a:xfrm>
@@ -37189,8 +37202,8 @@
           </p:nvSpPr>
           <p:spPr>
             <a:xfrm>
-              <a:off x="7848442" y="1859360"/>
-              <a:ext cx="1735200" cy="0"/>
+              <a:off x="7996042" y="1859360"/>
+              <a:ext cx="1440000" cy="0"/>
             </a:xfrm>
             <a:prstGeom prst="line">
               <a:avLst/>
@@ -37238,10 +37251,10 @@
         </p:nvGrpSpPr>
         <p:grpSpPr>
           <a:xfrm>
-            <a:off x="7858490" y="5161353"/>
-            <a:ext cx="1735200" cy="867600"/>
-            <a:chOff x="7858490" y="5161353"/>
-            <a:chExt cx="1735200" cy="867600"/>
+            <a:off x="8006090" y="5161353"/>
+            <a:ext cx="1440000" cy="867600"/>
+            <a:chOff x="8006090" y="5161353"/>
+            <a:chExt cx="1440000" cy="867600"/>
           </a:xfrm>
         </p:grpSpPr>
         <p:sp>
@@ -37260,8 +37273,8 @@
           </p:nvSpPr>
           <p:spPr>
             <a:xfrm>
-              <a:off x="7858490" y="5161353"/>
-              <a:ext cx="1735200" cy="867600"/>
+              <a:off x="8006090" y="5161353"/>
+              <a:ext cx="1440000" cy="867600"/>
             </a:xfrm>
             <a:prstGeom prst="roundRect">
               <a:avLst/>
@@ -37296,7 +37309,7 @@
             </a:fontRef>
           </p:style>
           <p:txBody>
-            <a:bodyPr tIns="28800" anchor="t"/>
+            <a:bodyPr tIns="28800" anchor="t" lIns="54000" rIns="54000" bIns="90000"/>
             <a:lstStyle/>
             <a:p>
               <a:pPr algn="ctr">
@@ -37337,15 +37350,16 @@
             <p:nvPr/>
           </p:nvPicPr>
           <p:blipFill>
-            <a:blip>
+            <a:blip r:embed="rId31">
               <a:extLst>
                 <a:ext uri="{96DAC541-7B7A-43D3-8B79-37D633B846F1}">
-                  <asvg:svgBlip xmlns:asvg="http://schemas.microsoft.com/office/drawing/2016/SVG/main" r:embed="rId10"/>
+                  <ns9:svgBlip xmlns:ns9="http://schemas.microsoft.com/office/drawing/2016/SVG/main" r:embed="rId32"/>
                 </a:ext>
               </a:extLst>
             </a:blip>
-            <a:srcRect/>
-            <a:stretch/>
+            <a:stretch>
+              <a:fillRect/>
+            </a:stretch>
           </p:blipFill>
           <p:spPr>
             <a:xfrm>
@@ -37373,8 +37387,8 @@
           </p:nvSpPr>
           <p:spPr>
             <a:xfrm flipV="1">
-              <a:off x="7858490" y="5449914"/>
-              <a:ext cx="1735200" cy="0"/>
+              <a:off x="8006090" y="5449914"/>
+              <a:ext cx="1440000" cy="0"/>
             </a:xfrm>
             <a:prstGeom prst="line">
               <a:avLst/>
@@ -37922,10 +37936,10 @@
         </p:nvGrpSpPr>
         <p:grpSpPr>
           <a:xfrm>
-            <a:off x="2558819" y="1570799"/>
-            <a:ext cx="1735200" cy="867600"/>
-            <a:chOff x="2636316" y="1570799"/>
-            <a:chExt cx="1735200" cy="867600"/>
+            <a:off x="2706419" y="1570799"/>
+            <a:ext cx="1440000" cy="867600"/>
+            <a:chOff x="2783916" y="1570799"/>
+            <a:chExt cx="1440000" cy="867600"/>
           </a:xfrm>
         </p:grpSpPr>
         <p:sp>
@@ -37944,8 +37958,8 @@
           </p:nvSpPr>
           <p:spPr>
             <a:xfrm>
-              <a:off x="2636316" y="1570799"/>
-              <a:ext cx="1735200" cy="867600"/>
+              <a:off x="2783916" y="1570799"/>
+              <a:ext cx="1440000" cy="867600"/>
             </a:xfrm>
             <a:prstGeom prst="roundRect">
               <a:avLst/>
@@ -37980,7 +37994,7 @@
             </a:fontRef>
           </p:style>
           <p:txBody>
-            <a:bodyPr tIns="28800" anchor="t"/>
+            <a:bodyPr tIns="28800" anchor="t" lIns="54000" rIns="54000" bIns="90000"/>
             <a:lstStyle/>
             <a:p>
               <a:pPr algn="ctr">
@@ -38021,15 +38035,16 @@
             <p:nvPr/>
           </p:nvPicPr>
           <p:blipFill>
-            <a:blip>
+            <a:blip r:embed="rId29">
               <a:extLst>
                 <a:ext uri="{96DAC541-7B7A-43D3-8B79-37D633B846F1}">
-                  <asvg:svgBlip xmlns:asvg="http://schemas.microsoft.com/office/drawing/2016/SVG/main" r:embed="rId10"/>
+                  <ns10:svgBlip xmlns:ns10="http://schemas.microsoft.com/office/drawing/2016/SVG/main" r:embed="rId30"/>
                 </a:ext>
               </a:extLst>
             </a:blip>
-            <a:srcRect/>
-            <a:stretch/>
+            <a:stretch>
+              <a:fillRect/>
+            </a:stretch>
           </p:blipFill>
           <p:spPr>
             <a:xfrm>
@@ -38057,8 +38072,8 @@
           </p:nvSpPr>
           <p:spPr>
             <a:xfrm>
-              <a:off x="2636316" y="1859360"/>
-              <a:ext cx="1735200" cy="0"/>
+              <a:off x="2783916" y="1859360"/>
+              <a:ext cx="1440000" cy="0"/>
             </a:xfrm>
             <a:prstGeom prst="line">
               <a:avLst/>
@@ -38442,10 +38457,10 @@
         </p:nvGrpSpPr>
         <p:grpSpPr>
           <a:xfrm>
-            <a:off x="470304" y="1570799"/>
-            <a:ext cx="1735200" cy="867600"/>
-            <a:chOff x="470304" y="1570799"/>
-            <a:chExt cx="1735200" cy="867600"/>
+            <a:off x="617904" y="1570799"/>
+            <a:ext cx="1440000" cy="867600"/>
+            <a:chOff x="617904" y="1570799"/>
+            <a:chExt cx="1440000" cy="867600"/>
           </a:xfrm>
         </p:grpSpPr>
         <p:sp>
@@ -38464,8 +38479,8 @@
           </p:nvSpPr>
           <p:spPr>
             <a:xfrm>
-              <a:off x="470304" y="1570799"/>
-              <a:ext cx="1735200" cy="867600"/>
+              <a:off x="617904" y="1570799"/>
+              <a:ext cx="1440000" cy="867600"/>
             </a:xfrm>
             <a:prstGeom prst="roundRect">
               <a:avLst/>
@@ -38500,7 +38515,7 @@
             </a:fontRef>
           </p:style>
           <p:txBody>
-            <a:bodyPr tIns="28800" anchor="t"/>
+            <a:bodyPr tIns="28800" anchor="t" lIns="54000" rIns="54000" bIns="90000"/>
             <a:lstStyle/>
             <a:p>
               <a:pPr algn="ctr">
@@ -38572,8 +38587,8 @@
           </p:nvSpPr>
           <p:spPr>
             <a:xfrm>
-              <a:off x="470304" y="1859360"/>
-              <a:ext cx="1735200" cy="0"/>
+              <a:off x="617904" y="1859360"/>
+              <a:ext cx="1440000" cy="0"/>
             </a:xfrm>
             <a:prstGeom prst="line">
               <a:avLst/>
@@ -38623,10 +38638,10 @@
         </p:nvGrpSpPr>
         <p:grpSpPr>
           <a:xfrm>
-            <a:off x="7858490" y="2761424"/>
-            <a:ext cx="1735200" cy="867600"/>
-            <a:chOff x="7858490" y="2794529"/>
-            <a:chExt cx="1735200" cy="867600"/>
+            <a:off x="8006090" y="2761424"/>
+            <a:ext cx="1440000" cy="867600"/>
+            <a:chOff x="8006090" y="2794529"/>
+            <a:chExt cx="1440000" cy="867600"/>
           </a:xfrm>
         </p:grpSpPr>
         <p:sp>
@@ -38645,8 +38660,8 @@
           </p:nvSpPr>
           <p:spPr>
             <a:xfrm>
-              <a:off x="7858490" y="2794529"/>
-              <a:ext cx="1735200" cy="867600"/>
+              <a:off x="8006090" y="2794529"/>
+              <a:ext cx="1440000" cy="867600"/>
             </a:xfrm>
             <a:prstGeom prst="roundRect">
               <a:avLst/>
@@ -38681,7 +38696,7 @@
             </a:fontRef>
           </p:style>
           <p:txBody>
-            <a:bodyPr tIns="28800" anchor="t"/>
+            <a:bodyPr tIns="28800" anchor="t" lIns="54000" rIns="54000" bIns="90000"/>
             <a:lstStyle/>
             <a:p>
               <a:pPr algn="ctr"/>
@@ -38720,15 +38735,16 @@
             <p:nvPr/>
           </p:nvPicPr>
           <p:blipFill>
-            <a:blip>
+            <a:blip r:embed="rId23">
               <a:extLst>
                 <a:ext uri="{96DAC541-7B7A-43D3-8B79-37D633B846F1}">
-                  <asvg:svgBlip xmlns:asvg="http://schemas.microsoft.com/office/drawing/2016/SVG/main" r:embed="rId7"/>
+                  <ns11:svgBlip xmlns:ns11="http://schemas.microsoft.com/office/drawing/2016/SVG/main" r:embed="rId24"/>
                 </a:ext>
               </a:extLst>
             </a:blip>
-            <a:srcRect/>
-            <a:stretch/>
+            <a:stretch>
+              <a:fillRect/>
+            </a:stretch>
           </p:blipFill>
           <p:spPr>
             <a:xfrm>
@@ -38756,8 +38772,8 @@
           </p:nvSpPr>
           <p:spPr>
             <a:xfrm flipV="1">
-              <a:off x="7858490" y="3083090"/>
-              <a:ext cx="1735200" cy="0"/>
+              <a:off x="8006090" y="3083090"/>
+              <a:ext cx="1440000" cy="0"/>
             </a:xfrm>
             <a:prstGeom prst="line">
               <a:avLst/>
@@ -38807,10 +38823,10 @@
         </p:nvGrpSpPr>
         <p:grpSpPr>
           <a:xfrm>
-            <a:off x="2543715" y="3952049"/>
-            <a:ext cx="1735200" cy="867600"/>
-            <a:chOff x="2636316" y="1570799"/>
-            <a:chExt cx="1735200" cy="867600"/>
+            <a:off x="2691315" y="3952049"/>
+            <a:ext cx="1440000" cy="867600"/>
+            <a:chOff x="2783916" y="1570799"/>
+            <a:chExt cx="1440000" cy="867600"/>
           </a:xfrm>
         </p:grpSpPr>
         <p:sp>
@@ -38829,8 +38845,8 @@
           </p:nvSpPr>
           <p:spPr>
             <a:xfrm>
-              <a:off x="2636316" y="1570799"/>
-              <a:ext cx="1735200" cy="867600"/>
+              <a:off x="2783916" y="1570799"/>
+              <a:ext cx="1440000" cy="867600"/>
             </a:xfrm>
             <a:prstGeom prst="roundRect">
               <a:avLst/>
@@ -38865,7 +38881,7 @@
             </a:fontRef>
           </p:style>
           <p:txBody>
-            <a:bodyPr tIns="28800" anchor="t"/>
+            <a:bodyPr tIns="28800" anchor="t" lIns="54000" rIns="54000" bIns="90000"/>
             <a:lstStyle/>
             <a:p>
               <a:pPr algn="ctr">
@@ -38906,15 +38922,16 @@
             <p:nvPr/>
           </p:nvPicPr>
           <p:blipFill>
-            <a:blip>
+            <a:blip r:embed="rId33">
               <a:extLst>
                 <a:ext uri="{96DAC541-7B7A-43D3-8B79-37D633B846F1}">
-                  <asvg:svgBlip xmlns:asvg="http://schemas.microsoft.com/office/drawing/2016/SVG/main" r:embed="rId12"/>
+                  <ns12:svgBlip xmlns:ns12="http://schemas.microsoft.com/office/drawing/2016/SVG/main" r:embed="rId34"/>
                 </a:ext>
               </a:extLst>
             </a:blip>
-            <a:srcRect/>
-            <a:stretch/>
+            <a:stretch>
+              <a:fillRect/>
+            </a:stretch>
           </p:blipFill>
           <p:spPr>
             <a:xfrm>
@@ -38942,8 +38959,8 @@
           </p:nvSpPr>
           <p:spPr>
             <a:xfrm>
-              <a:off x="2636316" y="1859360"/>
-              <a:ext cx="1735200" cy="0"/>
+              <a:off x="2783916" y="1859360"/>
+              <a:ext cx="1440000" cy="0"/>
             </a:xfrm>
             <a:prstGeom prst="line">
               <a:avLst/>

</xml_diff>

<commit_message>
Tweak new icon set and slide 7
Co-Authored-By: Claude Fable 5 <noreply@anthropic.com>
Claude-Session: https://claude.ai/code/session_01S2kGP2buE2HmxMttD3XczR
</commit_message>
<xml_diff>
--- a/RAG_Workshop.pptx
+++ b/RAG_Workshop.pptx
@@ -35634,7 +35634,7 @@
         </p:nvGrpSpPr>
         <p:grpSpPr>
           <a:xfrm>
-            <a:off x="624215" y="5142674"/>
+            <a:off x="540000" y="5018849"/>
             <a:ext cx="1440000" cy="867600"/>
             <a:chOff x="624215" y="5142674"/>
             <a:chExt cx="1440000" cy="867600"/>
@@ -35692,7 +35692,7 @@
             </a:fontRef>
           </p:style>
           <p:txBody>
-            <a:bodyPr tIns="28800" anchor="t" lIns="54000" rIns="54000" bIns="90000"/>
+            <a:bodyPr lIns="54000" tIns="28800" rIns="54000" bIns="90000" anchor="t"/>
             <a:lstStyle/>
             <a:p>
               <a:pPr algn="ctr">
@@ -35785,10 +35785,10 @@
             <p:nvPr/>
           </p:nvPicPr>
           <p:blipFill>
-            <a:blip r:embed="rId13">
+            <a:blip>
               <a:extLst>
                 <a:ext uri="{96DAC541-7B7A-43D3-8B79-37D633B846F1}">
-                  <ns0:svgBlip xmlns:ns0="http://schemas.microsoft.com/office/drawing/2016/SVG/main" r:embed="rId14"/>
+                  <asvg:svgBlip xmlns:asvg="http://schemas.microsoft.com/office/drawing/2016/SVG/main" r:embed="rId3"/>
                 </a:ext>
               </a:extLst>
             </a:blip>
@@ -35815,7 +35815,7 @@
         </p:nvGrpSpPr>
         <p:grpSpPr>
           <a:xfrm>
-            <a:off x="10196840" y="1570799"/>
+            <a:off x="9540000" y="1449525"/>
             <a:ext cx="1440000" cy="867600"/>
             <a:chOff x="10196840" y="1570799"/>
             <a:chExt cx="1440000" cy="867600"/>
@@ -35871,7 +35871,7 @@
             </a:fontRef>
           </p:style>
           <p:txBody>
-            <a:bodyPr tIns="28800" anchor="t" lIns="54000" rIns="54000" bIns="90000"/>
+            <a:bodyPr lIns="54000" tIns="28800" rIns="54000" bIns="90000" anchor="t"/>
             <a:lstStyle/>
             <a:p>
               <a:pPr algn="ctr">
@@ -35912,10 +35912,10 @@
             <p:nvPr/>
           </p:nvPicPr>
           <p:blipFill>
-            <a:blip r:embed="rId15">
+            <a:blip>
               <a:extLst>
                 <a:ext uri="{96DAC541-7B7A-43D3-8B79-37D633B846F1}">
-                  <ns1:svgBlip xmlns:ns1="http://schemas.microsoft.com/office/drawing/2016/SVG/main" r:embed="rId16"/>
+                  <asvg:svgBlip xmlns:asvg="http://schemas.microsoft.com/office/drawing/2016/SVG/main" r:embed="rId4"/>
                 </a:ext>
               </a:extLst>
             </a:blip>
@@ -35986,7 +35986,7 @@
         </p:nvGrpSpPr>
         <p:grpSpPr>
           <a:xfrm>
-            <a:off x="10196840" y="5161353"/>
+            <a:off x="9540000" y="5028003"/>
             <a:ext cx="1440000" cy="867600"/>
             <a:chOff x="10196840" y="5161353"/>
             <a:chExt cx="1440000" cy="867600"/>
@@ -36042,7 +36042,7 @@
             </a:fontRef>
           </p:style>
           <p:txBody>
-            <a:bodyPr tIns="28800" anchor="t" lIns="54000" rIns="54000" bIns="90000"/>
+            <a:bodyPr lIns="54000" tIns="28800" rIns="54000" bIns="90000" anchor="t"/>
             <a:lstStyle/>
             <a:p>
               <a:pPr algn="ctr">
@@ -36083,10 +36083,10 @@
             <p:nvPr/>
           </p:nvPicPr>
           <p:blipFill>
-            <a:blip r:embed="rId17">
+            <a:blip>
               <a:extLst>
                 <a:ext uri="{96DAC541-7B7A-43D3-8B79-37D633B846F1}">
-                  <ns2:svgBlip xmlns:ns2="http://schemas.microsoft.com/office/drawing/2016/SVG/main" r:embed="rId18"/>
+                  <asvg:svgBlip xmlns:asvg="http://schemas.microsoft.com/office/drawing/2016/SVG/main" r:embed="rId5"/>
                 </a:ext>
               </a:extLst>
             </a:blip>
@@ -36157,7 +36157,7 @@
         </p:nvGrpSpPr>
         <p:grpSpPr>
           <a:xfrm>
-            <a:off x="472711" y="3952049"/>
+            <a:off x="540000" y="3828224"/>
             <a:ext cx="1440000" cy="867600"/>
             <a:chOff x="622908" y="3952049"/>
             <a:chExt cx="1440000" cy="867600"/>
@@ -36215,7 +36215,7 @@
             </a:fontRef>
           </p:style>
           <p:txBody>
-            <a:bodyPr lIns="54000" tIns="28800" rIns="54000" anchor="t" bIns="90000"/>
+            <a:bodyPr lIns="54000" tIns="28800" rIns="54000" bIns="90000" anchor="t"/>
             <a:lstStyle/>
             <a:p>
               <a:pPr algn="ctr">
@@ -36256,10 +36256,10 @@
             <p:nvPr/>
           </p:nvPicPr>
           <p:blipFill>
-            <a:blip r:embed="rId19">
+            <a:blip>
               <a:extLst>
                 <a:ext uri="{96DAC541-7B7A-43D3-8B79-37D633B846F1}">
-                  <ns3:svgBlip xmlns:ns3="http://schemas.microsoft.com/office/drawing/2016/SVG/main" r:embed="rId20"/>
+                  <asvg:svgBlip xmlns:asvg="http://schemas.microsoft.com/office/drawing/2016/SVG/main" r:embed="rId6"/>
                 </a:ext>
               </a:extLst>
             </a:blip>
@@ -36344,7 +36344,7 @@
         </p:nvGrpSpPr>
         <p:grpSpPr>
           <a:xfrm>
-            <a:off x="624215" y="2761424"/>
+            <a:off x="540000" y="2637599"/>
             <a:ext cx="1440000" cy="867600"/>
             <a:chOff x="624215" y="2761424"/>
             <a:chExt cx="1440000" cy="867600"/>
@@ -36402,7 +36402,7 @@
             </a:fontRef>
           </p:style>
           <p:txBody>
-            <a:bodyPr tIns="28800" anchor="t" lIns="54000" rIns="54000" bIns="90000"/>
+            <a:bodyPr lIns="54000" tIns="28800" rIns="54000" bIns="90000" anchor="t"/>
             <a:lstStyle/>
             <a:p>
               <a:pPr algn="ctr"/>
@@ -36493,10 +36493,10 @@
             <p:nvPr/>
           </p:nvPicPr>
           <p:blipFill>
-            <a:blip r:embed="rId21">
+            <a:blip>
               <a:extLst>
                 <a:ext uri="{96DAC541-7B7A-43D3-8B79-37D633B846F1}">
-                  <ns4:svgBlip xmlns:ns4="http://schemas.microsoft.com/office/drawing/2016/SVG/main" r:embed="rId22"/>
+                  <asvg:svgBlip xmlns:asvg="http://schemas.microsoft.com/office/drawing/2016/SVG/main" r:embed="rId7"/>
                 </a:ext>
               </a:extLst>
             </a:blip>
@@ -36523,7 +36523,7 @@
         </p:nvGrpSpPr>
         <p:grpSpPr>
           <a:xfrm>
-            <a:off x="5009244" y="1578083"/>
+            <a:off x="5940000" y="1454258"/>
             <a:ext cx="1440000" cy="867600"/>
             <a:chOff x="5009244" y="1578083"/>
             <a:chExt cx="1440000" cy="867600"/>
@@ -36581,7 +36581,7 @@
             </a:fontRef>
           </p:style>
           <p:txBody>
-            <a:bodyPr tIns="28800" anchor="t" lIns="54000" rIns="54000" bIns="90000"/>
+            <a:bodyPr lIns="54000" tIns="28800" rIns="54000" bIns="90000" anchor="t"/>
             <a:lstStyle/>
             <a:p>
               <a:pPr algn="ctr">
@@ -36622,10 +36622,10 @@
             <p:nvPr/>
           </p:nvPicPr>
           <p:blipFill>
-            <a:blip r:embed="rId23">
+            <a:blip>
               <a:extLst>
                 <a:ext uri="{96DAC541-7B7A-43D3-8B79-37D633B846F1}">
-                  <ns5:svgBlip xmlns:ns5="http://schemas.microsoft.com/office/drawing/2016/SVG/main" r:embed="rId24"/>
+                  <asvg:svgBlip xmlns:asvg="http://schemas.microsoft.com/office/drawing/2016/SVG/main" r:embed="rId8"/>
                 </a:ext>
               </a:extLst>
             </a:blip>
@@ -36704,7 +36704,7 @@
         </p:nvGrpSpPr>
         <p:grpSpPr>
           <a:xfrm>
-            <a:off x="5005715" y="2761424"/>
+            <a:off x="5940000" y="2637599"/>
             <a:ext cx="1440000" cy="867600"/>
             <a:chOff x="5005715" y="2776165"/>
             <a:chExt cx="1440000" cy="867600"/>
@@ -36762,7 +36762,7 @@
             </a:fontRef>
           </p:style>
           <p:txBody>
-            <a:bodyPr tIns="28800" anchor="t" lIns="54000" rIns="54000" bIns="90000"/>
+            <a:bodyPr lIns="54000" tIns="28800" rIns="54000" bIns="90000" anchor="t"/>
             <a:lstStyle/>
             <a:p>
               <a:pPr algn="ctr">
@@ -36803,10 +36803,10 @@
             <p:nvPr/>
           </p:nvPicPr>
           <p:blipFill>
-            <a:blip r:embed="rId25">
+            <a:blip>
               <a:extLst>
                 <a:ext uri="{96DAC541-7B7A-43D3-8B79-37D633B846F1}">
-                  <ns6:svgBlip xmlns:ns6="http://schemas.microsoft.com/office/drawing/2016/SVG/main" r:embed="rId26"/>
+                  <asvg:svgBlip xmlns:asvg="http://schemas.microsoft.com/office/drawing/2016/SVG/main" r:embed="rId9"/>
                 </a:ext>
               </a:extLst>
             </a:blip>
@@ -36885,7 +36885,7 @@
         </p:nvGrpSpPr>
         <p:grpSpPr>
           <a:xfrm>
-            <a:off x="5005715" y="5161353"/>
+            <a:off x="5940000" y="5037528"/>
             <a:ext cx="1440000" cy="867600"/>
             <a:chOff x="5005715" y="5161353"/>
             <a:chExt cx="1440000" cy="867600"/>
@@ -36943,7 +36943,7 @@
             </a:fontRef>
           </p:style>
           <p:txBody>
-            <a:bodyPr tIns="28800" anchor="t" lIns="54000" rIns="54000" bIns="90000"/>
+            <a:bodyPr lIns="54000" tIns="28800" rIns="54000" bIns="90000" anchor="t"/>
             <a:lstStyle/>
             <a:p>
               <a:pPr algn="ctr">
@@ -36984,10 +36984,10 @@
             <p:nvPr/>
           </p:nvPicPr>
           <p:blipFill>
-            <a:blip r:embed="rId27">
+            <a:blip>
               <a:extLst>
                 <a:ext uri="{96DAC541-7B7A-43D3-8B79-37D633B846F1}">
-                  <ns7:svgBlip xmlns:ns7="http://schemas.microsoft.com/office/drawing/2016/SVG/main" r:embed="rId28"/>
+                  <asvg:svgBlip xmlns:asvg="http://schemas.microsoft.com/office/drawing/2016/SVG/main" r:embed="rId10"/>
                 </a:ext>
               </a:extLst>
             </a:blip>
@@ -37066,7 +37066,7 @@
         </p:nvGrpSpPr>
         <p:grpSpPr>
           <a:xfrm>
-            <a:off x="7996042" y="1570799"/>
+            <a:off x="7740000" y="1446974"/>
             <a:ext cx="1440000" cy="867600"/>
             <a:chOff x="7996042" y="1570799"/>
             <a:chExt cx="1440000" cy="867600"/>
@@ -37124,7 +37124,7 @@
             </a:fontRef>
           </p:style>
           <p:txBody>
-            <a:bodyPr tIns="28800" anchor="t" lIns="54000" rIns="54000" bIns="90000"/>
+            <a:bodyPr lIns="54000" tIns="28800" rIns="54000" bIns="90000" anchor="t"/>
             <a:lstStyle/>
             <a:p>
               <a:pPr algn="ctr">
@@ -37165,10 +37165,10 @@
             <p:nvPr/>
           </p:nvPicPr>
           <p:blipFill>
-            <a:blip r:embed="rId29">
+            <a:blip>
               <a:extLst>
                 <a:ext uri="{96DAC541-7B7A-43D3-8B79-37D633B846F1}">
-                  <ns8:svgBlip xmlns:ns8="http://schemas.microsoft.com/office/drawing/2016/SVG/main" r:embed="rId30"/>
+                  <asvg:svgBlip xmlns:asvg="http://schemas.microsoft.com/office/drawing/2016/SVG/main" r:embed="rId11"/>
                 </a:ext>
               </a:extLst>
             </a:blip>
@@ -37251,7 +37251,7 @@
         </p:nvGrpSpPr>
         <p:grpSpPr>
           <a:xfrm>
-            <a:off x="8006090" y="5161353"/>
+            <a:off x="7740000" y="5037528"/>
             <a:ext cx="1440000" cy="867600"/>
             <a:chOff x="8006090" y="5161353"/>
             <a:chExt cx="1440000" cy="867600"/>
@@ -37309,7 +37309,7 @@
             </a:fontRef>
           </p:style>
           <p:txBody>
-            <a:bodyPr tIns="28800" anchor="t" lIns="54000" rIns="54000" bIns="90000"/>
+            <a:bodyPr lIns="54000" tIns="28800" rIns="54000" bIns="90000" anchor="t"/>
             <a:lstStyle/>
             <a:p>
               <a:pPr algn="ctr">
@@ -37350,10 +37350,10 @@
             <p:nvPr/>
           </p:nvPicPr>
           <p:blipFill>
-            <a:blip r:embed="rId31">
+            <a:blip>
               <a:extLst>
                 <a:ext uri="{96DAC541-7B7A-43D3-8B79-37D633B846F1}">
-                  <ns9:svgBlip xmlns:ns9="http://schemas.microsoft.com/office/drawing/2016/SVG/main" r:embed="rId32"/>
+                  <asvg:svgBlip xmlns:asvg="http://schemas.microsoft.com/office/drawing/2016/SVG/main" r:embed="rId12"/>
                 </a:ext>
               </a:extLst>
             </a:blip>
@@ -37433,15 +37433,13 @@
           </p:cNvPr>
           <p:cNvCxnSpPr>
             <a:cxnSpLocks/>
-            <a:stCxn id="10" idx="0"/>
-            <a:endCxn id="137" idx="2"/>
           </p:cNvCxnSpPr>
           <p:nvPr/>
         </p:nvCxnSpPr>
         <p:spPr>
           <a:xfrm flipV="1">
-            <a:off x="1344215" y="2438399"/>
-            <a:ext cx="2082204" cy="2704275"/>
+            <a:off x="540000" y="2313687"/>
+            <a:ext cx="1777931" cy="2705162"/>
           </a:xfrm>
           <a:prstGeom prst="straightConnector1">
             <a:avLst/>
@@ -37485,8 +37483,8 @@
         </p:nvCxnSpPr>
         <p:spPr>
           <a:xfrm flipV="1">
-            <a:off x="1192712" y="3629024"/>
-            <a:ext cx="151503" cy="323025"/>
+            <a:off x="1260000" y="3505199"/>
+            <a:ext cx="0" cy="323025"/>
           </a:xfrm>
           <a:prstGeom prst="straightConnector1">
             <a:avLst/>
@@ -37533,9 +37531,9 @@
           <p:nvPr/>
         </p:nvCxnSpPr>
         <p:spPr>
-          <a:xfrm flipH="1" flipV="1">
-            <a:off x="1337904" y="2438399"/>
-            <a:ext cx="6311" cy="323025"/>
+          <a:xfrm flipV="1">
+            <a:off x="1260000" y="2314574"/>
+            <a:ext cx="0" cy="323025"/>
           </a:xfrm>
           <a:prstGeom prst="straightConnector1">
             <a:avLst/>
@@ -37575,15 +37573,15 @@
             </a:extLst>
           </p:cNvPr>
           <p:cNvCxnSpPr>
+            <a:cxnSpLocks/>
             <a:stCxn id="54" idx="3"/>
-            <a:endCxn id="77" idx="0"/>
           </p:cNvCxnSpPr>
           <p:nvPr/>
         </p:nvCxnSpPr>
         <p:spPr>
           <a:xfrm flipH="1">
-            <a:off x="6114751" y="2012297"/>
-            <a:ext cx="642461" cy="783373"/>
+            <a:off x="6114751" y="1888058"/>
+            <a:ext cx="1265249" cy="783787"/>
           </a:xfrm>
           <a:prstGeom prst="straightConnector1">
             <a:avLst/>
@@ -37625,7 +37623,7 @@
         </p:nvCxnSpPr>
         <p:spPr>
           <a:xfrm flipH="1">
-            <a:off x="6224316" y="5508983"/>
+            <a:off x="6224316" y="5385158"/>
             <a:ext cx="6013" cy="366749"/>
           </a:xfrm>
           <a:prstGeom prst="straightConnector1">
@@ -37670,8 +37668,8 @@
         </p:nvCxnSpPr>
         <p:spPr>
           <a:xfrm>
-            <a:off x="6593315" y="5595153"/>
-            <a:ext cx="1265175" cy="0"/>
+            <a:off x="7380000" y="5471328"/>
+            <a:ext cx="360000" cy="0"/>
           </a:xfrm>
           <a:prstGeom prst="straightConnector1">
             <a:avLst/>
@@ -37719,8 +37717,8 @@
         </p:nvCxnSpPr>
         <p:spPr>
           <a:xfrm flipH="1">
-            <a:off x="6593315" y="3195224"/>
-            <a:ext cx="1265175" cy="0"/>
+            <a:off x="7380000" y="3071399"/>
+            <a:ext cx="360000" cy="0"/>
           </a:xfrm>
           <a:prstGeom prst="straightConnector1">
             <a:avLst/>
@@ -37767,7 +37765,7 @@
         </p:nvCxnSpPr>
         <p:spPr>
           <a:xfrm flipH="1">
-            <a:off x="4355058" y="2005013"/>
+            <a:off x="4099016" y="1881188"/>
             <a:ext cx="3499473" cy="779775"/>
           </a:xfrm>
           <a:prstGeom prst="straightConnector1">
@@ -37808,7 +37806,7 @@
         </p:nvCxnSpPr>
         <p:spPr>
           <a:xfrm>
-            <a:off x="8589017" y="2354960"/>
+            <a:off x="8589017" y="2278760"/>
             <a:ext cx="1139991" cy="1310591"/>
           </a:xfrm>
           <a:prstGeom prst="straightConnector1">
@@ -37852,7 +37850,7 @@
         </p:nvCxnSpPr>
         <p:spPr>
           <a:xfrm flipH="1">
-            <a:off x="9355930" y="2005013"/>
+            <a:off x="8699090" y="1883739"/>
             <a:ext cx="931070" cy="1205366"/>
           </a:xfrm>
           <a:prstGeom prst="straightConnector1">
@@ -37896,9 +37894,9 @@
           <p:nvPr/>
         </p:nvCxnSpPr>
         <p:spPr>
-          <a:xfrm>
-            <a:off x="2205504" y="2004599"/>
-            <a:ext cx="353315" cy="0"/>
+          <a:xfrm flipV="1">
+            <a:off x="1980000" y="1879887"/>
+            <a:ext cx="360000" cy="887"/>
           </a:xfrm>
           <a:prstGeom prst="straightConnector1">
             <a:avLst/>
@@ -37936,7 +37934,7 @@
         </p:nvGrpSpPr>
         <p:grpSpPr>
           <a:xfrm>
-            <a:off x="2706419" y="1570799"/>
+            <a:off x="2340000" y="1446087"/>
             <a:ext cx="1440000" cy="867600"/>
             <a:chOff x="2783916" y="1570799"/>
             <a:chExt cx="1440000" cy="867600"/>
@@ -37994,7 +37992,7 @@
             </a:fontRef>
           </p:style>
           <p:txBody>
-            <a:bodyPr tIns="28800" anchor="t" lIns="54000" rIns="54000" bIns="90000"/>
+            <a:bodyPr lIns="54000" tIns="28800" rIns="54000" bIns="90000" anchor="t"/>
             <a:lstStyle/>
             <a:p>
               <a:pPr algn="ctr">
@@ -38035,10 +38033,10 @@
             <p:nvPr/>
           </p:nvPicPr>
           <p:blipFill>
-            <a:blip r:embed="rId29">
+            <a:blip>
               <a:extLst>
                 <a:ext uri="{96DAC541-7B7A-43D3-8B79-37D633B846F1}">
-                  <ns10:svgBlip xmlns:ns10="http://schemas.microsoft.com/office/drawing/2016/SVG/main" r:embed="rId30"/>
+                  <asvg:svgBlip xmlns:asvg="http://schemas.microsoft.com/office/drawing/2016/SVG/main" r:embed="rId11"/>
                 </a:ext>
               </a:extLst>
             </a:blip>
@@ -38125,8 +38123,8 @@
         </p:nvCxnSpPr>
         <p:spPr>
           <a:xfrm>
-            <a:off x="4294019" y="2004599"/>
-            <a:ext cx="567625" cy="7284"/>
+            <a:off x="3780000" y="1879887"/>
+            <a:ext cx="2160000" cy="8171"/>
           </a:xfrm>
           <a:prstGeom prst="straightConnector1">
             <a:avLst/>
@@ -38173,9 +38171,9 @@
           <p:nvPr/>
         </p:nvCxnSpPr>
         <p:spPr>
-          <a:xfrm>
-            <a:off x="9593690" y="5595153"/>
-            <a:ext cx="455550" cy="0"/>
+          <a:xfrm flipV="1">
+            <a:off x="9180000" y="5461803"/>
+            <a:ext cx="360000" cy="9525"/>
           </a:xfrm>
           <a:prstGeom prst="straightConnector1">
             <a:avLst/>
@@ -38217,14 +38215,14 @@
           <p:cNvCxnSpPr>
             <a:cxnSpLocks/>
             <a:stCxn id="10" idx="0"/>
-            <a:endCxn id="42" idx="2"/>
+            <a:endCxn id="37" idx="2"/>
           </p:cNvCxnSpPr>
           <p:nvPr/>
         </p:nvCxnSpPr>
         <p:spPr>
-          <a:xfrm flipH="1" flipV="1">
-            <a:off x="1192712" y="4755475"/>
-            <a:ext cx="151503" cy="387199"/>
+          <a:xfrm flipV="1">
+            <a:off x="1260000" y="4695824"/>
+            <a:ext cx="0" cy="323025"/>
           </a:xfrm>
           <a:prstGeom prst="straightConnector1">
             <a:avLst/>
@@ -38271,9 +38269,9 @@
           <p:nvPr/>
         </p:nvCxnSpPr>
         <p:spPr>
-          <a:xfrm flipH="1">
-            <a:off x="9583642" y="2004599"/>
-            <a:ext cx="465598" cy="0"/>
+          <a:xfrm flipH="1" flipV="1">
+            <a:off x="9180000" y="1880774"/>
+            <a:ext cx="360000" cy="2551"/>
           </a:xfrm>
           <a:prstGeom prst="straightConnector1">
             <a:avLst/>
@@ -38314,15 +38312,15 @@
           </p:cNvPr>
           <p:cNvCxnSpPr>
             <a:cxnSpLocks/>
-            <a:stCxn id="96" idx="2"/>
+            <a:stCxn id="93" idx="2"/>
             <a:endCxn id="32" idx="0"/>
           </p:cNvCxnSpPr>
           <p:nvPr/>
         </p:nvCxnSpPr>
         <p:spPr>
           <a:xfrm>
-            <a:off x="8716042" y="2374225"/>
-            <a:ext cx="10048" cy="387199"/>
+            <a:off x="8460000" y="2314574"/>
+            <a:ext cx="0" cy="323025"/>
           </a:xfrm>
           <a:prstGeom prst="straightConnector1">
             <a:avLst/>
@@ -38369,7 +38367,7 @@
         </p:nvCxnSpPr>
         <p:spPr>
           <a:xfrm>
-            <a:off x="5713094" y="2445683"/>
+            <a:off x="6647379" y="2321858"/>
             <a:ext cx="12621" cy="315741"/>
           </a:xfrm>
           <a:prstGeom prst="straightConnector1">
@@ -38412,14 +38410,14 @@
           <p:cNvCxnSpPr>
             <a:cxnSpLocks/>
             <a:stCxn id="72" idx="2"/>
-            <a:endCxn id="81" idx="0"/>
+            <a:endCxn id="41" idx="0"/>
           </p:cNvCxnSpPr>
           <p:nvPr/>
         </p:nvCxnSpPr>
         <p:spPr>
           <a:xfrm>
-            <a:off x="5725715" y="3629024"/>
-            <a:ext cx="0" cy="1532329"/>
+            <a:off x="6660000" y="3505199"/>
+            <a:ext cx="0" cy="323025"/>
           </a:xfrm>
           <a:prstGeom prst="straightConnector1">
             <a:avLst/>
@@ -38457,7 +38455,7 @@
         </p:nvGrpSpPr>
         <p:grpSpPr>
           <a:xfrm>
-            <a:off x="617904" y="1570799"/>
+            <a:off x="540000" y="1446974"/>
             <a:ext cx="1440000" cy="867600"/>
             <a:chOff x="617904" y="1570799"/>
             <a:chExt cx="1440000" cy="867600"/>
@@ -38515,7 +38513,7 @@
             </a:fontRef>
           </p:style>
           <p:txBody>
-            <a:bodyPr tIns="28800" anchor="t" lIns="54000" rIns="54000" bIns="90000"/>
+            <a:bodyPr lIns="54000" tIns="28800" rIns="54000" bIns="90000" anchor="t"/>
             <a:lstStyle/>
             <a:p>
               <a:pPr algn="ctr">
@@ -38556,7 +38554,7 @@
             <p:nvPr/>
           </p:nvPicPr>
           <p:blipFill>
-            <a:blip r:embed="rId11"/>
+            <a:blip r:embed="rId13"/>
             <a:stretch>
               <a:fillRect/>
             </a:stretch>
@@ -38638,7 +38636,7 @@
         </p:nvGrpSpPr>
         <p:grpSpPr>
           <a:xfrm>
-            <a:off x="8006090" y="2761424"/>
+            <a:off x="7740000" y="2637599"/>
             <a:ext cx="1440000" cy="867600"/>
             <a:chOff x="8006090" y="2794529"/>
             <a:chExt cx="1440000" cy="867600"/>
@@ -38696,7 +38694,7 @@
             </a:fontRef>
           </p:style>
           <p:txBody>
-            <a:bodyPr tIns="28800" anchor="t" lIns="54000" rIns="54000" bIns="90000"/>
+            <a:bodyPr lIns="54000" tIns="28800" rIns="54000" bIns="90000" anchor="t"/>
             <a:lstStyle/>
             <a:p>
               <a:pPr algn="ctr"/>
@@ -38735,10 +38733,10 @@
             <p:nvPr/>
           </p:nvPicPr>
           <p:blipFill>
-            <a:blip r:embed="rId23">
+            <a:blip>
               <a:extLst>
                 <a:ext uri="{96DAC541-7B7A-43D3-8B79-37D633B846F1}">
-                  <ns11:svgBlip xmlns:ns11="http://schemas.microsoft.com/office/drawing/2016/SVG/main" r:embed="rId24"/>
+                  <asvg:svgBlip xmlns:asvg="http://schemas.microsoft.com/office/drawing/2016/SVG/main" r:embed="rId8"/>
                 </a:ext>
               </a:extLst>
             </a:blip>
@@ -38823,7 +38821,7 @@
         </p:nvGrpSpPr>
         <p:grpSpPr>
           <a:xfrm>
-            <a:off x="2691315" y="3952049"/>
+            <a:off x="2340000" y="3828224"/>
             <a:ext cx="1440000" cy="867600"/>
             <a:chOff x="2783916" y="1570799"/>
             <a:chExt cx="1440000" cy="867600"/>
@@ -38881,7 +38879,7 @@
             </a:fontRef>
           </p:style>
           <p:txBody>
-            <a:bodyPr tIns="28800" anchor="t" lIns="54000" rIns="54000" bIns="90000"/>
+            <a:bodyPr lIns="54000" tIns="28800" rIns="54000" bIns="90000" anchor="t"/>
             <a:lstStyle/>
             <a:p>
               <a:pPr algn="ctr">
@@ -38922,10 +38920,10 @@
             <p:nvPr/>
           </p:nvPicPr>
           <p:blipFill>
-            <a:blip r:embed="rId33">
+            <a:blip>
               <a:extLst>
                 <a:ext uri="{96DAC541-7B7A-43D3-8B79-37D633B846F1}">
-                  <ns12:svgBlip xmlns:ns12="http://schemas.microsoft.com/office/drawing/2016/SVG/main" r:embed="rId34"/>
+                  <asvg:svgBlip xmlns:asvg="http://schemas.microsoft.com/office/drawing/2016/SVG/main" r:embed="rId14"/>
                 </a:ext>
               </a:extLst>
             </a:blip>
@@ -39012,8 +39010,527 @@
         </p:nvCxnSpPr>
         <p:spPr>
           <a:xfrm>
-            <a:off x="1910115" y="4385849"/>
-            <a:ext cx="633600" cy="0"/>
+            <a:off x="1980000" y="4262024"/>
+            <a:ext cx="360000" cy="0"/>
+          </a:xfrm>
+          <a:prstGeom prst="straightConnector1">
+            <a:avLst/>
+          </a:prstGeom>
+          <a:ln w="50800">
+            <a:solidFill>
+              <a:schemeClr val="tx1">
+                <a:alpha val="50000"/>
+              </a:schemeClr>
+            </a:solidFill>
+            <a:prstDash val="solid"/>
+            <a:tailEnd type="triangle"/>
+          </a:ln>
+        </p:spPr>
+        <p:style>
+          <a:lnRef idx="1">
+            <a:schemeClr val="accent1"/>
+          </a:lnRef>
+          <a:fillRef idx="0">
+            <a:schemeClr val="accent1"/>
+          </a:fillRef>
+          <a:effectRef idx="0">
+            <a:schemeClr val="accent1"/>
+          </a:effectRef>
+          <a:fontRef idx="minor">
+            <a:schemeClr val="tx1"/>
+          </a:fontRef>
+        </p:style>
+      </p:cxnSp>
+      <p:grpSp>
+        <p:nvGrpSpPr>
+          <p:cNvPr id="12" name="Gruppe Vector Database">
+            <a:extLst>
+              <a:ext uri="{FF2B5EF4-FFF2-40B4-BE49-F238E27FC236}">
+                <a16:creationId xmlns:a16="http://schemas.microsoft.com/office/drawing/2014/main" id="{BFB423DB-992A-5876-26AC-811D2AA99C40}"/>
+              </a:ext>
+            </a:extLst>
+          </p:cNvPr>
+          <p:cNvGrpSpPr/>
+          <p:nvPr/>
+        </p:nvGrpSpPr>
+        <p:grpSpPr>
+          <a:xfrm>
+            <a:off x="4140000" y="3828224"/>
+            <a:ext cx="1440000" cy="867600"/>
+            <a:chOff x="5005715" y="2776165"/>
+            <a:chExt cx="1440000" cy="867600"/>
+          </a:xfrm>
+        </p:grpSpPr>
+        <p:sp>
+          <p:nvSpPr>
+            <p:cNvPr id="13" name="Rechteck: abgerundete Ecken 12">
+              <a:extLst>
+                <a:ext uri="{FF2B5EF4-FFF2-40B4-BE49-F238E27FC236}">
+                  <a16:creationId xmlns:a16="http://schemas.microsoft.com/office/drawing/2014/main" id="{CC99E781-A55C-22DF-C8AA-03E22653591B}"/>
+                </a:ext>
+              </a:extLst>
+            </p:cNvPr>
+            <p:cNvSpPr>
+              <a:spLocks/>
+            </p:cNvSpPr>
+            <p:nvPr/>
+          </p:nvSpPr>
+          <p:spPr>
+            <a:xfrm>
+              <a:off x="5005715" y="2776165"/>
+              <a:ext cx="1440000" cy="867600"/>
+            </a:xfrm>
+            <a:prstGeom prst="roundRect">
+              <a:avLst/>
+            </a:prstGeom>
+            <a:solidFill>
+              <a:schemeClr val="bg2">
+                <a:alpha val="50000"/>
+              </a:schemeClr>
+            </a:solidFill>
+            <a:ln>
+              <a:solidFill>
+                <a:schemeClr val="bg2">
+                  <a:lumMod val="50000"/>
+                </a:schemeClr>
+              </a:solidFill>
+            </a:ln>
+          </p:spPr>
+          <p:style>
+            <a:lnRef idx="2">
+              <a:schemeClr val="accent1">
+                <a:shade val="15000"/>
+              </a:schemeClr>
+            </a:lnRef>
+            <a:fillRef idx="1">
+              <a:schemeClr val="accent1"/>
+            </a:fillRef>
+            <a:effectRef idx="0">
+              <a:schemeClr val="accent1"/>
+            </a:effectRef>
+            <a:fontRef idx="minor">
+              <a:schemeClr val="lt1"/>
+            </a:fontRef>
+          </p:style>
+          <p:txBody>
+            <a:bodyPr lIns="54000" tIns="28800" rIns="54000" bIns="90000" anchor="t"/>
+            <a:lstStyle/>
+            <a:p>
+              <a:pPr algn="ctr">
+                <a:buNone/>
+              </a:pPr>
+              <a:r>
+                <a:rPr lang="de-CH" sz="1000" dirty="0">
+                  <a:solidFill>
+                    <a:schemeClr val="bg2">
+                      <a:lumMod val="10000"/>
+                    </a:schemeClr>
+                  </a:solidFill>
+                </a:rPr>
+                <a:t>Graph Database</a:t>
+              </a:r>
+              <a:endParaRPr sz="1000" dirty="0">
+                <a:solidFill>
+                  <a:schemeClr val="bg2">
+                    <a:lumMod val="10000"/>
+                  </a:schemeClr>
+                </a:solidFill>
+              </a:endParaRPr>
+            </a:p>
+          </p:txBody>
+        </p:sp>
+        <p:pic>
+          <p:nvPicPr>
+            <p:cNvPr id="17" name="Grafik 14">
+              <a:extLst>
+                <a:ext uri="{FF2B5EF4-FFF2-40B4-BE49-F238E27FC236}">
+                  <a16:creationId xmlns:a16="http://schemas.microsoft.com/office/drawing/2014/main" id="{E645D8D1-1C81-9BB2-4C15-4C7B2E7D1632}"/>
+                </a:ext>
+              </a:extLst>
+            </p:cNvPr>
+            <p:cNvPicPr>
+              <a:picLocks noChangeAspect="1"/>
+            </p:cNvPicPr>
+            <p:nvPr/>
+          </p:nvPicPr>
+          <p:blipFill>
+            <a:blip>
+              <a:extLst>
+                <a:ext uri="{96DAC541-7B7A-43D3-8B79-37D633B846F1}">
+                  <asvg:svgBlip xmlns:asvg="http://schemas.microsoft.com/office/drawing/2016/SVG/main" r:embed="rId9"/>
+                </a:ext>
+              </a:extLst>
+            </a:blip>
+            <a:stretch>
+              <a:fillRect/>
+            </a:stretch>
+          </p:blipFill>
+          <p:spPr>
+            <a:xfrm>
+              <a:off x="5491715" y="3111591"/>
+              <a:ext cx="468000" cy="468000"/>
+            </a:xfrm>
+            <a:prstGeom prst="rect">
+              <a:avLst/>
+            </a:prstGeom>
+          </p:spPr>
+        </p:pic>
+        <p:sp>
+          <p:nvSpPr>
+            <p:cNvPr id="19" name="Gerader Verbinder 18">
+              <a:extLst>
+                <a:ext uri="{FF2B5EF4-FFF2-40B4-BE49-F238E27FC236}">
+                  <a16:creationId xmlns:a16="http://schemas.microsoft.com/office/drawing/2014/main" id="{D3D9A905-2AB4-FDD0-3893-A133C5A52487}"/>
+                </a:ext>
+              </a:extLst>
+            </p:cNvPr>
+            <p:cNvSpPr>
+              <a:spLocks/>
+            </p:cNvSpPr>
+            <p:nvPr/>
+          </p:nvSpPr>
+          <p:spPr>
+            <a:xfrm>
+              <a:off x="5005715" y="3064726"/>
+              <a:ext cx="1440000" cy="0"/>
+            </a:xfrm>
+            <a:prstGeom prst="line">
+              <a:avLst/>
+            </a:prstGeom>
+            <a:ln>
+              <a:solidFill>
+                <a:schemeClr val="bg2">
+                  <a:lumMod val="50000"/>
+                </a:schemeClr>
+              </a:solidFill>
+            </a:ln>
+          </p:spPr>
+          <p:style>
+            <a:lnRef idx="1">
+              <a:schemeClr val="accent1"/>
+            </a:lnRef>
+            <a:fillRef idx="0">
+              <a:schemeClr val="accent1"/>
+            </a:fillRef>
+            <a:effectRef idx="0">
+              <a:schemeClr val="accent1"/>
+            </a:effectRef>
+            <a:fontRef idx="minor">
+              <a:schemeClr val="tx1"/>
+            </a:fontRef>
+          </p:style>
+          <p:txBody>
+            <a:bodyPr/>
+            <a:lstStyle/>
+            <a:p>
+              <a:endParaRPr lang="de-CH" sz="1000"/>
+            </a:p>
+          </p:txBody>
+        </p:sp>
+      </p:grpSp>
+      <p:cxnSp>
+        <p:nvCxnSpPr>
+          <p:cNvPr id="21" name="Gerade Verbindung mit Pfeil 116">
+            <a:extLst>
+              <a:ext uri="{FF2B5EF4-FFF2-40B4-BE49-F238E27FC236}">
+                <a16:creationId xmlns:a16="http://schemas.microsoft.com/office/drawing/2014/main" id="{25C8CBDB-7E9A-B6BE-F8EC-E9E9D7622066}"/>
+              </a:ext>
+            </a:extLst>
+          </p:cNvPr>
+          <p:cNvCxnSpPr>
+            <a:cxnSpLocks/>
+            <a:stCxn id="25" idx="3"/>
+            <a:endCxn id="13" idx="1"/>
+          </p:cNvCxnSpPr>
+          <p:nvPr/>
+        </p:nvCxnSpPr>
+        <p:spPr>
+          <a:xfrm>
+            <a:off x="3780000" y="4262024"/>
+            <a:ext cx="360000" cy="0"/>
+          </a:xfrm>
+          <a:prstGeom prst="straightConnector1">
+            <a:avLst/>
+          </a:prstGeom>
+          <a:ln w="50800">
+            <a:solidFill>
+              <a:schemeClr val="tx1">
+                <a:alpha val="50000"/>
+              </a:schemeClr>
+            </a:solidFill>
+            <a:prstDash val="solid"/>
+            <a:tailEnd type="triangle"/>
+          </a:ln>
+        </p:spPr>
+        <p:style>
+          <a:lnRef idx="1">
+            <a:schemeClr val="accent1"/>
+          </a:lnRef>
+          <a:fillRef idx="0">
+            <a:schemeClr val="accent1"/>
+          </a:fillRef>
+          <a:effectRef idx="0">
+            <a:schemeClr val="accent1"/>
+          </a:effectRef>
+          <a:fontRef idx="minor">
+            <a:schemeClr val="tx1"/>
+          </a:fontRef>
+        </p:style>
+      </p:cxnSp>
+      <p:grpSp>
+        <p:nvGrpSpPr>
+          <p:cNvPr id="40" name="Gruppe Embedding LLM">
+            <a:extLst>
+              <a:ext uri="{FF2B5EF4-FFF2-40B4-BE49-F238E27FC236}">
+                <a16:creationId xmlns:a16="http://schemas.microsoft.com/office/drawing/2014/main" id="{62657446-9BFF-60C0-3E07-97265A6E0278}"/>
+              </a:ext>
+            </a:extLst>
+          </p:cNvPr>
+          <p:cNvGrpSpPr/>
+          <p:nvPr/>
+        </p:nvGrpSpPr>
+        <p:grpSpPr>
+          <a:xfrm>
+            <a:off x="5940000" y="3828224"/>
+            <a:ext cx="1440000" cy="867600"/>
+            <a:chOff x="2783916" y="1570799"/>
+            <a:chExt cx="1440000" cy="867600"/>
+          </a:xfrm>
+        </p:grpSpPr>
+        <p:sp>
+          <p:nvSpPr>
+            <p:cNvPr id="41" name="Rechteck: abgerundete Ecken 40">
+              <a:extLst>
+                <a:ext uri="{FF2B5EF4-FFF2-40B4-BE49-F238E27FC236}">
+                  <a16:creationId xmlns:a16="http://schemas.microsoft.com/office/drawing/2014/main" id="{E7DEB9CD-56E2-EB2F-CD4E-69F8AEE0181F}"/>
+                </a:ext>
+              </a:extLst>
+            </p:cNvPr>
+            <p:cNvSpPr>
+              <a:spLocks/>
+            </p:cNvSpPr>
+            <p:nvPr/>
+          </p:nvSpPr>
+          <p:spPr>
+            <a:xfrm>
+              <a:off x="2783916" y="1570799"/>
+              <a:ext cx="1440000" cy="867600"/>
+            </a:xfrm>
+            <a:prstGeom prst="roundRect">
+              <a:avLst/>
+            </a:prstGeom>
+            <a:solidFill>
+              <a:schemeClr val="accent6">
+                <a:lumMod val="40000"/>
+                <a:lumOff val="60000"/>
+                <a:alpha val="50000"/>
+              </a:schemeClr>
+            </a:solidFill>
+            <a:ln>
+              <a:solidFill>
+                <a:srgbClr val="FFC000"/>
+              </a:solidFill>
+            </a:ln>
+          </p:spPr>
+          <p:style>
+            <a:lnRef idx="2">
+              <a:schemeClr val="accent1">
+                <a:shade val="15000"/>
+              </a:schemeClr>
+            </a:lnRef>
+            <a:fillRef idx="1">
+              <a:schemeClr val="accent1"/>
+            </a:fillRef>
+            <a:effectRef idx="0">
+              <a:schemeClr val="accent1"/>
+            </a:effectRef>
+            <a:fontRef idx="minor">
+              <a:schemeClr val="lt1"/>
+            </a:fontRef>
+          </p:style>
+          <p:txBody>
+            <a:bodyPr lIns="54000" tIns="28800" rIns="54000" bIns="90000" anchor="t"/>
+            <a:lstStyle/>
+            <a:p>
+              <a:pPr algn="ctr">
+                <a:buNone/>
+              </a:pPr>
+              <a:r>
+                <a:rPr lang="de-CH" sz="1000" dirty="0">
+                  <a:solidFill>
+                    <a:schemeClr val="bg2">
+                      <a:lumMod val="10000"/>
+                    </a:schemeClr>
+                  </a:solidFill>
+                </a:rPr>
+                <a:t>Ranking</a:t>
+              </a:r>
+              <a:endParaRPr sz="1000" dirty="0">
+                <a:solidFill>
+                  <a:schemeClr val="bg2">
+                    <a:lumMod val="10000"/>
+                  </a:schemeClr>
+                </a:solidFill>
+              </a:endParaRPr>
+            </a:p>
+          </p:txBody>
+        </p:sp>
+        <p:pic>
+          <p:nvPicPr>
+            <p:cNvPr id="47" name="Grafik 39">
+              <a:extLst>
+                <a:ext uri="{FF2B5EF4-FFF2-40B4-BE49-F238E27FC236}">
+                  <a16:creationId xmlns:a16="http://schemas.microsoft.com/office/drawing/2014/main" id="{6081DB9F-9BB1-BAD7-BD2A-137B31691C27}"/>
+                </a:ext>
+              </a:extLst>
+            </p:cNvPr>
+            <p:cNvPicPr>
+              <a:picLocks noChangeAspect="1"/>
+            </p:cNvPicPr>
+            <p:nvPr/>
+          </p:nvPicPr>
+          <p:blipFill>
+            <a:blip>
+              <a:extLst>
+                <a:ext uri="{96DAC541-7B7A-43D3-8B79-37D633B846F1}">
+                  <asvg:svgBlip xmlns:asvg="http://schemas.microsoft.com/office/drawing/2016/SVG/main" r:embed="rId14"/>
+                </a:ext>
+              </a:extLst>
+            </a:blip>
+            <a:stretch>
+              <a:fillRect/>
+            </a:stretch>
+          </p:blipFill>
+          <p:spPr>
+            <a:xfrm>
+              <a:off x="3269916" y="1906225"/>
+              <a:ext cx="468000" cy="468000"/>
+            </a:xfrm>
+            <a:prstGeom prst="rect">
+              <a:avLst/>
+            </a:prstGeom>
+          </p:spPr>
+        </p:pic>
+        <p:sp>
+          <p:nvSpPr>
+            <p:cNvPr id="48" name="Gerader Verbinder 47">
+              <a:extLst>
+                <a:ext uri="{FF2B5EF4-FFF2-40B4-BE49-F238E27FC236}">
+                  <a16:creationId xmlns:a16="http://schemas.microsoft.com/office/drawing/2014/main" id="{C564D42D-36CE-ADD3-7AB2-73E4D9CA0D06}"/>
+                </a:ext>
+              </a:extLst>
+            </p:cNvPr>
+            <p:cNvSpPr>
+              <a:spLocks/>
+            </p:cNvSpPr>
+            <p:nvPr/>
+          </p:nvSpPr>
+          <p:spPr>
+            <a:xfrm>
+              <a:off x="2783916" y="1859360"/>
+              <a:ext cx="1440000" cy="0"/>
+            </a:xfrm>
+            <a:prstGeom prst="line">
+              <a:avLst/>
+            </a:prstGeom>
+            <a:ln>
+              <a:solidFill>
+                <a:srgbClr val="FA9400"/>
+              </a:solidFill>
+            </a:ln>
+          </p:spPr>
+          <p:style>
+            <a:lnRef idx="1">
+              <a:schemeClr val="accent1"/>
+            </a:lnRef>
+            <a:fillRef idx="0">
+              <a:schemeClr val="accent1"/>
+            </a:fillRef>
+            <a:effectRef idx="0">
+              <a:schemeClr val="accent1"/>
+            </a:effectRef>
+            <a:fontRef idx="minor">
+              <a:schemeClr val="tx1"/>
+            </a:fontRef>
+          </p:style>
+          <p:txBody>
+            <a:bodyPr/>
+            <a:lstStyle/>
+            <a:p>
+              <a:endParaRPr lang="de-CH" sz="1000"/>
+            </a:p>
+          </p:txBody>
+        </p:sp>
+      </p:grpSp>
+      <p:cxnSp>
+        <p:nvCxnSpPr>
+          <p:cNvPr id="53" name="Gerade Verbindung mit Pfeil 116">
+            <a:extLst>
+              <a:ext uri="{FF2B5EF4-FFF2-40B4-BE49-F238E27FC236}">
+                <a16:creationId xmlns:a16="http://schemas.microsoft.com/office/drawing/2014/main" id="{68090A40-0C56-9665-5D8C-4909AE97B1B9}"/>
+              </a:ext>
+            </a:extLst>
+          </p:cNvPr>
+          <p:cNvCxnSpPr>
+            <a:cxnSpLocks/>
+            <a:stCxn id="41" idx="2"/>
+            <a:endCxn id="81" idx="0"/>
+          </p:cNvCxnSpPr>
+          <p:nvPr/>
+        </p:nvCxnSpPr>
+        <p:spPr>
+          <a:xfrm>
+            <a:off x="6660000" y="4695824"/>
+            <a:ext cx="0" cy="341704"/>
+          </a:xfrm>
+          <a:prstGeom prst="straightConnector1">
+            <a:avLst/>
+          </a:prstGeom>
+          <a:ln w="50800">
+            <a:solidFill>
+              <a:schemeClr val="tx1">
+                <a:alpha val="50000"/>
+              </a:schemeClr>
+            </a:solidFill>
+            <a:prstDash val="solid"/>
+            <a:tailEnd type="triangle"/>
+          </a:ln>
+        </p:spPr>
+        <p:style>
+          <a:lnRef idx="1">
+            <a:schemeClr val="accent1"/>
+          </a:lnRef>
+          <a:fillRef idx="0">
+            <a:schemeClr val="accent1"/>
+          </a:fillRef>
+          <a:effectRef idx="0">
+            <a:schemeClr val="accent1"/>
+          </a:effectRef>
+          <a:fontRef idx="minor">
+            <a:schemeClr val="tx1"/>
+          </a:fontRef>
+        </p:style>
+      </p:cxnSp>
+      <p:cxnSp>
+        <p:nvCxnSpPr>
+          <p:cNvPr id="59" name="Gerade Verbindung mit Pfeil 116">
+            <a:extLst>
+              <a:ext uri="{FF2B5EF4-FFF2-40B4-BE49-F238E27FC236}">
+                <a16:creationId xmlns:a16="http://schemas.microsoft.com/office/drawing/2014/main" id="{FF4DA23A-99B1-2EA7-2BF4-A55BB1B63FEE}"/>
+              </a:ext>
+            </a:extLst>
+          </p:cNvPr>
+          <p:cNvCxnSpPr>
+            <a:cxnSpLocks/>
+            <a:stCxn id="13" idx="3"/>
+            <a:endCxn id="41" idx="1"/>
+          </p:cNvCxnSpPr>
+          <p:nvPr/>
+        </p:nvCxnSpPr>
+        <p:spPr>
+          <a:xfrm>
+            <a:off x="5580000" y="4262024"/>
+            <a:ext cx="360000" cy="0"/>
           </a:xfrm>
           <a:prstGeom prst="straightConnector1">
             <a:avLst/>
@@ -39053,1044 +39570,6 @@
   <p:clrMapOvr>
     <a:masterClrMapping/>
   </p:clrMapOvr>
-  <p:timing>
-    <p:tnLst>
-      <p:par>
-        <p:cTn id="1" dur="indefinite" restart="never" nodeType="tmRoot">
-          <p:childTnLst>
-            <p:seq concurrent="1" nextAc="seek">
-              <p:cTn id="2" dur="indefinite" nodeType="mainSeq">
-                <p:childTnLst>
-                  <p:par>
-                    <p:cTn id="3" fill="hold">
-                      <p:stCondLst>
-                        <p:cond delay="indefinite"/>
-                      </p:stCondLst>
-                      <p:childTnLst>
-                        <p:par>
-                          <p:cTn id="4" fill="hold">
-                            <p:stCondLst>
-                              <p:cond delay="0"/>
-                            </p:stCondLst>
-                            <p:childTnLst>
-                              <p:par>
-                                <p:cTn id="5" presetID="1" presetClass="entr" presetSubtype="0" fill="hold" nodeType="clickEffect">
-                                  <p:stCondLst>
-                                    <p:cond delay="0"/>
-                                  </p:stCondLst>
-                                  <p:childTnLst>
-                                    <p:set>
-                                      <p:cBhvr>
-                                        <p:cTn id="6" dur="1" fill="hold">
-                                          <p:stCondLst>
-                                            <p:cond delay="0"/>
-                                          </p:stCondLst>
-                                        </p:cTn>
-                                        <p:tgtEl>
-                                          <p:spTgt spid="72"/>
-                                        </p:tgtEl>
-                                        <p:attrNameLst>
-                                          <p:attrName>style.visibility</p:attrName>
-                                        </p:attrNameLst>
-                                      </p:cBhvr>
-                                      <p:to>
-                                        <p:strVal val="visible"/>
-                                      </p:to>
-                                    </p:set>
-                                  </p:childTnLst>
-                                </p:cTn>
-                              </p:par>
-                              <p:par>
-                                <p:cTn id="7" presetID="1" presetClass="entr" presetSubtype="0" fill="hold" nodeType="withEffect">
-                                  <p:stCondLst>
-                                    <p:cond delay="0"/>
-                                  </p:stCondLst>
-                                  <p:childTnLst>
-                                    <p:set>
-                                      <p:cBhvr>
-                                        <p:cTn id="8" dur="1" fill="hold">
-                                          <p:stCondLst>
-                                            <p:cond delay="0"/>
-                                          </p:stCondLst>
-                                        </p:cTn>
-                                        <p:tgtEl>
-                                          <p:spTgt spid="74"/>
-                                        </p:tgtEl>
-                                        <p:attrNameLst>
-                                          <p:attrName>style.visibility</p:attrName>
-                                        </p:attrNameLst>
-                                      </p:cBhvr>
-                                      <p:to>
-                                        <p:strVal val="visible"/>
-                                      </p:to>
-                                    </p:set>
-                                  </p:childTnLst>
-                                </p:cTn>
-                              </p:par>
-                              <p:par>
-                                <p:cTn id="9" presetID="1" presetClass="entr" presetSubtype="0" fill="hold" nodeType="withEffect">
-                                  <p:stCondLst>
-                                    <p:cond delay="0"/>
-                                  </p:stCondLst>
-                                  <p:childTnLst>
-                                    <p:set>
-                                      <p:cBhvr>
-                                        <p:cTn id="10" dur="1" fill="hold">
-                                          <p:stCondLst>
-                                            <p:cond delay="0"/>
-                                          </p:stCondLst>
-                                        </p:cTn>
-                                        <p:tgtEl>
-                                          <p:spTgt spid="79"/>
-                                        </p:tgtEl>
-                                        <p:attrNameLst>
-                                          <p:attrName>style.visibility</p:attrName>
-                                        </p:attrNameLst>
-                                      </p:cBhvr>
-                                      <p:to>
-                                        <p:strVal val="visible"/>
-                                      </p:to>
-                                    </p:set>
-                                  </p:childTnLst>
-                                </p:cTn>
-                              </p:par>
-                            </p:childTnLst>
-                          </p:cTn>
-                        </p:par>
-                      </p:childTnLst>
-                    </p:cTn>
-                  </p:par>
-                  <p:par>
-                    <p:cTn id="11" fill="hold">
-                      <p:stCondLst>
-                        <p:cond delay="indefinite"/>
-                      </p:stCondLst>
-                      <p:childTnLst>
-                        <p:par>
-                          <p:cTn id="12" fill="hold">
-                            <p:stCondLst>
-                              <p:cond delay="0"/>
-                            </p:stCondLst>
-                            <p:childTnLst>
-                              <p:par>
-                                <p:cTn id="13" presetID="1" presetClass="entr" presetSubtype="0" fill="hold" nodeType="clickEffect">
-                                  <p:stCondLst>
-                                    <p:cond delay="0"/>
-                                  </p:stCondLst>
-                                  <p:childTnLst>
-                                    <p:set>
-                                      <p:cBhvr>
-                                        <p:cTn id="14" dur="1" fill="hold">
-                                          <p:stCondLst>
-                                            <p:cond delay="0"/>
-                                          </p:stCondLst>
-                                        </p:cTn>
-                                        <p:tgtEl>
-                                          <p:spTgt spid="10"/>
-                                        </p:tgtEl>
-                                        <p:attrNameLst>
-                                          <p:attrName>style.visibility</p:attrName>
-                                        </p:attrNameLst>
-                                      </p:cBhvr>
-                                      <p:to>
-                                        <p:strVal val="visible"/>
-                                      </p:to>
-                                    </p:set>
-                                  </p:childTnLst>
-                                </p:cTn>
-                              </p:par>
-                              <p:par>
-                                <p:cTn id="15" presetID="1" presetClass="entr" presetSubtype="0" fill="hold" nodeType="withEffect">
-                                  <p:stCondLst>
-                                    <p:cond delay="0"/>
-                                  </p:stCondLst>
-                                  <p:childTnLst>
-                                    <p:set>
-                                      <p:cBhvr>
-                                        <p:cTn id="16" dur="1" fill="hold">
-                                          <p:stCondLst>
-                                            <p:cond delay="0"/>
-                                          </p:stCondLst>
-                                        </p:cTn>
-                                        <p:tgtEl>
-                                          <p:spTgt spid="14"/>
-                                        </p:tgtEl>
-                                        <p:attrNameLst>
-                                          <p:attrName>style.visibility</p:attrName>
-                                        </p:attrNameLst>
-                                      </p:cBhvr>
-                                      <p:to>
-                                        <p:strVal val="visible"/>
-                                      </p:to>
-                                    </p:set>
-                                  </p:childTnLst>
-                                </p:cTn>
-                              </p:par>
-                              <p:par>
-                                <p:cTn id="17" presetID="1" presetClass="entr" presetSubtype="0" fill="hold" nodeType="withEffect">
-                                  <p:stCondLst>
-                                    <p:cond delay="0"/>
-                                  </p:stCondLst>
-                                  <p:childTnLst>
-                                    <p:set>
-                                      <p:cBhvr>
-                                        <p:cTn id="18" dur="1" fill="hold">
-                                          <p:stCondLst>
-                                            <p:cond delay="0"/>
-                                          </p:stCondLst>
-                                        </p:cTn>
-                                        <p:tgtEl>
-                                          <p:spTgt spid="16"/>
-                                        </p:tgtEl>
-                                        <p:attrNameLst>
-                                          <p:attrName>style.visibility</p:attrName>
-                                        </p:attrNameLst>
-                                      </p:cBhvr>
-                                      <p:to>
-                                        <p:strVal val="visible"/>
-                                      </p:to>
-                                    </p:set>
-                                  </p:childTnLst>
-                                </p:cTn>
-                              </p:par>
-                            </p:childTnLst>
-                          </p:cTn>
-                        </p:par>
-                      </p:childTnLst>
-                    </p:cTn>
-                  </p:par>
-                  <p:par>
-                    <p:cTn id="19" fill="hold">
-                      <p:stCondLst>
-                        <p:cond delay="indefinite"/>
-                      </p:stCondLst>
-                      <p:childTnLst>
-                        <p:par>
-                          <p:cTn id="20" fill="hold">
-                            <p:stCondLst>
-                              <p:cond delay="0"/>
-                            </p:stCondLst>
-                            <p:childTnLst>
-                              <p:par>
-                                <p:cTn id="21" presetID="1" presetClass="entr" presetSubtype="0" fill="hold" nodeType="clickEffect">
-                                  <p:stCondLst>
-                                    <p:cond delay="0"/>
-                                  </p:stCondLst>
-                                  <p:childTnLst>
-                                    <p:set>
-                                      <p:cBhvr>
-                                        <p:cTn id="22" dur="1" fill="hold">
-                                          <p:stCondLst>
-                                            <p:cond delay="0"/>
-                                          </p:stCondLst>
-                                        </p:cTn>
-                                        <p:tgtEl>
-                                          <p:spTgt spid="37"/>
-                                        </p:tgtEl>
-                                        <p:attrNameLst>
-                                          <p:attrName>style.visibility</p:attrName>
-                                        </p:attrNameLst>
-                                      </p:cBhvr>
-                                      <p:to>
-                                        <p:strVal val="visible"/>
-                                      </p:to>
-                                    </p:set>
-                                  </p:childTnLst>
-                                </p:cTn>
-                              </p:par>
-                              <p:par>
-                                <p:cTn id="23" presetID="1" presetClass="entr" presetSubtype="0" fill="hold" nodeType="withEffect">
-                                  <p:stCondLst>
-                                    <p:cond delay="0"/>
-                                  </p:stCondLst>
-                                  <p:childTnLst>
-                                    <p:set>
-                                      <p:cBhvr>
-                                        <p:cTn id="24" dur="1" fill="hold">
-                                          <p:stCondLst>
-                                            <p:cond delay="0"/>
-                                          </p:stCondLst>
-                                        </p:cTn>
-                                        <p:tgtEl>
-                                          <p:spTgt spid="42"/>
-                                        </p:tgtEl>
-                                        <p:attrNameLst>
-                                          <p:attrName>style.visibility</p:attrName>
-                                        </p:attrNameLst>
-                                      </p:cBhvr>
-                                      <p:to>
-                                        <p:strVal val="visible"/>
-                                      </p:to>
-                                    </p:set>
-                                  </p:childTnLst>
-                                </p:cTn>
-                              </p:par>
-                              <p:par>
-                                <p:cTn id="25" presetID="1" presetClass="entr" presetSubtype="0" fill="hold" nodeType="withEffect">
-                                  <p:stCondLst>
-                                    <p:cond delay="0"/>
-                                  </p:stCondLst>
-                                  <p:childTnLst>
-                                    <p:set>
-                                      <p:cBhvr>
-                                        <p:cTn id="26" dur="1" fill="hold">
-                                          <p:stCondLst>
-                                            <p:cond delay="0"/>
-                                          </p:stCondLst>
-                                        </p:cTn>
-                                        <p:tgtEl>
-                                          <p:spTgt spid="44"/>
-                                        </p:tgtEl>
-                                        <p:attrNameLst>
-                                          <p:attrName>style.visibility</p:attrName>
-                                        </p:attrNameLst>
-                                      </p:cBhvr>
-                                      <p:to>
-                                        <p:strVal val="visible"/>
-                                      </p:to>
-                                    </p:set>
-                                  </p:childTnLst>
-                                </p:cTn>
-                              </p:par>
-                              <p:par>
-                                <p:cTn id="27" presetID="1" presetClass="entr" presetSubtype="0" fill="hold" nodeType="withEffect">
-                                  <p:stCondLst>
-                                    <p:cond delay="0"/>
-                                  </p:stCondLst>
-                                  <p:childTnLst>
-                                    <p:set>
-                                      <p:cBhvr>
-                                        <p:cTn id="28" dur="1" fill="hold">
-                                          <p:stCondLst>
-                                            <p:cond delay="0"/>
-                                          </p:stCondLst>
-                                        </p:cTn>
-                                        <p:tgtEl>
-                                          <p:spTgt spid="109"/>
-                                        </p:tgtEl>
-                                        <p:attrNameLst>
-                                          <p:attrName>style.visibility</p:attrName>
-                                        </p:attrNameLst>
-                                      </p:cBhvr>
-                                      <p:to>
-                                        <p:strVal val="visible"/>
-                                      </p:to>
-                                    </p:set>
-                                  </p:childTnLst>
-                                </p:cTn>
-                              </p:par>
-                              <p:par>
-                                <p:cTn id="29" presetID="1" presetClass="entr" presetSubtype="0" fill="hold" nodeType="withEffect">
-                                  <p:stCondLst>
-                                    <p:cond delay="0"/>
-                                  </p:stCondLst>
-                                  <p:childTnLst>
-                                    <p:set>
-                                      <p:cBhvr>
-                                        <p:cTn id="30" dur="1" fill="hold">
-                                          <p:stCondLst>
-                                            <p:cond delay="0"/>
-                                          </p:stCondLst>
-                                        </p:cTn>
-                                        <p:tgtEl>
-                                          <p:spTgt spid="46"/>
-                                        </p:tgtEl>
-                                        <p:attrNameLst>
-                                          <p:attrName>style.visibility</p:attrName>
-                                        </p:attrNameLst>
-                                      </p:cBhvr>
-                                      <p:to>
-                                        <p:strVal val="visible"/>
-                                      </p:to>
-                                    </p:set>
-                                  </p:childTnLst>
-                                </p:cTn>
-                              </p:par>
-                              <p:par>
-                                <p:cTn id="31" presetID="1" presetClass="entr" presetSubtype="0" fill="hold" nodeType="withEffect">
-                                  <p:stCondLst>
-                                    <p:cond delay="0"/>
-                                  </p:stCondLst>
-                                  <p:childTnLst>
-                                    <p:set>
-                                      <p:cBhvr>
-                                        <p:cTn id="32" dur="1" fill="hold">
-                                          <p:stCondLst>
-                                            <p:cond delay="0"/>
-                                          </p:stCondLst>
-                                        </p:cTn>
-                                        <p:tgtEl>
-                                          <p:spTgt spid="124"/>
-                                        </p:tgtEl>
-                                        <p:attrNameLst>
-                                          <p:attrName>style.visibility</p:attrName>
-                                        </p:attrNameLst>
-                                      </p:cBhvr>
-                                      <p:to>
-                                        <p:strVal val="visible"/>
-                                      </p:to>
-                                    </p:set>
-                                  </p:childTnLst>
-                                </p:cTn>
-                              </p:par>
-                              <p:par>
-                                <p:cTn id="33" presetID="1" presetClass="entr" presetSubtype="0" fill="hold" nodeType="withEffect">
-                                  <p:stCondLst>
-                                    <p:cond delay="0"/>
-                                  </p:stCondLst>
-                                  <p:childTnLst>
-                                    <p:set>
-                                      <p:cBhvr>
-                                        <p:cTn id="34" dur="1" fill="hold">
-                                          <p:stCondLst>
-                                            <p:cond delay="0"/>
-                                          </p:stCondLst>
-                                        </p:cTn>
-                                        <p:tgtEl>
-                                          <p:spTgt spid="121"/>
-                                        </p:tgtEl>
-                                        <p:attrNameLst>
-                                          <p:attrName>style.visibility</p:attrName>
-                                        </p:attrNameLst>
-                                      </p:cBhvr>
-                                      <p:to>
-                                        <p:strVal val="visible"/>
-                                      </p:to>
-                                    </p:set>
-                                  </p:childTnLst>
-                                </p:cTn>
-                              </p:par>
-                            </p:childTnLst>
-                          </p:cTn>
-                        </p:par>
-                      </p:childTnLst>
-                    </p:cTn>
-                  </p:par>
-                  <p:par>
-                    <p:cTn id="35" fill="hold">
-                      <p:stCondLst>
-                        <p:cond delay="indefinite"/>
-                      </p:stCondLst>
-                      <p:childTnLst>
-                        <p:par>
-                          <p:cTn id="36" fill="hold">
-                            <p:stCondLst>
-                              <p:cond delay="0"/>
-                            </p:stCondLst>
-                            <p:childTnLst>
-                              <p:par>
-                                <p:cTn id="37" presetID="1" presetClass="entr" presetSubtype="0" fill="hold" nodeType="clickEffect">
-                                  <p:stCondLst>
-                                    <p:cond delay="0"/>
-                                  </p:stCondLst>
-                                  <p:childTnLst>
-                                    <p:set>
-                                      <p:cBhvr>
-                                        <p:cTn id="38" dur="1" fill="hold">
-                                          <p:stCondLst>
-                                            <p:cond delay="0"/>
-                                          </p:stCondLst>
-                                        </p:cTn>
-                                        <p:tgtEl>
-                                          <p:spTgt spid="137"/>
-                                        </p:tgtEl>
-                                        <p:attrNameLst>
-                                          <p:attrName>style.visibility</p:attrName>
-                                        </p:attrNameLst>
-                                      </p:cBhvr>
-                                      <p:to>
-                                        <p:strVal val="visible"/>
-                                      </p:to>
-                                    </p:set>
-                                  </p:childTnLst>
-                                </p:cTn>
-                              </p:par>
-                              <p:par>
-                                <p:cTn id="39" presetID="1" presetClass="entr" presetSubtype="0" fill="hold" nodeType="withEffect">
-                                  <p:stCondLst>
-                                    <p:cond delay="0"/>
-                                  </p:stCondLst>
-                                  <p:childTnLst>
-                                    <p:set>
-                                      <p:cBhvr>
-                                        <p:cTn id="40" dur="1" fill="hold">
-                                          <p:stCondLst>
-                                            <p:cond delay="0"/>
-                                          </p:stCondLst>
-                                        </p:cTn>
-                                        <p:tgtEl>
-                                          <p:spTgt spid="138"/>
-                                        </p:tgtEl>
-                                        <p:attrNameLst>
-                                          <p:attrName>style.visibility</p:attrName>
-                                        </p:attrNameLst>
-                                      </p:cBhvr>
-                                      <p:to>
-                                        <p:strVal val="visible"/>
-                                      </p:to>
-                                    </p:set>
-                                  </p:childTnLst>
-                                </p:cTn>
-                              </p:par>
-                              <p:par>
-                                <p:cTn id="41" presetID="1" presetClass="entr" presetSubtype="0" fill="hold" nodeType="withEffect">
-                                  <p:stCondLst>
-                                    <p:cond delay="0"/>
-                                  </p:stCondLst>
-                                  <p:childTnLst>
-                                    <p:set>
-                                      <p:cBhvr>
-                                        <p:cTn id="42" dur="1" fill="hold">
-                                          <p:stCondLst>
-                                            <p:cond delay="0"/>
-                                          </p:stCondLst>
-                                        </p:cTn>
-                                        <p:tgtEl>
-                                          <p:spTgt spid="140"/>
-                                        </p:tgtEl>
-                                        <p:attrNameLst>
-                                          <p:attrName>style.visibility</p:attrName>
-                                        </p:attrNameLst>
-                                      </p:cBhvr>
-                                      <p:to>
-                                        <p:strVal val="visible"/>
-                                      </p:to>
-                                    </p:set>
-                                  </p:childTnLst>
-                                </p:cTn>
-                              </p:par>
-                            </p:childTnLst>
-                          </p:cTn>
-                        </p:par>
-                      </p:childTnLst>
-                    </p:cTn>
-                  </p:par>
-                  <p:par>
-                    <p:cTn id="43" fill="hold">
-                      <p:stCondLst>
-                        <p:cond delay="indefinite"/>
-                      </p:stCondLst>
-                      <p:childTnLst>
-                        <p:par>
-                          <p:cTn id="44" fill="hold">
-                            <p:stCondLst>
-                              <p:cond delay="0"/>
-                            </p:stCondLst>
-                            <p:childTnLst>
-                              <p:par>
-                                <p:cTn id="45" presetID="1" presetClass="entr" presetSubtype="0" fill="hold" nodeType="clickEffect">
-                                  <p:stCondLst>
-                                    <p:cond delay="0"/>
-                                  </p:stCondLst>
-                                  <p:childTnLst>
-                                    <p:set>
-                                      <p:cBhvr>
-                                        <p:cTn id="46" dur="1" fill="hold">
-                                          <p:stCondLst>
-                                            <p:cond delay="0"/>
-                                          </p:stCondLst>
-                                        </p:cTn>
-                                        <p:tgtEl>
-                                          <p:spTgt spid="54"/>
-                                        </p:tgtEl>
-                                        <p:attrNameLst>
-                                          <p:attrName>style.visibility</p:attrName>
-                                        </p:attrNameLst>
-                                      </p:cBhvr>
-                                      <p:to>
-                                        <p:strVal val="visible"/>
-                                      </p:to>
-                                    </p:set>
-                                  </p:childTnLst>
-                                </p:cTn>
-                              </p:par>
-                              <p:par>
-                                <p:cTn id="47" presetID="1" presetClass="entr" presetSubtype="0" fill="hold" nodeType="withEffect">
-                                  <p:stCondLst>
-                                    <p:cond delay="0"/>
-                                  </p:stCondLst>
-                                  <p:childTnLst>
-                                    <p:set>
-                                      <p:cBhvr>
-                                        <p:cTn id="48" dur="1" fill="hold">
-                                          <p:stCondLst>
-                                            <p:cond delay="0"/>
-                                          </p:stCondLst>
-                                        </p:cTn>
-                                        <p:tgtEl>
-                                          <p:spTgt spid="56"/>
-                                        </p:tgtEl>
-                                        <p:attrNameLst>
-                                          <p:attrName>style.visibility</p:attrName>
-                                        </p:attrNameLst>
-                                      </p:cBhvr>
-                                      <p:to>
-                                        <p:strVal val="visible"/>
-                                      </p:to>
-                                    </p:set>
-                                  </p:childTnLst>
-                                </p:cTn>
-                              </p:par>
-                              <p:par>
-                                <p:cTn id="49" presetID="1" presetClass="entr" presetSubtype="0" fill="hold" nodeType="withEffect">
-                                  <p:stCondLst>
-                                    <p:cond delay="0"/>
-                                  </p:stCondLst>
-                                  <p:childTnLst>
-                                    <p:set>
-                                      <p:cBhvr>
-                                        <p:cTn id="50" dur="1" fill="hold">
-                                          <p:stCondLst>
-                                            <p:cond delay="0"/>
-                                          </p:stCondLst>
-                                        </p:cTn>
-                                        <p:tgtEl>
-                                          <p:spTgt spid="58"/>
-                                        </p:tgtEl>
-                                        <p:attrNameLst>
-                                          <p:attrName>style.visibility</p:attrName>
-                                        </p:attrNameLst>
-                                      </p:cBhvr>
-                                      <p:to>
-                                        <p:strVal val="visible"/>
-                                      </p:to>
-                                    </p:set>
-                                  </p:childTnLst>
-                                </p:cTn>
-                              </p:par>
-                            </p:childTnLst>
-                          </p:cTn>
-                        </p:par>
-                      </p:childTnLst>
-                    </p:cTn>
-                  </p:par>
-                  <p:par>
-                    <p:cTn id="51" fill="hold">
-                      <p:stCondLst>
-                        <p:cond delay="indefinite"/>
-                      </p:stCondLst>
-                      <p:childTnLst>
-                        <p:par>
-                          <p:cTn id="52" fill="hold">
-                            <p:stCondLst>
-                              <p:cond delay="0"/>
-                            </p:stCondLst>
-                            <p:childTnLst>
-                              <p:par>
-                                <p:cTn id="53" presetID="1" presetClass="entr" presetSubtype="0" fill="hold" nodeType="clickEffect">
-                                  <p:stCondLst>
-                                    <p:cond delay="0"/>
-                                  </p:stCondLst>
-                                  <p:childTnLst>
-                                    <p:set>
-                                      <p:cBhvr>
-                                        <p:cTn id="54" dur="1" fill="hold">
-                                          <p:stCondLst>
-                                            <p:cond delay="0"/>
-                                          </p:stCondLst>
-                                        </p:cTn>
-                                        <p:tgtEl>
-                                          <p:spTgt spid="93"/>
-                                        </p:tgtEl>
-                                        <p:attrNameLst>
-                                          <p:attrName>style.visibility</p:attrName>
-                                        </p:attrNameLst>
-                                      </p:cBhvr>
-                                      <p:to>
-                                        <p:strVal val="visible"/>
-                                      </p:to>
-                                    </p:set>
-                                  </p:childTnLst>
-                                </p:cTn>
-                              </p:par>
-                              <p:par>
-                                <p:cTn id="55" presetID="1" presetClass="entr" presetSubtype="0" fill="hold" nodeType="withEffect">
-                                  <p:stCondLst>
-                                    <p:cond delay="0"/>
-                                  </p:stCondLst>
-                                  <p:childTnLst>
-                                    <p:set>
-                                      <p:cBhvr>
-                                        <p:cTn id="56" dur="1" fill="hold">
-                                          <p:stCondLst>
-                                            <p:cond delay="0"/>
-                                          </p:stCondLst>
-                                        </p:cTn>
-                                        <p:tgtEl>
-                                          <p:spTgt spid="96"/>
-                                        </p:tgtEl>
-                                        <p:attrNameLst>
-                                          <p:attrName>style.visibility</p:attrName>
-                                        </p:attrNameLst>
-                                      </p:cBhvr>
-                                      <p:to>
-                                        <p:strVal val="visible"/>
-                                      </p:to>
-                                    </p:set>
-                                  </p:childTnLst>
-                                </p:cTn>
-                              </p:par>
-                              <p:par>
-                                <p:cTn id="57" presetID="1" presetClass="entr" presetSubtype="0" fill="hold" nodeType="withEffect">
-                                  <p:stCondLst>
-                                    <p:cond delay="0"/>
-                                  </p:stCondLst>
-                                  <p:childTnLst>
-                                    <p:set>
-                                      <p:cBhvr>
-                                        <p:cTn id="58" dur="1" fill="hold">
-                                          <p:stCondLst>
-                                            <p:cond delay="0"/>
-                                          </p:stCondLst>
-                                        </p:cTn>
-                                        <p:tgtEl>
-                                          <p:spTgt spid="101"/>
-                                        </p:tgtEl>
-                                        <p:attrNameLst>
-                                          <p:attrName>style.visibility</p:attrName>
-                                        </p:attrNameLst>
-                                      </p:cBhvr>
-                                      <p:to>
-                                        <p:strVal val="visible"/>
-                                      </p:to>
-                                    </p:set>
-                                  </p:childTnLst>
-                                </p:cTn>
-                              </p:par>
-                            </p:childTnLst>
-                          </p:cTn>
-                        </p:par>
-                      </p:childTnLst>
-                    </p:cTn>
-                  </p:par>
-                  <p:par>
-                    <p:cTn id="59" fill="hold">
-                      <p:stCondLst>
-                        <p:cond delay="indefinite"/>
-                      </p:stCondLst>
-                      <p:childTnLst>
-                        <p:par>
-                          <p:cTn id="60" fill="hold">
-                            <p:stCondLst>
-                              <p:cond delay="0"/>
-                            </p:stCondLst>
-                            <p:childTnLst>
-                              <p:par>
-                                <p:cTn id="61" presetID="1" presetClass="entr" presetSubtype="0" fill="hold" nodeType="clickEffect">
-                                  <p:stCondLst>
-                                    <p:cond delay="0"/>
-                                  </p:stCondLst>
-                                  <p:childTnLst>
-                                    <p:set>
-                                      <p:cBhvr>
-                                        <p:cTn id="62" dur="1" fill="hold">
-                                          <p:stCondLst>
-                                            <p:cond delay="0"/>
-                                          </p:stCondLst>
-                                        </p:cTn>
-                                        <p:tgtEl>
-                                          <p:spTgt spid="81"/>
-                                        </p:tgtEl>
-                                        <p:attrNameLst>
-                                          <p:attrName>style.visibility</p:attrName>
-                                        </p:attrNameLst>
-                                      </p:cBhvr>
-                                      <p:to>
-                                        <p:strVal val="visible"/>
-                                      </p:to>
-                                    </p:set>
-                                  </p:childTnLst>
-                                </p:cTn>
-                              </p:par>
-                              <p:par>
-                                <p:cTn id="63" presetID="1" presetClass="entr" presetSubtype="0" fill="hold" nodeType="withEffect">
-                                  <p:stCondLst>
-                                    <p:cond delay="0"/>
-                                  </p:stCondLst>
-                                  <p:childTnLst>
-                                    <p:set>
-                                      <p:cBhvr>
-                                        <p:cTn id="64" dur="1" fill="hold">
-                                          <p:stCondLst>
-                                            <p:cond delay="0"/>
-                                          </p:stCondLst>
-                                        </p:cTn>
-                                        <p:tgtEl>
-                                          <p:spTgt spid="84"/>
-                                        </p:tgtEl>
-                                        <p:attrNameLst>
-                                          <p:attrName>style.visibility</p:attrName>
-                                        </p:attrNameLst>
-                                      </p:cBhvr>
-                                      <p:to>
-                                        <p:strVal val="visible"/>
-                                      </p:to>
-                                    </p:set>
-                                  </p:childTnLst>
-                                </p:cTn>
-                              </p:par>
-                              <p:par>
-                                <p:cTn id="65" presetID="1" presetClass="entr" presetSubtype="0" fill="hold" nodeType="withEffect">
-                                  <p:stCondLst>
-                                    <p:cond delay="0"/>
-                                  </p:stCondLst>
-                                  <p:childTnLst>
-                                    <p:set>
-                                      <p:cBhvr>
-                                        <p:cTn id="66" dur="1" fill="hold">
-                                          <p:stCondLst>
-                                            <p:cond delay="0"/>
-                                          </p:stCondLst>
-                                        </p:cTn>
-                                        <p:tgtEl>
-                                          <p:spTgt spid="90"/>
-                                        </p:tgtEl>
-                                        <p:attrNameLst>
-                                          <p:attrName>style.visibility</p:attrName>
-                                        </p:attrNameLst>
-                                      </p:cBhvr>
-                                      <p:to>
-                                        <p:strVal val="visible"/>
-                                      </p:to>
-                                    </p:set>
-                                  </p:childTnLst>
-                                </p:cTn>
-                              </p:par>
-                              <p:par>
-                                <p:cTn id="67" presetID="1" presetClass="entr" presetSubtype="0" fill="hold" nodeType="withEffect">
-                                  <p:stCondLst>
-                                    <p:cond delay="0"/>
-                                  </p:stCondLst>
-                                  <p:childTnLst>
-                                    <p:set>
-                                      <p:cBhvr>
-                                        <p:cTn id="68" dur="1" fill="hold">
-                                          <p:stCondLst>
-                                            <p:cond delay="0"/>
-                                          </p:stCondLst>
-                                        </p:cTn>
-                                        <p:tgtEl>
-                                          <p:spTgt spid="111"/>
-                                        </p:tgtEl>
-                                        <p:attrNameLst>
-                                          <p:attrName>style.visibility</p:attrName>
-                                        </p:attrNameLst>
-                                      </p:cBhvr>
-                                      <p:to>
-                                        <p:strVal val="visible"/>
-                                      </p:to>
-                                    </p:set>
-                                  </p:childTnLst>
-                                </p:cTn>
-                              </p:par>
-                              <p:par>
-                                <p:cTn id="69" presetID="1" presetClass="entr" presetSubtype="0" fill="hold" nodeType="withEffect">
-                                  <p:stCondLst>
-                                    <p:cond delay="0"/>
-                                  </p:stCondLst>
-                                  <p:childTnLst>
-                                    <p:set>
-                                      <p:cBhvr>
-                                        <p:cTn id="70" dur="1" fill="hold">
-                                          <p:stCondLst>
-                                            <p:cond delay="0"/>
-                                          </p:stCondLst>
-                                        </p:cTn>
-                                        <p:tgtEl>
-                                          <p:spTgt spid="24"/>
-                                        </p:tgtEl>
-                                        <p:attrNameLst>
-                                          <p:attrName>style.visibility</p:attrName>
-                                        </p:attrNameLst>
-                                      </p:cBhvr>
-                                      <p:to>
-                                        <p:strVal val="visible"/>
-                                      </p:to>
-                                    </p:set>
-                                  </p:childTnLst>
-                                </p:cTn>
-                              </p:par>
-                              <p:par>
-                                <p:cTn id="71" presetID="1" presetClass="entr" presetSubtype="0" fill="hold" nodeType="withEffect">
-                                  <p:stCondLst>
-                                    <p:cond delay="0"/>
-                                  </p:stCondLst>
-                                  <p:childTnLst>
-                                    <p:set>
-                                      <p:cBhvr>
-                                        <p:cTn id="72" dur="1" fill="hold">
-                                          <p:stCondLst>
-                                            <p:cond delay="0"/>
-                                          </p:stCondLst>
-                                        </p:cTn>
-                                        <p:tgtEl>
-                                          <p:spTgt spid="28"/>
-                                        </p:tgtEl>
-                                        <p:attrNameLst>
-                                          <p:attrName>style.visibility</p:attrName>
-                                        </p:attrNameLst>
-                                      </p:cBhvr>
-                                      <p:to>
-                                        <p:strVal val="visible"/>
-                                      </p:to>
-                                    </p:set>
-                                  </p:childTnLst>
-                                </p:cTn>
-                              </p:par>
-                            </p:childTnLst>
-                          </p:cTn>
-                        </p:par>
-                      </p:childTnLst>
-                    </p:cTn>
-                  </p:par>
-                  <p:par>
-                    <p:cTn id="73" fill="hold">
-                      <p:stCondLst>
-                        <p:cond delay="indefinite"/>
-                      </p:stCondLst>
-                      <p:childTnLst>
-                        <p:par>
-                          <p:cTn id="74" fill="hold">
-                            <p:stCondLst>
-                              <p:cond delay="0"/>
-                            </p:stCondLst>
-                            <p:childTnLst>
-                              <p:par>
-                                <p:cTn id="75" presetID="1" presetClass="entr" presetSubtype="0" fill="hold" nodeType="clickEffect">
-                                  <p:stCondLst>
-                                    <p:cond delay="0"/>
-                                  </p:stCondLst>
-                                  <p:childTnLst>
-                                    <p:set>
-                                      <p:cBhvr>
-                                        <p:cTn id="76" dur="1" fill="hold">
-                                          <p:stCondLst>
-                                            <p:cond delay="0"/>
-                                          </p:stCondLst>
-                                        </p:cTn>
-                                        <p:tgtEl>
-                                          <p:spTgt spid="25"/>
-                                        </p:tgtEl>
-                                        <p:attrNameLst>
-                                          <p:attrName>style.visibility</p:attrName>
-                                        </p:attrNameLst>
-                                      </p:cBhvr>
-                                      <p:to>
-                                        <p:strVal val="visible"/>
-                                      </p:to>
-                                    </p:set>
-                                  </p:childTnLst>
-                                </p:cTn>
-                              </p:par>
-                              <p:par>
-                                <p:cTn id="77" presetID="1" presetClass="entr" presetSubtype="0" fill="hold" nodeType="withEffect">
-                                  <p:stCondLst>
-                                    <p:cond delay="0"/>
-                                  </p:stCondLst>
-                                  <p:childTnLst>
-                                    <p:set>
-                                      <p:cBhvr>
-                                        <p:cTn id="78" dur="1" fill="hold">
-                                          <p:stCondLst>
-                                            <p:cond delay="0"/>
-                                          </p:stCondLst>
-                                        </p:cTn>
-                                        <p:tgtEl>
-                                          <p:spTgt spid="31"/>
-                                        </p:tgtEl>
-                                        <p:attrNameLst>
-                                          <p:attrName>style.visibility</p:attrName>
-                                        </p:attrNameLst>
-                                      </p:cBhvr>
-                                      <p:to>
-                                        <p:strVal val="visible"/>
-                                      </p:to>
-                                    </p:set>
-                                  </p:childTnLst>
-                                </p:cTn>
-                              </p:par>
-                              <p:par>
-                                <p:cTn id="79" presetID="1" presetClass="entr" presetSubtype="0" fill="hold" nodeType="withEffect">
-                                  <p:stCondLst>
-                                    <p:cond delay="0"/>
-                                  </p:stCondLst>
-                                  <p:childTnLst>
-                                    <p:set>
-                                      <p:cBhvr>
-                                        <p:cTn id="80" dur="1" fill="hold">
-                                          <p:stCondLst>
-                                            <p:cond delay="0"/>
-                                          </p:stCondLst>
-                                        </p:cTn>
-                                        <p:tgtEl>
-                                          <p:spTgt spid="36"/>
-                                        </p:tgtEl>
-                                        <p:attrNameLst>
-                                          <p:attrName>style.visibility</p:attrName>
-                                        </p:attrNameLst>
-                                      </p:cBhvr>
-                                      <p:to>
-                                        <p:strVal val="visible"/>
-                                      </p:to>
-                                    </p:set>
-                                  </p:childTnLst>
-                                </p:cTn>
-                              </p:par>
-                            </p:childTnLst>
-                          </p:cTn>
-                        </p:par>
-                      </p:childTnLst>
-                    </p:cTn>
-                  </p:par>
-                </p:childTnLst>
-              </p:cTn>
-              <p:prevCondLst>
-                <p:cond evt="onPrev" delay="0">
-                  <p:tgtEl>
-                    <p:sldTgt/>
-                  </p:tgtEl>
-                </p:cond>
-              </p:prevCondLst>
-              <p:nextCondLst>
-                <p:cond evt="onNext" delay="0">
-                  <p:tgtEl>
-                    <p:sldTgt/>
-                  </p:tgtEl>
-                </p:cond>
-              </p:nextCondLst>
-            </p:seq>
-          </p:childTnLst>
-        </p:cTn>
-      </p:par>
-    </p:tnLst>
-    <p:bldLst>
-      <p:bldP spid="10" grpId="0" animBg="1"/>
-      <p:bldP spid="14" grpId="0" animBg="1"/>
-      <p:bldP spid="24" grpId="0" animBg="1"/>
-      <p:bldP spid="37" grpId="0" animBg="1"/>
-      <p:bldP spid="44" grpId="0" animBg="1"/>
-      <p:bldP spid="45" grpId="0" animBg="1"/>
-      <p:bldP spid="51" grpId="0" animBg="1"/>
-      <p:bldP spid="54" grpId="0" animBg="1"/>
-      <p:bldP spid="58" grpId="0" animBg="1"/>
-      <p:bldP spid="72" grpId="0" animBg="1"/>
-      <p:bldP spid="79" grpId="0" animBg="1"/>
-      <p:bldP spid="81" grpId="0" animBg="1"/>
-      <p:bldP spid="90" grpId="0" animBg="1"/>
-      <p:bldP spid="93" grpId="0" animBg="1"/>
-      <p:bldP spid="101" grpId="0" animBg="1"/>
-      <p:bldP spid="102" grpId="0" animBg="1"/>
-      <p:bldP spid="106" grpId="0" animBg="1"/>
-      <p:bldP spid="137" grpId="0" animBg="1"/>
-      <p:bldP spid="140" grpId="0" animBg="1"/>
-      <p:bldP spid="121" grpId="0" animBg="1"/>
-      <p:bldP spid="124" grpId="0" animBg="1"/>
-      <p:bldP spid="32" grpId="0" animBg="1"/>
-      <p:bldP spid="35" grpId="0" animBg="1"/>
-      <p:bldP spid="25" grpId="0" animBg="1"/>
-      <p:bldP spid="36" grpId="0" animBg="1"/>
-    </p:bldLst>
-  </p:timing>
 </p:sld>
 </file>
 
@@ -43111,15 +42590,6 @@
 </file>
 
 <file path=customXml/item2.xml><?xml version="1.0" encoding="utf-8"?>
-<?mso-contentType ?>
-<FormTemplates xmlns="http://schemas.microsoft.com/sharepoint/v3/contenttype/forms">
-  <Display>DocumentLibraryForm</Display>
-  <Edit>DocumentLibraryForm</Edit>
-  <New>DocumentLibraryForm</New>
-</FormTemplates>
-</file>
-
-<file path=customXml/item3.xml><?xml version="1.0" encoding="utf-8"?>
 <p:properties xmlns:p="http://schemas.microsoft.com/office/2006/metadata/properties" xmlns:xsi="http://www.w3.org/2001/XMLSchema-instance" xmlns:pc="http://schemas.microsoft.com/office/infopath/2007/PartnerControls">
   <documentManagement>
     <lcf76f155ced4ddcb4097134ff3c332f xmlns="501edefc-5b9b-422a-9450-cf7f1f30e3fa">
@@ -43128,6 +42598,15 @@
     <TaxCatchAll xmlns="3083c7a9-d95a-44c4-8fb8-f93b125494d6" xsi:nil="true"/>
   </documentManagement>
 </p:properties>
+</file>
+
+<file path=customXml/item3.xml><?xml version="1.0" encoding="utf-8"?>
+<?mso-contentType ?>
+<FormTemplates xmlns="http://schemas.microsoft.com/sharepoint/v3/contenttype/forms">
+  <Display>DocumentLibraryForm</Display>
+  <Edit>DocumentLibraryForm</Edit>
+  <New>DocumentLibraryForm</New>
+</FormTemplates>
 </file>
 
 <file path=customXml/itemProps1.xml><?xml version="1.0" encoding="utf-8"?>
@@ -43150,14 +42629,6 @@
 </file>
 
 <file path=customXml/itemProps2.xml><?xml version="1.0" encoding="utf-8"?>
-<ds:datastoreItem xmlns:ds="http://schemas.openxmlformats.org/officeDocument/2006/customXml" ds:itemID="{334436CE-240F-4EE4-9FC5-4255E6874223}">
-  <ds:schemaRefs>
-    <ds:schemaRef ds:uri="http://schemas.microsoft.com/sharepoint/v3/contenttype/forms"/>
-  </ds:schemaRefs>
-</ds:datastoreItem>
-</file>
-
-<file path=customXml/itemProps3.xml><?xml version="1.0" encoding="utf-8"?>
 <ds:datastoreItem xmlns:ds="http://schemas.openxmlformats.org/officeDocument/2006/customXml" ds:itemID="{6302A1CC-4AEF-4830-BB1C-A446161EB02D}">
   <ds:schemaRefs>
     <ds:schemaRef ds:uri="http://schemas.microsoft.com/office/2006/metadata/properties"/>
@@ -43172,6 +42643,14 @@
 </ds:datastoreItem>
 </file>
 
+<file path=customXml/itemProps3.xml><?xml version="1.0" encoding="utf-8"?>
+<ds:datastoreItem xmlns:ds="http://schemas.openxmlformats.org/officeDocument/2006/customXml" ds:itemID="{334436CE-240F-4EE4-9FC5-4255E6874223}">
+  <ds:schemaRefs>
+    <ds:schemaRef ds:uri="http://schemas.microsoft.com/sharepoint/v3/contenttype/forms"/>
+  </ds:schemaRefs>
+</ds:datastoreItem>
+</file>
+
 <file path=docMetadata/LabelInfo.xml><?xml version="1.0" encoding="utf-8"?>
 <clbl:labelList xmlns:clbl="http://schemas.microsoft.com/office/2020/mipLabelMetadata">
   <clbl:label id="{42e461c6-591f-4920-9cf0-f1389542f8ad}" enabled="1" method="Standard" siteId="{2cda5d11-f0ac-46b3-967d-af1b2e1bd01a}" contentBits="2" removed="0"/>

</xml_diff>

<commit_message>
Place new tile-style icons in all slide-7 boxes
All boxes now use the svg-icons-new set (including the new Graph
Database and Ranking boxes), embedded as SVG with PNG fallback at
1.3 x 1.3 cm, horizontally centred and vertically centred between the
divider line and the box bottom. Unused image relationships dropped.

Co-Authored-By: Claude Fable 5 <noreply@anthropic.com>
Claude-Session: https://claude.ai/code/session_01S2kGP2buE2HmxMttD3XczR
</commit_message>
<xml_diff>
--- a/RAG_Workshop.pptx
+++ b/RAG_Workshop.pptx
@@ -35785,10 +35785,10 @@
             <p:nvPr/>
           </p:nvPicPr>
           <p:blipFill>
-            <a:blip>
+            <a:blip r:embed="rId15">
               <a:extLst>
                 <a:ext uri="{96DAC541-7B7A-43D3-8B79-37D633B846F1}">
-                  <asvg:svgBlip xmlns:asvg="http://schemas.microsoft.com/office/drawing/2016/SVG/main" r:embed="rId3"/>
+                  <ns0:svgBlip xmlns:ns0="http://schemas.microsoft.com/office/drawing/2016/SVG/main" r:embed="rId16"/>
                 </a:ext>
               </a:extLst>
             </a:blip>
@@ -35798,7 +35798,7 @@
           </p:blipFill>
           <p:spPr>
             <a:xfrm>
-              <a:off x="1110215" y="5478100"/>
+              <a:off x="1110215" y="5486754"/>
               <a:ext cx="468000" cy="468000"/>
             </a:xfrm>
             <a:prstGeom prst="rect">
@@ -35912,10 +35912,10 @@
             <p:nvPr/>
           </p:nvPicPr>
           <p:blipFill>
-            <a:blip>
+            <a:blip r:embed="rId17">
               <a:extLst>
                 <a:ext uri="{96DAC541-7B7A-43D3-8B79-37D633B846F1}">
-                  <asvg:svgBlip xmlns:asvg="http://schemas.microsoft.com/office/drawing/2016/SVG/main" r:embed="rId4"/>
+                  <ns1:svgBlip xmlns:ns1="http://schemas.microsoft.com/office/drawing/2016/SVG/main" r:embed="rId18"/>
                 </a:ext>
               </a:extLst>
             </a:blip>
@@ -35925,7 +35925,7 @@
           </p:blipFill>
           <p:spPr>
             <a:xfrm>
-              <a:off x="10682840" y="1906225"/>
+              <a:off x="10682840" y="1914879"/>
               <a:ext cx="468000" cy="468000"/>
             </a:xfrm>
             <a:prstGeom prst="rect">
@@ -36083,10 +36083,10 @@
             <p:nvPr/>
           </p:nvPicPr>
           <p:blipFill>
-            <a:blip>
+            <a:blip r:embed="rId19">
               <a:extLst>
                 <a:ext uri="{96DAC541-7B7A-43D3-8B79-37D633B846F1}">
-                  <asvg:svgBlip xmlns:asvg="http://schemas.microsoft.com/office/drawing/2016/SVG/main" r:embed="rId5"/>
+                  <ns2:svgBlip xmlns:ns2="http://schemas.microsoft.com/office/drawing/2016/SVG/main" r:embed="rId20"/>
                 </a:ext>
               </a:extLst>
             </a:blip>
@@ -36096,7 +36096,7 @@
           </p:blipFill>
           <p:spPr>
             <a:xfrm>
-              <a:off x="10682840" y="5496779"/>
+              <a:off x="10682840" y="5505433"/>
               <a:ext cx="468000" cy="468000"/>
             </a:xfrm>
             <a:prstGeom prst="rect">
@@ -36256,10 +36256,10 @@
             <p:nvPr/>
           </p:nvPicPr>
           <p:blipFill>
-            <a:blip>
+            <a:blip r:embed="rId21">
               <a:extLst>
                 <a:ext uri="{96DAC541-7B7A-43D3-8B79-37D633B846F1}">
-                  <asvg:svgBlip xmlns:asvg="http://schemas.microsoft.com/office/drawing/2016/SVG/main" r:embed="rId6"/>
+                  <ns3:svgBlip xmlns:ns3="http://schemas.microsoft.com/office/drawing/2016/SVG/main" r:embed="rId22"/>
                 </a:ext>
               </a:extLst>
             </a:blip>
@@ -36269,7 +36269,7 @@
           </p:blipFill>
           <p:spPr>
             <a:xfrm>
-              <a:off x="1108908" y="4287475"/>
+              <a:off x="1108908" y="4296129"/>
               <a:ext cx="468000" cy="468000"/>
             </a:xfrm>
             <a:prstGeom prst="rect">
@@ -36493,10 +36493,10 @@
             <p:nvPr/>
           </p:nvPicPr>
           <p:blipFill>
-            <a:blip>
+            <a:blip r:embed="rId23">
               <a:extLst>
                 <a:ext uri="{96DAC541-7B7A-43D3-8B79-37D633B846F1}">
-                  <asvg:svgBlip xmlns:asvg="http://schemas.microsoft.com/office/drawing/2016/SVG/main" r:embed="rId7"/>
+                  <ns4:svgBlip xmlns:ns4="http://schemas.microsoft.com/office/drawing/2016/SVG/main" r:embed="rId24"/>
                 </a:ext>
               </a:extLst>
             </a:blip>
@@ -36506,7 +36506,7 @@
           </p:blipFill>
           <p:spPr>
             <a:xfrm>
-              <a:off x="1110215" y="3096850"/>
+              <a:off x="1110215" y="3105504"/>
               <a:ext cx="468000" cy="468000"/>
             </a:xfrm>
             <a:prstGeom prst="rect">
@@ -36622,10 +36622,10 @@
             <p:nvPr/>
           </p:nvPicPr>
           <p:blipFill>
-            <a:blip>
+            <a:blip r:embed="rId25">
               <a:extLst>
                 <a:ext uri="{96DAC541-7B7A-43D3-8B79-37D633B846F1}">
-                  <asvg:svgBlip xmlns:asvg="http://schemas.microsoft.com/office/drawing/2016/SVG/main" r:embed="rId8"/>
+                  <ns5:svgBlip xmlns:ns5="http://schemas.microsoft.com/office/drawing/2016/SVG/main" r:embed="rId26"/>
                 </a:ext>
               </a:extLst>
             </a:blip>
@@ -36635,7 +36635,7 @@
           </p:blipFill>
           <p:spPr>
             <a:xfrm>
-              <a:off x="5495244" y="1913509"/>
+              <a:off x="5495244" y="1922163"/>
               <a:ext cx="468000" cy="468000"/>
             </a:xfrm>
             <a:prstGeom prst="rect">
@@ -36803,10 +36803,10 @@
             <p:nvPr/>
           </p:nvPicPr>
           <p:blipFill>
-            <a:blip>
+            <a:blip r:embed="rId27">
               <a:extLst>
                 <a:ext uri="{96DAC541-7B7A-43D3-8B79-37D633B846F1}">
-                  <asvg:svgBlip xmlns:asvg="http://schemas.microsoft.com/office/drawing/2016/SVG/main" r:embed="rId9"/>
+                  <ns6:svgBlip xmlns:ns6="http://schemas.microsoft.com/office/drawing/2016/SVG/main" r:embed="rId28"/>
                 </a:ext>
               </a:extLst>
             </a:blip>
@@ -36816,7 +36816,7 @@
           </p:blipFill>
           <p:spPr>
             <a:xfrm>
-              <a:off x="5491715" y="3111591"/>
+              <a:off x="5491715" y="3120245"/>
               <a:ext cx="468000" cy="468000"/>
             </a:xfrm>
             <a:prstGeom prst="rect">
@@ -36984,10 +36984,10 @@
             <p:nvPr/>
           </p:nvPicPr>
           <p:blipFill>
-            <a:blip>
+            <a:blip r:embed="rId29">
               <a:extLst>
                 <a:ext uri="{96DAC541-7B7A-43D3-8B79-37D633B846F1}">
-                  <asvg:svgBlip xmlns:asvg="http://schemas.microsoft.com/office/drawing/2016/SVG/main" r:embed="rId10"/>
+                  <ns7:svgBlip xmlns:ns7="http://schemas.microsoft.com/office/drawing/2016/SVG/main" r:embed="rId30"/>
                 </a:ext>
               </a:extLst>
             </a:blip>
@@ -36997,7 +36997,7 @@
           </p:blipFill>
           <p:spPr>
             <a:xfrm>
-              <a:off x="5491715" y="5496779"/>
+              <a:off x="5491715" y="5505433"/>
               <a:ext cx="468000" cy="468000"/>
             </a:xfrm>
             <a:prstGeom prst="rect">
@@ -37165,10 +37165,10 @@
             <p:nvPr/>
           </p:nvPicPr>
           <p:blipFill>
-            <a:blip>
+            <a:blip r:embed="rId31">
               <a:extLst>
                 <a:ext uri="{96DAC541-7B7A-43D3-8B79-37D633B846F1}">
-                  <asvg:svgBlip xmlns:asvg="http://schemas.microsoft.com/office/drawing/2016/SVG/main" r:embed="rId11"/>
+                  <ns8:svgBlip xmlns:ns8="http://schemas.microsoft.com/office/drawing/2016/SVG/main" r:embed="rId32"/>
                 </a:ext>
               </a:extLst>
             </a:blip>
@@ -37178,7 +37178,7 @@
           </p:blipFill>
           <p:spPr>
             <a:xfrm>
-              <a:off x="8482042" y="1906225"/>
+              <a:off x="8482042" y="1914879"/>
               <a:ext cx="468000" cy="468000"/>
             </a:xfrm>
             <a:prstGeom prst="rect">
@@ -37350,10 +37350,10 @@
             <p:nvPr/>
           </p:nvPicPr>
           <p:blipFill>
-            <a:blip>
+            <a:blip r:embed="rId33">
               <a:extLst>
                 <a:ext uri="{96DAC541-7B7A-43D3-8B79-37D633B846F1}">
-                  <asvg:svgBlip xmlns:asvg="http://schemas.microsoft.com/office/drawing/2016/SVG/main" r:embed="rId12"/>
+                  <ns9:svgBlip xmlns:ns9="http://schemas.microsoft.com/office/drawing/2016/SVG/main" r:embed="rId34"/>
                 </a:ext>
               </a:extLst>
             </a:blip>
@@ -37363,7 +37363,7 @@
           </p:blipFill>
           <p:spPr>
             <a:xfrm>
-              <a:off x="8492090" y="5496779"/>
+              <a:off x="8492090" y="5505433"/>
               <a:ext cx="468000" cy="468000"/>
             </a:xfrm>
             <a:prstGeom prst="rect">
@@ -38033,10 +38033,10 @@
             <p:nvPr/>
           </p:nvPicPr>
           <p:blipFill>
-            <a:blip>
+            <a:blip r:embed="rId31">
               <a:extLst>
                 <a:ext uri="{96DAC541-7B7A-43D3-8B79-37D633B846F1}">
-                  <asvg:svgBlip xmlns:asvg="http://schemas.microsoft.com/office/drawing/2016/SVG/main" r:embed="rId11"/>
+                  <ns10:svgBlip xmlns:ns10="http://schemas.microsoft.com/office/drawing/2016/SVG/main" r:embed="rId32"/>
                 </a:ext>
               </a:extLst>
             </a:blip>
@@ -38046,7 +38046,7 @@
           </p:blipFill>
           <p:spPr>
             <a:xfrm>
-              <a:off x="3269916" y="1906225"/>
+              <a:off x="3269916" y="1914879"/>
               <a:ext cx="468000" cy="468000"/>
             </a:xfrm>
             <a:prstGeom prst="rect">
@@ -38554,15 +38554,21 @@
             <p:nvPr/>
           </p:nvPicPr>
           <p:blipFill>
-            <a:blip r:embed="rId13"/>
+            <a:blip r:embed="rId23">
+              <a:extLst>
+                <a:ext uri="{96DAC541-7B7A-43D3-8B79-37D633B846F1}">
+                  <ns11:svgBlip xmlns:ns11="http://schemas.microsoft.com/office/drawing/2016/SVG/main" r:embed="rId24"/>
+                </a:ext>
+              </a:extLst>
+            </a:blip>
             <a:stretch>
               <a:fillRect/>
             </a:stretch>
           </p:blipFill>
           <p:spPr>
-            <a:xfrm flipH="1">
-              <a:off x="1137126" y="1906225"/>
-              <a:ext cx="401555" cy="468000"/>
+            <a:xfrm>
+              <a:off x="1103904" y="1914879"/>
+              <a:ext cx="468000" cy="468000"/>
             </a:xfrm>
             <a:prstGeom prst="rect">
               <a:avLst/>
@@ -38733,10 +38739,10 @@
             <p:nvPr/>
           </p:nvPicPr>
           <p:blipFill>
-            <a:blip>
+            <a:blip r:embed="rId25">
               <a:extLst>
                 <a:ext uri="{96DAC541-7B7A-43D3-8B79-37D633B846F1}">
-                  <asvg:svgBlip xmlns:asvg="http://schemas.microsoft.com/office/drawing/2016/SVG/main" r:embed="rId8"/>
+                  <ns12:svgBlip xmlns:ns12="http://schemas.microsoft.com/office/drawing/2016/SVG/main" r:embed="rId26"/>
                 </a:ext>
               </a:extLst>
             </a:blip>
@@ -38746,7 +38752,7 @@
           </p:blipFill>
           <p:spPr>
             <a:xfrm>
-              <a:off x="8492090" y="3129955"/>
+              <a:off x="8492090" y="3138609"/>
               <a:ext cx="468000" cy="468000"/>
             </a:xfrm>
             <a:prstGeom prst="rect">
@@ -38920,10 +38926,10 @@
             <p:nvPr/>
           </p:nvPicPr>
           <p:blipFill>
-            <a:blip>
+            <a:blip r:embed="rId35">
               <a:extLst>
                 <a:ext uri="{96DAC541-7B7A-43D3-8B79-37D633B846F1}">
-                  <asvg:svgBlip xmlns:asvg="http://schemas.microsoft.com/office/drawing/2016/SVG/main" r:embed="rId14"/>
+                  <ns13:svgBlip xmlns:ns13="http://schemas.microsoft.com/office/drawing/2016/SVG/main" r:embed="rId36"/>
                 </a:ext>
               </a:extLst>
             </a:blip>
@@ -38933,7 +38939,7 @@
           </p:blipFill>
           <p:spPr>
             <a:xfrm>
-              <a:off x="3269916" y="1906225"/>
+              <a:off x="3269916" y="1914879"/>
               <a:ext cx="468000" cy="468000"/>
             </a:xfrm>
             <a:prstGeom prst="rect">
@@ -39154,10 +39160,10 @@
             <p:nvPr/>
           </p:nvPicPr>
           <p:blipFill>
-            <a:blip>
+            <a:blip r:embed="rId37">
               <a:extLst>
                 <a:ext uri="{96DAC541-7B7A-43D3-8B79-37D633B846F1}">
-                  <asvg:svgBlip xmlns:asvg="http://schemas.microsoft.com/office/drawing/2016/SVG/main" r:embed="rId9"/>
+                  <ns14:svgBlip xmlns:ns14="http://schemas.microsoft.com/office/drawing/2016/SVG/main" r:embed="rId38"/>
                 </a:ext>
               </a:extLst>
             </a:blip>
@@ -39167,7 +39173,7 @@
           </p:blipFill>
           <p:spPr>
             <a:xfrm>
-              <a:off x="5491715" y="3111591"/>
+              <a:off x="5491715" y="3120245"/>
               <a:ext cx="468000" cy="468000"/>
             </a:xfrm>
             <a:prstGeom prst="rect">
@@ -39390,10 +39396,10 @@
             <p:nvPr/>
           </p:nvPicPr>
           <p:blipFill>
-            <a:blip>
+            <a:blip r:embed="rId39">
               <a:extLst>
                 <a:ext uri="{96DAC541-7B7A-43D3-8B79-37D633B846F1}">
-                  <asvg:svgBlip xmlns:asvg="http://schemas.microsoft.com/office/drawing/2016/SVG/main" r:embed="rId14"/>
+                  <ns15:svgBlip xmlns:ns15="http://schemas.microsoft.com/office/drawing/2016/SVG/main" r:embed="rId40"/>
                 </a:ext>
               </a:extLst>
             </a:blip>
@@ -39403,7 +39409,7 @@
           </p:blipFill>
           <p:spPr>
             <a:xfrm>
-              <a:off x="3269916" y="1906225"/>
+              <a:off x="3269916" y="1914879"/>
               <a:ext cx="468000" cy="468000"/>
             </a:xfrm>
             <a:prstGeom prst="rect">

</xml_diff>

<commit_message>
Make icon tile backgrounds transparent and apply semantic box colors
The cream tile fill of the svg-icons-new set is removed (fill none,
border and motif colors kept), icons re-embedded with transparent PNG
fallbacks. Box colors now follow the semantic scheme consistently:
Information Extraction turns yellow (processing step), Relevant Data
turns blue (data artefact); gray is reserved for the two databases.

Co-Authored-By: Claude Fable 5 <noreply@anthropic.com>
Claude-Session: https://claude.ai/code/session_01S2kGP2buE2HmxMttD3XczR
</commit_message>
<xml_diff>
--- a/RAG_Workshop.pptx
+++ b/RAG_Workshop.pptx
@@ -35785,10 +35785,10 @@
             <p:nvPr/>
           </p:nvPicPr>
           <p:blipFill>
-            <a:blip r:embed="rId15">
+            <a:blip r:embed="rId14">
               <a:extLst>
                 <a:ext uri="{96DAC541-7B7A-43D3-8B79-37D633B846F1}">
-                  <ns0:svgBlip xmlns:ns0="http://schemas.microsoft.com/office/drawing/2016/SVG/main" r:embed="rId16"/>
+                  <ns0:svgBlip xmlns:ns0="http://schemas.microsoft.com/office/drawing/2016/SVG/main" r:embed="rId13"/>
                 </a:ext>
               </a:extLst>
             </a:blip>
@@ -35912,10 +35912,10 @@
             <p:nvPr/>
           </p:nvPicPr>
           <p:blipFill>
-            <a:blip r:embed="rId17">
+            <a:blip r:embed="rId12">
               <a:extLst>
                 <a:ext uri="{96DAC541-7B7A-43D3-8B79-37D633B846F1}">
-                  <ns1:svgBlip xmlns:ns1="http://schemas.microsoft.com/office/drawing/2016/SVG/main" r:embed="rId18"/>
+                  <ns1:svgBlip xmlns:ns1="http://schemas.microsoft.com/office/drawing/2016/SVG/main" r:embed="rId11"/>
                 </a:ext>
               </a:extLst>
             </a:blip>
@@ -36083,10 +36083,10 @@
             <p:nvPr/>
           </p:nvPicPr>
           <p:blipFill>
-            <a:blip r:embed="rId19">
+            <a:blip r:embed="rId10">
               <a:extLst>
                 <a:ext uri="{96DAC541-7B7A-43D3-8B79-37D633B846F1}">
-                  <ns2:svgBlip xmlns:ns2="http://schemas.microsoft.com/office/drawing/2016/SVG/main" r:embed="rId20"/>
+                  <ns2:svgBlip xmlns:ns2="http://schemas.microsoft.com/office/drawing/2016/SVG/main" r:embed="rId9"/>
                 </a:ext>
               </a:extLst>
             </a:blip>
@@ -36186,15 +36186,15 @@
               <a:avLst/>
             </a:prstGeom>
             <a:solidFill>
-              <a:schemeClr val="accent2">
+              <a:schemeClr val="accent6">
+                <a:lumMod val="40000"/>
+                <a:lumOff val="60000"/>
                 <a:alpha val="50000"/>
               </a:schemeClr>
             </a:solidFill>
             <a:ln>
               <a:solidFill>
-                <a:schemeClr val="accent2">
-                  <a:lumMod val="50000"/>
-                </a:schemeClr>
+                <a:srgbClr val="FFC000"/>
               </a:solidFill>
             </a:ln>
           </p:spPr>
@@ -36256,10 +36256,10 @@
             <p:nvPr/>
           </p:nvPicPr>
           <p:blipFill>
-            <a:blip r:embed="rId21">
+            <a:blip r:embed="rId8">
               <a:extLst>
                 <a:ext uri="{96DAC541-7B7A-43D3-8B79-37D633B846F1}">
-                  <ns3:svgBlip xmlns:ns3="http://schemas.microsoft.com/office/drawing/2016/SVG/main" r:embed="rId22"/>
+                  <ns3:svgBlip xmlns:ns3="http://schemas.microsoft.com/office/drawing/2016/SVG/main" r:embed="rId7"/>
                 </a:ext>
               </a:extLst>
             </a:blip>
@@ -36301,9 +36301,7 @@
             </a:prstGeom>
             <a:ln>
               <a:solidFill>
-                <a:schemeClr val="accent2">
-                  <a:lumMod val="50000"/>
-                </a:schemeClr>
+                <a:srgbClr val="FA9400"/>
               </a:solidFill>
             </a:ln>
           </p:spPr>
@@ -36493,10 +36491,10 @@
             <p:nvPr/>
           </p:nvPicPr>
           <p:blipFill>
-            <a:blip r:embed="rId23">
+            <a:blip r:embed="rId6">
               <a:extLst>
                 <a:ext uri="{96DAC541-7B7A-43D3-8B79-37D633B846F1}">
-                  <ns4:svgBlip xmlns:ns4="http://schemas.microsoft.com/office/drawing/2016/SVG/main" r:embed="rId24"/>
+                  <ns4:svgBlip xmlns:ns4="http://schemas.microsoft.com/office/drawing/2016/SVG/main" r:embed="rId5"/>
                 </a:ext>
               </a:extLst>
             </a:blip>
@@ -36622,10 +36620,10 @@
             <p:nvPr/>
           </p:nvPicPr>
           <p:blipFill>
-            <a:blip r:embed="rId25">
+            <a:blip r:embed="rId4">
               <a:extLst>
                 <a:ext uri="{96DAC541-7B7A-43D3-8B79-37D633B846F1}">
-                  <ns5:svgBlip xmlns:ns5="http://schemas.microsoft.com/office/drawing/2016/SVG/main" r:embed="rId26"/>
+                  <ns5:svgBlip xmlns:ns5="http://schemas.microsoft.com/office/drawing/2016/SVG/main" r:embed="rId3"/>
                 </a:ext>
               </a:extLst>
             </a:blip>
@@ -36803,10 +36801,10 @@
             <p:nvPr/>
           </p:nvPicPr>
           <p:blipFill>
-            <a:blip r:embed="rId27">
+            <a:blip r:embed="rId41">
               <a:extLst>
                 <a:ext uri="{96DAC541-7B7A-43D3-8B79-37D633B846F1}">
-                  <ns6:svgBlip xmlns:ns6="http://schemas.microsoft.com/office/drawing/2016/SVG/main" r:embed="rId28"/>
+                  <ns6:svgBlip xmlns:ns6="http://schemas.microsoft.com/office/drawing/2016/SVG/main" r:embed="rId42"/>
                 </a:ext>
               </a:extLst>
             </a:blip>
@@ -36914,13 +36912,13 @@
               <a:avLst/>
             </a:prstGeom>
             <a:solidFill>
-              <a:schemeClr val="bg2">
+              <a:schemeClr val="accent2">
                 <a:alpha val="50000"/>
               </a:schemeClr>
             </a:solidFill>
             <a:ln>
               <a:solidFill>
-                <a:schemeClr val="bg2">
+                <a:schemeClr val="accent2">
                   <a:lumMod val="50000"/>
                 </a:schemeClr>
               </a:solidFill>
@@ -36984,10 +36982,10 @@
             <p:nvPr/>
           </p:nvPicPr>
           <p:blipFill>
-            <a:blip r:embed="rId29">
+            <a:blip r:embed="rId43">
               <a:extLst>
                 <a:ext uri="{96DAC541-7B7A-43D3-8B79-37D633B846F1}">
-                  <ns7:svgBlip xmlns:ns7="http://schemas.microsoft.com/office/drawing/2016/SVG/main" r:embed="rId30"/>
+                  <ns7:svgBlip xmlns:ns7="http://schemas.microsoft.com/office/drawing/2016/SVG/main" r:embed="rId44"/>
                 </a:ext>
               </a:extLst>
             </a:blip>
@@ -37029,7 +37027,7 @@
             </a:prstGeom>
             <a:ln>
               <a:solidFill>
-                <a:schemeClr val="bg2">
+                <a:schemeClr val="accent2">
                   <a:lumMod val="50000"/>
                 </a:schemeClr>
               </a:solidFill>
@@ -37165,10 +37163,10 @@
             <p:nvPr/>
           </p:nvPicPr>
           <p:blipFill>
-            <a:blip r:embed="rId31">
+            <a:blip r:embed="rId45">
               <a:extLst>
                 <a:ext uri="{96DAC541-7B7A-43D3-8B79-37D633B846F1}">
-                  <ns8:svgBlip xmlns:ns8="http://schemas.microsoft.com/office/drawing/2016/SVG/main" r:embed="rId32"/>
+                  <ns8:svgBlip xmlns:ns8="http://schemas.microsoft.com/office/drawing/2016/SVG/main" r:embed="rId46"/>
                 </a:ext>
               </a:extLst>
             </a:blip>
@@ -37350,10 +37348,10 @@
             <p:nvPr/>
           </p:nvPicPr>
           <p:blipFill>
-            <a:blip r:embed="rId33">
+            <a:blip r:embed="rId47">
               <a:extLst>
                 <a:ext uri="{96DAC541-7B7A-43D3-8B79-37D633B846F1}">
-                  <ns9:svgBlip xmlns:ns9="http://schemas.microsoft.com/office/drawing/2016/SVG/main" r:embed="rId34"/>
+                  <ns9:svgBlip xmlns:ns9="http://schemas.microsoft.com/office/drawing/2016/SVG/main" r:embed="rId48"/>
                 </a:ext>
               </a:extLst>
             </a:blip>
@@ -38033,10 +38031,10 @@
             <p:nvPr/>
           </p:nvPicPr>
           <p:blipFill>
-            <a:blip r:embed="rId31">
+            <a:blip r:embed="rId45">
               <a:extLst>
                 <a:ext uri="{96DAC541-7B7A-43D3-8B79-37D633B846F1}">
-                  <ns10:svgBlip xmlns:ns10="http://schemas.microsoft.com/office/drawing/2016/SVG/main" r:embed="rId32"/>
+                  <ns10:svgBlip xmlns:ns10="http://schemas.microsoft.com/office/drawing/2016/SVG/main" r:embed="rId46"/>
                 </a:ext>
               </a:extLst>
             </a:blip>
@@ -38554,10 +38552,10 @@
             <p:nvPr/>
           </p:nvPicPr>
           <p:blipFill>
-            <a:blip r:embed="rId23">
+            <a:blip r:embed="rId6">
               <a:extLst>
                 <a:ext uri="{96DAC541-7B7A-43D3-8B79-37D633B846F1}">
-                  <ns11:svgBlip xmlns:ns11="http://schemas.microsoft.com/office/drawing/2016/SVG/main" r:embed="rId24"/>
+                  <ns11:svgBlip xmlns:ns11="http://schemas.microsoft.com/office/drawing/2016/SVG/main" r:embed="rId5"/>
                 </a:ext>
               </a:extLst>
             </a:blip>
@@ -38739,10 +38737,10 @@
             <p:nvPr/>
           </p:nvPicPr>
           <p:blipFill>
-            <a:blip r:embed="rId25">
+            <a:blip r:embed="rId4">
               <a:extLst>
                 <a:ext uri="{96DAC541-7B7A-43D3-8B79-37D633B846F1}">
-                  <ns12:svgBlip xmlns:ns12="http://schemas.microsoft.com/office/drawing/2016/SVG/main" r:embed="rId26"/>
+                  <ns12:svgBlip xmlns:ns12="http://schemas.microsoft.com/office/drawing/2016/SVG/main" r:embed="rId3"/>
                 </a:ext>
               </a:extLst>
             </a:blip>
@@ -38926,10 +38924,10 @@
             <p:nvPr/>
           </p:nvPicPr>
           <p:blipFill>
-            <a:blip r:embed="rId35">
+            <a:blip r:embed="rId49">
               <a:extLst>
                 <a:ext uri="{96DAC541-7B7A-43D3-8B79-37D633B846F1}">
-                  <ns13:svgBlip xmlns:ns13="http://schemas.microsoft.com/office/drawing/2016/SVG/main" r:embed="rId36"/>
+                  <ns13:svgBlip xmlns:ns13="http://schemas.microsoft.com/office/drawing/2016/SVG/main" r:embed="rId50"/>
                 </a:ext>
               </a:extLst>
             </a:blip>
@@ -39160,10 +39158,10 @@
             <p:nvPr/>
           </p:nvPicPr>
           <p:blipFill>
-            <a:blip r:embed="rId37">
+            <a:blip r:embed="rId51">
               <a:extLst>
                 <a:ext uri="{96DAC541-7B7A-43D3-8B79-37D633B846F1}">
-                  <ns14:svgBlip xmlns:ns14="http://schemas.microsoft.com/office/drawing/2016/SVG/main" r:embed="rId38"/>
+                  <ns14:svgBlip xmlns:ns14="http://schemas.microsoft.com/office/drawing/2016/SVG/main" r:embed="rId52"/>
                 </a:ext>
               </a:extLst>
             </a:blip>
@@ -39396,10 +39394,10 @@
             <p:nvPr/>
           </p:nvPicPr>
           <p:blipFill>
-            <a:blip r:embed="rId39">
+            <a:blip r:embed="rId53">
               <a:extLst>
                 <a:ext uri="{96DAC541-7B7A-43D3-8B79-37D633B846F1}">
-                  <ns15:svgBlip xmlns:ns15="http://schemas.microsoft.com/office/drawing/2016/SVG/main" r:embed="rId40"/>
+                  <ns15:svgBlip xmlns:ns15="http://schemas.microsoft.com/office/drawing/2016/SVG/main" r:embed="rId54"/>
                 </a:ext>
               </a:extLst>
             </a:blip>

</xml_diff>

<commit_message>
Reformat color-representative boxes on slide 7
Border and divider styling adjusted on Raw Data Files, Embedding LLM
and Vector Database as templates for the blue, yellow and gray family.

Co-Authored-By: Claude Fable 5 <noreply@anthropic.com>
Claude-Session: https://claude.ai/code/session_01S2kGP2buE2HmxMttD3XczR
</commit_message>
<xml_diff>
--- a/RAG_Workshop.pptx
+++ b/RAG_Workshop.pptx
@@ -267,7 +267,7 @@
           <a:p>
             <a:fld id="{52E8011C-FE86-4EBC-8644-A1C19BB3B3D0}" type="datetimeFigureOut">
               <a:rPr lang="de-DE" sz="1000" smtClean="0"/>
-              <a:t>07.08.2026</a:t>
+              <a:t>08.08.2026</a:t>
             </a:fld>
             <a:endParaRPr lang="de-DE" sz="1000"/>
           </a:p>
@@ -445,7 +445,7 @@
             <a:fld id="{ADD5FE3D-F70B-4796-8811-3B9EE273F98E}" type="datetimeFigureOut">
               <a:rPr lang="de-DE" smtClean="0"/>
               <a:pPr/>
-              <a:t>07.08.2026</a:t>
+              <a:t>08.08.2026</a:t>
             </a:fld>
             <a:endParaRPr lang="de-DE" dirty="0"/>
           </a:p>
@@ -3066,7 +3066,7 @@
           <a:p>
             <a:fld id="{C0B5DAE3-E9C3-48BD-9F84-B39C87C1D4EA}" type="datetime1">
               <a:rPr lang="de-CH" smtClean="0"/>
-              <a:t>07.08.2026</a:t>
+              <a:t>08.08.2026</a:t>
             </a:fld>
             <a:endParaRPr lang="de-CH" dirty="0"/>
           </a:p>
@@ -3423,7 +3423,7 @@
           <a:p>
             <a:fld id="{C33DD234-259D-4F15-8408-EA64820F6397}" type="datetime1">
               <a:rPr lang="de-CH" smtClean="0"/>
-              <a:t>07.08.2026</a:t>
+              <a:t>08.08.2026</a:t>
             </a:fld>
             <a:endParaRPr lang="de-CH" dirty="0"/>
           </a:p>
@@ -3679,7 +3679,7 @@
           <a:p>
             <a:fld id="{CB295712-26CE-4B63-A766-0110588AF456}" type="datetime1">
               <a:rPr lang="de-CH" smtClean="0"/>
-              <a:t>07.08.2026</a:t>
+              <a:t>08.08.2026</a:t>
             </a:fld>
             <a:endParaRPr lang="de-CH" dirty="0"/>
           </a:p>
@@ -4045,7 +4045,7 @@
           <a:p>
             <a:fld id="{3B96E7C6-F2CE-4756-8C9C-414CDB636DDE}" type="datetime1">
               <a:rPr lang="de-CH" smtClean="0"/>
-              <a:t>07.08.2026</a:t>
+              <a:t>08.08.2026</a:t>
             </a:fld>
             <a:endParaRPr lang="de-CH" dirty="0"/>
           </a:p>
@@ -4232,7 +4232,7 @@
           <a:p>
             <a:fld id="{E2111384-F462-4D90-9803-E7B6DB23FD1B}" type="datetime1">
               <a:rPr lang="de-CH" smtClean="0"/>
-              <a:t>07.08.2026</a:t>
+              <a:t>08.08.2026</a:t>
             </a:fld>
             <a:endParaRPr lang="de-CH" dirty="0"/>
           </a:p>
@@ -4510,7 +4510,7 @@
           <a:p>
             <a:fld id="{54359010-3833-46D1-85CE-E9F83B9A0CAB}" type="datetime1">
               <a:rPr lang="de-CH" smtClean="0"/>
-              <a:t>07.08.2026</a:t>
+              <a:t>08.08.2026</a:t>
             </a:fld>
             <a:endParaRPr lang="de-CH" dirty="0"/>
           </a:p>
@@ -4745,7 +4745,7 @@
           <a:p>
             <a:fld id="{A44B8AD2-0CB6-4686-BC54-BC8E97B87777}" type="datetime1">
               <a:rPr lang="de-CH" smtClean="0"/>
-              <a:t>07.08.2026</a:t>
+              <a:t>08.08.2026</a:t>
             </a:fld>
             <a:endParaRPr lang="de-CH" dirty="0"/>
           </a:p>
@@ -4980,7 +4980,7 @@
           <a:p>
             <a:fld id="{B0557833-6AB4-4458-8CD6-D82947634C0B}" type="datetime1">
               <a:rPr lang="de-CH" smtClean="0"/>
-              <a:t>07.08.2026</a:t>
+              <a:t>08.08.2026</a:t>
             </a:fld>
             <a:endParaRPr lang="de-CH" dirty="0"/>
           </a:p>
@@ -5251,7 +5251,7 @@
           <a:p>
             <a:fld id="{5885801D-3341-4DAA-8DB7-EA54BF0E83F6}" type="datetime1">
               <a:rPr lang="de-CH" smtClean="0"/>
-              <a:t>07.08.2026</a:t>
+              <a:t>08.08.2026</a:t>
             </a:fld>
             <a:endParaRPr lang="de-CH" dirty="0"/>
           </a:p>
@@ -5487,7 +5487,7 @@
           <a:p>
             <a:fld id="{B4FC1744-D639-45C4-8D62-63B8E6EA4645}" type="datetime1">
               <a:rPr lang="de-CH" smtClean="0"/>
-              <a:t>07.08.2026</a:t>
+              <a:t>08.08.2026</a:t>
             </a:fld>
             <a:endParaRPr lang="de-CH" dirty="0"/>
           </a:p>
@@ -5697,7 +5697,7 @@
           <a:p>
             <a:fld id="{5F18E43C-E52F-48EA-B380-1F3AB6DC196F}" type="datetime1">
               <a:rPr lang="de-CH" smtClean="0"/>
-              <a:t>07.08.2026</a:t>
+              <a:t>08.08.2026</a:t>
             </a:fld>
             <a:endParaRPr lang="de-CH" dirty="0"/>
           </a:p>
@@ -6409,7 +6409,7 @@
           <a:p>
             <a:fld id="{63C4474F-84D2-49E0-A6C4-5163AC122E4E}" type="datetime1">
               <a:rPr lang="de-CH" smtClean="0"/>
-              <a:t>07.08.2026</a:t>
+              <a:t>08.08.2026</a:t>
             </a:fld>
             <a:endParaRPr lang="de-CH" dirty="0"/>
           </a:p>
@@ -6901,7 +6901,7 @@
                 <a:tabLst/>
                 <a:defRPr/>
               </a:pPr>
-              <a:t>07.08.2026</a:t>
+              <a:t>08.08.2026</a:t>
             </a:fld>
             <a:endParaRPr kumimoji="0" lang="de-CH" sz="900" b="0" i="0" u="none" strike="noStrike" kern="1200" cap="none" spc="0" normalizeH="0" baseline="0" noProof="0" dirty="0">
               <a:ln>
@@ -7138,7 +7138,7 @@
           <a:p>
             <a:fld id="{E668D7D0-CB17-47D3-88E8-EDADFD5EAF7A}" type="datetime1">
               <a:rPr lang="de-CH" smtClean="0"/>
-              <a:t>07.08.2026</a:t>
+              <a:t>08.08.2026</a:t>
             </a:fld>
             <a:endParaRPr lang="de-CH" dirty="0"/>
           </a:p>
@@ -27481,7 +27481,7 @@
           <a:p>
             <a:fld id="{E94A5EAB-87E9-4E72-ACDB-1A85F23C04B3}" type="datetime1">
               <a:rPr lang="de-CH" smtClean="0"/>
-              <a:t>07.08.2026</a:t>
+              <a:t>08.08.2026</a:t>
             </a:fld>
             <a:endParaRPr lang="de-CH" dirty="0"/>
           </a:p>
@@ -28979,7 +28979,7 @@
           <a:p>
             <a:fld id="{0CA583EE-97BD-443A-B41B-1EE41A4CF6B6}" type="datetime1">
               <a:rPr lang="de-CH" smtClean="0"/>
-              <a:t>07.08.2026</a:t>
+              <a:t>08.08.2026</a:t>
             </a:fld>
             <a:endParaRPr lang="de-CH" dirty="0"/>
           </a:p>
@@ -29520,7 +29520,7 @@
           <a:p>
             <a:fld id="{E668D7D0-CB17-47D3-88E8-EDADFD5EAF7A}" type="datetime1">
               <a:rPr lang="de-CH" smtClean="0"/>
-              <a:t>07.08.2026</a:t>
+              <a:t>08.08.2026</a:t>
             </a:fld>
             <a:endParaRPr lang="de-CH" dirty="0"/>
           </a:p>
@@ -29665,7 +29665,7 @@
           <a:p>
             <a:fld id="{3B96E7C6-F2CE-4756-8C9C-414CDB636DDE}" type="datetime1">
               <a:rPr lang="de-CH" smtClean="0"/>
-              <a:t>07.08.2026</a:t>
+              <a:t>08.08.2026</a:t>
             </a:fld>
             <a:endParaRPr lang="de-CH" dirty="0"/>
           </a:p>
@@ -32181,7 +32181,7 @@
           <a:p>
             <a:fld id="{1EB7C1D4-D1F3-40CB-8780-B2B6A9133392}" type="datetime1">
               <a:rPr lang="de-DE"/>
-              <a:t>07.08.2026</a:t>
+              <a:t>08.08.2026</a:t>
             </a:fld>
             <a:endParaRPr/>
           </a:p>
@@ -33879,7 +33879,7 @@
           <a:p>
             <a:fld id="{E2111384-F462-4D90-9803-E7B6DB23FD1B}" type="datetime1">
               <a:rPr lang="de-DE"/>
-              <a:t>07.08.2026</a:t>
+              <a:t>08.08.2026</a:t>
             </a:fld>
             <a:endParaRPr/>
           </a:p>
@@ -35626,6 +35626,790 @@
           </a:p>
         </p:txBody>
       </p:sp>
+      <p:cxnSp>
+        <p:nvCxnSpPr>
+          <p:cNvPr id="108" name="Gerade Verbindung mit Pfeil 116">
+            <a:extLst>
+              <a:ext uri="{FF2B5EF4-FFF2-40B4-BE49-F238E27FC236}">
+                <a16:creationId xmlns:a16="http://schemas.microsoft.com/office/drawing/2014/main" id="{0BDDCE84-4016-2B9D-139E-B6028861F673}"/>
+              </a:ext>
+            </a:extLst>
+          </p:cNvPr>
+          <p:cNvCxnSpPr>
+            <a:cxnSpLocks/>
+            <a:stCxn id="37" idx="0"/>
+            <a:endCxn id="45" idx="2"/>
+          </p:cNvCxnSpPr>
+          <p:nvPr/>
+        </p:nvCxnSpPr>
+        <p:spPr>
+          <a:xfrm flipV="1">
+            <a:off x="1260000" y="3505199"/>
+            <a:ext cx="0" cy="323025"/>
+          </a:xfrm>
+          <a:prstGeom prst="straightConnector1">
+            <a:avLst/>
+          </a:prstGeom>
+          <a:ln w="50800">
+            <a:solidFill>
+              <a:schemeClr val="tx1">
+                <a:alpha val="50000"/>
+              </a:schemeClr>
+            </a:solidFill>
+            <a:prstDash val="solid"/>
+            <a:tailEnd type="triangle"/>
+          </a:ln>
+        </p:spPr>
+        <p:style>
+          <a:lnRef idx="1">
+            <a:schemeClr val="accent1"/>
+          </a:lnRef>
+          <a:fillRef idx="0">
+            <a:schemeClr val="accent1"/>
+          </a:fillRef>
+          <a:effectRef idx="0">
+            <a:schemeClr val="accent1"/>
+          </a:effectRef>
+          <a:fontRef idx="minor">
+            <a:schemeClr val="tx1"/>
+          </a:fontRef>
+        </p:style>
+      </p:cxnSp>
+      <p:cxnSp>
+        <p:nvCxnSpPr>
+          <p:cNvPr id="109" name="Gerade Verbindung mit Pfeil 118">
+            <a:extLst>
+              <a:ext uri="{FF2B5EF4-FFF2-40B4-BE49-F238E27FC236}">
+                <a16:creationId xmlns:a16="http://schemas.microsoft.com/office/drawing/2014/main" id="{0BB315D1-6C56-0674-6B65-3777144E7075}"/>
+              </a:ext>
+            </a:extLst>
+          </p:cNvPr>
+          <p:cNvCxnSpPr>
+            <a:cxnSpLocks/>
+            <a:stCxn id="45" idx="0"/>
+            <a:endCxn id="121" idx="2"/>
+          </p:cNvCxnSpPr>
+          <p:nvPr/>
+        </p:nvCxnSpPr>
+        <p:spPr>
+          <a:xfrm flipV="1">
+            <a:off x="1260000" y="2314574"/>
+            <a:ext cx="0" cy="323025"/>
+          </a:xfrm>
+          <a:prstGeom prst="straightConnector1">
+            <a:avLst/>
+          </a:prstGeom>
+          <a:ln w="50800">
+            <a:solidFill>
+              <a:schemeClr val="tx1">
+                <a:alpha val="50000"/>
+              </a:schemeClr>
+            </a:solidFill>
+            <a:prstDash val="solid"/>
+            <a:tailEnd type="triangle"/>
+          </a:ln>
+        </p:spPr>
+        <p:style>
+          <a:lnRef idx="1">
+            <a:schemeClr val="accent1"/>
+          </a:lnRef>
+          <a:fillRef idx="0">
+            <a:schemeClr val="accent1"/>
+          </a:fillRef>
+          <a:effectRef idx="0">
+            <a:schemeClr val="accent1"/>
+          </a:effectRef>
+          <a:fontRef idx="minor">
+            <a:schemeClr val="tx1"/>
+          </a:fontRef>
+        </p:style>
+      </p:cxnSp>
+      <p:cxnSp>
+        <p:nvCxnSpPr>
+          <p:cNvPr id="112" name="Gerade Verbindung mit Pfeil 143">
+            <a:extLst>
+              <a:ext uri="{FF2B5EF4-FFF2-40B4-BE49-F238E27FC236}">
+                <a16:creationId xmlns:a16="http://schemas.microsoft.com/office/drawing/2014/main" id="{56983D44-8E80-3AB3-A9CF-D7232B3BF542}"/>
+              </a:ext>
+            </a:extLst>
+          </p:cNvPr>
+          <p:cNvCxnSpPr>
+            <a:cxnSpLocks/>
+            <a:stCxn id="81" idx="3"/>
+            <a:endCxn id="102" idx="1"/>
+          </p:cNvCxnSpPr>
+          <p:nvPr/>
+        </p:nvCxnSpPr>
+        <p:spPr>
+          <a:xfrm>
+            <a:off x="7380000" y="5471328"/>
+            <a:ext cx="360000" cy="0"/>
+          </a:xfrm>
+          <a:prstGeom prst="straightConnector1">
+            <a:avLst/>
+          </a:prstGeom>
+          <a:ln w="50800">
+            <a:solidFill>
+              <a:schemeClr val="tx1">
+                <a:alpha val="50000"/>
+              </a:schemeClr>
+            </a:solidFill>
+            <a:prstDash val="solid"/>
+            <a:tailEnd type="triangle"/>
+          </a:ln>
+        </p:spPr>
+        <p:style>
+          <a:lnRef idx="1">
+            <a:schemeClr val="accent1"/>
+          </a:lnRef>
+          <a:fillRef idx="0">
+            <a:schemeClr val="accent1"/>
+          </a:fillRef>
+          <a:effectRef idx="0">
+            <a:schemeClr val="accent1"/>
+          </a:effectRef>
+          <a:fontRef idx="minor">
+            <a:schemeClr val="tx1"/>
+          </a:fontRef>
+        </p:style>
+      </p:cxnSp>
+      <p:cxnSp>
+        <p:nvCxnSpPr>
+          <p:cNvPr id="114" name="Gerade Verbindung mit Pfeil 148">
+            <a:extLst>
+              <a:ext uri="{FF2B5EF4-FFF2-40B4-BE49-F238E27FC236}">
+                <a16:creationId xmlns:a16="http://schemas.microsoft.com/office/drawing/2014/main" id="{F5BC60B3-6D21-34AF-F241-F9DCA2E051D9}"/>
+              </a:ext>
+            </a:extLst>
+          </p:cNvPr>
+          <p:cNvCxnSpPr>
+            <a:cxnSpLocks/>
+            <a:stCxn id="32" idx="1"/>
+            <a:endCxn id="72" idx="3"/>
+          </p:cNvCxnSpPr>
+          <p:nvPr/>
+        </p:nvCxnSpPr>
+        <p:spPr>
+          <a:xfrm flipH="1">
+            <a:off x="7380000" y="3071399"/>
+            <a:ext cx="360000" cy="0"/>
+          </a:xfrm>
+          <a:prstGeom prst="straightConnector1">
+            <a:avLst/>
+          </a:prstGeom>
+          <a:ln w="50800">
+            <a:solidFill>
+              <a:schemeClr val="tx1">
+                <a:alpha val="50000"/>
+              </a:schemeClr>
+            </a:solidFill>
+            <a:prstDash val="solid"/>
+            <a:tailEnd type="triangle"/>
+          </a:ln>
+        </p:spPr>
+        <p:style>
+          <a:lnRef idx="1">
+            <a:schemeClr val="accent1"/>
+          </a:lnRef>
+          <a:fillRef idx="0">
+            <a:schemeClr val="accent1"/>
+          </a:fillRef>
+          <a:effectRef idx="0">
+            <a:schemeClr val="accent1"/>
+          </a:effectRef>
+          <a:fontRef idx="minor">
+            <a:schemeClr val="tx1"/>
+          </a:fontRef>
+        </p:style>
+      </p:cxnSp>
+      <p:cxnSp>
+        <p:nvCxnSpPr>
+          <p:cNvPr id="125" name="Gerade Verbindung mit Pfeil 175">
+            <a:extLst>
+              <a:ext uri="{FF2B5EF4-FFF2-40B4-BE49-F238E27FC236}">
+                <a16:creationId xmlns:a16="http://schemas.microsoft.com/office/drawing/2014/main" id="{C72D8DE9-33EF-8199-896F-3B4B34E4C33F}"/>
+              </a:ext>
+            </a:extLst>
+          </p:cNvPr>
+          <p:cNvCxnSpPr>
+            <a:cxnSpLocks/>
+            <a:stCxn id="121" idx="3"/>
+            <a:endCxn id="137" idx="1"/>
+          </p:cNvCxnSpPr>
+          <p:nvPr/>
+        </p:nvCxnSpPr>
+        <p:spPr>
+          <a:xfrm flipV="1">
+            <a:off x="1980000" y="1879887"/>
+            <a:ext cx="360000" cy="887"/>
+          </a:xfrm>
+          <a:prstGeom prst="straightConnector1">
+            <a:avLst/>
+          </a:prstGeom>
+          <a:ln w="50800">
+            <a:solidFill>
+              <a:schemeClr val="tx1">
+                <a:alpha val="50000"/>
+              </a:schemeClr>
+            </a:solidFill>
+            <a:prstDash val="solid"/>
+            <a:tailEnd type="triangle"/>
+          </a:ln>
+        </p:spPr>
+        <p:style>
+          <a:lnRef idx="1">
+            <a:schemeClr val="accent1"/>
+          </a:lnRef>
+          <a:fillRef idx="0">
+            <a:schemeClr val="accent1"/>
+          </a:fillRef>
+          <a:effectRef idx="0">
+            <a:schemeClr val="accent1"/>
+          </a:effectRef>
+          <a:fontRef idx="minor">
+            <a:schemeClr val="tx1"/>
+          </a:fontRef>
+        </p:style>
+      </p:cxnSp>
+      <p:cxnSp>
+        <p:nvCxnSpPr>
+          <p:cNvPr id="7" name="Gerade Verbindung mit Pfeil 175">
+            <a:extLst>
+              <a:ext uri="{FF2B5EF4-FFF2-40B4-BE49-F238E27FC236}">
+                <a16:creationId xmlns:a16="http://schemas.microsoft.com/office/drawing/2014/main" id="{0D4E258E-510F-CDC1-7824-B97B0D97B16A}"/>
+              </a:ext>
+            </a:extLst>
+          </p:cNvPr>
+          <p:cNvCxnSpPr>
+            <a:cxnSpLocks/>
+            <a:stCxn id="137" idx="3"/>
+            <a:endCxn id="54" idx="1"/>
+          </p:cNvCxnSpPr>
+          <p:nvPr/>
+        </p:nvCxnSpPr>
+        <p:spPr>
+          <a:xfrm>
+            <a:off x="3780000" y="1879887"/>
+            <a:ext cx="2160000" cy="8171"/>
+          </a:xfrm>
+          <a:prstGeom prst="straightConnector1">
+            <a:avLst/>
+          </a:prstGeom>
+          <a:ln w="50800">
+            <a:solidFill>
+              <a:schemeClr val="tx1">
+                <a:alpha val="50000"/>
+              </a:schemeClr>
+            </a:solidFill>
+            <a:prstDash val="solid"/>
+            <a:tailEnd type="triangle"/>
+          </a:ln>
+        </p:spPr>
+        <p:style>
+          <a:lnRef idx="1">
+            <a:schemeClr val="accent1"/>
+          </a:lnRef>
+          <a:fillRef idx="0">
+            <a:schemeClr val="accent1"/>
+          </a:fillRef>
+          <a:effectRef idx="0">
+            <a:schemeClr val="accent1"/>
+          </a:effectRef>
+          <a:fontRef idx="minor">
+            <a:schemeClr val="tx1"/>
+          </a:fontRef>
+        </p:style>
+      </p:cxnSp>
+      <p:cxnSp>
+        <p:nvCxnSpPr>
+          <p:cNvPr id="15" name="Gerade Verbindung mit Pfeil 143">
+            <a:extLst>
+              <a:ext uri="{FF2B5EF4-FFF2-40B4-BE49-F238E27FC236}">
+                <a16:creationId xmlns:a16="http://schemas.microsoft.com/office/drawing/2014/main" id="{A1A5E8C3-3F80-9A63-9DF4-CD841A9DCB7A}"/>
+              </a:ext>
+            </a:extLst>
+          </p:cNvPr>
+          <p:cNvCxnSpPr>
+            <a:cxnSpLocks/>
+            <a:stCxn id="102" idx="3"/>
+            <a:endCxn id="24" idx="1"/>
+          </p:cNvCxnSpPr>
+          <p:nvPr/>
+        </p:nvCxnSpPr>
+        <p:spPr>
+          <a:xfrm flipV="1">
+            <a:off x="9180000" y="5461803"/>
+            <a:ext cx="360000" cy="9525"/>
+          </a:xfrm>
+          <a:prstGeom prst="straightConnector1">
+            <a:avLst/>
+          </a:prstGeom>
+          <a:ln w="50800">
+            <a:solidFill>
+              <a:schemeClr val="tx1">
+                <a:alpha val="50000"/>
+              </a:schemeClr>
+            </a:solidFill>
+            <a:prstDash val="solid"/>
+            <a:tailEnd type="triangle"/>
+          </a:ln>
+        </p:spPr>
+        <p:style>
+          <a:lnRef idx="1">
+            <a:schemeClr val="accent1"/>
+          </a:lnRef>
+          <a:fillRef idx="0">
+            <a:schemeClr val="accent1"/>
+          </a:fillRef>
+          <a:effectRef idx="0">
+            <a:schemeClr val="accent1"/>
+          </a:effectRef>
+          <a:fontRef idx="minor">
+            <a:schemeClr val="tx1"/>
+          </a:fontRef>
+        </p:style>
+      </p:cxnSp>
+      <p:cxnSp>
+        <p:nvCxnSpPr>
+          <p:cNvPr id="26" name="Gerade Verbindung mit Pfeil 116">
+            <a:extLst>
+              <a:ext uri="{FF2B5EF4-FFF2-40B4-BE49-F238E27FC236}">
+                <a16:creationId xmlns:a16="http://schemas.microsoft.com/office/drawing/2014/main" id="{02CDE7FC-A0D5-07F3-2CE6-481F9220CCFB}"/>
+              </a:ext>
+            </a:extLst>
+          </p:cNvPr>
+          <p:cNvCxnSpPr>
+            <a:cxnSpLocks/>
+            <a:stCxn id="10" idx="0"/>
+            <a:endCxn id="37" idx="2"/>
+          </p:cNvCxnSpPr>
+          <p:nvPr/>
+        </p:nvCxnSpPr>
+        <p:spPr>
+          <a:xfrm flipV="1">
+            <a:off x="1260000" y="4695824"/>
+            <a:ext cx="0" cy="323025"/>
+          </a:xfrm>
+          <a:prstGeom prst="straightConnector1">
+            <a:avLst/>
+          </a:prstGeom>
+          <a:ln w="50800">
+            <a:solidFill>
+              <a:schemeClr val="tx1">
+                <a:alpha val="50000"/>
+              </a:schemeClr>
+            </a:solidFill>
+            <a:prstDash val="solid"/>
+            <a:tailEnd type="triangle"/>
+          </a:ln>
+        </p:spPr>
+        <p:style>
+          <a:lnRef idx="1">
+            <a:schemeClr val="accent1"/>
+          </a:lnRef>
+          <a:fillRef idx="0">
+            <a:schemeClr val="accent1"/>
+          </a:fillRef>
+          <a:effectRef idx="0">
+            <a:schemeClr val="accent1"/>
+          </a:effectRef>
+          <a:fontRef idx="minor">
+            <a:schemeClr val="tx1"/>
+          </a:fontRef>
+        </p:style>
+      </p:cxnSp>
+      <p:cxnSp>
+        <p:nvCxnSpPr>
+          <p:cNvPr id="30" name="Gerade Verbindung mit Pfeil 116">
+            <a:extLst>
+              <a:ext uri="{FF2B5EF4-FFF2-40B4-BE49-F238E27FC236}">
+                <a16:creationId xmlns:a16="http://schemas.microsoft.com/office/drawing/2014/main" id="{F834C3E5-D35F-44C7-AEE0-6AEAEACA36B4}"/>
+              </a:ext>
+            </a:extLst>
+          </p:cNvPr>
+          <p:cNvCxnSpPr>
+            <a:cxnSpLocks/>
+            <a:stCxn id="18" idx="1"/>
+            <a:endCxn id="93" idx="3"/>
+          </p:cNvCxnSpPr>
+          <p:nvPr/>
+        </p:nvCxnSpPr>
+        <p:spPr>
+          <a:xfrm flipH="1" flipV="1">
+            <a:off x="9180000" y="1880774"/>
+            <a:ext cx="360000" cy="2551"/>
+          </a:xfrm>
+          <a:prstGeom prst="straightConnector1">
+            <a:avLst/>
+          </a:prstGeom>
+          <a:ln w="50800">
+            <a:solidFill>
+              <a:schemeClr val="tx1">
+                <a:alpha val="50000"/>
+              </a:schemeClr>
+            </a:solidFill>
+            <a:prstDash val="solid"/>
+            <a:tailEnd type="triangle"/>
+          </a:ln>
+        </p:spPr>
+        <p:style>
+          <a:lnRef idx="1">
+            <a:schemeClr val="accent1"/>
+          </a:lnRef>
+          <a:fillRef idx="0">
+            <a:schemeClr val="accent1"/>
+          </a:fillRef>
+          <a:effectRef idx="0">
+            <a:schemeClr val="accent1"/>
+          </a:effectRef>
+          <a:fontRef idx="minor">
+            <a:schemeClr val="tx1"/>
+          </a:fontRef>
+        </p:style>
+      </p:cxnSp>
+      <p:cxnSp>
+        <p:nvCxnSpPr>
+          <p:cNvPr id="34" name="Gerade Verbindung mit Pfeil 116">
+            <a:extLst>
+              <a:ext uri="{FF2B5EF4-FFF2-40B4-BE49-F238E27FC236}">
+                <a16:creationId xmlns:a16="http://schemas.microsoft.com/office/drawing/2014/main" id="{AAD4A9FA-5DEA-3E74-98D7-E03DAAF937A5}"/>
+              </a:ext>
+            </a:extLst>
+          </p:cNvPr>
+          <p:cNvCxnSpPr>
+            <a:cxnSpLocks/>
+            <a:stCxn id="93" idx="2"/>
+            <a:endCxn id="32" idx="0"/>
+          </p:cNvCxnSpPr>
+          <p:nvPr/>
+        </p:nvCxnSpPr>
+        <p:spPr>
+          <a:xfrm>
+            <a:off x="8460000" y="2314574"/>
+            <a:ext cx="0" cy="323025"/>
+          </a:xfrm>
+          <a:prstGeom prst="straightConnector1">
+            <a:avLst/>
+          </a:prstGeom>
+          <a:ln w="50800">
+            <a:solidFill>
+              <a:schemeClr val="tx1">
+                <a:alpha val="50000"/>
+              </a:schemeClr>
+            </a:solidFill>
+            <a:prstDash val="solid"/>
+            <a:tailEnd type="triangle"/>
+          </a:ln>
+        </p:spPr>
+        <p:style>
+          <a:lnRef idx="1">
+            <a:schemeClr val="accent1"/>
+          </a:lnRef>
+          <a:fillRef idx="0">
+            <a:schemeClr val="accent1"/>
+          </a:fillRef>
+          <a:effectRef idx="0">
+            <a:schemeClr val="accent1"/>
+          </a:effectRef>
+          <a:fontRef idx="minor">
+            <a:schemeClr val="tx1"/>
+          </a:fontRef>
+        </p:style>
+      </p:cxnSp>
+      <p:cxnSp>
+        <p:nvCxnSpPr>
+          <p:cNvPr id="38" name="Gerade Verbindung mit Pfeil 116">
+            <a:extLst>
+              <a:ext uri="{FF2B5EF4-FFF2-40B4-BE49-F238E27FC236}">
+                <a16:creationId xmlns:a16="http://schemas.microsoft.com/office/drawing/2014/main" id="{BBC39D6B-1A7E-43A7-AB4C-507B2811AD74}"/>
+              </a:ext>
+            </a:extLst>
+          </p:cNvPr>
+          <p:cNvCxnSpPr>
+            <a:cxnSpLocks/>
+            <a:stCxn id="54" idx="2"/>
+            <a:endCxn id="72" idx="0"/>
+          </p:cNvCxnSpPr>
+          <p:nvPr/>
+        </p:nvCxnSpPr>
+        <p:spPr>
+          <a:xfrm>
+            <a:off x="6660000" y="2321858"/>
+            <a:ext cx="0" cy="315741"/>
+          </a:xfrm>
+          <a:prstGeom prst="straightConnector1">
+            <a:avLst/>
+          </a:prstGeom>
+          <a:ln w="50800">
+            <a:solidFill>
+              <a:schemeClr val="tx1">
+                <a:alpha val="50000"/>
+              </a:schemeClr>
+            </a:solidFill>
+            <a:prstDash val="solid"/>
+            <a:tailEnd type="triangle"/>
+          </a:ln>
+        </p:spPr>
+        <p:style>
+          <a:lnRef idx="1">
+            <a:schemeClr val="accent1"/>
+          </a:lnRef>
+          <a:fillRef idx="0">
+            <a:schemeClr val="accent1"/>
+          </a:fillRef>
+          <a:effectRef idx="0">
+            <a:schemeClr val="accent1"/>
+          </a:effectRef>
+          <a:fontRef idx="minor">
+            <a:schemeClr val="tx1"/>
+          </a:fontRef>
+        </p:style>
+      </p:cxnSp>
+      <p:cxnSp>
+        <p:nvCxnSpPr>
+          <p:cNvPr id="49" name="Gerade Verbindung mit Pfeil 116">
+            <a:extLst>
+              <a:ext uri="{FF2B5EF4-FFF2-40B4-BE49-F238E27FC236}">
+                <a16:creationId xmlns:a16="http://schemas.microsoft.com/office/drawing/2014/main" id="{95BD79AE-8E27-C417-44A9-1DA30BB87BB2}"/>
+              </a:ext>
+            </a:extLst>
+          </p:cNvPr>
+          <p:cNvCxnSpPr>
+            <a:cxnSpLocks/>
+            <a:stCxn id="72" idx="2"/>
+            <a:endCxn id="41" idx="0"/>
+          </p:cNvCxnSpPr>
+          <p:nvPr/>
+        </p:nvCxnSpPr>
+        <p:spPr>
+          <a:xfrm>
+            <a:off x="6660000" y="3505199"/>
+            <a:ext cx="0" cy="323025"/>
+          </a:xfrm>
+          <a:prstGeom prst="straightConnector1">
+            <a:avLst/>
+          </a:prstGeom>
+          <a:ln w="50800">
+            <a:solidFill>
+              <a:schemeClr val="tx1">
+                <a:alpha val="50000"/>
+              </a:schemeClr>
+            </a:solidFill>
+            <a:prstDash val="solid"/>
+            <a:tailEnd type="triangle"/>
+          </a:ln>
+        </p:spPr>
+        <p:style>
+          <a:lnRef idx="1">
+            <a:schemeClr val="accent1"/>
+          </a:lnRef>
+          <a:fillRef idx="0">
+            <a:schemeClr val="accent1"/>
+          </a:fillRef>
+          <a:effectRef idx="0">
+            <a:schemeClr val="accent1"/>
+          </a:effectRef>
+          <a:fontRef idx="minor">
+            <a:schemeClr val="tx1"/>
+          </a:fontRef>
+        </p:style>
+      </p:cxnSp>
+      <p:cxnSp>
+        <p:nvCxnSpPr>
+          <p:cNvPr id="43" name="Gerade Verbindung mit Pfeil 116">
+            <a:extLst>
+              <a:ext uri="{FF2B5EF4-FFF2-40B4-BE49-F238E27FC236}">
+                <a16:creationId xmlns:a16="http://schemas.microsoft.com/office/drawing/2014/main" id="{3BE2586C-9C1C-363F-5145-8C1A7F21DECA}"/>
+              </a:ext>
+            </a:extLst>
+          </p:cNvPr>
+          <p:cNvCxnSpPr>
+            <a:cxnSpLocks/>
+            <a:stCxn id="37" idx="3"/>
+            <a:endCxn id="25" idx="1"/>
+          </p:cNvCxnSpPr>
+          <p:nvPr/>
+        </p:nvCxnSpPr>
+        <p:spPr>
+          <a:xfrm>
+            <a:off x="1980000" y="4262024"/>
+            <a:ext cx="360000" cy="0"/>
+          </a:xfrm>
+          <a:prstGeom prst="straightConnector1">
+            <a:avLst/>
+          </a:prstGeom>
+          <a:ln w="50800">
+            <a:solidFill>
+              <a:schemeClr val="tx1">
+                <a:alpha val="50000"/>
+              </a:schemeClr>
+            </a:solidFill>
+            <a:prstDash val="solid"/>
+            <a:tailEnd type="triangle"/>
+          </a:ln>
+        </p:spPr>
+        <p:style>
+          <a:lnRef idx="1">
+            <a:schemeClr val="accent1"/>
+          </a:lnRef>
+          <a:fillRef idx="0">
+            <a:schemeClr val="accent1"/>
+          </a:fillRef>
+          <a:effectRef idx="0">
+            <a:schemeClr val="accent1"/>
+          </a:effectRef>
+          <a:fontRef idx="minor">
+            <a:schemeClr val="tx1"/>
+          </a:fontRef>
+        </p:style>
+      </p:cxnSp>
+      <p:cxnSp>
+        <p:nvCxnSpPr>
+          <p:cNvPr id="21" name="Gerade Verbindung mit Pfeil 116">
+            <a:extLst>
+              <a:ext uri="{FF2B5EF4-FFF2-40B4-BE49-F238E27FC236}">
+                <a16:creationId xmlns:a16="http://schemas.microsoft.com/office/drawing/2014/main" id="{25C8CBDB-7E9A-B6BE-F8EC-E9E9D7622066}"/>
+              </a:ext>
+            </a:extLst>
+          </p:cNvPr>
+          <p:cNvCxnSpPr>
+            <a:cxnSpLocks/>
+            <a:stCxn id="25" idx="3"/>
+            <a:endCxn id="13" idx="1"/>
+          </p:cNvCxnSpPr>
+          <p:nvPr/>
+        </p:nvCxnSpPr>
+        <p:spPr>
+          <a:xfrm>
+            <a:off x="3780000" y="4262024"/>
+            <a:ext cx="360000" cy="0"/>
+          </a:xfrm>
+          <a:prstGeom prst="straightConnector1">
+            <a:avLst/>
+          </a:prstGeom>
+          <a:ln w="50800">
+            <a:solidFill>
+              <a:schemeClr val="tx1">
+                <a:alpha val="50000"/>
+              </a:schemeClr>
+            </a:solidFill>
+            <a:prstDash val="solid"/>
+            <a:tailEnd type="triangle"/>
+          </a:ln>
+        </p:spPr>
+        <p:style>
+          <a:lnRef idx="1">
+            <a:schemeClr val="accent1"/>
+          </a:lnRef>
+          <a:fillRef idx="0">
+            <a:schemeClr val="accent1"/>
+          </a:fillRef>
+          <a:effectRef idx="0">
+            <a:schemeClr val="accent1"/>
+          </a:effectRef>
+          <a:fontRef idx="minor">
+            <a:schemeClr val="tx1"/>
+          </a:fontRef>
+        </p:style>
+      </p:cxnSp>
+      <p:cxnSp>
+        <p:nvCxnSpPr>
+          <p:cNvPr id="53" name="Gerade Verbindung mit Pfeil 116">
+            <a:extLst>
+              <a:ext uri="{FF2B5EF4-FFF2-40B4-BE49-F238E27FC236}">
+                <a16:creationId xmlns:a16="http://schemas.microsoft.com/office/drawing/2014/main" id="{68090A40-0C56-9665-5D8C-4909AE97B1B9}"/>
+              </a:ext>
+            </a:extLst>
+          </p:cNvPr>
+          <p:cNvCxnSpPr>
+            <a:cxnSpLocks/>
+            <a:stCxn id="41" idx="2"/>
+            <a:endCxn id="81" idx="0"/>
+          </p:cNvCxnSpPr>
+          <p:nvPr/>
+        </p:nvCxnSpPr>
+        <p:spPr>
+          <a:xfrm>
+            <a:off x="6660000" y="4695824"/>
+            <a:ext cx="0" cy="341704"/>
+          </a:xfrm>
+          <a:prstGeom prst="straightConnector1">
+            <a:avLst/>
+          </a:prstGeom>
+          <a:ln w="50800">
+            <a:solidFill>
+              <a:schemeClr val="tx1">
+                <a:alpha val="50000"/>
+              </a:schemeClr>
+            </a:solidFill>
+            <a:prstDash val="solid"/>
+            <a:tailEnd type="triangle"/>
+          </a:ln>
+        </p:spPr>
+        <p:style>
+          <a:lnRef idx="1">
+            <a:schemeClr val="accent1"/>
+          </a:lnRef>
+          <a:fillRef idx="0">
+            <a:schemeClr val="accent1"/>
+          </a:fillRef>
+          <a:effectRef idx="0">
+            <a:schemeClr val="accent1"/>
+          </a:effectRef>
+          <a:fontRef idx="minor">
+            <a:schemeClr val="tx1"/>
+          </a:fontRef>
+        </p:style>
+      </p:cxnSp>
+      <p:cxnSp>
+        <p:nvCxnSpPr>
+          <p:cNvPr id="59" name="Gerade Verbindung mit Pfeil 116">
+            <a:extLst>
+              <a:ext uri="{FF2B5EF4-FFF2-40B4-BE49-F238E27FC236}">
+                <a16:creationId xmlns:a16="http://schemas.microsoft.com/office/drawing/2014/main" id="{FF4DA23A-99B1-2EA7-2BF4-A55BB1B63FEE}"/>
+              </a:ext>
+            </a:extLst>
+          </p:cNvPr>
+          <p:cNvCxnSpPr>
+            <a:cxnSpLocks/>
+            <a:stCxn id="13" idx="3"/>
+            <a:endCxn id="41" idx="1"/>
+          </p:cNvCxnSpPr>
+          <p:nvPr/>
+        </p:nvCxnSpPr>
+        <p:spPr>
+          <a:xfrm>
+            <a:off x="5580000" y="4262024"/>
+            <a:ext cx="360000" cy="0"/>
+          </a:xfrm>
+          <a:prstGeom prst="straightConnector1">
+            <a:avLst/>
+          </a:prstGeom>
+          <a:ln w="50800">
+            <a:solidFill>
+              <a:schemeClr val="tx1">
+                <a:alpha val="50000"/>
+              </a:schemeClr>
+            </a:solidFill>
+            <a:prstDash val="solid"/>
+            <a:tailEnd type="triangle"/>
+          </a:ln>
+        </p:spPr>
+        <p:style>
+          <a:lnRef idx="1">
+            <a:schemeClr val="accent1"/>
+          </a:lnRef>
+          <a:fillRef idx="0">
+            <a:schemeClr val="accent1"/>
+          </a:fillRef>
+          <a:effectRef idx="0">
+            <a:schemeClr val="accent1"/>
+          </a:effectRef>
+          <a:fontRef idx="minor">
+            <a:schemeClr val="tx1"/>
+          </a:fontRef>
+        </p:style>
+      </p:cxnSp>
       <p:grpSp>
         <p:nvGrpSpPr>
           <p:cNvPr id="146" name="Gruppe Raw Data Files"/>
@@ -35667,11 +36451,9 @@
                 <a:alpha val="50000"/>
               </a:schemeClr>
             </a:solidFill>
-            <a:ln>
+            <a:ln w="12700">
               <a:solidFill>
-                <a:schemeClr val="accent2">
-                  <a:lumMod val="50000"/>
-                </a:schemeClr>
+                <a:srgbClr val="002060"/>
               </a:solidFill>
             </a:ln>
           </p:spPr>
@@ -35740,11 +36522,9 @@
             <a:prstGeom prst="line">
               <a:avLst/>
             </a:prstGeom>
-            <a:ln>
+            <a:ln w="12700">
               <a:solidFill>
-                <a:schemeClr val="accent2">
-                  <a:lumMod val="50000"/>
-                </a:schemeClr>
+                <a:srgbClr val="002060"/>
               </a:solidFill>
             </a:ln>
           </p:spPr>
@@ -35785,10 +36565,10 @@
             <p:nvPr/>
           </p:nvPicPr>
           <p:blipFill>
-            <a:blip r:embed="rId14">
+            <a:blip>
               <a:extLst>
                 <a:ext uri="{96DAC541-7B7A-43D3-8B79-37D633B846F1}">
-                  <ns0:svgBlip xmlns:ns0="http://schemas.microsoft.com/office/drawing/2016/SVG/main" r:embed="rId13"/>
+                  <asvg:svgBlip xmlns:asvg="http://schemas.microsoft.com/office/drawing/2016/SVG/main" r:embed="rId3"/>
                 </a:ext>
               </a:extLst>
             </a:blip>
@@ -35844,13 +36624,15 @@
               <a:avLst/>
             </a:prstGeom>
             <a:solidFill>
-              <a:schemeClr val="accent1">
-                <a:alpha val="50000"/>
-              </a:schemeClr>
+              <a:srgbClr val="C60C30">
+                <a:alpha val="20000"/>
+              </a:srgbClr>
             </a:solidFill>
-            <a:ln>
+            <a:ln w="19050">
               <a:solidFill>
-                <a:schemeClr val="accent1"/>
+                <a:schemeClr val="accent1">
+                  <a:lumMod val="50000"/>
+                </a:schemeClr>
               </a:solidFill>
             </a:ln>
           </p:spPr>
@@ -35912,10 +36694,10 @@
             <p:nvPr/>
           </p:nvPicPr>
           <p:blipFill>
-            <a:blip r:embed="rId12">
+            <a:blip>
               <a:extLst>
                 <a:ext uri="{96DAC541-7B7A-43D3-8B79-37D633B846F1}">
-                  <ns1:svgBlip xmlns:ns1="http://schemas.microsoft.com/office/drawing/2016/SVG/main" r:embed="rId11"/>
+                  <asvg:svgBlip xmlns:asvg="http://schemas.microsoft.com/office/drawing/2016/SVG/main" r:embed="rId4"/>
                 </a:ext>
               </a:extLst>
             </a:blip>
@@ -36015,13 +36797,15 @@
               <a:avLst/>
             </a:prstGeom>
             <a:solidFill>
-              <a:schemeClr val="accent5">
-                <a:alpha val="50000"/>
-              </a:schemeClr>
+              <a:srgbClr val="43858A">
+                <a:alpha val="20000"/>
+              </a:srgbClr>
             </a:solidFill>
-            <a:ln>
+            <a:ln w="19050">
               <a:solidFill>
-                <a:schemeClr val="accent5"/>
+                <a:schemeClr val="accent5">
+                  <a:lumMod val="50000"/>
+                </a:schemeClr>
               </a:solidFill>
             </a:ln>
           </p:spPr>
@@ -36083,10 +36867,10 @@
             <p:nvPr/>
           </p:nvPicPr>
           <p:blipFill>
-            <a:blip r:embed="rId10">
+            <a:blip>
               <a:extLst>
                 <a:ext uri="{96DAC541-7B7A-43D3-8B79-37D633B846F1}">
-                  <ns2:svgBlip xmlns:ns2="http://schemas.microsoft.com/office/drawing/2016/SVG/main" r:embed="rId9"/>
+                  <asvg:svgBlip xmlns:asvg="http://schemas.microsoft.com/office/drawing/2016/SVG/main" r:embed="rId5"/>
                 </a:ext>
               </a:extLst>
             </a:blip>
@@ -36256,10 +37040,10 @@
             <p:nvPr/>
           </p:nvPicPr>
           <p:blipFill>
-            <a:blip r:embed="rId8">
+            <a:blip>
               <a:extLst>
                 <a:ext uri="{96DAC541-7B7A-43D3-8B79-37D633B846F1}">
-                  <ns3:svgBlip xmlns:ns3="http://schemas.microsoft.com/office/drawing/2016/SVG/main" r:embed="rId7"/>
+                  <asvg:svgBlip xmlns:asvg="http://schemas.microsoft.com/office/drawing/2016/SVG/main" r:embed="rId6"/>
                 </a:ext>
               </a:extLst>
             </a:blip>
@@ -36491,10 +37275,10 @@
             <p:nvPr/>
           </p:nvPicPr>
           <p:blipFill>
-            <a:blip r:embed="rId6">
+            <a:blip>
               <a:extLst>
                 <a:ext uri="{96DAC541-7B7A-43D3-8B79-37D633B846F1}">
-                  <ns4:svgBlip xmlns:ns4="http://schemas.microsoft.com/office/drawing/2016/SVG/main" r:embed="rId5"/>
+                  <asvg:svgBlip xmlns:asvg="http://schemas.microsoft.com/office/drawing/2016/SVG/main" r:embed="rId7"/>
                 </a:ext>
               </a:extLst>
             </a:blip>
@@ -36620,10 +37404,10 @@
             <p:nvPr/>
           </p:nvPicPr>
           <p:blipFill>
-            <a:blip r:embed="rId4">
+            <a:blip>
               <a:extLst>
                 <a:ext uri="{96DAC541-7B7A-43D3-8B79-37D633B846F1}">
-                  <ns5:svgBlip xmlns:ns5="http://schemas.microsoft.com/office/drawing/2016/SVG/main" r:embed="rId3"/>
+                  <asvg:svgBlip xmlns:asvg="http://schemas.microsoft.com/office/drawing/2016/SVG/main" r:embed="rId8"/>
                 </a:ext>
               </a:extLst>
             </a:blip>
@@ -36801,10 +37585,10 @@
             <p:nvPr/>
           </p:nvPicPr>
           <p:blipFill>
-            <a:blip r:embed="rId41">
+            <a:blip>
               <a:extLst>
                 <a:ext uri="{96DAC541-7B7A-43D3-8B79-37D633B846F1}">
-                  <ns6:svgBlip xmlns:ns6="http://schemas.microsoft.com/office/drawing/2016/SVG/main" r:embed="rId42"/>
+                  <asvg:svgBlip xmlns:asvg="http://schemas.microsoft.com/office/drawing/2016/SVG/main" r:embed="rId9"/>
                 </a:ext>
               </a:extLst>
             </a:blip>
@@ -36982,10 +37766,10 @@
             <p:nvPr/>
           </p:nvPicPr>
           <p:blipFill>
-            <a:blip r:embed="rId43">
+            <a:blip>
               <a:extLst>
                 <a:ext uri="{96DAC541-7B7A-43D3-8B79-37D633B846F1}">
-                  <ns7:svgBlip xmlns:ns7="http://schemas.microsoft.com/office/drawing/2016/SVG/main" r:embed="rId44"/>
+                  <asvg:svgBlip xmlns:asvg="http://schemas.microsoft.com/office/drawing/2016/SVG/main" r:embed="rId10"/>
                 </a:ext>
               </a:extLst>
             </a:blip>
@@ -37163,10 +37947,10 @@
             <p:nvPr/>
           </p:nvPicPr>
           <p:blipFill>
-            <a:blip r:embed="rId45">
+            <a:blip>
               <a:extLst>
                 <a:ext uri="{96DAC541-7B7A-43D3-8B79-37D633B846F1}">
-                  <ns8:svgBlip xmlns:ns8="http://schemas.microsoft.com/office/drawing/2016/SVG/main" r:embed="rId46"/>
+                  <asvg:svgBlip xmlns:asvg="http://schemas.microsoft.com/office/drawing/2016/SVG/main" r:embed="rId11"/>
                 </a:ext>
               </a:extLst>
             </a:blip>
@@ -37348,10 +38132,10 @@
             <p:nvPr/>
           </p:nvPicPr>
           <p:blipFill>
-            <a:blip r:embed="rId47">
+            <a:blip>
               <a:extLst>
                 <a:ext uri="{96DAC541-7B7A-43D3-8B79-37D633B846F1}">
-                  <ns9:svgBlip xmlns:ns9="http://schemas.microsoft.com/office/drawing/2016/SVG/main" r:embed="rId48"/>
+                  <asvg:svgBlip xmlns:asvg="http://schemas.microsoft.com/office/drawing/2016/SVG/main" r:embed="rId12"/>
                 </a:ext>
               </a:extLst>
             </a:blip>
@@ -37420,510 +38204,6 @@
           </p:txBody>
         </p:sp>
       </p:grpSp>
-      <p:cxnSp>
-        <p:nvCxnSpPr>
-          <p:cNvPr id="107" name="Gerade Verbindung mit Pfeil 114">
-            <a:extLst>
-              <a:ext uri="{FF2B5EF4-FFF2-40B4-BE49-F238E27FC236}">
-                <a16:creationId xmlns:a16="http://schemas.microsoft.com/office/drawing/2014/main" id="{C51FF297-FBDC-ECF0-D713-029BB7225127}"/>
-              </a:ext>
-            </a:extLst>
-          </p:cNvPr>
-          <p:cNvCxnSpPr>
-            <a:cxnSpLocks/>
-          </p:cNvCxnSpPr>
-          <p:nvPr/>
-        </p:nvCxnSpPr>
-        <p:spPr>
-          <a:xfrm flipV="1">
-            <a:off x="540000" y="2313687"/>
-            <a:ext cx="1777931" cy="2705162"/>
-          </a:xfrm>
-          <a:prstGeom prst="straightConnector1">
-            <a:avLst/>
-          </a:prstGeom>
-          <a:ln w="0">
-            <a:noFill/>
-            <a:prstDash val="solid"/>
-            <a:tailEnd type="triangle"/>
-          </a:ln>
-        </p:spPr>
-        <p:style>
-          <a:lnRef idx="1">
-            <a:schemeClr val="accent1"/>
-          </a:lnRef>
-          <a:fillRef idx="0">
-            <a:schemeClr val="accent1"/>
-          </a:fillRef>
-          <a:effectRef idx="0">
-            <a:schemeClr val="accent1"/>
-          </a:effectRef>
-          <a:fontRef idx="minor">
-            <a:schemeClr val="tx1"/>
-          </a:fontRef>
-        </p:style>
-      </p:cxnSp>
-      <p:cxnSp>
-        <p:nvCxnSpPr>
-          <p:cNvPr id="108" name="Gerade Verbindung mit Pfeil 116">
-            <a:extLst>
-              <a:ext uri="{FF2B5EF4-FFF2-40B4-BE49-F238E27FC236}">
-                <a16:creationId xmlns:a16="http://schemas.microsoft.com/office/drawing/2014/main" id="{0BDDCE84-4016-2B9D-139E-B6028861F673}"/>
-              </a:ext>
-            </a:extLst>
-          </p:cNvPr>
-          <p:cNvCxnSpPr>
-            <a:cxnSpLocks/>
-            <a:stCxn id="37" idx="0"/>
-            <a:endCxn id="45" idx="2"/>
-          </p:cNvCxnSpPr>
-          <p:nvPr/>
-        </p:nvCxnSpPr>
-        <p:spPr>
-          <a:xfrm flipV="1">
-            <a:off x="1260000" y="3505199"/>
-            <a:ext cx="0" cy="323025"/>
-          </a:xfrm>
-          <a:prstGeom prst="straightConnector1">
-            <a:avLst/>
-          </a:prstGeom>
-          <a:ln w="50800">
-            <a:solidFill>
-              <a:schemeClr val="tx1">
-                <a:alpha val="50000"/>
-              </a:schemeClr>
-            </a:solidFill>
-            <a:prstDash val="solid"/>
-            <a:tailEnd type="triangle"/>
-          </a:ln>
-        </p:spPr>
-        <p:style>
-          <a:lnRef idx="1">
-            <a:schemeClr val="accent1"/>
-          </a:lnRef>
-          <a:fillRef idx="0">
-            <a:schemeClr val="accent1"/>
-          </a:fillRef>
-          <a:effectRef idx="0">
-            <a:schemeClr val="accent1"/>
-          </a:effectRef>
-          <a:fontRef idx="minor">
-            <a:schemeClr val="tx1"/>
-          </a:fontRef>
-        </p:style>
-      </p:cxnSp>
-      <p:cxnSp>
-        <p:nvCxnSpPr>
-          <p:cNvPr id="109" name="Gerade Verbindung mit Pfeil 118">
-            <a:extLst>
-              <a:ext uri="{FF2B5EF4-FFF2-40B4-BE49-F238E27FC236}">
-                <a16:creationId xmlns:a16="http://schemas.microsoft.com/office/drawing/2014/main" id="{0BB315D1-6C56-0674-6B65-3777144E7075}"/>
-              </a:ext>
-            </a:extLst>
-          </p:cNvPr>
-          <p:cNvCxnSpPr>
-            <a:cxnSpLocks/>
-            <a:stCxn id="45" idx="0"/>
-            <a:endCxn id="121" idx="2"/>
-          </p:cNvCxnSpPr>
-          <p:nvPr/>
-        </p:nvCxnSpPr>
-        <p:spPr>
-          <a:xfrm flipV="1">
-            <a:off x="1260000" y="2314574"/>
-            <a:ext cx="0" cy="323025"/>
-          </a:xfrm>
-          <a:prstGeom prst="straightConnector1">
-            <a:avLst/>
-          </a:prstGeom>
-          <a:ln w="50800">
-            <a:solidFill>
-              <a:schemeClr val="tx1">
-                <a:alpha val="50000"/>
-              </a:schemeClr>
-            </a:solidFill>
-            <a:prstDash val="solid"/>
-            <a:tailEnd type="triangle"/>
-          </a:ln>
-        </p:spPr>
-        <p:style>
-          <a:lnRef idx="1">
-            <a:schemeClr val="accent1"/>
-          </a:lnRef>
-          <a:fillRef idx="0">
-            <a:schemeClr val="accent1"/>
-          </a:fillRef>
-          <a:effectRef idx="0">
-            <a:schemeClr val="accent1"/>
-          </a:effectRef>
-          <a:fontRef idx="minor">
-            <a:schemeClr val="tx1"/>
-          </a:fontRef>
-        </p:style>
-      </p:cxnSp>
-      <p:cxnSp>
-        <p:nvCxnSpPr>
-          <p:cNvPr id="110" name="Gerade Verbindung mit Pfeil 131">
-            <a:extLst>
-              <a:ext uri="{FF2B5EF4-FFF2-40B4-BE49-F238E27FC236}">
-                <a16:creationId xmlns:a16="http://schemas.microsoft.com/office/drawing/2014/main" id="{5251572B-350B-C100-8968-FD93BB1542C3}"/>
-              </a:ext>
-            </a:extLst>
-          </p:cNvPr>
-          <p:cNvCxnSpPr>
-            <a:cxnSpLocks/>
-            <a:stCxn id="54" idx="3"/>
-          </p:cNvCxnSpPr>
-          <p:nvPr/>
-        </p:nvCxnSpPr>
-        <p:spPr>
-          <a:xfrm flipH="1">
-            <a:off x="6114751" y="1888058"/>
-            <a:ext cx="1265249" cy="783787"/>
-          </a:xfrm>
-          <a:prstGeom prst="straightConnector1">
-            <a:avLst/>
-          </a:prstGeom>
-          <a:ln w="0">
-            <a:noFill/>
-            <a:prstDash val="solid"/>
-            <a:tailEnd type="triangle"/>
-          </a:ln>
-        </p:spPr>
-        <p:style>
-          <a:lnRef idx="1">
-            <a:schemeClr val="accent1"/>
-          </a:lnRef>
-          <a:fillRef idx="0">
-            <a:schemeClr val="accent1"/>
-          </a:fillRef>
-          <a:effectRef idx="0">
-            <a:schemeClr val="accent1"/>
-          </a:effectRef>
-          <a:fontRef idx="minor">
-            <a:schemeClr val="tx1"/>
-          </a:fontRef>
-        </p:style>
-      </p:cxnSp>
-      <p:cxnSp>
-        <p:nvCxnSpPr>
-          <p:cNvPr id="111" name="Gerade Verbindung mit Pfeil 140">
-            <a:extLst>
-              <a:ext uri="{FF2B5EF4-FFF2-40B4-BE49-F238E27FC236}">
-                <a16:creationId xmlns:a16="http://schemas.microsoft.com/office/drawing/2014/main" id="{E5BD5263-3B5A-0D1D-357B-F50C33F87BA3}"/>
-              </a:ext>
-            </a:extLst>
-          </p:cNvPr>
-          <p:cNvCxnSpPr>
-            <a:cxnSpLocks/>
-          </p:cNvCxnSpPr>
-          <p:nvPr/>
-        </p:nvCxnSpPr>
-        <p:spPr>
-          <a:xfrm flipH="1">
-            <a:off x="6224316" y="5385158"/>
-            <a:ext cx="6013" cy="366749"/>
-          </a:xfrm>
-          <a:prstGeom prst="straightConnector1">
-            <a:avLst/>
-          </a:prstGeom>
-          <a:ln w="0">
-            <a:noFill/>
-            <a:prstDash val="solid"/>
-            <a:tailEnd type="triangle"/>
-          </a:ln>
-        </p:spPr>
-        <p:style>
-          <a:lnRef idx="1">
-            <a:schemeClr val="accent1"/>
-          </a:lnRef>
-          <a:fillRef idx="0">
-            <a:schemeClr val="accent1"/>
-          </a:fillRef>
-          <a:effectRef idx="0">
-            <a:schemeClr val="accent1"/>
-          </a:effectRef>
-          <a:fontRef idx="minor">
-            <a:schemeClr val="tx1"/>
-          </a:fontRef>
-        </p:style>
-      </p:cxnSp>
-      <p:cxnSp>
-        <p:nvCxnSpPr>
-          <p:cNvPr id="112" name="Gerade Verbindung mit Pfeil 143">
-            <a:extLst>
-              <a:ext uri="{FF2B5EF4-FFF2-40B4-BE49-F238E27FC236}">
-                <a16:creationId xmlns:a16="http://schemas.microsoft.com/office/drawing/2014/main" id="{56983D44-8E80-3AB3-A9CF-D7232B3BF542}"/>
-              </a:ext>
-            </a:extLst>
-          </p:cNvPr>
-          <p:cNvCxnSpPr>
-            <a:cxnSpLocks/>
-            <a:stCxn id="81" idx="3"/>
-            <a:endCxn id="102" idx="1"/>
-          </p:cNvCxnSpPr>
-          <p:nvPr/>
-        </p:nvCxnSpPr>
-        <p:spPr>
-          <a:xfrm>
-            <a:off x="7380000" y="5471328"/>
-            <a:ext cx="360000" cy="0"/>
-          </a:xfrm>
-          <a:prstGeom prst="straightConnector1">
-            <a:avLst/>
-          </a:prstGeom>
-          <a:ln w="50800">
-            <a:solidFill>
-              <a:schemeClr val="tx1">
-                <a:alpha val="50000"/>
-              </a:schemeClr>
-            </a:solidFill>
-            <a:prstDash val="solid"/>
-            <a:tailEnd type="triangle"/>
-          </a:ln>
-        </p:spPr>
-        <p:style>
-          <a:lnRef idx="1">
-            <a:schemeClr val="accent1"/>
-          </a:lnRef>
-          <a:fillRef idx="0">
-            <a:schemeClr val="accent1"/>
-          </a:fillRef>
-          <a:effectRef idx="0">
-            <a:schemeClr val="accent1"/>
-          </a:effectRef>
-          <a:fontRef idx="minor">
-            <a:schemeClr val="tx1"/>
-          </a:fontRef>
-        </p:style>
-      </p:cxnSp>
-      <p:cxnSp>
-        <p:nvCxnSpPr>
-          <p:cNvPr id="114" name="Gerade Verbindung mit Pfeil 148">
-            <a:extLst>
-              <a:ext uri="{FF2B5EF4-FFF2-40B4-BE49-F238E27FC236}">
-                <a16:creationId xmlns:a16="http://schemas.microsoft.com/office/drawing/2014/main" id="{F5BC60B3-6D21-34AF-F241-F9DCA2E051D9}"/>
-              </a:ext>
-            </a:extLst>
-          </p:cNvPr>
-          <p:cNvCxnSpPr>
-            <a:cxnSpLocks/>
-            <a:stCxn id="32" idx="1"/>
-            <a:endCxn id="72" idx="3"/>
-          </p:cNvCxnSpPr>
-          <p:nvPr/>
-        </p:nvCxnSpPr>
-        <p:spPr>
-          <a:xfrm flipH="1">
-            <a:off x="7380000" y="3071399"/>
-            <a:ext cx="360000" cy="0"/>
-          </a:xfrm>
-          <a:prstGeom prst="straightConnector1">
-            <a:avLst/>
-          </a:prstGeom>
-          <a:ln w="50800">
-            <a:solidFill>
-              <a:schemeClr val="tx1">
-                <a:alpha val="50000"/>
-              </a:schemeClr>
-            </a:solidFill>
-            <a:prstDash val="solid"/>
-            <a:tailEnd type="triangle"/>
-          </a:ln>
-        </p:spPr>
-        <p:style>
-          <a:lnRef idx="1">
-            <a:schemeClr val="accent1"/>
-          </a:lnRef>
-          <a:fillRef idx="0">
-            <a:schemeClr val="accent1"/>
-          </a:fillRef>
-          <a:effectRef idx="0">
-            <a:schemeClr val="accent1"/>
-          </a:effectRef>
-          <a:fontRef idx="minor">
-            <a:schemeClr val="tx1"/>
-          </a:fontRef>
-        </p:style>
-      </p:cxnSp>
-      <p:cxnSp>
-        <p:nvCxnSpPr>
-          <p:cNvPr id="116" name="Gerade Verbindung mit Pfeil 153">
-            <a:extLst>
-              <a:ext uri="{FF2B5EF4-FFF2-40B4-BE49-F238E27FC236}">
-                <a16:creationId xmlns:a16="http://schemas.microsoft.com/office/drawing/2014/main" id="{D607BF0C-A131-1483-6422-39F2657F50BA}"/>
-              </a:ext>
-            </a:extLst>
-          </p:cNvPr>
-          <p:cNvCxnSpPr>
-            <a:cxnSpLocks/>
-            <a:stCxn id="93" idx="1"/>
-          </p:cNvCxnSpPr>
-          <p:nvPr/>
-        </p:nvCxnSpPr>
-        <p:spPr>
-          <a:xfrm flipH="1">
-            <a:off x="4099016" y="1881188"/>
-            <a:ext cx="3499473" cy="779775"/>
-          </a:xfrm>
-          <a:prstGeom prst="straightConnector1">
-            <a:avLst/>
-          </a:prstGeom>
-          <a:ln w="0">
-            <a:noFill/>
-            <a:prstDash val="solid"/>
-            <a:tailEnd type="triangle"/>
-          </a:ln>
-        </p:spPr>
-        <p:style>
-          <a:lnRef idx="1">
-            <a:schemeClr val="accent1"/>
-          </a:lnRef>
-          <a:fillRef idx="0">
-            <a:schemeClr val="accent1"/>
-          </a:fillRef>
-          <a:effectRef idx="0">
-            <a:schemeClr val="accent1"/>
-          </a:effectRef>
-          <a:fontRef idx="minor">
-            <a:schemeClr val="tx1"/>
-          </a:fontRef>
-        </p:style>
-      </p:cxnSp>
-      <p:cxnSp>
-        <p:nvCxnSpPr>
-          <p:cNvPr id="118" name="Gerade Verbindung mit Pfeil 154">
-            <a:extLst>
-              <a:ext uri="{FF2B5EF4-FFF2-40B4-BE49-F238E27FC236}">
-                <a16:creationId xmlns:a16="http://schemas.microsoft.com/office/drawing/2014/main" id="{834D9059-9B1E-06B1-21DE-CCB1F5E0CF41}"/>
-              </a:ext>
-            </a:extLst>
-          </p:cNvPr>
-          <p:cNvCxnSpPr/>
-          <p:nvPr/>
-        </p:nvCxnSpPr>
-        <p:spPr>
-          <a:xfrm>
-            <a:off x="8589017" y="2278760"/>
-            <a:ext cx="1139991" cy="1310591"/>
-          </a:xfrm>
-          <a:prstGeom prst="straightConnector1">
-            <a:avLst/>
-          </a:prstGeom>
-          <a:ln w="0">
-            <a:noFill/>
-            <a:prstDash val="solid"/>
-            <a:tailEnd type="triangle"/>
-          </a:ln>
-        </p:spPr>
-        <p:style>
-          <a:lnRef idx="1">
-            <a:schemeClr val="accent1"/>
-          </a:lnRef>
-          <a:fillRef idx="0">
-            <a:schemeClr val="accent1"/>
-          </a:fillRef>
-          <a:effectRef idx="0">
-            <a:schemeClr val="accent1"/>
-          </a:effectRef>
-          <a:fontRef idx="minor">
-            <a:schemeClr val="tx1"/>
-          </a:fontRef>
-        </p:style>
-      </p:cxnSp>
-      <p:cxnSp>
-        <p:nvCxnSpPr>
-          <p:cNvPr id="120" name="Gerade Verbindung mit Pfeil 158">
-            <a:extLst>
-              <a:ext uri="{FF2B5EF4-FFF2-40B4-BE49-F238E27FC236}">
-                <a16:creationId xmlns:a16="http://schemas.microsoft.com/office/drawing/2014/main" id="{325B0423-E42C-0888-4607-AF9A76A04358}"/>
-              </a:ext>
-            </a:extLst>
-          </p:cNvPr>
-          <p:cNvCxnSpPr>
-            <a:cxnSpLocks/>
-            <a:stCxn id="18" idx="1"/>
-          </p:cNvCxnSpPr>
-          <p:nvPr/>
-        </p:nvCxnSpPr>
-        <p:spPr>
-          <a:xfrm flipH="1">
-            <a:off x="8699090" y="1883739"/>
-            <a:ext cx="931070" cy="1205366"/>
-          </a:xfrm>
-          <a:prstGeom prst="straightConnector1">
-            <a:avLst/>
-          </a:prstGeom>
-          <a:ln w="0">
-            <a:noFill/>
-            <a:prstDash val="solid"/>
-            <a:tailEnd type="triangle"/>
-          </a:ln>
-        </p:spPr>
-        <p:style>
-          <a:lnRef idx="1">
-            <a:schemeClr val="accent1"/>
-          </a:lnRef>
-          <a:fillRef idx="0">
-            <a:schemeClr val="accent1"/>
-          </a:fillRef>
-          <a:effectRef idx="0">
-            <a:schemeClr val="accent1"/>
-          </a:effectRef>
-          <a:fontRef idx="minor">
-            <a:schemeClr val="tx1"/>
-          </a:fontRef>
-        </p:style>
-      </p:cxnSp>
-      <p:cxnSp>
-        <p:nvCxnSpPr>
-          <p:cNvPr id="125" name="Gerade Verbindung mit Pfeil 175">
-            <a:extLst>
-              <a:ext uri="{FF2B5EF4-FFF2-40B4-BE49-F238E27FC236}">
-                <a16:creationId xmlns:a16="http://schemas.microsoft.com/office/drawing/2014/main" id="{C72D8DE9-33EF-8199-896F-3B4B34E4C33F}"/>
-              </a:ext>
-            </a:extLst>
-          </p:cNvPr>
-          <p:cNvCxnSpPr>
-            <a:cxnSpLocks/>
-            <a:stCxn id="121" idx="3"/>
-            <a:endCxn id="137" idx="1"/>
-          </p:cNvCxnSpPr>
-          <p:nvPr/>
-        </p:nvCxnSpPr>
-        <p:spPr>
-          <a:xfrm flipV="1">
-            <a:off x="1980000" y="1879887"/>
-            <a:ext cx="360000" cy="887"/>
-          </a:xfrm>
-          <a:prstGeom prst="straightConnector1">
-            <a:avLst/>
-          </a:prstGeom>
-          <a:ln w="50800">
-            <a:solidFill>
-              <a:schemeClr val="tx1">
-                <a:alpha val="50000"/>
-              </a:schemeClr>
-            </a:solidFill>
-            <a:prstDash val="solid"/>
-            <a:tailEnd type="triangle"/>
-          </a:ln>
-        </p:spPr>
-        <p:style>
-          <a:lnRef idx="1">
-            <a:schemeClr val="accent1"/>
-          </a:lnRef>
-          <a:fillRef idx="0">
-            <a:schemeClr val="accent1"/>
-          </a:fillRef>
-          <a:effectRef idx="0">
-            <a:schemeClr val="accent1"/>
-          </a:effectRef>
-          <a:fontRef idx="minor">
-            <a:schemeClr val="tx1"/>
-          </a:fontRef>
-        </p:style>
-      </p:cxnSp>
       <p:grpSp>
         <p:nvGrpSpPr>
           <p:cNvPr id="157" name="Gruppe Embedding LLM"/>
@@ -38031,10 +38311,10 @@
             <p:nvPr/>
           </p:nvPicPr>
           <p:blipFill>
-            <a:blip r:embed="rId45">
+            <a:blip>
               <a:extLst>
                 <a:ext uri="{96DAC541-7B7A-43D3-8B79-37D633B846F1}">
-                  <ns10:svgBlip xmlns:ns10="http://schemas.microsoft.com/office/drawing/2016/SVG/main" r:embed="rId46"/>
+                  <asvg:svgBlip xmlns:asvg="http://schemas.microsoft.com/office/drawing/2016/SVG/main" r:embed="rId11"/>
                 </a:ext>
               </a:extLst>
             </a:blip>
@@ -38103,348 +38383,6 @@
           </p:txBody>
         </p:sp>
       </p:grpSp>
-      <p:cxnSp>
-        <p:nvCxnSpPr>
-          <p:cNvPr id="7" name="Gerade Verbindung mit Pfeil 175">
-            <a:extLst>
-              <a:ext uri="{FF2B5EF4-FFF2-40B4-BE49-F238E27FC236}">
-                <a16:creationId xmlns:a16="http://schemas.microsoft.com/office/drawing/2014/main" id="{0D4E258E-510F-CDC1-7824-B97B0D97B16A}"/>
-              </a:ext>
-            </a:extLst>
-          </p:cNvPr>
-          <p:cNvCxnSpPr>
-            <a:cxnSpLocks/>
-            <a:stCxn id="137" idx="3"/>
-            <a:endCxn id="54" idx="1"/>
-          </p:cNvCxnSpPr>
-          <p:nvPr/>
-        </p:nvCxnSpPr>
-        <p:spPr>
-          <a:xfrm>
-            <a:off x="3780000" y="1879887"/>
-            <a:ext cx="2160000" cy="8171"/>
-          </a:xfrm>
-          <a:prstGeom prst="straightConnector1">
-            <a:avLst/>
-          </a:prstGeom>
-          <a:ln w="50800">
-            <a:solidFill>
-              <a:schemeClr val="tx1">
-                <a:alpha val="50000"/>
-              </a:schemeClr>
-            </a:solidFill>
-            <a:prstDash val="solid"/>
-            <a:tailEnd type="triangle"/>
-          </a:ln>
-        </p:spPr>
-        <p:style>
-          <a:lnRef idx="1">
-            <a:schemeClr val="accent1"/>
-          </a:lnRef>
-          <a:fillRef idx="0">
-            <a:schemeClr val="accent1"/>
-          </a:fillRef>
-          <a:effectRef idx="0">
-            <a:schemeClr val="accent1"/>
-          </a:effectRef>
-          <a:fontRef idx="minor">
-            <a:schemeClr val="tx1"/>
-          </a:fontRef>
-        </p:style>
-      </p:cxnSp>
-      <p:cxnSp>
-        <p:nvCxnSpPr>
-          <p:cNvPr id="15" name="Gerade Verbindung mit Pfeil 143">
-            <a:extLst>
-              <a:ext uri="{FF2B5EF4-FFF2-40B4-BE49-F238E27FC236}">
-                <a16:creationId xmlns:a16="http://schemas.microsoft.com/office/drawing/2014/main" id="{A1A5E8C3-3F80-9A63-9DF4-CD841A9DCB7A}"/>
-              </a:ext>
-            </a:extLst>
-          </p:cNvPr>
-          <p:cNvCxnSpPr>
-            <a:cxnSpLocks/>
-            <a:stCxn id="102" idx="3"/>
-            <a:endCxn id="24" idx="1"/>
-          </p:cNvCxnSpPr>
-          <p:nvPr/>
-        </p:nvCxnSpPr>
-        <p:spPr>
-          <a:xfrm flipV="1">
-            <a:off x="9180000" y="5461803"/>
-            <a:ext cx="360000" cy="9525"/>
-          </a:xfrm>
-          <a:prstGeom prst="straightConnector1">
-            <a:avLst/>
-          </a:prstGeom>
-          <a:ln w="50800">
-            <a:solidFill>
-              <a:schemeClr val="tx1">
-                <a:alpha val="50000"/>
-              </a:schemeClr>
-            </a:solidFill>
-            <a:prstDash val="solid"/>
-            <a:tailEnd type="triangle"/>
-          </a:ln>
-        </p:spPr>
-        <p:style>
-          <a:lnRef idx="1">
-            <a:schemeClr val="accent1"/>
-          </a:lnRef>
-          <a:fillRef idx="0">
-            <a:schemeClr val="accent1"/>
-          </a:fillRef>
-          <a:effectRef idx="0">
-            <a:schemeClr val="accent1"/>
-          </a:effectRef>
-          <a:fontRef idx="minor">
-            <a:schemeClr val="tx1"/>
-          </a:fontRef>
-        </p:style>
-      </p:cxnSp>
-      <p:cxnSp>
-        <p:nvCxnSpPr>
-          <p:cNvPr id="26" name="Gerade Verbindung mit Pfeil 116">
-            <a:extLst>
-              <a:ext uri="{FF2B5EF4-FFF2-40B4-BE49-F238E27FC236}">
-                <a16:creationId xmlns:a16="http://schemas.microsoft.com/office/drawing/2014/main" id="{02CDE7FC-A0D5-07F3-2CE6-481F9220CCFB}"/>
-              </a:ext>
-            </a:extLst>
-          </p:cNvPr>
-          <p:cNvCxnSpPr>
-            <a:cxnSpLocks/>
-            <a:stCxn id="10" idx="0"/>
-            <a:endCxn id="37" idx="2"/>
-          </p:cNvCxnSpPr>
-          <p:nvPr/>
-        </p:nvCxnSpPr>
-        <p:spPr>
-          <a:xfrm flipV="1">
-            <a:off x="1260000" y="4695824"/>
-            <a:ext cx="0" cy="323025"/>
-          </a:xfrm>
-          <a:prstGeom prst="straightConnector1">
-            <a:avLst/>
-          </a:prstGeom>
-          <a:ln w="50800">
-            <a:solidFill>
-              <a:schemeClr val="tx1">
-                <a:alpha val="50000"/>
-              </a:schemeClr>
-            </a:solidFill>
-            <a:prstDash val="solid"/>
-            <a:tailEnd type="triangle"/>
-          </a:ln>
-        </p:spPr>
-        <p:style>
-          <a:lnRef idx="1">
-            <a:schemeClr val="accent1"/>
-          </a:lnRef>
-          <a:fillRef idx="0">
-            <a:schemeClr val="accent1"/>
-          </a:fillRef>
-          <a:effectRef idx="0">
-            <a:schemeClr val="accent1"/>
-          </a:effectRef>
-          <a:fontRef idx="minor">
-            <a:schemeClr val="tx1"/>
-          </a:fontRef>
-        </p:style>
-      </p:cxnSp>
-      <p:cxnSp>
-        <p:nvCxnSpPr>
-          <p:cNvPr id="30" name="Gerade Verbindung mit Pfeil 116">
-            <a:extLst>
-              <a:ext uri="{FF2B5EF4-FFF2-40B4-BE49-F238E27FC236}">
-                <a16:creationId xmlns:a16="http://schemas.microsoft.com/office/drawing/2014/main" id="{F834C3E5-D35F-44C7-AEE0-6AEAEACA36B4}"/>
-              </a:ext>
-            </a:extLst>
-          </p:cNvPr>
-          <p:cNvCxnSpPr>
-            <a:cxnSpLocks/>
-            <a:stCxn id="18" idx="1"/>
-            <a:endCxn id="93" idx="3"/>
-          </p:cNvCxnSpPr>
-          <p:nvPr/>
-        </p:nvCxnSpPr>
-        <p:spPr>
-          <a:xfrm flipH="1" flipV="1">
-            <a:off x="9180000" y="1880774"/>
-            <a:ext cx="360000" cy="2551"/>
-          </a:xfrm>
-          <a:prstGeom prst="straightConnector1">
-            <a:avLst/>
-          </a:prstGeom>
-          <a:ln w="50800">
-            <a:solidFill>
-              <a:schemeClr val="tx1">
-                <a:alpha val="50000"/>
-              </a:schemeClr>
-            </a:solidFill>
-            <a:prstDash val="solid"/>
-            <a:tailEnd type="triangle"/>
-          </a:ln>
-        </p:spPr>
-        <p:style>
-          <a:lnRef idx="1">
-            <a:schemeClr val="accent1"/>
-          </a:lnRef>
-          <a:fillRef idx="0">
-            <a:schemeClr val="accent1"/>
-          </a:fillRef>
-          <a:effectRef idx="0">
-            <a:schemeClr val="accent1"/>
-          </a:effectRef>
-          <a:fontRef idx="minor">
-            <a:schemeClr val="tx1"/>
-          </a:fontRef>
-        </p:style>
-      </p:cxnSp>
-      <p:cxnSp>
-        <p:nvCxnSpPr>
-          <p:cNvPr id="34" name="Gerade Verbindung mit Pfeil 116">
-            <a:extLst>
-              <a:ext uri="{FF2B5EF4-FFF2-40B4-BE49-F238E27FC236}">
-                <a16:creationId xmlns:a16="http://schemas.microsoft.com/office/drawing/2014/main" id="{AAD4A9FA-5DEA-3E74-98D7-E03DAAF937A5}"/>
-              </a:ext>
-            </a:extLst>
-          </p:cNvPr>
-          <p:cNvCxnSpPr>
-            <a:cxnSpLocks/>
-            <a:stCxn id="93" idx="2"/>
-            <a:endCxn id="32" idx="0"/>
-          </p:cNvCxnSpPr>
-          <p:nvPr/>
-        </p:nvCxnSpPr>
-        <p:spPr>
-          <a:xfrm>
-            <a:off x="8460000" y="2314574"/>
-            <a:ext cx="0" cy="323025"/>
-          </a:xfrm>
-          <a:prstGeom prst="straightConnector1">
-            <a:avLst/>
-          </a:prstGeom>
-          <a:ln w="50800">
-            <a:solidFill>
-              <a:schemeClr val="tx1">
-                <a:alpha val="50000"/>
-              </a:schemeClr>
-            </a:solidFill>
-            <a:prstDash val="solid"/>
-            <a:tailEnd type="triangle"/>
-          </a:ln>
-        </p:spPr>
-        <p:style>
-          <a:lnRef idx="1">
-            <a:schemeClr val="accent1"/>
-          </a:lnRef>
-          <a:fillRef idx="0">
-            <a:schemeClr val="accent1"/>
-          </a:fillRef>
-          <a:effectRef idx="0">
-            <a:schemeClr val="accent1"/>
-          </a:effectRef>
-          <a:fontRef idx="minor">
-            <a:schemeClr val="tx1"/>
-          </a:fontRef>
-        </p:style>
-      </p:cxnSp>
-      <p:cxnSp>
-        <p:nvCxnSpPr>
-          <p:cNvPr id="38" name="Gerade Verbindung mit Pfeil 116">
-            <a:extLst>
-              <a:ext uri="{FF2B5EF4-FFF2-40B4-BE49-F238E27FC236}">
-                <a16:creationId xmlns:a16="http://schemas.microsoft.com/office/drawing/2014/main" id="{BBC39D6B-1A7E-43A7-AB4C-507B2811AD74}"/>
-              </a:ext>
-            </a:extLst>
-          </p:cNvPr>
-          <p:cNvCxnSpPr>
-            <a:cxnSpLocks/>
-            <a:endCxn id="72" idx="0"/>
-          </p:cNvCxnSpPr>
-          <p:nvPr/>
-        </p:nvCxnSpPr>
-        <p:spPr>
-          <a:xfrm>
-            <a:off x="6647379" y="2321858"/>
-            <a:ext cx="12621" cy="315741"/>
-          </a:xfrm>
-          <a:prstGeom prst="straightConnector1">
-            <a:avLst/>
-          </a:prstGeom>
-          <a:ln w="50800">
-            <a:solidFill>
-              <a:schemeClr val="tx1">
-                <a:alpha val="50000"/>
-              </a:schemeClr>
-            </a:solidFill>
-            <a:prstDash val="solid"/>
-            <a:tailEnd type="triangle"/>
-          </a:ln>
-        </p:spPr>
-        <p:style>
-          <a:lnRef idx="1">
-            <a:schemeClr val="accent1"/>
-          </a:lnRef>
-          <a:fillRef idx="0">
-            <a:schemeClr val="accent1"/>
-          </a:fillRef>
-          <a:effectRef idx="0">
-            <a:schemeClr val="accent1"/>
-          </a:effectRef>
-          <a:fontRef idx="minor">
-            <a:schemeClr val="tx1"/>
-          </a:fontRef>
-        </p:style>
-      </p:cxnSp>
-      <p:cxnSp>
-        <p:nvCxnSpPr>
-          <p:cNvPr id="49" name="Gerade Verbindung mit Pfeil 116">
-            <a:extLst>
-              <a:ext uri="{FF2B5EF4-FFF2-40B4-BE49-F238E27FC236}">
-                <a16:creationId xmlns:a16="http://schemas.microsoft.com/office/drawing/2014/main" id="{95BD79AE-8E27-C417-44A9-1DA30BB87BB2}"/>
-              </a:ext>
-            </a:extLst>
-          </p:cNvPr>
-          <p:cNvCxnSpPr>
-            <a:cxnSpLocks/>
-            <a:stCxn id="72" idx="2"/>
-            <a:endCxn id="41" idx="0"/>
-          </p:cNvCxnSpPr>
-          <p:nvPr/>
-        </p:nvCxnSpPr>
-        <p:spPr>
-          <a:xfrm>
-            <a:off x="6660000" y="3505199"/>
-            <a:ext cx="0" cy="323025"/>
-          </a:xfrm>
-          <a:prstGeom prst="straightConnector1">
-            <a:avLst/>
-          </a:prstGeom>
-          <a:ln w="50800">
-            <a:solidFill>
-              <a:schemeClr val="tx1">
-                <a:alpha val="50000"/>
-              </a:schemeClr>
-            </a:solidFill>
-            <a:prstDash val="solid"/>
-            <a:tailEnd type="triangle"/>
-          </a:ln>
-        </p:spPr>
-        <p:style>
-          <a:lnRef idx="1">
-            <a:schemeClr val="accent1"/>
-          </a:lnRef>
-          <a:fillRef idx="0">
-            <a:schemeClr val="accent1"/>
-          </a:fillRef>
-          <a:effectRef idx="0">
-            <a:schemeClr val="accent1"/>
-          </a:effectRef>
-          <a:fontRef idx="minor">
-            <a:schemeClr val="tx1"/>
-          </a:fontRef>
-        </p:style>
-      </p:cxnSp>
       <p:grpSp>
         <p:nvGrpSpPr>
           <p:cNvPr id="158" name="Gruppe Chunks"/>
@@ -38552,10 +38490,10 @@
             <p:nvPr/>
           </p:nvPicPr>
           <p:blipFill>
-            <a:blip r:embed="rId6">
+            <a:blip>
               <a:extLst>
                 <a:ext uri="{96DAC541-7B7A-43D3-8B79-37D633B846F1}">
-                  <ns11:svgBlip xmlns:ns11="http://schemas.microsoft.com/office/drawing/2016/SVG/main" r:embed="rId5"/>
+                  <asvg:svgBlip xmlns:asvg="http://schemas.microsoft.com/office/drawing/2016/SVG/main" r:embed="rId7"/>
                 </a:ext>
               </a:extLst>
             </a:blip>
@@ -38737,10 +38675,10 @@
             <p:nvPr/>
           </p:nvPicPr>
           <p:blipFill>
-            <a:blip r:embed="rId4">
+            <a:blip>
               <a:extLst>
                 <a:ext uri="{96DAC541-7B7A-43D3-8B79-37D633B846F1}">
-                  <ns12:svgBlip xmlns:ns12="http://schemas.microsoft.com/office/drawing/2016/SVG/main" r:embed="rId3"/>
+                  <asvg:svgBlip xmlns:asvg="http://schemas.microsoft.com/office/drawing/2016/SVG/main" r:embed="rId8"/>
                 </a:ext>
               </a:extLst>
             </a:blip>
@@ -38860,9 +38798,11 @@
                 <a:alpha val="50000"/>
               </a:schemeClr>
             </a:solidFill>
-            <a:ln>
+            <a:ln w="12700">
               <a:solidFill>
-                <a:srgbClr val="FFC000"/>
+                <a:schemeClr val="accent6">
+                  <a:lumMod val="75000"/>
+                </a:schemeClr>
               </a:solidFill>
             </a:ln>
           </p:spPr>
@@ -38924,10 +38864,10 @@
             <p:nvPr/>
           </p:nvPicPr>
           <p:blipFill>
-            <a:blip r:embed="rId49">
+            <a:blip>
               <a:extLst>
                 <a:ext uri="{96DAC541-7B7A-43D3-8B79-37D633B846F1}">
-                  <ns13:svgBlip xmlns:ns13="http://schemas.microsoft.com/office/drawing/2016/SVG/main" r:embed="rId50"/>
+                  <asvg:svgBlip xmlns:asvg="http://schemas.microsoft.com/office/drawing/2016/SVG/main" r:embed="rId13"/>
                 </a:ext>
               </a:extLst>
             </a:blip>
@@ -38967,9 +38907,11 @@
             <a:prstGeom prst="line">
               <a:avLst/>
             </a:prstGeom>
-            <a:ln>
+            <a:ln w="12700">
               <a:solidFill>
-                <a:srgbClr val="FA9400"/>
+                <a:schemeClr val="accent6">
+                  <a:lumMod val="75000"/>
+                </a:schemeClr>
               </a:solidFill>
             </a:ln>
           </p:spPr>
@@ -38996,55 +38938,6 @@
           </p:txBody>
         </p:sp>
       </p:grpSp>
-      <p:cxnSp>
-        <p:nvCxnSpPr>
-          <p:cNvPr id="43" name="Gerade Verbindung mit Pfeil 116">
-            <a:extLst>
-              <a:ext uri="{FF2B5EF4-FFF2-40B4-BE49-F238E27FC236}">
-                <a16:creationId xmlns:a16="http://schemas.microsoft.com/office/drawing/2014/main" id="{3BE2586C-9C1C-363F-5145-8C1A7F21DECA}"/>
-              </a:ext>
-            </a:extLst>
-          </p:cNvPr>
-          <p:cNvCxnSpPr>
-            <a:cxnSpLocks/>
-            <a:stCxn id="37" idx="3"/>
-            <a:endCxn id="25" idx="1"/>
-          </p:cNvCxnSpPr>
-          <p:nvPr/>
-        </p:nvCxnSpPr>
-        <p:spPr>
-          <a:xfrm>
-            <a:off x="1980000" y="4262024"/>
-            <a:ext cx="360000" cy="0"/>
-          </a:xfrm>
-          <a:prstGeom prst="straightConnector1">
-            <a:avLst/>
-          </a:prstGeom>
-          <a:ln w="50800">
-            <a:solidFill>
-              <a:schemeClr val="tx1">
-                <a:alpha val="50000"/>
-              </a:schemeClr>
-            </a:solidFill>
-            <a:prstDash val="solid"/>
-            <a:tailEnd type="triangle"/>
-          </a:ln>
-        </p:spPr>
-        <p:style>
-          <a:lnRef idx="1">
-            <a:schemeClr val="accent1"/>
-          </a:lnRef>
-          <a:fillRef idx="0">
-            <a:schemeClr val="accent1"/>
-          </a:fillRef>
-          <a:effectRef idx="0">
-            <a:schemeClr val="accent1"/>
-          </a:effectRef>
-          <a:fontRef idx="minor">
-            <a:schemeClr val="tx1"/>
-          </a:fontRef>
-        </p:style>
-      </p:cxnSp>
       <p:grpSp>
         <p:nvGrpSpPr>
           <p:cNvPr id="12" name="Gruppe Vector Database">
@@ -39092,10 +38985,10 @@
                 <a:alpha val="50000"/>
               </a:schemeClr>
             </a:solidFill>
-            <a:ln>
+            <a:ln w="12700">
               <a:solidFill>
                 <a:schemeClr val="bg2">
-                  <a:lumMod val="50000"/>
+                  <a:lumMod val="25000"/>
                 </a:schemeClr>
               </a:solidFill>
             </a:ln>
@@ -39158,10 +39051,10 @@
             <p:nvPr/>
           </p:nvPicPr>
           <p:blipFill>
-            <a:blip r:embed="rId51">
+            <a:blip>
               <a:extLst>
                 <a:ext uri="{96DAC541-7B7A-43D3-8B79-37D633B846F1}">
-                  <ns14:svgBlip xmlns:ns14="http://schemas.microsoft.com/office/drawing/2016/SVG/main" r:embed="rId52"/>
+                  <asvg:svgBlip xmlns:asvg="http://schemas.microsoft.com/office/drawing/2016/SVG/main" r:embed="rId14"/>
                 </a:ext>
               </a:extLst>
             </a:blip>
@@ -39201,10 +39094,10 @@
             <a:prstGeom prst="line">
               <a:avLst/>
             </a:prstGeom>
-            <a:ln>
+            <a:ln w="12700">
               <a:solidFill>
                 <a:schemeClr val="bg2">
-                  <a:lumMod val="50000"/>
+                  <a:lumMod val="25000"/>
                 </a:schemeClr>
               </a:solidFill>
             </a:ln>
@@ -39232,55 +39125,6 @@
           </p:txBody>
         </p:sp>
       </p:grpSp>
-      <p:cxnSp>
-        <p:nvCxnSpPr>
-          <p:cNvPr id="21" name="Gerade Verbindung mit Pfeil 116">
-            <a:extLst>
-              <a:ext uri="{FF2B5EF4-FFF2-40B4-BE49-F238E27FC236}">
-                <a16:creationId xmlns:a16="http://schemas.microsoft.com/office/drawing/2014/main" id="{25C8CBDB-7E9A-B6BE-F8EC-E9E9D7622066}"/>
-              </a:ext>
-            </a:extLst>
-          </p:cNvPr>
-          <p:cNvCxnSpPr>
-            <a:cxnSpLocks/>
-            <a:stCxn id="25" idx="3"/>
-            <a:endCxn id="13" idx="1"/>
-          </p:cNvCxnSpPr>
-          <p:nvPr/>
-        </p:nvCxnSpPr>
-        <p:spPr>
-          <a:xfrm>
-            <a:off x="3780000" y="4262024"/>
-            <a:ext cx="360000" cy="0"/>
-          </a:xfrm>
-          <a:prstGeom prst="straightConnector1">
-            <a:avLst/>
-          </a:prstGeom>
-          <a:ln w="50800">
-            <a:solidFill>
-              <a:schemeClr val="tx1">
-                <a:alpha val="50000"/>
-              </a:schemeClr>
-            </a:solidFill>
-            <a:prstDash val="solid"/>
-            <a:tailEnd type="triangle"/>
-          </a:ln>
-        </p:spPr>
-        <p:style>
-          <a:lnRef idx="1">
-            <a:schemeClr val="accent1"/>
-          </a:lnRef>
-          <a:fillRef idx="0">
-            <a:schemeClr val="accent1"/>
-          </a:fillRef>
-          <a:effectRef idx="0">
-            <a:schemeClr val="accent1"/>
-          </a:effectRef>
-          <a:fontRef idx="minor">
-            <a:schemeClr val="tx1"/>
-          </a:fontRef>
-        </p:style>
-      </p:cxnSp>
       <p:grpSp>
         <p:nvGrpSpPr>
           <p:cNvPr id="40" name="Gruppe Embedding LLM">
@@ -39394,10 +39238,10 @@
             <p:nvPr/>
           </p:nvPicPr>
           <p:blipFill>
-            <a:blip r:embed="rId53">
+            <a:blip>
               <a:extLst>
                 <a:ext uri="{96DAC541-7B7A-43D3-8B79-37D633B846F1}">
-                  <ns15:svgBlip xmlns:ns15="http://schemas.microsoft.com/office/drawing/2016/SVG/main" r:embed="rId54"/>
+                  <asvg:svgBlip xmlns:asvg="http://schemas.microsoft.com/office/drawing/2016/SVG/main" r:embed="rId15"/>
                 </a:ext>
               </a:extLst>
             </a:blip>
@@ -39466,104 +39310,6 @@
           </p:txBody>
         </p:sp>
       </p:grpSp>
-      <p:cxnSp>
-        <p:nvCxnSpPr>
-          <p:cNvPr id="53" name="Gerade Verbindung mit Pfeil 116">
-            <a:extLst>
-              <a:ext uri="{FF2B5EF4-FFF2-40B4-BE49-F238E27FC236}">
-                <a16:creationId xmlns:a16="http://schemas.microsoft.com/office/drawing/2014/main" id="{68090A40-0C56-9665-5D8C-4909AE97B1B9}"/>
-              </a:ext>
-            </a:extLst>
-          </p:cNvPr>
-          <p:cNvCxnSpPr>
-            <a:cxnSpLocks/>
-            <a:stCxn id="41" idx="2"/>
-            <a:endCxn id="81" idx="0"/>
-          </p:cNvCxnSpPr>
-          <p:nvPr/>
-        </p:nvCxnSpPr>
-        <p:spPr>
-          <a:xfrm>
-            <a:off x="6660000" y="4695824"/>
-            <a:ext cx="0" cy="341704"/>
-          </a:xfrm>
-          <a:prstGeom prst="straightConnector1">
-            <a:avLst/>
-          </a:prstGeom>
-          <a:ln w="50800">
-            <a:solidFill>
-              <a:schemeClr val="tx1">
-                <a:alpha val="50000"/>
-              </a:schemeClr>
-            </a:solidFill>
-            <a:prstDash val="solid"/>
-            <a:tailEnd type="triangle"/>
-          </a:ln>
-        </p:spPr>
-        <p:style>
-          <a:lnRef idx="1">
-            <a:schemeClr val="accent1"/>
-          </a:lnRef>
-          <a:fillRef idx="0">
-            <a:schemeClr val="accent1"/>
-          </a:fillRef>
-          <a:effectRef idx="0">
-            <a:schemeClr val="accent1"/>
-          </a:effectRef>
-          <a:fontRef idx="minor">
-            <a:schemeClr val="tx1"/>
-          </a:fontRef>
-        </p:style>
-      </p:cxnSp>
-      <p:cxnSp>
-        <p:nvCxnSpPr>
-          <p:cNvPr id="59" name="Gerade Verbindung mit Pfeil 116">
-            <a:extLst>
-              <a:ext uri="{FF2B5EF4-FFF2-40B4-BE49-F238E27FC236}">
-                <a16:creationId xmlns:a16="http://schemas.microsoft.com/office/drawing/2014/main" id="{FF4DA23A-99B1-2EA7-2BF4-A55BB1B63FEE}"/>
-              </a:ext>
-            </a:extLst>
-          </p:cNvPr>
-          <p:cNvCxnSpPr>
-            <a:cxnSpLocks/>
-            <a:stCxn id="13" idx="3"/>
-            <a:endCxn id="41" idx="1"/>
-          </p:cNvCxnSpPr>
-          <p:nvPr/>
-        </p:nvCxnSpPr>
-        <p:spPr>
-          <a:xfrm>
-            <a:off x="5580000" y="4262024"/>
-            <a:ext cx="360000" cy="0"/>
-          </a:xfrm>
-          <a:prstGeom prst="straightConnector1">
-            <a:avLst/>
-          </a:prstGeom>
-          <a:ln w="50800">
-            <a:solidFill>
-              <a:schemeClr val="tx1">
-                <a:alpha val="50000"/>
-              </a:schemeClr>
-            </a:solidFill>
-            <a:prstDash val="solid"/>
-            <a:tailEnd type="triangle"/>
-          </a:ln>
-        </p:spPr>
-        <p:style>
-          <a:lnRef idx="1">
-            <a:schemeClr val="accent1"/>
-          </a:lnRef>
-          <a:fillRef idx="0">
-            <a:schemeClr val="accent1"/>
-          </a:fillRef>
-          <a:effectRef idx="0">
-            <a:schemeClr val="accent1"/>
-          </a:effectRef>
-          <a:fontRef idx="minor">
-            <a:schemeClr val="tx1"/>
-          </a:fontRef>
-        </p:style>
-      </p:cxnSp>
     </p:spTree>
     <p:extLst>
       <p:ext uri="{BB962C8B-B14F-4D97-AF65-F5344CB8AC3E}">
@@ -39684,7 +39430,7 @@
             <a:fld id="{1EB7C1D4-D1F3-40CB-8780-B2B6A9133392}" type="datetime1">
               <a:rPr lang="de-DE"/>
               <a:pPr/>
-              <a:t>07.08.2026</a:t>
+              <a:t>08.08.2026</a:t>
             </a:fld>
             <a:endParaRPr lang="de-DE" dirty="0"/>
           </a:p>
@@ -41449,7 +41195,7 @@
           <a:p>
             <a:fld id="{E668D7D0-CB17-47D3-88E8-EDADFD5EAF7A}" type="datetime1">
               <a:rPr lang="de-CH" smtClean="0"/>
-              <a:t>07.08.2026</a:t>
+              <a:t>08.08.2026</a:t>
             </a:fld>
             <a:endParaRPr lang="de-CH" dirty="0"/>
           </a:p>
@@ -42594,6 +42340,15 @@
 </file>
 
 <file path=customXml/item2.xml><?xml version="1.0" encoding="utf-8"?>
+<?mso-contentType ?>
+<FormTemplates xmlns="http://schemas.microsoft.com/sharepoint/v3/contenttype/forms">
+  <Display>DocumentLibraryForm</Display>
+  <Edit>DocumentLibraryForm</Edit>
+  <New>DocumentLibraryForm</New>
+</FormTemplates>
+</file>
+
+<file path=customXml/item3.xml><?xml version="1.0" encoding="utf-8"?>
 <p:properties xmlns:p="http://schemas.microsoft.com/office/2006/metadata/properties" xmlns:xsi="http://www.w3.org/2001/XMLSchema-instance" xmlns:pc="http://schemas.microsoft.com/office/infopath/2007/PartnerControls">
   <documentManagement>
     <lcf76f155ced4ddcb4097134ff3c332f xmlns="501edefc-5b9b-422a-9450-cf7f1f30e3fa">
@@ -42602,15 +42357,6 @@
     <TaxCatchAll xmlns="3083c7a9-d95a-44c4-8fb8-f93b125494d6" xsi:nil="true"/>
   </documentManagement>
 </p:properties>
-</file>
-
-<file path=customXml/item3.xml><?xml version="1.0" encoding="utf-8"?>
-<?mso-contentType ?>
-<FormTemplates xmlns="http://schemas.microsoft.com/sharepoint/v3/contenttype/forms">
-  <Display>DocumentLibraryForm</Display>
-  <Edit>DocumentLibraryForm</Edit>
-  <New>DocumentLibraryForm</New>
-</FormTemplates>
 </file>
 
 <file path=customXml/itemProps1.xml><?xml version="1.0" encoding="utf-8"?>
@@ -42633,6 +42379,14 @@
 </file>
 
 <file path=customXml/itemProps2.xml><?xml version="1.0" encoding="utf-8"?>
+<ds:datastoreItem xmlns:ds="http://schemas.openxmlformats.org/officeDocument/2006/customXml" ds:itemID="{334436CE-240F-4EE4-9FC5-4255E6874223}">
+  <ds:schemaRefs>
+    <ds:schemaRef ds:uri="http://schemas.microsoft.com/sharepoint/v3/contenttype/forms"/>
+  </ds:schemaRefs>
+</ds:datastoreItem>
+</file>
+
+<file path=customXml/itemProps3.xml><?xml version="1.0" encoding="utf-8"?>
 <ds:datastoreItem xmlns:ds="http://schemas.openxmlformats.org/officeDocument/2006/customXml" ds:itemID="{6302A1CC-4AEF-4830-BB1C-A446161EB02D}">
   <ds:schemaRefs>
     <ds:schemaRef ds:uri="http://schemas.microsoft.com/office/2006/metadata/properties"/>
@@ -42647,14 +42401,6 @@
 </ds:datastoreItem>
 </file>
 
-<file path=customXml/itemProps3.xml><?xml version="1.0" encoding="utf-8"?>
-<ds:datastoreItem xmlns:ds="http://schemas.openxmlformats.org/officeDocument/2006/customXml" ds:itemID="{334436CE-240F-4EE4-9FC5-4255E6874223}">
-  <ds:schemaRefs>
-    <ds:schemaRef ds:uri="http://schemas.microsoft.com/sharepoint/v3/contenttype/forms"/>
-  </ds:schemaRefs>
-</ds:datastoreItem>
-</file>
-
 <file path=docMetadata/LabelInfo.xml><?xml version="1.0" encoding="utf-8"?>
 <clbl:labelList xmlns:clbl="http://schemas.microsoft.com/office/2020/mipLabelMetadata">
   <clbl:label id="{42e461c6-591f-4920-9cf0-f1389542f8ad}" enabled="1" method="Standard" siteId="{2cda5d11-f0ac-46b3-967d-af1b2e1bd01a}" contentBits="2" removed="0"/>

</xml_diff>

<commit_message>
Unify slide-7 line styles, rename groups, 50% white icon tiles
Border and divider of every box now follow the user-formatted family
templates: 1 pt width, divider matches the border color (blue #002060,
yellow accent6 75%, gray bg2 25%; Query/Response analogously in their
own hue). All groups are renamed to "Gruppe <box title>". Icon tiles
get a 50% transparent white background and are re-embedded.

Co-Authored-By: Claude Fable 5 <noreply@anthropic.com>
Claude-Session: https://claude.ai/code/session_01S2kGP2buE2HmxMttD3XczR
</commit_message>
<xml_diff>
--- a/RAG_Workshop.pptx
+++ b/RAG_Workshop.pptx
@@ -36565,10 +36565,10 @@
             <p:nvPr/>
           </p:nvPicPr>
           <p:blipFill>
-            <a:blip>
+            <a:blip r:embed="rId16">
               <a:extLst>
                 <a:ext uri="{96DAC541-7B7A-43D3-8B79-37D633B846F1}">
-                  <asvg:svgBlip xmlns:asvg="http://schemas.microsoft.com/office/drawing/2016/SVG/main" r:embed="rId3"/>
+                  <ns0:svgBlip xmlns:ns0="http://schemas.microsoft.com/office/drawing/2016/SVG/main" r:embed="rId17"/>
                 </a:ext>
               </a:extLst>
             </a:blip>
@@ -36628,7 +36628,7 @@
                 <a:alpha val="20000"/>
               </a:srgbClr>
             </a:solidFill>
-            <a:ln w="19050">
+            <a:ln w="12700">
               <a:solidFill>
                 <a:schemeClr val="accent1">
                   <a:lumMod val="50000"/>
@@ -36694,10 +36694,10 @@
             <p:nvPr/>
           </p:nvPicPr>
           <p:blipFill>
-            <a:blip>
+            <a:blip r:embed="rId18">
               <a:extLst>
                 <a:ext uri="{96DAC541-7B7A-43D3-8B79-37D633B846F1}">
-                  <asvg:svgBlip xmlns:asvg="http://schemas.microsoft.com/office/drawing/2016/SVG/main" r:embed="rId4"/>
+                  <ns1:svgBlip xmlns:ns1="http://schemas.microsoft.com/office/drawing/2016/SVG/main" r:embed="rId19"/>
                 </a:ext>
               </a:extLst>
             </a:blip>
@@ -36731,9 +36731,11 @@
             <a:prstGeom prst="line">
               <a:avLst/>
             </a:prstGeom>
-            <a:ln>
+            <a:ln w="12700">
               <a:solidFill>
-                <a:schemeClr val="accent1"/>
+                <a:schemeClr val="accent1">
+                  <a:lumMod val="50000"/>
+                </a:schemeClr>
               </a:solidFill>
             </a:ln>
           </p:spPr>
@@ -36801,7 +36803,7 @@
                 <a:alpha val="20000"/>
               </a:srgbClr>
             </a:solidFill>
-            <a:ln w="19050">
+            <a:ln w="12700">
               <a:solidFill>
                 <a:schemeClr val="accent5">
                   <a:lumMod val="50000"/>
@@ -36867,10 +36869,10 @@
             <p:nvPr/>
           </p:nvPicPr>
           <p:blipFill>
-            <a:blip>
+            <a:blip r:embed="rId20">
               <a:extLst>
                 <a:ext uri="{96DAC541-7B7A-43D3-8B79-37D633B846F1}">
-                  <asvg:svgBlip xmlns:asvg="http://schemas.microsoft.com/office/drawing/2016/SVG/main" r:embed="rId5"/>
+                  <ns2:svgBlip xmlns:ns2="http://schemas.microsoft.com/office/drawing/2016/SVG/main" r:embed="rId21"/>
                 </a:ext>
               </a:extLst>
             </a:blip>
@@ -36904,9 +36906,11 @@
             <a:prstGeom prst="line">
               <a:avLst/>
             </a:prstGeom>
-            <a:ln>
+            <a:ln w="12700">
               <a:solidFill>
-                <a:schemeClr val="accent5"/>
+                <a:schemeClr val="accent5">
+                  <a:lumMod val="50000"/>
+                </a:schemeClr>
               </a:solidFill>
             </a:ln>
           </p:spPr>
@@ -36976,9 +36980,11 @@
                 <a:alpha val="50000"/>
               </a:schemeClr>
             </a:solidFill>
-            <a:ln>
+            <a:ln w="12700">
               <a:solidFill>
-                <a:srgbClr val="FFC000"/>
+                <a:schemeClr val="accent6">
+                  <a:lumMod val="75000"/>
+                </a:schemeClr>
               </a:solidFill>
             </a:ln>
           </p:spPr>
@@ -37040,10 +37046,10 @@
             <p:nvPr/>
           </p:nvPicPr>
           <p:blipFill>
-            <a:blip>
+            <a:blip r:embed="rId22">
               <a:extLst>
                 <a:ext uri="{96DAC541-7B7A-43D3-8B79-37D633B846F1}">
-                  <asvg:svgBlip xmlns:asvg="http://schemas.microsoft.com/office/drawing/2016/SVG/main" r:embed="rId6"/>
+                  <ns3:svgBlip xmlns:ns3="http://schemas.microsoft.com/office/drawing/2016/SVG/main" r:embed="rId23"/>
                 </a:ext>
               </a:extLst>
             </a:blip>
@@ -37083,9 +37089,11 @@
             <a:prstGeom prst="line">
               <a:avLst/>
             </a:prstGeom>
-            <a:ln>
+            <a:ln w="12700">
               <a:solidFill>
-                <a:srgbClr val="FA9400"/>
+                <a:schemeClr val="accent6">
+                  <a:lumMod val="75000"/>
+                </a:schemeClr>
               </a:solidFill>
             </a:ln>
           </p:spPr>
@@ -37114,7 +37122,7 @@
       </p:grpSp>
       <p:grpSp>
         <p:nvGrpSpPr>
-          <p:cNvPr id="50" name="Gruppieren 49">
+          <p:cNvPr id="50" name="Gruppe Chunking">
             <a:extLst>
               <a:ext uri="{FF2B5EF4-FFF2-40B4-BE49-F238E27FC236}">
                 <a16:creationId xmlns:a16="http://schemas.microsoft.com/office/drawing/2014/main" id="{8508E21A-AF16-CF37-8FB0-BF8A7BDA03CE}"/>
@@ -37161,9 +37169,11 @@
                 <a:alpha val="50000"/>
               </a:schemeClr>
             </a:solidFill>
-            <a:ln>
+            <a:ln w="12700">
               <a:solidFill>
-                <a:srgbClr val="FFC000"/>
+                <a:schemeClr val="accent6">
+                  <a:lumMod val="75000"/>
+                </a:schemeClr>
               </a:solidFill>
             </a:ln>
           </p:spPr>
@@ -37230,10 +37240,10 @@
             <a:prstGeom prst="line">
               <a:avLst/>
             </a:prstGeom>
-            <a:ln>
+            <a:ln w="12700">
               <a:solidFill>
-                <a:schemeClr val="accent2">
-                  <a:lumMod val="50000"/>
+                <a:schemeClr val="accent6">
+                  <a:lumMod val="75000"/>
                 </a:schemeClr>
               </a:solidFill>
             </a:ln>
@@ -37275,10 +37285,10 @@
             <p:nvPr/>
           </p:nvPicPr>
           <p:blipFill>
-            <a:blip>
+            <a:blip r:embed="rId24">
               <a:extLst>
                 <a:ext uri="{96DAC541-7B7A-43D3-8B79-37D633B846F1}">
-                  <asvg:svgBlip xmlns:asvg="http://schemas.microsoft.com/office/drawing/2016/SVG/main" r:embed="rId7"/>
+                  <ns4:svgBlip xmlns:ns4="http://schemas.microsoft.com/office/drawing/2016/SVG/main" r:embed="rId25"/>
                 </a:ext>
               </a:extLst>
             </a:blip>
@@ -37299,7 +37309,7 @@
       </p:grpSp>
       <p:grpSp>
         <p:nvGrpSpPr>
-          <p:cNvPr id="151" name="Gruppe Embedding"/>
+          <p:cNvPr id="151" name="Gruppe Embeddings"/>
           <p:cNvGrpSpPr/>
           <p:nvPr/>
         </p:nvGrpSpPr>
@@ -37338,11 +37348,9 @@
                 <a:alpha val="50000"/>
               </a:schemeClr>
             </a:solidFill>
-            <a:ln>
+            <a:ln w="12700">
               <a:solidFill>
-                <a:schemeClr val="accent2">
-                  <a:lumMod val="50000"/>
-                </a:schemeClr>
+                <a:srgbClr val="002060"/>
               </a:solidFill>
             </a:ln>
           </p:spPr>
@@ -37404,10 +37412,10 @@
             <p:nvPr/>
           </p:nvPicPr>
           <p:blipFill>
-            <a:blip>
+            <a:blip r:embed="rId26">
               <a:extLst>
                 <a:ext uri="{96DAC541-7B7A-43D3-8B79-37D633B846F1}">
-                  <asvg:svgBlip xmlns:asvg="http://schemas.microsoft.com/office/drawing/2016/SVG/main" r:embed="rId8"/>
+                  <ns5:svgBlip xmlns:ns5="http://schemas.microsoft.com/office/drawing/2016/SVG/main" r:embed="rId27"/>
                 </a:ext>
               </a:extLst>
             </a:blip>
@@ -37447,11 +37455,9 @@
             <a:prstGeom prst="line">
               <a:avLst/>
             </a:prstGeom>
-            <a:ln>
+            <a:ln w="12700">
               <a:solidFill>
-                <a:schemeClr val="accent2">
-                  <a:lumMod val="50000"/>
-                </a:schemeClr>
+                <a:srgbClr val="002060"/>
               </a:solidFill>
             </a:ln>
           </p:spPr>
@@ -37519,10 +37525,10 @@
                 <a:alpha val="50000"/>
               </a:schemeClr>
             </a:solidFill>
-            <a:ln>
+            <a:ln w="12700">
               <a:solidFill>
                 <a:schemeClr val="bg2">
-                  <a:lumMod val="50000"/>
+                  <a:lumMod val="25000"/>
                 </a:schemeClr>
               </a:solidFill>
             </a:ln>
@@ -37585,10 +37591,10 @@
             <p:nvPr/>
           </p:nvPicPr>
           <p:blipFill>
-            <a:blip>
+            <a:blip r:embed="rId28">
               <a:extLst>
                 <a:ext uri="{96DAC541-7B7A-43D3-8B79-37D633B846F1}">
-                  <asvg:svgBlip xmlns:asvg="http://schemas.microsoft.com/office/drawing/2016/SVG/main" r:embed="rId9"/>
+                  <ns6:svgBlip xmlns:ns6="http://schemas.microsoft.com/office/drawing/2016/SVG/main" r:embed="rId29"/>
                 </a:ext>
               </a:extLst>
             </a:blip>
@@ -37628,10 +37634,10 @@
             <a:prstGeom prst="line">
               <a:avLst/>
             </a:prstGeom>
-            <a:ln>
+            <a:ln w="12700">
               <a:solidFill>
                 <a:schemeClr val="bg2">
-                  <a:lumMod val="50000"/>
+                  <a:lumMod val="25000"/>
                 </a:schemeClr>
               </a:solidFill>
             </a:ln>
@@ -37700,11 +37706,9 @@
                 <a:alpha val="50000"/>
               </a:schemeClr>
             </a:solidFill>
-            <a:ln>
+            <a:ln w="12700">
               <a:solidFill>
-                <a:schemeClr val="accent2">
-                  <a:lumMod val="50000"/>
-                </a:schemeClr>
+                <a:srgbClr val="002060"/>
               </a:solidFill>
             </a:ln>
           </p:spPr>
@@ -37766,10 +37770,10 @@
             <p:nvPr/>
           </p:nvPicPr>
           <p:blipFill>
-            <a:blip>
+            <a:blip r:embed="rId30">
               <a:extLst>
                 <a:ext uri="{96DAC541-7B7A-43D3-8B79-37D633B846F1}">
-                  <asvg:svgBlip xmlns:asvg="http://schemas.microsoft.com/office/drawing/2016/SVG/main" r:embed="rId10"/>
+                  <ns7:svgBlip xmlns:ns7="http://schemas.microsoft.com/office/drawing/2016/SVG/main" r:embed="rId31"/>
                 </a:ext>
               </a:extLst>
             </a:blip>
@@ -37809,11 +37813,9 @@
             <a:prstGeom prst="line">
               <a:avLst/>
             </a:prstGeom>
-            <a:ln>
+            <a:ln w="12700">
               <a:solidFill>
-                <a:schemeClr val="accent2">
-                  <a:lumMod val="50000"/>
-                </a:schemeClr>
+                <a:srgbClr val="002060"/>
               </a:solidFill>
             </a:ln>
           </p:spPr>
@@ -37883,9 +37885,11 @@
                 <a:alpha val="50000"/>
               </a:schemeClr>
             </a:solidFill>
-            <a:ln>
+            <a:ln w="12700">
               <a:solidFill>
-                <a:srgbClr val="FFC000"/>
+                <a:schemeClr val="accent6">
+                  <a:lumMod val="75000"/>
+                </a:schemeClr>
               </a:solidFill>
             </a:ln>
           </p:spPr>
@@ -37947,10 +37951,10 @@
             <p:nvPr/>
           </p:nvPicPr>
           <p:blipFill>
-            <a:blip>
+            <a:blip r:embed="rId32">
               <a:extLst>
                 <a:ext uri="{96DAC541-7B7A-43D3-8B79-37D633B846F1}">
-                  <asvg:svgBlip xmlns:asvg="http://schemas.microsoft.com/office/drawing/2016/SVG/main" r:embed="rId11"/>
+                  <ns8:svgBlip xmlns:ns8="http://schemas.microsoft.com/office/drawing/2016/SVG/main" r:embed="rId33"/>
                 </a:ext>
               </a:extLst>
             </a:blip>
@@ -37990,9 +37994,11 @@
             <a:prstGeom prst="line">
               <a:avLst/>
             </a:prstGeom>
-            <a:ln>
+            <a:ln w="12700">
               <a:solidFill>
-                <a:srgbClr val="FA9400"/>
+                <a:schemeClr val="accent6">
+                  <a:lumMod val="75000"/>
+                </a:schemeClr>
               </a:solidFill>
             </a:ln>
           </p:spPr>
@@ -38021,7 +38027,7 @@
       </p:grpSp>
       <p:grpSp>
         <p:nvGrpSpPr>
-          <p:cNvPr id="27" name="Gruppieren 26">
+          <p:cNvPr id="27" name="Gruppe LLM">
             <a:extLst>
               <a:ext uri="{FF2B5EF4-FFF2-40B4-BE49-F238E27FC236}">
                 <a16:creationId xmlns:a16="http://schemas.microsoft.com/office/drawing/2014/main" id="{CC8957DA-7EEF-07E6-4817-4A1CAB29C56A}"/>
@@ -38068,9 +38074,11 @@
                 <a:alpha val="50000"/>
               </a:schemeClr>
             </a:solidFill>
-            <a:ln>
+            <a:ln w="12700">
               <a:solidFill>
-                <a:srgbClr val="FFC000"/>
+                <a:schemeClr val="accent6">
+                  <a:lumMod val="75000"/>
+                </a:schemeClr>
               </a:solidFill>
             </a:ln>
           </p:spPr>
@@ -38132,10 +38140,10 @@
             <p:nvPr/>
           </p:nvPicPr>
           <p:blipFill>
-            <a:blip>
+            <a:blip r:embed="rId34">
               <a:extLst>
                 <a:ext uri="{96DAC541-7B7A-43D3-8B79-37D633B846F1}">
-                  <asvg:svgBlip xmlns:asvg="http://schemas.microsoft.com/office/drawing/2016/SVG/main" r:embed="rId12"/>
+                  <ns9:svgBlip xmlns:ns9="http://schemas.microsoft.com/office/drawing/2016/SVG/main" r:embed="rId35"/>
                 </a:ext>
               </a:extLst>
             </a:blip>
@@ -38175,9 +38183,11 @@
             <a:prstGeom prst="line">
               <a:avLst/>
             </a:prstGeom>
-            <a:ln>
+            <a:ln w="12700">
               <a:solidFill>
-                <a:srgbClr val="FA9400"/>
+                <a:schemeClr val="accent6">
+                  <a:lumMod val="75000"/>
+                </a:schemeClr>
               </a:solidFill>
             </a:ln>
           </p:spPr>
@@ -38247,9 +38257,11 @@
                 <a:alpha val="50000"/>
               </a:schemeClr>
             </a:solidFill>
-            <a:ln>
+            <a:ln w="12700">
               <a:solidFill>
-                <a:srgbClr val="FFC000"/>
+                <a:schemeClr val="accent6">
+                  <a:lumMod val="75000"/>
+                </a:schemeClr>
               </a:solidFill>
             </a:ln>
           </p:spPr>
@@ -38311,10 +38323,10 @@
             <p:nvPr/>
           </p:nvPicPr>
           <p:blipFill>
-            <a:blip>
+            <a:blip r:embed="rId32">
               <a:extLst>
                 <a:ext uri="{96DAC541-7B7A-43D3-8B79-37D633B846F1}">
-                  <asvg:svgBlip xmlns:asvg="http://schemas.microsoft.com/office/drawing/2016/SVG/main" r:embed="rId11"/>
+                  <ns10:svgBlip xmlns:ns10="http://schemas.microsoft.com/office/drawing/2016/SVG/main" r:embed="rId33"/>
                 </a:ext>
               </a:extLst>
             </a:blip>
@@ -38354,9 +38366,11 @@
             <a:prstGeom prst="line">
               <a:avLst/>
             </a:prstGeom>
-            <a:ln>
+            <a:ln w="12700">
               <a:solidFill>
-                <a:srgbClr val="FA9400"/>
+                <a:schemeClr val="accent6">
+                  <a:lumMod val="75000"/>
+                </a:schemeClr>
               </a:solidFill>
             </a:ln>
           </p:spPr>
@@ -38424,11 +38438,9 @@
                 <a:alpha val="50000"/>
               </a:schemeClr>
             </a:solidFill>
-            <a:ln>
+            <a:ln w="12700">
               <a:solidFill>
-                <a:schemeClr val="accent2">
-                  <a:lumMod val="50000"/>
-                </a:schemeClr>
+                <a:srgbClr val="002060"/>
               </a:solidFill>
             </a:ln>
           </p:spPr>
@@ -38490,10 +38502,10 @@
             <p:nvPr/>
           </p:nvPicPr>
           <p:blipFill>
-            <a:blip>
+            <a:blip r:embed="rId24">
               <a:extLst>
                 <a:ext uri="{96DAC541-7B7A-43D3-8B79-37D633B846F1}">
-                  <asvg:svgBlip xmlns:asvg="http://schemas.microsoft.com/office/drawing/2016/SVG/main" r:embed="rId7"/>
+                  <ns11:svgBlip xmlns:ns11="http://schemas.microsoft.com/office/drawing/2016/SVG/main" r:embed="rId25"/>
                 </a:ext>
               </a:extLst>
             </a:blip>
@@ -38533,11 +38545,9 @@
             <a:prstGeom prst="line">
               <a:avLst/>
             </a:prstGeom>
-            <a:ln>
+            <a:ln w="12700">
               <a:solidFill>
-                <a:schemeClr val="accent2">
-                  <a:lumMod val="50000"/>
-                </a:schemeClr>
+                <a:srgbClr val="002060"/>
               </a:solidFill>
             </a:ln>
           </p:spPr>
@@ -38566,7 +38576,7 @@
       </p:grpSp>
       <p:grpSp>
         <p:nvGrpSpPr>
-          <p:cNvPr id="39" name="Gruppieren 38">
+          <p:cNvPr id="39" name="Gruppe Embeddings">
             <a:extLst>
               <a:ext uri="{FF2B5EF4-FFF2-40B4-BE49-F238E27FC236}">
                 <a16:creationId xmlns:a16="http://schemas.microsoft.com/office/drawing/2014/main" id="{1CE371FF-AA8D-9463-C284-4D4EC69E806E}"/>
@@ -38611,11 +38621,9 @@
                 <a:alpha val="50000"/>
               </a:schemeClr>
             </a:solidFill>
-            <a:ln>
+            <a:ln w="12700">
               <a:solidFill>
-                <a:schemeClr val="accent2">
-                  <a:lumMod val="50000"/>
-                </a:schemeClr>
+                <a:srgbClr val="002060"/>
               </a:solidFill>
             </a:ln>
           </p:spPr>
@@ -38675,10 +38683,10 @@
             <p:nvPr/>
           </p:nvPicPr>
           <p:blipFill>
-            <a:blip>
+            <a:blip r:embed="rId26">
               <a:extLst>
                 <a:ext uri="{96DAC541-7B7A-43D3-8B79-37D633B846F1}">
-                  <asvg:svgBlip xmlns:asvg="http://schemas.microsoft.com/office/drawing/2016/SVG/main" r:embed="rId8"/>
+                  <ns12:svgBlip xmlns:ns12="http://schemas.microsoft.com/office/drawing/2016/SVG/main" r:embed="rId27"/>
                 </a:ext>
               </a:extLst>
             </a:blip>
@@ -38718,11 +38726,9 @@
             <a:prstGeom prst="line">
               <a:avLst/>
             </a:prstGeom>
-            <a:ln>
+            <a:ln w="12700">
               <a:solidFill>
-                <a:schemeClr val="bg2">
-                  <a:lumMod val="50000"/>
-                </a:schemeClr>
+                <a:srgbClr val="002060"/>
               </a:solidFill>
             </a:ln>
           </p:spPr>
@@ -38751,7 +38757,7 @@
       </p:grpSp>
       <p:grpSp>
         <p:nvGrpSpPr>
-          <p:cNvPr id="23" name="Gruppe Embedding LLM">
+          <p:cNvPr id="23" name="Gruppe Graph Engine">
             <a:extLst>
               <a:ext uri="{FF2B5EF4-FFF2-40B4-BE49-F238E27FC236}">
                 <a16:creationId xmlns:a16="http://schemas.microsoft.com/office/drawing/2014/main" id="{D25D0927-7500-9C4D-B2AC-C86A40E321DD}"/>
@@ -38864,10 +38870,10 @@
             <p:nvPr/>
           </p:nvPicPr>
           <p:blipFill>
-            <a:blip>
+            <a:blip r:embed="rId36">
               <a:extLst>
                 <a:ext uri="{96DAC541-7B7A-43D3-8B79-37D633B846F1}">
-                  <asvg:svgBlip xmlns:asvg="http://schemas.microsoft.com/office/drawing/2016/SVG/main" r:embed="rId13"/>
+                  <ns13:svgBlip xmlns:ns13="http://schemas.microsoft.com/office/drawing/2016/SVG/main" r:embed="rId37"/>
                 </a:ext>
               </a:extLst>
             </a:blip>
@@ -38940,7 +38946,7 @@
       </p:grpSp>
       <p:grpSp>
         <p:nvGrpSpPr>
-          <p:cNvPr id="12" name="Gruppe Vector Database">
+          <p:cNvPr id="12" name="Gruppe Graph Database">
             <a:extLst>
               <a:ext uri="{FF2B5EF4-FFF2-40B4-BE49-F238E27FC236}">
                 <a16:creationId xmlns:a16="http://schemas.microsoft.com/office/drawing/2014/main" id="{BFB423DB-992A-5876-26AC-811D2AA99C40}"/>
@@ -39051,10 +39057,10 @@
             <p:nvPr/>
           </p:nvPicPr>
           <p:blipFill>
-            <a:blip>
+            <a:blip r:embed="rId38">
               <a:extLst>
                 <a:ext uri="{96DAC541-7B7A-43D3-8B79-37D633B846F1}">
-                  <asvg:svgBlip xmlns:asvg="http://schemas.microsoft.com/office/drawing/2016/SVG/main" r:embed="rId14"/>
+                  <ns14:svgBlip xmlns:ns14="http://schemas.microsoft.com/office/drawing/2016/SVG/main" r:embed="rId39"/>
                 </a:ext>
               </a:extLst>
             </a:blip>
@@ -39127,7 +39133,7 @@
       </p:grpSp>
       <p:grpSp>
         <p:nvGrpSpPr>
-          <p:cNvPr id="40" name="Gruppe Embedding LLM">
+          <p:cNvPr id="40" name="Gruppe Ranking">
             <a:extLst>
               <a:ext uri="{FF2B5EF4-FFF2-40B4-BE49-F238E27FC236}">
                 <a16:creationId xmlns:a16="http://schemas.microsoft.com/office/drawing/2014/main" id="{62657446-9BFF-60C0-3E07-97265A6E0278}"/>
@@ -39174,9 +39180,11 @@
                 <a:alpha val="50000"/>
               </a:schemeClr>
             </a:solidFill>
-            <a:ln>
+            <a:ln w="12700">
               <a:solidFill>
-                <a:srgbClr val="FFC000"/>
+                <a:schemeClr val="accent6">
+                  <a:lumMod val="75000"/>
+                </a:schemeClr>
               </a:solidFill>
             </a:ln>
           </p:spPr>
@@ -39238,10 +39246,10 @@
             <p:nvPr/>
           </p:nvPicPr>
           <p:blipFill>
-            <a:blip>
+            <a:blip r:embed="rId40">
               <a:extLst>
                 <a:ext uri="{96DAC541-7B7A-43D3-8B79-37D633B846F1}">
-                  <asvg:svgBlip xmlns:asvg="http://schemas.microsoft.com/office/drawing/2016/SVG/main" r:embed="rId15"/>
+                  <ns15:svgBlip xmlns:ns15="http://schemas.microsoft.com/office/drawing/2016/SVG/main" r:embed="rId41"/>
                 </a:ext>
               </a:extLst>
             </a:blip>
@@ -39281,9 +39289,11 @@
             <a:prstGeom prst="line">
               <a:avLst/>
             </a:prstGeom>
-            <a:ln>
+            <a:ln w="12700">
               <a:solidFill>
-                <a:srgbClr val="FA9400"/>
+                <a:schemeClr val="accent6">
+                  <a:lumMod val="75000"/>
+                </a:schemeClr>
               </a:solidFill>
             </a:ln>
           </p:spPr>

</xml_diff>

<commit_message>
Add missing Query-to-LLM arrow to the overview and focus slides
The question is sent to the LLM together with the retrieved context;
the overview only showed the retrieval path. The connector is cloned
from the existing arrow style and the focus deck is rebuilt from the
updated template, so the arrow appears on every stage.

Co-Authored-By: Claude Fable 5 <noreply@anthropic.com>
Claude-Session: https://claude.ai/code/session_01S2kGP2buE2HmxMttD3XczR
</commit_message>
<xml_diff>
--- a/RAG_Workshop.pptx
+++ b/RAG_Workshop.pptx
@@ -39309,6 +39309,49 @@
           </p:txBody>
         </p:sp>
       </p:grpSp>
+      <p:cxnSp>
+        <p:nvCxnSpPr>
+          <p:cNvPr id="161" name="Gerade Verbindung Query LLM"/>
+          <p:cNvCxnSpPr>
+            <a:cxnSpLocks/>
+            <a:stCxn id="13" idx="3"/>
+            <a:endCxn id="41" idx="1"/>
+          </p:cNvCxnSpPr>
+          <p:nvPr/>
+        </p:nvCxnSpPr>
+        <p:spPr>
+          <a:xfrm flipH="1">
+            <a:off x="8460000" y="2407125"/>
+            <a:ext cx="1800000" cy="2540403"/>
+          </a:xfrm>
+          <a:prstGeom prst="straightConnector1">
+            <a:avLst/>
+          </a:prstGeom>
+          <a:ln w="50800">
+            <a:solidFill>
+              <a:schemeClr val="tx1">
+                <a:alpha val="50000"/>
+              </a:schemeClr>
+            </a:solidFill>
+            <a:prstDash val="solid"/>
+            <a:tailEnd type="triangle"/>
+          </a:ln>
+        </p:spPr>
+        <p:style>
+          <a:lnRef idx="1">
+            <a:schemeClr val="accent1"/>
+          </a:lnRef>
+          <a:fillRef idx="0">
+            <a:schemeClr val="accent1"/>
+          </a:fillRef>
+          <a:effectRef idx="0">
+            <a:schemeClr val="accent1"/>
+          </a:effectRef>
+          <a:fontRef idx="minor">
+            <a:schemeClr val="tx1"/>
+          </a:fontRef>
+        </p:style>
+      </p:cxnSp>
     </p:spTree>
     <p:extLst>
       <p:ext uri="{BB962C8B-B14F-4D97-AF65-F5344CB8AC3E}">

</xml_diff>

<commit_message>
Dock the Query-to-LLM connector to its shapes
The cloned connector still carried the docking references of its
template. It now connects Query (bottom centre) to LLM (top centre)
like every other connector, with the geometry snapped onto the
connection sites; the focus deck is rebuilt from the updated template.

Co-Authored-By: Claude Fable 5 <noreply@anthropic.com>
Claude-Session: https://claude.ai/code/session_01S2kGP2buE2HmxMttD3XczR
</commit_message>
<xml_diff>
--- a/RAG_Workshop.pptx
+++ b/RAG_Workshop.pptx
@@ -39314,15 +39314,15 @@
           <p:cNvPr id="161" name="Gerade Verbindung Query LLM"/>
           <p:cNvCxnSpPr>
             <a:cxnSpLocks/>
-            <a:stCxn id="13" idx="3"/>
-            <a:endCxn id="41" idx="1"/>
+            <a:stCxn id="18" idx="2"/>
+            <a:endCxn id="102" idx="0"/>
           </p:cNvCxnSpPr>
           <p:nvPr/>
         </p:nvCxnSpPr>
         <p:spPr>
           <a:xfrm flipH="1">
-            <a:off x="8460000" y="2407125"/>
-            <a:ext cx="1800000" cy="2540403"/>
+            <a:off x="8460000" y="2317125"/>
+            <a:ext cx="1800000" cy="2720403"/>
           </a:xfrm>
           <a:prstGeom prst="straightConnector1">
             <a:avLst/>

</xml_diff>

<commit_message>
Establish a recurring icon motif system across the pipeline
Artifact motifs now reappear as simplified miniatures in the boxes
that work with them: the chunk-block motif (new dedicated 03b-chunks
icon) recurs in Chunking (document to mini blocks), Ranking and
Relevant Data; the embedding star-net recurs in Embedding LLM and
Vector Database; the two databases share the same cylinder and differ
only in their content miniature (star net vs chain graph), which also
appears on Graph Engine. Icons re-embedded in both decks; the focus
deck build now retries directory cleanup because Google Drive sync
briefly locks files at the new repo location.

Co-Authored-By: Claude Fable 5 <noreply@anthropic.com>
Claude-Session: https://claude.ai/code/session_01S2kGP2buE2HmxMttD3XczR
</commit_message>
<xml_diff>
--- a/RAG_Workshop.pptx
+++ b/RAG_Workshop.pptx
@@ -36554,10 +36554,10 @@
             <p:nvPr/>
           </p:nvPicPr>
           <p:blipFill>
-            <a:blip>
+            <a:blip r:embed="rId16">
               <a:extLst>
                 <a:ext uri="{96DAC541-7B7A-43D3-8B79-37D633B846F1}">
-                  <asvg:svgBlip xmlns:asvg="http://schemas.microsoft.com/office/drawing/2016/SVG/main" r:embed="rId3"/>
+                  <ns0:svgBlip xmlns:ns0="http://schemas.microsoft.com/office/drawing/2016/SVG/main" r:embed="rId17"/>
                 </a:ext>
               </a:extLst>
             </a:blip>
@@ -36683,10 +36683,10 @@
             <p:nvPr/>
           </p:nvPicPr>
           <p:blipFill>
-            <a:blip>
+            <a:blip r:embed="rId18">
               <a:extLst>
                 <a:ext uri="{96DAC541-7B7A-43D3-8B79-37D633B846F1}">
-                  <asvg:svgBlip xmlns:asvg="http://schemas.microsoft.com/office/drawing/2016/SVG/main" r:embed="rId4"/>
+                  <ns1:svgBlip xmlns:ns1="http://schemas.microsoft.com/office/drawing/2016/SVG/main" r:embed="rId19"/>
                 </a:ext>
               </a:extLst>
             </a:blip>
@@ -36858,10 +36858,10 @@
             <p:nvPr/>
           </p:nvPicPr>
           <p:blipFill>
-            <a:blip>
+            <a:blip r:embed="rId20">
               <a:extLst>
                 <a:ext uri="{96DAC541-7B7A-43D3-8B79-37D633B846F1}">
-                  <asvg:svgBlip xmlns:asvg="http://schemas.microsoft.com/office/drawing/2016/SVG/main" r:embed="rId5"/>
+                  <ns2:svgBlip xmlns:ns2="http://schemas.microsoft.com/office/drawing/2016/SVG/main" r:embed="rId21"/>
                 </a:ext>
               </a:extLst>
             </a:blip>
@@ -37035,10 +37035,10 @@
             <p:nvPr/>
           </p:nvPicPr>
           <p:blipFill>
-            <a:blip>
+            <a:blip r:embed="rId22">
               <a:extLst>
                 <a:ext uri="{96DAC541-7B7A-43D3-8B79-37D633B846F1}">
-                  <asvg:svgBlip xmlns:asvg="http://schemas.microsoft.com/office/drawing/2016/SVG/main" r:embed="rId6"/>
+                  <ns3:svgBlip xmlns:ns3="http://schemas.microsoft.com/office/drawing/2016/SVG/main" r:embed="rId23"/>
                 </a:ext>
               </a:extLst>
             </a:blip>
@@ -37274,10 +37274,10 @@
             <p:nvPr/>
           </p:nvPicPr>
           <p:blipFill>
-            <a:blip>
+            <a:blip r:embed="rId24">
               <a:extLst>
                 <a:ext uri="{96DAC541-7B7A-43D3-8B79-37D633B846F1}">
-                  <asvg:svgBlip xmlns:asvg="http://schemas.microsoft.com/office/drawing/2016/SVG/main" r:embed="rId7"/>
+                  <ns4:svgBlip xmlns:ns4="http://schemas.microsoft.com/office/drawing/2016/SVG/main" r:embed="rId25"/>
                 </a:ext>
               </a:extLst>
             </a:blip>
@@ -37401,10 +37401,10 @@
             <p:nvPr/>
           </p:nvPicPr>
           <p:blipFill>
-            <a:blip>
+            <a:blip r:embed="rId26">
               <a:extLst>
                 <a:ext uri="{96DAC541-7B7A-43D3-8B79-37D633B846F1}">
-                  <asvg:svgBlip xmlns:asvg="http://schemas.microsoft.com/office/drawing/2016/SVG/main" r:embed="rId8"/>
+                  <ns5:svgBlip xmlns:ns5="http://schemas.microsoft.com/office/drawing/2016/SVG/main" r:embed="rId27"/>
                 </a:ext>
               </a:extLst>
             </a:blip>
@@ -37580,10 +37580,10 @@
             <p:nvPr/>
           </p:nvPicPr>
           <p:blipFill>
-            <a:blip>
+            <a:blip r:embed="rId28">
               <a:extLst>
                 <a:ext uri="{96DAC541-7B7A-43D3-8B79-37D633B846F1}">
-                  <asvg:svgBlip xmlns:asvg="http://schemas.microsoft.com/office/drawing/2016/SVG/main" r:embed="rId9"/>
+                  <ns6:svgBlip xmlns:ns6="http://schemas.microsoft.com/office/drawing/2016/SVG/main" r:embed="rId29"/>
                 </a:ext>
               </a:extLst>
             </a:blip>
@@ -37759,10 +37759,10 @@
             <p:nvPr/>
           </p:nvPicPr>
           <p:blipFill>
-            <a:blip>
+            <a:blip r:embed="rId30">
               <a:extLst>
                 <a:ext uri="{96DAC541-7B7A-43D3-8B79-37D633B846F1}">
-                  <asvg:svgBlip xmlns:asvg="http://schemas.microsoft.com/office/drawing/2016/SVG/main" r:embed="rId10"/>
+                  <ns7:svgBlip xmlns:ns7="http://schemas.microsoft.com/office/drawing/2016/SVG/main" r:embed="rId31"/>
                 </a:ext>
               </a:extLst>
             </a:blip>
@@ -37940,10 +37940,10 @@
             <p:nvPr/>
           </p:nvPicPr>
           <p:blipFill>
-            <a:blip>
+            <a:blip r:embed="rId32">
               <a:extLst>
                 <a:ext uri="{96DAC541-7B7A-43D3-8B79-37D633B846F1}">
-                  <asvg:svgBlip xmlns:asvg="http://schemas.microsoft.com/office/drawing/2016/SVG/main" r:embed="rId11"/>
+                  <ns8:svgBlip xmlns:ns8="http://schemas.microsoft.com/office/drawing/2016/SVG/main" r:embed="rId33"/>
                 </a:ext>
               </a:extLst>
             </a:blip>
@@ -38129,10 +38129,10 @@
             <p:nvPr/>
           </p:nvPicPr>
           <p:blipFill>
-            <a:blip>
+            <a:blip r:embed="rId34">
               <a:extLst>
                 <a:ext uri="{96DAC541-7B7A-43D3-8B79-37D633B846F1}">
-                  <asvg:svgBlip xmlns:asvg="http://schemas.microsoft.com/office/drawing/2016/SVG/main" r:embed="rId12"/>
+                  <ns9:svgBlip xmlns:ns9="http://schemas.microsoft.com/office/drawing/2016/SVG/main" r:embed="rId35"/>
                 </a:ext>
               </a:extLst>
             </a:blip>
@@ -38312,10 +38312,10 @@
             <p:nvPr/>
           </p:nvPicPr>
           <p:blipFill>
-            <a:blip>
+            <a:blip r:embed="rId32">
               <a:extLst>
                 <a:ext uri="{96DAC541-7B7A-43D3-8B79-37D633B846F1}">
-                  <asvg:svgBlip xmlns:asvg="http://schemas.microsoft.com/office/drawing/2016/SVG/main" r:embed="rId11"/>
+                  <ns10:svgBlip xmlns:ns10="http://schemas.microsoft.com/office/drawing/2016/SVG/main" r:embed="rId33"/>
                 </a:ext>
               </a:extLst>
             </a:blip>
@@ -38491,10 +38491,10 @@
             <p:nvPr/>
           </p:nvPicPr>
           <p:blipFill>
-            <a:blip>
+            <a:blip r:embed="rId36">
               <a:extLst>
                 <a:ext uri="{96DAC541-7B7A-43D3-8B79-37D633B846F1}">
-                  <asvg:svgBlip xmlns:asvg="http://schemas.microsoft.com/office/drawing/2016/SVG/main" r:embed="rId7"/>
+                  <ns11:svgBlip xmlns:ns11="http://schemas.microsoft.com/office/drawing/2016/SVG/main" r:embed="rId37"/>
                 </a:ext>
               </a:extLst>
             </a:blip>
@@ -38672,10 +38672,10 @@
             <p:nvPr/>
           </p:nvPicPr>
           <p:blipFill>
-            <a:blip>
+            <a:blip r:embed="rId26">
               <a:extLst>
                 <a:ext uri="{96DAC541-7B7A-43D3-8B79-37D633B846F1}">
-                  <asvg:svgBlip xmlns:asvg="http://schemas.microsoft.com/office/drawing/2016/SVG/main" r:embed="rId8"/>
+                  <ns12:svgBlip xmlns:ns12="http://schemas.microsoft.com/office/drawing/2016/SVG/main" r:embed="rId27"/>
                 </a:ext>
               </a:extLst>
             </a:blip>
@@ -38859,10 +38859,10 @@
             <p:nvPr/>
           </p:nvPicPr>
           <p:blipFill>
-            <a:blip>
+            <a:blip r:embed="rId38">
               <a:extLst>
                 <a:ext uri="{96DAC541-7B7A-43D3-8B79-37D633B846F1}">
-                  <asvg:svgBlip xmlns:asvg="http://schemas.microsoft.com/office/drawing/2016/SVG/main" r:embed="rId13"/>
+                  <ns13:svgBlip xmlns:ns13="http://schemas.microsoft.com/office/drawing/2016/SVG/main" r:embed="rId39"/>
                 </a:ext>
               </a:extLst>
             </a:blip>
@@ -39046,10 +39046,10 @@
             <p:nvPr/>
           </p:nvPicPr>
           <p:blipFill>
-            <a:blip>
+            <a:blip r:embed="rId40">
               <a:extLst>
                 <a:ext uri="{96DAC541-7B7A-43D3-8B79-37D633B846F1}">
-                  <asvg:svgBlip xmlns:asvg="http://schemas.microsoft.com/office/drawing/2016/SVG/main" r:embed="rId14"/>
+                  <ns14:svgBlip xmlns:ns14="http://schemas.microsoft.com/office/drawing/2016/SVG/main" r:embed="rId41"/>
                 </a:ext>
               </a:extLst>
             </a:blip>
@@ -39235,10 +39235,10 @@
             <p:nvPr/>
           </p:nvPicPr>
           <p:blipFill>
-            <a:blip>
+            <a:blip r:embed="rId42">
               <a:extLst>
                 <a:ext uri="{96DAC541-7B7A-43D3-8B79-37D633B846F1}">
-                  <asvg:svgBlip xmlns:asvg="http://schemas.microsoft.com/office/drawing/2016/SVG/main" r:embed="rId15"/>
+                  <ns15:svgBlip xmlns:ns15="http://schemas.microsoft.com/office/drawing/2016/SVG/main" r:embed="rId43"/>
                 </a:ext>
               </a:extLst>
             </a:blip>

</xml_diff>

<commit_message>
Use the full hexagon net as scaled-down embedding miniature
Embedding LLM and Vector Database now carry the same hexagonal net as
the Embeddings artifact - identical topology and color placement, just
scaled down - instead of the abstracted four-node star.

Co-Authored-By: Claude Fable 5 <noreply@anthropic.com>
Claude-Session: https://claude.ai/code/session_01S2kGP2buE2HmxMttD3XczR
</commit_message>
<xml_diff>
--- a/RAG_Workshop.pptx
+++ b/RAG_Workshop.pptx
@@ -36557,7 +36557,7 @@
             <a:blip r:embed="rId16">
               <a:extLst>
                 <a:ext uri="{96DAC541-7B7A-43D3-8B79-37D633B846F1}">
-                  <ns0:svgBlip xmlns:ns0="http://schemas.microsoft.com/office/drawing/2016/SVG/main" r:embed="rId17"/>
+                  <ns0:svgBlip xmlns:ns0="http://schemas.microsoft.com/office/drawing/2016/SVG/main" r:embed="rId15"/>
                 </a:ext>
               </a:extLst>
             </a:blip>
@@ -36686,7 +36686,7 @@
             <a:blip r:embed="rId18">
               <a:extLst>
                 <a:ext uri="{96DAC541-7B7A-43D3-8B79-37D633B846F1}">
-                  <ns1:svgBlip xmlns:ns1="http://schemas.microsoft.com/office/drawing/2016/SVG/main" r:embed="rId19"/>
+                  <ns1:svgBlip xmlns:ns1="http://schemas.microsoft.com/office/drawing/2016/SVG/main" r:embed="rId14"/>
                 </a:ext>
               </a:extLst>
             </a:blip>
@@ -36861,7 +36861,7 @@
             <a:blip r:embed="rId20">
               <a:extLst>
                 <a:ext uri="{96DAC541-7B7A-43D3-8B79-37D633B846F1}">
-                  <ns2:svgBlip xmlns:ns2="http://schemas.microsoft.com/office/drawing/2016/SVG/main" r:embed="rId21"/>
+                  <ns2:svgBlip xmlns:ns2="http://schemas.microsoft.com/office/drawing/2016/SVG/main" r:embed="rId13"/>
                 </a:ext>
               </a:extLst>
             </a:blip>
@@ -37038,7 +37038,7 @@
             <a:blip r:embed="rId22">
               <a:extLst>
                 <a:ext uri="{96DAC541-7B7A-43D3-8B79-37D633B846F1}">
-                  <ns3:svgBlip xmlns:ns3="http://schemas.microsoft.com/office/drawing/2016/SVG/main" r:embed="rId23"/>
+                  <ns3:svgBlip xmlns:ns3="http://schemas.microsoft.com/office/drawing/2016/SVG/main" r:embed="rId12"/>
                 </a:ext>
               </a:extLst>
             </a:blip>
@@ -37277,7 +37277,7 @@
             <a:blip r:embed="rId24">
               <a:extLst>
                 <a:ext uri="{96DAC541-7B7A-43D3-8B79-37D633B846F1}">
-                  <ns4:svgBlip xmlns:ns4="http://schemas.microsoft.com/office/drawing/2016/SVG/main" r:embed="rId25"/>
+                  <ns4:svgBlip xmlns:ns4="http://schemas.microsoft.com/office/drawing/2016/SVG/main" r:embed="rId11"/>
                 </a:ext>
               </a:extLst>
             </a:blip>
@@ -37404,7 +37404,7 @@
             <a:blip r:embed="rId26">
               <a:extLst>
                 <a:ext uri="{96DAC541-7B7A-43D3-8B79-37D633B846F1}">
-                  <ns5:svgBlip xmlns:ns5="http://schemas.microsoft.com/office/drawing/2016/SVG/main" r:embed="rId27"/>
+                  <ns5:svgBlip xmlns:ns5="http://schemas.microsoft.com/office/drawing/2016/SVG/main" r:embed="rId10"/>
                 </a:ext>
               </a:extLst>
             </a:blip>
@@ -37580,10 +37580,10 @@
             <p:nvPr/>
           </p:nvPicPr>
           <p:blipFill>
-            <a:blip r:embed="rId28">
+            <a:blip r:embed="rId9">
               <a:extLst>
                 <a:ext uri="{96DAC541-7B7A-43D3-8B79-37D633B846F1}">
-                  <ns6:svgBlip xmlns:ns6="http://schemas.microsoft.com/office/drawing/2016/SVG/main" r:embed="rId29"/>
+                  <ns6:svgBlip xmlns:ns6="http://schemas.microsoft.com/office/drawing/2016/SVG/main" r:embed="rId8"/>
                 </a:ext>
               </a:extLst>
             </a:blip>
@@ -37762,7 +37762,7 @@
             <a:blip r:embed="rId30">
               <a:extLst>
                 <a:ext uri="{96DAC541-7B7A-43D3-8B79-37D633B846F1}">
-                  <ns7:svgBlip xmlns:ns7="http://schemas.microsoft.com/office/drawing/2016/SVG/main" r:embed="rId31"/>
+                  <ns7:svgBlip xmlns:ns7="http://schemas.microsoft.com/office/drawing/2016/SVG/main" r:embed="rId7"/>
                 </a:ext>
               </a:extLst>
             </a:blip>
@@ -37940,10 +37940,10 @@
             <p:nvPr/>
           </p:nvPicPr>
           <p:blipFill>
-            <a:blip r:embed="rId32">
+            <a:blip r:embed="rId6">
               <a:extLst>
                 <a:ext uri="{96DAC541-7B7A-43D3-8B79-37D633B846F1}">
-                  <ns8:svgBlip xmlns:ns8="http://schemas.microsoft.com/office/drawing/2016/SVG/main" r:embed="rId33"/>
+                  <ns8:svgBlip xmlns:ns8="http://schemas.microsoft.com/office/drawing/2016/SVG/main" r:embed="rId5"/>
                 </a:ext>
               </a:extLst>
             </a:blip>
@@ -38132,7 +38132,7 @@
             <a:blip r:embed="rId34">
               <a:extLst>
                 <a:ext uri="{96DAC541-7B7A-43D3-8B79-37D633B846F1}">
-                  <ns9:svgBlip xmlns:ns9="http://schemas.microsoft.com/office/drawing/2016/SVG/main" r:embed="rId35"/>
+                  <ns9:svgBlip xmlns:ns9="http://schemas.microsoft.com/office/drawing/2016/SVG/main" r:embed="rId4"/>
                 </a:ext>
               </a:extLst>
             </a:blip>
@@ -38312,10 +38312,10 @@
             <p:nvPr/>
           </p:nvPicPr>
           <p:blipFill>
-            <a:blip r:embed="rId32">
+            <a:blip r:embed="rId6">
               <a:extLst>
                 <a:ext uri="{96DAC541-7B7A-43D3-8B79-37D633B846F1}">
-                  <ns10:svgBlip xmlns:ns10="http://schemas.microsoft.com/office/drawing/2016/SVG/main" r:embed="rId33"/>
+                  <ns10:svgBlip xmlns:ns10="http://schemas.microsoft.com/office/drawing/2016/SVG/main" r:embed="rId5"/>
                 </a:ext>
               </a:extLst>
             </a:blip>
@@ -38494,7 +38494,7 @@
             <a:blip r:embed="rId36">
               <a:extLst>
                 <a:ext uri="{96DAC541-7B7A-43D3-8B79-37D633B846F1}">
-                  <ns11:svgBlip xmlns:ns11="http://schemas.microsoft.com/office/drawing/2016/SVG/main" r:embed="rId37"/>
+                  <ns11:svgBlip xmlns:ns11="http://schemas.microsoft.com/office/drawing/2016/SVG/main" r:embed="rId3"/>
                 </a:ext>
               </a:extLst>
             </a:blip>
@@ -38675,7 +38675,7 @@
             <a:blip r:embed="rId26">
               <a:extLst>
                 <a:ext uri="{96DAC541-7B7A-43D3-8B79-37D633B846F1}">
-                  <ns12:svgBlip xmlns:ns12="http://schemas.microsoft.com/office/drawing/2016/SVG/main" r:embed="rId27"/>
+                  <ns12:svgBlip xmlns:ns12="http://schemas.microsoft.com/office/drawing/2016/SVG/main" r:embed="rId10"/>
                 </a:ext>
               </a:extLst>
             </a:blip>
@@ -38862,7 +38862,7 @@
             <a:blip r:embed="rId38">
               <a:extLst>
                 <a:ext uri="{96DAC541-7B7A-43D3-8B79-37D633B846F1}">
-                  <ns13:svgBlip xmlns:ns13="http://schemas.microsoft.com/office/drawing/2016/SVG/main" r:embed="rId39"/>
+                  <ns13:svgBlip xmlns:ns13="http://schemas.microsoft.com/office/drawing/2016/SVG/main" r:embed="rId44"/>
                 </a:ext>
               </a:extLst>
             </a:blip>
@@ -39049,7 +39049,7 @@
             <a:blip r:embed="rId40">
               <a:extLst>
                 <a:ext uri="{96DAC541-7B7A-43D3-8B79-37D633B846F1}">
-                  <ns14:svgBlip xmlns:ns14="http://schemas.microsoft.com/office/drawing/2016/SVG/main" r:embed="rId41"/>
+                  <ns14:svgBlip xmlns:ns14="http://schemas.microsoft.com/office/drawing/2016/SVG/main" r:embed="rId45"/>
                 </a:ext>
               </a:extLst>
             </a:blip>
@@ -39238,7 +39238,7 @@
             <a:blip r:embed="rId42">
               <a:extLst>
                 <a:ext uri="{96DAC541-7B7A-43D3-8B79-37D633B846F1}">
-                  <ns15:svgBlip xmlns:ns15="http://schemas.microsoft.com/office/drawing/2016/SVG/main" r:embed="rId43"/>
+                  <ns15:svgBlip xmlns:ns15="http://schemas.microsoft.com/office/drawing/2016/SVG/main" r:embed="rId46"/>
                 </a:ext>
               </a:extLst>
             </a:blip>

</xml_diff>

<commit_message>
Give the embedding model icon the LLM chip silhouette
Embedding LLM is drawn as the same chip as the LLM icon (identical
pins and proportions) with the scaled-down hexagon embedding net in
its core instead of the sparkle, so the box reads as a model again.

Co-Authored-By: Claude Fable 5 <noreply@anthropic.com>
Claude-Session: https://claude.ai/code/session_01S2kGP2buE2HmxMttD3XczR
</commit_message>
<xml_diff>
--- a/RAG_Workshop.pptx
+++ b/RAG_Workshop.pptx
@@ -36557,7 +36557,7 @@
             <a:blip r:embed="rId16">
               <a:extLst>
                 <a:ext uri="{96DAC541-7B7A-43D3-8B79-37D633B846F1}">
-                  <ns0:svgBlip xmlns:ns0="http://schemas.microsoft.com/office/drawing/2016/SVG/main" r:embed="rId15"/>
+                  <ns0:svgBlip xmlns:ns0="http://schemas.microsoft.com/office/drawing/2016/SVG/main" r:embed="rId31"/>
                 </a:ext>
               </a:extLst>
             </a:blip>
@@ -36686,7 +36686,7 @@
             <a:blip r:embed="rId18">
               <a:extLst>
                 <a:ext uri="{96DAC541-7B7A-43D3-8B79-37D633B846F1}">
-                  <ns1:svgBlip xmlns:ns1="http://schemas.microsoft.com/office/drawing/2016/SVG/main" r:embed="rId14"/>
+                  <ns1:svgBlip xmlns:ns1="http://schemas.microsoft.com/office/drawing/2016/SVG/main" r:embed="rId32"/>
                 </a:ext>
               </a:extLst>
             </a:blip>
@@ -36861,7 +36861,7 @@
             <a:blip r:embed="rId20">
               <a:extLst>
                 <a:ext uri="{96DAC541-7B7A-43D3-8B79-37D633B846F1}">
-                  <ns2:svgBlip xmlns:ns2="http://schemas.microsoft.com/office/drawing/2016/SVG/main" r:embed="rId13"/>
+                  <ns2:svgBlip xmlns:ns2="http://schemas.microsoft.com/office/drawing/2016/SVG/main" r:embed="rId33"/>
                 </a:ext>
               </a:extLst>
             </a:blip>
@@ -37038,7 +37038,7 @@
             <a:blip r:embed="rId22">
               <a:extLst>
                 <a:ext uri="{96DAC541-7B7A-43D3-8B79-37D633B846F1}">
-                  <ns3:svgBlip xmlns:ns3="http://schemas.microsoft.com/office/drawing/2016/SVG/main" r:embed="rId12"/>
+                  <ns3:svgBlip xmlns:ns3="http://schemas.microsoft.com/office/drawing/2016/SVG/main" r:embed="rId29"/>
                 </a:ext>
               </a:extLst>
             </a:blip>
@@ -37277,7 +37277,7 @@
             <a:blip r:embed="rId24">
               <a:extLst>
                 <a:ext uri="{96DAC541-7B7A-43D3-8B79-37D633B846F1}">
-                  <ns4:svgBlip xmlns:ns4="http://schemas.microsoft.com/office/drawing/2016/SVG/main" r:embed="rId11"/>
+                  <ns4:svgBlip xmlns:ns4="http://schemas.microsoft.com/office/drawing/2016/SVG/main" r:embed="rId35"/>
                 </a:ext>
               </a:extLst>
             </a:blip>
@@ -37404,7 +37404,7 @@
             <a:blip r:embed="rId26">
               <a:extLst>
                 <a:ext uri="{96DAC541-7B7A-43D3-8B79-37D633B846F1}">
-                  <ns5:svgBlip xmlns:ns5="http://schemas.microsoft.com/office/drawing/2016/SVG/main" r:embed="rId10"/>
+                  <ns5:svgBlip xmlns:ns5="http://schemas.microsoft.com/office/drawing/2016/SVG/main" r:embed="rId28"/>
                 </a:ext>
               </a:extLst>
             </a:blip>
@@ -37583,7 +37583,7 @@
             <a:blip r:embed="rId9">
               <a:extLst>
                 <a:ext uri="{96DAC541-7B7A-43D3-8B79-37D633B846F1}">
-                  <ns6:svgBlip xmlns:ns6="http://schemas.microsoft.com/office/drawing/2016/SVG/main" r:embed="rId8"/>
+                  <ns6:svgBlip xmlns:ns6="http://schemas.microsoft.com/office/drawing/2016/SVG/main" r:embed="rId37"/>
                 </a:ext>
               </a:extLst>
             </a:blip>
@@ -37762,7 +37762,7 @@
             <a:blip r:embed="rId30">
               <a:extLst>
                 <a:ext uri="{96DAC541-7B7A-43D3-8B79-37D633B846F1}">
-                  <ns7:svgBlip xmlns:ns7="http://schemas.microsoft.com/office/drawing/2016/SVG/main" r:embed="rId7"/>
+                  <ns7:svgBlip xmlns:ns7="http://schemas.microsoft.com/office/drawing/2016/SVG/main" r:embed="rId27"/>
                 </a:ext>
               </a:extLst>
             </a:blip>
@@ -37940,10 +37940,10 @@
             <p:nvPr/>
           </p:nvPicPr>
           <p:blipFill>
-            <a:blip r:embed="rId6">
+            <a:blip r:embed="rId39">
               <a:extLst>
                 <a:ext uri="{96DAC541-7B7A-43D3-8B79-37D633B846F1}">
-                  <ns8:svgBlip xmlns:ns8="http://schemas.microsoft.com/office/drawing/2016/SVG/main" r:embed="rId5"/>
+                  <ns8:svgBlip xmlns:ns8="http://schemas.microsoft.com/office/drawing/2016/SVG/main" r:embed="rId25"/>
                 </a:ext>
               </a:extLst>
             </a:blip>
@@ -38132,7 +38132,7 @@
             <a:blip r:embed="rId34">
               <a:extLst>
                 <a:ext uri="{96DAC541-7B7A-43D3-8B79-37D633B846F1}">
-                  <ns9:svgBlip xmlns:ns9="http://schemas.microsoft.com/office/drawing/2016/SVG/main" r:embed="rId4"/>
+                  <ns9:svgBlip xmlns:ns9="http://schemas.microsoft.com/office/drawing/2016/SVG/main" r:embed="rId41"/>
                 </a:ext>
               </a:extLst>
             </a:blip>
@@ -38312,10 +38312,10 @@
             <p:nvPr/>
           </p:nvPicPr>
           <p:blipFill>
-            <a:blip r:embed="rId6">
+            <a:blip r:embed="rId39">
               <a:extLst>
                 <a:ext uri="{96DAC541-7B7A-43D3-8B79-37D633B846F1}">
-                  <ns10:svgBlip xmlns:ns10="http://schemas.microsoft.com/office/drawing/2016/SVG/main" r:embed="rId5"/>
+                  <ns10:svgBlip xmlns:ns10="http://schemas.microsoft.com/office/drawing/2016/SVG/main" r:embed="rId25"/>
                 </a:ext>
               </a:extLst>
             </a:blip>
@@ -38494,7 +38494,7 @@
             <a:blip r:embed="rId36">
               <a:extLst>
                 <a:ext uri="{96DAC541-7B7A-43D3-8B79-37D633B846F1}">
-                  <ns11:svgBlip xmlns:ns11="http://schemas.microsoft.com/office/drawing/2016/SVG/main" r:embed="rId3"/>
+                  <ns11:svgBlip xmlns:ns11="http://schemas.microsoft.com/office/drawing/2016/SVG/main" r:embed="rId23"/>
                 </a:ext>
               </a:extLst>
             </a:blip>
@@ -38675,7 +38675,7 @@
             <a:blip r:embed="rId26">
               <a:extLst>
                 <a:ext uri="{96DAC541-7B7A-43D3-8B79-37D633B846F1}">
-                  <ns12:svgBlip xmlns:ns12="http://schemas.microsoft.com/office/drawing/2016/SVG/main" r:embed="rId10"/>
+                  <ns12:svgBlip xmlns:ns12="http://schemas.microsoft.com/office/drawing/2016/SVG/main" r:embed="rId28"/>
                 </a:ext>
               </a:extLst>
             </a:blip>
@@ -38862,7 +38862,7 @@
             <a:blip r:embed="rId38">
               <a:extLst>
                 <a:ext uri="{96DAC541-7B7A-43D3-8B79-37D633B846F1}">
-                  <ns13:svgBlip xmlns:ns13="http://schemas.microsoft.com/office/drawing/2016/SVG/main" r:embed="rId44"/>
+                  <ns13:svgBlip xmlns:ns13="http://schemas.microsoft.com/office/drawing/2016/SVG/main" r:embed="rId43"/>
                 </a:ext>
               </a:extLst>
             </a:blip>
@@ -39049,7 +39049,7 @@
             <a:blip r:embed="rId40">
               <a:extLst>
                 <a:ext uri="{96DAC541-7B7A-43D3-8B79-37D633B846F1}">
-                  <ns14:svgBlip xmlns:ns14="http://schemas.microsoft.com/office/drawing/2016/SVG/main" r:embed="rId45"/>
+                  <ns14:svgBlip xmlns:ns14="http://schemas.microsoft.com/office/drawing/2016/SVG/main" r:embed="rId21"/>
                 </a:ext>
               </a:extLst>
             </a:blip>
@@ -39238,7 +39238,7 @@
             <a:blip r:embed="rId42">
               <a:extLst>
                 <a:ext uri="{96DAC541-7B7A-43D3-8B79-37D633B846F1}">
-                  <ns15:svgBlip xmlns:ns15="http://schemas.microsoft.com/office/drawing/2016/SVG/main" r:embed="rId46"/>
+                  <ns15:svgBlip xmlns:ns15="http://schemas.microsoft.com/office/drawing/2016/SVG/main" r:embed="rId19"/>
                 </a:ext>
               </a:extLst>
             </a:blip>

</xml_diff>

<commit_message>
Phase 1: unify deck foundation on the corporate template
The six slides on the foreign "Title Slide" layout are re-hung onto
the corporate "Nur Titel" layout and the unused foreign layout is
removed from the master. All eight advanced slides get real title
placeholders fed from their former pseudo-title text boxes (36 pt like
the corporate reference, stepping down where a title would wrap), the
leftover clean-canvas cover is dropped and stray Helvetica typefaces
on slide 8 are replaced with Arial. Texts unchanged.

Co-Authored-By: Claude Fable 5 <noreply@anthropic.com>
Claude-Session: https://claude.ai/code/session_01S2kGP2buE2HmxMttD3XczR
</commit_message>
<xml_diff>
--- a/RAG_Workshop.pptx
+++ b/RAG_Workshop.pptx
@@ -3584,36 +3584,6 @@
 </p:sldLayout>
 </file>
 
-<file path=ppt/slideLayouts/slideLayout11.xml><?xml version="1.0" encoding="utf-8"?>
-<p:sldLayout xmlns:a="http://schemas.openxmlformats.org/drawingml/2006/main" xmlns:r="http://schemas.openxmlformats.org/officeDocument/2006/relationships" xmlns:p="http://schemas.openxmlformats.org/presentationml/2006/main" type="title">
-  <p:cSld name="Title Slide">
-    <p:spTree>
-      <p:nvGrpSpPr>
-        <p:cNvPr id="1" name=""/>
-        <p:cNvGrpSpPr/>
-        <p:nvPr/>
-      </p:nvGrpSpPr>
-      <p:grpSpPr>
-        <a:xfrm>
-          <a:off x="0" y="0"/>
-          <a:ext cx="0" cy="0"/>
-          <a:chOff x="0" y="0"/>
-          <a:chExt cx="0" cy="0"/>
-        </a:xfrm>
-      </p:grpSpPr>
-    </p:spTree>
-    <p:extLst>
-      <p:ext uri="{BB962C8B-B14F-4D97-AF65-F5344CB8AC3E}">
-        <p14:creationId xmlns:p14="http://schemas.microsoft.com/office/powerpoint/2010/main" val="3637233680"/>
-      </p:ext>
-    </p:extLst>
-  </p:cSld>
-  <p:clrMapOvr>
-    <a:masterClrMapping/>
-  </p:clrMapOvr>
-</p:sldLayout>
-</file>
-
 <file path=ppt/slideLayouts/slideLayout2.xml><?xml version="1.0" encoding="utf-8"?>
 <p:sldLayout xmlns:a="http://schemas.openxmlformats.org/drawingml/2006/main" xmlns:r="http://schemas.openxmlformats.org/officeDocument/2006/relationships" xmlns:p="http://schemas.openxmlformats.org/presentationml/2006/main" showMasterSp="0" preserve="1" userDrawn="1">
   <p:cSld name="Titelfolie mit Bild">
@@ -5983,7 +5953,6 @@
     <p:sldLayoutId id="2147483668" r:id="rId8"/>
     <p:sldLayoutId id="2147483654" r:id="rId9"/>
     <p:sldLayoutId id="2147483666" r:id="rId10"/>
-    <p:sldLayoutId id="2147483669" r:id="rId11"/>
   </p:sldLayoutIdLst>
   <p:hf hdr="0" ftr="0"/>
   <p:txStyles>
@@ -8813,63 +8782,29 @@
       </p:sp>
       <p:sp>
         <p:nvSpPr>
-          <p:cNvPr id="31" name="Titel 1">
-            <a:extLst>
-              <a:ext uri="{FF2B5EF4-FFF2-40B4-BE49-F238E27FC236}">
-                <a16:creationId xmlns:a16="http://schemas.microsoft.com/office/drawing/2014/main" id="{B2980687-90D9-7016-3632-98FC3B81D643}"/>
-              </a:ext>
-            </a:extLst>
-          </p:cNvPr>
-          <p:cNvSpPr txBox="1">
-            <a:spLocks/>
-          </p:cNvSpPr>
-          <p:nvPr/>
-        </p:nvSpPr>
-        <p:spPr>
-          <a:xfrm>
-            <a:off x="476250" y="342900"/>
-            <a:ext cx="11239500" cy="742950"/>
-          </a:xfrm>
-          <a:prstGeom prst="rect">
-            <a:avLst/>
-          </a:prstGeom>
-        </p:spPr>
-        <p:txBody>
-          <a:bodyPr anchor="ctr"/>
-          <a:lstStyle>
-            <a:lvl1pPr algn="l" defTabSz="914400" rtl="0" eaLnBrk="1" latinLnBrk="0" hangingPunct="1">
-              <a:lnSpc>
-                <a:spcPct val="90000"/>
-              </a:lnSpc>
-              <a:spcBef>
-                <a:spcPct val="0"/>
-              </a:spcBef>
-              <a:buNone/>
-              <a:defRPr sz="4000" b="0" kern="1200">
-                <a:solidFill>
-                  <a:schemeClr val="tx1"/>
-                </a:solidFill>
-                <a:latin typeface="+mj-lt"/>
-                <a:ea typeface="+mj-ea"/>
-                <a:cs typeface="+mj-cs"/>
-              </a:defRPr>
-            </a:lvl1pPr>
-          </a:lstStyle>
-          <a:p>
-            <a:pPr>
-              <a:defRPr sz="2850">
-                <a:solidFill>
-                  <a:srgbClr val="2D3F4B"/>
-                </a:solidFill>
-                <a:latin typeface="Arial"/>
-                <a:ea typeface="Arial"/>
-                <a:cs typeface="Arial"/>
-              </a:defRPr>
-            </a:pPr>
-            <a:r>
-              <a:rPr lang="de-DE" sz="3600" dirty="0"/>
+          <p:cNvPr id="44" name="Titel 1"/>
+          <p:cNvSpPr>
+            <a:spLocks noGrp="1"/>
+          </p:cNvSpPr>
+          <p:nvPr>
+            <p:ph type="title"/>
+          </p:nvPr>
+        </p:nvSpPr>
+        <p:spPr>
+          <a:xfrm>
+            <a:off x="482461" y="346633"/>
+            <a:ext cx="11230114" cy="767605"/>
+          </a:xfrm>
+        </p:spPr>
+        <p:txBody>
+          <a:bodyPr/>
+          <a:lstStyle/>
+          <a:p>
+            <a:r>
+              <a:rPr lang="de-CH" dirty="0" sz="3600"/>
               <a:t>Chunking entscheidet, was auffindbar bleibt</a:t>
             </a:r>
+            <a:endParaRPr lang="de-CH" dirty="0" sz="3600"/>
           </a:p>
         </p:txBody>
       </p:sp>
@@ -9644,164 +9579,29 @@
       </p:pic>
       <p:sp>
         <p:nvSpPr>
-          <p:cNvPr id="17" name="slide-title">
-            <a:extLst>
-              <a:ext uri="{FF2B5EF4-FFF2-40B4-BE49-F238E27FC236}">
-                <a16:creationId xmlns:a16="http://schemas.microsoft.com/office/drawing/2014/main" id="{B94511CE-68DE-4BF9-98FC-216466D2C497}"/>
-              </a:ext>
-            </a:extLst>
-          </p:cNvPr>
-          <p:cNvSpPr>
-            <a:spLocks noGrp="1"/>
-          </p:cNvSpPr>
-          <p:nvPr/>
-        </p:nvSpPr>
-        <p:spPr>
-          <a:xfrm>
-            <a:off x="476250" y="333375"/>
-            <a:ext cx="11239500" cy="714375"/>
-          </a:xfrm>
-          <a:prstGeom prst="rect">
-            <a:avLst/>
-          </a:prstGeom>
-          <a:noFill/>
-          <a:ln w="0">
-            <a:noFill/>
-            <a:prstDash val="solid"/>
-          </a:ln>
-        </p:spPr>
-        <p:txBody>
-          <a:bodyPr anchor="ctr"/>
-          <a:lstStyle/>
-          <a:p>
-            <a:pPr algn="l">
-              <a:defRPr sz="2850" b="0">
-                <a:solidFill>
-                  <a:srgbClr val="2D3F4B"/>
-                </a:solidFill>
-                <a:latin typeface="Arial"/>
-                <a:ea typeface="Arial"/>
-                <a:cs typeface="Arial"/>
-              </a:defRPr>
-            </a:pPr>
-            <a:r>
-              <a:rPr sz="2850" b="0" dirty="0">
-                <a:solidFill>
-                  <a:srgbClr val="2D3F4B"/>
-                </a:solidFill>
-                <a:latin typeface="Arial"/>
-                <a:ea typeface="Arial"/>
-                <a:cs typeface="Arial"/>
-              </a:rPr>
-              <a:t>Reranking </a:t>
-            </a:r>
-            <a:r>
-              <a:rPr sz="2850" b="0" dirty="0" err="1">
-                <a:solidFill>
-                  <a:srgbClr val="2D3F4B"/>
-                </a:solidFill>
-                <a:latin typeface="Arial"/>
-                <a:ea typeface="Arial"/>
-                <a:cs typeface="Arial"/>
-              </a:rPr>
-              <a:t>sortiert</a:t>
-            </a:r>
-            <a:r>
-              <a:rPr sz="2850" b="0" dirty="0">
-                <a:solidFill>
-                  <a:srgbClr val="2D3F4B"/>
-                </a:solidFill>
-                <a:latin typeface="Arial"/>
-                <a:ea typeface="Arial"/>
-                <a:cs typeface="Arial"/>
-              </a:rPr>
-              <a:t> </a:t>
-            </a:r>
-            <a:r>
-              <a:rPr sz="2850" b="0" dirty="0" err="1">
-                <a:solidFill>
-                  <a:srgbClr val="2D3F4B"/>
-                </a:solidFill>
-                <a:latin typeface="Arial"/>
-                <a:ea typeface="Arial"/>
-                <a:cs typeface="Arial"/>
-              </a:rPr>
-              <a:t>Kandidaten</a:t>
-            </a:r>
-            <a:r>
-              <a:rPr sz="2850" b="0" dirty="0">
-                <a:solidFill>
-                  <a:srgbClr val="2D3F4B"/>
-                </a:solidFill>
-                <a:latin typeface="Arial"/>
-                <a:ea typeface="Arial"/>
-                <a:cs typeface="Arial"/>
-              </a:rPr>
-              <a:t> – es </a:t>
-            </a:r>
-            <a:r>
-              <a:rPr sz="2850" b="0" dirty="0" err="1">
-                <a:solidFill>
-                  <a:srgbClr val="2D3F4B"/>
-                </a:solidFill>
-                <a:latin typeface="Arial"/>
-                <a:ea typeface="Arial"/>
-                <a:cs typeface="Arial"/>
-              </a:rPr>
-              <a:t>findet</a:t>
-            </a:r>
-            <a:r>
-              <a:rPr sz="2850" b="0" dirty="0">
-                <a:solidFill>
-                  <a:srgbClr val="2D3F4B"/>
-                </a:solidFill>
-                <a:latin typeface="Arial"/>
-                <a:ea typeface="Arial"/>
-                <a:cs typeface="Arial"/>
-              </a:rPr>
-              <a:t> </a:t>
-            </a:r>
-            <a:r>
-              <a:rPr sz="2850" b="0" dirty="0" err="1">
-                <a:solidFill>
-                  <a:srgbClr val="2D3F4B"/>
-                </a:solidFill>
-                <a:latin typeface="Arial"/>
-                <a:ea typeface="Arial"/>
-                <a:cs typeface="Arial"/>
-              </a:rPr>
-              <a:t>keine</a:t>
-            </a:r>
-            <a:r>
-              <a:rPr sz="2850" b="0" dirty="0">
-                <a:solidFill>
-                  <a:srgbClr val="2D3F4B"/>
-                </a:solidFill>
-                <a:latin typeface="Arial"/>
-                <a:ea typeface="Arial"/>
-                <a:cs typeface="Arial"/>
-              </a:rPr>
-              <a:t> </a:t>
-            </a:r>
-            <a:r>
-              <a:rPr sz="2850" b="0" dirty="0" err="1">
-                <a:solidFill>
-                  <a:srgbClr val="2D3F4B"/>
-                </a:solidFill>
-                <a:latin typeface="Arial"/>
-                <a:ea typeface="Arial"/>
-                <a:cs typeface="Arial"/>
-              </a:rPr>
-              <a:t>neuen</a:t>
-            </a:r>
-            <a:endParaRPr sz="2850" b="0" dirty="0">
-              <a:solidFill>
-                <a:srgbClr val="2D3F4B"/>
-              </a:solidFill>
-              <a:latin typeface="Arial"/>
-              <a:ea typeface="Arial"/>
-              <a:cs typeface="Arial"/>
-            </a:endParaRPr>
+          <p:cNvPr id="68" name="Titel 1"/>
+          <p:cNvSpPr>
+            <a:spLocks noGrp="1"/>
+          </p:cNvSpPr>
+          <p:nvPr>
+            <p:ph type="title"/>
+          </p:nvPr>
+        </p:nvSpPr>
+        <p:spPr>
+          <a:xfrm>
+            <a:off x="482461" y="346633"/>
+            <a:ext cx="11230114" cy="767605"/>
+          </a:xfrm>
+        </p:spPr>
+        <p:txBody>
+          <a:bodyPr/>
+          <a:lstStyle/>
+          <a:p>
+            <a:r>
+              <a:rPr lang="de-CH" dirty="0" sz="3600"/>
+              <a:t>Reranking sortiert Kandidaten – es findet keine neuen</a:t>
+            </a:r>
+            <a:endParaRPr lang="de-CH" dirty="0" sz="3600"/>
           </a:p>
         </p:txBody>
       </p:sp>
@@ -15933,131 +15733,29 @@
       </p:sp>
       <p:sp>
         <p:nvSpPr>
-          <p:cNvPr id="47" name="slide-title">
-            <a:extLst>
-              <a:ext uri="{FF2B5EF4-FFF2-40B4-BE49-F238E27FC236}">
-                <a16:creationId xmlns:a16="http://schemas.microsoft.com/office/drawing/2014/main" id="{C2984923-51DE-0413-B15B-2A1630DEB66E}"/>
-              </a:ext>
-            </a:extLst>
-          </p:cNvPr>
-          <p:cNvSpPr>
-            <a:spLocks noGrp="1"/>
-          </p:cNvSpPr>
-          <p:nvPr/>
-        </p:nvSpPr>
-        <p:spPr>
-          <a:xfrm>
-            <a:off x="476250" y="333375"/>
-            <a:ext cx="11239500" cy="714375"/>
-          </a:xfrm>
-          <a:prstGeom prst="rect">
-            <a:avLst/>
-          </a:prstGeom>
-          <a:noFill/>
-          <a:ln w="0">
-            <a:noFill/>
-            <a:prstDash val="solid"/>
-          </a:ln>
-        </p:spPr>
-        <p:txBody>
-          <a:bodyPr anchor="ctr"/>
-          <a:lstStyle/>
-          <a:p>
-            <a:pPr algn="l">
-              <a:defRPr sz="2850" b="0">
-                <a:solidFill>
-                  <a:srgbClr val="2D3F4B"/>
-                </a:solidFill>
-                <a:latin typeface="Arial"/>
-                <a:ea typeface="Arial"/>
-                <a:cs typeface="Arial"/>
-              </a:defRPr>
-            </a:pPr>
-            <a:r>
-              <a:rPr sz="2850" b="0" dirty="0" err="1">
-                <a:solidFill>
-                  <a:srgbClr val="2D3F4B"/>
-                </a:solidFill>
-                <a:latin typeface="Arial"/>
-                <a:ea typeface="Arial"/>
-                <a:cs typeface="Arial"/>
-              </a:rPr>
-              <a:t>GraphRAG</a:t>
-            </a:r>
-            <a:r>
-              <a:rPr sz="2850" b="0" dirty="0">
-                <a:solidFill>
-                  <a:srgbClr val="2D3F4B"/>
-                </a:solidFill>
-                <a:latin typeface="Arial"/>
-                <a:ea typeface="Arial"/>
-                <a:cs typeface="Arial"/>
-              </a:rPr>
-              <a:t> </a:t>
-            </a:r>
-            <a:r>
-              <a:rPr sz="2850" b="0" dirty="0" err="1">
-                <a:solidFill>
-                  <a:srgbClr val="2D3F4B"/>
-                </a:solidFill>
-                <a:latin typeface="Arial"/>
-                <a:ea typeface="Arial"/>
-                <a:cs typeface="Arial"/>
-              </a:rPr>
-              <a:t>verbindet</a:t>
-            </a:r>
-            <a:r>
-              <a:rPr sz="2850" b="0" dirty="0">
-                <a:solidFill>
-                  <a:srgbClr val="2D3F4B"/>
-                </a:solidFill>
-                <a:latin typeface="Arial"/>
-                <a:ea typeface="Arial"/>
-                <a:cs typeface="Arial"/>
-              </a:rPr>
-              <a:t> </a:t>
-            </a:r>
-            <a:r>
-              <a:rPr sz="2850" b="0" dirty="0" err="1">
-                <a:solidFill>
-                  <a:srgbClr val="2D3F4B"/>
-                </a:solidFill>
-                <a:latin typeface="Arial"/>
-                <a:ea typeface="Arial"/>
-                <a:cs typeface="Arial"/>
-              </a:rPr>
-              <a:t>mehrere</a:t>
-            </a:r>
-            <a:r>
-              <a:rPr sz="2850" b="0" dirty="0">
-                <a:solidFill>
-                  <a:srgbClr val="2D3F4B"/>
-                </a:solidFill>
-                <a:latin typeface="Arial"/>
-                <a:ea typeface="Arial"/>
-                <a:cs typeface="Arial"/>
-              </a:rPr>
-              <a:t> </a:t>
-            </a:r>
-            <a:r>
-              <a:rPr sz="2850" b="0" dirty="0" err="1">
-                <a:solidFill>
-                  <a:srgbClr val="2D3F4B"/>
-                </a:solidFill>
-                <a:latin typeface="Arial"/>
-                <a:ea typeface="Arial"/>
-                <a:cs typeface="Arial"/>
-              </a:rPr>
-              <a:t>Suchsignale</a:t>
-            </a:r>
-            <a:endParaRPr sz="2850" b="0" dirty="0">
-              <a:solidFill>
-                <a:srgbClr val="2D3F4B"/>
-              </a:solidFill>
-              <a:latin typeface="Arial"/>
-              <a:ea typeface="Arial"/>
-              <a:cs typeface="Arial"/>
-            </a:endParaRPr>
+          <p:cNvPr id="48" name="Titel 1"/>
+          <p:cNvSpPr>
+            <a:spLocks noGrp="1"/>
+          </p:cNvSpPr>
+          <p:nvPr>
+            <p:ph type="title"/>
+          </p:nvPr>
+        </p:nvSpPr>
+        <p:spPr>
+          <a:xfrm>
+            <a:off x="482461" y="346633"/>
+            <a:ext cx="11230114" cy="767605"/>
+          </a:xfrm>
+        </p:spPr>
+        <p:txBody>
+          <a:bodyPr/>
+          <a:lstStyle/>
+          <a:p>
+            <a:r>
+              <a:rPr lang="de-CH" dirty="0" sz="3600"/>
+              <a:t>GraphRAG verbindet mehrere Suchsignale</a:t>
+            </a:r>
+            <a:endParaRPr lang="de-CH" dirty="0" sz="3600"/>
           </a:p>
         </p:txBody>
       </p:sp>
@@ -20125,143 +19823,29 @@
       </p:sp>
       <p:sp>
         <p:nvSpPr>
-          <p:cNvPr id="132" name="slide-title">
-            <a:extLst>
-              <a:ext uri="{FF2B5EF4-FFF2-40B4-BE49-F238E27FC236}">
-                <a16:creationId xmlns:a16="http://schemas.microsoft.com/office/drawing/2014/main" id="{239C4669-0BE9-772E-98E4-69BE8C283166}"/>
-              </a:ext>
-            </a:extLst>
-          </p:cNvPr>
-          <p:cNvSpPr>
-            <a:spLocks noGrp="1"/>
-          </p:cNvSpPr>
-          <p:nvPr/>
-        </p:nvSpPr>
-        <p:spPr>
-          <a:xfrm>
-            <a:off x="476250" y="333375"/>
-            <a:ext cx="11239500" cy="714375"/>
-          </a:xfrm>
-          <a:prstGeom prst="rect">
-            <a:avLst/>
-          </a:prstGeom>
-          <a:noFill/>
-          <a:ln w="0">
-            <a:noFill/>
-            <a:prstDash val="solid"/>
-          </a:ln>
-        </p:spPr>
-        <p:txBody>
-          <a:bodyPr anchor="ctr"/>
-          <a:lstStyle/>
-          <a:p>
-            <a:pPr algn="l">
-              <a:buNone/>
-              <a:defRPr sz="2850" b="0">
-                <a:solidFill>
-                  <a:srgbClr val="2D3F4B"/>
-                </a:solidFill>
-                <a:latin typeface="Arial"/>
-                <a:ea typeface="Arial"/>
-                <a:cs typeface="Arial"/>
-              </a:defRPr>
-            </a:pPr>
-            <a:r>
-              <a:rPr lang="de-DE" sz="2850" b="0" dirty="0">
-                <a:solidFill>
-                  <a:srgbClr val="2D3F4B"/>
-                </a:solidFill>
-                <a:latin typeface="Arial"/>
-                <a:ea typeface="Arial"/>
-                <a:cs typeface="Arial"/>
-              </a:rPr>
-              <a:t>Hybrider </a:t>
-            </a:r>
-            <a:r>
-              <a:rPr sz="2850" b="0" dirty="0" err="1">
-                <a:solidFill>
-                  <a:srgbClr val="2D3F4B"/>
-                </a:solidFill>
-                <a:latin typeface="Arial"/>
-                <a:ea typeface="Arial"/>
-                <a:cs typeface="Arial"/>
-              </a:rPr>
-              <a:t>GraphRAG</a:t>
-            </a:r>
-            <a:r>
-              <a:rPr sz="2850" b="0" dirty="0">
-                <a:solidFill>
-                  <a:srgbClr val="2D3F4B"/>
-                </a:solidFill>
-                <a:latin typeface="Arial"/>
-                <a:ea typeface="Arial"/>
-                <a:cs typeface="Arial"/>
-              </a:rPr>
-              <a:t> </a:t>
-            </a:r>
-            <a:r>
-              <a:rPr sz="2850" b="0" dirty="0" err="1">
-                <a:solidFill>
-                  <a:srgbClr val="2D3F4B"/>
-                </a:solidFill>
-                <a:latin typeface="Arial"/>
-                <a:ea typeface="Arial"/>
-                <a:cs typeface="Arial"/>
-              </a:rPr>
-              <a:t>verbindet</a:t>
-            </a:r>
-            <a:r>
-              <a:rPr sz="2850" b="0" dirty="0">
-                <a:solidFill>
-                  <a:srgbClr val="2D3F4B"/>
-                </a:solidFill>
-                <a:latin typeface="Arial"/>
-                <a:ea typeface="Arial"/>
-                <a:cs typeface="Arial"/>
-              </a:rPr>
-              <a:t> </a:t>
-            </a:r>
-            <a:r>
-              <a:rPr sz="2850" b="0" dirty="0" err="1">
-                <a:solidFill>
-                  <a:srgbClr val="2D3F4B"/>
-                </a:solidFill>
-                <a:latin typeface="Arial"/>
-                <a:ea typeface="Arial"/>
-                <a:cs typeface="Arial"/>
-              </a:rPr>
-              <a:t>mehrere</a:t>
-            </a:r>
-            <a:r>
-              <a:rPr sz="2850" b="0" dirty="0">
-                <a:solidFill>
-                  <a:srgbClr val="2D3F4B"/>
-                </a:solidFill>
-                <a:latin typeface="Arial"/>
-                <a:ea typeface="Arial"/>
-                <a:cs typeface="Arial"/>
-              </a:rPr>
-              <a:t> </a:t>
-            </a:r>
-            <a:r>
-              <a:rPr sz="2850" b="0" dirty="0" err="1">
-                <a:solidFill>
-                  <a:srgbClr val="2D3F4B"/>
-                </a:solidFill>
-                <a:latin typeface="Arial"/>
-                <a:ea typeface="Arial"/>
-                <a:cs typeface="Arial"/>
-              </a:rPr>
-              <a:t>Suchsignale</a:t>
-            </a:r>
-            <a:endParaRPr sz="2850" b="0" dirty="0">
-              <a:solidFill>
-                <a:srgbClr val="2D3F4B"/>
-              </a:solidFill>
-              <a:latin typeface="Arial"/>
-              <a:ea typeface="Arial"/>
-              <a:cs typeface="Arial"/>
-            </a:endParaRPr>
+          <p:cNvPr id="133" name="Titel 1"/>
+          <p:cNvSpPr>
+            <a:spLocks noGrp="1"/>
+          </p:cNvSpPr>
+          <p:nvPr>
+            <p:ph type="title"/>
+          </p:nvPr>
+        </p:nvSpPr>
+        <p:spPr>
+          <a:xfrm>
+            <a:off x="482461" y="346633"/>
+            <a:ext cx="11230114" cy="767605"/>
+          </a:xfrm>
+        </p:spPr>
+        <p:txBody>
+          <a:bodyPr/>
+          <a:lstStyle/>
+          <a:p>
+            <a:r>
+              <a:rPr lang="de-CH" dirty="0" sz="3600"/>
+              <a:t>Hybrider GraphRAG verbindet mehrere Suchsignale</a:t>
+            </a:r>
+            <a:endParaRPr lang="de-CH" dirty="0" sz="3600"/>
           </a:p>
         </p:txBody>
       </p:sp>
@@ -22337,198 +21921,29 @@
       </p:grpSpPr>
       <p:sp>
         <p:nvSpPr>
-          <p:cNvPr id="2" name="slide-title">
-            <a:extLst>
-              <a:ext uri="{FF2B5EF4-FFF2-40B4-BE49-F238E27FC236}">
-                <a16:creationId xmlns:a16="http://schemas.microsoft.com/office/drawing/2014/main" id="{081F6242-4B33-4F6E-ABF2-96C4D73D1765}"/>
-              </a:ext>
-            </a:extLst>
-          </p:cNvPr>
-          <p:cNvSpPr>
-            <a:spLocks noGrp="1"/>
-          </p:cNvSpPr>
-          <p:nvPr/>
-        </p:nvSpPr>
-        <p:spPr>
-          <a:xfrm>
-            <a:off x="476250" y="333375"/>
-            <a:ext cx="11239500" cy="714375"/>
-          </a:xfrm>
-          <a:prstGeom prst="rect">
-            <a:avLst/>
-          </a:prstGeom>
-          <a:noFill/>
-          <a:ln w="0">
-            <a:noFill/>
-            <a:prstDash val="solid"/>
-          </a:ln>
-        </p:spPr>
-        <p:txBody>
-          <a:bodyPr anchor="ctr"/>
-          <a:lstStyle/>
-          <a:p>
-            <a:pPr algn="l">
-              <a:buNone/>
-              <a:defRPr sz="2850" b="0">
-                <a:solidFill>
-                  <a:srgbClr val="2D3F4B"/>
-                </a:solidFill>
-                <a:latin typeface="Arial"/>
-                <a:ea typeface="Arial"/>
-                <a:cs typeface="Arial"/>
-              </a:defRPr>
-            </a:pPr>
-            <a:r>
-              <a:rPr sz="2850" b="0" dirty="0" err="1">
-                <a:solidFill>
-                  <a:srgbClr val="2D3F4B"/>
-                </a:solidFill>
-                <a:latin typeface="Arial"/>
-                <a:ea typeface="Arial"/>
-                <a:cs typeface="Arial"/>
-              </a:rPr>
-              <a:t>Besseres</a:t>
-            </a:r>
-            <a:r>
-              <a:rPr sz="2850" b="0" dirty="0">
-                <a:solidFill>
-                  <a:srgbClr val="2D3F4B"/>
-                </a:solidFill>
-                <a:latin typeface="Arial"/>
-                <a:ea typeface="Arial"/>
-                <a:cs typeface="Arial"/>
-              </a:rPr>
-              <a:t> Retrieval </a:t>
-            </a:r>
-            <a:r>
-              <a:rPr sz="2850" b="0" dirty="0" err="1">
-                <a:solidFill>
-                  <a:srgbClr val="2D3F4B"/>
-                </a:solidFill>
-                <a:latin typeface="Arial"/>
-                <a:ea typeface="Arial"/>
-                <a:cs typeface="Arial"/>
-              </a:rPr>
-              <a:t>verbessert</a:t>
-            </a:r>
-            <a:r>
-              <a:rPr sz="2850" b="0" dirty="0">
-                <a:solidFill>
-                  <a:srgbClr val="2D3F4B"/>
-                </a:solidFill>
-                <a:latin typeface="Arial"/>
-                <a:ea typeface="Arial"/>
-                <a:cs typeface="Arial"/>
-              </a:rPr>
-              <a:t> </a:t>
-            </a:r>
-            <a:r>
-              <a:rPr sz="2850" b="0" dirty="0" err="1">
-                <a:solidFill>
-                  <a:srgbClr val="2D3F4B"/>
-                </a:solidFill>
-                <a:latin typeface="Arial"/>
-                <a:ea typeface="Arial"/>
-                <a:cs typeface="Arial"/>
-              </a:rPr>
-              <a:t>Antworten</a:t>
-            </a:r>
-            <a:r>
-              <a:rPr sz="2850" b="0" dirty="0">
-                <a:solidFill>
-                  <a:srgbClr val="2D3F4B"/>
-                </a:solidFill>
-                <a:latin typeface="Arial"/>
-                <a:ea typeface="Arial"/>
-                <a:cs typeface="Arial"/>
-              </a:rPr>
-              <a:t> – </a:t>
-            </a:r>
-            <a:r>
-              <a:rPr sz="2850" b="0" dirty="0" err="1">
-                <a:solidFill>
-                  <a:srgbClr val="2D3F4B"/>
-                </a:solidFill>
-                <a:latin typeface="Arial"/>
-                <a:ea typeface="Arial"/>
-                <a:cs typeface="Arial"/>
-              </a:rPr>
-              <a:t>garantiert</a:t>
-            </a:r>
-            <a:r>
-              <a:rPr sz="2850" b="0" dirty="0">
-                <a:solidFill>
-                  <a:srgbClr val="2D3F4B"/>
-                </a:solidFill>
-                <a:latin typeface="Arial"/>
-                <a:ea typeface="Arial"/>
-                <a:cs typeface="Arial"/>
-              </a:rPr>
-              <a:t> </a:t>
-            </a:r>
-            <a:r>
-              <a:rPr sz="2850" b="0" dirty="0" err="1">
-                <a:solidFill>
-                  <a:srgbClr val="2D3F4B"/>
-                </a:solidFill>
-                <a:latin typeface="Arial"/>
-                <a:ea typeface="Arial"/>
-                <a:cs typeface="Arial"/>
-              </a:rPr>
-              <a:t>sie</a:t>
-            </a:r>
-            <a:r>
-              <a:rPr sz="2850" b="0" dirty="0">
-                <a:solidFill>
-                  <a:srgbClr val="2D3F4B"/>
-                </a:solidFill>
-                <a:latin typeface="Arial"/>
-                <a:ea typeface="Arial"/>
-                <a:cs typeface="Arial"/>
-              </a:rPr>
-              <a:t> </a:t>
-            </a:r>
-            <a:r>
-              <a:rPr sz="2850" b="0" dirty="0" err="1">
-                <a:solidFill>
-                  <a:srgbClr val="2D3F4B"/>
-                </a:solidFill>
-                <a:latin typeface="Arial"/>
-                <a:ea typeface="Arial"/>
-                <a:cs typeface="Arial"/>
-              </a:rPr>
-              <a:t>aber</a:t>
-            </a:r>
-            <a:r>
-              <a:rPr sz="2850" b="0" dirty="0">
-                <a:solidFill>
-                  <a:srgbClr val="2D3F4B"/>
-                </a:solidFill>
-                <a:latin typeface="Arial"/>
-                <a:ea typeface="Arial"/>
-                <a:cs typeface="Arial"/>
-              </a:rPr>
-              <a:t> </a:t>
-            </a:r>
-            <a:r>
-              <a:rPr sz="2850" b="0" dirty="0" err="1">
-                <a:solidFill>
-                  <a:srgbClr val="2D3F4B"/>
-                </a:solidFill>
-                <a:latin typeface="Arial"/>
-                <a:ea typeface="Arial"/>
-                <a:cs typeface="Arial"/>
-              </a:rPr>
-              <a:t>nicht</a:t>
-            </a:r>
-            <a:endParaRPr sz="2850" b="0" dirty="0">
-              <a:solidFill>
-                <a:srgbClr val="2D3F4B"/>
-              </a:solidFill>
-              <a:latin typeface="Arial"/>
-              <a:ea typeface="Arial"/>
-              <a:cs typeface="Arial"/>
-            </a:endParaRPr>
+          <p:cNvPr id="35" name="Titel 1"/>
+          <p:cNvSpPr>
+            <a:spLocks noGrp="1"/>
+          </p:cNvSpPr>
+          <p:nvPr>
+            <p:ph type="title"/>
+          </p:nvPr>
+        </p:nvSpPr>
+        <p:spPr>
+          <a:xfrm>
+            <a:off x="482461" y="346633"/>
+            <a:ext cx="11230114" cy="767605"/>
+          </a:xfrm>
+        </p:spPr>
+        <p:txBody>
+          <a:bodyPr/>
+          <a:lstStyle/>
+          <a:p>
+            <a:r>
+              <a:rPr lang="de-CH" dirty="0" sz="2800"/>
+              <a:t>Besseres Retrieval verbessert Antworten – garantiert sie aber nicht</a:t>
+            </a:r>
+            <a:endParaRPr lang="de-CH" dirty="0" sz="2800"/>
           </a:p>
         </p:txBody>
       </p:sp>
@@ -24422,97 +23837,29 @@
       </p:grpSpPr>
       <p:sp>
         <p:nvSpPr>
-          <p:cNvPr id="27" name="clean-canvas">
-            <a:extLst>
-              <a:ext uri="{FF2B5EF4-FFF2-40B4-BE49-F238E27FC236}">
-                <a16:creationId xmlns:a16="http://schemas.microsoft.com/office/drawing/2014/main" id="{AC4D295C-DA35-4948-9A28-42A34DDCB8DC}"/>
-              </a:ext>
-            </a:extLst>
-          </p:cNvPr>
-          <p:cNvSpPr>
-            <a:spLocks noGrp="1"/>
-          </p:cNvSpPr>
-          <p:nvPr/>
-        </p:nvSpPr>
-        <p:spPr>
-          <a:xfrm>
-            <a:off x="0" y="0"/>
-            <a:ext cx="12192000" cy="6096000"/>
-          </a:xfrm>
-          <a:prstGeom prst="rect">
-            <a:avLst/>
-          </a:prstGeom>
-          <a:solidFill>
-            <a:srgbClr val="FFFFFF"/>
-          </a:solidFill>
-          <a:ln w="0">
-            <a:solidFill>
-              <a:srgbClr val="FFFFFF"/>
-            </a:solidFill>
-            <a:prstDash val="solid"/>
-          </a:ln>
+          <p:cNvPr id="28" name="Titel 1"/>
+          <p:cNvSpPr>
+            <a:spLocks noGrp="1"/>
+          </p:cNvSpPr>
+          <p:nvPr>
+            <p:ph type="title"/>
+          </p:nvPr>
+        </p:nvSpPr>
+        <p:spPr>
+          <a:xfrm>
+            <a:off x="482461" y="346633"/>
+            <a:ext cx="11230114" cy="767605"/>
+          </a:xfrm>
         </p:spPr>
         <p:txBody>
           <a:bodyPr/>
           <a:lstStyle/>
           <a:p>
-            <a:endParaRPr lang="de-CH"/>
-          </a:p>
-        </p:txBody>
-      </p:sp>
-      <p:sp>
-        <p:nvSpPr>
-          <p:cNvPr id="2" name="slide-title">
-            <a:extLst>
-              <a:ext uri="{FF2B5EF4-FFF2-40B4-BE49-F238E27FC236}">
-                <a16:creationId xmlns:a16="http://schemas.microsoft.com/office/drawing/2014/main" id="{EBF84E5B-9733-4D1C-891F-87753FEF6200}"/>
-              </a:ext>
-            </a:extLst>
-          </p:cNvPr>
-          <p:cNvSpPr>
-            <a:spLocks noGrp="1"/>
-          </p:cNvSpPr>
-          <p:nvPr/>
-        </p:nvSpPr>
-        <p:spPr>
-          <a:xfrm>
-            <a:off x="476250" y="333375"/>
-            <a:ext cx="11239500" cy="714375"/>
-          </a:xfrm>
-          <a:prstGeom prst="rect">
-            <a:avLst/>
-          </a:prstGeom>
-          <a:noFill/>
-          <a:ln w="0">
-            <a:noFill/>
-            <a:prstDash val="solid"/>
-          </a:ln>
-        </p:spPr>
-        <p:txBody>
-          <a:bodyPr anchor="ctr"/>
-          <a:lstStyle/>
-          <a:p>
-            <a:pPr algn="l">
-              <a:defRPr sz="2850" b="0">
-                <a:solidFill>
-                  <a:srgbClr val="2D3F4B"/>
-                </a:solidFill>
-                <a:latin typeface="Arial"/>
-                <a:ea typeface="Arial"/>
-                <a:cs typeface="Arial"/>
-              </a:defRPr>
-            </a:pPr>
-            <a:r>
-              <a:rPr sz="2850" b="0">
-                <a:solidFill>
-                  <a:srgbClr val="2D3F4B"/>
-                </a:solidFill>
-                <a:latin typeface="Arial"/>
-                <a:ea typeface="Arial"/>
-                <a:cs typeface="Arial"/>
-              </a:rPr>
+            <a:r>
+              <a:rPr lang="de-CH" dirty="0" sz="3600"/>
               <a:t>Wahlmodul: Drei Gruppen, ein gemeinsamer Befund</a:t>
             </a:r>
+            <a:endParaRPr lang="de-CH" dirty="0" sz="3600"/>
           </a:p>
         </p:txBody>
       </p:sp>
@@ -25925,57 +25272,29 @@
       </p:grpSpPr>
       <p:sp>
         <p:nvSpPr>
-          <p:cNvPr id="2" name="slide-title">
-            <a:extLst>
-              <a:ext uri="{FF2B5EF4-FFF2-40B4-BE49-F238E27FC236}">
-                <a16:creationId xmlns:a16="http://schemas.microsoft.com/office/drawing/2014/main" id="{EDAA12F4-DD2B-4E05-B0F5-F6000E07CF9A}"/>
-              </a:ext>
-            </a:extLst>
-          </p:cNvPr>
-          <p:cNvSpPr>
-            <a:spLocks noGrp="1"/>
-          </p:cNvSpPr>
-          <p:nvPr/>
-        </p:nvSpPr>
-        <p:spPr>
-          <a:xfrm>
-            <a:off x="476250" y="333375"/>
-            <a:ext cx="11239500" cy="714375"/>
-          </a:xfrm>
-          <a:prstGeom prst="rect">
-            <a:avLst/>
-          </a:prstGeom>
-          <a:noFill/>
-          <a:ln w="0">
-            <a:noFill/>
-            <a:prstDash val="solid"/>
-          </a:ln>
-        </p:spPr>
-        <p:txBody>
-          <a:bodyPr anchor="ctr"/>
-          <a:lstStyle/>
-          <a:p>
-            <a:pPr algn="l">
-              <a:defRPr sz="2850" b="0">
-                <a:solidFill>
-                  <a:srgbClr val="2D3F4B"/>
-                </a:solidFill>
-                <a:latin typeface="Arial"/>
-                <a:ea typeface="Arial"/>
-                <a:cs typeface="Arial"/>
-              </a:defRPr>
-            </a:pPr>
-            <a:r>
-              <a:rPr sz="2850" b="0">
-                <a:solidFill>
-                  <a:srgbClr val="2D3F4B"/>
-                </a:solidFill>
-                <a:latin typeface="Arial"/>
-                <a:ea typeface="Arial"/>
-                <a:cs typeface="Arial"/>
-              </a:rPr>
+          <p:cNvPr id="27" name="Titel 1"/>
+          <p:cNvSpPr>
+            <a:spLocks noGrp="1"/>
+          </p:cNvSpPr>
+          <p:nvPr>
+            <p:ph type="title"/>
+          </p:nvPr>
+        </p:nvSpPr>
+        <p:spPr>
+          <a:xfrm>
+            <a:off x="482461" y="346633"/>
+            <a:ext cx="11230114" cy="767605"/>
+          </a:xfrm>
+        </p:spPr>
+        <p:txBody>
+          <a:bodyPr/>
+          <a:lstStyle/>
+          <a:p>
+            <a:r>
+              <a:rPr lang="de-CH" dirty="0" sz="3600"/>
               <a:t>Frameworkwahl ist eine Betriebsentscheidung</a:t>
             </a:r>
+            <a:endParaRPr lang="de-CH" dirty="0" sz="3600"/>
           </a:p>
         </p:txBody>
       </p:sp>
@@ -27623,57 +26942,29 @@
       </p:grpSpPr>
       <p:sp>
         <p:nvSpPr>
-          <p:cNvPr id="2" name="slide-title">
-            <a:extLst>
-              <a:ext uri="{FF2B5EF4-FFF2-40B4-BE49-F238E27FC236}">
-                <a16:creationId xmlns:a16="http://schemas.microsoft.com/office/drawing/2014/main" id="{4EA02B6D-B5AD-492C-AC7D-DA36712DCA39}"/>
-              </a:ext>
-            </a:extLst>
-          </p:cNvPr>
-          <p:cNvSpPr>
-            <a:spLocks noGrp="1"/>
-          </p:cNvSpPr>
-          <p:nvPr/>
-        </p:nvSpPr>
-        <p:spPr>
-          <a:xfrm>
-            <a:off x="476250" y="333375"/>
-            <a:ext cx="11239500" cy="714375"/>
-          </a:xfrm>
-          <a:prstGeom prst="rect">
-            <a:avLst/>
-          </a:prstGeom>
-          <a:noFill/>
-          <a:ln w="0">
-            <a:noFill/>
-            <a:prstDash val="solid"/>
-          </a:ln>
-        </p:spPr>
-        <p:txBody>
-          <a:bodyPr anchor="ctr"/>
-          <a:lstStyle/>
-          <a:p>
-            <a:pPr algn="l">
-              <a:defRPr sz="2850" b="0">
-                <a:solidFill>
-                  <a:srgbClr val="2D3F4B"/>
-                </a:solidFill>
-                <a:latin typeface="Arial"/>
-                <a:ea typeface="Arial"/>
-                <a:cs typeface="Arial"/>
-              </a:defRPr>
-            </a:pPr>
-            <a:r>
-              <a:rPr lang="de-DE" sz="2850" b="0" noProof="0" dirty="0">
-                <a:solidFill>
-                  <a:srgbClr val="2D3F4B"/>
-                </a:solidFill>
-                <a:latin typeface="Arial"/>
-                <a:ea typeface="Arial"/>
-                <a:cs typeface="Arial"/>
-              </a:rPr>
+          <p:cNvPr id="20" name="Titel 1"/>
+          <p:cNvSpPr>
+            <a:spLocks noGrp="1"/>
+          </p:cNvSpPr>
+          <p:nvPr>
+            <p:ph type="title"/>
+          </p:nvPr>
+        </p:nvSpPr>
+        <p:spPr>
+          <a:xfrm>
+            <a:off x="482461" y="346633"/>
+            <a:ext cx="11230114" cy="767605"/>
+          </a:xfrm>
+        </p:spPr>
+        <p:txBody>
+          <a:bodyPr/>
+          <a:lstStyle/>
+          <a:p>
+            <a:r>
+              <a:rPr lang="de-CH" dirty="0" sz="3600"/>
               <a:t>Drei Leitlinien für gutes RAG</a:t>
             </a:r>
+            <a:endParaRPr lang="de-CH" dirty="0" sz="3600"/>
           </a:p>
         </p:txBody>
       </p:sp>
@@ -39571,9 +38862,9 @@
                 <a:solidFill>
                   <a:srgbClr val="000000"/>
                 </a:solidFill>
-                <a:latin typeface="Helvetica Neue"/>
-                <a:ea typeface="Helvetica Neue"/>
-                <a:cs typeface="Helvetica Neue"/>
+                <a:latin typeface="Arial"/>
+                <a:ea typeface="Arial"/>
+                <a:cs typeface="Arial"/>
               </a:defRPr>
             </a:pPr>
             <a:r>
@@ -39587,9 +38878,9 @@
                 <a:solidFill>
                   <a:srgbClr val="000000"/>
                 </a:solidFill>
-                <a:latin typeface="Helvetica Neue"/>
-                <a:ea typeface="Helvetica Neue"/>
-                <a:cs typeface="Helvetica Neue"/>
+                <a:latin typeface="Arial"/>
+                <a:ea typeface="Arial"/>
+                <a:cs typeface="Arial"/>
               </a:defRPr>
             </a:pPr>
             <a:r>
@@ -39631,9 +38922,9 @@
                 <a:solidFill>
                   <a:srgbClr val="000000"/>
                 </a:solidFill>
-                <a:latin typeface="Helvetica Neue"/>
-                <a:ea typeface="Helvetica Neue"/>
-                <a:cs typeface="Helvetica Neue"/>
+                <a:latin typeface="Arial"/>
+                <a:ea typeface="Arial"/>
+                <a:cs typeface="Arial"/>
               </a:defRPr>
             </a:pPr>
             <a:r>
@@ -39647,9 +38938,9 @@
                 <a:solidFill>
                   <a:srgbClr val="000000"/>
                 </a:solidFill>
-                <a:latin typeface="Helvetica Neue"/>
-                <a:ea typeface="Helvetica Neue"/>
-                <a:cs typeface="Helvetica Neue"/>
+                <a:latin typeface="Arial"/>
+                <a:ea typeface="Arial"/>
+                <a:cs typeface="Arial"/>
               </a:defRPr>
             </a:pPr>
             <a:r>
@@ -39693,9 +38984,9 @@
                 <a:solidFill>
                   <a:srgbClr val="000000"/>
                 </a:solidFill>
-                <a:latin typeface="Helvetica Neue"/>
-                <a:ea typeface="Helvetica Neue"/>
-                <a:cs typeface="Helvetica Neue"/>
+                <a:latin typeface="Arial"/>
+                <a:ea typeface="Arial"/>
+                <a:cs typeface="Arial"/>
               </a:defRPr>
             </a:pPr>
             <a:r>
@@ -39709,9 +39000,9 @@
                 <a:solidFill>
                   <a:srgbClr val="000000"/>
                 </a:solidFill>
-                <a:latin typeface="Helvetica Neue"/>
-                <a:ea typeface="Helvetica Neue"/>
-                <a:cs typeface="Helvetica Neue"/>
+                <a:latin typeface="Arial"/>
+                <a:ea typeface="Arial"/>
+                <a:cs typeface="Arial"/>
               </a:defRPr>
             </a:pPr>
             <a:r>
@@ -39755,9 +39046,9 @@
                 <a:solidFill>
                   <a:srgbClr val="000000"/>
                 </a:solidFill>
-                <a:latin typeface="Helvetica Neue"/>
-                <a:ea typeface="Helvetica Neue"/>
-                <a:cs typeface="Helvetica Neue"/>
+                <a:latin typeface="Arial"/>
+                <a:ea typeface="Arial"/>
+                <a:cs typeface="Arial"/>
               </a:defRPr>
             </a:pPr>
             <a:r>
@@ -39771,9 +39062,9 @@
                 <a:solidFill>
                   <a:srgbClr val="000000"/>
                 </a:solidFill>
-                <a:latin typeface="Helvetica Neue"/>
-                <a:ea typeface="Helvetica Neue"/>
-                <a:cs typeface="Helvetica Neue"/>
+                <a:latin typeface="Arial"/>
+                <a:ea typeface="Arial"/>
+                <a:cs typeface="Arial"/>
               </a:defRPr>
             </a:pPr>
             <a:r>

</xml_diff>

<commit_message>
Phase 2: snap all slide content onto a 5 mm grid
Positions of all top-level content shapes rounded to the 5 mm grid on
every slide; sizes too for shapes of 15 mm or larger, while small
decorations, pictures and group interiors keep their dimensions.
Docked connectors are recomputed from the connection sites after the
snap. Placeholders and the corporate master remain untouched. The
focus deck is rebuilt from the snapped overview slide.

Co-Authored-By: Claude Fable 5 <noreply@anthropic.com>
Claude-Session: https://claude.ai/code/session_01S2kGP2buE2HmxMttD3XczR
</commit_message>
<xml_diff>
--- a/RAG_Workshop.pptx
+++ b/RAG_Workshop.pptx
@@ -6499,8 +6499,8 @@
         </p:nvSpPr>
         <p:spPr>
           <a:xfrm>
-            <a:off x="498765" y="3660815"/>
-            <a:ext cx="6148215" cy="971475"/>
+            <a:off x="540000" y="3600000"/>
+            <a:ext cx="6120000" cy="900000"/>
           </a:xfrm>
           <a:prstGeom prst="rect">
             <a:avLst/>
@@ -7220,7 +7220,7 @@
         </p:nvSpPr>
         <p:spPr>
           <a:xfrm>
-            <a:off x="571500" y="1181100"/>
+            <a:off x="540000" y="1260000"/>
             <a:ext cx="8096250" cy="304800"/>
           </a:xfrm>
           <a:prstGeom prst="rect">
@@ -7302,7 +7302,7 @@
         </p:nvSpPr>
         <p:spPr>
           <a:xfrm>
-            <a:off x="571500" y="1724025"/>
+            <a:off x="540000" y="1800000"/>
             <a:ext cx="2667000" cy="266700"/>
           </a:xfrm>
           <a:prstGeom prst="rect">
@@ -7352,7 +7352,7 @@
         </p:nvSpPr>
         <p:spPr>
           <a:xfrm>
-            <a:off x="571500" y="1981200"/>
+            <a:off x="540000" y="1980000"/>
             <a:ext cx="2667000" cy="228600"/>
           </a:xfrm>
           <a:prstGeom prst="rect">
@@ -7415,7 +7415,7 @@
         </p:nvSpPr>
         <p:spPr>
           <a:xfrm>
-            <a:off x="6305550" y="1724025"/>
+            <a:off x="6300000" y="1800000"/>
             <a:ext cx="3238500" cy="266700"/>
           </a:xfrm>
           <a:prstGeom prst="rect">
@@ -7465,7 +7465,7 @@
         </p:nvSpPr>
         <p:spPr>
           <a:xfrm>
-            <a:off x="6305550" y="1981200"/>
+            <a:off x="6300000" y="1980000"/>
             <a:ext cx="4572000" cy="228600"/>
           </a:xfrm>
           <a:prstGeom prst="rect">
@@ -7592,8 +7592,8 @@
         </p:nvSpPr>
         <p:spPr>
           <a:xfrm>
-            <a:off x="552450" y="2343150"/>
-            <a:ext cx="5200650" cy="2857500"/>
+            <a:off x="540000" y="2340000"/>
+            <a:ext cx="5220000" cy="2880000"/>
           </a:xfrm>
           <a:prstGeom prst="roundRect">
             <a:avLst>
@@ -7634,8 +7634,8 @@
         </p:nvSpPr>
         <p:spPr>
           <a:xfrm>
-            <a:off x="6305550" y="2343150"/>
-            <a:ext cx="5334000" cy="2857500"/>
+            <a:off x="6300000" y="2340000"/>
+            <a:ext cx="5400000" cy="2880000"/>
           </a:xfrm>
           <a:prstGeom prst="roundRect">
             <a:avLst>
@@ -7676,7 +7676,7 @@
         </p:nvSpPr>
         <p:spPr>
           <a:xfrm>
-            <a:off x="800100" y="2552700"/>
+            <a:off x="720000" y="2520000"/>
             <a:ext cx="1143000" cy="209550"/>
           </a:xfrm>
           <a:prstGeom prst="rect">
@@ -7726,8 +7726,8 @@
         </p:nvSpPr>
         <p:spPr>
           <a:xfrm>
-            <a:off x="800100" y="2819400"/>
-            <a:ext cx="2114550" cy="1524000"/>
+            <a:off x="720000" y="2880000"/>
+            <a:ext cx="2160000" cy="1440000"/>
           </a:xfrm>
           <a:prstGeom prst="rect">
             <a:avLst/>
@@ -7793,7 +7793,7 @@
         </p:nvSpPr>
         <p:spPr>
           <a:xfrm>
-            <a:off x="3390900" y="2552700"/>
+            <a:off x="3420000" y="2520000"/>
             <a:ext cx="1143000" cy="209550"/>
           </a:xfrm>
           <a:prstGeom prst="rect">
@@ -7843,8 +7843,8 @@
         </p:nvSpPr>
         <p:spPr>
           <a:xfrm>
-            <a:off x="3390900" y="2819400"/>
-            <a:ext cx="1952625" cy="1428750"/>
+            <a:off x="3420000" y="2880000"/>
+            <a:ext cx="1980000" cy="1440000"/>
           </a:xfrm>
           <a:prstGeom prst="rect">
             <a:avLst/>
@@ -7934,7 +7934,7 @@
         </p:nvSpPr>
         <p:spPr>
           <a:xfrm>
-            <a:off x="3133725" y="2571750"/>
+            <a:off x="3060000" y="2520000"/>
             <a:ext cx="0" cy="1790700"/>
           </a:xfrm>
           <a:prstGeom prst="line">
@@ -7972,7 +7972,7 @@
         </p:nvSpPr>
         <p:spPr>
           <a:xfrm>
-            <a:off x="2705100" y="4286250"/>
+            <a:off x="2700000" y="4320000"/>
             <a:ext cx="857250" cy="400050"/>
           </a:xfrm>
           <a:prstGeom prst="rect">
@@ -8039,7 +8039,7 @@
         </p:nvSpPr>
         <p:spPr>
           <a:xfrm>
-            <a:off x="885825" y="4752975"/>
+            <a:off x="900000" y="4680000"/>
             <a:ext cx="4533900" cy="247650"/>
           </a:xfrm>
           <a:prstGeom prst="rect">
@@ -8089,8 +8089,8 @@
         </p:nvSpPr>
         <p:spPr>
           <a:xfrm>
-            <a:off x="6591300" y="2571750"/>
-            <a:ext cx="4762500" cy="1047750"/>
+            <a:off x="6660000" y="2520000"/>
+            <a:ext cx="4680000" cy="1080000"/>
           </a:xfrm>
           <a:prstGeom prst="roundRect">
             <a:avLst>
@@ -8131,7 +8131,7 @@
         </p:nvSpPr>
         <p:spPr>
           <a:xfrm>
-            <a:off x="6819900" y="2724150"/>
+            <a:off x="6840000" y="2700000"/>
             <a:ext cx="1524000" cy="209550"/>
           </a:xfrm>
           <a:prstGeom prst="rect">
@@ -8181,7 +8181,7 @@
         </p:nvSpPr>
         <p:spPr>
           <a:xfrm>
-            <a:off x="6819900" y="2952750"/>
+            <a:off x="6840000" y="2880000"/>
             <a:ext cx="4095750" cy="514350"/>
           </a:xfrm>
           <a:prstGeom prst="rect">
@@ -8325,7 +8325,7 @@
         </p:nvSpPr>
         <p:spPr>
           <a:xfrm>
-            <a:off x="8972550" y="3629025"/>
+            <a:off x="9000000" y="3600000"/>
             <a:ext cx="0" cy="228600"/>
           </a:xfrm>
           <a:prstGeom prst="line">
@@ -8363,7 +8363,7 @@
         </p:nvSpPr>
         <p:spPr>
           <a:xfrm>
-            <a:off x="6819900" y="3876675"/>
+            <a:off x="6840000" y="3960000"/>
             <a:ext cx="4095750" cy="266700"/>
           </a:xfrm>
           <a:prstGeom prst="rect">
@@ -8474,7 +8474,7 @@
         </p:nvSpPr>
         <p:spPr>
           <a:xfrm>
-            <a:off x="8972550" y="4171950"/>
+            <a:off x="9000000" y="4140000"/>
             <a:ext cx="0" cy="171450"/>
           </a:xfrm>
           <a:prstGeom prst="line">
@@ -8512,7 +8512,7 @@
         </p:nvSpPr>
         <p:spPr>
           <a:xfrm>
-            <a:off x="7353300" y="4362450"/>
+            <a:off x="7380000" y="4320000"/>
             <a:ext cx="3238500" cy="457200"/>
           </a:xfrm>
           <a:prstGeom prst="roundRect">
@@ -8554,7 +8554,7 @@
         </p:nvSpPr>
         <p:spPr>
           <a:xfrm>
-            <a:off x="7524750" y="4457700"/>
+            <a:off x="7560000" y="4500000"/>
             <a:ext cx="2895600" cy="247650"/>
           </a:xfrm>
           <a:prstGeom prst="rect">
@@ -8604,8 +8604,8 @@
         </p:nvSpPr>
         <p:spPr>
           <a:xfrm>
-            <a:off x="2095500" y="5467350"/>
-            <a:ext cx="8001000" cy="647700"/>
+            <a:off x="2160000" y="5400000"/>
+            <a:ext cx="7920000" cy="720000"/>
           </a:xfrm>
           <a:prstGeom prst="roundRect">
             <a:avLst>
@@ -8646,7 +8646,7 @@
         </p:nvSpPr>
         <p:spPr>
           <a:xfrm>
-            <a:off x="2381250" y="5600700"/>
+            <a:off x="2340000" y="5580000"/>
             <a:ext cx="7429500" cy="361950"/>
           </a:xfrm>
           <a:prstGeom prst="rect">
@@ -8696,7 +8696,7 @@
         </p:nvSpPr>
         <p:spPr>
           <a:xfrm>
-            <a:off x="533400" y="6448425"/>
+            <a:off x="540000" y="6480000"/>
             <a:ext cx="419100" cy="171450"/>
           </a:xfrm>
           <a:prstGeom prst="rect">
@@ -8746,7 +8746,7 @@
         </p:nvSpPr>
         <p:spPr>
           <a:xfrm>
-            <a:off x="990600" y="6448425"/>
+            <a:off x="1080000" y="6480000"/>
             <a:ext cx="857250" cy="171450"/>
           </a:xfrm>
           <a:prstGeom prst="rect">
@@ -8822,7 +8822,7 @@
         </p:nvGrpSpPr>
         <p:grpSpPr>
           <a:xfrm>
-            <a:off x="885825" y="3992773"/>
+            <a:off x="900000" y="3960000"/>
             <a:ext cx="576530" cy="276225"/>
             <a:chOff x="885825" y="3992773"/>
             <a:chExt cx="576530" cy="276225"/>
@@ -8927,7 +8927,7 @@
         </p:nvGrpSpPr>
         <p:grpSpPr>
           <a:xfrm>
-            <a:off x="3410491" y="3036497"/>
+            <a:off x="3420000" y="3060000"/>
             <a:ext cx="350628" cy="209912"/>
             <a:chOff x="3453621" y="3019245"/>
             <a:chExt cx="350628" cy="209912"/>
@@ -9569,7 +9569,7 @@
         </p:blipFill>
         <p:spPr>
           <a:xfrm>
-            <a:off x="5185617" y="4336553"/>
+            <a:off x="5220000" y="4320000"/>
             <a:ext cx="504056" cy="224739"/>
           </a:xfrm>
           <a:prstGeom prst="rect">
@@ -9621,7 +9621,7 @@
         </p:nvSpPr>
         <p:spPr>
           <a:xfrm>
-            <a:off x="476250" y="1133475"/>
+            <a:off x="540000" y="1080000"/>
             <a:ext cx="11239500" cy="0"/>
           </a:xfrm>
           <a:prstGeom prst="line">
@@ -9658,7 +9658,7 @@
         </p:nvSpPr>
         <p:spPr>
           <a:xfrm>
-            <a:off x="523875" y="1362075"/>
+            <a:off x="540000" y="1440000"/>
             <a:ext cx="11096625" cy="361950"/>
           </a:xfrm>
           <a:prstGeom prst="rect">
@@ -9714,7 +9714,7 @@
         </p:nvSpPr>
         <p:spPr>
           <a:xfrm>
-            <a:off x="476250" y="6353175"/>
+            <a:off x="540000" y="6300000"/>
             <a:ext cx="333375" cy="209550"/>
           </a:xfrm>
           <a:prstGeom prst="rect">
@@ -9770,7 +9770,7 @@
         </p:nvSpPr>
         <p:spPr>
           <a:xfrm>
-            <a:off x="933450" y="6353175"/>
+            <a:off x="900000" y="6300000"/>
             <a:ext cx="857250" cy="209550"/>
           </a:xfrm>
           <a:prstGeom prst="rect">
@@ -9826,7 +9826,7 @@
         </p:nvSpPr>
         <p:spPr>
           <a:xfrm>
-            <a:off x="714375" y="2000250"/>
+            <a:off x="720000" y="1980000"/>
             <a:ext cx="1428750" cy="266700"/>
           </a:xfrm>
           <a:prstGeom prst="rect">
@@ -9882,8 +9882,8 @@
         </p:nvSpPr>
         <p:spPr>
           <a:xfrm>
-            <a:off x="666750" y="2286000"/>
-            <a:ext cx="2238375" cy="781050"/>
+            <a:off x="720000" y="2340000"/>
+            <a:ext cx="2160000" cy="720000"/>
           </a:xfrm>
           <a:prstGeom prst="roundRect">
             <a:avLst>
@@ -9924,7 +9924,7 @@
         </p:nvSpPr>
         <p:spPr>
           <a:xfrm>
-            <a:off x="857250" y="2438400"/>
+            <a:off x="900000" y="2520000"/>
             <a:ext cx="1857375" cy="495300"/>
           </a:xfrm>
           <a:prstGeom prst="rect">
@@ -10003,7 +10003,7 @@
         </p:nvSpPr>
         <p:spPr>
           <a:xfrm>
-            <a:off x="2905125" y="2676525"/>
+            <a:off x="2880000" y="2700000"/>
             <a:ext cx="904875" cy="0"/>
           </a:xfrm>
           <a:prstGeom prst="line">
@@ -10040,7 +10040,7 @@
         </p:nvSpPr>
         <p:spPr>
           <a:xfrm>
-            <a:off x="3905250" y="2000250"/>
+            <a:off x="3960000" y="1980000"/>
             <a:ext cx="2286000" cy="266700"/>
           </a:xfrm>
           <a:prstGeom prst="rect">
@@ -10096,7 +10096,7 @@
         </p:nvSpPr>
         <p:spPr>
           <a:xfrm>
-            <a:off x="3810000" y="2305050"/>
+            <a:off x="3780000" y="2340000"/>
             <a:ext cx="2619375" cy="409575"/>
           </a:xfrm>
           <a:prstGeom prst="roundRect">
@@ -10138,7 +10138,7 @@
         </p:nvSpPr>
         <p:spPr>
           <a:xfrm>
-            <a:off x="3924300" y="2381250"/>
+            <a:off x="3960000" y="2340000"/>
             <a:ext cx="285750" cy="247650"/>
           </a:xfrm>
           <a:prstGeom prst="rect">
@@ -10194,7 +10194,7 @@
         </p:nvSpPr>
         <p:spPr>
           <a:xfrm>
-            <a:off x="4267200" y="2381250"/>
+            <a:off x="4320000" y="2340000"/>
             <a:ext cx="1476375" cy="247650"/>
           </a:xfrm>
           <a:prstGeom prst="rect">
@@ -10250,7 +10250,7 @@
         </p:nvSpPr>
         <p:spPr>
           <a:xfrm>
-            <a:off x="5743575" y="2381250"/>
+            <a:off x="5760000" y="2340000"/>
             <a:ext cx="552450" cy="247650"/>
           </a:xfrm>
           <a:prstGeom prst="rect">
@@ -10306,7 +10306,7 @@
         </p:nvSpPr>
         <p:spPr>
           <a:xfrm>
-            <a:off x="3810000" y="2809875"/>
+            <a:off x="3780000" y="2880000"/>
             <a:ext cx="2619375" cy="409575"/>
           </a:xfrm>
           <a:prstGeom prst="roundRect">
@@ -10348,7 +10348,7 @@
         </p:nvSpPr>
         <p:spPr>
           <a:xfrm>
-            <a:off x="3924300" y="2886075"/>
+            <a:off x="3960000" y="2880000"/>
             <a:ext cx="285750" cy="247650"/>
           </a:xfrm>
           <a:prstGeom prst="rect">
@@ -10404,7 +10404,7 @@
         </p:nvSpPr>
         <p:spPr>
           <a:xfrm>
-            <a:off x="4267200" y="2886075"/>
+            <a:off x="4320000" y="2880000"/>
             <a:ext cx="1476375" cy="247650"/>
           </a:xfrm>
           <a:prstGeom prst="rect">
@@ -10460,7 +10460,7 @@
         </p:nvSpPr>
         <p:spPr>
           <a:xfrm>
-            <a:off x="5743575" y="2886075"/>
+            <a:off x="5760000" y="2880000"/>
             <a:ext cx="552450" cy="247650"/>
           </a:xfrm>
           <a:prstGeom prst="rect">
@@ -10516,7 +10516,7 @@
         </p:nvSpPr>
         <p:spPr>
           <a:xfrm>
-            <a:off x="3810000" y="3314700"/>
+            <a:off x="3780000" y="3240000"/>
             <a:ext cx="2619375" cy="409575"/>
           </a:xfrm>
           <a:prstGeom prst="roundRect">
@@ -10558,7 +10558,7 @@
         </p:nvSpPr>
         <p:spPr>
           <a:xfrm>
-            <a:off x="3924300" y="3390900"/>
+            <a:off x="3960000" y="3420000"/>
             <a:ext cx="285750" cy="247650"/>
           </a:xfrm>
           <a:prstGeom prst="rect">
@@ -10614,7 +10614,7 @@
         </p:nvSpPr>
         <p:spPr>
           <a:xfrm>
-            <a:off x="4267200" y="3390900"/>
+            <a:off x="4320000" y="3420000"/>
             <a:ext cx="1476375" cy="247650"/>
           </a:xfrm>
           <a:prstGeom prst="rect">
@@ -10670,7 +10670,7 @@
         </p:nvSpPr>
         <p:spPr>
           <a:xfrm>
-            <a:off x="5743575" y="3390900"/>
+            <a:off x="5760000" y="3420000"/>
             <a:ext cx="552450" cy="247650"/>
           </a:xfrm>
           <a:prstGeom prst="rect">
@@ -10726,7 +10726,7 @@
         </p:nvSpPr>
         <p:spPr>
           <a:xfrm>
-            <a:off x="3810000" y="3819525"/>
+            <a:off x="3780000" y="3780000"/>
             <a:ext cx="2619375" cy="409575"/>
           </a:xfrm>
           <a:prstGeom prst="roundRect">
@@ -10768,7 +10768,7 @@
         </p:nvSpPr>
         <p:spPr>
           <a:xfrm>
-            <a:off x="3924300" y="3895725"/>
+            <a:off x="3960000" y="3960000"/>
             <a:ext cx="285750" cy="247650"/>
           </a:xfrm>
           <a:prstGeom prst="rect">
@@ -10824,7 +10824,7 @@
         </p:nvSpPr>
         <p:spPr>
           <a:xfrm>
-            <a:off x="4267200" y="3895725"/>
+            <a:off x="4320000" y="3960000"/>
             <a:ext cx="1476375" cy="247650"/>
           </a:xfrm>
           <a:prstGeom prst="rect">
@@ -10891,7 +10891,7 @@
         </p:nvSpPr>
         <p:spPr>
           <a:xfrm>
-            <a:off x="5743575" y="3895725"/>
+            <a:off x="5760000" y="3960000"/>
             <a:ext cx="552450" cy="247650"/>
           </a:xfrm>
           <a:prstGeom prst="rect">
@@ -10927,7 +10927,7 @@
         </p:nvSpPr>
         <p:spPr>
           <a:xfrm>
-            <a:off x="6477000" y="3009900"/>
+            <a:off x="6480000" y="3060000"/>
             <a:ext cx="762000" cy="0"/>
           </a:xfrm>
           <a:prstGeom prst="line">
@@ -10964,8 +10964,8 @@
         </p:nvSpPr>
         <p:spPr>
           <a:xfrm>
-            <a:off x="7239000" y="2628900"/>
-            <a:ext cx="781050" cy="781050"/>
+            <a:off x="7200000" y="2700000"/>
+            <a:ext cx="720000" cy="720000"/>
           </a:xfrm>
           <a:prstGeom prst="ellipse">
             <a:avLst/>
@@ -11021,7 +11021,7 @@
         </p:nvSpPr>
         <p:spPr>
           <a:xfrm>
-            <a:off x="6858000" y="3524250"/>
+            <a:off x="6840000" y="3600000"/>
             <a:ext cx="1571625" cy="228600"/>
           </a:xfrm>
           <a:prstGeom prst="rect">
@@ -11077,7 +11077,7 @@
         </p:nvSpPr>
         <p:spPr>
           <a:xfrm>
-            <a:off x="6858000" y="3810000"/>
+            <a:off x="6840000" y="3780000"/>
             <a:ext cx="1571625" cy="457200"/>
           </a:xfrm>
           <a:prstGeom prst="rect">
@@ -11156,7 +11156,7 @@
         </p:nvSpPr>
         <p:spPr>
           <a:xfrm>
-            <a:off x="8096250" y="3009900"/>
+            <a:off x="8100000" y="3060000"/>
             <a:ext cx="666750" cy="0"/>
           </a:xfrm>
           <a:prstGeom prst="line">
@@ -11193,7 +11193,7 @@
         </p:nvSpPr>
         <p:spPr>
           <a:xfrm>
-            <a:off x="8858250" y="2000250"/>
+            <a:off x="8820000" y="1980000"/>
             <a:ext cx="2381250" cy="266700"/>
           </a:xfrm>
           <a:prstGeom prst="rect">
@@ -11249,7 +11249,7 @@
         </p:nvSpPr>
         <p:spPr>
           <a:xfrm>
-            <a:off x="8763000" y="2305050"/>
+            <a:off x="8820000" y="2340000"/>
             <a:ext cx="2714625" cy="409575"/>
           </a:xfrm>
           <a:prstGeom prst="roundRect">
@@ -11291,7 +11291,7 @@
         </p:nvSpPr>
         <p:spPr>
           <a:xfrm>
-            <a:off x="8877300" y="2381250"/>
+            <a:off x="8820000" y="2340000"/>
             <a:ext cx="285750" cy="247650"/>
           </a:xfrm>
           <a:prstGeom prst="rect">
@@ -11347,7 +11347,7 @@
         </p:nvSpPr>
         <p:spPr>
           <a:xfrm>
-            <a:off x="9220200" y="2381250"/>
+            <a:off x="9180000" y="2340000"/>
             <a:ext cx="1571625" cy="247650"/>
           </a:xfrm>
           <a:prstGeom prst="rect">
@@ -11403,7 +11403,7 @@
         </p:nvSpPr>
         <p:spPr>
           <a:xfrm>
-            <a:off x="10791825" y="2381250"/>
+            <a:off x="10800000" y="2340000"/>
             <a:ext cx="552450" cy="247650"/>
           </a:xfrm>
           <a:prstGeom prst="rect">
@@ -11459,7 +11459,7 @@
         </p:nvSpPr>
         <p:spPr>
           <a:xfrm>
-            <a:off x="8763000" y="2809875"/>
+            <a:off x="8820000" y="2880000"/>
             <a:ext cx="2714625" cy="409575"/>
           </a:xfrm>
           <a:prstGeom prst="roundRect">
@@ -11501,7 +11501,7 @@
         </p:nvSpPr>
         <p:spPr>
           <a:xfrm>
-            <a:off x="8877300" y="2886075"/>
+            <a:off x="8820000" y="2880000"/>
             <a:ext cx="285750" cy="247650"/>
           </a:xfrm>
           <a:prstGeom prst="rect">
@@ -11557,7 +11557,7 @@
         </p:nvSpPr>
         <p:spPr>
           <a:xfrm>
-            <a:off x="9220200" y="2886075"/>
+            <a:off x="9180000" y="2880000"/>
             <a:ext cx="1571625" cy="247650"/>
           </a:xfrm>
           <a:prstGeom prst="rect">
@@ -11613,7 +11613,7 @@
         </p:nvSpPr>
         <p:spPr>
           <a:xfrm>
-            <a:off x="10791825" y="2886075"/>
+            <a:off x="10800000" y="2880000"/>
             <a:ext cx="552450" cy="247650"/>
           </a:xfrm>
           <a:prstGeom prst="rect">
@@ -11669,7 +11669,7 @@
         </p:nvSpPr>
         <p:spPr>
           <a:xfrm>
-            <a:off x="8763000" y="3314700"/>
+            <a:off x="8820000" y="3240000"/>
             <a:ext cx="2714625" cy="409575"/>
           </a:xfrm>
           <a:prstGeom prst="roundRect">
@@ -11711,7 +11711,7 @@
         </p:nvSpPr>
         <p:spPr>
           <a:xfrm>
-            <a:off x="8877300" y="3390900"/>
+            <a:off x="8820000" y="3420000"/>
             <a:ext cx="285750" cy="247650"/>
           </a:xfrm>
           <a:prstGeom prst="rect">
@@ -11767,7 +11767,7 @@
         </p:nvSpPr>
         <p:spPr>
           <a:xfrm>
-            <a:off x="9220200" y="3390900"/>
+            <a:off x="9180000" y="3420000"/>
             <a:ext cx="1571625" cy="247650"/>
           </a:xfrm>
           <a:prstGeom prst="rect">
@@ -11823,7 +11823,7 @@
         </p:nvSpPr>
         <p:spPr>
           <a:xfrm>
-            <a:off x="10791825" y="3390900"/>
+            <a:off x="10800000" y="3420000"/>
             <a:ext cx="552450" cy="247650"/>
           </a:xfrm>
           <a:prstGeom prst="rect">
@@ -11879,7 +11879,7 @@
         </p:nvSpPr>
         <p:spPr>
           <a:xfrm>
-            <a:off x="8763000" y="3819525"/>
+            <a:off x="8820000" y="3780000"/>
             <a:ext cx="2714625" cy="409575"/>
           </a:xfrm>
           <a:prstGeom prst="roundRect">
@@ -11921,7 +11921,7 @@
         </p:nvSpPr>
         <p:spPr>
           <a:xfrm>
-            <a:off x="8877300" y="3895725"/>
+            <a:off x="8820000" y="3960000"/>
             <a:ext cx="285750" cy="247650"/>
           </a:xfrm>
           <a:prstGeom prst="rect">
@@ -11977,7 +11977,7 @@
         </p:nvSpPr>
         <p:spPr>
           <a:xfrm>
-            <a:off x="9220200" y="3895725"/>
+            <a:off x="9180000" y="3960000"/>
             <a:ext cx="1571625" cy="247650"/>
           </a:xfrm>
           <a:prstGeom prst="rect">
@@ -12033,7 +12033,7 @@
         </p:nvSpPr>
         <p:spPr>
           <a:xfrm>
-            <a:off x="10791825" y="3895725"/>
+            <a:off x="10800000" y="3960000"/>
             <a:ext cx="552450" cy="247650"/>
           </a:xfrm>
           <a:prstGeom prst="rect">
@@ -12069,8 +12069,8 @@
         </p:nvSpPr>
         <p:spPr>
           <a:xfrm>
-            <a:off x="2190750" y="4953000"/>
-            <a:ext cx="7810500" cy="762000"/>
+            <a:off x="2160000" y="5040000"/>
+            <a:ext cx="7740000" cy="720000"/>
           </a:xfrm>
           <a:prstGeom prst="roundRect">
             <a:avLst>
@@ -12111,8 +12111,8 @@
         </p:nvSpPr>
         <p:spPr>
           <a:xfrm>
-            <a:off x="2476500" y="5048250"/>
-            <a:ext cx="7239000" cy="590550"/>
+            <a:off x="2520000" y="5040000"/>
+            <a:ext cx="7200000" cy="540000"/>
           </a:xfrm>
           <a:prstGeom prst="rect">
             <a:avLst/>
@@ -12196,7 +12196,7 @@
         </p:blipFill>
         <p:spPr>
           <a:xfrm flipH="1">
-            <a:off x="7337063" y="2714625"/>
+            <a:off x="7380000" y="2700000"/>
             <a:ext cx="584924" cy="593680"/>
           </a:xfrm>
           <a:prstGeom prst="rect">
@@ -13594,7 +13594,7 @@
         </p:nvSpPr>
         <p:spPr>
           <a:xfrm>
-            <a:off x="476250" y="1209674"/>
+            <a:off x="540000" y="1260000"/>
             <a:ext cx="10477500" cy="304800"/>
           </a:xfrm>
           <a:prstGeom prst="rect">
@@ -13644,7 +13644,7 @@
         </p:nvSpPr>
         <p:spPr>
           <a:xfrm>
-            <a:off x="1981200" y="3181350"/>
+            <a:off x="1980000" y="3240000"/>
             <a:ext cx="266700" cy="438150"/>
           </a:xfrm>
           <a:prstGeom prst="chevron">
@@ -13684,7 +13684,7 @@
         </p:nvSpPr>
         <p:spPr>
           <a:xfrm>
-            <a:off x="4914900" y="3181350"/>
+            <a:off x="4860000" y="3240000"/>
             <a:ext cx="266700" cy="438150"/>
           </a:xfrm>
           <a:prstGeom prst="chevron">
@@ -13724,7 +13724,7 @@
         </p:nvSpPr>
         <p:spPr>
           <a:xfrm>
-            <a:off x="6648450" y="3181350"/>
+            <a:off x="6660000" y="3240000"/>
             <a:ext cx="266700" cy="438150"/>
           </a:xfrm>
           <a:prstGeom prst="chevron">
@@ -13764,7 +13764,7 @@
         </p:nvSpPr>
         <p:spPr>
           <a:xfrm>
-            <a:off x="9220200" y="3181350"/>
+            <a:off x="9180000" y="3240000"/>
             <a:ext cx="266700" cy="438150"/>
           </a:xfrm>
           <a:prstGeom prst="chevron">
@@ -13804,7 +13804,7 @@
         </p:nvSpPr>
         <p:spPr>
           <a:xfrm>
-            <a:off x="628650" y="1924050"/>
+            <a:off x="540000" y="1980000"/>
             <a:ext cx="1524000" cy="228600"/>
           </a:xfrm>
           <a:prstGeom prst="rect">
@@ -13854,8 +13854,8 @@
         </p:nvSpPr>
         <p:spPr>
           <a:xfrm>
-            <a:off x="571500" y="2362200"/>
-            <a:ext cx="1524000" cy="2000250"/>
+            <a:off x="540000" y="2340000"/>
+            <a:ext cx="1440000" cy="1980000"/>
           </a:xfrm>
           <a:prstGeom prst="roundRect">
             <a:avLst>
@@ -13896,7 +13896,7 @@
         </p:nvSpPr>
         <p:spPr>
           <a:xfrm>
-            <a:off x="1047750" y="2571750"/>
+            <a:off x="1080000" y="2520000"/>
             <a:ext cx="571500" cy="533400"/>
           </a:xfrm>
           <a:prstGeom prst="rect">
@@ -13946,8 +13946,8 @@
         </p:nvSpPr>
         <p:spPr>
           <a:xfrm>
-            <a:off x="723900" y="3181350"/>
-            <a:ext cx="1219200" cy="723900"/>
+            <a:off x="720000" y="3240000"/>
+            <a:ext cx="1260000" cy="720000"/>
           </a:xfrm>
           <a:prstGeom prst="rect">
             <a:avLst/>
@@ -14013,7 +14013,7 @@
         </p:nvSpPr>
         <p:spPr>
           <a:xfrm>
-            <a:off x="2457450" y="1924050"/>
+            <a:off x="2520000" y="1980000"/>
             <a:ext cx="2381250" cy="228600"/>
           </a:xfrm>
           <a:prstGeom prst="rect">
@@ -14063,8 +14063,8 @@
         </p:nvSpPr>
         <p:spPr>
           <a:xfrm>
-            <a:off x="2381250" y="2266950"/>
-            <a:ext cx="2667000" cy="2190750"/>
+            <a:off x="2340000" y="2340000"/>
+            <a:ext cx="2700000" cy="2160000"/>
           </a:xfrm>
           <a:prstGeom prst="roundRect">
             <a:avLst>
@@ -14105,8 +14105,8 @@
         </p:nvSpPr>
         <p:spPr>
           <a:xfrm>
-            <a:off x="2609850" y="2505075"/>
-            <a:ext cx="2209800" cy="714375"/>
+            <a:off x="2520000" y="2520000"/>
+            <a:ext cx="2160000" cy="720000"/>
           </a:xfrm>
           <a:prstGeom prst="roundRect">
             <a:avLst>
@@ -14147,7 +14147,7 @@
         </p:nvSpPr>
         <p:spPr>
           <a:xfrm>
-            <a:off x="2781300" y="2609850"/>
+            <a:off x="2700000" y="2520000"/>
             <a:ext cx="1866900" cy="209550"/>
           </a:xfrm>
           <a:prstGeom prst="rect">
@@ -14197,7 +14197,7 @@
         </p:nvSpPr>
         <p:spPr>
           <a:xfrm>
-            <a:off x="2781300" y="2847975"/>
+            <a:off x="2700000" y="2880000"/>
             <a:ext cx="1866900" cy="209550"/>
           </a:xfrm>
           <a:prstGeom prst="rect">
@@ -14247,8 +14247,8 @@
         </p:nvSpPr>
         <p:spPr>
           <a:xfrm>
-            <a:off x="2609850" y="3438525"/>
-            <a:ext cx="2209800" cy="714375"/>
+            <a:off x="2520000" y="3420000"/>
+            <a:ext cx="2160000" cy="720000"/>
           </a:xfrm>
           <a:prstGeom prst="roundRect">
             <a:avLst>
@@ -14289,7 +14289,7 @@
         </p:nvSpPr>
         <p:spPr>
           <a:xfrm>
-            <a:off x="2781300" y="3543300"/>
+            <a:off x="2700000" y="3600000"/>
             <a:ext cx="1866900" cy="209550"/>
           </a:xfrm>
           <a:prstGeom prst="rect">
@@ -14339,7 +14339,7 @@
         </p:nvSpPr>
         <p:spPr>
           <a:xfrm>
-            <a:off x="2781300" y="3781425"/>
+            <a:off x="2700000" y="3780000"/>
             <a:ext cx="1866900" cy="209550"/>
           </a:xfrm>
           <a:prstGeom prst="rect">
@@ -14389,7 +14389,7 @@
         </p:nvSpPr>
         <p:spPr>
           <a:xfrm>
-            <a:off x="5295900" y="1924050"/>
+            <a:off x="5220000" y="1980000"/>
             <a:ext cx="1524000" cy="228600"/>
           </a:xfrm>
           <a:prstGeom prst="rect">
@@ -14439,8 +14439,8 @@
         </p:nvSpPr>
         <p:spPr>
           <a:xfrm>
-            <a:off x="5305425" y="2647950"/>
-            <a:ext cx="1200150" cy="1200150"/>
+            <a:off x="5220000" y="2700000"/>
+            <a:ext cx="1260000" cy="1260000"/>
           </a:xfrm>
           <a:prstGeom prst="ellipse">
             <a:avLst/>
@@ -14479,7 +14479,7 @@
         </p:nvSpPr>
         <p:spPr>
           <a:xfrm>
-            <a:off x="5514975" y="3052764"/>
+            <a:off x="5580000" y="3060000"/>
             <a:ext cx="762000" cy="342900"/>
           </a:xfrm>
           <a:prstGeom prst="rect">
@@ -14529,7 +14529,7 @@
         </p:nvSpPr>
         <p:spPr>
           <a:xfrm>
-            <a:off x="5267325" y="3898447"/>
+            <a:off x="5220000" y="3960000"/>
             <a:ext cx="1276350" cy="457200"/>
           </a:xfrm>
           <a:prstGeom prst="rect">
@@ -14617,7 +14617,7 @@
         </p:nvSpPr>
         <p:spPr>
           <a:xfrm>
-            <a:off x="7029450" y="1924050"/>
+            <a:off x="7020000" y="1980000"/>
             <a:ext cx="2190750" cy="228600"/>
           </a:xfrm>
           <a:prstGeom prst="rect">
@@ -14667,8 +14667,8 @@
         </p:nvSpPr>
         <p:spPr>
           <a:xfrm>
-            <a:off x="6953250" y="2266950"/>
-            <a:ext cx="2400300" cy="2190750"/>
+            <a:off x="7020000" y="2340000"/>
+            <a:ext cx="2340000" cy="2160000"/>
           </a:xfrm>
           <a:prstGeom prst="roundRect">
             <a:avLst>
@@ -14709,7 +14709,7 @@
         </p:nvSpPr>
         <p:spPr>
           <a:xfrm>
-            <a:off x="7553325" y="3105150"/>
+            <a:off x="7560000" y="3060000"/>
             <a:ext cx="723900" cy="0"/>
           </a:xfrm>
           <a:prstGeom prst="line">
@@ -14747,7 +14747,7 @@
         </p:nvSpPr>
         <p:spPr>
           <a:xfrm>
-            <a:off x="7553325" y="3105150"/>
+            <a:off x="7560000" y="3060000"/>
             <a:ext cx="819150" cy="409575"/>
           </a:xfrm>
           <a:prstGeom prst="line">
@@ -14785,7 +14785,7 @@
         </p:nvSpPr>
         <p:spPr>
           <a:xfrm>
-            <a:off x="8277225" y="2743200"/>
+            <a:off x="8280000" y="2700000"/>
             <a:ext cx="95250" cy="771525"/>
           </a:xfrm>
           <a:prstGeom prst="line">
@@ -14823,8 +14823,8 @@
         </p:nvSpPr>
         <p:spPr>
           <a:xfrm>
-            <a:off x="7334250" y="2819400"/>
-            <a:ext cx="590550" cy="590550"/>
+            <a:off x="7380000" y="2880000"/>
+            <a:ext cx="540000" cy="540000"/>
           </a:xfrm>
           <a:prstGeom prst="ellipse">
             <a:avLst/>
@@ -14863,8 +14863,8 @@
         </p:nvSpPr>
         <p:spPr>
           <a:xfrm>
-            <a:off x="8096250" y="2457450"/>
-            <a:ext cx="590550" cy="590550"/>
+            <a:off x="8100000" y="2520000"/>
+            <a:ext cx="540000" cy="540000"/>
           </a:xfrm>
           <a:prstGeom prst="ellipse">
             <a:avLst/>
@@ -14903,8 +14903,8 @@
         </p:nvSpPr>
         <p:spPr>
           <a:xfrm>
-            <a:off x="8191500" y="3238500"/>
-            <a:ext cx="590550" cy="590550"/>
+            <a:off x="8280000" y="3240000"/>
+            <a:ext cx="540000" cy="540000"/>
           </a:xfrm>
           <a:prstGeom prst="ellipse">
             <a:avLst/>
@@ -14943,7 +14943,7 @@
         </p:nvSpPr>
         <p:spPr>
           <a:xfrm>
-            <a:off x="7391400" y="2990850"/>
+            <a:off x="7380000" y="3060000"/>
             <a:ext cx="476250" cy="190500"/>
           </a:xfrm>
           <a:prstGeom prst="rect">
@@ -14993,7 +14993,7 @@
         </p:nvSpPr>
         <p:spPr>
           <a:xfrm>
-            <a:off x="8115300" y="2628900"/>
+            <a:off x="8100000" y="2700000"/>
             <a:ext cx="552450" cy="190500"/>
           </a:xfrm>
           <a:prstGeom prst="rect">
@@ -15043,7 +15043,7 @@
         </p:nvSpPr>
         <p:spPr>
           <a:xfrm>
-            <a:off x="8210550" y="3409950"/>
+            <a:off x="8280000" y="3420000"/>
             <a:ext cx="552450" cy="190500"/>
           </a:xfrm>
           <a:prstGeom prst="rect">
@@ -15093,7 +15093,7 @@
         </p:nvSpPr>
         <p:spPr>
           <a:xfrm>
-            <a:off x="7219950" y="3914775"/>
+            <a:off x="7200000" y="3960000"/>
             <a:ext cx="1866900" cy="400050"/>
           </a:xfrm>
           <a:prstGeom prst="rect">
@@ -15160,7 +15160,7 @@
         </p:nvSpPr>
         <p:spPr>
           <a:xfrm>
-            <a:off x="9658350" y="1924050"/>
+            <a:off x="9720000" y="1980000"/>
             <a:ext cx="1619250" cy="228600"/>
           </a:xfrm>
           <a:prstGeom prst="rect">
@@ -15210,8 +15210,8 @@
         </p:nvSpPr>
         <p:spPr>
           <a:xfrm>
-            <a:off x="9582150" y="2266950"/>
-            <a:ext cx="2076450" cy="2190750"/>
+            <a:off x="9540000" y="2340000"/>
+            <a:ext cx="2160000" cy="2160000"/>
           </a:xfrm>
           <a:prstGeom prst="roundRect">
             <a:avLst>
@@ -15252,7 +15252,7 @@
         </p:nvSpPr>
         <p:spPr>
           <a:xfrm>
-            <a:off x="9810750" y="2476500"/>
+            <a:off x="9900000" y="2520000"/>
             <a:ext cx="1619250" cy="514350"/>
           </a:xfrm>
           <a:prstGeom prst="rect">
@@ -15319,7 +15319,7 @@
         </p:nvSpPr>
         <p:spPr>
           <a:xfrm>
-            <a:off x="9858375" y="3114675"/>
+            <a:off x="9900000" y="3060000"/>
             <a:ext cx="1524000" cy="0"/>
           </a:xfrm>
           <a:prstGeom prst="line">
@@ -15357,8 +15357,8 @@
         </p:nvSpPr>
         <p:spPr>
           <a:xfrm>
-            <a:off x="9839325" y="3276600"/>
-            <a:ext cx="1600200" cy="838200"/>
+            <a:off x="9900000" y="3240000"/>
+            <a:ext cx="1620000" cy="900000"/>
           </a:xfrm>
           <a:prstGeom prst="rect">
             <a:avLst/>
@@ -15441,8 +15441,8 @@
         </p:nvSpPr>
         <p:spPr>
           <a:xfrm>
-            <a:off x="1924050" y="4962525"/>
-            <a:ext cx="8343900" cy="685800"/>
+            <a:off x="1980000" y="5040000"/>
+            <a:ext cx="8280000" cy="720000"/>
           </a:xfrm>
           <a:prstGeom prst="roundRect">
             <a:avLst>
@@ -15483,7 +15483,7 @@
         </p:nvSpPr>
         <p:spPr>
           <a:xfrm>
-            <a:off x="2209800" y="5076825"/>
+            <a:off x="2160000" y="5040000"/>
             <a:ext cx="2190750" cy="247650"/>
           </a:xfrm>
           <a:prstGeom prst="rect">
@@ -15533,7 +15533,7 @@
         </p:nvSpPr>
         <p:spPr>
           <a:xfrm>
-            <a:off x="2209800" y="5314950"/>
+            <a:off x="2160000" y="5400000"/>
             <a:ext cx="7772400" cy="228600"/>
           </a:xfrm>
           <a:prstGeom prst="rect">
@@ -15647,7 +15647,7 @@
         </p:nvSpPr>
         <p:spPr>
           <a:xfrm>
-            <a:off x="533400" y="6438900"/>
+            <a:off x="540000" y="6480000"/>
             <a:ext cx="419100" cy="171450"/>
           </a:xfrm>
           <a:prstGeom prst="rect">
@@ -15697,7 +15697,7 @@
         </p:nvSpPr>
         <p:spPr>
           <a:xfrm>
-            <a:off x="990600" y="6438900"/>
+            <a:off x="1080000" y="6480000"/>
             <a:ext cx="857250" cy="171450"/>
           </a:xfrm>
           <a:prstGeom prst="rect">
@@ -16907,7 +16907,7 @@
         </p:nvSpPr>
         <p:spPr>
           <a:xfrm>
-            <a:off x="552450" y="1266825"/>
+            <a:off x="540000" y="1260000"/>
             <a:ext cx="2857500" cy="228600"/>
           </a:xfrm>
           <a:prstGeom prst="rect">
@@ -16957,7 +16957,7 @@
         </p:nvSpPr>
         <p:spPr>
           <a:xfrm>
-            <a:off x="552450" y="3324225"/>
+            <a:off x="540000" y="3240000"/>
             <a:ext cx="2857500" cy="228600"/>
           </a:xfrm>
           <a:prstGeom prst="rect">
@@ -17007,7 +17007,7 @@
         </p:nvSpPr>
         <p:spPr>
           <a:xfrm>
-            <a:off x="2457450" y="2114550"/>
+            <a:off x="2520000" y="2160000"/>
             <a:ext cx="238125" cy="361950"/>
           </a:xfrm>
           <a:prstGeom prst="chevron">
@@ -17047,7 +17047,7 @@
         </p:nvSpPr>
         <p:spPr>
           <a:xfrm>
-            <a:off x="5105400" y="2114550"/>
+            <a:off x="5040000" y="2160000"/>
             <a:ext cx="238125" cy="361950"/>
           </a:xfrm>
           <a:prstGeom prst="chevron">
@@ -17087,7 +17087,7 @@
         </p:nvSpPr>
         <p:spPr>
           <a:xfrm>
-            <a:off x="1562100" y="2857500"/>
+            <a:off x="1620000" y="2880000"/>
             <a:ext cx="0" cy="866775"/>
           </a:xfrm>
           <a:prstGeom prst="line">
@@ -17125,7 +17125,7 @@
         </p:nvSpPr>
         <p:spPr>
           <a:xfrm>
-            <a:off x="6781800" y="2857500"/>
+            <a:off x="6840000" y="2880000"/>
             <a:ext cx="0" cy="866775"/>
           </a:xfrm>
           <a:prstGeom prst="line">
@@ -17163,7 +17163,7 @@
         </p:nvSpPr>
         <p:spPr>
           <a:xfrm>
-            <a:off x="1943100" y="4238625"/>
+            <a:off x="1980000" y="4320000"/>
             <a:ext cx="228600" cy="342900"/>
           </a:xfrm>
           <a:prstGeom prst="chevron">
@@ -17203,7 +17203,7 @@
         </p:nvSpPr>
         <p:spPr>
           <a:xfrm>
-            <a:off x="5267325" y="4238625"/>
+            <a:off x="5220000" y="4320000"/>
             <a:ext cx="228600" cy="342900"/>
           </a:xfrm>
           <a:prstGeom prst="chevron">
@@ -17243,7 +17243,7 @@
         </p:nvSpPr>
         <p:spPr>
           <a:xfrm>
-            <a:off x="7134225" y="4238625"/>
+            <a:off x="7200000" y="4320000"/>
             <a:ext cx="228600" cy="342900"/>
           </a:xfrm>
           <a:prstGeom prst="chevron">
@@ -17283,7 +17283,7 @@
         </p:nvSpPr>
         <p:spPr>
           <a:xfrm>
-            <a:off x="8743950" y="4238625"/>
+            <a:off x="8820000" y="4320000"/>
             <a:ext cx="228600" cy="342900"/>
           </a:xfrm>
           <a:prstGeom prst="chevron">
@@ -17323,7 +17323,7 @@
         </p:nvSpPr>
         <p:spPr>
           <a:xfrm>
-            <a:off x="10239375" y="4238625"/>
+            <a:off x="10260000" y="4320000"/>
             <a:ext cx="228600" cy="342900"/>
           </a:xfrm>
           <a:prstGeom prst="chevron">
@@ -17363,8 +17363,8 @@
         </p:nvSpPr>
         <p:spPr>
           <a:xfrm>
-            <a:off x="609600" y="1676400"/>
-            <a:ext cx="1714500" cy="1200150"/>
+            <a:off x="540000" y="1620000"/>
+            <a:ext cx="1800000" cy="1260000"/>
           </a:xfrm>
           <a:prstGeom prst="roundRect">
             <a:avLst>
@@ -17405,7 +17405,7 @@
         </p:nvSpPr>
         <p:spPr>
           <a:xfrm>
-            <a:off x="742950" y="1790700"/>
+            <a:off x="720000" y="1800000"/>
             <a:ext cx="1447800" cy="228600"/>
           </a:xfrm>
           <a:prstGeom prst="rect">
@@ -17455,7 +17455,7 @@
         </p:nvSpPr>
         <p:spPr>
           <a:xfrm>
-            <a:off x="1171575" y="2076450"/>
+            <a:off x="1260000" y="2160000"/>
             <a:ext cx="590550" cy="304800"/>
           </a:xfrm>
           <a:prstGeom prst="rect">
@@ -17505,7 +17505,7 @@
         </p:nvSpPr>
         <p:spPr>
           <a:xfrm>
-            <a:off x="742950" y="2476500"/>
+            <a:off x="720000" y="2520000"/>
             <a:ext cx="1447800" cy="228600"/>
           </a:xfrm>
           <a:prstGeom prst="rect">
@@ -17555,8 +17555,8 @@
         </p:nvSpPr>
         <p:spPr>
           <a:xfrm>
-            <a:off x="2819400" y="1676400"/>
-            <a:ext cx="2152650" cy="1200150"/>
+            <a:off x="2880000" y="1620000"/>
+            <a:ext cx="2160000" cy="1260000"/>
           </a:xfrm>
           <a:prstGeom prst="roundRect">
             <a:avLst>
@@ -17597,7 +17597,7 @@
         </p:nvSpPr>
         <p:spPr>
           <a:xfrm>
-            <a:off x="2990850" y="1790700"/>
+            <a:off x="3060000" y="1800000"/>
             <a:ext cx="1809750" cy="228600"/>
           </a:xfrm>
           <a:prstGeom prst="rect">
@@ -17647,7 +17647,7 @@
         </p:nvSpPr>
         <p:spPr>
           <a:xfrm>
-            <a:off x="3009900" y="2171700"/>
+            <a:off x="3060000" y="2160000"/>
             <a:ext cx="1771650" cy="514350"/>
           </a:xfrm>
           <a:prstGeom prst="rect">
@@ -17714,8 +17714,8 @@
         </p:nvSpPr>
         <p:spPr>
           <a:xfrm>
-            <a:off x="5448300" y="1457325"/>
-            <a:ext cx="2667000" cy="1419225"/>
+            <a:off x="5400000" y="1440000"/>
+            <a:ext cx="2700000" cy="1440000"/>
           </a:xfrm>
           <a:prstGeom prst="roundRect">
             <a:avLst>
@@ -17756,7 +17756,7 @@
         </p:nvSpPr>
         <p:spPr>
           <a:xfrm>
-            <a:off x="5657850" y="1565508"/>
+            <a:off x="5580000" y="1620000"/>
             <a:ext cx="2247900" cy="228600"/>
           </a:xfrm>
           <a:prstGeom prst="rect">
@@ -17806,7 +17806,7 @@
         </p:nvSpPr>
         <p:spPr>
           <a:xfrm>
-            <a:off x="6267450" y="2213637"/>
+            <a:off x="6300000" y="2160000"/>
             <a:ext cx="523875" cy="0"/>
           </a:xfrm>
           <a:prstGeom prst="line">
@@ -17844,7 +17844,7 @@
         </p:nvSpPr>
         <p:spPr>
           <a:xfrm>
-            <a:off x="6267450" y="2213637"/>
+            <a:off x="6300000" y="2160000"/>
             <a:ext cx="552450" cy="266700"/>
           </a:xfrm>
           <a:prstGeom prst="line">
@@ -17882,7 +17882,7 @@
         </p:nvSpPr>
         <p:spPr>
           <a:xfrm>
-            <a:off x="6791325" y="2042187"/>
+            <a:off x="6840000" y="1980000"/>
             <a:ext cx="28575" cy="438150"/>
           </a:xfrm>
           <a:prstGeom prst="line">
@@ -17920,7 +17920,7 @@
         </p:nvSpPr>
         <p:spPr>
           <a:xfrm>
-            <a:off x="6038850" y="1994562"/>
+            <a:off x="6120000" y="1980000"/>
             <a:ext cx="457200" cy="457200"/>
           </a:xfrm>
           <a:prstGeom prst="ellipse">
@@ -17960,7 +17960,7 @@
         </p:nvSpPr>
         <p:spPr>
           <a:xfrm>
-            <a:off x="6591300" y="1823112"/>
+            <a:off x="6660000" y="1800000"/>
             <a:ext cx="457200" cy="457200"/>
           </a:xfrm>
           <a:prstGeom prst="ellipse">
@@ -18000,7 +18000,7 @@
         </p:nvSpPr>
         <p:spPr>
           <a:xfrm>
-            <a:off x="6629400" y="2299362"/>
+            <a:off x="6660000" y="2340000"/>
             <a:ext cx="457200" cy="457200"/>
           </a:xfrm>
           <a:prstGeom prst="ellipse">
@@ -18040,7 +18040,7 @@
         </p:nvSpPr>
         <p:spPr>
           <a:xfrm>
-            <a:off x="6067425" y="2127912"/>
+            <a:off x="6120000" y="2160000"/>
             <a:ext cx="400050" cy="152400"/>
           </a:xfrm>
           <a:prstGeom prst="rect">
@@ -18090,7 +18090,7 @@
         </p:nvSpPr>
         <p:spPr>
           <a:xfrm>
-            <a:off x="6619875" y="1956462"/>
+            <a:off x="6660000" y="1980000"/>
             <a:ext cx="400050" cy="152400"/>
           </a:xfrm>
           <a:prstGeom prst="rect">
@@ -18140,7 +18140,7 @@
         </p:nvSpPr>
         <p:spPr>
           <a:xfrm>
-            <a:off x="6657975" y="2432712"/>
+            <a:off x="6660000" y="2520000"/>
             <a:ext cx="400050" cy="152400"/>
           </a:xfrm>
           <a:prstGeom prst="rect">
@@ -18190,7 +18190,7 @@
         </p:nvSpPr>
         <p:spPr>
           <a:xfrm>
-            <a:off x="7219950" y="2466975"/>
+            <a:off x="7200000" y="2520000"/>
             <a:ext cx="742950" cy="190500"/>
           </a:xfrm>
           <a:prstGeom prst="rect">
@@ -18240,8 +18240,8 @@
         </p:nvSpPr>
         <p:spPr>
           <a:xfrm>
-            <a:off x="609600" y="3752850"/>
-            <a:ext cx="1200150" cy="1314450"/>
+            <a:off x="540000" y="3780000"/>
+            <a:ext cx="1260000" cy="1260000"/>
           </a:xfrm>
           <a:prstGeom prst="roundRect">
             <a:avLst>
@@ -18282,7 +18282,7 @@
         </p:nvSpPr>
         <p:spPr>
           <a:xfrm>
-            <a:off x="723900" y="3876675"/>
+            <a:off x="720000" y="3960000"/>
             <a:ext cx="971550" cy="228600"/>
           </a:xfrm>
           <a:prstGeom prst="rect">
@@ -18332,7 +18332,7 @@
         </p:nvSpPr>
         <p:spPr>
           <a:xfrm>
-            <a:off x="942975" y="4171950"/>
+            <a:off x="900000" y="4140000"/>
             <a:ext cx="533400" cy="457200"/>
           </a:xfrm>
           <a:prstGeom prst="rect">
@@ -18382,7 +18382,7 @@
         </p:nvSpPr>
         <p:spPr>
           <a:xfrm>
-            <a:off x="723900" y="4695825"/>
+            <a:off x="720000" y="4680000"/>
             <a:ext cx="971550" cy="228600"/>
           </a:xfrm>
           <a:prstGeom prst="rect">
@@ -18432,8 +18432,8 @@
         </p:nvSpPr>
         <p:spPr>
           <a:xfrm>
-            <a:off x="2286000" y="3638550"/>
-            <a:ext cx="2857500" cy="1543050"/>
+            <a:off x="2340000" y="3600000"/>
+            <a:ext cx="2880000" cy="1620000"/>
           </a:xfrm>
           <a:prstGeom prst="roundRect">
             <a:avLst>
@@ -18474,7 +18474,7 @@
         </p:nvSpPr>
         <p:spPr>
           <a:xfrm>
-            <a:off x="2476500" y="3752850"/>
+            <a:off x="2520000" y="3780000"/>
             <a:ext cx="2476500" cy="209550"/>
           </a:xfrm>
           <a:prstGeom prst="rect">
@@ -18524,8 +18524,8 @@
         </p:nvSpPr>
         <p:spPr>
           <a:xfrm>
-            <a:off x="2457450" y="4057650"/>
-            <a:ext cx="1200150" cy="876300"/>
+            <a:off x="2520000" y="4140000"/>
+            <a:ext cx="1260000" cy="900000"/>
           </a:xfrm>
           <a:prstGeom prst="roundRect">
             <a:avLst>
@@ -18566,7 +18566,7 @@
         </p:nvSpPr>
         <p:spPr>
           <a:xfrm>
-            <a:off x="2533650" y="4143375"/>
+            <a:off x="2520000" y="4140000"/>
             <a:ext cx="1047750" cy="190500"/>
           </a:xfrm>
           <a:prstGeom prst="rect">
@@ -18616,7 +18616,7 @@
         </p:nvSpPr>
         <p:spPr>
           <a:xfrm>
-            <a:off x="2533650" y="4400550"/>
+            <a:off x="2520000" y="4320000"/>
             <a:ext cx="1047750" cy="361950"/>
           </a:xfrm>
           <a:prstGeom prst="rect">
@@ -18683,8 +18683,8 @@
         </p:nvSpPr>
         <p:spPr>
           <a:xfrm>
-            <a:off x="3752850" y="4057650"/>
-            <a:ext cx="1219200" cy="876300"/>
+            <a:off x="3780000" y="4140000"/>
+            <a:ext cx="1260000" cy="900000"/>
           </a:xfrm>
           <a:prstGeom prst="roundRect">
             <a:avLst>
@@ -18725,7 +18725,7 @@
         </p:nvSpPr>
         <p:spPr>
           <a:xfrm>
-            <a:off x="3819525" y="4143375"/>
+            <a:off x="3780000" y="4140000"/>
             <a:ext cx="1085850" cy="190500"/>
           </a:xfrm>
           <a:prstGeom prst="rect">
@@ -18775,7 +18775,7 @@
         </p:nvSpPr>
         <p:spPr>
           <a:xfrm>
-            <a:off x="3819525" y="4400550"/>
+            <a:off x="3780000" y="4320000"/>
             <a:ext cx="1085850" cy="361950"/>
           </a:xfrm>
           <a:prstGeom prst="rect">
@@ -18842,8 +18842,8 @@
         </p:nvSpPr>
         <p:spPr>
           <a:xfrm>
-            <a:off x="5619750" y="3752850"/>
-            <a:ext cx="1390650" cy="1314450"/>
+            <a:off x="5580000" y="3780000"/>
+            <a:ext cx="1440000" cy="1260000"/>
           </a:xfrm>
           <a:prstGeom prst="roundRect">
             <a:avLst>
@@ -18884,7 +18884,7 @@
         </p:nvSpPr>
         <p:spPr>
           <a:xfrm>
-            <a:off x="5762625" y="3876675"/>
+            <a:off x="5760000" y="3960000"/>
             <a:ext cx="1104900" cy="419100"/>
           </a:xfrm>
           <a:prstGeom prst="rect">
@@ -18951,7 +18951,7 @@
         </p:nvSpPr>
         <p:spPr>
           <a:xfrm>
-            <a:off x="5762625" y="4438650"/>
+            <a:off x="5760000" y="4500000"/>
             <a:ext cx="1104900" cy="400050"/>
           </a:xfrm>
           <a:prstGeom prst="rect">
@@ -19018,8 +19018,8 @@
         </p:nvSpPr>
         <p:spPr>
           <a:xfrm>
-            <a:off x="7486650" y="3752850"/>
-            <a:ext cx="1143000" cy="1314450"/>
+            <a:off x="7560000" y="3780000"/>
+            <a:ext cx="1080000" cy="1260000"/>
           </a:xfrm>
           <a:prstGeom prst="roundRect">
             <a:avLst>
@@ -19060,7 +19060,7 @@
         </p:nvSpPr>
         <p:spPr>
           <a:xfrm>
-            <a:off x="7600950" y="3876675"/>
+            <a:off x="7560000" y="3960000"/>
             <a:ext cx="914400" cy="228600"/>
           </a:xfrm>
           <a:prstGeom prst="rect">
@@ -19110,7 +19110,7 @@
         </p:nvSpPr>
         <p:spPr>
           <a:xfrm>
-            <a:off x="7705725" y="4191000"/>
+            <a:off x="7740000" y="4140000"/>
             <a:ext cx="704850" cy="381000"/>
           </a:xfrm>
           <a:prstGeom prst="rect">
@@ -19160,7 +19160,7 @@
         </p:nvSpPr>
         <p:spPr>
           <a:xfrm>
-            <a:off x="7600950" y="4638675"/>
+            <a:off x="7560000" y="4680000"/>
             <a:ext cx="914400" cy="323850"/>
           </a:xfrm>
           <a:prstGeom prst="rect">
@@ -19227,8 +19227,8 @@
         </p:nvSpPr>
         <p:spPr>
           <a:xfrm>
-            <a:off x="9086850" y="3752850"/>
-            <a:ext cx="1028700" cy="1314450"/>
+            <a:off x="9000000" y="3780000"/>
+            <a:ext cx="1080000" cy="1260000"/>
           </a:xfrm>
           <a:prstGeom prst="roundRect">
             <a:avLst>
@@ -19269,7 +19269,7 @@
         </p:nvSpPr>
         <p:spPr>
           <a:xfrm>
-            <a:off x="9220200" y="3876675"/>
+            <a:off x="9180000" y="3960000"/>
             <a:ext cx="762000" cy="228600"/>
           </a:xfrm>
           <a:prstGeom prst="rect">
@@ -19319,7 +19319,7 @@
         </p:nvSpPr>
         <p:spPr>
           <a:xfrm>
-            <a:off x="9220200" y="4276725"/>
+            <a:off x="9180000" y="4320000"/>
             <a:ext cx="762000" cy="247650"/>
           </a:xfrm>
           <a:prstGeom prst="rect">
@@ -19369,7 +19369,7 @@
         </p:nvSpPr>
         <p:spPr>
           <a:xfrm>
-            <a:off x="9220200" y="4619625"/>
+            <a:off x="9180000" y="4680000"/>
             <a:ext cx="762000" cy="285750"/>
           </a:xfrm>
           <a:prstGeom prst="rect">
@@ -19436,8 +19436,8 @@
         </p:nvSpPr>
         <p:spPr>
           <a:xfrm>
-            <a:off x="10591800" y="3752850"/>
-            <a:ext cx="1066800" cy="1314450"/>
+            <a:off x="10620000" y="3780000"/>
+            <a:ext cx="1080000" cy="1260000"/>
           </a:xfrm>
           <a:prstGeom prst="roundRect">
             <a:avLst>
@@ -19478,7 +19478,7 @@
         </p:nvSpPr>
         <p:spPr>
           <a:xfrm>
-            <a:off x="10629900" y="3876675"/>
+            <a:off x="10620000" y="3960000"/>
             <a:ext cx="990600" cy="228600"/>
           </a:xfrm>
           <a:prstGeom prst="rect">
@@ -19528,7 +19528,7 @@
         </p:nvSpPr>
         <p:spPr>
           <a:xfrm>
-            <a:off x="10810875" y="4200525"/>
+            <a:off x="10800000" y="4140000"/>
             <a:ext cx="628650" cy="400050"/>
           </a:xfrm>
           <a:prstGeom prst="rect">
@@ -19578,7 +19578,7 @@
         </p:nvSpPr>
         <p:spPr>
           <a:xfrm>
-            <a:off x="10706100" y="4657725"/>
+            <a:off x="10620000" y="4680000"/>
             <a:ext cx="838200" cy="285750"/>
           </a:xfrm>
           <a:prstGeom prst="rect">
@@ -19645,8 +19645,8 @@
         </p:nvSpPr>
         <p:spPr>
           <a:xfrm>
-            <a:off x="2133600" y="5476875"/>
-            <a:ext cx="7924800" cy="552450"/>
+            <a:off x="2160000" y="5400000"/>
+            <a:ext cx="7920000" cy="540000"/>
           </a:xfrm>
           <a:prstGeom prst="roundRect">
             <a:avLst>
@@ -19687,7 +19687,7 @@
         </p:nvSpPr>
         <p:spPr>
           <a:xfrm>
-            <a:off x="2381250" y="5591175"/>
+            <a:off x="2340000" y="5580000"/>
             <a:ext cx="7429500" cy="323850"/>
           </a:xfrm>
           <a:prstGeom prst="rect">
@@ -19737,7 +19737,7 @@
         </p:nvSpPr>
         <p:spPr>
           <a:xfrm>
-            <a:off x="533400" y="6448425"/>
+            <a:off x="540000" y="6480000"/>
             <a:ext cx="419100" cy="171450"/>
           </a:xfrm>
           <a:prstGeom prst="rect">
@@ -19787,7 +19787,7 @@
         </p:nvSpPr>
         <p:spPr>
           <a:xfrm>
-            <a:off x="990600" y="6448425"/>
+            <a:off x="1080000" y="6480000"/>
             <a:ext cx="857250" cy="171450"/>
           </a:xfrm>
           <a:prstGeom prst="rect">
@@ -19895,7 +19895,7 @@
         </p:nvSpPr>
         <p:spPr>
           <a:xfrm>
-            <a:off x="476250" y="1133475"/>
+            <a:off x="540000" y="1080000"/>
             <a:ext cx="11239500" cy="0"/>
           </a:xfrm>
           <a:prstGeom prst="line">
@@ -19932,7 +19932,7 @@
         </p:nvSpPr>
         <p:spPr>
           <a:xfrm>
-            <a:off x="523875" y="1362075"/>
+            <a:off x="540000" y="1440000"/>
             <a:ext cx="11096625" cy="361950"/>
           </a:xfrm>
           <a:prstGeom prst="rect">
@@ -19989,7 +19989,7 @@
         </p:nvSpPr>
         <p:spPr>
           <a:xfrm>
-            <a:off x="476250" y="6353175"/>
+            <a:off x="540000" y="6300000"/>
             <a:ext cx="333375" cy="209550"/>
           </a:xfrm>
           <a:prstGeom prst="rect">
@@ -20046,7 +20046,7 @@
         </p:nvSpPr>
         <p:spPr>
           <a:xfrm>
-            <a:off x="933450" y="6353175"/>
+            <a:off x="900000" y="6300000"/>
             <a:ext cx="857250" cy="209550"/>
           </a:xfrm>
           <a:prstGeom prst="rect">
@@ -20103,7 +20103,7 @@
         </p:nvSpPr>
         <p:spPr>
           <a:xfrm>
-            <a:off x="619125" y="2047875"/>
+            <a:off x="540000" y="1980000"/>
             <a:ext cx="3143250" cy="266700"/>
           </a:xfrm>
           <a:prstGeom prst="rect">
@@ -20160,8 +20160,8 @@
         </p:nvSpPr>
         <p:spPr>
           <a:xfrm>
-            <a:off x="619125" y="2381250"/>
-            <a:ext cx="3143250" cy="2238375"/>
+            <a:off x="540000" y="2340000"/>
+            <a:ext cx="3060000" cy="2160000"/>
           </a:xfrm>
           <a:prstGeom prst="roundRect">
             <a:avLst>
@@ -20202,7 +20202,7 @@
         </p:nvSpPr>
         <p:spPr>
           <a:xfrm>
-            <a:off x="857250" y="2647950"/>
+            <a:off x="900000" y="2700000"/>
             <a:ext cx="1190625" cy="228600"/>
           </a:xfrm>
           <a:prstGeom prst="rect">
@@ -20283,8 +20283,8 @@
         </p:nvSpPr>
         <p:spPr>
           <a:xfrm>
-            <a:off x="857250" y="2952750"/>
-            <a:ext cx="1190625" cy="552450"/>
+            <a:off x="900000" y="2880000"/>
+            <a:ext cx="1260000" cy="540000"/>
           </a:xfrm>
           <a:prstGeom prst="rect">
             <a:avLst/>
@@ -20364,7 +20364,7 @@
         </p:nvSpPr>
         <p:spPr>
           <a:xfrm>
-            <a:off x="2333625" y="2647950"/>
+            <a:off x="2340000" y="2700000"/>
             <a:ext cx="1190625" cy="228600"/>
           </a:xfrm>
           <a:prstGeom prst="rect">
@@ -20445,8 +20445,8 @@
         </p:nvSpPr>
         <p:spPr>
           <a:xfrm>
-            <a:off x="2333625" y="2952750"/>
-            <a:ext cx="1190625" cy="552450"/>
+            <a:off x="2340000" y="2880000"/>
+            <a:ext cx="1260000" cy="540000"/>
           </a:xfrm>
           <a:prstGeom prst="rect">
             <a:avLst/>
@@ -20526,7 +20526,7 @@
         </p:nvSpPr>
         <p:spPr>
           <a:xfrm>
-            <a:off x="2190750" y="2686050"/>
+            <a:off x="2160000" y="2700000"/>
             <a:ext cx="0" cy="952500"/>
           </a:xfrm>
           <a:prstGeom prst="line">
@@ -20563,7 +20563,7 @@
         </p:nvSpPr>
         <p:spPr>
           <a:xfrm>
-            <a:off x="904875" y="3848100"/>
+            <a:off x="900000" y="3780000"/>
             <a:ext cx="2571750" cy="438150"/>
           </a:xfrm>
           <a:prstGeom prst="rect">
@@ -20620,7 +20620,7 @@
         </p:nvSpPr>
         <p:spPr>
           <a:xfrm>
-            <a:off x="4095750" y="2047875"/>
+            <a:off x="4140000" y="1980000"/>
             <a:ext cx="3143250" cy="266700"/>
           </a:xfrm>
           <a:prstGeom prst="rect">
@@ -20677,8 +20677,8 @@
         </p:nvSpPr>
         <p:spPr>
           <a:xfrm>
-            <a:off x="4095750" y="2381250"/>
-            <a:ext cx="3143250" cy="2238375"/>
+            <a:off x="4140000" y="2340000"/>
+            <a:ext cx="3060000" cy="2160000"/>
           </a:xfrm>
           <a:prstGeom prst="roundRect">
             <a:avLst>
@@ -20719,7 +20719,7 @@
         </p:nvSpPr>
         <p:spPr>
           <a:xfrm>
-            <a:off x="4333875" y="2647950"/>
+            <a:off x="4320000" y="2700000"/>
             <a:ext cx="1190625" cy="228600"/>
           </a:xfrm>
           <a:prstGeom prst="rect">
@@ -20800,8 +20800,8 @@
         </p:nvSpPr>
         <p:spPr>
           <a:xfrm>
-            <a:off x="4333875" y="2952750"/>
-            <a:ext cx="1190625" cy="552450"/>
+            <a:off x="4320000" y="2880000"/>
+            <a:ext cx="1260000" cy="540000"/>
           </a:xfrm>
           <a:prstGeom prst="rect">
             <a:avLst/>
@@ -20881,7 +20881,7 @@
         </p:nvSpPr>
         <p:spPr>
           <a:xfrm>
-            <a:off x="5810250" y="2647950"/>
+            <a:off x="5760000" y="2700000"/>
             <a:ext cx="1190625" cy="228600"/>
           </a:xfrm>
           <a:prstGeom prst="rect">
@@ -20962,8 +20962,8 @@
         </p:nvSpPr>
         <p:spPr>
           <a:xfrm>
-            <a:off x="5810250" y="2952750"/>
-            <a:ext cx="1190625" cy="552450"/>
+            <a:off x="5760000" y="2880000"/>
+            <a:ext cx="1260000" cy="540000"/>
           </a:xfrm>
           <a:prstGeom prst="rect">
             <a:avLst/>
@@ -21043,7 +21043,7 @@
         </p:nvSpPr>
         <p:spPr>
           <a:xfrm>
-            <a:off x="5667375" y="2686050"/>
+            <a:off x="5580000" y="2700000"/>
             <a:ext cx="0" cy="952500"/>
           </a:xfrm>
           <a:prstGeom prst="line">
@@ -21080,7 +21080,7 @@
         </p:nvSpPr>
         <p:spPr>
           <a:xfrm>
-            <a:off x="4381500" y="3848100"/>
+            <a:off x="4320000" y="3780000"/>
             <a:ext cx="2571750" cy="438150"/>
           </a:xfrm>
           <a:prstGeom prst="rect">
@@ -21137,7 +21137,7 @@
         </p:nvSpPr>
         <p:spPr>
           <a:xfrm>
-            <a:off x="7572375" y="2047875"/>
+            <a:off x="7560000" y="1980000"/>
             <a:ext cx="3143250" cy="266700"/>
           </a:xfrm>
           <a:prstGeom prst="rect">
@@ -21194,8 +21194,8 @@
         </p:nvSpPr>
         <p:spPr>
           <a:xfrm>
-            <a:off x="7572375" y="2381250"/>
-            <a:ext cx="3143250" cy="2238375"/>
+            <a:off x="7560000" y="2340000"/>
+            <a:ext cx="3060000" cy="2160000"/>
           </a:xfrm>
           <a:prstGeom prst="roundRect">
             <a:avLst>
@@ -21236,7 +21236,7 @@
         </p:nvSpPr>
         <p:spPr>
           <a:xfrm>
-            <a:off x="7810500" y="2647950"/>
+            <a:off x="7740000" y="2700000"/>
             <a:ext cx="1190625" cy="228600"/>
           </a:xfrm>
           <a:prstGeom prst="rect">
@@ -21317,8 +21317,8 @@
         </p:nvSpPr>
         <p:spPr>
           <a:xfrm>
-            <a:off x="7810500" y="2952750"/>
-            <a:ext cx="1190625" cy="552450"/>
+            <a:off x="7740000" y="2880000"/>
+            <a:ext cx="1260000" cy="540000"/>
           </a:xfrm>
           <a:prstGeom prst="rect">
             <a:avLst/>
@@ -21398,7 +21398,7 @@
         </p:nvSpPr>
         <p:spPr>
           <a:xfrm>
-            <a:off x="9286875" y="2647950"/>
+            <a:off x="9360000" y="2700000"/>
             <a:ext cx="1190625" cy="228600"/>
           </a:xfrm>
           <a:prstGeom prst="rect">
@@ -21479,8 +21479,8 @@
         </p:nvSpPr>
         <p:spPr>
           <a:xfrm>
-            <a:off x="9286875" y="2952750"/>
-            <a:ext cx="1190625" cy="552450"/>
+            <a:off x="9360000" y="2880000"/>
+            <a:ext cx="1260000" cy="540000"/>
           </a:xfrm>
           <a:prstGeom prst="rect">
             <a:avLst/>
@@ -21560,7 +21560,7 @@
         </p:nvSpPr>
         <p:spPr>
           <a:xfrm>
-            <a:off x="9144000" y="2686050"/>
+            <a:off x="9180000" y="2700000"/>
             <a:ext cx="0" cy="952500"/>
           </a:xfrm>
           <a:prstGeom prst="line">
@@ -21597,7 +21597,7 @@
         </p:nvSpPr>
         <p:spPr>
           <a:xfrm>
-            <a:off x="7858125" y="3848100"/>
+            <a:off x="7920000" y="3780000"/>
             <a:ext cx="2571750" cy="438150"/>
           </a:xfrm>
           <a:prstGeom prst="rect">
@@ -21654,8 +21654,8 @@
         </p:nvSpPr>
         <p:spPr>
           <a:xfrm>
-            <a:off x="2095500" y="5000625"/>
-            <a:ext cx="8001000" cy="666750"/>
+            <a:off x="2160000" y="5040000"/>
+            <a:ext cx="7920000" cy="720000"/>
           </a:xfrm>
           <a:prstGeom prst="roundRect">
             <a:avLst>
@@ -21696,7 +21696,7 @@
         </p:nvSpPr>
         <p:spPr>
           <a:xfrm>
-            <a:off x="2333625" y="5181600"/>
+            <a:off x="2340000" y="5220000"/>
             <a:ext cx="7524750" cy="304800"/>
           </a:xfrm>
           <a:prstGeom prst="rect">
@@ -21963,7 +21963,7 @@
         </p:nvSpPr>
         <p:spPr>
           <a:xfrm>
-            <a:off x="476250" y="1133475"/>
+            <a:off x="540000" y="1080000"/>
             <a:ext cx="11239500" cy="0"/>
           </a:xfrm>
           <a:prstGeom prst="line">
@@ -22000,7 +22000,7 @@
         </p:nvSpPr>
         <p:spPr>
           <a:xfrm>
-            <a:off x="523875" y="1362075"/>
+            <a:off x="540000" y="1440000"/>
             <a:ext cx="11096625" cy="361950"/>
           </a:xfrm>
           <a:prstGeom prst="rect">
@@ -22200,7 +22200,7 @@
         </p:nvSpPr>
         <p:spPr>
           <a:xfrm>
-            <a:off x="476250" y="6353175"/>
+            <a:off x="540000" y="6300000"/>
             <a:ext cx="333375" cy="209550"/>
           </a:xfrm>
           <a:prstGeom prst="rect">
@@ -22257,7 +22257,7 @@
         </p:nvSpPr>
         <p:spPr>
           <a:xfrm>
-            <a:off x="933450" y="6353175"/>
+            <a:off x="900000" y="6300000"/>
             <a:ext cx="857250" cy="209550"/>
           </a:xfrm>
           <a:prstGeom prst="rect">
@@ -22314,7 +22314,7 @@
         </p:nvSpPr>
         <p:spPr>
           <a:xfrm>
-            <a:off x="5905500" y="1933575"/>
+            <a:off x="5940000" y="1980000"/>
             <a:ext cx="1238250" cy="228600"/>
           </a:xfrm>
           <a:prstGeom prst="rect">
@@ -22371,7 +22371,7 @@
         </p:nvSpPr>
         <p:spPr>
           <a:xfrm>
-            <a:off x="9334500" y="1933575"/>
+            <a:off x="9360000" y="1980000"/>
             <a:ext cx="1238250" cy="228600"/>
           </a:xfrm>
           <a:prstGeom prst="rect">
@@ -22428,7 +22428,7 @@
         </p:nvSpPr>
         <p:spPr>
           <a:xfrm>
-            <a:off x="809625" y="2381250"/>
+            <a:off x="720000" y="2340000"/>
             <a:ext cx="2381250" cy="266700"/>
           </a:xfrm>
           <a:prstGeom prst="rect">
@@ -22485,7 +22485,7 @@
         </p:nvSpPr>
         <p:spPr>
           <a:xfrm>
-            <a:off x="3333750" y="2333625"/>
+            <a:off x="3420000" y="2340000"/>
             <a:ext cx="7239000" cy="323850"/>
           </a:xfrm>
           <a:prstGeom prst="roundRect">
@@ -22527,7 +22527,7 @@
         </p:nvSpPr>
         <p:spPr>
           <a:xfrm>
-            <a:off x="3333750" y="2333625"/>
+            <a:off x="3420000" y="2340000"/>
             <a:ext cx="2500313" cy="133350"/>
           </a:xfrm>
           <a:prstGeom prst="roundRect">
@@ -22569,7 +22569,7 @@
         </p:nvSpPr>
         <p:spPr>
           <a:xfrm>
-            <a:off x="3333750" y="2524125"/>
+            <a:off x="3420000" y="2520000"/>
             <a:ext cx="2680335" cy="133350"/>
           </a:xfrm>
           <a:prstGeom prst="roundRect">
@@ -22611,7 +22611,7 @@
         </p:nvSpPr>
         <p:spPr>
           <a:xfrm>
-            <a:off x="5905500" y="2352675"/>
+            <a:off x="5940000" y="2340000"/>
             <a:ext cx="1238250" cy="304800"/>
           </a:xfrm>
           <a:prstGeom prst="rect">
@@ -22668,7 +22668,7 @@
         </p:nvSpPr>
         <p:spPr>
           <a:xfrm>
-            <a:off x="9334500" y="2333625"/>
+            <a:off x="9360000" y="2340000"/>
             <a:ext cx="1238250" cy="361950"/>
           </a:xfrm>
           <a:prstGeom prst="rect">
@@ -22725,7 +22725,7 @@
         </p:nvSpPr>
         <p:spPr>
           <a:xfrm>
-            <a:off x="809625" y="3105150"/>
+            <a:off x="720000" y="3060000"/>
             <a:ext cx="2381250" cy="266700"/>
           </a:xfrm>
           <a:prstGeom prst="rect">
@@ -22782,7 +22782,7 @@
         </p:nvSpPr>
         <p:spPr>
           <a:xfrm>
-            <a:off x="3333750" y="3057525"/>
+            <a:off x="3420000" y="3060000"/>
             <a:ext cx="7239000" cy="323850"/>
           </a:xfrm>
           <a:prstGeom prst="roundRect">
@@ -22824,7 +22824,7 @@
         </p:nvSpPr>
         <p:spPr>
           <a:xfrm>
-            <a:off x="3333750" y="3057525"/>
+            <a:off x="3420000" y="3060000"/>
             <a:ext cx="1548765" cy="133350"/>
           </a:xfrm>
           <a:prstGeom prst="roundRect">
@@ -22866,7 +22866,7 @@
         </p:nvSpPr>
         <p:spPr>
           <a:xfrm>
-            <a:off x="3333750" y="3248025"/>
+            <a:off x="3420000" y="3240000"/>
             <a:ext cx="1131570" cy="133350"/>
           </a:xfrm>
           <a:prstGeom prst="roundRect">
@@ -22908,7 +22908,7 @@
         </p:nvSpPr>
         <p:spPr>
           <a:xfrm>
-            <a:off x="5905500" y="3095625"/>
+            <a:off x="5940000" y="3060000"/>
             <a:ext cx="1238250" cy="266700"/>
           </a:xfrm>
           <a:prstGeom prst="rect">
@@ -22965,7 +22965,7 @@
         </p:nvSpPr>
         <p:spPr>
           <a:xfrm>
-            <a:off x="9334500" y="3076575"/>
+            <a:off x="9360000" y="3060000"/>
             <a:ext cx="1238250" cy="342900"/>
           </a:xfrm>
           <a:prstGeom prst="rect">
@@ -23022,7 +23022,7 @@
         </p:nvSpPr>
         <p:spPr>
           <a:xfrm>
-            <a:off x="809625" y="3829050"/>
+            <a:off x="720000" y="3780000"/>
             <a:ext cx="2381250" cy="266700"/>
           </a:xfrm>
           <a:prstGeom prst="rect">
@@ -23079,7 +23079,7 @@
         </p:nvSpPr>
         <p:spPr>
           <a:xfrm>
-            <a:off x="3333750" y="3781425"/>
+            <a:off x="3420000" y="3780000"/>
             <a:ext cx="7239000" cy="323850"/>
           </a:xfrm>
           <a:prstGeom prst="roundRect">
@@ -23121,7 +23121,7 @@
         </p:nvSpPr>
         <p:spPr>
           <a:xfrm>
-            <a:off x="3333750" y="3781425"/>
+            <a:off x="3420000" y="3780000"/>
             <a:ext cx="2500313" cy="133350"/>
           </a:xfrm>
           <a:prstGeom prst="roundRect">
@@ -23163,7 +23163,7 @@
         </p:nvSpPr>
         <p:spPr>
           <a:xfrm>
-            <a:off x="3333750" y="3971925"/>
+            <a:off x="3420000" y="3960000"/>
             <a:ext cx="2263140" cy="133350"/>
           </a:xfrm>
           <a:prstGeom prst="roundRect">
@@ -23205,7 +23205,7 @@
         </p:nvSpPr>
         <p:spPr>
           <a:xfrm>
-            <a:off x="5905500" y="3813499"/>
+            <a:off x="5940000" y="3780000"/>
             <a:ext cx="1238250" cy="323850"/>
           </a:xfrm>
           <a:prstGeom prst="rect">
@@ -23262,7 +23262,7 @@
         </p:nvSpPr>
         <p:spPr>
           <a:xfrm>
-            <a:off x="9334500" y="3824751"/>
+            <a:off x="9360000" y="3780000"/>
             <a:ext cx="1238250" cy="342900"/>
           </a:xfrm>
           <a:prstGeom prst="rect">
@@ -23319,7 +23319,7 @@
         </p:nvSpPr>
         <p:spPr>
           <a:xfrm>
-            <a:off x="809625" y="4552950"/>
+            <a:off x="720000" y="4500000"/>
             <a:ext cx="2381250" cy="266700"/>
           </a:xfrm>
           <a:prstGeom prst="rect">
@@ -23376,7 +23376,7 @@
         </p:nvSpPr>
         <p:spPr>
           <a:xfrm>
-            <a:off x="3333750" y="4505325"/>
+            <a:off x="3420000" y="4500000"/>
             <a:ext cx="7239000" cy="323850"/>
           </a:xfrm>
           <a:prstGeom prst="roundRect">
@@ -23418,7 +23418,7 @@
         </p:nvSpPr>
         <p:spPr>
           <a:xfrm>
-            <a:off x="3333750" y="4505325"/>
+            <a:off x="3420000" y="4500000"/>
             <a:ext cx="2500313" cy="133350"/>
           </a:xfrm>
           <a:prstGeom prst="roundRect">
@@ -23460,7 +23460,7 @@
         </p:nvSpPr>
         <p:spPr>
           <a:xfrm>
-            <a:off x="3333750" y="4695825"/>
+            <a:off x="3420000" y="4680000"/>
             <a:ext cx="2143125" cy="133350"/>
           </a:xfrm>
           <a:prstGeom prst="roundRect">
@@ -23502,7 +23502,7 @@
         </p:nvSpPr>
         <p:spPr>
           <a:xfrm>
-            <a:off x="5905500" y="4543425"/>
+            <a:off x="5940000" y="4500000"/>
             <a:ext cx="1238250" cy="304800"/>
           </a:xfrm>
           <a:prstGeom prst="rect">
@@ -23559,7 +23559,7 @@
         </p:nvSpPr>
         <p:spPr>
           <a:xfrm>
-            <a:off x="9334500" y="4543425"/>
+            <a:off x="9360000" y="4500000"/>
             <a:ext cx="1238250" cy="323850"/>
           </a:xfrm>
           <a:prstGeom prst="rect">
@@ -23616,8 +23616,8 @@
         </p:nvSpPr>
         <p:spPr>
           <a:xfrm>
-            <a:off x="1143000" y="5286375"/>
-            <a:ext cx="9906000" cy="590550"/>
+            <a:off x="1080000" y="5220000"/>
+            <a:ext cx="9900000" cy="540000"/>
           </a:xfrm>
           <a:prstGeom prst="roundRect">
             <a:avLst>
@@ -23658,7 +23658,7 @@
         </p:nvSpPr>
         <p:spPr>
           <a:xfrm>
-            <a:off x="1428750" y="5429250"/>
+            <a:off x="1440000" y="5400000"/>
             <a:ext cx="9334500" cy="304800"/>
           </a:xfrm>
           <a:prstGeom prst="rect">
@@ -23879,7 +23879,7 @@
         </p:nvSpPr>
         <p:spPr>
           <a:xfrm>
-            <a:off x="476250" y="1133475"/>
+            <a:off x="540000" y="1080000"/>
             <a:ext cx="11239500" cy="0"/>
           </a:xfrm>
           <a:prstGeom prst="line">
@@ -23916,7 +23916,7 @@
         </p:nvSpPr>
         <p:spPr>
           <a:xfrm>
-            <a:off x="523875" y="1362075"/>
+            <a:off x="540000" y="1440000"/>
             <a:ext cx="11096625" cy="361950"/>
           </a:xfrm>
           <a:prstGeom prst="rect">
@@ -23972,7 +23972,7 @@
         </p:nvSpPr>
         <p:spPr>
           <a:xfrm>
-            <a:off x="476250" y="6353175"/>
+            <a:off x="540000" y="6300000"/>
             <a:ext cx="333375" cy="209550"/>
           </a:xfrm>
           <a:prstGeom prst="rect">
@@ -24028,7 +24028,7 @@
         </p:nvSpPr>
         <p:spPr>
           <a:xfrm>
-            <a:off x="933450" y="6353175"/>
+            <a:off x="900000" y="6300000"/>
             <a:ext cx="857250" cy="209550"/>
           </a:xfrm>
           <a:prstGeom prst="rect">
@@ -24084,8 +24084,8 @@
         </p:nvSpPr>
         <p:spPr>
           <a:xfrm>
-            <a:off x="571500" y="2143125"/>
-            <a:ext cx="3286125" cy="2857500"/>
+            <a:off x="540000" y="2160000"/>
+            <a:ext cx="3240000" cy="2880000"/>
           </a:xfrm>
           <a:prstGeom prst="roundRect">
             <a:avLst>
@@ -24126,8 +24126,8 @@
         </p:nvSpPr>
         <p:spPr>
           <a:xfrm>
-            <a:off x="762000" y="2333625"/>
-            <a:ext cx="552450" cy="552450"/>
+            <a:off x="720000" y="2340000"/>
+            <a:ext cx="540000" cy="540000"/>
           </a:xfrm>
           <a:prstGeom prst="ellipse">
             <a:avLst/>
@@ -24186,7 +24186,7 @@
         </p:nvSpPr>
         <p:spPr>
           <a:xfrm>
-            <a:off x="1447800" y="2362200"/>
+            <a:off x="1440000" y="2340000"/>
             <a:ext cx="2095500" cy="285750"/>
           </a:xfrm>
           <a:prstGeom prst="rect">
@@ -24242,7 +24242,7 @@
         </p:nvSpPr>
         <p:spPr>
           <a:xfrm>
-            <a:off x="762000" y="3000375"/>
+            <a:off x="720000" y="3060000"/>
             <a:ext cx="2905125" cy="428625"/>
           </a:xfrm>
           <a:prstGeom prst="roundRect">
@@ -24284,7 +24284,7 @@
         </p:nvSpPr>
         <p:spPr>
           <a:xfrm>
-            <a:off x="857250" y="3095625"/>
+            <a:off x="900000" y="3060000"/>
             <a:ext cx="2714625" cy="238125"/>
           </a:xfrm>
           <a:prstGeom prst="rect">
@@ -24340,8 +24340,8 @@
         </p:nvSpPr>
         <p:spPr>
           <a:xfrm>
-            <a:off x="838200" y="3714750"/>
-            <a:ext cx="2762250" cy="1000125"/>
+            <a:off x="900000" y="3780000"/>
+            <a:ext cx="2700000" cy="1080000"/>
           </a:xfrm>
           <a:prstGeom prst="rect">
             <a:avLst/>
@@ -24442,8 +24442,8 @@
         </p:nvSpPr>
         <p:spPr>
           <a:xfrm>
-            <a:off x="4143375" y="2143125"/>
-            <a:ext cx="3286125" cy="2857500"/>
+            <a:off x="4140000" y="2160000"/>
+            <a:ext cx="3240000" cy="2880000"/>
           </a:xfrm>
           <a:prstGeom prst="roundRect">
             <a:avLst>
@@ -24484,8 +24484,8 @@
         </p:nvSpPr>
         <p:spPr>
           <a:xfrm>
-            <a:off x="4333875" y="2333625"/>
-            <a:ext cx="552450" cy="552450"/>
+            <a:off x="4320000" y="2340000"/>
+            <a:ext cx="540000" cy="540000"/>
           </a:xfrm>
           <a:prstGeom prst="ellipse">
             <a:avLst/>
@@ -24544,7 +24544,7 @@
         </p:nvSpPr>
         <p:spPr>
           <a:xfrm>
-            <a:off x="5019675" y="2362200"/>
+            <a:off x="5040000" y="2340000"/>
             <a:ext cx="2095500" cy="285750"/>
           </a:xfrm>
           <a:prstGeom prst="rect">
@@ -24600,7 +24600,7 @@
         </p:nvSpPr>
         <p:spPr>
           <a:xfrm>
-            <a:off x="4333875" y="3000375"/>
+            <a:off x="4320000" y="3060000"/>
             <a:ext cx="2905125" cy="428625"/>
           </a:xfrm>
           <a:prstGeom prst="roundRect">
@@ -24642,7 +24642,7 @@
         </p:nvSpPr>
         <p:spPr>
           <a:xfrm>
-            <a:off x="4429125" y="3095625"/>
+            <a:off x="4500000" y="3060000"/>
             <a:ext cx="2714625" cy="238125"/>
           </a:xfrm>
           <a:prstGeom prst="rect">
@@ -24698,8 +24698,8 @@
         </p:nvSpPr>
         <p:spPr>
           <a:xfrm>
-            <a:off x="4410075" y="3714750"/>
-            <a:ext cx="2762250" cy="1000125"/>
+            <a:off x="4500000" y="3780000"/>
+            <a:ext cx="2700000" cy="1080000"/>
           </a:xfrm>
           <a:prstGeom prst="rect">
             <a:avLst/>
@@ -24800,8 +24800,8 @@
         </p:nvSpPr>
         <p:spPr>
           <a:xfrm>
-            <a:off x="7715250" y="2143125"/>
-            <a:ext cx="3286125" cy="2857500"/>
+            <a:off x="7740000" y="2160000"/>
+            <a:ext cx="3240000" cy="2880000"/>
           </a:xfrm>
           <a:prstGeom prst="roundRect">
             <a:avLst>
@@ -24842,8 +24842,8 @@
         </p:nvSpPr>
         <p:spPr>
           <a:xfrm>
-            <a:off x="7905750" y="2333625"/>
-            <a:ext cx="552450" cy="552450"/>
+            <a:off x="7920000" y="2340000"/>
+            <a:ext cx="540000" cy="540000"/>
           </a:xfrm>
           <a:prstGeom prst="ellipse">
             <a:avLst/>
@@ -24902,7 +24902,7 @@
         </p:nvSpPr>
         <p:spPr>
           <a:xfrm>
-            <a:off x="8591550" y="2362200"/>
+            <a:off x="8640000" y="2340000"/>
             <a:ext cx="2095500" cy="285750"/>
           </a:xfrm>
           <a:prstGeom prst="rect">
@@ -24958,7 +24958,7 @@
         </p:nvSpPr>
         <p:spPr>
           <a:xfrm>
-            <a:off x="7905750" y="3000375"/>
+            <a:off x="7920000" y="3060000"/>
             <a:ext cx="2905125" cy="428625"/>
           </a:xfrm>
           <a:prstGeom prst="roundRect">
@@ -25000,7 +25000,7 @@
         </p:nvSpPr>
         <p:spPr>
           <a:xfrm>
-            <a:off x="8001000" y="3095625"/>
+            <a:off x="7920000" y="3060000"/>
             <a:ext cx="2714625" cy="238125"/>
           </a:xfrm>
           <a:prstGeom prst="rect">
@@ -25056,8 +25056,8 @@
         </p:nvSpPr>
         <p:spPr>
           <a:xfrm>
-            <a:off x="7981950" y="3714750"/>
-            <a:ext cx="2762250" cy="1000125"/>
+            <a:off x="7920000" y="3780000"/>
+            <a:ext cx="2700000" cy="1080000"/>
           </a:xfrm>
           <a:prstGeom prst="rect">
             <a:avLst/>
@@ -25158,8 +25158,8 @@
         </p:nvSpPr>
         <p:spPr>
           <a:xfrm>
-            <a:off x="2190750" y="5286375"/>
-            <a:ext cx="7810500" cy="571500"/>
+            <a:off x="2160000" y="5220000"/>
+            <a:ext cx="7740000" cy="540000"/>
           </a:xfrm>
           <a:prstGeom prst="roundRect">
             <a:avLst>
@@ -25200,7 +25200,7 @@
         </p:nvSpPr>
         <p:spPr>
           <a:xfrm>
-            <a:off x="2428875" y="5410200"/>
+            <a:off x="2340000" y="5400000"/>
             <a:ext cx="7334250" cy="323850"/>
           </a:xfrm>
           <a:prstGeom prst="rect">
@@ -25314,7 +25314,7 @@
         </p:nvSpPr>
         <p:spPr>
           <a:xfrm>
-            <a:off x="476250" y="1133475"/>
+            <a:off x="540000" y="1080000"/>
             <a:ext cx="11239500" cy="0"/>
           </a:xfrm>
           <a:prstGeom prst="line">
@@ -25351,7 +25351,7 @@
         </p:nvSpPr>
         <p:spPr>
           <a:xfrm>
-            <a:off x="523875" y="1362075"/>
+            <a:off x="540000" y="1440000"/>
             <a:ext cx="11096625" cy="361950"/>
           </a:xfrm>
           <a:prstGeom prst="rect">
@@ -25407,7 +25407,7 @@
         </p:nvSpPr>
         <p:spPr>
           <a:xfrm>
-            <a:off x="476250" y="6353175"/>
+            <a:off x="540000" y="6300000"/>
             <a:ext cx="333375" cy="209550"/>
           </a:xfrm>
           <a:prstGeom prst="rect">
@@ -25463,7 +25463,7 @@
         </p:nvSpPr>
         <p:spPr>
           <a:xfrm>
-            <a:off x="933450" y="6353175"/>
+            <a:off x="900000" y="6300000"/>
             <a:ext cx="857250" cy="209550"/>
           </a:xfrm>
           <a:prstGeom prst="rect">
@@ -25519,7 +25519,7 @@
         </p:nvSpPr>
         <p:spPr>
           <a:xfrm>
-            <a:off x="1809750" y="4905375"/>
+            <a:off x="1800000" y="4860000"/>
             <a:ext cx="8191500" cy="0"/>
           </a:xfrm>
           <a:prstGeom prst="line">
@@ -25556,7 +25556,7 @@
         </p:nvSpPr>
         <p:spPr>
           <a:xfrm>
-            <a:off x="1809750" y="2047875"/>
+            <a:off x="1800000" y="1980000"/>
             <a:ext cx="0" cy="2857500"/>
           </a:xfrm>
           <a:prstGeom prst="line">
@@ -25593,7 +25593,7 @@
         </p:nvSpPr>
         <p:spPr>
           <a:xfrm>
-            <a:off x="1790700" y="5106761"/>
+            <a:off x="1800000" y="5040000"/>
             <a:ext cx="1428750" cy="238125"/>
           </a:xfrm>
           <a:prstGeom prst="rect">
@@ -25679,7 +25679,7 @@
         </p:nvSpPr>
         <p:spPr>
           <a:xfrm>
-            <a:off x="8422821" y="5106760"/>
+            <a:off x="8460000" y="5040000"/>
             <a:ext cx="1619250" cy="238125"/>
           </a:xfrm>
           <a:prstGeom prst="rect">
@@ -25765,7 +25765,7 @@
         </p:nvSpPr>
         <p:spPr>
           <a:xfrm>
-            <a:off x="523875" y="1786618"/>
+            <a:off x="540000" y="1800000"/>
             <a:ext cx="1714500" cy="238125"/>
           </a:xfrm>
           <a:prstGeom prst="rect">
@@ -25851,7 +25851,7 @@
         </p:nvSpPr>
         <p:spPr>
           <a:xfrm>
-            <a:off x="528637" y="4862512"/>
+            <a:off x="540000" y="4860000"/>
             <a:ext cx="1666875" cy="238125"/>
           </a:xfrm>
           <a:prstGeom prst="rect">
@@ -25937,7 +25937,7 @@
         </p:nvSpPr>
         <p:spPr>
           <a:xfrm>
-            <a:off x="2619375" y="2428875"/>
+            <a:off x="2700000" y="2340000"/>
             <a:ext cx="323850" cy="323850"/>
           </a:xfrm>
           <a:prstGeom prst="ellipse">
@@ -25977,7 +25977,7 @@
         </p:nvSpPr>
         <p:spPr>
           <a:xfrm>
-            <a:off x="1905000" y="2066925"/>
+            <a:off x="1980000" y="1980000"/>
             <a:ext cx="1762125" cy="238125"/>
           </a:xfrm>
           <a:prstGeom prst="rect">
@@ -26033,7 +26033,7 @@
         </p:nvSpPr>
         <p:spPr>
           <a:xfrm>
-            <a:off x="1809750" y="2828925"/>
+            <a:off x="1800000" y="2880000"/>
             <a:ext cx="1952625" cy="495300"/>
           </a:xfrm>
           <a:prstGeom prst="rect">
@@ -26112,7 +26112,7 @@
         </p:nvSpPr>
         <p:spPr>
           <a:xfrm>
-            <a:off x="5191125" y="3190875"/>
+            <a:off x="5220000" y="3240000"/>
             <a:ext cx="323850" cy="323850"/>
           </a:xfrm>
           <a:prstGeom prst="ellipse">
@@ -26152,7 +26152,7 @@
         </p:nvSpPr>
         <p:spPr>
           <a:xfrm>
-            <a:off x="4476750" y="2828925"/>
+            <a:off x="4500000" y="2880000"/>
             <a:ext cx="1762125" cy="238125"/>
           </a:xfrm>
           <a:prstGeom prst="rect">
@@ -26208,7 +26208,7 @@
         </p:nvSpPr>
         <p:spPr>
           <a:xfrm>
-            <a:off x="4381500" y="3590925"/>
+            <a:off x="4320000" y="3600000"/>
             <a:ext cx="1952625" cy="495300"/>
           </a:xfrm>
           <a:prstGeom prst="rect">
@@ -26287,7 +26287,7 @@
         </p:nvSpPr>
         <p:spPr>
           <a:xfrm>
-            <a:off x="7000875" y="2286000"/>
+            <a:off x="7020000" y="2340000"/>
             <a:ext cx="323850" cy="323850"/>
           </a:xfrm>
           <a:prstGeom prst="ellipse">
@@ -26327,7 +26327,7 @@
         </p:nvSpPr>
         <p:spPr>
           <a:xfrm>
-            <a:off x="6286500" y="1924050"/>
+            <a:off x="6300000" y="1980000"/>
             <a:ext cx="1762125" cy="238125"/>
           </a:xfrm>
           <a:prstGeom prst="rect">
@@ -26383,7 +26383,7 @@
         </p:nvSpPr>
         <p:spPr>
           <a:xfrm>
-            <a:off x="6191250" y="2686050"/>
+            <a:off x="6120000" y="2700000"/>
             <a:ext cx="1952625" cy="495300"/>
           </a:xfrm>
           <a:prstGeom prst="rect">
@@ -26462,7 +26462,7 @@
         </p:nvSpPr>
         <p:spPr>
           <a:xfrm>
-            <a:off x="8572500" y="3857625"/>
+            <a:off x="8640000" y="3780000"/>
             <a:ext cx="323850" cy="323850"/>
           </a:xfrm>
           <a:prstGeom prst="ellipse">
@@ -26502,7 +26502,7 @@
         </p:nvSpPr>
         <p:spPr>
           <a:xfrm>
-            <a:off x="7858125" y="3495675"/>
+            <a:off x="7920000" y="3420000"/>
             <a:ext cx="1762125" cy="238125"/>
           </a:xfrm>
           <a:prstGeom prst="rect">
@@ -26558,7 +26558,7 @@
         </p:nvSpPr>
         <p:spPr>
           <a:xfrm>
-            <a:off x="7762875" y="4257675"/>
+            <a:off x="7740000" y="4320000"/>
             <a:ext cx="1952625" cy="495300"/>
           </a:xfrm>
           <a:prstGeom prst="rect">
@@ -26637,7 +26637,7 @@
         </p:nvSpPr>
         <p:spPr>
           <a:xfrm>
-            <a:off x="2524125" y="5572125"/>
+            <a:off x="2520000" y="5580000"/>
             <a:ext cx="7143750" cy="400050"/>
           </a:xfrm>
           <a:prstGeom prst="roundRect">
@@ -26679,7 +26679,7 @@
         </p:nvSpPr>
         <p:spPr>
           <a:xfrm>
-            <a:off x="2714625" y="5657850"/>
+            <a:off x="2700000" y="5580000"/>
             <a:ext cx="6762750" cy="228600"/>
           </a:xfrm>
           <a:prstGeom prst="rect">
@@ -26984,7 +26984,7 @@
         </p:nvSpPr>
         <p:spPr>
           <a:xfrm>
-            <a:off x="476250" y="1133475"/>
+            <a:off x="540000" y="1080000"/>
             <a:ext cx="11239500" cy="0"/>
           </a:xfrm>
           <a:prstGeom prst="line">
@@ -27021,7 +27021,7 @@
         </p:nvSpPr>
         <p:spPr>
           <a:xfrm>
-            <a:off x="476251" y="1362075"/>
+            <a:off x="540000" y="1440000"/>
             <a:ext cx="11239500" cy="361950"/>
           </a:xfrm>
           <a:prstGeom prst="rect">
@@ -27077,7 +27077,7 @@
         </p:nvSpPr>
         <p:spPr>
           <a:xfrm>
-            <a:off x="476250" y="6353175"/>
+            <a:off x="540000" y="6300000"/>
             <a:ext cx="333375" cy="209550"/>
           </a:xfrm>
           <a:prstGeom prst="rect">
@@ -27133,7 +27133,7 @@
         </p:nvSpPr>
         <p:spPr>
           <a:xfrm>
-            <a:off x="933450" y="6353175"/>
+            <a:off x="900000" y="6300000"/>
             <a:ext cx="857250" cy="209550"/>
           </a:xfrm>
           <a:prstGeom prst="rect">
@@ -27189,8 +27189,8 @@
         </p:nvSpPr>
         <p:spPr>
           <a:xfrm>
-            <a:off x="857250" y="2095500"/>
-            <a:ext cx="685800" cy="685800"/>
+            <a:off x="900000" y="2160000"/>
+            <a:ext cx="720000" cy="720000"/>
           </a:xfrm>
           <a:prstGeom prst="ellipse">
             <a:avLst/>
@@ -27249,7 +27249,7 @@
         </p:nvSpPr>
         <p:spPr>
           <a:xfrm>
-            <a:off x="1857375" y="2124075"/>
+            <a:off x="1800000" y="2160000"/>
             <a:ext cx="3429000" cy="323850"/>
           </a:xfrm>
           <a:prstGeom prst="rect">
@@ -27305,8 +27305,8 @@
         </p:nvSpPr>
         <p:spPr>
           <a:xfrm>
-            <a:off x="5334000" y="2076450"/>
-            <a:ext cx="5810250" cy="590550"/>
+            <a:off x="5400000" y="2160000"/>
+            <a:ext cx="5760000" cy="540000"/>
           </a:xfrm>
           <a:prstGeom prst="rect">
             <a:avLst/>
@@ -27361,7 +27361,7 @@
         </p:nvSpPr>
         <p:spPr>
           <a:xfrm>
-            <a:off x="1857375" y="2905125"/>
+            <a:off x="1800000" y="2880000"/>
             <a:ext cx="9286875" cy="0"/>
           </a:xfrm>
           <a:prstGeom prst="line">
@@ -27398,8 +27398,8 @@
         </p:nvSpPr>
         <p:spPr>
           <a:xfrm>
-            <a:off x="857250" y="3238500"/>
-            <a:ext cx="685800" cy="685800"/>
+            <a:off x="900000" y="3240000"/>
+            <a:ext cx="720000" cy="720000"/>
           </a:xfrm>
           <a:prstGeom prst="ellipse">
             <a:avLst/>
@@ -27458,7 +27458,7 @@
         </p:nvSpPr>
         <p:spPr>
           <a:xfrm>
-            <a:off x="1857375" y="3267075"/>
+            <a:off x="1800000" y="3240000"/>
             <a:ext cx="3429000" cy="323850"/>
           </a:xfrm>
           <a:prstGeom prst="rect">
@@ -27514,8 +27514,8 @@
         </p:nvSpPr>
         <p:spPr>
           <a:xfrm>
-            <a:off x="5334000" y="3219450"/>
-            <a:ext cx="5810250" cy="590550"/>
+            <a:off x="5400000" y="3240000"/>
+            <a:ext cx="5760000" cy="540000"/>
           </a:xfrm>
           <a:prstGeom prst="rect">
             <a:avLst/>
@@ -27570,7 +27570,7 @@
         </p:nvSpPr>
         <p:spPr>
           <a:xfrm>
-            <a:off x="1857375" y="4048125"/>
+            <a:off x="1800000" y="3960000"/>
             <a:ext cx="9286875" cy="0"/>
           </a:xfrm>
           <a:prstGeom prst="line">
@@ -27607,8 +27607,8 @@
         </p:nvSpPr>
         <p:spPr>
           <a:xfrm>
-            <a:off x="857250" y="4381500"/>
-            <a:ext cx="685800" cy="685800"/>
+            <a:off x="900000" y="4320000"/>
+            <a:ext cx="720000" cy="720000"/>
           </a:xfrm>
           <a:prstGeom prst="ellipse">
             <a:avLst/>
@@ -27667,7 +27667,7 @@
         </p:nvSpPr>
         <p:spPr>
           <a:xfrm>
-            <a:off x="1857375" y="4410075"/>
+            <a:off x="1800000" y="4500000"/>
             <a:ext cx="3429000" cy="323850"/>
           </a:xfrm>
           <a:prstGeom prst="rect">
@@ -27723,8 +27723,8 @@
         </p:nvSpPr>
         <p:spPr>
           <a:xfrm>
-            <a:off x="5334000" y="4362450"/>
-            <a:ext cx="5810250" cy="590550"/>
+            <a:off x="5400000" y="4320000"/>
+            <a:ext cx="5760000" cy="540000"/>
           </a:xfrm>
           <a:prstGeom prst="rect">
             <a:avLst/>
@@ -27779,7 +27779,7 @@
         </p:nvSpPr>
         <p:spPr>
           <a:xfrm>
-            <a:off x="2476500" y="5572125"/>
+            <a:off x="2520000" y="5580000"/>
             <a:ext cx="7239000" cy="400050"/>
           </a:xfrm>
           <a:prstGeom prst="roundRect">
@@ -27821,7 +27821,7 @@
         </p:nvSpPr>
         <p:spPr>
           <a:xfrm>
-            <a:off x="2714625" y="5603420"/>
+            <a:off x="2700000" y="5580000"/>
             <a:ext cx="6762750" cy="228600"/>
           </a:xfrm>
           <a:prstGeom prst="rect">
@@ -28369,8 +28369,8 @@
         </p:nvSpPr>
         <p:spPr>
           <a:xfrm>
-            <a:off x="479425" y="1412874"/>
-            <a:ext cx="2016125" cy="2016125"/>
+            <a:off x="540000" y="1440000"/>
+            <a:ext cx="1980000" cy="1980000"/>
           </a:xfrm>
           <a:prstGeom prst="ellipse">
             <a:avLst/>
@@ -28435,8 +28435,8 @@
         </p:nvSpPr>
         <p:spPr>
           <a:xfrm>
-            <a:off x="6191250" y="1412873"/>
-            <a:ext cx="2016125" cy="2016125"/>
+            <a:off x="6120000" y="1440000"/>
+            <a:ext cx="1980000" cy="1980000"/>
           </a:xfrm>
           <a:prstGeom prst="ellipse">
             <a:avLst/>
@@ -28503,8 +28503,8 @@
         </p:nvSpPr>
         <p:spPr>
           <a:xfrm>
-            <a:off x="6191250" y="3591718"/>
-            <a:ext cx="3332302" cy="1894681"/>
+            <a:off x="6120000" y="3600000"/>
+            <a:ext cx="3420000" cy="1980000"/>
           </a:xfrm>
           <a:prstGeom prst="rect">
             <a:avLst/>
@@ -29005,7 +29005,7 @@
         </p:nvGrpSpPr>
         <p:grpSpPr>
           <a:xfrm>
-            <a:off x="479421" y="3691487"/>
+            <a:off x="540000" y="3780000"/>
             <a:ext cx="11329274" cy="1809720"/>
             <a:chOff x="380265" y="3161590"/>
             <a:chExt cx="11329274" cy="1809720"/>
@@ -30654,7 +30654,7 @@
         </p:nvSpPr>
         <p:spPr>
           <a:xfrm>
-            <a:off x="479421" y="2756433"/>
+            <a:off x="540000" y="2700000"/>
             <a:ext cx="3419470" cy="45719"/>
           </a:xfrm>
           <a:prstGeom prst="rect">
@@ -30702,7 +30702,7 @@
         </p:nvSpPr>
         <p:spPr>
           <a:xfrm>
-            <a:off x="4434322" y="2754675"/>
+            <a:off x="4500000" y="2700000"/>
             <a:ext cx="3419473" cy="45719"/>
           </a:xfrm>
           <a:prstGeom prst="rect">
@@ -30736,7 +30736,7 @@
         </p:nvSpPr>
         <p:spPr>
           <a:xfrm>
-            <a:off x="8389222" y="2749092"/>
+            <a:off x="8460000" y="2700000"/>
             <a:ext cx="3419474" cy="47624"/>
           </a:xfrm>
           <a:prstGeom prst="rect">
@@ -30768,7 +30768,7 @@
         </p:nvSpPr>
         <p:spPr>
           <a:xfrm>
-            <a:off x="479421" y="2883822"/>
+            <a:off x="540000" y="2880000"/>
             <a:ext cx="474453" cy="276999"/>
           </a:xfrm>
           <a:prstGeom prst="rect">
@@ -30805,7 +30805,7 @@
         </p:nvSpPr>
         <p:spPr>
           <a:xfrm>
-            <a:off x="4434319" y="2883823"/>
+            <a:off x="4500000" y="2880000"/>
             <a:ext cx="474453" cy="276999"/>
           </a:xfrm>
           <a:prstGeom prst="rect">
@@ -30850,7 +30850,7 @@
         </p:nvSpPr>
         <p:spPr>
           <a:xfrm>
-            <a:off x="8404569" y="2889066"/>
+            <a:off x="8460000" y="2880000"/>
             <a:ext cx="474453" cy="276999"/>
           </a:xfrm>
           <a:prstGeom prst="rect">
@@ -30925,8 +30925,8 @@
         </p:nvSpPr>
         <p:spPr>
           <a:xfrm>
-            <a:off x="482461" y="4857750"/>
-            <a:ext cx="11042789" cy="1028700"/>
+            <a:off x="540000" y="4860000"/>
+            <a:ext cx="10980000" cy="1080000"/>
           </a:xfrm>
           <a:custGeom>
             <a:avLst/>
@@ -31114,8 +31114,8 @@
         </p:nvSpPr>
         <p:spPr>
           <a:xfrm>
-            <a:off x="666750" y="1673516"/>
-            <a:ext cx="4572000" cy="2818746"/>
+            <a:off x="720000" y="1620000"/>
+            <a:ext cx="4500000" cy="2880000"/>
           </a:xfrm>
           <a:custGeom>
             <a:avLst/>
@@ -31267,8 +31267,8 @@
         </p:nvSpPr>
         <p:spPr>
           <a:xfrm>
-            <a:off x="6953250" y="1698989"/>
-            <a:ext cx="4572001" cy="2818746"/>
+            <a:off x="7020000" y="1620000"/>
+            <a:ext cx="4500000" cy="2880000"/>
           </a:xfrm>
           <a:custGeom>
             <a:avLst/>
@@ -31523,7 +31523,7 @@
         </p:nvSpPr>
         <p:spPr>
           <a:xfrm>
-            <a:off x="666750" y="1666875"/>
+            <a:off x="720000" y="1620000"/>
             <a:ext cx="4572000" cy="76200"/>
           </a:xfrm>
           <a:prstGeom prst="rect">
@@ -31563,7 +31563,7 @@
         </p:nvSpPr>
         <p:spPr>
           <a:xfrm>
-            <a:off x="6953250" y="1666875"/>
+            <a:off x="7020000" y="1620000"/>
             <a:ext cx="4572000" cy="76200"/>
           </a:xfrm>
           <a:prstGeom prst="rect">
@@ -31607,8 +31607,8 @@
         </p:nvSpPr>
         <p:spPr>
           <a:xfrm>
-            <a:off x="5476875" y="2724150"/>
-            <a:ext cx="1238250" cy="666750"/>
+            <a:off x="5400000" y="2700000"/>
+            <a:ext cx="1260000" cy="720000"/>
           </a:xfrm>
           <a:prstGeom prst="rightArrow">
             <a:avLst/>
@@ -31647,7 +31647,7 @@
         </p:nvSpPr>
         <p:spPr>
           <a:xfrm>
-            <a:off x="666750" y="4857750"/>
+            <a:off x="720000" y="4860000"/>
             <a:ext cx="85725" cy="1028700"/>
           </a:xfrm>
           <a:prstGeom prst="rect">
@@ -31687,8 +31687,8 @@
         </p:nvSpPr>
         <p:spPr>
           <a:xfrm>
-            <a:off x="7277100" y="2000250"/>
-            <a:ext cx="990600" cy="990600"/>
+            <a:off x="7200000" y="1980000"/>
+            <a:ext cx="1080000" cy="1080000"/>
           </a:xfrm>
           <a:prstGeom prst="ellipse">
             <a:avLst/>
@@ -31731,7 +31731,7 @@
         </p:blipFill>
         <p:spPr>
           <a:xfrm>
-            <a:off x="7505700" y="2228850"/>
+            <a:off x="7560000" y="2160000"/>
             <a:ext cx="533400" cy="533400"/>
           </a:xfrm>
           <a:prstGeom prst="rect">
@@ -31755,7 +31755,7 @@
         </p:nvSpPr>
         <p:spPr>
           <a:xfrm>
-            <a:off x="8496300" y="2057400"/>
+            <a:off x="8460000" y="1980000"/>
             <a:ext cx="2667000" cy="266700"/>
           </a:xfrm>
           <a:prstGeom prst="rect">
@@ -31811,7 +31811,7 @@
         </p:nvSpPr>
         <p:spPr>
           <a:xfrm>
-            <a:off x="8496300" y="2400300"/>
+            <a:off x="8460000" y="2340000"/>
             <a:ext cx="2667000" cy="495300"/>
           </a:xfrm>
           <a:prstGeom prst="rect">
@@ -31867,8 +31867,8 @@
         </p:nvSpPr>
         <p:spPr>
           <a:xfrm>
-            <a:off x="7277100" y="3295650"/>
-            <a:ext cx="3905250" cy="895350"/>
+            <a:off x="7200000" y="3240000"/>
+            <a:ext cx="3960000" cy="900000"/>
           </a:xfrm>
           <a:prstGeom prst="rect">
             <a:avLst/>
@@ -32023,8 +32023,8 @@
         </p:nvSpPr>
         <p:spPr>
           <a:xfrm>
-            <a:off x="990600" y="2000250"/>
-            <a:ext cx="990600" cy="990600"/>
+            <a:off x="1080000" y="1980000"/>
+            <a:ext cx="1080000" cy="1080000"/>
           </a:xfrm>
           <a:prstGeom prst="ellipse">
             <a:avLst/>
@@ -32067,7 +32067,7 @@
         </p:blipFill>
         <p:spPr>
           <a:xfrm>
-            <a:off x="1219200" y="2228850"/>
+            <a:off x="1260000" y="2160000"/>
             <a:ext cx="533400" cy="533400"/>
           </a:xfrm>
           <a:prstGeom prst="rect">
@@ -32091,7 +32091,7 @@
         </p:nvSpPr>
         <p:spPr>
           <a:xfrm>
-            <a:off x="2209800" y="2057400"/>
+            <a:off x="2160000" y="1980000"/>
             <a:ext cx="2667000" cy="266700"/>
           </a:xfrm>
           <a:prstGeom prst="rect">
@@ -32147,7 +32147,7 @@
         </p:nvSpPr>
         <p:spPr>
           <a:xfrm>
-            <a:off x="2209800" y="2400300"/>
+            <a:off x="2160000" y="2340000"/>
             <a:ext cx="2667000" cy="495300"/>
           </a:xfrm>
           <a:prstGeom prst="rect">
@@ -32203,8 +32203,8 @@
         </p:nvSpPr>
         <p:spPr>
           <a:xfrm>
-            <a:off x="990600" y="3295650"/>
-            <a:ext cx="3905250" cy="895350"/>
+            <a:off x="1080000" y="3240000"/>
+            <a:ext cx="3960000" cy="900000"/>
           </a:xfrm>
           <a:prstGeom prst="rect">
             <a:avLst/>
@@ -32352,7 +32352,7 @@
         </p:blipFill>
         <p:spPr>
           <a:xfrm>
-            <a:off x="971550" y="5067300"/>
+            <a:off x="900000" y="5040000"/>
             <a:ext cx="609600" cy="609600"/>
           </a:xfrm>
           <a:prstGeom prst="rect">
@@ -32376,7 +32376,7 @@
         </p:nvSpPr>
         <p:spPr>
           <a:xfrm>
-            <a:off x="1809750" y="5010150"/>
+            <a:off x="1800000" y="5040000"/>
             <a:ext cx="2381250" cy="361950"/>
           </a:xfrm>
           <a:prstGeom prst="rect">
@@ -32440,7 +32440,7 @@
         </p:nvSpPr>
         <p:spPr>
           <a:xfrm>
-            <a:off x="1809750" y="5391150"/>
+            <a:off x="1800000" y="5400000"/>
             <a:ext cx="8953500" cy="361950"/>
           </a:xfrm>
           <a:prstGeom prst="rect">
@@ -32530,8 +32530,8 @@
         </p:nvSpPr>
         <p:spPr>
           <a:xfrm>
-            <a:off x="9337998" y="4210332"/>
-            <a:ext cx="2441633" cy="1518578"/>
+            <a:off x="9360000" y="4140000"/>
+            <a:ext cx="2520000" cy="1440000"/>
           </a:xfrm>
           <a:custGeom>
             <a:avLst/>
@@ -32681,8 +32681,8 @@
         </p:nvSpPr>
         <p:spPr>
           <a:xfrm>
-            <a:off x="6482361" y="4206511"/>
-            <a:ext cx="2441633" cy="1518578"/>
+            <a:off x="6480000" y="4140000"/>
+            <a:ext cx="2520000" cy="1440000"/>
           </a:xfrm>
           <a:custGeom>
             <a:avLst/>
@@ -32832,8 +32832,8 @@
         </p:nvSpPr>
         <p:spPr>
           <a:xfrm>
-            <a:off x="3627560" y="4210332"/>
-            <a:ext cx="2441633" cy="1518578"/>
+            <a:off x="3600000" y="4140000"/>
+            <a:ext cx="2520000" cy="1440000"/>
           </a:xfrm>
           <a:custGeom>
             <a:avLst/>
@@ -32983,8 +32983,8 @@
         </p:nvSpPr>
         <p:spPr>
           <a:xfrm>
-            <a:off x="668204" y="4230513"/>
-            <a:ext cx="2441633" cy="1518578"/>
+            <a:off x="720000" y="4320000"/>
+            <a:ext cx="2520000" cy="1440000"/>
           </a:xfrm>
           <a:custGeom>
             <a:avLst/>
@@ -33403,7 +33403,7 @@
         </p:nvSpPr>
         <p:spPr>
           <a:xfrm>
-            <a:off x="668266" y="4788671"/>
+            <a:off x="720000" y="4860000"/>
             <a:ext cx="2441571" cy="0"/>
           </a:xfrm>
           <a:prstGeom prst="line">
@@ -33454,7 +33454,7 @@
         </p:nvSpPr>
         <p:spPr>
           <a:xfrm>
-            <a:off x="668265" y="4394296"/>
+            <a:off x="720000" y="4320000"/>
             <a:ext cx="2441570" cy="276999"/>
           </a:xfrm>
           <a:prstGeom prst="rect">
@@ -33509,8 +33509,8 @@
         </p:nvSpPr>
         <p:spPr>
           <a:xfrm>
-            <a:off x="668263" y="4954814"/>
-            <a:ext cx="2441571" cy="553998"/>
+            <a:off x="720000" y="5040000"/>
+            <a:ext cx="2520000" cy="540000"/>
           </a:xfrm>
           <a:prstGeom prst="rect">
             <a:avLst/>
@@ -33607,7 +33607,7 @@
         </p:nvSpPr>
         <p:spPr>
           <a:xfrm>
-            <a:off x="3627642" y="4394296"/>
+            <a:off x="3600000" y="4320000"/>
             <a:ext cx="2441571" cy="276999"/>
           </a:xfrm>
           <a:prstGeom prst="rect">
@@ -33662,8 +33662,8 @@
         </p:nvSpPr>
         <p:spPr>
           <a:xfrm>
-            <a:off x="3634826" y="4954814"/>
-            <a:ext cx="2441571" cy="553998"/>
+            <a:off x="3600000" y="5040000"/>
+            <a:ext cx="2520000" cy="540000"/>
           </a:xfrm>
           <a:prstGeom prst="rect">
             <a:avLst/>
@@ -33771,7 +33771,7 @@
         </p:nvSpPr>
         <p:spPr>
           <a:xfrm>
-            <a:off x="6489637" y="4758515"/>
+            <a:off x="6480000" y="4680000"/>
             <a:ext cx="2441568" cy="0"/>
           </a:xfrm>
           <a:prstGeom prst="line">
@@ -33822,7 +33822,7 @@
         </p:nvSpPr>
         <p:spPr>
           <a:xfrm>
-            <a:off x="6489635" y="4394296"/>
+            <a:off x="6480000" y="4320000"/>
             <a:ext cx="2441570" cy="276999"/>
           </a:xfrm>
           <a:prstGeom prst="rect">
@@ -33877,8 +33877,8 @@
         </p:nvSpPr>
         <p:spPr>
           <a:xfrm>
-            <a:off x="6489636" y="4954814"/>
-            <a:ext cx="2441568" cy="553998"/>
+            <a:off x="6480000" y="5040000"/>
+            <a:ext cx="2520000" cy="540000"/>
           </a:xfrm>
           <a:prstGeom prst="rect">
             <a:avLst/>
@@ -33956,7 +33956,7 @@
         </p:nvSpPr>
         <p:spPr>
           <a:xfrm>
-            <a:off x="9344444" y="4791446"/>
+            <a:off x="9360000" y="4860000"/>
             <a:ext cx="2441567" cy="0"/>
           </a:xfrm>
           <a:prstGeom prst="line">
@@ -34007,7 +34007,7 @@
         </p:nvSpPr>
         <p:spPr>
           <a:xfrm>
-            <a:off x="9344442" y="4394296"/>
+            <a:off x="9360000" y="4320000"/>
             <a:ext cx="2621587" cy="276999"/>
           </a:xfrm>
           <a:prstGeom prst="rect">
@@ -34062,7 +34062,7 @@
         </p:nvSpPr>
         <p:spPr>
           <a:xfrm>
-            <a:off x="9337142" y="4977897"/>
+            <a:off x="9360000" y="5040000"/>
             <a:ext cx="2448869" cy="507831"/>
           </a:xfrm>
           <a:prstGeom prst="rect">
@@ -34179,8 +34179,8 @@
         </p:nvSpPr>
         <p:spPr>
           <a:xfrm>
-            <a:off x="4286250" y="2524495"/>
-            <a:ext cx="3619500" cy="819150"/>
+            <a:off x="4320000" y="2520000"/>
+            <a:ext cx="3600000" cy="900000"/>
           </a:xfrm>
           <a:prstGeom prst="roundRect">
             <a:avLst>
@@ -34240,7 +34240,7 @@
         </p:nvSpPr>
         <p:spPr>
           <a:xfrm>
-            <a:off x="4286250" y="2780181"/>
+            <a:off x="4320000" y="2700000"/>
             <a:ext cx="3619500" cy="307777"/>
           </a:xfrm>
           <a:prstGeom prst="rect">
@@ -34305,8 +34305,8 @@
         </p:nvCxnSpPr>
         <p:spPr>
           <a:xfrm flipV="1">
-            <a:off x="1889046" y="2934070"/>
-            <a:ext cx="2397204" cy="1276262"/>
+            <a:off x="1940771" y="2853888"/>
+            <a:ext cx="2379228" cy="1286111"/>
           </a:xfrm>
           <a:prstGeom prst="straightConnector1">
             <a:avLst/>
@@ -34442,8 +34442,8 @@
         </p:nvCxnSpPr>
         <p:spPr>
           <a:xfrm flipH="1" flipV="1">
-            <a:off x="7905750" y="2934070"/>
-            <a:ext cx="2644188" cy="1264278"/>
+            <a:off x="7939500" y="2853888"/>
+            <a:ext cx="2641271" cy="1286111"/>
           </a:xfrm>
           <a:prstGeom prst="straightConnector1">
             <a:avLst/>
@@ -34487,7 +34487,7 @@
         </p:nvSpPr>
         <p:spPr>
           <a:xfrm>
-            <a:off x="668274" y="4210332"/>
+            <a:off x="720000" y="4140000"/>
             <a:ext cx="2441543" cy="93355"/>
           </a:xfrm>
           <a:prstGeom prst="rect">
@@ -34527,7 +34527,7 @@
         </p:nvSpPr>
         <p:spPr>
           <a:xfrm>
-            <a:off x="3626724" y="4210332"/>
+            <a:off x="3600000" y="4140000"/>
             <a:ext cx="2441543" cy="97758"/>
           </a:xfrm>
           <a:prstGeom prst="rect">
@@ -34567,7 +34567,7 @@
         </p:nvSpPr>
         <p:spPr>
           <a:xfrm>
-            <a:off x="6475178" y="4206511"/>
+            <a:off x="6480000" y="4140000"/>
             <a:ext cx="2441543" cy="97169"/>
           </a:xfrm>
           <a:prstGeom prst="rect">
@@ -34607,7 +34607,7 @@
         </p:nvSpPr>
         <p:spPr>
           <a:xfrm>
-            <a:off x="9329166" y="4198348"/>
+            <a:off x="9360000" y="4140000"/>
             <a:ext cx="2441543" cy="105340"/>
           </a:xfrm>
           <a:prstGeom prst="rect">
@@ -34647,7 +34647,7 @@
         </p:nvSpPr>
         <p:spPr>
           <a:xfrm>
-            <a:off x="4286250" y="2052156"/>
+            <a:off x="4320000" y="1980000"/>
             <a:ext cx="3619500" cy="472727"/>
           </a:xfrm>
           <a:prstGeom prst="rect">
@@ -34788,7 +34788,7 @@
         </p:nvSpPr>
         <p:spPr>
           <a:xfrm>
-            <a:off x="3626699" y="4788671"/>
+            <a:off x="3600000" y="4860000"/>
             <a:ext cx="2441568" cy="0"/>
           </a:xfrm>
           <a:prstGeom prst="line">
@@ -34924,8 +34924,8 @@
         </p:nvCxnSpPr>
         <p:spPr>
           <a:xfrm flipV="1">
-            <a:off x="1260000" y="3505199"/>
-            <a:ext cx="0" cy="323025"/>
+            <a:off x="1260000" y="3567600"/>
+            <a:ext cx="0" cy="212400"/>
           </a:xfrm>
           <a:prstGeom prst="straightConnector1">
             <a:avLst/>
@@ -34973,8 +34973,8 @@
         </p:nvCxnSpPr>
         <p:spPr>
           <a:xfrm flipV="1">
-            <a:off x="1260000" y="2314574"/>
-            <a:ext cx="0" cy="323025"/>
+            <a:off x="1260000" y="2307600"/>
+            <a:ext cx="0" cy="392400"/>
           </a:xfrm>
           <a:prstGeom prst="straightConnector1">
             <a:avLst/>
@@ -35022,7 +35022,7 @@
         </p:nvCxnSpPr>
         <p:spPr>
           <a:xfrm>
-            <a:off x="7380000" y="5471328"/>
+            <a:off x="7380000" y="5473800"/>
             <a:ext cx="360000" cy="0"/>
           </a:xfrm>
           <a:prstGeom prst="straightConnector1">
@@ -35071,7 +35071,7 @@
         </p:nvCxnSpPr>
         <p:spPr>
           <a:xfrm flipH="1">
-            <a:off x="7380000" y="3071399"/>
+            <a:off x="7380000" y="3133800"/>
             <a:ext cx="360000" cy="0"/>
           </a:xfrm>
           <a:prstGeom prst="straightConnector1">
@@ -35119,9 +35119,9 @@
           <p:nvPr/>
         </p:nvCxnSpPr>
         <p:spPr>
-          <a:xfrm flipV="1">
-            <a:off x="1980000" y="1866221"/>
-            <a:ext cx="2160000" cy="14553"/>
+          <a:xfrm>
+            <a:off x="1980000" y="1873800"/>
+            <a:ext cx="2160000" cy="0"/>
           </a:xfrm>
           <a:prstGeom prst="straightConnector1">
             <a:avLst/>
@@ -35169,8 +35169,8 @@
         </p:nvCxnSpPr>
         <p:spPr>
           <a:xfrm>
-            <a:off x="4860000" y="2300021"/>
-            <a:ext cx="0" cy="336752"/>
+            <a:off x="4860000" y="2307600"/>
+            <a:ext cx="0" cy="392400"/>
           </a:xfrm>
           <a:prstGeom prst="straightConnector1">
             <a:avLst/>
@@ -35217,9 +35217,9 @@
           <p:nvPr/>
         </p:nvCxnSpPr>
         <p:spPr>
-          <a:xfrm flipV="1">
-            <a:off x="9180000" y="5461803"/>
-            <a:ext cx="360000" cy="9525"/>
+          <a:xfrm>
+            <a:off x="9180000" y="5473800"/>
+            <a:ext cx="360000" cy="0"/>
           </a:xfrm>
           <a:prstGeom prst="straightConnector1">
             <a:avLst/>
@@ -35267,8 +35267,8 @@
         </p:nvCxnSpPr>
         <p:spPr>
           <a:xfrm flipV="1">
-            <a:off x="1260000" y="4695824"/>
-            <a:ext cx="0" cy="323025"/>
+            <a:off x="1260000" y="4647600"/>
+            <a:ext cx="0" cy="392400"/>
           </a:xfrm>
           <a:prstGeom prst="straightConnector1">
             <a:avLst/>
@@ -35315,9 +35315,9 @@
           <p:nvPr/>
         </p:nvCxnSpPr>
         <p:spPr>
-          <a:xfrm flipH="1" flipV="1">
-            <a:off x="9180000" y="1880774"/>
-            <a:ext cx="360000" cy="2551"/>
+          <a:xfrm flipH="1">
+            <a:off x="9180000" y="1873800"/>
+            <a:ext cx="360000" cy="0"/>
           </a:xfrm>
           <a:prstGeom prst="straightConnector1">
             <a:avLst/>
@@ -35365,8 +35365,8 @@
         </p:nvCxnSpPr>
         <p:spPr>
           <a:xfrm>
-            <a:off x="8460000" y="2314574"/>
-            <a:ext cx="0" cy="323025"/>
+            <a:off x="8460000" y="2307600"/>
+            <a:ext cx="0" cy="392400"/>
           </a:xfrm>
           <a:prstGeom prst="straightConnector1">
             <a:avLst/>
@@ -35414,8 +35414,8 @@
         </p:nvCxnSpPr>
         <p:spPr>
           <a:xfrm>
-            <a:off x="5580000" y="3070573"/>
-            <a:ext cx="360000" cy="826"/>
+            <a:off x="5580000" y="3133800"/>
+            <a:ext cx="360000" cy="0"/>
           </a:xfrm>
           <a:prstGeom prst="straightConnector1">
             <a:avLst/>
@@ -35463,8 +35463,8 @@
         </p:nvCxnSpPr>
         <p:spPr>
           <a:xfrm>
-            <a:off x="6660000" y="3505199"/>
-            <a:ext cx="0" cy="323025"/>
+            <a:off x="6660000" y="3567600"/>
+            <a:ext cx="0" cy="212400"/>
           </a:xfrm>
           <a:prstGeom prst="straightConnector1">
             <a:avLst/>
@@ -35512,7 +35512,7 @@
         </p:nvCxnSpPr>
         <p:spPr>
           <a:xfrm>
-            <a:off x="1980000" y="4262024"/>
+            <a:off x="1980000" y="4213800"/>
             <a:ext cx="360000" cy="0"/>
           </a:xfrm>
           <a:prstGeom prst="straightConnector1">
@@ -35561,7 +35561,7 @@
         </p:nvCxnSpPr>
         <p:spPr>
           <a:xfrm>
-            <a:off x="3780000" y="4262024"/>
+            <a:off x="3780000" y="4213800"/>
             <a:ext cx="360000" cy="0"/>
           </a:xfrm>
           <a:prstGeom prst="straightConnector1">
@@ -35610,8 +35610,8 @@
         </p:nvCxnSpPr>
         <p:spPr>
           <a:xfrm>
-            <a:off x="6660000" y="4695824"/>
-            <a:ext cx="0" cy="341704"/>
+            <a:off x="6660000" y="4647600"/>
+            <a:ext cx="0" cy="392400"/>
           </a:xfrm>
           <a:prstGeom prst="straightConnector1">
             <a:avLst/>
@@ -35659,7 +35659,7 @@
         </p:nvCxnSpPr>
         <p:spPr>
           <a:xfrm>
-            <a:off x="5580000" y="4262024"/>
+            <a:off x="5580000" y="4213800"/>
             <a:ext cx="360000" cy="0"/>
           </a:xfrm>
           <a:prstGeom prst="straightConnector1">
@@ -35698,7 +35698,7 @@
         </p:nvGrpSpPr>
         <p:grpSpPr>
           <a:xfrm>
-            <a:off x="540000" y="5018849"/>
+            <a:off x="540000" y="5040000"/>
             <a:ext cx="1440000" cy="867600"/>
             <a:chOff x="624215" y="5142674"/>
             <a:chExt cx="1440000" cy="867600"/>
@@ -35875,7 +35875,7 @@
         </p:nvGrpSpPr>
         <p:grpSpPr>
           <a:xfrm>
-            <a:off x="9540000" y="1449525"/>
+            <a:off x="9540000" y="1440000"/>
             <a:ext cx="1440000" cy="867600"/>
             <a:chOff x="10196840" y="1570799"/>
             <a:chExt cx="1440000" cy="867600"/>
@@ -36050,7 +36050,7 @@
         </p:nvGrpSpPr>
         <p:grpSpPr>
           <a:xfrm>
-            <a:off x="9540000" y="5028003"/>
+            <a:off x="9540000" y="5040000"/>
             <a:ext cx="1440000" cy="867600"/>
             <a:chOff x="10196840" y="5161353"/>
             <a:chExt cx="1440000" cy="867600"/>
@@ -36225,7 +36225,7 @@
         </p:nvGrpSpPr>
         <p:grpSpPr>
           <a:xfrm>
-            <a:off x="540000" y="3828224"/>
+            <a:off x="540000" y="3780000"/>
             <a:ext cx="1440000" cy="867600"/>
             <a:chOff x="622908" y="3952049"/>
             <a:chExt cx="1440000" cy="867600"/>
@@ -36414,7 +36414,7 @@
         </p:nvGrpSpPr>
         <p:grpSpPr>
           <a:xfrm>
-            <a:off x="540000" y="2637599"/>
+            <a:off x="540000" y="2700000"/>
             <a:ext cx="1440000" cy="867600"/>
             <a:chOff x="624215" y="2761424"/>
             <a:chExt cx="1440000" cy="867600"/>
@@ -36595,7 +36595,7 @@
         </p:nvGrpSpPr>
         <p:grpSpPr>
           <a:xfrm>
-            <a:off x="4140000" y="2636773"/>
+            <a:off x="4140000" y="2700000"/>
             <a:ext cx="1440000" cy="867600"/>
             <a:chOff x="5009244" y="1578083"/>
             <a:chExt cx="1440000" cy="867600"/>
@@ -36772,7 +36772,7 @@
         </p:nvGrpSpPr>
         <p:grpSpPr>
           <a:xfrm>
-            <a:off x="5940000" y="2637599"/>
+            <a:off x="5940000" y="2700000"/>
             <a:ext cx="1440000" cy="867600"/>
             <a:chOff x="5005715" y="2776165"/>
             <a:chExt cx="1440000" cy="867600"/>
@@ -36953,7 +36953,7 @@
         </p:nvGrpSpPr>
         <p:grpSpPr>
           <a:xfrm>
-            <a:off x="5940000" y="5037528"/>
+            <a:off x="5940000" y="5040000"/>
             <a:ext cx="1440000" cy="867600"/>
             <a:chOff x="5005715" y="5161353"/>
             <a:chExt cx="1440000" cy="867600"/>
@@ -37130,7 +37130,7 @@
         </p:nvGrpSpPr>
         <p:grpSpPr>
           <a:xfrm>
-            <a:off x="7740000" y="1446974"/>
+            <a:off x="7740000" y="1440000"/>
             <a:ext cx="1440000" cy="867600"/>
             <a:chOff x="7996042" y="1570799"/>
             <a:chExt cx="1440000" cy="867600"/>
@@ -37319,7 +37319,7 @@
         </p:nvGrpSpPr>
         <p:grpSpPr>
           <a:xfrm>
-            <a:off x="7740000" y="5037528"/>
+            <a:off x="7740000" y="5040000"/>
             <a:ext cx="1440000" cy="867600"/>
             <a:chOff x="8006090" y="5161353"/>
             <a:chExt cx="1440000" cy="867600"/>
@@ -37502,7 +37502,7 @@
         </p:nvGrpSpPr>
         <p:grpSpPr>
           <a:xfrm>
-            <a:off x="4140000" y="1432421"/>
+            <a:off x="4140000" y="1440000"/>
             <a:ext cx="1440000" cy="867600"/>
             <a:chOff x="2783916" y="1570799"/>
             <a:chExt cx="1440000" cy="867600"/>
@@ -37685,7 +37685,7 @@
         </p:nvGrpSpPr>
         <p:grpSpPr>
           <a:xfrm>
-            <a:off x="540000" y="1446974"/>
+            <a:off x="540000" y="1440000"/>
             <a:ext cx="1440000" cy="867600"/>
             <a:chOff x="617904" y="1570799"/>
             <a:chExt cx="1440000" cy="867600"/>
@@ -37868,7 +37868,7 @@
         </p:nvGrpSpPr>
         <p:grpSpPr>
           <a:xfrm>
-            <a:off x="7740000" y="2637599"/>
+            <a:off x="7740000" y="2700000"/>
             <a:ext cx="1440000" cy="867600"/>
             <a:chOff x="8006090" y="2794529"/>
             <a:chExt cx="1440000" cy="867600"/>
@@ -38049,7 +38049,7 @@
         </p:nvGrpSpPr>
         <p:grpSpPr>
           <a:xfrm>
-            <a:off x="2340000" y="3828224"/>
+            <a:off x="2340000" y="3780000"/>
             <a:ext cx="1440000" cy="867600"/>
             <a:chOff x="2783916" y="1570799"/>
             <a:chExt cx="1440000" cy="867600"/>
@@ -38238,7 +38238,7 @@
         </p:nvGrpSpPr>
         <p:grpSpPr>
           <a:xfrm>
-            <a:off x="4140000" y="3828224"/>
+            <a:off x="4140000" y="3780000"/>
             <a:ext cx="1440000" cy="867600"/>
             <a:chOff x="5005715" y="2776165"/>
             <a:chExt cx="1440000" cy="867600"/>
@@ -38425,7 +38425,7 @@
         </p:nvGrpSpPr>
         <p:grpSpPr>
           <a:xfrm>
-            <a:off x="5940000" y="3828224"/>
+            <a:off x="5940000" y="3780000"/>
             <a:ext cx="1440000" cy="867600"/>
             <a:chOff x="2783916" y="1570799"/>
             <a:chExt cx="1440000" cy="867600"/>
@@ -38612,8 +38612,8 @@
         </p:nvCxnSpPr>
         <p:spPr>
           <a:xfrm flipH="1">
-            <a:off x="8460000" y="2317125"/>
-            <a:ext cx="1800000" cy="2720403"/>
+            <a:off x="8460000" y="2307600"/>
+            <a:ext cx="1800000" cy="2732400"/>
           </a:xfrm>
           <a:prstGeom prst="straightConnector1">
             <a:avLst/>
@@ -38845,8 +38845,8 @@
         </p:nvSpPr>
         <p:spPr>
           <a:xfrm>
-            <a:off x="393668" y="2031968"/>
-            <a:ext cx="5537168" cy="1643063"/>
+            <a:off x="360000" y="1980000"/>
+            <a:ext cx="5580000" cy="1620000"/>
           </a:xfrm>
           <a:prstGeom prst="rect">
             <a:avLst/>
@@ -38905,8 +38905,8 @@
         </p:nvSpPr>
         <p:spPr>
           <a:xfrm>
-            <a:off x="6256592" y="2031968"/>
-            <a:ext cx="5537168" cy="1643063"/>
+            <a:off x="6300000" y="1980000"/>
+            <a:ext cx="5580000" cy="1620000"/>
           </a:xfrm>
           <a:prstGeom prst="rect">
             <a:avLst/>
@@ -38965,8 +38965,8 @@
         </p:nvSpPr>
         <p:spPr>
           <a:xfrm>
-            <a:off x="393668" y="4016978"/>
-            <a:ext cx="5537168" cy="1643158"/>
+            <a:off x="360000" y="3960000"/>
+            <a:ext cx="5580000" cy="1620000"/>
           </a:xfrm>
           <a:prstGeom prst="rect">
             <a:avLst/>
@@ -39027,8 +39027,8 @@
         </p:nvSpPr>
         <p:spPr>
           <a:xfrm>
-            <a:off x="6256592" y="4016978"/>
-            <a:ext cx="5537168" cy="1643158"/>
+            <a:off x="6300000" y="3960000"/>
+            <a:ext cx="5580000" cy="1620000"/>
           </a:xfrm>
           <a:prstGeom prst="rect">
             <a:avLst/>
@@ -39089,8 +39089,8 @@
         </p:nvSpPr>
         <p:spPr>
           <a:xfrm>
-            <a:off x="333375" y="1285875"/>
-            <a:ext cx="11525250" cy="4762500"/>
+            <a:off x="360000" y="1260000"/>
+            <a:ext cx="11520000" cy="4680000"/>
           </a:xfrm>
           <a:prstGeom prst="rect">
             <a:avLst/>
@@ -39129,7 +39129,7 @@
         </p:nvSpPr>
         <p:spPr>
           <a:xfrm>
-            <a:off x="523875" y="1409700"/>
+            <a:off x="540000" y="1440000"/>
             <a:ext cx="10668000" cy="361950"/>
           </a:xfrm>
           <a:prstGeom prst="rect">
@@ -39186,7 +39186,7 @@
         </p:nvSpPr>
         <p:spPr>
           <a:xfrm>
-            <a:off x="1238250" y="2514600"/>
+            <a:off x="1260000" y="2520000"/>
             <a:ext cx="8286750" cy="0"/>
           </a:xfrm>
           <a:prstGeom prst="line">
@@ -39223,8 +39223,8 @@
         </p:nvSpPr>
         <p:spPr>
           <a:xfrm>
-            <a:off x="1476375" y="2171700"/>
-            <a:ext cx="685800" cy="685800"/>
+            <a:off x="1440000" y="2160000"/>
+            <a:ext cx="720000" cy="720000"/>
           </a:xfrm>
           <a:prstGeom prst="ellipse">
             <a:avLst/>
@@ -39284,7 +39284,7 @@
         </p:nvSpPr>
         <p:spPr>
           <a:xfrm>
-            <a:off x="714375" y="3095625"/>
+            <a:off x="720000" y="3060000"/>
             <a:ext cx="2238375" cy="361950"/>
           </a:xfrm>
           <a:prstGeom prst="roundRect">
@@ -39347,7 +39347,7 @@
         </p:nvSpPr>
         <p:spPr>
           <a:xfrm>
-            <a:off x="714375" y="3600450"/>
+            <a:off x="720000" y="3600000"/>
             <a:ext cx="2238375" cy="342900"/>
           </a:xfrm>
           <a:prstGeom prst="rect">
@@ -39404,8 +39404,8 @@
         </p:nvSpPr>
         <p:spPr>
           <a:xfrm>
-            <a:off x="714375" y="4019550"/>
-            <a:ext cx="2238375" cy="723900"/>
+            <a:off x="720000" y="3960000"/>
+            <a:ext cx="2160000" cy="720000"/>
           </a:xfrm>
           <a:prstGeom prst="rect">
             <a:avLst/>
@@ -39485,8 +39485,8 @@
         </p:nvSpPr>
         <p:spPr>
           <a:xfrm>
-            <a:off x="4238625" y="2171700"/>
-            <a:ext cx="685800" cy="685800"/>
+            <a:off x="4320000" y="2160000"/>
+            <a:ext cx="720000" cy="720000"/>
           </a:xfrm>
           <a:prstGeom prst="ellipse">
             <a:avLst/>
@@ -39546,7 +39546,7 @@
         </p:nvSpPr>
         <p:spPr>
           <a:xfrm>
-            <a:off x="3476625" y="3095625"/>
+            <a:off x="3420000" y="3060000"/>
             <a:ext cx="2238375" cy="361950"/>
           </a:xfrm>
           <a:prstGeom prst="roundRect">
@@ -39609,7 +39609,7 @@
         </p:nvSpPr>
         <p:spPr>
           <a:xfrm>
-            <a:off x="3476625" y="3600450"/>
+            <a:off x="3420000" y="3600000"/>
             <a:ext cx="2238375" cy="342900"/>
           </a:xfrm>
           <a:prstGeom prst="rect">
@@ -39677,8 +39677,8 @@
         </p:nvSpPr>
         <p:spPr>
           <a:xfrm>
-            <a:off x="3476625" y="4019550"/>
-            <a:ext cx="2238375" cy="723900"/>
+            <a:off x="3420000" y="3960000"/>
+            <a:ext cx="2160000" cy="720000"/>
           </a:xfrm>
           <a:prstGeom prst="rect">
             <a:avLst/>
@@ -39758,8 +39758,8 @@
         </p:nvSpPr>
         <p:spPr>
           <a:xfrm>
-            <a:off x="7000875" y="2171700"/>
-            <a:ext cx="685800" cy="685800"/>
+            <a:off x="7020000" y="2160000"/>
+            <a:ext cx="720000" cy="720000"/>
           </a:xfrm>
           <a:prstGeom prst="ellipse">
             <a:avLst/>
@@ -39819,7 +39819,7 @@
         </p:nvSpPr>
         <p:spPr>
           <a:xfrm>
-            <a:off x="6238875" y="3095625"/>
+            <a:off x="6300000" y="3060000"/>
             <a:ext cx="2238375" cy="361950"/>
           </a:xfrm>
           <a:prstGeom prst="roundRect">
@@ -39882,7 +39882,7 @@
         </p:nvSpPr>
         <p:spPr>
           <a:xfrm>
-            <a:off x="6238875" y="3600450"/>
+            <a:off x="6300000" y="3600000"/>
             <a:ext cx="2238375" cy="342900"/>
           </a:xfrm>
           <a:prstGeom prst="rect">
@@ -39950,8 +39950,8 @@
         </p:nvSpPr>
         <p:spPr>
           <a:xfrm>
-            <a:off x="6238875" y="4019550"/>
-            <a:ext cx="2238375" cy="723900"/>
+            <a:off x="6300000" y="3960000"/>
+            <a:ext cx="2160000" cy="720000"/>
           </a:xfrm>
           <a:prstGeom prst="rect">
             <a:avLst/>
@@ -40031,8 +40031,8 @@
         </p:nvSpPr>
         <p:spPr>
           <a:xfrm>
-            <a:off x="9763125" y="2171700"/>
-            <a:ext cx="685800" cy="685800"/>
+            <a:off x="9720000" y="2160000"/>
+            <a:ext cx="720000" cy="720000"/>
           </a:xfrm>
           <a:prstGeom prst="ellipse">
             <a:avLst/>
@@ -40092,7 +40092,7 @@
         </p:nvSpPr>
         <p:spPr>
           <a:xfrm>
-            <a:off x="9001125" y="3095625"/>
+            <a:off x="9000000" y="3060000"/>
             <a:ext cx="2238375" cy="361950"/>
           </a:xfrm>
           <a:prstGeom prst="roundRect">
@@ -40155,7 +40155,7 @@
         </p:nvSpPr>
         <p:spPr>
           <a:xfrm>
-            <a:off x="9001125" y="3600450"/>
+            <a:off x="9000000" y="3600000"/>
             <a:ext cx="2238375" cy="342900"/>
           </a:xfrm>
           <a:prstGeom prst="rect">
@@ -40234,8 +40234,8 @@
         </p:nvSpPr>
         <p:spPr>
           <a:xfrm>
-            <a:off x="9001125" y="4019550"/>
-            <a:ext cx="2238375" cy="723900"/>
+            <a:off x="9000000" y="3960000"/>
+            <a:ext cx="2160000" cy="720000"/>
           </a:xfrm>
           <a:prstGeom prst="rect">
             <a:avLst/>
@@ -40315,8 +40315,8 @@
         </p:nvSpPr>
         <p:spPr>
           <a:xfrm>
-            <a:off x="1190625" y="5095875"/>
-            <a:ext cx="9810750" cy="781050"/>
+            <a:off x="1260000" y="5040000"/>
+            <a:ext cx="9900000" cy="720000"/>
           </a:xfrm>
           <a:prstGeom prst="roundRect">
             <a:avLst>

</xml_diff>

<commit_message>
Remove duplicate title rules and replace the last old icons
- Delete slide-local title-rule lines on slides 17 and 21-25 (the
  master already draws the red rule under the title)
- Add three new family-style icons: 16-expand, 17-compress,
  18-translate
- Slide 5: swap the Material-style glyphs for the new tile icons and
  drop the circle backgrounds behind them
- Slide 17: swap the old cross-encoder chip PNG for 13-llm-advanced,
  drop the teal circle and the indent clip-art

Co-Authored-By: Claude Fable 5 <noreply@anthropic.com>
Claude-Session: https://claude.ai/code/session_011vYBTx36whjSXkRTknHQuP
</commit_message>
<xml_diff>
--- a/RAG_Workshop.pptx
+++ b/RAG_Workshop.pptx
@@ -19632,29 +19632,6 @@
           <a:chExt cx="0" cy="0"/>
         </a:xfrm>
       </p:grpSpPr>
-      <p:pic>
-        <p:nvPicPr>
-          <p:cNvPr id="67" name="Grafik 12"/>
-          <p:cNvPicPr>
-            <a:picLocks noChangeAspect="1"/>
-          </p:cNvPicPr>
-          <p:nvPr/>
-        </p:nvPicPr>
-        <p:blipFill rotWithShape="1">
-          <a:blip r:embed="rId3"/>
-          <a:srcRect/>
-          <a:stretch/>
-        </p:blipFill>
-        <p:spPr>
-          <a:xfrm>
-            <a:off x="5220000" y="4320000"/>
-            <a:ext cx="504056" cy="224739"/>
-          </a:xfrm>
-          <a:prstGeom prst="rect">
-            <a:avLst/>
-          </a:prstGeom>
-        </p:spPr>
-      </p:pic>
       <p:sp>
         <p:nvSpPr>
           <p:cNvPr id="68" name="Titel 1"/>
@@ -19680,43 +19657,6 @@
               <a:t>Reranking sortiert Kandidaten – es findet keine neuen</a:t>
             </a:r>
             <a:endParaRPr lang="de-CH" dirty="0" sz="3600"/>
-          </a:p>
-        </p:txBody>
-      </p:sp>
-      <p:sp>
-        <p:nvSpPr>
-          <p:cNvPr id="18" name="title-rule">
-            <a:extLst>
-              <a:ext uri="{FF2B5EF4-FFF2-40B4-BE49-F238E27FC236}">
-                <a16:creationId xmlns:a16="http://schemas.microsoft.com/office/drawing/2014/main" id="{6942C085-3770-4E03-B601-DAEA48B3476F}"/>
-              </a:ext>
-            </a:extLst>
-          </p:cNvPr>
-          <p:cNvSpPr>
-            <a:spLocks noGrp="1"/>
-          </p:cNvSpPr>
-          <p:nvPr/>
-        </p:nvSpPr>
-        <p:spPr>
-          <a:xfrm>
-            <a:off x="540000" y="1080000"/>
-            <a:ext cx="11239500" cy="0"/>
-          </a:xfrm>
-          <a:prstGeom prst="line">
-            <a:avLst/>
-          </a:prstGeom>
-          <a:ln w="25718">
-            <a:solidFill>
-              <a:srgbClr val="C60C30"/>
-            </a:solidFill>
-            <a:prstDash val="solid"/>
-          </a:ln>
-        </p:spPr>
-        <p:txBody>
-          <a:bodyPr/>
-          <a:lstStyle/>
-          <a:p>
-            <a:endParaRPr lang="de-CH"/>
           </a:p>
         </p:txBody>
       </p:sp>
@@ -21028,63 +20968,6 @@
       </p:sp>
       <p:sp>
         <p:nvSpPr>
-          <p:cNvPr id="44" name="cross-encoder">
-            <a:extLst>
-              <a:ext uri="{FF2B5EF4-FFF2-40B4-BE49-F238E27FC236}">
-                <a16:creationId xmlns:a16="http://schemas.microsoft.com/office/drawing/2014/main" id="{5ACAE4B7-BBAD-44F8-9F1E-3C128F4A775F}"/>
-              </a:ext>
-            </a:extLst>
-          </p:cNvPr>
-          <p:cNvSpPr>
-            <a:spLocks noGrp="1"/>
-          </p:cNvSpPr>
-          <p:nvPr/>
-        </p:nvSpPr>
-        <p:spPr>
-          <a:xfrm>
-            <a:off x="7200000" y="2700000"/>
-            <a:ext cx="720000" cy="720000"/>
-          </a:xfrm>
-          <a:prstGeom prst="ellipse">
-            <a:avLst/>
-          </a:prstGeom>
-          <a:solidFill>
-            <a:srgbClr val="43858A"/>
-          </a:solidFill>
-          <a:ln w="23813">
-            <a:solidFill>
-              <a:srgbClr val="FFFFFF"/>
-            </a:solidFill>
-            <a:prstDash val="solid"/>
-          </a:ln>
-        </p:spPr>
-        <p:txBody>
-          <a:bodyPr anchor="ctr"/>
-          <a:lstStyle/>
-          <a:p>
-            <a:pPr algn="ctr">
-              <a:defRPr sz="2550" b="1">
-                <a:solidFill>
-                  <a:srgbClr val="FFFFFF"/>
-                </a:solidFill>
-                <a:latin typeface="Arial"/>
-                <a:ea typeface="Arial"/>
-                <a:cs typeface="Arial"/>
-              </a:defRPr>
-            </a:pPr>
-            <a:endParaRPr sz="2550" b="1" dirty="0">
-              <a:solidFill>
-                <a:srgbClr val="FFFFFF"/>
-              </a:solidFill>
-              <a:latin typeface="Arial"/>
-              <a:ea typeface="Arial"/>
-              <a:cs typeface="Arial"/>
-            </a:endParaRPr>
-          </a:p>
-        </p:txBody>
-      </p:sp>
-      <p:sp>
-        <p:nvSpPr>
           <p:cNvPr id="45" name="cross-label">
             <a:extLst>
               <a:ext uri="{FF2B5EF4-FFF2-40B4-BE49-F238E27FC236}">
@@ -22254,7 +22137,7 @@
       </p:sp>
       <p:pic>
         <p:nvPicPr>
-          <p:cNvPr id="2" name="Grafik 39">
+          <p:cNvPr id="2" name="Icon Cross-Encoder">
             <a:extLst>
               <a:ext uri="{FF2B5EF4-FFF2-40B4-BE49-F238E27FC236}">
                 <a16:creationId xmlns:a16="http://schemas.microsoft.com/office/drawing/2014/main" id="{010C40FB-D25D-CD65-BF09-E9CF2713632D}"/>
@@ -22267,15 +22150,21 @@
           <p:nvPr/>
         </p:nvPicPr>
         <p:blipFill>
-          <a:blip r:embed="rId4"/>
+          <a:blip r:embed="rId5">
+            <a:extLst>
+              <a:ext uri="{96DAC541-7B7A-43D3-8B79-37D633B846F1}">
+                <ns0:svgBlip xmlns:ns0="http://schemas.microsoft.com/office/drawing/2016/SVG/main" r:embed="rId6"/>
+              </a:ext>
+            </a:extLst>
+          </a:blip>
           <a:stretch>
             <a:fillRect/>
           </a:stretch>
         </p:blipFill>
         <p:spPr>
-          <a:xfrm flipH="1">
-            <a:off x="7380000" y="2700000"/>
-            <a:ext cx="584924" cy="593680"/>
+          <a:xfrm>
+            <a:off x="7200000" y="2700000"/>
+            <a:ext cx="720000" cy="720000"/>
           </a:xfrm>
           <a:prstGeom prst="rect">
             <a:avLst/>
@@ -22312,33 +22201,6 @@
                               <p:cond delay="0"/>
                             </p:stCondLst>
                             <p:childTnLst>
-                              <p:par>
-                                <p:cTn id="5" presetID="1" presetClass="entr" presetSubtype="0" fill="hold" nodeType="clickEffect">
-                                  <p:stCondLst>
-                                    <p:cond delay="0"/>
-                                  </p:stCondLst>
-                                  <p:childTnLst>
-                                    <p:set>
-                                      <p:cBhvr>
-                                        <p:cTn id="6" dur="1" fill="hold">
-                                          <p:stCondLst>
-                                            <p:cond delay="0"/>
-                                          </p:stCondLst>
-                                        </p:cTn>
-                                        <p:tgtEl>
-                                          <p:spTgt spid="67"/>
-                                        </p:tgtEl>
-                                        <p:attrNameLst>
-                                          <p:attrName>style.visibility</p:attrName>
-                                        </p:attrNameLst>
-                                      </p:cBhvr>
-                                      <p:to>
-                                        <p:strVal val="visible"/>
-                                      </p:to>
-                                    </p:set>
-                                  </p:childTnLst>
-                                </p:cTn>
-                              </p:par>
                               <p:par>
                                 <p:cTn id="7" presetID="1" presetClass="entr" presetSubtype="0" fill="hold" grpId="0" nodeType="withEffect">
                                   <p:stCondLst>
@@ -23358,33 +23220,6 @@
                                 </p:cTn>
                               </p:par>
                               <p:par>
-                                <p:cTn id="83" presetID="1" presetClass="entr" presetSubtype="0" fill="hold" grpId="0" nodeType="withEffect">
-                                  <p:stCondLst>
-                                    <p:cond delay="0"/>
-                                  </p:stCondLst>
-                                  <p:childTnLst>
-                                    <p:set>
-                                      <p:cBhvr>
-                                        <p:cTn id="84" dur="1" fill="hold">
-                                          <p:stCondLst>
-                                            <p:cond delay="0"/>
-                                          </p:stCondLst>
-                                        </p:cTn>
-                                        <p:tgtEl>
-                                          <p:spTgt spid="44"/>
-                                        </p:tgtEl>
-                                        <p:attrNameLst>
-                                          <p:attrName>style.visibility</p:attrName>
-                                        </p:attrNameLst>
-                                      </p:cBhvr>
-                                      <p:to>
-                                        <p:strVal val="visible"/>
-                                      </p:to>
-                                    </p:set>
-                                  </p:childTnLst>
-                                </p:cTn>
-                              </p:par>
-                              <p:par>
                                 <p:cTn id="85" presetID="1" presetClass="entr" presetSubtype="0" fill="hold" grpId="0" nodeType="withEffect">
                                   <p:stCondLst>
                                     <p:cond delay="0"/>
@@ -23611,7 +23446,6 @@
       <p:bldP spid="41" grpId="0"/>
       <p:bldP spid="42" grpId="0"/>
       <p:bldP spid="43" grpId="0" animBg="1"/>
-      <p:bldP spid="44" grpId="0" animBg="1"/>
       <p:bldP spid="45" grpId="0"/>
       <p:bldP spid="46" grpId="0"/>
       <p:bldP spid="47" grpId="0" animBg="1"/>
@@ -34037,43 +33871,6 @@
       </p:grpSpPr>
       <p:sp>
         <p:nvSpPr>
-          <p:cNvPr id="3" name="title-rule">
-            <a:extLst>
-              <a:ext uri="{FF2B5EF4-FFF2-40B4-BE49-F238E27FC236}">
-                <a16:creationId xmlns:a16="http://schemas.microsoft.com/office/drawing/2014/main" id="{D9277F89-7AAC-4778-8ADF-2F34CDC56F6F}"/>
-              </a:ext>
-            </a:extLst>
-          </p:cNvPr>
-          <p:cNvSpPr>
-            <a:spLocks noGrp="1"/>
-          </p:cNvSpPr>
-          <p:nvPr/>
-        </p:nvSpPr>
-        <p:spPr>
-          <a:xfrm>
-            <a:off x="540000" y="1080000"/>
-            <a:ext cx="11239500" cy="0"/>
-          </a:xfrm>
-          <a:prstGeom prst="line">
-            <a:avLst/>
-          </a:prstGeom>
-          <a:ln w="25718">
-            <a:solidFill>
-              <a:srgbClr val="C60C30"/>
-            </a:solidFill>
-            <a:prstDash val="solid"/>
-          </a:ln>
-        </p:spPr>
-        <p:txBody>
-          <a:bodyPr/>
-          <a:lstStyle/>
-          <a:p>
-            <a:endParaRPr/>
-          </a:p>
-        </p:txBody>
-      </p:sp>
-      <p:sp>
-        <p:nvSpPr>
           <p:cNvPr id="4" name="slide-subtitle">
             <a:extLst>
               <a:ext uri="{FF2B5EF4-FFF2-40B4-BE49-F238E27FC236}">
@@ -36105,43 +35902,6 @@
       </p:sp>
       <p:sp>
         <p:nvSpPr>
-          <p:cNvPr id="3" name="title-rule">
-            <a:extLst>
-              <a:ext uri="{FF2B5EF4-FFF2-40B4-BE49-F238E27FC236}">
-                <a16:creationId xmlns:a16="http://schemas.microsoft.com/office/drawing/2014/main" id="{4BE0893D-6444-4CF5-896E-61287A6092E5}"/>
-              </a:ext>
-            </a:extLst>
-          </p:cNvPr>
-          <p:cNvSpPr>
-            <a:spLocks noGrp="1"/>
-          </p:cNvSpPr>
-          <p:nvPr/>
-        </p:nvSpPr>
-        <p:spPr>
-          <a:xfrm>
-            <a:off x="540000" y="1080000"/>
-            <a:ext cx="11239500" cy="0"/>
-          </a:xfrm>
-          <a:prstGeom prst="line">
-            <a:avLst/>
-          </a:prstGeom>
-          <a:ln w="25718">
-            <a:solidFill>
-              <a:srgbClr val="C60C30"/>
-            </a:solidFill>
-            <a:prstDash val="solid"/>
-          </a:ln>
-        </p:spPr>
-        <p:txBody>
-          <a:bodyPr/>
-          <a:lstStyle/>
-          <a:p>
-            <a:endParaRPr/>
-          </a:p>
-        </p:txBody>
-      </p:sp>
-      <p:sp>
-        <p:nvSpPr>
           <p:cNvPr id="4" name="slide-subtitle">
             <a:extLst>
               <a:ext uri="{FF2B5EF4-FFF2-40B4-BE49-F238E27FC236}">
@@ -38021,43 +37781,6 @@
       </p:sp>
       <p:sp>
         <p:nvSpPr>
-          <p:cNvPr id="3" name="title-rule">
-            <a:extLst>
-              <a:ext uri="{FF2B5EF4-FFF2-40B4-BE49-F238E27FC236}">
-                <a16:creationId xmlns:a16="http://schemas.microsoft.com/office/drawing/2014/main" id="{F89291CC-D312-4577-8F2B-4346D995CEAB}"/>
-              </a:ext>
-            </a:extLst>
-          </p:cNvPr>
-          <p:cNvSpPr>
-            <a:spLocks noGrp="1"/>
-          </p:cNvSpPr>
-          <p:nvPr/>
-        </p:nvSpPr>
-        <p:spPr>
-          <a:xfrm>
-            <a:off x="540000" y="1080000"/>
-            <a:ext cx="11239500" cy="0"/>
-          </a:xfrm>
-          <a:prstGeom prst="line">
-            <a:avLst/>
-          </a:prstGeom>
-          <a:ln w="25718">
-            <a:solidFill>
-              <a:srgbClr val="C60C30"/>
-            </a:solidFill>
-            <a:prstDash val="solid"/>
-          </a:ln>
-        </p:spPr>
-        <p:txBody>
-          <a:bodyPr/>
-          <a:lstStyle/>
-          <a:p>
-            <a:endParaRPr lang="de-CH"/>
-          </a:p>
-        </p:txBody>
-      </p:sp>
-      <p:sp>
-        <p:nvSpPr>
           <p:cNvPr id="4" name="slide-subtitle">
             <a:extLst>
               <a:ext uri="{FF2B5EF4-FFF2-40B4-BE49-F238E27FC236}">
@@ -39456,43 +39179,6 @@
       </p:sp>
       <p:sp>
         <p:nvSpPr>
-          <p:cNvPr id="3" name="title-rule">
-            <a:extLst>
-              <a:ext uri="{FF2B5EF4-FFF2-40B4-BE49-F238E27FC236}">
-                <a16:creationId xmlns:a16="http://schemas.microsoft.com/office/drawing/2014/main" id="{742A57DF-B26E-46AE-AE0B-871F1DC60C91}"/>
-              </a:ext>
-            </a:extLst>
-          </p:cNvPr>
-          <p:cNvSpPr>
-            <a:spLocks noGrp="1"/>
-          </p:cNvSpPr>
-          <p:nvPr/>
-        </p:nvSpPr>
-        <p:spPr>
-          <a:xfrm>
-            <a:off x="540000" y="1080000"/>
-            <a:ext cx="11239500" cy="0"/>
-          </a:xfrm>
-          <a:prstGeom prst="line">
-            <a:avLst/>
-          </a:prstGeom>
-          <a:ln w="25718">
-            <a:solidFill>
-              <a:srgbClr val="C60C30"/>
-            </a:solidFill>
-            <a:prstDash val="solid"/>
-          </a:ln>
-        </p:spPr>
-        <p:txBody>
-          <a:bodyPr/>
-          <a:lstStyle/>
-          <a:p>
-            <a:endParaRPr lang="de-CH"/>
-          </a:p>
-        </p:txBody>
-      </p:sp>
-      <p:sp>
-        <p:nvSpPr>
           <p:cNvPr id="4" name="slide-subtitle">
             <a:extLst>
               <a:ext uri="{FF2B5EF4-FFF2-40B4-BE49-F238E27FC236}">
@@ -40930,43 +40616,6 @@
               <a:t>Drei Leitlinien für gutes RAG</a:t>
             </a:r>
             <a:endParaRPr lang="de-CH" dirty="0" sz="3600"/>
-          </a:p>
-        </p:txBody>
-      </p:sp>
-      <p:sp>
-        <p:nvSpPr>
-          <p:cNvPr id="3" name="title-rule">
-            <a:extLst>
-              <a:ext uri="{FF2B5EF4-FFF2-40B4-BE49-F238E27FC236}">
-                <a16:creationId xmlns:a16="http://schemas.microsoft.com/office/drawing/2014/main" id="{F07EF700-241F-4664-BD5F-529E0F094C76}"/>
-              </a:ext>
-            </a:extLst>
-          </p:cNvPr>
-          <p:cNvSpPr>
-            <a:spLocks noGrp="1"/>
-          </p:cNvSpPr>
-          <p:nvPr/>
-        </p:nvSpPr>
-        <p:spPr>
-          <a:xfrm>
-            <a:off x="540000" y="1080000"/>
-            <a:ext cx="11239500" cy="0"/>
-          </a:xfrm>
-          <a:prstGeom prst="line">
-            <a:avLst/>
-          </a:prstGeom>
-          <a:ln w="25718">
-            <a:solidFill>
-              <a:srgbClr val="C60C30"/>
-            </a:solidFill>
-            <a:prstDash val="solid"/>
-          </a:ln>
-        </p:spPr>
-        <p:txBody>
-          <a:bodyPr/>
-          <a:lstStyle/>
-          <a:p>
-            <a:endParaRPr lang="de-DE" noProof="0" dirty="0"/>
           </a:p>
         </p:txBody>
       </p:sp>
@@ -45636,68 +45285,30 @@
           </a:p>
         </p:txBody>
       </p:sp>
-      <p:sp>
-        <p:nvSpPr>
-          <p:cNvPr id="26" name="Komprimieren-icon-background">
-            <a:extLst>
-              <a:ext uri="{FF2B5EF4-FFF2-40B4-BE49-F238E27FC236}">
-                <a16:creationId xmlns:a16="http://schemas.microsoft.com/office/drawing/2014/main" id="{AE5F489A-B22B-45B4-B5E9-27A843A475CA}"/>
-              </a:ext>
-            </a:extLst>
-          </p:cNvPr>
-          <p:cNvSpPr>
-            <a:spLocks noGrp="1"/>
-          </p:cNvSpPr>
-          <p:nvPr/>
-        </p:nvSpPr>
-        <p:spPr>
-          <a:xfrm>
-            <a:off x="7200000" y="1980000"/>
-            <a:ext cx="1080000" cy="1080000"/>
-          </a:xfrm>
-          <a:prstGeom prst="ellipse">
-            <a:avLst/>
-          </a:prstGeom>
-          <a:solidFill>
-            <a:srgbClr val="9BC7EE"/>
-          </a:solidFill>
-          <a:ln w="0">
-            <a:solidFill>
-              <a:srgbClr val="9BC7EE"/>
-            </a:solidFill>
-            <a:prstDash val="solid"/>
-          </a:ln>
-        </p:spPr>
-        <p:txBody>
-          <a:bodyPr/>
-          <a:lstStyle/>
-          <a:p>
-            <a:endParaRPr lang="de-CH"/>
-          </a:p>
-        </p:txBody>
-      </p:sp>
       <p:pic>
         <p:nvPicPr>
-          <p:cNvPr id="27" name="Grafik 26"/>
+          <p:cNvPr id="27" name="Icon Komprimieren"/>
           <p:cNvPicPr>
             <a:picLocks noChangeAspect="1"/>
           </p:cNvPicPr>
           <p:nvPr/>
         </p:nvPicPr>
         <p:blipFill>
-          <a:blip>
+          <a:blip r:embed="rId8">
             <a:extLst>
               <a:ext uri="{96DAC541-7B7A-43D3-8B79-37D633B846F1}">
-                <asvg:svgBlip xmlns:asvg="http://schemas.microsoft.com/office/drawing/2016/SVG/main" r:embed="rId3"/>
+                <ns1:svgBlip xmlns:ns1="http://schemas.microsoft.com/office/drawing/2016/SVG/main" r:embed="rId9"/>
               </a:ext>
             </a:extLst>
           </a:blip>
-          <a:stretch/>
+          <a:stretch>
+            <a:fillRect/>
+          </a:stretch>
         </p:blipFill>
         <p:spPr>
           <a:xfrm>
-            <a:off x="7560000" y="2160000"/>
-            <a:ext cx="533400" cy="533400"/>
+            <a:off x="7200000" y="1980000"/>
+            <a:ext cx="1080000" cy="1080000"/>
           </a:xfrm>
           <a:prstGeom prst="rect">
             <a:avLst/>
@@ -45972,68 +45583,30 @@
           </a:p>
         </p:txBody>
       </p:sp>
-      <p:sp>
-        <p:nvSpPr>
-          <p:cNvPr id="34" name="Expandieren-icon-background">
-            <a:extLst>
-              <a:ext uri="{FF2B5EF4-FFF2-40B4-BE49-F238E27FC236}">
-                <a16:creationId xmlns:a16="http://schemas.microsoft.com/office/drawing/2014/main" id="{6F2B703B-43AC-4242-AA8D-70AAA7E7DF51}"/>
-              </a:ext>
-            </a:extLst>
-          </p:cNvPr>
-          <p:cNvSpPr>
-            <a:spLocks noGrp="1"/>
-          </p:cNvSpPr>
-          <p:nvPr/>
-        </p:nvSpPr>
-        <p:spPr>
-          <a:xfrm>
-            <a:off x="1080000" y="1980000"/>
-            <a:ext cx="1080000" cy="1080000"/>
-          </a:xfrm>
-          <a:prstGeom prst="ellipse">
-            <a:avLst/>
-          </a:prstGeom>
-          <a:solidFill>
-            <a:srgbClr val="FFFFFF"/>
-          </a:solidFill>
-          <a:ln w="0">
-            <a:solidFill>
-              <a:srgbClr val="FFFFFF"/>
-            </a:solidFill>
-            <a:prstDash val="solid"/>
-          </a:ln>
-        </p:spPr>
-        <p:txBody>
-          <a:bodyPr/>
-          <a:lstStyle/>
-          <a:p>
-            <a:endParaRPr lang="de-CH"/>
-          </a:p>
-        </p:txBody>
-      </p:sp>
       <p:pic>
         <p:nvPicPr>
-          <p:cNvPr id="35" name="Grafik 34"/>
+          <p:cNvPr id="35" name="Icon Expandieren"/>
           <p:cNvPicPr>
             <a:picLocks noChangeAspect="1"/>
           </p:cNvPicPr>
           <p:nvPr/>
         </p:nvPicPr>
         <p:blipFill>
-          <a:blip>
+          <a:blip r:embed="rId6">
             <a:extLst>
               <a:ext uri="{96DAC541-7B7A-43D3-8B79-37D633B846F1}">
-                <asvg:svgBlip xmlns:asvg="http://schemas.microsoft.com/office/drawing/2016/SVG/main" r:embed="rId4"/>
+                <ns0:svgBlip xmlns:ns0="http://schemas.microsoft.com/office/drawing/2016/SVG/main" r:embed="rId7"/>
               </a:ext>
             </a:extLst>
           </a:blip>
-          <a:stretch/>
+          <a:stretch>
+            <a:fillRect/>
+          </a:stretch>
         </p:blipFill>
         <p:spPr>
           <a:xfrm>
-            <a:off x="1260000" y="2160000"/>
-            <a:ext cx="533400" cy="533400"/>
+            <a:off x="1080000" y="1980000"/>
+            <a:ext cx="1080000" cy="1080000"/>
           </a:xfrm>
           <a:prstGeom prst="rect">
             <a:avLst/>
@@ -46299,26 +45872,28 @@
       </p:sp>
       <p:pic>
         <p:nvPicPr>
-          <p:cNvPr id="41" name="Grafik 40"/>
+          <p:cNvPr id="41" name="Icon Translatieren"/>
           <p:cNvPicPr>
             <a:picLocks noChangeAspect="1"/>
           </p:cNvPicPr>
           <p:nvPr/>
         </p:nvPicPr>
         <p:blipFill>
-          <a:blip>
+          <a:blip r:embed="rId10">
             <a:extLst>
               <a:ext uri="{96DAC541-7B7A-43D3-8B79-37D633B846F1}">
-                <asvg:svgBlip xmlns:asvg="http://schemas.microsoft.com/office/drawing/2016/SVG/main" r:embed="rId5"/>
+                <ns2:svgBlip xmlns:ns2="http://schemas.microsoft.com/office/drawing/2016/SVG/main" r:embed="rId11"/>
               </a:ext>
             </a:extLst>
           </a:blip>
-          <a:stretch/>
+          <a:stretch>
+            <a:fillRect/>
+          </a:stretch>
         </p:blipFill>
         <p:spPr>
           <a:xfrm>
             <a:off x="900000" y="5040000"/>
-            <a:ext cx="609600" cy="609600"/>
+            <a:ext cx="612000" cy="612000"/>
           </a:xfrm>
           <a:prstGeom prst="rect">
             <a:avLst/>

</xml_diff>

<commit_message>
Repositioning of a text field.
</commit_message>
<xml_diff>
--- a/RAG_Workshop.pptx
+++ b/RAG_Workshop.pptx
@@ -5,10 +5,10 @@
     <p:sldMasterId id="2147483648" r:id="rId4"/>
   </p:sldMasterIdLst>
   <p:notesMasterIdLst>
-    <p:notesMasterId r:id="rId26"/>
+    <p:notesMasterId r:id="rId31"/>
   </p:notesMasterIdLst>
   <p:handoutMasterIdLst>
-    <p:handoutMasterId r:id="rId27"/>
+    <p:handoutMasterId r:id="rId32"/>
   </p:handoutMasterIdLst>
   <p:sldIdLst>
     <p:sldId id="290" r:id="rId5"/>
@@ -21,27 +21,27 @@
     <p:sldId id="266" r:id="rId12"/>
     <p:sldId id="307" r:id="rId13"/>
     <p:sldId id="322" r:id="rId14"/>
-    <p:sldId id="323" r:id="rId33"/>
-    <p:sldId id="324" r:id="rId34"/>
-    <p:sldId id="325" r:id="rId35"/>
-    <p:sldId id="308" r:id="rId15"/>
-    <p:sldId id="326" r:id="rId36"/>
-    <p:sldId id="256" r:id="rId16"/>
-    <p:sldId id="313" r:id="rId17"/>
-    <p:sldId id="327" r:id="rId37"/>
-    <p:sldId id="320" r:id="rId18"/>
-    <p:sldId id="321" r:id="rId19"/>
-    <p:sldId id="271" r:id="rId20"/>
-    <p:sldId id="272" r:id="rId21"/>
-    <p:sldId id="274" r:id="rId22"/>
-    <p:sldId id="275" r:id="rId23"/>
-    <p:sldId id="276" r:id="rId24"/>
-    <p:sldId id="295" r:id="rId25"/>
+    <p:sldId id="323" r:id="rId15"/>
+    <p:sldId id="324" r:id="rId16"/>
+    <p:sldId id="325" r:id="rId17"/>
+    <p:sldId id="308" r:id="rId18"/>
+    <p:sldId id="326" r:id="rId19"/>
+    <p:sldId id="256" r:id="rId20"/>
+    <p:sldId id="313" r:id="rId21"/>
+    <p:sldId id="327" r:id="rId22"/>
+    <p:sldId id="320" r:id="rId23"/>
+    <p:sldId id="321" r:id="rId24"/>
+    <p:sldId id="271" r:id="rId25"/>
+    <p:sldId id="272" r:id="rId26"/>
+    <p:sldId id="274" r:id="rId27"/>
+    <p:sldId id="275" r:id="rId28"/>
+    <p:sldId id="276" r:id="rId29"/>
+    <p:sldId id="295" r:id="rId30"/>
   </p:sldIdLst>
   <p:sldSz cx="12192000" cy="6858000"/>
   <p:notesSz cx="6858000" cy="9144000"/>
   <p:custDataLst>
-    <p:tags r:id="rId28"/>
+    <p:tags r:id="rId33"/>
   </p:custDataLst>
   <p:defaultTextStyle>
     <a:defPPr>
@@ -153,9 +153,14 @@
             <p14:sldId id="266"/>
             <p14:sldId id="307"/>
             <p14:sldId id="322"/>
+            <p14:sldId id="323"/>
+            <p14:sldId id="324"/>
+            <p14:sldId id="325"/>
             <p14:sldId id="308"/>
+            <p14:sldId id="326"/>
             <p14:sldId id="256"/>
             <p14:sldId id="313"/>
+            <p14:sldId id="327"/>
             <p14:sldId id="320"/>
             <p14:sldId id="321"/>
             <p14:sldId id="271"/>
@@ -272,7 +277,7 @@
           <a:p>
             <a:fld id="{52E8011C-FE86-4EBC-8644-A1C19BB3B3D0}" type="datetimeFigureOut">
               <a:rPr lang="de-DE" sz="1000" smtClean="0"/>
-              <a:t>08.08.2026</a:t>
+              <a:t>10.08.2026</a:t>
             </a:fld>
             <a:endParaRPr lang="de-DE" sz="1000"/>
           </a:p>
@@ -450,7 +455,7 @@
             <a:fld id="{ADD5FE3D-F70B-4796-8811-3B9EE273F98E}" type="datetimeFigureOut">
               <a:rPr lang="de-DE" smtClean="0"/>
               <a:pPr/>
-              <a:t>08.08.2026</a:t>
+              <a:t>10.08.2026</a:t>
             </a:fld>
             <a:endParaRPr lang="de-DE" dirty="0"/>
           </a:p>
@@ -3071,7 +3076,7 @@
           <a:p>
             <a:fld id="{C0B5DAE3-E9C3-48BD-9F84-B39C87C1D4EA}" type="datetime1">
               <a:rPr lang="de-CH" smtClean="0"/>
-              <a:t>08.08.2026</a:t>
+              <a:t>10.08.2026</a:t>
             </a:fld>
             <a:endParaRPr lang="de-CH" dirty="0"/>
           </a:p>
@@ -3428,7 +3433,7 @@
           <a:p>
             <a:fld id="{C33DD234-259D-4F15-8408-EA64820F6397}" type="datetime1">
               <a:rPr lang="de-CH" smtClean="0"/>
-              <a:t>08.08.2026</a:t>
+              <a:t>10.08.2026</a:t>
             </a:fld>
             <a:endParaRPr lang="de-CH" dirty="0"/>
           </a:p>
@@ -3654,7 +3659,7 @@
           <a:p>
             <a:fld id="{CB295712-26CE-4B63-A766-0110588AF456}" type="datetime1">
               <a:rPr lang="de-CH" smtClean="0"/>
-              <a:t>08.08.2026</a:t>
+              <a:t>10.08.2026</a:t>
             </a:fld>
             <a:endParaRPr lang="de-CH" dirty="0"/>
           </a:p>
@@ -4020,7 +4025,7 @@
           <a:p>
             <a:fld id="{3B96E7C6-F2CE-4756-8C9C-414CDB636DDE}" type="datetime1">
               <a:rPr lang="de-CH" smtClean="0"/>
-              <a:t>08.08.2026</a:t>
+              <a:t>10.08.2026</a:t>
             </a:fld>
             <a:endParaRPr lang="de-CH" dirty="0"/>
           </a:p>
@@ -4207,7 +4212,7 @@
           <a:p>
             <a:fld id="{E2111384-F462-4D90-9803-E7B6DB23FD1B}" type="datetime1">
               <a:rPr lang="de-CH" smtClean="0"/>
-              <a:t>08.08.2026</a:t>
+              <a:t>10.08.2026</a:t>
             </a:fld>
             <a:endParaRPr lang="de-CH" dirty="0"/>
           </a:p>
@@ -4485,7 +4490,7 @@
           <a:p>
             <a:fld id="{54359010-3833-46D1-85CE-E9F83B9A0CAB}" type="datetime1">
               <a:rPr lang="de-CH" smtClean="0"/>
-              <a:t>08.08.2026</a:t>
+              <a:t>10.08.2026</a:t>
             </a:fld>
             <a:endParaRPr lang="de-CH" dirty="0"/>
           </a:p>
@@ -4720,7 +4725,7 @@
           <a:p>
             <a:fld id="{A44B8AD2-0CB6-4686-BC54-BC8E97B87777}" type="datetime1">
               <a:rPr lang="de-CH" smtClean="0"/>
-              <a:t>08.08.2026</a:t>
+              <a:t>10.08.2026</a:t>
             </a:fld>
             <a:endParaRPr lang="de-CH" dirty="0"/>
           </a:p>
@@ -4955,7 +4960,7 @@
           <a:p>
             <a:fld id="{B0557833-6AB4-4458-8CD6-D82947634C0B}" type="datetime1">
               <a:rPr lang="de-CH" smtClean="0"/>
-              <a:t>08.08.2026</a:t>
+              <a:t>10.08.2026</a:t>
             </a:fld>
             <a:endParaRPr lang="de-CH" dirty="0"/>
           </a:p>
@@ -5226,7 +5231,7 @@
           <a:p>
             <a:fld id="{5885801D-3341-4DAA-8DB7-EA54BF0E83F6}" type="datetime1">
               <a:rPr lang="de-CH" smtClean="0"/>
-              <a:t>08.08.2026</a:t>
+              <a:t>10.08.2026</a:t>
             </a:fld>
             <a:endParaRPr lang="de-CH" dirty="0"/>
           </a:p>
@@ -5462,7 +5467,7 @@
           <a:p>
             <a:fld id="{B4FC1744-D639-45C4-8D62-63B8E6EA4645}" type="datetime1">
               <a:rPr lang="de-CH" smtClean="0"/>
-              <a:t>08.08.2026</a:t>
+              <a:t>10.08.2026</a:t>
             </a:fld>
             <a:endParaRPr lang="de-CH" dirty="0"/>
           </a:p>
@@ -5546,7 +5551,7 @@
           </p:cNvGraphicFramePr>
           <p:nvPr userDrawn="1">
             <p:custDataLst>
-              <p:tags r:id="rId13"/>
+              <p:tags r:id="rId12"/>
             </p:custDataLst>
             <p:extLst>
               <p:ext uri="{D42A27DB-BD31-4B8C-83A1-F6EECF244321}">
@@ -5563,12 +5568,12 @@
           <a:graphicData uri="http://schemas.openxmlformats.org/presentationml/2006/ole">
             <mc:AlternateContent xmlns:mc="http://schemas.openxmlformats.org/markup-compatibility/2006">
               <mc:Choice xmlns:v="urn:schemas-microsoft-com:vml" Requires="v">
-                <p:oleObj name="think-cell Folie" r:id="rId14" imgW="306" imgH="306" progId="TCLayout.ActiveDocument.1">
+                <p:oleObj name="think-cell Folie" r:id="rId13" imgW="306" imgH="306" progId="TCLayout.ActiveDocument.1">
                   <p:embed/>
                 </p:oleObj>
               </mc:Choice>
               <mc:Fallback>
-                <p:oleObj name="think-cell Folie" r:id="rId14" imgW="306" imgH="306" progId="TCLayout.ActiveDocument.1">
+                <p:oleObj name="think-cell Folie" r:id="rId13" imgW="306" imgH="306" progId="TCLayout.ActiveDocument.1">
                   <p:embed/>
                   <p:pic>
                     <p:nvPicPr>
@@ -5577,7 +5582,7 @@
                       <p:nvPr/>
                     </p:nvPicPr>
                     <p:blipFill>
-                      <a:blip r:embed="rId15"/>
+                      <a:blip r:embed="rId14"/>
                       <a:stretch>
                         <a:fillRect/>
                       </a:stretch>
@@ -5672,7 +5677,7 @@
           <a:p>
             <a:fld id="{5F18E43C-E52F-48EA-B380-1F3AB6DC196F}" type="datetime1">
               <a:rPr lang="de-CH" smtClean="0"/>
-              <a:t>08.08.2026</a:t>
+              <a:t>10.08.2026</a:t>
             </a:fld>
             <a:endParaRPr lang="de-CH" dirty="0"/>
           </a:p>
@@ -5834,7 +5839,7 @@
           <p:nvPr userDrawn="1"/>
         </p:nvPicPr>
         <p:blipFill>
-          <a:blip r:embed="rId16"/>
+          <a:blip r:embed="rId15"/>
           <a:stretch>
             <a:fillRect/>
           </a:stretch>
@@ -6383,7 +6388,7 @@
           <a:p>
             <a:fld id="{63C4474F-84D2-49E0-A6C4-5163AC122E4E}" type="datetime1">
               <a:rPr lang="de-CH" smtClean="0"/>
-              <a:t>08.08.2026</a:t>
+              <a:t>10.08.2026</a:t>
             </a:fld>
             <a:endParaRPr lang="de-CH" dirty="0"/>
           </a:p>
@@ -6875,7 +6880,7 @@
                 <a:tabLst/>
                 <a:defRPr/>
               </a:pPr>
-              <a:t>08.08.2026</a:t>
+              <a:t>10.08.2026</a:t>
             </a:fld>
             <a:endParaRPr kumimoji="0" lang="de-CH" sz="900" b="0" i="0" u="none" strike="noStrike" kern="1200" cap="none" spc="0" normalizeH="0" baseline="0" noProof="0" dirty="0">
               <a:ln>
@@ -7141,7 +7146,7 @@
           <a:p>
             <a:fld id="{CE7E00E2-F08D-429A-AD9B-1ECBEC02F4DB}" type="slidenum">
               <a:rPr lang="de-CH" smtClean="0"/>
-              <a:t>7</a:t>
+              <a:t>11</a:t>
             </a:fld>
             <a:endParaRPr lang="de-CH"/>
           </a:p>
@@ -7303,10 +7308,10 @@
             <p:nvPr/>
           </p:nvPicPr>
           <p:blipFill>
-            <a:blip r:embed="rId18">
+            <a:blip r:embed="rId2">
               <a:extLst>
                 <a:ext uri="{96DAC541-7B7A-43D3-8B79-37D633B846F1}">
-                  <ns1:svgBlip xmlns:ns1="http://schemas.microsoft.com/office/drawing/2016/SVG/main" r:embed="rId32"/>
+                  <asvg:svgBlip xmlns:asvg="http://schemas.microsoft.com/office/drawing/2016/SVG/main" r:embed="rId3"/>
                 </a:ext>
               </a:extLst>
             </a:blip>
@@ -7478,10 +7483,10 @@
             <p:nvPr/>
           </p:nvPicPr>
           <p:blipFill>
-            <a:blip r:embed="rId20">
+            <a:blip r:embed="rId4">
               <a:extLst>
                 <a:ext uri="{96DAC541-7B7A-43D3-8B79-37D633B846F1}">
-                  <ns2:svgBlip xmlns:ns2="http://schemas.microsoft.com/office/drawing/2016/SVG/main" r:embed="rId33"/>
+                  <asvg:svgBlip xmlns:asvg="http://schemas.microsoft.com/office/drawing/2016/SVG/main" r:embed="rId5"/>
                 </a:ext>
               </a:extLst>
             </a:blip>
@@ -7661,10 +7666,10 @@
             <p:nvPr/>
           </p:nvPicPr>
           <p:blipFill>
-            <a:blip r:embed="rId34">
+            <a:blip r:embed="rId6">
               <a:extLst>
                 <a:ext uri="{96DAC541-7B7A-43D3-8B79-37D633B846F1}">
-                  <ns9:svgBlip xmlns:ns9="http://schemas.microsoft.com/office/drawing/2016/SVG/main" r:embed="rId41"/>
+                  <asvg:svgBlip xmlns:asvg="http://schemas.microsoft.com/office/drawing/2016/SVG/main" r:embed="rId7"/>
                 </a:ext>
               </a:extLst>
             </a:blip>
@@ -7803,7 +7808,9 @@
         <p:txBody>
           <a:bodyPr/>
           <a:lstStyle/>
-          <a:p/>
+          <a:p>
+            <a:endParaRPr/>
+          </a:p>
         </p:txBody>
       </p:sp>
       <p:sp>
@@ -7831,7 +7838,9 @@
         <p:txBody>
           <a:bodyPr/>
           <a:lstStyle/>
-          <a:p/>
+          <a:p>
+            <a:endParaRPr/>
+          </a:p>
         </p:txBody>
       </p:sp>
       <p:sp>
@@ -7859,7 +7868,9 @@
         <p:txBody>
           <a:bodyPr/>
           <a:lstStyle/>
-          <a:p/>
+          <a:p>
+            <a:endParaRPr/>
+          </a:p>
         </p:txBody>
       </p:sp>
     </p:spTree>
@@ -7950,7 +7961,7 @@
           <a:p>
             <a:fld id="{CE7E00E2-F08D-429A-AD9B-1ECBEC02F4DB}" type="slidenum">
               <a:rPr lang="de-CH" smtClean="0"/>
-              <a:t>7</a:t>
+              <a:t>12</a:t>
             </a:fld>
             <a:endParaRPr lang="de-CH"/>
           </a:p>
@@ -8454,10 +8465,10 @@
             <p:nvPr/>
           </p:nvPicPr>
           <p:blipFill>
-            <a:blip r:embed="rId16">
+            <a:blip r:embed="rId2">
               <a:extLst>
                 <a:ext uri="{96DAC541-7B7A-43D3-8B79-37D633B846F1}">
-                  <ns0:svgBlip xmlns:ns0="http://schemas.microsoft.com/office/drawing/2016/SVG/main" r:embed="rId31"/>
+                  <asvg:svgBlip xmlns:asvg="http://schemas.microsoft.com/office/drawing/2016/SVG/main" r:embed="rId3"/>
                 </a:ext>
               </a:extLst>
             </a:blip>
@@ -8583,10 +8594,10 @@
             <p:nvPr/>
           </p:nvPicPr>
           <p:blipFill>
-            <a:blip r:embed="rId18">
+            <a:blip r:embed="rId4">
               <a:extLst>
                 <a:ext uri="{96DAC541-7B7A-43D3-8B79-37D633B846F1}">
-                  <ns1:svgBlip xmlns:ns1="http://schemas.microsoft.com/office/drawing/2016/SVG/main" r:embed="rId32"/>
+                  <asvg:svgBlip xmlns:asvg="http://schemas.microsoft.com/office/drawing/2016/SVG/main" r:embed="rId5"/>
                 </a:ext>
               </a:extLst>
             </a:blip>
@@ -8758,10 +8769,10 @@
             <p:nvPr/>
           </p:nvPicPr>
           <p:blipFill>
-            <a:blip r:embed="rId20">
+            <a:blip r:embed="rId6">
               <a:extLst>
                 <a:ext uri="{96DAC541-7B7A-43D3-8B79-37D633B846F1}">
-                  <ns2:svgBlip xmlns:ns2="http://schemas.microsoft.com/office/drawing/2016/SVG/main" r:embed="rId33"/>
+                  <asvg:svgBlip xmlns:asvg="http://schemas.microsoft.com/office/drawing/2016/SVG/main" r:embed="rId7"/>
                 </a:ext>
               </a:extLst>
             </a:blip>
@@ -8935,10 +8946,10 @@
             <p:nvPr/>
           </p:nvPicPr>
           <p:blipFill>
-            <a:blip r:embed="rId22">
+            <a:blip r:embed="rId8">
               <a:extLst>
                 <a:ext uri="{96DAC541-7B7A-43D3-8B79-37D633B846F1}">
-                  <ns3:svgBlip xmlns:ns3="http://schemas.microsoft.com/office/drawing/2016/SVG/main" r:embed="rId29"/>
+                  <asvg:svgBlip xmlns:asvg="http://schemas.microsoft.com/office/drawing/2016/SVG/main" r:embed="rId9"/>
                 </a:ext>
               </a:extLst>
             </a:blip>
@@ -9174,10 +9185,10 @@
             <p:nvPr/>
           </p:nvPicPr>
           <p:blipFill>
-            <a:blip r:embed="rId24">
+            <a:blip r:embed="rId10">
               <a:extLst>
                 <a:ext uri="{96DAC541-7B7A-43D3-8B79-37D633B846F1}">
-                  <ns4:svgBlip xmlns:ns4="http://schemas.microsoft.com/office/drawing/2016/SVG/main" r:embed="rId35"/>
+                  <asvg:svgBlip xmlns:asvg="http://schemas.microsoft.com/office/drawing/2016/SVG/main" r:embed="rId11"/>
                 </a:ext>
               </a:extLst>
             </a:blip>
@@ -9301,10 +9312,10 @@
             <p:nvPr/>
           </p:nvPicPr>
           <p:blipFill>
-            <a:blip r:embed="rId26">
+            <a:blip r:embed="rId12">
               <a:extLst>
                 <a:ext uri="{96DAC541-7B7A-43D3-8B79-37D633B846F1}">
-                  <ns5:svgBlip xmlns:ns5="http://schemas.microsoft.com/office/drawing/2016/SVG/main" r:embed="rId28"/>
+                  <asvg:svgBlip xmlns:asvg="http://schemas.microsoft.com/office/drawing/2016/SVG/main" r:embed="rId13"/>
                 </a:ext>
               </a:extLst>
             </a:blip>
@@ -9480,10 +9491,10 @@
             <p:nvPr/>
           </p:nvPicPr>
           <p:blipFill>
-            <a:blip r:embed="rId9">
+            <a:blip r:embed="rId14">
               <a:extLst>
                 <a:ext uri="{96DAC541-7B7A-43D3-8B79-37D633B846F1}">
-                  <ns6:svgBlip xmlns:ns6="http://schemas.microsoft.com/office/drawing/2016/SVG/main" r:embed="rId37"/>
+                  <asvg:svgBlip xmlns:asvg="http://schemas.microsoft.com/office/drawing/2016/SVG/main" r:embed="rId15"/>
                 </a:ext>
               </a:extLst>
             </a:blip>
@@ -9669,10 +9680,10 @@
             <p:nvPr/>
           </p:nvPicPr>
           <p:blipFill>
-            <a:blip r:embed="rId34">
+            <a:blip r:embed="rId16">
               <a:extLst>
                 <a:ext uri="{96DAC541-7B7A-43D3-8B79-37D633B846F1}">
-                  <ns9:svgBlip xmlns:ns9="http://schemas.microsoft.com/office/drawing/2016/SVG/main" r:embed="rId41"/>
+                  <asvg:svgBlip xmlns:asvg="http://schemas.microsoft.com/office/drawing/2016/SVG/main" r:embed="rId17"/>
                 </a:ext>
               </a:extLst>
             </a:blip>
@@ -9852,10 +9863,10 @@
             <p:nvPr/>
           </p:nvPicPr>
           <p:blipFill>
-            <a:blip r:embed="rId39">
+            <a:blip r:embed="rId18">
               <a:extLst>
                 <a:ext uri="{96DAC541-7B7A-43D3-8B79-37D633B846F1}">
-                  <ns10:svgBlip xmlns:ns10="http://schemas.microsoft.com/office/drawing/2016/SVG/main" r:embed="rId25"/>
+                  <asvg:svgBlip xmlns:asvg="http://schemas.microsoft.com/office/drawing/2016/SVG/main" r:embed="rId19"/>
                 </a:ext>
               </a:extLst>
             </a:blip>
@@ -10031,10 +10042,10 @@
             <p:nvPr/>
           </p:nvPicPr>
           <p:blipFill>
-            <a:blip r:embed="rId36">
+            <a:blip r:embed="rId20">
               <a:extLst>
                 <a:ext uri="{96DAC541-7B7A-43D3-8B79-37D633B846F1}">
-                  <ns11:svgBlip xmlns:ns11="http://schemas.microsoft.com/office/drawing/2016/SVG/main" r:embed="rId23"/>
+                  <asvg:svgBlip xmlns:asvg="http://schemas.microsoft.com/office/drawing/2016/SVG/main" r:embed="rId21"/>
                 </a:ext>
               </a:extLst>
             </a:blip>
@@ -10171,7 +10182,9 @@
         <p:txBody>
           <a:bodyPr/>
           <a:lstStyle/>
-          <a:p/>
+          <a:p>
+            <a:endParaRPr/>
+          </a:p>
         </p:txBody>
       </p:sp>
       <p:sp>
@@ -10199,7 +10212,9 @@
         <p:txBody>
           <a:bodyPr/>
           <a:lstStyle/>
-          <a:p/>
+          <a:p>
+            <a:endParaRPr/>
+          </a:p>
         </p:txBody>
       </p:sp>
       <p:sp>
@@ -10227,7 +10242,9 @@
         <p:txBody>
           <a:bodyPr/>
           <a:lstStyle/>
-          <a:p/>
+          <a:p>
+            <a:endParaRPr/>
+          </a:p>
         </p:txBody>
       </p:sp>
       <p:sp>
@@ -10255,7 +10272,9 @@
         <p:txBody>
           <a:bodyPr/>
           <a:lstStyle/>
-          <a:p/>
+          <a:p>
+            <a:endParaRPr/>
+          </a:p>
         </p:txBody>
       </p:sp>
       <p:sp>
@@ -10283,7 +10302,9 @@
         <p:txBody>
           <a:bodyPr/>
           <a:lstStyle/>
-          <a:p/>
+          <a:p>
+            <a:endParaRPr/>
+          </a:p>
         </p:txBody>
       </p:sp>
       <p:sp>
@@ -10311,7 +10332,9 @@
         <p:txBody>
           <a:bodyPr/>
           <a:lstStyle/>
-          <a:p/>
+          <a:p>
+            <a:endParaRPr/>
+          </a:p>
         </p:txBody>
       </p:sp>
       <p:sp>
@@ -10339,7 +10362,9 @@
         <p:txBody>
           <a:bodyPr/>
           <a:lstStyle/>
-          <a:p/>
+          <a:p>
+            <a:endParaRPr/>
+          </a:p>
         </p:txBody>
       </p:sp>
     </p:spTree>
@@ -10430,7 +10455,7 @@
           <a:p>
             <a:fld id="{CE7E00E2-F08D-429A-AD9B-1ECBEC02F4DB}" type="slidenum">
               <a:rPr lang="de-CH" smtClean="0"/>
-              <a:t>7</a:t>
+              <a:t>13</a:t>
             </a:fld>
             <a:endParaRPr lang="de-CH"/>
           </a:p>
@@ -11228,10 +11253,10 @@
             <p:nvPr/>
           </p:nvPicPr>
           <p:blipFill>
-            <a:blip r:embed="rId16">
+            <a:blip r:embed="rId2">
               <a:extLst>
                 <a:ext uri="{96DAC541-7B7A-43D3-8B79-37D633B846F1}">
-                  <ns0:svgBlip xmlns:ns0="http://schemas.microsoft.com/office/drawing/2016/SVG/main" r:embed="rId31"/>
+                  <asvg:svgBlip xmlns:asvg="http://schemas.microsoft.com/office/drawing/2016/SVG/main" r:embed="rId3"/>
                 </a:ext>
               </a:extLst>
             </a:blip>
@@ -11357,10 +11382,10 @@
             <p:nvPr/>
           </p:nvPicPr>
           <p:blipFill>
-            <a:blip r:embed="rId18">
+            <a:blip r:embed="rId4">
               <a:extLst>
                 <a:ext uri="{96DAC541-7B7A-43D3-8B79-37D633B846F1}">
-                  <ns1:svgBlip xmlns:ns1="http://schemas.microsoft.com/office/drawing/2016/SVG/main" r:embed="rId32"/>
+                  <asvg:svgBlip xmlns:asvg="http://schemas.microsoft.com/office/drawing/2016/SVG/main" r:embed="rId5"/>
                 </a:ext>
               </a:extLst>
             </a:blip>
@@ -11532,10 +11557,10 @@
             <p:nvPr/>
           </p:nvPicPr>
           <p:blipFill>
-            <a:blip r:embed="rId20">
+            <a:blip r:embed="rId6">
               <a:extLst>
                 <a:ext uri="{96DAC541-7B7A-43D3-8B79-37D633B846F1}">
-                  <ns2:svgBlip xmlns:ns2="http://schemas.microsoft.com/office/drawing/2016/SVG/main" r:embed="rId33"/>
+                  <asvg:svgBlip xmlns:asvg="http://schemas.microsoft.com/office/drawing/2016/SVG/main" r:embed="rId7"/>
                 </a:ext>
               </a:extLst>
             </a:blip>
@@ -11709,10 +11734,10 @@
             <p:nvPr/>
           </p:nvPicPr>
           <p:blipFill>
-            <a:blip r:embed="rId22">
+            <a:blip r:embed="rId8">
               <a:extLst>
                 <a:ext uri="{96DAC541-7B7A-43D3-8B79-37D633B846F1}">
-                  <ns3:svgBlip xmlns:ns3="http://schemas.microsoft.com/office/drawing/2016/SVG/main" r:embed="rId29"/>
+                  <asvg:svgBlip xmlns:asvg="http://schemas.microsoft.com/office/drawing/2016/SVG/main" r:embed="rId9"/>
                 </a:ext>
               </a:extLst>
             </a:blip>
@@ -11948,10 +11973,10 @@
             <p:nvPr/>
           </p:nvPicPr>
           <p:blipFill>
-            <a:blip r:embed="rId24">
+            <a:blip r:embed="rId10">
               <a:extLst>
                 <a:ext uri="{96DAC541-7B7A-43D3-8B79-37D633B846F1}">
-                  <ns4:svgBlip xmlns:ns4="http://schemas.microsoft.com/office/drawing/2016/SVG/main" r:embed="rId35"/>
+                  <asvg:svgBlip xmlns:asvg="http://schemas.microsoft.com/office/drawing/2016/SVG/main" r:embed="rId11"/>
                 </a:ext>
               </a:extLst>
             </a:blip>
@@ -12075,10 +12100,10 @@
             <p:nvPr/>
           </p:nvPicPr>
           <p:blipFill>
-            <a:blip r:embed="rId26">
+            <a:blip r:embed="rId12">
               <a:extLst>
                 <a:ext uri="{96DAC541-7B7A-43D3-8B79-37D633B846F1}">
-                  <ns5:svgBlip xmlns:ns5="http://schemas.microsoft.com/office/drawing/2016/SVG/main" r:embed="rId28"/>
+                  <asvg:svgBlip xmlns:asvg="http://schemas.microsoft.com/office/drawing/2016/SVG/main" r:embed="rId13"/>
                 </a:ext>
               </a:extLst>
             </a:blip>
@@ -12254,10 +12279,10 @@
             <p:nvPr/>
           </p:nvPicPr>
           <p:blipFill>
-            <a:blip r:embed="rId9">
+            <a:blip r:embed="rId14">
               <a:extLst>
                 <a:ext uri="{96DAC541-7B7A-43D3-8B79-37D633B846F1}">
-                  <ns6:svgBlip xmlns:ns6="http://schemas.microsoft.com/office/drawing/2016/SVG/main" r:embed="rId37"/>
+                  <asvg:svgBlip xmlns:asvg="http://schemas.microsoft.com/office/drawing/2016/SVG/main" r:embed="rId15"/>
                 </a:ext>
               </a:extLst>
             </a:blip>
@@ -12433,10 +12458,10 @@
             <p:nvPr/>
           </p:nvPicPr>
           <p:blipFill>
-            <a:blip r:embed="rId30">
+            <a:blip r:embed="rId16">
               <a:extLst>
                 <a:ext uri="{96DAC541-7B7A-43D3-8B79-37D633B846F1}">
-                  <ns7:svgBlip xmlns:ns7="http://schemas.microsoft.com/office/drawing/2016/SVG/main" r:embed="rId27"/>
+                  <asvg:svgBlip xmlns:asvg="http://schemas.microsoft.com/office/drawing/2016/SVG/main" r:embed="rId17"/>
                 </a:ext>
               </a:extLst>
             </a:blip>
@@ -12614,10 +12639,10 @@
             <p:nvPr/>
           </p:nvPicPr>
           <p:blipFill>
-            <a:blip r:embed="rId39">
+            <a:blip r:embed="rId18">
               <a:extLst>
                 <a:ext uri="{96DAC541-7B7A-43D3-8B79-37D633B846F1}">
-                  <ns8:svgBlip xmlns:ns8="http://schemas.microsoft.com/office/drawing/2016/SVG/main" r:embed="rId25"/>
+                  <asvg:svgBlip xmlns:asvg="http://schemas.microsoft.com/office/drawing/2016/SVG/main" r:embed="rId19"/>
                 </a:ext>
               </a:extLst>
             </a:blip>
@@ -12803,10 +12828,10 @@
             <p:nvPr/>
           </p:nvPicPr>
           <p:blipFill>
-            <a:blip r:embed="rId34">
+            <a:blip r:embed="rId20">
               <a:extLst>
                 <a:ext uri="{96DAC541-7B7A-43D3-8B79-37D633B846F1}">
-                  <ns9:svgBlip xmlns:ns9="http://schemas.microsoft.com/office/drawing/2016/SVG/main" r:embed="rId41"/>
+                  <asvg:svgBlip xmlns:asvg="http://schemas.microsoft.com/office/drawing/2016/SVG/main" r:embed="rId21"/>
                 </a:ext>
               </a:extLst>
             </a:blip>
@@ -12986,10 +13011,10 @@
             <p:nvPr/>
           </p:nvPicPr>
           <p:blipFill>
-            <a:blip r:embed="rId39">
+            <a:blip r:embed="rId18">
               <a:extLst>
                 <a:ext uri="{96DAC541-7B7A-43D3-8B79-37D633B846F1}">
-                  <ns10:svgBlip xmlns:ns10="http://schemas.microsoft.com/office/drawing/2016/SVG/main" r:embed="rId25"/>
+                  <asvg:svgBlip xmlns:asvg="http://schemas.microsoft.com/office/drawing/2016/SVG/main" r:embed="rId19"/>
                 </a:ext>
               </a:extLst>
             </a:blip>
@@ -13165,10 +13190,10 @@
             <p:nvPr/>
           </p:nvPicPr>
           <p:blipFill>
-            <a:blip r:embed="rId36">
+            <a:blip r:embed="rId22">
               <a:extLst>
                 <a:ext uri="{96DAC541-7B7A-43D3-8B79-37D633B846F1}">
-                  <ns11:svgBlip xmlns:ns11="http://schemas.microsoft.com/office/drawing/2016/SVG/main" r:embed="rId23"/>
+                  <asvg:svgBlip xmlns:asvg="http://schemas.microsoft.com/office/drawing/2016/SVG/main" r:embed="rId23"/>
                 </a:ext>
               </a:extLst>
             </a:blip>
@@ -13346,10 +13371,10 @@
             <p:nvPr/>
           </p:nvPicPr>
           <p:blipFill>
-            <a:blip r:embed="rId26">
+            <a:blip r:embed="rId12">
               <a:extLst>
                 <a:ext uri="{96DAC541-7B7A-43D3-8B79-37D633B846F1}">
-                  <ns12:svgBlip xmlns:ns12="http://schemas.microsoft.com/office/drawing/2016/SVG/main" r:embed="rId28"/>
+                  <asvg:svgBlip xmlns:asvg="http://schemas.microsoft.com/office/drawing/2016/SVG/main" r:embed="rId13"/>
                 </a:ext>
               </a:extLst>
             </a:blip>
@@ -13533,10 +13558,10 @@
             <p:nvPr/>
           </p:nvPicPr>
           <p:blipFill>
-            <a:blip r:embed="rId42">
+            <a:blip r:embed="rId24">
               <a:extLst>
                 <a:ext uri="{96DAC541-7B7A-43D3-8B79-37D633B846F1}">
-                  <ns15:svgBlip xmlns:ns15="http://schemas.microsoft.com/office/drawing/2016/SVG/main" r:embed="rId19"/>
+                  <asvg:svgBlip xmlns:asvg="http://schemas.microsoft.com/office/drawing/2016/SVG/main" r:embed="rId25"/>
                 </a:ext>
               </a:extLst>
             </a:blip>
@@ -13675,7 +13700,9 @@
         <p:txBody>
           <a:bodyPr/>
           <a:lstStyle/>
-          <a:p/>
+          <a:p>
+            <a:endParaRPr/>
+          </a:p>
         </p:txBody>
       </p:sp>
       <p:sp>
@@ -13703,7 +13730,9 @@
         <p:txBody>
           <a:bodyPr/>
           <a:lstStyle/>
-          <a:p/>
+          <a:p>
+            <a:endParaRPr/>
+          </a:p>
         </p:txBody>
       </p:sp>
       <p:sp>
@@ -13731,7 +13760,9 @@
         <p:txBody>
           <a:bodyPr/>
           <a:lstStyle/>
-          <a:p/>
+          <a:p>
+            <a:endParaRPr/>
+          </a:p>
         </p:txBody>
       </p:sp>
       <p:sp>
@@ -13759,7 +13790,9 @@
         <p:txBody>
           <a:bodyPr/>
           <a:lstStyle/>
-          <a:p/>
+          <a:p>
+            <a:endParaRPr/>
+          </a:p>
         </p:txBody>
       </p:sp>
     </p:spTree>
@@ -13821,7 +13854,7 @@
           <a:p>
             <a:fld id="{E668D7D0-CB17-47D3-88E8-EDADFD5EAF7A}" type="datetime1">
               <a:rPr lang="de-CH" smtClean="0"/>
-              <a:t>08.08.2026</a:t>
+              <a:t>10.08.2026</a:t>
             </a:fld>
             <a:endParaRPr lang="de-CH" dirty="0"/>
           </a:p>
@@ -13850,7 +13883,7 @@
           <a:p>
             <a:fld id="{CE7E00E2-F08D-429A-AD9B-1ECBEC02F4DB}" type="slidenum">
               <a:rPr lang="de-CH" smtClean="0"/>
-              <a:t>11</a:t>
+              <a:t>14</a:t>
             </a:fld>
             <a:endParaRPr lang="de-CH" dirty="0"/>
           </a:p>
@@ -13976,7 +14009,7 @@
           <a:p>
             <a:fld id="{CE7E00E2-F08D-429A-AD9B-1ECBEC02F4DB}" type="slidenum">
               <a:rPr lang="de-CH" smtClean="0"/>
-              <a:t>7</a:t>
+              <a:t>15</a:t>
             </a:fld>
             <a:endParaRPr lang="de-CH"/>
           </a:p>
@@ -14774,10 +14807,10 @@
             <p:nvPr/>
           </p:nvPicPr>
           <p:blipFill>
-            <a:blip r:embed="rId16">
+            <a:blip r:embed="rId2">
               <a:extLst>
                 <a:ext uri="{96DAC541-7B7A-43D3-8B79-37D633B846F1}">
-                  <ns0:svgBlip xmlns:ns0="http://schemas.microsoft.com/office/drawing/2016/SVG/main" r:embed="rId31"/>
+                  <asvg:svgBlip xmlns:asvg="http://schemas.microsoft.com/office/drawing/2016/SVG/main" r:embed="rId3"/>
                 </a:ext>
               </a:extLst>
             </a:blip>
@@ -14903,10 +14936,10 @@
             <p:nvPr/>
           </p:nvPicPr>
           <p:blipFill>
-            <a:blip r:embed="rId18">
+            <a:blip r:embed="rId4">
               <a:extLst>
                 <a:ext uri="{96DAC541-7B7A-43D3-8B79-37D633B846F1}">
-                  <ns1:svgBlip xmlns:ns1="http://schemas.microsoft.com/office/drawing/2016/SVG/main" r:embed="rId32"/>
+                  <asvg:svgBlip xmlns:asvg="http://schemas.microsoft.com/office/drawing/2016/SVG/main" r:embed="rId5"/>
                 </a:ext>
               </a:extLst>
             </a:blip>
@@ -15078,10 +15111,10 @@
             <p:nvPr/>
           </p:nvPicPr>
           <p:blipFill>
-            <a:blip r:embed="rId20">
+            <a:blip r:embed="rId6">
               <a:extLst>
                 <a:ext uri="{96DAC541-7B7A-43D3-8B79-37D633B846F1}">
-                  <ns2:svgBlip xmlns:ns2="http://schemas.microsoft.com/office/drawing/2016/SVG/main" r:embed="rId33"/>
+                  <asvg:svgBlip xmlns:asvg="http://schemas.microsoft.com/office/drawing/2016/SVG/main" r:embed="rId7"/>
                 </a:ext>
               </a:extLst>
             </a:blip>
@@ -15255,10 +15288,10 @@
             <p:nvPr/>
           </p:nvPicPr>
           <p:blipFill>
-            <a:blip r:embed="rId22">
+            <a:blip r:embed="rId8">
               <a:extLst>
                 <a:ext uri="{96DAC541-7B7A-43D3-8B79-37D633B846F1}">
-                  <ns3:svgBlip xmlns:ns3="http://schemas.microsoft.com/office/drawing/2016/SVG/main" r:embed="rId29"/>
+                  <asvg:svgBlip xmlns:asvg="http://schemas.microsoft.com/office/drawing/2016/SVG/main" r:embed="rId9"/>
                 </a:ext>
               </a:extLst>
             </a:blip>
@@ -15494,10 +15527,10 @@
             <p:nvPr/>
           </p:nvPicPr>
           <p:blipFill>
-            <a:blip r:embed="rId24">
+            <a:blip r:embed="rId10">
               <a:extLst>
                 <a:ext uri="{96DAC541-7B7A-43D3-8B79-37D633B846F1}">
-                  <ns4:svgBlip xmlns:ns4="http://schemas.microsoft.com/office/drawing/2016/SVG/main" r:embed="rId35"/>
+                  <asvg:svgBlip xmlns:asvg="http://schemas.microsoft.com/office/drawing/2016/SVG/main" r:embed="rId11"/>
                 </a:ext>
               </a:extLst>
             </a:blip>
@@ -15621,10 +15654,10 @@
             <p:nvPr/>
           </p:nvPicPr>
           <p:blipFill>
-            <a:blip r:embed="rId26">
+            <a:blip r:embed="rId12">
               <a:extLst>
                 <a:ext uri="{96DAC541-7B7A-43D3-8B79-37D633B846F1}">
-                  <ns5:svgBlip xmlns:ns5="http://schemas.microsoft.com/office/drawing/2016/SVG/main" r:embed="rId28"/>
+                  <asvg:svgBlip xmlns:asvg="http://schemas.microsoft.com/office/drawing/2016/SVG/main" r:embed="rId13"/>
                 </a:ext>
               </a:extLst>
             </a:blip>
@@ -15800,10 +15833,10 @@
             <p:nvPr/>
           </p:nvPicPr>
           <p:blipFill>
-            <a:blip r:embed="rId9">
+            <a:blip r:embed="rId14">
               <a:extLst>
                 <a:ext uri="{96DAC541-7B7A-43D3-8B79-37D633B846F1}">
-                  <ns6:svgBlip xmlns:ns6="http://schemas.microsoft.com/office/drawing/2016/SVG/main" r:embed="rId37"/>
+                  <asvg:svgBlip xmlns:asvg="http://schemas.microsoft.com/office/drawing/2016/SVG/main" r:embed="rId15"/>
                 </a:ext>
               </a:extLst>
             </a:blip>
@@ -15979,10 +16012,10 @@
             <p:nvPr/>
           </p:nvPicPr>
           <p:blipFill>
-            <a:blip r:embed="rId30">
+            <a:blip r:embed="rId16">
               <a:extLst>
                 <a:ext uri="{96DAC541-7B7A-43D3-8B79-37D633B846F1}">
-                  <ns7:svgBlip xmlns:ns7="http://schemas.microsoft.com/office/drawing/2016/SVG/main" r:embed="rId27"/>
+                  <asvg:svgBlip xmlns:asvg="http://schemas.microsoft.com/office/drawing/2016/SVG/main" r:embed="rId17"/>
                 </a:ext>
               </a:extLst>
             </a:blip>
@@ -16160,10 +16193,10 @@
             <p:nvPr/>
           </p:nvPicPr>
           <p:blipFill>
-            <a:blip r:embed="rId39">
+            <a:blip r:embed="rId18">
               <a:extLst>
                 <a:ext uri="{96DAC541-7B7A-43D3-8B79-37D633B846F1}">
-                  <ns8:svgBlip xmlns:ns8="http://schemas.microsoft.com/office/drawing/2016/SVG/main" r:embed="rId25"/>
+                  <asvg:svgBlip xmlns:asvg="http://schemas.microsoft.com/office/drawing/2016/SVG/main" r:embed="rId19"/>
                 </a:ext>
               </a:extLst>
             </a:blip>
@@ -16349,10 +16382,10 @@
             <p:nvPr/>
           </p:nvPicPr>
           <p:blipFill>
-            <a:blip r:embed="rId34">
+            <a:blip r:embed="rId20">
               <a:extLst>
                 <a:ext uri="{96DAC541-7B7A-43D3-8B79-37D633B846F1}">
-                  <ns9:svgBlip xmlns:ns9="http://schemas.microsoft.com/office/drawing/2016/SVG/main" r:embed="rId41"/>
+                  <asvg:svgBlip xmlns:asvg="http://schemas.microsoft.com/office/drawing/2016/SVG/main" r:embed="rId21"/>
                 </a:ext>
               </a:extLst>
             </a:blip>
@@ -16532,10 +16565,10 @@
             <p:nvPr/>
           </p:nvPicPr>
           <p:blipFill>
-            <a:blip r:embed="rId39">
+            <a:blip r:embed="rId18">
               <a:extLst>
                 <a:ext uri="{96DAC541-7B7A-43D3-8B79-37D633B846F1}">
-                  <ns10:svgBlip xmlns:ns10="http://schemas.microsoft.com/office/drawing/2016/SVG/main" r:embed="rId25"/>
+                  <asvg:svgBlip xmlns:asvg="http://schemas.microsoft.com/office/drawing/2016/SVG/main" r:embed="rId19"/>
                 </a:ext>
               </a:extLst>
             </a:blip>
@@ -16711,10 +16744,10 @@
             <p:nvPr/>
           </p:nvPicPr>
           <p:blipFill>
-            <a:blip r:embed="rId36">
+            <a:blip r:embed="rId22">
               <a:extLst>
                 <a:ext uri="{96DAC541-7B7A-43D3-8B79-37D633B846F1}">
-                  <ns11:svgBlip xmlns:ns11="http://schemas.microsoft.com/office/drawing/2016/SVG/main" r:embed="rId23"/>
+                  <asvg:svgBlip xmlns:asvg="http://schemas.microsoft.com/office/drawing/2016/SVG/main" r:embed="rId23"/>
                 </a:ext>
               </a:extLst>
             </a:blip>
@@ -16892,10 +16925,10 @@
             <p:nvPr/>
           </p:nvPicPr>
           <p:blipFill>
-            <a:blip r:embed="rId26">
+            <a:blip r:embed="rId12">
               <a:extLst>
                 <a:ext uri="{96DAC541-7B7A-43D3-8B79-37D633B846F1}">
-                  <ns12:svgBlip xmlns:ns12="http://schemas.microsoft.com/office/drawing/2016/SVG/main" r:embed="rId28"/>
+                  <asvg:svgBlip xmlns:asvg="http://schemas.microsoft.com/office/drawing/2016/SVG/main" r:embed="rId13"/>
                 </a:ext>
               </a:extLst>
             </a:blip>
@@ -17079,10 +17112,10 @@
             <p:nvPr/>
           </p:nvPicPr>
           <p:blipFill>
-            <a:blip r:embed="rId42">
+            <a:blip r:embed="rId24">
               <a:extLst>
                 <a:ext uri="{96DAC541-7B7A-43D3-8B79-37D633B846F1}">
-                  <ns15:svgBlip xmlns:ns15="http://schemas.microsoft.com/office/drawing/2016/SVG/main" r:embed="rId19"/>
+                  <asvg:svgBlip xmlns:asvg="http://schemas.microsoft.com/office/drawing/2016/SVG/main" r:embed="rId25"/>
                 </a:ext>
               </a:extLst>
             </a:blip>
@@ -17221,7 +17254,9 @@
         <p:txBody>
           <a:bodyPr/>
           <a:lstStyle/>
-          <a:p/>
+          <a:p>
+            <a:endParaRPr/>
+          </a:p>
         </p:txBody>
       </p:sp>
       <p:sp>
@@ -17249,7 +17284,9 @@
         <p:txBody>
           <a:bodyPr/>
           <a:lstStyle/>
-          <a:p/>
+          <a:p>
+            <a:endParaRPr/>
+          </a:p>
         </p:txBody>
       </p:sp>
     </p:spTree>
@@ -18879,10 +18916,9 @@
           <a:lstStyle/>
           <a:p>
             <a:r>
-              <a:rPr lang="de-CH" dirty="0" sz="3600"/>
+              <a:rPr lang="de-CH" sz="3600" dirty="0"/>
               <a:t>Chunking entscheidet, was auffindbar bleibt</a:t>
             </a:r>
-            <a:endParaRPr lang="de-CH" dirty="0" sz="3600"/>
           </a:p>
         </p:txBody>
       </p:sp>
@@ -19653,10 +19689,9 @@
           <a:lstStyle/>
           <a:p>
             <a:r>
-              <a:rPr lang="de-CH" dirty="0" sz="3600"/>
+              <a:rPr lang="de-CH" sz="3600" dirty="0"/>
               <a:t>Reranking sortiert Kandidaten – es findet keine neuen</a:t>
             </a:r>
-            <a:endParaRPr lang="de-CH" dirty="0" sz="3600"/>
           </a:p>
         </p:txBody>
       </p:sp>
@@ -22150,10 +22185,10 @@
           <p:nvPr/>
         </p:nvPicPr>
         <p:blipFill>
-          <a:blip r:embed="rId5">
+          <a:blip r:embed="rId3">
             <a:extLst>
               <a:ext uri="{96DAC541-7B7A-43D3-8B79-37D633B846F1}">
-                <ns0:svgBlip xmlns:ns0="http://schemas.microsoft.com/office/drawing/2016/SVG/main" r:embed="rId6"/>
+                <asvg:svgBlip xmlns:asvg="http://schemas.microsoft.com/office/drawing/2016/SVG/main" r:embed="rId4"/>
               </a:ext>
             </a:extLst>
           </a:blip>
@@ -22202,6 +22237,33 @@
                             </p:stCondLst>
                             <p:childTnLst>
                               <p:par>
+                                <p:cTn id="5" presetID="1" presetClass="entr" presetSubtype="0" fill="hold" grpId="0" nodeType="withEffect">
+                                  <p:stCondLst>
+                                    <p:cond delay="0"/>
+                                  </p:stCondLst>
+                                  <p:childTnLst>
+                                    <p:set>
+                                      <p:cBhvr>
+                                        <p:cTn id="6" dur="1" fill="hold">
+                                          <p:stCondLst>
+                                            <p:cond delay="0"/>
+                                          </p:stCondLst>
+                                        </p:cTn>
+                                        <p:tgtEl>
+                                          <p:spTgt spid="27"/>
+                                        </p:tgtEl>
+                                        <p:attrNameLst>
+                                          <p:attrName>style.visibility</p:attrName>
+                                        </p:attrNameLst>
+                                      </p:cBhvr>
+                                      <p:to>
+                                        <p:strVal val="visible"/>
+                                      </p:to>
+                                    </p:set>
+                                  </p:childTnLst>
+                                </p:cTn>
+                              </p:par>
+                              <p:par>
                                 <p:cTn id="7" presetID="1" presetClass="entr" presetSubtype="0" fill="hold" grpId="0" nodeType="withEffect">
                                   <p:stCondLst>
                                     <p:cond delay="0"/>
@@ -22215,7 +22277,7 @@
                                           </p:stCondLst>
                                         </p:cTn>
                                         <p:tgtEl>
-                                          <p:spTgt spid="27"/>
+                                          <p:spTgt spid="28"/>
                                         </p:tgtEl>
                                         <p:attrNameLst>
                                           <p:attrName>style.visibility</p:attrName>
@@ -22242,7 +22304,7 @@
                                           </p:stCondLst>
                                         </p:cTn>
                                         <p:tgtEl>
-                                          <p:spTgt spid="28"/>
+                                          <p:spTgt spid="29"/>
                                         </p:tgtEl>
                                         <p:attrNameLst>
                                           <p:attrName>style.visibility</p:attrName>
@@ -22269,7 +22331,7 @@
                                           </p:stCondLst>
                                         </p:cTn>
                                         <p:tgtEl>
-                                          <p:spTgt spid="29"/>
+                                          <p:spTgt spid="30"/>
                                         </p:tgtEl>
                                         <p:attrNameLst>
                                           <p:attrName>style.visibility</p:attrName>
@@ -22296,7 +22358,7 @@
                                           </p:stCondLst>
                                         </p:cTn>
                                         <p:tgtEl>
-                                          <p:spTgt spid="30"/>
+                                          <p:spTgt spid="31"/>
                                         </p:tgtEl>
                                         <p:attrNameLst>
                                           <p:attrName>style.visibility</p:attrName>
@@ -22323,7 +22385,7 @@
                                           </p:stCondLst>
                                         </p:cTn>
                                         <p:tgtEl>
-                                          <p:spTgt spid="31"/>
+                                          <p:spTgt spid="32"/>
                                         </p:tgtEl>
                                         <p:attrNameLst>
                                           <p:attrName>style.visibility</p:attrName>
@@ -22350,7 +22412,7 @@
                                           </p:stCondLst>
                                         </p:cTn>
                                         <p:tgtEl>
-                                          <p:spTgt spid="32"/>
+                                          <p:spTgt spid="33"/>
                                         </p:tgtEl>
                                         <p:attrNameLst>
                                           <p:attrName>style.visibility</p:attrName>
@@ -22377,7 +22439,7 @@
                                           </p:stCondLst>
                                         </p:cTn>
                                         <p:tgtEl>
-                                          <p:spTgt spid="33"/>
+                                          <p:spTgt spid="34"/>
                                         </p:tgtEl>
                                         <p:attrNameLst>
                                           <p:attrName>style.visibility</p:attrName>
@@ -22404,7 +22466,7 @@
                                           </p:stCondLst>
                                         </p:cTn>
                                         <p:tgtEl>
-                                          <p:spTgt spid="34"/>
+                                          <p:spTgt spid="35"/>
                                         </p:tgtEl>
                                         <p:attrNameLst>
                                           <p:attrName>style.visibility</p:attrName>
@@ -22431,7 +22493,7 @@
                                           </p:stCondLst>
                                         </p:cTn>
                                         <p:tgtEl>
-                                          <p:spTgt spid="35"/>
+                                          <p:spTgt spid="36"/>
                                         </p:tgtEl>
                                         <p:attrNameLst>
                                           <p:attrName>style.visibility</p:attrName>
@@ -22458,7 +22520,7 @@
                                           </p:stCondLst>
                                         </p:cTn>
                                         <p:tgtEl>
-                                          <p:spTgt spid="36"/>
+                                          <p:spTgt spid="37"/>
                                         </p:tgtEl>
                                         <p:attrNameLst>
                                           <p:attrName>style.visibility</p:attrName>
@@ -22485,7 +22547,7 @@
                                           </p:stCondLst>
                                         </p:cTn>
                                         <p:tgtEl>
-                                          <p:spTgt spid="37"/>
+                                          <p:spTgt spid="38"/>
                                         </p:tgtEl>
                                         <p:attrNameLst>
                                           <p:attrName>style.visibility</p:attrName>
@@ -22512,7 +22574,7 @@
                                           </p:stCondLst>
                                         </p:cTn>
                                         <p:tgtEl>
-                                          <p:spTgt spid="38"/>
+                                          <p:spTgt spid="39"/>
                                         </p:tgtEl>
                                         <p:attrNameLst>
                                           <p:attrName>style.visibility</p:attrName>
@@ -22539,7 +22601,7 @@
                                           </p:stCondLst>
                                         </p:cTn>
                                         <p:tgtEl>
-                                          <p:spTgt spid="39"/>
+                                          <p:spTgt spid="40"/>
                                         </p:tgtEl>
                                         <p:attrNameLst>
                                           <p:attrName>style.visibility</p:attrName>
@@ -22566,33 +22628,6 @@
                                           </p:stCondLst>
                                         </p:cTn>
                                         <p:tgtEl>
-                                          <p:spTgt spid="40"/>
-                                        </p:tgtEl>
-                                        <p:attrNameLst>
-                                          <p:attrName>style.visibility</p:attrName>
-                                        </p:attrNameLst>
-                                      </p:cBhvr>
-                                      <p:to>
-                                        <p:strVal val="visible"/>
-                                      </p:to>
-                                    </p:set>
-                                  </p:childTnLst>
-                                </p:cTn>
-                              </p:par>
-                              <p:par>
-                                <p:cTn id="35" presetID="1" presetClass="entr" presetSubtype="0" fill="hold" grpId="0" nodeType="withEffect">
-                                  <p:stCondLst>
-                                    <p:cond delay="0"/>
-                                  </p:stCondLst>
-                                  <p:childTnLst>
-                                    <p:set>
-                                      <p:cBhvr>
-                                        <p:cTn id="36" dur="1" fill="hold">
-                                          <p:stCondLst>
-                                            <p:cond delay="0"/>
-                                          </p:stCondLst>
-                                        </p:cTn>
-                                        <p:tgtEl>
                                           <p:spTgt spid="41"/>
                                         </p:tgtEl>
                                         <p:attrNameLst>
@@ -22607,15 +22642,42 @@
                                 </p:cTn>
                               </p:par>
                               <p:par>
-                                <p:cTn id="37" presetID="1" presetClass="entr" presetSubtype="0" fill="hold" grpId="0" nodeType="withEffect" nodePh="1">
+                                <p:cTn id="35" presetID="1" presetClass="entr" presetSubtype="0" fill="hold" grpId="0" nodeType="withEffect" nodePh="1">
                                   <p:stCondLst>
                                     <p:cond delay="0"/>
                                   </p:stCondLst>
                                   <p:endCondLst>
                                     <p:cond evt="begin" delay="0">
-                                      <p:tn val="37"/>
+                                      <p:tn val="35"/>
                                     </p:cond>
                                   </p:endCondLst>
+                                  <p:childTnLst>
+                                    <p:set>
+                                      <p:cBhvr>
+                                        <p:cTn id="36" dur="1" fill="hold">
+                                          <p:stCondLst>
+                                            <p:cond delay="0"/>
+                                          </p:stCondLst>
+                                        </p:cTn>
+                                        <p:tgtEl>
+                                          <p:spTgt spid="42"/>
+                                        </p:tgtEl>
+                                        <p:attrNameLst>
+                                          <p:attrName>style.visibility</p:attrName>
+                                        </p:attrNameLst>
+                                      </p:cBhvr>
+                                      <p:to>
+                                        <p:strVal val="visible"/>
+                                      </p:to>
+                                    </p:set>
+                                  </p:childTnLst>
+                                </p:cTn>
+                              </p:par>
+                              <p:par>
+                                <p:cTn id="37" presetID="1" presetClass="entr" presetSubtype="0" fill="hold" grpId="0" nodeType="withEffect">
+                                  <p:stCondLst>
+                                    <p:cond delay="0"/>
+                                  </p:stCondLst>
                                   <p:childTnLst>
                                     <p:set>
                                       <p:cBhvr>
@@ -22625,7 +22687,7 @@
                                           </p:stCondLst>
                                         </p:cTn>
                                         <p:tgtEl>
-                                          <p:spTgt spid="42"/>
+                                          <p:spTgt spid="25"/>
                                         </p:tgtEl>
                                         <p:attrNameLst>
                                           <p:attrName>style.visibility</p:attrName>
@@ -22652,33 +22714,6 @@
                                           </p:stCondLst>
                                         </p:cTn>
                                         <p:tgtEl>
-                                          <p:spTgt spid="25"/>
-                                        </p:tgtEl>
-                                        <p:attrNameLst>
-                                          <p:attrName>style.visibility</p:attrName>
-                                        </p:attrNameLst>
-                                      </p:cBhvr>
-                                      <p:to>
-                                        <p:strVal val="visible"/>
-                                      </p:to>
-                                    </p:set>
-                                  </p:childTnLst>
-                                </p:cTn>
-                              </p:par>
-                              <p:par>
-                                <p:cTn id="41" presetID="1" presetClass="entr" presetSubtype="0" fill="hold" grpId="0" nodeType="withEffect">
-                                  <p:stCondLst>
-                                    <p:cond delay="0"/>
-                                  </p:stCondLst>
-                                  <p:childTnLst>
-                                    <p:set>
-                                      <p:cBhvr>
-                                        <p:cTn id="42" dur="1" fill="hold">
-                                          <p:stCondLst>
-                                            <p:cond delay="0"/>
-                                          </p:stCondLst>
-                                        </p:cTn>
-                                        <p:tgtEl>
                                           <p:spTgt spid="26"/>
                                         </p:tgtEl>
                                         <p:attrNameLst>
@@ -22699,19 +22734,46 @@
                     </p:cTn>
                   </p:par>
                   <p:par>
-                    <p:cTn id="43" fill="hold">
+                    <p:cTn id="41" fill="hold">
                       <p:stCondLst>
                         <p:cond delay="indefinite"/>
                       </p:stCondLst>
                       <p:childTnLst>
                         <p:par>
-                          <p:cTn id="44" fill="hold">
+                          <p:cTn id="42" fill="hold">
                             <p:stCondLst>
                               <p:cond delay="0"/>
                             </p:stCondLst>
                             <p:childTnLst>
                               <p:par>
-                                <p:cTn id="45" presetID="1" presetClass="entr" presetSubtype="0" fill="hold" grpId="0" nodeType="clickEffect">
+                                <p:cTn id="43" presetID="1" presetClass="entr" presetSubtype="0" fill="hold" grpId="0" nodeType="clickEffect">
+                                  <p:stCondLst>
+                                    <p:cond delay="0"/>
+                                  </p:stCondLst>
+                                  <p:childTnLst>
+                                    <p:set>
+                                      <p:cBhvr>
+                                        <p:cTn id="44" dur="1" fill="hold">
+                                          <p:stCondLst>
+                                            <p:cond delay="0"/>
+                                          </p:stCondLst>
+                                        </p:cTn>
+                                        <p:tgtEl>
+                                          <p:spTgt spid="48"/>
+                                        </p:tgtEl>
+                                        <p:attrNameLst>
+                                          <p:attrName>style.visibility</p:attrName>
+                                        </p:attrNameLst>
+                                      </p:cBhvr>
+                                      <p:to>
+                                        <p:strVal val="visible"/>
+                                      </p:to>
+                                    </p:set>
+                                  </p:childTnLst>
+                                </p:cTn>
+                              </p:par>
+                              <p:par>
+                                <p:cTn id="45" presetID="1" presetClass="entr" presetSubtype="0" fill="hold" grpId="0" nodeType="withEffect">
                                   <p:stCondLst>
                                     <p:cond delay="0"/>
                                   </p:stCondLst>
@@ -22724,7 +22786,7 @@
                                           </p:stCondLst>
                                         </p:cTn>
                                         <p:tgtEl>
-                                          <p:spTgt spid="48"/>
+                                          <p:spTgt spid="49"/>
                                         </p:tgtEl>
                                         <p:attrNameLst>
                                           <p:attrName>style.visibility</p:attrName>
@@ -22751,7 +22813,7 @@
                                           </p:stCondLst>
                                         </p:cTn>
                                         <p:tgtEl>
-                                          <p:spTgt spid="49"/>
+                                          <p:spTgt spid="50"/>
                                         </p:tgtEl>
                                         <p:attrNameLst>
                                           <p:attrName>style.visibility</p:attrName>
@@ -22778,7 +22840,7 @@
                                           </p:stCondLst>
                                         </p:cTn>
                                         <p:tgtEl>
-                                          <p:spTgt spid="50"/>
+                                          <p:spTgt spid="51"/>
                                         </p:tgtEl>
                                         <p:attrNameLst>
                                           <p:attrName>style.visibility</p:attrName>
@@ -22805,7 +22867,7 @@
                                           </p:stCondLst>
                                         </p:cTn>
                                         <p:tgtEl>
-                                          <p:spTgt spid="51"/>
+                                          <p:spTgt spid="52"/>
                                         </p:tgtEl>
                                         <p:attrNameLst>
                                           <p:attrName>style.visibility</p:attrName>
@@ -22832,7 +22894,7 @@
                                           </p:stCondLst>
                                         </p:cTn>
                                         <p:tgtEl>
-                                          <p:spTgt spid="52"/>
+                                          <p:spTgt spid="53"/>
                                         </p:tgtEl>
                                         <p:attrNameLst>
                                           <p:attrName>style.visibility</p:attrName>
@@ -22859,7 +22921,7 @@
                                           </p:stCondLst>
                                         </p:cTn>
                                         <p:tgtEl>
-                                          <p:spTgt spid="53"/>
+                                          <p:spTgt spid="54"/>
                                         </p:tgtEl>
                                         <p:attrNameLst>
                                           <p:attrName>style.visibility</p:attrName>
@@ -22886,7 +22948,7 @@
                                           </p:stCondLst>
                                         </p:cTn>
                                         <p:tgtEl>
-                                          <p:spTgt spid="54"/>
+                                          <p:spTgt spid="55"/>
                                         </p:tgtEl>
                                         <p:attrNameLst>
                                           <p:attrName>style.visibility</p:attrName>
@@ -22913,7 +22975,7 @@
                                           </p:stCondLst>
                                         </p:cTn>
                                         <p:tgtEl>
-                                          <p:spTgt spid="55"/>
+                                          <p:spTgt spid="56"/>
                                         </p:tgtEl>
                                         <p:attrNameLst>
                                           <p:attrName>style.visibility</p:attrName>
@@ -22940,7 +23002,7 @@
                                           </p:stCondLst>
                                         </p:cTn>
                                         <p:tgtEl>
-                                          <p:spTgt spid="56"/>
+                                          <p:spTgt spid="57"/>
                                         </p:tgtEl>
                                         <p:attrNameLst>
                                           <p:attrName>style.visibility</p:attrName>
@@ -22967,7 +23029,7 @@
                                           </p:stCondLst>
                                         </p:cTn>
                                         <p:tgtEl>
-                                          <p:spTgt spid="57"/>
+                                          <p:spTgt spid="58"/>
                                         </p:tgtEl>
                                         <p:attrNameLst>
                                           <p:attrName>style.visibility</p:attrName>
@@ -22994,7 +23056,7 @@
                                           </p:stCondLst>
                                         </p:cTn>
                                         <p:tgtEl>
-                                          <p:spTgt spid="58"/>
+                                          <p:spTgt spid="59"/>
                                         </p:tgtEl>
                                         <p:attrNameLst>
                                           <p:attrName>style.visibility</p:attrName>
@@ -23021,7 +23083,7 @@
                                           </p:stCondLst>
                                         </p:cTn>
                                         <p:tgtEl>
-                                          <p:spTgt spid="59"/>
+                                          <p:spTgt spid="60"/>
                                         </p:tgtEl>
                                         <p:attrNameLst>
                                           <p:attrName>style.visibility</p:attrName>
@@ -23048,7 +23110,7 @@
                                           </p:stCondLst>
                                         </p:cTn>
                                         <p:tgtEl>
-                                          <p:spTgt spid="60"/>
+                                          <p:spTgt spid="61"/>
                                         </p:tgtEl>
                                         <p:attrNameLst>
                                           <p:attrName>style.visibility</p:attrName>
@@ -23075,7 +23137,7 @@
                                           </p:stCondLst>
                                         </p:cTn>
                                         <p:tgtEl>
-                                          <p:spTgt spid="61"/>
+                                          <p:spTgt spid="62"/>
                                         </p:tgtEl>
                                         <p:attrNameLst>
                                           <p:attrName>style.visibility</p:attrName>
@@ -23102,33 +23164,6 @@
                                           </p:stCondLst>
                                         </p:cTn>
                                         <p:tgtEl>
-                                          <p:spTgt spid="62"/>
-                                        </p:tgtEl>
-                                        <p:attrNameLst>
-                                          <p:attrName>style.visibility</p:attrName>
-                                        </p:attrNameLst>
-                                      </p:cBhvr>
-                                      <p:to>
-                                        <p:strVal val="visible"/>
-                                      </p:to>
-                                    </p:set>
-                                  </p:childTnLst>
-                                </p:cTn>
-                              </p:par>
-                              <p:par>
-                                <p:cTn id="75" presetID="1" presetClass="entr" presetSubtype="0" fill="hold" grpId="0" nodeType="withEffect">
-                                  <p:stCondLst>
-                                    <p:cond delay="0"/>
-                                  </p:stCondLst>
-                                  <p:childTnLst>
-                                    <p:set>
-                                      <p:cBhvr>
-                                        <p:cTn id="76" dur="1" fill="hold">
-                                          <p:stCondLst>
-                                            <p:cond delay="0"/>
-                                          </p:stCondLst>
-                                        </p:cTn>
-                                        <p:tgtEl>
                                           <p:spTgt spid="63"/>
                                         </p:tgtEl>
                                         <p:attrNameLst>
@@ -23143,19 +23178,19 @@
                                 </p:cTn>
                               </p:par>
                               <p:par>
-                                <p:cTn id="77" presetID="1" presetClass="entr" presetSubtype="0" fill="hold" grpId="0" nodeType="withEffect" nodePh="1">
+                                <p:cTn id="75" presetID="1" presetClass="entr" presetSubtype="0" fill="hold" grpId="0" nodeType="withEffect" nodePh="1">
                                   <p:stCondLst>
                                     <p:cond delay="0"/>
                                   </p:stCondLst>
                                   <p:endCondLst>
                                     <p:cond evt="begin" delay="0">
-                                      <p:tn val="77"/>
+                                      <p:tn val="75"/>
                                     </p:cond>
                                   </p:endCondLst>
                                   <p:childTnLst>
                                     <p:set>
                                       <p:cBhvr>
-                                        <p:cTn id="78" dur="1" fill="hold">
+                                        <p:cTn id="76" dur="1" fill="hold">
                                           <p:stCondLst>
                                             <p:cond delay="0"/>
                                           </p:stCondLst>
@@ -23181,19 +23216,46 @@
                     </p:cTn>
                   </p:par>
                   <p:par>
-                    <p:cTn id="79" fill="hold">
+                    <p:cTn id="77" fill="hold">
                       <p:stCondLst>
                         <p:cond delay="indefinite"/>
                       </p:stCondLst>
                       <p:childTnLst>
                         <p:par>
-                          <p:cTn id="80" fill="hold">
+                          <p:cTn id="78" fill="hold">
                             <p:stCondLst>
                               <p:cond delay="0"/>
                             </p:stCondLst>
                             <p:childTnLst>
                               <p:par>
-                                <p:cTn id="81" presetID="1" presetClass="entr" presetSubtype="0" fill="hold" grpId="0" nodeType="clickEffect">
+                                <p:cTn id="79" presetID="1" presetClass="entr" presetSubtype="0" fill="hold" grpId="0" nodeType="clickEffect">
+                                  <p:stCondLst>
+                                    <p:cond delay="0"/>
+                                  </p:stCondLst>
+                                  <p:childTnLst>
+                                    <p:set>
+                                      <p:cBhvr>
+                                        <p:cTn id="80" dur="1" fill="hold">
+                                          <p:stCondLst>
+                                            <p:cond delay="0"/>
+                                          </p:stCondLst>
+                                        </p:cTn>
+                                        <p:tgtEl>
+                                          <p:spTgt spid="43"/>
+                                        </p:tgtEl>
+                                        <p:attrNameLst>
+                                          <p:attrName>style.visibility</p:attrName>
+                                        </p:attrNameLst>
+                                      </p:cBhvr>
+                                      <p:to>
+                                        <p:strVal val="visible"/>
+                                      </p:to>
+                                    </p:set>
+                                  </p:childTnLst>
+                                </p:cTn>
+                              </p:par>
+                              <p:par>
+                                <p:cTn id="81" presetID="1" presetClass="entr" presetSubtype="0" fill="hold" grpId="0" nodeType="withEffect">
                                   <p:stCondLst>
                                     <p:cond delay="0"/>
                                   </p:stCondLst>
@@ -23206,7 +23268,34 @@
                                           </p:stCondLst>
                                         </p:cTn>
                                         <p:tgtEl>
-                                          <p:spTgt spid="43"/>
+                                          <p:spTgt spid="47"/>
+                                        </p:tgtEl>
+                                        <p:attrNameLst>
+                                          <p:attrName>style.visibility</p:attrName>
+                                        </p:attrNameLst>
+                                      </p:cBhvr>
+                                      <p:to>
+                                        <p:strVal val="visible"/>
+                                      </p:to>
+                                    </p:set>
+                                  </p:childTnLst>
+                                </p:cTn>
+                              </p:par>
+                              <p:par>
+                                <p:cTn id="83" presetID="1" presetClass="entr" presetSubtype="0" fill="hold" grpId="0" nodeType="withEffect">
+                                  <p:stCondLst>
+                                    <p:cond delay="0"/>
+                                  </p:stCondLst>
+                                  <p:childTnLst>
+                                    <p:set>
+                                      <p:cBhvr>
+                                        <p:cTn id="84" dur="1" fill="hold">
+                                          <p:stCondLst>
+                                            <p:cond delay="0"/>
+                                          </p:stCondLst>
+                                        </p:cTn>
+                                        <p:tgtEl>
+                                          <p:spTgt spid="45"/>
                                         </p:tgtEl>
                                         <p:attrNameLst>
                                           <p:attrName>style.visibility</p:attrName>
@@ -23233,60 +23322,6 @@
                                           </p:stCondLst>
                                         </p:cTn>
                                         <p:tgtEl>
-                                          <p:spTgt spid="47"/>
-                                        </p:tgtEl>
-                                        <p:attrNameLst>
-                                          <p:attrName>style.visibility</p:attrName>
-                                        </p:attrNameLst>
-                                      </p:cBhvr>
-                                      <p:to>
-                                        <p:strVal val="visible"/>
-                                      </p:to>
-                                    </p:set>
-                                  </p:childTnLst>
-                                </p:cTn>
-                              </p:par>
-                              <p:par>
-                                <p:cTn id="87" presetID="1" presetClass="entr" presetSubtype="0" fill="hold" grpId="0" nodeType="withEffect">
-                                  <p:stCondLst>
-                                    <p:cond delay="0"/>
-                                  </p:stCondLst>
-                                  <p:childTnLst>
-                                    <p:set>
-                                      <p:cBhvr>
-                                        <p:cTn id="88" dur="1" fill="hold">
-                                          <p:stCondLst>
-                                            <p:cond delay="0"/>
-                                          </p:stCondLst>
-                                        </p:cTn>
-                                        <p:tgtEl>
-                                          <p:spTgt spid="45"/>
-                                        </p:tgtEl>
-                                        <p:attrNameLst>
-                                          <p:attrName>style.visibility</p:attrName>
-                                        </p:attrNameLst>
-                                      </p:cBhvr>
-                                      <p:to>
-                                        <p:strVal val="visible"/>
-                                      </p:to>
-                                    </p:set>
-                                  </p:childTnLst>
-                                </p:cTn>
-                              </p:par>
-                              <p:par>
-                                <p:cTn id="89" presetID="1" presetClass="entr" presetSubtype="0" fill="hold" grpId="0" nodeType="withEffect">
-                                  <p:stCondLst>
-                                    <p:cond delay="0"/>
-                                  </p:stCondLst>
-                                  <p:childTnLst>
-                                    <p:set>
-                                      <p:cBhvr>
-                                        <p:cTn id="90" dur="1" fill="hold">
-                                          <p:stCondLst>
-                                            <p:cond delay="0"/>
-                                          </p:stCondLst>
-                                        </p:cTn>
-                                        <p:tgtEl>
                                           <p:spTgt spid="46"/>
                                         </p:tgtEl>
                                         <p:attrNameLst>
@@ -23301,14 +23336,14 @@
                                 </p:cTn>
                               </p:par>
                               <p:par>
-                                <p:cTn id="91" presetID="1" presetClass="entr" presetSubtype="0" fill="hold" nodeType="withEffect">
+                                <p:cTn id="87" presetID="1" presetClass="entr" presetSubtype="0" fill="hold" nodeType="withEffect">
                                   <p:stCondLst>
                                     <p:cond delay="0"/>
                                   </p:stCondLst>
                                   <p:childTnLst>
                                     <p:set>
                                       <p:cBhvr>
-                                        <p:cTn id="92" dur="1" fill="hold">
+                                        <p:cTn id="88" dur="1" fill="hold">
                                           <p:stCondLst>
                                             <p:cond delay="0"/>
                                           </p:stCondLst>
@@ -23334,26 +23369,26 @@
                     </p:cTn>
                   </p:par>
                   <p:par>
-                    <p:cTn id="93" fill="hold">
+                    <p:cTn id="89" fill="hold">
                       <p:stCondLst>
                         <p:cond delay="indefinite"/>
                       </p:stCondLst>
                       <p:childTnLst>
                         <p:par>
-                          <p:cTn id="94" fill="hold">
+                          <p:cTn id="90" fill="hold">
                             <p:stCondLst>
                               <p:cond delay="0"/>
                             </p:stCondLst>
                             <p:childTnLst>
                               <p:par>
-                                <p:cTn id="95" presetID="1" presetClass="entr" presetSubtype="0" fill="hold" grpId="0" nodeType="clickEffect">
+                                <p:cTn id="91" presetID="1" presetClass="entr" presetSubtype="0" fill="hold" grpId="0" nodeType="clickEffect">
                                   <p:stCondLst>
                                     <p:cond delay="0"/>
                                   </p:stCondLst>
                                   <p:childTnLst>
                                     <p:set>
                                       <p:cBhvr>
-                                        <p:cTn id="96" dur="1" fill="hold">
+                                        <p:cTn id="92" dur="1" fill="hold">
                                           <p:stCondLst>
                                             <p:cond delay="0"/>
                                           </p:stCondLst>
@@ -23373,14 +23408,14 @@
                                 </p:cTn>
                               </p:par>
                               <p:par>
-                                <p:cTn id="97" presetID="1" presetClass="entr" presetSubtype="0" fill="hold" grpId="0" nodeType="withEffect">
+                                <p:cTn id="93" presetID="1" presetClass="entr" presetSubtype="0" fill="hold" grpId="0" nodeType="withEffect">
                                   <p:stCondLst>
                                     <p:cond delay="0"/>
                                   </p:stCondLst>
                                   <p:childTnLst>
                                     <p:set>
                                       <p:cBhvr>
-                                        <p:cTn id="98" dur="1" fill="hold">
+                                        <p:cTn id="94" dur="1" fill="hold">
                                           <p:stCondLst>
                                             <p:cond delay="0"/>
                                           </p:stCondLst>
@@ -23548,7 +23583,7 @@
           <a:p>
             <a:fld id="{CE7E00E2-F08D-429A-AD9B-1ECBEC02F4DB}" type="slidenum">
               <a:rPr lang="de-CH" smtClean="0"/>
-              <a:t>7</a:t>
+              <a:t>18</a:t>
             </a:fld>
             <a:endParaRPr lang="de-CH"/>
           </a:p>
@@ -24493,10 +24528,10 @@
             <p:nvPr/>
           </p:nvPicPr>
           <p:blipFill>
-            <a:blip r:embed="rId16">
+            <a:blip r:embed="rId2">
               <a:extLst>
                 <a:ext uri="{96DAC541-7B7A-43D3-8B79-37D633B846F1}">
-                  <ns0:svgBlip xmlns:ns0="http://schemas.microsoft.com/office/drawing/2016/SVG/main" r:embed="rId31"/>
+                  <asvg:svgBlip xmlns:asvg="http://schemas.microsoft.com/office/drawing/2016/SVG/main" r:embed="rId3"/>
                 </a:ext>
               </a:extLst>
             </a:blip>
@@ -24622,10 +24657,10 @@
             <p:nvPr/>
           </p:nvPicPr>
           <p:blipFill>
-            <a:blip r:embed="rId18">
+            <a:blip r:embed="rId4">
               <a:extLst>
                 <a:ext uri="{96DAC541-7B7A-43D3-8B79-37D633B846F1}">
-                  <ns1:svgBlip xmlns:ns1="http://schemas.microsoft.com/office/drawing/2016/SVG/main" r:embed="rId32"/>
+                  <asvg:svgBlip xmlns:asvg="http://schemas.microsoft.com/office/drawing/2016/SVG/main" r:embed="rId5"/>
                 </a:ext>
               </a:extLst>
             </a:blip>
@@ -24797,10 +24832,10 @@
             <p:nvPr/>
           </p:nvPicPr>
           <p:blipFill>
-            <a:blip r:embed="rId20">
+            <a:blip r:embed="rId6">
               <a:extLst>
                 <a:ext uri="{96DAC541-7B7A-43D3-8B79-37D633B846F1}">
-                  <ns2:svgBlip xmlns:ns2="http://schemas.microsoft.com/office/drawing/2016/SVG/main" r:embed="rId33"/>
+                  <asvg:svgBlip xmlns:asvg="http://schemas.microsoft.com/office/drawing/2016/SVG/main" r:embed="rId7"/>
                 </a:ext>
               </a:extLst>
             </a:blip>
@@ -24974,10 +25009,10 @@
             <p:nvPr/>
           </p:nvPicPr>
           <p:blipFill>
-            <a:blip r:embed="rId22">
+            <a:blip r:embed="rId8">
               <a:extLst>
                 <a:ext uri="{96DAC541-7B7A-43D3-8B79-37D633B846F1}">
-                  <ns3:svgBlip xmlns:ns3="http://schemas.microsoft.com/office/drawing/2016/SVG/main" r:embed="rId29"/>
+                  <asvg:svgBlip xmlns:asvg="http://schemas.microsoft.com/office/drawing/2016/SVG/main" r:embed="rId9"/>
                 </a:ext>
               </a:extLst>
             </a:blip>
@@ -25213,10 +25248,10 @@
             <p:nvPr/>
           </p:nvPicPr>
           <p:blipFill>
-            <a:blip r:embed="rId24">
+            <a:blip r:embed="rId10">
               <a:extLst>
                 <a:ext uri="{96DAC541-7B7A-43D3-8B79-37D633B846F1}">
-                  <ns4:svgBlip xmlns:ns4="http://schemas.microsoft.com/office/drawing/2016/SVG/main" r:embed="rId35"/>
+                  <asvg:svgBlip xmlns:asvg="http://schemas.microsoft.com/office/drawing/2016/SVG/main" r:embed="rId11"/>
                 </a:ext>
               </a:extLst>
             </a:blip>
@@ -25340,10 +25375,10 @@
             <p:nvPr/>
           </p:nvPicPr>
           <p:blipFill>
-            <a:blip r:embed="rId26">
+            <a:blip r:embed="rId12">
               <a:extLst>
                 <a:ext uri="{96DAC541-7B7A-43D3-8B79-37D633B846F1}">
-                  <ns5:svgBlip xmlns:ns5="http://schemas.microsoft.com/office/drawing/2016/SVG/main" r:embed="rId28"/>
+                  <asvg:svgBlip xmlns:asvg="http://schemas.microsoft.com/office/drawing/2016/SVG/main" r:embed="rId13"/>
                 </a:ext>
               </a:extLst>
             </a:blip>
@@ -25519,10 +25554,10 @@
             <p:nvPr/>
           </p:nvPicPr>
           <p:blipFill>
-            <a:blip r:embed="rId9">
+            <a:blip r:embed="rId14">
               <a:extLst>
                 <a:ext uri="{96DAC541-7B7A-43D3-8B79-37D633B846F1}">
-                  <ns6:svgBlip xmlns:ns6="http://schemas.microsoft.com/office/drawing/2016/SVG/main" r:embed="rId37"/>
+                  <asvg:svgBlip xmlns:asvg="http://schemas.microsoft.com/office/drawing/2016/SVG/main" r:embed="rId15"/>
                 </a:ext>
               </a:extLst>
             </a:blip>
@@ -25698,10 +25733,10 @@
             <p:nvPr/>
           </p:nvPicPr>
           <p:blipFill>
-            <a:blip r:embed="rId30">
+            <a:blip r:embed="rId16">
               <a:extLst>
                 <a:ext uri="{96DAC541-7B7A-43D3-8B79-37D633B846F1}">
-                  <ns7:svgBlip xmlns:ns7="http://schemas.microsoft.com/office/drawing/2016/SVG/main" r:embed="rId27"/>
+                  <asvg:svgBlip xmlns:asvg="http://schemas.microsoft.com/office/drawing/2016/SVG/main" r:embed="rId17"/>
                 </a:ext>
               </a:extLst>
             </a:blip>
@@ -25879,10 +25914,10 @@
             <p:nvPr/>
           </p:nvPicPr>
           <p:blipFill>
-            <a:blip r:embed="rId39">
+            <a:blip r:embed="rId18">
               <a:extLst>
                 <a:ext uri="{96DAC541-7B7A-43D3-8B79-37D633B846F1}">
-                  <ns8:svgBlip xmlns:ns8="http://schemas.microsoft.com/office/drawing/2016/SVG/main" r:embed="rId25"/>
+                  <asvg:svgBlip xmlns:asvg="http://schemas.microsoft.com/office/drawing/2016/SVG/main" r:embed="rId19"/>
                 </a:ext>
               </a:extLst>
             </a:blip>
@@ -26068,10 +26103,10 @@
             <p:nvPr/>
           </p:nvPicPr>
           <p:blipFill>
-            <a:blip r:embed="rId34">
+            <a:blip r:embed="rId20">
               <a:extLst>
                 <a:ext uri="{96DAC541-7B7A-43D3-8B79-37D633B846F1}">
-                  <ns9:svgBlip xmlns:ns9="http://schemas.microsoft.com/office/drawing/2016/SVG/main" r:embed="rId41"/>
+                  <asvg:svgBlip xmlns:asvg="http://schemas.microsoft.com/office/drawing/2016/SVG/main" r:embed="rId21"/>
                 </a:ext>
               </a:extLst>
             </a:blip>
@@ -26251,10 +26286,10 @@
             <p:nvPr/>
           </p:nvPicPr>
           <p:blipFill>
-            <a:blip r:embed="rId39">
+            <a:blip r:embed="rId18">
               <a:extLst>
                 <a:ext uri="{96DAC541-7B7A-43D3-8B79-37D633B846F1}">
-                  <ns10:svgBlip xmlns:ns10="http://schemas.microsoft.com/office/drawing/2016/SVG/main" r:embed="rId25"/>
+                  <asvg:svgBlip xmlns:asvg="http://schemas.microsoft.com/office/drawing/2016/SVG/main" r:embed="rId19"/>
                 </a:ext>
               </a:extLst>
             </a:blip>
@@ -26430,10 +26465,10 @@
             <p:nvPr/>
           </p:nvPicPr>
           <p:blipFill>
-            <a:blip r:embed="rId36">
+            <a:blip r:embed="rId22">
               <a:extLst>
                 <a:ext uri="{96DAC541-7B7A-43D3-8B79-37D633B846F1}">
-                  <ns11:svgBlip xmlns:ns11="http://schemas.microsoft.com/office/drawing/2016/SVG/main" r:embed="rId23"/>
+                  <asvg:svgBlip xmlns:asvg="http://schemas.microsoft.com/office/drawing/2016/SVG/main" r:embed="rId23"/>
                 </a:ext>
               </a:extLst>
             </a:blip>
@@ -26611,10 +26646,10 @@
             <p:nvPr/>
           </p:nvPicPr>
           <p:blipFill>
-            <a:blip r:embed="rId26">
+            <a:blip r:embed="rId12">
               <a:extLst>
                 <a:ext uri="{96DAC541-7B7A-43D3-8B79-37D633B846F1}">
-                  <ns12:svgBlip xmlns:ns12="http://schemas.microsoft.com/office/drawing/2016/SVG/main" r:embed="rId28"/>
+                  <asvg:svgBlip xmlns:asvg="http://schemas.microsoft.com/office/drawing/2016/SVG/main" r:embed="rId13"/>
                 </a:ext>
               </a:extLst>
             </a:blip>
@@ -26798,10 +26833,10 @@
             <p:nvPr/>
           </p:nvPicPr>
           <p:blipFill>
-            <a:blip r:embed="rId38">
+            <a:blip r:embed="rId24">
               <a:extLst>
                 <a:ext uri="{96DAC541-7B7A-43D3-8B79-37D633B846F1}">
-                  <ns13:svgBlip xmlns:ns13="http://schemas.microsoft.com/office/drawing/2016/SVG/main" r:embed="rId43"/>
+                  <asvg:svgBlip xmlns:asvg="http://schemas.microsoft.com/office/drawing/2016/SVG/main" r:embed="rId25"/>
                 </a:ext>
               </a:extLst>
             </a:blip>
@@ -26985,10 +27020,10 @@
             <p:nvPr/>
           </p:nvPicPr>
           <p:blipFill>
-            <a:blip r:embed="rId40">
+            <a:blip r:embed="rId26">
               <a:extLst>
                 <a:ext uri="{96DAC541-7B7A-43D3-8B79-37D633B846F1}">
-                  <ns14:svgBlip xmlns:ns14="http://schemas.microsoft.com/office/drawing/2016/SVG/main" r:embed="rId21"/>
+                  <asvg:svgBlip xmlns:asvg="http://schemas.microsoft.com/office/drawing/2016/SVG/main" r:embed="rId27"/>
                 </a:ext>
               </a:extLst>
             </a:blip>
@@ -27174,10 +27209,10 @@
             <p:nvPr/>
           </p:nvPicPr>
           <p:blipFill>
-            <a:blip r:embed="rId42">
+            <a:blip r:embed="rId28">
               <a:extLst>
                 <a:ext uri="{96DAC541-7B7A-43D3-8B79-37D633B846F1}">
-                  <ns15:svgBlip xmlns:ns15="http://schemas.microsoft.com/office/drawing/2016/SVG/main" r:embed="rId19"/>
+                  <asvg:svgBlip xmlns:asvg="http://schemas.microsoft.com/office/drawing/2016/SVG/main" r:embed="rId29"/>
                 </a:ext>
               </a:extLst>
             </a:blip>
@@ -27316,7 +27351,9 @@
         <p:txBody>
           <a:bodyPr/>
           <a:lstStyle/>
-          <a:p/>
+          <a:p>
+            <a:endParaRPr/>
+          </a:p>
         </p:txBody>
       </p:sp>
       <p:sp>
@@ -27344,7 +27381,9 @@
         <p:txBody>
           <a:bodyPr/>
           <a:lstStyle/>
-          <a:p/>
+          <a:p>
+            <a:endParaRPr/>
+          </a:p>
         </p:txBody>
       </p:sp>
     </p:spTree>
@@ -29551,10 +29590,9 @@
           <a:lstStyle/>
           <a:p>
             <a:r>
-              <a:rPr lang="de-CH" dirty="0" sz="3600"/>
+              <a:rPr lang="de-CH" sz="3600" dirty="0"/>
               <a:t>GraphRAG verbindet mehrere Suchsignale</a:t>
             </a:r>
-            <a:endParaRPr lang="de-CH" dirty="0" sz="3600"/>
           </a:p>
         </p:txBody>
       </p:sp>
@@ -30741,7 +30779,7 @@
           <a:p>
             <a:fld id="{E94A5EAB-87E9-4E72-ACDB-1A85F23C04B3}" type="datetime1">
               <a:rPr lang="de-CH" smtClean="0"/>
-              <a:t>08.08.2026</a:t>
+              <a:t>10.08.2026</a:t>
             </a:fld>
             <a:endParaRPr lang="de-CH" dirty="0"/>
           </a:p>
@@ -33832,10 +33870,9 @@
           <a:lstStyle/>
           <a:p>
             <a:r>
-              <a:rPr lang="de-CH" dirty="0" sz="3600"/>
+              <a:rPr lang="de-CH" sz="3600" dirty="0"/>
               <a:t>Hybrider GraphRAG verbindet mehrere Suchsignale</a:t>
             </a:r>
-            <a:endParaRPr lang="de-CH" dirty="0" sz="3600"/>
           </a:p>
         </p:txBody>
       </p:sp>
@@ -34236,7 +34273,7 @@
         </p:nvSpPr>
         <p:spPr>
           <a:xfrm>
-            <a:off x="900000" y="2880000"/>
+            <a:off x="900000" y="3108600"/>
             <a:ext cx="1260000" cy="540000"/>
           </a:xfrm>
           <a:prstGeom prst="rect">
@@ -34264,7 +34301,7 @@
               </a:defRPr>
             </a:pPr>
             <a:r>
-              <a:rPr sz="1725" b="1">
+              <a:rPr sz="1725" b="1" dirty="0">
                 <a:solidFill>
                   <a:srgbClr val="304554"/>
                 </a:solidFill>
@@ -34288,7 +34325,7 @@
               </a:defRPr>
             </a:pPr>
             <a:r>
-              <a:rPr sz="1725" b="1">
+              <a:rPr sz="1725" b="1" dirty="0">
                 <a:solidFill>
                   <a:srgbClr val="304554"/>
                 </a:solidFill>
@@ -34398,7 +34435,7 @@
         </p:nvSpPr>
         <p:spPr>
           <a:xfrm>
-            <a:off x="2340000" y="2880000"/>
+            <a:off x="2340000" y="3108600"/>
             <a:ext cx="1260000" cy="540000"/>
           </a:xfrm>
           <a:prstGeom prst="rect">
@@ -34753,7 +34790,7 @@
         </p:nvSpPr>
         <p:spPr>
           <a:xfrm>
-            <a:off x="4320000" y="2880000"/>
+            <a:off x="4320000" y="3108600"/>
             <a:ext cx="1260000" cy="540000"/>
           </a:xfrm>
           <a:prstGeom prst="rect">
@@ -34915,7 +34952,7 @@
         </p:nvSpPr>
         <p:spPr>
           <a:xfrm>
-            <a:off x="5760000" y="2880000"/>
+            <a:off x="5760000" y="3108600"/>
             <a:ext cx="1260000" cy="540000"/>
           </a:xfrm>
           <a:prstGeom prst="rect">
@@ -35270,7 +35307,7 @@
         </p:nvSpPr>
         <p:spPr>
           <a:xfrm>
-            <a:off x="7740000" y="2880000"/>
+            <a:off x="7740000" y="3108600"/>
             <a:ext cx="1260000" cy="540000"/>
           </a:xfrm>
           <a:prstGeom prst="rect">
@@ -35432,7 +35469,7 @@
         </p:nvSpPr>
         <p:spPr>
           <a:xfrm>
-            <a:off x="9360000" y="2880000"/>
+            <a:off x="9360000" y="3108600"/>
             <a:ext cx="1260000" cy="540000"/>
           </a:xfrm>
           <a:prstGeom prst="rect">
@@ -35893,10 +35930,9 @@
           <a:lstStyle/>
           <a:p>
             <a:r>
-              <a:rPr lang="de-CH" dirty="0" sz="2800"/>
+              <a:rPr lang="de-CH" sz="2800" dirty="0"/>
               <a:t>Besseres Retrieval verbessert Antworten – garantiert sie aber nicht</a:t>
             </a:r>
-            <a:endParaRPr lang="de-CH" dirty="0" sz="2800"/>
           </a:p>
         </p:txBody>
       </p:sp>
@@ -37772,10 +37808,9 @@
           <a:lstStyle/>
           <a:p>
             <a:r>
-              <a:rPr lang="de-CH" dirty="0" sz="3600"/>
+              <a:rPr lang="de-CH" sz="3600" dirty="0"/>
               <a:t>Wahlmodul: Drei Gruppen, ein gemeinsamer Befund</a:t>
             </a:r>
-            <a:endParaRPr lang="de-CH" dirty="0" sz="3600"/>
           </a:p>
         </p:txBody>
       </p:sp>
@@ -39170,10 +39205,9 @@
           <a:lstStyle/>
           <a:p>
             <a:r>
-              <a:rPr lang="de-CH" dirty="0" sz="3600"/>
+              <a:rPr lang="de-CH" sz="3600" dirty="0"/>
               <a:t>Frameworkwahl ist eine Betriebsentscheidung</a:t>
             </a:r>
-            <a:endParaRPr lang="de-CH" dirty="0" sz="3600"/>
           </a:p>
         </p:txBody>
       </p:sp>
@@ -40612,10 +40646,9 @@
           <a:lstStyle/>
           <a:p>
             <a:r>
-              <a:rPr lang="de-CH" dirty="0" sz="3600"/>
+              <a:rPr lang="de-CH" sz="3600" dirty="0"/>
               <a:t>Drei Leitlinien für gutes RAG</a:t>
             </a:r>
-            <a:endParaRPr lang="de-CH" dirty="0" sz="3600"/>
           </a:p>
         </p:txBody>
       </p:sp>
@@ -41884,7 +41917,7 @@
           <a:p>
             <a:fld id="{0CA583EE-97BD-443A-B41B-1EE41A4CF6B6}" type="datetime1">
               <a:rPr lang="de-CH" smtClean="0"/>
-              <a:t>08.08.2026</a:t>
+              <a:t>10.08.2026</a:t>
             </a:fld>
             <a:endParaRPr lang="de-CH" dirty="0"/>
           </a:p>
@@ -41913,7 +41946,7 @@
           <a:p>
             <a:fld id="{CE7E00E2-F08D-429A-AD9B-1ECBEC02F4DB}" type="slidenum">
               <a:rPr lang="de-CH" smtClean="0"/>
-              <a:t>21</a:t>
+              <a:t>26</a:t>
             </a:fld>
             <a:endParaRPr lang="de-CH" dirty="0"/>
           </a:p>
@@ -42425,7 +42458,7 @@
           <a:p>
             <a:fld id="{E668D7D0-CB17-47D3-88E8-EDADFD5EAF7A}" type="datetime1">
               <a:rPr lang="de-CH" smtClean="0"/>
-              <a:t>08.08.2026</a:t>
+              <a:t>10.08.2026</a:t>
             </a:fld>
             <a:endParaRPr lang="de-CH" dirty="0"/>
           </a:p>
@@ -42570,7 +42603,7 @@
           <a:p>
             <a:fld id="{3B96E7C6-F2CE-4756-8C9C-414CDB636DDE}" type="datetime1">
               <a:rPr lang="de-CH" smtClean="0"/>
-              <a:t>08.08.2026</a:t>
+              <a:t>10.08.2026</a:t>
             </a:fld>
             <a:endParaRPr lang="de-CH" dirty="0"/>
           </a:p>
@@ -45086,7 +45119,7 @@
           <a:p>
             <a:fld id="{1EB7C1D4-D1F3-40CB-8780-B2B6A9133392}" type="datetime1">
               <a:rPr lang="de-DE"/>
-              <a:t>08.08.2026</a:t>
+              <a:t>10.08.2026</a:t>
             </a:fld>
             <a:endParaRPr/>
           </a:p>
@@ -45294,10 +45327,10 @@
           <p:nvPr/>
         </p:nvPicPr>
         <p:blipFill>
-          <a:blip r:embed="rId8">
+          <a:blip r:embed="rId3">
             <a:extLst>
               <a:ext uri="{96DAC541-7B7A-43D3-8B79-37D633B846F1}">
-                <ns1:svgBlip xmlns:ns1="http://schemas.microsoft.com/office/drawing/2016/SVG/main" r:embed="rId9"/>
+                <asvg:svgBlip xmlns:asvg="http://schemas.microsoft.com/office/drawing/2016/SVG/main" r:embed="rId4"/>
               </a:ext>
             </a:extLst>
           </a:blip>
@@ -45592,10 +45625,10 @@
           <p:nvPr/>
         </p:nvPicPr>
         <p:blipFill>
-          <a:blip r:embed="rId6">
+          <a:blip r:embed="rId5">
             <a:extLst>
               <a:ext uri="{96DAC541-7B7A-43D3-8B79-37D633B846F1}">
-                <ns0:svgBlip xmlns:ns0="http://schemas.microsoft.com/office/drawing/2016/SVG/main" r:embed="rId7"/>
+                <asvg:svgBlip xmlns:asvg="http://schemas.microsoft.com/office/drawing/2016/SVG/main" r:embed="rId6"/>
               </a:ext>
             </a:extLst>
           </a:blip>
@@ -45879,10 +45912,10 @@
           <p:nvPr/>
         </p:nvPicPr>
         <p:blipFill>
-          <a:blip r:embed="rId10">
+          <a:blip r:embed="rId7">
             <a:extLst>
               <a:ext uri="{96DAC541-7B7A-43D3-8B79-37D633B846F1}">
-                <ns2:svgBlip xmlns:ns2="http://schemas.microsoft.com/office/drawing/2016/SVG/main" r:embed="rId11"/>
+                <asvg:svgBlip xmlns:asvg="http://schemas.microsoft.com/office/drawing/2016/SVG/main" r:embed="rId8"/>
               </a:ext>
             </a:extLst>
           </a:blip>
@@ -46710,7 +46743,7 @@
           <a:p>
             <a:fld id="{E2111384-F462-4D90-9803-E7B6DB23FD1B}" type="datetime1">
               <a:rPr lang="de-DE"/>
-              <a:t>08.08.2026</a:t>
+              <a:t>10.08.2026</a:t>
             </a:fld>
             <a:endParaRPr/>
           </a:p>
@@ -49385,10 +49418,10 @@
             <p:nvPr/>
           </p:nvPicPr>
           <p:blipFill>
-            <a:blip r:embed="rId16">
+            <a:blip r:embed="rId3">
               <a:extLst>
                 <a:ext uri="{96DAC541-7B7A-43D3-8B79-37D633B846F1}">
-                  <ns0:svgBlip xmlns:ns0="http://schemas.microsoft.com/office/drawing/2016/SVG/main" r:embed="rId31"/>
+                  <asvg:svgBlip xmlns:asvg="http://schemas.microsoft.com/office/drawing/2016/SVG/main" r:embed="rId4"/>
                 </a:ext>
               </a:extLst>
             </a:blip>
@@ -49514,10 +49547,10 @@
             <p:nvPr/>
           </p:nvPicPr>
           <p:blipFill>
-            <a:blip r:embed="rId18">
+            <a:blip r:embed="rId5">
               <a:extLst>
                 <a:ext uri="{96DAC541-7B7A-43D3-8B79-37D633B846F1}">
-                  <ns1:svgBlip xmlns:ns1="http://schemas.microsoft.com/office/drawing/2016/SVG/main" r:embed="rId32"/>
+                  <asvg:svgBlip xmlns:asvg="http://schemas.microsoft.com/office/drawing/2016/SVG/main" r:embed="rId6"/>
                 </a:ext>
               </a:extLst>
             </a:blip>
@@ -49689,10 +49722,10 @@
             <p:nvPr/>
           </p:nvPicPr>
           <p:blipFill>
-            <a:blip r:embed="rId20">
+            <a:blip r:embed="rId7">
               <a:extLst>
                 <a:ext uri="{96DAC541-7B7A-43D3-8B79-37D633B846F1}">
-                  <ns2:svgBlip xmlns:ns2="http://schemas.microsoft.com/office/drawing/2016/SVG/main" r:embed="rId33"/>
+                  <asvg:svgBlip xmlns:asvg="http://schemas.microsoft.com/office/drawing/2016/SVG/main" r:embed="rId8"/>
                 </a:ext>
               </a:extLst>
             </a:blip>
@@ -49866,10 +49899,10 @@
             <p:nvPr/>
           </p:nvPicPr>
           <p:blipFill>
-            <a:blip r:embed="rId22">
+            <a:blip r:embed="rId9">
               <a:extLst>
                 <a:ext uri="{96DAC541-7B7A-43D3-8B79-37D633B846F1}">
-                  <ns3:svgBlip xmlns:ns3="http://schemas.microsoft.com/office/drawing/2016/SVG/main" r:embed="rId29"/>
+                  <asvg:svgBlip xmlns:asvg="http://schemas.microsoft.com/office/drawing/2016/SVG/main" r:embed="rId10"/>
                 </a:ext>
               </a:extLst>
             </a:blip>
@@ -50105,10 +50138,10 @@
             <p:nvPr/>
           </p:nvPicPr>
           <p:blipFill>
-            <a:blip r:embed="rId24">
+            <a:blip r:embed="rId11">
               <a:extLst>
                 <a:ext uri="{96DAC541-7B7A-43D3-8B79-37D633B846F1}">
-                  <ns4:svgBlip xmlns:ns4="http://schemas.microsoft.com/office/drawing/2016/SVG/main" r:embed="rId35"/>
+                  <asvg:svgBlip xmlns:asvg="http://schemas.microsoft.com/office/drawing/2016/SVG/main" r:embed="rId12"/>
                 </a:ext>
               </a:extLst>
             </a:blip>
@@ -50232,10 +50265,10 @@
             <p:nvPr/>
           </p:nvPicPr>
           <p:blipFill>
-            <a:blip r:embed="rId26">
+            <a:blip r:embed="rId13">
               <a:extLst>
                 <a:ext uri="{96DAC541-7B7A-43D3-8B79-37D633B846F1}">
-                  <ns5:svgBlip xmlns:ns5="http://schemas.microsoft.com/office/drawing/2016/SVG/main" r:embed="rId28"/>
+                  <asvg:svgBlip xmlns:asvg="http://schemas.microsoft.com/office/drawing/2016/SVG/main" r:embed="rId14"/>
                 </a:ext>
               </a:extLst>
             </a:blip>
@@ -50411,10 +50444,10 @@
             <p:nvPr/>
           </p:nvPicPr>
           <p:blipFill>
-            <a:blip r:embed="rId9">
+            <a:blip r:embed="rId15">
               <a:extLst>
                 <a:ext uri="{96DAC541-7B7A-43D3-8B79-37D633B846F1}">
-                  <ns6:svgBlip xmlns:ns6="http://schemas.microsoft.com/office/drawing/2016/SVG/main" r:embed="rId37"/>
+                  <asvg:svgBlip xmlns:asvg="http://schemas.microsoft.com/office/drawing/2016/SVG/main" r:embed="rId16"/>
                 </a:ext>
               </a:extLst>
             </a:blip>
@@ -50590,10 +50623,10 @@
             <p:nvPr/>
           </p:nvPicPr>
           <p:blipFill>
-            <a:blip r:embed="rId30">
+            <a:blip r:embed="rId17">
               <a:extLst>
                 <a:ext uri="{96DAC541-7B7A-43D3-8B79-37D633B846F1}">
-                  <ns7:svgBlip xmlns:ns7="http://schemas.microsoft.com/office/drawing/2016/SVG/main" r:embed="rId27"/>
+                  <asvg:svgBlip xmlns:asvg="http://schemas.microsoft.com/office/drawing/2016/SVG/main" r:embed="rId18"/>
                 </a:ext>
               </a:extLst>
             </a:blip>
@@ -50771,10 +50804,10 @@
             <p:nvPr/>
           </p:nvPicPr>
           <p:blipFill>
-            <a:blip r:embed="rId39">
+            <a:blip r:embed="rId19">
               <a:extLst>
                 <a:ext uri="{96DAC541-7B7A-43D3-8B79-37D633B846F1}">
-                  <ns8:svgBlip xmlns:ns8="http://schemas.microsoft.com/office/drawing/2016/SVG/main" r:embed="rId25"/>
+                  <asvg:svgBlip xmlns:asvg="http://schemas.microsoft.com/office/drawing/2016/SVG/main" r:embed="rId20"/>
                 </a:ext>
               </a:extLst>
             </a:blip>
@@ -50960,10 +50993,10 @@
             <p:nvPr/>
           </p:nvPicPr>
           <p:blipFill>
-            <a:blip r:embed="rId34">
+            <a:blip r:embed="rId21">
               <a:extLst>
                 <a:ext uri="{96DAC541-7B7A-43D3-8B79-37D633B846F1}">
-                  <ns9:svgBlip xmlns:ns9="http://schemas.microsoft.com/office/drawing/2016/SVG/main" r:embed="rId41"/>
+                  <asvg:svgBlip xmlns:asvg="http://schemas.microsoft.com/office/drawing/2016/SVG/main" r:embed="rId22"/>
                 </a:ext>
               </a:extLst>
             </a:blip>
@@ -51143,10 +51176,10 @@
             <p:nvPr/>
           </p:nvPicPr>
           <p:blipFill>
-            <a:blip r:embed="rId39">
+            <a:blip r:embed="rId19">
               <a:extLst>
                 <a:ext uri="{96DAC541-7B7A-43D3-8B79-37D633B846F1}">
-                  <ns10:svgBlip xmlns:ns10="http://schemas.microsoft.com/office/drawing/2016/SVG/main" r:embed="rId25"/>
+                  <asvg:svgBlip xmlns:asvg="http://schemas.microsoft.com/office/drawing/2016/SVG/main" r:embed="rId20"/>
                 </a:ext>
               </a:extLst>
             </a:blip>
@@ -51322,10 +51355,10 @@
             <p:nvPr/>
           </p:nvPicPr>
           <p:blipFill>
-            <a:blip r:embed="rId36">
+            <a:blip r:embed="rId23">
               <a:extLst>
                 <a:ext uri="{96DAC541-7B7A-43D3-8B79-37D633B846F1}">
-                  <ns11:svgBlip xmlns:ns11="http://schemas.microsoft.com/office/drawing/2016/SVG/main" r:embed="rId23"/>
+                  <asvg:svgBlip xmlns:asvg="http://schemas.microsoft.com/office/drawing/2016/SVG/main" r:embed="rId24"/>
                 </a:ext>
               </a:extLst>
             </a:blip>
@@ -51503,10 +51536,10 @@
             <p:nvPr/>
           </p:nvPicPr>
           <p:blipFill>
-            <a:blip r:embed="rId26">
+            <a:blip r:embed="rId13">
               <a:extLst>
                 <a:ext uri="{96DAC541-7B7A-43D3-8B79-37D633B846F1}">
-                  <ns12:svgBlip xmlns:ns12="http://schemas.microsoft.com/office/drawing/2016/SVG/main" r:embed="rId28"/>
+                  <asvg:svgBlip xmlns:asvg="http://schemas.microsoft.com/office/drawing/2016/SVG/main" r:embed="rId14"/>
                 </a:ext>
               </a:extLst>
             </a:blip>
@@ -51690,10 +51723,10 @@
             <p:nvPr/>
           </p:nvPicPr>
           <p:blipFill>
-            <a:blip r:embed="rId38">
+            <a:blip r:embed="rId25">
               <a:extLst>
                 <a:ext uri="{96DAC541-7B7A-43D3-8B79-37D633B846F1}">
-                  <ns13:svgBlip xmlns:ns13="http://schemas.microsoft.com/office/drawing/2016/SVG/main" r:embed="rId43"/>
+                  <asvg:svgBlip xmlns:asvg="http://schemas.microsoft.com/office/drawing/2016/SVG/main" r:embed="rId26"/>
                 </a:ext>
               </a:extLst>
             </a:blip>
@@ -51877,10 +51910,10 @@
             <p:nvPr/>
           </p:nvPicPr>
           <p:blipFill>
-            <a:blip r:embed="rId40">
+            <a:blip r:embed="rId27">
               <a:extLst>
                 <a:ext uri="{96DAC541-7B7A-43D3-8B79-37D633B846F1}">
-                  <ns14:svgBlip xmlns:ns14="http://schemas.microsoft.com/office/drawing/2016/SVG/main" r:embed="rId21"/>
+                  <asvg:svgBlip xmlns:asvg="http://schemas.microsoft.com/office/drawing/2016/SVG/main" r:embed="rId28"/>
                 </a:ext>
               </a:extLst>
             </a:blip>
@@ -52066,10 +52099,10 @@
             <p:nvPr/>
           </p:nvPicPr>
           <p:blipFill>
-            <a:blip r:embed="rId42">
+            <a:blip r:embed="rId29">
               <a:extLst>
                 <a:ext uri="{96DAC541-7B7A-43D3-8B79-37D633B846F1}">
-                  <ns15:svgBlip xmlns:ns15="http://schemas.microsoft.com/office/drawing/2016/SVG/main" r:embed="rId19"/>
+                  <asvg:svgBlip xmlns:asvg="http://schemas.microsoft.com/office/drawing/2016/SVG/main" r:embed="rId30"/>
                 </a:ext>
               </a:extLst>
             </a:blip>
@@ -52303,7 +52336,7 @@
             <a:fld id="{1EB7C1D4-D1F3-40CB-8780-B2B6A9133392}" type="datetime1">
               <a:rPr lang="de-DE"/>
               <a:pPr/>
-              <a:t>08.08.2026</a:t>
+              <a:t>10.08.2026</a:t>
             </a:fld>
             <a:endParaRPr lang="de-DE" dirty="0"/>
           </a:p>
@@ -54068,7 +54101,7 @@
           <a:p>
             <a:fld id="{E668D7D0-CB17-47D3-88E8-EDADFD5EAF7A}" type="datetime1">
               <a:rPr lang="de-CH" smtClean="0"/>
-              <a:t>08.08.2026</a:t>
+              <a:t>10.08.2026</a:t>
             </a:fld>
             <a:endParaRPr lang="de-CH" dirty="0"/>
           </a:p>
@@ -55213,15 +55246,6 @@
 </file>
 
 <file path=customXml/item2.xml><?xml version="1.0" encoding="utf-8"?>
-<?mso-contentType ?>
-<FormTemplates xmlns="http://schemas.microsoft.com/sharepoint/v3/contenttype/forms">
-  <Display>DocumentLibraryForm</Display>
-  <Edit>DocumentLibraryForm</Edit>
-  <New>DocumentLibraryForm</New>
-</FormTemplates>
-</file>
-
-<file path=customXml/item3.xml><?xml version="1.0" encoding="utf-8"?>
 <p:properties xmlns:p="http://schemas.microsoft.com/office/2006/metadata/properties" xmlns:xsi="http://www.w3.org/2001/XMLSchema-instance" xmlns:pc="http://schemas.microsoft.com/office/infopath/2007/PartnerControls">
   <documentManagement>
     <lcf76f155ced4ddcb4097134ff3c332f xmlns="501edefc-5b9b-422a-9450-cf7f1f30e3fa">
@@ -55230,6 +55254,15 @@
     <TaxCatchAll xmlns="3083c7a9-d95a-44c4-8fb8-f93b125494d6" xsi:nil="true"/>
   </documentManagement>
 </p:properties>
+</file>
+
+<file path=customXml/item3.xml><?xml version="1.0" encoding="utf-8"?>
+<?mso-contentType ?>
+<FormTemplates xmlns="http://schemas.microsoft.com/sharepoint/v3/contenttype/forms">
+  <Display>DocumentLibraryForm</Display>
+  <Edit>DocumentLibraryForm</Edit>
+  <New>DocumentLibraryForm</New>
+</FormTemplates>
 </file>
 
 <file path=customXml/itemProps1.xml><?xml version="1.0" encoding="utf-8"?>
@@ -55252,14 +55285,6 @@
 </file>
 
 <file path=customXml/itemProps2.xml><?xml version="1.0" encoding="utf-8"?>
-<ds:datastoreItem xmlns:ds="http://schemas.openxmlformats.org/officeDocument/2006/customXml" ds:itemID="{334436CE-240F-4EE4-9FC5-4255E6874223}">
-  <ds:schemaRefs>
-    <ds:schemaRef ds:uri="http://schemas.microsoft.com/sharepoint/v3/contenttype/forms"/>
-  </ds:schemaRefs>
-</ds:datastoreItem>
-</file>
-
-<file path=customXml/itemProps3.xml><?xml version="1.0" encoding="utf-8"?>
 <ds:datastoreItem xmlns:ds="http://schemas.openxmlformats.org/officeDocument/2006/customXml" ds:itemID="{6302A1CC-4AEF-4830-BB1C-A446161EB02D}">
   <ds:schemaRefs>
     <ds:schemaRef ds:uri="http://schemas.microsoft.com/office/2006/metadata/properties"/>
@@ -55274,6 +55299,14 @@
 </ds:datastoreItem>
 </file>
 
+<file path=customXml/itemProps3.xml><?xml version="1.0" encoding="utf-8"?>
+<ds:datastoreItem xmlns:ds="http://schemas.openxmlformats.org/officeDocument/2006/customXml" ds:itemID="{334436CE-240F-4EE4-9FC5-4255E6874223}">
+  <ds:schemaRefs>
+    <ds:schemaRef ds:uri="http://schemas.microsoft.com/sharepoint/v3/contenttype/forms"/>
+  </ds:schemaRefs>
+</ds:datastoreItem>
+</file>
+
 <file path=docMetadata/LabelInfo.xml><?xml version="1.0" encoding="utf-8"?>
 <clbl:labelList xmlns:clbl="http://schemas.microsoft.com/office/2020/mipLabelMetadata">
   <clbl:label id="{42e461c6-591f-4920-9cf0-f1389542f8ad}" enabled="1" method="Standard" siteId="{2cda5d11-f0ac-46b3-967d-af1b2e1bd01a}" contentBits="2" removed="0"/>

</xml_diff>